<commit_message>
Talk: studio demo slide, experiments framed by what they show
Experiment 1 is presented as a design check (the tier fixes the count; load and
congestion follow from the rules), Experiment 2 as the independent test (the gap
distribution was fitted on the duplex; the clinic was held out), Experiment 3 as
a use of the dataset. Slide 12 is a live demo of the Generator Studio with its
screenshot and a QR code as the fallback; the first appendix slide shows two
more studio sections. Script retimed to about 9.5 minutes, with answers to
'isn't Experiment 1 circular?' and 'was it tuned to the clinic?'.

scripts/screenshot_studio.js captures the studio for the deck; make_figures.py
writes the studio QR code. PPTX and PDF rebuilt.

Co-Authored-By: Claude <noreply@anthropic.com>
Claude-Session: https://claude.ai/code/session_01R1ft1rokeRJHR95rzLxNEC
</commit_message>
<xml_diff>
--- a/docs/CrossMEP_CIBW78_talk.pptx
+++ b/docs/CrossMEP_CIBW78_talk.pptx
@@ -23,9 +23,11 @@
     <p:sldId id="271" r:id="rId17"/>
     <p:sldId id="272" r:id="rId18"/>
     <p:sldId id="273" r:id="rId19"/>
+    <p:sldId id="274" r:id="rId20"/>
+    <p:sldId id="275" r:id="rId21"/>
   </p:sldIdLst>
   <p:notesMasterIdLst>
-    <p:notesMasterId r:id="rId20"/>
+    <p:notesMasterId r:id="rId22"/>
   </p:notesMasterIdLst>
   <p:sldSz cx="12192000" cy="6858000"/>
   <p:notesSz cx="6858000" cy="12192000"/>
@@ -124,18 +126,18 @@
   <p:extLst>
     <p:ext uri="{521415D9-36F7-43E2-AB2F-B90AF26B5E84}">
       <p14:sectionLst xmlns:p14="http://schemas.microsoft.com/office/powerpoint/2010/main">
-        <p14:section name="Opening" id="{ae595e5e-94ce-81c5-e535-810e40650e6a}">
+        <p14:section name="Opening" id="{4c611684-4a5d-11ba-3c2f-2a96587b7a76}">
           <p14:sldIdLst>
             <p14:sldId id="256"/>
           </p14:sldIdLst>
         </p14:section>
-        <p14:section name="Motivation" id="{3b89c19d-0cb8-d8aa-956f-bafa473af851}">
+        <p14:section name="Motivation" id="{d23312e0-704f-ec5a-6a3c-8ff2d7ee669c}">
           <p14:sldIdLst>
             <p14:sldId id="257"/>
             <p14:sldId id="258"/>
           </p14:sldIdLst>
         </p14:section>
-        <p14:section name="The dataset" id="{814136bf-ffcc-4142-eb50-e191096d1801}">
+        <p14:section name="The dataset" id="{4c5f959b-55d5-84b4-d094-b454fc8bcaef}">
           <p14:sldIdLst>
             <p14:sldId id="259"/>
             <p14:sldId id="260"/>
@@ -144,26 +146,28 @@
             <p14:sldId id="263"/>
           </p14:sldIdLst>
         </p14:section>
-        <p14:section name="Experiments" id="{32e14631-e5ef-3172-1046-09b601e35a4c}">
+        <p14:section name="Experiments" id="{bbb2e11e-54ba-a0ec-6c0d-6e7169dd0181}">
           <p14:sldIdLst>
             <p14:sldId id="264"/>
             <p14:sldId id="265"/>
             <p14:sldId id="266"/>
           </p14:sldIdLst>
         </p14:section>
-        <p14:section name="Use" id="{a131732d-eb52-1a21-8dbe-3b34d3992790}">
+        <p14:section name="Use" id="{e88cd628-f5fc-6f7d-69e4-e45826598288}">
           <p14:sldIdLst>
             <p14:sldId id="267"/>
             <p14:sldId id="268"/>
             <p14:sldId id="269"/>
+            <p14:sldId id="270"/>
           </p14:sldIdLst>
         </p14:section>
-        <p14:section name="Appendix" id="{f5ebbb5c-7571-06b5-c085-1d2bfe93f2f0}">
+        <p14:section name="Appendix" id="{11d5b320-f10b-5b31-bb11-55531da13b9b}">
           <p14:sldIdLst>
-            <p14:sldId id="270"/>
             <p14:sldId id="271"/>
             <p14:sldId id="272"/>
             <p14:sldId id="273"/>
+            <p14:sldId id="274"/>
+            <p14:sldId id="275"/>
           </p14:sldIdLst>
         </p14:section>
       </p14:sectionLst>
@@ -2033,7 +2037,7 @@
           <a:p>
             <a:r>
               <a:rPr lang="en-US" dirty="0"/>
-              <a:t>Second experiment: is the spacing realistic? We took two open buildings from buildingSMART - a residential duplex and a medical-dental clinic, which is a real building - and cut sections every 250 millimetres, the way a context is defined, measuring the gap between pipes running side by side. On the left, the clinic, which the generator never saw: the generated gaps follow the measured ones closely. On the right, the distances. Generated to clinic: 28 millimetres, about as close as the duplex's own two models are to each other. The small duplex is as far from the generator as it is from the clinic. A fixed modular gap would be about 190 millimetres off. (6:15)</a:t>
+              <a:t>The second experiment is the one the generator could fail: is the spacing realistic in a building it never saw? The gap distribution was fitted on a residential duplex from buildingSMART. We held out a second open building, a medical-dental clinic, which is a real building, cut it into sections every 250 millimetres, the way a context is defined, and measured the gap between pipes running side by side. On the left, the clinic: the generated gaps follow the measured ones. On the right, the distances: generated to clinic 28 millimetres, about as close as the duplex's own two models are to each other. A fixed modular gap would be about 190 millimetres off. (6:00)</a:t>
             </a:r>
             <a:endParaRPr lang="en-US" dirty="0"/>
           </a:p>
@@ -2121,7 +2125,7 @@
           <a:p>
             <a:r>
               <a:rPr lang="en-US" dirty="0"/>
-              <a:t>The third experiment connects the dataset to the task it serves: what must a catalog of clamps cover? Take the two-size catalog from the paper as an illustration. It attaches 11.6 per cent of the pipes - 293 of 2,529, interval 10 to 13 - and every one is a single size, DN40. Load never binds: the heaviest pipe is 0.88 kilonewtons against a 2.5 kilonewton clamp. Trays, ducts and conduits are not covered at all. On the right is what the dataset asks of any catalog: two sizes placed where the pipes are would attach 43 per cent, six sizes 80, and 12 sizes every pipe. So 'what should the catalog contain' becomes a measurement. (7:05)</a:t>
+              <a:t>The third is a use of the dataset, not a test of it: what must a catalog of clamps cover? Take the paper's two-size catalog as an illustration. It attaches 11.6 per cent of the pipes, interval 10 to 13, all of one size, DN40; load never binds, and trays, ducts and conduits are not covered at all. On the right is what the dataset asks of any catalog: two well-placed sizes attach 43 per cent, six 80, 12 every pipe. So 'what should the catalog contain' becomes a measurement. (6:50)</a:t>
             </a:r>
             <a:endParaRPr lang="en-US" dirty="0"/>
           </a:p>
@@ -2209,7 +2213,7 @@
           <a:p>
             <a:r>
               <a:rPr lang="en-US" dirty="0"/>
-              <a:t>Using it takes a few lines. Load a split - only the Python standard library is needed - filter by composition, or generate your own mix with the same rules; there is an interactive gallery for inspection. Because there are no labels, the same files serve reinforcement learning, constraint-programming baselines and human benchmarking, and we ship the scoring too: train on the generator with as many seeds as you like, from C1 up to C8; evaluate on the benchmark, the same 125 contexts per tier for every method; and report per tier with 95 per cent intervals and paired tests, so two methods can be compared fairly. (7:50)</a:t>
+              <a:t>Here is what that means in practice. In the studio I choose what crosses the hanger: a tier, or an exact mix, and the seed. Out comes the section a support designer receives, drawn the way an engineer would issue it: every service at true size, its level below the slab, its load at the support, the closest clear gap; and the same run in 3D. Every section is a stored output of the released generator, with the Python call that reproduces it. [Live: switch to the studio, click C3, then Generate another twice, then Exact mix with a duct. If the demo fails, stay on this slide; slide 16 shows two more sections.] (7:30)</a:t>
             </a:r>
             <a:endParaRPr lang="en-US" dirty="0"/>
           </a:p>
@@ -2297,7 +2301,7 @@
           <a:p>
             <a:r>
               <a:rPr lang="en-US" dirty="0"/>
-              <a:t>Its scope: one section at one support - routing, branches and spacing are outside it, although the span is recorded so a method can vary it. Realism is checked on sections of two open buildings; congested racks rest on practice and standards. The trade mix is a design choice, and the data is not for structural design. Next: a public checker for support designs, with best-known costs, so methods can be compared on the answer and not only on the brief; the catalog as an input, so a method is tested on catalogs it has never seen; and a real test set from commercial projects, with supports designed by engineers - which is where we would value your eye. (8:40)</a:t>
+              <a:t>Using it takes a few lines: load a split with the Python standard library, filter by composition, or generate your own mix with the same rules. Because there are no labels, the same files serve reinforcement learning, constraint-programming baselines and human benchmarking, and we ship the scoring: train on the generator, from C1 up to C8; evaluate on the benchmark, the same 125 contexts per tier for every method; report per tier with 95 per cent intervals and paired tests. (8:10)</a:t>
             </a:r>
             <a:endParaRPr lang="en-US" dirty="0"/>
           </a:p>
@@ -2385,7 +2389,7 @@
           <a:p>
             <a:r>
               <a:rPr lang="en-US" dirty="0"/>
-              <a:t>CrossMEP is the brief, not the answer: 7,000 support-design problems, every number traced to its source, checked against two open buildings, and open. The QR code takes you to the data, the code and the gallery. Thank you. (9:10)</a:t>
+              <a:t>Its scope: one section at one support - routing, branches and spacing are outside it, although the span is recorded so a method can vary it. Realism is checked on sections of two open buildings; congested racks rest on practice and standards. The trade mix is a design choice, and the data is not for structural design. Next: a public checker for support designs, with best-known costs, so methods can be compared on the answer and not only on the brief; the catalog as an input, so a method is tested on catalogs it has never seen; and a real test set from commercial projects, with supports designed by engineers - which is where we would value your eye. (8:45)</a:t>
             </a:r>
             <a:endParaRPr lang="en-US" dirty="0"/>
           </a:p>
@@ -2473,7 +2477,7 @@
           <a:p>
             <a:r>
               <a:rPr lang="en-US" dirty="0"/>
-              <a:t>Backup: per-tier medians on the benchmark split, the distance to the held-out building, and the trend statistics behind experiment 1.</a:t>
+              <a:t>CrossMEP is the brief, not the answer: 7,000 support-design problems, every number traced to its source, checked against two open buildings, and open. The QR code takes you to the data, the code, the gallery and the studio. Thank you. (9:15)</a:t>
             </a:r>
             <a:endParaRPr lang="en-US" dirty="0"/>
           </a:p>
@@ -2561,7 +2565,7 @@
           <a:p>
             <a:r>
               <a:rPr lang="en-US" dirty="0"/>
-              <a:t>Backup for questions on experiment 2: sample sizes, both weightings, the noise floor and the sensitivity of the result to the way the sections are cut.</a:t>
+              <a:t>Backup for the live demo. Left: a wall section, six pipes in two rows, each labelled with its size, trade, insulation, offset from the wall and load at the support. Right: an exact mix on a slab, with a duct, a tray, conduits and pipes, their levels below the soffit and the closest clear gap.</a:t>
             </a:r>
             <a:endParaRPr lang="en-US" dirty="0"/>
           </a:p>
@@ -2649,7 +2653,7 @@
           <a:p>
             <a:r>
               <a:rPr lang="en-US" dirty="0"/>
-              <a:t>Backup for questions on experiment 3. Per tier, the benchmark has only 125 contexts, so its intervals are wide; the population estimate from two thousand generated contexts per tier shows the tiers are about equal. The headline depends on the attach-diameter rule and on bin-edge tolerance because one nominal size, DN100, sits 0.3 millimetres outside a bin. Only size and capacity are tested - clearance, insert orientation and anchors are not - so the coverage is an upper bound on what can be installed.</a:t>
+              <a:t>Backup: per-tier medians on the benchmark split, the distance to the held-out building, and the trend statistics behind experiment 1.</a:t>
             </a:r>
             <a:endParaRPr lang="en-US" dirty="0"/>
           </a:p>
@@ -2737,7 +2741,7 @@
           <a:p>
             <a:r>
               <a:rPr lang="en-US" dirty="0"/>
-              <a:t>Backup: what one stored context looks like - plain JSON, one object per context.</a:t>
+              <a:t>Backup for questions on experiment 2: sample sizes, both weightings, the noise floor and the sensitivity of the result to the way the sections are cut.</a:t>
             </a:r>
             <a:endParaRPr lang="en-US" dirty="0"/>
           </a:p>
@@ -2761,6 +2765,94 @@
             <a:fld id="{F7021451-1387-4CA6-816F-3879F97B5CBC}" type="slidenum">
               <a:rPr lang="en-US"/>
               <a:t>18</a:t>
+            </a:fld>
+            <a:endParaRPr lang="en-US"/>
+          </a:p>
+        </p:txBody>
+      </p:sp>
+    </p:spTree>
+    <p:extLst>
+      <p:ext uri="{BB962C8B-B14F-4D97-AF65-F5344CB8AC3E}">
+        <p14:creationId xmlns:p14="http://schemas.microsoft.com/office/powerpoint/2010/main" val="1024086991"/>
+      </p:ext>
+    </p:extLst>
+  </p:cSld>
+  <p:clrMapOvr>
+    <a:masterClrMapping/>
+  </p:clrMapOvr>
+</p:notes>
+</file>
+
+<file path=ppt/notesSlides/notesSlide19.xml><?xml version="1.0" encoding="utf-8"?>
+<p:notes xmlns:a="http://schemas.openxmlformats.org/drawingml/2006/main" xmlns:r="http://schemas.openxmlformats.org/officeDocument/2006/relationships" xmlns:p="http://schemas.openxmlformats.org/presentationml/2006/main">
+  <p:cSld>
+    <p:spTree>
+      <p:nvGrpSpPr>
+        <p:cNvPr id="1" name=""/>
+        <p:cNvGrpSpPr/>
+        <p:nvPr/>
+      </p:nvGrpSpPr>
+      <p:grpSpPr>
+        <a:xfrm>
+          <a:off x="0" y="0"/>
+          <a:ext cx="0" cy="0"/>
+          <a:chOff x="0" y="0"/>
+          <a:chExt cx="0" cy="0"/>
+        </a:xfrm>
+      </p:grpSpPr>
+      <p:sp>
+        <p:nvSpPr>
+          <p:cNvPr id="2" name="Slide Image Placeholder 1"/>
+          <p:cNvSpPr>
+            <a:spLocks noGrp="1" noRot="1" noChangeAspect="1"/>
+          </p:cNvSpPr>
+          <p:nvPr>
+            <p:ph type="sldImg"/>
+          </p:nvPr>
+        </p:nvSpPr>
+        <p:spPr/>
+      </p:sp>
+      <p:sp>
+        <p:nvSpPr>
+          <p:cNvPr id="3" name="Notes Placeholder 2"/>
+          <p:cNvSpPr>
+            <a:spLocks noGrp="1"/>
+          </p:cNvSpPr>
+          <p:nvPr>
+            <p:ph type="body" idx="1"/>
+          </p:nvPr>
+        </p:nvSpPr>
+        <p:spPr/>
+        <p:txBody>
+          <a:bodyPr/>
+          <a:lstStyle/>
+          <a:p>
+            <a:r>
+              <a:rPr lang="en-US" dirty="0"/>
+              <a:t>Backup for questions on experiment 3. Per tier, the benchmark has only 125 contexts, so its intervals are wide; the population estimate from two thousand generated contexts per tier shows the tiers are about equal. The headline depends on the attach-diameter rule and on bin-edge tolerance because one nominal size, DN100, sits 0.3 millimetres outside a bin. Only size and capacity are tested - clearance, insert orientation and anchors are not - so the coverage is an upper bound on what can be installed.</a:t>
+            </a:r>
+            <a:endParaRPr lang="en-US" dirty="0"/>
+          </a:p>
+        </p:txBody>
+      </p:sp>
+      <p:sp>
+        <p:nvSpPr>
+          <p:cNvPr id="4" name="Slide Number Placeholder 3"/>
+          <p:cNvSpPr>
+            <a:spLocks noGrp="1"/>
+          </p:cNvSpPr>
+          <p:nvPr>
+            <p:ph type="sldNum" sz="quarter" idx="10"/>
+          </p:nvPr>
+        </p:nvSpPr>
+        <p:spPr/>
+        <p:txBody>
+          <a:bodyPr/>
+          <a:lstStyle/>
+          <a:p>
+            <a:fld id="{F7021451-1387-4CA6-816F-3879F97B5CBC}" type="slidenum">
+              <a:rPr lang="en-US"/>
+              <a:t>19</a:t>
             </a:fld>
             <a:endParaRPr lang="en-US"/>
           </a:p>
@@ -2849,6 +2941,94 @@
             <a:fld id="{F7021451-1387-4CA6-816F-3879F97B5CBC}" type="slidenum">
               <a:rPr lang="en-US"/>
               <a:t>2</a:t>
+            </a:fld>
+            <a:endParaRPr lang="en-US"/>
+          </a:p>
+        </p:txBody>
+      </p:sp>
+    </p:spTree>
+    <p:extLst>
+      <p:ext uri="{BB962C8B-B14F-4D97-AF65-F5344CB8AC3E}">
+        <p14:creationId xmlns:p14="http://schemas.microsoft.com/office/powerpoint/2010/main" val="1024086991"/>
+      </p:ext>
+    </p:extLst>
+  </p:cSld>
+  <p:clrMapOvr>
+    <a:masterClrMapping/>
+  </p:clrMapOvr>
+</p:notes>
+</file>
+
+<file path=ppt/notesSlides/notesSlide20.xml><?xml version="1.0" encoding="utf-8"?>
+<p:notes xmlns:a="http://schemas.openxmlformats.org/drawingml/2006/main" xmlns:r="http://schemas.openxmlformats.org/officeDocument/2006/relationships" xmlns:p="http://schemas.openxmlformats.org/presentationml/2006/main">
+  <p:cSld>
+    <p:spTree>
+      <p:nvGrpSpPr>
+        <p:cNvPr id="1" name=""/>
+        <p:cNvGrpSpPr/>
+        <p:nvPr/>
+      </p:nvGrpSpPr>
+      <p:grpSpPr>
+        <a:xfrm>
+          <a:off x="0" y="0"/>
+          <a:ext cx="0" cy="0"/>
+          <a:chOff x="0" y="0"/>
+          <a:chExt cx="0" cy="0"/>
+        </a:xfrm>
+      </p:grpSpPr>
+      <p:sp>
+        <p:nvSpPr>
+          <p:cNvPr id="2" name="Slide Image Placeholder 1"/>
+          <p:cNvSpPr>
+            <a:spLocks noGrp="1" noRot="1" noChangeAspect="1"/>
+          </p:cNvSpPr>
+          <p:nvPr>
+            <p:ph type="sldImg"/>
+          </p:nvPr>
+        </p:nvSpPr>
+        <p:spPr/>
+      </p:sp>
+      <p:sp>
+        <p:nvSpPr>
+          <p:cNvPr id="3" name="Notes Placeholder 2"/>
+          <p:cNvSpPr>
+            <a:spLocks noGrp="1"/>
+          </p:cNvSpPr>
+          <p:nvPr>
+            <p:ph type="body" idx="1"/>
+          </p:nvPr>
+        </p:nvSpPr>
+        <p:spPr/>
+        <p:txBody>
+          <a:bodyPr/>
+          <a:lstStyle/>
+          <a:p>
+            <a:r>
+              <a:rPr lang="en-US" dirty="0"/>
+              <a:t>Backup: what one stored context looks like - plain JSON, one object per context.</a:t>
+            </a:r>
+            <a:endParaRPr lang="en-US" dirty="0"/>
+          </a:p>
+        </p:txBody>
+      </p:sp>
+      <p:sp>
+        <p:nvSpPr>
+          <p:cNvPr id="4" name="Slide Number Placeholder 3"/>
+          <p:cNvSpPr>
+            <a:spLocks noGrp="1"/>
+          </p:cNvSpPr>
+          <p:nvPr>
+            <p:ph type="sldNum" sz="quarter" idx="10"/>
+          </p:nvPr>
+        </p:nvSpPr>
+        <p:spPr/>
+        <p:txBody>
+          <a:bodyPr/>
+          <a:lstStyle/>
+          <a:p>
+            <a:fld id="{F7021451-1387-4CA6-816F-3879F97B5CBC}" type="slidenum">
+              <a:rPr lang="en-US"/>
+              <a:t>20</a:t>
             </a:fld>
             <a:endParaRPr lang="en-US"/>
           </a:p>
@@ -3441,7 +3621,7 @@
           <a:p>
             <a:r>
               <a:rPr lang="en-US" dirty="0"/>
-              <a:t>First experiment: are the tiers ordered by difficulty? The count is exact by construction, so we look at congestion and load. The boxes are the benchmark; the diamonds are medians over 2,000 freshly generated contexts per tier - the generator itself, not sampling noise. Load at the support rises at every step, from 0.1 to 1.7 kilonewtons. Congestion rises overall - the closest gap falls from 120 to about 62 millimetres - but at C6 the generator starts stacking in two or three rows, so each row holds fewer elements and the gap widens again. So the tier fixes the count; congestion and load follow on average, and methods should be compared tier by tier. (5:20)</a:t>
+              <a:t>The first experiment is a design check, not a discovery: does difficulty grow with the tier, as intended? The count is fixed by construction; load and congestion follow from the rules, so this shows the dataset behaves as designed. Load at the support rises at every step, from 0.1 to 1.7 kilonewtons. The closest gap falls from 120 to about 62 millimetres, but widens again at C6, where the generator starts stacking in two or three rows. So report methods tier by tier. (5:20)</a:t>
             </a:r>
             <a:endParaRPr lang="en-US" dirty="0"/>
           </a:p>
@@ -4567,7 +4747,7 @@
                   <a:schemeClr val="tx1"/>
                 </a:solidFill>
               </a:rPr>
-              <a:t>Experiment 2: generated spacing matches a building it never saw</a:t>
+              <a:t>Experiment 2, the real test: spacing in a building it never saw</a:t>
             </a:r>
             <a:endParaRPr lang="en-US" sz="2600" dirty="0"/>
           </a:p>
@@ -4627,7 +4807,7 @@
                   <a:srgbClr val="52514E"/>
                 </a:solidFill>
               </a:rPr>
-              <a:t>Sections cut every 250 mm through two open IFC buildings from buildingSMART (CC BY 4.0), measuring the clear gap between side-by-side pipes. The medical-dental clinic, a real building with 797 measured pipe pairs, is 28 mm from the generated gaps (95 % CI 16–44): about as close as the duplex’s own two models are to each other (26 mm). The small residential duplex is as far from the generator (70–85 mm) as from the clinic (71–85 mm).</a:t>
+              <a:t>The gap distribution was fitted on the duplex; the clinic was held out. Sections cut every 250 mm through two open IFC buildings from buildingSMART (CC BY 4.0), measuring the clear gap between side-by-side pipes. The medical-dental clinic, a real building with 797 measured pipe pairs, is 28 mm from the generated gaps (95 % CI 16–44): about as close as the duplex’s own two models are to each other (26 mm). The small residential duplex is as far from the generator (70–85 mm) as from the clinic (71–85 mm).</a:t>
             </a:r>
             <a:endParaRPr lang="en-US" sz="1100" dirty="0"/>
           </a:p>
@@ -4735,7 +4915,7 @@
                   <a:schemeClr val="tx1"/>
                 </a:solidFill>
               </a:rPr>
-              <a:t>Experiment 3: a two-size clamp catalog attaches 1 pipe in 9</a:t>
+              <a:t>Experiment 3, a use: what must a clamp catalog cover?</a:t>
             </a:r>
             <a:endParaRPr lang="en-US" sz="2600" dirty="0"/>
           </a:p>
@@ -5111,6 +5291,310 @@
 <file path=ppt/slides/slide12.xml><?xml version="1.0" encoding="utf-8"?>
 <p:sld xmlns:a="http://schemas.openxmlformats.org/drawingml/2006/main" xmlns:r="http://schemas.openxmlformats.org/officeDocument/2006/relationships" xmlns:p="http://schemas.openxmlformats.org/presentationml/2006/main">
   <p:cSld name="Slide 12">
+    <p:spTree>
+      <p:nvGrpSpPr>
+        <p:cNvPr id="1" name=""/>
+        <p:cNvGrpSpPr/>
+        <p:nvPr/>
+      </p:nvGrpSpPr>
+      <p:grpSpPr>
+        <a:xfrm>
+          <a:off x="0" y="0"/>
+          <a:ext cx="0" cy="0"/>
+          <a:chOff x="0" y="0"/>
+          <a:chExt cx="0" cy="0"/>
+        </a:xfrm>
+      </p:grpSpPr>
+      <p:sp>
+        <p:nvSpPr>
+          <p:cNvPr id="2" name="Text 0"/>
+          <p:cNvSpPr/>
+          <p:nvPr>
+            <p:ph idx="100" type="title" hasCustomPrompt="1"/>
+          </p:nvPr>
+        </p:nvSpPr>
+        <p:spPr>
+          <a:xfrm>
+            <a:off x="548640" y="274320"/>
+            <a:ext cx="11091672" cy="960120"/>
+          </a:xfrm>
+          <a:prstGeom prst="rect">
+            <a:avLst/>
+          </a:prstGeom>
+          <a:noFill/>
+          <a:ln/>
+        </p:spPr>
+        <p:txBody>
+          <a:bodyPr wrap="square" lIns="0" tIns="0" rIns="0" bIns="0" rtlCol="0" anchor="ctr"/>
+          <a:lstStyle/>
+          <a:p>
+            <a:pPr algn="l" indent="0" marL="0">
+              <a:buNone/>
+            </a:pPr>
+            <a:r>
+              <a:rPr lang="en-US" sz="2600" b="1" dirty="0">
+                <a:solidFill>
+                  <a:schemeClr val="tx1"/>
+                </a:solidFill>
+              </a:rPr>
+              <a:t>See it: set the parameters, get the support designer’s brief</a:t>
+            </a:r>
+            <a:endParaRPr lang="en-US" sz="2600" dirty="0"/>
+          </a:p>
+        </p:txBody>
+      </p:sp>
+      <p:pic>
+        <p:nvPicPr>
+          <p:cNvPr id="3" name="studio screenshot" descr="/home/user/crossmep_dataset/docs/figures/08_studio_demo.png">    </p:cNvPr>
+          <p:cNvPicPr>
+            <a:picLocks noChangeAspect="1"/>
+          </p:cNvPicPr>
+          <p:nvPr/>
+        </p:nvPicPr>
+        <p:blipFill>
+          <a:blip r:embed="rId1"/>
+          <a:stretch>
+            <a:fillRect/>
+          </a:stretch>
+        </p:blipFill>
+        <p:spPr>
+          <a:xfrm>
+            <a:off x="548640" y="1355716"/>
+            <a:ext cx="8001000" cy="4512329"/>
+          </a:xfrm>
+          <a:prstGeom prst="rect">
+            <a:avLst/>
+          </a:prstGeom>
+        </p:spPr>
+      </p:pic>
+      <p:sp>
+        <p:nvSpPr>
+          <p:cNvPr id="4" name="studio caption"/>
+          <p:cNvSpPr txBox="1"/>
+          <p:nvPr/>
+        </p:nvSpPr>
+        <p:spPr>
+          <a:xfrm>
+            <a:off x="548640" y="5941196"/>
+            <a:ext cx="8001000" cy="274320"/>
+          </a:xfrm>
+          <a:prstGeom prst="rect">
+            <a:avLst/>
+          </a:prstGeom>
+          <a:noFill/>
+          <a:ln/>
+        </p:spPr>
+        <p:txBody>
+          <a:bodyPr wrap="square" lIns="0" tIns="0" rIns="0" bIns="0" rtlCol="0" anchor="t"/>
+          <a:lstStyle/>
+          <a:p>
+            <a:pPr indent="0" marL="0">
+              <a:buNone/>
+            </a:pPr>
+            <a:r>
+              <a:rPr lang="en-US" sz="1100" dirty="0">
+                <a:solidFill>
+                  <a:srgbClr val="52514E"/>
+                </a:solidFill>
+              </a:rPr>
+              <a:t>Generator Studio, tier C7, seed 0: the section as a support detail (scale 1:20) and in 3D.</a:t>
+            </a:r>
+            <a:endParaRPr lang="en-US" sz="1100" dirty="0"/>
+          </a:p>
+        </p:txBody>
+      </p:sp>
+      <p:sp>
+        <p:nvSpPr>
+          <p:cNvPr id="5" name="studio bullets"/>
+          <p:cNvSpPr txBox="1"/>
+          <p:nvPr/>
+        </p:nvSpPr>
+        <p:spPr>
+          <a:xfrm>
+            <a:off x="8823960" y="1371600"/>
+            <a:ext cx="2816352" cy="2743200"/>
+          </a:xfrm>
+          <a:prstGeom prst="rect">
+            <a:avLst/>
+          </a:prstGeom>
+          <a:noFill/>
+          <a:ln/>
+        </p:spPr>
+        <p:txBody>
+          <a:bodyPr wrap="square" lIns="0" tIns="0" rIns="0" bIns="0" rtlCol="0" anchor="t"/>
+          <a:lstStyle/>
+          <a:p>
+            <a:pPr marL="342900" indent="-342900">
+              <a:spcAft>
+                <a:spcPts val="600"/>
+              </a:spcAft>
+              <a:buSzPct val="100000"/>
+              <a:buChar char="•"/>
+            </a:pPr>
+            <a:r>
+              <a:rPr lang="en-US" sz="1400" dirty="0">
+                <a:solidFill>
+                  <a:schemeClr val="tx1"/>
+                </a:solidFill>
+              </a:rPr>
+              <a:t>In: a tier or an exact mix of services, slab or wall, a seed</a:t>
+            </a:r>
+            <a:endParaRPr lang="en-US" sz="1400" dirty="0"/>
+          </a:p>
+          <a:p>
+            <a:pPr marL="342900" indent="-342900">
+              <a:spcAft>
+                <a:spcPts val="600"/>
+              </a:spcAft>
+              <a:buSzPct val="100000"/>
+              <a:buChar char="•"/>
+            </a:pPr>
+            <a:r>
+              <a:rPr lang="en-US" sz="1400" dirty="0">
+                <a:solidFill>
+                  <a:schemeClr val="tx1"/>
+                </a:solidFill>
+              </a:rPr>
+              <a:t>Out: the section a support designer receives, with sizes, levels, loads and clear gaps</a:t>
+            </a:r>
+            <a:endParaRPr lang="en-US" sz="1400" dirty="0"/>
+          </a:p>
+          <a:p>
+            <a:pPr marL="342900" indent="-342900">
+              <a:spcAft>
+                <a:spcPts val="600"/>
+              </a:spcAft>
+              <a:buSzPct val="100000"/>
+              <a:buChar char="•"/>
+            </a:pPr>
+            <a:r>
+              <a:rPr lang="en-US" sz="1400" dirty="0">
+                <a:solidFill>
+                  <a:schemeClr val="tx1"/>
+                </a:solidFill>
+              </a:rPr>
+              <a:t>Every section is a stored output of the released generator, with the Python call that reproduces it</a:t>
+            </a:r>
+            <a:endParaRPr lang="en-US" sz="1400" dirty="0"/>
+          </a:p>
+        </p:txBody>
+      </p:sp>
+      <p:pic>
+        <p:nvPicPr>
+          <p:cNvPr id="6" name="qr studio" descr="/home/user/crossmep_dataset/docs/figures/qr_studio.png">    </p:cNvPr>
+          <p:cNvPicPr>
+            <a:picLocks noChangeAspect="1"/>
+          </p:cNvPicPr>
+          <p:nvPr/>
+        </p:nvPicPr>
+        <p:blipFill>
+          <a:blip r:embed="rId2"/>
+          <a:stretch>
+            <a:fillRect/>
+          </a:stretch>
+        </p:blipFill>
+        <p:spPr>
+          <a:xfrm>
+            <a:off x="9500616" y="4160520"/>
+            <a:ext cx="1463040" cy="1463040"/>
+          </a:xfrm>
+          <a:prstGeom prst="rect">
+            <a:avLst/>
+          </a:prstGeom>
+        </p:spPr>
+      </p:pic>
+      <p:sp>
+        <p:nvSpPr>
+          <p:cNvPr id="7" name="studio link"/>
+          <p:cNvSpPr txBox="1"/>
+          <p:nvPr/>
+        </p:nvSpPr>
+        <p:spPr>
+          <a:xfrm>
+            <a:off x="8823960" y="5669280"/>
+            <a:ext cx="2816352" cy="320040"/>
+          </a:xfrm>
+          <a:prstGeom prst="rect">
+            <a:avLst/>
+          </a:prstGeom>
+          <a:noFill/>
+          <a:ln/>
+        </p:spPr>
+        <p:txBody>
+          <a:bodyPr wrap="square" lIns="0" tIns="0" rIns="0" bIns="0" rtlCol="0" anchor="t"/>
+          <a:lstStyle/>
+          <a:p>
+            <a:pPr algn="ctr" indent="0" marL="0">
+              <a:buNone/>
+            </a:pPr>
+            <a:r>
+              <a:rPr lang="en-US" sz="1100" dirty="0">
+                <a:solidFill>
+                  <a:srgbClr val="52514E"/>
+                </a:solidFill>
+              </a:rPr>
+              <a:t>Try it: docs/studio in the repository</a:t>
+            </a:r>
+            <a:endParaRPr lang="en-US" sz="1100" dirty="0"/>
+          </a:p>
+        </p:txBody>
+      </p:sp>
+      <p:sp>
+        <p:nvSpPr>
+          <p:cNvPr id="25" name="Slide Number Placeholder 0"/>
+          <p:cNvSpPr>
+            <a:spLocks noGrp="1"/>
+          </p:cNvSpPr>
+          <p:nvPr>
+            <p:ph type="sldNum" sz="quarter" idx="4294967295"/>
+          </p:nvPr>
+        </p:nvSpPr>
+        <p:spPr>
+          <a:xfrm>
+            <a:off x="11064240" y="6419088"/>
+            <a:ext cx="594360" cy="274320"/>
+          </a:xfrm>
+          <a:prstGeom prst="rect">
+            <a:avLst/>
+          </a:prstGeom>
+          <a:extLst>
+            <a:ext uri="{C572A759-6A51-4108-AA02-DFA0A04FC94B}">
+              <ma14:wrappingTextBoxFlag xmlns:ma14="http://schemas.microsoft.com/office/mac/drawingml/2011/main" val="0"/>
+            </a:ext>
+          </a:extLst>
+        </p:spPr>
+        <p:txBody>
+          <a:bodyPr/>
+          <a:lstStyle>
+            <a:lvl1pPr>
+              <a:defRPr sz="900">
+                <a:solidFill>
+                  <a:srgbClr val="898781"/>
+                </a:solidFill>
+              </a:defRPr>
+            </a:lvl1pPr>
+          </a:lstStyle>
+          <a:p>
+            <a:pPr algn="r"/>
+            <a:fld id="{F7021451-1387-4CA6-816F-3879F97B5CBC}" type="slidenum">
+              <a:rPr b="0" lang="en-US"/>
+              <a:t>12</a:t>
+            </a:fld>
+            <a:endParaRPr lang="en-US"/>
+          </a:p>
+        </p:txBody>
+      </p:sp>
+    </p:spTree>
+  </p:cSld>
+  <p:clrMapOvr>
+    <a:masterClrMapping/>
+  </p:clrMapOvr>
+</p:sld>
+</file>
+
+<file path=ppt/slides/slide13.xml><?xml version="1.0" encoding="utf-8"?>
+<p:sld xmlns:a="http://schemas.openxmlformats.org/drawingml/2006/main" xmlns:r="http://schemas.openxmlformats.org/officeDocument/2006/relationships" xmlns:p="http://schemas.openxmlformats.org/presentationml/2006/main">
+  <p:cSld name="Slide 13">
     <p:spTree>
       <p:nvGrpSpPr>
         <p:cNvPr id="1" name=""/>
@@ -5785,7 +6269,7 @@
             <a:pPr algn="r"/>
             <a:fld id="{F7021451-1387-4CA6-816F-3879F97B5CBC}" type="slidenum">
               <a:rPr b="0" lang="en-US"/>
-              <a:t>12</a:t>
+              <a:t>13</a:t>
             </a:fld>
             <a:endParaRPr lang="en-US"/>
           </a:p>
@@ -5799,9 +6283,9 @@
 </p:sld>
 </file>
 
-<file path=ppt/slides/slide13.xml><?xml version="1.0" encoding="utf-8"?>
+<file path=ppt/slides/slide14.xml><?xml version="1.0" encoding="utf-8"?>
 <p:sld xmlns:a="http://schemas.openxmlformats.org/drawingml/2006/main" xmlns:r="http://schemas.openxmlformats.org/officeDocument/2006/relationships" xmlns:p="http://schemas.openxmlformats.org/presentationml/2006/main">
-  <p:cSld name="Slide 13">
+  <p:cSld name="Slide 14">
     <p:spTree>
       <p:nvGrpSpPr>
         <p:cNvPr id="1" name=""/>
@@ -6272,7 +6756,7 @@
             <a:pPr algn="r"/>
             <a:fld id="{F7021451-1387-4CA6-816F-3879F97B5CBC}" type="slidenum">
               <a:rPr b="0" lang="en-US"/>
-              <a:t>13</a:t>
+              <a:t>14</a:t>
             </a:fld>
             <a:endParaRPr lang="en-US"/>
           </a:p>
@@ -6286,9 +6770,9 @@
 </p:sld>
 </file>
 
-<file path=ppt/slides/slide14.xml><?xml version="1.0" encoding="utf-8"?>
+<file path=ppt/slides/slide15.xml><?xml version="1.0" encoding="utf-8"?>
 <p:sld xmlns:a="http://schemas.openxmlformats.org/drawingml/2006/main" xmlns:r="http://schemas.openxmlformats.org/officeDocument/2006/relationships" xmlns:p="http://schemas.openxmlformats.org/presentationml/2006/main">
-  <p:cSld name="Slide 14">
+  <p:cSld name="Slide 15">
     <p:spTree>
       <p:nvGrpSpPr>
         <p:cNvPr id="1" name=""/>
@@ -6489,9 +6973,237 @@
 </p:sld>
 </file>
 
-<file path=ppt/slides/slide15.xml><?xml version="1.0" encoding="utf-8"?>
+<file path=ppt/slides/slide16.xml><?xml version="1.0" encoding="utf-8"?>
 <p:sld xmlns:a="http://schemas.openxmlformats.org/drawingml/2006/main" xmlns:r="http://schemas.openxmlformats.org/officeDocument/2006/relationships" xmlns:p="http://schemas.openxmlformats.org/presentationml/2006/main">
-  <p:cSld name="Slide 15">
+  <p:cSld name="Slide 16">
+    <p:spTree>
+      <p:nvGrpSpPr>
+        <p:cNvPr id="1" name=""/>
+        <p:cNvGrpSpPr/>
+        <p:nvPr/>
+      </p:nvGrpSpPr>
+      <p:grpSpPr>
+        <a:xfrm>
+          <a:off x="0" y="0"/>
+          <a:ext cx="0" cy="0"/>
+          <a:chOff x="0" y="0"/>
+          <a:chExt cx="0" cy="0"/>
+        </a:xfrm>
+      </p:grpSpPr>
+      <p:sp>
+        <p:nvSpPr>
+          <p:cNvPr id="2" name="Text 0"/>
+          <p:cNvSpPr/>
+          <p:nvPr>
+            <p:ph idx="100" type="title" hasCustomPrompt="1"/>
+          </p:nvPr>
+        </p:nvSpPr>
+        <p:spPr>
+          <a:xfrm>
+            <a:off x="548640" y="274320"/>
+            <a:ext cx="11091672" cy="960120"/>
+          </a:xfrm>
+          <a:prstGeom prst="rect">
+            <a:avLst/>
+          </a:prstGeom>
+          <a:noFill/>
+          <a:ln/>
+        </p:spPr>
+        <p:txBody>
+          <a:bodyPr wrap="square" lIns="0" tIns="0" rIns="0" bIns="0" rtlCol="0" anchor="ctr"/>
+          <a:lstStyle/>
+          <a:p>
+            <a:pPr algn="l" indent="0" marL="0">
+              <a:buNone/>
+            </a:pPr>
+            <a:r>
+              <a:rPr lang="en-US" sz="2600" b="1" dirty="0">
+                <a:solidFill>
+                  <a:schemeClr val="tx1"/>
+                </a:solidFill>
+              </a:rPr>
+              <a:t>Appendix: two more sections from the Generator Studio</a:t>
+            </a:r>
+            <a:endParaRPr lang="en-US" sz="2600" dirty="0"/>
+          </a:p>
+        </p:txBody>
+      </p:sp>
+      <p:pic>
+        <p:nvPicPr>
+          <p:cNvPr id="3" name="studio wall sheet" descr="/home/user/crossmep_dataset/docs/figures/09_studio_wall.png">    </p:cNvPr>
+          <p:cNvPicPr>
+            <a:picLocks noChangeAspect="1"/>
+          </p:cNvPicPr>
+          <p:nvPr/>
+        </p:nvPicPr>
+        <p:blipFill>
+          <a:blip r:embed="rId1"/>
+          <a:stretch>
+            <a:fillRect/>
+          </a:stretch>
+        </p:blipFill>
+        <p:spPr>
+          <a:xfrm>
+            <a:off x="548640" y="1553108"/>
+            <a:ext cx="5431536" cy="3843223"/>
+          </a:xfrm>
+          <a:prstGeom prst="rect">
+            <a:avLst/>
+          </a:prstGeom>
+        </p:spPr>
+      </p:pic>
+      <p:pic>
+        <p:nvPicPr>
+          <p:cNvPr id="4" name="studio mix sheet" descr="/home/user/crossmep_dataset/docs/figures/10_studio_mix.png">    </p:cNvPr>
+          <p:cNvPicPr>
+            <a:picLocks noChangeAspect="1"/>
+          </p:cNvPicPr>
+          <p:nvPr/>
+        </p:nvPicPr>
+        <p:blipFill>
+          <a:blip r:embed="rId2"/>
+          <a:stretch>
+            <a:fillRect/>
+          </a:stretch>
+        </p:blipFill>
+        <p:spPr>
+          <a:xfrm>
+            <a:off x="6208776" y="1553108"/>
+            <a:ext cx="5431536" cy="3843223"/>
+          </a:xfrm>
+          <a:prstGeom prst="rect">
+            <a:avLst/>
+          </a:prstGeom>
+        </p:spPr>
+      </p:pic>
+      <p:sp>
+        <p:nvSpPr>
+          <p:cNvPr id="5" name="wall caption"/>
+          <p:cNvSpPr txBox="1"/>
+          <p:nvPr/>
+        </p:nvSpPr>
+        <p:spPr>
+          <a:xfrm>
+            <a:off x="548640" y="5469484"/>
+            <a:ext cx="5431536" cy="457200"/>
+          </a:xfrm>
+          <a:prstGeom prst="rect">
+            <a:avLst/>
+          </a:prstGeom>
+          <a:noFill/>
+          <a:ln/>
+        </p:spPr>
+        <p:txBody>
+          <a:bodyPr wrap="square" lIns="0" tIns="0" rIns="0" bIns="0" rtlCol="0" anchor="t"/>
+          <a:lstStyle/>
+          <a:p>
+            <a:pPr indent="0" marL="0">
+              <a:buNone/>
+            </a:pPr>
+            <a:r>
+              <a:rPr lang="en-US" sz="1100" dirty="0">
+                <a:solidFill>
+                  <a:srgbClr val="52514E"/>
+                </a:solidFill>
+              </a:rPr>
+              <a:t>Tier C6, seed 0, section 5: six pipes fixed to a wall; offsets from the wall face, the closest clear gap 25 mm.</a:t>
+            </a:r>
+            <a:endParaRPr lang="en-US" sz="1100" dirty="0"/>
+          </a:p>
+        </p:txBody>
+      </p:sp>
+      <p:sp>
+        <p:nvSpPr>
+          <p:cNvPr id="6" name="mix caption"/>
+          <p:cNvSpPr txBox="1"/>
+          <p:nvPr/>
+        </p:nvSpPr>
+        <p:spPr>
+          <a:xfrm>
+            <a:off x="6208776" y="5469484"/>
+            <a:ext cx="5431536" cy="457200"/>
+          </a:xfrm>
+          <a:prstGeom prst="rect">
+            <a:avLst/>
+          </a:prstGeom>
+          <a:noFill/>
+          <a:ln/>
+        </p:spPr>
+        <p:txBody>
+          <a:bodyPr wrap="square" lIns="0" tIns="0" rIns="0" bIns="0" rtlCol="0" anchor="t"/>
+          <a:lstStyle/>
+          <a:p>
+            <a:pPr indent="0" marL="0">
+              <a:buNone/>
+            </a:pPr>
+            <a:r>
+              <a:rPr lang="en-US" sz="1100" dirty="0">
+                <a:solidFill>
+                  <a:srgbClr val="52514E"/>
+                </a:solidFill>
+              </a:rPr>
+              <a:t>Exact mix: 2 pipes, 1 tray, 1 duct, 2 conduits on a slab; levels below the soffit and the load at the support.</a:t>
+            </a:r>
+            <a:endParaRPr lang="en-US" sz="1100" dirty="0"/>
+          </a:p>
+        </p:txBody>
+      </p:sp>
+      <p:sp>
+        <p:nvSpPr>
+          <p:cNvPr id="25" name="Slide Number Placeholder 0"/>
+          <p:cNvSpPr>
+            <a:spLocks noGrp="1"/>
+          </p:cNvSpPr>
+          <p:nvPr>
+            <p:ph type="sldNum" sz="quarter" idx="4294967295"/>
+          </p:nvPr>
+        </p:nvSpPr>
+        <p:spPr>
+          <a:xfrm>
+            <a:off x="11064240" y="6419088"/>
+            <a:ext cx="594360" cy="274320"/>
+          </a:xfrm>
+          <a:prstGeom prst="rect">
+            <a:avLst/>
+          </a:prstGeom>
+          <a:extLst>
+            <a:ext uri="{C572A759-6A51-4108-AA02-DFA0A04FC94B}">
+              <ma14:wrappingTextBoxFlag xmlns:ma14="http://schemas.microsoft.com/office/mac/drawingml/2011/main" val="0"/>
+            </a:ext>
+          </a:extLst>
+        </p:spPr>
+        <p:txBody>
+          <a:bodyPr/>
+          <a:lstStyle>
+            <a:lvl1pPr>
+              <a:defRPr sz="900">
+                <a:solidFill>
+                  <a:srgbClr val="898781"/>
+                </a:solidFill>
+              </a:defRPr>
+            </a:lvl1pPr>
+          </a:lstStyle>
+          <a:p>
+            <a:pPr algn="r"/>
+            <a:fld id="{F7021451-1387-4CA6-816F-3879F97B5CBC}" type="slidenum">
+              <a:rPr b="0" lang="en-US"/>
+              <a:t>16</a:t>
+            </a:fld>
+            <a:endParaRPr lang="en-US"/>
+          </a:p>
+        </p:txBody>
+      </p:sp>
+    </p:spTree>
+  </p:cSld>
+  <p:clrMapOvr>
+    <a:masterClrMapping/>
+  </p:clrMapOvr>
+</p:sld>
+</file>
+
+<file path=ppt/slides/slide17.xml><?xml version="1.0" encoding="utf-8"?>
+<p:sld xmlns:a="http://schemas.openxmlformats.org/drawingml/2006/main" xmlns:r="http://schemas.openxmlformats.org/officeDocument/2006/relationships" xmlns:p="http://schemas.openxmlformats.org/presentationml/2006/main">
+  <p:cSld name="Slide 17">
     <p:spTree>
       <p:nvGrpSpPr>
         <p:cNvPr id="1" name=""/>
@@ -6546,7 +7258,7 @@
       </p:sp>
       <p:graphicFrame>
         <p:nvGraphicFramePr>
-          <p:cNvPr id="16" name="tier table"/>
+          <p:cNvPr id="18" name="tier table"/>
           <p:cNvGraphicFramePr>
             <a:graphicFrameLocks noGrp="1"/>
           </p:cNvGraphicFramePr>
@@ -9856,7 +10568,7 @@
             <a:pPr algn="r"/>
             <a:fld id="{F7021451-1387-4CA6-816F-3879F97B5CBC}" type="slidenum">
               <a:rPr b="0" lang="en-US"/>
-              <a:t>15</a:t>
+              <a:t>17</a:t>
             </a:fld>
             <a:endParaRPr lang="en-US"/>
           </a:p>
@@ -9870,9 +10582,9 @@
 </p:sld>
 </file>
 
-<file path=ppt/slides/slide16.xml><?xml version="1.0" encoding="utf-8"?>
+<file path=ppt/slides/slide18.xml><?xml version="1.0" encoding="utf-8"?>
 <p:sld xmlns:a="http://schemas.openxmlformats.org/drawingml/2006/main" xmlns:r="http://schemas.openxmlformats.org/officeDocument/2006/relationships" xmlns:p="http://schemas.openxmlformats.org/presentationml/2006/main">
-  <p:cSld name="Slide 16">
+  <p:cSld name="Slide 18">
     <p:spTree>
       <p:nvGrpSpPr>
         <p:cNvPr id="1" name=""/>
@@ -9927,7 +10639,7 @@
       </p:sp>
       <p:graphicFrame>
         <p:nvGraphicFramePr>
-          <p:cNvPr id="17" name="samples table"/>
+          <p:cNvPr id="19" name="samples table"/>
           <p:cNvGraphicFramePr>
             <a:graphicFrameLocks noGrp="1"/>
           </p:cNvGraphicFramePr>
@@ -11610,7 +12322,7 @@
       </p:graphicFrame>
       <p:graphicFrame>
         <p:nvGraphicFramePr>
-          <p:cNvPr id="33" name="distances table"/>
+          <p:cNvPr id="37" name="distances table"/>
           <p:cNvGraphicFramePr>
             <a:graphicFrameLocks noGrp="1"/>
           </p:cNvGraphicFramePr>
@@ -13655,7 +14367,7 @@
             <a:pPr algn="r"/>
             <a:fld id="{F7021451-1387-4CA6-816F-3879F97B5CBC}" type="slidenum">
               <a:rPr b="0" lang="en-US"/>
-              <a:t>16</a:t>
+              <a:t>18</a:t>
             </a:fld>
             <a:endParaRPr lang="en-US"/>
           </a:p>
@@ -13669,9 +14381,9 @@
 </p:sld>
 </file>
 
-<file path=ppt/slides/slide17.xml><?xml version="1.0" encoding="utf-8"?>
+<file path=ppt/slides/slide19.xml><?xml version="1.0" encoding="utf-8"?>
 <p:sld xmlns:a="http://schemas.openxmlformats.org/drawingml/2006/main" xmlns:r="http://schemas.openxmlformats.org/officeDocument/2006/relationships" xmlns:p="http://schemas.openxmlformats.org/presentationml/2006/main">
-  <p:cSld name="Slide 17">
+  <p:cSld name="Slide 19">
     <p:spTree>
       <p:nvGrpSpPr>
         <p:cNvPr id="1" name=""/>
@@ -13726,7 +14438,7 @@
       </p:sp>
       <p:graphicFrame>
         <p:nvGraphicFramePr>
-          <p:cNvPr id="18" name="per tier catalog table"/>
+          <p:cNvPr id="20" name="per tier catalog table"/>
           <p:cNvGraphicFramePr>
             <a:graphicFrameLocks noGrp="1"/>
           </p:cNvGraphicFramePr>
@@ -16128,7 +16840,7 @@
       </p:graphicFrame>
       <p:graphicFrame>
         <p:nvGraphicFramePr>
-          <p:cNvPr id="35" name="sensitivity table"/>
+          <p:cNvPr id="39" name="sensitivity table"/>
           <p:cNvGraphicFramePr>
             <a:graphicFrameLocks noGrp="1"/>
           </p:cNvGraphicFramePr>
@@ -17256,7 +17968,7 @@
       </p:sp>
       <p:graphicFrame>
         <p:nvGraphicFramePr>
-          <p:cNvPr id="52" name="split catalog table"/>
+          <p:cNvPr id="58" name="split catalog table"/>
           <p:cNvGraphicFramePr>
             <a:graphicFrameLocks noGrp="1"/>
           </p:cNvGraphicFramePr>
@@ -18412,492 +19124,7 @@
             <a:pPr algn="r"/>
             <a:fld id="{F7021451-1387-4CA6-816F-3879F97B5CBC}" type="slidenum">
               <a:rPr b="0" lang="en-US"/>
-              <a:t>17</a:t>
-            </a:fld>
-            <a:endParaRPr lang="en-US"/>
-          </a:p>
-        </p:txBody>
-      </p:sp>
-    </p:spTree>
-  </p:cSld>
-  <p:clrMapOvr>
-    <a:masterClrMapping/>
-  </p:clrMapOvr>
-</p:sld>
-</file>
-
-<file path=ppt/slides/slide18.xml><?xml version="1.0" encoding="utf-8"?>
-<p:sld xmlns:a="http://schemas.openxmlformats.org/drawingml/2006/main" xmlns:r="http://schemas.openxmlformats.org/officeDocument/2006/relationships" xmlns:p="http://schemas.openxmlformats.org/presentationml/2006/main">
-  <p:cSld name="Slide 18">
-    <p:spTree>
-      <p:nvGrpSpPr>
-        <p:cNvPr id="1" name=""/>
-        <p:cNvGrpSpPr/>
-        <p:nvPr/>
-      </p:nvGrpSpPr>
-      <p:grpSpPr>
-        <a:xfrm>
-          <a:off x="0" y="0"/>
-          <a:ext cx="0" cy="0"/>
-          <a:chOff x="0" y="0"/>
-          <a:chExt cx="0" cy="0"/>
-        </a:xfrm>
-      </p:grpSpPr>
-      <p:sp>
-        <p:nvSpPr>
-          <p:cNvPr id="2" name="Text 0"/>
-          <p:cNvSpPr/>
-          <p:nvPr>
-            <p:ph idx="100" type="title" hasCustomPrompt="1"/>
-          </p:nvPr>
-        </p:nvSpPr>
-        <p:spPr>
-          <a:xfrm>
-            <a:off x="548640" y="274320"/>
-            <a:ext cx="11091672" cy="960120"/>
-          </a:xfrm>
-          <a:prstGeom prst="rect">
-            <a:avLst/>
-          </a:prstGeom>
-          <a:noFill/>
-          <a:ln/>
-        </p:spPr>
-        <p:txBody>
-          <a:bodyPr wrap="square" lIns="0" tIns="0" rIns="0" bIns="0" rtlCol="0" anchor="ctr"/>
-          <a:lstStyle/>
-          <a:p>
-            <a:pPr algn="l" indent="0" marL="0">
-              <a:buNone/>
-            </a:pPr>
-            <a:r>
-              <a:rPr lang="en-US" sz="2600" b="1" dirty="0">
-                <a:solidFill>
-                  <a:schemeClr val="tx1"/>
-                </a:solidFill>
-              </a:rPr>
-              <a:t>Appendix: one record, as stored</a:t>
-            </a:r>
-            <a:endParaRPr lang="en-US" sz="2600" dirty="0"/>
-          </a:p>
-        </p:txBody>
-      </p:sp>
-      <p:sp>
-        <p:nvSpPr>
-          <p:cNvPr id="3" name="record card"/>
-          <p:cNvSpPr/>
-          <p:nvPr/>
-        </p:nvSpPr>
-        <p:spPr>
-          <a:xfrm>
-            <a:off x="548640" y="1417320"/>
-            <a:ext cx="7818120" cy="2560320"/>
-          </a:xfrm>
-          <a:prstGeom prst="roundRect">
-            <a:avLst>
-              <a:gd name="adj" fmla="val 2500"/>
-            </a:avLst>
-          </a:prstGeom>
-          <a:solidFill>
-            <a:schemeClr val="tx2"/>
-          </a:solidFill>
-          <a:ln/>
-        </p:spPr>
-      </p:sp>
-      <p:sp>
-        <p:nvSpPr>
-          <p:cNvPr id="4" name="record"/>
-          <p:cNvSpPr txBox="1"/>
-          <p:nvPr/>
-        </p:nvSpPr>
-        <p:spPr>
-          <a:xfrm>
-            <a:off x="777240" y="1600200"/>
-            <a:ext cx="7360920" cy="2194560"/>
-          </a:xfrm>
-          <a:prstGeom prst="rect">
-            <a:avLst/>
-          </a:prstGeom>
-          <a:noFill/>
-          <a:ln/>
-        </p:spPr>
-        <p:txBody>
-          <a:bodyPr wrap="square" lIns="0" tIns="0" rIns="0" bIns="0" rtlCol="0" anchor="t"/>
-          <a:lstStyle/>
-          <a:p>
-            <a:pPr indent="0" marL="0">
-              <a:buNone/>
-            </a:pPr>
-            <a:r>
-              <a:rPr lang="en-US" sz="1050" dirty="0">
-                <a:solidFill>
-                  <a:srgbClr val="FFFFFF"/>
-                </a:solidFill>
-                <a:latin typeface="Courier New" pitchFamily="34" charset="0"/>
-                <a:ea typeface="Courier New" pitchFamily="34" charset="-122"/>
-                <a:cs typeface="Courier New" pitchFamily="34" charset="-120"/>
-              </a:rPr>
-              <a:t>{"context_id": "mep_57", "tier": "C2",</a:t>
-            </a:r>
-            <a:endParaRPr lang="en-US" sz="1050" dirty="0"/>
-          </a:p>
-          <a:p>
-            <a:pPr indent="0" marL="0">
-              <a:buNone/>
-            </a:pPr>
-            <a:r>
-              <a:rPr lang="en-US" sz="1050" dirty="0">
-                <a:solidFill>
-                  <a:srgbClr val="FFFFFF"/>
-                </a:solidFill>
-                <a:latin typeface="Courier New" pitchFamily="34" charset="0"/>
-                <a:ea typeface="Courier New" pitchFamily="34" charset="-122"/>
-                <a:cs typeface="Courier New" pitchFamily="34" charset="-120"/>
-              </a:rPr>
-              <a:t> "surface": {"kind": "ceiling", "substrate": "concrete_C25", "thickness_mm": 200.0},</a:t>
-            </a:r>
-            <a:endParaRPr lang="en-US" sz="1050" dirty="0"/>
-          </a:p>
-          <a:p>
-            <a:pPr indent="0" marL="0">
-              <a:buNone/>
-            </a:pPr>
-            <a:r>
-              <a:rPr lang="en-US" sz="1050" dirty="0">
-                <a:solidFill>
-                  <a:srgbClr val="FFFFFF"/>
-                </a:solidFill>
-                <a:latin typeface="Courier New" pitchFamily="34" charset="0"/>
-                <a:ea typeface="Courier New" pitchFamily="34" charset="-122"/>
-                <a:cs typeface="Courier New" pitchFamily="34" charset="-120"/>
-              </a:rPr>
-              <a:t> "n_elements": 2, "n_levels": 1, "total_load_kN": 1.12, "bundle_width_mm": 588.0,</a:t>
-            </a:r>
-            <a:endParaRPr lang="en-US" sz="1050" dirty="0"/>
-          </a:p>
-          <a:p>
-            <a:pPr indent="0" marL="0">
-              <a:buNone/>
-            </a:pPr>
-            <a:r>
-              <a:rPr lang="en-US" sz="1050" dirty="0">
-                <a:solidFill>
-                  <a:srgbClr val="FFFFFF"/>
-                </a:solidFill>
-                <a:latin typeface="Courier New" pitchFamily="34" charset="0"/>
-                <a:ea typeface="Courier New" pitchFamily="34" charset="-122"/>
-                <a:cs typeface="Courier New" pitchFamily="34" charset="-120"/>
-              </a:rPr>
-              <a:t> "elements": [</a:t>
-            </a:r>
-            <a:endParaRPr lang="en-US" sz="1050" dirty="0"/>
-          </a:p>
-          <a:p>
-            <a:pPr indent="0" marL="0">
-              <a:buNone/>
-            </a:pPr>
-            <a:r>
-              <a:rPr lang="en-US" sz="1050" dirty="0">
-                <a:solidFill>
-                  <a:srgbClr val="FFFFFF"/>
-                </a:solidFill>
-                <a:latin typeface="Courier New" pitchFamily="34" charset="0"/>
-                <a:ea typeface="Courier New" pitchFamily="34" charset="-122"/>
-                <a:cs typeface="Courier New" pitchFamily="34" charset="-120"/>
-              </a:rPr>
-              <a:t>  {"kind": "cable_tray", "service": "tray", "trade": "electrical", "shape": "rect",</a:t>
-            </a:r>
-            <a:endParaRPr lang="en-US" sz="1050" dirty="0"/>
-          </a:p>
-          <a:p>
-            <a:pPr indent="0" marL="0">
-              <a:buNone/>
-            </a:pPr>
-            <a:r>
-              <a:rPr lang="en-US" sz="1050" dirty="0">
-                <a:solidFill>
-                  <a:srgbClr val="FFFFFF"/>
-                </a:solidFill>
-                <a:latin typeface="Courier New" pitchFamily="34" charset="0"/>
-                <a:ea typeface="Courier New" pitchFamily="34" charset="-122"/>
-                <a:cs typeface="Courier New" pitchFamily="34" charset="-120"/>
-              </a:rPr>
-              <a:t>   "label": "300 tray", "width_mm": 300.0, "height_mm": 60.0, "insulation_mm": 0.0,</a:t>
-            </a:r>
-            <a:endParaRPr lang="en-US" sz="1050" dirty="0"/>
-          </a:p>
-          <a:p>
-            <a:pPr indent="0" marL="0">
-              <a:buNone/>
-            </a:pPr>
-            <a:r>
-              <a:rPr lang="en-US" sz="1050" dirty="0">
-                <a:solidFill>
-                  <a:srgbClr val="FFFFFF"/>
-                </a:solidFill>
-                <a:latin typeface="Courier New" pitchFamily="34" charset="0"/>
-                <a:ea typeface="Courier New" pitchFamily="34" charset="-122"/>
-                <a:cs typeface="Courier New" pitchFamily="34" charset="-120"/>
-              </a:rPr>
-              <a:t>   "load_kN": 1.08, "span_m": 2.0, "load_kN_per_m": 0.5396,</a:t>
-            </a:r>
-            <a:endParaRPr lang="en-US" sz="1050" dirty="0"/>
-          </a:p>
-          <a:p>
-            <a:pPr indent="0" marL="0">
-              <a:buNone/>
-            </a:pPr>
-            <a:r>
-              <a:rPr lang="en-US" sz="1050" dirty="0">
-                <a:solidFill>
-                  <a:srgbClr val="FFFFFF"/>
-                </a:solidFill>
-                <a:latin typeface="Courier New" pitchFamily="34" charset="0"/>
-                <a:ea typeface="Courier New" pitchFamily="34" charset="-122"/>
-                <a:cs typeface="Courier New" pitchFamily="34" charset="-120"/>
-              </a:rPr>
-              <a:t>   "level": 0, "along_mm": -144.0, "out_mm": 120.0},</a:t>
-            </a:r>
-            <a:endParaRPr lang="en-US" sz="1050" dirty="0"/>
-          </a:p>
-          <a:p>
-            <a:pPr indent="0" marL="0">
-              <a:buNone/>
-            </a:pPr>
-            <a:r>
-              <a:rPr lang="en-US" sz="1050" dirty="0">
-                <a:solidFill>
-                  <a:srgbClr val="FFFFFF"/>
-                </a:solidFill>
-                <a:latin typeface="Courier New" pitchFamily="34" charset="0"/>
-                <a:ea typeface="Courier New" pitchFamily="34" charset="-122"/>
-                <a:cs typeface="Courier New" pitchFamily="34" charset="-120"/>
-              </a:rPr>
-              <a:t>  {"kind": "pipe", "service": "heating", "trade": "heating", "shape": "round",</a:t>
-            </a:r>
-            <a:endParaRPr lang="en-US" sz="1050" dirty="0"/>
-          </a:p>
-          <a:p>
-            <a:pPr indent="0" marL="0">
-              <a:buNone/>
-            </a:pPr>
-            <a:r>
-              <a:rPr lang="en-US" sz="1050" dirty="0">
-                <a:solidFill>
-                  <a:srgbClr val="FFFFFF"/>
-                </a:solidFill>
-                <a:latin typeface="Courier New" pitchFamily="34" charset="0"/>
-                <a:ea typeface="Courier New" pitchFamily="34" charset="-122"/>
-                <a:cs typeface="Courier New" pitchFamily="34" charset="-120"/>
-              </a:rPr>
-              <a:t>   "label": "DN20", "width_mm": 26.9, "height_mm": 26.9, "insulation_mm": 20.0,</a:t>
-            </a:r>
-            <a:endParaRPr lang="en-US" sz="1050" dirty="0"/>
-          </a:p>
-          <a:p>
-            <a:pPr indent="0" marL="0">
-              <a:buNone/>
-            </a:pPr>
-            <a:r>
-              <a:rPr lang="en-US" sz="1050" dirty="0">
-                <a:solidFill>
-                  <a:srgbClr val="FFFFFF"/>
-                </a:solidFill>
-                <a:latin typeface="Courier New" pitchFamily="34" charset="0"/>
-                <a:ea typeface="Courier New" pitchFamily="34" charset="-122"/>
-                <a:cs typeface="Courier New" pitchFamily="34" charset="-120"/>
-              </a:rPr>
-              <a:t>   "load_kN": 0.04, "span_m": 2.1, "load_kN_per_m": 0.0189,</a:t>
-            </a:r>
-            <a:endParaRPr lang="en-US" sz="1050" dirty="0"/>
-          </a:p>
-          <a:p>
-            <a:pPr indent="0" marL="0">
-              <a:buNone/>
-            </a:pPr>
-            <a:r>
-              <a:rPr lang="en-US" sz="1050" dirty="0">
-                <a:solidFill>
-                  <a:srgbClr val="FFFFFF"/>
-                </a:solidFill>
-                <a:latin typeface="Courier New" pitchFamily="34" charset="0"/>
-                <a:ea typeface="Courier New" pitchFamily="34" charset="-122"/>
-                <a:cs typeface="Courier New" pitchFamily="34" charset="-120"/>
-              </a:rPr>
-              <a:t>   "level": 0, "along_mm": 260.5, "out_mm": 156.2}</a:t>
-            </a:r>
-            <a:endParaRPr lang="en-US" sz="1050" dirty="0"/>
-          </a:p>
-          <a:p>
-            <a:pPr indent="0" marL="0">
-              <a:buNone/>
-            </a:pPr>
-            <a:r>
-              <a:rPr lang="en-US" sz="1050" dirty="0">
-                <a:solidFill>
-                  <a:srgbClr val="FFFFFF"/>
-                </a:solidFill>
-                <a:latin typeface="Courier New" pitchFamily="34" charset="0"/>
-                <a:ea typeface="Courier New" pitchFamily="34" charset="-122"/>
-                <a:cs typeface="Courier New" pitchFamily="34" charset="-120"/>
-              </a:rPr>
-              <a:t> ]}</a:t>
-            </a:r>
-            <a:endParaRPr lang="en-US" sz="1050" dirty="0"/>
-          </a:p>
-        </p:txBody>
-      </p:sp>
-      <p:sp>
-        <p:nvSpPr>
-          <p:cNvPr id="5" name="record notes"/>
-          <p:cNvSpPr txBox="1"/>
-          <p:nvPr/>
-        </p:nvSpPr>
-        <p:spPr>
-          <a:xfrm>
-            <a:off x="8641080" y="1463040"/>
-            <a:ext cx="2999232" cy="3749040"/>
-          </a:xfrm>
-          <a:prstGeom prst="rect">
-            <a:avLst/>
-          </a:prstGeom>
-          <a:noFill/>
-          <a:ln/>
-        </p:spPr>
-        <p:txBody>
-          <a:bodyPr wrap="square" lIns="0" tIns="0" rIns="0" bIns="0" rtlCol="0" anchor="t"/>
-          <a:lstStyle/>
-          <a:p>
-            <a:pPr marL="342900" indent="-342900">
-              <a:spcAft>
-                <a:spcPts val="600"/>
-              </a:spcAft>
-              <a:buSzPct val="100000"/>
-              <a:buChar char="•"/>
-            </a:pPr>
-            <a:r>
-              <a:rPr lang="en-US" sz="1300" dirty="0">
-                <a:solidFill>
-                  <a:schemeClr val="tx1"/>
-                </a:solidFill>
-              </a:rPr>
-              <a:t>Units: millimetres, kilonewtons, metres (span)</a:t>
-            </a:r>
-            <a:endParaRPr lang="en-US" sz="1300" dirty="0"/>
-          </a:p>
-          <a:p>
-            <a:pPr marL="342900" indent="-342900">
-              <a:spcAft>
-                <a:spcPts val="600"/>
-              </a:spcAft>
-              <a:buSzPct val="100000"/>
-              <a:buChar char="•"/>
-            </a:pPr>
-            <a:r>
-              <a:rPr lang="en-US" sz="1300" dirty="0">
-                <a:solidFill>
-                  <a:schemeClr val="tx1"/>
-                </a:solidFill>
-              </a:rPr>
-              <a:t>Widths are bare; insulation_mm is per side</a:t>
-            </a:r>
-            <a:endParaRPr lang="en-US" sz="1300" dirty="0"/>
-          </a:p>
-          <a:p>
-            <a:pPr marL="342900" indent="-342900">
-              <a:spcAft>
-                <a:spcPts val="600"/>
-              </a:spcAft>
-              <a:buSzPct val="100000"/>
-              <a:buChar char="•"/>
-            </a:pPr>
-            <a:r>
-              <a:rPr lang="en-US" sz="1300" dirty="0">
-                <a:solidFill>
-                  <a:schemeClr val="tx1"/>
-                </a:solidFill>
-              </a:rPr>
-              <a:t>load_kN = load_kN_per_m × span_m</a:t>
-            </a:r>
-            <a:endParaRPr lang="en-US" sz="1300" dirty="0"/>
-          </a:p>
-          <a:p>
-            <a:pPr marL="342900" indent="-342900">
-              <a:spcAft>
-                <a:spcPts val="600"/>
-              </a:spcAft>
-              <a:buSzPct val="100000"/>
-              <a:buChar char="•"/>
-            </a:pPr>
-            <a:r>
-              <a:rPr lang="en-US" sz="1300" dirty="0">
-                <a:solidFill>
-                  <a:schemeClr val="tx1"/>
-                </a:solidFill>
-              </a:rPr>
-              <a:t>along_mm, out_mm: position along and out from the surface</a:t>
-            </a:r>
-            <a:endParaRPr lang="en-US" sz="1300" dirty="0"/>
-          </a:p>
-          <a:p>
-            <a:pPr marL="342900" indent="-342900">
-              <a:spcAft>
-                <a:spcPts val="600"/>
-              </a:spcAft>
-              <a:buSzPct val="100000"/>
-              <a:buChar char="•"/>
-            </a:pPr>
-            <a:r>
-              <a:rPr lang="en-US" sz="1300" dirty="0">
-                <a:solidFill>
-                  <a:schemeClr val="tx1"/>
-                </a:solidFill>
-              </a:rPr>
-              <a:t>level: the generative row (metadata)</a:t>
-            </a:r>
-            <a:endParaRPr lang="en-US" sz="1300" dirty="0"/>
-          </a:p>
-        </p:txBody>
-      </p:sp>
-      <p:sp>
-        <p:nvSpPr>
-          <p:cNvPr id="25" name="Slide Number Placeholder 0"/>
-          <p:cNvSpPr>
-            <a:spLocks noGrp="1"/>
-          </p:cNvSpPr>
-          <p:nvPr>
-            <p:ph type="sldNum" sz="quarter" idx="4294967295"/>
-          </p:nvPr>
-        </p:nvSpPr>
-        <p:spPr>
-          <a:xfrm>
-            <a:off x="11064240" y="6419088"/>
-            <a:ext cx="594360" cy="274320"/>
-          </a:xfrm>
-          <a:prstGeom prst="rect">
-            <a:avLst/>
-          </a:prstGeom>
-          <a:extLst>
-            <a:ext uri="{C572A759-6A51-4108-AA02-DFA0A04FC94B}">
-              <ma14:wrappingTextBoxFlag xmlns:ma14="http://schemas.microsoft.com/office/mac/drawingml/2011/main" val="0"/>
-            </a:ext>
-          </a:extLst>
-        </p:spPr>
-        <p:txBody>
-          <a:bodyPr/>
-          <a:lstStyle>
-            <a:lvl1pPr>
-              <a:defRPr sz="900">
-                <a:solidFill>
-                  <a:srgbClr val="898781"/>
-                </a:solidFill>
-              </a:defRPr>
-            </a:lvl1pPr>
-          </a:lstStyle>
-          <a:p>
-            <a:pPr algn="r"/>
-            <a:fld id="{F7021451-1387-4CA6-816F-3879F97B5CBC}" type="slidenum">
-              <a:rPr b="0" lang="en-US"/>
-              <a:t>18</a:t>
+              <a:t>19</a:t>
             </a:fld>
             <a:endParaRPr lang="en-US"/>
           </a:p>
@@ -19456,6 +19683,491 @@
             <a:fld id="{F7021451-1387-4CA6-816F-3879F97B5CBC}" type="slidenum">
               <a:rPr b="0" lang="en-US"/>
               <a:t>2</a:t>
+            </a:fld>
+            <a:endParaRPr lang="en-US"/>
+          </a:p>
+        </p:txBody>
+      </p:sp>
+    </p:spTree>
+  </p:cSld>
+  <p:clrMapOvr>
+    <a:masterClrMapping/>
+  </p:clrMapOvr>
+</p:sld>
+</file>
+
+<file path=ppt/slides/slide20.xml><?xml version="1.0" encoding="utf-8"?>
+<p:sld xmlns:a="http://schemas.openxmlformats.org/drawingml/2006/main" xmlns:r="http://schemas.openxmlformats.org/officeDocument/2006/relationships" xmlns:p="http://schemas.openxmlformats.org/presentationml/2006/main">
+  <p:cSld name="Slide 20">
+    <p:spTree>
+      <p:nvGrpSpPr>
+        <p:cNvPr id="1" name=""/>
+        <p:cNvGrpSpPr/>
+        <p:nvPr/>
+      </p:nvGrpSpPr>
+      <p:grpSpPr>
+        <a:xfrm>
+          <a:off x="0" y="0"/>
+          <a:ext cx="0" cy="0"/>
+          <a:chOff x="0" y="0"/>
+          <a:chExt cx="0" cy="0"/>
+        </a:xfrm>
+      </p:grpSpPr>
+      <p:sp>
+        <p:nvSpPr>
+          <p:cNvPr id="2" name="Text 0"/>
+          <p:cNvSpPr/>
+          <p:nvPr>
+            <p:ph idx="100" type="title" hasCustomPrompt="1"/>
+          </p:nvPr>
+        </p:nvSpPr>
+        <p:spPr>
+          <a:xfrm>
+            <a:off x="548640" y="274320"/>
+            <a:ext cx="11091672" cy="960120"/>
+          </a:xfrm>
+          <a:prstGeom prst="rect">
+            <a:avLst/>
+          </a:prstGeom>
+          <a:noFill/>
+          <a:ln/>
+        </p:spPr>
+        <p:txBody>
+          <a:bodyPr wrap="square" lIns="0" tIns="0" rIns="0" bIns="0" rtlCol="0" anchor="ctr"/>
+          <a:lstStyle/>
+          <a:p>
+            <a:pPr algn="l" indent="0" marL="0">
+              <a:buNone/>
+            </a:pPr>
+            <a:r>
+              <a:rPr lang="en-US" sz="2600" b="1" dirty="0">
+                <a:solidFill>
+                  <a:schemeClr val="tx1"/>
+                </a:solidFill>
+              </a:rPr>
+              <a:t>Appendix: one record, as stored</a:t>
+            </a:r>
+            <a:endParaRPr lang="en-US" sz="2600" dirty="0"/>
+          </a:p>
+        </p:txBody>
+      </p:sp>
+      <p:sp>
+        <p:nvSpPr>
+          <p:cNvPr id="3" name="record card"/>
+          <p:cNvSpPr/>
+          <p:nvPr/>
+        </p:nvSpPr>
+        <p:spPr>
+          <a:xfrm>
+            <a:off x="548640" y="1417320"/>
+            <a:ext cx="7818120" cy="2560320"/>
+          </a:xfrm>
+          <a:prstGeom prst="roundRect">
+            <a:avLst>
+              <a:gd name="adj" fmla="val 2500"/>
+            </a:avLst>
+          </a:prstGeom>
+          <a:solidFill>
+            <a:schemeClr val="tx2"/>
+          </a:solidFill>
+          <a:ln/>
+        </p:spPr>
+      </p:sp>
+      <p:sp>
+        <p:nvSpPr>
+          <p:cNvPr id="4" name="record"/>
+          <p:cNvSpPr txBox="1"/>
+          <p:nvPr/>
+        </p:nvSpPr>
+        <p:spPr>
+          <a:xfrm>
+            <a:off x="777240" y="1600200"/>
+            <a:ext cx="7360920" cy="2194560"/>
+          </a:xfrm>
+          <a:prstGeom prst="rect">
+            <a:avLst/>
+          </a:prstGeom>
+          <a:noFill/>
+          <a:ln/>
+        </p:spPr>
+        <p:txBody>
+          <a:bodyPr wrap="square" lIns="0" tIns="0" rIns="0" bIns="0" rtlCol="0" anchor="t"/>
+          <a:lstStyle/>
+          <a:p>
+            <a:pPr indent="0" marL="0">
+              <a:buNone/>
+            </a:pPr>
+            <a:r>
+              <a:rPr lang="en-US" sz="1050" dirty="0">
+                <a:solidFill>
+                  <a:srgbClr val="FFFFFF"/>
+                </a:solidFill>
+                <a:latin typeface="Courier New" pitchFamily="34" charset="0"/>
+                <a:ea typeface="Courier New" pitchFamily="34" charset="-122"/>
+                <a:cs typeface="Courier New" pitchFamily="34" charset="-120"/>
+              </a:rPr>
+              <a:t>{"context_id": "mep_57", "tier": "C2",</a:t>
+            </a:r>
+            <a:endParaRPr lang="en-US" sz="1050" dirty="0"/>
+          </a:p>
+          <a:p>
+            <a:pPr indent="0" marL="0">
+              <a:buNone/>
+            </a:pPr>
+            <a:r>
+              <a:rPr lang="en-US" sz="1050" dirty="0">
+                <a:solidFill>
+                  <a:srgbClr val="FFFFFF"/>
+                </a:solidFill>
+                <a:latin typeface="Courier New" pitchFamily="34" charset="0"/>
+                <a:ea typeface="Courier New" pitchFamily="34" charset="-122"/>
+                <a:cs typeface="Courier New" pitchFamily="34" charset="-120"/>
+              </a:rPr>
+              <a:t> "surface": {"kind": "ceiling", "substrate": "concrete_C25", "thickness_mm": 200.0},</a:t>
+            </a:r>
+            <a:endParaRPr lang="en-US" sz="1050" dirty="0"/>
+          </a:p>
+          <a:p>
+            <a:pPr indent="0" marL="0">
+              <a:buNone/>
+            </a:pPr>
+            <a:r>
+              <a:rPr lang="en-US" sz="1050" dirty="0">
+                <a:solidFill>
+                  <a:srgbClr val="FFFFFF"/>
+                </a:solidFill>
+                <a:latin typeface="Courier New" pitchFamily="34" charset="0"/>
+                <a:ea typeface="Courier New" pitchFamily="34" charset="-122"/>
+                <a:cs typeface="Courier New" pitchFamily="34" charset="-120"/>
+              </a:rPr>
+              <a:t> "n_elements": 2, "n_levels": 1, "total_load_kN": 1.12, "bundle_width_mm": 588.0,</a:t>
+            </a:r>
+            <a:endParaRPr lang="en-US" sz="1050" dirty="0"/>
+          </a:p>
+          <a:p>
+            <a:pPr indent="0" marL="0">
+              <a:buNone/>
+            </a:pPr>
+            <a:r>
+              <a:rPr lang="en-US" sz="1050" dirty="0">
+                <a:solidFill>
+                  <a:srgbClr val="FFFFFF"/>
+                </a:solidFill>
+                <a:latin typeface="Courier New" pitchFamily="34" charset="0"/>
+                <a:ea typeface="Courier New" pitchFamily="34" charset="-122"/>
+                <a:cs typeface="Courier New" pitchFamily="34" charset="-120"/>
+              </a:rPr>
+              <a:t> "elements": [</a:t>
+            </a:r>
+            <a:endParaRPr lang="en-US" sz="1050" dirty="0"/>
+          </a:p>
+          <a:p>
+            <a:pPr indent="0" marL="0">
+              <a:buNone/>
+            </a:pPr>
+            <a:r>
+              <a:rPr lang="en-US" sz="1050" dirty="0">
+                <a:solidFill>
+                  <a:srgbClr val="FFFFFF"/>
+                </a:solidFill>
+                <a:latin typeface="Courier New" pitchFamily="34" charset="0"/>
+                <a:ea typeface="Courier New" pitchFamily="34" charset="-122"/>
+                <a:cs typeface="Courier New" pitchFamily="34" charset="-120"/>
+              </a:rPr>
+              <a:t>  {"kind": "cable_tray", "service": "tray", "trade": "electrical", "shape": "rect",</a:t>
+            </a:r>
+            <a:endParaRPr lang="en-US" sz="1050" dirty="0"/>
+          </a:p>
+          <a:p>
+            <a:pPr indent="0" marL="0">
+              <a:buNone/>
+            </a:pPr>
+            <a:r>
+              <a:rPr lang="en-US" sz="1050" dirty="0">
+                <a:solidFill>
+                  <a:srgbClr val="FFFFFF"/>
+                </a:solidFill>
+                <a:latin typeface="Courier New" pitchFamily="34" charset="0"/>
+                <a:ea typeface="Courier New" pitchFamily="34" charset="-122"/>
+                <a:cs typeface="Courier New" pitchFamily="34" charset="-120"/>
+              </a:rPr>
+              <a:t>   "label": "300 tray", "width_mm": 300.0, "height_mm": 60.0, "insulation_mm": 0.0,</a:t>
+            </a:r>
+            <a:endParaRPr lang="en-US" sz="1050" dirty="0"/>
+          </a:p>
+          <a:p>
+            <a:pPr indent="0" marL="0">
+              <a:buNone/>
+            </a:pPr>
+            <a:r>
+              <a:rPr lang="en-US" sz="1050" dirty="0">
+                <a:solidFill>
+                  <a:srgbClr val="FFFFFF"/>
+                </a:solidFill>
+                <a:latin typeface="Courier New" pitchFamily="34" charset="0"/>
+                <a:ea typeface="Courier New" pitchFamily="34" charset="-122"/>
+                <a:cs typeface="Courier New" pitchFamily="34" charset="-120"/>
+              </a:rPr>
+              <a:t>   "load_kN": 1.08, "span_m": 2.0, "load_kN_per_m": 0.5396,</a:t>
+            </a:r>
+            <a:endParaRPr lang="en-US" sz="1050" dirty="0"/>
+          </a:p>
+          <a:p>
+            <a:pPr indent="0" marL="0">
+              <a:buNone/>
+            </a:pPr>
+            <a:r>
+              <a:rPr lang="en-US" sz="1050" dirty="0">
+                <a:solidFill>
+                  <a:srgbClr val="FFFFFF"/>
+                </a:solidFill>
+                <a:latin typeface="Courier New" pitchFamily="34" charset="0"/>
+                <a:ea typeface="Courier New" pitchFamily="34" charset="-122"/>
+                <a:cs typeface="Courier New" pitchFamily="34" charset="-120"/>
+              </a:rPr>
+              <a:t>   "level": 0, "along_mm": -144.0, "out_mm": 120.0},</a:t>
+            </a:r>
+            <a:endParaRPr lang="en-US" sz="1050" dirty="0"/>
+          </a:p>
+          <a:p>
+            <a:pPr indent="0" marL="0">
+              <a:buNone/>
+            </a:pPr>
+            <a:r>
+              <a:rPr lang="en-US" sz="1050" dirty="0">
+                <a:solidFill>
+                  <a:srgbClr val="FFFFFF"/>
+                </a:solidFill>
+                <a:latin typeface="Courier New" pitchFamily="34" charset="0"/>
+                <a:ea typeface="Courier New" pitchFamily="34" charset="-122"/>
+                <a:cs typeface="Courier New" pitchFamily="34" charset="-120"/>
+              </a:rPr>
+              <a:t>  {"kind": "pipe", "service": "heating", "trade": "heating", "shape": "round",</a:t>
+            </a:r>
+            <a:endParaRPr lang="en-US" sz="1050" dirty="0"/>
+          </a:p>
+          <a:p>
+            <a:pPr indent="0" marL="0">
+              <a:buNone/>
+            </a:pPr>
+            <a:r>
+              <a:rPr lang="en-US" sz="1050" dirty="0">
+                <a:solidFill>
+                  <a:srgbClr val="FFFFFF"/>
+                </a:solidFill>
+                <a:latin typeface="Courier New" pitchFamily="34" charset="0"/>
+                <a:ea typeface="Courier New" pitchFamily="34" charset="-122"/>
+                <a:cs typeface="Courier New" pitchFamily="34" charset="-120"/>
+              </a:rPr>
+              <a:t>   "label": "DN20", "width_mm": 26.9, "height_mm": 26.9, "insulation_mm": 20.0,</a:t>
+            </a:r>
+            <a:endParaRPr lang="en-US" sz="1050" dirty="0"/>
+          </a:p>
+          <a:p>
+            <a:pPr indent="0" marL="0">
+              <a:buNone/>
+            </a:pPr>
+            <a:r>
+              <a:rPr lang="en-US" sz="1050" dirty="0">
+                <a:solidFill>
+                  <a:srgbClr val="FFFFFF"/>
+                </a:solidFill>
+                <a:latin typeface="Courier New" pitchFamily="34" charset="0"/>
+                <a:ea typeface="Courier New" pitchFamily="34" charset="-122"/>
+                <a:cs typeface="Courier New" pitchFamily="34" charset="-120"/>
+              </a:rPr>
+              <a:t>   "load_kN": 0.04, "span_m": 2.1, "load_kN_per_m": 0.0189,</a:t>
+            </a:r>
+            <a:endParaRPr lang="en-US" sz="1050" dirty="0"/>
+          </a:p>
+          <a:p>
+            <a:pPr indent="0" marL="0">
+              <a:buNone/>
+            </a:pPr>
+            <a:r>
+              <a:rPr lang="en-US" sz="1050" dirty="0">
+                <a:solidFill>
+                  <a:srgbClr val="FFFFFF"/>
+                </a:solidFill>
+                <a:latin typeface="Courier New" pitchFamily="34" charset="0"/>
+                <a:ea typeface="Courier New" pitchFamily="34" charset="-122"/>
+                <a:cs typeface="Courier New" pitchFamily="34" charset="-120"/>
+              </a:rPr>
+              <a:t>   "level": 0, "along_mm": 260.5, "out_mm": 156.2}</a:t>
+            </a:r>
+            <a:endParaRPr lang="en-US" sz="1050" dirty="0"/>
+          </a:p>
+          <a:p>
+            <a:pPr indent="0" marL="0">
+              <a:buNone/>
+            </a:pPr>
+            <a:r>
+              <a:rPr lang="en-US" sz="1050" dirty="0">
+                <a:solidFill>
+                  <a:srgbClr val="FFFFFF"/>
+                </a:solidFill>
+                <a:latin typeface="Courier New" pitchFamily="34" charset="0"/>
+                <a:ea typeface="Courier New" pitchFamily="34" charset="-122"/>
+                <a:cs typeface="Courier New" pitchFamily="34" charset="-120"/>
+              </a:rPr>
+              <a:t> ]}</a:t>
+            </a:r>
+            <a:endParaRPr lang="en-US" sz="1050" dirty="0"/>
+          </a:p>
+        </p:txBody>
+      </p:sp>
+      <p:sp>
+        <p:nvSpPr>
+          <p:cNvPr id="5" name="record notes"/>
+          <p:cNvSpPr txBox="1"/>
+          <p:nvPr/>
+        </p:nvSpPr>
+        <p:spPr>
+          <a:xfrm>
+            <a:off x="8641080" y="1463040"/>
+            <a:ext cx="2999232" cy="3749040"/>
+          </a:xfrm>
+          <a:prstGeom prst="rect">
+            <a:avLst/>
+          </a:prstGeom>
+          <a:noFill/>
+          <a:ln/>
+        </p:spPr>
+        <p:txBody>
+          <a:bodyPr wrap="square" lIns="0" tIns="0" rIns="0" bIns="0" rtlCol="0" anchor="t"/>
+          <a:lstStyle/>
+          <a:p>
+            <a:pPr marL="342900" indent="-342900">
+              <a:spcAft>
+                <a:spcPts val="600"/>
+              </a:spcAft>
+              <a:buSzPct val="100000"/>
+              <a:buChar char="•"/>
+            </a:pPr>
+            <a:r>
+              <a:rPr lang="en-US" sz="1300" dirty="0">
+                <a:solidFill>
+                  <a:schemeClr val="tx1"/>
+                </a:solidFill>
+              </a:rPr>
+              <a:t>Units: millimetres, kilonewtons, metres (span)</a:t>
+            </a:r>
+            <a:endParaRPr lang="en-US" sz="1300" dirty="0"/>
+          </a:p>
+          <a:p>
+            <a:pPr marL="342900" indent="-342900">
+              <a:spcAft>
+                <a:spcPts val="600"/>
+              </a:spcAft>
+              <a:buSzPct val="100000"/>
+              <a:buChar char="•"/>
+            </a:pPr>
+            <a:r>
+              <a:rPr lang="en-US" sz="1300" dirty="0">
+                <a:solidFill>
+                  <a:schemeClr val="tx1"/>
+                </a:solidFill>
+              </a:rPr>
+              <a:t>Widths are bare; insulation_mm is per side</a:t>
+            </a:r>
+            <a:endParaRPr lang="en-US" sz="1300" dirty="0"/>
+          </a:p>
+          <a:p>
+            <a:pPr marL="342900" indent="-342900">
+              <a:spcAft>
+                <a:spcPts val="600"/>
+              </a:spcAft>
+              <a:buSzPct val="100000"/>
+              <a:buChar char="•"/>
+            </a:pPr>
+            <a:r>
+              <a:rPr lang="en-US" sz="1300" dirty="0">
+                <a:solidFill>
+                  <a:schemeClr val="tx1"/>
+                </a:solidFill>
+              </a:rPr>
+              <a:t>load_kN = load_kN_per_m × span_m</a:t>
+            </a:r>
+            <a:endParaRPr lang="en-US" sz="1300" dirty="0"/>
+          </a:p>
+          <a:p>
+            <a:pPr marL="342900" indent="-342900">
+              <a:spcAft>
+                <a:spcPts val="600"/>
+              </a:spcAft>
+              <a:buSzPct val="100000"/>
+              <a:buChar char="•"/>
+            </a:pPr>
+            <a:r>
+              <a:rPr lang="en-US" sz="1300" dirty="0">
+                <a:solidFill>
+                  <a:schemeClr val="tx1"/>
+                </a:solidFill>
+              </a:rPr>
+              <a:t>along_mm, out_mm: position along and out from the surface</a:t>
+            </a:r>
+            <a:endParaRPr lang="en-US" sz="1300" dirty="0"/>
+          </a:p>
+          <a:p>
+            <a:pPr marL="342900" indent="-342900">
+              <a:spcAft>
+                <a:spcPts val="600"/>
+              </a:spcAft>
+              <a:buSzPct val="100000"/>
+              <a:buChar char="•"/>
+            </a:pPr>
+            <a:r>
+              <a:rPr lang="en-US" sz="1300" dirty="0">
+                <a:solidFill>
+                  <a:schemeClr val="tx1"/>
+                </a:solidFill>
+              </a:rPr>
+              <a:t>level: the generative row (metadata)</a:t>
+            </a:r>
+            <a:endParaRPr lang="en-US" sz="1300" dirty="0"/>
+          </a:p>
+        </p:txBody>
+      </p:sp>
+      <p:sp>
+        <p:nvSpPr>
+          <p:cNvPr id="25" name="Slide Number Placeholder 0"/>
+          <p:cNvSpPr>
+            <a:spLocks noGrp="1"/>
+          </p:cNvSpPr>
+          <p:nvPr>
+            <p:ph type="sldNum" sz="quarter" idx="4294967295"/>
+          </p:nvPr>
+        </p:nvSpPr>
+        <p:spPr>
+          <a:xfrm>
+            <a:off x="11064240" y="6419088"/>
+            <a:ext cx="594360" cy="274320"/>
+          </a:xfrm>
+          <a:prstGeom prst="rect">
+            <a:avLst/>
+          </a:prstGeom>
+          <a:extLst>
+            <a:ext uri="{C572A759-6A51-4108-AA02-DFA0A04FC94B}">
+              <ma14:wrappingTextBoxFlag xmlns:ma14="http://schemas.microsoft.com/office/mac/drawingml/2011/main" val="0"/>
+            </a:ext>
+          </a:extLst>
+        </p:spPr>
+        <p:txBody>
+          <a:bodyPr/>
+          <a:lstStyle>
+            <a:lvl1pPr>
+              <a:defRPr sz="900">
+                <a:solidFill>
+                  <a:srgbClr val="898781"/>
+                </a:solidFill>
+              </a:defRPr>
+            </a:lvl1pPr>
+          </a:lstStyle>
+          <a:p>
+            <a:pPr algn="r"/>
+            <a:fld id="{F7021451-1387-4CA6-816F-3879F97B5CBC}" type="slidenum">
+              <a:rPr b="0" lang="en-US"/>
+              <a:t>20</a:t>
             </a:fld>
             <a:endParaRPr lang="en-US"/>
           </a:p>
@@ -25107,7 +25819,7 @@
                   <a:schemeClr val="tx1"/>
                 </a:solidFill>
               </a:rPr>
-              <a:t>Experiment 1: higher tiers are heavier and, on average, tighter</a:t>
+              <a:t>Experiment 1, a design check: difficulty grows with the tier</a:t>
             </a:r>
             <a:endParaRPr lang="en-US" sz="2600" dirty="0"/>
           </a:p>
@@ -25167,7 +25879,7 @@
                   <a:srgbClr val="52514E"/>
                 </a:solidFill>
               </a:rPr>
-              <a:t>Boxes: the benchmark, 125 contexts per tier. Diamonds: medians of 2,000 freshly generated contexts per tier, so the trends belong to the generator, not to sampling noise. Load rises at every tier (rank correlation with tier +0.56); the closest gap shrinks overall (−0.36) but widens again at C6 (70 → 75 mm), where the generator starts stacking elements in two or three rows.</a:t>
+              <a:t>A check that the dataset behaves as designed, not a finding about buildings: the tier fixes the element count, and load and congestion follow from the generator’s rules. Boxes: the benchmark, 125 contexts per tier; diamonds: medians of 2,000 freshly generated contexts per tier. Load rises at every tier (rank correlation with tier +0.56); the closest gap shrinks overall (−0.36) but widens again at C6 (70 → 75 mm), where the generator starts stacking elements in two or three rows.</a:t>
             </a:r>
             <a:endParaRPr lang="en-US" sz="1100" dirty="0"/>
           </a:p>

</xml_diff>

<commit_message>
Talk: claims match the evidence, readable studio and figures, retimed
From a review of the deck and script against the repository:
- Experiment 2 states its noise floor (28 mm vs 8 for a perfect generator:
  close, not identical); the baseline is named as a fixed gap at the 25 mm
  minimum, not a modular gap.
- 'Every number traced' becomes 'every constant sourced or declared a design
  choice'; 'checked against two open buildings' is narrowed to the pipe gaps.
- Q&A: the duplex answer gives the generator's share of the mismatch; the 41 mm
  answer says the June sample cannot be reproduced; the catalog answer no
  longer hints at a source.
- Studio and gallery screenshots cropped so the drawings can be read; figure
  footnotes cropped from slides 9 and 10 with one caption each (CC BY 4.0
  attribution kept); chart fonts and label sizes fixed on slide 11.
- Marks retimed at about 145 words a minute with 30 s for the demo; a
  pre-talk checklist in TALK.md; CHANGELOG talk entries merged.
</commit_message>
<xml_diff>
--- a/docs/CrossMEP_CIBW78_talk.pptx
+++ b/docs/CrossMEP_CIBW78_talk.pptx
@@ -126,18 +126,18 @@
   <p:extLst>
     <p:ext uri="{521415D9-36F7-43E2-AB2F-B90AF26B5E84}">
       <p14:sectionLst xmlns:p14="http://schemas.microsoft.com/office/powerpoint/2010/main">
-        <p14:section name="Opening" id="{4c611684-4a5d-11ba-3c2f-2a96587b7a76}">
+        <p14:section name="Opening" id="{222d0e4b-2290-b829-86b3-fe2b48b4af00}">
           <p14:sldIdLst>
             <p14:sldId id="256"/>
           </p14:sldIdLst>
         </p14:section>
-        <p14:section name="Motivation" id="{d23312e0-704f-ec5a-6a3c-8ff2d7ee669c}">
+        <p14:section name="Motivation" id="{1a55bc43-81fb-9643-76d7-e9e36c672aa5}">
           <p14:sldIdLst>
             <p14:sldId id="257"/>
             <p14:sldId id="258"/>
           </p14:sldIdLst>
         </p14:section>
-        <p14:section name="The dataset" id="{4c5f959b-55d5-84b4-d094-b454fc8bcaef}">
+        <p14:section name="The dataset" id="{6be02dc2-8c5e-892b-f328-66315ddcd4bd}">
           <p14:sldIdLst>
             <p14:sldId id="259"/>
             <p14:sldId id="260"/>
@@ -146,14 +146,14 @@
             <p14:sldId id="263"/>
           </p14:sldIdLst>
         </p14:section>
-        <p14:section name="Experiments" id="{bbb2e11e-54ba-a0ec-6c0d-6e7169dd0181}">
+        <p14:section name="Experiments" id="{906f8a34-1dad-623f-8783-c4b89e06b19c}">
           <p14:sldIdLst>
             <p14:sldId id="264"/>
             <p14:sldId id="265"/>
             <p14:sldId id="266"/>
           </p14:sldIdLst>
         </p14:section>
-        <p14:section name="Use" id="{e88cd628-f5fc-6f7d-69e4-e45826598288}">
+        <p14:section name="Use" id="{41ce8121-4ca6-d21d-a734-6c94be272bad}">
           <p14:sldIdLst>
             <p14:sldId id="267"/>
             <p14:sldId id="268"/>
@@ -161,7 +161,7 @@
             <p14:sldId id="270"/>
           </p14:sldIdLst>
         </p14:section>
-        <p14:section name="Appendix" id="{11d5b320-f10b-5b31-bb11-55531da13b9b}">
+        <p14:section name="Appendix" id="{93fb55c0-1488-1f0d-ecf2-6a333f428a70}">
           <p14:sldIdLst>
             <p14:sldId id="271"/>
             <p14:sldId id="272"/>
@@ -787,7 +787,17 @@
     </c:title>
     <c:autoTitleDeleted val="0"/>
     <c:plotArea>
-      <c:layout/>
+      <c:layout>
+        <c:manualLayout>
+          <c:layoutTarget val="inner"/>
+          <c:xMode val="edge"/>
+          <c:yMode val="edge"/>
+          <c:x val="0.08"/>
+          <c:y val="0.14"/>
+          <c:w val="0.9"/>
+          <c:h val="0.62"/>
+        </c:manualLayout>
+      </c:layout>
       <c:barChart>
         <c:barDir val="col"/>
         <c:grouping val="stacked"/>
@@ -820,7 +830,7 @@
               <a:lstStyle/>
               <a:p>
                 <a:pPr>
-                  <a:defRPr b="0" i="0" strike="noStrike" sz="900" u="none">
+                  <a:defRPr b="0" i="0" strike="noStrike" sz="1100" u="none">
                     <a:solidFill>
                       <a:srgbClr val="0B0B0B"/>
                     </a:solidFill>
@@ -940,7 +950,7 @@
               <a:lstStyle/>
               <a:p>
                 <a:pPr>
-                  <a:defRPr b="0" i="0" strike="noStrike" sz="900" u="none">
+                  <a:defRPr b="0" i="0" strike="noStrike" sz="1100" u="none">
                     <a:solidFill>
                       <a:srgbClr val="0B0B0B"/>
                     </a:solidFill>
@@ -1039,7 +1049,7 @@
             <a:lstStyle/>
             <a:p>
               <a:pPr>
-                <a:defRPr b="0" i="0" strike="noStrike" sz="900" u="none">
+                <a:defRPr b="0" i="0" strike="noStrike" sz="1100" u="none">
                   <a:solidFill>
                     <a:srgbClr val="0B0B0B"/>
                   </a:solidFill>
@@ -1235,7 +1245,17 @@
     </c:title>
     <c:autoTitleDeleted val="0"/>
     <c:plotArea>
-      <c:layout/>
+      <c:layout>
+        <c:manualLayout>
+          <c:layoutTarget val="inner"/>
+          <c:xMode val="edge"/>
+          <c:yMode val="edge"/>
+          <c:x val="0.08"/>
+          <c:y val="0.14"/>
+          <c:w val="0.9"/>
+          <c:h val="0.62"/>
+        </c:manualLayout>
+      </c:layout>
       <c:barChart>
         <c:barDir val="col"/>
         <c:grouping val="clustered"/>
@@ -1268,7 +1288,7 @@
               <a:lstStyle/>
               <a:p>
                 <a:pPr>
-                  <a:defRPr b="0" i="0" strike="noStrike" sz="900" u="none">
+                  <a:defRPr b="0" i="0" strike="noStrike" sz="1100" u="none">
                     <a:solidFill>
                       <a:srgbClr val="0B0B0B"/>
                     </a:solidFill>
@@ -1384,7 +1404,7 @@
             <a:lstStyle/>
             <a:p>
               <a:pPr>
-                <a:defRPr b="0" i="0" strike="noStrike" sz="900" u="none">
+                <a:defRPr b="0" i="0" strike="noStrike" sz="1100" u="none">
                   <a:solidFill>
                     <a:srgbClr val="0B0B0B"/>
                   </a:solidFill>
@@ -1425,7 +1445,7 @@
                     <a:solidFill>
                       <a:srgbClr val="52514E"/>
                     </a:solidFill>
-                    <a:latin typeface="Arial"/>
+                    <a:latin typeface="+mn-lt"/>
                   </a:defRPr>
                 </a:pPr>
                 <a:r>
@@ -1433,7 +1453,7 @@
                     <a:solidFill>
                       <a:srgbClr val="52514E"/>
                     </a:solidFill>
-                    <a:latin typeface="Arial"/>
+                    <a:latin typeface="+mn-lt"/>
                   </a:rPr>
                   <a:t>number of clamp sizes, each fitting a 6 mm diameter window</a:t>
                 </a:r>
@@ -2037,7 +2057,7 @@
           <a:p>
             <a:r>
               <a:rPr lang="en-US" dirty="0"/>
-              <a:t>The second experiment is the one the generator could fail: is the spacing realistic in a building it never saw? The gap distribution was fitted on a residential duplex from buildingSMART. We held out a second open building, a medical-dental clinic, which is a real building, cut it into sections every 250 millimetres, the way a context is defined, and measured the gap between pipes running side by side. On the left, the clinic: the generated gaps follow the measured ones. On the right, the distances: generated to clinic 28 millimetres, about as close as the duplex's own two models are to each other. A fixed modular gap would be about 190 millimetres off. (6:00)</a:t>
+              <a:t>The second experiment is the one the generator could fail: is the spacing realistic in a building it never saw? The gap distribution was fitted on a residential duplex from buildingSMART. We held out a second open building, a medical-dental clinic, which is a real building, cut it into sections every 250 millimetres, the way a context is defined, and measured the gap between pipes running side by side. On the left, the clinic: the generated gaps are close to the measured ones, though not identical. On the right, the distances: generated to clinic 28 millimetres. That is above the 8 a perfect generator would show, so not a perfect match, but about as close as the duplex's own two models are to each other. A fixed gap at the 25 millimetre minimum would be about 190 millimetres off. (5:20)</a:t>
             </a:r>
             <a:endParaRPr lang="en-US" dirty="0"/>
           </a:p>
@@ -2125,7 +2145,7 @@
           <a:p>
             <a:r>
               <a:rPr lang="en-US" dirty="0"/>
-              <a:t>The third is a use of the dataset, not a test of it: what must a catalog of clamps cover? Take the paper's two-size catalog as an illustration. It attaches 11.6 per cent of the pipes, interval 10 to 13, all of one size, DN40; load never binds, and trays, ducts and conduits are not covered at all. On the right is what the dataset asks of any catalog: two well-placed sizes attach 43 per cent, six 80, 12 every pipe. So 'what should the catalog contain' becomes a measurement. (6:50)</a:t>
+              <a:t>The third is a use of the dataset, not a test of it: what must a catalog of clamps cover? Take the paper's two-size catalog as an illustration. It attaches 11.6 per cent of the pipes, interval 10 to 13, all of one size, DN40; load never binds, and trays, ducts and conduits are not covered at all. On the right is what the dataset asks of any catalog: two well-placed sizes attach 43 per cent, six 80, twelve every pipe. So 'what should the catalog contain' becomes a measurement. (6:05)</a:t>
             </a:r>
             <a:endParaRPr lang="en-US" dirty="0"/>
           </a:p>
@@ -2213,7 +2233,7 @@
           <a:p>
             <a:r>
               <a:rPr lang="en-US" dirty="0"/>
-              <a:t>Here is what that means in practice. In the studio I choose what crosses the hanger: a tier, or an exact mix, and the seed. Out comes the section a support designer receives, drawn the way an engineer would issue it: every service at true size, its level below the slab, its load at the support, the closest clear gap; and the same run in 3D. Every section is a stored output of the released generator, with the Python call that reproduces it. [Live: switch to the studio, click C3, then Generate another twice, then Exact mix with a duct. If the demo fails, stay on this slide; slide 16 shows two more sections.] (7:30)</a:t>
+              <a:t>Here is what that means in practice. In the studio I choose what crosses the hanger: a tier, or an exact mix, and the seed. Out comes the section a support designer receives, drawn the way an engineer would issue it: every service at true size, its level below the slab, its load at the support, the closest clear gap; and the same run in 3D. Every section is a stored output of the released generator, with the Python call that reproduces it. [Live: switch to the studio, click C3, then Generate another twice, then Exact mix with a duct. If the demo fails, stay on this slide; slide 16 shows two more sections. Before the talk: open the studio once with internet, set its link sharing to public, scan the QR from a phone not logged in.] (6:40)</a:t>
             </a:r>
             <a:endParaRPr lang="en-US" dirty="0"/>
           </a:p>
@@ -2301,7 +2321,7 @@
           <a:p>
             <a:r>
               <a:rPr lang="en-US" dirty="0"/>
-              <a:t>Using it takes a few lines: load a split with the Python standard library, filter by composition, or generate your own mix with the same rules. Because there are no labels, the same files serve reinforcement learning, constraint-programming baselines and human benchmarking, and we ship the scoring: train on the generator, from C1 up to C8; evaluate on the benchmark, the same 125 contexts per tier for every method; report per tier with 95 per cent intervals and paired tests. (8:10)</a:t>
+              <a:t>Using it takes a few lines: load a split with the Python standard library, filter by composition, or generate your own mix with the same rules. Because there are no labels, the same files serve reinforcement learning, constraint-programming baselines and human benchmarking, and we ship the scoring: train on the generator, from C1 up to C8; evaluate on the benchmark, the same 125 contexts per tier for every method; report per tier with 95 per cent intervals and paired tests. (7:45)</a:t>
             </a:r>
             <a:endParaRPr lang="en-US" dirty="0"/>
           </a:p>
@@ -2389,7 +2409,7 @@
           <a:p>
             <a:r>
               <a:rPr lang="en-US" dirty="0"/>
-              <a:t>Its scope: one section at one support - routing, branches and spacing are outside it, although the span is recorded so a method can vary it. Realism is checked on sections of two open buildings; congested racks rest on practice and standards. The trade mix is a design choice, and the data is not for structural design. Next: a public checker for support designs, with best-known costs, so methods can be compared on the answer and not only on the brief; the catalog as an input, so a method is tested on catalogs it has never seen; and a real test set from commercial projects, with supports designed by engineers - which is where we would value your eye. (8:45)</a:t>
+              <a:t>Its scope: one section at one support - routing, branches and spacing are outside it, although the span is recorded so a method can vary it. Realism is checked on sections of two open buildings; congested racks rest on practice and standards. The trade mix is a design choice, and the data is not for structural design. Next: a public checker for support designs, with best-known costs, so methods can be compared on the answer and not only on the brief; the catalog as an input, so a method is tested on catalogs it has never seen; and a real test set from commercial projects, with supports designed by engineers - which is where we would value your eye. (8:20)</a:t>
             </a:r>
             <a:endParaRPr lang="en-US" dirty="0"/>
           </a:p>
@@ -2477,7 +2497,7 @@
           <a:p>
             <a:r>
               <a:rPr lang="en-US" dirty="0"/>
-              <a:t>CrossMEP is the brief, not the answer: 7,000 support-design problems, every number traced to its source, checked against two open buildings, and open. The QR code takes you to the data, the code, the gallery and the studio. Thank you. (9:15)</a:t>
+              <a:t>CrossMEP is the brief, not the answer: 7,000 support-design problems, every constant traced to its source or declared a design choice, pipe gaps checked against two open buildings, and open. The QR code takes you to the data, the code, the gallery and the studio. Thank you. (9:10)</a:t>
             </a:r>
             <a:endParaRPr lang="en-US" dirty="0"/>
           </a:p>
@@ -2917,7 +2937,7 @@
           <a:p>
             <a:r>
               <a:rPr lang="en-US" dirty="0"/>
-              <a:t>Every pipe, duct and tray in a building hangs from a support assembly: anchors, rods, channel, clamps. On a 200,000 square-foot hospital that is on the order of 10,000 assemblies, each taking 20 minutes to two hours by hand - together roughly a quarter of the MEP design effort. These are practitioner estimates. The work starts after coordination: at every hanger location the designer takes the section across the run and designs a support for exactly what passes through it. That section is the unit of work, and it is the unit of our dataset. (0:15)</a:t>
+              <a:t>Every pipe, duct and tray in a building hangs from a support assembly: anchors, rods, channel, clamps. On a 200,000 square-foot hospital that is on the order of 10,000 assemblies, each taking 20 minutes to two hours by hand - together roughly a quarter of the MEP design effort. These are practitioner estimates. The work starts after coordination: at every hanger location the designer takes the section across the run and designs a support for exactly what passes through it. That section is the unit of work, and it is the unit of our dataset. (0:20)</a:t>
             </a:r>
             <a:endParaRPr lang="en-US" dirty="0"/>
           </a:p>
@@ -3093,7 +3113,7 @@
           <a:p>
             <a:r>
               <a:rPr lang="en-US" dirty="0"/>
-              <a:t>Learning-based methods for this task need many such sections, and none were public. Project models are proprietary, the open ones are not organised around supports, and any one project covers one narrow slice. So we built CrossMEP: 7,000 contexts with about 31,500 elements, stratified into eight tiers, deliberately unlabeled, with every constant traced to its source, checked against open IFC buildings, and released openly with the generator. (1:00)</a:t>
+              <a:t>Learning-based methods for this task need many such sections, and none were public. Project models are proprietary, the open ones are not organised around supports, and any one project covers one narrow slice. So we built CrossMEP: 7,000 contexts with about 31,500 elements, stratified into eight tiers, deliberately unlabeled, with every constant traced to its source or declared a design choice, pipe gaps checked against open IFC buildings, and released openly with the generator. (1:00)</a:t>
             </a:r>
             <a:endParaRPr lang="en-US" dirty="0"/>
           </a:p>
@@ -3181,7 +3201,7 @@
           <a:p>
             <a:r>
               <a:rPr lang="en-US" dirty="0"/>
-              <a:t>Here is one context. It is a 2-D section at one support location. Each element carries its kind, service and trade, its bare size, its insulation, its load per metre and the span it was sized at - so the load at this support - and its position along and out from the surface. Plus the surface itself: slab or wall, substrate, thickness. What is not in it is the support: no channel, no rods, no anchors, and no 'correct answer', because a feasible support depends on the catalog you build from. The context is the brief; the assembly is the answer. (1:40)</a:t>
+              <a:t>Here is one context. It is a 2-D section at one support location. Each element carries its kind, service and trade, its bare size, its insulation, its load per metre and the span it was sized at - so the load at this support - and its position along and out from the surface. Plus the surface itself: slab or wall, substrate, thickness. What is not in it is the support: no channel, no rods, no anchors, and no 'correct answer', because a feasible support depends on the catalog you build from. The context is the brief; the assembly is the answer. (1:25)</a:t>
             </a:r>
             <a:endParaRPr lang="en-US" dirty="0"/>
           </a:p>
@@ -3269,7 +3289,7 @@
           <a:p>
             <a:r>
               <a:rPr lang="en-US" dirty="0"/>
-              <a:t>How is a context made? Not by free randomness: by rules you would recognise. The tier fixes the number of elements. We pick the surface. We fill the count with services the way trades actually run - hot and cold together, flow and return together, conduits in groups. Bulky services go nearest the slab: ducts, then containment, then pipes. Gaps between neighbours are drawn from gaps measured on a built project, with a 25 millimetre minimum, plus a small stagger within rows; on walls, electrical stays above water. Finally every context is checked - every pair at least 25 millimetres clear - and it is seeded: the same seed gives the same file, byte for byte. (2:30)</a:t>
+              <a:t>How is a context made? Not by free randomness: by rules you would recognise. The tier fixes the number of elements. We pick the surface. We fill the count with services the way trades actually run - hot and cold together, flow and return together, conduits in groups. Bulky services go nearest the slab: ducts, then containment, then pipes. Gaps between neighbours are drawn from gaps measured on a built project, with a 25 millimetre minimum, plus a small stagger within rows; on walls, electrical stays above water. Finally every context is checked - every pair at least 25 millimetres clear - and it is seeded: the same seed gives the same file, byte for byte. (2:10)</a:t>
             </a:r>
             <a:endParaRPr lang="en-US" dirty="0"/>
           </a:p>
@@ -3357,7 +3377,7 @@
           <a:p>
             <a:r>
               <a:rPr lang="en-US" dirty="0"/>
-              <a:t>Every number in a context has a source. Pipe sizes and walls from EN 10220 and 10255, filled with water, at ASME B31.1 water-service spans. Insulation from the German GEG for heated lines and a condensation-control schedule for chilled water. Trays at IEC 61537 widths, loaded full. Ducts at the EN preferred sizes with a manufacturer weight table. Conduits at IEC 61386 sizes with 40 per cent cable fill. The loads are computed from these sources in the code, and every constant is documented with its source and status. Things that are choices - the trade mix, the tier composition - are labelled as design choices, not presented as measurements. (3:20)</a:t>
+              <a:t>Every number in a context comes from a cited source or a declared design choice. Pipe sizes and walls from EN 10220 and 10255, filled with water, at ASME B31.1 water-service spans. Insulation from the German GEG for heated lines and a condensation-control schedule for chilled water. Trays at IEC 61537 widths, loaded full. Ducts at the EN preferred sizes with a manufacturer weight table. Conduits at IEC 61386 sizes with 40 per cent cable fill. The loads are computed from these sources in the code, and every constant is documented with its source and status. Things that are choices - the trade mix, the tier composition - are labelled as design choices, not presented as measurements. (2:55)</a:t>
             </a:r>
             <a:endParaRPr lang="en-US" dirty="0"/>
           </a:p>
@@ -3445,7 +3465,7 @@
           <a:p>
             <a:r>
               <a:rPr lang="en-US" dirty="0"/>
-              <a:t>The release has four splits on disjoint seeds: 5,000 contexts for training, 500 for validation, 500 for test, and a 1,000-context benchmark with 125 per tier. 31,484 elements in total - mostly pipes, then conduits, trays and ducts; pipe sizes from DN15 to DN100, mostly small bore, as in the measured project. Four in five contexts hang from a ceiling, one in five from a wall, and electrical containment is the largest trade by count. Everything is plain JSON with a schema, metadata and a datasheet. (4:05)</a:t>
+              <a:t>The release has four splits on disjoint seeds: 5,000 contexts for training, 500 for validation, 500 for test, and a 1,000-context benchmark with 125 per tier. 31,484 elements in total - mostly pipes, then conduits, trays and ducts; pipe sizes from DN15 to DN100, mostly small bore, as in the measured project. Four in five contexts hang from a ceiling, one in five from a wall, and electrical containment is the largest trade by count. Everything is plain JSON with a schema, metadata and a datasheet. (3:40)</a:t>
             </a:r>
             <a:endParaRPr lang="en-US" dirty="0"/>
           </a:p>
@@ -3533,7 +3553,7 @@
           <a:p>
             <a:r>
               <a:rPr lang="en-US" dirty="0"/>
-              <a:t>This is what the data looks like: one benchmark context per tier. C1 is a single element - the most common support in any building. By C8 you have eight services on three rows. Within a tier everything else varies - kinds, trades, surfaces and stacking - so the element count is the one controlled difficulty axis. Note the walls: the section rotates, and electrical sits above water. (4:45)</a:t>
+              <a:t>This is what the data looks like: one benchmark context per tier. C1 is a single element - the most common support in any building. By C8 you have eight services on three rows. Within a tier everything else varies - kinds, trades, surfaces and stacking - so the element count is the one controlled difficulty axis. Note the walls: the section rotates, and electrical sits above water. (4:15)</a:t>
             </a:r>
             <a:endParaRPr lang="en-US" dirty="0"/>
           </a:p>
@@ -3621,7 +3641,7 @@
           <a:p>
             <a:r>
               <a:rPr lang="en-US" dirty="0"/>
-              <a:t>The first experiment is a design check, not a discovery: does difficulty grow with the tier, as intended? The count is fixed by construction; load and congestion follow from the rules, so this shows the dataset behaves as designed. Load at the support rises at every step, from 0.1 to 1.7 kilonewtons. The closest gap falls from 120 to about 62 millimetres, but widens again at C6, where the generator starts stacking in two or three rows. So report methods tier by tier. (5:20)</a:t>
+              <a:t>The first experiment is a design check, not a discovery: does difficulty grow with the tier, as intended? The count is fixed by construction; load and congestion follow from the rules, so this shows the dataset behaves as designed. Load at the support rises at every step, from 0.1 to 1.7 kilonewtons. The closest gap falls from 120 to about 62 millimetres, but widens again at C6, where the generator starts stacking in two or three rows. So report methods tier by tier. (4:45)</a:t>
             </a:r>
             <a:endParaRPr lang="en-US" dirty="0"/>
           </a:p>
@@ -4755,7 +4775,7 @@
       </p:sp>
       <p:pic>
         <p:nvPicPr>
-          <p:cNvPr id="3" name="gap distributions" descr="/home/user/crossmep_dataset/docs/figures/04_gaps_vs_buildings.png">    </p:cNvPr>
+          <p:cNvPr id="3" name="gap distributions" descr="preencoded.png">    </p:cNvPr>
           <p:cNvPicPr>
             <a:picLocks noChangeAspect="1"/>
           </p:cNvPicPr>
@@ -4769,8 +4789,8 @@
         </p:blipFill>
         <p:spPr>
           <a:xfrm>
-            <a:off x="797336" y="1325880"/>
-            <a:ext cx="10594281" cy="4297680"/>
+            <a:off x="548640" y="1325880"/>
+            <a:ext cx="11091672" cy="4133217"/>
           </a:xfrm>
           <a:prstGeom prst="rect">
             <a:avLst/>
@@ -4785,8 +4805,8 @@
         </p:nvSpPr>
         <p:spPr>
           <a:xfrm>
-            <a:off x="548640" y="5715000"/>
-            <a:ext cx="11091672" cy="594360"/>
+            <a:off x="548640" y="5568825"/>
+            <a:ext cx="11091672" cy="731520"/>
           </a:xfrm>
           <a:prstGeom prst="rect">
             <a:avLst/>
@@ -4802,14 +4822,14 @@
               <a:buNone/>
             </a:pPr>
             <a:r>
-              <a:rPr lang="en-US" sz="1100" dirty="0">
+              <a:rPr lang="en-US" sz="1250" dirty="0">
                 <a:solidFill>
                   <a:srgbClr val="52514E"/>
                 </a:solidFill>
               </a:rPr>
-              <a:t>The gap distribution was fitted on the duplex; the clinic was held out. Sections cut every 250 mm through two open IFC buildings from buildingSMART (CC BY 4.0), measuring the clear gap between side-by-side pipes. The medical-dental clinic, a real building with 797 measured pipe pairs, is 28 mm from the generated gaps (95 % CI 16–44): about as close as the duplex’s own two models are to each other (26 mm). The small residential duplex is as far from the generator (70–85 mm) as from the clinic (71–85 mm).</a:t>
+              <a:t>The gap distribution was fitted on the duplex; the clinic was held out. Clear gaps between side-by-side pipes, on sections every 250 mm. Clinic (797 pipe pairs): 28 mm from the generated gaps (95 % CI 16–44), more than the 8 mm a perfect generator would show, and about as close as the duplex’s own two models are to each other (26 mm). Models: buildingSMART Duplex Apartment and Medical-Dental Clinic, CC BY 4.0.</a:t>
             </a:r>
-            <a:endParaRPr lang="en-US" sz="1100" dirty="0"/>
+            <a:endParaRPr lang="en-US" sz="1250" dirty="0"/>
           </a:p>
         </p:txBody>
       </p:sp>
@@ -5345,7 +5365,7 @@
       </p:sp>
       <p:pic>
         <p:nvPicPr>
-          <p:cNvPr id="3" name="studio screenshot" descr="/home/user/crossmep_dataset/docs/figures/08_studio_demo.png">    </p:cNvPr>
+          <p:cNvPr id="3" name="studio parameters" descr="preencoded.png">    </p:cNvPr>
           <p:cNvPicPr>
             <a:picLocks noChangeAspect="1"/>
           </p:cNvPicPr>
@@ -5359,8 +5379,32 @@
         </p:blipFill>
         <p:spPr>
           <a:xfrm>
-            <a:off x="548640" y="1355716"/>
-            <a:ext cx="8001000" cy="4512329"/>
+            <a:off x="548640" y="1280160"/>
+            <a:ext cx="11091672" cy="733885"/>
+          </a:xfrm>
+          <a:prstGeom prst="rect">
+            <a:avLst/>
+          </a:prstGeom>
+        </p:spPr>
+      </p:pic>
+      <p:pic>
+        <p:nvPicPr>
+          <p:cNvPr id="4" name="studio section" descr="preencoded.png">    </p:cNvPr>
+          <p:cNvPicPr>
+            <a:picLocks noChangeAspect="1"/>
+          </p:cNvPicPr>
+          <p:nvPr/>
+        </p:nvPicPr>
+        <p:blipFill>
+          <a:blip r:embed="rId2"/>
+          <a:stretch>
+            <a:fillRect/>
+          </a:stretch>
+        </p:blipFill>
+        <p:spPr>
+          <a:xfrm>
+            <a:off x="548640" y="2196925"/>
+            <a:ext cx="7726680" cy="3000652"/>
           </a:xfrm>
           <a:prstGeom prst="rect">
             <a:avLst/>
@@ -5369,14 +5413,14 @@
       </p:pic>
       <p:sp>
         <p:nvSpPr>
-          <p:cNvPr id="4" name="studio caption"/>
+          <p:cNvPr id="5" name="studio caption"/>
           <p:cNvSpPr txBox="1"/>
           <p:nvPr/>
         </p:nvSpPr>
         <p:spPr>
           <a:xfrm>
-            <a:off x="548640" y="5941196"/>
-            <a:ext cx="8001000" cy="274320"/>
+            <a:off x="548640" y="5334737"/>
+            <a:ext cx="7726680" cy="731520"/>
           </a:xfrm>
           <a:prstGeom prst="rect">
             <a:avLst/>
@@ -5392,111 +5436,59 @@
               <a:buNone/>
             </a:pPr>
             <a:r>
-              <a:rPr lang="en-US" sz="1100" dirty="0">
+              <a:rPr lang="en-US" sz="1250" dirty="0">
                 <a:solidFill>
                   <a:srgbClr val="52514E"/>
                 </a:solidFill>
               </a:rPr>
-              <a:t>Generator Studio, tier C7, seed 0: the section as a support detail (scale 1:20) and in 3D.</a:t>
+              <a:t>In: the parameters (tier C7, seed 0). Out: section A–A at the support, as the support designer receives it (scale 1:20), and the same run in 3D. Every section is a stored output of the released generator, with the Python call that reproduces it.</a:t>
             </a:r>
-            <a:endParaRPr lang="en-US" sz="1100" dirty="0"/>
-          </a:p>
-        </p:txBody>
-      </p:sp>
-      <p:sp>
-        <p:nvSpPr>
-          <p:cNvPr id="5" name="studio bullets"/>
-          <p:cNvSpPr txBox="1"/>
-          <p:nvPr/>
-        </p:nvSpPr>
-        <p:spPr>
-          <a:xfrm>
-            <a:off x="8823960" y="1371600"/>
-            <a:ext cx="2816352" cy="2743200"/>
-          </a:xfrm>
-          <a:prstGeom prst="rect">
-            <a:avLst/>
-          </a:prstGeom>
-          <a:noFill/>
-          <a:ln/>
-        </p:spPr>
-        <p:txBody>
-          <a:bodyPr wrap="square" lIns="0" tIns="0" rIns="0" bIns="0" rtlCol="0" anchor="t"/>
-          <a:lstStyle/>
-          <a:p>
-            <a:pPr marL="342900" indent="-342900">
-              <a:spcAft>
-                <a:spcPts val="600"/>
-              </a:spcAft>
-              <a:buSzPct val="100000"/>
-              <a:buChar char="•"/>
-            </a:pPr>
-            <a:r>
-              <a:rPr lang="en-US" sz="1400" dirty="0">
-                <a:solidFill>
-                  <a:schemeClr val="tx1"/>
-                </a:solidFill>
-              </a:rPr>
-              <a:t>In: a tier or an exact mix of services, slab or wall, a seed</a:t>
-            </a:r>
-            <a:endParaRPr lang="en-US" sz="1400" dirty="0"/>
-          </a:p>
-          <a:p>
-            <a:pPr marL="342900" indent="-342900">
-              <a:spcAft>
-                <a:spcPts val="600"/>
-              </a:spcAft>
-              <a:buSzPct val="100000"/>
-              <a:buChar char="•"/>
-            </a:pPr>
-            <a:r>
-              <a:rPr lang="en-US" sz="1400" dirty="0">
-                <a:solidFill>
-                  <a:schemeClr val="tx1"/>
-                </a:solidFill>
-              </a:rPr>
-              <a:t>Out: the section a support designer receives, with sizes, levels, loads and clear gaps</a:t>
-            </a:r>
-            <a:endParaRPr lang="en-US" sz="1400" dirty="0"/>
-          </a:p>
-          <a:p>
-            <a:pPr marL="342900" indent="-342900">
-              <a:spcAft>
-                <a:spcPts val="600"/>
-              </a:spcAft>
-              <a:buSzPct val="100000"/>
-              <a:buChar char="•"/>
-            </a:pPr>
-            <a:r>
-              <a:rPr lang="en-US" sz="1400" dirty="0">
-                <a:solidFill>
-                  <a:schemeClr val="tx1"/>
-                </a:solidFill>
-              </a:rPr>
-              <a:t>Every section is a stored output of the released generator, with the Python call that reproduces it</a:t>
-            </a:r>
-            <a:endParaRPr lang="en-US" sz="1400" dirty="0"/>
+            <a:endParaRPr lang="en-US" sz="1250" dirty="0"/>
           </a:p>
         </p:txBody>
       </p:sp>
       <p:pic>
         <p:nvPicPr>
-          <p:cNvPr id="6" name="qr studio" descr="/home/user/crossmep_dataset/docs/figures/qr_studio.png">    </p:cNvPr>
+          <p:cNvPr id="6" name="studio 3D" descr="preencoded.png">    </p:cNvPr>
           <p:cNvPicPr>
             <a:picLocks noChangeAspect="1"/>
           </p:cNvPicPr>
           <p:nvPr/>
         </p:nvPicPr>
         <p:blipFill>
-          <a:blip r:embed="rId2"/>
+          <a:blip r:embed="rId3"/>
           <a:stretch>
             <a:fillRect/>
           </a:stretch>
         </p:blipFill>
         <p:spPr>
           <a:xfrm>
-            <a:off x="9500616" y="4160520"/>
-            <a:ext cx="1463040" cy="1463040"/>
+            <a:off x="8503920" y="2196925"/>
+            <a:ext cx="3136392" cy="2240280"/>
+          </a:xfrm>
+          <a:prstGeom prst="rect">
+            <a:avLst/>
+          </a:prstGeom>
+        </p:spPr>
+      </p:pic>
+      <p:pic>
+        <p:nvPicPr>
+          <p:cNvPr id="7" name="qr studio" descr="/home/user/crossmep_dataset/docs/figures/qr_studio.png">    </p:cNvPr>
+          <p:cNvPicPr>
+            <a:picLocks noChangeAspect="1"/>
+          </p:cNvPicPr>
+          <p:nvPr/>
+        </p:nvPicPr>
+        <p:blipFill>
+          <a:blip r:embed="rId4"/>
+          <a:stretch>
+            <a:fillRect/>
+          </a:stretch>
+        </p:blipFill>
+        <p:spPr>
+          <a:xfrm>
+            <a:off x="9454896" y="4665805"/>
+            <a:ext cx="1234440" cy="1234440"/>
           </a:xfrm>
           <a:prstGeom prst="rect">
             <a:avLst/>
@@ -5505,14 +5497,14 @@
       </p:pic>
       <p:sp>
         <p:nvSpPr>
-          <p:cNvPr id="7" name="studio link"/>
+          <p:cNvPr id="8" name="studio link"/>
           <p:cNvSpPr txBox="1"/>
           <p:nvPr/>
         </p:nvSpPr>
         <p:spPr>
           <a:xfrm>
-            <a:off x="8823960" y="5669280"/>
-            <a:ext cx="2816352" cy="320040"/>
+            <a:off x="8503920" y="5945965"/>
+            <a:ext cx="3136392" cy="274320"/>
           </a:xfrm>
           <a:prstGeom prst="rect">
             <a:avLst/>
@@ -5528,14 +5520,14 @@
               <a:buNone/>
             </a:pPr>
             <a:r>
-              <a:rPr lang="en-US" sz="1100" dirty="0">
+              <a:rPr lang="en-US" sz="1200" dirty="0">
                 <a:solidFill>
                   <a:srgbClr val="52514E"/>
                 </a:solidFill>
               </a:rPr>
-              <a:t>Try it: docs/studio in the repository</a:t>
+              <a:t>Scan to open the studio</a:t>
             </a:r>
-            <a:endParaRPr lang="en-US" sz="1100" dirty="0"/>
+            <a:endParaRPr lang="en-US" sz="1200" dirty="0"/>
           </a:p>
         </p:txBody>
       </p:sp>
@@ -5890,7 +5882,7 @@
       </p:sp>
       <p:pic>
         <p:nvPicPr>
-          <p:cNvPr id="6" name="gallery screenshot" descr="/home/user/crossmep_dataset/docs/figures/07_gallery_screenshot.png">    </p:cNvPr>
+          <p:cNvPr id="6" name="gallery screenshot" descr="preencoded.png">    </p:cNvPr>
           <p:cNvPicPr>
             <a:picLocks noChangeAspect="1"/>
           </p:cNvPicPr>
@@ -5904,8 +5896,8 @@
         </p:blipFill>
         <p:spPr>
           <a:xfrm>
-            <a:off x="6812259" y="1417320"/>
-            <a:ext cx="4370873" cy="2834640"/>
+            <a:off x="6570536" y="1417320"/>
+            <a:ext cx="4854321" cy="2834640"/>
           </a:xfrm>
           <a:prstGeom prst="rect">
             <a:avLst/>
@@ -5920,8 +5912,8 @@
         </p:nvSpPr>
         <p:spPr>
           <a:xfrm>
-            <a:off x="6355080" y="4325112"/>
-            <a:ext cx="5285232" cy="274320"/>
+            <a:off x="6570536" y="4325112"/>
+            <a:ext cx="4854321" cy="274320"/>
           </a:xfrm>
           <a:prstGeom prst="rect">
             <a:avLst/>
@@ -6857,7 +6849,21 @@
                   <a:srgbClr val="CADCFC"/>
                 </a:solidFill>
               </a:rPr>
-              <a:t>7,000 support-design problems  ·  every number traced  ·  checked against two open buildings  ·  open data and code</a:t>
+              <a:t>7,000 support-design problems  ·  every constant sourced or declared</a:t>
+            </a:r>
+            <a:endParaRPr lang="en-US" sz="1600" dirty="0"/>
+          </a:p>
+          <a:p>
+            <a:pPr indent="0" marL="0">
+              <a:buNone/>
+            </a:pPr>
+            <a:r>
+              <a:rPr lang="en-US" sz="1600" dirty="0">
+                <a:solidFill>
+                  <a:srgbClr val="CADCFC"/>
+                </a:solidFill>
+              </a:rPr>
+              <a:t>pipe gaps checked on two open buildings  ·  open data and code</a:t>
             </a:r>
             <a:endParaRPr lang="en-US" sz="1600" dirty="0"/>
           </a:p>
@@ -7030,7 +7036,7 @@
       </p:sp>
       <p:pic>
         <p:nvPicPr>
-          <p:cNvPr id="3" name="studio wall sheet" descr="/home/user/crossmep_dataset/docs/figures/09_studio_wall.png">    </p:cNvPr>
+          <p:cNvPr id="3" name="studio wall sheet" descr="preencoded.png">    </p:cNvPr>
           <p:cNvPicPr>
             <a:picLocks noChangeAspect="1"/>
           </p:cNvPicPr>
@@ -7044,8 +7050,8 @@
         </p:blipFill>
         <p:spPr>
           <a:xfrm>
-            <a:off x="548640" y="1553108"/>
-            <a:ext cx="5431536" cy="3843223"/>
+            <a:off x="1564579" y="1325880"/>
+            <a:ext cx="3399657" cy="4297680"/>
           </a:xfrm>
           <a:prstGeom prst="rect">
             <a:avLst/>
@@ -7054,7 +7060,7 @@
       </p:pic>
       <p:pic>
         <p:nvPicPr>
-          <p:cNvPr id="4" name="studio mix sheet" descr="/home/user/crossmep_dataset/docs/figures/10_studio_mix.png">    </p:cNvPr>
+          <p:cNvPr id="4" name="studio mix sheet" descr="preencoded.png">    </p:cNvPr>
           <p:cNvPicPr>
             <a:picLocks noChangeAspect="1"/>
           </p:cNvPicPr>
@@ -7068,8 +7074,8 @@
         </p:blipFill>
         <p:spPr>
           <a:xfrm>
-            <a:off x="6208776" y="1553108"/>
-            <a:ext cx="5431536" cy="3843223"/>
+            <a:off x="6542497" y="1325880"/>
+            <a:ext cx="4764095" cy="4297680"/>
           </a:xfrm>
           <a:prstGeom prst="rect">
             <a:avLst/>
@@ -7084,8 +7090,8 @@
         </p:nvSpPr>
         <p:spPr>
           <a:xfrm>
-            <a:off x="548640" y="5469484"/>
-            <a:ext cx="5431536" cy="457200"/>
+            <a:off x="1564579" y="5696712"/>
+            <a:ext cx="3399657" cy="457200"/>
           </a:xfrm>
           <a:prstGeom prst="rect">
             <a:avLst/>
@@ -7120,8 +7126,8 @@
         </p:nvSpPr>
         <p:spPr>
           <a:xfrm>
-            <a:off x="6208776" y="5469484"/>
-            <a:ext cx="5431536" cy="457200"/>
+            <a:off x="6542497" y="5696712"/>
+            <a:ext cx="4764095" cy="457200"/>
           </a:xfrm>
           <a:prstGeom prst="rect">
             <a:avLst/>
@@ -21034,7 +21040,7 @@
       </p:sp>
       <p:sp>
         <p:nvSpPr>
-          <p:cNvPr id="29" name="tile every constant from a standard, a manufacturer table or a measurement"/>
+          <p:cNvPr id="29" name="tile every constant with its source, or declared a design choice"/>
           <p:cNvSpPr/>
           <p:nvPr/>
         </p:nvSpPr>
@@ -21056,7 +21062,7 @@
       </p:sp>
       <p:sp>
         <p:nvSpPr>
-          <p:cNvPr id="30" name="value every constant from a standard, a manufacturer table or a measurement"/>
+          <p:cNvPr id="30" name="value every constant with its source, or declared a design choice"/>
           <p:cNvSpPr txBox="1"/>
           <p:nvPr/>
         </p:nvSpPr>
@@ -21092,7 +21098,7 @@
       </p:sp>
       <p:sp>
         <p:nvSpPr>
-          <p:cNvPr id="31" name="label every constant from a standard, a manufacturer table or a measurement"/>
+          <p:cNvPr id="31" name="label every constant with its source, or declared a design choice"/>
           <p:cNvSpPr txBox="1"/>
           <p:nvPr/>
         </p:nvSpPr>
@@ -21120,7 +21126,7 @@
                   <a:srgbClr val="52514E"/>
                 </a:solidFill>
               </a:rPr>
-              <a:t>every constant from a standard, a manufacturer table or a measurement</a:t>
+              <a:t>every constant with its source, or declared a design choice</a:t>
             </a:r>
             <a:endParaRPr lang="en-US" sz="1150" dirty="0"/>
           </a:p>
@@ -22276,7 +22282,7 @@
                   <a:schemeClr val="tx1"/>
                 </a:solidFill>
               </a:rPr>
-              <a:t>Every number has a source, and every load is computed from it</a:t>
+              <a:t>Every constant is sourced or declared a choice; every load is computed</a:t>
             </a:r>
             <a:endParaRPr lang="en-US" sz="2600" dirty="0"/>
           </a:p>
@@ -25827,7 +25833,7 @@
       </p:sp>
       <p:pic>
         <p:nvPicPr>
-          <p:cNvPr id="3" name="tier statistics" descr="/home/user/crossmep_dataset/docs/figures/03_tiers_stats.png">    </p:cNvPr>
+          <p:cNvPr id="3" name="tier statistics" descr="preencoded.png">    </p:cNvPr>
           <p:cNvPicPr>
             <a:picLocks noChangeAspect="1"/>
           </p:cNvPicPr>
@@ -25841,8 +25847,8 @@
         </p:blipFill>
         <p:spPr>
           <a:xfrm>
-            <a:off x="584630" y="1325880"/>
-            <a:ext cx="11019692" cy="4297680"/>
+            <a:off x="548640" y="1325880"/>
+            <a:ext cx="11091672" cy="3965273"/>
           </a:xfrm>
           <a:prstGeom prst="rect">
             <a:avLst/>
@@ -25857,8 +25863,8 @@
         </p:nvSpPr>
         <p:spPr>
           <a:xfrm>
-            <a:off x="548640" y="5715000"/>
-            <a:ext cx="11091672" cy="594360"/>
+            <a:off x="548640" y="5400881"/>
+            <a:ext cx="11091672" cy="731520"/>
           </a:xfrm>
           <a:prstGeom prst="rect">
             <a:avLst/>
@@ -25874,14 +25880,14 @@
               <a:buNone/>
             </a:pPr>
             <a:r>
-              <a:rPr lang="en-US" sz="1100" dirty="0">
+              <a:rPr lang="en-US" sz="1250" dirty="0">
                 <a:solidFill>
                   <a:srgbClr val="52514E"/>
                 </a:solidFill>
               </a:rPr>
-              <a:t>A check that the dataset behaves as designed, not a finding about buildings: the tier fixes the element count, and load and congestion follow from the generator’s rules. Boxes: the benchmark, 125 contexts per tier; diamonds: medians of 2,000 freshly generated contexts per tier. Load rises at every tier (rank correlation with tier +0.56); the closest gap shrinks overall (−0.36) but widens again at C6 (70 → 75 mm), where the generator starts stacking elements in two or three rows.</a:t>
+              <a:t>A check that the dataset behaves as designed: the tier fixes the element count; load and congestion follow from the rules. Boxes: benchmark, 125 contexts per tier (IQR, whiskers 1.5 IQR); diamonds: medians of 2,000 generated contexts per tier. Load rises at every tier (rank correlation +0.56); the closest gap shrinks overall (−0.36) but widens at C6 (70 → 75 mm), where elements start to stack in two or three rows.</a:t>
             </a:r>
-            <a:endParaRPr lang="en-US" sz="1100" dirty="0"/>
+            <a:endParaRPr lang="en-US" sz="1250" dirty="0"/>
           </a:p>
         </p:txBody>
       </p:sp>

</xml_diff>

<commit_message>
Talk: slide titles state their message
Each title is now a sentence with a point (for example 'Spacing holds up on a
clinic the generator never saw', 'Nowadays, every pipe, duct and tray hangs from
a hand-designed support') rather than a topic label. Numbers in titles are
computed from the released data. Script headings updated to match; PPTX and PDF
rebuilt.

Co-Authored-By: Claude <noreply@anthropic.com>
Claude-Session: https://claude.ai/code/session_01R1ft1rokeRJHR95rzLxNEC
</commit_message>
<xml_diff>
--- a/docs/CrossMEP_CIBW78_talk.pptx
+++ b/docs/CrossMEP_CIBW78_talk.pptx
@@ -126,18 +126,18 @@
   <p:extLst>
     <p:ext uri="{521415D9-36F7-43E2-AB2F-B90AF26B5E84}">
       <p14:sectionLst xmlns:p14="http://schemas.microsoft.com/office/powerpoint/2010/main">
-        <p14:section name="Opening" id="{222d0e4b-2290-b829-86b3-fe2b48b4af00}">
+        <p14:section name="Opening" id="{d96c531c-391f-a77b-2589-7bbab5d88ce3}">
           <p14:sldIdLst>
             <p14:sldId id="256"/>
           </p14:sldIdLst>
         </p14:section>
-        <p14:section name="Motivation" id="{1a55bc43-81fb-9643-76d7-e9e36c672aa5}">
+        <p14:section name="Motivation" id="{57b0d418-9757-a80d-ed0e-2304d7793489}">
           <p14:sldIdLst>
             <p14:sldId id="257"/>
             <p14:sldId id="258"/>
           </p14:sldIdLst>
         </p14:section>
-        <p14:section name="The dataset" id="{6be02dc2-8c5e-892b-f328-66315ddcd4bd}">
+        <p14:section name="The dataset" id="{0647dabb-f33c-9f6d-864a-2bc9373d6266}">
           <p14:sldIdLst>
             <p14:sldId id="259"/>
             <p14:sldId id="260"/>
@@ -146,14 +146,14 @@
             <p14:sldId id="263"/>
           </p14:sldIdLst>
         </p14:section>
-        <p14:section name="Experiments" id="{906f8a34-1dad-623f-8783-c4b89e06b19c}">
+        <p14:section name="Experiments" id="{81d08310-2509-2e35-a957-77b78003ee35}">
           <p14:sldIdLst>
             <p14:sldId id="264"/>
             <p14:sldId id="265"/>
             <p14:sldId id="266"/>
           </p14:sldIdLst>
         </p14:section>
-        <p14:section name="Use" id="{41ce8121-4ca6-d21d-a734-6c94be272bad}">
+        <p14:section name="Use" id="{f597c559-b6a0-e3bc-65de-6de29064ca2d}">
           <p14:sldIdLst>
             <p14:sldId id="267"/>
             <p14:sldId id="268"/>
@@ -161,7 +161,7 @@
             <p14:sldId id="270"/>
           </p14:sldIdLst>
         </p14:section>
-        <p14:section name="Appendix" id="{93fb55c0-1488-1f0d-ecf2-6a333f428a70}">
+        <p14:section name="Appendix" id="{14edb194-819a-3276-a9dd-4b62614448cb}">
           <p14:sldIdLst>
             <p14:sldId id="271"/>
             <p14:sldId id="272"/>
@@ -4767,7 +4767,7 @@
                   <a:schemeClr val="tx1"/>
                 </a:solidFill>
               </a:rPr>
-              <a:t>Experiment 2, the real test: spacing in a building it never saw</a:t>
+              <a:t>Spacing holds up on a clinic the generator never saw</a:t>
             </a:r>
             <a:endParaRPr lang="en-US" sz="2600" dirty="0"/>
           </a:p>
@@ -4935,7 +4935,7 @@
                   <a:schemeClr val="tx1"/>
                 </a:solidFill>
               </a:rPr>
-              <a:t>Experiment 3, a use: what must a clamp catalog cover?</a:t>
+              <a:t>A two-size catalog attaches 1 pipe in 9; the dataset shows what to cover</a:t>
             </a:r>
             <a:endParaRPr lang="en-US" sz="2600" dirty="0"/>
           </a:p>
@@ -5357,7 +5357,7 @@
                   <a:schemeClr val="tx1"/>
                 </a:solidFill>
               </a:rPr>
-              <a:t>See it: set the parameters, get the support designer’s brief</a:t>
+              <a:t>Set the parameters and the generator returns the designer’s brief</a:t>
             </a:r>
             <a:endParaRPr lang="en-US" sz="2600" dirty="0"/>
           </a:p>
@@ -5633,7 +5633,7 @@
                   <a:schemeClr val="tx1"/>
                 </a:solidFill>
               </a:rPr>
-              <a:t>Using CrossMEP: train, evaluate, report</a:t>
+              <a:t>Train on the generator, evaluate on the benchmark, report per tier</a:t>
             </a:r>
             <a:endParaRPr lang="en-US" sz="2600" dirty="0"/>
           </a:p>
@@ -6324,7 +6324,7 @@
                   <a:schemeClr val="tx1"/>
                 </a:solidFill>
               </a:rPr>
-              <a:t>Scope, and what comes next</a:t>
+              <a:t>One section at one support today; a checker and real data come next</a:t>
             </a:r>
             <a:endParaRPr lang="en-US" sz="2600" dirty="0"/>
           </a:p>
@@ -6811,7 +6811,7 @@
                   <a:schemeClr val="bg1"/>
                 </a:solidFill>
               </a:rPr>
-              <a:t>CrossMEP: the brief, not the answer</a:t>
+              <a:t>Support design now has open problems to learn from</a:t>
             </a:r>
             <a:endParaRPr lang="en-US" sz="3600" dirty="0"/>
           </a:p>
@@ -7028,7 +7028,7 @@
                   <a:schemeClr val="tx1"/>
                 </a:solidFill>
               </a:rPr>
-              <a:t>Appendix: two more sections from the Generator Studio</a:t>
+              <a:t>A wall with six pipes, and a slab with a duct, a tray and conduits</a:t>
             </a:r>
             <a:endParaRPr lang="en-US" sz="2600" dirty="0"/>
           </a:p>
@@ -7256,7 +7256,7 @@
                   <a:schemeClr val="tx1"/>
                 </a:solidFill>
               </a:rPr>
-              <a:t>Appendix: per-tier statistics, benchmark split</a:t>
+              <a:t>Median load rises from 0.10 kN at C1 to 1.71 kN at C8 as the gap narrows</a:t>
             </a:r>
             <a:endParaRPr lang="en-US" sz="2600" dirty="0"/>
           </a:p>
@@ -10637,7 +10637,7 @@
                   <a:schemeClr val="tx1"/>
                 </a:solidFill>
               </a:rPr>
-              <a:t>Appendix: the realism check, in detail</a:t>
+              <a:t>Against the clinic the generator is 28 mm off; the small duplex is 70 to 85</a:t>
             </a:r>
             <a:endParaRPr lang="en-US" sz="2600" dirty="0"/>
           </a:p>
@@ -14436,7 +14436,7 @@
                   <a:schemeClr val="tx1"/>
                 </a:solidFill>
               </a:rPr>
-              <a:t>Appendix: the catalog stress test, with error bars</a:t>
+              <a:t>The diameter rule moves catalog coverage more than tier or split does</a:t>
             </a:r>
             <a:endParaRPr lang="en-US" sz="2600" dirty="0"/>
           </a:p>
@@ -19193,7 +19193,7 @@
                   <a:schemeClr val="tx1"/>
                 </a:solidFill>
               </a:rPr>
-              <a:t>Every pipe, duct and tray hangs from a support designed by hand</a:t>
+              <a:t>Nowadays, every pipe, duct and tray hangs from a hand-designed support</a:t>
             </a:r>
             <a:endParaRPr lang="en-US" sz="2600" dirty="0"/>
           </a:p>
@@ -19751,7 +19751,7 @@
                   <a:schemeClr val="tx1"/>
                 </a:solidFill>
               </a:rPr>
-              <a:t>Appendix: one record, as stored</a:t>
+              <a:t>A context is stored as plain JSON: elements, sizes, loads, positions</a:t>
             </a:r>
             <a:endParaRPr lang="en-US" sz="2600" dirty="0"/>
           </a:p>
@@ -20236,7 +20236,7 @@
                   <a:schemeClr val="tx1"/>
                 </a:solidFill>
               </a:rPr>
-              <a:t>There was no public dataset of support-design problems</a:t>
+              <a:t>Learning to design supports needs many problems, and none were public</a:t>
             </a:r>
             <a:endParaRPr lang="en-US" sz="2600" dirty="0"/>
           </a:p>
@@ -21328,7 +21328,7 @@
                   <a:schemeClr val="tx1"/>
                 </a:solidFill>
               </a:rPr>
-              <a:t>A context is the section at one hanger: the brief, not the answer</a:t>
+              <a:t>We generate what a designer receives: the section at one hanger</a:t>
             </a:r>
             <a:endParaRPr lang="en-US" sz="2600" dirty="0"/>
           </a:p>
@@ -21496,7 +21496,7 @@
                   <a:schemeClr val="tx1"/>
                 </a:solidFill>
               </a:rPr>
-              <a:t>How a context is generated: rules, not free randomness</a:t>
+              <a:t>Sections follow trade practice and measured spacing, not random shapes</a:t>
             </a:r>
             <a:endParaRPr lang="en-US" sz="2600" dirty="0"/>
           </a:p>
@@ -22282,7 +22282,7 @@
                   <a:schemeClr val="tx1"/>
                 </a:solidFill>
               </a:rPr>
-              <a:t>Every constant is sourced or declared a choice; every load is computed</a:t>
+              <a:t>Sizes, spans and loads come from standards; the choices are declared</a:t>
             </a:r>
             <a:endParaRPr lang="en-US" sz="2600" dirty="0"/>
           </a:p>
@@ -23818,7 +23818,7 @@
                   <a:schemeClr val="tx1"/>
                 </a:solidFill>
               </a:rPr>
-              <a:t>The release: 7,000 contexts in four splits on disjoint seeds</a:t>
+              <a:t>7,000 contexts in four splits; the test seeds are never trained on</a:t>
             </a:r>
             <a:endParaRPr lang="en-US" sz="2600" dirty="0"/>
           </a:p>
@@ -25657,7 +25657,7 @@
                   <a:schemeClr val="tx1"/>
                 </a:solidFill>
               </a:rPr>
-              <a:t>Eight difficulty tiers: tier Cn holds exactly n elements</a:t>
+              <a:t>Difficulty is one number: tier Cn holds exactly n elements</a:t>
             </a:r>
             <a:endParaRPr lang="en-US" sz="2600" dirty="0"/>
           </a:p>
@@ -25825,7 +25825,7 @@
                   <a:schemeClr val="tx1"/>
                 </a:solidFill>
               </a:rPr>
-              <a:t>Experiment 1, a design check: difficulty grows with the tier</a:t>
+              <a:t>Higher tiers are heavier and, overall, tighter, as designed</a:t>
             </a:r>
             <a:endParaRPr lang="en-US" sz="2600" dirty="0"/>
           </a:p>

</xml_diff>

<commit_message>
Talk: opening slides from the ISARC 2026 talk, Calibri throughout
Slides 2 and 3 adapt the opening of the ISARC 2026 talk: a hospital model zoomed
to one modular support assembly with the cost of designing them by hand, then the
synthesis problem and the three reasons it resists automation. Only the two
neutral renders are reused; product names, logos and tool screenshots are left
out. Headings switch from Cambria to Calibri, and the figures use Calibri (or its
metric twin Carlito). Marks retimed from the script's word count (about 9:40).
</commit_message>
<xml_diff>
--- a/docs/CrossMEP_CIBW78_talk.pptx
+++ b/docs/CrossMEP_CIBW78_talk.pptx
@@ -25,9 +25,10 @@
     <p:sldId id="273" r:id="rId19"/>
     <p:sldId id="274" r:id="rId20"/>
     <p:sldId id="275" r:id="rId21"/>
+    <p:sldId id="276" r:id="rId22"/>
   </p:sldIdLst>
   <p:notesMasterIdLst>
-    <p:notesMasterId r:id="rId22"/>
+    <p:notesMasterId r:id="rId23"/>
   </p:notesMasterIdLst>
   <p:sldSz cx="12192000" cy="6858000"/>
   <p:notesSz cx="6858000" cy="12192000"/>
@@ -126,48 +127,49 @@
   <p:extLst>
     <p:ext uri="{521415D9-36F7-43E2-AB2F-B90AF26B5E84}">
       <p14:sectionLst xmlns:p14="http://schemas.microsoft.com/office/powerpoint/2010/main">
-        <p14:section name="Opening" id="{d96c531c-391f-a77b-2589-7bbab5d88ce3}">
+        <p14:section name="Opening" id="{4ba9412d-72b2-c3d6-8d40-587955bf9c75}">
           <p14:sldIdLst>
             <p14:sldId id="256"/>
           </p14:sldIdLst>
         </p14:section>
-        <p14:section name="Motivation" id="{57b0d418-9757-a80d-ed0e-2304d7793489}">
+        <p14:section name="Motivation" id="{5101bc50-b2ec-a1ab-70fe-49adc88418bf}">
           <p14:sldIdLst>
             <p14:sldId id="257"/>
             <p14:sldId id="258"/>
+            <p14:sldId id="259"/>
           </p14:sldIdLst>
         </p14:section>
-        <p14:section name="The dataset" id="{0647dabb-f33c-9f6d-864a-2bc9373d6266}">
+        <p14:section name="The dataset" id="{be418935-f5f2-dec0-23f7-db9e5066ccef}">
           <p14:sldIdLst>
-            <p14:sldId id="259"/>
             <p14:sldId id="260"/>
             <p14:sldId id="261"/>
             <p14:sldId id="262"/>
             <p14:sldId id="263"/>
+            <p14:sldId id="264"/>
           </p14:sldIdLst>
         </p14:section>
-        <p14:section name="Experiments" id="{81d08310-2509-2e35-a957-77b78003ee35}">
+        <p14:section name="Experiments" id="{2bd65c4c-b1fc-1921-b425-34a5bae00738}">
           <p14:sldIdLst>
-            <p14:sldId id="264"/>
             <p14:sldId id="265"/>
             <p14:sldId id="266"/>
+            <p14:sldId id="267"/>
           </p14:sldIdLst>
         </p14:section>
-        <p14:section name="Use" id="{f597c559-b6a0-e3bc-65de-6de29064ca2d}">
+        <p14:section name="Use" id="{ad95764a-de7c-b336-ff4d-51ccc51f8cac}">
           <p14:sldIdLst>
-            <p14:sldId id="267"/>
             <p14:sldId id="268"/>
             <p14:sldId id="269"/>
             <p14:sldId id="270"/>
+            <p14:sldId id="271"/>
           </p14:sldIdLst>
         </p14:section>
-        <p14:section name="Appendix" id="{14edb194-819a-3276-a9dd-4b62614448cb}">
+        <p14:section name="Appendix" id="{cf67def0-fc7c-8476-6df5-32113d772a2f}">
           <p14:sldIdLst>
-            <p14:sldId id="271"/>
             <p14:sldId id="272"/>
             <p14:sldId id="273"/>
             <p14:sldId id="274"/>
             <p14:sldId id="275"/>
+            <p14:sldId id="276"/>
           </p14:sldIdLst>
         </p14:section>
       </p14:sectionLst>
@@ -2057,7 +2059,7 @@
           <a:p>
             <a:r>
               <a:rPr lang="en-US" dirty="0"/>
-              <a:t>The second experiment is the one the generator could fail: is the spacing realistic in a building it never saw? The gap distribution was fitted on a residential duplex from buildingSMART. We held out a second open building, a medical-dental clinic, which is a real building, cut it into sections every 250 millimetres, the way a context is defined, and measured the gap between pipes running side by side. On the left, the clinic: the generated gaps are close to the measured ones, though not identical. On the right, the distances: generated to clinic 28 millimetres. That is above the 8 a perfect generator would show, so not a perfect match, but about as close as the duplex's own two models are to each other. A fixed gap at the 25 millimetre minimum would be about 190 millimetres off. (5:20)</a:t>
+              <a:t>The first experiment is a design check, not a discovery: does difficulty grow with the tier, as intended? The count is fixed by construction; load and congestion follow from the rules, so this shows the dataset behaves as designed. Load at the support rises at every step, from 0.1 to 1.7 kilonewtons. The closest gap falls from 120 to about 62 millimetres, but widens again at C6, where the generator starts stacking in two or three rows. So report methods tier by tier. (4:55)</a:t>
             </a:r>
             <a:endParaRPr lang="en-US" dirty="0"/>
           </a:p>
@@ -2145,7 +2147,7 @@
           <a:p>
             <a:r>
               <a:rPr lang="en-US" dirty="0"/>
-              <a:t>The third is a use of the dataset, not a test of it: what must a catalog of clamps cover? Take the paper's two-size catalog as an illustration. It attaches 11.6 per cent of the pipes, interval 10 to 13, all of one size, DN40; load never binds, and trays, ducts and conduits are not covered at all. On the right is what the dataset asks of any catalog: two well-placed sizes attach 43 per cent, six 80, twelve every pipe. So 'what should the catalog contain' becomes a measurement. (6:05)</a:t>
+              <a:t>The second experiment is the one the generator could fail: is the spacing realistic in a building it never saw? The gap distribution was fitted on a residential duplex from buildingSMART. We held out a second open building, a medical-dental clinic, which is a real building, cut it into sections every 250 millimetres, the way a context is defined, and measured the gap between pipes running side by side. On the left, the clinic: the generated gaps are close to the measured ones, though not identical. On the right, the distances: generated to clinic 28 millimetres. That is above the 8 a perfect generator would show, so not a perfect match, but about as close as the duplex's own two models are to each other. A fixed gap at the 25 millimetre minimum would be about 190 millimetres off. (5:30)</a:t>
             </a:r>
             <a:endParaRPr lang="en-US" dirty="0"/>
           </a:p>
@@ -2233,7 +2235,7 @@
           <a:p>
             <a:r>
               <a:rPr lang="en-US" dirty="0"/>
-              <a:t>Here is what that means in practice. In the studio I choose what crosses the hanger: a tier, or an exact mix, and the seed. Out comes the section a support designer receives, drawn the way an engineer would issue it: every service at true size, its level below the slab, its load at the support, the closest clear gap; and the same run in 3D. Every section is a stored output of the released generator, with the Python call that reproduces it. [Live: switch to the studio, click C3, then Generate another twice, then Exact mix with a duct. If the demo fails, stay on this slide; slide 16 shows two more sections. Before the talk: open the studio once with internet, set its link sharing to public, scan the QR from a phone not logged in.] (6:40)</a:t>
+              <a:t>The third is a use of the dataset, not a test of it: what must a catalog of clamps cover? Take the paper's two-size catalog as an illustration. It attaches 11.6 per cent of the pipes, interval 10 to 13, all of one size, DN40; load never binds, and trays, ducts and conduits are not covered at all. On the right is what the dataset asks of any catalog: two well-placed sizes attach 43 per cent, six 80, twelve every pipe. So 'what should the catalog contain' becomes a measurement. (6:25)</a:t>
             </a:r>
             <a:endParaRPr lang="en-US" dirty="0"/>
           </a:p>
@@ -2321,7 +2323,7 @@
           <a:p>
             <a:r>
               <a:rPr lang="en-US" dirty="0"/>
-              <a:t>Using it takes a few lines: load a split with the Python standard library, filter by composition, or generate your own mix with the same rules. Because there are no labels, the same files serve reinforcement learning, constraint-programming baselines and human benchmarking, and we ship the scoring: train on the generator, from C1 up to C8; evaluate on the benchmark, the same 125 contexts per tier for every method; report per tier with 95 per cent intervals and paired tests. (7:45)</a:t>
+              <a:t>Here is what that means in practice. In the studio I choose what crosses the hanger: a tier, or an exact mix, and the seed. Out comes the section a support designer receives, drawn the way an engineer would issue it: every service at true size, its level below the slab, its load at the support, the closest clear gap; and the same run in 3D. Every section is a stored output of the released generator, with the Python call that reproduces it. [Live: switch to the studio, click C3, then Generate another twice, then Exact mix with a duct. If the demo fails, stay on this slide; slide 17 shows two more sections. Before the talk: open the studio once with internet, set its link sharing to public, scan the QR from a phone not logged in.] (7:00)</a:t>
             </a:r>
             <a:endParaRPr lang="en-US" dirty="0"/>
           </a:p>
@@ -2409,7 +2411,7 @@
           <a:p>
             <a:r>
               <a:rPr lang="en-US" dirty="0"/>
-              <a:t>Its scope: one section at one support - routing, branches and spacing are outside it, although the span is recorded so a method can vary it. Realism is checked on sections of two open buildings; congested racks rest on practice and standards. The trade mix is a design choice, and the data is not for structural design. Next: a public checker for support designs, with best-known costs, so methods can be compared on the answer and not only on the brief; the catalog as an input, so a method is tested on catalogs it has never seen; and a real test set from commercial projects, with supports designed by engineers - which is where we would value your eye. (8:20)</a:t>
+              <a:t>Using it takes a few lines: load a split with the Python standard library, filter by composition, or generate your own mix with the same rules. Because there are no labels, the same files serve reinforcement learning, constraint-programming baselines and human benchmarking, and we ship the scoring: train on the generator, from C1 up to C8; evaluate on the benchmark, the same 125 contexts per tier for every method; report per tier with 95 per cent intervals and paired tests. (8:05)</a:t>
             </a:r>
             <a:endParaRPr lang="en-US" dirty="0"/>
           </a:p>
@@ -2497,7 +2499,7 @@
           <a:p>
             <a:r>
               <a:rPr lang="en-US" dirty="0"/>
-              <a:t>CrossMEP is the brief, not the answer: 7,000 support-design problems, every constant traced to its source or declared a design choice, pipe gaps checked against two open buildings, and open. The QR code takes you to the data, the code, the gallery and the studio. Thank you. (9:10)</a:t>
+              <a:t>Its scope: one section at one support - routing, branches and spacing are outside it, although the span is recorded so a method can vary it. Realism is checked on sections of two open buildings; congested racks rest on practice and standards. The trade mix is a design choice, and the data is not for structural design. Next: a public checker for support designs, with best-known costs, so methods can be compared on the answer and not only on the brief; the catalog as an input, so a method is tested on catalogs it has never seen; and a real test set from commercial projects, with supports designed by engineers - which is where we would value your eye. (8:35)</a:t>
             </a:r>
             <a:endParaRPr lang="en-US" dirty="0"/>
           </a:p>
@@ -2585,7 +2587,7 @@
           <a:p>
             <a:r>
               <a:rPr lang="en-US" dirty="0"/>
-              <a:t>Backup for the live demo. Left: a wall section, six pipes in two rows, each labelled with its size, trade, insulation, offset from the wall and load at the support. Right: an exact mix on a slab, with a duct, a tray, conduits and pipes, their levels below the soffit and the closest clear gap.</a:t>
+              <a:t>CrossMEP is the brief, not the answer: 7,000 support-design problems, every constant traced to its source or declared a design choice, pipe gaps checked against two open buildings, and open. The QR code takes you to the data, the code, the gallery and the studio. Thank you. (9:25)</a:t>
             </a:r>
             <a:endParaRPr lang="en-US" dirty="0"/>
           </a:p>
@@ -2673,7 +2675,7 @@
           <a:p>
             <a:r>
               <a:rPr lang="en-US" dirty="0"/>
-              <a:t>Backup: per-tier medians on the benchmark split, the distance to the held-out building, and the trend statistics behind experiment 1.</a:t>
+              <a:t>Backup for the live demo. Left: a wall section, six pipes in two rows, each labelled with its size, trade, insulation, offset from the wall and load at the support. Right: an exact mix on a slab, with a duct, a tray, conduits and pipes, their levels below the soffit and the closest clear gap.</a:t>
             </a:r>
             <a:endParaRPr lang="en-US" dirty="0"/>
           </a:p>
@@ -2761,7 +2763,7 @@
           <a:p>
             <a:r>
               <a:rPr lang="en-US" dirty="0"/>
-              <a:t>Backup for questions on experiment 2: sample sizes, both weightings, the noise floor and the sensitivity of the result to the way the sections are cut.</a:t>
+              <a:t>Backup: per-tier medians on the benchmark split, the distance to the held-out building, and the trend statistics behind experiment 1.</a:t>
             </a:r>
             <a:endParaRPr lang="en-US" dirty="0"/>
           </a:p>
@@ -2849,7 +2851,7 @@
           <a:p>
             <a:r>
               <a:rPr lang="en-US" dirty="0"/>
-              <a:t>Backup for questions on experiment 3. Per tier, the benchmark has only 125 contexts, so its intervals are wide; the population estimate from two thousand generated contexts per tier shows the tiers are about equal. The headline depends on the attach-diameter rule and on bin-edge tolerance because one nominal size, DN100, sits 0.3 millimetres outside a bin. Only size and capacity are tested - clearance, insert orientation and anchors are not - so the coverage is an upper bound on what can be installed.</a:t>
+              <a:t>Backup for questions on experiment 2: sample sizes, both weightings, the noise floor and the sensitivity of the result to the way the sections are cut.</a:t>
             </a:r>
             <a:endParaRPr lang="en-US" dirty="0"/>
           </a:p>
@@ -2937,7 +2939,7 @@
           <a:p>
             <a:r>
               <a:rPr lang="en-US" dirty="0"/>
-              <a:t>Every pipe, duct and tray in a building hangs from a support assembly: anchors, rods, channel, clamps. On a 200,000 square-foot hospital that is on the order of 10,000 assemblies, each taking 20 minutes to two hours by hand - together roughly a quarter of the MEP design effort. These are practitioner estimates. The work starts after coordination: at every hanger location the designer takes the section across the run and designs a support for exactly what passes through it. That section is the unit of work, and it is the unit of our dataset. (0:20)</a:t>
+              <a:t>A modular support system groups several MEP services - pipes, ducts, cable trays - onto one prefabricated frame, installed as one unit: a structural support assembly. A 200,000 square-foot hospital needs on the order of 10,000 of them, and each takes 20 minutes to two hours to design by hand: together about a quarter of the MEP design effort. These are practitioner estimates. (0:15)</a:t>
             </a:r>
             <a:endParaRPr lang="en-US" dirty="0"/>
           </a:p>
@@ -3025,6 +3027,94 @@
           <a:p>
             <a:r>
               <a:rPr lang="en-US" dirty="0"/>
+              <a:t>Backup for questions on experiment 3. Per tier, the benchmark has only 125 contexts, so its intervals are wide; the population estimate from two thousand generated contexts per tier shows the tiers are about equal. The headline depends on the attach-diameter rule and on bin-edge tolerance because one nominal size, DN100, sits 0.3 millimetres outside a bin. Only size and capacity are tested - clearance, insert orientation and anchors are not - so the coverage is an upper bound on what can be installed.</a:t>
+            </a:r>
+            <a:endParaRPr lang="en-US" dirty="0"/>
+          </a:p>
+        </p:txBody>
+      </p:sp>
+      <p:sp>
+        <p:nvSpPr>
+          <p:cNvPr id="4" name="Slide Number Placeholder 3"/>
+          <p:cNvSpPr>
+            <a:spLocks noGrp="1"/>
+          </p:cNvSpPr>
+          <p:nvPr>
+            <p:ph type="sldNum" sz="quarter" idx="10"/>
+          </p:nvPr>
+        </p:nvSpPr>
+        <p:spPr/>
+        <p:txBody>
+          <a:bodyPr/>
+          <a:lstStyle/>
+          <a:p>
+            <a:fld id="{F7021451-1387-4CA6-816F-3879F97B5CBC}" type="slidenum">
+              <a:rPr lang="en-US"/>
+              <a:t>20</a:t>
+            </a:fld>
+            <a:endParaRPr lang="en-US"/>
+          </a:p>
+        </p:txBody>
+      </p:sp>
+    </p:spTree>
+    <p:extLst>
+      <p:ext uri="{BB962C8B-B14F-4D97-AF65-F5344CB8AC3E}">
+        <p14:creationId xmlns:p14="http://schemas.microsoft.com/office/powerpoint/2010/main" val="1024086991"/>
+      </p:ext>
+    </p:extLst>
+  </p:cSld>
+  <p:clrMapOvr>
+    <a:masterClrMapping/>
+  </p:clrMapOvr>
+</p:notes>
+</file>
+
+<file path=ppt/notesSlides/notesSlide21.xml><?xml version="1.0" encoding="utf-8"?>
+<p:notes xmlns:a="http://schemas.openxmlformats.org/drawingml/2006/main" xmlns:r="http://schemas.openxmlformats.org/officeDocument/2006/relationships" xmlns:p="http://schemas.openxmlformats.org/presentationml/2006/main">
+  <p:cSld>
+    <p:spTree>
+      <p:nvGrpSpPr>
+        <p:cNvPr id="1" name=""/>
+        <p:cNvGrpSpPr/>
+        <p:nvPr/>
+      </p:nvGrpSpPr>
+      <p:grpSpPr>
+        <a:xfrm>
+          <a:off x="0" y="0"/>
+          <a:ext cx="0" cy="0"/>
+          <a:chOff x="0" y="0"/>
+          <a:chExt cx="0" cy="0"/>
+        </a:xfrm>
+      </p:grpSpPr>
+      <p:sp>
+        <p:nvSpPr>
+          <p:cNvPr id="2" name="Slide Image Placeholder 1"/>
+          <p:cNvSpPr>
+            <a:spLocks noGrp="1" noRot="1" noChangeAspect="1"/>
+          </p:cNvSpPr>
+          <p:nvPr>
+            <p:ph type="sldImg"/>
+          </p:nvPr>
+        </p:nvSpPr>
+        <p:spPr/>
+      </p:sp>
+      <p:sp>
+        <p:nvSpPr>
+          <p:cNvPr id="3" name="Notes Placeholder 2"/>
+          <p:cNvSpPr>
+            <a:spLocks noGrp="1"/>
+          </p:cNvSpPr>
+          <p:nvPr>
+            <p:ph type="body" idx="1"/>
+          </p:nvPr>
+        </p:nvSpPr>
+        <p:spPr/>
+        <p:txBody>
+          <a:bodyPr/>
+          <a:lstStyle/>
+          <a:p>
+            <a:r>
+              <a:rPr lang="en-US" dirty="0"/>
               <a:t>Backup: what one stored context looks like - plain JSON, one object per context.</a:t>
             </a:r>
             <a:endParaRPr lang="en-US" dirty="0"/>
@@ -3048,7 +3138,7 @@
           <a:p>
             <a:fld id="{F7021451-1387-4CA6-816F-3879F97B5CBC}" type="slidenum">
               <a:rPr lang="en-US"/>
-              <a:t>20</a:t>
+              <a:t>21</a:t>
             </a:fld>
             <a:endParaRPr lang="en-US"/>
           </a:p>
@@ -3113,7 +3203,7 @@
           <a:p>
             <a:r>
               <a:rPr lang="en-US" dirty="0"/>
-              <a:t>Learning-based methods for this task need many such sections, and none were public. Project models are proprietary, the open ones are not organised around supports, and any one project covers one narrow slice. So we built CrossMEP: 7,000 contexts with about 31,500 elements, stratified into eight tiers, deliberately unlabeled, with every constant traced to its source or declared a design choice, pipe gaps checked against open IFC buildings, and released openly with the generator. (1:00)</a:t>
+              <a:t>At ISARC we stated the task: given a fixed catalog of components and the MEP context - the services crossing the hanger and the surface they hang from - synthesize a feasible assembly. Design starts after coordination, from the section at each hanger, not from the whole model. Tools coordinate the model and check a design, but choosing the topology and the parts is still manual, because it rests on judgment, on rules that interact across thousands of combinations, and on catalogs that keep changing. The section at the hanger is the unit of that work, and the unit of our dataset. (0:40)</a:t>
             </a:r>
             <a:endParaRPr lang="en-US" dirty="0"/>
           </a:p>
@@ -3201,7 +3291,7 @@
           <a:p>
             <a:r>
               <a:rPr lang="en-US" dirty="0"/>
-              <a:t>Here is one context. It is a 2-D section at one support location. Each element carries its kind, service and trade, its bare size, its insulation, its load per metre and the span it was sized at - so the load at this support - and its position along and out from the surface. Plus the surface itself: slab or wall, substrate, thickness. What is not in it is the support: no channel, no rods, no anchors, and no 'correct answer', because a feasible support depends on the catalog you build from. The context is the brief; the assembly is the answer. (1:25)</a:t>
+              <a:t>Learning-based methods for this task need many such sections, and none were public. Project models are proprietary, the open ones are not organised around supports, and any one project covers one narrow slice. So we built CrossMEP: 7,000 contexts with about 31,500 elements, stratified into eight tiers, deliberately unlabeled, with every constant traced to its source or declared a design choice, pipe gaps checked against open IFC buildings, and released openly with the generator. (1:25)</a:t>
             </a:r>
             <a:endParaRPr lang="en-US" dirty="0"/>
           </a:p>
@@ -3289,7 +3379,7 @@
           <a:p>
             <a:r>
               <a:rPr lang="en-US" dirty="0"/>
-              <a:t>How is a context made? Not by free randomness: by rules you would recognise. The tier fixes the number of elements. We pick the surface. We fill the count with services the way trades actually run - hot and cold together, flow and return together, conduits in groups. Bulky services go nearest the slab: ducts, then containment, then pipes. Gaps between neighbours are drawn from gaps measured on a built project, with a 25 millimetre minimum, plus a small stagger within rows; on walls, electrical stays above water. Finally every context is checked - every pair at least 25 millimetres clear - and it is seeded: the same seed gives the same file, byte for byte. (2:10)</a:t>
+              <a:t>Here is one context. It is a 2-D section at one support location. Each element carries its kind, service and trade, its bare size, its insulation, its load per metre and the span it was sized at - so the load at this support - and its position along and out from the surface. Plus the surface itself: slab or wall, substrate, thickness. What is not in it is the support: no channel, no rods, no anchors, and no 'correct answer', because a feasible support depends on the catalog you build from. The context is the brief; the assembly is the answer. (1:55)</a:t>
             </a:r>
             <a:endParaRPr lang="en-US" dirty="0"/>
           </a:p>
@@ -3377,7 +3467,7 @@
           <a:p>
             <a:r>
               <a:rPr lang="en-US" dirty="0"/>
-              <a:t>Every number in a context comes from a cited source or a declared design choice. Pipe sizes and walls from EN 10220 and 10255, filled with water, at ASME B31.1 water-service spans. Insulation from the German GEG for heated lines and a condensation-control schedule for chilled water. Trays at IEC 61537 widths, loaded full. Ducts at the EN preferred sizes with a manufacturer weight table. Conduits at IEC 61386 sizes with 40 per cent cable fill. The loads are computed from these sources in the code, and every constant is documented with its source and status. Things that are choices - the trade mix, the tier composition - are labelled as design choices, not presented as measurements. (2:55)</a:t>
+              <a:t>How is a context made? Not by free randomness: by rules you would recognise. The tier fixes the number of elements. We pick the surface. We fill the count with services the way trades actually run - hot and cold together, flow and return together, conduits in groups. Bulky services go nearest the slab: ducts, then containment, then pipes. Gaps between neighbours are drawn from gaps measured on a built project, with a 25 millimetre minimum, plus a small stagger within rows; on walls, electrical stays above water. Finally every context is checked - every pair at least 25 millimetres clear - and it is seeded: the same seed gives the same file, byte for byte. (2:35)</a:t>
             </a:r>
             <a:endParaRPr lang="en-US" dirty="0"/>
           </a:p>
@@ -3465,7 +3555,7 @@
           <a:p>
             <a:r>
               <a:rPr lang="en-US" dirty="0"/>
-              <a:t>The release has four splits on disjoint seeds: 5,000 contexts for training, 500 for validation, 500 for test, and a 1,000-context benchmark with 125 per tier. 31,484 elements in total - mostly pipes, then conduits, trays and ducts; pipe sizes from DN15 to DN100, mostly small bore, as in the measured project. Four in five contexts hang from a ceiling, one in five from a wall, and electrical containment is the largest trade by count. Everything is plain JSON with a schema, metadata and a datasheet. (3:40)</a:t>
+              <a:t>Every number in a context comes from a cited source or a declared design choice. Pipes from EN 10220 and 10255, filled with water, at ASME B31.1 water-service spans; insulation from the German GEG and a condensation-control schedule; trays at IEC 61537 widths, loaded full; ducts at EN sizes with a manufacturer weight table; conduits at IEC 61386 sizes with 40 per cent fill. Loads are computed from these in the code, and choices such as the trade mix are labelled as design choices. (3:20)</a:t>
             </a:r>
             <a:endParaRPr lang="en-US" dirty="0"/>
           </a:p>
@@ -3553,7 +3643,7 @@
           <a:p>
             <a:r>
               <a:rPr lang="en-US" dirty="0"/>
-              <a:t>This is what the data looks like: one benchmark context per tier. C1 is a single element - the most common support in any building. By C8 you have eight services on three rows. Within a tier everything else varies - kinds, trades, surfaces and stacking - so the element count is the one controlled difficulty axis. Note the walls: the section rotates, and electrical sits above water. (4:15)</a:t>
+              <a:t>The release has four splits on disjoint seeds: 5,000 contexts for training, 500 for validation, 500 for test, and a 1,000-context benchmark with 125 per tier. 31,484 elements in total - mostly pipes, then conduits, trays and ducts; pipe sizes from DN15 to DN100, mostly small bore, as in the measured project. Four in five contexts hang from a ceiling, one in five from a wall, and electrical containment is the largest trade by count. Everything is plain JSON with a schema, metadata and a datasheet. (3:55)</a:t>
             </a:r>
             <a:endParaRPr lang="en-US" dirty="0"/>
           </a:p>
@@ -3641,7 +3731,7 @@
           <a:p>
             <a:r>
               <a:rPr lang="en-US" dirty="0"/>
-              <a:t>The first experiment is a design check, not a discovery: does difficulty grow with the tier, as intended? The count is fixed by construction; load and congestion follow from the rules, so this shows the dataset behaves as designed. Load at the support rises at every step, from 0.1 to 1.7 kilonewtons. The closest gap falls from 120 to about 62 millimetres, but widens again at C6, where the generator starts stacking in two or three rows. So report methods tier by tier. (4:45)</a:t>
+              <a:t>This is what the data looks like: one benchmark context per tier. C1 is a single element - the most common support in any building. By C8 you have eight services on three rows. Within a tier everything else varies - kinds, trades, surfaces and stacking - so the element count is the one controlled difficulty axis. Note the walls: the section rotates, and electrical sits above water. (4:30)</a:t>
             </a:r>
             <a:endParaRPr lang="en-US" dirty="0"/>
           </a:p>
@@ -4767,6 +4857,174 @@
                   <a:schemeClr val="tx1"/>
                 </a:solidFill>
               </a:rPr>
+              <a:t>Higher tiers are heavier and, overall, tighter, as designed</a:t>
+            </a:r>
+            <a:endParaRPr lang="en-US" sz="2600" dirty="0"/>
+          </a:p>
+        </p:txBody>
+      </p:sp>
+      <p:pic>
+        <p:nvPicPr>
+          <p:cNvPr id="3" name="tier statistics" descr="preencoded.png">    </p:cNvPr>
+          <p:cNvPicPr>
+            <a:picLocks noChangeAspect="1"/>
+          </p:cNvPicPr>
+          <p:nvPr/>
+        </p:nvPicPr>
+        <p:blipFill>
+          <a:blip r:embed="rId1"/>
+          <a:stretch>
+            <a:fillRect/>
+          </a:stretch>
+        </p:blipFill>
+        <p:spPr>
+          <a:xfrm>
+            <a:off x="548640" y="1325880"/>
+            <a:ext cx="11091672" cy="3965273"/>
+          </a:xfrm>
+          <a:prstGeom prst="rect">
+            <a:avLst/>
+          </a:prstGeom>
+        </p:spPr>
+      </p:pic>
+      <p:sp>
+        <p:nvSpPr>
+          <p:cNvPr id="4" name="experiment 1 caption"/>
+          <p:cNvSpPr txBox="1"/>
+          <p:nvPr/>
+        </p:nvSpPr>
+        <p:spPr>
+          <a:xfrm>
+            <a:off x="548640" y="5400881"/>
+            <a:ext cx="11091672" cy="731520"/>
+          </a:xfrm>
+          <a:prstGeom prst="rect">
+            <a:avLst/>
+          </a:prstGeom>
+          <a:noFill/>
+          <a:ln/>
+        </p:spPr>
+        <p:txBody>
+          <a:bodyPr wrap="square" lIns="0" tIns="0" rIns="0" bIns="0" rtlCol="0" anchor="t"/>
+          <a:lstStyle/>
+          <a:p>
+            <a:pPr indent="0" marL="0">
+              <a:buNone/>
+            </a:pPr>
+            <a:r>
+              <a:rPr lang="en-US" sz="1250" dirty="0">
+                <a:solidFill>
+                  <a:srgbClr val="52514E"/>
+                </a:solidFill>
+              </a:rPr>
+              <a:t>A check that the dataset behaves as designed: the tier fixes the element count; load and congestion follow from the rules. Boxes: benchmark, 125 contexts per tier (IQR, whiskers 1.5 IQR); diamonds: medians of 2,000 generated contexts per tier. Load rises at every tier (rank correlation +0.56); the closest gap shrinks overall (−0.36) but widens at C6 (70 → 75 mm), where elements start to stack in two or three rows.</a:t>
+            </a:r>
+            <a:endParaRPr lang="en-US" sz="1250" dirty="0"/>
+          </a:p>
+        </p:txBody>
+      </p:sp>
+      <p:sp>
+        <p:nvSpPr>
+          <p:cNvPr id="25" name="Slide Number Placeholder 0"/>
+          <p:cNvSpPr>
+            <a:spLocks noGrp="1"/>
+          </p:cNvSpPr>
+          <p:nvPr>
+            <p:ph type="sldNum" sz="quarter" idx="4294967295"/>
+          </p:nvPr>
+        </p:nvSpPr>
+        <p:spPr>
+          <a:xfrm>
+            <a:off x="11064240" y="6419088"/>
+            <a:ext cx="594360" cy="274320"/>
+          </a:xfrm>
+          <a:prstGeom prst="rect">
+            <a:avLst/>
+          </a:prstGeom>
+          <a:extLst>
+            <a:ext uri="{C572A759-6A51-4108-AA02-DFA0A04FC94B}">
+              <ma14:wrappingTextBoxFlag xmlns:ma14="http://schemas.microsoft.com/office/mac/drawingml/2011/main" val="0"/>
+            </a:ext>
+          </a:extLst>
+        </p:spPr>
+        <p:txBody>
+          <a:bodyPr/>
+          <a:lstStyle>
+            <a:lvl1pPr>
+              <a:defRPr sz="900">
+                <a:solidFill>
+                  <a:srgbClr val="898781"/>
+                </a:solidFill>
+              </a:defRPr>
+            </a:lvl1pPr>
+          </a:lstStyle>
+          <a:p>
+            <a:pPr algn="r"/>
+            <a:fld id="{F7021451-1387-4CA6-816F-3879F97B5CBC}" type="slidenum">
+              <a:rPr b="0" lang="en-US"/>
+              <a:t>10</a:t>
+            </a:fld>
+            <a:endParaRPr lang="en-US"/>
+          </a:p>
+        </p:txBody>
+      </p:sp>
+    </p:spTree>
+  </p:cSld>
+  <p:clrMapOvr>
+    <a:masterClrMapping/>
+  </p:clrMapOvr>
+</p:sld>
+</file>
+
+<file path=ppt/slides/slide11.xml><?xml version="1.0" encoding="utf-8"?>
+<p:sld xmlns:a="http://schemas.openxmlformats.org/drawingml/2006/main" xmlns:r="http://schemas.openxmlformats.org/officeDocument/2006/relationships" xmlns:p="http://schemas.openxmlformats.org/presentationml/2006/main">
+  <p:cSld name="Slide 11">
+    <p:spTree>
+      <p:nvGrpSpPr>
+        <p:cNvPr id="1" name=""/>
+        <p:cNvGrpSpPr/>
+        <p:nvPr/>
+      </p:nvGrpSpPr>
+      <p:grpSpPr>
+        <a:xfrm>
+          <a:off x="0" y="0"/>
+          <a:ext cx="0" cy="0"/>
+          <a:chOff x="0" y="0"/>
+          <a:chExt cx="0" cy="0"/>
+        </a:xfrm>
+      </p:grpSpPr>
+      <p:sp>
+        <p:nvSpPr>
+          <p:cNvPr id="2" name="Text 0"/>
+          <p:cNvSpPr/>
+          <p:nvPr>
+            <p:ph idx="100" type="title" hasCustomPrompt="1"/>
+          </p:nvPr>
+        </p:nvSpPr>
+        <p:spPr>
+          <a:xfrm>
+            <a:off x="548640" y="274320"/>
+            <a:ext cx="11091672" cy="960120"/>
+          </a:xfrm>
+          <a:prstGeom prst="rect">
+            <a:avLst/>
+          </a:prstGeom>
+          <a:noFill/>
+          <a:ln/>
+        </p:spPr>
+        <p:txBody>
+          <a:bodyPr wrap="square" lIns="0" tIns="0" rIns="0" bIns="0" rtlCol="0" anchor="ctr"/>
+          <a:lstStyle/>
+          <a:p>
+            <a:pPr algn="l" indent="0" marL="0">
+              <a:buNone/>
+            </a:pPr>
+            <a:r>
+              <a:rPr lang="en-US" sz="2600" b="1" dirty="0">
+                <a:solidFill>
+                  <a:schemeClr val="tx1"/>
+                </a:solidFill>
+              </a:rPr>
               <a:t>Spacing holds up on a clinic the generator never saw</a:t>
             </a:r>
             <a:endParaRPr lang="en-US" sz="2600" dirty="0"/>
@@ -4872,7 +5130,7 @@
             <a:pPr algn="r"/>
             <a:fld id="{F7021451-1387-4CA6-816F-3879F97B5CBC}" type="slidenum">
               <a:rPr b="0" lang="en-US"/>
-              <a:t>10</a:t>
+              <a:t>11</a:t>
             </a:fld>
             <a:endParaRPr lang="en-US"/>
           </a:p>
@@ -4886,9 +5144,9 @@
 </p:sld>
 </file>
 
-<file path=ppt/slides/slide11.xml><?xml version="1.0" encoding="utf-8"?>
+<file path=ppt/slides/slide12.xml><?xml version="1.0" encoding="utf-8"?>
 <p:sld xmlns:a="http://schemas.openxmlformats.org/drawingml/2006/main" xmlns:r="http://schemas.openxmlformats.org/officeDocument/2006/relationships" xmlns:p="http://schemas.openxmlformats.org/presentationml/2006/main">
-  <p:cSld name="Slide 11">
+  <p:cSld name="Slide 12">
     <p:spTree>
       <p:nvGrpSpPr>
         <p:cNvPr id="1" name=""/>
@@ -5294,7 +5552,7 @@
             <a:pPr algn="r"/>
             <a:fld id="{F7021451-1387-4CA6-816F-3879F97B5CBC}" type="slidenum">
               <a:rPr b="0" lang="en-US"/>
-              <a:t>11</a:t>
+              <a:t>12</a:t>
             </a:fld>
             <a:endParaRPr lang="en-US"/>
           </a:p>
@@ -5308,9 +5566,9 @@
 </p:sld>
 </file>
 
-<file path=ppt/slides/slide12.xml><?xml version="1.0" encoding="utf-8"?>
+<file path=ppt/slides/slide13.xml><?xml version="1.0" encoding="utf-8"?>
 <p:sld xmlns:a="http://schemas.openxmlformats.org/drawingml/2006/main" xmlns:r="http://schemas.openxmlformats.org/officeDocument/2006/relationships" xmlns:p="http://schemas.openxmlformats.org/presentationml/2006/main">
-  <p:cSld name="Slide 12">
+  <p:cSld name="Slide 13">
     <p:spTree>
       <p:nvGrpSpPr>
         <p:cNvPr id="1" name=""/>
@@ -5570,7 +5828,7 @@
             <a:pPr algn="r"/>
             <a:fld id="{F7021451-1387-4CA6-816F-3879F97B5CBC}" type="slidenum">
               <a:rPr b="0" lang="en-US"/>
-              <a:t>12</a:t>
+              <a:t>13</a:t>
             </a:fld>
             <a:endParaRPr lang="en-US"/>
           </a:p>
@@ -5584,9 +5842,9 @@
 </p:sld>
 </file>
 
-<file path=ppt/slides/slide13.xml><?xml version="1.0" encoding="utf-8"?>
+<file path=ppt/slides/slide14.xml><?xml version="1.0" encoding="utf-8"?>
 <p:sld xmlns:a="http://schemas.openxmlformats.org/drawingml/2006/main" xmlns:r="http://schemas.openxmlformats.org/officeDocument/2006/relationships" xmlns:p="http://schemas.openxmlformats.org/presentationml/2006/main">
-  <p:cSld name="Slide 13">
+  <p:cSld name="Slide 14">
     <p:spTree>
       <p:nvGrpSpPr>
         <p:cNvPr id="1" name=""/>
@@ -6261,7 +6519,7 @@
             <a:pPr algn="r"/>
             <a:fld id="{F7021451-1387-4CA6-816F-3879F97B5CBC}" type="slidenum">
               <a:rPr b="0" lang="en-US"/>
-              <a:t>13</a:t>
+              <a:t>14</a:t>
             </a:fld>
             <a:endParaRPr lang="en-US"/>
           </a:p>
@@ -6275,9 +6533,9 @@
 </p:sld>
 </file>
 
-<file path=ppt/slides/slide14.xml><?xml version="1.0" encoding="utf-8"?>
+<file path=ppt/slides/slide15.xml><?xml version="1.0" encoding="utf-8"?>
 <p:sld xmlns:a="http://schemas.openxmlformats.org/drawingml/2006/main" xmlns:r="http://schemas.openxmlformats.org/officeDocument/2006/relationships" xmlns:p="http://schemas.openxmlformats.org/presentationml/2006/main">
-  <p:cSld name="Slide 14">
+  <p:cSld name="Slide 15">
     <p:spTree>
       <p:nvGrpSpPr>
         <p:cNvPr id="1" name=""/>
@@ -6748,7 +7006,7 @@
             <a:pPr algn="r"/>
             <a:fld id="{F7021451-1387-4CA6-816F-3879F97B5CBC}" type="slidenum">
               <a:rPr b="0" lang="en-US"/>
-              <a:t>14</a:t>
+              <a:t>15</a:t>
             </a:fld>
             <a:endParaRPr lang="en-US"/>
           </a:p>
@@ -6762,9 +7020,9 @@
 </p:sld>
 </file>
 
-<file path=ppt/slides/slide15.xml><?xml version="1.0" encoding="utf-8"?>
+<file path=ppt/slides/slide16.xml><?xml version="1.0" encoding="utf-8"?>
 <p:sld xmlns:a="http://schemas.openxmlformats.org/drawingml/2006/main" xmlns:r="http://schemas.openxmlformats.org/officeDocument/2006/relationships" xmlns:p="http://schemas.openxmlformats.org/presentationml/2006/main">
-  <p:cSld name="Slide 15">
+  <p:cSld name="Slide 16">
     <p:spTree>
       <p:nvGrpSpPr>
         <p:cNvPr id="1" name=""/>
@@ -6979,9 +7237,9 @@
 </p:sld>
 </file>
 
-<file path=ppt/slides/slide16.xml><?xml version="1.0" encoding="utf-8"?>
+<file path=ppt/slides/slide17.xml><?xml version="1.0" encoding="utf-8"?>
 <p:sld xmlns:a="http://schemas.openxmlformats.org/drawingml/2006/main" xmlns:r="http://schemas.openxmlformats.org/officeDocument/2006/relationships" xmlns:p="http://schemas.openxmlformats.org/presentationml/2006/main">
-  <p:cSld name="Slide 16">
+  <p:cSld name="Slide 17">
     <p:spTree>
       <p:nvGrpSpPr>
         <p:cNvPr id="1" name=""/>
@@ -7193,7 +7451,7 @@
             <a:pPr algn="r"/>
             <a:fld id="{F7021451-1387-4CA6-816F-3879F97B5CBC}" type="slidenum">
               <a:rPr b="0" lang="en-US"/>
-              <a:t>16</a:t>
+              <a:t>17</a:t>
             </a:fld>
             <a:endParaRPr lang="en-US"/>
           </a:p>
@@ -7207,9 +7465,9 @@
 </p:sld>
 </file>
 
-<file path=ppt/slides/slide17.xml><?xml version="1.0" encoding="utf-8"?>
+<file path=ppt/slides/slide18.xml><?xml version="1.0" encoding="utf-8"?>
 <p:sld xmlns:a="http://schemas.openxmlformats.org/drawingml/2006/main" xmlns:r="http://schemas.openxmlformats.org/officeDocument/2006/relationships" xmlns:p="http://schemas.openxmlformats.org/presentationml/2006/main">
-  <p:cSld name="Slide 17">
+  <p:cSld name="Slide 18">
     <p:spTree>
       <p:nvGrpSpPr>
         <p:cNvPr id="1" name=""/>
@@ -7264,7 +7522,7 @@
       </p:sp>
       <p:graphicFrame>
         <p:nvGraphicFramePr>
-          <p:cNvPr id="18" name="tier table"/>
+          <p:cNvPr id="19" name="tier table"/>
           <p:cNvGraphicFramePr>
             <a:graphicFrameLocks noGrp="1"/>
           </p:cNvGraphicFramePr>
@@ -10574,7 +10832,7 @@
             <a:pPr algn="r"/>
             <a:fld id="{F7021451-1387-4CA6-816F-3879F97B5CBC}" type="slidenum">
               <a:rPr b="0" lang="en-US"/>
-              <a:t>17</a:t>
+              <a:t>18</a:t>
             </a:fld>
             <a:endParaRPr lang="en-US"/>
           </a:p>
@@ -10588,9 +10846,9 @@
 </p:sld>
 </file>
 
-<file path=ppt/slides/slide18.xml><?xml version="1.0" encoding="utf-8"?>
+<file path=ppt/slides/slide19.xml><?xml version="1.0" encoding="utf-8"?>
 <p:sld xmlns:a="http://schemas.openxmlformats.org/drawingml/2006/main" xmlns:r="http://schemas.openxmlformats.org/officeDocument/2006/relationships" xmlns:p="http://schemas.openxmlformats.org/presentationml/2006/main">
-  <p:cSld name="Slide 18">
+  <p:cSld name="Slide 19">
     <p:spTree>
       <p:nvGrpSpPr>
         <p:cNvPr id="1" name=""/>
@@ -10645,7 +10903,7 @@
       </p:sp>
       <p:graphicFrame>
         <p:nvGraphicFramePr>
-          <p:cNvPr id="19" name="samples table"/>
+          <p:cNvPr id="20" name="samples table"/>
           <p:cNvGraphicFramePr>
             <a:graphicFrameLocks noGrp="1"/>
           </p:cNvGraphicFramePr>
@@ -12328,7 +12586,7 @@
       </p:graphicFrame>
       <p:graphicFrame>
         <p:nvGraphicFramePr>
-          <p:cNvPr id="37" name="distances table"/>
+          <p:cNvPr id="39" name="distances table"/>
           <p:cNvGraphicFramePr>
             <a:graphicFrameLocks noGrp="1"/>
           </p:cNvGraphicFramePr>
@@ -14373,7 +14631,7 @@
             <a:pPr algn="r"/>
             <a:fld id="{F7021451-1387-4CA6-816F-3879F97B5CBC}" type="slidenum">
               <a:rPr b="0" lang="en-US"/>
-              <a:t>18</a:t>
+              <a:t>19</a:t>
             </a:fld>
             <a:endParaRPr lang="en-US"/>
           </a:p>
@@ -14387,9 +14645,609 @@
 </p:sld>
 </file>
 
-<file path=ppt/slides/slide19.xml><?xml version="1.0" encoding="utf-8"?>
+<file path=ppt/slides/slide2.xml><?xml version="1.0" encoding="utf-8"?>
 <p:sld xmlns:a="http://schemas.openxmlformats.org/drawingml/2006/main" xmlns:r="http://schemas.openxmlformats.org/officeDocument/2006/relationships" xmlns:p="http://schemas.openxmlformats.org/presentationml/2006/main">
-  <p:cSld name="Slide 19">
+  <p:cSld name="Slide 2">
+    <p:spTree>
+      <p:nvGrpSpPr>
+        <p:cNvPr id="1" name=""/>
+        <p:cNvGrpSpPr/>
+        <p:nvPr/>
+      </p:nvGrpSpPr>
+      <p:grpSpPr>
+        <a:xfrm>
+          <a:off x="0" y="0"/>
+          <a:ext cx="0" cy="0"/>
+          <a:chOff x="0" y="0"/>
+          <a:chExt cx="0" cy="0"/>
+        </a:xfrm>
+      </p:grpSpPr>
+      <p:sp>
+        <p:nvSpPr>
+          <p:cNvPr id="2" name="Text 0"/>
+          <p:cNvSpPr/>
+          <p:nvPr>
+            <p:ph idx="100" type="title" hasCustomPrompt="1"/>
+          </p:nvPr>
+        </p:nvSpPr>
+        <p:spPr>
+          <a:xfrm>
+            <a:off x="548640" y="274320"/>
+            <a:ext cx="11091672" cy="960120"/>
+          </a:xfrm>
+          <a:prstGeom prst="rect">
+            <a:avLst/>
+          </a:prstGeom>
+          <a:noFill/>
+          <a:ln/>
+        </p:spPr>
+        <p:txBody>
+          <a:bodyPr wrap="square" lIns="0" tIns="0" rIns="0" bIns="0" rtlCol="0" anchor="ctr"/>
+          <a:lstStyle/>
+          <a:p>
+            <a:pPr algn="l" indent="0" marL="0">
+              <a:buNone/>
+            </a:pPr>
+            <a:r>
+              <a:rPr lang="en-US" sz="2600" b="1" dirty="0">
+                <a:solidFill>
+                  <a:schemeClr val="tx1"/>
+                </a:solidFill>
+              </a:rPr>
+              <a:t>A hospital needs about 10,000 support assemblies, each designed by hand</a:t>
+            </a:r>
+            <a:endParaRPr lang="en-US" sz="2600" dirty="0"/>
+          </a:p>
+        </p:txBody>
+      </p:sp>
+      <p:pic>
+        <p:nvPicPr>
+          <p:cNvPr id="3" name="hospital model" descr="/home/user/crossmep_dataset/docs/figures/isarc_building.jpg">    </p:cNvPr>
+          <p:cNvPicPr>
+            <a:picLocks noChangeAspect="1"/>
+          </p:cNvPicPr>
+          <p:nvPr/>
+        </p:nvPicPr>
+        <p:blipFill>
+          <a:blip r:embed="rId1"/>
+          <a:stretch>
+            <a:fillRect/>
+          </a:stretch>
+        </p:blipFill>
+        <p:spPr>
+          <a:xfrm>
+            <a:off x="548640" y="1325880"/>
+            <a:ext cx="6035040" cy="3394710"/>
+          </a:xfrm>
+          <a:prstGeom prst="rect">
+            <a:avLst/>
+          </a:prstGeom>
+        </p:spPr>
+      </p:pic>
+      <p:sp>
+        <p:nvSpPr>
+          <p:cNvPr id="4" name="zoom box"/>
+          <p:cNvSpPr/>
+          <p:nvPr/>
+        </p:nvSpPr>
+        <p:spPr>
+          <a:xfrm>
+            <a:off x="3304843" y="2791716"/>
+            <a:ext cx="592641" cy="473902"/>
+          </a:xfrm>
+          <a:prstGeom prst="rect">
+            <a:avLst/>
+          </a:prstGeom>
+          <a:ln w="19050">
+            <a:solidFill>
+              <a:srgbClr val="EB6834"/>
+            </a:solidFill>
+            <a:prstDash val="solid"/>
+          </a:ln>
+        </p:spPr>
+      </p:sp>
+      <p:sp>
+        <p:nvSpPr>
+          <p:cNvPr id="5" name="zoom line top"/>
+          <p:cNvSpPr/>
+          <p:nvPr/>
+        </p:nvSpPr>
+        <p:spPr>
+          <a:xfrm flipV="1">
+            <a:off x="3897484" y="2791716"/>
+            <a:ext cx="3051956" cy="-1008636"/>
+          </a:xfrm>
+          <a:prstGeom prst="line">
+            <a:avLst/>
+          </a:prstGeom>
+          <a:noFill/>
+          <a:ln w="19050">
+            <a:solidFill>
+              <a:srgbClr val="EB6834"/>
+            </a:solidFill>
+            <a:prstDash val="solid"/>
+          </a:ln>
+        </p:spPr>
+      </p:sp>
+      <p:sp>
+        <p:nvSpPr>
+          <p:cNvPr id="6" name="zoom line bottom"/>
+          <p:cNvSpPr/>
+          <p:nvPr/>
+        </p:nvSpPr>
+        <p:spPr>
+          <a:xfrm>
+            <a:off x="3897484" y="3265617"/>
+            <a:ext cx="3051956" cy="1210645"/>
+          </a:xfrm>
+          <a:prstGeom prst="line">
+            <a:avLst/>
+          </a:prstGeom>
+          <a:noFill/>
+          <a:ln w="19050">
+            <a:solidFill>
+              <a:srgbClr val="EB6834"/>
+            </a:solidFill>
+            <a:prstDash val="solid"/>
+          </a:ln>
+        </p:spPr>
+      </p:sp>
+      <p:pic>
+        <p:nvPicPr>
+          <p:cNvPr id="7" name="one assembly" descr="/home/user/crossmep_dataset/docs/figures/isarc_ssa.jpg">    </p:cNvPr>
+          <p:cNvPicPr>
+            <a:picLocks noChangeAspect="1"/>
+          </p:cNvPicPr>
+          <p:nvPr/>
+        </p:nvPicPr>
+        <p:blipFill>
+          <a:blip r:embed="rId2"/>
+          <a:stretch>
+            <a:fillRect/>
+          </a:stretch>
+        </p:blipFill>
+        <p:spPr>
+          <a:xfrm>
+            <a:off x="6949440" y="1783080"/>
+            <a:ext cx="4690872" cy="2693182"/>
+          </a:xfrm>
+          <a:prstGeom prst="rect">
+            <a:avLst/>
+          </a:prstGeom>
+        </p:spPr>
+      </p:pic>
+      <p:sp>
+        <p:nvSpPr>
+          <p:cNvPr id="8" name="inset frame"/>
+          <p:cNvSpPr/>
+          <p:nvPr/>
+        </p:nvSpPr>
+        <p:spPr>
+          <a:xfrm>
+            <a:off x="6949440" y="1783080"/>
+            <a:ext cx="4690872" cy="2693182"/>
+          </a:xfrm>
+          <a:prstGeom prst="rect">
+            <a:avLst/>
+          </a:prstGeom>
+          <a:ln w="19050">
+            <a:solidFill>
+              <a:srgbClr val="EB6834"/>
+            </a:solidFill>
+            <a:prstDash val="solid"/>
+          </a:ln>
+        </p:spPr>
+      </p:sp>
+      <p:sp>
+        <p:nvSpPr>
+          <p:cNvPr id="9" name="inset label"/>
+          <p:cNvSpPr txBox="1"/>
+          <p:nvPr/>
+        </p:nvSpPr>
+        <p:spPr>
+          <a:xfrm>
+            <a:off x="6949440" y="1325880"/>
+            <a:ext cx="4690872" cy="411480"/>
+          </a:xfrm>
+          <a:prstGeom prst="rect">
+            <a:avLst/>
+          </a:prstGeom>
+          <a:noFill/>
+          <a:ln/>
+        </p:spPr>
+        <p:txBody>
+          <a:bodyPr wrap="square" lIns="0" tIns="0" rIns="0" bIns="0" rtlCol="0" anchor="b"/>
+          <a:lstStyle/>
+          <a:p>
+            <a:pPr indent="0" marL="0">
+              <a:buNone/>
+            </a:pPr>
+            <a:r>
+              <a:rPr lang="en-US" sz="1500" b="1" dirty="0">
+                <a:solidFill>
+                  <a:schemeClr val="tx1"/>
+                </a:solidFill>
+              </a:rPr>
+              <a:t>1 unit = 1 structural support assembly (SSA)</a:t>
+            </a:r>
+            <a:endParaRPr lang="en-US" sz="1500" dirty="0"/>
+          </a:p>
+        </p:txBody>
+      </p:sp>
+      <p:sp>
+        <p:nvSpPr>
+          <p:cNvPr id="10" name="tile support assemblies in one 200,000 sq ft hospital"/>
+          <p:cNvSpPr/>
+          <p:nvPr/>
+        </p:nvSpPr>
+        <p:spPr>
+          <a:xfrm>
+            <a:off x="548640" y="4892040"/>
+            <a:ext cx="3575304" cy="1188720"/>
+          </a:xfrm>
+          <a:prstGeom prst="roundRect">
+            <a:avLst>
+              <a:gd name="adj" fmla="val 5385"/>
+            </a:avLst>
+          </a:prstGeom>
+          <a:solidFill>
+            <a:schemeClr val="bg2"/>
+          </a:solidFill>
+          <a:ln/>
+        </p:spPr>
+      </p:sp>
+      <p:sp>
+        <p:nvSpPr>
+          <p:cNvPr id="11" name="value support assemblies in one 200,000 sq ft hospital"/>
+          <p:cNvSpPr txBox="1"/>
+          <p:nvPr/>
+        </p:nvSpPr>
+        <p:spPr>
+          <a:xfrm>
+            <a:off x="749808" y="4983480"/>
+            <a:ext cx="3172968" cy="594360"/>
+          </a:xfrm>
+          <a:prstGeom prst="rect">
+            <a:avLst/>
+          </a:prstGeom>
+          <a:noFill/>
+          <a:ln/>
+        </p:spPr>
+        <p:txBody>
+          <a:bodyPr wrap="square" lIns="0" tIns="0" rIns="0" bIns="0" rtlCol="0" anchor="ctr"/>
+          <a:lstStyle/>
+          <a:p>
+            <a:pPr indent="0" marL="0">
+              <a:buNone/>
+            </a:pPr>
+            <a:r>
+              <a:rPr lang="en-US" sz="2800" b="1" dirty="0">
+                <a:solidFill>
+                  <a:schemeClr val="accent1"/>
+                </a:solidFill>
+              </a:rPr>
+              <a:t>≈ 10,000</a:t>
+            </a:r>
+            <a:endParaRPr lang="en-US" sz="2800" dirty="0"/>
+          </a:p>
+        </p:txBody>
+      </p:sp>
+      <p:sp>
+        <p:nvSpPr>
+          <p:cNvPr id="12" name="label support assemblies in one 200,000 sq ft hospital"/>
+          <p:cNvSpPr txBox="1"/>
+          <p:nvPr/>
+        </p:nvSpPr>
+        <p:spPr>
+          <a:xfrm>
+            <a:off x="749808" y="5581498"/>
+            <a:ext cx="3172968" cy="451714"/>
+          </a:xfrm>
+          <a:prstGeom prst="rect">
+            <a:avLst/>
+          </a:prstGeom>
+          <a:noFill/>
+          <a:ln/>
+        </p:spPr>
+        <p:txBody>
+          <a:bodyPr wrap="square" lIns="0" tIns="0" rIns="0" bIns="0" rtlCol="0" anchor="t"/>
+          <a:lstStyle/>
+          <a:p>
+            <a:pPr indent="0" marL="0">
+              <a:buNone/>
+            </a:pPr>
+            <a:r>
+              <a:rPr lang="en-US" sz="1200" dirty="0">
+                <a:solidFill>
+                  <a:srgbClr val="52514E"/>
+                </a:solidFill>
+              </a:rPr>
+              <a:t>support assemblies in one 200,000 sq ft hospital</a:t>
+            </a:r>
+            <a:endParaRPr lang="en-US" sz="1200" dirty="0"/>
+          </a:p>
+        </p:txBody>
+      </p:sp>
+      <p:sp>
+        <p:nvSpPr>
+          <p:cNvPr id="13" name="tile of engineering for each assembly, designed one by one"/>
+          <p:cNvSpPr/>
+          <p:nvPr/>
+        </p:nvSpPr>
+        <p:spPr>
+          <a:xfrm>
+            <a:off x="4306824" y="4892040"/>
+            <a:ext cx="3575304" cy="1188720"/>
+          </a:xfrm>
+          <a:prstGeom prst="roundRect">
+            <a:avLst>
+              <a:gd name="adj" fmla="val 5385"/>
+            </a:avLst>
+          </a:prstGeom>
+          <a:solidFill>
+            <a:schemeClr val="bg2"/>
+          </a:solidFill>
+          <a:ln/>
+        </p:spPr>
+      </p:sp>
+      <p:sp>
+        <p:nvSpPr>
+          <p:cNvPr id="14" name="value of engineering for each assembly, designed one by one"/>
+          <p:cNvSpPr txBox="1"/>
+          <p:nvPr/>
+        </p:nvSpPr>
+        <p:spPr>
+          <a:xfrm>
+            <a:off x="4507992" y="4983480"/>
+            <a:ext cx="3172968" cy="594360"/>
+          </a:xfrm>
+          <a:prstGeom prst="rect">
+            <a:avLst/>
+          </a:prstGeom>
+          <a:noFill/>
+          <a:ln/>
+        </p:spPr>
+        <p:txBody>
+          <a:bodyPr wrap="square" lIns="0" tIns="0" rIns="0" bIns="0" rtlCol="0" anchor="ctr"/>
+          <a:lstStyle/>
+          <a:p>
+            <a:pPr indent="0" marL="0">
+              <a:buNone/>
+            </a:pPr>
+            <a:r>
+              <a:rPr lang="en-US" sz="2800" b="1" dirty="0">
+                <a:solidFill>
+                  <a:schemeClr val="accent1"/>
+                </a:solidFill>
+              </a:rPr>
+              <a:t>20 min – 2 h</a:t>
+            </a:r>
+            <a:endParaRPr lang="en-US" sz="2800" dirty="0"/>
+          </a:p>
+        </p:txBody>
+      </p:sp>
+      <p:sp>
+        <p:nvSpPr>
+          <p:cNvPr id="15" name="label of engineering for each assembly, designed one by one"/>
+          <p:cNvSpPr txBox="1"/>
+          <p:nvPr/>
+        </p:nvSpPr>
+        <p:spPr>
+          <a:xfrm>
+            <a:off x="4507992" y="5581498"/>
+            <a:ext cx="3172968" cy="451714"/>
+          </a:xfrm>
+          <a:prstGeom prst="rect">
+            <a:avLst/>
+          </a:prstGeom>
+          <a:noFill/>
+          <a:ln/>
+        </p:spPr>
+        <p:txBody>
+          <a:bodyPr wrap="square" lIns="0" tIns="0" rIns="0" bIns="0" rtlCol="0" anchor="t"/>
+          <a:lstStyle/>
+          <a:p>
+            <a:pPr indent="0" marL="0">
+              <a:buNone/>
+            </a:pPr>
+            <a:r>
+              <a:rPr lang="en-US" sz="1200" dirty="0">
+                <a:solidFill>
+                  <a:srgbClr val="52514E"/>
+                </a:solidFill>
+              </a:rPr>
+              <a:t>of engineering for each assembly, designed one by one</a:t>
+            </a:r>
+            <a:endParaRPr lang="en-US" sz="1200" dirty="0"/>
+          </a:p>
+        </p:txBody>
+      </p:sp>
+      <p:sp>
+        <p:nvSpPr>
+          <p:cNvPr id="16" name="tile of MEP design effort; on the order of $600K per project"/>
+          <p:cNvSpPr/>
+          <p:nvPr/>
+        </p:nvSpPr>
+        <p:spPr>
+          <a:xfrm>
+            <a:off x="8065008" y="4892040"/>
+            <a:ext cx="3575304" cy="1188720"/>
+          </a:xfrm>
+          <a:prstGeom prst="roundRect">
+            <a:avLst>
+              <a:gd name="adj" fmla="val 5385"/>
+            </a:avLst>
+          </a:prstGeom>
+          <a:solidFill>
+            <a:schemeClr val="bg2"/>
+          </a:solidFill>
+          <a:ln/>
+        </p:spPr>
+      </p:sp>
+      <p:sp>
+        <p:nvSpPr>
+          <p:cNvPr id="17" name="value of MEP design effort; on the order of $600K per project"/>
+          <p:cNvSpPr txBox="1"/>
+          <p:nvPr/>
+        </p:nvSpPr>
+        <p:spPr>
+          <a:xfrm>
+            <a:off x="8266176" y="4983480"/>
+            <a:ext cx="3172968" cy="594360"/>
+          </a:xfrm>
+          <a:prstGeom prst="rect">
+            <a:avLst/>
+          </a:prstGeom>
+          <a:noFill/>
+          <a:ln/>
+        </p:spPr>
+        <p:txBody>
+          <a:bodyPr wrap="square" lIns="0" tIns="0" rIns="0" bIns="0" rtlCol="0" anchor="ctr"/>
+          <a:lstStyle/>
+          <a:p>
+            <a:pPr indent="0" marL="0">
+              <a:buNone/>
+            </a:pPr>
+            <a:r>
+              <a:rPr lang="en-US" sz="2800" b="1" dirty="0">
+                <a:solidFill>
+                  <a:schemeClr val="accent1"/>
+                </a:solidFill>
+              </a:rPr>
+              <a:t>≈ ¼</a:t>
+            </a:r>
+            <a:endParaRPr lang="en-US" sz="2800" dirty="0"/>
+          </a:p>
+        </p:txBody>
+      </p:sp>
+      <p:sp>
+        <p:nvSpPr>
+          <p:cNvPr id="18" name="label of MEP design effort; on the order of $600K per project"/>
+          <p:cNvSpPr txBox="1"/>
+          <p:nvPr/>
+        </p:nvSpPr>
+        <p:spPr>
+          <a:xfrm>
+            <a:off x="8266176" y="5581498"/>
+            <a:ext cx="3172968" cy="451714"/>
+          </a:xfrm>
+          <a:prstGeom prst="rect">
+            <a:avLst/>
+          </a:prstGeom>
+          <a:noFill/>
+          <a:ln/>
+        </p:spPr>
+        <p:txBody>
+          <a:bodyPr wrap="square" lIns="0" tIns="0" rIns="0" bIns="0" rtlCol="0" anchor="t"/>
+          <a:lstStyle/>
+          <a:p>
+            <a:pPr indent="0" marL="0">
+              <a:buNone/>
+            </a:pPr>
+            <a:r>
+              <a:rPr lang="en-US" sz="1200" dirty="0">
+                <a:solidFill>
+                  <a:srgbClr val="52514E"/>
+                </a:solidFill>
+              </a:rPr>
+              <a:t>of MEP design effort; on the order of $600K per project</a:t>
+            </a:r>
+            <a:endParaRPr lang="en-US" sz="1200" dirty="0"/>
+          </a:p>
+        </p:txBody>
+      </p:sp>
+      <p:sp>
+        <p:nvSpPr>
+          <p:cNvPr id="19" name="estimates note"/>
+          <p:cNvSpPr txBox="1"/>
+          <p:nvPr/>
+        </p:nvSpPr>
+        <p:spPr>
+          <a:xfrm>
+            <a:off x="548640" y="6126480"/>
+            <a:ext cx="5486400" cy="228600"/>
+          </a:xfrm>
+          <a:prstGeom prst="rect">
+            <a:avLst/>
+          </a:prstGeom>
+          <a:noFill/>
+          <a:ln/>
+        </p:spPr>
+        <p:txBody>
+          <a:bodyPr wrap="square" lIns="0" tIns="0" rIns="0" bIns="0" rtlCol="0" anchor="t"/>
+          <a:lstStyle/>
+          <a:p>
+            <a:pPr indent="0" marL="0">
+              <a:buNone/>
+            </a:pPr>
+            <a:r>
+              <a:rPr lang="en-US" sz="1100" dirty="0">
+                <a:solidFill>
+                  <a:srgbClr val="52514E"/>
+                </a:solidFill>
+              </a:rPr>
+              <a:t>Approximate practitioner estimates.</a:t>
+            </a:r>
+            <a:endParaRPr lang="en-US" sz="1100" dirty="0"/>
+          </a:p>
+        </p:txBody>
+      </p:sp>
+      <p:sp>
+        <p:nvSpPr>
+          <p:cNvPr id="25" name="Slide Number Placeholder 0"/>
+          <p:cNvSpPr>
+            <a:spLocks noGrp="1"/>
+          </p:cNvSpPr>
+          <p:nvPr>
+            <p:ph type="sldNum" sz="quarter" idx="4294967295"/>
+          </p:nvPr>
+        </p:nvSpPr>
+        <p:spPr>
+          <a:xfrm>
+            <a:off x="11064240" y="6419088"/>
+            <a:ext cx="594360" cy="274320"/>
+          </a:xfrm>
+          <a:prstGeom prst="rect">
+            <a:avLst/>
+          </a:prstGeom>
+          <a:extLst>
+            <a:ext uri="{C572A759-6A51-4108-AA02-DFA0A04FC94B}">
+              <ma14:wrappingTextBoxFlag xmlns:ma14="http://schemas.microsoft.com/office/mac/drawingml/2011/main" val="0"/>
+            </a:ext>
+          </a:extLst>
+        </p:spPr>
+        <p:txBody>
+          <a:bodyPr/>
+          <a:lstStyle>
+            <a:lvl1pPr>
+              <a:defRPr sz="900">
+                <a:solidFill>
+                  <a:srgbClr val="898781"/>
+                </a:solidFill>
+              </a:defRPr>
+            </a:lvl1pPr>
+          </a:lstStyle>
+          <a:p>
+            <a:pPr algn="r"/>
+            <a:fld id="{F7021451-1387-4CA6-816F-3879F97B5CBC}" type="slidenum">
+              <a:rPr b="0" lang="en-US"/>
+              <a:t>2</a:t>
+            </a:fld>
+            <a:endParaRPr lang="en-US"/>
+          </a:p>
+        </p:txBody>
+      </p:sp>
+    </p:spTree>
+  </p:cSld>
+  <p:clrMapOvr>
+    <a:masterClrMapping/>
+  </p:clrMapOvr>
+</p:sld>
+</file>
+
+<file path=ppt/slides/slide20.xml><?xml version="1.0" encoding="utf-8"?>
+<p:sld xmlns:a="http://schemas.openxmlformats.org/drawingml/2006/main" xmlns:r="http://schemas.openxmlformats.org/officeDocument/2006/relationships" xmlns:p="http://schemas.openxmlformats.org/presentationml/2006/main">
+  <p:cSld name="Slide 20">
     <p:spTree>
       <p:nvGrpSpPr>
         <p:cNvPr id="1" name=""/>
@@ -14444,7 +15302,7 @@
       </p:sp>
       <p:graphicFrame>
         <p:nvGraphicFramePr>
-          <p:cNvPr id="20" name="per tier catalog table"/>
+          <p:cNvPr id="21" name="per tier catalog table"/>
           <p:cNvGraphicFramePr>
             <a:graphicFrameLocks noGrp="1"/>
           </p:cNvGraphicFramePr>
@@ -16846,7 +17704,7 @@
       </p:graphicFrame>
       <p:graphicFrame>
         <p:nvGraphicFramePr>
-          <p:cNvPr id="39" name="sensitivity table"/>
+          <p:cNvPr id="41" name="sensitivity table"/>
           <p:cNvGraphicFramePr>
             <a:graphicFrameLocks noGrp="1"/>
           </p:cNvGraphicFramePr>
@@ -17974,7 +18832,7 @@
       </p:sp>
       <p:graphicFrame>
         <p:nvGraphicFramePr>
-          <p:cNvPr id="58" name="split catalog table"/>
+          <p:cNvPr id="61" name="split catalog table"/>
           <p:cNvGraphicFramePr>
             <a:graphicFrameLocks noGrp="1"/>
           </p:cNvGraphicFramePr>
@@ -19130,7 +19988,7 @@
             <a:pPr algn="r"/>
             <a:fld id="{F7021451-1387-4CA6-816F-3879F97B5CBC}" type="slidenum">
               <a:rPr b="0" lang="en-US"/>
-              <a:t>19</a:t>
+              <a:t>20</a:t>
             </a:fld>
             <a:endParaRPr lang="en-US"/>
           </a:p>
@@ -19144,567 +20002,9 @@
 </p:sld>
 </file>
 
-<file path=ppt/slides/slide2.xml><?xml version="1.0" encoding="utf-8"?>
+<file path=ppt/slides/slide21.xml><?xml version="1.0" encoding="utf-8"?>
 <p:sld xmlns:a="http://schemas.openxmlformats.org/drawingml/2006/main" xmlns:r="http://schemas.openxmlformats.org/officeDocument/2006/relationships" xmlns:p="http://schemas.openxmlformats.org/presentationml/2006/main">
-  <p:cSld name="Slide 2">
-    <p:spTree>
-      <p:nvGrpSpPr>
-        <p:cNvPr id="1" name=""/>
-        <p:cNvGrpSpPr/>
-        <p:nvPr/>
-      </p:nvGrpSpPr>
-      <p:grpSpPr>
-        <a:xfrm>
-          <a:off x="0" y="0"/>
-          <a:ext cx="0" cy="0"/>
-          <a:chOff x="0" y="0"/>
-          <a:chExt cx="0" cy="0"/>
-        </a:xfrm>
-      </p:grpSpPr>
-      <p:sp>
-        <p:nvSpPr>
-          <p:cNvPr id="2" name="Text 0"/>
-          <p:cNvSpPr/>
-          <p:nvPr>
-            <p:ph idx="100" type="title" hasCustomPrompt="1"/>
-          </p:nvPr>
-        </p:nvSpPr>
-        <p:spPr>
-          <a:xfrm>
-            <a:off x="548640" y="274320"/>
-            <a:ext cx="11091672" cy="960120"/>
-          </a:xfrm>
-          <a:prstGeom prst="rect">
-            <a:avLst/>
-          </a:prstGeom>
-          <a:noFill/>
-          <a:ln/>
-        </p:spPr>
-        <p:txBody>
-          <a:bodyPr wrap="square" lIns="0" tIns="0" rIns="0" bIns="0" rtlCol="0" anchor="ctr"/>
-          <a:lstStyle/>
-          <a:p>
-            <a:pPr algn="l" indent="0" marL="0">
-              <a:buNone/>
-            </a:pPr>
-            <a:r>
-              <a:rPr lang="en-US" sz="2600" b="1" dirty="0">
-                <a:solidFill>
-                  <a:schemeClr val="tx1"/>
-                </a:solidFill>
-              </a:rPr>
-              <a:t>Nowadays, every pipe, duct and tray hangs from a hand-designed support</a:t>
-            </a:r>
-            <a:endParaRPr lang="en-US" sz="2600" dirty="0"/>
-          </a:p>
-        </p:txBody>
-      </p:sp>
-      <p:sp>
-        <p:nvSpPr>
-          <p:cNvPr id="3" name="tile support assemblies in one 200,000 sq ft hospital"/>
-          <p:cNvSpPr/>
-          <p:nvPr/>
-        </p:nvSpPr>
-        <p:spPr>
-          <a:xfrm>
-            <a:off x="548640" y="1417320"/>
-            <a:ext cx="3566160" cy="1371600"/>
-          </a:xfrm>
-          <a:prstGeom prst="roundRect">
-            <a:avLst>
-              <a:gd name="adj" fmla="val 4667"/>
-            </a:avLst>
-          </a:prstGeom>
-          <a:solidFill>
-            <a:schemeClr val="bg2"/>
-          </a:solidFill>
-          <a:ln/>
-        </p:spPr>
-      </p:sp>
-      <p:sp>
-        <p:nvSpPr>
-          <p:cNvPr id="4" name="value support assemblies in one 200,000 sq ft hospital"/>
-          <p:cNvSpPr txBox="1"/>
-          <p:nvPr/>
-        </p:nvSpPr>
-        <p:spPr>
-          <a:xfrm>
-            <a:off x="749808" y="1508760"/>
-            <a:ext cx="3163824" cy="685800"/>
-          </a:xfrm>
-          <a:prstGeom prst="rect">
-            <a:avLst/>
-          </a:prstGeom>
-          <a:noFill/>
-          <a:ln/>
-        </p:spPr>
-        <p:txBody>
-          <a:bodyPr wrap="square" lIns="0" tIns="0" rIns="0" bIns="0" rtlCol="0" anchor="ctr"/>
-          <a:lstStyle/>
-          <a:p>
-            <a:pPr indent="0" marL="0">
-              <a:buNone/>
-            </a:pPr>
-            <a:r>
-              <a:rPr lang="en-US" sz="3200" b="1" dirty="0">
-                <a:solidFill>
-                  <a:schemeClr val="accent1"/>
-                </a:solidFill>
-              </a:rPr>
-              <a:t>≈ 10,000</a:t>
-            </a:r>
-            <a:endParaRPr lang="en-US" sz="3200" dirty="0"/>
-          </a:p>
-        </p:txBody>
-      </p:sp>
-      <p:sp>
-        <p:nvSpPr>
-          <p:cNvPr id="5" name="label support assemblies in one 200,000 sq ft hospital"/>
-          <p:cNvSpPr txBox="1"/>
-          <p:nvPr/>
-        </p:nvSpPr>
-        <p:spPr>
-          <a:xfrm>
-            <a:off x="749808" y="2212848"/>
-            <a:ext cx="3163824" cy="521208"/>
-          </a:xfrm>
-          <a:prstGeom prst="rect">
-            <a:avLst/>
-          </a:prstGeom>
-          <a:noFill/>
-          <a:ln/>
-        </p:spPr>
-        <p:txBody>
-          <a:bodyPr wrap="square" lIns="0" tIns="0" rIns="0" bIns="0" rtlCol="0" anchor="t"/>
-          <a:lstStyle/>
-          <a:p>
-            <a:pPr indent="0" marL="0">
-              <a:buNone/>
-            </a:pPr>
-            <a:r>
-              <a:rPr lang="en-US" sz="1200" dirty="0">
-                <a:solidFill>
-                  <a:srgbClr val="52514E"/>
-                </a:solidFill>
-              </a:rPr>
-              <a:t>support assemblies in one 200,000 sq ft hospital</a:t>
-            </a:r>
-            <a:endParaRPr lang="en-US" sz="1200" dirty="0"/>
-          </a:p>
-        </p:txBody>
-      </p:sp>
-      <p:sp>
-        <p:nvSpPr>
-          <p:cNvPr id="6" name="tile to design each one by hand, from the coordinated model"/>
-          <p:cNvSpPr/>
-          <p:nvPr/>
-        </p:nvSpPr>
-        <p:spPr>
-          <a:xfrm>
-            <a:off x="548640" y="2926080"/>
-            <a:ext cx="3566160" cy="1371600"/>
-          </a:xfrm>
-          <a:prstGeom prst="roundRect">
-            <a:avLst>
-              <a:gd name="adj" fmla="val 4667"/>
-            </a:avLst>
-          </a:prstGeom>
-          <a:solidFill>
-            <a:schemeClr val="bg2"/>
-          </a:solidFill>
-          <a:ln/>
-        </p:spPr>
-      </p:sp>
-      <p:sp>
-        <p:nvSpPr>
-          <p:cNvPr id="7" name="value to design each one by hand, from the coordinated model"/>
-          <p:cNvSpPr txBox="1"/>
-          <p:nvPr/>
-        </p:nvSpPr>
-        <p:spPr>
-          <a:xfrm>
-            <a:off x="749808" y="3017520"/>
-            <a:ext cx="3163824" cy="685800"/>
-          </a:xfrm>
-          <a:prstGeom prst="rect">
-            <a:avLst/>
-          </a:prstGeom>
-          <a:noFill/>
-          <a:ln/>
-        </p:spPr>
-        <p:txBody>
-          <a:bodyPr wrap="square" lIns="0" tIns="0" rIns="0" bIns="0" rtlCol="0" anchor="ctr"/>
-          <a:lstStyle/>
-          <a:p>
-            <a:pPr indent="0" marL="0">
-              <a:buNone/>
-            </a:pPr>
-            <a:r>
-              <a:rPr lang="en-US" sz="3200" b="1" dirty="0">
-                <a:solidFill>
-                  <a:schemeClr val="accent1"/>
-                </a:solidFill>
-              </a:rPr>
-              <a:t>20 min – 2 h</a:t>
-            </a:r>
-            <a:endParaRPr lang="en-US" sz="3200" dirty="0"/>
-          </a:p>
-        </p:txBody>
-      </p:sp>
-      <p:sp>
-        <p:nvSpPr>
-          <p:cNvPr id="8" name="label to design each one by hand, from the coordinated model"/>
-          <p:cNvSpPr txBox="1"/>
-          <p:nvPr/>
-        </p:nvSpPr>
-        <p:spPr>
-          <a:xfrm>
-            <a:off x="749808" y="3721608"/>
-            <a:ext cx="3163824" cy="521208"/>
-          </a:xfrm>
-          <a:prstGeom prst="rect">
-            <a:avLst/>
-          </a:prstGeom>
-          <a:noFill/>
-          <a:ln/>
-        </p:spPr>
-        <p:txBody>
-          <a:bodyPr wrap="square" lIns="0" tIns="0" rIns="0" bIns="0" rtlCol="0" anchor="t"/>
-          <a:lstStyle/>
-          <a:p>
-            <a:pPr indent="0" marL="0">
-              <a:buNone/>
-            </a:pPr>
-            <a:r>
-              <a:rPr lang="en-US" sz="1200" dirty="0">
-                <a:solidFill>
-                  <a:srgbClr val="52514E"/>
-                </a:solidFill>
-              </a:rPr>
-              <a:t>to design each one by hand, from the coordinated model</a:t>
-            </a:r>
-            <a:endParaRPr lang="en-US" sz="1200" dirty="0"/>
-          </a:p>
-        </p:txBody>
-      </p:sp>
-      <p:sp>
-        <p:nvSpPr>
-          <p:cNvPr id="9" name="tile of all MEP design effort; on the order of $600K of engineering per project"/>
-          <p:cNvSpPr/>
-          <p:nvPr/>
-        </p:nvSpPr>
-        <p:spPr>
-          <a:xfrm>
-            <a:off x="548640" y="4434840"/>
-            <a:ext cx="3566160" cy="1371600"/>
-          </a:xfrm>
-          <a:prstGeom prst="roundRect">
-            <a:avLst>
-              <a:gd name="adj" fmla="val 4667"/>
-            </a:avLst>
-          </a:prstGeom>
-          <a:solidFill>
-            <a:schemeClr val="bg2"/>
-          </a:solidFill>
-          <a:ln/>
-        </p:spPr>
-      </p:sp>
-      <p:sp>
-        <p:nvSpPr>
-          <p:cNvPr id="10" name="value of all MEP design effort; on the order of $600K of engineering per project"/>
-          <p:cNvSpPr txBox="1"/>
-          <p:nvPr/>
-        </p:nvSpPr>
-        <p:spPr>
-          <a:xfrm>
-            <a:off x="749808" y="4526280"/>
-            <a:ext cx="3163824" cy="685800"/>
-          </a:xfrm>
-          <a:prstGeom prst="rect">
-            <a:avLst/>
-          </a:prstGeom>
-          <a:noFill/>
-          <a:ln/>
-        </p:spPr>
-        <p:txBody>
-          <a:bodyPr wrap="square" lIns="0" tIns="0" rIns="0" bIns="0" rtlCol="0" anchor="ctr"/>
-          <a:lstStyle/>
-          <a:p>
-            <a:pPr indent="0" marL="0">
-              <a:buNone/>
-            </a:pPr>
-            <a:r>
-              <a:rPr lang="en-US" sz="3200" b="1" dirty="0">
-                <a:solidFill>
-                  <a:schemeClr val="accent1"/>
-                </a:solidFill>
-              </a:rPr>
-              <a:t>≈ ¼</a:t>
-            </a:r>
-            <a:endParaRPr lang="en-US" sz="3200" dirty="0"/>
-          </a:p>
-        </p:txBody>
-      </p:sp>
-      <p:sp>
-        <p:nvSpPr>
-          <p:cNvPr id="11" name="label of all MEP design effort; on the order of $600K of engineering per project"/>
-          <p:cNvSpPr txBox="1"/>
-          <p:nvPr/>
-        </p:nvSpPr>
-        <p:spPr>
-          <a:xfrm>
-            <a:off x="749808" y="5230368"/>
-            <a:ext cx="3163824" cy="521208"/>
-          </a:xfrm>
-          <a:prstGeom prst="rect">
-            <a:avLst/>
-          </a:prstGeom>
-          <a:noFill/>
-          <a:ln/>
-        </p:spPr>
-        <p:txBody>
-          <a:bodyPr wrap="square" lIns="0" tIns="0" rIns="0" bIns="0" rtlCol="0" anchor="t"/>
-          <a:lstStyle/>
-          <a:p>
-            <a:pPr indent="0" marL="0">
-              <a:buNone/>
-            </a:pPr>
-            <a:r>
-              <a:rPr lang="en-US" sz="1200" dirty="0">
-                <a:solidFill>
-                  <a:srgbClr val="52514E"/>
-                </a:solidFill>
-              </a:rPr>
-              <a:t>of all MEP design effort; on the order of $600K of engineering per project</a:t>
-            </a:r>
-            <a:endParaRPr lang="en-US" sz="1200" dirty="0"/>
-          </a:p>
-        </p:txBody>
-      </p:sp>
-      <p:sp>
-        <p:nvSpPr>
-          <p:cNvPr id="12" name="estimates note"/>
-          <p:cNvSpPr txBox="1"/>
-          <p:nvPr/>
-        </p:nvSpPr>
-        <p:spPr>
-          <a:xfrm>
-            <a:off x="548640" y="5897880"/>
-            <a:ext cx="3566160" cy="274320"/>
-          </a:xfrm>
-          <a:prstGeom prst="rect">
-            <a:avLst/>
-          </a:prstGeom>
-          <a:noFill/>
-          <a:ln/>
-        </p:spPr>
-        <p:txBody>
-          <a:bodyPr wrap="square" lIns="0" tIns="0" rIns="0" bIns="0" rtlCol="0" anchor="t"/>
-          <a:lstStyle/>
-          <a:p>
-            <a:pPr indent="0" marL="0">
-              <a:buNone/>
-            </a:pPr>
-            <a:r>
-              <a:rPr lang="en-US" sz="1100" dirty="0">
-                <a:solidFill>
-                  <a:srgbClr val="52514E"/>
-                </a:solidFill>
-              </a:rPr>
-              <a:t>Approximate practitioner estimates.</a:t>
-            </a:r>
-            <a:endParaRPr lang="en-US" sz="1100" dirty="0"/>
-          </a:p>
-        </p:txBody>
-      </p:sp>
-      <p:pic>
-        <p:nvPicPr>
-          <p:cNvPr id="13" name="route to section" descr="/home/user/crossmep_dataset/docs/figures/paper_fig1_route_to_section.png">    </p:cNvPr>
-          <p:cNvPicPr>
-            <a:picLocks noChangeAspect="1"/>
-          </p:cNvPicPr>
-          <p:nvPr/>
-        </p:nvPicPr>
-        <p:blipFill>
-          <a:blip r:embed="rId1"/>
-          <a:stretch>
-            <a:fillRect/>
-          </a:stretch>
-        </p:blipFill>
-        <p:spPr>
-          <a:xfrm>
-            <a:off x="4480560" y="1525290"/>
-            <a:ext cx="7159752" cy="1978621"/>
-          </a:xfrm>
-          <a:prstGeom prst="rect">
-            <a:avLst/>
-          </a:prstGeom>
-        </p:spPr>
-      </p:pic>
-      <p:sp>
-        <p:nvSpPr>
-          <p:cNvPr id="14" name="fig1 caption"/>
-          <p:cNvSpPr txBox="1"/>
-          <p:nvPr/>
-        </p:nvSpPr>
-        <p:spPr>
-          <a:xfrm>
-            <a:off x="4480560" y="3641070"/>
-            <a:ext cx="7159752" cy="685800"/>
-          </a:xfrm>
-          <a:prstGeom prst="rect">
-            <a:avLst/>
-          </a:prstGeom>
-          <a:noFill/>
-          <a:ln/>
-        </p:spPr>
-        <p:txBody>
-          <a:bodyPr wrap="square" lIns="0" tIns="0" rIns="0" bIns="0" rtlCol="0" anchor="t"/>
-          <a:lstStyle/>
-          <a:p>
-            <a:pPr indent="0" marL="0">
-              <a:buNone/>
-            </a:pPr>
-            <a:r>
-              <a:rPr lang="en-US" sz="1100" dirty="0">
-                <a:solidFill>
-                  <a:srgbClr val="52514E"/>
-                </a:solidFill>
-              </a:rPr>
-              <a:t>Support design starts after coordination. At each hanger location the designer works from the section across the run: what passes, how big, how heavy, how far apart, what it hangs from.</a:t>
-            </a:r>
-            <a:endParaRPr lang="en-US" sz="1100" dirty="0"/>
-          </a:p>
-        </p:txBody>
-      </p:sp>
-      <p:sp>
-        <p:nvSpPr>
-          <p:cNvPr id="15" name="quote card"/>
-          <p:cNvSpPr/>
-          <p:nvPr/>
-        </p:nvSpPr>
-        <p:spPr>
-          <a:xfrm>
-            <a:off x="4480560" y="4434840"/>
-            <a:ext cx="7159752" cy="1371600"/>
-          </a:xfrm>
-          <a:prstGeom prst="roundRect">
-            <a:avLst>
-              <a:gd name="adj" fmla="val 4667"/>
-            </a:avLst>
-          </a:prstGeom>
-          <a:solidFill>
-            <a:schemeClr val="bg2"/>
-          </a:solidFill>
-          <a:ln/>
-        </p:spPr>
-      </p:sp>
-      <p:sp>
-        <p:nvSpPr>
-          <p:cNvPr id="16" name="quote"/>
-          <p:cNvSpPr txBox="1"/>
-          <p:nvPr/>
-        </p:nvSpPr>
-        <p:spPr>
-          <a:xfrm>
-            <a:off x="4754880" y="4572000"/>
-            <a:ext cx="6611112" cy="1097280"/>
-          </a:xfrm>
-          <a:prstGeom prst="rect">
-            <a:avLst/>
-          </a:prstGeom>
-          <a:noFill/>
-          <a:ln/>
-        </p:spPr>
-        <p:txBody>
-          <a:bodyPr wrap="square" lIns="0" tIns="0" rIns="0" bIns="0" rtlCol="0" anchor="ctr"/>
-          <a:lstStyle/>
-          <a:p>
-            <a:pPr indent="0" marL="0">
-              <a:buNone/>
-            </a:pPr>
-            <a:r>
-              <a:rPr lang="en-US" sz="1500" i="1" dirty="0">
-                <a:solidFill>
-                  <a:schemeClr val="tx1"/>
-                </a:solidFill>
-              </a:rPr>
-              <a:t>Nobody designs a support from the whole model; it is designed from the section at that hanger.</a:t>
-            </a:r>
-            <a:endParaRPr lang="en-US" sz="1500" dirty="0"/>
-          </a:p>
-          <a:p>
-            <a:pPr indent="0" marL="0">
-              <a:buNone/>
-            </a:pPr>
-            <a:r>
-              <a:rPr lang="en-US" sz="1500" b="1" dirty="0">
-                <a:solidFill>
-                  <a:schemeClr val="tx1"/>
-                </a:solidFill>
-              </a:rPr>
-              <a:t>That section is the unit of work — and the unit of CrossMEP.</a:t>
-            </a:r>
-            <a:endParaRPr lang="en-US" sz="1500" dirty="0"/>
-          </a:p>
-        </p:txBody>
-      </p:sp>
-      <p:sp>
-        <p:nvSpPr>
-          <p:cNvPr id="25" name="Slide Number Placeholder 0"/>
-          <p:cNvSpPr>
-            <a:spLocks noGrp="1"/>
-          </p:cNvSpPr>
-          <p:nvPr>
-            <p:ph type="sldNum" sz="quarter" idx="4294967295"/>
-          </p:nvPr>
-        </p:nvSpPr>
-        <p:spPr>
-          <a:xfrm>
-            <a:off x="11064240" y="6419088"/>
-            <a:ext cx="594360" cy="274320"/>
-          </a:xfrm>
-          <a:prstGeom prst="rect">
-            <a:avLst/>
-          </a:prstGeom>
-          <a:extLst>
-            <a:ext uri="{C572A759-6A51-4108-AA02-DFA0A04FC94B}">
-              <ma14:wrappingTextBoxFlag xmlns:ma14="http://schemas.microsoft.com/office/mac/drawingml/2011/main" val="0"/>
-            </a:ext>
-          </a:extLst>
-        </p:spPr>
-        <p:txBody>
-          <a:bodyPr/>
-          <a:lstStyle>
-            <a:lvl1pPr>
-              <a:defRPr sz="900">
-                <a:solidFill>
-                  <a:srgbClr val="898781"/>
-                </a:solidFill>
-              </a:defRPr>
-            </a:lvl1pPr>
-          </a:lstStyle>
-          <a:p>
-            <a:pPr algn="r"/>
-            <a:fld id="{F7021451-1387-4CA6-816F-3879F97B5CBC}" type="slidenum">
-              <a:rPr b="0" lang="en-US"/>
-              <a:t>2</a:t>
-            </a:fld>
-            <a:endParaRPr lang="en-US"/>
-          </a:p>
-        </p:txBody>
-      </p:sp>
-    </p:spTree>
-  </p:cSld>
-  <p:clrMapOvr>
-    <a:masterClrMapping/>
-  </p:clrMapOvr>
-</p:sld>
-</file>
-
-<file path=ppt/slides/slide20.xml><?xml version="1.0" encoding="utf-8"?>
-<p:sld xmlns:a="http://schemas.openxmlformats.org/drawingml/2006/main" xmlns:r="http://schemas.openxmlformats.org/officeDocument/2006/relationships" xmlns:p="http://schemas.openxmlformats.org/presentationml/2006/main">
-  <p:cSld name="Slide 20">
+  <p:cSld name="Slide 21">
     <p:spTree>
       <p:nvGrpSpPr>
         <p:cNvPr id="1" name=""/>
@@ -20173,7 +20473,7 @@
             <a:pPr algn="r"/>
             <a:fld id="{F7021451-1387-4CA6-816F-3879F97B5CBC}" type="slidenum">
               <a:rPr b="0" lang="en-US"/>
-              <a:t>20</a:t>
+              <a:t>21</a:t>
             </a:fld>
             <a:endParaRPr lang="en-US"/>
           </a:p>
@@ -20190,6 +20490,620 @@
 <file path=ppt/slides/slide3.xml><?xml version="1.0" encoding="utf-8"?>
 <p:sld xmlns:a="http://schemas.openxmlformats.org/drawingml/2006/main" xmlns:r="http://schemas.openxmlformats.org/officeDocument/2006/relationships" xmlns:p="http://schemas.openxmlformats.org/presentationml/2006/main">
   <p:cSld name="Slide 3">
+    <p:spTree>
+      <p:nvGrpSpPr>
+        <p:cNvPr id="1" name=""/>
+        <p:cNvGrpSpPr/>
+        <p:nvPr/>
+      </p:nvGrpSpPr>
+      <p:grpSpPr>
+        <a:xfrm>
+          <a:off x="0" y="0"/>
+          <a:ext cx="0" cy="0"/>
+          <a:chOff x="0" y="0"/>
+          <a:chExt cx="0" cy="0"/>
+        </a:xfrm>
+      </p:grpSpPr>
+      <p:sp>
+        <p:nvSpPr>
+          <p:cNvPr id="2" name="Text 0"/>
+          <p:cNvSpPr/>
+          <p:nvPr>
+            <p:ph idx="100" type="title" hasCustomPrompt="1"/>
+          </p:nvPr>
+        </p:nvSpPr>
+        <p:spPr>
+          <a:xfrm>
+            <a:off x="548640" y="274320"/>
+            <a:ext cx="11091672" cy="960120"/>
+          </a:xfrm>
+          <a:prstGeom prst="rect">
+            <a:avLst/>
+          </a:prstGeom>
+          <a:noFill/>
+          <a:ln/>
+        </p:spPr>
+        <p:txBody>
+          <a:bodyPr wrap="square" lIns="0" tIns="0" rIns="0" bIns="0" rtlCol="0" anchor="ctr"/>
+          <a:lstStyle/>
+          <a:p>
+            <a:pPr algn="l" indent="0" marL="0">
+              <a:buNone/>
+            </a:pPr>
+            <a:r>
+              <a:rPr lang="en-US" sz="2600" b="1" dirty="0">
+                <a:solidFill>
+                  <a:schemeClr val="tx1"/>
+                </a:solidFill>
+              </a:rPr>
+              <a:t>Synthesizing an assembly from a catalog and a section has resisted automation</a:t>
+            </a:r>
+            <a:endParaRPr lang="en-US" sz="2600" dirty="0"/>
+          </a:p>
+        </p:txBody>
+      </p:sp>
+      <p:sp>
+        <p:nvSpPr>
+          <p:cNvPr id="3" name="problem card"/>
+          <p:cNvSpPr/>
+          <p:nvPr/>
+        </p:nvSpPr>
+        <p:spPr>
+          <a:xfrm>
+            <a:off x="548640" y="1371600"/>
+            <a:ext cx="5212080" cy="2606040"/>
+          </a:xfrm>
+          <a:prstGeom prst="roundRect">
+            <a:avLst>
+              <a:gd name="adj" fmla="val 2456"/>
+            </a:avLst>
+          </a:prstGeom>
+          <a:solidFill>
+            <a:schemeClr val="bg2"/>
+          </a:solidFill>
+          <a:ln/>
+        </p:spPr>
+      </p:sp>
+      <p:sp>
+        <p:nvSpPr>
+          <p:cNvPr id="4" name="problem"/>
+          <p:cNvSpPr txBox="1"/>
+          <p:nvPr/>
+        </p:nvSpPr>
+        <p:spPr>
+          <a:xfrm>
+            <a:off x="777240" y="1508760"/>
+            <a:ext cx="4754880" cy="2377440"/>
+          </a:xfrm>
+          <a:prstGeom prst="rect">
+            <a:avLst/>
+          </a:prstGeom>
+          <a:noFill/>
+          <a:ln/>
+        </p:spPr>
+        <p:txBody>
+          <a:bodyPr wrap="square" lIns="0" tIns="0" rIns="0" bIns="0" rtlCol="0" anchor="t"/>
+          <a:lstStyle/>
+          <a:p>
+            <a:pPr indent="0" marL="0">
+              <a:buNone/>
+            </a:pPr>
+            <a:r>
+              <a:rPr lang="en-US" sz="1700" b="1" dirty="0">
+                <a:solidFill>
+                  <a:schemeClr val="tx1"/>
+                </a:solidFill>
+              </a:rPr>
+              <a:t>The synthesis problem</a:t>
+            </a:r>
+            <a:endParaRPr lang="en-US" sz="1500" dirty="0"/>
+          </a:p>
+          <a:p>
+            <a:pPr indent="0" marL="0">
+              <a:buNone/>
+            </a:pPr>
+            <a:r>
+              <a:rPr lang="en-US" sz="600" dirty="0">
+                <a:solidFill>
+                  <a:schemeClr val="tx1"/>
+                </a:solidFill>
+              </a:rPr>
+              <a:t> </a:t>
+            </a:r>
+            <a:endParaRPr lang="en-US" sz="1500" dirty="0"/>
+          </a:p>
+          <a:p>
+            <a:pPr indent="0" marL="0">
+              <a:buNone/>
+            </a:pPr>
+            <a:r>
+              <a:rPr lang="en-US" sz="1500" b="1" dirty="0">
+                <a:solidFill>
+                  <a:schemeClr val="tx1"/>
+                </a:solidFill>
+              </a:rPr>
+              <a:t>Given </a:t>
+            </a:r>
+            <a:pPr indent="0" marL="0">
+              <a:buNone/>
+            </a:pPr>
+            <a:r>
+              <a:rPr lang="en-US" sz="1500" dirty="0">
+                <a:solidFill>
+                  <a:schemeClr val="tx1"/>
+                </a:solidFill>
+              </a:rPr>
+              <a:t>a fixed catalog of components and the MEP context: the services crossing the hanger and the surface they hang from.</a:t>
+            </a:r>
+            <a:endParaRPr lang="en-US" sz="1500" dirty="0"/>
+          </a:p>
+          <a:p>
+            <a:pPr indent="0" marL="0">
+              <a:buNone/>
+            </a:pPr>
+            <a:r>
+              <a:rPr lang="en-US" sz="600" dirty="0">
+                <a:solidFill>
+                  <a:schemeClr val="tx1"/>
+                </a:solidFill>
+              </a:rPr>
+              <a:t> </a:t>
+            </a:r>
+            <a:endParaRPr lang="en-US" sz="1500" dirty="0"/>
+          </a:p>
+          <a:p>
+            <a:pPr indent="0" marL="0">
+              <a:buNone/>
+            </a:pPr>
+            <a:r>
+              <a:rPr lang="en-US" sz="1500" b="1" dirty="0">
+                <a:solidFill>
+                  <a:schemeClr val="tx1"/>
+                </a:solidFill>
+              </a:rPr>
+              <a:t>Find </a:t>
+            </a:r>
+            <a:pPr indent="0" marL="0">
+              <a:buNone/>
+            </a:pPr>
+            <a:r>
+              <a:rPr lang="en-US" sz="1500" dirty="0">
+                <a:solidFill>
+                  <a:schemeClr val="tx1"/>
+                </a:solidFill>
+              </a:rPr>
+              <a:t>a feasible assembly that carries the services to the structure.</a:t>
+            </a:r>
+            <a:endParaRPr lang="en-US" sz="1500" dirty="0"/>
+          </a:p>
+          <a:p>
+            <a:pPr indent="0" marL="0">
+              <a:buNone/>
+            </a:pPr>
+            <a:r>
+              <a:rPr lang="en-US" sz="600" dirty="0">
+                <a:solidFill>
+                  <a:schemeClr val="tx1"/>
+                </a:solidFill>
+              </a:rPr>
+              <a:t> </a:t>
+            </a:r>
+            <a:endParaRPr lang="en-US" sz="1500" dirty="0"/>
+          </a:p>
+          <a:p>
+            <a:pPr indent="0" marL="0">
+              <a:buNone/>
+            </a:pPr>
+            <a:r>
+              <a:rPr lang="en-US" sz="1500" i="1" dirty="0">
+                <a:solidFill>
+                  <a:schemeClr val="tx1"/>
+                </a:solidFill>
+              </a:rPr>
+              <a:t>Tools coordinate the model and check a design; choosing the topology and the parts is still done by hand.</a:t>
+            </a:r>
+            <a:endParaRPr lang="en-US" sz="1500" dirty="0"/>
+          </a:p>
+        </p:txBody>
+      </p:sp>
+      <p:pic>
+        <p:nvPicPr>
+          <p:cNvPr id="5" name="route to section" descr="/home/user/crossmep_dataset/docs/figures/paper_fig1_route_to_section.png">    </p:cNvPr>
+          <p:cNvPicPr>
+            <a:picLocks noChangeAspect="1"/>
+          </p:cNvPicPr>
+          <p:nvPr/>
+        </p:nvPicPr>
+        <p:blipFill>
+          <a:blip r:embed="rId1"/>
+          <a:stretch>
+            <a:fillRect/>
+          </a:stretch>
+        </p:blipFill>
+        <p:spPr>
+          <a:xfrm>
+            <a:off x="5989320" y="1642325"/>
+            <a:ext cx="5650992" cy="1561670"/>
+          </a:xfrm>
+          <a:prstGeom prst="rect">
+            <a:avLst/>
+          </a:prstGeom>
+        </p:spPr>
+      </p:pic>
+      <p:sp>
+        <p:nvSpPr>
+          <p:cNvPr id="6" name="fig1 caption"/>
+          <p:cNvSpPr txBox="1"/>
+          <p:nvPr/>
+        </p:nvSpPr>
+        <p:spPr>
+          <a:xfrm>
+            <a:off x="5989320" y="3295435"/>
+            <a:ext cx="5650992" cy="457200"/>
+          </a:xfrm>
+          <a:prstGeom prst="rect">
+            <a:avLst/>
+          </a:prstGeom>
+          <a:noFill/>
+          <a:ln/>
+        </p:spPr>
+        <p:txBody>
+          <a:bodyPr wrap="square" lIns="0" tIns="0" rIns="0" bIns="0" rtlCol="0" anchor="t"/>
+          <a:lstStyle/>
+          <a:p>
+            <a:pPr indent="0" marL="0">
+              <a:buNone/>
+            </a:pPr>
+            <a:r>
+              <a:rPr lang="en-US" sz="1100" dirty="0">
+                <a:solidFill>
+                  <a:srgbClr val="52514E"/>
+                </a:solidFill>
+              </a:rPr>
+              <a:t>Design starts after coordination: at each hanger the designer works from the section across the run, not from the whole model.</a:t>
+            </a:r>
+            <a:endParaRPr lang="en-US" sz="1100" dirty="0"/>
+          </a:p>
+        </p:txBody>
+      </p:sp>
+      <p:sp>
+        <p:nvSpPr>
+          <p:cNvPr id="7" name="why Geometric judgment"/>
+          <p:cNvSpPr/>
+          <p:nvPr/>
+        </p:nvSpPr>
+        <p:spPr>
+          <a:xfrm>
+            <a:off x="548640" y="4251960"/>
+            <a:ext cx="3575304" cy="1463040"/>
+          </a:xfrm>
+          <a:prstGeom prst="roundRect">
+            <a:avLst>
+              <a:gd name="adj" fmla="val 4375"/>
+            </a:avLst>
+          </a:prstGeom>
+          <a:solidFill>
+            <a:schemeClr val="bg2"/>
+          </a:solidFill>
+          <a:ln/>
+        </p:spPr>
+      </p:sp>
+      <p:sp>
+        <p:nvSpPr>
+          <p:cNvPr id="8" name="why head Geometric judgment"/>
+          <p:cNvSpPr txBox="1"/>
+          <p:nvPr/>
+        </p:nvSpPr>
+        <p:spPr>
+          <a:xfrm>
+            <a:off x="777240" y="4389120"/>
+            <a:ext cx="3118104" cy="384048"/>
+          </a:xfrm>
+          <a:prstGeom prst="rect">
+            <a:avLst/>
+          </a:prstGeom>
+          <a:noFill/>
+          <a:ln/>
+        </p:spPr>
+        <p:txBody>
+          <a:bodyPr wrap="square" lIns="0" tIns="0" rIns="0" bIns="0" rtlCol="0" anchor="ctr"/>
+          <a:lstStyle/>
+          <a:p>
+            <a:pPr indent="0" marL="0">
+              <a:buNone/>
+            </a:pPr>
+            <a:r>
+              <a:rPr lang="en-US" sz="1700" b="1" dirty="0">
+                <a:solidFill>
+                  <a:schemeClr val="accent1"/>
+                </a:solidFill>
+              </a:rPr>
+              <a:t>1. Geometric judgment</a:t>
+            </a:r>
+            <a:endParaRPr lang="en-US" sz="1700" dirty="0"/>
+          </a:p>
+        </p:txBody>
+      </p:sp>
+      <p:sp>
+        <p:nvSpPr>
+          <p:cNvPr id="9" name="why text Geometric judgment"/>
+          <p:cNvSpPr txBox="1"/>
+          <p:nvPr/>
+        </p:nvSpPr>
+        <p:spPr>
+          <a:xfrm>
+            <a:off x="777240" y="4828032"/>
+            <a:ext cx="3118104" cy="822960"/>
+          </a:xfrm>
+          <a:prstGeom prst="rect">
+            <a:avLst/>
+          </a:prstGeom>
+          <a:noFill/>
+          <a:ln/>
+        </p:spPr>
+        <p:txBody>
+          <a:bodyPr wrap="square" lIns="0" tIns="0" rIns="0" bIns="0" rtlCol="0" anchor="t"/>
+          <a:lstStyle/>
+          <a:p>
+            <a:pPr indent="0" marL="0">
+              <a:buNone/>
+            </a:pPr>
+            <a:r>
+              <a:rPr lang="en-US" sz="1500" dirty="0">
+                <a:solidFill>
+                  <a:schemeClr val="tx1"/>
+                </a:solidFill>
+              </a:rPr>
+              <a:t>Engineers choose an assembly’s topology from experience.</a:t>
+            </a:r>
+            <a:endParaRPr lang="en-US" sz="1500" dirty="0"/>
+          </a:p>
+        </p:txBody>
+      </p:sp>
+      <p:sp>
+        <p:nvSpPr>
+          <p:cNvPr id="10" name="why Rule explosion"/>
+          <p:cNvSpPr/>
+          <p:nvPr/>
+        </p:nvSpPr>
+        <p:spPr>
+          <a:xfrm>
+            <a:off x="4306824" y="4251960"/>
+            <a:ext cx="3575304" cy="1463040"/>
+          </a:xfrm>
+          <a:prstGeom prst="roundRect">
+            <a:avLst>
+              <a:gd name="adj" fmla="val 4375"/>
+            </a:avLst>
+          </a:prstGeom>
+          <a:solidFill>
+            <a:schemeClr val="bg2"/>
+          </a:solidFill>
+          <a:ln/>
+        </p:spPr>
+      </p:sp>
+      <p:sp>
+        <p:nvSpPr>
+          <p:cNvPr id="11" name="why head Rule explosion"/>
+          <p:cNvSpPr txBox="1"/>
+          <p:nvPr/>
+        </p:nvSpPr>
+        <p:spPr>
+          <a:xfrm>
+            <a:off x="4535424" y="4389120"/>
+            <a:ext cx="3118104" cy="384048"/>
+          </a:xfrm>
+          <a:prstGeom prst="rect">
+            <a:avLst/>
+          </a:prstGeom>
+          <a:noFill/>
+          <a:ln/>
+        </p:spPr>
+        <p:txBody>
+          <a:bodyPr wrap="square" lIns="0" tIns="0" rIns="0" bIns="0" rtlCol="0" anchor="ctr"/>
+          <a:lstStyle/>
+          <a:p>
+            <a:pPr indent="0" marL="0">
+              <a:buNone/>
+            </a:pPr>
+            <a:r>
+              <a:rPr lang="en-US" sz="1700" b="1" dirty="0">
+                <a:solidFill>
+                  <a:schemeClr val="accent1"/>
+                </a:solidFill>
+              </a:rPr>
+              <a:t>2. Rule explosion</a:t>
+            </a:r>
+            <a:endParaRPr lang="en-US" sz="1700" dirty="0"/>
+          </a:p>
+        </p:txBody>
+      </p:sp>
+      <p:sp>
+        <p:nvSpPr>
+          <p:cNvPr id="12" name="why text Rule explosion"/>
+          <p:cNvSpPr txBox="1"/>
+          <p:nvPr/>
+        </p:nvSpPr>
+        <p:spPr>
+          <a:xfrm>
+            <a:off x="4535424" y="4828032"/>
+            <a:ext cx="3118104" cy="822960"/>
+          </a:xfrm>
+          <a:prstGeom prst="rect">
+            <a:avLst/>
+          </a:prstGeom>
+          <a:noFill/>
+          <a:ln/>
+        </p:spPr>
+        <p:txBody>
+          <a:bodyPr wrap="square" lIns="0" tIns="0" rIns="0" bIns="0" rtlCol="0" anchor="t"/>
+          <a:lstStyle/>
+          <a:p>
+            <a:pPr indent="0" marL="0">
+              <a:buNone/>
+            </a:pPr>
+            <a:r>
+              <a:rPr lang="en-US" sz="1500" dirty="0">
+                <a:solidFill>
+                  <a:schemeClr val="tx1"/>
+                </a:solidFill>
+              </a:rPr>
+              <a:t>Code, load and material constraints interact across thousands of combinations.</a:t>
+            </a:r>
+            <a:endParaRPr lang="en-US" sz="1500" dirty="0"/>
+          </a:p>
+        </p:txBody>
+      </p:sp>
+      <p:sp>
+        <p:nvSpPr>
+          <p:cNvPr id="13" name="why Catalog volatility"/>
+          <p:cNvSpPr/>
+          <p:nvPr/>
+        </p:nvSpPr>
+        <p:spPr>
+          <a:xfrm>
+            <a:off x="8065008" y="4251960"/>
+            <a:ext cx="3575304" cy="1463040"/>
+          </a:xfrm>
+          <a:prstGeom prst="roundRect">
+            <a:avLst>
+              <a:gd name="adj" fmla="val 4375"/>
+            </a:avLst>
+          </a:prstGeom>
+          <a:solidFill>
+            <a:schemeClr val="bg2"/>
+          </a:solidFill>
+          <a:ln/>
+        </p:spPr>
+      </p:sp>
+      <p:sp>
+        <p:nvSpPr>
+          <p:cNvPr id="14" name="why head Catalog volatility"/>
+          <p:cNvSpPr txBox="1"/>
+          <p:nvPr/>
+        </p:nvSpPr>
+        <p:spPr>
+          <a:xfrm>
+            <a:off x="8293608" y="4389120"/>
+            <a:ext cx="3118104" cy="384048"/>
+          </a:xfrm>
+          <a:prstGeom prst="rect">
+            <a:avLst/>
+          </a:prstGeom>
+          <a:noFill/>
+          <a:ln/>
+        </p:spPr>
+        <p:txBody>
+          <a:bodyPr wrap="square" lIns="0" tIns="0" rIns="0" bIns="0" rtlCol="0" anchor="ctr"/>
+          <a:lstStyle/>
+          <a:p>
+            <a:pPr indent="0" marL="0">
+              <a:buNone/>
+            </a:pPr>
+            <a:r>
+              <a:rPr lang="en-US" sz="1700" b="1" dirty="0">
+                <a:solidFill>
+                  <a:schemeClr val="accent1"/>
+                </a:solidFill>
+              </a:rPr>
+              <a:t>3. Catalog volatility</a:t>
+            </a:r>
+            <a:endParaRPr lang="en-US" sz="1700" dirty="0"/>
+          </a:p>
+        </p:txBody>
+      </p:sp>
+      <p:sp>
+        <p:nvSpPr>
+          <p:cNvPr id="15" name="why text Catalog volatility"/>
+          <p:cNvSpPr txBox="1"/>
+          <p:nvPr/>
+        </p:nvSpPr>
+        <p:spPr>
+          <a:xfrm>
+            <a:off x="8293608" y="4828032"/>
+            <a:ext cx="3118104" cy="822960"/>
+          </a:xfrm>
+          <a:prstGeom prst="rect">
+            <a:avLst/>
+          </a:prstGeom>
+          <a:noFill/>
+          <a:ln/>
+        </p:spPr>
+        <p:txBody>
+          <a:bodyPr wrap="square" lIns="0" tIns="0" rIns="0" bIns="0" rtlCol="0" anchor="t"/>
+          <a:lstStyle/>
+          <a:p>
+            <a:pPr indent="0" marL="0">
+              <a:buNone/>
+            </a:pPr>
+            <a:r>
+              <a:rPr lang="en-US" sz="1500" dirty="0">
+                <a:solidFill>
+                  <a:schemeClr val="tx1"/>
+                </a:solidFill>
+              </a:rPr>
+              <a:t>Catalogs change faster than rule-based systems can be rewritten.</a:t>
+            </a:r>
+            <a:endParaRPr lang="en-US" sz="1500" dirty="0"/>
+          </a:p>
+        </p:txBody>
+      </p:sp>
+      <p:sp>
+        <p:nvSpPr>
+          <p:cNvPr id="25" name="Slide Number Placeholder 0"/>
+          <p:cNvSpPr>
+            <a:spLocks noGrp="1"/>
+          </p:cNvSpPr>
+          <p:nvPr>
+            <p:ph type="sldNum" sz="quarter" idx="4294967295"/>
+          </p:nvPr>
+        </p:nvSpPr>
+        <p:spPr>
+          <a:xfrm>
+            <a:off x="11064240" y="6419088"/>
+            <a:ext cx="594360" cy="274320"/>
+          </a:xfrm>
+          <a:prstGeom prst="rect">
+            <a:avLst/>
+          </a:prstGeom>
+          <a:extLst>
+            <a:ext uri="{C572A759-6A51-4108-AA02-DFA0A04FC94B}">
+              <ma14:wrappingTextBoxFlag xmlns:ma14="http://schemas.microsoft.com/office/mac/drawingml/2011/main" val="0"/>
+            </a:ext>
+          </a:extLst>
+        </p:spPr>
+        <p:txBody>
+          <a:bodyPr/>
+          <a:lstStyle>
+            <a:lvl1pPr>
+              <a:defRPr sz="900">
+                <a:solidFill>
+                  <a:srgbClr val="898781"/>
+                </a:solidFill>
+              </a:defRPr>
+            </a:lvl1pPr>
+          </a:lstStyle>
+          <a:p>
+            <a:pPr algn="r"/>
+            <a:fld id="{F7021451-1387-4CA6-816F-3879F97B5CBC}" type="slidenum">
+              <a:rPr b="0" lang="en-US"/>
+              <a:t>3</a:t>
+            </a:fld>
+            <a:endParaRPr lang="en-US"/>
+          </a:p>
+        </p:txBody>
+      </p:sp>
+    </p:spTree>
+  </p:cSld>
+  <p:clrMapOvr>
+    <a:masterClrMapping/>
+  </p:clrMapOvr>
+</p:sld>
+</file>
+
+<file path=ppt/slides/slide4.xml><?xml version="1.0" encoding="utf-8"?>
+<p:sld xmlns:a="http://schemas.openxmlformats.org/drawingml/2006/main" xmlns:r="http://schemas.openxmlformats.org/officeDocument/2006/relationships" xmlns:p="http://schemas.openxmlformats.org/presentationml/2006/main">
+  <p:cSld name="Slide 4">
     <p:spTree>
       <p:nvGrpSpPr>
         <p:cNvPr id="1" name=""/>
@@ -21265,7 +22179,7 @@
             <a:pPr algn="r"/>
             <a:fld id="{F7021451-1387-4CA6-816F-3879F97B5CBC}" type="slidenum">
               <a:rPr b="0" lang="en-US"/>
-              <a:t>3</a:t>
+              <a:t>4</a:t>
             </a:fld>
             <a:endParaRPr lang="en-US"/>
           </a:p>
@@ -21279,9 +22193,9 @@
 </p:sld>
 </file>
 
-<file path=ppt/slides/slide4.xml><?xml version="1.0" encoding="utf-8"?>
+<file path=ppt/slides/slide5.xml><?xml version="1.0" encoding="utf-8"?>
 <p:sld xmlns:a="http://schemas.openxmlformats.org/drawingml/2006/main" xmlns:r="http://schemas.openxmlformats.org/officeDocument/2006/relationships" xmlns:p="http://schemas.openxmlformats.org/presentationml/2006/main">
-  <p:cSld name="Slide 4">
+  <p:cSld name="Slide 5">
     <p:spTree>
       <p:nvGrpSpPr>
         <p:cNvPr id="1" name=""/>
@@ -21433,7 +22347,7 @@
             <a:pPr algn="r"/>
             <a:fld id="{F7021451-1387-4CA6-816F-3879F97B5CBC}" type="slidenum">
               <a:rPr b="0" lang="en-US"/>
-              <a:t>4</a:t>
+              <a:t>5</a:t>
             </a:fld>
             <a:endParaRPr lang="en-US"/>
           </a:p>
@@ -21447,9 +22361,9 @@
 </p:sld>
 </file>
 
-<file path=ppt/slides/slide5.xml><?xml version="1.0" encoding="utf-8"?>
+<file path=ppt/slides/slide6.xml><?xml version="1.0" encoding="utf-8"?>
 <p:sld xmlns:a="http://schemas.openxmlformats.org/drawingml/2006/main" xmlns:r="http://schemas.openxmlformats.org/officeDocument/2006/relationships" xmlns:p="http://schemas.openxmlformats.org/presentationml/2006/main">
-  <p:cSld name="Slide 5">
+  <p:cSld name="Slide 6">
     <p:spTree>
       <p:nvGrpSpPr>
         <p:cNvPr id="1" name=""/>
@@ -22219,7 +23133,7 @@
             <a:pPr algn="r"/>
             <a:fld id="{F7021451-1387-4CA6-816F-3879F97B5CBC}" type="slidenum">
               <a:rPr b="0" lang="en-US"/>
-              <a:t>5</a:t>
+              <a:t>6</a:t>
             </a:fld>
             <a:endParaRPr lang="en-US"/>
           </a:p>
@@ -22233,9 +23147,9 @@
 </p:sld>
 </file>
 
-<file path=ppt/slides/slide6.xml><?xml version="1.0" encoding="utf-8"?>
+<file path=ppt/slides/slide7.xml><?xml version="1.0" encoding="utf-8"?>
 <p:sld xmlns:a="http://schemas.openxmlformats.org/drawingml/2006/main" xmlns:r="http://schemas.openxmlformats.org/officeDocument/2006/relationships" xmlns:p="http://schemas.openxmlformats.org/presentationml/2006/main">
-  <p:cSld name="Slide 6">
+  <p:cSld name="Slide 7">
     <p:spTree>
       <p:nvGrpSpPr>
         <p:cNvPr id="1" name=""/>
@@ -22290,7 +23204,7 @@
       </p:sp>
       <p:graphicFrame>
         <p:nvGraphicFramePr>
-          <p:cNvPr id="7" name="sources table"/>
+          <p:cNvPr id="8" name="sources table"/>
           <p:cNvGraphicFramePr>
             <a:graphicFrameLocks noGrp="1"/>
           </p:cNvGraphicFramePr>
@@ -23755,7 +24669,7 @@
             <a:pPr algn="r"/>
             <a:fld id="{F7021451-1387-4CA6-816F-3879F97B5CBC}" type="slidenum">
               <a:rPr b="0" lang="en-US"/>
-              <a:t>6</a:t>
+              <a:t>7</a:t>
             </a:fld>
             <a:endParaRPr lang="en-US"/>
           </a:p>
@@ -23769,9 +24683,9 @@
 </p:sld>
 </file>
 
-<file path=ppt/slides/slide7.xml><?xml version="1.0" encoding="utf-8"?>
+<file path=ppt/slides/slide8.xml><?xml version="1.0" encoding="utf-8"?>
 <p:sld xmlns:a="http://schemas.openxmlformats.org/drawingml/2006/main" xmlns:r="http://schemas.openxmlformats.org/officeDocument/2006/relationships" xmlns:p="http://schemas.openxmlformats.org/presentationml/2006/main">
-  <p:cSld name="Slide 7">
+  <p:cSld name="Slide 8">
     <p:spTree>
       <p:nvGrpSpPr>
         <p:cNvPr id="1" name=""/>
@@ -23826,7 +24740,7 @@
       </p:sp>
       <p:graphicFrame>
         <p:nvGraphicFramePr>
-          <p:cNvPr id="8" name="splits table"/>
+          <p:cNvPr id="9" name="splits table"/>
           <p:cNvGraphicFramePr>
             <a:graphicFrameLocks noGrp="1"/>
           </p:cNvGraphicFramePr>
@@ -25594,7 +26508,7 @@
             <a:pPr algn="r"/>
             <a:fld id="{F7021451-1387-4CA6-816F-3879F97B5CBC}" type="slidenum">
               <a:rPr b="0" lang="en-US"/>
-              <a:t>7</a:t>
+              <a:t>8</a:t>
             </a:fld>
             <a:endParaRPr lang="en-US"/>
           </a:p>
@@ -25608,9 +26522,9 @@
 </p:sld>
 </file>
 
-<file path=ppt/slides/slide8.xml><?xml version="1.0" encoding="utf-8"?>
+<file path=ppt/slides/slide9.xml><?xml version="1.0" encoding="utf-8"?>
 <p:sld xmlns:a="http://schemas.openxmlformats.org/drawingml/2006/main" xmlns:r="http://schemas.openxmlformats.org/officeDocument/2006/relationships" xmlns:p="http://schemas.openxmlformats.org/presentationml/2006/main">
-  <p:cSld name="Slide 8">
+  <p:cSld name="Slide 9">
     <p:spTree>
       <p:nvGrpSpPr>
         <p:cNvPr id="1" name=""/>
@@ -25762,174 +26676,6 @@
             <a:pPr algn="r"/>
             <a:fld id="{F7021451-1387-4CA6-816F-3879F97B5CBC}" type="slidenum">
               <a:rPr b="0" lang="en-US"/>
-              <a:t>8</a:t>
-            </a:fld>
-            <a:endParaRPr lang="en-US"/>
-          </a:p>
-        </p:txBody>
-      </p:sp>
-    </p:spTree>
-  </p:cSld>
-  <p:clrMapOvr>
-    <a:masterClrMapping/>
-  </p:clrMapOvr>
-</p:sld>
-</file>
-
-<file path=ppt/slides/slide9.xml><?xml version="1.0" encoding="utf-8"?>
-<p:sld xmlns:a="http://schemas.openxmlformats.org/drawingml/2006/main" xmlns:r="http://schemas.openxmlformats.org/officeDocument/2006/relationships" xmlns:p="http://schemas.openxmlformats.org/presentationml/2006/main">
-  <p:cSld name="Slide 9">
-    <p:spTree>
-      <p:nvGrpSpPr>
-        <p:cNvPr id="1" name=""/>
-        <p:cNvGrpSpPr/>
-        <p:nvPr/>
-      </p:nvGrpSpPr>
-      <p:grpSpPr>
-        <a:xfrm>
-          <a:off x="0" y="0"/>
-          <a:ext cx="0" cy="0"/>
-          <a:chOff x="0" y="0"/>
-          <a:chExt cx="0" cy="0"/>
-        </a:xfrm>
-      </p:grpSpPr>
-      <p:sp>
-        <p:nvSpPr>
-          <p:cNvPr id="2" name="Text 0"/>
-          <p:cNvSpPr/>
-          <p:nvPr>
-            <p:ph idx="100" type="title" hasCustomPrompt="1"/>
-          </p:nvPr>
-        </p:nvSpPr>
-        <p:spPr>
-          <a:xfrm>
-            <a:off x="548640" y="274320"/>
-            <a:ext cx="11091672" cy="960120"/>
-          </a:xfrm>
-          <a:prstGeom prst="rect">
-            <a:avLst/>
-          </a:prstGeom>
-          <a:noFill/>
-          <a:ln/>
-        </p:spPr>
-        <p:txBody>
-          <a:bodyPr wrap="square" lIns="0" tIns="0" rIns="0" bIns="0" rtlCol="0" anchor="ctr"/>
-          <a:lstStyle/>
-          <a:p>
-            <a:pPr algn="l" indent="0" marL="0">
-              <a:buNone/>
-            </a:pPr>
-            <a:r>
-              <a:rPr lang="en-US" sz="2600" b="1" dirty="0">
-                <a:solidFill>
-                  <a:schemeClr val="tx1"/>
-                </a:solidFill>
-              </a:rPr>
-              <a:t>Higher tiers are heavier and, overall, tighter, as designed</a:t>
-            </a:r>
-            <a:endParaRPr lang="en-US" sz="2600" dirty="0"/>
-          </a:p>
-        </p:txBody>
-      </p:sp>
-      <p:pic>
-        <p:nvPicPr>
-          <p:cNvPr id="3" name="tier statistics" descr="preencoded.png">    </p:cNvPr>
-          <p:cNvPicPr>
-            <a:picLocks noChangeAspect="1"/>
-          </p:cNvPicPr>
-          <p:nvPr/>
-        </p:nvPicPr>
-        <p:blipFill>
-          <a:blip r:embed="rId1"/>
-          <a:stretch>
-            <a:fillRect/>
-          </a:stretch>
-        </p:blipFill>
-        <p:spPr>
-          <a:xfrm>
-            <a:off x="548640" y="1325880"/>
-            <a:ext cx="11091672" cy="3965273"/>
-          </a:xfrm>
-          <a:prstGeom prst="rect">
-            <a:avLst/>
-          </a:prstGeom>
-        </p:spPr>
-      </p:pic>
-      <p:sp>
-        <p:nvSpPr>
-          <p:cNvPr id="4" name="experiment 1 caption"/>
-          <p:cNvSpPr txBox="1"/>
-          <p:nvPr/>
-        </p:nvSpPr>
-        <p:spPr>
-          <a:xfrm>
-            <a:off x="548640" y="5400881"/>
-            <a:ext cx="11091672" cy="731520"/>
-          </a:xfrm>
-          <a:prstGeom prst="rect">
-            <a:avLst/>
-          </a:prstGeom>
-          <a:noFill/>
-          <a:ln/>
-        </p:spPr>
-        <p:txBody>
-          <a:bodyPr wrap="square" lIns="0" tIns="0" rIns="0" bIns="0" rtlCol="0" anchor="t"/>
-          <a:lstStyle/>
-          <a:p>
-            <a:pPr indent="0" marL="0">
-              <a:buNone/>
-            </a:pPr>
-            <a:r>
-              <a:rPr lang="en-US" sz="1250" dirty="0">
-                <a:solidFill>
-                  <a:srgbClr val="52514E"/>
-                </a:solidFill>
-              </a:rPr>
-              <a:t>A check that the dataset behaves as designed: the tier fixes the element count; load and congestion follow from the rules. Boxes: benchmark, 125 contexts per tier (IQR, whiskers 1.5 IQR); diamonds: medians of 2,000 generated contexts per tier. Load rises at every tier (rank correlation +0.56); the closest gap shrinks overall (−0.36) but widens at C6 (70 → 75 mm), where elements start to stack in two or three rows.</a:t>
-            </a:r>
-            <a:endParaRPr lang="en-US" sz="1250" dirty="0"/>
-          </a:p>
-        </p:txBody>
-      </p:sp>
-      <p:sp>
-        <p:nvSpPr>
-          <p:cNvPr id="25" name="Slide Number Placeholder 0"/>
-          <p:cNvSpPr>
-            <a:spLocks noGrp="1"/>
-          </p:cNvSpPr>
-          <p:nvPr>
-            <p:ph type="sldNum" sz="quarter" idx="4294967295"/>
-          </p:nvPr>
-        </p:nvSpPr>
-        <p:spPr>
-          <a:xfrm>
-            <a:off x="11064240" y="6419088"/>
-            <a:ext cx="594360" cy="274320"/>
-          </a:xfrm>
-          <a:prstGeom prst="rect">
-            <a:avLst/>
-          </a:prstGeom>
-          <a:extLst>
-            <a:ext uri="{C572A759-6A51-4108-AA02-DFA0A04FC94B}">
-              <ma14:wrappingTextBoxFlag xmlns:ma14="http://schemas.microsoft.com/office/mac/drawingml/2011/main" val="0"/>
-            </a:ext>
-          </a:extLst>
-        </p:spPr>
-        <p:txBody>
-          <a:bodyPr/>
-          <a:lstStyle>
-            <a:lvl1pPr>
-              <a:defRPr sz="900">
-                <a:solidFill>
-                  <a:srgbClr val="898781"/>
-                </a:solidFill>
-              </a:defRPr>
-            </a:lvl1pPr>
-          </a:lstStyle>
-          <a:p>
-            <a:pPr algn="r"/>
-            <a:fld id="{F7021451-1387-4CA6-816F-3879F97B5CBC}" type="slidenum">
-              <a:rPr b="0" lang="en-US"/>
               <a:t>9</a:t>
             </a:fld>
             <a:endParaRPr lang="en-US"/>
@@ -25987,7 +26733,7 @@
     </a:clrScheme>
     <a:fontScheme name="Office">
       <a:majorFont>
-        <a:latin typeface="Cambria"/>
+        <a:latin typeface="Calibri"/>
         <a:ea typeface=""/>
         <a:cs typeface=""/>
         <a:font script="Jpan" typeface="游ゴシック Light"/>

</xml_diff>

<commit_message>
Talk: natural spoken script for recording
Every slide's speech is rewritten in spoken English (contractions, shorter
sentences, numbers as one would say them), trimmed to about 1,300 words, and
retimed at 145 words a minute with 35 s for the studio demo (about 9:40).
Speaker notes match TALK.md word for word; docs/TALK_to_record.md holds the
read-aloud text with recording tips. PPTX and PDF rebuilt.

Co-Authored-By: Claude <noreply@anthropic.com>
Claude-Session: https://claude.ai/code/session_01R1ft1rokeRJHR95rzLxNEC
</commit_message>
<xml_diff>
--- a/docs/CrossMEP_CIBW78_talk.pptx
+++ b/docs/CrossMEP_CIBW78_talk.pptx
@@ -127,19 +127,19 @@
   <p:extLst>
     <p:ext uri="{521415D9-36F7-43E2-AB2F-B90AF26B5E84}">
       <p14:sectionLst xmlns:p14="http://schemas.microsoft.com/office/powerpoint/2010/main">
-        <p14:section name="Opening" id="{4ba9412d-72b2-c3d6-8d40-587955bf9c75}">
+        <p14:section name="Opening" id="{e65f3c1d-c380-a6a4-18a6-b977126011d9}">
           <p14:sldIdLst>
             <p14:sldId id="256"/>
           </p14:sldIdLst>
         </p14:section>
-        <p14:section name="Motivation" id="{5101bc50-b2ec-a1ab-70fe-49adc88418bf}">
+        <p14:section name="Motivation" id="{acade001-3c0d-0fd1-29c9-67a0ea581c0a}">
           <p14:sldIdLst>
             <p14:sldId id="257"/>
             <p14:sldId id="258"/>
             <p14:sldId id="259"/>
           </p14:sldIdLst>
         </p14:section>
-        <p14:section name="The dataset" id="{be418935-f5f2-dec0-23f7-db9e5066ccef}">
+        <p14:section name="The dataset" id="{73343f88-bc53-41b1-4bc8-3d900e2eb1a0}">
           <p14:sldIdLst>
             <p14:sldId id="260"/>
             <p14:sldId id="261"/>
@@ -148,14 +148,14 @@
             <p14:sldId id="264"/>
           </p14:sldIdLst>
         </p14:section>
-        <p14:section name="Experiments" id="{2bd65c4c-b1fc-1921-b425-34a5bae00738}">
+        <p14:section name="Experiments" id="{6442129f-f8dd-e9ff-355e-54e88ca28ae0}">
           <p14:sldIdLst>
             <p14:sldId id="265"/>
             <p14:sldId id="266"/>
             <p14:sldId id="267"/>
           </p14:sldIdLst>
         </p14:section>
-        <p14:section name="Use" id="{ad95764a-de7c-b336-ff4d-51ccc51f8cac}">
+        <p14:section name="Use" id="{3d1e51c7-5c52-9a6e-8d81-dac0c0239b26}">
           <p14:sldIdLst>
             <p14:sldId id="268"/>
             <p14:sldId id="269"/>
@@ -163,7 +163,7 @@
             <p14:sldId id="271"/>
           </p14:sldIdLst>
         </p14:section>
-        <p14:section name="Appendix" id="{cf67def0-fc7c-8476-6df5-32113d772a2f}">
+        <p14:section name="Appendix" id="{7eceff1c-2356-f682-60b2-f5e3c18d4de1}">
           <p14:sldIdLst>
             <p14:sldId id="272"/>
             <p14:sldId id="273"/>
@@ -1971,7 +1971,7 @@
           <a:p>
             <a:r>
               <a:rPr lang="en-US" dirty="0"/>
-              <a:t>Hello, I'm Lavinia Pedrollo from Stanford's Center for Integrated Facility Engineering. This is CrossMEP, joint work with David Gvadzabia, Torben Graeber and Martin Fischer: a dataset of the problems a support designer solves, made for training and testing methods that design MEP supports. (0:00)</a:t>
+              <a:t>Hello everyone, I'm Lavinia Pedrollo from Stanford's Center for Integrated Facility Engineering. Today I'll show you CrossMEP, built with David Gvadzabia, Torben Graeber and Martin Fischer. It's a dataset of the problems a support designer solves, made so we can train and test methods that design MEP supports. (0:00)</a:t>
             </a:r>
             <a:endParaRPr lang="en-US" dirty="0"/>
           </a:p>
@@ -2059,7 +2059,7 @@
           <a:p>
             <a:r>
               <a:rPr lang="en-US" dirty="0"/>
-              <a:t>The first experiment is a design check, not a discovery: does difficulty grow with the tier, as intended? The count is fixed by construction; load and congestion follow from the rules, so this shows the dataset behaves as designed. Load at the support rises at every step, from 0.1 to 1.7 kilonewtons. The closest gap falls from 120 to about 62 millimetres, but widens again at C6, where the generator starts stacking in two or three rows. So report methods tier by tier. (4:55)</a:t>
+              <a:t>Now three experiments. The first is a design check, not a discovery: does difficulty grow with the tier? The count is fixed by construction, and load and congestion follow from the rules, so this shows the dataset behaves as designed. The load at the support rises at every step, from 0.1 to 1.7 kilonewtons. The closest gap shrinks from 120 to about 62 millimeters, but widens again at C6, where elements start stacking in two or three rows. So: report methods tier by tier. (4:50)</a:t>
             </a:r>
             <a:endParaRPr lang="en-US" dirty="0"/>
           </a:p>
@@ -2147,7 +2147,7 @@
           <a:p>
             <a:r>
               <a:rPr lang="en-US" dirty="0"/>
-              <a:t>The second experiment is the one the generator could fail: is the spacing realistic in a building it never saw? The gap distribution was fitted on a residential duplex from buildingSMART. We held out a second open building, a medical-dental clinic, which is a real building, cut it into sections every 250 millimetres, the way a context is defined, and measured the gap between pipes running side by side. On the left, the clinic: the generated gaps are close to the measured ones, though not identical. On the right, the distances: generated to clinic 28 millimetres. That is above the 8 a perfect generator would show, so not a perfect match, but about as close as the duplex's own two models are to each other. A fixed gap at the 25 millimetre minimum would be about 190 millimetres off. (5:30)</a:t>
+              <a:t>The second experiment is the one the generator could fail. Is the spacing realistic in a building it has never seen? The gap distribution was fitted on a residential duplex. We kept a second open building aside, a medical-dental clinic, cut it into sections every 250 millimeters, the way a context is defined, and measured the gaps between pipes running side by side. On the left, the clinic: generated gaps are close to measured ones, though not identical. On the right, the distances. Generator to clinic: 28 millimeters. That is above the 8 a perfect generator would show, so not a perfect match, but about as close as the duplex's own two models are to each other. A fixed 25-millimeter gap would be about 190 off. (5:25)</a:t>
             </a:r>
             <a:endParaRPr lang="en-US" dirty="0"/>
           </a:p>
@@ -2235,7 +2235,7 @@
           <a:p>
             <a:r>
               <a:rPr lang="en-US" dirty="0"/>
-              <a:t>The third is a use of the dataset, not a test of it: what must a catalog of clamps cover? Take the paper's two-size catalog as an illustration. It attaches 11.6 per cent of the pipes, interval 10 to 13, all of one size, DN40; load never binds, and trays, ducts and conduits are not covered at all. On the right is what the dataset asks of any catalog: two well-placed sizes attach 43 per cent, six 80, twelve every pipe. So 'what should the catalog contain' becomes a measurement. (6:25)</a:t>
+              <a:t>The third experiment is a use of the dataset, not a test of it: what must a catalog of clamps cover? Our paper's two-size catalog attaches 11.6 percent of the pipes, with an interval of 10 to 13, all one size, DN40. Load is never the limit, and trays, ducts and conduits aren't covered at all. On the right is what the dataset asks of any catalog: two well-placed sizes could attach 43 percent, six sizes 80, twelve sizes every pipe. So 'what should the catalog contain' becomes a measurement. (6:20)</a:t>
             </a:r>
             <a:endParaRPr lang="en-US" dirty="0"/>
           </a:p>
@@ -2323,7 +2323,7 @@
           <a:p>
             <a:r>
               <a:rPr lang="en-US" dirty="0"/>
-              <a:t>Here is what that means in practice. In the studio I choose what crosses the hanger: a tier, or an exact mix, and the seed. Out comes the section a support designer receives, drawn the way an engineer would issue it: every service at true size, its level below the slab, its load at the support, the closest clear gap; and the same run in 3D. Every section is a stored output of the released generator, with the Python call that reproduces it. [Live: switch to the studio, click C3, then Generate another twice, then Exact mix with a duct. If the demo fails, stay on this slide; slide 17 shows two more sections. Before the talk: open the studio once with internet, set its link sharing to public, scan the QR from a phone not logged in.] (7:00)</a:t>
+              <a:t>Let me show it. This is the Generator Studio. I choose what crosses the hanger, a tier or an exact mix, and a seed. Out comes the section a support designer receives, drawn the way an engineer would issue it: every service at true size, its level below the slab, its load, the closest clear gap, and the same run in 3D. Every section is a stored output of the released generator, with the Python call that reproduces it. Scan the code to try it yourself. [Live: switch to the studio, click C3, then Generate another twice, then Exact mix with a duct. If the demo fails, stay on this slide; slide 17 shows two more sections. Before the talk: open the studio once with internet, set its link sharing to public, scan the QR from a phone not logged in.] (6:55)</a:t>
             </a:r>
             <a:endParaRPr lang="en-US" dirty="0"/>
           </a:p>
@@ -2411,7 +2411,7 @@
           <a:p>
             <a:r>
               <a:rPr lang="en-US" dirty="0"/>
-              <a:t>Using it takes a few lines: load a split with the Python standard library, filter by composition, or generate your own mix with the same rules. Because there are no labels, the same files serve reinforcement learning, constraint-programming baselines and human benchmarking, and we ship the scoring: train on the generator, from C1 up to C8; evaluate on the benchmark, the same 125 contexts per tier for every method; report per tier with 95 per cent intervals and paired tests. (8:05)</a:t>
+              <a:t>Using it takes a few lines: load a split, filter by composition, or generate your own mix. Because there are no labels, the same files serve reinforcement learning, constraint programming, and benchmarking people. We ship the scoring too. Train on the generator, from C1 up to C8. Evaluate on the benchmark, the same 125 contexts per tier for every method. Report per tier, with 95 percent intervals and paired tests. (8:05)</a:t>
             </a:r>
             <a:endParaRPr lang="en-US" dirty="0"/>
           </a:p>
@@ -2499,7 +2499,7 @@
           <a:p>
             <a:r>
               <a:rPr lang="en-US" dirty="0"/>
-              <a:t>Its scope: one section at one support - routing, branches and spacing are outside it, although the span is recorded so a method can vary it. Realism is checked on sections of two open buildings; congested racks rest on practice and standards. The trade mix is a design choice, and the data is not for structural design. Next: a public checker for support designs, with best-known costs, so methods can be compared on the answer and not only on the brief; the catalog as an input, so a method is tested on catalogs it has never seen; and a real test set from commercial projects, with supports designed by engineers - which is where we would value your eye. (8:35)</a:t>
+              <a:t>A word on scope. CrossMEP is one section at one support. Routing and branches are outside it, but the span is recorded, so a method can vary it. Pipe spacing was checked on two open buildings; the rest rests on practice and standards, and the trade mix is a design choice. It's not for structural design of real installations. Next: a public checker, with best-known costs, so we can compare methods on the answer; the catalog as an input; and a real test set from commercial projects, with supports designed by engineers. That's where I'd value your eye. (8:35)</a:t>
             </a:r>
             <a:endParaRPr lang="en-US" dirty="0"/>
           </a:p>
@@ -2587,7 +2587,7 @@
           <a:p>
             <a:r>
               <a:rPr lang="en-US" dirty="0"/>
-              <a:t>CrossMEP is the brief, not the answer: 7,000 support-design problems, every constant traced to its source or declared a design choice, pipe gaps checked against two open buildings, and open. The QR code takes you to the data, the code, the gallery and the studio. Thank you. (9:25)</a:t>
+              <a:t>To sum up: CrossMEP is the brief, not the answer. Seven thousand support-design problems, every constant sourced or declared a design choice, pipe spacing checked on two open buildings, and all of it open. If you coordinate services or design supports, try the studio and tell me what looks wrong. Thank you. (9:15)</a:t>
             </a:r>
             <a:endParaRPr lang="en-US" dirty="0"/>
           </a:p>
@@ -2939,7 +2939,7 @@
           <a:p>
             <a:r>
               <a:rPr lang="en-US" dirty="0"/>
-              <a:t>A modular support system groups several MEP services - pipes, ducts, cable trays - onto one prefabricated frame, installed as one unit: a structural support assembly. A 200,000 square-foot hospital needs on the order of 10,000 of them, and each takes 20 minutes to two hours to design by hand: together about a quarter of the MEP design effort. These are practitioner estimates. (0:15)</a:t>
+              <a:t>Let's start with the problem. In this hospital, every red mark is a place where pipes, ducts or cable trays hang from the structure. A modular support system groups several services onto one prefabricated frame, installed as a single unit: a structural support assembly. A hospital of two hundred thousand square feet needs about ten thousand of them. Each takes twenty minutes to two hours to design by hand, roughly a quarter of the whole MEP design effort. These are practitioner estimates, but they give you the scale. (0:20)</a:t>
             </a:r>
             <a:endParaRPr lang="en-US" dirty="0"/>
           </a:p>
@@ -3203,7 +3203,7 @@
           <a:p>
             <a:r>
               <a:rPr lang="en-US" dirty="0"/>
-              <a:t>At ISARC we stated the task: given a fixed catalog of components and the MEP context - the services crossing the hanger and the surface they hang from - synthesize a feasible assembly. Design starts after coordination, from the section at each hanger, not from the whole model. Tools coordinate the model and check a design, but choosing the topology and the parts is still manual, because it rests on judgment, on rules that interact across thousands of combinations, and on catalogs that keep changing. The section at the hanger is the unit of that work, and the unit of our dataset. (0:40)</a:t>
+              <a:t>So what is the task? At ISARC we defined it like this. You're given a fixed catalog of components and the context: which services cross the hanger, and what they hang from. You must find a feasible assembly that carries them to the structure. Designers don't work from the whole model. They work from one section at each hanger, like this one. Today's tools help coordinate the model and check a design, but choosing the layout and the parts is still manual. It takes judgment, interacting rules, and ever-changing catalogs. That section is the unit of this work, and the unit of our dataset. (0:55)</a:t>
             </a:r>
             <a:endParaRPr lang="en-US" dirty="0"/>
           </a:p>
@@ -3291,7 +3291,7 @@
           <a:p>
             <a:r>
               <a:rPr lang="en-US" dirty="0"/>
-              <a:t>Learning-based methods for this task need many such sections, and none were public. Project models are proprietary, the open ones are not organised around supports, and any one project covers one narrow slice. So we built CrossMEP: 7,000 contexts with about 31,500 elements, stratified into eight tiers, deliberately unlabeled, with every constant traced to its source or declared a design choice, pipe gaps checked against open IFC buildings, and released openly with the generator. (1:25)</a:t>
+              <a:t>To teach a machine this, you need many examples, and there were none. Project models are proprietary, the open ones aren't organized around supports, and any one project is a narrow slice. So we built CrossMEP: seven thousand contexts, about thirty-one and a half thousand elements, in eight difficulty tiers. They are deliberately unlabeled: you get the problem, never the answer. Every constant is sourced or declared a design choice, and everything is open. (1:40)</a:t>
             </a:r>
             <a:endParaRPr lang="en-US" dirty="0"/>
           </a:p>
@@ -3379,7 +3379,7 @@
           <a:p>
             <a:r>
               <a:rPr lang="en-US" dirty="0"/>
-              <a:t>Here is one context. It is a 2-D section at one support location. Each element carries its kind, service and trade, its bare size, its insulation, its load per metre and the span it was sized at - so the load at this support - and its position along and out from the surface. Plus the surface itself: slab or wall, substrate, thickness. What is not in it is the support: no channel, no rods, no anchors, and no 'correct answer', because a feasible support depends on the catalog you build from. The context is the brief; the assembly is the answer. (1:55)</a:t>
+              <a:t>Here's one context: a two-dimensional section at one support location. Each element has its kind, service and trade, its size, its insulation, and its load, which is weight per metre times the span it was sized at, plus its position. Add the surface, a slab or a wall, and that's all. What you won't find is the support: no channel, no rods, no anchors, and no correct answer, because a feasible support depends on the catalog you build from. The context is the brief. The assembly is the answer. (2:10)</a:t>
             </a:r>
             <a:endParaRPr lang="en-US" dirty="0"/>
           </a:p>
@@ -3467,7 +3467,7 @@
           <a:p>
             <a:r>
               <a:rPr lang="en-US" dirty="0"/>
-              <a:t>How is a context made? Not by free randomness: by rules you would recognise. The tier fixes the number of elements. We pick the surface. We fill the count with services the way trades actually run - hot and cold together, flow and return together, conduits in groups. Bulky services go nearest the slab: ducts, then containment, then pipes. Gaps between neighbours are drawn from gaps measured on a built project, with a 25 millimetre minimum, plus a small stagger within rows; on walls, electrical stays above water. Finally every context is checked - every pair at least 25 millimetres clear - and it is seeded: the same seed gives the same file, byte for byte. (2:35)</a:t>
+              <a:t>How do we make a context? Not by free randomness, but by rules an engineer would recognize. The tier fixes how many elements there are. We pick the surface and fill it the way trades really run services: hot and cold together, flow and return together, conduits in groups, bulky services nearest the slab. Gaps between neighbors are drawn from gaps measured on a built project, never below twenty-five millimeters. On walls, electrical stays above water. Every context is checked, and it's seeded: the same seed gives the same file, byte for byte. (2:45)</a:t>
             </a:r>
             <a:endParaRPr lang="en-US" dirty="0"/>
           </a:p>
@@ -3555,7 +3555,7 @@
           <a:p>
             <a:r>
               <a:rPr lang="en-US" dirty="0"/>
-              <a:t>Every number in a context comes from a cited source or a declared design choice. Pipes from EN 10220 and 10255, filled with water, at ASME B31.1 water-service spans; insulation from the German GEG and a condensation-control schedule; trays at IEC 61537 widths, loaded full; ducts at EN sizes with a manufacturer weight table; conduits at IEC 61386 sizes with 40 per cent fill. Loads are computed from these in the code, and choices such as the trade mix are labelled as design choices. (3:20)</a:t>
+              <a:t>Where do the numbers come from? Each comes from a cited source or is declared a design choice. Pipes follow the European steel pipe standards, filled with water, at ASME B31.1 spans. Insulation follows the German GEG, and a condensation schedule for chilled water. Trays and conduits follow IEC standards, ducts European sizes with a manufacturer's weight table. Loads are computed in code, and pure choices, like the trade mix, are labeled as choices. (3:25)</a:t>
             </a:r>
             <a:endParaRPr lang="en-US" dirty="0"/>
           </a:p>
@@ -3643,7 +3643,7 @@
           <a:p>
             <a:r>
               <a:rPr lang="en-US" dirty="0"/>
-              <a:t>The release has four splits on disjoint seeds: 5,000 contexts for training, 500 for validation, 500 for test, and a 1,000-context benchmark with 125 per tier. 31,484 elements in total - mostly pipes, then conduits, trays and ducts; pipe sizes from DN15 to DN100, mostly small bore, as in the measured project. Four in five contexts hang from a ceiling, one in five from a wall, and electrical containment is the largest trade by count. Everything is plain JSON with a schema, metadata and a datasheet. (3:55)</a:t>
+              <a:t>The release has four splits on disjoint seeds, so a method is never tested on what it trained on: five thousand contexts for training, five hundred each for validation and test, and a benchmark of one thousand, a hundred and twenty-five per tier. Mostly pipes, then conduits, trays and ducts. Four in five hang from a ceiling, one in five from a wall. Everything is plain JSON with a schema and a datasheet. (3:55)</a:t>
             </a:r>
             <a:endParaRPr lang="en-US" dirty="0"/>
           </a:p>
@@ -3731,7 +3731,7 @@
           <a:p>
             <a:r>
               <a:rPr lang="en-US" dirty="0"/>
-              <a:t>This is what the data looks like: one benchmark context per tier. C1 is a single element - the most common support in any building. By C8 you have eight services on three rows. Within a tier everything else varies - kinds, trades, surfaces and stacking - so the element count is the one controlled difficulty axis. Note the walls: the section rotates, and electrical sits above water. (4:30)</a:t>
+              <a:t>Here's one benchmark context per tier. C1 is a single element, the most common support in any building. By C8 you have eight services on three rows. Within a tier everything else varies: kinds, trades, surfaces, stacking. So the element count is the one controlled axis of difficulty. And notice the walls: the section rotates, and electrical sits above water. (4:25)</a:t>
             </a:r>
             <a:endParaRPr lang="en-US" dirty="0"/>
           </a:p>

</xml_diff>

<commit_message>
Talk: a stronger opening hook
The talk now opens on the picture the audience knows (look up in a hospital:
every pipe, duct and tray hangs from a support designed by hand) and the gap
(no public data to teach a machine to do it) before introducing the work.
Slide 2 trimmed to keep the total under 10 minutes (about 9:45).
</commit_message>
<xml_diff>
--- a/docs/CrossMEP_CIBW78_talk.pptx
+++ b/docs/CrossMEP_CIBW78_talk.pptx
@@ -127,19 +127,19 @@
   <p:extLst>
     <p:ext uri="{521415D9-36F7-43E2-AB2F-B90AF26B5E84}">
       <p14:sectionLst xmlns:p14="http://schemas.microsoft.com/office/powerpoint/2010/main">
-        <p14:section name="Opening" id="{e65f3c1d-c380-a6a4-18a6-b977126011d9}">
+        <p14:section name="Opening" id="{4e27408b-89b1-49b7-d13f-4a7a61d8a484}">
           <p14:sldIdLst>
             <p14:sldId id="256"/>
           </p14:sldIdLst>
         </p14:section>
-        <p14:section name="Motivation" id="{acade001-3c0d-0fd1-29c9-67a0ea581c0a}">
+        <p14:section name="Motivation" id="{be1eb483-1da7-b5a9-df59-dc2c937fb447}">
           <p14:sldIdLst>
             <p14:sldId id="257"/>
             <p14:sldId id="258"/>
             <p14:sldId id="259"/>
           </p14:sldIdLst>
         </p14:section>
-        <p14:section name="The dataset" id="{73343f88-bc53-41b1-4bc8-3d900e2eb1a0}">
+        <p14:section name="The dataset" id="{d5581d54-24e7-c1a7-196e-a250db613ccb}">
           <p14:sldIdLst>
             <p14:sldId id="260"/>
             <p14:sldId id="261"/>
@@ -148,14 +148,14 @@
             <p14:sldId id="264"/>
           </p14:sldIdLst>
         </p14:section>
-        <p14:section name="Experiments" id="{6442129f-f8dd-e9ff-355e-54e88ca28ae0}">
+        <p14:section name="Experiments" id="{437b6458-ef8d-1a1a-ab56-424bd354df7a}">
           <p14:sldIdLst>
             <p14:sldId id="265"/>
             <p14:sldId id="266"/>
             <p14:sldId id="267"/>
           </p14:sldIdLst>
         </p14:section>
-        <p14:section name="Use" id="{3d1e51c7-5c52-9a6e-8d81-dac0c0239b26}">
+        <p14:section name="Use" id="{396ec00b-1b79-9267-fcad-67ca0a727990}">
           <p14:sldIdLst>
             <p14:sldId id="268"/>
             <p14:sldId id="269"/>
@@ -163,7 +163,7 @@
             <p14:sldId id="271"/>
           </p14:sldIdLst>
         </p14:section>
-        <p14:section name="Appendix" id="{7eceff1c-2356-f682-60b2-f5e3c18d4de1}">
+        <p14:section name="Appendix" id="{12241547-dc0d-39ab-e9cf-83eff5387825}">
           <p14:sldIdLst>
             <p14:sldId id="272"/>
             <p14:sldId id="273"/>
@@ -1971,7 +1971,7 @@
           <a:p>
             <a:r>
               <a:rPr lang="en-US" dirty="0"/>
-              <a:t>Hello everyone, I'm Lavinia Pedrollo from Stanford's Center for Integrated Facility Engineering. Today I'll show you CrossMEP, built with David Gvadzabia, Torben Graeber and Martin Fischer. It's a dataset of the problems a support designer solves, made so we can train and test methods that design MEP supports. (0:00)</a:t>
+              <a:t>Next time you're in a hospital, look up. Above the ceiling, pipes, ducts and cable trays run in every direction, and not one of them floats. Each hangs from a support that an engineer designed by hand, one at a time. And until now, there was no public data to teach a machine to do that. I'm Lavinia Pedrollo, from Stanford, and with David Gvadzabia, Torben Graeber and Martin Fischer, we built that data: CrossMEP. (0:00)</a:t>
             </a:r>
             <a:endParaRPr lang="en-US" dirty="0"/>
           </a:p>
@@ -2059,7 +2059,7 @@
           <a:p>
             <a:r>
               <a:rPr lang="en-US" dirty="0"/>
-              <a:t>Now three experiments. The first is a design check, not a discovery: does difficulty grow with the tier? The count is fixed by construction, and load and congestion follow from the rules, so this shows the dataset behaves as designed. The load at the support rises at every step, from 0.1 to 1.7 kilonewtons. The closest gap shrinks from 120 to about 62 millimeters, but widens again at C6, where elements start stacking in two or three rows. So: report methods tier by tier. (4:50)</a:t>
+              <a:t>Now three experiments. The first is a design check, not a discovery: does difficulty grow with the tier? The count is fixed by construction, and load and congestion follow from the rules, so this shows the dataset behaves as designed. The load at the support rises at every step, from 0.1 to 1.7 kilonewtons. The closest gap shrinks from 120 to about 62 millimeters, but widens again at C6, where elements start stacking in two or three rows. So: report methods tier by tier. (5:00)</a:t>
             </a:r>
             <a:endParaRPr lang="en-US" dirty="0"/>
           </a:p>
@@ -2147,7 +2147,7 @@
           <a:p>
             <a:r>
               <a:rPr lang="en-US" dirty="0"/>
-              <a:t>The second experiment is the one the generator could fail. Is the spacing realistic in a building it has never seen? The gap distribution was fitted on a residential duplex. We kept a second open building aside, a medical-dental clinic, cut it into sections every 250 millimeters, the way a context is defined, and measured the gaps between pipes running side by side. On the left, the clinic: generated gaps are close to measured ones, though not identical. On the right, the distances. Generator to clinic: 28 millimeters. That is above the 8 a perfect generator would show, so not a perfect match, but about as close as the duplex's own two models are to each other. A fixed 25-millimeter gap would be about 190 off. (5:25)</a:t>
+              <a:t>The second experiment is the one the generator could fail. Is the spacing realistic in a building it has never seen? The gap distribution was fitted on a residential duplex. We kept a second open building aside, a medical-dental clinic, cut it into sections every 250 millimeters, the way a context is defined, and measured the gaps between pipes running side by side. On the left, the clinic: generated gaps are close to measured ones, though not identical. On the right, the distances. Generator to clinic: 28 millimeters. That is above the 8 a perfect generator would show, so not a perfect match, but about as close as the duplex's own two models are to each other. A fixed 25-millimeter gap would be about 190 off. (5:35)</a:t>
             </a:r>
             <a:endParaRPr lang="en-US" dirty="0"/>
           </a:p>
@@ -2235,7 +2235,7 @@
           <a:p>
             <a:r>
               <a:rPr lang="en-US" dirty="0"/>
-              <a:t>The third experiment is a use of the dataset, not a test of it: what must a catalog of clamps cover? Our paper's two-size catalog attaches 11.6 percent of the pipes, with an interval of 10 to 13, all one size, DN40. Load is never the limit, and trays, ducts and conduits aren't covered at all. On the right is what the dataset asks of any catalog: two well-placed sizes could attach 43 percent, six sizes 80, twelve sizes every pipe. So 'what should the catalog contain' becomes a measurement. (6:20)</a:t>
+              <a:t>The third experiment is a use of the dataset, not a test of it: what must a catalog of clamps cover? Our paper's two-size catalog attaches 11.6 percent of the pipes, with an interval of 10 to 13, all one size, DN40. Load is never the limit, and trays, ducts and conduits aren't covered at all. On the right is what the dataset asks of any catalog: two well-placed sizes could attach 43 percent, six sizes 80, twelve sizes every pipe. So 'what should the catalog contain' becomes a measurement. (6:25)</a:t>
             </a:r>
             <a:endParaRPr lang="en-US" dirty="0"/>
           </a:p>
@@ -2323,7 +2323,7 @@
           <a:p>
             <a:r>
               <a:rPr lang="en-US" dirty="0"/>
-              <a:t>Let me show it. This is the Generator Studio. I choose what crosses the hanger, a tier or an exact mix, and a seed. Out comes the section a support designer receives, drawn the way an engineer would issue it: every service at true size, its level below the slab, its load, the closest clear gap, and the same run in 3D. Every section is a stored output of the released generator, with the Python call that reproduces it. Scan the code to try it yourself. [Live: switch to the studio, click C3, then Generate another twice, then Exact mix with a duct. If the demo fails, stay on this slide; slide 17 shows two more sections. Before the talk: open the studio once with internet, set its link sharing to public, scan the QR from a phone not logged in.] (6:55)</a:t>
+              <a:t>Let me show it. This is the Generator Studio. I choose what crosses the hanger, a tier or an exact mix, and a seed. Out comes the section a support designer receives, drawn the way an engineer would issue it: every service at true size, its level below the slab, its load, the closest clear gap, and the same run in 3D. Every section is a stored output of the released generator, with the Python call that reproduces it. Scan the code to try it yourself. [Live: switch to the studio, click C3, then Generate another twice, then Exact mix with a duct. If the demo fails, stay on this slide; slide 17 shows two more sections. Before the talk: open the studio once with internet, set its link sharing to public, scan the QR from a phone not logged in.] (7:05)</a:t>
             </a:r>
             <a:endParaRPr lang="en-US" dirty="0"/>
           </a:p>
@@ -2411,7 +2411,7 @@
           <a:p>
             <a:r>
               <a:rPr lang="en-US" dirty="0"/>
-              <a:t>Using it takes a few lines: load a split, filter by composition, or generate your own mix. Because there are no labels, the same files serve reinforcement learning, constraint programming, and benchmarking people. We ship the scoring too. Train on the generator, from C1 up to C8. Evaluate on the benchmark, the same 125 contexts per tier for every method. Report per tier, with 95 percent intervals and paired tests. (8:05)</a:t>
+              <a:t>Using it takes a few lines: load a split, filter by composition, or generate your own mix. Because there are no labels, the same files serve reinforcement learning, constraint programming, and benchmarking people. We ship the scoring too. Train on the generator, from C1 up to C8. Evaluate on the benchmark, the same 125 contexts per tier for every method. Report per tier, with 95 percent intervals and paired tests. (8:15)</a:t>
             </a:r>
             <a:endParaRPr lang="en-US" dirty="0"/>
           </a:p>
@@ -2499,7 +2499,7 @@
           <a:p>
             <a:r>
               <a:rPr lang="en-US" dirty="0"/>
-              <a:t>A word on scope. CrossMEP is one section at one support. Routing and branches are outside it, but the span is recorded, so a method can vary it. Pipe spacing was checked on two open buildings; the rest rests on practice and standards, and the trade mix is a design choice. It's not for structural design of real installations. Next: a public checker, with best-known costs, so we can compare methods on the answer; the catalog as an input; and a real test set from commercial projects, with supports designed by engineers. That's where I'd value your eye. (8:35)</a:t>
+              <a:t>A word on scope. CrossMEP is one section at one support. Routing and branches are outside it, but the span is recorded, so a method can vary it. Pipe spacing was checked on two open buildings; the rest rests on practice and standards, and the trade mix is a design choice. It's not for structural design of real installations. Next: a public checker, with best-known costs, so we can compare methods on the answer; the catalog as an input; and a real test set from commercial projects, with supports designed by engineers. That's where I'd value your eye. (8:45)</a:t>
             </a:r>
             <a:endParaRPr lang="en-US" dirty="0"/>
           </a:p>
@@ -2587,7 +2587,7 @@
           <a:p>
             <a:r>
               <a:rPr lang="en-US" dirty="0"/>
-              <a:t>To sum up: CrossMEP is the brief, not the answer. Seven thousand support-design problems, every constant sourced or declared a design choice, pipe spacing checked on two open buildings, and all of it open. If you coordinate services or design supports, try the studio and tell me what looks wrong. Thank you. (9:15)</a:t>
+              <a:t>To sum up: CrossMEP is the brief, not the answer. Seven thousand support-design problems, every constant sourced or declared a design choice, pipe spacing checked on two open buildings, and all of it open. If you coordinate services or design supports, try the studio and tell me what looks wrong. Thank you. (9:25)</a:t>
             </a:r>
             <a:endParaRPr lang="en-US" dirty="0"/>
           </a:p>
@@ -2939,7 +2939,7 @@
           <a:p>
             <a:r>
               <a:rPr lang="en-US" dirty="0"/>
-              <a:t>Let's start with the problem. In this hospital, every red mark is a place where pipes, ducts or cable trays hang from the structure. A modular support system groups several services onto one prefabricated frame, installed as a single unit: a structural support assembly. A hospital of two hundred thousand square feet needs about ten thousand of them. Each takes twenty minutes to two hours to design by hand, roughly a quarter of the whole MEP design effort. These are practitioner estimates, but they give you the scale. (0:20)</a:t>
+              <a:t>Here's what that looks like. In this hospital, every red mark is a place where pipes, ducts or cable trays hang from the structure. A modular support system groups several services onto one prefabricated frame, installed as a single unit: a structural support assembly. A hospital of two hundred thousand square feet needs about ten thousand of them. Each takes twenty minutes to two hours to design by hand, roughly a quarter of the whole MEP design effort. These are practitioner estimates. (0:30)</a:t>
             </a:r>
             <a:endParaRPr lang="en-US" dirty="0"/>
           </a:p>
@@ -3203,7 +3203,7 @@
           <a:p>
             <a:r>
               <a:rPr lang="en-US" dirty="0"/>
-              <a:t>So what is the task? At ISARC we defined it like this. You're given a fixed catalog of components and the context: which services cross the hanger, and what they hang from. You must find a feasible assembly that carries them to the structure. Designers don't work from the whole model. They work from one section at each hanger, like this one. Today's tools help coordinate the model and check a design, but choosing the layout and the parts is still manual. It takes judgment, interacting rules, and ever-changing catalogs. That section is the unit of this work, and the unit of our dataset. (0:55)</a:t>
+              <a:t>So what is the task? At ISARC we defined it like this. You're given a fixed catalog of components and the context: which services cross the hanger, and what they hang from. You must find a feasible assembly that carries them to the structure. Designers don't work from the whole model. They work from one section at each hanger, like this one. Today's tools help coordinate the model and check a design, but choosing the layout and the parts is still manual. It takes judgment, interacting rules, and ever-changing catalogs. That section is the unit of this work, and the unit of our dataset. (1:05)</a:t>
             </a:r>
             <a:endParaRPr lang="en-US" dirty="0"/>
           </a:p>
@@ -3291,7 +3291,7 @@
           <a:p>
             <a:r>
               <a:rPr lang="en-US" dirty="0"/>
-              <a:t>To teach a machine this, you need many examples, and there were none. Project models are proprietary, the open ones aren't organized around supports, and any one project is a narrow slice. So we built CrossMEP: seven thousand contexts, about thirty-one and a half thousand elements, in eight difficulty tiers. They are deliberately unlabeled: you get the problem, never the answer. Every constant is sourced or declared a design choice, and everything is open. (1:40)</a:t>
+              <a:t>To teach a machine this, you need many examples, and there were none. Project models are proprietary, the open ones aren't organized around supports, and any one project is a narrow slice. So we built CrossMEP: seven thousand contexts, about thirty-one and a half thousand elements, in eight difficulty tiers. They are deliberately unlabeled: you get the problem, never the answer. Every constant is sourced or declared a design choice, and everything is open. (1:50)</a:t>
             </a:r>
             <a:endParaRPr lang="en-US" dirty="0"/>
           </a:p>
@@ -3379,7 +3379,7 @@
           <a:p>
             <a:r>
               <a:rPr lang="en-US" dirty="0"/>
-              <a:t>Here's one context: a two-dimensional section at one support location. Each element has its kind, service and trade, its size, its insulation, and its load, which is weight per metre times the span it was sized at, plus its position. Add the surface, a slab or a wall, and that's all. What you won't find is the support: no channel, no rods, no anchors, and no correct answer, because a feasible support depends on the catalog you build from. The context is the brief. The assembly is the answer. (2:10)</a:t>
+              <a:t>Here's one context: a two-dimensional section at one support location. Each element has its kind, service and trade, its size, its insulation, and its load, which is weight per metre times the span it was sized at, plus its position. Add the surface, a slab or a wall, and that's all. What you won't find is the support: no channel, no rods, no anchors, and no correct answer, because a feasible support depends on the catalog you build from. The context is the brief. The assembly is the answer. (2:20)</a:t>
             </a:r>
             <a:endParaRPr lang="en-US" dirty="0"/>
           </a:p>
@@ -3467,7 +3467,7 @@
           <a:p>
             <a:r>
               <a:rPr lang="en-US" dirty="0"/>
-              <a:t>How do we make a context? Not by free randomness, but by rules an engineer would recognize. The tier fixes how many elements there are. We pick the surface and fill it the way trades really run services: hot and cold together, flow and return together, conduits in groups, bulky services nearest the slab. Gaps between neighbors are drawn from gaps measured on a built project, never below twenty-five millimeters. On walls, electrical stays above water. Every context is checked, and it's seeded: the same seed gives the same file, byte for byte. (2:45)</a:t>
+              <a:t>How do we make a context? Not by free randomness, but by rules an engineer would recognize. The tier fixes how many elements there are. We pick the surface and fill it the way trades really run services: hot and cold together, flow and return together, conduits in groups, bulky services nearest the slab. Gaps between neighbors are drawn from gaps measured on a built project, never below twenty-five millimeters. On walls, electrical stays above water. Every context is checked, and it's seeded: the same seed gives the same file, byte for byte. (2:55)</a:t>
             </a:r>
             <a:endParaRPr lang="en-US" dirty="0"/>
           </a:p>
@@ -3555,7 +3555,7 @@
           <a:p>
             <a:r>
               <a:rPr lang="en-US" dirty="0"/>
-              <a:t>Where do the numbers come from? Each comes from a cited source or is declared a design choice. Pipes follow the European steel pipe standards, filled with water, at ASME B31.1 spans. Insulation follows the German GEG, and a condensation schedule for chilled water. Trays and conduits follow IEC standards, ducts European sizes with a manufacturer's weight table. Loads are computed in code, and pure choices, like the trade mix, are labeled as choices. (3:25)</a:t>
+              <a:t>Where do the numbers come from? Each comes from a cited source or is declared a design choice. Pipes follow the European steel pipe standards, filled with water, at ASME B31.1 spans. Insulation follows the German GEG, and a condensation schedule for chilled water. Trays and conduits follow IEC standards, ducts European sizes with a manufacturer's weight table. Loads are computed in code, and pure choices, like the trade mix, are labeled as choices. (3:35)</a:t>
             </a:r>
             <a:endParaRPr lang="en-US" dirty="0"/>
           </a:p>
@@ -3643,7 +3643,7 @@
           <a:p>
             <a:r>
               <a:rPr lang="en-US" dirty="0"/>
-              <a:t>The release has four splits on disjoint seeds, so a method is never tested on what it trained on: five thousand contexts for training, five hundred each for validation and test, and a benchmark of one thousand, a hundred and twenty-five per tier. Mostly pipes, then conduits, trays and ducts. Four in five hang from a ceiling, one in five from a wall. Everything is plain JSON with a schema and a datasheet. (3:55)</a:t>
+              <a:t>The release has four splits on disjoint seeds, so a method is never tested on what it trained on: five thousand contexts for training, five hundred each for validation and test, and a benchmark of one thousand, a hundred and twenty-five per tier. Mostly pipes, then conduits, trays and ducts. Four in five hang from a ceiling, one in five from a wall. Everything is plain JSON with a schema and a datasheet. (4:05)</a:t>
             </a:r>
             <a:endParaRPr lang="en-US" dirty="0"/>
           </a:p>
@@ -3731,7 +3731,7 @@
           <a:p>
             <a:r>
               <a:rPr lang="en-US" dirty="0"/>
-              <a:t>Here's one benchmark context per tier. C1 is a single element, the most common support in any building. By C8 you have eight services on three rows. Within a tier everything else varies: kinds, trades, surfaces, stacking. So the element count is the one controlled axis of difficulty. And notice the walls: the section rotates, and electrical sits above water. (4:25)</a:t>
+              <a:t>Here's one benchmark context per tier. C1 is a single element, the most common support in any building. By C8 you have eight services on three rows. Within a tier everything else varies: kinds, trades, surfaces, stacking. So the element count is the one controlled axis of difficulty. And notice the walls: the section rotates, and electrical sits above water. (4:35)</a:t>
             </a:r>
             <a:endParaRPr lang="en-US" dirty="0"/>
           </a:p>

</xml_diff>

<commit_message>
Talk: a plainer opening
The opening states the work as it is: supports are designed by hand from the
section at each spot, we want machines to do some of it, and the missing piece
was public data. No staged scene.

Co-Authored-By: Claude <noreply@anthropic.com>
Claude-Session: https://claude.ai/code/session_01R1ft1rokeRJHR95rzLxNEC
</commit_message>
<xml_diff>
--- a/docs/CrossMEP_CIBW78_talk.pptx
+++ b/docs/CrossMEP_CIBW78_talk.pptx
@@ -127,19 +127,19 @@
   <p:extLst>
     <p:ext uri="{521415D9-36F7-43E2-AB2F-B90AF26B5E84}">
       <p14:sectionLst xmlns:p14="http://schemas.microsoft.com/office/powerpoint/2010/main">
-        <p14:section name="Opening" id="{4e27408b-89b1-49b7-d13f-4a7a61d8a484}">
+        <p14:section name="Opening" id="{207b5f30-6313-e9f5-0728-a76c3984fcdc}">
           <p14:sldIdLst>
             <p14:sldId id="256"/>
           </p14:sldIdLst>
         </p14:section>
-        <p14:section name="Motivation" id="{be1eb483-1da7-b5a9-df59-dc2c937fb447}">
+        <p14:section name="Motivation" id="{73c61c99-1c51-9abc-2815-a7b8bf8fdc4d}">
           <p14:sldIdLst>
             <p14:sldId id="257"/>
             <p14:sldId id="258"/>
             <p14:sldId id="259"/>
           </p14:sldIdLst>
         </p14:section>
-        <p14:section name="The dataset" id="{d5581d54-24e7-c1a7-196e-a250db613ccb}">
+        <p14:section name="The dataset" id="{fdc4878a-4bc3-6df2-fe2c-7734f0f08d62}">
           <p14:sldIdLst>
             <p14:sldId id="260"/>
             <p14:sldId id="261"/>
@@ -148,14 +148,14 @@
             <p14:sldId id="264"/>
           </p14:sldIdLst>
         </p14:section>
-        <p14:section name="Experiments" id="{437b6458-ef8d-1a1a-ab56-424bd354df7a}">
+        <p14:section name="Experiments" id="{55266165-38ff-343a-ccc7-00b06895a68d}">
           <p14:sldIdLst>
             <p14:sldId id="265"/>
             <p14:sldId id="266"/>
             <p14:sldId id="267"/>
           </p14:sldIdLst>
         </p14:section>
-        <p14:section name="Use" id="{396ec00b-1b79-9267-fcad-67ca0a727990}">
+        <p14:section name="Use" id="{5719fcaa-7769-ea54-ba49-bd9e06b778bb}">
           <p14:sldIdLst>
             <p14:sldId id="268"/>
             <p14:sldId id="269"/>
@@ -163,7 +163,7 @@
             <p14:sldId id="271"/>
           </p14:sldIdLst>
         </p14:section>
-        <p14:section name="Appendix" id="{12241547-dc0d-39ab-e9cf-83eff5387825}">
+        <p14:section name="Appendix" id="{55675618-867e-8995-20a8-b9b7a4b21393}">
           <p14:sldIdLst>
             <p14:sldId id="272"/>
             <p14:sldId id="273"/>
@@ -1971,7 +1971,7 @@
           <a:p>
             <a:r>
               <a:rPr lang="en-US" dirty="0"/>
-              <a:t>Next time you're in a hospital, look up. Above the ceiling, pipes, ducts and cable trays run in every direction, and not one of them floats. Each hangs from a support that an engineer designed by hand, one at a time. And until now, there was no public data to teach a machine to do that. I'm Lavinia Pedrollo, from Stanford, and with David Gvadzabia, Torben Graeber and Martin Fischer, we built that data: CrossMEP. (0:00)</a:t>
+              <a:t>Hello everyone, I'm Lavinia Pedrollo, from Stanford. Every pipe, duct and cable tray in a building hangs from a support that an engineer designs by hand, from the section at that spot. We want to teach machines to do some of that work, and the first thing we found missing was data: there was no public set of support-design problems. So, with David Gvadzabia, Torben Graeber and Martin Fischer, we built one. It's called CrossMEP. (0:00)</a:t>
             </a:r>
             <a:endParaRPr lang="en-US" dirty="0"/>
           </a:p>

</xml_diff>

<commit_message>
Talk: analyses not experiments; say what the generator is grounded on
The three checks are called analyses (a design check, a test on a building the
generator never saw, and a use). Slide 7 and its speech name the three kinds of
ground: standards (what each element is and weighs), measured open buildings
(how close neighbours sit) and declared design choices. New questions and
answers on this in TALK.md.
</commit_message>
<xml_diff>
--- a/docs/CrossMEP_CIBW78_talk.pptx
+++ b/docs/CrossMEP_CIBW78_talk.pptx
@@ -127,19 +127,19 @@
   <p:extLst>
     <p:ext uri="{521415D9-36F7-43E2-AB2F-B90AF26B5E84}">
       <p14:sectionLst xmlns:p14="http://schemas.microsoft.com/office/powerpoint/2010/main">
-        <p14:section name="Opening" id="{207b5f30-6313-e9f5-0728-a76c3984fcdc}">
+        <p14:section name="Opening" id="{f619b1dd-9bde-542a-de63-f1b60ef8eebb}">
           <p14:sldIdLst>
             <p14:sldId id="256"/>
           </p14:sldIdLst>
         </p14:section>
-        <p14:section name="Motivation" id="{73c61c99-1c51-9abc-2815-a7b8bf8fdc4d}">
+        <p14:section name="Motivation" id="{bc2681ef-5355-a865-9fac-73b550e01649}">
           <p14:sldIdLst>
             <p14:sldId id="257"/>
             <p14:sldId id="258"/>
             <p14:sldId id="259"/>
           </p14:sldIdLst>
         </p14:section>
-        <p14:section name="The dataset" id="{fdc4878a-4bc3-6df2-fe2c-7734f0f08d62}">
+        <p14:section name="The dataset" id="{7e3d5f0c-e114-ec5d-91ea-19b92d958cf5}">
           <p14:sldIdLst>
             <p14:sldId id="260"/>
             <p14:sldId id="261"/>
@@ -148,14 +148,14 @@
             <p14:sldId id="264"/>
           </p14:sldIdLst>
         </p14:section>
-        <p14:section name="Experiments" id="{55266165-38ff-343a-ccc7-00b06895a68d}">
+        <p14:section name="Experiments" id="{227babb1-eddf-d202-4db9-5141d570910b}">
           <p14:sldIdLst>
             <p14:sldId id="265"/>
             <p14:sldId id="266"/>
             <p14:sldId id="267"/>
           </p14:sldIdLst>
         </p14:section>
-        <p14:section name="Use" id="{5719fcaa-7769-ea54-ba49-bd9e06b778bb}">
+        <p14:section name="Use" id="{380cd82d-b7dd-f40a-864f-1c98181bbe3d}">
           <p14:sldIdLst>
             <p14:sldId id="268"/>
             <p14:sldId id="269"/>
@@ -163,7 +163,7 @@
             <p14:sldId id="271"/>
           </p14:sldIdLst>
         </p14:section>
-        <p14:section name="Appendix" id="{55675618-867e-8995-20a8-b9b7a4b21393}">
+        <p14:section name="Appendix" id="{a007e22d-99f7-c498-1b46-2a31c895fc5c}">
           <p14:sldIdLst>
             <p14:sldId id="272"/>
             <p14:sldId id="273"/>
@@ -2059,7 +2059,7 @@
           <a:p>
             <a:r>
               <a:rPr lang="en-US" dirty="0"/>
-              <a:t>Now three experiments. The first is a design check, not a discovery: does difficulty grow with the tier? The count is fixed by construction, and load and congestion follow from the rules, so this shows the dataset behaves as designed. The load at the support rises at every step, from 0.1 to 1.7 kilonewtons. The closest gap shrinks from 120 to about 62 millimeters, but widens again at C6, where elements start stacking in two or three rows. So: report methods tier by tier. (5:00)</a:t>
+              <a:t>Now three analyses. The first is a design check, not a discovery: does difficulty grow with the tier? The count is fixed by construction, and load and congestion follow from the rules, so this shows the dataset behaves as designed. The load at the support rises at every step, from 0.1 to 1.7 kilonewtons. The closest gap shrinks from 120 to about 62 millimeters, but widens again at C6, where elements start stacking in two or three rows. So: report methods tier by tier. (4:50)</a:t>
             </a:r>
             <a:endParaRPr lang="en-US" dirty="0"/>
           </a:p>
@@ -2147,7 +2147,7 @@
           <a:p>
             <a:r>
               <a:rPr lang="en-US" dirty="0"/>
-              <a:t>The second experiment is the one the generator could fail. Is the spacing realistic in a building it has never seen? The gap distribution was fitted on a residential duplex. We kept a second open building aside, a medical-dental clinic, cut it into sections every 250 millimeters, the way a context is defined, and measured the gaps between pipes running side by side. On the left, the clinic: generated gaps are close to measured ones, though not identical. On the right, the distances. Generator to clinic: 28 millimeters. That is above the 8 a perfect generator would show, so not a perfect match, but about as close as the duplex's own two models are to each other. A fixed 25-millimeter gap would be about 190 off. (5:35)</a:t>
+              <a:t>The second analysis is the one the generator could fail. Is the spacing realistic in a building it has never seen? The gap distribution was fitted on a residential duplex. We kept a second open building aside, a medical-dental clinic, cut it into sections every 250 millimeters, the way a context is defined, and measured the gaps between pipes running side by side. On the left, the clinic: generated gaps are close to measured ones, though not identical. On the right, the distances. Generator to clinic: 28 millimeters. That is above the 8 a perfect generator would show, so not a perfect match, but about as close as the duplex's own two models are to each other. A fixed 25-millimeter gap would be about 190 off. (5:25)</a:t>
             </a:r>
             <a:endParaRPr lang="en-US" dirty="0"/>
           </a:p>
@@ -2235,7 +2235,7 @@
           <a:p>
             <a:r>
               <a:rPr lang="en-US" dirty="0"/>
-              <a:t>The third experiment is a use of the dataset, not a test of it: what must a catalog of clamps cover? Our paper's two-size catalog attaches 11.6 percent of the pipes, with an interval of 10 to 13, all one size, DN40. Load is never the limit, and trays, ducts and conduits aren't covered at all. On the right is what the dataset asks of any catalog: two well-placed sizes could attach 43 percent, six sizes 80, twelve sizes every pipe. So 'what should the catalog contain' becomes a measurement. (6:25)</a:t>
+              <a:t>The third analysis is a use of the dataset, not a test of it: what must a catalog of clamps cover? Our paper's two-size catalog attaches 11.6 percent of the pipes, with an interval of 10 to 13, all one size, DN40. Load is never the limit, and trays, ducts and conduits aren't covered at all. On the right is what the dataset asks of any catalog: two well-placed sizes could attach 43 percent, six sizes 80, twelve sizes every pipe. So 'what should the catalog contain' becomes a measurement. (6:15)</a:t>
             </a:r>
             <a:endParaRPr lang="en-US" dirty="0"/>
           </a:p>
@@ -2323,7 +2323,7 @@
           <a:p>
             <a:r>
               <a:rPr lang="en-US" dirty="0"/>
-              <a:t>Let me show it. This is the Generator Studio. I choose what crosses the hanger, a tier or an exact mix, and a seed. Out comes the section a support designer receives, drawn the way an engineer would issue it: every service at true size, its level below the slab, its load, the closest clear gap, and the same run in 3D. Every section is a stored output of the released generator, with the Python call that reproduces it. Scan the code to try it yourself. [Live: switch to the studio, click C3, then Generate another twice, then Exact mix with a duct. If the demo fails, stay on this slide; slide 17 shows two more sections. Before the talk: open the studio once with internet, set its link sharing to public, scan the QR from a phone not logged in.] (7:05)</a:t>
+              <a:t>Let me show it. This is the Generator Studio. I choose what crosses the hanger, a tier or an exact mix, and a seed. Out comes the section a support designer receives, drawn the way an engineer would issue it: every service at true size, its level below the slab, its load, the closest clear gap, and the same run in 3D. Every section is a stored output of the released generator, with the Python call that reproduces it. Scan the code to try it yourself. [Live: switch to the studio, click C3, then Generate another twice, then Exact mix with a duct. If the demo fails, stay on this slide; slide 17 shows two more sections. Before the talk: open the studio once with internet, set its link sharing to public, scan the QR from a phone not logged in.] (6:55)</a:t>
             </a:r>
             <a:endParaRPr lang="en-US" dirty="0"/>
           </a:p>
@@ -2411,7 +2411,7 @@
           <a:p>
             <a:r>
               <a:rPr lang="en-US" dirty="0"/>
-              <a:t>Using it takes a few lines: load a split, filter by composition, or generate your own mix. Because there are no labels, the same files serve reinforcement learning, constraint programming, and benchmarking people. We ship the scoring too. Train on the generator, from C1 up to C8. Evaluate on the benchmark, the same 125 contexts per tier for every method. Report per tier, with 95 percent intervals and paired tests. (8:15)</a:t>
+              <a:t>Using it takes a few lines: load a split, filter by composition, or generate your own mix. Because there are no labels, the same files serve reinforcement learning, constraint programming, and benchmarking people. We ship the scoring too. Train on the generator, from C1 up to C8. Evaluate on the benchmark, the same 125 contexts per tier for every method. Report per tier, with 95 percent intervals and paired tests. (8:05)</a:t>
             </a:r>
             <a:endParaRPr lang="en-US" dirty="0"/>
           </a:p>
@@ -2499,7 +2499,7 @@
           <a:p>
             <a:r>
               <a:rPr lang="en-US" dirty="0"/>
-              <a:t>A word on scope. CrossMEP is one section at one support. Routing and branches are outside it, but the span is recorded, so a method can vary it. Pipe spacing was checked on two open buildings; the rest rests on practice and standards, and the trade mix is a design choice. It's not for structural design of real installations. Next: a public checker, with best-known costs, so we can compare methods on the answer; the catalog as an input; and a real test set from commercial projects, with supports designed by engineers. That's where I'd value your eye. (8:45)</a:t>
+              <a:t>A word on scope. CrossMEP is one section at one support. Routing and branches are outside it, but the span is recorded, so a method can vary it. Pipe spacing was checked on two open buildings; the rest rests on practice and standards, and the trade mix is a design choice. It's not for structural design of real installations. Next: a public checker, with best-known costs, so we can compare methods on the answer; the catalog as an input; and a real test set from commercial projects, with supports designed by engineers. That's where I'd value your eye. (8:35)</a:t>
             </a:r>
             <a:endParaRPr lang="en-US" dirty="0"/>
           </a:p>
@@ -2587,7 +2587,7 @@
           <a:p>
             <a:r>
               <a:rPr lang="en-US" dirty="0"/>
-              <a:t>To sum up: CrossMEP is the brief, not the answer. Seven thousand support-design problems, every constant sourced or declared a design choice, pipe spacing checked on two open buildings, and all of it open. If you coordinate services or design supports, try the studio and tell me what looks wrong. Thank you. (9:25)</a:t>
+              <a:t>To sum up: CrossMEP is the brief, not the answer. Seven thousand support-design problems, every constant sourced or declared a design choice, pipe spacing checked on two open buildings, and all of it open. If you coordinate services or design supports, try the studio and tell me what looks wrong. Thank you. (9:15)</a:t>
             </a:r>
             <a:endParaRPr lang="en-US" dirty="0"/>
           </a:p>
@@ -3555,7 +3555,7 @@
           <a:p>
             <a:r>
               <a:rPr lang="en-US" dirty="0"/>
-              <a:t>Where do the numbers come from? Each comes from a cited source or is declared a design choice. Pipes follow the European steel pipe standards, filled with water, at ASME B31.1 spans. Insulation follows the German GEG, and a condensation schedule for chilled water. Trays and conduits follow IEC standards, ducts European sizes with a manufacturer's weight table. Loads are computed in code, and pure choices, like the trade mix, are labeled as choices. (3:35)</a:t>
+              <a:t>Where do the numbers come from? Three places. Sizes, weights and spans come from standards: European steel pipe and duct standards, IEC for conduits and trays, ASME for spans, the German GEG for insulation. How close neighbors sit comes from measured open buildings. And a few things are simply our choices, like the trade mix, and we label them that way. Loads are computed in code from all of this. (3:35)</a:t>
             </a:r>
             <a:endParaRPr lang="en-US" dirty="0"/>
           </a:p>
@@ -3643,7 +3643,7 @@
           <a:p>
             <a:r>
               <a:rPr lang="en-US" dirty="0"/>
-              <a:t>The release has four splits on disjoint seeds, so a method is never tested on what it trained on: five thousand contexts for training, five hundred each for validation and test, and a benchmark of one thousand, a hundred and twenty-five per tier. Mostly pipes, then conduits, trays and ducts. Four in five hang from a ceiling, one in five from a wall. Everything is plain JSON with a schema and a datasheet. (4:05)</a:t>
+              <a:t>The release has four splits on disjoint seeds, so a method is never tested on what it trained on: five thousand contexts for training, five hundred each for validation and test, and a benchmark of one thousand, a hundred and twenty-five per tier. Everything is plain JSON with a schema and a datasheet. (4:05)</a:t>
             </a:r>
             <a:endParaRPr lang="en-US" dirty="0"/>
           </a:p>
@@ -3731,7 +3731,7 @@
           <a:p>
             <a:r>
               <a:rPr lang="en-US" dirty="0"/>
-              <a:t>Here's one benchmark context per tier. C1 is a single element, the most common support in any building. By C8 you have eight services on three rows. Within a tier everything else varies: kinds, trades, surfaces, stacking. So the element count is the one controlled axis of difficulty. And notice the walls: the section rotates, and electrical sits above water. (4:35)</a:t>
+              <a:t>Here's one benchmark context per tier. C1 is a single element, the most common support in any building. By C8 you have eight services on three rows. Within a tier everything else varies: kinds, trades, surfaces, stacking. So the element count is the one controlled axis of difficulty. And notice the walls: the section rotates, and electrical sits above water. (4:25)</a:t>
             </a:r>
             <a:endParaRPr lang="en-US" dirty="0"/>
           </a:p>
@@ -24624,7 +24624,7 @@
                   <a:schemeClr val="tx1"/>
                 </a:solidFill>
               </a:rPr>
-              <a:t>Every constant carries a source and a status (verified, practice-cited, or a declared design choice) in the repository. Loads are derived in code from those sources, so each number can be traced and checked.</a:t>
+              <a:t>Three kinds of ground: standards (what each element is and weighs), measured open buildings (how close neighbours sit) and declared design choices (trade mix, surface mix, number of rows). Every constant carries its source and status in the repository.</a:t>
             </a:r>
             <a:endParaRPr lang="en-US" sz="1300" dirty="0"/>
           </a:p>

</xml_diff>

<commit_message>
Verification log: cite the standards behind spans, tray widths and the wall rule; say why each standard was chosen
No value changes; data byte-identical (196 tests pass). Tray widths are the
NEMA VE 1 series; pipe spans confirmed by the ASHRAE Handbook table; conduit
span from the IET On-Site Guide table under BS 7671; wall rule from BS 7671
Reg. 528.3.2; tray and duct spans bracketed by NEMA VE 1 and SMACNA Table 5-1.
New sections 10 (selection rules, alternatives not used) and 11 (public
sources); deferred value changes listed in section 9. Code comments, README,
DATASHEET, TALK Q&A, slide 7 and CHANGELOG updated; deck and PDF rebuilt.

Co-Authored-By: Claude Fable 5.1 <noreply@anthropic.com>
Claude-Session: https://claude.ai/code/session_01R1ft1rokeRJHR95rzLxNEC
</commit_message>
<xml_diff>
--- a/docs/CrossMEP_CIBW78_talk.pptx
+++ b/docs/CrossMEP_CIBW78_talk.pptx
@@ -127,19 +127,19 @@
   <p:extLst>
     <p:ext uri="{521415D9-36F7-43E2-AB2F-B90AF26B5E84}">
       <p14:sectionLst xmlns:p14="http://schemas.microsoft.com/office/powerpoint/2010/main">
-        <p14:section name="Opening" id="{f619b1dd-9bde-542a-de63-f1b60ef8eebb}">
+        <p14:section name="Opening" id="{cd55ca8e-65ae-d9cc-cbde-8d694977a650}">
           <p14:sldIdLst>
             <p14:sldId id="256"/>
           </p14:sldIdLst>
         </p14:section>
-        <p14:section name="Motivation" id="{bc2681ef-5355-a865-9fac-73b550e01649}">
+        <p14:section name="Motivation" id="{398e56f7-b272-22ad-397b-1c63fb8deb7d}">
           <p14:sldIdLst>
             <p14:sldId id="257"/>
             <p14:sldId id="258"/>
             <p14:sldId id="259"/>
           </p14:sldIdLst>
         </p14:section>
-        <p14:section name="The dataset" id="{7e3d5f0c-e114-ec5d-91ea-19b92d958cf5}">
+        <p14:section name="The dataset" id="{0f711070-7125-3e0f-fbc5-3ef5ce34b63c}">
           <p14:sldIdLst>
             <p14:sldId id="260"/>
             <p14:sldId id="261"/>
@@ -148,14 +148,14 @@
             <p14:sldId id="264"/>
           </p14:sldIdLst>
         </p14:section>
-        <p14:section name="Experiments" id="{227babb1-eddf-d202-4db9-5141d570910b}">
+        <p14:section name="Experiments" id="{7454a8f7-c38c-5428-c566-a382a6171289}">
           <p14:sldIdLst>
             <p14:sldId id="265"/>
             <p14:sldId id="266"/>
             <p14:sldId id="267"/>
           </p14:sldIdLst>
         </p14:section>
-        <p14:section name="Use" id="{380cd82d-b7dd-f40a-864f-1c98181bbe3d}">
+        <p14:section name="Use" id="{b954cbcf-8d57-270e-3fd0-5d5b8327e0fe}">
           <p14:sldIdLst>
             <p14:sldId id="268"/>
             <p14:sldId id="269"/>
@@ -163,7 +163,7 @@
             <p14:sldId id="271"/>
           </p14:sldIdLst>
         </p14:section>
-        <p14:section name="Appendix" id="{a007e22d-99f7-c498-1b46-2a31c895fc5c}">
+        <p14:section name="Appendix" id="{20d71cb3-5a9d-b9f6-85a9-517588e27e90}">
           <p14:sldIdLst>
             <p14:sldId id="272"/>
             <p14:sldId id="273"/>
@@ -23912,7 +23912,7 @@
                           <a:ea typeface="Calibri" pitchFamily="34" charset="-122"/>
                           <a:cs typeface="Calibri" pitchFamily="34" charset="-120"/>
                         </a:rPr>
-                        <a:t>IEC 61537 systems</a:t>
+                        <a:t>IEC 61537 systems, NEMA VE 1 widths</a:t>
                       </a:r>
                       <a:endParaRPr lang="en-US" sz="1200" dirty="0">
                         <a:latin typeface="Calibri" charset="0"/>
@@ -23977,7 +23977,7 @@
                           <a:ea typeface="Calibri" pitchFamily="34" charset="-122"/>
                           <a:cs typeface="Calibri" pitchFamily="34" charset="-120"/>
                         </a:rPr>
-                        <a:t>full tray: 50 kg/m at 300 mm datum, × 2.0 m</a:t>
+                        <a:t>full tray: 50 kg/m at 300 mm datum, × 2.0 m (NEMA VE 1 class span)</a:t>
                       </a:r>
                       <a:endParaRPr lang="en-US" sz="1200" dirty="0">
                         <a:latin typeface="Calibri" charset="0"/>
@@ -24174,7 +24174,7 @@
                           <a:ea typeface="Calibri" pitchFamily="34" charset="-122"/>
                           <a:cs typeface="Calibri" pitchFamily="34" charset="-120"/>
                         </a:rPr>
-                        <a:t>manufacturer duct-weight table incl. flanges, × 2.4 m</a:t>
+                        <a:t>manufacturer duct-weight table incl. flanges, × 2.4 m (SMACNA)</a:t>
                       </a:r>
                       <a:endParaRPr lang="en-US" sz="1200" dirty="0">
                         <a:latin typeface="Calibri" charset="0"/>
@@ -24371,7 +24371,7 @@
                           <a:ea typeface="Calibri" pitchFamily="34" charset="-122"/>
                           <a:cs typeface="Calibri" pitchFamily="34" charset="-120"/>
                         </a:rPr>
-                        <a:t>steel tube + 40 %-of-bore cable fill, × 2.0 m</a:t>
+                        <a:t>steel tube + 40 %-of-bore cable fill, × 2.0 m (IET / BS 7671)</a:t>
                       </a:r>
                       <a:endParaRPr lang="en-US" sz="1200" dirty="0">
                         <a:latin typeface="Calibri" charset="0"/>
@@ -24530,7 +24530,7 @@
                   <a:schemeClr val="tx1"/>
                 </a:solidFill>
               </a:rPr>
-              <a:t>Electrical kept above wet services on walls (drip)</a:t>
+              <a:t>Electrical kept above wet services on walls (drip; BS 7671 528.3.2)</a:t>
             </a:r>
             <a:endParaRPr lang="en-US" sz="1300" dirty="0"/>
           </a:p>
@@ -24624,7 +24624,7 @@
                   <a:schemeClr val="tx1"/>
                 </a:solidFill>
               </a:rPr>
-              <a:t>Three kinds of ground: standards (what each element is and weighs), measured open buildings (how close neighbours sit) and declared design choices (trade mix, surface mix, number of rows). Every constant carries its source and status in the repository.</a:t>
+              <a:t>Three kinds of ground: standards (what each element is and weighs), measured open buildings (how close neighbours sit) and declared design choices (trade mix, surface mix, number of rows). Every constant carries its source and status in the repository, and the log says why each standard was chosen over its alternatives.</a:t>
             </a:r>
             <a:endParaRPr lang="en-US" sz="1300" dirty="0"/>
           </a:p>

</xml_diff>

<commit_message>
Data revision 4.1: composition adjusted after the open-building comparison; DN125 and DN150
Revision.composition selects the parameter set, so 3.0 and 4.0 regenerate
byte-for-byte as before. 4.1 draws the number of rows by element count,
repeats the previous kind with probability 0.5, offers duct pairs and widens
the DN bands (DN125/150 added to the library: EN 10255 medium 5.0 mm wall,
ASME NPS 6 span). On the clinic the composition is now within TV 0.13 by
count with mixing and stacking close (in sample, reported as a design check);
spacing stays held out (clinic 32 mm, 4.0: 28). Benchmark: 2,488 pipes, 485
ducts, 19 % stacked, catalog coverage 14.5 %.

Files under data/v4.1, checksums, croissant, galleries; scripts/make_results.py
assembles RESULTS.md; figures, studio, deck, talk and read-aloud script rebuilt
on 4.1; README, DATASHEET, VERIFICATION_LOG, CHANGELOG, CITATION, version
4.1.0. Tests: paper-era pins kept on the 4.0 files (benchmark_v40), 4.1 pins
added; 227 pass.
</commit_message>
<xml_diff>
--- a/docs/CrossMEP_CIBW78_talk.pptx
+++ b/docs/CrossMEP_CIBW78_talk.pptx
@@ -127,19 +127,19 @@
   <p:extLst>
     <p:ext uri="{521415D9-36F7-43E2-AB2F-B90AF26B5E84}">
       <p14:sectionLst xmlns:p14="http://schemas.microsoft.com/office/powerpoint/2010/main">
-        <p14:section name="Opening" id="{cd55ca8e-65ae-d9cc-cbde-8d694977a650}">
+        <p14:section name="Opening" id="{3ecd03bf-27e8-cac9-d6fc-a4c6572562ce}">
           <p14:sldIdLst>
             <p14:sldId id="256"/>
           </p14:sldIdLst>
         </p14:section>
-        <p14:section name="Motivation" id="{398e56f7-b272-22ad-397b-1c63fb8deb7d}">
+        <p14:section name="Motivation" id="{47d5fc43-069d-ad00-3223-c7cb4e1e356f}">
           <p14:sldIdLst>
             <p14:sldId id="257"/>
             <p14:sldId id="258"/>
             <p14:sldId id="259"/>
           </p14:sldIdLst>
         </p14:section>
-        <p14:section name="The dataset" id="{0f711070-7125-3e0f-fbc5-3ef5ce34b63c}">
+        <p14:section name="The dataset" id="{cf077af1-df7b-ee94-fe34-93b4edc9517d}">
           <p14:sldIdLst>
             <p14:sldId id="260"/>
             <p14:sldId id="261"/>
@@ -148,14 +148,14 @@
             <p14:sldId id="264"/>
           </p14:sldIdLst>
         </p14:section>
-        <p14:section name="Experiments" id="{7454a8f7-c38c-5428-c566-a382a6171289}">
+        <p14:section name="Experiments" id="{6f77a037-3f3e-cf5c-b7be-10f2ed2d4500}">
           <p14:sldIdLst>
             <p14:sldId id="265"/>
             <p14:sldId id="266"/>
             <p14:sldId id="267"/>
           </p14:sldIdLst>
         </p14:section>
-        <p14:section name="Use" id="{b954cbcf-8d57-270e-3fd0-5d5b8327e0fe}">
+        <p14:section name="Use" id="{50420905-d810-d3e8-c453-8db36bb35d74}">
           <p14:sldIdLst>
             <p14:sldId id="268"/>
             <p14:sldId id="269"/>
@@ -163,7 +163,7 @@
             <p14:sldId id="271"/>
           </p14:sldIdLst>
         </p14:section>
-        <p14:section name="Appendix" id="{20d71cb3-5a9d-b9f6-85a9-517588e27e90}">
+        <p14:section name="Appendix" id="{f19a98a8-2692-b28d-8571-0f5c497b70f5}">
           <p14:sldIdLst>
             <p14:sldId id="272"/>
             <p14:sldId id="273"/>
@@ -296,16 +296,16 @@
                 <c:formatCode>General</c:formatCode>
                 <c:ptCount val="4"/>
                 <c:pt idx="0">
-                  <c:v>17984</c:v>
+                  <c:v>17573</c:v>
                 </c:pt>
                 <c:pt idx="1">
-                  <c:v>7617</c:v>
+                  <c:v>6257</c:v>
                 </c:pt>
                 <c:pt idx="2">
-                  <c:v>3975</c:v>
+                  <c:v>4237</c:v>
                 </c:pt>
                 <c:pt idx="3">
-                  <c:v>1908</c:v>
+                  <c:v>3417</c:v>
                 </c:pt>
               </c:numCache>
             </c:numRef>
@@ -533,9 +533,9 @@
           </c:dLbls>
           <c:cat>
             <c:multiLvlStrRef>
-              <c:f>Sheet1!$A$2:$A$10</c:f>
+              <c:f>Sheet1!$A$2:$A$12</c:f>
               <c:multiLvlStrCache>
-                <c:ptCount val="9"/>
+                <c:ptCount val="11"/>
                 <c:lvl>
                   <c:pt idx="0">
                     <c:v>DN15</c:v>
@@ -564,42 +564,54 @@
                   <c:pt idx="8">
                     <c:v>DN100</c:v>
                   </c:pt>
+                  <c:pt idx="9">
+                    <c:v>DN125</c:v>
+                  </c:pt>
+                  <c:pt idx="10">
+                    <c:v>DN150</c:v>
+                  </c:pt>
                 </c:lvl>
               </c:multiLvlStrCache>
             </c:multiLvlStrRef>
           </c:cat>
           <c:val>
             <c:numRef>
-              <c:f>Sheet1!$B$2:$B$10</c:f>
+              <c:f>Sheet1!$B$2:$B$12</c:f>
               <c:numCache>
                 <c:formatCode>General</c:formatCode>
-                <c:ptCount val="9"/>
+                <c:ptCount val="11"/>
                 <c:pt idx="0">
-                  <c:v>1495</c:v>
+                  <c:v>959</c:v>
                 </c:pt>
                 <c:pt idx="1">
-                  <c:v>2415</c:v>
+                  <c:v>1654</c:v>
                 </c:pt>
                 <c:pt idx="2">
-                  <c:v>3399</c:v>
+                  <c:v>2503</c:v>
                 </c:pt>
                 <c:pt idx="3">
-                  <c:v>3431</c:v>
+                  <c:v>2443</c:v>
                 </c:pt>
                 <c:pt idx="4">
-                  <c:v>1924</c:v>
+                  <c:v>2512</c:v>
                 </c:pt>
                 <c:pt idx="5">
-                  <c:v>1777</c:v>
+                  <c:v>2276</c:v>
                 </c:pt>
                 <c:pt idx="6">
-                  <c:v>1804</c:v>
+                  <c:v>1308</c:v>
                 </c:pt>
                 <c:pt idx="7">
-                  <c:v>865</c:v>
+                  <c:v>1313</c:v>
                 </c:pt>
                 <c:pt idx="8">
-                  <c:v>874</c:v>
+                  <c:v>1348</c:v>
+                </c:pt>
+                <c:pt idx="9">
+                  <c:v>635</c:v>
+                </c:pt>
+                <c:pt idx="10">
+                  <c:v>622</c:v>
                 </c:pt>
               </c:numCache>
             </c:numRef>
@@ -852,9 +864,9 @@
           </c:dLbls>
           <c:cat>
             <c:multiLvlStrRef>
-              <c:f>Sheet1!$A$2:$A$10</c:f>
+              <c:f>Sheet1!$A$2:$A$12</c:f>
               <c:multiLvlStrCache>
-                <c:ptCount val="9"/>
+                <c:ptCount val="11"/>
                 <c:lvl>
                   <c:pt idx="0">
                     <c:v>DN15</c:v>
@@ -883,16 +895,22 @@
                   <c:pt idx="8">
                     <c:v>DN100</c:v>
                   </c:pt>
+                  <c:pt idx="9">
+                    <c:v>DN125</c:v>
+                  </c:pt>
+                  <c:pt idx="10">
+                    <c:v>DN150</c:v>
+                  </c:pt>
                 </c:lvl>
               </c:multiLvlStrCache>
             </c:multiLvlStrRef>
           </c:cat>
           <c:val>
             <c:numRef>
-              <c:f>Sheet1!$B$2:$B$10</c:f>
+              <c:f>Sheet1!$B$2:$B$12</c:f>
               <c:numCache>
                 <c:formatCode>General</c:formatCode>
-                <c:ptCount val="9"/>
+                <c:ptCount val="11"/>
                 <c:pt idx="0">
                   <c:v>0</c:v>
                 </c:pt>
@@ -906,7 +924,7 @@
                   <c:v>0</c:v>
                 </c:pt>
                 <c:pt idx="4">
-                  <c:v>293</c:v>
+                  <c:v>360</c:v>
                 </c:pt>
                 <c:pt idx="5">
                   <c:v>0</c:v>
@@ -918,6 +936,12 @@
                   <c:v>0</c:v>
                 </c:pt>
                 <c:pt idx="8">
+                  <c:v>0</c:v>
+                </c:pt>
+                <c:pt idx="9">
+                  <c:v>0</c:v>
+                </c:pt>
+                <c:pt idx="10">
                   <c:v>0</c:v>
                 </c:pt>
               </c:numCache>
@@ -972,9 +996,9 @@
           </c:dLbls>
           <c:cat>
             <c:multiLvlStrRef>
-              <c:f>Sheet1!$A$2:$A$10</c:f>
+              <c:f>Sheet1!$A$2:$A$12</c:f>
               <c:multiLvlStrCache>
-                <c:ptCount val="9"/>
+                <c:ptCount val="11"/>
                 <c:lvl>
                   <c:pt idx="0">
                     <c:v>DN15</c:v>
@@ -1003,42 +1027,54 @@
                   <c:pt idx="8">
                     <c:v>DN100</c:v>
                   </c:pt>
+                  <c:pt idx="9">
+                    <c:v>DN125</c:v>
+                  </c:pt>
+                  <c:pt idx="10">
+                    <c:v>DN150</c:v>
+                  </c:pt>
                 </c:lvl>
               </c:multiLvlStrCache>
             </c:multiLvlStrRef>
           </c:cat>
           <c:val>
             <c:numRef>
-              <c:f>Sheet1!$C$2:$C$10</c:f>
+              <c:f>Sheet1!$C$2:$C$12</c:f>
               <c:numCache>
                 <c:formatCode>General</c:formatCode>
-                <c:ptCount val="9"/>
+                <c:ptCount val="11"/>
                 <c:pt idx="0">
-                  <c:v>221</c:v>
+                  <c:v>137</c:v>
                 </c:pt>
                 <c:pt idx="1">
-                  <c:v>294</c:v>
+                  <c:v>239</c:v>
                 </c:pt>
                 <c:pt idx="2">
-                  <c:v>523</c:v>
+                  <c:v>390</c:v>
                 </c:pt>
                 <c:pt idx="3">
-                  <c:v>463</c:v>
+                  <c:v>335</c:v>
                 </c:pt>
                 <c:pt idx="4">
                   <c:v>0</c:v>
                 </c:pt>
                 <c:pt idx="5">
-                  <c:v>245</c:v>
+                  <c:v>316</c:v>
                 </c:pt>
                 <c:pt idx="6">
-                  <c:v>250</c:v>
+                  <c:v>190</c:v>
                 </c:pt>
                 <c:pt idx="7">
-                  <c:v>117</c:v>
+                  <c:v>160</c:v>
                 </c:pt>
                 <c:pt idx="8">
-                  <c:v>123</c:v>
+                  <c:v>188</c:v>
+                </c:pt>
+                <c:pt idx="9">
+                  <c:v>85</c:v>
+                </c:pt>
+                <c:pt idx="10">
+                  <c:v>88</c:v>
                 </c:pt>
               </c:numCache>
             </c:numRef>
@@ -1309,9 +1345,9 @@
           </c:dLbls>
           <c:cat>
             <c:multiLvlStrRef>
-              <c:f>Sheet1!$A$2:$A$13</c:f>
+              <c:f>Sheet1!$A$2:$A$16</c:f>
               <c:multiLvlStrCache>
-                <c:ptCount val="12"/>
+                <c:ptCount val="15"/>
                 <c:lvl>
                   <c:pt idx="0">
                     <c:v>1</c:v>
@@ -1349,50 +1385,68 @@
                   <c:pt idx="11">
                     <c:v>12</c:v>
                   </c:pt>
+                  <c:pt idx="12">
+                    <c:v>13</c:v>
+                  </c:pt>
+                  <c:pt idx="13">
+                    <c:v>14</c:v>
+                  </c:pt>
+                  <c:pt idx="14">
+                    <c:v>15</c:v>
+                  </c:pt>
                 </c:lvl>
               </c:multiLvlStrCache>
             </c:multiLvlStrRef>
           </c:cat>
           <c:val>
             <c:numRef>
-              <c:f>Sheet1!$B$2:$B$13</c:f>
+              <c:f>Sheet1!$B$2:$B$16</c:f>
               <c:numCache>
                 <c:formatCode>General</c:formatCode>
-                <c:ptCount val="12"/>
+                <c:ptCount val="15"/>
                 <c:pt idx="0">
-                  <c:v>22.61763542902333</c:v>
+                  <c:v>22.95016077170418</c:v>
                 </c:pt>
                 <c:pt idx="1">
-                  <c:v>42.981415579280345</c:v>
+                  <c:v>38.062700964630224</c:v>
                 </c:pt>
                 <c:pt idx="2">
-                  <c:v>60.41913799920918</c:v>
+                  <c:v>50.643086816720256</c:v>
                 </c:pt>
                 <c:pt idx="3">
-                  <c:v>67.69474100434955</c:v>
+                  <c:v>60.4903536977492</c:v>
                 </c:pt>
                 <c:pt idx="4">
-                  <c:v>74.06089363384737</c:v>
+                  <c:v>68.72990353697749</c:v>
                 </c:pt>
                 <c:pt idx="5">
-                  <c:v>80.11071569790431</c:v>
+                  <c:v>76.20578778135048</c:v>
                 </c:pt>
                 <c:pt idx="6">
-                  <c:v>84.53934361407671</c:v>
+                  <c:v>81.39067524115755</c:v>
                 </c:pt>
                 <c:pt idx="7">
-                  <c:v>88.1771451166469</c:v>
+                  <c:v>85.20900321543408</c:v>
                 </c:pt>
                 <c:pt idx="8">
-                  <c:v>91.73586397785687</c:v>
+                  <c:v>87.78135048231512</c:v>
                 </c:pt>
                 <c:pt idx="9">
-                  <c:v>95.25504151838672</c:v>
+                  <c:v>90.23311897106109</c:v>
                 </c:pt>
                 <c:pt idx="10">
-                  <c:v>98.69513641755634</c:v>
+                  <c:v>92.60450160771704</c:v>
                 </c:pt>
                 <c:pt idx="11">
+                  <c:v>94.85530546623794</c:v>
+                </c:pt>
+                <c:pt idx="12">
+                  <c:v>96.90514469453376</c:v>
+                </c:pt>
+                <c:pt idx="13">
+                  <c:v>98.95498392282958</c:v>
+                </c:pt>
+                <c:pt idx="14">
                   <c:v>100</c:v>
                 </c:pt>
               </c:numCache>
@@ -2059,7 +2113,7 @@
           <a:p>
             <a:r>
               <a:rPr lang="en-US" dirty="0"/>
-              <a:t>Now three analyses. The first is a design check, not a discovery: does difficulty grow with the tier? The count is fixed by construction, and load and congestion follow from the rules, so this shows the dataset behaves as designed. The load at the support rises at every step, from 0.1 to 1.7 kilonewtons. The closest gap shrinks from 120 to about 62 millimeters, but widens again at C6, where elements start stacking in two or three rows. So: report methods tier by tier. (4:50)</a:t>
+              <a:t>Now three analyses. The first is a design check, not a discovery: does difficulty grow with the tier? The count is fixed by construction, and load and congestion follow from the rules, so this shows the dataset behaves as designed. The load at the support rises with the tier, from about 0.3 to 2.0 kilonewtons. The closest gap narrows at every step, from 130 to about 51 millimeters. So: report methods tier by tier. (4:50)</a:t>
             </a:r>
             <a:endParaRPr lang="en-US" dirty="0"/>
           </a:p>
@@ -2147,7 +2201,7 @@
           <a:p>
             <a:r>
               <a:rPr lang="en-US" dirty="0"/>
-              <a:t>The second analysis is the one the generator could fail. Is the spacing realistic in a building it has never seen? The gap distribution was fitted on a residential duplex. We kept a second open building aside, a medical-dental clinic, cut it into sections every 250 millimeters, the way a context is defined, and measured the gaps between pipes running side by side. On the left, the clinic: generated gaps are close to measured ones, though not identical. On the right, the distances. Generator to clinic: 28 millimeters. That is above the 8 a perfect generator would show, so not a perfect match, but about as close as the duplex's own two models are to each other. A fixed 25-millimeter gap would be about 190 off. (5:25)</a:t>
+              <a:t>The second analysis is the one the generator could fail. Is the spacing realistic in a building it has never seen? The gap distribution was fitted on a residential duplex. We kept a second open building aside, a medical-dental clinic, cut it into sections every 250 millimeters, the way a context is defined, and measured the gaps between pipes running side by side. On the left, the clinic: generated gaps are close to measured ones, though not identical. On the right, the distances. Generator to clinic: 32 millimeters. That is above the 8 a perfect generator would show, so not a perfect match, but about as close as the duplex's own two models are to each other. A fixed 25-millimeter gap would be about 190 off. (5:20)</a:t>
             </a:r>
             <a:endParaRPr lang="en-US" dirty="0"/>
           </a:p>
@@ -2235,7 +2289,7 @@
           <a:p>
             <a:r>
               <a:rPr lang="en-US" dirty="0"/>
-              <a:t>The third analysis is a use of the dataset, not a test of it: what must a catalog of clamps cover? Our paper's two-size catalog attaches 11.6 percent of the pipes, with an interval of 10 to 13, all one size, DN40. Load is never the limit, and trays, ducts and conduits aren't covered at all. On the right is what the dataset asks of any catalog: two well-placed sizes could attach 43 percent, six sizes 80, twelve sizes every pipe. So 'what should the catalog contain' becomes a measurement. (6:15)</a:t>
+              <a:t>The third analysis is a use of the dataset, not a test of it: what must a catalog of clamps cover? Our paper's two-size catalog attaches 14.5 percent of the pipes, with an interval of 13 to 16, all one size, DN40. Load is never the limit, and trays, ducts and conduits aren't covered at all. On the right is what the dataset asks of any catalog: two well-placed sizes could attach 38 percent, six sizes 76, fifteen sizes every pipe. So 'what should the catalog contain' becomes a measurement. (6:10)</a:t>
             </a:r>
             <a:endParaRPr lang="en-US" dirty="0"/>
           </a:p>
@@ -2323,7 +2377,7 @@
           <a:p>
             <a:r>
               <a:rPr lang="en-US" dirty="0"/>
-              <a:t>Let me show it. This is the Generator Studio. I choose what crosses the hanger, a tier or an exact mix, and a seed. Out comes the section a support designer receives, drawn the way an engineer would issue it: every service at true size, its level below the slab, its load, the closest clear gap, and the same run in 3D. Every section is a stored output of the released generator, with the Python call that reproduces it. Scan the code to try it yourself. [Live: switch to the studio, click C3, then Generate another twice, then Exact mix with a duct. If the demo fails, stay on this slide; slide 17 shows two more sections. Before the talk: open the studio once with internet, set its link sharing to public, scan the QR from a phone not logged in.] (6:55)</a:t>
+              <a:t>Let me show it. This is the Generator Studio. I choose what crosses the hanger, a tier or an exact mix, and a seed. Out comes the section a support designer receives, drawn the way an engineer would issue it: every service at true size, its level below the slab, its load, the closest clear gap, and the same run in 3D. Every section is a stored output of the released generator, with the Python call that reproduces it. Scan the code to try it yourself. [Live: switch to the studio, click C3, then Generate another twice, then Exact mix with a duct. If the demo fails, stay on this slide; slide 17 shows two more sections. Before the talk: open the studio once with internet, set its link sharing to public, scan the QR from a phone not logged in.] (6:50)</a:t>
             </a:r>
             <a:endParaRPr lang="en-US" dirty="0"/>
           </a:p>
@@ -2411,7 +2465,7 @@
           <a:p>
             <a:r>
               <a:rPr lang="en-US" dirty="0"/>
-              <a:t>Using it takes a few lines: load a split, filter by composition, or generate your own mix. Because there are no labels, the same files serve reinforcement learning, constraint programming, and benchmarking people. We ship the scoring too. Train on the generator, from C1 up to C8. Evaluate on the benchmark, the same 125 contexts per tier for every method. Report per tier, with 95 percent intervals and paired tests. (8:05)</a:t>
+              <a:t>Using it takes a few lines: load a split, filter by composition, or generate your own mix. Because there are no labels, the same files serve reinforcement learning, constraint programming, and benchmarking people. We ship the scoring too. Train on the generator, from C1 up to C8. Evaluate on the benchmark, the same 125 contexts per tier for every method. Report per tier, with 95 percent intervals and paired tests. (8:00)</a:t>
             </a:r>
             <a:endParaRPr lang="en-US" dirty="0"/>
           </a:p>
@@ -2499,7 +2553,7 @@
           <a:p>
             <a:r>
               <a:rPr lang="en-US" dirty="0"/>
-              <a:t>A word on scope. CrossMEP is one section at one support. Routing and branches are outside it, but the span is recorded, so a method can vary it. Pipe spacing was checked on two open buildings; the rest rests on practice and standards, and the trade mix is a design choice. It's not for structural design of real installations. Next: a public checker, with best-known costs, so we can compare methods on the answer; the catalog as an input; and a real test set from commercial projects, with supports designed by engineers. That's where I'd value your eye. (8:35)</a:t>
+              <a:t>A word on scope. CrossMEP is one section at one support. Routing and branches are outside it, but the span is recorded, so a method can vary it. Pipe spacing was checked on two open buildings; the rest rests on practice and standards, and the trade mix is a design choice. It's not for structural design of real installations. Next: a public checker, with best-known costs, so we can compare methods on the answer; the catalog as an input; and a real test set from commercial projects, with supports designed by engineers. That's where I'd value your eye. (8:30)</a:t>
             </a:r>
             <a:endParaRPr lang="en-US" dirty="0"/>
           </a:p>
@@ -2587,7 +2641,7 @@
           <a:p>
             <a:r>
               <a:rPr lang="en-US" dirty="0"/>
-              <a:t>To sum up: CrossMEP is the brief, not the answer. Seven thousand support-design problems, every constant sourced or declared a design choice, pipe spacing checked on two open buildings, and all of it open. If you coordinate services or design supports, try the studio and tell me what looks wrong. Thank you. (9:15)</a:t>
+              <a:t>To sum up: CrossMEP is the brief, not the answer. Seven thousand support-design problems, every constant sourced or declared a design choice, pipe spacing checked on two open buildings, and all of it open. If you coordinate services or design supports, try the studio and tell me what looks wrong. Thank you. (9:10)</a:t>
             </a:r>
             <a:endParaRPr lang="en-US" dirty="0"/>
           </a:p>
@@ -4857,7 +4911,7 @@
                   <a:schemeClr val="tx1"/>
                 </a:solidFill>
               </a:rPr>
-              <a:t>Higher tiers are heavier and, overall, tighter, as designed</a:t>
+              <a:t>Higher tiers are heavier and tighter, as designed</a:t>
             </a:r>
             <a:endParaRPr lang="en-US" sz="2600" dirty="0"/>
           </a:p>
@@ -4917,7 +4971,7 @@
                   <a:srgbClr val="52514E"/>
                 </a:solidFill>
               </a:rPr>
-              <a:t>A check that the dataset behaves as designed: the tier fixes the element count; load and congestion follow from the rules. Boxes: benchmark, 125 contexts per tier (IQR, whiskers 1.5 IQR); diamonds: medians of 2,000 generated contexts per tier. Load rises at every tier (rank correlation +0.56); the closest gap shrinks overall (−0.36) but widens at C6 (70 → 75 mm), where elements start to stack in two or three rows.</a:t>
+              <a:t>A check that the dataset behaves as designed: the tier fixes the element count; load and congestion follow from the rules. Boxes: benchmark, 125 contexts per tier (IQR, whiskers 1.5 IQR); diamonds: medians of 2,000 generated contexts per tier. Load rises with the tier (rank correlation +0.46; the population medians rise at every step) and the closest gap narrows at every step (−0.38; 149 → 55 mm in the population).</a:t>
             </a:r>
             <a:endParaRPr lang="en-US" sz="1250" dirty="0"/>
           </a:p>
@@ -5085,7 +5139,7 @@
                   <a:srgbClr val="52514E"/>
                 </a:solidFill>
               </a:rPr>
-              <a:t>The gap distribution was fitted on the duplex; the clinic was held out. Clear gaps between side-by-side pipes, on sections every 250 mm. Clinic (797 pipe pairs): 28 mm from the generated gaps (95 % CI 16–44), more than the 8 mm a perfect generator would show, and about as close as the duplex’s own two models are to each other (26 mm). Models: buildingSMART Duplex Apartment and Medical-Dental Clinic, CC BY 4.0.</a:t>
+              <a:t>The gap distribution was fitted on the duplex; the clinic was held out. Clear gaps between side-by-side pipes, on sections every 250 mm. Clinic (797 pipe pairs): 32 mm from the generated gaps (95 % CI 17–48), more than the 8 mm a perfect generator would show, and about as close as the duplex’s own two models are to each other (26 mm). Models: buildingSMART Duplex Apartment and Medical-Dental Clinic, CC BY 4.0.</a:t>
             </a:r>
             <a:endParaRPr lang="en-US" sz="1250" dirty="0"/>
           </a:p>
@@ -5193,7 +5247,7 @@
                   <a:schemeClr val="tx1"/>
                 </a:solidFill>
               </a:rPr>
-              <a:t>A two-size catalog attaches 1 pipe in 9; the dataset shows what to cover</a:t>
+              <a:t>A two-size catalog attaches 1 pipe in 7; the dataset shows what to cover</a:t>
             </a:r>
             <a:endParaRPr lang="en-US" sz="2600" dirty="0"/>
           </a:p>
@@ -5233,7 +5287,7 @@
       </p:graphicFrame>
       <p:sp>
         <p:nvSpPr>
-          <p:cNvPr id="5" name="tile of benchmark pipes attachable with the paper’s two sizes (95 % CI 10.1–13.0); every one is DN40"/>
+          <p:cNvPr id="5" name="tile of benchmark pipes attachable with the paper’s two sizes (95 % CI 12.7–16.2); every one is DN40"/>
           <p:cNvSpPr/>
           <p:nvPr/>
         </p:nvSpPr>
@@ -5255,7 +5309,7 @@
       </p:sp>
       <p:sp>
         <p:nvSpPr>
-          <p:cNvPr id="6" name="value of benchmark pipes attachable with the paper’s two sizes (95 % CI 10.1–13.0); every one is DN40"/>
+          <p:cNvPr id="6" name="value of benchmark pipes attachable with the paper’s two sizes (95 % CI 12.7–16.2); every one is DN40"/>
           <p:cNvSpPr txBox="1"/>
           <p:nvPr/>
         </p:nvSpPr>
@@ -5283,7 +5337,7 @@
                   <a:schemeClr val="accent1"/>
                 </a:solidFill>
               </a:rPr>
-              <a:t>11.6 %</a:t>
+              <a:t>14.5 %</a:t>
             </a:r>
             <a:endParaRPr lang="en-US" sz="3200" dirty="0"/>
           </a:p>
@@ -5291,7 +5345,7 @@
       </p:sp>
       <p:sp>
         <p:nvSpPr>
-          <p:cNvPr id="7" name="label of benchmark pipes attachable with the paper’s two sizes (95 % CI 10.1–13.0); every one is DN40"/>
+          <p:cNvPr id="7" name="label of benchmark pipes attachable with the paper’s two sizes (95 % CI 12.7–16.2); every one is DN40"/>
           <p:cNvSpPr txBox="1"/>
           <p:nvPr/>
         </p:nvSpPr>
@@ -5319,7 +5373,7 @@
                   <a:srgbClr val="52514E"/>
                 </a:solidFill>
               </a:rPr>
-              <a:t>of benchmark pipes attachable with the paper’s two sizes (95 % CI 10.1–13.0); every one is DN40</a:t>
+              <a:t>of benchmark pipes attachable with the paper’s two sizes (95 % CI 12.7–16.2); every one is DN40</a:t>
             </a:r>
             <a:endParaRPr lang="en-US" sz="1100" dirty="0"/>
           </a:p>
@@ -5327,7 +5381,7 @@
       </p:sp>
       <p:sp>
         <p:nvSpPr>
-          <p:cNvPr id="8" name="tile with two sizes placed where the pipes are; 80 % with six, and every pipe with 12"/>
+          <p:cNvPr id="8" name="tile with two sizes placed where the pipes are; 76 % with six, and every pipe with 15"/>
           <p:cNvSpPr/>
           <p:nvPr/>
         </p:nvSpPr>
@@ -5349,7 +5403,7 @@
       </p:sp>
       <p:sp>
         <p:nvSpPr>
-          <p:cNvPr id="9" name="value with two sizes placed where the pipes are; 80 % with six, and every pipe with 12"/>
+          <p:cNvPr id="9" name="value with two sizes placed where the pipes are; 76 % with six, and every pipe with 15"/>
           <p:cNvSpPr txBox="1"/>
           <p:nvPr/>
         </p:nvSpPr>
@@ -5377,7 +5431,7 @@
                   <a:schemeClr val="accent1"/>
                 </a:solidFill>
               </a:rPr>
-              <a:t>43.0 %</a:t>
+              <a:t>38.1 %</a:t>
             </a:r>
             <a:endParaRPr lang="en-US" sz="3200" dirty="0"/>
           </a:p>
@@ -5385,7 +5439,7 @@
       </p:sp>
       <p:sp>
         <p:nvSpPr>
-          <p:cNvPr id="10" name="label with two sizes placed where the pipes are; 80 % with six, and every pipe with 12"/>
+          <p:cNvPr id="10" name="label with two sizes placed where the pipes are; 76 % with six, and every pipe with 15"/>
           <p:cNvSpPr txBox="1"/>
           <p:nvPr/>
         </p:nvSpPr>
@@ -5413,7 +5467,7 @@
                   <a:srgbClr val="52514E"/>
                 </a:solidFill>
               </a:rPr>
-              <a:t>with two sizes placed where the pipes are; 80 % with six, and every pipe with 12</a:t>
+              <a:t>with two sizes placed where the pipes are; 76 % with six, and every pipe with 15</a:t>
             </a:r>
             <a:endParaRPr lang="en-US" sz="1100" dirty="0"/>
           </a:p>
@@ -5421,7 +5475,7 @@
       </p:sp>
       <p:sp>
         <p:nvSpPr>
-          <p:cNvPr id="11" name="tile trays, ducts and conduits: a pipe-clamp catalog defines no attachment. Load never binds (0.88 vs 2.5 kN)"/>
+          <p:cNvPr id="11" name="tile trays, ducts and conduits: a pipe-clamp catalog defines no attachment. Load never binds (1.97 vs 2.5 kN)"/>
           <p:cNvSpPr/>
           <p:nvPr/>
         </p:nvSpPr>
@@ -5443,7 +5497,7 @@
       </p:sp>
       <p:sp>
         <p:nvSpPr>
-          <p:cNvPr id="12" name="value trays, ducts and conduits: a pipe-clamp catalog defines no attachment. Load never binds (0.88 vs 2.5 kN)"/>
+          <p:cNvPr id="12" name="value trays, ducts and conduits: a pipe-clamp catalog defines no attachment. Load never binds (1.97 vs 2.5 kN)"/>
           <p:cNvSpPr txBox="1"/>
           <p:nvPr/>
         </p:nvSpPr>
@@ -5471,7 +5525,7 @@
                   <a:schemeClr val="accent1"/>
                 </a:solidFill>
               </a:rPr>
-              <a:t>0 of 1,971</a:t>
+              <a:t>0 of 2,012</a:t>
             </a:r>
             <a:endParaRPr lang="en-US" sz="3200" dirty="0"/>
           </a:p>
@@ -5479,7 +5533,7 @@
       </p:sp>
       <p:sp>
         <p:nvSpPr>
-          <p:cNvPr id="13" name="label trays, ducts and conduits: a pipe-clamp catalog defines no attachment. Load never binds (0.88 vs 2.5 kN)"/>
+          <p:cNvPr id="13" name="label trays, ducts and conduits: a pipe-clamp catalog defines no attachment. Load never binds (1.97 vs 2.5 kN)"/>
           <p:cNvSpPr txBox="1"/>
           <p:nvPr/>
         </p:nvSpPr>
@@ -5507,7 +5561,7 @@
                   <a:srgbClr val="52514E"/>
                 </a:solidFill>
               </a:rPr>
-              <a:t>trays, ducts and conduits: a pipe-clamp catalog defines no attachment. Load never binds (0.88 vs 2.5 kN)</a:t>
+              <a:t>trays, ducts and conduits: a pipe-clamp catalog defines no attachment. Load never binds (1.97 vs 2.5 kN)</a:t>
             </a:r>
             <a:endParaRPr lang="en-US" sz="1100" dirty="0"/>
           </a:p>
@@ -7514,7 +7568,7 @@
                   <a:schemeClr val="tx1"/>
                 </a:solidFill>
               </a:rPr>
-              <a:t>Median load rises from 0.10 kN at C1 to 1.71 kN at C8 as the gap narrows</a:t>
+              <a:t>Median load rises from 0.30 kN at C1 to 2.04 kN at C8 as the gap narrows</a:t>
             </a:r>
             <a:endParaRPr lang="en-US" sz="2600" dirty="0"/>
           </a:p>
@@ -8104,7 +8158,7 @@
                           <a:ea typeface="Calibri" pitchFamily="34" charset="-122"/>
                           <a:cs typeface="Calibri" pitchFamily="34" charset="-120"/>
                         </a:rPr>
-                        <a:t>0.10</a:t>
+                        <a:t>0.30</a:t>
                       </a:r>
                       <a:endParaRPr lang="en-US" sz="1200" dirty="0">
                         <a:latin typeface="Calibri" charset="0"/>
@@ -8169,7 +8223,7 @@
                           <a:ea typeface="Calibri" pitchFamily="34" charset="-122"/>
                           <a:cs typeface="Calibri" pitchFamily="34" charset="-120"/>
                         </a:rPr>
-                        <a:t>102</a:t>
+                        <a:t>140</a:t>
                       </a:r>
                       <a:endParaRPr lang="en-US" sz="1200" dirty="0">
                         <a:latin typeface="Calibri" charset="0"/>
@@ -8366,7 +8420,7 @@
                           <a:ea typeface="Calibri" pitchFamily="34" charset="-122"/>
                           <a:cs typeface="Calibri" pitchFamily="34" charset="-120"/>
                         </a:rPr>
-                        <a:t>120</a:t>
+                        <a:t>130</a:t>
                       </a:r>
                       <a:endParaRPr lang="en-US" sz="1200" dirty="0">
                         <a:latin typeface="Calibri" charset="0"/>
@@ -8431,7 +8485,7 @@
                           <a:ea typeface="Calibri" pitchFamily="34" charset="-122"/>
                           <a:cs typeface="Calibri" pitchFamily="34" charset="-120"/>
                         </a:rPr>
-                        <a:t>0.23</a:t>
+                        <a:t>0.24</a:t>
                       </a:r>
                       <a:endParaRPr lang="en-US" sz="1200" dirty="0">
                         <a:latin typeface="Calibri" charset="0"/>
@@ -8496,7 +8550,7 @@
                           <a:ea typeface="Calibri" pitchFamily="34" charset="-122"/>
                           <a:cs typeface="Calibri" pitchFamily="34" charset="-120"/>
                         </a:rPr>
-                        <a:t>344</a:t>
+                        <a:t>431</a:t>
                       </a:r>
                       <a:endParaRPr lang="en-US" sz="1200" dirty="0">
                         <a:latin typeface="Calibri" charset="0"/>
@@ -8693,7 +8747,7 @@
                           <a:ea typeface="Calibri" pitchFamily="34" charset="-122"/>
                           <a:cs typeface="Calibri" pitchFamily="34" charset="-120"/>
                         </a:rPr>
-                        <a:t>98</a:t>
+                        <a:t>89</a:t>
                       </a:r>
                       <a:endParaRPr lang="en-US" sz="1200" dirty="0">
                         <a:latin typeface="Calibri" charset="0"/>
@@ -8758,7 +8812,7 @@
                           <a:ea typeface="Calibri" pitchFamily="34" charset="-122"/>
                           <a:cs typeface="Calibri" pitchFamily="34" charset="-120"/>
                         </a:rPr>
-                        <a:t>0.44</a:t>
+                        <a:t>1.04</a:t>
                       </a:r>
                       <a:endParaRPr lang="en-US" sz="1200" dirty="0">
                         <a:latin typeface="Calibri" charset="0"/>
@@ -8823,7 +8877,7 @@
                           <a:ea typeface="Calibri" pitchFamily="34" charset="-122"/>
                           <a:cs typeface="Calibri" pitchFamily="34" charset="-120"/>
                         </a:rPr>
-                        <a:t>613</a:t>
+                        <a:t>776</a:t>
                       </a:r>
                       <a:endParaRPr lang="en-US" sz="1200" dirty="0">
                         <a:latin typeface="Calibri" charset="0"/>
@@ -9020,7 +9074,7 @@
                           <a:ea typeface="Calibri" pitchFamily="34" charset="-122"/>
                           <a:cs typeface="Calibri" pitchFamily="34" charset="-120"/>
                         </a:rPr>
-                        <a:t>90</a:t>
+                        <a:t>77</a:t>
                       </a:r>
                       <a:endParaRPr lang="en-US" sz="1200" dirty="0">
                         <a:latin typeface="Calibri" charset="0"/>
@@ -9085,7 +9139,7 @@
                           <a:ea typeface="Calibri" pitchFamily="34" charset="-122"/>
                           <a:cs typeface="Calibri" pitchFamily="34" charset="-120"/>
                         </a:rPr>
-                        <a:t>0.55</a:t>
+                        <a:t>0.94</a:t>
                       </a:r>
                       <a:endParaRPr lang="en-US" sz="1200" dirty="0">
                         <a:latin typeface="Calibri" charset="0"/>
@@ -9150,7 +9204,7 @@
                           <a:ea typeface="Calibri" pitchFamily="34" charset="-122"/>
                           <a:cs typeface="Calibri" pitchFamily="34" charset="-120"/>
                         </a:rPr>
-                        <a:t>728</a:t>
+                        <a:t>1037</a:t>
                       </a:r>
                       <a:endParaRPr lang="en-US" sz="1200" dirty="0">
                         <a:latin typeface="Calibri" charset="0"/>
@@ -9347,7 +9401,7 @@
                           <a:ea typeface="Calibri" pitchFamily="34" charset="-122"/>
                           <a:cs typeface="Calibri" pitchFamily="34" charset="-120"/>
                         </a:rPr>
-                        <a:t>73</a:t>
+                        <a:t>72</a:t>
                       </a:r>
                       <a:endParaRPr lang="en-US" sz="1200" dirty="0">
                         <a:latin typeface="Calibri" charset="0"/>
@@ -9412,7 +9466,7 @@
                           <a:ea typeface="Calibri" pitchFamily="34" charset="-122"/>
                           <a:cs typeface="Calibri" pitchFamily="34" charset="-120"/>
                         </a:rPr>
-                        <a:t>0.78</a:t>
+                        <a:t>1.22</a:t>
                       </a:r>
                       <a:endParaRPr lang="en-US" sz="1200" dirty="0">
                         <a:latin typeface="Calibri" charset="0"/>
@@ -9477,7 +9531,7 @@
                           <a:ea typeface="Calibri" pitchFamily="34" charset="-122"/>
                           <a:cs typeface="Calibri" pitchFamily="34" charset="-120"/>
                         </a:rPr>
-                        <a:t>1027</a:t>
+                        <a:t>1275</a:t>
                       </a:r>
                       <a:endParaRPr lang="en-US" sz="1200" dirty="0">
                         <a:latin typeface="Calibri" charset="0"/>
@@ -9674,7 +9728,7 @@
                           <a:ea typeface="Calibri" pitchFamily="34" charset="-122"/>
                           <a:cs typeface="Calibri" pitchFamily="34" charset="-120"/>
                         </a:rPr>
-                        <a:t>76</a:t>
+                        <a:t>69</a:t>
                       </a:r>
                       <a:endParaRPr lang="en-US" sz="1200" dirty="0">
                         <a:latin typeface="Calibri" charset="0"/>
@@ -9739,7 +9793,7 @@
                           <a:ea typeface="Calibri" pitchFamily="34" charset="-122"/>
                           <a:cs typeface="Calibri" pitchFamily="34" charset="-120"/>
                         </a:rPr>
-                        <a:t>1.21</a:t>
+                        <a:t>1.36</a:t>
                       </a:r>
                       <a:endParaRPr lang="en-US" sz="1200" dirty="0">
                         <a:latin typeface="Calibri" charset="0"/>
@@ -9804,7 +9858,7 @@
                           <a:ea typeface="Calibri" pitchFamily="34" charset="-122"/>
                           <a:cs typeface="Calibri" pitchFamily="34" charset="-120"/>
                         </a:rPr>
-                        <a:t>993</a:t>
+                        <a:t>1494</a:t>
                       </a:r>
                       <a:endParaRPr lang="en-US" sz="1200" dirty="0">
                         <a:latin typeface="Calibri" charset="0"/>
@@ -10001,7 +10055,7 @@
                           <a:ea typeface="Calibri" pitchFamily="34" charset="-122"/>
                           <a:cs typeface="Calibri" pitchFamily="34" charset="-120"/>
                         </a:rPr>
-                        <a:t>60</a:t>
+                        <a:t>61</a:t>
                       </a:r>
                       <a:endParaRPr lang="en-US" sz="1200" dirty="0">
                         <a:latin typeface="Calibri" charset="0"/>
@@ -10066,7 +10120,7 @@
                           <a:ea typeface="Calibri" pitchFamily="34" charset="-122"/>
                           <a:cs typeface="Calibri" pitchFamily="34" charset="-120"/>
                         </a:rPr>
-                        <a:t>1.49</a:t>
+                        <a:t>2.24</a:t>
                       </a:r>
                       <a:endParaRPr lang="en-US" sz="1200" dirty="0">
                         <a:latin typeface="Calibri" charset="0"/>
@@ -10131,7 +10185,7 @@
                           <a:ea typeface="Calibri" pitchFamily="34" charset="-122"/>
                           <a:cs typeface="Calibri" pitchFamily="34" charset="-120"/>
                         </a:rPr>
-                        <a:t>1138</a:t>
+                        <a:t>1861</a:t>
                       </a:r>
                       <a:endParaRPr lang="en-US" sz="1200" dirty="0">
                         <a:latin typeface="Calibri" charset="0"/>
@@ -10328,7 +10382,7 @@
                           <a:ea typeface="Calibri" pitchFamily="34" charset="-122"/>
                           <a:cs typeface="Calibri" pitchFamily="34" charset="-120"/>
                         </a:rPr>
-                        <a:t>62</a:t>
+                        <a:t>51</a:t>
                       </a:r>
                       <a:endParaRPr lang="en-US" sz="1200" dirty="0">
                         <a:latin typeface="Calibri" charset="0"/>
@@ -10393,7 +10447,7 @@
                           <a:ea typeface="Calibri" pitchFamily="34" charset="-122"/>
                           <a:cs typeface="Calibri" pitchFamily="34" charset="-120"/>
                         </a:rPr>
-                        <a:t>1.71</a:t>
+                        <a:t>2.04</a:t>
                       </a:r>
                       <a:endParaRPr lang="en-US" sz="1200" dirty="0">
                         <a:latin typeface="Calibri" charset="0"/>
@@ -10458,7 +10512,7 @@
                           <a:ea typeface="Calibri" pitchFamily="34" charset="-122"/>
                           <a:cs typeface="Calibri" pitchFamily="34" charset="-120"/>
                         </a:rPr>
-                        <a:t>1448</a:t>
+                        <a:t>2225</a:t>
                       </a:r>
                       <a:endParaRPr lang="en-US" sz="1200" dirty="0">
                         <a:latin typeface="Calibri" charset="0"/>
@@ -10513,7 +10567,7 @@
       </p:graphicFrame>
       <p:sp>
         <p:nvSpPr>
-          <p:cNvPr id="4" name="tile 2,529 pipes · 1,141 conduits · 569 trays · 261 ducts"/>
+          <p:cNvPr id="4" name="tile 2,488 pipes · 968 conduits · 559 trays · 485 ducts"/>
           <p:cNvSpPr/>
           <p:nvPr/>
         </p:nvSpPr>
@@ -10535,7 +10589,7 @@
       </p:sp>
       <p:sp>
         <p:nvSpPr>
-          <p:cNvPr id="5" name="value 2,529 pipes · 1,141 conduits · 569 trays · 261 ducts"/>
+          <p:cNvPr id="5" name="value 2,488 pipes · 968 conduits · 559 trays · 485 ducts"/>
           <p:cNvSpPr txBox="1"/>
           <p:nvPr/>
         </p:nvSpPr>
@@ -10571,7 +10625,7 @@
       </p:sp>
       <p:sp>
         <p:nvSpPr>
-          <p:cNvPr id="6" name="label 2,529 pipes · 1,141 conduits · 569 trays · 261 ducts"/>
+          <p:cNvPr id="6" name="label 2,488 pipes · 968 conduits · 559 trays · 485 ducts"/>
           <p:cNvSpPr txBox="1"/>
           <p:nvPr/>
         </p:nvSpPr>
@@ -10599,7 +10653,7 @@
                   <a:srgbClr val="52514E"/>
                 </a:solidFill>
               </a:rPr>
-              <a:t>2,529 pipes · 1,141 conduits · 569 trays · 261 ducts</a:t>
+              <a:t>2,488 pipes · 968 conduits · 559 trays · 485 ducts</a:t>
             </a:r>
             <a:endParaRPr lang="en-US" sz="1100" dirty="0"/>
           </a:p>
@@ -10607,7 +10661,7 @@
       </p:sp>
       <p:sp>
         <p:nvSpPr>
-          <p:cNvPr id="7" name="tile Wasserstein-1, generated to measured pipe gaps of the clinic (95 % CI 16–44)"/>
+          <p:cNvPr id="7" name="tile Wasserstein-1, generated to measured pipe gaps of the clinic (95 % CI 17–48)"/>
           <p:cNvSpPr/>
           <p:nvPr/>
         </p:nvSpPr>
@@ -10629,7 +10683,7 @@
       </p:sp>
       <p:sp>
         <p:nvSpPr>
-          <p:cNvPr id="8" name="value Wasserstein-1, generated to measured pipe gaps of the clinic (95 % CI 16–44)"/>
+          <p:cNvPr id="8" name="value Wasserstein-1, generated to measured pipe gaps of the clinic (95 % CI 17–48)"/>
           <p:cNvSpPr txBox="1"/>
           <p:nvPr/>
         </p:nvSpPr>
@@ -10657,7 +10711,7 @@
                   <a:schemeClr val="accent1"/>
                 </a:solidFill>
               </a:rPr>
-              <a:t>28 mm</a:t>
+              <a:t>32 mm</a:t>
             </a:r>
             <a:endParaRPr lang="en-US" sz="2400" dirty="0"/>
           </a:p>
@@ -10665,7 +10719,7 @@
       </p:sp>
       <p:sp>
         <p:nvSpPr>
-          <p:cNvPr id="9" name="label Wasserstein-1, generated to measured pipe gaps of the clinic (95 % CI 16–44)"/>
+          <p:cNvPr id="9" name="label Wasserstein-1, generated to measured pipe gaps of the clinic (95 % CI 17–48)"/>
           <p:cNvSpPr txBox="1"/>
           <p:nvPr/>
         </p:nvSpPr>
@@ -10693,7 +10747,7 @@
                   <a:srgbClr val="52514E"/>
                 </a:solidFill>
               </a:rPr>
-              <a:t>Wasserstein-1, generated to measured pipe gaps of the clinic (95 % CI 16–44)</a:t>
+              <a:t>Wasserstein-1, generated to measured pipe gaps of the clinic (95 % CI 17–48)</a:t>
             </a:r>
             <a:endParaRPr lang="en-US" sz="1100" dirty="0"/>
           </a:p>
@@ -10751,7 +10805,7 @@
                   <a:schemeClr val="accent1"/>
                 </a:solidFill>
               </a:rPr>
-              <a:t>−0.36 / +0.56</a:t>
+              <a:t>−0.38 / +0.46</a:t>
             </a:r>
             <a:endParaRPr lang="en-US" sz="2400" dirty="0"/>
           </a:p>
@@ -10895,7 +10949,7 @@
                   <a:schemeClr val="tx1"/>
                 </a:solidFill>
               </a:rPr>
-              <a:t>Against the clinic the generator is 28 mm off; the small duplex is 70 to 85</a:t>
+              <a:t>Against the clinic the generator is 32 mm off; the small duplex is 76 to 88</a:t>
             </a:r>
             <a:endParaRPr lang="en-US" sz="2600" dirty="0"/>
           </a:p>
@@ -11355,7 +11409,7 @@
                           <a:ea typeface="Calibri" pitchFamily="34" charset="-122"/>
                           <a:cs typeface="Calibri" pitchFamily="34" charset="-120"/>
                         </a:rPr>
-                        <a:t>1,543</a:t>
+                        <a:t>1,690</a:t>
                       </a:r>
                       <a:endParaRPr lang="en-US" sz="1100" dirty="0">
                         <a:latin typeface="Calibri" charset="0"/>
@@ -11485,7 +11539,7 @@
                           <a:ea typeface="Calibri" pitchFamily="34" charset="-122"/>
                           <a:cs typeface="Calibri" pitchFamily="34" charset="-120"/>
                         </a:rPr>
-                        <a:t>207</a:t>
+                        <a:t>216</a:t>
                       </a:r>
                       <a:endParaRPr lang="en-US" sz="1100" dirty="0">
                         <a:latin typeface="Calibri" charset="0"/>
@@ -12969,7 +13023,7 @@
                           <a:ea typeface="Calibri" pitchFamily="34" charset="-122"/>
                           <a:cs typeface="Calibri" pitchFamily="34" charset="-120"/>
                         </a:rPr>
-                        <a:t>28 (16–44)</a:t>
+                        <a:t>32 (17–48)</a:t>
                       </a:r>
                       <a:endParaRPr lang="en-US" sz="1100" dirty="0">
                         <a:latin typeface="Calibri" charset="0"/>
@@ -13034,7 +13088,7 @@
                           <a:ea typeface="Calibri" pitchFamily="34" charset="-122"/>
                           <a:cs typeface="Calibri" pitchFamily="34" charset="-120"/>
                         </a:rPr>
-                        <a:t>15 (11–24)</a:t>
+                        <a:t>18 (13–27)</a:t>
                       </a:r>
                       <a:endParaRPr lang="en-US" sz="1100" dirty="0">
                         <a:latin typeface="Calibri" charset="0"/>
@@ -13231,7 +13285,7 @@
                           <a:ea typeface="Calibri" pitchFamily="34" charset="-122"/>
                           <a:cs typeface="Calibri" pitchFamily="34" charset="-120"/>
                         </a:rPr>
-                        <a:t>70 (57–99)</a:t>
+                        <a:t>76 (61–103)</a:t>
                       </a:r>
                       <a:endParaRPr lang="en-US" sz="1100" dirty="0">
                         <a:latin typeface="Calibri" charset="0"/>
@@ -13296,7 +13350,7 @@
                           <a:ea typeface="Calibri" pitchFamily="34" charset="-122"/>
                           <a:cs typeface="Calibri" pitchFamily="34" charset="-120"/>
                         </a:rPr>
-                        <a:t>94 (74–119)</a:t>
+                        <a:t>97 (78–120)</a:t>
                       </a:r>
                       <a:endParaRPr lang="en-US" sz="1100" dirty="0">
                         <a:latin typeface="Calibri" charset="0"/>
@@ -13361,7 +13415,7 @@
                           <a:ea typeface="Calibri" pitchFamily="34" charset="-122"/>
                           <a:cs typeface="Calibri" pitchFamily="34" charset="-120"/>
                         </a:rPr>
-                        <a:t>25</a:t>
+                        <a:t>23</a:t>
                       </a:r>
                       <a:endParaRPr lang="en-US" sz="1100" dirty="0">
                         <a:latin typeface="Calibri" charset="0"/>
@@ -13493,7 +13547,7 @@
                           <a:ea typeface="Calibri" pitchFamily="34" charset="-122"/>
                           <a:cs typeface="Calibri" pitchFamily="34" charset="-120"/>
                         </a:rPr>
-                        <a:t>85 (59–132)</a:t>
+                        <a:t>88 (62–132)</a:t>
                       </a:r>
                       <a:endParaRPr lang="en-US" sz="1100" dirty="0">
                         <a:latin typeface="Calibri" charset="0"/>
@@ -13558,7 +13612,7 @@
                           <a:ea typeface="Calibri" pitchFamily="34" charset="-122"/>
                           <a:cs typeface="Calibri" pitchFamily="34" charset="-120"/>
                         </a:rPr>
-                        <a:t>100 (85–125)</a:t>
+                        <a:t>104 (89–127)</a:t>
                       </a:r>
                       <a:endParaRPr lang="en-US" sz="1100" dirty="0">
                         <a:latin typeface="Calibri" charset="0"/>
@@ -13623,7 +13677,7 @@
                           <a:ea typeface="Calibri" pitchFamily="34" charset="-122"/>
                           <a:cs typeface="Calibri" pitchFamily="34" charset="-120"/>
                         </a:rPr>
-                        <a:t>34</a:t>
+                        <a:t>32</a:t>
                       </a:r>
                       <a:endParaRPr lang="en-US" sz="1100" dirty="0">
                         <a:latin typeface="Calibri" charset="0"/>
@@ -14514,7 +14568,7 @@
                   <a:schemeClr val="tx1"/>
                 </a:solidFill>
               </a:rPr>
-              <a:t>Robust: across 11 settings of the cut (spacing, row band, axis tolerance, run length) generated ↔ clinic stays at 27–36 mm</a:t>
+              <a:t>Robust: across 11 settings of the cut (spacing, row band, axis tolerance, run length) generated ↔ clinic stays at 31–41 mm</a:t>
             </a:r>
             <a:endParaRPr lang="en-US" sz="1250" dirty="0"/>
           </a:p>
@@ -15685,7 +15739,7 @@
                           <a:ea typeface="Calibri" pitchFamily="34" charset="-122"/>
                           <a:cs typeface="Calibri" pitchFamily="34" charset="-120"/>
                         </a:rPr>
-                        <a:t>71</a:t>
+                        <a:t>66</a:t>
                       </a:r>
                       <a:endParaRPr lang="en-US" sz="1100" dirty="0">
                         <a:latin typeface="Calibri" charset="0"/>
@@ -15750,7 +15804,7 @@
                           <a:ea typeface="Calibri" pitchFamily="34" charset="-122"/>
                           <a:cs typeface="Calibri" pitchFamily="34" charset="-120"/>
                         </a:rPr>
-                        <a:t>11.3 (4.1–19.1)</a:t>
+                        <a:t>16.7 (8.3–26.6)</a:t>
                       </a:r>
                       <a:endParaRPr lang="en-US" sz="1100" dirty="0">
                         <a:latin typeface="Calibri" charset="0"/>
@@ -15815,7 +15869,7 @@
                           <a:ea typeface="Calibri" pitchFamily="34" charset="-122"/>
                           <a:cs typeface="Calibri" pitchFamily="34" charset="-120"/>
                         </a:rPr>
-                        <a:t>11.4 (9.6–13.3)</a:t>
+                        <a:t>12.7 (10.7–14.7)</a:t>
                       </a:r>
                       <a:endParaRPr lang="en-US" sz="1100" dirty="0">
                         <a:latin typeface="Calibri" charset="0"/>
@@ -15947,7 +16001,7 @@
                           <a:ea typeface="Calibri" pitchFamily="34" charset="-122"/>
                           <a:cs typeface="Calibri" pitchFamily="34" charset="-120"/>
                         </a:rPr>
-                        <a:t>147</a:t>
+                        <a:t>132</a:t>
                       </a:r>
                       <a:endParaRPr lang="en-US" sz="1100" dirty="0">
                         <a:latin typeface="Calibri" charset="0"/>
@@ -16012,7 +16066,7 @@
                           <a:ea typeface="Calibri" pitchFamily="34" charset="-122"/>
                           <a:cs typeface="Calibri" pitchFamily="34" charset="-120"/>
                         </a:rPr>
-                        <a:t>12.2 (6.5–18.8)</a:t>
+                        <a:t>11.4 (5.0–18.4)</a:t>
                       </a:r>
                       <a:endParaRPr lang="en-US" sz="1100" dirty="0">
                         <a:latin typeface="Calibri" charset="0"/>
@@ -16077,7 +16131,7 @@
                           <a:ea typeface="Calibri" pitchFamily="34" charset="-122"/>
                           <a:cs typeface="Calibri" pitchFamily="34" charset="-120"/>
                         </a:rPr>
-                        <a:t>10.9 (9.4–12.5)</a:t>
+                        <a:t>13.5 (11.8–15.4)</a:t>
                       </a:r>
                       <a:endParaRPr lang="en-US" sz="1100" dirty="0">
                         <a:latin typeface="Calibri" charset="0"/>
@@ -16209,7 +16263,7 @@
                           <a:ea typeface="Calibri" pitchFamily="34" charset="-122"/>
                           <a:cs typeface="Calibri" pitchFamily="34" charset="-120"/>
                         </a:rPr>
-                        <a:t>203</a:t>
+                        <a:t>212</a:t>
                       </a:r>
                       <a:endParaRPr lang="en-US" sz="1100" dirty="0">
                         <a:latin typeface="Calibri" charset="0"/>
@@ -16274,7 +16328,7 @@
                           <a:ea typeface="Calibri" pitchFamily="34" charset="-122"/>
                           <a:cs typeface="Calibri" pitchFamily="34" charset="-120"/>
                         </a:rPr>
-                        <a:t>10.3 (5.7–15.6)</a:t>
+                        <a:t>15.6 (10.5–21.1)</a:t>
                       </a:r>
                       <a:endParaRPr lang="en-US" sz="1100" dirty="0">
                         <a:latin typeface="Calibri" charset="0"/>
@@ -16339,7 +16393,7 @@
                           <a:ea typeface="Calibri" pitchFamily="34" charset="-122"/>
                           <a:cs typeface="Calibri" pitchFamily="34" charset="-120"/>
                         </a:rPr>
-                        <a:t>10.8 (9.6–12.0)</a:t>
+                        <a:t>13.8 (12.4–15.2)</a:t>
                       </a:r>
                       <a:endParaRPr lang="en-US" sz="1100" dirty="0">
                         <a:latin typeface="Calibri" charset="0"/>
@@ -16471,7 +16525,7 @@
                           <a:ea typeface="Calibri" pitchFamily="34" charset="-122"/>
                           <a:cs typeface="Calibri" pitchFamily="34" charset="-120"/>
                         </a:rPr>
-                        <a:t>257</a:t>
+                        <a:t>284</a:t>
                       </a:r>
                       <a:endParaRPr lang="en-US" sz="1100" dirty="0">
                         <a:latin typeface="Calibri" charset="0"/>
@@ -16536,7 +16590,7 @@
                           <a:ea typeface="Calibri" pitchFamily="34" charset="-122"/>
                           <a:cs typeface="Calibri" pitchFamily="34" charset="-120"/>
                         </a:rPr>
-                        <a:t>13.6 (8.4–19.3)</a:t>
+                        <a:t>16.9 (11.8–22.1)</a:t>
                       </a:r>
                       <a:endParaRPr lang="en-US" sz="1100" dirty="0">
                         <a:latin typeface="Calibri" charset="0"/>
@@ -16601,7 +16655,7 @@
                           <a:ea typeface="Calibri" pitchFamily="34" charset="-122"/>
                           <a:cs typeface="Calibri" pitchFamily="34" charset="-120"/>
                         </a:rPr>
-                        <a:t>10.4 (9.4–11.4)</a:t>
+                        <a:t>13.2 (12.0–14.4)</a:t>
                       </a:r>
                       <a:endParaRPr lang="en-US" sz="1100" dirty="0">
                         <a:latin typeface="Calibri" charset="0"/>
@@ -16733,7 +16787,7 @@
                           <a:ea typeface="Calibri" pitchFamily="34" charset="-122"/>
                           <a:cs typeface="Calibri" pitchFamily="34" charset="-120"/>
                         </a:rPr>
-                        <a:t>391</a:t>
+                        <a:t>365</a:t>
                       </a:r>
                       <a:endParaRPr lang="en-US" sz="1100" dirty="0">
                         <a:latin typeface="Calibri" charset="0"/>
@@ -16798,7 +16852,7 @@
                           <a:ea typeface="Calibri" pitchFamily="34" charset="-122"/>
                           <a:cs typeface="Calibri" pitchFamily="34" charset="-120"/>
                         </a:rPr>
-                        <a:t>9.2 (6.1–12.6)</a:t>
+                        <a:t>11.5 (7.3–16.0)</a:t>
                       </a:r>
                       <a:endParaRPr lang="en-US" sz="1100" dirty="0">
                         <a:latin typeface="Calibri" charset="0"/>
@@ -16863,7 +16917,7 @@
                           <a:ea typeface="Calibri" pitchFamily="34" charset="-122"/>
                           <a:cs typeface="Calibri" pitchFamily="34" charset="-120"/>
                         </a:rPr>
-                        <a:t>10.5 (9.6–11.5)</a:t>
+                        <a:t>14.7 (13.5–15.9)</a:t>
                       </a:r>
                       <a:endParaRPr lang="en-US" sz="1100" dirty="0">
                         <a:latin typeface="Calibri" charset="0"/>
@@ -16995,7 +17049,7 @@
                           <a:ea typeface="Calibri" pitchFamily="34" charset="-122"/>
                           <a:cs typeface="Calibri" pitchFamily="34" charset="-120"/>
                         </a:rPr>
-                        <a:t>410</a:t>
+                        <a:t>366</a:t>
                       </a:r>
                       <a:endParaRPr lang="en-US" sz="1100" dirty="0">
                         <a:latin typeface="Calibri" charset="0"/>
@@ -17060,7 +17114,7 @@
                           <a:ea typeface="Calibri" pitchFamily="34" charset="-122"/>
                           <a:cs typeface="Calibri" pitchFamily="34" charset="-120"/>
                         </a:rPr>
-                        <a:t>11.5 (7.9–15.4)</a:t>
+                        <a:t>10.7 (7.2–14.5)</a:t>
                       </a:r>
                       <a:endParaRPr lang="en-US" sz="1100" dirty="0">
                         <a:latin typeface="Calibri" charset="0"/>
@@ -17125,7 +17179,7 @@
                           <a:ea typeface="Calibri" pitchFamily="34" charset="-122"/>
                           <a:cs typeface="Calibri" pitchFamily="34" charset="-120"/>
                         </a:rPr>
-                        <a:t>10.8 (9.9–11.8)</a:t>
+                        <a:t>14.3 (13.3–15.4)</a:t>
                       </a:r>
                       <a:endParaRPr lang="en-US" sz="1100" dirty="0">
                         <a:latin typeface="Calibri" charset="0"/>
@@ -17257,7 +17311,7 @@
                           <a:ea typeface="Calibri" pitchFamily="34" charset="-122"/>
                           <a:cs typeface="Calibri" pitchFamily="34" charset="-120"/>
                         </a:rPr>
-                        <a:t>465</a:t>
+                        <a:t>517</a:t>
                       </a:r>
                       <a:endParaRPr lang="en-US" sz="1100" dirty="0">
                         <a:latin typeface="Calibri" charset="0"/>
@@ -17322,7 +17376,7 @@
                           <a:ea typeface="Calibri" pitchFamily="34" charset="-122"/>
                           <a:cs typeface="Calibri" pitchFamily="34" charset="-120"/>
                         </a:rPr>
-                        <a:t>10.8 (7.5–14.1)</a:t>
+                        <a:t>17.2 (13.4–21.1)</a:t>
                       </a:r>
                       <a:endParaRPr lang="en-US" sz="1100" dirty="0">
                         <a:latin typeface="Calibri" charset="0"/>
@@ -17387,7 +17441,7 @@
                           <a:ea typeface="Calibri" pitchFamily="34" charset="-122"/>
                           <a:cs typeface="Calibri" pitchFamily="34" charset="-120"/>
                         </a:rPr>
-                        <a:t>11.0 (10.1–11.8)</a:t>
+                        <a:t>14.9 (13.9–16.0)</a:t>
                       </a:r>
                       <a:endParaRPr lang="en-US" sz="1100" dirty="0">
                         <a:latin typeface="Calibri" charset="0"/>
@@ -17519,7 +17573,7 @@
                           <a:ea typeface="Calibri" pitchFamily="34" charset="-122"/>
                           <a:cs typeface="Calibri" pitchFamily="34" charset="-120"/>
                         </a:rPr>
-                        <a:t>585</a:t>
+                        <a:t>546</a:t>
                       </a:r>
                       <a:endParaRPr lang="en-US" sz="1100" dirty="0">
                         <a:latin typeface="Calibri" charset="0"/>
@@ -17584,7 +17638,7 @@
                           <a:ea typeface="Calibri" pitchFamily="34" charset="-122"/>
                           <a:cs typeface="Calibri" pitchFamily="34" charset="-120"/>
                         </a:rPr>
-                        <a:t>13.3 (9.8–17.1)</a:t>
+                        <a:t>15.2 (11.7–19.1)</a:t>
                       </a:r>
                       <a:endParaRPr lang="en-US" sz="1100" dirty="0">
                         <a:latin typeface="Calibri" charset="0"/>
@@ -17649,7 +17703,7 @@
                           <a:ea typeface="Calibri" pitchFamily="34" charset="-122"/>
                           <a:cs typeface="Calibri" pitchFamily="34" charset="-120"/>
                         </a:rPr>
-                        <a:t>11.2 (10.4–12.0)</a:t>
+                        <a:t>14.4 (13.5–15.4)</a:t>
                       </a:r>
                       <a:endParaRPr lang="en-US" sz="1100" dirty="0">
                         <a:latin typeface="Calibri" charset="0"/>
@@ -18087,7 +18141,7 @@
                           <a:ea typeface="Calibri" pitchFamily="34" charset="-122"/>
                           <a:cs typeface="Calibri" pitchFamily="34" charset="-120"/>
                         </a:rPr>
-                        <a:t>11.6</a:t>
+                        <a:t>14.5</a:t>
                       </a:r>
                       <a:endParaRPr lang="en-US" sz="1100" dirty="0">
                         <a:latin typeface="Calibri" charset="0"/>
@@ -18152,7 +18206,7 @@
                           <a:ea typeface="Calibri" pitchFamily="34" charset="-122"/>
                           <a:cs typeface="Calibri" pitchFamily="34" charset="-120"/>
                         </a:rPr>
-                        <a:t>12.9</a:t>
+                        <a:t>19.8</a:t>
                       </a:r>
                       <a:endParaRPr lang="en-US" sz="1100" dirty="0">
                         <a:latin typeface="Calibri" charset="0"/>
@@ -18217,7 +18271,7 @@
                           <a:ea typeface="Calibri" pitchFamily="34" charset="-122"/>
                           <a:cs typeface="Calibri" pitchFamily="34" charset="-120"/>
                         </a:rPr>
-                        <a:t>12.9</a:t>
+                        <a:t>19.8</a:t>
                       </a:r>
                       <a:endParaRPr lang="en-US" sz="1100" dirty="0">
                         <a:latin typeface="Calibri" charset="0"/>
@@ -18349,7 +18403,7 @@
                           <a:ea typeface="Calibri" pitchFamily="34" charset="-122"/>
                           <a:cs typeface="Calibri" pitchFamily="34" charset="-120"/>
                         </a:rPr>
-                        <a:t>11.6</a:t>
+                        <a:t>14.5</a:t>
                       </a:r>
                       <a:endParaRPr lang="en-US" sz="1100" dirty="0">
                         <a:latin typeface="Calibri" charset="0"/>
@@ -18414,7 +18468,7 @@
                           <a:ea typeface="Calibri" pitchFamily="34" charset="-122"/>
                           <a:cs typeface="Calibri" pitchFamily="34" charset="-120"/>
                         </a:rPr>
-                        <a:t>16.4</a:t>
+                        <a:t>22.0</a:t>
                       </a:r>
                       <a:endParaRPr lang="en-US" sz="1100" dirty="0">
                         <a:latin typeface="Calibri" charset="0"/>
@@ -18479,7 +18533,7 @@
                           <a:ea typeface="Calibri" pitchFamily="34" charset="-122"/>
                           <a:cs typeface="Calibri" pitchFamily="34" charset="-120"/>
                         </a:rPr>
-                        <a:t>16.4</a:t>
+                        <a:t>22.0</a:t>
                       </a:r>
                       <a:endParaRPr lang="en-US" sz="1100" dirty="0">
                         <a:latin typeface="Calibri" charset="0"/>
@@ -18611,7 +18665,7 @@
                           <a:ea typeface="Calibri" pitchFamily="34" charset="-122"/>
                           <a:cs typeface="Calibri" pitchFamily="34" charset="-120"/>
                         </a:rPr>
-                        <a:t>6.2</a:t>
+                        <a:t>7.2</a:t>
                       </a:r>
                       <a:endParaRPr lang="en-US" sz="1100" dirty="0">
                         <a:latin typeface="Calibri" charset="0"/>
@@ -18676,7 +18730,7 @@
                           <a:ea typeface="Calibri" pitchFamily="34" charset="-122"/>
                           <a:cs typeface="Calibri" pitchFamily="34" charset="-120"/>
                         </a:rPr>
-                        <a:t>7.5</a:t>
+                        <a:t>8.2</a:t>
                       </a:r>
                       <a:endParaRPr lang="en-US" sz="1100" dirty="0">
                         <a:latin typeface="Calibri" charset="0"/>
@@ -18741,7 +18795,7 @@
                           <a:ea typeface="Calibri" pitchFamily="34" charset="-122"/>
                           <a:cs typeface="Calibri" pitchFamily="34" charset="-120"/>
                         </a:rPr>
-                        <a:t>7.5</a:t>
+                        <a:t>8.2</a:t>
                       </a:r>
                       <a:endParaRPr lang="en-US" sz="1100" dirty="0">
                         <a:latin typeface="Calibri" charset="0"/>
@@ -19146,7 +19200,7 @@
                           <a:ea typeface="Calibri" pitchFamily="34" charset="-122"/>
                           <a:cs typeface="Calibri" pitchFamily="34" charset="-120"/>
                         </a:rPr>
-                        <a:t>12,930</a:t>
+                        <a:t>12,590</a:t>
                       </a:r>
                       <a:endParaRPr lang="en-US" sz="1100" dirty="0">
                         <a:latin typeface="Calibri" charset="0"/>
@@ -19211,7 +19265,7 @@
                           <a:ea typeface="Calibri" pitchFamily="34" charset="-122"/>
                           <a:cs typeface="Calibri" pitchFamily="34" charset="-120"/>
                         </a:rPr>
-                        <a:t>10.8 (10.2–11.5)</a:t>
+                        <a:t>14.4 (13.7–15.2)</a:t>
                       </a:r>
                       <a:endParaRPr lang="en-US" sz="1100" dirty="0">
                         <a:latin typeface="Calibri" charset="0"/>
@@ -19343,7 +19397,7 @@
                           <a:ea typeface="Calibri" pitchFamily="34" charset="-122"/>
                           <a:cs typeface="Calibri" pitchFamily="34" charset="-120"/>
                         </a:rPr>
-                        <a:t>1,254</a:t>
+                        <a:t>1,295</a:t>
                       </a:r>
                       <a:endParaRPr lang="en-US" sz="1100" dirty="0">
                         <a:latin typeface="Calibri" charset="0"/>
@@ -19408,7 +19462,7 @@
                           <a:ea typeface="Calibri" pitchFamily="34" charset="-122"/>
                           <a:cs typeface="Calibri" pitchFamily="34" charset="-120"/>
                         </a:rPr>
-                        <a:t>9.4 (7.4–11.4)</a:t>
+                        <a:t>13.2 (11.2–15.6)</a:t>
                       </a:r>
                       <a:endParaRPr lang="en-US" sz="1100" dirty="0">
                         <a:latin typeface="Calibri" charset="0"/>
@@ -19540,7 +19594,7 @@
                           <a:ea typeface="Calibri" pitchFamily="34" charset="-122"/>
                           <a:cs typeface="Calibri" pitchFamily="34" charset="-120"/>
                         </a:rPr>
-                        <a:t>1,271</a:t>
+                        <a:t>1,200</a:t>
                       </a:r>
                       <a:endParaRPr lang="en-US" sz="1100" dirty="0">
                         <a:latin typeface="Calibri" charset="0"/>
@@ -19605,7 +19659,7 @@
                           <a:ea typeface="Calibri" pitchFamily="34" charset="-122"/>
                           <a:cs typeface="Calibri" pitchFamily="34" charset="-120"/>
                         </a:rPr>
-                        <a:t>9.0 (7.2–11.0)</a:t>
+                        <a:t>13.8 (11.5–16.4)</a:t>
                       </a:r>
                       <a:endParaRPr lang="en-US" sz="1100" dirty="0">
                         <a:latin typeface="Calibri" charset="0"/>
@@ -19737,7 +19791,7 @@
                           <a:ea typeface="Calibri" pitchFamily="34" charset="-122"/>
                           <a:cs typeface="Calibri" pitchFamily="34" charset="-120"/>
                         </a:rPr>
-                        <a:t>2,529</a:t>
+                        <a:t>2,488</a:t>
                       </a:r>
                       <a:endParaRPr lang="en-US" sz="1100" dirty="0">
                         <a:latin typeface="Calibri" charset="0"/>
@@ -19802,7 +19856,7 @@
                           <a:ea typeface="Calibri" pitchFamily="34" charset="-122"/>
                           <a:cs typeface="Calibri" pitchFamily="34" charset="-120"/>
                         </a:rPr>
-                        <a:t>11.6 (10.1–13.0)</a:t>
+                        <a:t>14.5 (12.7–16.2)</a:t>
                       </a:r>
                       <a:endParaRPr lang="en-US" sz="1100" dirty="0">
                         <a:latin typeface="Calibri" charset="0"/>
@@ -19907,7 +19961,7 @@
                   <a:schemeClr val="tx1"/>
                 </a:solidFill>
               </a:rPr>
-              <a:t>Population: 2,000 freshly generated contexts per tier; overall 10.8 % (95 % CI 10.5–11.2)</a:t>
+              <a:t>Population: 2,000 freshly generated contexts per tier; overall 14.3 % (95 % CI 13.8–14.7)</a:t>
             </a:r>
             <a:endParaRPr lang="en-US" sz="1200" dirty="0"/>
           </a:p>
@@ -20112,7 +20166,7 @@
                 <a:ea typeface="Courier New" pitchFamily="34" charset="-122"/>
                 <a:cs typeface="Courier New" pitchFamily="34" charset="-120"/>
               </a:rPr>
-              <a:t>{"context_id": "mep_57", "tier": "C2",</a:t>
+              <a:t>{"context_id": "mep_9", "tier": "C2",</a:t>
             </a:r>
             <a:endParaRPr lang="en-US" sz="1050" dirty="0"/>
           </a:p>
@@ -20146,7 +20200,7 @@
                 <a:ea typeface="Courier New" pitchFamily="34" charset="-122"/>
                 <a:cs typeface="Courier New" pitchFamily="34" charset="-120"/>
               </a:rPr>
-              <a:t> "n_elements": 2, "n_levels": 1, "total_load_kN": 1.12, "bundle_width_mm": 588.0,</a:t>
+              <a:t> "n_elements": 2, "n_levels": 1, "total_load_kN": 0.76, "bundle_width_mm": 1527.0,</a:t>
             </a:r>
             <a:endParaRPr lang="en-US" sz="1050" dirty="0"/>
           </a:p>
@@ -20180,7 +20234,7 @@
                 <a:ea typeface="Courier New" pitchFamily="34" charset="-122"/>
                 <a:cs typeface="Courier New" pitchFamily="34" charset="-120"/>
               </a:rPr>
-              <a:t>  {"kind": "cable_tray", "service": "tray", "trade": "electrical", "shape": "rect",</a:t>
+              <a:t>  {"kind": "duct", "service": "duct", "trade": "ventilation", "shape": "rect",</a:t>
             </a:r>
             <a:endParaRPr lang="en-US" sz="1050" dirty="0"/>
           </a:p>
@@ -20197,7 +20251,7 @@
                 <a:ea typeface="Courier New" pitchFamily="34" charset="-122"/>
                 <a:cs typeface="Courier New" pitchFamily="34" charset="-120"/>
               </a:rPr>
-              <a:t>   "label": "300 tray", "width_mm": 300.0, "height_mm": 60.0, "insulation_mm": 0.0,</a:t>
+              <a:t>   "label": "1000x500 duct", "width_mm": 1000.0, "height_mm": 500.0, "insulation_mm": 0.0,</a:t>
             </a:r>
             <a:endParaRPr lang="en-US" sz="1050" dirty="0"/>
           </a:p>
@@ -20214,7 +20268,7 @@
                 <a:ea typeface="Courier New" pitchFamily="34" charset="-122"/>
                 <a:cs typeface="Courier New" pitchFamily="34" charset="-120"/>
               </a:rPr>
-              <a:t>   "load_kN": 1.08, "span_m": 2.0, "load_kN_per_m": 0.5396,</a:t>
+              <a:t>   "load_kN": 0.72, "span_m": 2.4, "load_kN_per_m": 0.3002,</a:t>
             </a:r>
             <a:endParaRPr lang="en-US" sz="1050" dirty="0"/>
           </a:p>
@@ -20231,7 +20285,7 @@
                 <a:ea typeface="Courier New" pitchFamily="34" charset="-122"/>
                 <a:cs typeface="Courier New" pitchFamily="34" charset="-120"/>
               </a:rPr>
-              <a:t>   "level": 0, "along_mm": -144.0, "out_mm": 120.0},</a:t>
+              <a:t>   "level": 0, "along_mm": -263.5, "out_mm": 340.0},</a:t>
             </a:r>
             <a:endParaRPr lang="en-US" sz="1050" dirty="0"/>
           </a:p>
@@ -20248,7 +20302,7 @@
                 <a:ea typeface="Courier New" pitchFamily="34" charset="-122"/>
                 <a:cs typeface="Courier New" pitchFamily="34" charset="-120"/>
               </a:rPr>
-              <a:t>  {"kind": "pipe", "service": "heating", "trade": "heating", "shape": "round",</a:t>
+              <a:t>  {"kind": "pipe", "service": "domestic_cold", "trade": "domestic", "shape": "round",</a:t>
             </a:r>
             <a:endParaRPr lang="en-US" sz="1050" dirty="0"/>
           </a:p>
@@ -20265,7 +20319,7 @@
                 <a:ea typeface="Courier New" pitchFamily="34" charset="-122"/>
                 <a:cs typeface="Courier New" pitchFamily="34" charset="-120"/>
               </a:rPr>
-              <a:t>   "label": "DN20", "width_mm": 26.9, "height_mm": 26.9, "insulation_mm": 20.0,</a:t>
+              <a:t>   "label": "DN20", "width_mm": 26.9, "height_mm": 26.9, "insulation_mm": 0.0,</a:t>
             </a:r>
             <a:endParaRPr lang="en-US" sz="1050" dirty="0"/>
           </a:p>
@@ -20299,7 +20353,7 @@
                 <a:ea typeface="Courier New" pitchFamily="34" charset="-122"/>
                 <a:cs typeface="Courier New" pitchFamily="34" charset="-120"/>
               </a:rPr>
-              <a:t>   "level": 0, "along_mm": 260.5, "out_mm": 156.2}</a:t>
+              <a:t>   "level": 0, "along_mm": 750.0, "out_mm": 341.3}</a:t>
             </a:r>
             <a:endParaRPr lang="en-US" sz="1050" dirty="0"/>
           </a:p>
@@ -23050,8 +23104,8 @@
         </p:blipFill>
         <p:spPr>
           <a:xfrm>
-            <a:off x="6309360" y="1582022"/>
-            <a:ext cx="5330952" cy="3511075"/>
+            <a:off x="6309360" y="1708403"/>
+            <a:ext cx="5330952" cy="3258315"/>
           </a:xfrm>
           <a:prstGeom prst="rect">
             <a:avLst/>
@@ -23066,7 +23120,7 @@
         </p:nvSpPr>
         <p:spPr>
           <a:xfrm>
-            <a:off x="6309360" y="5202826"/>
+            <a:off x="6309360" y="5076445"/>
             <a:ext cx="5330952" cy="685800"/>
           </a:xfrm>
           <a:prstGeom prst="rect">
@@ -26413,7 +26467,7 @@
                   <a:schemeClr val="tx1"/>
                 </a:solidFill>
               </a:rPr>
-              <a:t>Six trades: electrical 11,592, domestic water 5,889, heating 5,766, chilled water 4,129, sprinkler 2,200, ventilation 1,908 elements</a:t>
+              <a:t>Six trades: electrical 10,494, domestic water 5,725, heating 5,788, chilled water 3,987, sprinkler 2,073, ventilation 3,417 elements</a:t>
             </a:r>
             <a:endParaRPr lang="en-US" sz="1300" dirty="0"/>
           </a:p>

</xml_diff>

<commit_message>
Deck: crop the gallery screenshot relative to its height; rebuild the deck and PDF on 4.1
</commit_message>
<xml_diff>
--- a/docs/CrossMEP_CIBW78_talk.pptx
+++ b/docs/CrossMEP_CIBW78_talk.pptx
@@ -127,19 +127,19 @@
   <p:extLst>
     <p:ext uri="{521415D9-36F7-43E2-AB2F-B90AF26B5E84}">
       <p14:sectionLst xmlns:p14="http://schemas.microsoft.com/office/powerpoint/2010/main">
-        <p14:section name="Opening" id="{3ecd03bf-27e8-cac9-d6fc-a4c6572562ce}">
+        <p14:section name="Opening" id="{021b6d9c-56d5-f91f-1381-3a955c152bcd}">
           <p14:sldIdLst>
             <p14:sldId id="256"/>
           </p14:sldIdLst>
         </p14:section>
-        <p14:section name="Motivation" id="{47d5fc43-069d-ad00-3223-c7cb4e1e356f}">
+        <p14:section name="Motivation" id="{02f0e3e0-5816-8845-29ae-2722d9f0aa4d}">
           <p14:sldIdLst>
             <p14:sldId id="257"/>
             <p14:sldId id="258"/>
             <p14:sldId id="259"/>
           </p14:sldIdLst>
         </p14:section>
-        <p14:section name="The dataset" id="{cf077af1-df7b-ee94-fe34-93b4edc9517d}">
+        <p14:section name="The dataset" id="{57215155-aa2d-eff5-a6a3-5a61810bd123}">
           <p14:sldIdLst>
             <p14:sldId id="260"/>
             <p14:sldId id="261"/>
@@ -148,14 +148,14 @@
             <p14:sldId id="264"/>
           </p14:sldIdLst>
         </p14:section>
-        <p14:section name="Experiments" id="{6f77a037-3f3e-cf5c-b7be-10f2ed2d4500}">
+        <p14:section name="Experiments" id="{a70baab3-c231-ad61-af91-e9928648d7bf}">
           <p14:sldIdLst>
             <p14:sldId id="265"/>
             <p14:sldId id="266"/>
             <p14:sldId id="267"/>
           </p14:sldIdLst>
         </p14:section>
-        <p14:section name="Use" id="{50420905-d810-d3e8-c453-8db36bb35d74}">
+        <p14:section name="Use" id="{6816cbe2-03ef-006b-635b-fd72e3d5f12b}">
           <p14:sldIdLst>
             <p14:sldId id="268"/>
             <p14:sldId id="269"/>
@@ -163,7 +163,7 @@
             <p14:sldId id="271"/>
           </p14:sldIdLst>
         </p14:section>
-        <p14:section name="Appendix" id="{f19a98a8-2692-b28d-8571-0f5c497b70f5}">
+        <p14:section name="Appendix" id="{15802603-c737-0810-f18e-99de15b8193a}">
           <p14:sldIdLst>
             <p14:sldId id="272"/>
             <p14:sldId id="273"/>

</xml_diff>

<commit_message>
Talk: slide 4 as an architecture diagram with the approach as a black box
</commit_message>
<xml_diff>
--- a/docs/CrossMEP_CIBW78_talk.pptx
+++ b/docs/CrossMEP_CIBW78_talk.pptx
@@ -128,12 +128,12 @@
   <p:extLst>
     <p:ext uri="{521415D9-36F7-43E2-AB2F-B90AF26B5E84}">
       <p14:sectionLst xmlns:p14="http://schemas.microsoft.com/office/powerpoint/2010/main">
-        <p14:section name="Opening" id="{9c4030de-114d-c0e5-2726-f3fd4d80ce72}">
+        <p14:section name="Opening" id="{31f29fa2-fc81-a175-6699-e8f9f6b214b1}">
           <p14:sldIdLst>
             <p14:sldId id="256"/>
           </p14:sldIdLst>
         </p14:section>
-        <p14:section name="Motivation" id="{440fec81-15e4-8400-ac1c-88370ec92a30}">
+        <p14:section name="Motivation" id="{9c32c71e-94ac-03b5-eff5-372297e607a2}">
           <p14:sldIdLst>
             <p14:sldId id="257"/>
             <p14:sldId id="258"/>
@@ -141,7 +141,7 @@
             <p14:sldId id="260"/>
           </p14:sldIdLst>
         </p14:section>
-        <p14:section name="The dataset" id="{fbb90206-4df6-db85-45e7-00e33dbb79c2}">
+        <p14:section name="The dataset" id="{8caa210c-38f6-4b0f-12ab-5df97c59af36}">
           <p14:sldIdLst>
             <p14:sldId id="261"/>
             <p14:sldId id="262"/>
@@ -150,14 +150,14 @@
             <p14:sldId id="265"/>
           </p14:sldIdLst>
         </p14:section>
-        <p14:section name="Experiments" id="{f17f2e08-4f9a-6e76-ba2f-aa957f1f4829}">
+        <p14:section name="Experiments" id="{b8daf8d6-11d2-8c5b-d9a7-76f22832ac2d}">
           <p14:sldIdLst>
             <p14:sldId id="266"/>
             <p14:sldId id="267"/>
             <p14:sldId id="268"/>
           </p14:sldIdLst>
         </p14:section>
-        <p14:section name="Use" id="{067e71b8-6d08-0ff0-feb5-621cf1b493f5}">
+        <p14:section name="Use" id="{f9cdaaab-1e09-eea7-e613-6797021d7e62}">
           <p14:sldIdLst>
             <p14:sldId id="269"/>
             <p14:sldId id="270"/>
@@ -165,7 +165,7 @@
             <p14:sldId id="272"/>
           </p14:sldIdLst>
         </p14:section>
-        <p14:section name="Appendix" id="{6be03e17-062f-bf95-f71e-21b3fc8c0610}">
+        <p14:section name="Appendix" id="{2902dba2-6425-1ed0-9162-24fc703f2bad}">
           <p14:sldIdLst>
             <p14:sldId id="273"/>
             <p14:sldId id="274"/>
@@ -21470,36 +21470,407 @@
       </p:sp>
       <p:sp>
         <p:nvSpPr>
-          <p:cNvPr id="3" name="flow box brief"/>
+          <p:cNvPr id="3" name="box context"/>
           <p:cNvSpPr/>
           <p:nvPr/>
         </p:nvSpPr>
         <p:spPr>
           <a:xfrm>
-            <a:off x="548640" y="1600200"/>
-            <a:ext cx="2148840" cy="1554480"/>
+            <a:off x="548640" y="1554480"/>
+            <a:ext cx="1737360" cy="960120"/>
           </a:xfrm>
           <a:prstGeom prst="roundRect">
             <a:avLst>
-              <a:gd name="adj" fmla="val 4118"/>
+              <a:gd name="adj" fmla="val 5714"/>
             </a:avLst>
           </a:prstGeom>
           <a:solidFill>
             <a:schemeClr val="bg2"/>
           </a:solidFill>
+          <a:ln w="12700">
+            <a:solidFill>
+              <a:srgbClr val="52514E"/>
+            </a:solidFill>
+            <a:prstDash val="solid"/>
+          </a:ln>
+        </p:spPr>
+      </p:sp>
+      <p:sp>
+        <p:nvSpPr>
+          <p:cNvPr id="4" name="text context"/>
+          <p:cNvSpPr txBox="1"/>
+          <p:nvPr/>
+        </p:nvSpPr>
+        <p:spPr>
+          <a:xfrm>
+            <a:off x="548640" y="1554480"/>
+            <a:ext cx="1737360" cy="960120"/>
+          </a:xfrm>
+          <a:prstGeom prst="rect">
+            <a:avLst/>
+          </a:prstGeom>
+          <a:noFill/>
           <a:ln/>
         </p:spPr>
-      </p:sp>
-      <p:sp>
-        <p:nvSpPr>
-          <p:cNvPr id="4" name="flow text brief"/>
+        <p:txBody>
+          <a:bodyPr wrap="square" lIns="1016" tIns="1016" rIns="1016" bIns="1016" rtlCol="0" anchor="ctr"/>
+          <a:lstStyle/>
+          <a:p>
+            <a:pPr algn="ctr" indent="0" marL="0">
+              <a:buNone/>
+            </a:pPr>
+            <a:r>
+              <a:rPr lang="en-US" sz="1400" b="1" dirty="0">
+                <a:solidFill>
+                  <a:schemeClr val="tx1"/>
+                </a:solidFill>
+              </a:rPr>
+              <a:t>Context</a:t>
+            </a:r>
+            <a:endParaRPr lang="en-US" sz="1400" dirty="0"/>
+          </a:p>
+          <a:p>
+            <a:pPr algn="ctr" indent="0" marL="0">
+              <a:buNone/>
+            </a:pPr>
+            <a:r>
+              <a:rPr lang="en-US" sz="1150" dirty="0">
+                <a:solidFill>
+                  <a:srgbClr val="52514E"/>
+                </a:solidFill>
+              </a:rPr>
+              <a:t>structure, services, loads</a:t>
+            </a:r>
+            <a:endParaRPr lang="en-US" sz="1400" dirty="0"/>
+          </a:p>
+        </p:txBody>
+      </p:sp>
+      <p:sp>
+        <p:nvSpPr>
+          <p:cNvPr id="5" name="box catalog"/>
+          <p:cNvSpPr/>
+          <p:nvPr/>
+        </p:nvSpPr>
+        <p:spPr>
+          <a:xfrm>
+            <a:off x="640080" y="2743200"/>
+            <a:ext cx="1554480" cy="1051560"/>
+          </a:xfrm>
+          <a:prstGeom prst="can">
+            <a:avLst/>
+          </a:prstGeom>
+          <a:solidFill>
+            <a:schemeClr val="bg2"/>
+          </a:solidFill>
+          <a:ln w="12700">
+            <a:solidFill>
+              <a:srgbClr val="52514E"/>
+            </a:solidFill>
+            <a:prstDash val="solid"/>
+          </a:ln>
+        </p:spPr>
+      </p:sp>
+      <p:sp>
+        <p:nvSpPr>
+          <p:cNvPr id="6" name="text catalog"/>
           <p:cNvSpPr txBox="1"/>
           <p:nvPr/>
         </p:nvSpPr>
         <p:spPr>
           <a:xfrm>
-            <a:off x="713232" y="1709928"/>
-            <a:ext cx="1819656" cy="1335024"/>
+            <a:off x="548640" y="2834640"/>
+            <a:ext cx="1737360" cy="914400"/>
+          </a:xfrm>
+          <a:prstGeom prst="rect">
+            <a:avLst/>
+          </a:prstGeom>
+          <a:noFill/>
+          <a:ln/>
+        </p:spPr>
+        <p:txBody>
+          <a:bodyPr wrap="square" lIns="1016" tIns="1016" rIns="1016" bIns="1016" rtlCol="0" anchor="ctr"/>
+          <a:lstStyle/>
+          <a:p>
+            <a:pPr algn="ctr" indent="0" marL="0">
+              <a:buNone/>
+            </a:pPr>
+            <a:r>
+              <a:rPr lang="en-US" sz="1400" b="1" dirty="0">
+                <a:solidFill>
+                  <a:schemeClr val="tx1"/>
+                </a:solidFill>
+              </a:rPr>
+              <a:t>Catalog</a:t>
+            </a:r>
+            <a:endParaRPr lang="en-US" sz="1400" dirty="0"/>
+          </a:p>
+          <a:p>
+            <a:pPr algn="ctr" indent="0" marL="0">
+              <a:buNone/>
+            </a:pPr>
+            <a:r>
+              <a:rPr lang="en-US" sz="1150" dirty="0">
+                <a:solidFill>
+                  <a:srgbClr val="52514E"/>
+                </a:solidFill>
+              </a:rPr>
+              <a:t>parts, sizes, unit costs</a:t>
+            </a:r>
+            <a:endParaRPr lang="en-US" sz="1400" dirty="0"/>
+          </a:p>
+        </p:txBody>
+      </p:sp>
+      <p:sp>
+        <p:nvSpPr>
+          <p:cNvPr id="7" name="box rules"/>
+          <p:cNvSpPr/>
+          <p:nvPr/>
+        </p:nvSpPr>
+        <p:spPr>
+          <a:xfrm>
+            <a:off x="2743200" y="1554480"/>
+            <a:ext cx="1828800" cy="2240280"/>
+          </a:xfrm>
+          <a:prstGeom prst="roundRect">
+            <a:avLst>
+              <a:gd name="adj" fmla="val 3000"/>
+            </a:avLst>
+          </a:prstGeom>
+          <a:solidFill>
+            <a:schemeClr val="bg2"/>
+          </a:solidFill>
+          <a:ln w="15875">
+            <a:solidFill>
+              <a:srgbClr val="1F2933"/>
+            </a:solidFill>
+            <a:prstDash val="solid"/>
+          </a:ln>
+        </p:spPr>
+      </p:sp>
+      <p:sp>
+        <p:nvSpPr>
+          <p:cNvPr id="8" name="text rules"/>
+          <p:cNvSpPr txBox="1"/>
+          <p:nvPr/>
+        </p:nvSpPr>
+        <p:spPr>
+          <a:xfrm>
+            <a:off x="2743200" y="1554480"/>
+            <a:ext cx="1828800" cy="2240280"/>
+          </a:xfrm>
+          <a:prstGeom prst="rect">
+            <a:avLst/>
+          </a:prstGeom>
+          <a:noFill/>
+          <a:ln/>
+        </p:spPr>
+        <p:txBody>
+          <a:bodyPr wrap="square" lIns="1016" tIns="1016" rIns="1016" bIns="1016" rtlCol="0" anchor="ctr"/>
+          <a:lstStyle/>
+          <a:p>
+            <a:pPr algn="ctr" indent="0" marL="0">
+              <a:buNone/>
+            </a:pPr>
+            <a:r>
+              <a:rPr lang="en-US" sz="1400" b="1" dirty="0">
+                <a:solidFill>
+                  <a:schemeClr val="tx1"/>
+                </a:solidFill>
+              </a:rPr>
+              <a:t>Rules</a:t>
+            </a:r>
+            <a:endParaRPr lang="en-US" sz="1400" dirty="0"/>
+          </a:p>
+          <a:p>
+            <a:pPr algn="ctr" indent="0" marL="0">
+              <a:buNone/>
+            </a:pPr>
+            <a:r>
+              <a:rPr lang="en-US" sz="1150" dirty="0">
+                <a:solidFill>
+                  <a:srgbClr val="52514E"/>
+                </a:solidFill>
+              </a:rPr>
+              <a:t>which actions are legal in a state; each action adds parts</a:t>
+            </a:r>
+            <a:endParaRPr lang="en-US" sz="1400" dirty="0"/>
+          </a:p>
+        </p:txBody>
+      </p:sp>
+      <p:sp>
+        <p:nvSpPr>
+          <p:cNvPr id="9" name="arrow context to rules"/>
+          <p:cNvSpPr/>
+          <p:nvPr/>
+        </p:nvSpPr>
+        <p:spPr>
+          <a:xfrm>
+            <a:off x="2286000" y="2029968"/>
+            <a:ext cx="457200" cy="0"/>
+          </a:xfrm>
+          <a:prstGeom prst="line">
+            <a:avLst/>
+          </a:prstGeom>
+          <a:noFill/>
+          <a:ln w="15875">
+            <a:solidFill>
+              <a:srgbClr val="52514E"/>
+            </a:solidFill>
+            <a:prstDash val="solid"/>
+            <a:tailEnd type="triangle"/>
+          </a:ln>
+        </p:spPr>
+      </p:sp>
+      <p:sp>
+        <p:nvSpPr>
+          <p:cNvPr id="10" name="arrow catalog to rules"/>
+          <p:cNvSpPr/>
+          <p:nvPr/>
+        </p:nvSpPr>
+        <p:spPr>
+          <a:xfrm>
+            <a:off x="2194560" y="3291840"/>
+            <a:ext cx="548640" cy="0"/>
+          </a:xfrm>
+          <a:prstGeom prst="line">
+            <a:avLst/>
+          </a:prstGeom>
+          <a:noFill/>
+          <a:ln w="15875">
+            <a:solidFill>
+              <a:srgbClr val="52514E"/>
+            </a:solidFill>
+            <a:prstDash val="solid"/>
+            <a:tailEnd type="triangle"/>
+          </a:ln>
+        </p:spPr>
+      </p:sp>
+      <p:sp>
+        <p:nvSpPr>
+          <p:cNvPr id="11" name="black box approach"/>
+          <p:cNvSpPr/>
+          <p:nvPr/>
+        </p:nvSpPr>
+        <p:spPr>
+          <a:xfrm>
+            <a:off x="5120640" y="1554480"/>
+            <a:ext cx="2194560" cy="2240280"/>
+          </a:xfrm>
+          <a:prstGeom prst="roundRect">
+            <a:avLst>
+              <a:gd name="adj" fmla="val 2500"/>
+            </a:avLst>
+          </a:prstGeom>
+          <a:solidFill>
+            <a:srgbClr val="0B0B0B"/>
+          </a:solidFill>
+          <a:ln/>
+        </p:spPr>
+      </p:sp>
+      <p:sp>
+        <p:nvSpPr>
+          <p:cNvPr id="12" name="text approach"/>
+          <p:cNvSpPr txBox="1"/>
+          <p:nvPr/>
+        </p:nvSpPr>
+        <p:spPr>
+          <a:xfrm>
+            <a:off x="5120640" y="1554480"/>
+            <a:ext cx="2194560" cy="2240280"/>
+          </a:xfrm>
+          <a:prstGeom prst="rect">
+            <a:avLst/>
+          </a:prstGeom>
+          <a:noFill/>
+          <a:ln/>
+        </p:spPr>
+        <p:txBody>
+          <a:bodyPr wrap="square" lIns="1016" tIns="1016" rIns="1016" bIns="1016" rtlCol="0" anchor="ctr"/>
+          <a:lstStyle/>
+          <a:p>
+            <a:pPr algn="ctr" indent="0" marL="0">
+              <a:buNone/>
+            </a:pPr>
+            <a:r>
+              <a:rPr lang="en-US" sz="1600" b="1" dirty="0">
+                <a:solidFill>
+                  <a:srgbClr val="FFFFFF"/>
+                </a:solidFill>
+              </a:rPr>
+              <a:t>Approach</a:t>
+            </a:r>
+            <a:endParaRPr lang="en-US" sz="1600" dirty="0"/>
+          </a:p>
+          <a:p>
+            <a:pPr algn="ctr" indent="0" marL="0">
+              <a:buNone/>
+            </a:pPr>
+            <a:r>
+              <a:rPr lang="en-US" sz="1150" dirty="0">
+                <a:solidFill>
+                  <a:srgbClr val="CADCFC"/>
+                </a:solidFill>
+              </a:rPr>
+              <a:t>a black box that chooses the next action</a:t>
+            </a:r>
+            <a:endParaRPr lang="en-US" sz="1600" dirty="0"/>
+          </a:p>
+          <a:p>
+            <a:pPr algn="ctr" indent="0" marL="0">
+              <a:buNone/>
+            </a:pPr>
+            <a:endParaRPr lang="en-US" sz="1600" dirty="0"/>
+          </a:p>
+          <a:p>
+            <a:pPr algn="ctr" indent="0" marL="0">
+              <a:buNone/>
+            </a:pPr>
+            <a:r>
+              <a:rPr lang="en-US" sz="1150" dirty="0">
+                <a:solidFill>
+                  <a:srgbClr val="CADCFC"/>
+                </a:solidFill>
+              </a:rPr>
+              <a:t>rule table · search · learned policy</a:t>
+            </a:r>
+            <a:endParaRPr lang="en-US" sz="1600" dirty="0"/>
+          </a:p>
+        </p:txBody>
+      </p:sp>
+      <p:sp>
+        <p:nvSpPr>
+          <p:cNvPr id="13" name="arrow legal actions"/>
+          <p:cNvSpPr/>
+          <p:nvPr/>
+        </p:nvSpPr>
+        <p:spPr>
+          <a:xfrm>
+            <a:off x="4572000" y="2354580"/>
+            <a:ext cx="548640" cy="0"/>
+          </a:xfrm>
+          <a:prstGeom prst="line">
+            <a:avLst/>
+          </a:prstGeom>
+          <a:noFill/>
+          <a:ln w="15875">
+            <a:solidFill>
+              <a:srgbClr val="52514E"/>
+            </a:solidFill>
+            <a:prstDash val="solid"/>
+            <a:tailEnd type="triangle"/>
+          </a:ln>
+        </p:spPr>
+      </p:sp>
+      <p:sp>
+        <p:nvSpPr>
+          <p:cNvPr id="14" name="label legal actions"/>
+          <p:cNvSpPr txBox="1"/>
+          <p:nvPr/>
+        </p:nvSpPr>
+        <p:spPr>
+          <a:xfrm>
+            <a:off x="4572000" y="2071116"/>
+            <a:ext cx="548640" cy="237744"/>
           </a:xfrm>
           <a:prstGeom prst="rect">
             <a:avLst/>
@@ -21515,92 +21886,51 @@
               <a:buNone/>
             </a:pPr>
             <a:r>
-              <a:rPr lang="en-US" sz="1500" b="1" dirty="0">
-                <a:solidFill>
-                  <a:schemeClr val="tx1"/>
-                </a:solidFill>
-              </a:rPr>
-              <a:t>The brief</a:t>
-            </a:r>
-            <a:endParaRPr lang="en-US" sz="1500" dirty="0"/>
-          </a:p>
-          <a:p>
-            <a:pPr algn="ctr" indent="0" marL="0">
-              <a:buNone/>
-            </a:pPr>
-            <a:r>
-              <a:rPr lang="en-US" sz="1250" dirty="0">
+              <a:rPr lang="en-US" sz="1050" dirty="0">
                 <a:solidFill>
                   <a:srgbClr val="52514E"/>
                 </a:solidFill>
               </a:rPr>
-              <a:t>the section at one hanger: structure, services and their loads, plus a catalog of parts with unit costs</a:t>
+              <a:t>legal actions</a:t>
             </a:r>
-            <a:endParaRPr lang="en-US" sz="1500" dirty="0"/>
+            <a:endParaRPr lang="en-US" sz="1050" dirty="0"/>
           </a:p>
         </p:txBody>
       </p:sp>
       <p:sp>
         <p:nvSpPr>
-          <p:cNvPr id="5" name="flow arrow 1"/>
+          <p:cNvPr id="15" name="arrow chosen action"/>
           <p:cNvSpPr/>
           <p:nvPr/>
         </p:nvSpPr>
         <p:spPr>
           <a:xfrm>
-            <a:off x="2697480" y="2377440"/>
-            <a:ext cx="457200" cy="0"/>
+            <a:off x="4572000" y="2994660"/>
+            <a:ext cx="548640" cy="0"/>
           </a:xfrm>
           <a:prstGeom prst="line">
             <a:avLst/>
           </a:prstGeom>
           <a:noFill/>
-          <a:ln w="19050">
+          <a:ln w="15875">
             <a:solidFill>
               <a:srgbClr val="52514E"/>
             </a:solidFill>
             <a:prstDash val="solid"/>
-            <a:tailEnd type="triangle"/>
+            <a:headEnd type="triangle"/>
           </a:ln>
         </p:spPr>
       </p:sp>
       <p:sp>
         <p:nvSpPr>
-          <p:cNvPr id="6" name="flow box build"/>
-          <p:cNvSpPr/>
+          <p:cNvPr id="16" name="label chosen action"/>
+          <p:cNvSpPr txBox="1"/>
           <p:nvPr/>
         </p:nvSpPr>
         <p:spPr>
           <a:xfrm>
-            <a:off x="3154680" y="1600200"/>
-            <a:ext cx="3017520" cy="1554480"/>
-          </a:xfrm>
-          <a:prstGeom prst="roundRect">
-            <a:avLst>
-              <a:gd name="adj" fmla="val 4118"/>
-            </a:avLst>
-          </a:prstGeom>
-          <a:solidFill>
-            <a:schemeClr val="bg2"/>
-          </a:solidFill>
-          <a:ln w="19050">
-            <a:solidFill>
-              <a:schemeClr val="accent1"/>
-            </a:solidFill>
-            <a:prstDash val="solid"/>
-          </a:ln>
-        </p:spPr>
-      </p:sp>
-      <p:sp>
-        <p:nvSpPr>
-          <p:cNvPr id="7" name="flow text build"/>
-          <p:cNvSpPr txBox="1"/>
-          <p:nvPr/>
-        </p:nvSpPr>
-        <p:spPr>
-          <a:xfrm>
-            <a:off x="3319272" y="1709928"/>
-            <a:ext cx="2688336" cy="1335024"/>
+            <a:off x="4572000" y="3040380"/>
+            <a:ext cx="548640" cy="237744"/>
           </a:xfrm>
           <a:prstGeom prst="rect">
             <a:avLst/>
@@ -21616,73 +21946,35 @@
               <a:buNone/>
             </a:pPr>
             <a:r>
-              <a:rPr lang="en-US" sz="1500" b="1" dirty="0">
-                <a:solidFill>
-                  <a:schemeClr val="tx1"/>
-                </a:solidFill>
-              </a:rPr>
-              <a:t>Build the assembly step by step</a:t>
-            </a:r>
-            <a:endParaRPr lang="en-US" sz="1500" dirty="0"/>
-          </a:p>
-          <a:p>
-            <a:pPr algn="ctr" indent="0" marL="0">
-              <a:buNone/>
-            </a:pPr>
-            <a:r>
-              <a:rPr lang="en-US" sz="1250" dirty="0">
+              <a:rPr lang="en-US" sz="1050" dirty="0">
                 <a:solidFill>
                   <a:srgbClr val="52514E"/>
                 </a:solidFill>
               </a:rPr>
-              <a:t>each step adds parts the rules allow; the step is chosen by a rule table, by search, or by a learned policy</a:t>
+              <a:t>chosen action</a:t>
             </a:r>
-            <a:endParaRPr lang="en-US" sz="1500" dirty="0"/>
+            <a:endParaRPr lang="en-US" sz="1050" dirty="0"/>
           </a:p>
         </p:txBody>
       </p:sp>
       <p:sp>
         <p:nvSpPr>
-          <p:cNvPr id="8" name="flow arrow 2"/>
+          <p:cNvPr id="17" name="box verifier"/>
           <p:cNvSpPr/>
           <p:nvPr/>
         </p:nvSpPr>
         <p:spPr>
           <a:xfrm>
-            <a:off x="6172200" y="2377440"/>
-            <a:ext cx="457200" cy="0"/>
-          </a:xfrm>
-          <a:prstGeom prst="line">
-            <a:avLst/>
-          </a:prstGeom>
-          <a:noFill/>
-          <a:ln w="19050">
-            <a:solidFill>
-              <a:srgbClr val="52514E"/>
-            </a:solidFill>
-            <a:prstDash val="solid"/>
-            <a:tailEnd type="triangle"/>
-          </a:ln>
-        </p:spPr>
-      </p:sp>
-      <p:sp>
-        <p:nvSpPr>
-          <p:cNvPr id="9" name="flow box check"/>
-          <p:cNvSpPr/>
-          <p:nvPr/>
-        </p:nvSpPr>
-        <p:spPr>
-          <a:xfrm>
-            <a:off x="6629400" y="1600200"/>
-            <a:ext cx="2697480" cy="1554480"/>
+            <a:off x="7863840" y="1554480"/>
+            <a:ext cx="1828800" cy="2240280"/>
           </a:xfrm>
           <a:prstGeom prst="roundRect">
             <a:avLst>
-              <a:gd name="adj" fmla="val 4118"/>
+              <a:gd name="adj" fmla="val 3000"/>
             </a:avLst>
           </a:prstGeom>
           <a:solidFill>
-            <a:schemeClr val="bg2"/>
+            <a:srgbClr val="EAF5EE"/>
           </a:solidFill>
           <a:ln w="19050">
             <a:solidFill>
@@ -21694,14 +21986,88 @@
       </p:sp>
       <p:sp>
         <p:nvSpPr>
-          <p:cNvPr id="10" name="flow text check"/>
+          <p:cNvPr id="18" name="text verifier"/>
           <p:cNvSpPr txBox="1"/>
           <p:nvPr/>
         </p:nvSpPr>
         <p:spPr>
           <a:xfrm>
-            <a:off x="6793992" y="1709928"/>
-            <a:ext cx="2368296" cy="1335024"/>
+            <a:off x="7863840" y="1554480"/>
+            <a:ext cx="1828800" cy="2240280"/>
+          </a:xfrm>
+          <a:prstGeom prst="rect">
+            <a:avLst/>
+          </a:prstGeom>
+          <a:noFill/>
+          <a:ln/>
+        </p:spPr>
+        <p:txBody>
+          <a:bodyPr wrap="square" lIns="1016" tIns="1016" rIns="1016" bIns="1016" rtlCol="0" anchor="ctr"/>
+          <a:lstStyle/>
+          <a:p>
+            <a:pPr algn="ctr" indent="0" marL="0">
+              <a:buNone/>
+            </a:pPr>
+            <a:r>
+              <a:rPr lang="en-US" sz="1400" b="1" dirty="0">
+                <a:solidFill>
+                  <a:schemeClr val="tx1"/>
+                </a:solidFill>
+              </a:rPr>
+              <a:t>Verifier</a:t>
+            </a:r>
+            <a:endParaRPr lang="en-US" sz="1400" dirty="0"/>
+          </a:p>
+          <a:p>
+            <a:pPr algn="ctr" indent="0" marL="0">
+              <a:buNone/>
+            </a:pPr>
+            <a:r>
+              <a:rPr lang="en-US" sz="1150" dirty="0">
+                <a:solidFill>
+                  <a:srgbClr val="52514E"/>
+                </a:solidFill>
+              </a:rPr>
+              <a:t>judges every finished design: statics, anchors, connectors, buildability</a:t>
+            </a:r>
+            <a:endParaRPr lang="en-US" sz="1400" dirty="0"/>
+          </a:p>
+        </p:txBody>
+      </p:sp>
+      <p:sp>
+        <p:nvSpPr>
+          <p:cNvPr id="19" name="arrow finished design"/>
+          <p:cNvSpPr/>
+          <p:nvPr/>
+        </p:nvSpPr>
+        <p:spPr>
+          <a:xfrm>
+            <a:off x="7315200" y="2674620"/>
+            <a:ext cx="548640" cy="0"/>
+          </a:xfrm>
+          <a:prstGeom prst="line">
+            <a:avLst/>
+          </a:prstGeom>
+          <a:noFill/>
+          <a:ln w="15875">
+            <a:solidFill>
+              <a:srgbClr val="52514E"/>
+            </a:solidFill>
+            <a:prstDash val="solid"/>
+            <a:tailEnd type="triangle"/>
+          </a:ln>
+        </p:spPr>
+      </p:sp>
+      <p:sp>
+        <p:nvSpPr>
+          <p:cNvPr id="20" name="label finished design"/>
+          <p:cNvSpPr txBox="1"/>
+          <p:nvPr/>
+        </p:nvSpPr>
+        <p:spPr>
+          <a:xfrm>
+            <a:off x="7315200" y="2391156"/>
+            <a:ext cx="548640" cy="237744"/>
           </a:xfrm>
           <a:prstGeom prst="rect">
             <a:avLst/>
@@ -21717,87 +22083,54 @@
               <a:buNone/>
             </a:pPr>
             <a:r>
-              <a:rPr lang="en-US" sz="1500" b="1" dirty="0">
-                <a:solidFill>
-                  <a:schemeClr val="tx1"/>
-                </a:solidFill>
-              </a:rPr>
-              <a:t>Check every finished design</a:t>
-            </a:r>
-            <a:endParaRPr lang="en-US" sz="1500" dirty="0"/>
-          </a:p>
-          <a:p>
-            <a:pPr algn="ctr" indent="0" marL="0">
-              <a:buNone/>
-            </a:pPr>
-            <a:r>
-              <a:rPr lang="en-US" sz="1250" dirty="0">
+              <a:rPr lang="en-US" sz="1050" dirty="0">
                 <a:solidFill>
                   <a:srgbClr val="52514E"/>
                 </a:solidFill>
               </a:rPr>
-              <a:t>statics, anchors, connectors, buildability</a:t>
+              <a:t>finished design</a:t>
             </a:r>
-            <a:endParaRPr lang="en-US" sz="1500" dirty="0"/>
+            <a:endParaRPr lang="en-US" sz="1050" dirty="0"/>
           </a:p>
         </p:txBody>
       </p:sp>
       <p:sp>
         <p:nvSpPr>
-          <p:cNvPr id="11" name="flow arrow 3"/>
+          <p:cNvPr id="21" name="box output"/>
           <p:cNvSpPr/>
           <p:nvPr/>
         </p:nvSpPr>
         <p:spPr>
           <a:xfrm>
-            <a:off x="9326880" y="2377440"/>
-            <a:ext cx="457200" cy="0"/>
-          </a:xfrm>
-          <a:prstGeom prst="line">
-            <a:avLst/>
-          </a:prstGeom>
-          <a:noFill/>
-          <a:ln w="19050">
-            <a:solidFill>
-              <a:srgbClr val="52514E"/>
-            </a:solidFill>
-            <a:prstDash val="solid"/>
-            <a:tailEnd type="triangle"/>
-          </a:ln>
-        </p:spPr>
-      </p:sp>
-      <p:sp>
-        <p:nvSpPr>
-          <p:cNvPr id="12" name="flow box out"/>
-          <p:cNvSpPr/>
-          <p:nvPr/>
-        </p:nvSpPr>
-        <p:spPr>
-          <a:xfrm>
-            <a:off x="9784080" y="1600200"/>
-            <a:ext cx="1856232" cy="1554480"/>
+            <a:off x="10104120" y="1554480"/>
+            <a:ext cx="1536192" cy="2240280"/>
           </a:xfrm>
           <a:prstGeom prst="roundRect">
             <a:avLst>
-              <a:gd name="adj" fmla="val 4118"/>
+              <a:gd name="adj" fmla="val 3571"/>
             </a:avLst>
           </a:prstGeom>
           <a:solidFill>
-            <a:schemeClr val="tx2"/>
+            <a:schemeClr val="bg2"/>
           </a:solidFill>
-          <a:ln/>
+          <a:ln w="19050">
+            <a:solidFill>
+              <a:srgbClr val="0B0B0B"/>
+            </a:solidFill>
+            <a:prstDash val="solid"/>
+          </a:ln>
         </p:spPr>
       </p:sp>
       <p:sp>
         <p:nvSpPr>
-          <p:cNvPr id="13" name="flow text out"/>
+          <p:cNvPr id="22" name="text output"/>
           <p:cNvSpPr txBox="1"/>
           <p:nvPr/>
         </p:nvSpPr>
         <p:spPr>
           <a:xfrm>
-            <a:off x="9948672" y="1709928"/>
-            <a:ext cx="1527048" cy="1335024"/>
+            <a:off x="10104120" y="1554480"/>
+            <a:ext cx="1536192" cy="2240280"/>
           </a:xfrm>
           <a:prstGeom prst="rect">
             <a:avLst/>
@@ -21806,48 +22139,118 @@
           <a:ln/>
         </p:spPr>
         <p:txBody>
-          <a:bodyPr wrap="square" lIns="0" tIns="0" rIns="0" bIns="0" rtlCol="0" anchor="ctr"/>
+          <a:bodyPr wrap="square" lIns="1016" tIns="1016" rIns="1016" bIns="1016" rtlCol="0" anchor="ctr"/>
           <a:lstStyle/>
           <a:p>
             <a:pPr algn="ctr" indent="0" marL="0">
               <a:buNone/>
             </a:pPr>
             <a:r>
-              <a:rPr lang="en-US" sz="1500" b="1" dirty="0">
+              <a:rPr lang="en-US" sz="1400" b="1" dirty="0">
                 <a:solidFill>
-                  <a:srgbClr val="FFFFFF"/>
+                  <a:schemeClr val="tx1"/>
                 </a:solidFill>
               </a:rPr>
               <a:t>Verified designs</a:t>
             </a:r>
-            <a:endParaRPr lang="en-US" sz="1500" dirty="0"/>
+            <a:endParaRPr lang="en-US" sz="1400" dirty="0"/>
           </a:p>
           <a:p>
             <a:pPr algn="ctr" indent="0" marL="0">
               <a:buNone/>
             </a:pPr>
             <a:r>
-              <a:rPr lang="en-US" sz="1250" dirty="0">
+              <a:rPr lang="en-US" sz="1150" dirty="0">
                 <a:solidFill>
-                  <a:srgbClr val="CADCFC"/>
+                  <a:srgbClr val="52514E"/>
                 </a:solidFill>
               </a:rPr>
               <a:t>up to ten, ranked by installed cost</a:t>
             </a:r>
-            <a:endParaRPr lang="en-US" sz="1500" dirty="0"/>
+            <a:endParaRPr lang="en-US" sz="1400" dirty="0"/>
           </a:p>
         </p:txBody>
       </p:sp>
       <p:sp>
         <p:nvSpPr>
-          <p:cNvPr id="14" name="feedback line"/>
+          <p:cNvPr id="23" name="arrow to output"/>
           <p:cNvSpPr/>
           <p:nvPr/>
         </p:nvSpPr>
         <p:spPr>
           <a:xfrm>
-            <a:off x="4663440" y="3227832"/>
-            <a:ext cx="3291840" cy="0"/>
+            <a:off x="9692640" y="2674620"/>
+            <a:ext cx="411480" cy="0"/>
+          </a:xfrm>
+          <a:prstGeom prst="line">
+            <a:avLst/>
+          </a:prstGeom>
+          <a:noFill/>
+          <a:ln w="15875">
+            <a:solidFill>
+              <a:srgbClr val="52514E"/>
+            </a:solidFill>
+            <a:prstDash val="solid"/>
+            <a:tailEnd type="triangle"/>
+          </a:ln>
+        </p:spPr>
+      </p:sp>
+      <p:sp>
+        <p:nvSpPr>
+          <p:cNvPr id="24" name="feedback down"/>
+          <p:cNvSpPr/>
+          <p:nvPr/>
+        </p:nvSpPr>
+        <p:spPr>
+          <a:xfrm>
+            <a:off x="8778240" y="3794760"/>
+            <a:ext cx="0" cy="274320"/>
+          </a:xfrm>
+          <a:prstGeom prst="line">
+            <a:avLst/>
+          </a:prstGeom>
+          <a:noFill/>
+          <a:ln w="15875">
+            <a:solidFill>
+              <a:srgbClr val="008300"/>
+            </a:solidFill>
+            <a:prstDash val="dash"/>
+          </a:ln>
+        </p:spPr>
+      </p:sp>
+      <p:sp>
+        <p:nvSpPr>
+          <p:cNvPr id="25" name="feedback across"/>
+          <p:cNvSpPr/>
+          <p:nvPr/>
+        </p:nvSpPr>
+        <p:spPr>
+          <a:xfrm>
+            <a:off x="6217920" y="4069080"/>
+            <a:ext cx="2560320" cy="0"/>
+          </a:xfrm>
+          <a:prstGeom prst="line">
+            <a:avLst/>
+          </a:prstGeom>
+          <a:noFill/>
+          <a:ln w="15875">
+            <a:solidFill>
+              <a:srgbClr val="008300"/>
+            </a:solidFill>
+            <a:prstDash val="dash"/>
+          </a:ln>
+        </p:spPr>
+      </p:sp>
+      <p:sp>
+        <p:nvSpPr>
+          <p:cNvPr id="26" name="feedback up"/>
+          <p:cNvSpPr/>
+          <p:nvPr/>
+        </p:nvSpPr>
+        <p:spPr>
+          <a:xfrm>
+            <a:off x="6217920" y="3794760"/>
+            <a:ext cx="0" cy="274320"/>
           </a:xfrm>
           <a:prstGeom prst="line">
             <a:avLst/>
@@ -21864,14 +22267,14 @@
       </p:sp>
       <p:sp>
         <p:nvSpPr>
-          <p:cNvPr id="15" name="feedback label"/>
+          <p:cNvPr id="27" name="label feedback"/>
           <p:cNvSpPr txBox="1"/>
           <p:nvPr/>
         </p:nvSpPr>
         <p:spPr>
           <a:xfrm>
-            <a:off x="4663440" y="3264408"/>
-            <a:ext cx="3291840" cy="274320"/>
+            <a:off x="6400800" y="4096512"/>
+            <a:ext cx="2194560" cy="237744"/>
           </a:xfrm>
           <a:prstGeom prst="rect">
             <a:avLst/>
@@ -21887,27 +22290,54 @@
               <a:buNone/>
             </a:pPr>
             <a:r>
-              <a:rPr lang="en-US" sz="1100" dirty="0">
+              <a:rPr lang="en-US" sz="1050" dirty="0">
                 <a:solidFill>
                   <a:srgbClr val="008300"/>
                 </a:solidFill>
               </a:rPr>
-              <a:t>pass or fail, fed back to the next attempt</a:t>
+              <a:t>pass or fail, fed back</a:t>
             </a:r>
-            <a:endParaRPr lang="en-US" sz="1100" dirty="0"/>
+            <a:endParaRPr lang="en-US" sz="1050" dirty="0"/>
           </a:p>
         </p:txBody>
       </p:sp>
       <p:sp>
         <p:nvSpPr>
-          <p:cNvPr id="16" name="needs heading"/>
+          <p:cNvPr id="28" name="legend swatch Input"/>
+          <p:cNvSpPr/>
+          <p:nvPr/>
+        </p:nvSpPr>
+        <p:spPr>
+          <a:xfrm>
+            <a:off x="548640" y="4654296"/>
+            <a:ext cx="274320" cy="182880"/>
+          </a:xfrm>
+          <a:prstGeom prst="roundRect">
+            <a:avLst>
+              <a:gd name="adj" fmla="val 20000"/>
+            </a:avLst>
+          </a:prstGeom>
+          <a:solidFill>
+            <a:schemeClr val="bg2"/>
+          </a:solidFill>
+          <a:ln w="12700">
+            <a:solidFill>
+              <a:srgbClr val="52514E"/>
+            </a:solidFill>
+            <a:prstDash val="solid"/>
+          </a:ln>
+        </p:spPr>
+      </p:sp>
+      <p:sp>
+        <p:nvSpPr>
+          <p:cNvPr id="29" name="legend Input"/>
           <p:cNvSpPr txBox="1"/>
           <p:nvPr/>
         </p:nvSpPr>
         <p:spPr>
           <a:xfrm>
-            <a:off x="548640" y="3931920"/>
-            <a:ext cx="11091672" cy="365760"/>
+            <a:off x="896112" y="4617720"/>
+            <a:ext cx="2011680" cy="256032"/>
           </a:xfrm>
           <a:prstGeom prst="rect">
             <a:avLst/>
@@ -21923,49 +22353,54 @@
               <a:buNone/>
             </a:pPr>
             <a:r>
-              <a:rPr lang="en-US" sz="1700" b="1" dirty="0">
+              <a:rPr lang="en-US" sz="1150" dirty="0">
                 <a:solidFill>
                   <a:schemeClr val="tx1"/>
                 </a:solidFill>
               </a:rPr>
-              <a:t>What any such method needs before it can be built or compared</a:t>
+              <a:t>Input</a:t>
             </a:r>
-            <a:endParaRPr lang="en-US" sz="1700" dirty="0"/>
+            <a:endParaRPr lang="en-US" sz="1150" dirty="0"/>
           </a:p>
         </p:txBody>
       </p:sp>
       <p:sp>
         <p:nvSpPr>
-          <p:cNvPr id="17" name="need Problems to learn from"/>
+          <p:cNvPr id="30" name="legend swatch Rules"/>
           <p:cNvSpPr/>
           <p:nvPr/>
         </p:nvSpPr>
         <p:spPr>
           <a:xfrm>
-            <a:off x="548640" y="4434840"/>
-            <a:ext cx="3575304" cy="1325880"/>
+            <a:off x="1787652" y="4654296"/>
+            <a:ext cx="274320" cy="182880"/>
           </a:xfrm>
           <a:prstGeom prst="roundRect">
             <a:avLst>
-              <a:gd name="adj" fmla="val 4828"/>
+              <a:gd name="adj" fmla="val 20000"/>
             </a:avLst>
           </a:prstGeom>
           <a:solidFill>
             <a:schemeClr val="bg2"/>
           </a:solidFill>
-          <a:ln/>
+          <a:ln w="12700">
+            <a:solidFill>
+              <a:srgbClr val="1F2933"/>
+            </a:solidFill>
+            <a:prstDash val="solid"/>
+          </a:ln>
         </p:spPr>
       </p:sp>
       <p:sp>
         <p:nvSpPr>
-          <p:cNvPr id="18" name="need head Problems to learn from"/>
+          <p:cNvPr id="31" name="legend Rules"/>
           <p:cNvSpPr txBox="1"/>
           <p:nvPr/>
         </p:nvSpPr>
         <p:spPr>
           <a:xfrm>
-            <a:off x="777240" y="4553712"/>
-            <a:ext cx="3118104" cy="384048"/>
+            <a:off x="2135124" y="4617720"/>
+            <a:ext cx="2011680" cy="256032"/>
           </a:xfrm>
           <a:prstGeom prst="rect">
             <a:avLst/>
@@ -21981,85 +22416,54 @@
               <a:buNone/>
             </a:pPr>
             <a:r>
-              <a:rPr lang="en-US" sz="1600" b="1" dirty="0">
-                <a:solidFill>
-                  <a:schemeClr val="accent1"/>
-                </a:solidFill>
-              </a:rPr>
-              <a:t>1. Problems to learn from</a:t>
-            </a:r>
-            <a:endParaRPr lang="en-US" sz="1600" dirty="0"/>
-          </a:p>
-        </p:txBody>
-      </p:sp>
-      <p:sp>
-        <p:nvSpPr>
-          <p:cNvPr id="19" name="need text Problems to learn from"/>
-          <p:cNvSpPr txBox="1"/>
-          <p:nvPr/>
-        </p:nvSpPr>
-        <p:spPr>
-          <a:xfrm>
-            <a:off x="777240" y="4983480"/>
-            <a:ext cx="3118104" cy="685800"/>
-          </a:xfrm>
-          <a:prstGeom prst="rect">
-            <a:avLst/>
-          </a:prstGeom>
-          <a:noFill/>
-          <a:ln/>
-        </p:spPr>
-        <p:txBody>
-          <a:bodyPr wrap="square" lIns="0" tIns="0" rIns="0" bIns="0" rtlCol="0" anchor="t"/>
-          <a:lstStyle/>
-          <a:p>
-            <a:pPr indent="0" marL="0">
-              <a:buNone/>
-            </a:pPr>
-            <a:r>
-              <a:rPr lang="en-US" sz="1400" dirty="0">
+              <a:rPr lang="en-US" sz="1150" dirty="0">
                 <a:solidFill>
                   <a:schemeClr val="tx1"/>
                 </a:solidFill>
               </a:rPr>
-              <a:t>many sections at hangers, varied the way buildings vary</a:t>
+              <a:t>Rules</a:t>
             </a:r>
-            <a:endParaRPr lang="en-US" sz="1400" dirty="0"/>
+            <a:endParaRPr lang="en-US" sz="1150" dirty="0"/>
           </a:p>
         </p:txBody>
       </p:sp>
       <p:sp>
         <p:nvSpPr>
-          <p:cNvPr id="20" name="need A fixed set to compare on"/>
+          <p:cNvPr id="32" name="legend swatch Approach (black box)"/>
           <p:cNvSpPr/>
           <p:nvPr/>
         </p:nvSpPr>
         <p:spPr>
           <a:xfrm>
-            <a:off x="4306824" y="4434840"/>
-            <a:ext cx="3575304" cy="1325880"/>
+            <a:off x="3026664" y="4654296"/>
+            <a:ext cx="274320" cy="182880"/>
           </a:xfrm>
           <a:prstGeom prst="roundRect">
             <a:avLst>
-              <a:gd name="adj" fmla="val 4828"/>
+              <a:gd name="adj" fmla="val 20000"/>
             </a:avLst>
           </a:prstGeom>
           <a:solidFill>
-            <a:schemeClr val="bg2"/>
+            <a:srgbClr val="0B0B0B"/>
           </a:solidFill>
-          <a:ln/>
+          <a:ln w="12700">
+            <a:solidFill>
+              <a:srgbClr val="0B0B0B"/>
+            </a:solidFill>
+            <a:prstDash val="solid"/>
+          </a:ln>
         </p:spPr>
       </p:sp>
       <p:sp>
         <p:nvSpPr>
-          <p:cNvPr id="21" name="need head A fixed set to compare on"/>
+          <p:cNvPr id="33" name="legend Approach (black box)"/>
           <p:cNvSpPr txBox="1"/>
           <p:nvPr/>
         </p:nvSpPr>
         <p:spPr>
           <a:xfrm>
-            <a:off x="4535424" y="4553712"/>
-            <a:ext cx="3118104" cy="384048"/>
+            <a:off x="3374136" y="4617720"/>
+            <a:ext cx="2011680" cy="256032"/>
           </a:xfrm>
           <a:prstGeom prst="rect">
             <a:avLst/>
@@ -22075,85 +22479,54 @@
               <a:buNone/>
             </a:pPr>
             <a:r>
-              <a:rPr lang="en-US" sz="1600" b="1" dirty="0">
-                <a:solidFill>
-                  <a:schemeClr val="accent1"/>
-                </a:solidFill>
-              </a:rPr>
-              <a:t>2. A fixed set to compare on</a:t>
-            </a:r>
-            <a:endParaRPr lang="en-US" sz="1600" dirty="0"/>
-          </a:p>
-        </p:txBody>
-      </p:sp>
-      <p:sp>
-        <p:nvSpPr>
-          <p:cNvPr id="22" name="need text A fixed set to compare on"/>
-          <p:cNvSpPr txBox="1"/>
-          <p:nvPr/>
-        </p:nvSpPr>
-        <p:spPr>
-          <a:xfrm>
-            <a:off x="4535424" y="4983480"/>
-            <a:ext cx="3118104" cy="685800"/>
-          </a:xfrm>
-          <a:prstGeom prst="rect">
-            <a:avLst/>
-          </a:prstGeom>
-          <a:noFill/>
-          <a:ln/>
-        </p:spPr>
-        <p:txBody>
-          <a:bodyPr wrap="square" lIns="0" tIns="0" rIns="0" bIns="0" rtlCol="0" anchor="t"/>
-          <a:lstStyle/>
-          <a:p>
-            <a:pPr indent="0" marL="0">
-              <a:buNone/>
-            </a:pPr>
-            <a:r>
-              <a:rPr lang="en-US" sz="1400" dirty="0">
+              <a:rPr lang="en-US" sz="1150" dirty="0">
                 <a:solidFill>
                   <a:schemeClr val="tx1"/>
                 </a:solidFill>
               </a:rPr>
-              <a:t>the same problems for every method, by difficulty</a:t>
+              <a:t>Approach (black box)</a:t>
             </a:r>
-            <a:endParaRPr lang="en-US" sz="1400" dirty="0"/>
+            <a:endParaRPr lang="en-US" sz="1150" dirty="0"/>
           </a:p>
         </p:txBody>
       </p:sp>
       <p:sp>
         <p:nvSpPr>
-          <p:cNvPr id="23" name="need Problems that look like practice"/>
+          <p:cNvPr id="34" name="legend swatch Verifier"/>
           <p:cNvSpPr/>
           <p:nvPr/>
         </p:nvSpPr>
         <p:spPr>
           <a:xfrm>
-            <a:off x="8065008" y="4434840"/>
-            <a:ext cx="3575304" cy="1325880"/>
+            <a:off x="5431536" y="4654296"/>
+            <a:ext cx="274320" cy="182880"/>
           </a:xfrm>
           <a:prstGeom prst="roundRect">
             <a:avLst>
-              <a:gd name="adj" fmla="val 4828"/>
+              <a:gd name="adj" fmla="val 20000"/>
             </a:avLst>
           </a:prstGeom>
           <a:solidFill>
-            <a:schemeClr val="bg2"/>
+            <a:srgbClr val="EAF5EE"/>
           </a:solidFill>
-          <a:ln/>
+          <a:ln w="12700">
+            <a:solidFill>
+              <a:srgbClr val="008300"/>
+            </a:solidFill>
+            <a:prstDash val="solid"/>
+          </a:ln>
         </p:spPr>
       </p:sp>
       <p:sp>
         <p:nvSpPr>
-          <p:cNvPr id="24" name="need head Problems that look like practice"/>
+          <p:cNvPr id="35" name="legend Verifier"/>
           <p:cNvSpPr txBox="1"/>
           <p:nvPr/>
         </p:nvSpPr>
         <p:spPr>
           <a:xfrm>
-            <a:off x="8293608" y="4553712"/>
-            <a:ext cx="3118104" cy="384048"/>
+            <a:off x="5779008" y="4617720"/>
+            <a:ext cx="2011680" cy="256032"/>
           </a:xfrm>
           <a:prstGeom prst="rect">
             <a:avLst/>
@@ -22169,27 +22542,54 @@
               <a:buNone/>
             </a:pPr>
             <a:r>
-              <a:rPr lang="en-US" sz="1600" b="1" dirty="0">
+              <a:rPr lang="en-US" sz="1150" dirty="0">
                 <a:solidFill>
-                  <a:schemeClr val="accent1"/>
+                  <a:schemeClr val="tx1"/>
                 </a:solidFill>
               </a:rPr>
-              <a:t>3. Problems that look like practice</a:t>
+              <a:t>Verifier</a:t>
             </a:r>
-            <a:endParaRPr lang="en-US" sz="1600" dirty="0"/>
+            <a:endParaRPr lang="en-US" sz="1150" dirty="0"/>
           </a:p>
         </p:txBody>
       </p:sp>
       <p:sp>
         <p:nvSpPr>
-          <p:cNvPr id="25" name="need text Problems that look like practice"/>
+          <p:cNvPr id="36" name="legend swatch Output"/>
+          <p:cNvSpPr/>
+          <p:nvPr/>
+        </p:nvSpPr>
+        <p:spPr>
+          <a:xfrm>
+            <a:off x="6903720" y="4654296"/>
+            <a:ext cx="274320" cy="182880"/>
+          </a:xfrm>
+          <a:prstGeom prst="roundRect">
+            <a:avLst>
+              <a:gd name="adj" fmla="val 20000"/>
+            </a:avLst>
+          </a:prstGeom>
+          <a:solidFill>
+            <a:schemeClr val="bg2"/>
+          </a:solidFill>
+          <a:ln w="12700">
+            <a:solidFill>
+              <a:srgbClr val="0B0B0B"/>
+            </a:solidFill>
+            <a:prstDash val="solid"/>
+          </a:ln>
+        </p:spPr>
+      </p:sp>
+      <p:sp>
+        <p:nvSpPr>
+          <p:cNvPr id="37" name="legend Output"/>
           <p:cNvSpPr txBox="1"/>
           <p:nvPr/>
         </p:nvSpPr>
         <p:spPr>
           <a:xfrm>
-            <a:off x="8293608" y="4983480"/>
-            <a:ext cx="3118104" cy="685800"/>
+            <a:off x="7251192" y="4617720"/>
+            <a:ext cx="2011680" cy="256032"/>
           </a:xfrm>
           <a:prstGeom prst="rect">
             <a:avLst/>
@@ -22198,21 +22598,145 @@
           <a:ln/>
         </p:spPr>
         <p:txBody>
-          <a:bodyPr wrap="square" lIns="0" tIns="0" rIns="0" bIns="0" rtlCol="0" anchor="t"/>
+          <a:bodyPr wrap="square" lIns="0" tIns="0" rIns="0" bIns="0" rtlCol="0" anchor="ctr"/>
           <a:lstStyle/>
           <a:p>
             <a:pPr indent="0" marL="0">
               <a:buNone/>
             </a:pPr>
             <a:r>
-              <a:rPr lang="en-US" sz="1400" dirty="0">
+              <a:rPr lang="en-US" sz="1150" dirty="0">
                 <a:solidFill>
                   <a:schemeClr val="tx1"/>
                 </a:solidFill>
               </a:rPr>
-              <a:t>sizes, spacing and loads an engineer would recognise</a:t>
+              <a:t>Output</a:t>
             </a:r>
-            <a:endParaRPr lang="en-US" sz="1400" dirty="0"/>
+            <a:endParaRPr lang="en-US" sz="1150" dirty="0"/>
+          </a:p>
+        </p:txBody>
+      </p:sp>
+      <p:sp>
+        <p:nvSpPr>
+          <p:cNvPr id="38" name="needs band"/>
+          <p:cNvSpPr/>
+          <p:nvPr/>
+        </p:nvSpPr>
+        <p:spPr>
+          <a:xfrm>
+            <a:off x="548640" y="5074920"/>
+            <a:ext cx="11091672" cy="914400"/>
+          </a:xfrm>
+          <a:prstGeom prst="roundRect">
+            <a:avLst>
+              <a:gd name="adj" fmla="val 7000"/>
+            </a:avLst>
+          </a:prstGeom>
+          <a:solidFill>
+            <a:schemeClr val="tx2"/>
+          </a:solidFill>
+          <a:ln/>
+        </p:spPr>
+      </p:sp>
+      <p:sp>
+        <p:nvSpPr>
+          <p:cNvPr id="39" name="needs text"/>
+          <p:cNvSpPr txBox="1"/>
+          <p:nvPr/>
+        </p:nvSpPr>
+        <p:spPr>
+          <a:xfrm>
+            <a:off x="822960" y="5074920"/>
+            <a:ext cx="10515600" cy="914400"/>
+          </a:xfrm>
+          <a:prstGeom prst="rect">
+            <a:avLst/>
+          </a:prstGeom>
+          <a:noFill/>
+          <a:ln/>
+        </p:spPr>
+        <p:txBody>
+          <a:bodyPr wrap="square" lIns="0" tIns="0" rIns="0" bIns="0" rtlCol="0" anchor="ctr"/>
+          <a:lstStyle/>
+          <a:p>
+            <a:pPr indent="0" marL="0">
+              <a:buNone/>
+            </a:pPr>
+            <a:r>
+              <a:rPr lang="en-US" sz="1600" dirty="0">
+                <a:solidFill>
+                  <a:srgbClr val="FFFFFF"/>
+                </a:solidFill>
+              </a:rPr>
+              <a:t>Whatever sits in the black box, it needs </a:t>
+            </a:r>
+            <a:pPr indent="0" marL="0">
+              <a:buNone/>
+            </a:pPr>
+            <a:r>
+              <a:rPr lang="en-US" sz="1600" b="1" dirty="0">
+                <a:solidFill>
+                  <a:srgbClr val="FFFFFF"/>
+                </a:solidFill>
+              </a:rPr>
+              <a:t>problems to learn from</a:t>
+            </a:r>
+            <a:pPr indent="0" marL="0">
+              <a:buNone/>
+            </a:pPr>
+            <a:r>
+              <a:rPr lang="en-US" sz="1600" dirty="0">
+                <a:solidFill>
+                  <a:srgbClr val="FFFFFF"/>
+                </a:solidFill>
+              </a:rPr>
+              <a:t>, </a:t>
+            </a:r>
+            <a:pPr indent="0" marL="0">
+              <a:buNone/>
+            </a:pPr>
+            <a:r>
+              <a:rPr lang="en-US" sz="1600" b="1" dirty="0">
+                <a:solidFill>
+                  <a:srgbClr val="FFFFFF"/>
+                </a:solidFill>
+              </a:rPr>
+              <a:t>a fixed set to compare on</a:t>
+            </a:r>
+            <a:pPr indent="0" marL="0">
+              <a:buNone/>
+            </a:pPr>
+            <a:r>
+              <a:rPr lang="en-US" sz="1600" dirty="0">
+                <a:solidFill>
+                  <a:srgbClr val="FFFFFF"/>
+                </a:solidFill>
+              </a:rPr>
+              <a:t> and </a:t>
+            </a:r>
+            <a:pPr indent="0" marL="0">
+              <a:buNone/>
+            </a:pPr>
+            <a:r>
+              <a:rPr lang="en-US" sz="1600" b="1" dirty="0">
+                <a:solidFill>
+                  <a:srgbClr val="FFFFFF"/>
+                </a:solidFill>
+              </a:rPr>
+              <a:t>problems that look like practice</a:t>
+            </a:r>
+            <a:pPr indent="0" marL="0">
+              <a:buNone/>
+            </a:pPr>
+            <a:r>
+              <a:rPr lang="en-US" sz="1600" dirty="0">
+                <a:solidFill>
+                  <a:srgbClr val="FFFFFF"/>
+                </a:solidFill>
+              </a:rPr>
+              <a:t>.</a:t>
+            </a:r>
+            <a:endParaRPr lang="en-US" sz="1600" dirty="0"/>
           </a:p>
         </p:txBody>
       </p:sp>

</xml_diff>

<commit_message>
Talk: slide 4 speech walks the diagram
</commit_message>
<xml_diff>
--- a/docs/CrossMEP_CIBW78_talk.pptx
+++ b/docs/CrossMEP_CIBW78_talk.pptx
@@ -128,12 +128,12 @@
   <p:extLst>
     <p:ext uri="{521415D9-36F7-43E2-AB2F-B90AF26B5E84}">
       <p14:sectionLst xmlns:p14="http://schemas.microsoft.com/office/powerpoint/2010/main">
-        <p14:section name="Opening" id="{31f29fa2-fc81-a175-6699-e8f9f6b214b1}">
+        <p14:section name="Opening" id="{82ac0653-a41a-33f5-6b5d-37467d25163c}">
           <p14:sldIdLst>
             <p14:sldId id="256"/>
           </p14:sldIdLst>
         </p14:section>
-        <p14:section name="Motivation" id="{9c32c71e-94ac-03b5-eff5-372297e607a2}">
+        <p14:section name="Motivation" id="{46b6629c-60c0-9abe-1faf-a6dde6a84244}">
           <p14:sldIdLst>
             <p14:sldId id="257"/>
             <p14:sldId id="258"/>
@@ -141,7 +141,7 @@
             <p14:sldId id="260"/>
           </p14:sldIdLst>
         </p14:section>
-        <p14:section name="The dataset" id="{8caa210c-38f6-4b0f-12ab-5df97c59af36}">
+        <p14:section name="The dataset" id="{6988c8fc-c5a3-99f4-bc44-54b62fb8c7a5}">
           <p14:sldIdLst>
             <p14:sldId id="261"/>
             <p14:sldId id="262"/>
@@ -150,14 +150,14 @@
             <p14:sldId id="265"/>
           </p14:sldIdLst>
         </p14:section>
-        <p14:section name="Experiments" id="{b8daf8d6-11d2-8c5b-d9a7-76f22832ac2d}">
+        <p14:section name="Experiments" id="{ae2329e8-53e4-c805-f436-cf41d0646b77}">
           <p14:sldIdLst>
             <p14:sldId id="266"/>
             <p14:sldId id="267"/>
             <p14:sldId id="268"/>
           </p14:sldIdLst>
         </p14:section>
-        <p14:section name="Use" id="{f9cdaaab-1e09-eea7-e613-6797021d7e62}">
+        <p14:section name="Use" id="{27d8e8a0-dfa3-6bd8-7c33-04245facefd1}">
           <p14:sldIdLst>
             <p14:sldId id="269"/>
             <p14:sldId id="270"/>
@@ -165,7 +165,7 @@
             <p14:sldId id="272"/>
           </p14:sldIdLst>
         </p14:section>
-        <p14:section name="Appendix" id="{2902dba2-6425-1ed0-9162-24fc703f2bad}">
+        <p14:section name="Appendix" id="{21758f25-c35d-d6c4-0388-29614f98d7cb}">
           <p14:sldIdLst>
             <p14:sldId id="273"/>
             <p14:sldId id="274"/>
@@ -2115,7 +2115,7 @@
           <a:p>
             <a:r>
               <a:rPr lang="en-US" dirty="0"/>
-              <a:t>Here's one benchmark context per tier. C1 is a single element, the most common support in any building. By C8 you have eight services on three rows. Within a tier everything else varies: kinds, trades, surfaces, stacking. So the element count is the one controlled axis of difficulty. And notice the walls: the section rotates, and electrical sits above water. (4:45)</a:t>
+              <a:t>Here's one benchmark context per tier. C1 is a single element, the most common support in any building. By C8 you have eight services on three rows. Within a tier everything else varies: kinds, trades, surfaces, stacking. So the element count is the one controlled axis of difficulty. And notice the walls: the section rotates, and electrical sits above water. (5:00)</a:t>
             </a:r>
             <a:endParaRPr lang="en-US" dirty="0"/>
           </a:p>
@@ -2203,7 +2203,7 @@
           <a:p>
             <a:r>
               <a:rPr lang="en-US" dirty="0"/>
-              <a:t>Now three analyses. The first is a design check, not a discovery: does difficulty grow with the tier? The count is fixed by construction, and load and congestion follow from the rules, so this shows the dataset behaves as designed. The load at the support rises with the tier, from about 0.3 to 2.0 kilonewtons. The closest gap narrows at every step, from 130 to about 51 millimeters. So: report methods tier by tier. (5:10)</a:t>
+              <a:t>Now three analyses. The first is a design check, not a discovery: does difficulty grow with the tier? The count is fixed by construction, and load and congestion follow from the rules, so this shows the dataset behaves as designed. The load at the support rises with the tier, from about 0.3 to 2.0 kilonewtons. The closest gap narrows at every step, from 130 to about 51 millimeters. So: report methods tier by tier. (5:25)</a:t>
             </a:r>
             <a:endParaRPr lang="en-US" dirty="0"/>
           </a:p>
@@ -2291,7 +2291,7 @@
           <a:p>
             <a:r>
               <a:rPr lang="en-US" dirty="0"/>
-              <a:t>The second analysis is the one the generator could fail. Is the spacing realistic in a building it has never seen? The gap distribution was fitted on a residential duplex. We kept a second open building aside, a medical-dental clinic, cut it into sections every 250 millimeters, the way a context is defined, and measured the gaps between pipes running side by side. On the left, the clinic: generated gaps are close to measured ones, though not identical. On the right, the distances. Generator to clinic: 32 millimeters. That is above the 8 a perfect generator would show, so not a perfect match, but about as close as the duplex's own two models are to each other. A fixed 25-millimeter gap would be about 190 off. (5:40)</a:t>
+              <a:t>The second analysis is the one the generator could fail. Is the spacing realistic in a building it has never seen? The gap distribution was fitted on a residential duplex. We kept a second open building aside, a medical-dental clinic, cut it into sections every 250 millimeters, the way a context is defined, and measured the gaps between pipes running side by side. On the left, the clinic: generated gaps are close to measured ones, though not identical. On the right, the distances. Generator to clinic: 32 millimeters. That is above the 8 a perfect generator would show, so not a perfect match, but about as close as the duplex's own two models are to each other. A fixed 25-millimeter gap would be about 190 off. (6:00)</a:t>
             </a:r>
             <a:endParaRPr lang="en-US" dirty="0"/>
           </a:p>
@@ -2379,7 +2379,7 @@
           <a:p>
             <a:r>
               <a:rPr lang="en-US" dirty="0"/>
-              <a:t>The third analysis is a use of the dataset, not a test of it: what must a catalog of clamps cover? Our paper's two-size catalog attaches 14.5 percent of the pipes, with an interval of 13 to 16, all one size, DN40. Load is never the limit, and trays, ducts and conduits aren't covered at all. On the right is what the dataset asks of any catalog: two well-placed sizes could attach 38 percent, six sizes 76, fifteen sizes every pipe. So 'what should the catalog contain' becomes a measurement. (6:35)</a:t>
+              <a:t>The third analysis is a use of the dataset, not a test of it: what must a catalog of clamps cover? Our paper's two-size catalog attaches 14.5 percent of the pipes, with an interval of 13 to 16, all one size, DN40. Load is never the limit, and trays, ducts and conduits aren't covered at all. On the right is what the dataset asks of any catalog: two well-placed sizes could attach 38 percent, six sizes 76, fifteen sizes every pipe. So 'what should the catalog contain' becomes a measurement. (6:50)</a:t>
             </a:r>
             <a:endParaRPr lang="en-US" dirty="0"/>
           </a:p>
@@ -2467,7 +2467,7 @@
           <a:p>
             <a:r>
               <a:rPr lang="en-US" dirty="0"/>
-              <a:t>Let me show it. This is the Generator Studio. I choose what crosses the hanger, a tier or an exact mix, and a seed. Out comes the section a support designer receives, drawn the way an engineer would issue it: every service at true size, its level below the slab, its load, the closest clear gap, and the same run in 3D. Every section is a stored output of the released generator, with the Python call that reproduces it. Scan the code to try it yourself. [Live: switch to the studio, click C3, then Generate another twice, then Exact mix with a duct. If the demo fails, stay on this slide; slide 18 shows two more sections. Before the talk: open the studio once with internet, set its link sharing to public, scan the QR from a phone not logged in.] (7:10)</a:t>
+              <a:t>Let me show it. This is the Generator Studio. I choose what crosses the hanger, a tier or an exact mix, and a seed. Out comes the section a support designer receives, drawn the way an engineer would issue it: every service at true size, its level below the slab, its load, the closest clear gap, and the same run in 3D. Every section is a stored output of the released generator, with the Python call that reproduces it. Scan the code to try it yourself. [Live: switch to the studio, click C3, then Generate another twice, then Exact mix with a duct. If the demo fails, stay on this slide; slide 18 shows two more sections. Before the talk: open the studio once with internet, set its link sharing to public, scan the QR from a phone not logged in.] (7:25)</a:t>
             </a:r>
             <a:endParaRPr lang="en-US" dirty="0"/>
           </a:p>
@@ -2555,7 +2555,7 @@
           <a:p>
             <a:r>
               <a:rPr lang="en-US" dirty="0"/>
-              <a:t>Using it takes a few lines: load a split, filter by composition, or generate your own mix. Because there are no labels, the same files serve reinforcement learning, constraint programming, and benchmarking people. We ship the scoring too. Train on the generator, from C1 up to C8. Evaluate on the benchmark, the same 125 contexts per tier for every method. Report per tier, with 95 percent intervals and paired tests. (8:20)</a:t>
+              <a:t>Using it takes a few lines: load a split, filter by composition, or generate your own mix. Because there are no labels, the same files serve reinforcement learning, constraint programming, and benchmarking people. We ship the scoring too. Train on the generator, from C1 up to C8. Evaluate on the benchmark, the same 125 contexts per tier for every method. Report per tier, with 95 percent intervals and paired tests. (8:35)</a:t>
             </a:r>
             <a:endParaRPr lang="en-US" dirty="0"/>
           </a:p>
@@ -2643,7 +2643,7 @@
           <a:p>
             <a:r>
               <a:rPr lang="en-US" dirty="0"/>
-              <a:t>A word on scope. CrossMEP is one section at one support. Routing and branches are outside it, but the span is recorded, so a method can vary it. Pipe spacing was checked on two open buildings; the rest rests on practice and standards, and the trade mix is a design choice. It's not for structural design of real installations. Next: a public checker, with best-known costs, so we can compare methods on the answer; the catalog as an input; and a real test set from commercial projects, with supports designed by engineers. That's where I'd value your eye. (8:50)</a:t>
+              <a:t>A word on scope. CrossMEP is one section at one support. Routing and branches are outside it, but the span is recorded, so a method can vary it. Pipe spacing was checked on two open buildings; the rest rests on practice and standards, and the trade mix is a design choice. It's not for structural design of real installations. Next: a public checker, with best-known costs, so we can compare methods on the answer; the catalog as an input; and a real test set from commercial projects, with supports designed by engineers. That's where I'd value your eye. (9:05)</a:t>
             </a:r>
             <a:endParaRPr lang="en-US" dirty="0"/>
           </a:p>
@@ -2731,7 +2731,7 @@
           <a:p>
             <a:r>
               <a:rPr lang="en-US" dirty="0"/>
-              <a:t>To sum up: CrossMEP is the brief, not the answer. Seven thousand support-design problems, every constant sourced or declared a design choice, pipe spacing checked on two open buildings, and all of it open. If you coordinate services or design supports, try the studio and tell me what looks wrong. Thank you. (9:30)</a:t>
+              <a:t>To sum up: CrossMEP is the brief, not the answer. Seven thousand support-design problems, every constant sourced or declared a design choice, pipe spacing checked on two open buildings, and all of it open. If you coordinate services or design supports, try the studio and tell me what looks wrong. Thank you. (9:45)</a:t>
             </a:r>
             <a:endParaRPr lang="en-US" dirty="0"/>
           </a:p>
@@ -3435,7 +3435,7 @@
           <a:p>
             <a:r>
               <a:rPr lang="en-US" dirty="0"/>
-              <a:t>What would a method look like? One section in, verified supports out. Build the assembly step by step from a catalog, each step allowed by the rules and chosen by a rule table, by search, or by a learned policy; then check every finished design: statics, anchors, buildability. That is learnable. But anything that learns needs problems to learn from, a fixed set to compare on, and problems that look like practice. (1:40)</a:t>
+              <a:t>What would a method look like? Think of it as a pipeline. On the left, the brief: the context, and a catalog of parts with prices. The rules say which actions are legal in a given state; each action adds parts. In the middle, a black box chooses the next action. It could be a rule table, a search, or a learned policy; the pipeline doesn't care. A verifier judges every finished design, statics, anchors, buildability, and feeds pass or fail back. Out come verified designs, ranked by cost. Whatever sits in that black box, it needs problems to learn from, a fixed set to compare on, and problems that look like practice. (1:40)</a:t>
             </a:r>
             <a:endParaRPr lang="en-US" dirty="0"/>
           </a:p>
@@ -3523,7 +3523,7 @@
           <a:p>
             <a:r>
               <a:rPr lang="en-US" dirty="0"/>
-              <a:t>And there were none. Project models are proprietary, the open ones aren't organized around supports, and any one project is a narrow slice. So we built CrossMEP: seven thousand contexts, about thirty-one and a half thousand elements, in eight difficulty tiers. They are deliberately unlabeled: you get the problem, never the answer. Every constant is sourced or declared a design choice, and everything is open. (2:10)</a:t>
+              <a:t>And there were none. Project models are proprietary, the open ones aren't organized around supports, and any one project is a narrow slice. So we built CrossMEP: seven thousand contexts, about thirty-one and a half thousand elements, in eight difficulty tiers. They are deliberately unlabeled: you get the problem, never the answer. Every constant is sourced or declared a design choice, and everything is open. (2:30)</a:t>
             </a:r>
             <a:endParaRPr lang="en-US" dirty="0"/>
           </a:p>
@@ -3611,7 +3611,7 @@
           <a:p>
             <a:r>
               <a:rPr lang="en-US" dirty="0"/>
-              <a:t>Here's one context: a two-dimensional section at one support location. Each element has its kind, service and trade, its size, its insulation, and its load, which is weight per metre times the span it was sized at, plus its position. Add the surface, a slab or a wall, and that's all. What you won't find is the support: no channel, no rods, no anchors, and no correct answer, because a feasible support depends on the catalog you build from. The context is the brief. The assembly is the answer. (2:40)</a:t>
+              <a:t>Here's one context: a two-dimensional section at one support location. Each element has its kind, service and trade, its size, its insulation, and its load, which is weight per metre times the span it was sized at, plus its position. Add the surface, a slab or a wall, and that's all. What you won't find is the support: no channel, no rods, no anchors, and no correct answer, because a feasible support depends on the catalog you build from. The context is the brief. The assembly is the answer. (2:55)</a:t>
             </a:r>
             <a:endParaRPr lang="en-US" dirty="0"/>
           </a:p>
@@ -3699,7 +3699,7 @@
           <a:p>
             <a:r>
               <a:rPr lang="en-US" dirty="0"/>
-              <a:t>How do we make a context? Not by free randomness, but by rules an engineer would recognize. The tier fixes how many elements there are. We pick the surface and fill it the way trades really run services: hot and cold together, flow and return together, conduits in groups, bulky services nearest the slab. Gaps between neighbors are drawn from gaps measured on a built project, never below twenty-five millimeters. On walls, electrical stays above water. Every context is checked, and it's seeded: the same seed gives the same file, byte for byte. (3:15)</a:t>
+              <a:t>How do we make a context? Not by free randomness, but by rules an engineer would recognize. The tier fixes how many elements there are. We pick the surface and fill it the way trades really run services: hot and cold together, flow and return together, conduits in groups, bulky services nearest the slab. Gaps between neighbors are drawn from gaps measured on a built project, never below twenty-five millimeters. On walls, electrical stays above water. Every context is checked, and it's seeded: the same seed gives the same file, byte for byte. (3:35)</a:t>
             </a:r>
             <a:endParaRPr lang="en-US" dirty="0"/>
           </a:p>
@@ -3787,7 +3787,7 @@
           <a:p>
             <a:r>
               <a:rPr lang="en-US" dirty="0"/>
-              <a:t>Where do the numbers come from? Three places. Sizes, weights and spans come from standards: European steel pipe and duct standards, IEC for conduits and trays, ASME for spans, the German GEG for insulation. How close neighbors sit comes from measured open buildings. And a few things are simply our choices, like the trade mix, and we label them that way. Loads are computed in code from all of this. (3:55)</a:t>
+              <a:t>Where do the numbers come from? Three places. Sizes, weights and spans come from standards: European steel pipe and duct standards, IEC for conduits and trays, ASME for spans, the German GEG for insulation. How close neighbors sit comes from measured open buildings. And a few things are simply our choices, like the trade mix, and we label them that way. Loads are computed in code from all of this. (4:10)</a:t>
             </a:r>
             <a:endParaRPr lang="en-US" dirty="0"/>
           </a:p>
@@ -3875,7 +3875,7 @@
           <a:p>
             <a:r>
               <a:rPr lang="en-US" dirty="0"/>
-              <a:t>The release has four splits on disjoint seeds, so a method is never tested on what it trained on: five thousand contexts for training, five hundred each for validation and test, and a benchmark of one thousand, a hundred and twenty-five per tier. Everything is plain JSON with a schema and a datasheet. (4:25)</a:t>
+              <a:t>The release has four splits on disjoint seeds, so a method is never tested on what it trained on: five thousand contexts for training, five hundred each for validation and test, and a benchmark of one thousand, a hundred and twenty-five per tier. Everything is plain JSON with a schema and a datasheet. (4:40)</a:t>
             </a:r>
             <a:endParaRPr lang="en-US" dirty="0"/>
           </a:p>

</xml_diff>

<commit_message>
Talk: trim three slides to keep the speech under ten minutes
Co-Authored-By: Claude Fable 5.1 <noreply@anthropic.com>
Claude-Session: https://claude.ai/code/session_01R1ft1rokeRJHR95rzLxNEC
</commit_message>
<xml_diff>
--- a/docs/CrossMEP_CIBW78_talk.pptx
+++ b/docs/CrossMEP_CIBW78_talk.pptx
@@ -128,12 +128,12 @@
   <p:extLst>
     <p:ext uri="{521415D9-36F7-43E2-AB2F-B90AF26B5E84}">
       <p14:sectionLst xmlns:p14="http://schemas.microsoft.com/office/powerpoint/2010/main">
-        <p14:section name="Opening" id="{82ac0653-a41a-33f5-6b5d-37467d25163c}">
+        <p14:section name="Opening" id="{33e86e91-eb94-6cbe-144c-42cfe58cb314}">
           <p14:sldIdLst>
             <p14:sldId id="256"/>
           </p14:sldIdLst>
         </p14:section>
-        <p14:section name="Motivation" id="{46b6629c-60c0-9abe-1faf-a6dde6a84244}">
+        <p14:section name="Motivation" id="{94e6513c-1ec1-572f-b684-bba4e459683d}">
           <p14:sldIdLst>
             <p14:sldId id="257"/>
             <p14:sldId id="258"/>
@@ -141,7 +141,7 @@
             <p14:sldId id="260"/>
           </p14:sldIdLst>
         </p14:section>
-        <p14:section name="The dataset" id="{6988c8fc-c5a3-99f4-bc44-54b62fb8c7a5}">
+        <p14:section name="The dataset" id="{a91a8b79-35c9-7535-7bc1-952095e98f77}">
           <p14:sldIdLst>
             <p14:sldId id="261"/>
             <p14:sldId id="262"/>
@@ -150,14 +150,14 @@
             <p14:sldId id="265"/>
           </p14:sldIdLst>
         </p14:section>
-        <p14:section name="Experiments" id="{ae2329e8-53e4-c805-f436-cf41d0646b77}">
+        <p14:section name="Experiments" id="{97888156-51ef-126b-94f4-45f41495ceed}">
           <p14:sldIdLst>
             <p14:sldId id="266"/>
             <p14:sldId id="267"/>
             <p14:sldId id="268"/>
           </p14:sldIdLst>
         </p14:section>
-        <p14:section name="Use" id="{27d8e8a0-dfa3-6bd8-7c33-04245facefd1}">
+        <p14:section name="Use" id="{d4f1bc69-25fc-8912-6afa-b98367dec7c2}">
           <p14:sldIdLst>
             <p14:sldId id="269"/>
             <p14:sldId id="270"/>
@@ -165,7 +165,7 @@
             <p14:sldId id="272"/>
           </p14:sldIdLst>
         </p14:section>
-        <p14:section name="Appendix" id="{21758f25-c35d-d6c4-0388-29614f98d7cb}">
+        <p14:section name="Appendix" id="{d4ac16dd-8e3f-d33e-9fe4-27076ea172c9}">
           <p14:sldIdLst>
             <p14:sldId id="273"/>
             <p14:sldId id="274"/>
@@ -2115,7 +2115,7 @@
           <a:p>
             <a:r>
               <a:rPr lang="en-US" dirty="0"/>
-              <a:t>Here's one benchmark context per tier. C1 is a single element, the most common support in any building. By C8 you have eight services on three rows. Within a tier everything else varies: kinds, trades, surfaces, stacking. So the element count is the one controlled axis of difficulty. And notice the walls: the section rotates, and electrical sits above water. (5:00)</a:t>
+              <a:t>Here's one benchmark context per tier. C1 is a single element, the most common support in any building. By C8 you have eight services on three rows. Within a tier everything else varies: kinds, trades, surfaces, stacking. So the element count is the one controlled axis of difficulty. And notice the walls: the section rotates, and electrical sits above water. (4:55)</a:t>
             </a:r>
             <a:endParaRPr lang="en-US" dirty="0"/>
           </a:p>
@@ -2203,7 +2203,7 @@
           <a:p>
             <a:r>
               <a:rPr lang="en-US" dirty="0"/>
-              <a:t>Now three analyses. The first is a design check, not a discovery: does difficulty grow with the tier? The count is fixed by construction, and load and congestion follow from the rules, so this shows the dataset behaves as designed. The load at the support rises with the tier, from about 0.3 to 2.0 kilonewtons. The closest gap narrows at every step, from 130 to about 51 millimeters. So: report methods tier by tier. (5:25)</a:t>
+              <a:t>Now three analyses. The first is a design check, not a discovery: does difficulty grow with the tier? The count is fixed by construction, and load and congestion follow from the rules, so this shows the dataset behaves as designed. The load at the support rises with the tier, from about 0.3 to 2.0 kilonewtons. The closest gap narrows at every step, from 130 to about 51 millimeters. So: report methods tier by tier. (5:20)</a:t>
             </a:r>
             <a:endParaRPr lang="en-US" dirty="0"/>
           </a:p>
@@ -2291,7 +2291,7 @@
           <a:p>
             <a:r>
               <a:rPr lang="en-US" dirty="0"/>
-              <a:t>The second analysis is the one the generator could fail. Is the spacing realistic in a building it has never seen? The gap distribution was fitted on a residential duplex. We kept a second open building aside, a medical-dental clinic, cut it into sections every 250 millimeters, the way a context is defined, and measured the gaps between pipes running side by side. On the left, the clinic: generated gaps are close to measured ones, though not identical. On the right, the distances. Generator to clinic: 32 millimeters. That is above the 8 a perfect generator would show, so not a perfect match, but about as close as the duplex's own two models are to each other. A fixed 25-millimeter gap would be about 190 off. (6:00)</a:t>
+              <a:t>The second analysis is the one the generator could fail. Is the spacing realistic in a building it has never seen? The gap distribution was fitted on a residential duplex. We kept a second open building aside, a medical-dental clinic, cut it into sections every 250 millimeters, the way a context is defined, and measured the gaps between pipes running side by side. On the right, the distances. Generator to clinic: 32 millimeters. That is above the 8 a perfect generator would show, so not a perfect match, but about as close as the duplex's own two models are to each other. A fixed 25-millimeter gap would be about 190 off. (5:50)</a:t>
             </a:r>
             <a:endParaRPr lang="en-US" dirty="0"/>
           </a:p>
@@ -2379,7 +2379,7 @@
           <a:p>
             <a:r>
               <a:rPr lang="en-US" dirty="0"/>
-              <a:t>The third analysis is a use of the dataset, not a test of it: what must a catalog of clamps cover? Our paper's two-size catalog attaches 14.5 percent of the pipes, with an interval of 13 to 16, all one size, DN40. Load is never the limit, and trays, ducts and conduits aren't covered at all. On the right is what the dataset asks of any catalog: two well-placed sizes could attach 38 percent, six sizes 76, fifteen sizes every pipe. So 'what should the catalog contain' becomes a measurement. (6:50)</a:t>
+              <a:t>The third analysis is a use of the dataset, not a test of it: what must a catalog of clamps cover? Our paper's two-size catalog attaches 14.5 percent of the pipes, with an interval of 13 to 16, all one size, DN40. Load is never the limit, and trays, ducts and conduits aren't covered at all. On the right is what the dataset asks of any catalog: two well-placed sizes could attach 38 percent, six sizes 76, fifteen sizes every pipe. So 'what should the catalog contain' becomes a measurement. (6:35)</a:t>
             </a:r>
             <a:endParaRPr lang="en-US" dirty="0"/>
           </a:p>
@@ -2467,7 +2467,7 @@
           <a:p>
             <a:r>
               <a:rPr lang="en-US" dirty="0"/>
-              <a:t>Let me show it. This is the Generator Studio. I choose what crosses the hanger, a tier or an exact mix, and a seed. Out comes the section a support designer receives, drawn the way an engineer would issue it: every service at true size, its level below the slab, its load, the closest clear gap, and the same run in 3D. Every section is a stored output of the released generator, with the Python call that reproduces it. Scan the code to try it yourself. [Live: switch to the studio, click C3, then Generate another twice, then Exact mix with a duct. If the demo fails, stay on this slide; slide 18 shows two more sections. Before the talk: open the studio once with internet, set its link sharing to public, scan the QR from a phone not logged in.] (7:25)</a:t>
+              <a:t>Let me show it. This is the Generator Studio. I choose what crosses the hanger, a tier or an exact mix, and a seed. Out comes the section a support designer receives, drawn the way an engineer would issue it: every service at true size, its level below the slab, its load, the closest clear gap, and the same run in 3D. Every section is a stored output of the released generator, with the Python call that reproduces it. Scan the code to try it yourself. [Live: switch to the studio, click C3, then Generate another twice, then Exact mix with a duct. If the demo fails, stay on this slide; slide 18 shows two more sections. Before the talk: open the studio once with internet, set its link sharing to public, scan the QR from a phone not logged in.] (7:15)</a:t>
             </a:r>
             <a:endParaRPr lang="en-US" dirty="0"/>
           </a:p>
@@ -2555,7 +2555,7 @@
           <a:p>
             <a:r>
               <a:rPr lang="en-US" dirty="0"/>
-              <a:t>Using it takes a few lines: load a split, filter by composition, or generate your own mix. Because there are no labels, the same files serve reinforcement learning, constraint programming, and benchmarking people. We ship the scoring too. Train on the generator, from C1 up to C8. Evaluate on the benchmark, the same 125 contexts per tier for every method. Report per tier, with 95 percent intervals and paired tests. (8:35)</a:t>
+              <a:t>Using it takes a few lines: load a split, filter by composition, or generate your own mix. Because there are no labels, the same files serve reinforcement learning, constraint programming, and benchmarking people. We ship the scoring too. Train on the generator, from C1 up to C8. Evaluate on the benchmark, the same 125 contexts per tier for every method. Report per tier, with 95 percent intervals and paired tests. (8:25)</a:t>
             </a:r>
             <a:endParaRPr lang="en-US" dirty="0"/>
           </a:p>
@@ -2643,7 +2643,7 @@
           <a:p>
             <a:r>
               <a:rPr lang="en-US" dirty="0"/>
-              <a:t>A word on scope. CrossMEP is one section at one support. Routing and branches are outside it, but the span is recorded, so a method can vary it. Pipe spacing was checked on two open buildings; the rest rests on practice and standards, and the trade mix is a design choice. It's not for structural design of real installations. Next: a public checker, with best-known costs, so we can compare methods on the answer; the catalog as an input; and a real test set from commercial projects, with supports designed by engineers. That's where I'd value your eye. (9:05)</a:t>
+              <a:t>A word on scope. CrossMEP is one section at one support. Pipe spacing was checked on two open buildings; the rest rests on practice and standards, and the trade mix is a design choice. It's not for structural design of real installations. Next: a public checker, with best-known costs, so we can compare methods on the answer; the catalog as an input; and a real test set from commercial projects, with supports designed by engineers. That's where I'd value your eye. (8:55)</a:t>
             </a:r>
             <a:endParaRPr lang="en-US" dirty="0"/>
           </a:p>
@@ -2731,7 +2731,7 @@
           <a:p>
             <a:r>
               <a:rPr lang="en-US" dirty="0"/>
-              <a:t>To sum up: CrossMEP is the brief, not the answer. Seven thousand support-design problems, every constant sourced or declared a design choice, pipe spacing checked on two open buildings, and all of it open. If you coordinate services or design supports, try the studio and tell me what looks wrong. Thank you. (9:45)</a:t>
+              <a:t>To sum up: CrossMEP is the brief, not the answer. Seven thousand support-design problems, every constant sourced or declared a design choice, pipe spacing checked on two open buildings, and all of it open. If you coordinate services or design supports, try the studio and tell me what looks wrong. Thank you. (9:25)</a:t>
             </a:r>
             <a:endParaRPr lang="en-US" dirty="0"/>
           </a:p>
@@ -3435,7 +3435,7 @@
           <a:p>
             <a:r>
               <a:rPr lang="en-US" dirty="0"/>
-              <a:t>What would a method look like? Think of it as a pipeline. On the left, the brief: the context, and a catalog of parts with prices. The rules say which actions are legal in a given state; each action adds parts. In the middle, a black box chooses the next action. It could be a rule table, a search, or a learned policy; the pipeline doesn't care. A verifier judges every finished design, statics, anchors, buildability, and feeds pass or fail back. Out come verified designs, ranked by cost. Whatever sits in that black box, it needs problems to learn from, a fixed set to compare on, and problems that look like practice. (1:40)</a:t>
+              <a:t>What would a method look like? On the left, the brief: the context, and a catalog of parts with prices. The rules say which actions are legal; each action adds parts. In the middle, a black box chooses the next action: a rule table, a search, or a learned policy. A verifier judges every finished design, statics, anchors, buildability, and feeds pass or fail back. Out come verified designs, ranked by cost. Whatever sits in that black box, it needs problems to learn from, a fixed set to compare on, and problems that look like practice. (1:40)</a:t>
             </a:r>
             <a:endParaRPr lang="en-US" dirty="0"/>
           </a:p>
@@ -3523,7 +3523,7 @@
           <a:p>
             <a:r>
               <a:rPr lang="en-US" dirty="0"/>
-              <a:t>And there were none. Project models are proprietary, the open ones aren't organized around supports, and any one project is a narrow slice. So we built CrossMEP: seven thousand contexts, about thirty-one and a half thousand elements, in eight difficulty tiers. They are deliberately unlabeled: you get the problem, never the answer. Every constant is sourced or declared a design choice, and everything is open. (2:30)</a:t>
+              <a:t>And there were none. Project models are proprietary, the open ones aren't organized around supports, and any one project is a narrow slice. So we built CrossMEP: seven thousand contexts, about thirty-one and a half thousand elements, in eight difficulty tiers. They are deliberately unlabeled: you get the problem, never the answer. Every constant is sourced or declared a design choice, and everything is open. (2:20)</a:t>
             </a:r>
             <a:endParaRPr lang="en-US" dirty="0"/>
           </a:p>
@@ -3611,7 +3611,7 @@
           <a:p>
             <a:r>
               <a:rPr lang="en-US" dirty="0"/>
-              <a:t>Here's one context: a two-dimensional section at one support location. Each element has its kind, service and trade, its size, its insulation, and its load, which is weight per metre times the span it was sized at, plus its position. Add the surface, a slab or a wall, and that's all. What you won't find is the support: no channel, no rods, no anchors, and no correct answer, because a feasible support depends on the catalog you build from. The context is the brief. The assembly is the answer. (2:55)</a:t>
+              <a:t>Here's one context: a two-dimensional section at one support location. Each element has its kind, service and trade, its size, its insulation, and its load, which is weight per metre times the span it was sized at, plus its position. Add the surface, a slab or a wall, and that's all. What you won't find is the support: no channel, no rods, no anchors, and no correct answer, because a feasible support depends on the catalog you build from. The context is the brief. The assembly is the answer. (2:50)</a:t>
             </a:r>
             <a:endParaRPr lang="en-US" dirty="0"/>
           </a:p>
@@ -3699,7 +3699,7 @@
           <a:p>
             <a:r>
               <a:rPr lang="en-US" dirty="0"/>
-              <a:t>How do we make a context? Not by free randomness, but by rules an engineer would recognize. The tier fixes how many elements there are. We pick the surface and fill it the way trades really run services: hot and cold together, flow and return together, conduits in groups, bulky services nearest the slab. Gaps between neighbors are drawn from gaps measured on a built project, never below twenty-five millimeters. On walls, electrical stays above water. Every context is checked, and it's seeded: the same seed gives the same file, byte for byte. (3:35)</a:t>
+              <a:t>How do we make a context? Not by free randomness, but by rules an engineer would recognize. The tier fixes how many elements there are. We pick the surface and fill it the way trades really run services: hot and cold together, flow and return together, conduits in groups, bulky services nearest the slab. Gaps between neighbors are drawn from gaps measured on a built project, never below twenty-five millimeters. On walls, electrical stays above water. Every context is checked, and it's seeded: the same seed gives the same file, byte for byte. (3:25)</a:t>
             </a:r>
             <a:endParaRPr lang="en-US" dirty="0"/>
           </a:p>
@@ -3787,7 +3787,7 @@
           <a:p>
             <a:r>
               <a:rPr lang="en-US" dirty="0"/>
-              <a:t>Where do the numbers come from? Three places. Sizes, weights and spans come from standards: European steel pipe and duct standards, IEC for conduits and trays, ASME for spans, the German GEG for insulation. How close neighbors sit comes from measured open buildings. And a few things are simply our choices, like the trade mix, and we label them that way. Loads are computed in code from all of this. (4:10)</a:t>
+              <a:t>Where do the numbers come from? Three places. Sizes, weights and spans come from standards: European steel pipe and duct standards, IEC for conduits and trays, ASME for spans, the German GEG for insulation. How close neighbors sit comes from measured open buildings. And a few things are simply our choices, like the trade mix, and we label them that way. Loads are computed in code from all of this. (4:05)</a:t>
             </a:r>
             <a:endParaRPr lang="en-US" dirty="0"/>
           </a:p>
@@ -3875,7 +3875,7 @@
           <a:p>
             <a:r>
               <a:rPr lang="en-US" dirty="0"/>
-              <a:t>The release has four splits on disjoint seeds, so a method is never tested on what it trained on: five thousand contexts for training, five hundred each for validation and test, and a benchmark of one thousand, a hundred and twenty-five per tier. Everything is plain JSON with a schema and a datasheet. (4:40)</a:t>
+              <a:t>The release has four splits on disjoint seeds, so a method is never tested on what it trained on: five thousand contexts for training, five hundred each for validation and test, and a benchmark of one thousand, a hundred and twenty-five per tier. Everything is plain JSON with a schema and a datasheet. (4:35)</a:t>
             </a:r>
             <a:endParaRPr lang="en-US" dirty="0"/>
           </a:p>

</xml_diff>

<commit_message>
Talk: slide 5 shows the idea, real designs in one corner of the design space, CrossMEP covering it by construction
Co-Authored-By: Claude Fable 5.1 <noreply@anthropic.com>
Claude-Session: https://claude.ai/code/session_01R1ft1rokeRJHR95rzLxNEC
</commit_message>
<xml_diff>
--- a/docs/CrossMEP_CIBW78_talk.pptx
+++ b/docs/CrossMEP_CIBW78_talk.pptx
@@ -128,12 +128,12 @@
   <p:extLst>
     <p:ext uri="{521415D9-36F7-43E2-AB2F-B90AF26B5E84}">
       <p14:sectionLst xmlns:p14="http://schemas.microsoft.com/office/powerpoint/2010/main">
-        <p14:section name="Opening" id="{33e86e91-eb94-6cbe-144c-42cfe58cb314}">
+        <p14:section name="Opening" id="{69f9f7ff-88d0-815e-977e-921b4825ca9d}">
           <p14:sldIdLst>
             <p14:sldId id="256"/>
           </p14:sldIdLst>
         </p14:section>
-        <p14:section name="Motivation" id="{94e6513c-1ec1-572f-b684-bba4e459683d}">
+        <p14:section name="Motivation" id="{f59603e7-eb3f-e8b0-ae36-1d4d9780f69b}">
           <p14:sldIdLst>
             <p14:sldId id="257"/>
             <p14:sldId id="258"/>
@@ -141,7 +141,7 @@
             <p14:sldId id="260"/>
           </p14:sldIdLst>
         </p14:section>
-        <p14:section name="The dataset" id="{a91a8b79-35c9-7535-7bc1-952095e98f77}">
+        <p14:section name="The dataset" id="{8635cb3a-0985-fac6-02e0-9ef048966470}">
           <p14:sldIdLst>
             <p14:sldId id="261"/>
             <p14:sldId id="262"/>
@@ -150,14 +150,14 @@
             <p14:sldId id="265"/>
           </p14:sldIdLst>
         </p14:section>
-        <p14:section name="Experiments" id="{97888156-51ef-126b-94f4-45f41495ceed}">
+        <p14:section name="Experiments" id="{8126c942-6515-c622-7dd8-4dcdd1accb35}">
           <p14:sldIdLst>
             <p14:sldId id="266"/>
             <p14:sldId id="267"/>
             <p14:sldId id="268"/>
           </p14:sldIdLst>
         </p14:section>
-        <p14:section name="Use" id="{d4f1bc69-25fc-8912-6afa-b98367dec7c2}">
+        <p14:section name="Use" id="{9fb13e76-6dd3-4563-fbd1-2c6290d770dc}">
           <p14:sldIdLst>
             <p14:sldId id="269"/>
             <p14:sldId id="270"/>
@@ -165,7 +165,7 @@
             <p14:sldId id="272"/>
           </p14:sldIdLst>
         </p14:section>
-        <p14:section name="Appendix" id="{d4ac16dd-8e3f-d33e-9fe4-27076ea172c9}">
+        <p14:section name="Appendix" id="{ec553587-b12e-489b-0c3a-57873fd6345d}">
           <p14:sldIdLst>
             <p14:sldId id="273"/>
             <p14:sldId id="274"/>
@@ -2115,7 +2115,7 @@
           <a:p>
             <a:r>
               <a:rPr lang="en-US" dirty="0"/>
-              <a:t>Here's one benchmark context per tier. C1 is a single element, the most common support in any building. By C8 you have eight services on three rows. Within a tier everything else varies: kinds, trades, surfaces, stacking. So the element count is the one controlled axis of difficulty. And notice the walls: the section rotates, and electrical sits above water. (4:55)</a:t>
+              <a:t>Here's one benchmark context per tier. C1 is a single element, the most common support in any building. By C8 you have eight services on three rows. Within a tier everything else varies: kinds, trades, surfaces, stacking. So the element count is the one controlled axis of difficulty. And notice the walls: the section rotates, and electrical sits above water. (5:05)</a:t>
             </a:r>
             <a:endParaRPr lang="en-US" dirty="0"/>
           </a:p>
@@ -2203,7 +2203,7 @@
           <a:p>
             <a:r>
               <a:rPr lang="en-US" dirty="0"/>
-              <a:t>Now three analyses. The first is a design check, not a discovery: does difficulty grow with the tier? The count is fixed by construction, and load and congestion follow from the rules, so this shows the dataset behaves as designed. The load at the support rises with the tier, from about 0.3 to 2.0 kilonewtons. The closest gap narrows at every step, from 130 to about 51 millimeters. So: report methods tier by tier. (5:20)</a:t>
+              <a:t>Now three analyses. The first is a design check, not a discovery: does difficulty grow with the tier? The count is fixed by construction, and load and congestion follow from the rules, so this shows the dataset behaves as designed. The load at the support rises with the tier, from about 0.3 to 2.0 kilonewtons. The closest gap narrows at every step, from 130 to about 51 millimeters. So: report methods tier by tier. (5:30)</a:t>
             </a:r>
             <a:endParaRPr lang="en-US" dirty="0"/>
           </a:p>
@@ -2291,7 +2291,7 @@
           <a:p>
             <a:r>
               <a:rPr lang="en-US" dirty="0"/>
-              <a:t>The second analysis is the one the generator could fail. Is the spacing realistic in a building it has never seen? The gap distribution was fitted on a residential duplex. We kept a second open building aside, a medical-dental clinic, cut it into sections every 250 millimeters, the way a context is defined, and measured the gaps between pipes running side by side. On the right, the distances. Generator to clinic: 32 millimeters. That is above the 8 a perfect generator would show, so not a perfect match, but about as close as the duplex's own two models are to each other. A fixed 25-millimeter gap would be about 190 off. (5:50)</a:t>
+              <a:t>The second analysis is the one the generator could fail. Is the spacing realistic in a building it has never seen? The gap distribution was fitted on a residential duplex. We kept a second open building aside, a medical-dental clinic, cut it into sections every 250 millimeters, the way a context is defined, and measured the gaps between pipes running side by side. On the right, the distances. Generator to clinic: 32 millimeters. That is above the 8 a perfect generator would show, so not a perfect match, but about as close as the duplex's own two models are to each other. A fixed 25-millimeter gap would be about 190 off. (6:00)</a:t>
             </a:r>
             <a:endParaRPr lang="en-US" dirty="0"/>
           </a:p>
@@ -2379,7 +2379,7 @@
           <a:p>
             <a:r>
               <a:rPr lang="en-US" dirty="0"/>
-              <a:t>The third analysis is a use of the dataset, not a test of it: what must a catalog of clamps cover? Our paper's two-size catalog attaches 14.5 percent of the pipes, with an interval of 13 to 16, all one size, DN40. Load is never the limit, and trays, ducts and conduits aren't covered at all. On the right is what the dataset asks of any catalog: two well-placed sizes could attach 38 percent, six sizes 76, fifteen sizes every pipe. So 'what should the catalog contain' becomes a measurement. (6:35)</a:t>
+              <a:t>The third analysis is a use of the dataset, not a test of it: what must a catalog of clamps cover? Our paper's two-size catalog attaches 14.5 percent of the pipes, with an interval of 13 to 16, all one size, DN40. Load is never the limit, and trays, ducts and conduits aren't covered at all. On the right is what the dataset asks of any catalog: two well-placed sizes could attach 38 percent, six sizes 76, fifteen sizes every pipe. So 'what should the catalog contain' becomes a measurement. (6:45)</a:t>
             </a:r>
             <a:endParaRPr lang="en-US" dirty="0"/>
           </a:p>
@@ -2467,7 +2467,7 @@
           <a:p>
             <a:r>
               <a:rPr lang="en-US" dirty="0"/>
-              <a:t>Let me show it. This is the Generator Studio. I choose what crosses the hanger, a tier or an exact mix, and a seed. Out comes the section a support designer receives, drawn the way an engineer would issue it: every service at true size, its level below the slab, its load, the closest clear gap, and the same run in 3D. Every section is a stored output of the released generator, with the Python call that reproduces it. Scan the code to try it yourself. [Live: switch to the studio, click C3, then Generate another twice, then Exact mix with a duct. If the demo fails, stay on this slide; slide 18 shows two more sections. Before the talk: open the studio once with internet, set its link sharing to public, scan the QR from a phone not logged in.] (7:15)</a:t>
+              <a:t>Let me show it. This is the Generator Studio. I choose what crosses the hanger, a tier or an exact mix, and a seed. Out comes the section a support designer receives, drawn the way an engineer would issue it: every service at true size, its level below the slab, its load, the closest clear gap, and the same run in 3D. Every section is a stored output of the released generator, with the Python call that reproduces it. Scan the code to try it yourself. [Live: switch to the studio, click C3, then Generate another twice, then Exact mix with a duct. If the demo fails, stay on this slide; slide 18 shows two more sections. Before the talk: open the studio once with internet, set its link sharing to public, scan the QR from a phone not logged in.] (7:20)</a:t>
             </a:r>
             <a:endParaRPr lang="en-US" dirty="0"/>
           </a:p>
@@ -2555,7 +2555,7 @@
           <a:p>
             <a:r>
               <a:rPr lang="en-US" dirty="0"/>
-              <a:t>Using it takes a few lines: load a split, filter by composition, or generate your own mix. Because there are no labels, the same files serve reinforcement learning, constraint programming, and benchmarking people. We ship the scoring too. Train on the generator, from C1 up to C8. Evaluate on the benchmark, the same 125 contexts per tier for every method. Report per tier, with 95 percent intervals and paired tests. (8:25)</a:t>
+              <a:t>Using it takes a few lines: load a split, filter by composition, or generate your own mix. Because there are no labels, the same files serve reinforcement learning, constraint programming, and benchmarking people. We ship the scoring too. Train on the generator, from C1 up to C8. Evaluate on the benchmark, the same 125 contexts per tier for every method. Report per tier, with 95 percent intervals and paired tests. (8:35)</a:t>
             </a:r>
             <a:endParaRPr lang="en-US" dirty="0"/>
           </a:p>
@@ -2643,7 +2643,7 @@
           <a:p>
             <a:r>
               <a:rPr lang="en-US" dirty="0"/>
-              <a:t>A word on scope. CrossMEP is one section at one support. Pipe spacing was checked on two open buildings; the rest rests on practice and standards, and the trade mix is a design choice. It's not for structural design of real installations. Next: a public checker, with best-known costs, so we can compare methods on the answer; the catalog as an input; and a real test set from commercial projects, with supports designed by engineers. That's where I'd value your eye. (8:55)</a:t>
+              <a:t>A word on scope. CrossMEP is one section at one support. Pipe spacing was checked on two open buildings; the rest rests on practice and standards, and the trade mix is a design choice. It's not for structural design of real installations. Next: a public checker, with best-known costs, so we can compare methods on the answer; the catalog as an input; and a real test set from commercial projects, with supports designed by engineers. That's where I'd value your eye. (9:00)</a:t>
             </a:r>
             <a:endParaRPr lang="en-US" dirty="0"/>
           </a:p>
@@ -2731,7 +2731,7 @@
           <a:p>
             <a:r>
               <a:rPr lang="en-US" dirty="0"/>
-              <a:t>To sum up: CrossMEP is the brief, not the answer. Seven thousand support-design problems, every constant sourced or declared a design choice, pipe spacing checked on two open buildings, and all of it open. If you coordinate services or design supports, try the studio and tell me what looks wrong. Thank you. (9:25)</a:t>
+              <a:t>To sum up: CrossMEP is the brief, not the answer. Seven thousand support-design problems, every constant sourced or declared a design choice, pipe spacing checked on two open buildings, and all of it open. If you coordinate services or design supports, try the studio and tell me what looks wrong. Thank you. (9:35)</a:t>
             </a:r>
             <a:endParaRPr lang="en-US" dirty="0"/>
           </a:p>
@@ -3523,7 +3523,7 @@
           <a:p>
             <a:r>
               <a:rPr lang="en-US" dirty="0"/>
-              <a:t>And there were none. Project models are proprietary, the open ones aren't organized around supports, and any one project is a narrow slice. So we built CrossMEP: seven thousand contexts, about thirty-one and a half thousand elements, in eight difficulty tiers. They are deliberately unlabeled: you get the problem, never the answer. Every constant is sourced or declared a design choice, and everything is open. (2:20)</a:t>
+              <a:t>Here is the idea behind CrossMEP. The real designs we had were few, and they sat in one corner of the design space: one kind of project, one trade mix. A method tuned to them measures fit to that project, and project models are proprietary anyway. So we generate. CrossMEP covers the space by construction: uniform over the tiers, or shaped to whatever mix you ask for. Seven thousand contexts in eight tiers, deliberately unlabeled, every constant sourced or declared, and all of it open. (2:20)</a:t>
             </a:r>
             <a:endParaRPr lang="en-US" dirty="0"/>
           </a:p>
@@ -3611,7 +3611,7 @@
           <a:p>
             <a:r>
               <a:rPr lang="en-US" dirty="0"/>
-              <a:t>Here's one context: a two-dimensional section at one support location. Each element has its kind, service and trade, its size, its insulation, and its load, which is weight per metre times the span it was sized at, plus its position. Add the surface, a slab or a wall, and that's all. What you won't find is the support: no channel, no rods, no anchors, and no correct answer, because a feasible support depends on the catalog you build from. The context is the brief. The assembly is the answer. (2:50)</a:t>
+              <a:t>Here's one context: a two-dimensional section at one support location. Each element has its kind, service and trade, its size, its insulation, and its load, which is weight per metre times the span it was sized at, plus its position. Add the surface, a slab or a wall, and that's all. What you won't find is the support: no channel, no rods, no anchors, and no correct answer, because a feasible support depends on the catalog you build from. The context is the brief. The assembly is the answer. (2:55)</a:t>
             </a:r>
             <a:endParaRPr lang="en-US" dirty="0"/>
           </a:p>
@@ -3699,7 +3699,7 @@
           <a:p>
             <a:r>
               <a:rPr lang="en-US" dirty="0"/>
-              <a:t>How do we make a context? Not by free randomness, but by rules an engineer would recognize. The tier fixes how many elements there are. We pick the surface and fill it the way trades really run services: hot and cold together, flow and return together, conduits in groups, bulky services nearest the slab. Gaps between neighbors are drawn from gaps measured on a built project, never below twenty-five millimeters. On walls, electrical stays above water. Every context is checked, and it's seeded: the same seed gives the same file, byte for byte. (3:25)</a:t>
+              <a:t>How do we make a context? Not by free randomness, but by rules an engineer would recognize. The tier fixes how many elements there are. We pick the surface and fill it the way trades really run services: hot and cold together, flow and return together, conduits in groups, bulky services nearest the slab. Gaps between neighbors are drawn from gaps measured on a built project, never below twenty-five millimeters. On walls, electrical stays above water. Every context is checked, and it's seeded: the same seed gives the same file, byte for byte. (3:35)</a:t>
             </a:r>
             <a:endParaRPr lang="en-US" dirty="0"/>
           </a:p>
@@ -3787,7 +3787,7 @@
           <a:p>
             <a:r>
               <a:rPr lang="en-US" dirty="0"/>
-              <a:t>Where do the numbers come from? Three places. Sizes, weights and spans come from standards: European steel pipe and duct standards, IEC for conduits and trays, ASME for spans, the German GEG for insulation. How close neighbors sit comes from measured open buildings. And a few things are simply our choices, like the trade mix, and we label them that way. Loads are computed in code from all of this. (4:05)</a:t>
+              <a:t>Where do the numbers come from? Three places. Sizes, weights and spans come from standards: European steel pipe and duct standards, IEC for conduits and trays, ASME for spans, the German GEG for insulation. How close neighbors sit comes from measured open buildings. And a few things are simply our choices, like the trade mix, and we label them that way. Loads are computed in code from all of this. (4:10)</a:t>
             </a:r>
             <a:endParaRPr lang="en-US" dirty="0"/>
           </a:p>
@@ -3875,7 +3875,7 @@
           <a:p>
             <a:r>
               <a:rPr lang="en-US" dirty="0"/>
-              <a:t>The release has four splits on disjoint seeds, so a method is never tested on what it trained on: five thousand contexts for training, five hundred each for validation and test, and a benchmark of one thousand, a hundred and twenty-five per tier. Everything is plain JSON with a schema and a datasheet. (4:35)</a:t>
+              <a:t>The release has four splits on disjoint seeds, so a method is never tested on what it trained on: five thousand contexts for training, five hundred each for validation and test, and a benchmark of one thousand, a hundred and twenty-five per tier. Everything is plain JSON with a schema and a datasheet. (4:40)</a:t>
             </a:r>
             <a:endParaRPr lang="en-US" dirty="0"/>
           </a:p>
@@ -22842,7 +22842,7 @@
                   <a:schemeClr val="tx1"/>
                 </a:solidFill>
               </a:rPr>
-              <a:t>Learning to design supports needs many problems, and none were public</a:t>
+              <a:t>Real designs cover one corner of the design space; CrossMEP covers all of it</a:t>
             </a:r>
             <a:endParaRPr lang="en-US" sz="2600" dirty="0"/>
           </a:p>
@@ -22850,14 +22850,528 @@
       </p:sp>
       <p:sp>
         <p:nvSpPr>
-          <p:cNvPr id="3" name="why heading"/>
+          <p:cNvPr id="3" name="space real"/>
+          <p:cNvSpPr/>
+          <p:nvPr/>
+        </p:nvSpPr>
+        <p:spPr>
+          <a:xfrm>
+            <a:off x="548640" y="1371600"/>
+            <a:ext cx="5212080" cy="2103120"/>
+          </a:xfrm>
+          <a:prstGeom prst="roundRect">
+            <a:avLst>
+              <a:gd name="adj" fmla="val 3043"/>
+            </a:avLst>
+          </a:prstGeom>
+          <a:solidFill>
+            <a:schemeClr val="bg2"/>
+          </a:solidFill>
+          <a:ln/>
+        </p:spPr>
+      </p:sp>
+      <p:sp>
+        <p:nvSpPr>
+          <p:cNvPr id="4" name="space head real"/>
           <p:cNvSpPr txBox="1"/>
           <p:nvPr/>
         </p:nvSpPr>
         <p:spPr>
           <a:xfrm>
-            <a:off x="548640" y="1371600"/>
-            <a:ext cx="4937760" cy="365760"/>
+            <a:off x="731520" y="1481328"/>
+            <a:ext cx="4846320" cy="566928"/>
+          </a:xfrm>
+          <a:prstGeom prst="rect">
+            <a:avLst/>
+          </a:prstGeom>
+          <a:noFill/>
+          <a:ln/>
+        </p:spPr>
+        <p:txBody>
+          <a:bodyPr wrap="square" lIns="0" tIns="0" rIns="0" bIns="0" rtlCol="0" anchor="t"/>
+          <a:lstStyle/>
+          <a:p>
+            <a:pPr indent="0" marL="0">
+              <a:buNone/>
+            </a:pPr>
+            <a:r>
+              <a:rPr lang="en-US" sz="1400" b="1" dirty="0">
+                <a:solidFill>
+                  <a:schemeClr val="tx1"/>
+                </a:solidFill>
+              </a:rPr>
+              <a:t>The real designs we had</a:t>
+            </a:r>
+            <a:endParaRPr lang="en-US" sz="1400" dirty="0"/>
+          </a:p>
+          <a:p>
+            <a:pPr indent="0" marL="0">
+              <a:buNone/>
+            </a:pPr>
+            <a:r>
+              <a:rPr lang="en-US" sz="1150" dirty="0">
+                <a:solidFill>
+                  <a:srgbClr val="52514E"/>
+                </a:solidFill>
+              </a:rPr>
+              <a:t>few, from one kind of project with one trade mix: one corner of the space</a:t>
+            </a:r>
+            <a:endParaRPr lang="en-US" sz="1400" dirty="0"/>
+          </a:p>
+        </p:txBody>
+      </p:sp>
+      <p:sp>
+        <p:nvSpPr>
+          <p:cNvPr id="5" name="x axis real"/>
+          <p:cNvSpPr/>
+          <p:nvPr/>
+        </p:nvSpPr>
+        <p:spPr>
+          <a:xfrm>
+            <a:off x="1051560" y="3063240"/>
+            <a:ext cx="4480560" cy="0"/>
+          </a:xfrm>
+          <a:prstGeom prst="line">
+            <a:avLst/>
+          </a:prstGeom>
+          <a:noFill/>
+          <a:ln w="12700">
+            <a:solidFill>
+              <a:srgbClr val="52514E"/>
+            </a:solidFill>
+            <a:prstDash val="solid"/>
+            <a:tailEnd type="triangle"/>
+          </a:ln>
+        </p:spPr>
+      </p:sp>
+      <p:sp>
+        <p:nvSpPr>
+          <p:cNvPr id="6" name="y axis real"/>
+          <p:cNvSpPr/>
+          <p:nvPr/>
+        </p:nvSpPr>
+        <p:spPr>
+          <a:xfrm>
+            <a:off x="1051560" y="2148840"/>
+            <a:ext cx="0" cy="914400"/>
+          </a:xfrm>
+          <a:prstGeom prst="line">
+            <a:avLst/>
+          </a:prstGeom>
+          <a:noFill/>
+          <a:ln w="12700">
+            <a:solidFill>
+              <a:srgbClr val="52514E"/>
+            </a:solidFill>
+            <a:prstDash val="solid"/>
+            <a:headEnd type="triangle"/>
+          </a:ln>
+        </p:spPr>
+      </p:sp>
+      <p:sp>
+        <p:nvSpPr>
+          <p:cNvPr id="7" name="x label real"/>
+          <p:cNvSpPr txBox="1"/>
+          <p:nvPr/>
+        </p:nvSpPr>
+        <p:spPr>
+          <a:xfrm>
+            <a:off x="1051560" y="3090672"/>
+            <a:ext cx="4480560" cy="228600"/>
+          </a:xfrm>
+          <a:prstGeom prst="rect">
+            <a:avLst/>
+          </a:prstGeom>
+          <a:noFill/>
+          <a:ln/>
+        </p:spPr>
+        <p:txBody>
+          <a:bodyPr wrap="square" lIns="0" tIns="0" rIns="0" bIns="0" rtlCol="0" anchor="ctr"/>
+          <a:lstStyle/>
+          <a:p>
+            <a:pPr algn="ctr" indent="0" marL="0">
+              <a:buNone/>
+            </a:pPr>
+            <a:r>
+              <a:rPr lang="en-US" sz="1000" dirty="0">
+                <a:solidFill>
+                  <a:srgbClr val="52514E"/>
+                </a:solidFill>
+              </a:rPr>
+              <a:t>elements at the hanger: 1 … 8</a:t>
+            </a:r>
+            <a:endParaRPr lang="en-US" sz="1000" dirty="0"/>
+          </a:p>
+        </p:txBody>
+      </p:sp>
+      <p:sp>
+        <p:nvSpPr>
+          <p:cNvPr id="8" name="y label real"/>
+          <p:cNvSpPr txBox="1"/>
+          <p:nvPr/>
+        </p:nvSpPr>
+        <p:spPr>
+          <a:xfrm rot="16200000">
+            <a:off x="566928" y="2148840"/>
+            <a:ext cx="457200" cy="914400"/>
+          </a:xfrm>
+          <a:prstGeom prst="rect">
+            <a:avLst/>
+          </a:prstGeom>
+          <a:noFill/>
+          <a:ln/>
+        </p:spPr>
+        <p:txBody>
+          <a:bodyPr wrap="square" lIns="0" tIns="0" rIns="0" bIns="0" rtlCol="0" anchor="ctr"/>
+          <a:lstStyle/>
+          <a:p>
+            <a:pPr algn="ctr" indent="0" marL="0">
+              <a:buNone/>
+            </a:pPr>
+            <a:r>
+              <a:rPr lang="en-US" sz="1000" dirty="0">
+                <a:solidFill>
+                  <a:srgbClr val="52514E"/>
+                </a:solidFill>
+              </a:rPr>
+              <a:t>kinds, trades, surface</a:t>
+            </a:r>
+            <a:endParaRPr lang="en-US" sz="1000" dirty="0"/>
+          </a:p>
+        </p:txBody>
+      </p:sp>
+      <p:sp>
+        <p:nvSpPr>
+          <p:cNvPr id="9" name="dot real 0"/>
+          <p:cNvSpPr/>
+          <p:nvPr/>
+        </p:nvSpPr>
+        <p:spPr>
+          <a:xfrm>
+            <a:off x="1516075" y="2807208"/>
+            <a:ext cx="146304" cy="146304"/>
+          </a:xfrm>
+          <a:prstGeom prst="ellipse">
+            <a:avLst/>
+          </a:prstGeom>
+          <a:solidFill>
+            <a:srgbClr val="EB6834"/>
+          </a:solidFill>
+          <a:ln w="6350">
+            <a:solidFill>
+              <a:srgbClr val="FFFFFF"/>
+            </a:solidFill>
+            <a:prstDash val="solid"/>
+          </a:ln>
+        </p:spPr>
+      </p:sp>
+      <p:sp>
+        <p:nvSpPr>
+          <p:cNvPr id="10" name="dot real 1"/>
+          <p:cNvSpPr/>
+          <p:nvPr/>
+        </p:nvSpPr>
+        <p:spPr>
+          <a:xfrm>
+            <a:off x="1784909" y="2752344"/>
+            <a:ext cx="146304" cy="146304"/>
+          </a:xfrm>
+          <a:prstGeom prst="ellipse">
+            <a:avLst/>
+          </a:prstGeom>
+          <a:solidFill>
+            <a:srgbClr val="EB6834"/>
+          </a:solidFill>
+          <a:ln w="6350">
+            <a:solidFill>
+              <a:srgbClr val="FFFFFF"/>
+            </a:solidFill>
+            <a:prstDash val="solid"/>
+          </a:ln>
+        </p:spPr>
+      </p:sp>
+      <p:sp>
+        <p:nvSpPr>
+          <p:cNvPr id="11" name="dot real 2"/>
+          <p:cNvSpPr/>
+          <p:nvPr/>
+        </p:nvSpPr>
+        <p:spPr>
+          <a:xfrm>
+            <a:off x="1964131" y="2834640"/>
+            <a:ext cx="146304" cy="146304"/>
+          </a:xfrm>
+          <a:prstGeom prst="ellipse">
+            <a:avLst/>
+          </a:prstGeom>
+          <a:solidFill>
+            <a:srgbClr val="EB6834"/>
+          </a:solidFill>
+          <a:ln w="6350">
+            <a:solidFill>
+              <a:srgbClr val="FFFFFF"/>
+            </a:solidFill>
+            <a:prstDash val="solid"/>
+          </a:ln>
+        </p:spPr>
+      </p:sp>
+      <p:sp>
+        <p:nvSpPr>
+          <p:cNvPr id="12" name="dot real 3"/>
+          <p:cNvSpPr/>
+          <p:nvPr/>
+        </p:nvSpPr>
+        <p:spPr>
+          <a:xfrm>
+            <a:off x="1650492" y="2688336"/>
+            <a:ext cx="146304" cy="146304"/>
+          </a:xfrm>
+          <a:prstGeom prst="ellipse">
+            <a:avLst/>
+          </a:prstGeom>
+          <a:solidFill>
+            <a:srgbClr val="EB6834"/>
+          </a:solidFill>
+          <a:ln w="6350">
+            <a:solidFill>
+              <a:srgbClr val="FFFFFF"/>
+            </a:solidFill>
+            <a:prstDash val="solid"/>
+          </a:ln>
+        </p:spPr>
+      </p:sp>
+      <p:sp>
+        <p:nvSpPr>
+          <p:cNvPr id="13" name="dot real 4"/>
+          <p:cNvSpPr/>
+          <p:nvPr/>
+        </p:nvSpPr>
+        <p:spPr>
+          <a:xfrm>
+            <a:off x="2188159" y="2770632"/>
+            <a:ext cx="146304" cy="146304"/>
+          </a:xfrm>
+          <a:prstGeom prst="ellipse">
+            <a:avLst/>
+          </a:prstGeom>
+          <a:solidFill>
+            <a:srgbClr val="EB6834"/>
+          </a:solidFill>
+          <a:ln w="6350">
+            <a:solidFill>
+              <a:srgbClr val="FFFFFF"/>
+            </a:solidFill>
+            <a:prstDash val="solid"/>
+          </a:ln>
+        </p:spPr>
+      </p:sp>
+      <p:sp>
+        <p:nvSpPr>
+          <p:cNvPr id="14" name="dot real 5"/>
+          <p:cNvSpPr/>
+          <p:nvPr/>
+        </p:nvSpPr>
+        <p:spPr>
+          <a:xfrm>
+            <a:off x="1874520" y="2880360"/>
+            <a:ext cx="146304" cy="146304"/>
+          </a:xfrm>
+          <a:prstGeom prst="ellipse">
+            <a:avLst/>
+          </a:prstGeom>
+          <a:solidFill>
+            <a:srgbClr val="EB6834"/>
+          </a:solidFill>
+          <a:ln w="6350">
+            <a:solidFill>
+              <a:srgbClr val="FFFFFF"/>
+            </a:solidFill>
+            <a:prstDash val="solid"/>
+          </a:ln>
+        </p:spPr>
+      </p:sp>
+      <p:sp>
+        <p:nvSpPr>
+          <p:cNvPr id="15" name="dot real 6"/>
+          <p:cNvSpPr/>
+          <p:nvPr/>
+        </p:nvSpPr>
+        <p:spPr>
+          <a:xfrm>
+            <a:off x="2367382" y="2715768"/>
+            <a:ext cx="146304" cy="146304"/>
+          </a:xfrm>
+          <a:prstGeom prst="ellipse">
+            <a:avLst/>
+          </a:prstGeom>
+          <a:solidFill>
+            <a:srgbClr val="EB6834"/>
+          </a:solidFill>
+          <a:ln w="6350">
+            <a:solidFill>
+              <a:srgbClr val="FFFFFF"/>
+            </a:solidFill>
+            <a:prstDash val="solid"/>
+          </a:ln>
+        </p:spPr>
+      </p:sp>
+      <p:sp>
+        <p:nvSpPr>
+          <p:cNvPr id="16" name="dot real 7"/>
+          <p:cNvSpPr/>
+          <p:nvPr/>
+        </p:nvSpPr>
+        <p:spPr>
+          <a:xfrm>
+            <a:off x="1381658" y="2734056"/>
+            <a:ext cx="146304" cy="146304"/>
+          </a:xfrm>
+          <a:prstGeom prst="ellipse">
+            <a:avLst/>
+          </a:prstGeom>
+          <a:solidFill>
+            <a:srgbClr val="EB6834"/>
+          </a:solidFill>
+          <a:ln w="6350">
+            <a:solidFill>
+              <a:srgbClr val="FFFFFF"/>
+            </a:solidFill>
+            <a:prstDash val="solid"/>
+          </a:ln>
+        </p:spPr>
+      </p:sp>
+      <p:sp>
+        <p:nvSpPr>
+          <p:cNvPr id="17" name="dot real 8"/>
+          <p:cNvSpPr/>
+          <p:nvPr/>
+        </p:nvSpPr>
+        <p:spPr>
+          <a:xfrm>
+            <a:off x="2098548" y="2660904"/>
+            <a:ext cx="146304" cy="146304"/>
+          </a:xfrm>
+          <a:prstGeom prst="ellipse">
+            <a:avLst/>
+          </a:prstGeom>
+          <a:solidFill>
+            <a:srgbClr val="EB6834"/>
+          </a:solidFill>
+          <a:ln w="6350">
+            <a:solidFill>
+              <a:srgbClr val="FFFFFF"/>
+            </a:solidFill>
+            <a:prstDash val="solid"/>
+          </a:ln>
+        </p:spPr>
+      </p:sp>
+      <p:sp>
+        <p:nvSpPr>
+          <p:cNvPr id="18" name="dot real 9"/>
+          <p:cNvSpPr/>
+          <p:nvPr/>
+        </p:nvSpPr>
+        <p:spPr>
+          <a:xfrm>
+            <a:off x="2456993" y="2816352"/>
+            <a:ext cx="146304" cy="146304"/>
+          </a:xfrm>
+          <a:prstGeom prst="ellipse">
+            <a:avLst/>
+          </a:prstGeom>
+          <a:solidFill>
+            <a:srgbClr val="EB6834"/>
+          </a:solidFill>
+          <a:ln w="6350">
+            <a:solidFill>
+              <a:srgbClr val="FFFFFF"/>
+            </a:solidFill>
+            <a:prstDash val="solid"/>
+          </a:ln>
+        </p:spPr>
+      </p:sp>
+      <p:sp>
+        <p:nvSpPr>
+          <p:cNvPr id="19" name="dot real 10"/>
+          <p:cNvSpPr/>
+          <p:nvPr/>
+        </p:nvSpPr>
+        <p:spPr>
+          <a:xfrm>
+            <a:off x="1740103" y="2624328"/>
+            <a:ext cx="146304" cy="146304"/>
+          </a:xfrm>
+          <a:prstGeom prst="ellipse">
+            <a:avLst/>
+          </a:prstGeom>
+          <a:solidFill>
+            <a:srgbClr val="EB6834"/>
+          </a:solidFill>
+          <a:ln w="6350">
+            <a:solidFill>
+              <a:srgbClr val="FFFFFF"/>
+            </a:solidFill>
+            <a:prstDash val="solid"/>
+          </a:ln>
+        </p:spPr>
+      </p:sp>
+      <p:sp>
+        <p:nvSpPr>
+          <p:cNvPr id="20" name="dot real 11"/>
+          <p:cNvSpPr/>
+          <p:nvPr/>
+        </p:nvSpPr>
+        <p:spPr>
+          <a:xfrm>
+            <a:off x="2322576" y="2898648"/>
+            <a:ext cx="146304" cy="146304"/>
+          </a:xfrm>
+          <a:prstGeom prst="ellipse">
+            <a:avLst/>
+          </a:prstGeom>
+          <a:solidFill>
+            <a:srgbClr val="EB6834"/>
+          </a:solidFill>
+          <a:ln w="6350">
+            <a:solidFill>
+              <a:srgbClr val="FFFFFF"/>
+            </a:solidFill>
+            <a:prstDash val="solid"/>
+          </a:ln>
+        </p:spPr>
+      </p:sp>
+      <p:sp>
+        <p:nvSpPr>
+          <p:cNvPr id="21" name="real cluster ring"/>
+          <p:cNvSpPr/>
+          <p:nvPr/>
+        </p:nvSpPr>
+        <p:spPr>
+          <a:xfrm>
+            <a:off x="1141171" y="2624328"/>
+            <a:ext cx="1702613" cy="420624"/>
+          </a:xfrm>
+          <a:prstGeom prst="ellipse">
+            <a:avLst/>
+          </a:prstGeom>
+          <a:ln w="12700">
+            <a:solidFill>
+              <a:srgbClr val="EB6834"/>
+            </a:solidFill>
+            <a:prstDash val="dash"/>
+          </a:ln>
+        </p:spPr>
+      </p:sp>
+      <p:sp>
+        <p:nvSpPr>
+          <p:cNvPr id="22" name="real note"/>
+          <p:cNvSpPr txBox="1"/>
+          <p:nvPr/>
+        </p:nvSpPr>
+        <p:spPr>
+          <a:xfrm>
+            <a:off x="3023006" y="2377440"/>
+            <a:ext cx="2464308" cy="457200"/>
           </a:xfrm>
           <a:prstGeom prst="rect">
             <a:avLst/>
@@ -22873,107 +23387,49 @@
               <a:buNone/>
             </a:pPr>
             <a:r>
-              <a:rPr lang="en-US" sz="1600" b="1" dirty="0">
+              <a:rPr lang="en-US" sz="1100" i="1" dirty="0">
                 <a:solidFill>
-                  <a:schemeClr val="tx1"/>
+                  <a:srgbClr val="52514E"/>
                 </a:solidFill>
               </a:rPr>
-              <a:t>Why it has to be synthetic</a:t>
+              <a:t>a method tuned here measures fit to that project</a:t>
             </a:r>
-            <a:endParaRPr lang="en-US" sz="1600" dirty="0"/>
+            <a:endParaRPr lang="en-US" sz="1100" dirty="0"/>
           </a:p>
         </p:txBody>
       </p:sp>
       <p:sp>
         <p:nvSpPr>
-          <p:cNvPr id="4" name="icon ring Scarcity"/>
+          <p:cNvPr id="23" name="space synthetic"/>
           <p:cNvSpPr/>
           <p:nvPr/>
         </p:nvSpPr>
         <p:spPr>
           <a:xfrm>
-            <a:off x="548640" y="1874520"/>
-            <a:ext cx="530352" cy="530352"/>
-          </a:xfrm>
-          <a:prstGeom prst="ellipse">
-            <a:avLst/>
+            <a:off x="548640" y="3611880"/>
+            <a:ext cx="5212080" cy="2103120"/>
+          </a:xfrm>
+          <a:prstGeom prst="roundRect">
+            <a:avLst>
+              <a:gd name="adj" fmla="val 3043"/>
+            </a:avLst>
           </a:prstGeom>
           <a:solidFill>
-            <a:schemeClr val="accent1"/>
+            <a:schemeClr val="bg2"/>
           </a:solidFill>
           <a:ln/>
         </p:spPr>
       </p:sp>
-      <p:pic>
-        <p:nvPicPr>
-          <p:cNvPr id="5" name="icon Scarcity" descr="preencoded.png">    </p:cNvPr>
-          <p:cNvPicPr>
-            <a:picLocks noChangeAspect="1"/>
-          </p:cNvPicPr>
-          <p:nvPr/>
-        </p:nvPicPr>
-        <p:blipFill>
-          <a:blip r:embed="rId1"/>
-          <a:stretch>
-            <a:fillRect/>
-          </a:stretch>
-        </p:blipFill>
-        <p:spPr>
-          <a:xfrm>
-            <a:off x="660014" y="1985894"/>
-            <a:ext cx="307604" cy="307604"/>
-          </a:xfrm>
-          <a:prstGeom prst="rect">
-            <a:avLst/>
-          </a:prstGeom>
-        </p:spPr>
-      </p:pic>
-      <p:sp>
-        <p:nvSpPr>
-          <p:cNvPr id="6" name="reason Scarcity"/>
+      <p:sp>
+        <p:nvSpPr>
+          <p:cNvPr id="24" name="space head synthetic"/>
           <p:cNvSpPr txBox="1"/>
           <p:nvPr/>
         </p:nvSpPr>
         <p:spPr>
           <a:xfrm>
-            <a:off x="1280160" y="1856232"/>
-            <a:ext cx="4206240" cy="329184"/>
-          </a:xfrm>
-          <a:prstGeom prst="rect">
-            <a:avLst/>
-          </a:prstGeom>
-          <a:noFill/>
-          <a:ln/>
-        </p:spPr>
-        <p:txBody>
-          <a:bodyPr wrap="square" lIns="0" tIns="0" rIns="0" bIns="0" rtlCol="0" anchor="ctr"/>
-          <a:lstStyle/>
-          <a:p>
-            <a:pPr indent="0" marL="0">
-              <a:buNone/>
-            </a:pPr>
-            <a:r>
-              <a:rPr lang="en-US" sz="1500" b="1" dirty="0">
-                <a:solidFill>
-                  <a:schemeClr val="tx1"/>
-                </a:solidFill>
-              </a:rPr>
-              <a:t>Scarcity</a:t>
-            </a:r>
-            <a:endParaRPr lang="en-US" sz="1500" dirty="0"/>
-          </a:p>
-        </p:txBody>
-      </p:sp>
-      <p:sp>
-        <p:nvSpPr>
-          <p:cNvPr id="7" name="reason text Scarcity"/>
-          <p:cNvSpPr txBox="1"/>
-          <p:nvPr/>
-        </p:nvSpPr>
-        <p:spPr>
-          <a:xfrm>
-            <a:off x="1280160" y="2221992"/>
-            <a:ext cx="4206240" cy="868680"/>
+            <a:off x="731520" y="3721608"/>
+            <a:ext cx="4846320" cy="566928"/>
           </a:xfrm>
           <a:prstGeom prst="rect">
             <a:avLst/>
@@ -22989,187 +23445,89 @@
               <a:buNone/>
             </a:pPr>
             <a:r>
-              <a:rPr lang="en-US" sz="1250" dirty="0">
+              <a:rPr lang="en-US" sz="1400" b="1" dirty="0">
                 <a:solidFill>
                   <a:schemeClr val="tx1"/>
                 </a:solidFill>
               </a:rPr>
-              <a:t>Project models are proprietary; the few open ones are not organised around supports and often export no element sizes.</a:t>
+              <a:t>CrossMEP</a:t>
             </a:r>
-            <a:endParaRPr lang="en-US" sz="1250" dirty="0"/>
+            <a:endParaRPr lang="en-US" sz="1400" dirty="0"/>
           </a:p>
-        </p:txBody>
-      </p:sp>
-      <p:sp>
-        <p:nvSpPr>
-          <p:cNvPr id="8" name="icon ring Coverage"/>
-          <p:cNvSpPr/>
-          <p:nvPr/>
-        </p:nvSpPr>
-        <p:spPr>
-          <a:xfrm>
-            <a:off x="548640" y="3246120"/>
-            <a:ext cx="530352" cy="530352"/>
-          </a:xfrm>
-          <a:prstGeom prst="ellipse">
-            <a:avLst/>
-          </a:prstGeom>
-          <a:solidFill>
-            <a:schemeClr val="accent1"/>
-          </a:solidFill>
-          <a:ln/>
-        </p:spPr>
-      </p:sp>
-      <p:pic>
-        <p:nvPicPr>
-          <p:cNvPr id="9" name="icon Coverage" descr="preencoded.png">    </p:cNvPr>
-          <p:cNvPicPr>
-            <a:picLocks noChangeAspect="1"/>
-          </p:cNvPicPr>
-          <p:nvPr/>
-        </p:nvPicPr>
-        <p:blipFill>
-          <a:blip r:embed="rId2"/>
-          <a:stretch>
-            <a:fillRect/>
-          </a:stretch>
-        </p:blipFill>
-        <p:spPr>
-          <a:xfrm>
-            <a:off x="660014" y="3357494"/>
-            <a:ext cx="307604" cy="307604"/>
-          </a:xfrm>
-          <a:prstGeom prst="rect">
-            <a:avLst/>
-          </a:prstGeom>
-        </p:spPr>
-      </p:pic>
-      <p:sp>
-        <p:nvSpPr>
-          <p:cNvPr id="10" name="reason Coverage"/>
-          <p:cNvSpPr txBox="1"/>
-          <p:nvPr/>
-        </p:nvSpPr>
-        <p:spPr>
-          <a:xfrm>
-            <a:off x="1280160" y="3227832"/>
-            <a:ext cx="4206240" cy="329184"/>
-          </a:xfrm>
-          <a:prstGeom prst="rect">
-            <a:avLst/>
-          </a:prstGeom>
-          <a:noFill/>
-          <a:ln/>
-        </p:spPr>
-        <p:txBody>
-          <a:bodyPr wrap="square" lIns="0" tIns="0" rIns="0" bIns="0" rtlCol="0" anchor="ctr"/>
-          <a:lstStyle/>
           <a:p>
             <a:pPr indent="0" marL="0">
               <a:buNone/>
             </a:pPr>
             <a:r>
-              <a:rPr lang="en-US" sz="1500" b="1" dirty="0">
+              <a:rPr lang="en-US" sz="1150" dirty="0">
                 <a:solidFill>
-                  <a:schemeClr val="tx1"/>
+                  <a:srgbClr val="52514E"/>
                 </a:solidFill>
               </a:rPr>
-              <a:t>Coverage</a:t>
+              <a:t>the space filled by construction: uniform over the tiers, or any mix you ask for (generate_custom)</a:t>
             </a:r>
-            <a:endParaRPr lang="en-US" sz="1500" dirty="0"/>
+            <a:endParaRPr lang="en-US" sz="1400" dirty="0"/>
           </a:p>
         </p:txBody>
       </p:sp>
       <p:sp>
         <p:nvSpPr>
-          <p:cNvPr id="11" name="reason text Coverage"/>
+          <p:cNvPr id="25" name="x axis synthetic"/>
+          <p:cNvSpPr/>
+          <p:nvPr/>
+        </p:nvSpPr>
+        <p:spPr>
+          <a:xfrm>
+            <a:off x="1051560" y="5303520"/>
+            <a:ext cx="4480560" cy="0"/>
+          </a:xfrm>
+          <a:prstGeom prst="line">
+            <a:avLst/>
+          </a:prstGeom>
+          <a:noFill/>
+          <a:ln w="12700">
+            <a:solidFill>
+              <a:srgbClr val="52514E"/>
+            </a:solidFill>
+            <a:prstDash val="solid"/>
+            <a:tailEnd type="triangle"/>
+          </a:ln>
+        </p:spPr>
+      </p:sp>
+      <p:sp>
+        <p:nvSpPr>
+          <p:cNvPr id="26" name="y axis synthetic"/>
+          <p:cNvSpPr/>
+          <p:nvPr/>
+        </p:nvSpPr>
+        <p:spPr>
+          <a:xfrm>
+            <a:off x="1051560" y="4389120"/>
+            <a:ext cx="0" cy="914400"/>
+          </a:xfrm>
+          <a:prstGeom prst="line">
+            <a:avLst/>
+          </a:prstGeom>
+          <a:noFill/>
+          <a:ln w="12700">
+            <a:solidFill>
+              <a:srgbClr val="52514E"/>
+            </a:solidFill>
+            <a:prstDash val="solid"/>
+            <a:headEnd type="triangle"/>
+          </a:ln>
+        </p:spPr>
+      </p:sp>
+      <p:sp>
+        <p:nvSpPr>
+          <p:cNvPr id="27" name="x label synthetic"/>
           <p:cNvSpPr txBox="1"/>
           <p:nvPr/>
         </p:nvSpPr>
         <p:spPr>
           <a:xfrm>
-            <a:off x="1280160" y="3593592"/>
-            <a:ext cx="4206240" cy="868680"/>
-          </a:xfrm>
-          <a:prstGeom prst="rect">
-            <a:avLst/>
-          </a:prstGeom>
-          <a:noFill/>
-          <a:ln/>
-        </p:spPr>
-        <p:txBody>
-          <a:bodyPr wrap="square" lIns="0" tIns="0" rIns="0" bIns="0" rtlCol="0" anchor="t"/>
-          <a:lstStyle/>
-          <a:p>
-            <a:pPr indent="0" marL="0">
-              <a:buNone/>
-            </a:pPr>
-            <a:r>
-              <a:rPr lang="en-US" sz="1250" dirty="0">
-                <a:solidFill>
-                  <a:schemeClr val="tx1"/>
-                </a:solidFill>
-              </a:rPr>
-              <a:t>One project is one narrow slice: one building type, one trade mix. A method tuned to it measures fit to that project.</a:t>
-            </a:r>
-            <a:endParaRPr lang="en-US" sz="1250" dirty="0"/>
-          </a:p>
-        </p:txBody>
-      </p:sp>
-      <p:sp>
-        <p:nvSpPr>
-          <p:cNvPr id="12" name="icon ring Control"/>
-          <p:cNvSpPr/>
-          <p:nvPr/>
-        </p:nvSpPr>
-        <p:spPr>
-          <a:xfrm>
-            <a:off x="548640" y="4617720"/>
-            <a:ext cx="530352" cy="530352"/>
-          </a:xfrm>
-          <a:prstGeom prst="ellipse">
-            <a:avLst/>
-          </a:prstGeom>
-          <a:solidFill>
-            <a:schemeClr val="accent1"/>
-          </a:solidFill>
-          <a:ln/>
-        </p:spPr>
-      </p:sp>
-      <p:pic>
-        <p:nvPicPr>
-          <p:cNvPr id="13" name="icon Control" descr="preencoded.png">    </p:cNvPr>
-          <p:cNvPicPr>
-            <a:picLocks noChangeAspect="1"/>
-          </p:cNvPicPr>
-          <p:nvPr/>
-        </p:nvPicPr>
-        <p:blipFill>
-          <a:blip r:embed="rId3"/>
-          <a:stretch>
-            <a:fillRect/>
-          </a:stretch>
-        </p:blipFill>
-        <p:spPr>
-          <a:xfrm>
-            <a:off x="660014" y="4729094"/>
-            <a:ext cx="307604" cy="307604"/>
-          </a:xfrm>
-          <a:prstGeom prst="rect">
-            <a:avLst/>
-          </a:prstGeom>
-        </p:spPr>
-      </p:pic>
-      <p:sp>
-        <p:nvSpPr>
-          <p:cNvPr id="14" name="reason Control"/>
-          <p:cNvSpPr txBox="1"/>
-          <p:nvPr/>
-        </p:nvSpPr>
-        <p:spPr>
-          <a:xfrm>
-            <a:off x="1280160" y="4599432"/>
-            <a:ext cx="4206240" cy="329184"/>
+            <a:off x="1051560" y="5330952"/>
+            <a:ext cx="4480560" cy="228600"/>
           </a:xfrm>
           <a:prstGeom prst="rect">
             <a:avLst/>
@@ -23181,31 +23539,31 @@
           <a:bodyPr wrap="square" lIns="0" tIns="0" rIns="0" bIns="0" rtlCol="0" anchor="ctr"/>
           <a:lstStyle/>
           <a:p>
-            <a:pPr indent="0" marL="0">
+            <a:pPr algn="ctr" indent="0" marL="0">
               <a:buNone/>
             </a:pPr>
             <a:r>
-              <a:rPr lang="en-US" sz="1500" b="1" dirty="0">
+              <a:rPr lang="en-US" sz="1000" dirty="0">
                 <a:solidFill>
-                  <a:schemeClr val="tx1"/>
+                  <a:srgbClr val="52514E"/>
                 </a:solidFill>
               </a:rPr>
-              <a:t>Control</a:t>
+              <a:t>elements at the hanger: 1 … 8</a:t>
             </a:r>
-            <a:endParaRPr lang="en-US" sz="1500" dirty="0"/>
+            <a:endParaRPr lang="en-US" sz="1000" dirty="0"/>
           </a:p>
         </p:txBody>
       </p:sp>
       <p:sp>
         <p:nvSpPr>
-          <p:cNvPr id="15" name="reason text Control"/>
+          <p:cNvPr id="28" name="y label synthetic"/>
           <p:cNvSpPr txBox="1"/>
           <p:nvPr/>
         </p:nvSpPr>
         <p:spPr>
-          <a:xfrm>
-            <a:off x="1280160" y="4965192"/>
-            <a:ext cx="4206240" cy="868680"/>
+          <a:xfrm rot="16200000">
+            <a:off x="566928" y="4389120"/>
+            <a:ext cx="457200" cy="914400"/>
           </a:xfrm>
           <a:prstGeom prst="rect">
             <a:avLst/>
@@ -23214,27 +23572,827 @@
           <a:ln/>
         </p:spPr>
         <p:txBody>
-          <a:bodyPr wrap="square" lIns="0" tIns="0" rIns="0" bIns="0" rtlCol="0" anchor="t"/>
+          <a:bodyPr wrap="square" lIns="0" tIns="0" rIns="0" bIns="0" rtlCol="0" anchor="ctr"/>
           <a:lstStyle/>
           <a:p>
-            <a:pPr indent="0" marL="0">
+            <a:pPr algn="ctr" indent="0" marL="0">
               <a:buNone/>
             </a:pPr>
             <a:r>
-              <a:rPr lang="en-US" sz="1250" dirty="0">
+              <a:rPr lang="en-US" sz="1000" dirty="0">
                 <a:solidFill>
-                  <a:schemeClr val="tx1"/>
+                  <a:srgbClr val="52514E"/>
                 </a:solidFill>
               </a:rPr>
-              <a:t>A seeded generator gives unlimited problems with a known distribution, difficulty by construction and held-out seeds.</a:t>
+              <a:t>kinds, trades, surface</a:t>
             </a:r>
-            <a:endParaRPr lang="en-US" sz="1250" dirty="0"/>
+            <a:endParaRPr lang="en-US" sz="1000" dirty="0"/>
           </a:p>
         </p:txBody>
       </p:sp>
       <p:sp>
         <p:nvSpPr>
-          <p:cNvPr id="16" name="glance heading"/>
+          <p:cNvPr id="29" name="dot syn 00"/>
+          <p:cNvSpPr/>
+          <p:nvPr/>
+        </p:nvSpPr>
+        <p:spPr>
+          <a:xfrm>
+            <a:off x="1350569" y="5134356"/>
+            <a:ext cx="118872" cy="118872"/>
+          </a:xfrm>
+          <a:prstGeom prst="ellipse">
+            <a:avLst/>
+          </a:prstGeom>
+          <a:solidFill>
+            <a:schemeClr val="accent1"/>
+          </a:solidFill>
+          <a:ln w="6350">
+            <a:solidFill>
+              <a:srgbClr val="FFFFFF"/>
+            </a:solidFill>
+            <a:prstDash val="solid"/>
+          </a:ln>
+        </p:spPr>
+      </p:sp>
+      <p:sp>
+        <p:nvSpPr>
+          <p:cNvPr id="30" name="dot syn 01"/>
+          <p:cNvSpPr/>
+          <p:nvPr/>
+        </p:nvSpPr>
+        <p:spPr>
+          <a:xfrm>
+            <a:off x="1350569" y="4896612"/>
+            <a:ext cx="118872" cy="118872"/>
+          </a:xfrm>
+          <a:prstGeom prst="ellipse">
+            <a:avLst/>
+          </a:prstGeom>
+          <a:solidFill>
+            <a:schemeClr val="accent1"/>
+          </a:solidFill>
+          <a:ln w="6350">
+            <a:solidFill>
+              <a:srgbClr val="FFFFFF"/>
+            </a:solidFill>
+            <a:prstDash val="solid"/>
+          </a:ln>
+        </p:spPr>
+      </p:sp>
+      <p:sp>
+        <p:nvSpPr>
+          <p:cNvPr id="31" name="dot syn 02"/>
+          <p:cNvSpPr/>
+          <p:nvPr/>
+        </p:nvSpPr>
+        <p:spPr>
+          <a:xfrm>
+            <a:off x="1350569" y="4658868"/>
+            <a:ext cx="118872" cy="118872"/>
+          </a:xfrm>
+          <a:prstGeom prst="ellipse">
+            <a:avLst/>
+          </a:prstGeom>
+          <a:solidFill>
+            <a:schemeClr val="accent1"/>
+          </a:solidFill>
+          <a:ln w="6350">
+            <a:solidFill>
+              <a:srgbClr val="FFFFFF"/>
+            </a:solidFill>
+            <a:prstDash val="solid"/>
+          </a:ln>
+        </p:spPr>
+      </p:sp>
+      <p:sp>
+        <p:nvSpPr>
+          <p:cNvPr id="32" name="dot syn 03"/>
+          <p:cNvSpPr/>
+          <p:nvPr/>
+        </p:nvSpPr>
+        <p:spPr>
+          <a:xfrm>
+            <a:off x="1350569" y="4421124"/>
+            <a:ext cx="118872" cy="118872"/>
+          </a:xfrm>
+          <a:prstGeom prst="ellipse">
+            <a:avLst/>
+          </a:prstGeom>
+          <a:solidFill>
+            <a:schemeClr val="accent1"/>
+          </a:solidFill>
+          <a:ln w="6350">
+            <a:solidFill>
+              <a:srgbClr val="FFFFFF"/>
+            </a:solidFill>
+            <a:prstDash val="solid"/>
+          </a:ln>
+        </p:spPr>
+      </p:sp>
+      <p:sp>
+        <p:nvSpPr>
+          <p:cNvPr id="33" name="dot syn 10"/>
+          <p:cNvSpPr/>
+          <p:nvPr/>
+        </p:nvSpPr>
+        <p:spPr>
+          <a:xfrm>
+            <a:off x="1910639" y="5134356"/>
+            <a:ext cx="118872" cy="118872"/>
+          </a:xfrm>
+          <a:prstGeom prst="ellipse">
+            <a:avLst/>
+          </a:prstGeom>
+          <a:solidFill>
+            <a:schemeClr val="accent1"/>
+          </a:solidFill>
+          <a:ln w="6350">
+            <a:solidFill>
+              <a:srgbClr val="FFFFFF"/>
+            </a:solidFill>
+            <a:prstDash val="solid"/>
+          </a:ln>
+        </p:spPr>
+      </p:sp>
+      <p:sp>
+        <p:nvSpPr>
+          <p:cNvPr id="34" name="dot syn 11"/>
+          <p:cNvSpPr/>
+          <p:nvPr/>
+        </p:nvSpPr>
+        <p:spPr>
+          <a:xfrm>
+            <a:off x="1910639" y="4896612"/>
+            <a:ext cx="118872" cy="118872"/>
+          </a:xfrm>
+          <a:prstGeom prst="ellipse">
+            <a:avLst/>
+          </a:prstGeom>
+          <a:solidFill>
+            <a:schemeClr val="accent1"/>
+          </a:solidFill>
+          <a:ln w="6350">
+            <a:solidFill>
+              <a:srgbClr val="FFFFFF"/>
+            </a:solidFill>
+            <a:prstDash val="solid"/>
+          </a:ln>
+        </p:spPr>
+      </p:sp>
+      <p:sp>
+        <p:nvSpPr>
+          <p:cNvPr id="35" name="dot syn 12"/>
+          <p:cNvSpPr/>
+          <p:nvPr/>
+        </p:nvSpPr>
+        <p:spPr>
+          <a:xfrm>
+            <a:off x="1910639" y="4658868"/>
+            <a:ext cx="118872" cy="118872"/>
+          </a:xfrm>
+          <a:prstGeom prst="ellipse">
+            <a:avLst/>
+          </a:prstGeom>
+          <a:solidFill>
+            <a:schemeClr val="accent1"/>
+          </a:solidFill>
+          <a:ln w="6350">
+            <a:solidFill>
+              <a:srgbClr val="FFFFFF"/>
+            </a:solidFill>
+            <a:prstDash val="solid"/>
+          </a:ln>
+        </p:spPr>
+      </p:sp>
+      <p:sp>
+        <p:nvSpPr>
+          <p:cNvPr id="36" name="dot syn 13"/>
+          <p:cNvSpPr/>
+          <p:nvPr/>
+        </p:nvSpPr>
+        <p:spPr>
+          <a:xfrm>
+            <a:off x="1910639" y="4421124"/>
+            <a:ext cx="118872" cy="118872"/>
+          </a:xfrm>
+          <a:prstGeom prst="ellipse">
+            <a:avLst/>
+          </a:prstGeom>
+          <a:solidFill>
+            <a:schemeClr val="accent1"/>
+          </a:solidFill>
+          <a:ln w="6350">
+            <a:solidFill>
+              <a:srgbClr val="FFFFFF"/>
+            </a:solidFill>
+            <a:prstDash val="solid"/>
+          </a:ln>
+        </p:spPr>
+      </p:sp>
+      <p:sp>
+        <p:nvSpPr>
+          <p:cNvPr id="37" name="dot syn 20"/>
+          <p:cNvSpPr/>
+          <p:nvPr/>
+        </p:nvSpPr>
+        <p:spPr>
+          <a:xfrm>
+            <a:off x="2470709" y="5134356"/>
+            <a:ext cx="118872" cy="118872"/>
+          </a:xfrm>
+          <a:prstGeom prst="ellipse">
+            <a:avLst/>
+          </a:prstGeom>
+          <a:solidFill>
+            <a:schemeClr val="accent1"/>
+          </a:solidFill>
+          <a:ln w="6350">
+            <a:solidFill>
+              <a:srgbClr val="FFFFFF"/>
+            </a:solidFill>
+            <a:prstDash val="solid"/>
+          </a:ln>
+        </p:spPr>
+      </p:sp>
+      <p:sp>
+        <p:nvSpPr>
+          <p:cNvPr id="38" name="dot syn 21"/>
+          <p:cNvSpPr/>
+          <p:nvPr/>
+        </p:nvSpPr>
+        <p:spPr>
+          <a:xfrm>
+            <a:off x="2470709" y="4896612"/>
+            <a:ext cx="118872" cy="118872"/>
+          </a:xfrm>
+          <a:prstGeom prst="ellipse">
+            <a:avLst/>
+          </a:prstGeom>
+          <a:solidFill>
+            <a:schemeClr val="accent1"/>
+          </a:solidFill>
+          <a:ln w="6350">
+            <a:solidFill>
+              <a:srgbClr val="FFFFFF"/>
+            </a:solidFill>
+            <a:prstDash val="solid"/>
+          </a:ln>
+        </p:spPr>
+      </p:sp>
+      <p:sp>
+        <p:nvSpPr>
+          <p:cNvPr id="39" name="dot syn 22"/>
+          <p:cNvSpPr/>
+          <p:nvPr/>
+        </p:nvSpPr>
+        <p:spPr>
+          <a:xfrm>
+            <a:off x="2470709" y="4658868"/>
+            <a:ext cx="118872" cy="118872"/>
+          </a:xfrm>
+          <a:prstGeom prst="ellipse">
+            <a:avLst/>
+          </a:prstGeom>
+          <a:solidFill>
+            <a:schemeClr val="accent1"/>
+          </a:solidFill>
+          <a:ln w="6350">
+            <a:solidFill>
+              <a:srgbClr val="FFFFFF"/>
+            </a:solidFill>
+            <a:prstDash val="solid"/>
+          </a:ln>
+        </p:spPr>
+      </p:sp>
+      <p:sp>
+        <p:nvSpPr>
+          <p:cNvPr id="40" name="dot syn 23"/>
+          <p:cNvSpPr/>
+          <p:nvPr/>
+        </p:nvSpPr>
+        <p:spPr>
+          <a:xfrm>
+            <a:off x="2470709" y="4421124"/>
+            <a:ext cx="118872" cy="118872"/>
+          </a:xfrm>
+          <a:prstGeom prst="ellipse">
+            <a:avLst/>
+          </a:prstGeom>
+          <a:solidFill>
+            <a:schemeClr val="accent1"/>
+          </a:solidFill>
+          <a:ln w="6350">
+            <a:solidFill>
+              <a:srgbClr val="FFFFFF"/>
+            </a:solidFill>
+            <a:prstDash val="solid"/>
+          </a:ln>
+        </p:spPr>
+      </p:sp>
+      <p:sp>
+        <p:nvSpPr>
+          <p:cNvPr id="41" name="dot syn 30"/>
+          <p:cNvSpPr/>
+          <p:nvPr/>
+        </p:nvSpPr>
+        <p:spPr>
+          <a:xfrm>
+            <a:off x="3030779" y="5134356"/>
+            <a:ext cx="118872" cy="118872"/>
+          </a:xfrm>
+          <a:prstGeom prst="ellipse">
+            <a:avLst/>
+          </a:prstGeom>
+          <a:solidFill>
+            <a:schemeClr val="accent1"/>
+          </a:solidFill>
+          <a:ln w="6350">
+            <a:solidFill>
+              <a:srgbClr val="FFFFFF"/>
+            </a:solidFill>
+            <a:prstDash val="solid"/>
+          </a:ln>
+        </p:spPr>
+      </p:sp>
+      <p:sp>
+        <p:nvSpPr>
+          <p:cNvPr id="42" name="dot syn 31"/>
+          <p:cNvSpPr/>
+          <p:nvPr/>
+        </p:nvSpPr>
+        <p:spPr>
+          <a:xfrm>
+            <a:off x="3030779" y="4896612"/>
+            <a:ext cx="118872" cy="118872"/>
+          </a:xfrm>
+          <a:prstGeom prst="ellipse">
+            <a:avLst/>
+          </a:prstGeom>
+          <a:solidFill>
+            <a:schemeClr val="accent1"/>
+          </a:solidFill>
+          <a:ln w="6350">
+            <a:solidFill>
+              <a:srgbClr val="FFFFFF"/>
+            </a:solidFill>
+            <a:prstDash val="solid"/>
+          </a:ln>
+        </p:spPr>
+      </p:sp>
+      <p:sp>
+        <p:nvSpPr>
+          <p:cNvPr id="43" name="dot syn 32"/>
+          <p:cNvSpPr/>
+          <p:nvPr/>
+        </p:nvSpPr>
+        <p:spPr>
+          <a:xfrm>
+            <a:off x="3030779" y="4658868"/>
+            <a:ext cx="118872" cy="118872"/>
+          </a:xfrm>
+          <a:prstGeom prst="ellipse">
+            <a:avLst/>
+          </a:prstGeom>
+          <a:solidFill>
+            <a:schemeClr val="accent1"/>
+          </a:solidFill>
+          <a:ln w="6350">
+            <a:solidFill>
+              <a:srgbClr val="FFFFFF"/>
+            </a:solidFill>
+            <a:prstDash val="solid"/>
+          </a:ln>
+        </p:spPr>
+      </p:sp>
+      <p:sp>
+        <p:nvSpPr>
+          <p:cNvPr id="44" name="dot syn 33"/>
+          <p:cNvSpPr/>
+          <p:nvPr/>
+        </p:nvSpPr>
+        <p:spPr>
+          <a:xfrm>
+            <a:off x="3030779" y="4421124"/>
+            <a:ext cx="118872" cy="118872"/>
+          </a:xfrm>
+          <a:prstGeom prst="ellipse">
+            <a:avLst/>
+          </a:prstGeom>
+          <a:solidFill>
+            <a:schemeClr val="accent1"/>
+          </a:solidFill>
+          <a:ln w="6350">
+            <a:solidFill>
+              <a:srgbClr val="FFFFFF"/>
+            </a:solidFill>
+            <a:prstDash val="solid"/>
+          </a:ln>
+        </p:spPr>
+      </p:sp>
+      <p:sp>
+        <p:nvSpPr>
+          <p:cNvPr id="45" name="dot syn 40"/>
+          <p:cNvSpPr/>
+          <p:nvPr/>
+        </p:nvSpPr>
+        <p:spPr>
+          <a:xfrm>
+            <a:off x="3590849" y="5134356"/>
+            <a:ext cx="118872" cy="118872"/>
+          </a:xfrm>
+          <a:prstGeom prst="ellipse">
+            <a:avLst/>
+          </a:prstGeom>
+          <a:solidFill>
+            <a:schemeClr val="accent1"/>
+          </a:solidFill>
+          <a:ln w="6350">
+            <a:solidFill>
+              <a:srgbClr val="FFFFFF"/>
+            </a:solidFill>
+            <a:prstDash val="solid"/>
+          </a:ln>
+        </p:spPr>
+      </p:sp>
+      <p:sp>
+        <p:nvSpPr>
+          <p:cNvPr id="46" name="dot syn 41"/>
+          <p:cNvSpPr/>
+          <p:nvPr/>
+        </p:nvSpPr>
+        <p:spPr>
+          <a:xfrm>
+            <a:off x="3590849" y="4896612"/>
+            <a:ext cx="118872" cy="118872"/>
+          </a:xfrm>
+          <a:prstGeom prst="ellipse">
+            <a:avLst/>
+          </a:prstGeom>
+          <a:solidFill>
+            <a:schemeClr val="accent1"/>
+          </a:solidFill>
+          <a:ln w="6350">
+            <a:solidFill>
+              <a:srgbClr val="FFFFFF"/>
+            </a:solidFill>
+            <a:prstDash val="solid"/>
+          </a:ln>
+        </p:spPr>
+      </p:sp>
+      <p:sp>
+        <p:nvSpPr>
+          <p:cNvPr id="47" name="dot syn 42"/>
+          <p:cNvSpPr/>
+          <p:nvPr/>
+        </p:nvSpPr>
+        <p:spPr>
+          <a:xfrm>
+            <a:off x="3590849" y="4658868"/>
+            <a:ext cx="118872" cy="118872"/>
+          </a:xfrm>
+          <a:prstGeom prst="ellipse">
+            <a:avLst/>
+          </a:prstGeom>
+          <a:solidFill>
+            <a:schemeClr val="accent1"/>
+          </a:solidFill>
+          <a:ln w="6350">
+            <a:solidFill>
+              <a:srgbClr val="FFFFFF"/>
+            </a:solidFill>
+            <a:prstDash val="solid"/>
+          </a:ln>
+        </p:spPr>
+      </p:sp>
+      <p:sp>
+        <p:nvSpPr>
+          <p:cNvPr id="48" name="dot syn 43"/>
+          <p:cNvSpPr/>
+          <p:nvPr/>
+        </p:nvSpPr>
+        <p:spPr>
+          <a:xfrm>
+            <a:off x="3590849" y="4421124"/>
+            <a:ext cx="118872" cy="118872"/>
+          </a:xfrm>
+          <a:prstGeom prst="ellipse">
+            <a:avLst/>
+          </a:prstGeom>
+          <a:solidFill>
+            <a:schemeClr val="accent1"/>
+          </a:solidFill>
+          <a:ln w="6350">
+            <a:solidFill>
+              <a:srgbClr val="FFFFFF"/>
+            </a:solidFill>
+            <a:prstDash val="solid"/>
+          </a:ln>
+        </p:spPr>
+      </p:sp>
+      <p:sp>
+        <p:nvSpPr>
+          <p:cNvPr id="49" name="dot syn 50"/>
+          <p:cNvSpPr/>
+          <p:nvPr/>
+        </p:nvSpPr>
+        <p:spPr>
+          <a:xfrm>
+            <a:off x="4150919" y="5134356"/>
+            <a:ext cx="118872" cy="118872"/>
+          </a:xfrm>
+          <a:prstGeom prst="ellipse">
+            <a:avLst/>
+          </a:prstGeom>
+          <a:solidFill>
+            <a:schemeClr val="accent1"/>
+          </a:solidFill>
+          <a:ln w="6350">
+            <a:solidFill>
+              <a:srgbClr val="FFFFFF"/>
+            </a:solidFill>
+            <a:prstDash val="solid"/>
+          </a:ln>
+        </p:spPr>
+      </p:sp>
+      <p:sp>
+        <p:nvSpPr>
+          <p:cNvPr id="50" name="dot syn 51"/>
+          <p:cNvSpPr/>
+          <p:nvPr/>
+        </p:nvSpPr>
+        <p:spPr>
+          <a:xfrm>
+            <a:off x="4150919" y="4896612"/>
+            <a:ext cx="118872" cy="118872"/>
+          </a:xfrm>
+          <a:prstGeom prst="ellipse">
+            <a:avLst/>
+          </a:prstGeom>
+          <a:solidFill>
+            <a:schemeClr val="accent1"/>
+          </a:solidFill>
+          <a:ln w="6350">
+            <a:solidFill>
+              <a:srgbClr val="FFFFFF"/>
+            </a:solidFill>
+            <a:prstDash val="solid"/>
+          </a:ln>
+        </p:spPr>
+      </p:sp>
+      <p:sp>
+        <p:nvSpPr>
+          <p:cNvPr id="51" name="dot syn 52"/>
+          <p:cNvSpPr/>
+          <p:nvPr/>
+        </p:nvSpPr>
+        <p:spPr>
+          <a:xfrm>
+            <a:off x="4150919" y="4658868"/>
+            <a:ext cx="118872" cy="118872"/>
+          </a:xfrm>
+          <a:prstGeom prst="ellipse">
+            <a:avLst/>
+          </a:prstGeom>
+          <a:solidFill>
+            <a:schemeClr val="accent1"/>
+          </a:solidFill>
+          <a:ln w="6350">
+            <a:solidFill>
+              <a:srgbClr val="FFFFFF"/>
+            </a:solidFill>
+            <a:prstDash val="solid"/>
+          </a:ln>
+        </p:spPr>
+      </p:sp>
+      <p:sp>
+        <p:nvSpPr>
+          <p:cNvPr id="52" name="dot syn 53"/>
+          <p:cNvSpPr/>
+          <p:nvPr/>
+        </p:nvSpPr>
+        <p:spPr>
+          <a:xfrm>
+            <a:off x="4150919" y="4421124"/>
+            <a:ext cx="118872" cy="118872"/>
+          </a:xfrm>
+          <a:prstGeom prst="ellipse">
+            <a:avLst/>
+          </a:prstGeom>
+          <a:solidFill>
+            <a:schemeClr val="accent1"/>
+          </a:solidFill>
+          <a:ln w="6350">
+            <a:solidFill>
+              <a:srgbClr val="FFFFFF"/>
+            </a:solidFill>
+            <a:prstDash val="solid"/>
+          </a:ln>
+        </p:spPr>
+      </p:sp>
+      <p:sp>
+        <p:nvSpPr>
+          <p:cNvPr id="53" name="dot syn 60"/>
+          <p:cNvSpPr/>
+          <p:nvPr/>
+        </p:nvSpPr>
+        <p:spPr>
+          <a:xfrm>
+            <a:off x="4710989" y="5134356"/>
+            <a:ext cx="118872" cy="118872"/>
+          </a:xfrm>
+          <a:prstGeom prst="ellipse">
+            <a:avLst/>
+          </a:prstGeom>
+          <a:solidFill>
+            <a:schemeClr val="accent1"/>
+          </a:solidFill>
+          <a:ln w="6350">
+            <a:solidFill>
+              <a:srgbClr val="FFFFFF"/>
+            </a:solidFill>
+            <a:prstDash val="solid"/>
+          </a:ln>
+        </p:spPr>
+      </p:sp>
+      <p:sp>
+        <p:nvSpPr>
+          <p:cNvPr id="54" name="dot syn 61"/>
+          <p:cNvSpPr/>
+          <p:nvPr/>
+        </p:nvSpPr>
+        <p:spPr>
+          <a:xfrm>
+            <a:off x="4710989" y="4896612"/>
+            <a:ext cx="118872" cy="118872"/>
+          </a:xfrm>
+          <a:prstGeom prst="ellipse">
+            <a:avLst/>
+          </a:prstGeom>
+          <a:solidFill>
+            <a:schemeClr val="accent1"/>
+          </a:solidFill>
+          <a:ln w="6350">
+            <a:solidFill>
+              <a:srgbClr val="FFFFFF"/>
+            </a:solidFill>
+            <a:prstDash val="solid"/>
+          </a:ln>
+        </p:spPr>
+      </p:sp>
+      <p:sp>
+        <p:nvSpPr>
+          <p:cNvPr id="55" name="dot syn 62"/>
+          <p:cNvSpPr/>
+          <p:nvPr/>
+        </p:nvSpPr>
+        <p:spPr>
+          <a:xfrm>
+            <a:off x="4710989" y="4658868"/>
+            <a:ext cx="118872" cy="118872"/>
+          </a:xfrm>
+          <a:prstGeom prst="ellipse">
+            <a:avLst/>
+          </a:prstGeom>
+          <a:solidFill>
+            <a:schemeClr val="accent1"/>
+          </a:solidFill>
+          <a:ln w="6350">
+            <a:solidFill>
+              <a:srgbClr val="FFFFFF"/>
+            </a:solidFill>
+            <a:prstDash val="solid"/>
+          </a:ln>
+        </p:spPr>
+      </p:sp>
+      <p:sp>
+        <p:nvSpPr>
+          <p:cNvPr id="56" name="dot syn 63"/>
+          <p:cNvSpPr/>
+          <p:nvPr/>
+        </p:nvSpPr>
+        <p:spPr>
+          <a:xfrm>
+            <a:off x="4710989" y="4421124"/>
+            <a:ext cx="118872" cy="118872"/>
+          </a:xfrm>
+          <a:prstGeom prst="ellipse">
+            <a:avLst/>
+          </a:prstGeom>
+          <a:solidFill>
+            <a:schemeClr val="accent1"/>
+          </a:solidFill>
+          <a:ln w="6350">
+            <a:solidFill>
+              <a:srgbClr val="FFFFFF"/>
+            </a:solidFill>
+            <a:prstDash val="solid"/>
+          </a:ln>
+        </p:spPr>
+      </p:sp>
+      <p:sp>
+        <p:nvSpPr>
+          <p:cNvPr id="57" name="dot syn 70"/>
+          <p:cNvSpPr/>
+          <p:nvPr/>
+        </p:nvSpPr>
+        <p:spPr>
+          <a:xfrm>
+            <a:off x="5271059" y="5134356"/>
+            <a:ext cx="118872" cy="118872"/>
+          </a:xfrm>
+          <a:prstGeom prst="ellipse">
+            <a:avLst/>
+          </a:prstGeom>
+          <a:solidFill>
+            <a:schemeClr val="accent1"/>
+          </a:solidFill>
+          <a:ln w="6350">
+            <a:solidFill>
+              <a:srgbClr val="FFFFFF"/>
+            </a:solidFill>
+            <a:prstDash val="solid"/>
+          </a:ln>
+        </p:spPr>
+      </p:sp>
+      <p:sp>
+        <p:nvSpPr>
+          <p:cNvPr id="58" name="dot syn 71"/>
+          <p:cNvSpPr/>
+          <p:nvPr/>
+        </p:nvSpPr>
+        <p:spPr>
+          <a:xfrm>
+            <a:off x="5271059" y="4896612"/>
+            <a:ext cx="118872" cy="118872"/>
+          </a:xfrm>
+          <a:prstGeom prst="ellipse">
+            <a:avLst/>
+          </a:prstGeom>
+          <a:solidFill>
+            <a:schemeClr val="accent1"/>
+          </a:solidFill>
+          <a:ln w="6350">
+            <a:solidFill>
+              <a:srgbClr val="FFFFFF"/>
+            </a:solidFill>
+            <a:prstDash val="solid"/>
+          </a:ln>
+        </p:spPr>
+      </p:sp>
+      <p:sp>
+        <p:nvSpPr>
+          <p:cNvPr id="59" name="dot syn 72"/>
+          <p:cNvSpPr/>
+          <p:nvPr/>
+        </p:nvSpPr>
+        <p:spPr>
+          <a:xfrm>
+            <a:off x="5271059" y="4658868"/>
+            <a:ext cx="118872" cy="118872"/>
+          </a:xfrm>
+          <a:prstGeom prst="ellipse">
+            <a:avLst/>
+          </a:prstGeom>
+          <a:solidFill>
+            <a:schemeClr val="accent1"/>
+          </a:solidFill>
+          <a:ln w="6350">
+            <a:solidFill>
+              <a:srgbClr val="FFFFFF"/>
+            </a:solidFill>
+            <a:prstDash val="solid"/>
+          </a:ln>
+        </p:spPr>
+      </p:sp>
+      <p:sp>
+        <p:nvSpPr>
+          <p:cNvPr id="60" name="dot syn 73"/>
+          <p:cNvSpPr/>
+          <p:nvPr/>
+        </p:nvSpPr>
+        <p:spPr>
+          <a:xfrm>
+            <a:off x="5271059" y="4421124"/>
+            <a:ext cx="118872" cy="118872"/>
+          </a:xfrm>
+          <a:prstGeom prst="ellipse">
+            <a:avLst/>
+          </a:prstGeom>
+          <a:solidFill>
+            <a:schemeClr val="accent1"/>
+          </a:solidFill>
+          <a:ln w="6350">
+            <a:solidFill>
+              <a:srgbClr val="FFFFFF"/>
+            </a:solidFill>
+            <a:prstDash val="solid"/>
+          </a:ln>
+        </p:spPr>
+      </p:sp>
+      <p:sp>
+        <p:nvSpPr>
+          <p:cNvPr id="61" name="glance heading"/>
           <p:cNvSpPr txBox="1"/>
           <p:nvPr/>
         </p:nvSpPr>
@@ -23270,7 +24428,7 @@
       </p:sp>
       <p:sp>
         <p:nvSpPr>
-          <p:cNvPr id="17" name="tile contexts in four splits on disjoint seeds"/>
+          <p:cNvPr id="62" name="tile contexts in four splits on disjoint seeds"/>
           <p:cNvSpPr/>
           <p:nvPr/>
         </p:nvSpPr>
@@ -23292,7 +24450,7 @@
       </p:sp>
       <p:sp>
         <p:nvSpPr>
-          <p:cNvPr id="18" name="value contexts in four splits on disjoint seeds"/>
+          <p:cNvPr id="63" name="value contexts in four splits on disjoint seeds"/>
           <p:cNvSpPr txBox="1"/>
           <p:nvPr/>
         </p:nvSpPr>
@@ -23328,7 +24486,7 @@
       </p:sp>
       <p:sp>
         <p:nvSpPr>
-          <p:cNvPr id="19" name="label contexts in four splits on disjoint seeds"/>
+          <p:cNvPr id="64" name="label contexts in four splits on disjoint seeds"/>
           <p:cNvSpPr txBox="1"/>
           <p:nvPr/>
         </p:nvSpPr>
@@ -23364,7 +24522,7 @@
       </p:sp>
       <p:sp>
         <p:nvSpPr>
-          <p:cNvPr id="20" name="tile elements: pipes, cable trays, ducts and conduits; six trades"/>
+          <p:cNvPr id="65" name="tile elements: pipes, cable trays, ducts and conduits; six trades"/>
           <p:cNvSpPr/>
           <p:nvPr/>
         </p:nvSpPr>
@@ -23386,7 +24544,7 @@
       </p:sp>
       <p:sp>
         <p:nvSpPr>
-          <p:cNvPr id="21" name="value elements: pipes, cable trays, ducts and conduits; six trades"/>
+          <p:cNvPr id="66" name="value elements: pipes, cable trays, ducts and conduits; six trades"/>
           <p:cNvSpPr txBox="1"/>
           <p:nvPr/>
         </p:nvSpPr>
@@ -23422,7 +24580,7 @@
       </p:sp>
       <p:sp>
         <p:nvSpPr>
-          <p:cNvPr id="22" name="label elements: pipes, cable trays, ducts and conduits; six trades"/>
+          <p:cNvPr id="67" name="label elements: pipes, cable trays, ducts and conduits; six trades"/>
           <p:cNvSpPr txBox="1"/>
           <p:nvPr/>
         </p:nvSpPr>
@@ -23458,7 +24616,7 @@
       </p:sp>
       <p:sp>
         <p:nvSpPr>
-          <p:cNvPr id="23" name="tile eight difficulty tiers by exact element count"/>
+          <p:cNvPr id="68" name="tile eight difficulty tiers by exact element count"/>
           <p:cNvSpPr/>
           <p:nvPr/>
         </p:nvSpPr>
@@ -23480,7 +24638,7 @@
       </p:sp>
       <p:sp>
         <p:nvSpPr>
-          <p:cNvPr id="24" name="value eight difficulty tiers by exact element count"/>
+          <p:cNvPr id="69" name="value eight difficulty tiers by exact element count"/>
           <p:cNvSpPr txBox="1"/>
           <p:nvPr/>
         </p:nvSpPr>
@@ -23516,7 +24674,7 @@
       </p:sp>
       <p:sp>
         <p:nvSpPr>
-          <p:cNvPr id="25" name="label eight difficulty tiers by exact element count"/>
+          <p:cNvPr id="70" name="label eight difficulty tiers by exact element count"/>
           <p:cNvSpPr txBox="1"/>
           <p:nvPr/>
         </p:nvSpPr>
@@ -23552,7 +24710,7 @@
       </p:sp>
       <p:sp>
         <p:nvSpPr>
-          <p:cNvPr id="26" name="tile the brief, not the answer: no support-assembly information"/>
+          <p:cNvPr id="71" name="tile the brief, not the answer: no support-assembly information"/>
           <p:cNvSpPr/>
           <p:nvPr/>
         </p:nvSpPr>
@@ -23574,7 +24732,7 @@
       </p:sp>
       <p:sp>
         <p:nvSpPr>
-          <p:cNvPr id="27" name="value the brief, not the answer: no support-assembly information"/>
+          <p:cNvPr id="72" name="value the brief, not the answer: no support-assembly information"/>
           <p:cNvSpPr txBox="1"/>
           <p:nvPr/>
         </p:nvSpPr>
@@ -23610,7 +24768,7 @@
       </p:sp>
       <p:sp>
         <p:nvSpPr>
-          <p:cNvPr id="28" name="label the brief, not the answer: no support-assembly information"/>
+          <p:cNvPr id="73" name="label the brief, not the answer: no support-assembly information"/>
           <p:cNvSpPr txBox="1"/>
           <p:nvPr/>
         </p:nvSpPr>
@@ -23646,7 +24804,7 @@
       </p:sp>
       <p:sp>
         <p:nvSpPr>
-          <p:cNvPr id="29" name="tile every constant with its source, or declared a design choice"/>
+          <p:cNvPr id="74" name="tile every constant with its source, or declared a design choice"/>
           <p:cNvSpPr/>
           <p:nvPr/>
         </p:nvSpPr>
@@ -23668,7 +24826,7 @@
       </p:sp>
       <p:sp>
         <p:nvSpPr>
-          <p:cNvPr id="30" name="value every constant with its source, or declared a design choice"/>
+          <p:cNvPr id="75" name="value every constant with its source, or declared a design choice"/>
           <p:cNvSpPr txBox="1"/>
           <p:nvPr/>
         </p:nvSpPr>
@@ -23704,7 +24862,7 @@
       </p:sp>
       <p:sp>
         <p:nvSpPr>
-          <p:cNvPr id="31" name="label every constant with its source, or declared a design choice"/>
+          <p:cNvPr id="76" name="label every constant with its source, or declared a design choice"/>
           <p:cNvSpPr txBox="1"/>
           <p:nvPr/>
         </p:nvSpPr>
@@ -23740,7 +24898,7 @@
       </p:sp>
       <p:sp>
         <p:nvSpPr>
-          <p:cNvPr id="32" name="tile data CC BY 4.0, code MIT; a seeded, deterministic generator"/>
+          <p:cNvPr id="77" name="tile data CC BY 4.0, code MIT; a seeded, deterministic generator"/>
           <p:cNvSpPr/>
           <p:nvPr/>
         </p:nvSpPr>
@@ -23762,7 +24920,7 @@
       </p:sp>
       <p:sp>
         <p:nvSpPr>
-          <p:cNvPr id="33" name="value data CC BY 4.0, code MIT; a seeded, deterministic generator"/>
+          <p:cNvPr id="78" name="value data CC BY 4.0, code MIT; a seeded, deterministic generator"/>
           <p:cNvSpPr txBox="1"/>
           <p:nvPr/>
         </p:nvSpPr>
@@ -23798,7 +24956,7 @@
       </p:sp>
       <p:sp>
         <p:nvSpPr>
-          <p:cNvPr id="34" name="label data CC BY 4.0, code MIT; a seeded, deterministic generator"/>
+          <p:cNvPr id="79" name="label data CC BY 4.0, code MIT; a seeded, deterministic generator"/>
           <p:cNvSpPr txBox="1"/>
           <p:nvPr/>
         </p:nvSpPr>

</xml_diff>

<commit_message>
Talk: slide 5 says the generator is unlimited, a new seed is a new set
Co-Authored-By: Claude Fable 5.1 <noreply@anthropic.com>
Claude-Session: https://claude.ai/code/session_01R1ft1rokeRJHR95rzLxNEC
</commit_message>
<xml_diff>
--- a/docs/CrossMEP_CIBW78_talk.pptx
+++ b/docs/CrossMEP_CIBW78_talk.pptx
@@ -128,12 +128,12 @@
   <p:extLst>
     <p:ext uri="{521415D9-36F7-43E2-AB2F-B90AF26B5E84}">
       <p14:sectionLst xmlns:p14="http://schemas.microsoft.com/office/powerpoint/2010/main">
-        <p14:section name="Opening" id="{69f9f7ff-88d0-815e-977e-921b4825ca9d}">
+        <p14:section name="Opening" id="{dfe1afe3-a823-4255-9608-39023fa2363f}">
           <p14:sldIdLst>
             <p14:sldId id="256"/>
           </p14:sldIdLst>
         </p14:section>
-        <p14:section name="Motivation" id="{f59603e7-eb3f-e8b0-ae36-1d4d9780f69b}">
+        <p14:section name="Motivation" id="{6e67dcb6-a399-d06d-1bd0-da367e61f274}">
           <p14:sldIdLst>
             <p14:sldId id="257"/>
             <p14:sldId id="258"/>
@@ -141,7 +141,7 @@
             <p14:sldId id="260"/>
           </p14:sldIdLst>
         </p14:section>
-        <p14:section name="The dataset" id="{8635cb3a-0985-fac6-02e0-9ef048966470}">
+        <p14:section name="The dataset" id="{6d75c548-553a-c7dd-bd8c-6056f11ca4b4}">
           <p14:sldIdLst>
             <p14:sldId id="261"/>
             <p14:sldId id="262"/>
@@ -150,14 +150,14 @@
             <p14:sldId id="265"/>
           </p14:sldIdLst>
         </p14:section>
-        <p14:section name="Experiments" id="{8126c942-6515-c622-7dd8-4dcdd1accb35}">
+        <p14:section name="Experiments" id="{6d43f88d-be2f-835f-3355-424698a4ddb9}">
           <p14:sldIdLst>
             <p14:sldId id="266"/>
             <p14:sldId id="267"/>
             <p14:sldId id="268"/>
           </p14:sldIdLst>
         </p14:section>
-        <p14:section name="Use" id="{9fb13e76-6dd3-4563-fbd1-2c6290d770dc}">
+        <p14:section name="Use" id="{fea792df-5679-e342-e44a-203daf60c439}">
           <p14:sldIdLst>
             <p14:sldId id="269"/>
             <p14:sldId id="270"/>
@@ -165,7 +165,7 @@
             <p14:sldId id="272"/>
           </p14:sldIdLst>
         </p14:section>
-        <p14:section name="Appendix" id="{ec553587-b12e-489b-0c3a-57873fd6345d}">
+        <p14:section name="Appendix" id="{f19ce314-4422-d3ab-a5cf-67ae5898172f}">
           <p14:sldIdLst>
             <p14:sldId id="273"/>
             <p14:sldId id="274"/>
@@ -2115,7 +2115,7 @@
           <a:p>
             <a:r>
               <a:rPr lang="en-US" dirty="0"/>
-              <a:t>Here's one benchmark context per tier. C1 is a single element, the most common support in any building. By C8 you have eight services on three rows. Within a tier everything else varies: kinds, trades, surfaces, stacking. So the element count is the one controlled axis of difficulty. And notice the walls: the section rotates, and electrical sits above water. (5:05)</a:t>
+              <a:t>Here's one benchmark context per tier. C1 is a single element, the most common support in any building. By C8 you have eight services on three rows. Within a tier everything else varies: kinds, trades, surfaces, stacking. So the element count is the one controlled axis of difficulty. And notice the walls: the section rotates, and electrical sits above water. (5:10)</a:t>
             </a:r>
             <a:endParaRPr lang="en-US" dirty="0"/>
           </a:p>
@@ -2203,7 +2203,7 @@
           <a:p>
             <a:r>
               <a:rPr lang="en-US" dirty="0"/>
-              <a:t>Now three analyses. The first is a design check, not a discovery: does difficulty grow with the tier? The count is fixed by construction, and load and congestion follow from the rules, so this shows the dataset behaves as designed. The load at the support rises with the tier, from about 0.3 to 2.0 kilonewtons. The closest gap narrows at every step, from 130 to about 51 millimeters. So: report methods tier by tier. (5:30)</a:t>
+              <a:t>Now three analyses. The first is a design check, not a discovery: does difficulty grow with the tier? The count is fixed by construction, and load and congestion follow from the rules, so this shows the dataset behaves as designed. The load at the support rises with the tier, from about 0.3 to 2.0 kilonewtons. The closest gap narrows at every step, from 130 to about 51 millimeters. So: report methods tier by tier. (5:35)</a:t>
             </a:r>
             <a:endParaRPr lang="en-US" dirty="0"/>
           </a:p>
@@ -2291,7 +2291,7 @@
           <a:p>
             <a:r>
               <a:rPr lang="en-US" dirty="0"/>
-              <a:t>The second analysis is the one the generator could fail. Is the spacing realistic in a building it has never seen? The gap distribution was fitted on a residential duplex. We kept a second open building aside, a medical-dental clinic, cut it into sections every 250 millimeters, the way a context is defined, and measured the gaps between pipes running side by side. On the right, the distances. Generator to clinic: 32 millimeters. That is above the 8 a perfect generator would show, so not a perfect match, but about as close as the duplex's own two models are to each other. A fixed 25-millimeter gap would be about 190 off. (6:00)</a:t>
+              <a:t>The second analysis is the one the generator could fail. Is the spacing realistic in a building it has never seen? The gap distribution was fitted on a residential duplex. We kept a second open building aside, a medical-dental clinic, cut it into sections every 250 millimeters, the way a context is defined, and measured the gaps between pipes running side by side. On the right, the distances. Generator to clinic: 32 millimeters. That is above the 8 a perfect generator would show, so not a perfect match, but about as close as the duplex's own two models are to each other. A fixed 25-millimeter gap would be about 190 off. (6:05)</a:t>
             </a:r>
             <a:endParaRPr lang="en-US" dirty="0"/>
           </a:p>
@@ -2379,7 +2379,7 @@
           <a:p>
             <a:r>
               <a:rPr lang="en-US" dirty="0"/>
-              <a:t>The third analysis is a use of the dataset, not a test of it: what must a catalog of clamps cover? Our paper's two-size catalog attaches 14.5 percent of the pipes, with an interval of 13 to 16, all one size, DN40. Load is never the limit, and trays, ducts and conduits aren't covered at all. On the right is what the dataset asks of any catalog: two well-placed sizes could attach 38 percent, six sizes 76, fifteen sizes every pipe. So 'what should the catalog contain' becomes a measurement. (6:45)</a:t>
+              <a:t>The third analysis is a use of the dataset, not a test of it: what must a catalog of clamps cover? Our paper's two-size catalog attaches 14.5 percent of the pipes, with an interval of 13 to 16, all one size, DN40. Load is never the limit, and trays, ducts and conduits aren't covered at all. On the right is what the dataset asks of any catalog: two well-placed sizes could attach 38 percent, six sizes 76, fifteen sizes every pipe. So 'what should the catalog contain' becomes a measurement. (6:50)</a:t>
             </a:r>
             <a:endParaRPr lang="en-US" dirty="0"/>
           </a:p>
@@ -2467,7 +2467,7 @@
           <a:p>
             <a:r>
               <a:rPr lang="en-US" dirty="0"/>
-              <a:t>Let me show it. This is the Generator Studio. I choose what crosses the hanger, a tier or an exact mix, and a seed. Out comes the section a support designer receives, drawn the way an engineer would issue it: every service at true size, its level below the slab, its load, the closest clear gap, and the same run in 3D. Every section is a stored output of the released generator, with the Python call that reproduces it. Scan the code to try it yourself. [Live: switch to the studio, click C3, then Generate another twice, then Exact mix with a duct. If the demo fails, stay on this slide; slide 18 shows two more sections. Before the talk: open the studio once with internet, set its link sharing to public, scan the QR from a phone not logged in.] (7:20)</a:t>
+              <a:t>Let me show it. This is the Generator Studio. I choose what crosses the hanger, a tier or an exact mix, and a seed. Out comes the section a support designer receives, drawn the way an engineer would issue it: every service at true size, its level below the slab, its load, the closest clear gap, and the same run in 3D. Every section is a stored output of the released generator, with the Python call that reproduces it. Scan the code to try it yourself. [Live: switch to the studio, click C3, then Generate another twice, then Exact mix with a duct. If the demo fails, stay on this slide; slide 18 shows two more sections. Before the talk: open the studio once with internet, set its link sharing to public, scan the QR from a phone not logged in.] (7:25)</a:t>
             </a:r>
             <a:endParaRPr lang="en-US" dirty="0"/>
           </a:p>
@@ -2555,7 +2555,7 @@
           <a:p>
             <a:r>
               <a:rPr lang="en-US" dirty="0"/>
-              <a:t>Using it takes a few lines: load a split, filter by composition, or generate your own mix. Because there are no labels, the same files serve reinforcement learning, constraint programming, and benchmarking people. We ship the scoring too. Train on the generator, from C1 up to C8. Evaluate on the benchmark, the same 125 contexts per tier for every method. Report per tier, with 95 percent intervals and paired tests. (8:35)</a:t>
+              <a:t>Using it takes a few lines: load a split, filter by composition, or generate your own mix. Because there are no labels, the same files serve reinforcement learning, constraint programming, and benchmarking people. We ship the scoring too. Train on the generator, from C1 up to C8. Evaluate on the benchmark, the same 125 contexts per tier for every method. Report per tier, with 95 percent intervals and paired tests. (8:40)</a:t>
             </a:r>
             <a:endParaRPr lang="en-US" dirty="0"/>
           </a:p>
@@ -2643,7 +2643,7 @@
           <a:p>
             <a:r>
               <a:rPr lang="en-US" dirty="0"/>
-              <a:t>A word on scope. CrossMEP is one section at one support. Pipe spacing was checked on two open buildings; the rest rests on practice and standards, and the trade mix is a design choice. It's not for structural design of real installations. Next: a public checker, with best-known costs, so we can compare methods on the answer; the catalog as an input; and a real test set from commercial projects, with supports designed by engineers. That's where I'd value your eye. (9:00)</a:t>
+              <a:t>A word on scope. CrossMEP is one section at one support. Pipe spacing was checked on two open buildings; the rest rests on practice and standards, and the trade mix is a design choice. It's not for structural design of real installations. Next: a public checker, with best-known costs, so we can compare methods on the answer; the catalog as an input; and a real test set from commercial projects, with supports designed by engineers. That's where I'd value your eye. (9:05)</a:t>
             </a:r>
             <a:endParaRPr lang="en-US" dirty="0"/>
           </a:p>
@@ -2731,7 +2731,7 @@
           <a:p>
             <a:r>
               <a:rPr lang="en-US" dirty="0"/>
-              <a:t>To sum up: CrossMEP is the brief, not the answer. Seven thousand support-design problems, every constant sourced or declared a design choice, pipe spacing checked on two open buildings, and all of it open. If you coordinate services or design supports, try the studio and tell me what looks wrong. Thank you. (9:35)</a:t>
+              <a:t>To sum up: CrossMEP is the brief, not the answer. Seven thousand support-design problems, every constant sourced or declared a design choice, pipe spacing checked on two open buildings, and all of it open. If you coordinate services or design supports, try the studio and tell me what looks wrong. Thank you. (9:40)</a:t>
             </a:r>
             <a:endParaRPr lang="en-US" dirty="0"/>
           </a:p>
@@ -3523,7 +3523,7 @@
           <a:p>
             <a:r>
               <a:rPr lang="en-US" dirty="0"/>
-              <a:t>Here is the idea behind CrossMEP. The real designs we had were few, and they sat in one corner of the design space: one kind of project, one trade mix. A method tuned to them measures fit to that project, and project models are proprietary anyway. So we generate. CrossMEP covers the space by construction: uniform over the tiers, or shaped to whatever mix you ask for. Seven thousand contexts in eight tiers, deliberately unlabeled, every constant sourced or declared, and all of it open. (2:20)</a:t>
+              <a:t>Here is the idea behind CrossMEP. The real designs we had were few, and they sat in one corner of the design space: one kind of project, one trade mix. A method tuned to them measures fit to that project. So we generate. CrossMEP covers the space by construction, and without limit: a new seed is a new set of problems, uniform over the tiers, or shaped to whatever mix you ask for. The seven thousand contexts in eight tiers are the release, not the ceiling: deliberately unlabeled, every constant sourced or declared, and all of it open. (2:20)</a:t>
             </a:r>
             <a:endParaRPr lang="en-US" dirty="0"/>
           </a:p>
@@ -3611,7 +3611,7 @@
           <a:p>
             <a:r>
               <a:rPr lang="en-US" dirty="0"/>
-              <a:t>Here's one context: a two-dimensional section at one support location. Each element has its kind, service and trade, its size, its insulation, and its load, which is weight per metre times the span it was sized at, plus its position. Add the surface, a slab or a wall, and that's all. What you won't find is the support: no channel, no rods, no anchors, and no correct answer, because a feasible support depends on the catalog you build from. The context is the brief. The assembly is the answer. (2:55)</a:t>
+              <a:t>Here's one context: a two-dimensional section at one support location. Each element has its kind, service and trade, its size, its insulation, and its load, which is weight per metre times the span it was sized at, plus its position. Add the surface, a slab or a wall, and that's all. What you won't find is the support: no channel, no rods, no anchors, and no correct answer, because a feasible support depends on the catalog you build from. The context is the brief. The assembly is the answer. (3:00)</a:t>
             </a:r>
             <a:endParaRPr lang="en-US" dirty="0"/>
           </a:p>
@@ -3699,7 +3699,7 @@
           <a:p>
             <a:r>
               <a:rPr lang="en-US" dirty="0"/>
-              <a:t>How do we make a context? Not by free randomness, but by rules an engineer would recognize. The tier fixes how many elements there are. We pick the surface and fill it the way trades really run services: hot and cold together, flow and return together, conduits in groups, bulky services nearest the slab. Gaps between neighbors are drawn from gaps measured on a built project, never below twenty-five millimeters. On walls, electrical stays above water. Every context is checked, and it's seeded: the same seed gives the same file, byte for byte. (3:35)</a:t>
+              <a:t>How do we make a context? Not by free randomness, but by rules an engineer would recognize. The tier fixes how many elements there are. We pick the surface and fill it the way trades really run services: hot and cold together, flow and return together, conduits in groups, bulky services nearest the slab. Gaps between neighbors are drawn from gaps measured on a built project, never below twenty-five millimeters. On walls, electrical stays above water. Every context is checked, and it's seeded: the same seed gives the same file, byte for byte. (3:40)</a:t>
             </a:r>
             <a:endParaRPr lang="en-US" dirty="0"/>
           </a:p>
@@ -3787,7 +3787,7 @@
           <a:p>
             <a:r>
               <a:rPr lang="en-US" dirty="0"/>
-              <a:t>Where do the numbers come from? Three places. Sizes, weights and spans come from standards: European steel pipe and duct standards, IEC for conduits and trays, ASME for spans, the German GEG for insulation. How close neighbors sit comes from measured open buildings. And a few things are simply our choices, like the trade mix, and we label them that way. Loads are computed in code from all of this. (4:10)</a:t>
+              <a:t>Where do the numbers come from? Three places. Sizes, weights and spans come from standards: European steel pipe and duct standards, IEC for conduits and trays, ASME for spans, the German GEG for insulation. How close neighbors sit comes from measured open buildings. And a few things are simply our choices, like the trade mix, and we label them that way. Loads are computed in code from all of this. (4:20)</a:t>
             </a:r>
             <a:endParaRPr lang="en-US" dirty="0"/>
           </a:p>
@@ -3875,7 +3875,7 @@
           <a:p>
             <a:r>
               <a:rPr lang="en-US" dirty="0"/>
-              <a:t>The release has four splits on disjoint seeds, so a method is never tested on what it trained on: five thousand contexts for training, five hundred each for validation and test, and a benchmark of one thousand, a hundred and twenty-five per tier. Everything is plain JSON with a schema and a datasheet. (4:40)</a:t>
+              <a:t>The release has four splits on disjoint seeds, so a method is never tested on what it trained on: five thousand contexts for training, five hundred each for validation and test, and a benchmark of one thousand, a hundred and twenty-five per tier. Everything is plain JSON with a schema and a datasheet. (4:45)</a:t>
             </a:r>
             <a:endParaRPr lang="en-US" dirty="0"/>
           </a:p>
@@ -23464,7 +23464,7 @@
                   <a:srgbClr val="52514E"/>
                 </a:solidFill>
               </a:rPr>
-              <a:t>the space filled by construction: uniform over the tiers, or any mix you ask for (generate_custom)</a:t>
+              <a:t>the space filled by construction, without limit: a new seed is a new set; uniform over the tiers, or any mix you ask for (generate_custom)</a:t>
             </a:r>
             <a:endParaRPr lang="en-US" sz="1400" dirty="0"/>
           </a:p>

</xml_diff>

<commit_message>
Talk: trim to stay under ten minutes
</commit_message>
<xml_diff>
--- a/docs/CrossMEP_CIBW78_talk.pptx
+++ b/docs/CrossMEP_CIBW78_talk.pptx
@@ -128,12 +128,12 @@
   <p:extLst>
     <p:ext uri="{521415D9-36F7-43E2-AB2F-B90AF26B5E84}">
       <p14:sectionLst xmlns:p14="http://schemas.microsoft.com/office/powerpoint/2010/main">
-        <p14:section name="Opening" id="{dfe1afe3-a823-4255-9608-39023fa2363f}">
+        <p14:section name="Opening" id="{cec6755c-285a-34b9-e910-83f32fa24f22}">
           <p14:sldIdLst>
             <p14:sldId id="256"/>
           </p14:sldIdLst>
         </p14:section>
-        <p14:section name="Motivation" id="{6e67dcb6-a399-d06d-1bd0-da367e61f274}">
+        <p14:section name="Motivation" id="{7cf64c2c-af39-2147-94c2-9ccf7f88dffa}">
           <p14:sldIdLst>
             <p14:sldId id="257"/>
             <p14:sldId id="258"/>
@@ -141,7 +141,7 @@
             <p14:sldId id="260"/>
           </p14:sldIdLst>
         </p14:section>
-        <p14:section name="The dataset" id="{6d75c548-553a-c7dd-bd8c-6056f11ca4b4}">
+        <p14:section name="The dataset" id="{970a061f-d158-c9b1-bd39-49c4c713c698}">
           <p14:sldIdLst>
             <p14:sldId id="261"/>
             <p14:sldId id="262"/>
@@ -150,14 +150,14 @@
             <p14:sldId id="265"/>
           </p14:sldIdLst>
         </p14:section>
-        <p14:section name="Experiments" id="{6d43f88d-be2f-835f-3355-424698a4ddb9}">
+        <p14:section name="Experiments" id="{30038198-7fda-66a7-9b81-4575a0d0781b}">
           <p14:sldIdLst>
             <p14:sldId id="266"/>
             <p14:sldId id="267"/>
             <p14:sldId id="268"/>
           </p14:sldIdLst>
         </p14:section>
-        <p14:section name="Use" id="{fea792df-5679-e342-e44a-203daf60c439}">
+        <p14:section name="Use" id="{41bea3ca-0fd5-9612-f129-51215dedda8f}">
           <p14:sldIdLst>
             <p14:sldId id="269"/>
             <p14:sldId id="270"/>
@@ -165,7 +165,7 @@
             <p14:sldId id="272"/>
           </p14:sldIdLst>
         </p14:section>
-        <p14:section name="Appendix" id="{f19ce314-4422-d3ab-a5cf-67ae5898172f}">
+        <p14:section name="Appendix" id="{ef06d59e-7076-9b44-c31e-cf7dcb0a1730}">
           <p14:sldIdLst>
             <p14:sldId id="273"/>
             <p14:sldId id="274"/>
@@ -2115,7 +2115,7 @@
           <a:p>
             <a:r>
               <a:rPr lang="en-US" dirty="0"/>
-              <a:t>Here's one benchmark context per tier. C1 is a single element, the most common support in any building. By C8 you have eight services on three rows. Within a tier everything else varies: kinds, trades, surfaces, stacking. So the element count is the one controlled axis of difficulty. And notice the walls: the section rotates, and electrical sits above water. (5:10)</a:t>
+              <a:t>Here's one benchmark context per tier. C1 is a single element, the most common support in any building. By C8 you have eight services on three rows. Within a tier everything else varies: kinds, trades, surfaces, stacking. So the element count is the one controlled axis of difficulty. And notice the walls: the section rotates, and electrical sits above water. (5:00)</a:t>
             </a:r>
             <a:endParaRPr lang="en-US" dirty="0"/>
           </a:p>
@@ -2203,7 +2203,7 @@
           <a:p>
             <a:r>
               <a:rPr lang="en-US" dirty="0"/>
-              <a:t>Now three analyses. The first is a design check, not a discovery: does difficulty grow with the tier? The count is fixed by construction, and load and congestion follow from the rules, so this shows the dataset behaves as designed. The load at the support rises with the tier, from about 0.3 to 2.0 kilonewtons. The closest gap narrows at every step, from 130 to about 51 millimeters. So: report methods tier by tier. (5:35)</a:t>
+              <a:t>Now three analyses. The first is a design check, not a discovery: does difficulty grow with the tier? The count is fixed by construction, and load and congestion follow from the rules, so this shows the dataset behaves as designed. The load at the support rises with the tier, from about 0.3 to 2.0 kilonewtons. The closest gap narrows at every step, from 130 to about 51 millimeters. So: report methods tier by tier. (5:25)</a:t>
             </a:r>
             <a:endParaRPr lang="en-US" dirty="0"/>
           </a:p>
@@ -2291,7 +2291,7 @@
           <a:p>
             <a:r>
               <a:rPr lang="en-US" dirty="0"/>
-              <a:t>The second analysis is the one the generator could fail. Is the spacing realistic in a building it has never seen? The gap distribution was fitted on a residential duplex. We kept a second open building aside, a medical-dental clinic, cut it into sections every 250 millimeters, the way a context is defined, and measured the gaps between pipes running side by side. On the right, the distances. Generator to clinic: 32 millimeters. That is above the 8 a perfect generator would show, so not a perfect match, but about as close as the duplex's own two models are to each other. A fixed 25-millimeter gap would be about 190 off. (6:05)</a:t>
+              <a:t>The second analysis is the one the generator could fail. Is the spacing realistic in a building it has never seen? The gap distribution was fitted on a residential duplex. We kept a second open building aside, a medical-dental clinic, cut it into sections every 250 millimeters, the way a context is defined, and measured the gaps between pipes running side by side. On the right, the distances. Generator to clinic: 32 millimeters. That is above the 8 a perfect generator would show, so not a perfect match, but about as close as the duplex's own two models are to each other. A fixed 25-millimeter gap would be about 190 off. (5:55)</a:t>
             </a:r>
             <a:endParaRPr lang="en-US" dirty="0"/>
           </a:p>
@@ -2379,7 +2379,7 @@
           <a:p>
             <a:r>
               <a:rPr lang="en-US" dirty="0"/>
-              <a:t>The third analysis is a use of the dataset, not a test of it: what must a catalog of clamps cover? Our paper's two-size catalog attaches 14.5 percent of the pipes, with an interval of 13 to 16, all one size, DN40. Load is never the limit, and trays, ducts and conduits aren't covered at all. On the right is what the dataset asks of any catalog: two well-placed sizes could attach 38 percent, six sizes 76, fifteen sizes every pipe. So 'what should the catalog contain' becomes a measurement. (6:50)</a:t>
+              <a:t>The third analysis is a use of the dataset, not a test of it: what must a catalog of clamps cover? Our paper's two-size catalog attaches 14.5 percent of the pipes, with an interval of 13 to 16, all one size, DN40. Load is never the limit, and trays, ducts and conduits aren't covered at all. On the right is what the dataset asks of any catalog: two well-placed sizes could attach 38 percent, six sizes 76, fifteen sizes every pipe. So 'what should the catalog contain' becomes a measurement. (6:45)</a:t>
             </a:r>
             <a:endParaRPr lang="en-US" dirty="0"/>
           </a:p>
@@ -2467,7 +2467,7 @@
           <a:p>
             <a:r>
               <a:rPr lang="en-US" dirty="0"/>
-              <a:t>Let me show it. This is the Generator Studio. I choose what crosses the hanger, a tier or an exact mix, and a seed. Out comes the section a support designer receives, drawn the way an engineer would issue it: every service at true size, its level below the slab, its load, the closest clear gap, and the same run in 3D. Every section is a stored output of the released generator, with the Python call that reproduces it. Scan the code to try it yourself. [Live: switch to the studio, click C3, then Generate another twice, then Exact mix with a duct. If the demo fails, stay on this slide; slide 18 shows two more sections. Before the talk: open the studio once with internet, set its link sharing to public, scan the QR from a phone not logged in.] (7:25)</a:t>
+              <a:t>Let me show it. This is the Generator Studio. I choose what crosses the hanger, a tier or an exact mix, and a seed. Out comes the section a support designer receives, drawn the way an engineer would issue it: every service at true size, its level below the slab, its load, the closest clear gap, and the same run in 3D. Every section is a stored output of the released generator, with the Python call that reproduces it. Scan the code to try it yourself. [Live: switch to the studio, click C3, then Generate another twice, then Exact mix with a duct. If the demo fails, stay on this slide; slide 18 shows two more sections. Before the talk: open the studio once with internet, set its link sharing to public, scan the QR from a phone not logged in.] (7:20)</a:t>
             </a:r>
             <a:endParaRPr lang="en-US" dirty="0"/>
           </a:p>
@@ -2555,7 +2555,7 @@
           <a:p>
             <a:r>
               <a:rPr lang="en-US" dirty="0"/>
-              <a:t>Using it takes a few lines: load a split, filter by composition, or generate your own mix. Because there are no labels, the same files serve reinforcement learning, constraint programming, and benchmarking people. We ship the scoring too. Train on the generator, from C1 up to C8. Evaluate on the benchmark, the same 125 contexts per tier for every method. Report per tier, with 95 percent intervals and paired tests. (8:40)</a:t>
+              <a:t>Using it takes a few lines: load a split, filter by composition, or generate your own mix. Because there are no labels, the same files serve reinforcement learning, constraint programming, and benchmarking people. We ship the scoring too. Train on the generator, from C1 up to C8. Evaluate on the benchmark, the same 125 contexts per tier for every method. Report per tier, with 95 percent intervals and paired tests. (8:30)</a:t>
             </a:r>
             <a:endParaRPr lang="en-US" dirty="0"/>
           </a:p>
@@ -2643,7 +2643,7 @@
           <a:p>
             <a:r>
               <a:rPr lang="en-US" dirty="0"/>
-              <a:t>A word on scope. CrossMEP is one section at one support. Pipe spacing was checked on two open buildings; the rest rests on practice and standards, and the trade mix is a design choice. It's not for structural design of real installations. Next: a public checker, with best-known costs, so we can compare methods on the answer; the catalog as an input; and a real test set from commercial projects, with supports designed by engineers. That's where I'd value your eye. (9:05)</a:t>
+              <a:t>A word on scope. CrossMEP is one section at one support. Pipe spacing was checked on two open buildings; the rest rests on practice and standards, and the trade mix is a design choice. It's not for structural design of real installations. Next: a public checker, with best-known costs, so we can compare methods on the answer; the catalog as an input; and a real test set from commercial projects, with supports designed by engineers. That's where I'd value your eye. (9:00)</a:t>
             </a:r>
             <a:endParaRPr lang="en-US" dirty="0"/>
           </a:p>
@@ -2731,7 +2731,7 @@
           <a:p>
             <a:r>
               <a:rPr lang="en-US" dirty="0"/>
-              <a:t>To sum up: CrossMEP is the brief, not the answer. Seven thousand support-design problems, every constant sourced or declared a design choice, pipe spacing checked on two open buildings, and all of it open. If you coordinate services or design supports, try the studio and tell me what looks wrong. Thank you. (9:40)</a:t>
+              <a:t>To sum up: CrossMEP is the brief, not the answer. Seven thousand support-design problems, every constant sourced or declared a design choice, pipe spacing checked on two open buildings, and all of it open. If you coordinate services or design supports, try the studio and tell me what looks wrong. Thank you. (9:35)</a:t>
             </a:r>
             <a:endParaRPr lang="en-US" dirty="0"/>
           </a:p>
@@ -3523,7 +3523,7 @@
           <a:p>
             <a:r>
               <a:rPr lang="en-US" dirty="0"/>
-              <a:t>Here is the idea behind CrossMEP. The real designs we had were few, and they sat in one corner of the design space: one kind of project, one trade mix. A method tuned to them measures fit to that project. So we generate. CrossMEP covers the space by construction, and without limit: a new seed is a new set of problems, uniform over the tiers, or shaped to whatever mix you ask for. The seven thousand contexts in eight tiers are the release, not the ceiling: deliberately unlabeled, every constant sourced or declared, and all of it open. (2:20)</a:t>
+              <a:t>The real designs we had were few, and they sat in one corner of the design space: one kind of project, one trade mix. A method tuned to them measures fit to that project. So we generate. CrossMEP covers the space by construction, and without limit: a new seed is a new set of problems, uniform over the tiers, or shaped to whatever mix you ask for. The seven thousand contexts in eight tiers are the release, not the ceiling: deliberately unlabeled, every constant sourced or declared, and all of it open. (2:20)</a:t>
             </a:r>
             <a:endParaRPr lang="en-US" dirty="0"/>
           </a:p>
@@ -3699,7 +3699,7 @@
           <a:p>
             <a:r>
               <a:rPr lang="en-US" dirty="0"/>
-              <a:t>How do we make a context? Not by free randomness, but by rules an engineer would recognize. The tier fixes how many elements there are. We pick the surface and fill it the way trades really run services: hot and cold together, flow and return together, conduits in groups, bulky services nearest the slab. Gaps between neighbors are drawn from gaps measured on a built project, never below twenty-five millimeters. On walls, electrical stays above water. Every context is checked, and it's seeded: the same seed gives the same file, byte for byte. (3:40)</a:t>
+              <a:t>How do we make a context? Not by free randomness, but by rules an engineer would recognize. The tier fixes how many elements there are. We pick the surface and fill it the way trades really run services: hot and cold together, flow and return together, conduits in groups, bulky services nearest the slab. Gaps between neighbors are drawn from gaps measured on a built project, never below twenty-five millimeters. On walls, electrical stays above water. Every context is checked, and the same seed gives the same file, byte for byte. (3:35)</a:t>
             </a:r>
             <a:endParaRPr lang="en-US" dirty="0"/>
           </a:p>
@@ -3787,7 +3787,7 @@
           <a:p>
             <a:r>
               <a:rPr lang="en-US" dirty="0"/>
-              <a:t>Where do the numbers come from? Three places. Sizes, weights and spans come from standards: European steel pipe and duct standards, IEC for conduits and trays, ASME for spans, the German GEG for insulation. How close neighbors sit comes from measured open buildings. And a few things are simply our choices, like the trade mix, and we label them that way. Loads are computed in code from all of this. (4:20)</a:t>
+              <a:t>Where do the numbers come from? Three places. Sizes, weights and spans come from standards: European steel pipe and duct standards, IEC for conduits and trays, ASME for spans, the German GEG for insulation. How close neighbors sit comes from measured open buildings. And a few things are simply our choices, like the trade mix, and we label them that way. (4:15)</a:t>
             </a:r>
             <a:endParaRPr lang="en-US" dirty="0"/>
           </a:p>
@@ -3875,7 +3875,7 @@
           <a:p>
             <a:r>
               <a:rPr lang="en-US" dirty="0"/>
-              <a:t>The release has four splits on disjoint seeds, so a method is never tested on what it trained on: five thousand contexts for training, five hundred each for validation and test, and a benchmark of one thousand, a hundred and twenty-five per tier. Everything is plain JSON with a schema and a datasheet. (4:45)</a:t>
+              <a:t>The release has four splits on disjoint seeds, so a method is never tested on what it trained on: five thousand contexts for training, five hundred each for validation and test, and a benchmark of one thousand, a hundred and twenty-five per tier. Everything is plain JSON with a schema and a datasheet. (4:40)</a:t>
             </a:r>
             <a:endParaRPr lang="en-US" dirty="0"/>
           </a:p>

</xml_diff>

<commit_message>
Talk: slide 3 and 5 titles read as sentences
</commit_message>
<xml_diff>
--- a/docs/CrossMEP_CIBW78_talk.pptx
+++ b/docs/CrossMEP_CIBW78_talk.pptx
@@ -129,12 +129,12 @@
   <p:extLst>
     <p:ext uri="{521415D9-36F7-43E2-AB2F-B90AF26B5E84}">
       <p14:sectionLst xmlns:p14="http://schemas.microsoft.com/office/powerpoint/2010/main">
-        <p14:section name="Opening" id="{63ca1c73-4561-f43b-4b3e-9b0e0627a27d}">
+        <p14:section name="Opening" id="{9a97ff16-487b-8c73-c28a-55b990e7fe9f}">
           <p14:sldIdLst>
             <p14:sldId id="256"/>
           </p14:sldIdLst>
         </p14:section>
-        <p14:section name="Motivation" id="{2091e7c1-8bb5-8c96-e63f-8e0469fd5161}">
+        <p14:section name="Motivation" id="{e23ae679-a5cf-5866-75cb-6c834f3b4f19}">
           <p14:sldIdLst>
             <p14:sldId id="257"/>
             <p14:sldId id="258"/>
@@ -143,7 +143,7 @@
             <p14:sldId id="261"/>
           </p14:sldIdLst>
         </p14:section>
-        <p14:section name="The dataset" id="{ebbc53fc-170a-4888-0f45-7e266a3b3642}">
+        <p14:section name="The dataset" id="{f46f1102-e59b-b27e-533b-c1c7358d77af}">
           <p14:sldIdLst>
             <p14:sldId id="262"/>
             <p14:sldId id="263"/>
@@ -152,14 +152,14 @@
             <p14:sldId id="266"/>
           </p14:sldIdLst>
         </p14:section>
-        <p14:section name="Experiments" id="{e29de9b3-6966-ee5a-28ae-27b9a92f3964}">
+        <p14:section name="Experiments" id="{c53eeb9d-7a87-ce88-4263-cac04369345c}">
           <p14:sldIdLst>
             <p14:sldId id="267"/>
             <p14:sldId id="268"/>
             <p14:sldId id="269"/>
           </p14:sldIdLst>
         </p14:section>
-        <p14:section name="Use" id="{e633a837-f26c-6528-7199-da554c7faccb}">
+        <p14:section name="Use" id="{a7cf815c-2601-a6eb-fe75-77b8f8b837a9}">
           <p14:sldIdLst>
             <p14:sldId id="270"/>
             <p14:sldId id="271"/>
@@ -167,7 +167,7 @@
             <p14:sldId id="273"/>
           </p14:sldIdLst>
         </p14:section>
-        <p14:section name="Appendix" id="{9e3b50b4-3f4a-8972-0c8e-9fbaaee74257}">
+        <p14:section name="Appendix" id="{204b50c4-6711-3c38-807d-f903fb4e4ea5}">
           <p14:sldIdLst>
             <p14:sldId id="274"/>
             <p14:sldId id="275"/>
@@ -22777,7 +22777,7 @@
                   <a:schemeClr val="tx1"/>
                 </a:solidFill>
               </a:rPr>
-              <a:t>One cross-section in, verified support designs out</a:t>
+              <a:t>A designer turns one cross-section into verified support assemblies</a:t>
             </a:r>
             <a:endParaRPr lang="en-US" sz="2600" dirty="0"/>
           </a:p>
@@ -25341,7 +25341,7 @@
                   <a:schemeClr val="tx1"/>
                 </a:solidFill>
               </a:rPr>
-              <a:t>One section in, verified supports out: learnable, given problems to learn from</a:t>
+              <a:t>Whatever the method, it needs problems to learn from and a fixed set to compare on</a:t>
             </a:r>
             <a:endParaRPr lang="en-US" sz="2600" dirty="0"/>
           </a:p>

</xml_diff>

<commit_message>
Talk: visuals in the method diagram, a small section in the context box, a rod trapeze in the output, icons for rules, approach and verifier
Co-Authored-By: Claude Fable 5.1 <noreply@anthropic.com>
Claude-Session: https://claude.ai/code/session_01R1ft1rokeRJHR95rzLxNEC
</commit_message>
<xml_diff>
--- a/docs/CrossMEP_CIBW78_talk.pptx
+++ b/docs/CrossMEP_CIBW78_talk.pptx
@@ -129,12 +129,12 @@
   <p:extLst>
     <p:ext uri="{521415D9-36F7-43E2-AB2F-B90AF26B5E84}">
       <p14:sectionLst xmlns:p14="http://schemas.microsoft.com/office/powerpoint/2010/main">
-        <p14:section name="Opening" id="{9a97ff16-487b-8c73-c28a-55b990e7fe9f}">
+        <p14:section name="Opening" id="{0dfe272f-d792-88b8-9614-e4abfb1d46e9}">
           <p14:sldIdLst>
             <p14:sldId id="256"/>
           </p14:sldIdLst>
         </p14:section>
-        <p14:section name="Motivation" id="{e23ae679-a5cf-5866-75cb-6c834f3b4f19}">
+        <p14:section name="Motivation" id="{e7404278-e84d-6b24-d25e-6fc5205cc32b}">
           <p14:sldIdLst>
             <p14:sldId id="257"/>
             <p14:sldId id="258"/>
@@ -143,7 +143,7 @@
             <p14:sldId id="261"/>
           </p14:sldIdLst>
         </p14:section>
-        <p14:section name="The dataset" id="{f46f1102-e59b-b27e-533b-c1c7358d77af}">
+        <p14:section name="The dataset" id="{3f3781ff-ded6-a46f-0411-33bd0136dc1f}">
           <p14:sldIdLst>
             <p14:sldId id="262"/>
             <p14:sldId id="263"/>
@@ -152,14 +152,14 @@
             <p14:sldId id="266"/>
           </p14:sldIdLst>
         </p14:section>
-        <p14:section name="Experiments" id="{c53eeb9d-7a87-ce88-4263-cac04369345c}">
+        <p14:section name="Experiments" id="{5c444600-9395-9fce-1fff-73e332459cb8}">
           <p14:sldIdLst>
             <p14:sldId id="267"/>
             <p14:sldId id="268"/>
             <p14:sldId id="269"/>
           </p14:sldIdLst>
         </p14:section>
-        <p14:section name="Use" id="{a7cf815c-2601-a6eb-fe75-77b8f8b837a9}">
+        <p14:section name="Use" id="{01dbfdb5-0bcd-3491-d6ed-4ea0a5fbce10}">
           <p14:sldIdLst>
             <p14:sldId id="270"/>
             <p14:sldId id="271"/>
@@ -167,7 +167,7 @@
             <p14:sldId id="273"/>
           </p14:sldIdLst>
         </p14:section>
-        <p14:section name="Appendix" id="{204b50c4-6711-3c38-807d-f903fb4e4ea5}">
+        <p14:section name="Appendix" id="{4e017b5a-212e-1064-2654-016c3caac2f3}">
           <p14:sldIdLst>
             <p14:sldId id="274"/>
             <p14:sldId id="275"/>
@@ -25356,11 +25356,11 @@
         <p:spPr>
           <a:xfrm>
             <a:off x="548640" y="1554480"/>
-            <a:ext cx="1737360" cy="960120"/>
+            <a:ext cx="1737360" cy="1097280"/>
           </a:xfrm>
           <a:prstGeom prst="roundRect">
             <a:avLst>
-              <a:gd name="adj" fmla="val 5714"/>
+              <a:gd name="adj" fmla="val 5000"/>
             </a:avLst>
           </a:prstGeom>
           <a:solidFill>
@@ -25376,14 +25376,139 @@
       </p:sp>
       <p:sp>
         <p:nvSpPr>
-          <p:cNvPr id="4" name="text context"/>
+          <p:cNvPr id="4" name="mini slab"/>
+          <p:cNvSpPr/>
+          <p:nvPr/>
+        </p:nvSpPr>
+        <p:spPr>
+          <a:xfrm>
+            <a:off x="777240" y="1664208"/>
+            <a:ext cx="1280160" cy="91440"/>
+          </a:xfrm>
+          <a:prstGeom prst="rect">
+            <a:avLst/>
+          </a:prstGeom>
+          <a:solidFill>
+            <a:srgbClr val="EEF1F4"/>
+          </a:solidFill>
+          <a:ln w="6350">
+            <a:solidFill>
+              <a:srgbClr val="52514E"/>
+            </a:solidFill>
+            <a:prstDash val="solid"/>
+          </a:ln>
+        </p:spPr>
+      </p:sp>
+      <p:sp>
+        <p:nvSpPr>
+          <p:cNvPr id="5" name="mini duct"/>
+          <p:cNvSpPr/>
+          <p:nvPr/>
+        </p:nvSpPr>
+        <p:spPr>
+          <a:xfrm>
+            <a:off x="868680" y="1828800"/>
+            <a:ext cx="384048" cy="219456"/>
+          </a:xfrm>
+          <a:prstGeom prst="rect">
+            <a:avLst/>
+          </a:prstGeom>
+          <a:solidFill>
+            <a:srgbClr val="FFFFFF"/>
+          </a:solidFill>
+          <a:ln w="9525">
+            <a:solidFill>
+              <a:srgbClr val="52514E"/>
+            </a:solidFill>
+            <a:prstDash val="solid"/>
+          </a:ln>
+        </p:spPr>
+      </p:sp>
+      <p:sp>
+        <p:nvSpPr>
+          <p:cNvPr id="6" name="mini pipe a"/>
+          <p:cNvSpPr/>
+          <p:nvPr/>
+        </p:nvSpPr>
+        <p:spPr>
+          <a:xfrm>
+            <a:off x="1371600" y="1856232"/>
+            <a:ext cx="192024" cy="192024"/>
+          </a:xfrm>
+          <a:prstGeom prst="ellipse">
+            <a:avLst/>
+          </a:prstGeom>
+          <a:solidFill>
+            <a:srgbClr val="FFFFFF"/>
+          </a:solidFill>
+          <a:ln w="9525">
+            <a:solidFill>
+              <a:srgbClr val="52514E"/>
+            </a:solidFill>
+            <a:prstDash val="solid"/>
+          </a:ln>
+        </p:spPr>
+      </p:sp>
+      <p:sp>
+        <p:nvSpPr>
+          <p:cNvPr id="7" name="mini pipe b"/>
+          <p:cNvSpPr/>
+          <p:nvPr/>
+        </p:nvSpPr>
+        <p:spPr>
+          <a:xfrm>
+            <a:off x="1618488" y="1911096"/>
+            <a:ext cx="137160" cy="137160"/>
+          </a:xfrm>
+          <a:prstGeom prst="ellipse">
+            <a:avLst/>
+          </a:prstGeom>
+          <a:solidFill>
+            <a:srgbClr val="FFFFFF"/>
+          </a:solidFill>
+          <a:ln w="9525">
+            <a:solidFill>
+              <a:srgbClr val="52514E"/>
+            </a:solidFill>
+            <a:prstDash val="solid"/>
+          </a:ln>
+        </p:spPr>
+      </p:sp>
+      <p:sp>
+        <p:nvSpPr>
+          <p:cNvPr id="8" name="mini tray"/>
+          <p:cNvSpPr/>
+          <p:nvPr/>
+        </p:nvSpPr>
+        <p:spPr>
+          <a:xfrm>
+            <a:off x="1828800" y="1965960"/>
+            <a:ext cx="237744" cy="82296"/>
+          </a:xfrm>
+          <a:prstGeom prst="rect">
+            <a:avLst/>
+          </a:prstGeom>
+          <a:solidFill>
+            <a:srgbClr val="FFFFFF"/>
+          </a:solidFill>
+          <a:ln w="9525">
+            <a:solidFill>
+              <a:srgbClr val="52514E"/>
+            </a:solidFill>
+            <a:prstDash val="solid"/>
+          </a:ln>
+        </p:spPr>
+      </p:sp>
+      <p:sp>
+        <p:nvSpPr>
+          <p:cNvPr id="9" name="text context"/>
           <p:cNvSpPr txBox="1"/>
           <p:nvPr/>
         </p:nvSpPr>
         <p:spPr>
           <a:xfrm>
-            <a:off x="548640" y="1554480"/>
-            <a:ext cx="1737360" cy="960120"/>
+            <a:off x="548640" y="2084832"/>
+            <a:ext cx="1737360" cy="548640"/>
           </a:xfrm>
           <a:prstGeom prst="rect">
             <a:avLst/>
@@ -25426,7 +25551,7 @@
       </p:sp>
       <p:sp>
         <p:nvSpPr>
-          <p:cNvPr id="5" name="box catalog"/>
+          <p:cNvPr id="10" name="box catalog"/>
           <p:cNvSpPr/>
           <p:nvPr/>
         </p:nvSpPr>
@@ -25451,7 +25576,7 @@
       </p:sp>
       <p:sp>
         <p:nvSpPr>
-          <p:cNvPr id="6" name="text catalog"/>
+          <p:cNvPr id="11" name="text catalog"/>
           <p:cNvSpPr txBox="1"/>
           <p:nvPr/>
         </p:nvSpPr>
@@ -25501,7 +25626,7 @@
       </p:sp>
       <p:sp>
         <p:nvSpPr>
-          <p:cNvPr id="7" name="box rules"/>
+          <p:cNvPr id="12" name="box rules"/>
           <p:cNvSpPr/>
           <p:nvPr/>
         </p:nvSpPr>
@@ -25526,16 +25651,40 @@
           </a:ln>
         </p:spPr>
       </p:sp>
-      <p:sp>
-        <p:nvSpPr>
-          <p:cNvPr id="8" name="text rules"/>
+      <p:pic>
+        <p:nvPicPr>
+          <p:cNvPr id="13" name="icon rules" descr="preencoded.png">    </p:cNvPr>
+          <p:cNvPicPr>
+            <a:picLocks noChangeAspect="1"/>
+          </p:cNvPicPr>
+          <p:nvPr/>
+        </p:nvPicPr>
+        <p:blipFill>
+          <a:blip r:embed="rId1"/>
+          <a:stretch>
+            <a:fillRect/>
+          </a:stretch>
+        </p:blipFill>
+        <p:spPr>
+          <a:xfrm>
+            <a:off x="3429000" y="1828800"/>
+            <a:ext cx="457200" cy="457200"/>
+          </a:xfrm>
+          <a:prstGeom prst="rect">
+            <a:avLst/>
+          </a:prstGeom>
+        </p:spPr>
+      </p:pic>
+      <p:sp>
+        <p:nvSpPr>
+          <p:cNvPr id="14" name="text rules"/>
           <p:cNvSpPr txBox="1"/>
           <p:nvPr/>
         </p:nvSpPr>
         <p:spPr>
           <a:xfrm>
-            <a:off x="2743200" y="1554480"/>
-            <a:ext cx="1828800" cy="2240280"/>
+            <a:off x="2743200" y="2331720"/>
+            <a:ext cx="1828800" cy="1371600"/>
           </a:xfrm>
           <a:prstGeom prst="rect">
             <a:avLst/>
@@ -25578,13 +25727,13 @@
       </p:sp>
       <p:sp>
         <p:nvSpPr>
-          <p:cNvPr id="9" name="arrow context to rules"/>
+          <p:cNvPr id="15" name="arrow context to rules"/>
           <p:cNvSpPr/>
           <p:nvPr/>
         </p:nvSpPr>
         <p:spPr>
           <a:xfrm>
-            <a:off x="2286000" y="2029968"/>
+            <a:off x="2286000" y="2103120"/>
             <a:ext cx="457200" cy="0"/>
           </a:xfrm>
           <a:prstGeom prst="line">
@@ -25602,7 +25751,7 @@
       </p:sp>
       <p:sp>
         <p:nvSpPr>
-          <p:cNvPr id="10" name="arrow catalog to rules"/>
+          <p:cNvPr id="16" name="arrow catalog to rules"/>
           <p:cNvSpPr/>
           <p:nvPr/>
         </p:nvSpPr>
@@ -25626,7 +25775,7 @@
       </p:sp>
       <p:sp>
         <p:nvSpPr>
-          <p:cNvPr id="11" name="black box approach"/>
+          <p:cNvPr id="17" name="black box approach"/>
           <p:cNvSpPr/>
           <p:nvPr/>
         </p:nvSpPr>
@@ -25646,16 +25795,40 @@
           <a:ln/>
         </p:spPr>
       </p:sp>
-      <p:sp>
-        <p:nvSpPr>
-          <p:cNvPr id="12" name="text approach"/>
+      <p:pic>
+        <p:nvPicPr>
+          <p:cNvPr id="18" name="icon approach" descr="preencoded.png">    </p:cNvPr>
+          <p:cNvPicPr>
+            <a:picLocks noChangeAspect="1"/>
+          </p:cNvPicPr>
+          <p:nvPr/>
+        </p:nvPicPr>
+        <p:blipFill>
+          <a:blip r:embed="rId2"/>
+          <a:stretch>
+            <a:fillRect/>
+          </a:stretch>
+        </p:blipFill>
+        <p:spPr>
+          <a:xfrm>
+            <a:off x="5989320" y="1828800"/>
+            <a:ext cx="457200" cy="457200"/>
+          </a:xfrm>
+          <a:prstGeom prst="rect">
+            <a:avLst/>
+          </a:prstGeom>
+        </p:spPr>
+      </p:pic>
+      <p:sp>
+        <p:nvSpPr>
+          <p:cNvPr id="19" name="text approach"/>
           <p:cNvSpPr txBox="1"/>
           <p:nvPr/>
         </p:nvSpPr>
         <p:spPr>
           <a:xfrm>
-            <a:off x="5120640" y="1554480"/>
-            <a:ext cx="2194560" cy="2240280"/>
+            <a:off x="5120640" y="2331720"/>
+            <a:ext cx="2194560" cy="1371600"/>
           </a:xfrm>
           <a:prstGeom prst="rect">
             <a:avLst/>
@@ -25718,7 +25891,7 @@
       </p:sp>
       <p:sp>
         <p:nvSpPr>
-          <p:cNvPr id="13" name="arrow legal actions"/>
+          <p:cNvPr id="20" name="arrow legal actions"/>
           <p:cNvSpPr/>
           <p:nvPr/>
         </p:nvSpPr>
@@ -25742,7 +25915,7 @@
       </p:sp>
       <p:sp>
         <p:nvSpPr>
-          <p:cNvPr id="14" name="label legal actions"/>
+          <p:cNvPr id="21" name="label legal actions"/>
           <p:cNvSpPr txBox="1"/>
           <p:nvPr/>
         </p:nvSpPr>
@@ -25778,7 +25951,7 @@
       </p:sp>
       <p:sp>
         <p:nvSpPr>
-          <p:cNvPr id="15" name="arrow chosen action"/>
+          <p:cNvPr id="22" name="arrow chosen action"/>
           <p:cNvSpPr/>
           <p:nvPr/>
         </p:nvSpPr>
@@ -25802,7 +25975,7 @@
       </p:sp>
       <p:sp>
         <p:nvSpPr>
-          <p:cNvPr id="16" name="label chosen action"/>
+          <p:cNvPr id="23" name="label chosen action"/>
           <p:cNvSpPr txBox="1"/>
           <p:nvPr/>
         </p:nvSpPr>
@@ -25838,7 +26011,7 @@
       </p:sp>
       <p:sp>
         <p:nvSpPr>
-          <p:cNvPr id="17" name="box verifier"/>
+          <p:cNvPr id="24" name="box verifier"/>
           <p:cNvSpPr/>
           <p:nvPr/>
         </p:nvSpPr>
@@ -25863,16 +26036,40 @@
           </a:ln>
         </p:spPr>
       </p:sp>
-      <p:sp>
-        <p:nvSpPr>
-          <p:cNvPr id="18" name="text verifier"/>
+      <p:pic>
+        <p:nvPicPr>
+          <p:cNvPr id="25" name="icon verifier" descr="preencoded.png">    </p:cNvPr>
+          <p:cNvPicPr>
+            <a:picLocks noChangeAspect="1"/>
+          </p:cNvPicPr>
+          <p:nvPr/>
+        </p:nvPicPr>
+        <p:blipFill>
+          <a:blip r:embed="rId3"/>
+          <a:stretch>
+            <a:fillRect/>
+          </a:stretch>
+        </p:blipFill>
+        <p:spPr>
+          <a:xfrm>
+            <a:off x="8549640" y="1828800"/>
+            <a:ext cx="457200" cy="457200"/>
+          </a:xfrm>
+          <a:prstGeom prst="rect">
+            <a:avLst/>
+          </a:prstGeom>
+        </p:spPr>
+      </p:pic>
+      <p:sp>
+        <p:nvSpPr>
+          <p:cNvPr id="26" name="text verifier"/>
           <p:cNvSpPr txBox="1"/>
           <p:nvPr/>
         </p:nvSpPr>
         <p:spPr>
           <a:xfrm>
-            <a:off x="7863840" y="1554480"/>
-            <a:ext cx="1828800" cy="2240280"/>
+            <a:off x="7863840" y="2331720"/>
+            <a:ext cx="1828800" cy="1371600"/>
           </a:xfrm>
           <a:prstGeom prst="rect">
             <a:avLst/>
@@ -25915,7 +26112,7 @@
       </p:sp>
       <p:sp>
         <p:nvSpPr>
-          <p:cNvPr id="19" name="arrow finished design"/>
+          <p:cNvPr id="27" name="arrow finished design"/>
           <p:cNvSpPr/>
           <p:nvPr/>
         </p:nvSpPr>
@@ -25939,7 +26136,7 @@
       </p:sp>
       <p:sp>
         <p:nvSpPr>
-          <p:cNvPr id="20" name="label finished design"/>
+          <p:cNvPr id="28" name="label finished design"/>
           <p:cNvSpPr txBox="1"/>
           <p:nvPr/>
         </p:nvSpPr>
@@ -25975,7 +26172,7 @@
       </p:sp>
       <p:sp>
         <p:nvSpPr>
-          <p:cNvPr id="21" name="box output"/>
+          <p:cNvPr id="29" name="box output"/>
           <p:cNvSpPr/>
           <p:nvPr/>
         </p:nvSpPr>
@@ -26002,14 +26199,149 @@
       </p:sp>
       <p:sp>
         <p:nvSpPr>
-          <p:cNvPr id="22" name="text output"/>
+          <p:cNvPr id="30" name="mini out slab"/>
+          <p:cNvSpPr/>
+          <p:nvPr/>
+        </p:nvSpPr>
+        <p:spPr>
+          <a:xfrm>
+            <a:off x="10287000" y="1719072"/>
+            <a:ext cx="1170432" cy="91440"/>
+          </a:xfrm>
+          <a:prstGeom prst="rect">
+            <a:avLst/>
+          </a:prstGeom>
+          <a:solidFill>
+            <a:srgbClr val="EEF1F4"/>
+          </a:solidFill>
+          <a:ln w="6350">
+            <a:solidFill>
+              <a:srgbClr val="52514E"/>
+            </a:solidFill>
+            <a:prstDash val="solid"/>
+          </a:ln>
+        </p:spPr>
+      </p:sp>
+      <p:sp>
+        <p:nvSpPr>
+          <p:cNvPr id="31" name="mini rod 0"/>
+          <p:cNvSpPr/>
+          <p:nvPr/>
+        </p:nvSpPr>
+        <p:spPr>
+          <a:xfrm>
+            <a:off x="10378440" y="1810512"/>
+            <a:ext cx="27432" cy="429768"/>
+          </a:xfrm>
+          <a:prstGeom prst="rect">
+            <a:avLst/>
+          </a:prstGeom>
+          <a:solidFill>
+            <a:srgbClr val="1F2933"/>
+          </a:solidFill>
+          <a:ln/>
+        </p:spPr>
+      </p:sp>
+      <p:sp>
+        <p:nvSpPr>
+          <p:cNvPr id="32" name="mini rod 1"/>
+          <p:cNvSpPr/>
+          <p:nvPr/>
+        </p:nvSpPr>
+        <p:spPr>
+          <a:xfrm>
+            <a:off x="11338560" y="1810512"/>
+            <a:ext cx="27432" cy="429768"/>
+          </a:xfrm>
+          <a:prstGeom prst="rect">
+            <a:avLst/>
+          </a:prstGeom>
+          <a:solidFill>
+            <a:srgbClr val="1F2933"/>
+          </a:solidFill>
+          <a:ln/>
+        </p:spPr>
+      </p:sp>
+      <p:sp>
+        <p:nvSpPr>
+          <p:cNvPr id="33" name="mini bar"/>
+          <p:cNvSpPr/>
+          <p:nvPr/>
+        </p:nvSpPr>
+        <p:spPr>
+          <a:xfrm>
+            <a:off x="10305288" y="2240280"/>
+            <a:ext cx="1133856" cy="36576"/>
+          </a:xfrm>
+          <a:prstGeom prst="rect">
+            <a:avLst/>
+          </a:prstGeom>
+          <a:solidFill>
+            <a:srgbClr val="1F2933"/>
+          </a:solidFill>
+          <a:ln/>
+        </p:spPr>
+      </p:sp>
+      <p:sp>
+        <p:nvSpPr>
+          <p:cNvPr id="34" name="mini out pipe a"/>
+          <p:cNvSpPr/>
+          <p:nvPr/>
+        </p:nvSpPr>
+        <p:spPr>
+          <a:xfrm>
+            <a:off x="10543032" y="2029968"/>
+            <a:ext cx="210312" cy="210312"/>
+          </a:xfrm>
+          <a:prstGeom prst="ellipse">
+            <a:avLst/>
+          </a:prstGeom>
+          <a:solidFill>
+            <a:srgbClr val="FFFFFF"/>
+          </a:solidFill>
+          <a:ln w="9525">
+            <a:solidFill>
+              <a:srgbClr val="52514E"/>
+            </a:solidFill>
+            <a:prstDash val="solid"/>
+          </a:ln>
+        </p:spPr>
+      </p:sp>
+      <p:sp>
+        <p:nvSpPr>
+          <p:cNvPr id="35" name="mini out pipe b"/>
+          <p:cNvSpPr/>
+          <p:nvPr/>
+        </p:nvSpPr>
+        <p:spPr>
+          <a:xfrm>
+            <a:off x="10890504" y="2084832"/>
+            <a:ext cx="155448" cy="155448"/>
+          </a:xfrm>
+          <a:prstGeom prst="ellipse">
+            <a:avLst/>
+          </a:prstGeom>
+          <a:solidFill>
+            <a:srgbClr val="FFFFFF"/>
+          </a:solidFill>
+          <a:ln w="9525">
+            <a:solidFill>
+              <a:srgbClr val="52514E"/>
+            </a:solidFill>
+            <a:prstDash val="solid"/>
+          </a:ln>
+        </p:spPr>
+      </p:sp>
+      <p:sp>
+        <p:nvSpPr>
+          <p:cNvPr id="36" name="text output"/>
           <p:cNvSpPr txBox="1"/>
           <p:nvPr/>
         </p:nvSpPr>
         <p:spPr>
           <a:xfrm>
-            <a:off x="10104120" y="1554480"/>
-            <a:ext cx="1536192" cy="2240280"/>
+            <a:off x="10104120" y="2331720"/>
+            <a:ext cx="1536192" cy="1371600"/>
           </a:xfrm>
           <a:prstGeom prst="rect">
             <a:avLst/>
@@ -26052,7 +26384,7 @@
       </p:sp>
       <p:sp>
         <p:nvSpPr>
-          <p:cNvPr id="23" name="arrow to output"/>
+          <p:cNvPr id="37" name="arrow to output"/>
           <p:cNvSpPr/>
           <p:nvPr/>
         </p:nvSpPr>
@@ -26076,7 +26408,7 @@
       </p:sp>
       <p:sp>
         <p:nvSpPr>
-          <p:cNvPr id="24" name="feedback down"/>
+          <p:cNvPr id="38" name="feedback down"/>
           <p:cNvSpPr/>
           <p:nvPr/>
         </p:nvSpPr>
@@ -26099,7 +26431,7 @@
       </p:sp>
       <p:sp>
         <p:nvSpPr>
-          <p:cNvPr id="25" name="feedback across"/>
+          <p:cNvPr id="39" name="feedback across"/>
           <p:cNvSpPr/>
           <p:nvPr/>
         </p:nvSpPr>
@@ -26122,7 +26454,7 @@
       </p:sp>
       <p:sp>
         <p:nvSpPr>
-          <p:cNvPr id="26" name="feedback up"/>
+          <p:cNvPr id="40" name="feedback up"/>
           <p:cNvSpPr/>
           <p:nvPr/>
         </p:nvSpPr>
@@ -26146,7 +26478,7 @@
       </p:sp>
       <p:sp>
         <p:nvSpPr>
-          <p:cNvPr id="27" name="label feedback"/>
+          <p:cNvPr id="41" name="label feedback"/>
           <p:cNvSpPr txBox="1"/>
           <p:nvPr/>
         </p:nvSpPr>
@@ -26182,7 +26514,7 @@
       </p:sp>
       <p:sp>
         <p:nvSpPr>
-          <p:cNvPr id="28" name="legend swatch Input"/>
+          <p:cNvPr id="42" name="legend swatch Input"/>
           <p:cNvSpPr/>
           <p:nvPr/>
         </p:nvSpPr>
@@ -26209,7 +26541,7 @@
       </p:sp>
       <p:sp>
         <p:nvSpPr>
-          <p:cNvPr id="29" name="legend Input"/>
+          <p:cNvPr id="43" name="legend Input"/>
           <p:cNvSpPr txBox="1"/>
           <p:nvPr/>
         </p:nvSpPr>
@@ -26245,7 +26577,7 @@
       </p:sp>
       <p:sp>
         <p:nvSpPr>
-          <p:cNvPr id="30" name="legend swatch Rules"/>
+          <p:cNvPr id="44" name="legend swatch Rules"/>
           <p:cNvSpPr/>
           <p:nvPr/>
         </p:nvSpPr>
@@ -26272,7 +26604,7 @@
       </p:sp>
       <p:sp>
         <p:nvSpPr>
-          <p:cNvPr id="31" name="legend Rules"/>
+          <p:cNvPr id="45" name="legend Rules"/>
           <p:cNvSpPr txBox="1"/>
           <p:nvPr/>
         </p:nvSpPr>
@@ -26308,7 +26640,7 @@
       </p:sp>
       <p:sp>
         <p:nvSpPr>
-          <p:cNvPr id="32" name="legend swatch Approach (black box)"/>
+          <p:cNvPr id="46" name="legend swatch Approach (black box)"/>
           <p:cNvSpPr/>
           <p:nvPr/>
         </p:nvSpPr>
@@ -26335,7 +26667,7 @@
       </p:sp>
       <p:sp>
         <p:nvSpPr>
-          <p:cNvPr id="33" name="legend Approach (black box)"/>
+          <p:cNvPr id="47" name="legend Approach (black box)"/>
           <p:cNvSpPr txBox="1"/>
           <p:nvPr/>
         </p:nvSpPr>
@@ -26371,7 +26703,7 @@
       </p:sp>
       <p:sp>
         <p:nvSpPr>
-          <p:cNvPr id="34" name="legend swatch Verifier"/>
+          <p:cNvPr id="48" name="legend swatch Verifier"/>
           <p:cNvSpPr/>
           <p:nvPr/>
         </p:nvSpPr>
@@ -26398,7 +26730,7 @@
       </p:sp>
       <p:sp>
         <p:nvSpPr>
-          <p:cNvPr id="35" name="legend Verifier"/>
+          <p:cNvPr id="49" name="legend Verifier"/>
           <p:cNvSpPr txBox="1"/>
           <p:nvPr/>
         </p:nvSpPr>
@@ -26434,7 +26766,7 @@
       </p:sp>
       <p:sp>
         <p:nvSpPr>
-          <p:cNvPr id="36" name="legend swatch Output"/>
+          <p:cNvPr id="50" name="legend swatch Output"/>
           <p:cNvSpPr/>
           <p:nvPr/>
         </p:nvSpPr>
@@ -26461,7 +26793,7 @@
       </p:sp>
       <p:sp>
         <p:nvSpPr>
-          <p:cNvPr id="37" name="legend Output"/>
+          <p:cNvPr id="51" name="legend Output"/>
           <p:cNvSpPr txBox="1"/>
           <p:nvPr/>
         </p:nvSpPr>
@@ -26497,7 +26829,7 @@
       </p:sp>
       <p:sp>
         <p:nvSpPr>
-          <p:cNvPr id="38" name="needs band"/>
+          <p:cNvPr id="52" name="needs band"/>
           <p:cNvSpPr/>
           <p:nvPr/>
         </p:nvSpPr>
@@ -26519,7 +26851,7 @@
       </p:sp>
       <p:sp>
         <p:nvSpPr>
-          <p:cNvPr id="39" name="needs text"/>
+          <p:cNvPr id="53" name="needs text"/>
           <p:cNvSpPr txBox="1"/>
           <p:nvPr/>
         </p:nvSpPr>

</xml_diff>

<commit_message>
Talk: speech rewritten from scratch to a per-slide budget, about 8:30 with the demo
</commit_message>
<xml_diff>
--- a/docs/CrossMEP_CIBW78_talk.pptx
+++ b/docs/CrossMEP_CIBW78_talk.pptx
@@ -129,12 +129,12 @@
   <p:extLst>
     <p:ext uri="{521415D9-36F7-43E2-AB2F-B90AF26B5E84}">
       <p14:sectionLst xmlns:p14="http://schemas.microsoft.com/office/powerpoint/2010/main">
-        <p14:section name="Opening" id="{0dfe272f-d792-88b8-9614-e4abfb1d46e9}">
+        <p14:section name="Opening" id="{577ccaca-a128-3039-2740-110de3c36e44}">
           <p14:sldIdLst>
             <p14:sldId id="256"/>
           </p14:sldIdLst>
         </p14:section>
-        <p14:section name="Motivation" id="{e7404278-e84d-6b24-d25e-6fc5205cc32b}">
+        <p14:section name="Motivation" id="{b2a9495c-5e40-332c-1c49-f43c9ad592cb}">
           <p14:sldIdLst>
             <p14:sldId id="257"/>
             <p14:sldId id="258"/>
@@ -143,7 +143,7 @@
             <p14:sldId id="261"/>
           </p14:sldIdLst>
         </p14:section>
-        <p14:section name="The dataset" id="{3f3781ff-ded6-a46f-0411-33bd0136dc1f}">
+        <p14:section name="The dataset" id="{752d7ec6-ffe9-1f43-7463-df86752d50df}">
           <p14:sldIdLst>
             <p14:sldId id="262"/>
             <p14:sldId id="263"/>
@@ -152,14 +152,14 @@
             <p14:sldId id="266"/>
           </p14:sldIdLst>
         </p14:section>
-        <p14:section name="Experiments" id="{5c444600-9395-9fce-1fff-73e332459cb8}">
+        <p14:section name="Experiments" id="{a7b575e1-56dd-5f33-be0d-b63d15a3cc3b}">
           <p14:sldIdLst>
             <p14:sldId id="267"/>
             <p14:sldId id="268"/>
             <p14:sldId id="269"/>
           </p14:sldIdLst>
         </p14:section>
-        <p14:section name="Use" id="{01dbfdb5-0bcd-3491-d6ed-4ea0a5fbce10}">
+        <p14:section name="Use" id="{dbaa0df0-091f-0e2e-9174-a506d3fb19e6}">
           <p14:sldIdLst>
             <p14:sldId id="270"/>
             <p14:sldId id="271"/>
@@ -167,7 +167,7 @@
             <p14:sldId id="273"/>
           </p14:sldIdLst>
         </p14:section>
-        <p14:section name="Appendix" id="{4e017b5a-212e-1064-2654-016c3caac2f3}">
+        <p14:section name="Appendix" id="{afbba0d5-91f7-ed0d-ffb9-2dcd0351f685}">
           <p14:sldIdLst>
             <p14:sldId id="274"/>
             <p14:sldId id="275"/>
@@ -2029,7 +2029,7 @@
           <a:p>
             <a:r>
               <a:rPr lang="en-US" dirty="0"/>
-              <a:t>Hello everyone, I'm Lavinia Pedrollo, from Stanford. Every pipe, duct and cable tray in a building hangs from a support that an engineer designs by hand, from the section at that spot. We want to teach machines to do some of that work, and the first thing we found missing was data: there was no public set of support-design problems. So, with David Gvadzabia, Torben Graeber and Martin Fischer, we built one. It's called CrossMEP. (0:00)</a:t>
+              <a:t>I'm Lavinia Pedrollo, from Stanford. Every pipe, duct and cable tray in a building hangs from a support that an engineer designs by hand. We want machines to do some of that, and the first thing missing was data: no public set of support-design problems existed. So we built one, CrossMEP, with David Gvadzabia, Torben Graeber and Martin Fischer. (0:00)</a:t>
             </a:r>
             <a:endParaRPr lang="en-US" dirty="0"/>
           </a:p>
@@ -2117,7 +2117,7 @@
           <a:p>
             <a:r>
               <a:rPr lang="en-US" dirty="0"/>
-              <a:t>The release has four splits on disjoint seeds, so a method is never tested on what it trained on: five thousand contexts for training, five hundred each for validation and test, and a benchmark of one thousand, a hundred and twenty-five per tier. Everything is plain JSON with a schema and a datasheet. (4:55)</a:t>
+              <a:t>Four splits on disjoint seeds: five thousand for training, five hundred each for validation and test, and a benchmark of a thousand, a hundred and twenty-five per tier. Plain JSON, with a schema and a datasheet. (4:00)</a:t>
             </a:r>
             <a:endParaRPr lang="en-US" dirty="0"/>
           </a:p>
@@ -2205,7 +2205,7 @@
           <a:p>
             <a:r>
               <a:rPr lang="en-US" dirty="0"/>
-              <a:t>Here's one benchmark context per tier. C1 is a single element, the most common support in any building. By C8 you have eight services on three rows. Within a tier everything else varies, so the element count is the one controlled axis of difficulty. And notice the walls: the section rotates, and electrical sits above water. (5:20)</a:t>
+              <a:t>One benchmark context per tier. C1 is a single element, the most common support in any building; C8 has eight services on three rows. Within a tier everything else varies, so the element count is the one controlled axis of difficulty. On walls the section rotates, and electrical sits above water. (4:15)</a:t>
             </a:r>
             <a:endParaRPr lang="en-US" dirty="0"/>
           </a:p>
@@ -2293,7 +2293,7 @@
           <a:p>
             <a:r>
               <a:rPr lang="en-US" dirty="0"/>
-              <a:t>Now three analyses. The first is a design check, not a discovery: the count is fixed by construction, and load and congestion follow from the rules, so this shows the dataset behaves as designed. The load at the support rises with the tier, from about 0.3 to 2.0 kilonewtons. The closest gap narrows at every step, from 130 to about 51 millimeters. (5:40)</a:t>
+              <a:t>Three analyses. The first is a design check: the count is fixed by construction, and load and congestion follow from the rules. Load at the support rises with the tier, from about 0.3 to 2.0 kilonewtons, and the closest gap narrows at every step, from 130 to about 51 millimetres. The dataset behaves as designed. (4:40)</a:t>
             </a:r>
             <a:endParaRPr lang="en-US" dirty="0"/>
           </a:p>
@@ -2381,7 +2381,7 @@
           <a:p>
             <a:r>
               <a:rPr lang="en-US" dirty="0"/>
-              <a:t>The second analysis is the one the generator could fail. Is the spacing realistic in a building it has never seen? The gap distribution was fitted on a residential duplex. We kept a second open building aside, a medical-dental clinic, cut it into sections every 250 millimeters, and measured the gaps between pipes running side by side. Generator to clinic: 32 millimeters. Above the 8 a perfect generator would show, but about as close as the duplex's own two models are to each other. A fixed 25-millimeter gap would be about 190 off. (6:05)</a:t>
+              <a:t>The second is the one the generator could fail: is the spacing realistic in a building it has never seen? The gap distribution was fitted on a residential duplex. We held out a medical clinic, cut it into sections every 250 millimetres, and measured the gaps between pipes side by side. Generator to clinic: 32 millimetres. Above the 8 a perfect generator would show, but about as close as the duplex's own two models are to each other. A fixed 25-millimetre gap would be about 190 off. (5:00)</a:t>
             </a:r>
             <a:endParaRPr lang="en-US" dirty="0"/>
           </a:p>
@@ -2469,7 +2469,7 @@
           <a:p>
             <a:r>
               <a:rPr lang="en-US" dirty="0"/>
-              <a:t>The third analysis is a use of the dataset, not a test of it: what must a catalog of clamps cover? Our paper's two-size catalog attaches 14.5 percent of the pipes, with an interval of 13 to 16, all one size, DN40. Load is never the limit, and trays, ducts and conduits aren't covered at all. On the right is what the dataset asks of any catalog: two well-placed sizes could attach 38 percent, six sizes 76, fifteen sizes every pipe. So 'what should the catalog contain' becomes a measurement. (6:45)</a:t>
+              <a:t>The third is a use of the dataset: what must a catalog of clamps cover? Our paper's two-size catalog attaches 14.5 percent of the pipes, interval 13 to 16, all one size, DN40. Trays, ducts and conduits are not covered at all. On the right, what the dataset asks of any catalog: two well-placed sizes reach 38 percent, six sizes 76, fifteen every pipe. What the catalog should contain becomes a measurement. (5:35)</a:t>
             </a:r>
             <a:endParaRPr lang="en-US" dirty="0"/>
           </a:p>
@@ -2557,7 +2557,7 @@
           <a:p>
             <a:r>
               <a:rPr lang="en-US" dirty="0"/>
-              <a:t>Let me show it. This is the Generator Studio. I choose what crosses the hanger, a tier or an exact mix, and a seed. Out comes the section a support designer receives, drawn the way an engineer would issue it: every service at true size, its level below the slab, its load, the closest clear gap, and the same run in 3D. Every section is a stored output of the released generator, with the call that reproduces it. Scan the code to try it yourself. [Live: switch to the studio, click C3, then Generate another twice, then Exact mix with a duct. If the demo fails, stay on this slide; slide 19 shows two more sections. Before the talk: open the studio once with internet, set its link sharing to public, scan the QR from a phone not logged in.] (7:25)</a:t>
+              <a:t>Let me show it. This is the Generator Studio. I choose what crosses the hanger, a tier or an exact mix, and a seed. Out comes the section a designer receives, drawn as an engineer would issue it: every service at true size, its level, its load, the closest gap, and the run in 3D. Every section is a stored output of the released generator. Scan the code to try it. [Live: switch to the studio, click C3, then Generate another twice, then Exact mix with a duct. If the demo fails, stay on this slide; slide 19 shows two more sections. Before the talk: open the studio once with internet, set its link sharing to public, scan the QR from a phone not logged in.] (6:05)</a:t>
             </a:r>
             <a:endParaRPr lang="en-US" dirty="0"/>
           </a:p>
@@ -2645,7 +2645,7 @@
           <a:p>
             <a:r>
               <a:rPr lang="en-US" dirty="0"/>
-              <a:t>Using it takes a few lines: load a split, filter by composition, or generate your own mix. With no labels, the same files serve reinforcement learning, constraint programming, and benchmarking. We ship the scoring too. Train on the generator, from C1 up to C8. Evaluate on the benchmark, the same 125 contexts per tier for every method. Report per tier, with 95 percent intervals and paired tests. (8:35)</a:t>
+              <a:t>Using it takes a few lines: load a split, filter by composition, or generate your own mix. The same files serve reinforcement learning, constraint programming and benchmarking, and we ship the scoring. Train on the generator, C1 up to C8. Evaluate on the benchmark, the same 125 contexts per tier for every method. Report per tier, with intervals and paired tests. (7:10)</a:t>
             </a:r>
             <a:endParaRPr lang="en-US" dirty="0"/>
           </a:p>
@@ -2733,7 +2733,7 @@
           <a:p>
             <a:r>
               <a:rPr lang="en-US" dirty="0"/>
-              <a:t>A word on scope. CrossMEP is one section at one support. Pipe spacing was checked on two open buildings; the rest rests on practice and standards, and the trade mix is a design choice. It's not for structural design of real installations. Next: a public checker, so we can compare methods on the answer; the catalog as an input; and a real test set from commercial projects, with supports designed by engineers. That's where I'd value your eye. (9:00)</a:t>
+              <a:t>Scope. CrossMEP is one section at one support. Pipe spacing was checked on two open buildings; the rest rests on practice and standards, and the trade mix is a design choice. It is not for the structural design of real installations. Next: a public checker, so methods can be compared on the answer; the catalog as an input; and a real test set from commercial projects, with supports designed by engineers. That is where I would value your eye. (7:35)</a:t>
             </a:r>
             <a:endParaRPr lang="en-US" dirty="0"/>
           </a:p>
@@ -2821,7 +2821,7 @@
           <a:p>
             <a:r>
               <a:rPr lang="en-US" dirty="0"/>
-              <a:t>To sum up: CrossMEP is the brief, not the answer. Seven thousand support-design problems, every constant sourced or declared a design choice, pipe spacing checked on two open buildings, and all of it open. If you coordinate services or design supports, try the studio and tell me what looks wrong. Thank you. (9:35)</a:t>
+              <a:t>To sum up: CrossMEP is the brief, not the answer. Seven thousand support-design problems, every constant sourced or declared, spacing checked on two open buildings, all of it open. If you coordinate services or design supports, try the studio and tell me what looks wrong. Thank you. (8:10)</a:t>
             </a:r>
             <a:endParaRPr lang="en-US" dirty="0"/>
           </a:p>
@@ -2997,7 +2997,7 @@
           <a:p>
             <a:r>
               <a:rPr lang="en-US" dirty="0"/>
-              <a:t>Here is the scale of it. In this hospital, every red mark is a place where pipes, ducts or cable trays hang from the structure. A modular support system groups several services onto one prefabricated frame: a structural support assembly. A hospital of two hundred thousand square feet needs about ten thousand of them. Each takes twenty minutes to two hours to design by hand, roughly a quarter of the whole MEP design effort. These are practitioner estimates. (0:30)</a:t>
+              <a:t>Here is the scale. Every red mark in this hospital is a place where services hang from the structure. A modular support groups several services on one prefabricated frame: a structural support assembly. A hospital this size needs about ten thousand. Each takes twenty minutes to two hours to design, roughly a quarter of the MEP design effort. Practitioner estimates, but these are the numbers people live with. (0:25)</a:t>
             </a:r>
             <a:endParaRPr lang="en-US" dirty="0"/>
           </a:p>
@@ -3437,7 +3437,7 @@
           <a:p>
             <a:r>
               <a:rPr lang="en-US" dirty="0"/>
-              <a:t>What exactly is designed, and from what? At ISARC we defined the task like this. In: one cross-section at a hanger. The structure it hangs from, with its anchor zones, and the services crossing it, each with trade, position, size and weight per metre. We call that a context: the brief. Out: assemblies of catalog parts that carry those services to the structure, each checked for statics, anchors, connectors and buildability, up to ten, ranked by cost. The assembly is the answer. Keep the two apart: CrossMEP is contexts. It contains no assemblies. (1:05)</a:t>
+              <a:t>What exactly is designed, and from what? In: one cross-section at a hanger. The structure it hangs from, and the services crossing it, each with trade, position, size and weight per metre. That is the context: the brief. Out: assemblies of catalog parts that carry those services to the structure, checked for statics, anchors, connectors and buildability, ranked by cost. That is the answer. Keep the two apart: CrossMEP is contexts. It contains no assemblies. (0:55)</a:t>
             </a:r>
             <a:endParaRPr lang="en-US" dirty="0"/>
           </a:p>
@@ -3525,7 +3525,7 @@
           <a:p>
             <a:r>
               <a:rPr lang="en-US" dirty="0"/>
-              <a:t>Why has this resisted automation? Designers don't work from the whole model: after coordination they work from one section at each hanger, like this one. Today's tools coordinate and check; choosing the layout and the parts is still manual. Three reasons. The topology comes from experience. Code, load and material rules interact across thousands of combinations. And catalogs change faster than rule systems can be rewritten. (1:40)</a:t>
+              <a:t>Why is this still done by hand? Designers work from one section at each hanger, after coordination. Tools coordinate and check; they do not choose the layout or the parts. Three reasons: the topology comes from experience, the rules interact across thousands of combinations, and catalogs change faster than rule systems can be rewritten. (1:25)</a:t>
             </a:r>
             <a:endParaRPr lang="en-US" dirty="0"/>
           </a:p>
@@ -3613,7 +3613,7 @@
           <a:p>
             <a:r>
               <a:rPr lang="en-US" dirty="0"/>
-              <a:t>What would a method look like? On the left, the context and a catalog of parts with prices. The rules say which actions are legal; each action adds parts. In the middle, a black box chooses the next action: a rule table, a search, or a learned policy. A verifier judges every finished design, statics, anchors, buildability, and feeds pass or fail back. Whatever sits in that black box, it needs problems to learn from, a fixed set to compare on, and problems that look like practice. (2:10)</a:t>
+              <a:t>What would a method look like? The context and a catalog go in. Rules say which actions are legal; each action adds parts. In the middle, a black box chooses the next action: a rule table, a search, or a learned policy. A verifier checks every finished design and feeds pass or fail back. Whatever sits in the black box, it needs problems to learn from, a fixed set to compare on, and problems that look like practice. (1:45)</a:t>
             </a:r>
             <a:endParaRPr lang="en-US" dirty="0"/>
           </a:p>
@@ -3701,7 +3701,7 @@
           <a:p>
             <a:r>
               <a:rPr lang="en-US" dirty="0"/>
-              <a:t>The real designs we had were few, and they sat in one corner of the design space: one kind of project, one trade mix. A method tuned to them measures fit to that project. So we generate. CrossMEP covers the space by construction, and without limit: a new seed is a new set of problems, uniform over the tiers, or shaped to whatever mix you ask for. The seven thousand contexts in eight tiers are the release, not the ceiling: deliberately unlabeled, every constant sourced or declared, and all of it open. (2:45)</a:t>
+              <a:t>The real designs we had were few, from one kind of project with one trade mix: one corner of the design space. A method tuned on them measures fit to that project. So we generate. CrossMEP fills the space by construction, without limit: a new seed is a new set, uniform over the tiers or any mix you ask for. Seven thousand contexts are the release, not the ceiling. (2:20)</a:t>
             </a:r>
             <a:endParaRPr lang="en-US" dirty="0"/>
           </a:p>
@@ -3789,7 +3789,7 @@
           <a:p>
             <a:r>
               <a:rPr lang="en-US" dirty="0"/>
-              <a:t>Here's one context: a two-dimensional section at one support location. Each element has its kind, service and trade, its size, its insulation, and its load, which is weight per metre times the span it was sized at, plus its position. Add the surface, a slab or a wall, and that's all. What you won't find is the support: no channel, no rods, no anchors, and no correct answer, because a feasible support depends on the catalog you build from. (3:25)</a:t>
+              <a:t>Here is one context: a two-dimensional section at one support. Each element has its kind, service and trade, its size, insulation and position, and its load: weight per metre times the span it was sized at. Add the surface, slab or wall, and that is all. No channel, no rods, no anchors, no correct answer, because a feasible support depends on the catalog you build from. (2:45)</a:t>
             </a:r>
             <a:endParaRPr lang="en-US" dirty="0"/>
           </a:p>
@@ -3877,7 +3877,7 @@
           <a:p>
             <a:r>
               <a:rPr lang="en-US" dirty="0"/>
-              <a:t>How do we make a context? By rules an engineer would recognize, not free randomness. The tier fixes how many elements there are. We pick the surface and fill it the way trades really run services: hot and cold together, flow and return together, conduits in groups, bulky services nearest the slab. Gaps between neighbors are drawn from gaps measured on a built project, never below twenty-five millimeters. On walls, electrical stays above water. Every context is checked; same seed, same file, byte for byte. (3:55)</a:t>
+              <a:t>How is a context made? By rules an engineer would recognize. The tier fixes the element count. We pick the surface and fill it the way trades run services: hot and cold together, flow and return together, conduits in groups, bulky services nearest the slab. Gaps are drawn from gaps measured on a built project, never below twenty-five millimetres. On walls, electrical stays above water. Same seed, same file. (3:15)</a:t>
             </a:r>
             <a:endParaRPr lang="en-US" dirty="0"/>
           </a:p>
@@ -3965,7 +3965,7 @@
           <a:p>
             <a:r>
               <a:rPr lang="en-US" dirty="0"/>
-              <a:t>Where do the numbers come from? Three places. Sizes, weights and spans come from standards: European steel pipe and duct standards, IEC for conduits and trays, ASME for spans, the German GEG for insulation. How close neighbors sit comes from measured open buildings. And a few things are simply our choices, like the trade mix, and we label them that way. (4:30)</a:t>
+              <a:t>Where do the numbers come from? Sizes, weights and spans from standards: EN for pipes and ducts, IEC for conduits and trays, ASME for spans, GEG for insulation. Spacing from measured open buildings. And a few choices of our own, like the trade mix, labelled as choices. (3:45)</a:t>
             </a:r>
             <a:endParaRPr lang="en-US" dirty="0"/>
           </a:p>

</xml_diff>

<commit_message>
Talk: Aptos throughout; numbered references with [n] markers and a dark-grey reference line on every slide that cites a source
</commit_message>
<xml_diff>
--- a/docs/CrossMEP_CIBW78_talk.pptx
+++ b/docs/CrossMEP_CIBW78_talk.pptx
@@ -124,12 +124,12 @@
   <p:extLst>
     <p:ext uri="{521415D9-36F7-43E2-AB2F-B90AF26B5E84}">
       <p14:sectionLst xmlns:p14="http://schemas.microsoft.com/office/powerpoint/2010/main">
-        <p14:section name="Opening" id="{776b8d9b-b26a-c203-ce33-1d2e139bc47d}">
+        <p14:section name="Opening" id="{9a7a4107-7484-aeeb-4f19-bd0ea906fae2}">
           <p14:sldIdLst>
             <p14:sldId id="256"/>
           </p14:sldIdLst>
         </p14:section>
-        <p14:section name="Motivation" id="{4a9490e0-d710-0a1e-1bbe-e8216f255ad4}">
+        <p14:section name="Motivation" id="{27887e46-45e2-cf4e-3be4-ab13fbb86296}">
           <p14:sldIdLst>
             <p14:sldId id="257"/>
             <p14:sldId id="258"/>
@@ -138,7 +138,7 @@
             <p14:sldId id="261"/>
           </p14:sldIdLst>
         </p14:section>
-        <p14:section name="The dataset" id="{653e4263-ec41-4832-0ae2-f658d5f2f78e}">
+        <p14:section name="The dataset" id="{da36ba2e-a855-2118-6271-e33023b46354}">
           <p14:sldIdLst>
             <p14:sldId id="262"/>
             <p14:sldId id="263"/>
@@ -147,14 +147,14 @@
             <p14:sldId id="266"/>
           </p14:sldIdLst>
         </p14:section>
-        <p14:section name="Experiments" id="{b3b4bb02-4e87-d671-7d66-af298a75ec50}">
+        <p14:section name="Experiments" id="{c8632744-151b-2915-f053-553f90ca5cb7}">
           <p14:sldIdLst>
             <p14:sldId id="267"/>
             <p14:sldId id="268"/>
             <p14:sldId id="269"/>
           </p14:sldIdLst>
         </p14:section>
-        <p14:section name="Use" id="{30f03894-345b-6eb3-e981-e64c45443ac6}">
+        <p14:section name="Use" id="{aabce9d3-6bcb-9df1-5020-172f67b04ec7}">
           <p14:sldIdLst>
             <p14:sldId id="270"/>
             <p14:sldId id="271"/>
@@ -4685,16 +4685,16 @@
                           <a:solidFill>
                             <a:srgbClr val="FFFFFF"/>
                           </a:solidFill>
-                          <a:latin typeface="Calibri" pitchFamily="34" charset="0"/>
-                          <a:ea typeface="Calibri" pitchFamily="34" charset="-122"/>
-                          <a:cs typeface="Calibri" pitchFamily="34" charset="-120"/>
+                          <a:latin typeface="Aptos" pitchFamily="34" charset="0"/>
+                          <a:ea typeface="Aptos" pitchFamily="34" charset="-122"/>
+                          <a:cs typeface="Aptos" pitchFamily="34" charset="-120"/>
                         </a:rPr>
                         <a:t>split</a:t>
                       </a:r>
                       <a:endParaRPr lang="en-US" sz="1200" dirty="0">
-                        <a:latin typeface="Calibri" charset="0"/>
-                        <a:ea typeface="Calibri" charset="0"/>
-                        <a:cs typeface="Calibri" charset="0"/>
+                        <a:latin typeface="Aptos" charset="0"/>
+                        <a:ea typeface="Aptos" charset="0"/>
+                        <a:cs typeface="Aptos" charset="0"/>
                       </a:endParaRPr>
                     </a:p>
                   </a:txBody>
@@ -4753,16 +4753,16 @@
                           <a:solidFill>
                             <a:srgbClr val="FFFFFF"/>
                           </a:solidFill>
-                          <a:latin typeface="Calibri" pitchFamily="34" charset="0"/>
-                          <a:ea typeface="Calibri" pitchFamily="34" charset="-122"/>
-                          <a:cs typeface="Calibri" pitchFamily="34" charset="-120"/>
+                          <a:latin typeface="Aptos" pitchFamily="34" charset="0"/>
+                          <a:ea typeface="Aptos" pitchFamily="34" charset="-122"/>
+                          <a:cs typeface="Aptos" pitchFamily="34" charset="-120"/>
                         </a:rPr>
                         <a:t>contexts</a:t>
                       </a:r>
                       <a:endParaRPr lang="en-US" sz="1200" dirty="0">
-                        <a:latin typeface="Calibri" charset="0"/>
-                        <a:ea typeface="Calibri" charset="0"/>
-                        <a:cs typeface="Calibri" charset="0"/>
+                        <a:latin typeface="Aptos" charset="0"/>
+                        <a:ea typeface="Aptos" charset="0"/>
+                        <a:cs typeface="Aptos" charset="0"/>
                       </a:endParaRPr>
                     </a:p>
                   </a:txBody>
@@ -4821,16 +4821,16 @@
                           <a:solidFill>
                             <a:srgbClr val="FFFFFF"/>
                           </a:solidFill>
-                          <a:latin typeface="Calibri" pitchFamily="34" charset="0"/>
-                          <a:ea typeface="Calibri" pitchFamily="34" charset="-122"/>
-                          <a:cs typeface="Calibri" pitchFamily="34" charset="-120"/>
+                          <a:latin typeface="Aptos" pitchFamily="34" charset="0"/>
+                          <a:ea typeface="Aptos" pitchFamily="34" charset="-122"/>
+                          <a:cs typeface="Aptos" pitchFamily="34" charset="-120"/>
                         </a:rPr>
                         <a:t>elements</a:t>
                       </a:r>
                       <a:endParaRPr lang="en-US" sz="1200" dirty="0">
-                        <a:latin typeface="Calibri" charset="0"/>
-                        <a:ea typeface="Calibri" charset="0"/>
-                        <a:cs typeface="Calibri" charset="0"/>
+                        <a:latin typeface="Aptos" charset="0"/>
+                        <a:ea typeface="Aptos" charset="0"/>
+                        <a:cs typeface="Aptos" charset="0"/>
                       </a:endParaRPr>
                     </a:p>
                   </a:txBody>
@@ -4889,16 +4889,16 @@
                           <a:solidFill>
                             <a:srgbClr val="FFFFFF"/>
                           </a:solidFill>
-                          <a:latin typeface="Calibri" pitchFamily="34" charset="0"/>
-                          <a:ea typeface="Calibri" pitchFamily="34" charset="-122"/>
-                          <a:cs typeface="Calibri" pitchFamily="34" charset="-120"/>
+                          <a:latin typeface="Aptos" pitchFamily="34" charset="0"/>
+                          <a:ea typeface="Aptos" pitchFamily="34" charset="-122"/>
+                          <a:cs typeface="Aptos" pitchFamily="34" charset="-120"/>
                         </a:rPr>
                         <a:t>seed</a:t>
                       </a:r>
                       <a:endParaRPr lang="en-US" sz="1200" dirty="0">
-                        <a:latin typeface="Calibri" charset="0"/>
-                        <a:ea typeface="Calibri" charset="0"/>
-                        <a:cs typeface="Calibri" charset="0"/>
+                        <a:latin typeface="Aptos" charset="0"/>
+                        <a:ea typeface="Aptos" charset="0"/>
+                        <a:cs typeface="Aptos" charset="0"/>
                       </a:endParaRPr>
                     </a:p>
                   </a:txBody>
@@ -4959,16 +4959,16 @@
                           <a:solidFill>
                             <a:srgbClr val="0B0B0B"/>
                           </a:solidFill>
-                          <a:latin typeface="Calibri" pitchFamily="34" charset="0"/>
-                          <a:ea typeface="Calibri" pitchFamily="34" charset="-122"/>
-                          <a:cs typeface="Calibri" pitchFamily="34" charset="-120"/>
+                          <a:latin typeface="Aptos" pitchFamily="34" charset="0"/>
+                          <a:ea typeface="Aptos" pitchFamily="34" charset="-122"/>
+                          <a:cs typeface="Aptos" pitchFamily="34" charset="-120"/>
                         </a:rPr>
                         <a:t>train</a:t>
                       </a:r>
                       <a:endParaRPr lang="en-US" sz="1200" dirty="0">
-                        <a:latin typeface="Calibri" charset="0"/>
-                        <a:ea typeface="Calibri" charset="0"/>
-                        <a:cs typeface="Calibri" charset="0"/>
+                        <a:latin typeface="Aptos" charset="0"/>
+                        <a:ea typeface="Aptos" charset="0"/>
+                        <a:cs typeface="Aptos" charset="0"/>
                       </a:endParaRPr>
                     </a:p>
                   </a:txBody>
@@ -5024,16 +5024,16 @@
                           <a:solidFill>
                             <a:srgbClr val="0B0B0B"/>
                           </a:solidFill>
-                          <a:latin typeface="Calibri" pitchFamily="34" charset="0"/>
-                          <a:ea typeface="Calibri" pitchFamily="34" charset="-122"/>
-                          <a:cs typeface="Calibri" pitchFamily="34" charset="-120"/>
+                          <a:latin typeface="Aptos" pitchFamily="34" charset="0"/>
+                          <a:ea typeface="Aptos" pitchFamily="34" charset="-122"/>
+                          <a:cs typeface="Aptos" pitchFamily="34" charset="-120"/>
                         </a:rPr>
                         <a:t>5,000</a:t>
                       </a:r>
                       <a:endParaRPr lang="en-US" sz="1200" dirty="0">
-                        <a:latin typeface="Calibri" charset="0"/>
-                        <a:ea typeface="Calibri" charset="0"/>
-                        <a:cs typeface="Calibri" charset="0"/>
+                        <a:latin typeface="Aptos" charset="0"/>
+                        <a:ea typeface="Aptos" charset="0"/>
+                        <a:cs typeface="Aptos" charset="0"/>
                       </a:endParaRPr>
                     </a:p>
                   </a:txBody>
@@ -5089,16 +5089,16 @@
                           <a:solidFill>
                             <a:srgbClr val="0B0B0B"/>
                           </a:solidFill>
-                          <a:latin typeface="Calibri" pitchFamily="34" charset="0"/>
-                          <a:ea typeface="Calibri" pitchFamily="34" charset="-122"/>
-                          <a:cs typeface="Calibri" pitchFamily="34" charset="-120"/>
+                          <a:latin typeface="Aptos" pitchFamily="34" charset="0"/>
+                          <a:ea typeface="Aptos" pitchFamily="34" charset="-122"/>
+                          <a:cs typeface="Aptos" pitchFamily="34" charset="-120"/>
                         </a:rPr>
                         <a:t>22,500</a:t>
                       </a:r>
                       <a:endParaRPr lang="en-US" sz="1200" dirty="0">
-                        <a:latin typeface="Calibri" charset="0"/>
-                        <a:ea typeface="Calibri" charset="0"/>
-                        <a:cs typeface="Calibri" charset="0"/>
+                        <a:latin typeface="Aptos" charset="0"/>
+                        <a:ea typeface="Aptos" charset="0"/>
+                        <a:cs typeface="Aptos" charset="0"/>
                       </a:endParaRPr>
                     </a:p>
                   </a:txBody>
@@ -5154,16 +5154,16 @@
                           <a:solidFill>
                             <a:srgbClr val="0B0B0B"/>
                           </a:solidFill>
-                          <a:latin typeface="Calibri" pitchFamily="34" charset="0"/>
-                          <a:ea typeface="Calibri" pitchFamily="34" charset="-122"/>
-                          <a:cs typeface="Calibri" pitchFamily="34" charset="-120"/>
+                          <a:latin typeface="Aptos" pitchFamily="34" charset="0"/>
+                          <a:ea typeface="Aptos" pitchFamily="34" charset="-122"/>
+                          <a:cs typeface="Aptos" pitchFamily="34" charset="-120"/>
                         </a:rPr>
                         <a:t>1000</a:t>
                       </a:r>
                       <a:endParaRPr lang="en-US" sz="1200" dirty="0">
-                        <a:latin typeface="Calibri" charset="0"/>
-                        <a:ea typeface="Calibri" charset="0"/>
-                        <a:cs typeface="Calibri" charset="0"/>
+                        <a:latin typeface="Aptos" charset="0"/>
+                        <a:ea typeface="Aptos" charset="0"/>
+                        <a:cs typeface="Aptos" charset="0"/>
                       </a:endParaRPr>
                     </a:p>
                   </a:txBody>
@@ -5221,16 +5221,16 @@
                           <a:solidFill>
                             <a:srgbClr val="0B0B0B"/>
                           </a:solidFill>
-                          <a:latin typeface="Calibri" pitchFamily="34" charset="0"/>
-                          <a:ea typeface="Calibri" pitchFamily="34" charset="-122"/>
-                          <a:cs typeface="Calibri" pitchFamily="34" charset="-120"/>
+                          <a:latin typeface="Aptos" pitchFamily="34" charset="0"/>
+                          <a:ea typeface="Aptos" pitchFamily="34" charset="-122"/>
+                          <a:cs typeface="Aptos" pitchFamily="34" charset="-120"/>
                         </a:rPr>
                         <a:t>validation</a:t>
                       </a:r>
                       <a:endParaRPr lang="en-US" sz="1200" dirty="0">
-                        <a:latin typeface="Calibri" charset="0"/>
-                        <a:ea typeface="Calibri" charset="0"/>
-                        <a:cs typeface="Calibri" charset="0"/>
+                        <a:latin typeface="Aptos" charset="0"/>
+                        <a:ea typeface="Aptos" charset="0"/>
+                        <a:cs typeface="Aptos" charset="0"/>
                       </a:endParaRPr>
                     </a:p>
                   </a:txBody>
@@ -5286,16 +5286,16 @@
                           <a:solidFill>
                             <a:srgbClr val="0B0B0B"/>
                           </a:solidFill>
-                          <a:latin typeface="Calibri" pitchFamily="34" charset="0"/>
-                          <a:ea typeface="Calibri" pitchFamily="34" charset="-122"/>
-                          <a:cs typeface="Calibri" pitchFamily="34" charset="-120"/>
+                          <a:latin typeface="Aptos" pitchFamily="34" charset="0"/>
+                          <a:ea typeface="Aptos" pitchFamily="34" charset="-122"/>
+                          <a:cs typeface="Aptos" pitchFamily="34" charset="-120"/>
                         </a:rPr>
                         <a:t>500</a:t>
                       </a:r>
                       <a:endParaRPr lang="en-US" sz="1200" dirty="0">
-                        <a:latin typeface="Calibri" charset="0"/>
-                        <a:ea typeface="Calibri" charset="0"/>
-                        <a:cs typeface="Calibri" charset="0"/>
+                        <a:latin typeface="Aptos" charset="0"/>
+                        <a:ea typeface="Aptos" charset="0"/>
+                        <a:cs typeface="Aptos" charset="0"/>
                       </a:endParaRPr>
                     </a:p>
                   </a:txBody>
@@ -5351,16 +5351,16 @@
                           <a:solidFill>
                             <a:srgbClr val="0B0B0B"/>
                           </a:solidFill>
-                          <a:latin typeface="Calibri" pitchFamily="34" charset="0"/>
-                          <a:ea typeface="Calibri" pitchFamily="34" charset="-122"/>
-                          <a:cs typeface="Calibri" pitchFamily="34" charset="-120"/>
+                          <a:latin typeface="Aptos" pitchFamily="34" charset="0"/>
+                          <a:ea typeface="Aptos" pitchFamily="34" charset="-122"/>
+                          <a:cs typeface="Aptos" pitchFamily="34" charset="-120"/>
                         </a:rPr>
                         <a:t>2,242</a:t>
                       </a:r>
                       <a:endParaRPr lang="en-US" sz="1200" dirty="0">
-                        <a:latin typeface="Calibri" charset="0"/>
-                        <a:ea typeface="Calibri" charset="0"/>
-                        <a:cs typeface="Calibri" charset="0"/>
+                        <a:latin typeface="Aptos" charset="0"/>
+                        <a:ea typeface="Aptos" charset="0"/>
+                        <a:cs typeface="Aptos" charset="0"/>
                       </a:endParaRPr>
                     </a:p>
                   </a:txBody>
@@ -5416,16 +5416,16 @@
                           <a:solidFill>
                             <a:srgbClr val="0B0B0B"/>
                           </a:solidFill>
-                          <a:latin typeface="Calibri" pitchFamily="34" charset="0"/>
-                          <a:ea typeface="Calibri" pitchFamily="34" charset="-122"/>
-                          <a:cs typeface="Calibri" pitchFamily="34" charset="-120"/>
+                          <a:latin typeface="Aptos" pitchFamily="34" charset="0"/>
+                          <a:ea typeface="Aptos" pitchFamily="34" charset="-122"/>
+                          <a:cs typeface="Aptos" pitchFamily="34" charset="-120"/>
                         </a:rPr>
                         <a:t>2000</a:t>
                       </a:r>
                       <a:endParaRPr lang="en-US" sz="1200" dirty="0">
-                        <a:latin typeface="Calibri" charset="0"/>
-                        <a:ea typeface="Calibri" charset="0"/>
-                        <a:cs typeface="Calibri" charset="0"/>
+                        <a:latin typeface="Aptos" charset="0"/>
+                        <a:ea typeface="Aptos" charset="0"/>
+                        <a:cs typeface="Aptos" charset="0"/>
                       </a:endParaRPr>
                     </a:p>
                   </a:txBody>
@@ -5483,16 +5483,16 @@
                           <a:solidFill>
                             <a:srgbClr val="0B0B0B"/>
                           </a:solidFill>
-                          <a:latin typeface="Calibri" pitchFamily="34" charset="0"/>
-                          <a:ea typeface="Calibri" pitchFamily="34" charset="-122"/>
-                          <a:cs typeface="Calibri" pitchFamily="34" charset="-120"/>
+                          <a:latin typeface="Aptos" pitchFamily="34" charset="0"/>
+                          <a:ea typeface="Aptos" pitchFamily="34" charset="-122"/>
+                          <a:cs typeface="Aptos" pitchFamily="34" charset="-120"/>
                         </a:rPr>
                         <a:t>test</a:t>
                       </a:r>
                       <a:endParaRPr lang="en-US" sz="1200" dirty="0">
-                        <a:latin typeface="Calibri" charset="0"/>
-                        <a:ea typeface="Calibri" charset="0"/>
-                        <a:cs typeface="Calibri" charset="0"/>
+                        <a:latin typeface="Aptos" charset="0"/>
+                        <a:ea typeface="Aptos" charset="0"/>
+                        <a:cs typeface="Aptos" charset="0"/>
                       </a:endParaRPr>
                     </a:p>
                   </a:txBody>
@@ -5548,16 +5548,16 @@
                           <a:solidFill>
                             <a:srgbClr val="0B0B0B"/>
                           </a:solidFill>
-                          <a:latin typeface="Calibri" pitchFamily="34" charset="0"/>
-                          <a:ea typeface="Calibri" pitchFamily="34" charset="-122"/>
-                          <a:cs typeface="Calibri" pitchFamily="34" charset="-120"/>
+                          <a:latin typeface="Aptos" pitchFamily="34" charset="0"/>
+                          <a:ea typeface="Aptos" pitchFamily="34" charset="-122"/>
+                          <a:cs typeface="Aptos" pitchFamily="34" charset="-120"/>
                         </a:rPr>
                         <a:t>500</a:t>
                       </a:r>
                       <a:endParaRPr lang="en-US" sz="1200" dirty="0">
-                        <a:latin typeface="Calibri" charset="0"/>
-                        <a:ea typeface="Calibri" charset="0"/>
-                        <a:cs typeface="Calibri" charset="0"/>
+                        <a:latin typeface="Aptos" charset="0"/>
+                        <a:ea typeface="Aptos" charset="0"/>
+                        <a:cs typeface="Aptos" charset="0"/>
                       </a:endParaRPr>
                     </a:p>
                   </a:txBody>
@@ -5613,16 +5613,16 @@
                           <a:solidFill>
                             <a:srgbClr val="0B0B0B"/>
                           </a:solidFill>
-                          <a:latin typeface="Calibri" pitchFamily="34" charset="0"/>
-                          <a:ea typeface="Calibri" pitchFamily="34" charset="-122"/>
-                          <a:cs typeface="Calibri" pitchFamily="34" charset="-120"/>
+                          <a:latin typeface="Aptos" pitchFamily="34" charset="0"/>
+                          <a:ea typeface="Aptos" pitchFamily="34" charset="-122"/>
+                          <a:cs typeface="Aptos" pitchFamily="34" charset="-120"/>
                         </a:rPr>
                         <a:t>2,242</a:t>
                       </a:r>
                       <a:endParaRPr lang="en-US" sz="1200" dirty="0">
-                        <a:latin typeface="Calibri" charset="0"/>
-                        <a:ea typeface="Calibri" charset="0"/>
-                        <a:cs typeface="Calibri" charset="0"/>
+                        <a:latin typeface="Aptos" charset="0"/>
+                        <a:ea typeface="Aptos" charset="0"/>
+                        <a:cs typeface="Aptos" charset="0"/>
                       </a:endParaRPr>
                     </a:p>
                   </a:txBody>
@@ -5678,16 +5678,16 @@
                           <a:solidFill>
                             <a:srgbClr val="0B0B0B"/>
                           </a:solidFill>
-                          <a:latin typeface="Calibri" pitchFamily="34" charset="0"/>
-                          <a:ea typeface="Calibri" pitchFamily="34" charset="-122"/>
-                          <a:cs typeface="Calibri" pitchFamily="34" charset="-120"/>
+                          <a:latin typeface="Aptos" pitchFamily="34" charset="0"/>
+                          <a:ea typeface="Aptos" pitchFamily="34" charset="-122"/>
+                          <a:cs typeface="Aptos" pitchFamily="34" charset="-120"/>
                         </a:rPr>
                         <a:t>3000</a:t>
                       </a:r>
                       <a:endParaRPr lang="en-US" sz="1200" dirty="0">
-                        <a:latin typeface="Calibri" charset="0"/>
-                        <a:ea typeface="Calibri" charset="0"/>
-                        <a:cs typeface="Calibri" charset="0"/>
+                        <a:latin typeface="Aptos" charset="0"/>
+                        <a:ea typeface="Aptos" charset="0"/>
+                        <a:cs typeface="Aptos" charset="0"/>
                       </a:endParaRPr>
                     </a:p>
                   </a:txBody>
@@ -5745,16 +5745,16 @@
                           <a:solidFill>
                             <a:srgbClr val="0B0B0B"/>
                           </a:solidFill>
-                          <a:latin typeface="Calibri" pitchFamily="34" charset="0"/>
-                          <a:ea typeface="Calibri" pitchFamily="34" charset="-122"/>
-                          <a:cs typeface="Calibri" pitchFamily="34" charset="-120"/>
+                          <a:latin typeface="Aptos" pitchFamily="34" charset="0"/>
+                          <a:ea typeface="Aptos" pitchFamily="34" charset="-122"/>
+                          <a:cs typeface="Aptos" pitchFamily="34" charset="-120"/>
                         </a:rPr>
                         <a:t>benchmark</a:t>
                       </a:r>
                       <a:endParaRPr lang="en-US" sz="1200" dirty="0">
-                        <a:latin typeface="Calibri" charset="0"/>
-                        <a:ea typeface="Calibri" charset="0"/>
-                        <a:cs typeface="Calibri" charset="0"/>
+                        <a:latin typeface="Aptos" charset="0"/>
+                        <a:ea typeface="Aptos" charset="0"/>
+                        <a:cs typeface="Aptos" charset="0"/>
                       </a:endParaRPr>
                     </a:p>
                   </a:txBody>
@@ -5810,16 +5810,16 @@
                           <a:solidFill>
                             <a:srgbClr val="0B0B0B"/>
                           </a:solidFill>
-                          <a:latin typeface="Calibri" pitchFamily="34" charset="0"/>
-                          <a:ea typeface="Calibri" pitchFamily="34" charset="-122"/>
-                          <a:cs typeface="Calibri" pitchFamily="34" charset="-120"/>
+                          <a:latin typeface="Aptos" pitchFamily="34" charset="0"/>
+                          <a:ea typeface="Aptos" pitchFamily="34" charset="-122"/>
+                          <a:cs typeface="Aptos" pitchFamily="34" charset="-120"/>
                         </a:rPr>
                         <a:t>1,000</a:t>
                       </a:r>
                       <a:endParaRPr lang="en-US" sz="1200" dirty="0">
-                        <a:latin typeface="Calibri" charset="0"/>
-                        <a:ea typeface="Calibri" charset="0"/>
-                        <a:cs typeface="Calibri" charset="0"/>
+                        <a:latin typeface="Aptos" charset="0"/>
+                        <a:ea typeface="Aptos" charset="0"/>
+                        <a:cs typeface="Aptos" charset="0"/>
                       </a:endParaRPr>
                     </a:p>
                   </a:txBody>
@@ -5875,16 +5875,16 @@
                           <a:solidFill>
                             <a:srgbClr val="0B0B0B"/>
                           </a:solidFill>
-                          <a:latin typeface="Calibri" pitchFamily="34" charset="0"/>
-                          <a:ea typeface="Calibri" pitchFamily="34" charset="-122"/>
-                          <a:cs typeface="Calibri" pitchFamily="34" charset="-120"/>
+                          <a:latin typeface="Aptos" pitchFamily="34" charset="0"/>
+                          <a:ea typeface="Aptos" pitchFamily="34" charset="-122"/>
+                          <a:cs typeface="Aptos" pitchFamily="34" charset="-120"/>
                         </a:rPr>
                         <a:t>4,500</a:t>
                       </a:r>
                       <a:endParaRPr lang="en-US" sz="1200" dirty="0">
-                        <a:latin typeface="Calibri" charset="0"/>
-                        <a:ea typeface="Calibri" charset="0"/>
-                        <a:cs typeface="Calibri" charset="0"/>
+                        <a:latin typeface="Aptos" charset="0"/>
+                        <a:ea typeface="Aptos" charset="0"/>
+                        <a:cs typeface="Aptos" charset="0"/>
                       </a:endParaRPr>
                     </a:p>
                   </a:txBody>
@@ -5940,16 +5940,16 @@
                           <a:solidFill>
                             <a:srgbClr val="0B0B0B"/>
                           </a:solidFill>
-                          <a:latin typeface="Calibri" pitchFamily="34" charset="0"/>
-                          <a:ea typeface="Calibri" pitchFamily="34" charset="-122"/>
-                          <a:cs typeface="Calibri" pitchFamily="34" charset="-120"/>
+                          <a:latin typeface="Aptos" pitchFamily="34" charset="0"/>
+                          <a:ea typeface="Aptos" pitchFamily="34" charset="-122"/>
+                          <a:cs typeface="Aptos" pitchFamily="34" charset="-120"/>
                         </a:rPr>
                         <a:t>42</a:t>
                       </a:r>
                       <a:endParaRPr lang="en-US" sz="1200" dirty="0">
-                        <a:latin typeface="Calibri" charset="0"/>
-                        <a:ea typeface="Calibri" charset="0"/>
-                        <a:cs typeface="Calibri" charset="0"/>
+                        <a:latin typeface="Aptos" charset="0"/>
+                        <a:ea typeface="Aptos" charset="0"/>
+                        <a:cs typeface="Aptos" charset="0"/>
                       </a:endParaRPr>
                     </a:p>
                   </a:txBody>
@@ -6007,16 +6007,16 @@
                           <a:solidFill>
                             <a:srgbClr val="0B0B0B"/>
                           </a:solidFill>
-                          <a:latin typeface="Calibri" pitchFamily="34" charset="0"/>
-                          <a:ea typeface="Calibri" pitchFamily="34" charset="-122"/>
-                          <a:cs typeface="Calibri" pitchFamily="34" charset="-120"/>
+                          <a:latin typeface="Aptos" pitchFamily="34" charset="0"/>
+                          <a:ea typeface="Aptos" pitchFamily="34" charset="-122"/>
+                          <a:cs typeface="Aptos" pitchFamily="34" charset="-120"/>
                         </a:rPr>
                         <a:t>total</a:t>
                       </a:r>
                       <a:endParaRPr lang="en-US" sz="1200" dirty="0">
-                        <a:latin typeface="Calibri" charset="0"/>
-                        <a:ea typeface="Calibri" charset="0"/>
-                        <a:cs typeface="Calibri" charset="0"/>
+                        <a:latin typeface="Aptos" charset="0"/>
+                        <a:ea typeface="Aptos" charset="0"/>
+                        <a:cs typeface="Aptos" charset="0"/>
                       </a:endParaRPr>
                     </a:p>
                   </a:txBody>
@@ -6072,16 +6072,16 @@
                           <a:solidFill>
                             <a:srgbClr val="0B0B0B"/>
                           </a:solidFill>
-                          <a:latin typeface="Calibri" pitchFamily="34" charset="0"/>
-                          <a:ea typeface="Calibri" pitchFamily="34" charset="-122"/>
-                          <a:cs typeface="Calibri" pitchFamily="34" charset="-120"/>
+                          <a:latin typeface="Aptos" pitchFamily="34" charset="0"/>
+                          <a:ea typeface="Aptos" pitchFamily="34" charset="-122"/>
+                          <a:cs typeface="Aptos" pitchFamily="34" charset="-120"/>
                         </a:rPr>
                         <a:t>7,000</a:t>
                       </a:r>
                       <a:endParaRPr lang="en-US" sz="1200" dirty="0">
-                        <a:latin typeface="Calibri" charset="0"/>
-                        <a:ea typeface="Calibri" charset="0"/>
-                        <a:cs typeface="Calibri" charset="0"/>
+                        <a:latin typeface="Aptos" charset="0"/>
+                        <a:ea typeface="Aptos" charset="0"/>
+                        <a:cs typeface="Aptos" charset="0"/>
                       </a:endParaRPr>
                     </a:p>
                   </a:txBody>
@@ -6137,16 +6137,16 @@
                           <a:solidFill>
                             <a:srgbClr val="0B0B0B"/>
                           </a:solidFill>
-                          <a:latin typeface="Calibri" pitchFamily="34" charset="0"/>
-                          <a:ea typeface="Calibri" pitchFamily="34" charset="-122"/>
-                          <a:cs typeface="Calibri" pitchFamily="34" charset="-120"/>
+                          <a:latin typeface="Aptos" pitchFamily="34" charset="0"/>
+                          <a:ea typeface="Aptos" pitchFamily="34" charset="-122"/>
+                          <a:cs typeface="Aptos" pitchFamily="34" charset="-120"/>
                         </a:rPr>
                         <a:t>31,484</a:t>
                       </a:r>
                       <a:endParaRPr lang="en-US" sz="1200" dirty="0">
-                        <a:latin typeface="Calibri" charset="0"/>
-                        <a:ea typeface="Calibri" charset="0"/>
-                        <a:cs typeface="Calibri" charset="0"/>
+                        <a:latin typeface="Aptos" charset="0"/>
+                        <a:ea typeface="Aptos" charset="0"/>
+                        <a:cs typeface="Aptos" charset="0"/>
                       </a:endParaRPr>
                     </a:p>
                   </a:txBody>
@@ -6198,9 +6198,9 @@
                         <a:buNone/>
                       </a:pPr>
                       <a:endParaRPr lang="en-US" sz="1200" dirty="0">
-                        <a:latin typeface="Calibri" charset="0"/>
-                        <a:ea typeface="Calibri" charset="0"/>
-                        <a:cs typeface="Calibri" charset="0"/>
+                        <a:latin typeface="Aptos" charset="0"/>
+                        <a:ea typeface="Aptos" charset="0"/>
+                        <a:cs typeface="Aptos" charset="0"/>
                       </a:endParaRPr>
                     </a:p>
                   </a:txBody>
@@ -6850,8 +6850,8 @@
         </p:nvSpPr>
         <p:spPr>
           <a:xfrm>
-            <a:off x="548640" y="5568825"/>
-            <a:ext cx="11091672" cy="731520"/>
+            <a:off x="548640" y="5550537"/>
+            <a:ext cx="11091672" cy="640080"/>
           </a:xfrm>
           <a:prstGeom prst="rect">
             <a:avLst/>
@@ -6867,14 +6867,50 @@
               <a:buNone/>
             </a:pPr>
             <a:r>
-              <a:rPr lang="en-US" sz="1250" dirty="0">
+              <a:rPr lang="en-US" sz="1200" dirty="0">
                 <a:solidFill>
                   <a:srgbClr val="52514E"/>
                 </a:solidFill>
               </a:rPr>
-              <a:t>The gap distribution was fitted on the duplex; the clinic was held out. Clear gaps between side-by-side pipes, on sections every 250 mm. Clinic (797 pipe pairs): 32 mm from the generated gaps (95 % CI 17–48), more than the 8 mm a perfect generator would show, and about as close as the duplex’s own two models are to each other (26 mm). Models: buildingSMART Duplex Apartment and Medical-Dental Clinic, CC BY 4.0.</a:t>
-            </a:r>
-            <a:endParaRPr lang="en-US" sz="1250" dirty="0"/>
+              <a:t>The gap distribution was fitted on the duplex; the clinic was held out. Clear gaps between side-by-side pipes, on sections every 250 mm. Clinic (797 pipe pairs): 32 mm from the generated gaps (95 % CI 17–48), more than the 8 mm a perfect generator would show, and about as close as the duplex’s own two models are to each other (26 mm). Models: buildingSMART Duplex Apartment and Medical-Dental Clinic [12].</a:t>
+            </a:r>
+            <a:endParaRPr lang="en-US" sz="1200" dirty="0"/>
+          </a:p>
+        </p:txBody>
+      </p:sp>
+      <p:sp>
+        <p:nvSpPr>
+          <p:cNvPr id="5" name="references"/>
+          <p:cNvSpPr txBox="1"/>
+          <p:nvPr/>
+        </p:nvSpPr>
+        <p:spPr>
+          <a:xfrm>
+            <a:off x="548640" y="6217920"/>
+            <a:ext cx="11091672" cy="237744"/>
+          </a:xfrm>
+          <a:prstGeom prst="rect">
+            <a:avLst/>
+          </a:prstGeom>
+          <a:noFill/>
+          <a:ln/>
+        </p:spPr>
+        <p:txBody>
+          <a:bodyPr wrap="square" lIns="0" tIns="0" rIns="0" bIns="0" rtlCol="0" anchor="b"/>
+          <a:lstStyle/>
+          <a:p>
+            <a:pPr indent="0" marL="0">
+              <a:buNone/>
+            </a:pPr>
+            <a:r>
+              <a:rPr lang="en-US" sz="800" dirty="0">
+                <a:solidFill>
+                  <a:srgbClr val="52514E"/>
+                </a:solidFill>
+              </a:rPr>
+              <a:t>[12] buildingSMART International (2020), Duplex Apartment and Medical-Dental Clinic sample IFC files, CC BY 4.0</a:t>
+            </a:r>
+            <a:endParaRPr lang="en-US" sz="800" dirty="0"/>
           </a:p>
         </p:txBody>
       </p:sp>
@@ -7020,7 +7056,7 @@
       </p:graphicFrame>
       <p:sp>
         <p:nvSpPr>
-          <p:cNvPr id="5" name="tile of benchmark pipes attachable with the paper’s two sizes (95 % CI 12.7–16.2); every one is DN40"/>
+          <p:cNvPr id="5" name="tile of benchmark pipes attachable with the paper’s two sizes [2] (95 % CI 12.7–16.2); every one is DN40"/>
           <p:cNvSpPr/>
           <p:nvPr/>
         </p:nvSpPr>
@@ -7042,7 +7078,7 @@
       </p:sp>
       <p:sp>
         <p:nvSpPr>
-          <p:cNvPr id="6" name="value of benchmark pipes attachable with the paper’s two sizes (95 % CI 12.7–16.2); every one is DN40"/>
+          <p:cNvPr id="6" name="value of benchmark pipes attachable with the paper’s two sizes [2] (95 % CI 12.7–16.2); every one is DN40"/>
           <p:cNvSpPr txBox="1"/>
           <p:nvPr/>
         </p:nvSpPr>
@@ -7078,7 +7114,7 @@
       </p:sp>
       <p:sp>
         <p:nvSpPr>
-          <p:cNvPr id="7" name="label of benchmark pipes attachable with the paper’s two sizes (95 % CI 12.7–16.2); every one is DN40"/>
+          <p:cNvPr id="7" name="label of benchmark pipes attachable with the paper’s two sizes [2] (95 % CI 12.7–16.2); every one is DN40"/>
           <p:cNvSpPr txBox="1"/>
           <p:nvPr/>
         </p:nvSpPr>
@@ -7106,7 +7142,7 @@
                   <a:srgbClr val="52514E"/>
                 </a:solidFill>
               </a:rPr>
-              <a:t>of benchmark pipes attachable with the paper’s two sizes (95 % CI 12.7–16.2); every one is DN40</a:t>
+              <a:t>of benchmark pipes attachable with the paper’s two sizes [2] (95 % CI 12.7–16.2); every one is DN40</a:t>
             </a:r>
             <a:endParaRPr lang="en-US" sz="1100" dirty="0"/>
           </a:p>
@@ -7297,6 +7333,42 @@
               <a:t>trays, ducts and conduits: a pipe-clamp catalog defines no attachment. Load never binds (1.97 vs 2.5 kN)</a:t>
             </a:r>
             <a:endParaRPr lang="en-US" sz="1100" dirty="0"/>
+          </a:p>
+        </p:txBody>
+      </p:sp>
+      <p:sp>
+        <p:nvSpPr>
+          <p:cNvPr id="14" name="references"/>
+          <p:cNvSpPr txBox="1"/>
+          <p:nvPr/>
+        </p:nvSpPr>
+        <p:spPr>
+          <a:xfrm>
+            <a:off x="548640" y="6163056"/>
+            <a:ext cx="11091672" cy="237744"/>
+          </a:xfrm>
+          <a:prstGeom prst="rect">
+            <a:avLst/>
+          </a:prstGeom>
+          <a:noFill/>
+          <a:ln/>
+        </p:spPr>
+        <p:txBody>
+          <a:bodyPr wrap="square" lIns="0" tIns="0" rIns="0" bIns="0" rtlCol="0" anchor="b"/>
+          <a:lstStyle/>
+          <a:p>
+            <a:pPr indent="0" marL="0">
+              <a:buNone/>
+            </a:pPr>
+            <a:r>
+              <a:rPr lang="en-US" sz="800" dirty="0">
+                <a:solidFill>
+                  <a:srgbClr val="52514E"/>
+                </a:solidFill>
+              </a:rPr>
+              <a:t>[2] Pedrollo, Gvadzabia, Graeber &amp; Fischer (2026), CrossMEP, CIB W78 2026 (this paper)</a:t>
+            </a:r>
+            <a:endParaRPr lang="en-US" sz="800" dirty="0"/>
           </a:p>
         </p:txBody>
       </p:sp>
@@ -9537,14 +9609,14 @@
       </p:sp>
       <p:sp>
         <p:nvSpPr>
-          <p:cNvPr id="19" name="estimates note"/>
+          <p:cNvPr id="19" name="references"/>
           <p:cNvSpPr txBox="1"/>
           <p:nvPr/>
         </p:nvSpPr>
         <p:spPr>
           <a:xfrm>
-            <a:off x="548640" y="6126480"/>
-            <a:ext cx="5486400" cy="228600"/>
+            <a:off x="548640" y="6163056"/>
+            <a:ext cx="11091672" cy="237744"/>
           </a:xfrm>
           <a:prstGeom prst="rect">
             <a:avLst/>
@@ -9553,21 +9625,21 @@
           <a:ln/>
         </p:spPr>
         <p:txBody>
-          <a:bodyPr wrap="square" lIns="0" tIns="0" rIns="0" bIns="0" rtlCol="0" anchor="t"/>
+          <a:bodyPr wrap="square" lIns="0" tIns="0" rIns="0" bIns="0" rtlCol="0" anchor="b"/>
           <a:lstStyle/>
           <a:p>
             <a:pPr indent="0" marL="0">
               <a:buNone/>
             </a:pPr>
             <a:r>
-              <a:rPr lang="en-US" sz="1100" dirty="0">
+              <a:rPr lang="en-US" sz="800" dirty="0">
                 <a:solidFill>
                   <a:srgbClr val="52514E"/>
                 </a:solidFill>
               </a:rPr>
-              <a:t>Approximate practitioner estimates.</a:t>
-            </a:r>
-            <a:endParaRPr lang="en-US" sz="1100" dirty="0"/>
+              <a:t>Approximate practitioner estimates [1].   [1] Pedrollo, Graeber &amp; Fischer (2026), Feasibility-aware sequential synthesis of structural support assemblies, ISARC 2026</a:t>
+            </a:r>
+            <a:endParaRPr lang="en-US" sz="800" dirty="0"/>
           </a:p>
         </p:txBody>
       </p:sp>
@@ -11537,14 +11609,14 @@
       </p:sp>
       <p:sp>
         <p:nvSpPr>
-          <p:cNvPr id="72" name="isarc note"/>
+          <p:cNvPr id="72" name="references"/>
           <p:cNvSpPr txBox="1"/>
           <p:nvPr/>
         </p:nvSpPr>
         <p:spPr>
           <a:xfrm>
-            <a:off x="548640" y="6108192"/>
-            <a:ext cx="5486400" cy="228600"/>
+            <a:off x="548640" y="6163056"/>
+            <a:ext cx="11091672" cy="237744"/>
           </a:xfrm>
           <a:prstGeom prst="rect">
             <a:avLst/>
@@ -11553,21 +11625,21 @@
           <a:ln/>
         </p:spPr>
         <p:txBody>
-          <a:bodyPr wrap="square" lIns="0" tIns="0" rIns="0" bIns="0" rtlCol="0" anchor="t"/>
+          <a:bodyPr wrap="square" lIns="0" tIns="0" rIns="0" bIns="0" rtlCol="0" anchor="b"/>
           <a:lstStyle/>
           <a:p>
             <a:pPr indent="0" marL="0">
               <a:buNone/>
             </a:pPr>
             <a:r>
-              <a:rPr lang="en-US" sz="1100" dirty="0">
+              <a:rPr lang="en-US" sz="800" dirty="0">
                 <a:solidFill>
                   <a:srgbClr val="52514E"/>
                 </a:solidFill>
               </a:rPr>
-              <a:t>The synthesis problem as defined at ISARC 2026.</a:t>
-            </a:r>
-            <a:endParaRPr lang="en-US" sz="1100" dirty="0"/>
+              <a:t>The synthesis problem as defined at ISARC 2026 [1].   [1] Pedrollo, Graeber &amp; Fischer (2026), Feasibility-aware sequential synthesis of structural support assemblies, ISARC 2026</a:t>
+            </a:r>
+            <a:endParaRPr lang="en-US" sz="800" dirty="0"/>
           </a:p>
         </p:txBody>
       </p:sp>
@@ -11733,7 +11805,7 @@
                   <a:srgbClr val="52514E"/>
                 </a:solidFill>
               </a:rPr>
-              <a:t>Design starts after coordination: at each hanger the designer works from the section across the run, not from the whole model.</a:t>
+              <a:t>Design starts after coordination [3]: at each hanger the designer works from the section across the run, not from the whole model [2].</a:t>
             </a:r>
             <a:endParaRPr lang="en-US" sz="1100" dirty="0"/>
           </a:p>
@@ -11847,7 +11919,7 @@
                   <a:schemeClr val="tx1"/>
                 </a:solidFill>
               </a:rPr>
-              <a:t>Choosing the topology and the parts, from a fixed catalog, is still done by hand, one section at a time.</a:t>
+              <a:t>Choosing the topology and the parts, from a fixed catalog, is still done by hand, one section at a time [1].</a:t>
             </a:r>
             <a:endParaRPr lang="en-US" sz="1500" dirty="0"/>
           </a:p>
@@ -12132,6 +12204,42 @@
               <a:t>Catalogs change faster than rule-based systems can be rewritten.</a:t>
             </a:r>
             <a:endParaRPr lang="en-US" sz="1500" dirty="0"/>
+          </a:p>
+        </p:txBody>
+      </p:sp>
+      <p:sp>
+        <p:nvSpPr>
+          <p:cNvPr id="16" name="references"/>
+          <p:cNvSpPr txBox="1"/>
+          <p:nvPr/>
+        </p:nvSpPr>
+        <p:spPr>
+          <a:xfrm>
+            <a:off x="548640" y="6163056"/>
+            <a:ext cx="11091672" cy="237744"/>
+          </a:xfrm>
+          <a:prstGeom prst="rect">
+            <a:avLst/>
+          </a:prstGeom>
+          <a:noFill/>
+          <a:ln/>
+        </p:spPr>
+        <p:txBody>
+          <a:bodyPr wrap="square" lIns="0" tIns="0" rIns="0" bIns="0" rtlCol="0" anchor="b"/>
+          <a:lstStyle/>
+          <a:p>
+            <a:pPr indent="0" marL="0">
+              <a:buNone/>
+            </a:pPr>
+            <a:r>
+              <a:rPr lang="en-US" sz="800" dirty="0">
+                <a:solidFill>
+                  <a:srgbClr val="52514E"/>
+                </a:solidFill>
+              </a:rPr>
+              <a:t>[1] Pedrollo, Graeber &amp; Fischer (2026), Feasibility-aware sequential synthesis of structural support assemblies, ISARC 2026   [2] Pedrollo, Gvadzabia, Graeber &amp; Fischer (2026), CrossMEP, CIB W78 2026 (this paper)   [3] Korman, Fischer &amp; Tatum (2003), Knowledge and reasoning for MEP coordination, J. Constr. Eng. Manage. 129(6)</a:t>
+            </a:r>
+            <a:endParaRPr lang="en-US" sz="800" dirty="0"/>
           </a:p>
         </p:txBody>
       </p:sp>
@@ -16676,7 +16784,7 @@
                   <a:schemeClr val="tx1"/>
                 </a:solidFill>
               </a:rPr>
-              <a:t>Grouped as trades run: hot + cold pairs, flow + return, chilled banks, sprinkler mains, 1–2 trays, ducts, conduit groups of 2–6.</a:t>
+              <a:t>Grouped as trades run [3]: hot + cold pairs, flow + return, chilled banks, sprinkler mains, 1–2 trays, ducts, conduit groups of 2–6.</a:t>
             </a:r>
             <a:endParaRPr lang="en-US" sz="1300" dirty="0"/>
           </a:p>
@@ -16882,7 +16990,7 @@
                   <a:schemeClr val="tx1"/>
                 </a:solidFill>
               </a:rPr>
-              <a:t>Gaps drawn from gaps measured on a built project (at least 25 mm); stagger within rows; electrical above wet on walls.</a:t>
+              <a:t>Gaps drawn from gaps measured on a built project [12] (at least 25 mm); stagger within rows; electrical above wet on walls [10].</a:t>
             </a:r>
             <a:endParaRPr lang="en-US" sz="1300" dirty="0"/>
           </a:p>
@@ -17048,6 +17156,42 @@
               <a:t>One generated benchmark context, three rows by priority; the gap marked is one draw from the measured distribution. Every context is seeded: the same seed gives the same file, byte for byte.</a:t>
             </a:r>
             <a:endParaRPr lang="en-US" sz="1100" dirty="0"/>
+          </a:p>
+        </p:txBody>
+      </p:sp>
+      <p:sp>
+        <p:nvSpPr>
+          <p:cNvPr id="23" name="references"/>
+          <p:cNvSpPr txBox="1"/>
+          <p:nvPr/>
+        </p:nvSpPr>
+        <p:spPr>
+          <a:xfrm>
+            <a:off x="548640" y="6163056"/>
+            <a:ext cx="11091672" cy="237744"/>
+          </a:xfrm>
+          <a:prstGeom prst="rect">
+            <a:avLst/>
+          </a:prstGeom>
+          <a:noFill/>
+          <a:ln/>
+        </p:spPr>
+        <p:txBody>
+          <a:bodyPr wrap="square" lIns="0" tIns="0" rIns="0" bIns="0" rtlCol="0" anchor="b"/>
+          <a:lstStyle/>
+          <a:p>
+            <a:pPr indent="0" marL="0">
+              <a:buNone/>
+            </a:pPr>
+            <a:r>
+              <a:rPr lang="en-US" sz="800" dirty="0">
+                <a:solidFill>
+                  <a:srgbClr val="52514E"/>
+                </a:solidFill>
+              </a:rPr>
+              <a:t>[3] Korman, Fischer &amp; Tatum (2003), Knowledge and reasoning for MEP coordination, J. Constr. Eng. Manage. 129(6)   [10] IET On-Site Guide (BS 7671), conduit support spacing; BS 7671 Reg. 528.3.2   [12] buildingSMART International (2020), Duplex Apartment and Medical-Dental Clinic sample IFC files, CC BY 4.0</a:t>
+            </a:r>
+            <a:endParaRPr lang="en-US" sz="800" dirty="0"/>
           </a:p>
         </p:txBody>
       </p:sp>
@@ -17200,16 +17344,16 @@
                           <a:solidFill>
                             <a:srgbClr val="FFFFFF"/>
                           </a:solidFill>
-                          <a:latin typeface="Calibri" pitchFamily="34" charset="0"/>
-                          <a:ea typeface="Calibri" pitchFamily="34" charset="-122"/>
-                          <a:cs typeface="Calibri" pitchFamily="34" charset="-120"/>
+                          <a:latin typeface="Aptos" pitchFamily="34" charset="0"/>
+                          <a:ea typeface="Aptos" pitchFamily="34" charset="-122"/>
+                          <a:cs typeface="Aptos" pitchFamily="34" charset="-120"/>
                         </a:rPr>
                         <a:t>Element</a:t>
                       </a:r>
                       <a:endParaRPr lang="en-US" sz="1200" dirty="0">
-                        <a:latin typeface="Calibri" charset="0"/>
-                        <a:ea typeface="Calibri" charset="0"/>
-                        <a:cs typeface="Calibri" charset="0"/>
+                        <a:latin typeface="Aptos" charset="0"/>
+                        <a:ea typeface="Aptos" charset="0"/>
+                        <a:cs typeface="Aptos" charset="0"/>
                       </a:endParaRPr>
                     </a:p>
                   </a:txBody>
@@ -17268,16 +17412,16 @@
                           <a:solidFill>
                             <a:srgbClr val="FFFFFF"/>
                           </a:solidFill>
-                          <a:latin typeface="Calibri" pitchFamily="34" charset="0"/>
-                          <a:ea typeface="Calibri" pitchFamily="34" charset="-122"/>
-                          <a:cs typeface="Calibri" pitchFamily="34" charset="-120"/>
+                          <a:latin typeface="Aptos" pitchFamily="34" charset="0"/>
+                          <a:ea typeface="Aptos" pitchFamily="34" charset="-122"/>
+                          <a:cs typeface="Aptos" pitchFamily="34" charset="-120"/>
                         </a:rPr>
                         <a:t>Sizes</a:t>
                       </a:r>
                       <a:endParaRPr lang="en-US" sz="1200" dirty="0">
-                        <a:latin typeface="Calibri" charset="0"/>
-                        <a:ea typeface="Calibri" charset="0"/>
-                        <a:cs typeface="Calibri" charset="0"/>
+                        <a:latin typeface="Aptos" charset="0"/>
+                        <a:ea typeface="Aptos" charset="0"/>
+                        <a:cs typeface="Aptos" charset="0"/>
                       </a:endParaRPr>
                     </a:p>
                   </a:txBody>
@@ -17336,16 +17480,16 @@
                           <a:solidFill>
                             <a:srgbClr val="FFFFFF"/>
                           </a:solidFill>
-                          <a:latin typeface="Calibri" pitchFamily="34" charset="0"/>
-                          <a:ea typeface="Calibri" pitchFamily="34" charset="-122"/>
-                          <a:cs typeface="Calibri" pitchFamily="34" charset="-120"/>
+                          <a:latin typeface="Aptos" pitchFamily="34" charset="0"/>
+                          <a:ea typeface="Aptos" pitchFamily="34" charset="-122"/>
+                          <a:cs typeface="Aptos" pitchFamily="34" charset="-120"/>
                         </a:rPr>
                         <a:t>Load basis</a:t>
                       </a:r>
                       <a:endParaRPr lang="en-US" sz="1200" dirty="0">
-                        <a:latin typeface="Calibri" charset="0"/>
-                        <a:ea typeface="Calibri" charset="0"/>
-                        <a:cs typeface="Calibri" charset="0"/>
+                        <a:latin typeface="Aptos" charset="0"/>
+                        <a:ea typeface="Aptos" charset="0"/>
+                        <a:cs typeface="Aptos" charset="0"/>
                       </a:endParaRPr>
                     </a:p>
                   </a:txBody>
@@ -17406,16 +17550,16 @@
                           <a:solidFill>
                             <a:srgbClr val="0B0B0B"/>
                           </a:solidFill>
-                          <a:latin typeface="Calibri" pitchFamily="34" charset="0"/>
-                          <a:ea typeface="Calibri" pitchFamily="34" charset="-122"/>
-                          <a:cs typeface="Calibri" pitchFamily="34" charset="-120"/>
+                          <a:latin typeface="Aptos" pitchFamily="34" charset="0"/>
+                          <a:ea typeface="Aptos" pitchFamily="34" charset="-122"/>
+                          <a:cs typeface="Aptos" pitchFamily="34" charset="-120"/>
                         </a:rPr>
                         <a:t>Pipes DN15–100</a:t>
                       </a:r>
                       <a:endParaRPr lang="en-US" sz="1200" dirty="0">
-                        <a:latin typeface="Calibri" charset="0"/>
-                        <a:ea typeface="Calibri" charset="0"/>
-                        <a:cs typeface="Calibri" charset="0"/>
+                        <a:latin typeface="Aptos" charset="0"/>
+                        <a:ea typeface="Aptos" charset="0"/>
+                        <a:cs typeface="Aptos" charset="0"/>
                       </a:endParaRPr>
                     </a:p>
                   </a:txBody>
@@ -17471,16 +17615,16 @@
                           <a:solidFill>
                             <a:srgbClr val="0B0B0B"/>
                           </a:solidFill>
-                          <a:latin typeface="Calibri" pitchFamily="34" charset="0"/>
-                          <a:ea typeface="Calibri" pitchFamily="34" charset="-122"/>
-                          <a:cs typeface="Calibri" pitchFamily="34" charset="-120"/>
+                          <a:latin typeface="Aptos" pitchFamily="34" charset="0"/>
+                          <a:ea typeface="Aptos" pitchFamily="34" charset="-122"/>
+                          <a:cs typeface="Aptos" pitchFamily="34" charset="-120"/>
                         </a:rPr>
-                        <a:t>EN 10220 / EN 10255 medium series</a:t>
+                        <a:t>EN 10220 / EN 10255 medium series [4]</a:t>
                       </a:r>
                       <a:endParaRPr lang="en-US" sz="1200" dirty="0">
-                        <a:latin typeface="Calibri" charset="0"/>
-                        <a:ea typeface="Calibri" charset="0"/>
-                        <a:cs typeface="Calibri" charset="0"/>
+                        <a:latin typeface="Aptos" charset="0"/>
+                        <a:ea typeface="Aptos" charset="0"/>
+                        <a:cs typeface="Aptos" charset="0"/>
                       </a:endParaRPr>
                     </a:p>
                   </a:txBody>
@@ -17536,16 +17680,16 @@
                           <a:solidFill>
                             <a:srgbClr val="0B0B0B"/>
                           </a:solidFill>
-                          <a:latin typeface="Calibri" pitchFamily="34" charset="0"/>
-                          <a:ea typeface="Calibri" pitchFamily="34" charset="-122"/>
-                          <a:cs typeface="Calibri" pitchFamily="34" charset="-120"/>
+                          <a:latin typeface="Aptos" pitchFamily="34" charset="0"/>
+                          <a:ea typeface="Aptos" pitchFamily="34" charset="-122"/>
+                          <a:cs typeface="Aptos" pitchFamily="34" charset="-120"/>
                         </a:rPr>
-                        <a:t>steel + water × ASME B31.1 water-service span (published points only)</a:t>
+                        <a:t>steel + water × ASME B31.1 water-service span (published points only) [8]</a:t>
                       </a:r>
                       <a:endParaRPr lang="en-US" sz="1200" dirty="0">
-                        <a:latin typeface="Calibri" charset="0"/>
-                        <a:ea typeface="Calibri" charset="0"/>
-                        <a:cs typeface="Calibri" charset="0"/>
+                        <a:latin typeface="Aptos" charset="0"/>
+                        <a:ea typeface="Aptos" charset="0"/>
+                        <a:cs typeface="Aptos" charset="0"/>
                       </a:endParaRPr>
                     </a:p>
                   </a:txBody>
@@ -17603,16 +17747,16 @@
                           <a:solidFill>
                             <a:srgbClr val="0B0B0B"/>
                           </a:solidFill>
-                          <a:latin typeface="Calibri" pitchFamily="34" charset="0"/>
-                          <a:ea typeface="Calibri" pitchFamily="34" charset="-122"/>
-                          <a:cs typeface="Calibri" pitchFamily="34" charset="-120"/>
+                          <a:latin typeface="Aptos" pitchFamily="34" charset="0"/>
+                          <a:ea typeface="Aptos" pitchFamily="34" charset="-122"/>
+                          <a:cs typeface="Aptos" pitchFamily="34" charset="-120"/>
                         </a:rPr>
                         <a:t>Insulation</a:t>
                       </a:r>
                       <a:endParaRPr lang="en-US" sz="1200" dirty="0">
-                        <a:latin typeface="Calibri" charset="0"/>
-                        <a:ea typeface="Calibri" charset="0"/>
-                        <a:cs typeface="Calibri" charset="0"/>
+                        <a:latin typeface="Aptos" charset="0"/>
+                        <a:ea typeface="Aptos" charset="0"/>
+                        <a:cs typeface="Aptos" charset="0"/>
                       </a:endParaRPr>
                     </a:p>
                   </a:txBody>
@@ -17668,16 +17812,16 @@
                           <a:solidFill>
                             <a:srgbClr val="0B0B0B"/>
                           </a:solidFill>
-                          <a:latin typeface="Calibri" pitchFamily="34" charset="0"/>
-                          <a:ea typeface="Calibri" pitchFamily="34" charset="-122"/>
-                          <a:cs typeface="Calibri" pitchFamily="34" charset="-120"/>
+                          <a:latin typeface="Aptos" pitchFamily="34" charset="0"/>
+                          <a:ea typeface="Aptos" pitchFamily="34" charset="-122"/>
+                          <a:cs typeface="Aptos" pitchFamily="34" charset="-120"/>
                         </a:rPr>
-                        <a:t>GEG Anlage 8 (heated); 30/50 mm condensation control (chilled)</a:t>
+                        <a:t>GEG Anlage 8 (heated) [11]; 30/50 mm condensation control (chilled)</a:t>
                       </a:r>
                       <a:endParaRPr lang="en-US" sz="1200" dirty="0">
-                        <a:latin typeface="Calibri" charset="0"/>
-                        <a:ea typeface="Calibri" charset="0"/>
-                        <a:cs typeface="Calibri" charset="0"/>
+                        <a:latin typeface="Aptos" charset="0"/>
+                        <a:ea typeface="Aptos" charset="0"/>
+                        <a:cs typeface="Aptos" charset="0"/>
                       </a:endParaRPr>
                     </a:p>
                   </a:txBody>
@@ -17733,16 +17877,16 @@
                           <a:solidFill>
                             <a:srgbClr val="0B0B0B"/>
                           </a:solidFill>
-                          <a:latin typeface="Calibri" pitchFamily="34" charset="0"/>
-                          <a:ea typeface="Calibri" pitchFamily="34" charset="-122"/>
-                          <a:cs typeface="Calibri" pitchFamily="34" charset="-120"/>
+                          <a:latin typeface="Aptos" pitchFamily="34" charset="0"/>
+                          <a:ea typeface="Aptos" pitchFamily="34" charset="-122"/>
+                          <a:cs typeface="Aptos" pitchFamily="34" charset="-120"/>
                         </a:rPr>
                         <a:t>—</a:t>
                       </a:r>
                       <a:endParaRPr lang="en-US" sz="1200" dirty="0">
-                        <a:latin typeface="Calibri" charset="0"/>
-                        <a:ea typeface="Calibri" charset="0"/>
-                        <a:cs typeface="Calibri" charset="0"/>
+                        <a:latin typeface="Aptos" charset="0"/>
+                        <a:ea typeface="Aptos" charset="0"/>
+                        <a:cs typeface="Aptos" charset="0"/>
                       </a:endParaRPr>
                     </a:p>
                   </a:txBody>
@@ -17800,16 +17944,16 @@
                           <a:solidFill>
                             <a:srgbClr val="0B0B0B"/>
                           </a:solidFill>
-                          <a:latin typeface="Calibri" pitchFamily="34" charset="0"/>
-                          <a:ea typeface="Calibri" pitchFamily="34" charset="-122"/>
-                          <a:cs typeface="Calibri" pitchFamily="34" charset="-120"/>
+                          <a:latin typeface="Aptos" pitchFamily="34" charset="0"/>
+                          <a:ea typeface="Aptos" pitchFamily="34" charset="-122"/>
+                          <a:cs typeface="Aptos" pitchFamily="34" charset="-120"/>
                         </a:rPr>
                         <a:t>Cable trays 150–600</a:t>
                       </a:r>
                       <a:endParaRPr lang="en-US" sz="1200" dirty="0">
-                        <a:latin typeface="Calibri" charset="0"/>
-                        <a:ea typeface="Calibri" charset="0"/>
-                        <a:cs typeface="Calibri" charset="0"/>
+                        <a:latin typeface="Aptos" charset="0"/>
+                        <a:ea typeface="Aptos" charset="0"/>
+                        <a:cs typeface="Aptos" charset="0"/>
                       </a:endParaRPr>
                     </a:p>
                   </a:txBody>
@@ -17865,16 +18009,16 @@
                           <a:solidFill>
                             <a:srgbClr val="0B0B0B"/>
                           </a:solidFill>
-                          <a:latin typeface="Calibri" pitchFamily="34" charset="0"/>
-                          <a:ea typeface="Calibri" pitchFamily="34" charset="-122"/>
-                          <a:cs typeface="Calibri" pitchFamily="34" charset="-120"/>
+                          <a:latin typeface="Aptos" pitchFamily="34" charset="0"/>
+                          <a:ea typeface="Aptos" pitchFamily="34" charset="-122"/>
+                          <a:cs typeface="Aptos" pitchFamily="34" charset="-120"/>
                         </a:rPr>
-                        <a:t>IEC 61537 systems, NEMA VE 1 widths</a:t>
+                        <a:t>IEC 61537 systems [6], NEMA VE 1 widths [7]</a:t>
                       </a:r>
                       <a:endParaRPr lang="en-US" sz="1200" dirty="0">
-                        <a:latin typeface="Calibri" charset="0"/>
-                        <a:ea typeface="Calibri" charset="0"/>
-                        <a:cs typeface="Calibri" charset="0"/>
+                        <a:latin typeface="Aptos" charset="0"/>
+                        <a:ea typeface="Aptos" charset="0"/>
+                        <a:cs typeface="Aptos" charset="0"/>
                       </a:endParaRPr>
                     </a:p>
                   </a:txBody>
@@ -17930,16 +18074,16 @@
                           <a:solidFill>
                             <a:srgbClr val="0B0B0B"/>
                           </a:solidFill>
-                          <a:latin typeface="Calibri" pitchFamily="34" charset="0"/>
-                          <a:ea typeface="Calibri" pitchFamily="34" charset="-122"/>
-                          <a:cs typeface="Calibri" pitchFamily="34" charset="-120"/>
+                          <a:latin typeface="Aptos" pitchFamily="34" charset="0"/>
+                          <a:ea typeface="Aptos" pitchFamily="34" charset="-122"/>
+                          <a:cs typeface="Aptos" pitchFamily="34" charset="-120"/>
                         </a:rPr>
-                        <a:t>full tray: 50 kg/m at 300 mm datum, × 2.0 m (NEMA VE 1 class span)</a:t>
+                        <a:t>full tray: 50 kg/m at 300 mm datum, × 2.0 m (NEMA VE 1 class span) [7]</a:t>
                       </a:r>
                       <a:endParaRPr lang="en-US" sz="1200" dirty="0">
-                        <a:latin typeface="Calibri" charset="0"/>
-                        <a:ea typeface="Calibri" charset="0"/>
-                        <a:cs typeface="Calibri" charset="0"/>
+                        <a:latin typeface="Aptos" charset="0"/>
+                        <a:ea typeface="Aptos" charset="0"/>
+                        <a:cs typeface="Aptos" charset="0"/>
                       </a:endParaRPr>
                     </a:p>
                   </a:txBody>
@@ -17997,16 +18141,16 @@
                           <a:solidFill>
                             <a:srgbClr val="0B0B0B"/>
                           </a:solidFill>
-                          <a:latin typeface="Calibri" pitchFamily="34" charset="0"/>
-                          <a:ea typeface="Calibri" pitchFamily="34" charset="-122"/>
-                          <a:cs typeface="Calibri" pitchFamily="34" charset="-120"/>
+                          <a:latin typeface="Aptos" pitchFamily="34" charset="0"/>
+                          <a:ea typeface="Aptos" pitchFamily="34" charset="-122"/>
+                          <a:cs typeface="Aptos" pitchFamily="34" charset="-120"/>
                         </a:rPr>
                         <a:t>Ducts</a:t>
                       </a:r>
                       <a:endParaRPr lang="en-US" sz="1200" dirty="0">
-                        <a:latin typeface="Calibri" charset="0"/>
-                        <a:ea typeface="Calibri" charset="0"/>
-                        <a:cs typeface="Calibri" charset="0"/>
+                        <a:latin typeface="Aptos" charset="0"/>
+                        <a:ea typeface="Aptos" charset="0"/>
+                        <a:cs typeface="Aptos" charset="0"/>
                       </a:endParaRPr>
                     </a:p>
                   </a:txBody>
@@ -18062,16 +18206,16 @@
                           <a:solidFill>
                             <a:srgbClr val="0B0B0B"/>
                           </a:solidFill>
-                          <a:latin typeface="Calibri" pitchFamily="34" charset="0"/>
-                          <a:ea typeface="Calibri" pitchFamily="34" charset="-122"/>
-                          <a:cs typeface="Calibri" pitchFamily="34" charset="-120"/>
+                          <a:latin typeface="Aptos" pitchFamily="34" charset="0"/>
+                          <a:ea typeface="Aptos" pitchFamily="34" charset="-122"/>
+                          <a:cs typeface="Aptos" pitchFamily="34" charset="-120"/>
                         </a:rPr>
-                        <a:t>EN 1505 rectangular; EN 1506 round</a:t>
+                        <a:t>EN 1505 rectangular; EN 1506 round [5]</a:t>
                       </a:r>
                       <a:endParaRPr lang="en-US" sz="1200" dirty="0">
-                        <a:latin typeface="Calibri" charset="0"/>
-                        <a:ea typeface="Calibri" charset="0"/>
-                        <a:cs typeface="Calibri" charset="0"/>
+                        <a:latin typeface="Aptos" charset="0"/>
+                        <a:ea typeface="Aptos" charset="0"/>
+                        <a:cs typeface="Aptos" charset="0"/>
                       </a:endParaRPr>
                     </a:p>
                   </a:txBody>
@@ -18127,16 +18271,16 @@
                           <a:solidFill>
                             <a:srgbClr val="0B0B0B"/>
                           </a:solidFill>
-                          <a:latin typeface="Calibri" pitchFamily="34" charset="0"/>
-                          <a:ea typeface="Calibri" pitchFamily="34" charset="-122"/>
-                          <a:cs typeface="Calibri" pitchFamily="34" charset="-120"/>
+                          <a:latin typeface="Aptos" pitchFamily="34" charset="0"/>
+                          <a:ea typeface="Aptos" pitchFamily="34" charset="-122"/>
+                          <a:cs typeface="Aptos" pitchFamily="34" charset="-120"/>
                         </a:rPr>
-                        <a:t>manufacturer duct-weight table incl. flanges, × 2.4 m (SMACNA)</a:t>
+                        <a:t>manufacturer duct-weight table incl. flanges, × 2.4 m (SMACNA) [9]</a:t>
                       </a:r>
                       <a:endParaRPr lang="en-US" sz="1200" dirty="0">
-                        <a:latin typeface="Calibri" charset="0"/>
-                        <a:ea typeface="Calibri" charset="0"/>
-                        <a:cs typeface="Calibri" charset="0"/>
+                        <a:latin typeface="Aptos" charset="0"/>
+                        <a:ea typeface="Aptos" charset="0"/>
+                        <a:cs typeface="Aptos" charset="0"/>
                       </a:endParaRPr>
                     </a:p>
                   </a:txBody>
@@ -18194,16 +18338,16 @@
                           <a:solidFill>
                             <a:srgbClr val="0B0B0B"/>
                           </a:solidFill>
-                          <a:latin typeface="Calibri" pitchFamily="34" charset="0"/>
-                          <a:ea typeface="Calibri" pitchFamily="34" charset="-122"/>
-                          <a:cs typeface="Calibri" pitchFamily="34" charset="-120"/>
+                          <a:latin typeface="Aptos" pitchFamily="34" charset="0"/>
+                          <a:ea typeface="Aptos" pitchFamily="34" charset="-122"/>
+                          <a:cs typeface="Aptos" pitchFamily="34" charset="-120"/>
                         </a:rPr>
                         <a:t>Conduits Ø20–50</a:t>
                       </a:r>
                       <a:endParaRPr lang="en-US" sz="1200" dirty="0">
-                        <a:latin typeface="Calibri" charset="0"/>
-                        <a:ea typeface="Calibri" charset="0"/>
-                        <a:cs typeface="Calibri" charset="0"/>
+                        <a:latin typeface="Aptos" charset="0"/>
+                        <a:ea typeface="Aptos" charset="0"/>
+                        <a:cs typeface="Aptos" charset="0"/>
                       </a:endParaRPr>
                     </a:p>
                   </a:txBody>
@@ -18259,16 +18403,16 @@
                           <a:solidFill>
                             <a:srgbClr val="0B0B0B"/>
                           </a:solidFill>
-                          <a:latin typeface="Calibri" pitchFamily="34" charset="0"/>
-                          <a:ea typeface="Calibri" pitchFamily="34" charset="-122"/>
-                          <a:cs typeface="Calibri" pitchFamily="34" charset="-120"/>
+                          <a:latin typeface="Aptos" pitchFamily="34" charset="0"/>
+                          <a:ea typeface="Aptos" pitchFamily="34" charset="-122"/>
+                          <a:cs typeface="Aptos" pitchFamily="34" charset="-120"/>
                         </a:rPr>
-                        <a:t>IEC 61386-1, parallel groups of 2–6</a:t>
+                        <a:t>IEC 61386-1 [6], parallel groups of 2–6</a:t>
                       </a:r>
                       <a:endParaRPr lang="en-US" sz="1200" dirty="0">
-                        <a:latin typeface="Calibri" charset="0"/>
-                        <a:ea typeface="Calibri" charset="0"/>
-                        <a:cs typeface="Calibri" charset="0"/>
+                        <a:latin typeface="Aptos" charset="0"/>
+                        <a:ea typeface="Aptos" charset="0"/>
+                        <a:cs typeface="Aptos" charset="0"/>
                       </a:endParaRPr>
                     </a:p>
                   </a:txBody>
@@ -18324,16 +18468,16 @@
                           <a:solidFill>
                             <a:srgbClr val="0B0B0B"/>
                           </a:solidFill>
-                          <a:latin typeface="Calibri" pitchFamily="34" charset="0"/>
-                          <a:ea typeface="Calibri" pitchFamily="34" charset="-122"/>
-                          <a:cs typeface="Calibri" pitchFamily="34" charset="-120"/>
+                          <a:latin typeface="Aptos" pitchFamily="34" charset="0"/>
+                          <a:ea typeface="Aptos" pitchFamily="34" charset="-122"/>
+                          <a:cs typeface="Aptos" pitchFamily="34" charset="-120"/>
                         </a:rPr>
-                        <a:t>steel tube + 40 %-of-bore cable fill, × 2.0 m (IET / BS 7671)</a:t>
+                        <a:t>steel tube + 40 %-of-bore cable fill, × 2.0 m (IET / BS 7671) [10]</a:t>
                       </a:r>
                       <a:endParaRPr lang="en-US" sz="1200" dirty="0">
-                        <a:latin typeface="Calibri" charset="0"/>
-                        <a:ea typeface="Calibri" charset="0"/>
-                        <a:cs typeface="Calibri" charset="0"/>
+                        <a:latin typeface="Aptos" charset="0"/>
+                        <a:ea typeface="Aptos" charset="0"/>
+                        <a:cs typeface="Aptos" charset="0"/>
                       </a:endParaRPr>
                     </a:p>
                   </a:txBody>
@@ -18487,7 +18631,7 @@
                   <a:schemeClr val="tx1"/>
                 </a:solidFill>
               </a:rPr>
-              <a:t>Electrical kept above wet services on walls (drip; BS 7671 528.3.2)</a:t>
+              <a:t>Electrical kept above wet services on walls (drip; BS 7671 528.3.2) [10]</a:t>
             </a:r>
             <a:endParaRPr lang="en-US" sz="1300" dirty="0"/>
           </a:p>
@@ -18505,7 +18649,7 @@
                   <a:schemeClr val="tx1"/>
                 </a:solidFill>
               </a:rPr>
-              <a:t>Clear gaps drawn from a distribution measured on a built project; 25 mm minimum</a:t>
+              <a:t>Clear gaps drawn from a distribution measured on a built project [12]; 25 mm minimum</a:t>
             </a:r>
             <a:endParaRPr lang="en-US" sz="1300" dirty="0"/>
           </a:p>
@@ -18537,12 +18681,12 @@
         </p:nvSpPr>
         <p:spPr>
           <a:xfrm>
-            <a:off x="548640" y="5257800"/>
-            <a:ext cx="11091672" cy="777240"/>
+            <a:off x="548640" y="4983480"/>
+            <a:ext cx="11091672" cy="685800"/>
           </a:xfrm>
           <a:prstGeom prst="roundRect">
             <a:avLst>
-              <a:gd name="adj" fmla="val 8235"/>
+              <a:gd name="adj" fmla="val 9333"/>
             </a:avLst>
           </a:prstGeom>
           <a:solidFill>
@@ -18559,7 +18703,7 @@
         </p:nvSpPr>
         <p:spPr>
           <a:xfrm>
-            <a:off x="822960" y="5303520"/>
+            <a:off x="822960" y="4983480"/>
             <a:ext cx="10515600" cy="685800"/>
           </a:xfrm>
           <a:prstGeom prst="rect">
@@ -18576,14 +18720,50 @@
               <a:buNone/>
             </a:pPr>
             <a:r>
-              <a:rPr lang="en-US" sz="1300" dirty="0">
+              <a:rPr lang="en-US" sz="1250" dirty="0">
                 <a:solidFill>
                   <a:schemeClr val="tx1"/>
                 </a:solidFill>
               </a:rPr>
               <a:t>Three kinds of ground: standards (what each element is and weighs), measured open buildings (how close neighbours sit) and declared design choices (trade mix, surface mix, number of rows). Every constant carries its source and status in the repository, and the log says why each standard was chosen over its alternatives.</a:t>
             </a:r>
-            <a:endParaRPr lang="en-US" sz="1300" dirty="0"/>
+            <a:endParaRPr lang="en-US" sz="1250" dirty="0"/>
+          </a:p>
+        </p:txBody>
+      </p:sp>
+      <p:sp>
+        <p:nvSpPr>
+          <p:cNvPr id="8" name="references"/>
+          <p:cNvSpPr txBox="1"/>
+          <p:nvPr/>
+        </p:nvSpPr>
+        <p:spPr>
+          <a:xfrm>
+            <a:off x="548640" y="5715000"/>
+            <a:ext cx="11091672" cy="658368"/>
+          </a:xfrm>
+          <a:prstGeom prst="rect">
+            <a:avLst/>
+          </a:prstGeom>
+          <a:noFill/>
+          <a:ln/>
+        </p:spPr>
+        <p:txBody>
+          <a:bodyPr wrap="square" lIns="0" tIns="0" rIns="0" bIns="0" rtlCol="0" anchor="b"/>
+          <a:lstStyle/>
+          <a:p>
+            <a:pPr indent="0" marL="0">
+              <a:buNone/>
+            </a:pPr>
+            <a:r>
+              <a:rPr lang="en-US" sz="800" dirty="0">
+                <a:solidFill>
+                  <a:srgbClr val="52514E"/>
+                </a:solidFill>
+              </a:rPr>
+              <a:t>[4] EN 10220:2002, EN 10255:2004 (steel tubes: dimensions, medium series)   [5] EN 1505:1997, EN 1506:2007 (sheet-metal air ducts: rectangular and circular dimensions)   [6] IEC 61386-1 (conduit systems), IEC 61537 (cable tray and ladder systems)   [7] NEMA VE 1 (metal cable tray systems: widths, load-class spans)   [8] ASME B31.1 Table 121.5 (hanger spacing), as republished in the ASHRAE Handbook, HVAC Systems and Equipment   [9] SMACNA, HVAC Duct Construction Standards, Metal and Flexible, Table 5-1   [10] IET On-Site Guide (BS 7671), conduit support spacing; BS 7671 Reg. 528.3.2   [11] GEG (Gebäudeenergiegesetz), Anlage 8 (pipe insulation thickness)   [12] buildingSMART International (2020), Duplex Apartment and Medical-Dental Clinic sample IFC files, CC BY 4.0</a:t>
+            </a:r>
+            <a:endParaRPr lang="en-US" sz="800" dirty="0"/>
           </a:p>
         </p:txBody>
       </p:sp>
@@ -18683,7 +18863,7 @@
     </a:clrScheme>
     <a:fontScheme name="Office">
       <a:majorFont>
-        <a:latin typeface="Calibri"/>
+        <a:latin typeface="Aptos"/>
         <a:ea typeface=""/>
         <a:cs typeface=""/>
         <a:font script="Jpan" typeface="游ゴシック Light"/>
@@ -18735,7 +18915,7 @@
         <a:font script="Tfng" typeface="Ebrima"/>
       </a:majorFont>
       <a:minorFont>
-        <a:latin typeface="Calibri"/>
+        <a:latin typeface="Aptos"/>
         <a:ea typeface=""/>
         <a:cs typeface=""/>
         <a:font script="Jpan" typeface="游ゴシック"/>

</xml_diff>

<commit_message>
Talk: icons on the slide 2 figures and the slide 4 cards
</commit_message>
<xml_diff>
--- a/docs/CrossMEP_CIBW78_talk.pptx
+++ b/docs/CrossMEP_CIBW78_talk.pptx
@@ -124,12 +124,12 @@
   <p:extLst>
     <p:ext uri="{521415D9-36F7-43E2-AB2F-B90AF26B5E84}">
       <p14:sectionLst xmlns:p14="http://schemas.microsoft.com/office/powerpoint/2010/main">
-        <p14:section name="Opening" id="{9a7a4107-7484-aeeb-4f19-bd0ea906fae2}">
+        <p14:section name="Opening" id="{003beba9-3b6d-f021-488d-1ef7d7622296}">
           <p14:sldIdLst>
             <p14:sldId id="256"/>
           </p14:sldIdLst>
         </p14:section>
-        <p14:section name="Motivation" id="{27887e46-45e2-cf4e-3be4-ab13fbb86296}">
+        <p14:section name="Motivation" id="{4f7cdbf3-b342-615c-0c01-88573a0618bc}">
           <p14:sldIdLst>
             <p14:sldId id="257"/>
             <p14:sldId id="258"/>
@@ -138,7 +138,7 @@
             <p14:sldId id="261"/>
           </p14:sldIdLst>
         </p14:section>
-        <p14:section name="The dataset" id="{da36ba2e-a855-2118-6271-e33023b46354}">
+        <p14:section name="The dataset" id="{f19a24e6-ede9-481c-4896-959e65d2452a}">
           <p14:sldIdLst>
             <p14:sldId id="262"/>
             <p14:sldId id="263"/>
@@ -147,14 +147,14 @@
             <p14:sldId id="266"/>
           </p14:sldIdLst>
         </p14:section>
-        <p14:section name="Experiments" id="{c8632744-151b-2915-f053-553f90ca5cb7}">
+        <p14:section name="Experiments" id="{22d2f891-d592-7368-3e6d-70bfc3c17f6f}">
           <p14:sldIdLst>
             <p14:sldId id="267"/>
             <p14:sldId id="268"/>
             <p14:sldId id="269"/>
           </p14:sldIdLst>
         </p14:section>
-        <p14:section name="Use" id="{aabce9d3-6bcb-9df1-5020-172f67b04ec7}">
+        <p14:section name="Use" id="{213e8dfc-8382-23b1-4674-9da3832948de}">
           <p14:sldIdLst>
             <p14:sldId id="270"/>
             <p14:sldId id="271"/>
@@ -9327,7 +9327,7 @@
       </p:sp>
       <p:sp>
         <p:nvSpPr>
-          <p:cNvPr id="10" name="tile support assemblies in one 200,000 sq ft hospital"/>
+          <p:cNvPr id="10" name="tile assemblies"/>
           <p:cNvSpPr/>
           <p:nvPr/>
         </p:nvSpPr>
@@ -9349,14 +9349,58 @@
       </p:sp>
       <p:sp>
         <p:nvSpPr>
-          <p:cNvPr id="11" name="value support assemblies in one 200,000 sq ft hospital"/>
+          <p:cNvPr id="11" name="icon ring assemblies"/>
+          <p:cNvSpPr/>
+          <p:nvPr/>
+        </p:nvSpPr>
+        <p:spPr>
+          <a:xfrm>
+            <a:off x="777240" y="5193792"/>
+            <a:ext cx="585216" cy="585216"/>
+          </a:xfrm>
+          <a:prstGeom prst="ellipse">
+            <a:avLst/>
+          </a:prstGeom>
+          <a:solidFill>
+            <a:schemeClr val="accent1"/>
+          </a:solidFill>
+          <a:ln/>
+        </p:spPr>
+      </p:sp>
+      <p:pic>
+        <p:nvPicPr>
+          <p:cNvPr id="12" name="icon assemblies" descr="preencoded.png">    </p:cNvPr>
+          <p:cNvPicPr>
+            <a:picLocks noChangeAspect="1"/>
+          </p:cNvPicPr>
+          <p:nvPr/>
+        </p:nvPicPr>
+        <p:blipFill>
+          <a:blip r:embed="rId3"/>
+          <a:stretch>
+            <a:fillRect/>
+          </a:stretch>
+        </p:blipFill>
+        <p:spPr>
+          <a:xfrm>
+            <a:off x="900135" y="5316687"/>
+            <a:ext cx="339425" cy="339425"/>
+          </a:xfrm>
+          <a:prstGeom prst="rect">
+            <a:avLst/>
+          </a:prstGeom>
+        </p:spPr>
+      </p:pic>
+      <p:sp>
+        <p:nvSpPr>
+          <p:cNvPr id="13" name="value assemblies"/>
           <p:cNvSpPr txBox="1"/>
           <p:nvPr/>
         </p:nvSpPr>
         <p:spPr>
           <a:xfrm>
-            <a:off x="749808" y="4983480"/>
-            <a:ext cx="3172968" cy="594360"/>
+            <a:off x="1554480" y="4956048"/>
+            <a:ext cx="2386584" cy="548640"/>
           </a:xfrm>
           <a:prstGeom prst="rect">
             <a:avLst/>
@@ -9385,14 +9429,14 @@
       </p:sp>
       <p:sp>
         <p:nvSpPr>
-          <p:cNvPr id="12" name="label support assemblies in one 200,000 sq ft hospital"/>
+          <p:cNvPr id="14" name="label assemblies"/>
           <p:cNvSpPr txBox="1"/>
           <p:nvPr/>
         </p:nvSpPr>
         <p:spPr>
           <a:xfrm>
-            <a:off x="749808" y="5581498"/>
-            <a:ext cx="3172968" cy="451714"/>
+            <a:off x="1554480" y="5504688"/>
+            <a:ext cx="2386584" cy="530352"/>
           </a:xfrm>
           <a:prstGeom prst="rect">
             <a:avLst/>
@@ -9421,7 +9465,7 @@
       </p:sp>
       <p:sp>
         <p:nvSpPr>
-          <p:cNvPr id="13" name="tile of engineering for each assembly, designed one by one"/>
+          <p:cNvPr id="15" name="tile time"/>
           <p:cNvSpPr/>
           <p:nvPr/>
         </p:nvSpPr>
@@ -9443,14 +9487,58 @@
       </p:sp>
       <p:sp>
         <p:nvSpPr>
-          <p:cNvPr id="14" name="value of engineering for each assembly, designed one by one"/>
+          <p:cNvPr id="16" name="icon ring time"/>
+          <p:cNvSpPr/>
+          <p:nvPr/>
+        </p:nvSpPr>
+        <p:spPr>
+          <a:xfrm>
+            <a:off x="4535424" y="5193792"/>
+            <a:ext cx="585216" cy="585216"/>
+          </a:xfrm>
+          <a:prstGeom prst="ellipse">
+            <a:avLst/>
+          </a:prstGeom>
+          <a:solidFill>
+            <a:schemeClr val="accent1"/>
+          </a:solidFill>
+          <a:ln/>
+        </p:spPr>
+      </p:sp>
+      <p:pic>
+        <p:nvPicPr>
+          <p:cNvPr id="17" name="icon time" descr="preencoded.png">    </p:cNvPr>
+          <p:cNvPicPr>
+            <a:picLocks noChangeAspect="1"/>
+          </p:cNvPicPr>
+          <p:nvPr/>
+        </p:nvPicPr>
+        <p:blipFill>
+          <a:blip r:embed="rId4"/>
+          <a:stretch>
+            <a:fillRect/>
+          </a:stretch>
+        </p:blipFill>
+        <p:spPr>
+          <a:xfrm>
+            <a:off x="4658319" y="5316687"/>
+            <a:ext cx="339425" cy="339425"/>
+          </a:xfrm>
+          <a:prstGeom prst="rect">
+            <a:avLst/>
+          </a:prstGeom>
+        </p:spPr>
+      </p:pic>
+      <p:sp>
+        <p:nvSpPr>
+          <p:cNvPr id="18" name="value time"/>
           <p:cNvSpPr txBox="1"/>
           <p:nvPr/>
         </p:nvSpPr>
         <p:spPr>
           <a:xfrm>
-            <a:off x="4507992" y="4983480"/>
-            <a:ext cx="3172968" cy="594360"/>
+            <a:off x="5312664" y="4956048"/>
+            <a:ext cx="2386584" cy="548640"/>
           </a:xfrm>
           <a:prstGeom prst="rect">
             <a:avLst/>
@@ -9479,14 +9567,14 @@
       </p:sp>
       <p:sp>
         <p:nvSpPr>
-          <p:cNvPr id="15" name="label of engineering for each assembly, designed one by one"/>
+          <p:cNvPr id="19" name="label time"/>
           <p:cNvSpPr txBox="1"/>
           <p:nvPr/>
         </p:nvSpPr>
         <p:spPr>
           <a:xfrm>
-            <a:off x="4507992" y="5581498"/>
-            <a:ext cx="3172968" cy="451714"/>
+            <a:off x="5312664" y="5504688"/>
+            <a:ext cx="2386584" cy="530352"/>
           </a:xfrm>
           <a:prstGeom prst="rect">
             <a:avLst/>
@@ -9515,7 +9603,7 @@
       </p:sp>
       <p:sp>
         <p:nvSpPr>
-          <p:cNvPr id="16" name="tile of MEP design effort; on the order of $600K per project"/>
+          <p:cNvPr id="20" name="tile effort"/>
           <p:cNvSpPr/>
           <p:nvPr/>
         </p:nvSpPr>
@@ -9537,14 +9625,58 @@
       </p:sp>
       <p:sp>
         <p:nvSpPr>
-          <p:cNvPr id="17" name="value of MEP design effort; on the order of $600K per project"/>
+          <p:cNvPr id="21" name="icon ring effort"/>
+          <p:cNvSpPr/>
+          <p:nvPr/>
+        </p:nvSpPr>
+        <p:spPr>
+          <a:xfrm>
+            <a:off x="8293608" y="5193792"/>
+            <a:ext cx="585216" cy="585216"/>
+          </a:xfrm>
+          <a:prstGeom prst="ellipse">
+            <a:avLst/>
+          </a:prstGeom>
+          <a:solidFill>
+            <a:schemeClr val="accent1"/>
+          </a:solidFill>
+          <a:ln/>
+        </p:spPr>
+      </p:sp>
+      <p:pic>
+        <p:nvPicPr>
+          <p:cNvPr id="22" name="icon effort" descr="preencoded.png">    </p:cNvPr>
+          <p:cNvPicPr>
+            <a:picLocks noChangeAspect="1"/>
+          </p:cNvPicPr>
+          <p:nvPr/>
+        </p:nvPicPr>
+        <p:blipFill>
+          <a:blip r:embed="rId5"/>
+          <a:stretch>
+            <a:fillRect/>
+          </a:stretch>
+        </p:blipFill>
+        <p:spPr>
+          <a:xfrm>
+            <a:off x="8416503" y="5316687"/>
+            <a:ext cx="339425" cy="339425"/>
+          </a:xfrm>
+          <a:prstGeom prst="rect">
+            <a:avLst/>
+          </a:prstGeom>
+        </p:spPr>
+      </p:pic>
+      <p:sp>
+        <p:nvSpPr>
+          <p:cNvPr id="23" name="value effort"/>
           <p:cNvSpPr txBox="1"/>
           <p:nvPr/>
         </p:nvSpPr>
         <p:spPr>
           <a:xfrm>
-            <a:off x="8266176" y="4983480"/>
-            <a:ext cx="3172968" cy="594360"/>
+            <a:off x="9070848" y="4956048"/>
+            <a:ext cx="2386584" cy="548640"/>
           </a:xfrm>
           <a:prstGeom prst="rect">
             <a:avLst/>
@@ -9573,14 +9705,14 @@
       </p:sp>
       <p:sp>
         <p:nvSpPr>
-          <p:cNvPr id="18" name="label of MEP design effort; on the order of $600K per project"/>
+          <p:cNvPr id="24" name="label effort"/>
           <p:cNvSpPr txBox="1"/>
           <p:nvPr/>
         </p:nvSpPr>
         <p:spPr>
           <a:xfrm>
-            <a:off x="8266176" y="5581498"/>
-            <a:ext cx="3172968" cy="451714"/>
+            <a:off x="9070848" y="5504688"/>
+            <a:ext cx="2386584" cy="530352"/>
           </a:xfrm>
           <a:prstGeom prst="rect">
             <a:avLst/>
@@ -9609,7 +9741,7 @@
       </p:sp>
       <p:sp>
         <p:nvSpPr>
-          <p:cNvPr id="19" name="references"/>
+          <p:cNvPr id="25" name="references"/>
           <p:cNvSpPr txBox="1"/>
           <p:nvPr/>
         </p:nvSpPr>
@@ -11835,14 +11967,58 @@
       </p:sp>
       <p:sp>
         <p:nvSpPr>
-          <p:cNvPr id="6" name="practice"/>
+          <p:cNvPr id="6" name="icon ring practice"/>
+          <p:cNvSpPr/>
+          <p:nvPr/>
+        </p:nvSpPr>
+        <p:spPr>
+          <a:xfrm>
+            <a:off x="7772400" y="1536192"/>
+            <a:ext cx="457200" cy="457200"/>
+          </a:xfrm>
+          <a:prstGeom prst="ellipse">
+            <a:avLst/>
+          </a:prstGeom>
+          <a:solidFill>
+            <a:schemeClr val="accent1"/>
+          </a:solidFill>
+          <a:ln/>
+        </p:spPr>
+      </p:sp>
+      <p:pic>
+        <p:nvPicPr>
+          <p:cNvPr id="7" name="icon practice" descr="preencoded.png">    </p:cNvPr>
+          <p:cNvPicPr>
+            <a:picLocks noChangeAspect="1"/>
+          </p:cNvPicPr>
+          <p:nvPr/>
+        </p:nvPicPr>
+        <p:blipFill>
+          <a:blip r:embed="rId2"/>
+          <a:stretch>
+            <a:fillRect/>
+          </a:stretch>
+        </p:blipFill>
+        <p:spPr>
+          <a:xfrm>
+            <a:off x="7868412" y="1632204"/>
+            <a:ext cx="265176" cy="265176"/>
+          </a:xfrm>
+          <a:prstGeom prst="rect">
+            <a:avLst/>
+          </a:prstGeom>
+        </p:spPr>
+      </p:pic>
+      <p:sp>
+        <p:nvSpPr>
+          <p:cNvPr id="8" name="practice"/>
           <p:cNvSpPr txBox="1"/>
           <p:nvPr/>
         </p:nvSpPr>
         <p:spPr>
           <a:xfrm>
-            <a:off x="7772400" y="1508760"/>
-            <a:ext cx="3657600" cy="2377440"/>
+            <a:off x="8366760" y="1508760"/>
+            <a:ext cx="3108960" cy="2377440"/>
           </a:xfrm>
           <a:prstGeom prst="rect">
             <a:avLst/>
@@ -11927,7 +12103,7 @@
       </p:sp>
       <p:sp>
         <p:nvSpPr>
-          <p:cNvPr id="7" name="why Geometric judgment"/>
+          <p:cNvPr id="9" name="why Geometric judgment"/>
           <p:cNvSpPr/>
           <p:nvPr/>
         </p:nvSpPr>
@@ -11949,14 +12125,58 @@
       </p:sp>
       <p:sp>
         <p:nvSpPr>
-          <p:cNvPr id="8" name="why head Geometric judgment"/>
+          <p:cNvPr id="10" name="icon ring why Geometric judgment"/>
+          <p:cNvSpPr/>
+          <p:nvPr/>
+        </p:nvSpPr>
+        <p:spPr>
+          <a:xfrm>
+            <a:off x="777240" y="4389120"/>
+            <a:ext cx="457200" cy="457200"/>
+          </a:xfrm>
+          <a:prstGeom prst="ellipse">
+            <a:avLst/>
+          </a:prstGeom>
+          <a:solidFill>
+            <a:schemeClr val="accent1"/>
+          </a:solidFill>
+          <a:ln/>
+        </p:spPr>
+      </p:sp>
+      <p:pic>
+        <p:nvPicPr>
+          <p:cNvPr id="11" name="icon why Geometric judgment" descr="preencoded.png">    </p:cNvPr>
+          <p:cNvPicPr>
+            <a:picLocks noChangeAspect="1"/>
+          </p:cNvPicPr>
+          <p:nvPr/>
+        </p:nvPicPr>
+        <p:blipFill>
+          <a:blip r:embed="rId3"/>
+          <a:stretch>
+            <a:fillRect/>
+          </a:stretch>
+        </p:blipFill>
+        <p:spPr>
+          <a:xfrm>
+            <a:off x="873252" y="4485132"/>
+            <a:ext cx="265176" cy="265176"/>
+          </a:xfrm>
+          <a:prstGeom prst="rect">
+            <a:avLst/>
+          </a:prstGeom>
+        </p:spPr>
+      </p:pic>
+      <p:sp>
+        <p:nvSpPr>
+          <p:cNvPr id="12" name="why head Geometric judgment"/>
           <p:cNvSpPr txBox="1"/>
           <p:nvPr/>
         </p:nvSpPr>
         <p:spPr>
           <a:xfrm>
-            <a:off x="777240" y="4389120"/>
-            <a:ext cx="3118104" cy="384048"/>
+            <a:off x="1371600" y="4389120"/>
+            <a:ext cx="2569464" cy="457200"/>
           </a:xfrm>
           <a:prstGeom prst="rect">
             <a:avLst/>
@@ -11985,14 +12205,14 @@
       </p:sp>
       <p:sp>
         <p:nvSpPr>
-          <p:cNvPr id="9" name="why text Geometric judgment"/>
+          <p:cNvPr id="13" name="why text Geometric judgment"/>
           <p:cNvSpPr txBox="1"/>
           <p:nvPr/>
         </p:nvSpPr>
         <p:spPr>
           <a:xfrm>
-            <a:off x="777240" y="4828032"/>
-            <a:ext cx="3118104" cy="822960"/>
+            <a:off x="777240" y="4937760"/>
+            <a:ext cx="3118104" cy="731520"/>
           </a:xfrm>
           <a:prstGeom prst="rect">
             <a:avLst/>
@@ -12008,20 +12228,20 @@
               <a:buNone/>
             </a:pPr>
             <a:r>
-              <a:rPr lang="en-US" sz="1500" dirty="0">
+              <a:rPr lang="en-US" sz="1400" dirty="0">
                 <a:solidFill>
                   <a:schemeClr val="tx1"/>
                 </a:solidFill>
               </a:rPr>
               <a:t>Engineers choose an assembly’s topology from experience.</a:t>
             </a:r>
-            <a:endParaRPr lang="en-US" sz="1500" dirty="0"/>
-          </a:p>
-        </p:txBody>
-      </p:sp>
-      <p:sp>
-        <p:nvSpPr>
-          <p:cNvPr id="10" name="why Rule explosion"/>
+            <a:endParaRPr lang="en-US" sz="1400" dirty="0"/>
+          </a:p>
+        </p:txBody>
+      </p:sp>
+      <p:sp>
+        <p:nvSpPr>
+          <p:cNvPr id="14" name="why Rule explosion"/>
           <p:cNvSpPr/>
           <p:nvPr/>
         </p:nvSpPr>
@@ -12043,14 +12263,58 @@
       </p:sp>
       <p:sp>
         <p:nvSpPr>
-          <p:cNvPr id="11" name="why head Rule explosion"/>
+          <p:cNvPr id="15" name="icon ring why Rule explosion"/>
+          <p:cNvSpPr/>
+          <p:nvPr/>
+        </p:nvSpPr>
+        <p:spPr>
+          <a:xfrm>
+            <a:off x="4535424" y="4389120"/>
+            <a:ext cx="457200" cy="457200"/>
+          </a:xfrm>
+          <a:prstGeom prst="ellipse">
+            <a:avLst/>
+          </a:prstGeom>
+          <a:solidFill>
+            <a:schemeClr val="accent1"/>
+          </a:solidFill>
+          <a:ln/>
+        </p:spPr>
+      </p:sp>
+      <p:pic>
+        <p:nvPicPr>
+          <p:cNvPr id="16" name="icon why Rule explosion" descr="preencoded.png">    </p:cNvPr>
+          <p:cNvPicPr>
+            <a:picLocks noChangeAspect="1"/>
+          </p:cNvPicPr>
+          <p:nvPr/>
+        </p:nvPicPr>
+        <p:blipFill>
+          <a:blip r:embed="rId4"/>
+          <a:stretch>
+            <a:fillRect/>
+          </a:stretch>
+        </p:blipFill>
+        <p:spPr>
+          <a:xfrm>
+            <a:off x="4631436" y="4485132"/>
+            <a:ext cx="265176" cy="265176"/>
+          </a:xfrm>
+          <a:prstGeom prst="rect">
+            <a:avLst/>
+          </a:prstGeom>
+        </p:spPr>
+      </p:pic>
+      <p:sp>
+        <p:nvSpPr>
+          <p:cNvPr id="17" name="why head Rule explosion"/>
           <p:cNvSpPr txBox="1"/>
           <p:nvPr/>
         </p:nvSpPr>
         <p:spPr>
           <a:xfrm>
-            <a:off x="4535424" y="4389120"/>
-            <a:ext cx="3118104" cy="384048"/>
+            <a:off x="5129784" y="4389120"/>
+            <a:ext cx="2569464" cy="457200"/>
           </a:xfrm>
           <a:prstGeom prst="rect">
             <a:avLst/>
@@ -12079,14 +12343,14 @@
       </p:sp>
       <p:sp>
         <p:nvSpPr>
-          <p:cNvPr id="12" name="why text Rule explosion"/>
+          <p:cNvPr id="18" name="why text Rule explosion"/>
           <p:cNvSpPr txBox="1"/>
           <p:nvPr/>
         </p:nvSpPr>
         <p:spPr>
           <a:xfrm>
-            <a:off x="4535424" y="4828032"/>
-            <a:ext cx="3118104" cy="822960"/>
+            <a:off x="4535424" y="4937760"/>
+            <a:ext cx="3118104" cy="731520"/>
           </a:xfrm>
           <a:prstGeom prst="rect">
             <a:avLst/>
@@ -12102,20 +12366,20 @@
               <a:buNone/>
             </a:pPr>
             <a:r>
-              <a:rPr lang="en-US" sz="1500" dirty="0">
+              <a:rPr lang="en-US" sz="1400" dirty="0">
                 <a:solidFill>
                   <a:schemeClr val="tx1"/>
                 </a:solidFill>
               </a:rPr>
               <a:t>Code, load and material constraints interact across thousands of combinations.</a:t>
             </a:r>
-            <a:endParaRPr lang="en-US" sz="1500" dirty="0"/>
-          </a:p>
-        </p:txBody>
-      </p:sp>
-      <p:sp>
-        <p:nvSpPr>
-          <p:cNvPr id="13" name="why Catalog volatility"/>
+            <a:endParaRPr lang="en-US" sz="1400" dirty="0"/>
+          </a:p>
+        </p:txBody>
+      </p:sp>
+      <p:sp>
+        <p:nvSpPr>
+          <p:cNvPr id="19" name="why Catalog volatility"/>
           <p:cNvSpPr/>
           <p:nvPr/>
         </p:nvSpPr>
@@ -12137,14 +12401,58 @@
       </p:sp>
       <p:sp>
         <p:nvSpPr>
-          <p:cNvPr id="14" name="why head Catalog volatility"/>
+          <p:cNvPr id="20" name="icon ring why Catalog volatility"/>
+          <p:cNvSpPr/>
+          <p:nvPr/>
+        </p:nvSpPr>
+        <p:spPr>
+          <a:xfrm>
+            <a:off x="8293608" y="4389120"/>
+            <a:ext cx="457200" cy="457200"/>
+          </a:xfrm>
+          <a:prstGeom prst="ellipse">
+            <a:avLst/>
+          </a:prstGeom>
+          <a:solidFill>
+            <a:schemeClr val="accent1"/>
+          </a:solidFill>
+          <a:ln/>
+        </p:spPr>
+      </p:sp>
+      <p:pic>
+        <p:nvPicPr>
+          <p:cNvPr id="21" name="icon why Catalog volatility" descr="preencoded.png">    </p:cNvPr>
+          <p:cNvPicPr>
+            <a:picLocks noChangeAspect="1"/>
+          </p:cNvPicPr>
+          <p:nvPr/>
+        </p:nvPicPr>
+        <p:blipFill>
+          <a:blip r:embed="rId5"/>
+          <a:stretch>
+            <a:fillRect/>
+          </a:stretch>
+        </p:blipFill>
+        <p:spPr>
+          <a:xfrm>
+            <a:off x="8389620" y="4485132"/>
+            <a:ext cx="265176" cy="265176"/>
+          </a:xfrm>
+          <a:prstGeom prst="rect">
+            <a:avLst/>
+          </a:prstGeom>
+        </p:spPr>
+      </p:pic>
+      <p:sp>
+        <p:nvSpPr>
+          <p:cNvPr id="22" name="why head Catalog volatility"/>
           <p:cNvSpPr txBox="1"/>
           <p:nvPr/>
         </p:nvSpPr>
         <p:spPr>
           <a:xfrm>
-            <a:off x="8293608" y="4389120"/>
-            <a:ext cx="3118104" cy="384048"/>
+            <a:off x="8887968" y="4389120"/>
+            <a:ext cx="2569464" cy="457200"/>
           </a:xfrm>
           <a:prstGeom prst="rect">
             <a:avLst/>
@@ -12173,14 +12481,14 @@
       </p:sp>
       <p:sp>
         <p:nvSpPr>
-          <p:cNvPr id="15" name="why text Catalog volatility"/>
+          <p:cNvPr id="23" name="why text Catalog volatility"/>
           <p:cNvSpPr txBox="1"/>
           <p:nvPr/>
         </p:nvSpPr>
         <p:spPr>
           <a:xfrm>
-            <a:off x="8293608" y="4828032"/>
-            <a:ext cx="3118104" cy="822960"/>
+            <a:off x="8293608" y="4937760"/>
+            <a:ext cx="3118104" cy="731520"/>
           </a:xfrm>
           <a:prstGeom prst="rect">
             <a:avLst/>
@@ -12196,20 +12504,20 @@
               <a:buNone/>
             </a:pPr>
             <a:r>
-              <a:rPr lang="en-US" sz="1500" dirty="0">
+              <a:rPr lang="en-US" sz="1400" dirty="0">
                 <a:solidFill>
                   <a:schemeClr val="tx1"/>
                 </a:solidFill>
               </a:rPr>
               <a:t>Catalogs change faster than rule-based systems can be rewritten.</a:t>
             </a:r>
-            <a:endParaRPr lang="en-US" sz="1500" dirty="0"/>
-          </a:p>
-        </p:txBody>
-      </p:sp>
-      <p:sp>
-        <p:nvSpPr>
-          <p:cNvPr id="16" name="references"/>
+            <a:endParaRPr lang="en-US" sz="1400" dirty="0"/>
+          </a:p>
+        </p:txBody>
+      </p:sp>
+      <p:sp>
+        <p:nvSpPr>
+          <p:cNvPr id="24" name="references"/>
           <p:cNvSpPr txBox="1"/>
           <p:nvPr/>
         </p:nvSpPr>

</xml_diff>

<commit_message>
Talk: slide 6 shows the design space with thumbnail sections instead of dots; shorter tiles
Co-Authored-By: Claude Fable 5.1 <noreply@anthropic.com>
Claude-Session: https://claude.ai/code/session_01R1ft1rokeRJHR95rzLxNEC
</commit_message>
<xml_diff>
--- a/docs/CrossMEP_CIBW78_talk.pptx
+++ b/docs/CrossMEP_CIBW78_talk.pptx
@@ -124,12 +124,12 @@
   <p:extLst>
     <p:ext uri="{521415D9-36F7-43E2-AB2F-B90AF26B5E84}">
       <p14:sectionLst xmlns:p14="http://schemas.microsoft.com/office/powerpoint/2010/main">
-        <p14:section name="Opening" id="{003beba9-3b6d-f021-488d-1ef7d7622296}">
+        <p14:section name="Opening" id="{521c0017-bd6d-fe2d-035d-e867eea9b7b9}">
           <p14:sldIdLst>
             <p14:sldId id="256"/>
           </p14:sldIdLst>
         </p14:section>
-        <p14:section name="Motivation" id="{4f7cdbf3-b342-615c-0c01-88573a0618bc}">
+        <p14:section name="Motivation" id="{e18b5bb8-1f13-f976-aee9-2a98f360947f}">
           <p14:sldIdLst>
             <p14:sldId id="257"/>
             <p14:sldId id="258"/>
@@ -138,7 +138,7 @@
             <p14:sldId id="261"/>
           </p14:sldIdLst>
         </p14:section>
-        <p14:section name="The dataset" id="{f19a24e6-ede9-481c-4896-959e65d2452a}">
+        <p14:section name="The dataset" id="{22c66ab9-fb38-fae5-623f-5b49cd9e0105}">
           <p14:sldIdLst>
             <p14:sldId id="262"/>
             <p14:sldId id="263"/>
@@ -147,14 +147,14 @@
             <p14:sldId id="266"/>
           </p14:sldIdLst>
         </p14:section>
-        <p14:section name="Experiments" id="{22d2f891-d592-7368-3e6d-70bfc3c17f6f}">
+        <p14:section name="Experiments" id="{4cf845ca-fd69-5860-5c24-a5e696147190}">
           <p14:sldIdLst>
             <p14:sldId id="267"/>
             <p14:sldId id="268"/>
             <p14:sldId id="269"/>
           </p14:sldIdLst>
         </p14:section>
-        <p14:section name="Use" id="{213e8dfc-8382-23b1-4674-9da3832948de}">
+        <p14:section name="Use" id="{b294b918-0363-943f-9613-27707e0547d9}">
           <p14:sldIdLst>
             <p14:sldId id="270"/>
             <p14:sldId id="271"/>
@@ -14401,8 +14401,8 @@
         </p:nvSpPr>
         <p:spPr>
           <a:xfrm>
-            <a:off x="731520" y="1481328"/>
-            <a:ext cx="4846320" cy="566928"/>
+            <a:off x="731520" y="1463040"/>
+            <a:ext cx="4846320" cy="292608"/>
           </a:xfrm>
           <a:prstGeom prst="rect">
             <a:avLst/>
@@ -14411,7 +14411,7 @@
           <a:ln/>
         </p:spPr>
         <p:txBody>
-          <a:bodyPr wrap="square" lIns="0" tIns="0" rIns="0" bIns="0" rtlCol="0" anchor="t"/>
+          <a:bodyPr wrap="square" lIns="0" tIns="0" rIns="0" bIns="0" rtlCol="0" anchor="ctr"/>
           <a:lstStyle/>
           <a:p>
             <a:pPr indent="0" marL="0">
@@ -14425,9 +14425,6 @@
               </a:rPr>
               <a:t>The real designs we had</a:t>
             </a:r>
-            <a:endParaRPr lang="en-US" sz="1400" dirty="0"/>
-          </a:p>
-          <a:p>
             <a:pPr indent="0" marL="0">
               <a:buNone/>
             </a:pPr>
@@ -14437,7 +14434,7 @@
                   <a:srgbClr val="52514E"/>
                 </a:solidFill>
               </a:rPr>
-              <a:t>few, from one kind of project with one trade mix: one corner of the space</a:t>
+              <a:t>   few · one project · one trade mix</a:t>
             </a:r>
             <a:endParaRPr lang="en-US" sz="1400" dirty="0"/>
           </a:p>
@@ -14451,8 +14448,8 @@
         </p:nvSpPr>
         <p:spPr>
           <a:xfrm>
-            <a:off x="1051560" y="3063240"/>
-            <a:ext cx="4480560" cy="0"/>
+            <a:off x="1005840" y="3081528"/>
+            <a:ext cx="4526280" cy="0"/>
           </a:xfrm>
           <a:prstGeom prst="line">
             <a:avLst/>
@@ -14475,8 +14472,8 @@
         </p:nvSpPr>
         <p:spPr>
           <a:xfrm>
-            <a:off x="1051560" y="2148840"/>
-            <a:ext cx="0" cy="914400"/>
+            <a:off x="1005840" y="1847088"/>
+            <a:ext cx="0" cy="1234440"/>
           </a:xfrm>
           <a:prstGeom prst="line">
             <a:avLst/>
@@ -14499,8 +14496,8 @@
         </p:nvSpPr>
         <p:spPr>
           <a:xfrm>
-            <a:off x="1051560" y="3090672"/>
-            <a:ext cx="4480560" cy="228600"/>
+            <a:off x="1005840" y="3108960"/>
+            <a:ext cx="4526280" cy="228600"/>
           </a:xfrm>
           <a:prstGeom prst="rect">
             <a:avLst/>
@@ -14535,8 +14532,8 @@
         </p:nvSpPr>
         <p:spPr>
           <a:xfrm rot="16200000">
-            <a:off x="566928" y="2148840"/>
-            <a:ext cx="457200" cy="914400"/>
+            <a:off x="521208" y="1847088"/>
+            <a:ext cx="457200" cy="1234440"/>
           </a:xfrm>
           <a:prstGeom prst="rect">
             <a:avLst/>
@@ -14565,14 +14562,34 @@
       </p:sp>
       <p:sp>
         <p:nvSpPr>
-          <p:cNvPr id="9" name="dot real 0"/>
-          <p:cNvSpPr/>
-          <p:nvPr/>
-        </p:nvSpPr>
-        <p:spPr>
-          <a:xfrm>
-            <a:off x="1516075" y="2807208"/>
-            <a:ext cx="146304" cy="146304"/>
+          <p:cNvPr id="9" name="mini slab real 0"/>
+          <p:cNvSpPr/>
+          <p:nvPr/>
+        </p:nvSpPr>
+        <p:spPr>
+          <a:xfrm>
+            <a:off x="1141628" y="2782062"/>
+            <a:ext cx="457200" cy="32004"/>
+          </a:xfrm>
+          <a:prstGeom prst="rect">
+            <a:avLst/>
+          </a:prstGeom>
+          <a:solidFill>
+            <a:srgbClr val="52514E"/>
+          </a:solidFill>
+          <a:ln/>
+        </p:spPr>
+      </p:sp>
+      <p:sp>
+        <p:nvSpPr>
+          <p:cNvPr id="10" name="mini real 0 0"/>
+          <p:cNvSpPr/>
+          <p:nvPr/>
+        </p:nvSpPr>
+        <p:spPr>
+          <a:xfrm>
+            <a:off x="1225673" y="2855214"/>
+            <a:ext cx="60512" cy="60512"/>
           </a:xfrm>
           <a:prstGeom prst="ellipse">
             <a:avLst/>
@@ -14580,7 +14597,7 @@
           <a:solidFill>
             <a:srgbClr val="EB6834"/>
           </a:solidFill>
-          <a:ln w="6350">
+          <a:ln w="5080">
             <a:solidFill>
               <a:srgbClr val="FFFFFF"/>
             </a:solidFill>
@@ -14590,14 +14607,14 @@
       </p:sp>
       <p:sp>
         <p:nvSpPr>
-          <p:cNvPr id="10" name="dot real 1"/>
-          <p:cNvSpPr/>
-          <p:nvPr/>
-        </p:nvSpPr>
-        <p:spPr>
-          <a:xfrm>
-            <a:off x="1784909" y="2752344"/>
-            <a:ext cx="146304" cy="146304"/>
+          <p:cNvPr id="11" name="mini real 0 1"/>
+          <p:cNvSpPr/>
+          <p:nvPr/>
+        </p:nvSpPr>
+        <p:spPr>
+          <a:xfrm>
+            <a:off x="1339973" y="2855214"/>
+            <a:ext cx="60512" cy="60512"/>
           </a:xfrm>
           <a:prstGeom prst="ellipse">
             <a:avLst/>
@@ -14605,7 +14622,7 @@
           <a:solidFill>
             <a:srgbClr val="EB6834"/>
           </a:solidFill>
-          <a:ln w="6350">
+          <a:ln w="5080">
             <a:solidFill>
               <a:srgbClr val="FFFFFF"/>
             </a:solidFill>
@@ -14615,14 +14632,14 @@
       </p:sp>
       <p:sp>
         <p:nvSpPr>
-          <p:cNvPr id="11" name="dot real 2"/>
-          <p:cNvSpPr/>
-          <p:nvPr/>
-        </p:nvSpPr>
-        <p:spPr>
-          <a:xfrm>
-            <a:off x="1964131" y="2834640"/>
-            <a:ext cx="146304" cy="146304"/>
+          <p:cNvPr id="12" name="mini real 0 2"/>
+          <p:cNvSpPr/>
+          <p:nvPr/>
+        </p:nvSpPr>
+        <p:spPr>
+          <a:xfrm>
+            <a:off x="1454273" y="2855214"/>
+            <a:ext cx="60512" cy="60512"/>
           </a:xfrm>
           <a:prstGeom prst="ellipse">
             <a:avLst/>
@@ -14630,7 +14647,7 @@
           <a:solidFill>
             <a:srgbClr val="EB6834"/>
           </a:solidFill>
-          <a:ln w="6350">
+          <a:ln w="5080">
             <a:solidFill>
               <a:srgbClr val="FFFFFF"/>
             </a:solidFill>
@@ -14640,14 +14657,34 @@
       </p:sp>
       <p:sp>
         <p:nvSpPr>
-          <p:cNvPr id="12" name="dot real 3"/>
-          <p:cNvSpPr/>
-          <p:nvPr/>
-        </p:nvSpPr>
-        <p:spPr>
-          <a:xfrm>
-            <a:off x="1650492" y="2688336"/>
-            <a:ext cx="146304" cy="146304"/>
+          <p:cNvPr id="13" name="mini slab real 1"/>
+          <p:cNvSpPr/>
+          <p:nvPr/>
+        </p:nvSpPr>
+        <p:spPr>
+          <a:xfrm>
+            <a:off x="1639519" y="2695651"/>
+            <a:ext cx="457200" cy="32004"/>
+          </a:xfrm>
+          <a:prstGeom prst="rect">
+            <a:avLst/>
+          </a:prstGeom>
+          <a:solidFill>
+            <a:srgbClr val="52514E"/>
+          </a:solidFill>
+          <a:ln/>
+        </p:spPr>
+      </p:sp>
+      <p:sp>
+        <p:nvSpPr>
+          <p:cNvPr id="14" name="mini real 1 0"/>
+          <p:cNvSpPr/>
+          <p:nvPr/>
+        </p:nvSpPr>
+        <p:spPr>
+          <a:xfrm>
+            <a:off x="1723563" y="2768803"/>
+            <a:ext cx="60512" cy="60512"/>
           </a:xfrm>
           <a:prstGeom prst="ellipse">
             <a:avLst/>
@@ -14655,7 +14692,7 @@
           <a:solidFill>
             <a:srgbClr val="EB6834"/>
           </a:solidFill>
-          <a:ln w="6350">
+          <a:ln w="5080">
             <a:solidFill>
               <a:srgbClr val="FFFFFF"/>
             </a:solidFill>
@@ -14665,14 +14702,14 @@
       </p:sp>
       <p:sp>
         <p:nvSpPr>
-          <p:cNvPr id="13" name="dot real 4"/>
-          <p:cNvSpPr/>
-          <p:nvPr/>
-        </p:nvSpPr>
-        <p:spPr>
-          <a:xfrm>
-            <a:off x="2188159" y="2770632"/>
-            <a:ext cx="146304" cy="146304"/>
+          <p:cNvPr id="15" name="mini real 1 1"/>
+          <p:cNvSpPr/>
+          <p:nvPr/>
+        </p:nvSpPr>
+        <p:spPr>
+          <a:xfrm>
+            <a:off x="1837863" y="2768803"/>
+            <a:ext cx="60512" cy="60512"/>
           </a:xfrm>
           <a:prstGeom prst="ellipse">
             <a:avLst/>
@@ -14680,7 +14717,7 @@
           <a:solidFill>
             <a:srgbClr val="EB6834"/>
           </a:solidFill>
-          <a:ln w="6350">
+          <a:ln w="5080">
             <a:solidFill>
               <a:srgbClr val="FFFFFF"/>
             </a:solidFill>
@@ -14690,14 +14727,14 @@
       </p:sp>
       <p:sp>
         <p:nvSpPr>
-          <p:cNvPr id="14" name="dot real 5"/>
-          <p:cNvSpPr/>
-          <p:nvPr/>
-        </p:nvSpPr>
-        <p:spPr>
-          <a:xfrm>
-            <a:off x="1874520" y="2880360"/>
-            <a:ext cx="146304" cy="146304"/>
+          <p:cNvPr id="16" name="mini real 1 2"/>
+          <p:cNvSpPr/>
+          <p:nvPr/>
+        </p:nvSpPr>
+        <p:spPr>
+          <a:xfrm>
+            <a:off x="1952163" y="2768803"/>
+            <a:ext cx="60512" cy="60512"/>
           </a:xfrm>
           <a:prstGeom prst="ellipse">
             <a:avLst/>
@@ -14705,7 +14742,7 @@
           <a:solidFill>
             <a:srgbClr val="EB6834"/>
           </a:solidFill>
-          <a:ln w="6350">
+          <a:ln w="5080">
             <a:solidFill>
               <a:srgbClr val="FFFFFF"/>
             </a:solidFill>
@@ -14715,14 +14752,34 @@
       </p:sp>
       <p:sp>
         <p:nvSpPr>
-          <p:cNvPr id="15" name="dot real 6"/>
-          <p:cNvSpPr/>
-          <p:nvPr/>
-        </p:nvSpPr>
-        <p:spPr>
-          <a:xfrm>
-            <a:off x="2367382" y="2715768"/>
-            <a:ext cx="146304" cy="146304"/>
+          <p:cNvPr id="17" name="mini slab real 2"/>
+          <p:cNvSpPr/>
+          <p:nvPr/>
+        </p:nvSpPr>
+        <p:spPr>
+          <a:xfrm>
+            <a:off x="2137410" y="2794406"/>
+            <a:ext cx="457200" cy="32004"/>
+          </a:xfrm>
+          <a:prstGeom prst="rect">
+            <a:avLst/>
+          </a:prstGeom>
+          <a:solidFill>
+            <a:srgbClr val="52514E"/>
+          </a:solidFill>
+          <a:ln/>
+        </p:spPr>
+      </p:sp>
+      <p:sp>
+        <p:nvSpPr>
+          <p:cNvPr id="18" name="mini real 2 0"/>
+          <p:cNvSpPr/>
+          <p:nvPr/>
+        </p:nvSpPr>
+        <p:spPr>
+          <a:xfrm>
+            <a:off x="2221454" y="2867558"/>
+            <a:ext cx="60512" cy="60512"/>
           </a:xfrm>
           <a:prstGeom prst="ellipse">
             <a:avLst/>
@@ -14730,7 +14787,7 @@
           <a:solidFill>
             <a:srgbClr val="EB6834"/>
           </a:solidFill>
-          <a:ln w="6350">
+          <a:ln w="5080">
             <a:solidFill>
               <a:srgbClr val="FFFFFF"/>
             </a:solidFill>
@@ -14740,14 +14797,14 @@
       </p:sp>
       <p:sp>
         <p:nvSpPr>
-          <p:cNvPr id="16" name="dot real 7"/>
-          <p:cNvSpPr/>
-          <p:nvPr/>
-        </p:nvSpPr>
-        <p:spPr>
-          <a:xfrm>
-            <a:off x="1381658" y="2734056"/>
-            <a:ext cx="146304" cy="146304"/>
+          <p:cNvPr id="19" name="mini real 2 1"/>
+          <p:cNvSpPr/>
+          <p:nvPr/>
+        </p:nvSpPr>
+        <p:spPr>
+          <a:xfrm>
+            <a:off x="2335754" y="2867558"/>
+            <a:ext cx="60512" cy="60512"/>
           </a:xfrm>
           <a:prstGeom prst="ellipse">
             <a:avLst/>
@@ -14755,7 +14812,7 @@
           <a:solidFill>
             <a:srgbClr val="EB6834"/>
           </a:solidFill>
-          <a:ln w="6350">
+          <a:ln w="5080">
             <a:solidFill>
               <a:srgbClr val="FFFFFF"/>
             </a:solidFill>
@@ -14765,14 +14822,14 @@
       </p:sp>
       <p:sp>
         <p:nvSpPr>
-          <p:cNvPr id="17" name="dot real 8"/>
-          <p:cNvSpPr/>
-          <p:nvPr/>
-        </p:nvSpPr>
-        <p:spPr>
-          <a:xfrm>
-            <a:off x="2098548" y="2660904"/>
-            <a:ext cx="146304" cy="146304"/>
+          <p:cNvPr id="20" name="mini real 2 2"/>
+          <p:cNvSpPr/>
+          <p:nvPr/>
+        </p:nvSpPr>
+        <p:spPr>
+          <a:xfrm>
+            <a:off x="2450054" y="2867558"/>
+            <a:ext cx="60512" cy="60512"/>
           </a:xfrm>
           <a:prstGeom prst="ellipse">
             <a:avLst/>
@@ -14780,7 +14837,7 @@
           <a:solidFill>
             <a:srgbClr val="EB6834"/>
           </a:solidFill>
-          <a:ln w="6350">
+          <a:ln w="5080">
             <a:solidFill>
               <a:srgbClr val="FFFFFF"/>
             </a:solidFill>
@@ -14790,14 +14847,34 @@
       </p:sp>
       <p:sp>
         <p:nvSpPr>
-          <p:cNvPr id="18" name="dot real 9"/>
-          <p:cNvSpPr/>
-          <p:nvPr/>
-        </p:nvSpPr>
-        <p:spPr>
-          <a:xfrm>
-            <a:off x="2456993" y="2816352"/>
-            <a:ext cx="146304" cy="146304"/>
+          <p:cNvPr id="21" name="mini slab real 3"/>
+          <p:cNvSpPr/>
+          <p:nvPr/>
+        </p:nvSpPr>
+        <p:spPr>
+          <a:xfrm>
+            <a:off x="1277417" y="2350008"/>
+            <a:ext cx="457200" cy="32004"/>
+          </a:xfrm>
+          <a:prstGeom prst="rect">
+            <a:avLst/>
+          </a:prstGeom>
+          <a:solidFill>
+            <a:srgbClr val="52514E"/>
+          </a:solidFill>
+          <a:ln/>
+        </p:spPr>
+      </p:sp>
+      <p:sp>
+        <p:nvSpPr>
+          <p:cNvPr id="22" name="mini real 3 0"/>
+          <p:cNvSpPr/>
+          <p:nvPr/>
+        </p:nvSpPr>
+        <p:spPr>
+          <a:xfrm>
+            <a:off x="1361461" y="2423160"/>
+            <a:ext cx="60512" cy="60512"/>
           </a:xfrm>
           <a:prstGeom prst="ellipse">
             <a:avLst/>
@@ -14805,7 +14882,7 @@
           <a:solidFill>
             <a:srgbClr val="EB6834"/>
           </a:solidFill>
-          <a:ln w="6350">
+          <a:ln w="5080">
             <a:solidFill>
               <a:srgbClr val="FFFFFF"/>
             </a:solidFill>
@@ -14815,14 +14892,14 @@
       </p:sp>
       <p:sp>
         <p:nvSpPr>
-          <p:cNvPr id="19" name="dot real 10"/>
-          <p:cNvSpPr/>
-          <p:nvPr/>
-        </p:nvSpPr>
-        <p:spPr>
-          <a:xfrm>
-            <a:off x="1740103" y="2624328"/>
-            <a:ext cx="146304" cy="146304"/>
+          <p:cNvPr id="23" name="mini real 3 1"/>
+          <p:cNvSpPr/>
+          <p:nvPr/>
+        </p:nvSpPr>
+        <p:spPr>
+          <a:xfrm>
+            <a:off x="1475761" y="2423160"/>
+            <a:ext cx="60512" cy="60512"/>
           </a:xfrm>
           <a:prstGeom prst="ellipse">
             <a:avLst/>
@@ -14830,7 +14907,7 @@
           <a:solidFill>
             <a:srgbClr val="EB6834"/>
           </a:solidFill>
-          <a:ln w="6350">
+          <a:ln w="5080">
             <a:solidFill>
               <a:srgbClr val="FFFFFF"/>
             </a:solidFill>
@@ -14840,14 +14917,14 @@
       </p:sp>
       <p:sp>
         <p:nvSpPr>
-          <p:cNvPr id="20" name="dot real 11"/>
-          <p:cNvSpPr/>
-          <p:nvPr/>
-        </p:nvSpPr>
-        <p:spPr>
-          <a:xfrm>
-            <a:off x="2322576" y="2898648"/>
-            <a:ext cx="146304" cy="146304"/>
+          <p:cNvPr id="24" name="mini real 3 2"/>
+          <p:cNvSpPr/>
+          <p:nvPr/>
+        </p:nvSpPr>
+        <p:spPr>
+          <a:xfrm>
+            <a:off x="1590061" y="2423160"/>
+            <a:ext cx="60512" cy="60512"/>
           </a:xfrm>
           <a:prstGeom prst="ellipse">
             <a:avLst/>
@@ -14855,7 +14932,7 @@
           <a:solidFill>
             <a:srgbClr val="EB6834"/>
           </a:solidFill>
-          <a:ln w="6350">
+          <a:ln w="5080">
             <a:solidFill>
               <a:srgbClr val="FFFFFF"/>
             </a:solidFill>
@@ -14865,14 +14942,204 @@
       </p:sp>
       <p:sp>
         <p:nvSpPr>
-          <p:cNvPr id="21" name="real cluster ring"/>
-          <p:cNvSpPr/>
-          <p:nvPr/>
-        </p:nvSpPr>
-        <p:spPr>
-          <a:xfrm>
-            <a:off x="1141171" y="2624328"/>
-            <a:ext cx="1702613" cy="420624"/>
+          <p:cNvPr id="25" name="mini slab real 4"/>
+          <p:cNvSpPr/>
+          <p:nvPr/>
+        </p:nvSpPr>
+        <p:spPr>
+          <a:xfrm>
+            <a:off x="1911096" y="2399386"/>
+            <a:ext cx="457200" cy="32004"/>
+          </a:xfrm>
+          <a:prstGeom prst="rect">
+            <a:avLst/>
+          </a:prstGeom>
+          <a:solidFill>
+            <a:srgbClr val="52514E"/>
+          </a:solidFill>
+          <a:ln/>
+        </p:spPr>
+      </p:sp>
+      <p:sp>
+        <p:nvSpPr>
+          <p:cNvPr id="26" name="mini real 4 0"/>
+          <p:cNvSpPr/>
+          <p:nvPr/>
+        </p:nvSpPr>
+        <p:spPr>
+          <a:xfrm>
+            <a:off x="1995140" y="2472538"/>
+            <a:ext cx="60512" cy="60512"/>
+          </a:xfrm>
+          <a:prstGeom prst="ellipse">
+            <a:avLst/>
+          </a:prstGeom>
+          <a:solidFill>
+            <a:srgbClr val="EB6834"/>
+          </a:solidFill>
+          <a:ln w="5080">
+            <a:solidFill>
+              <a:srgbClr val="FFFFFF"/>
+            </a:solidFill>
+            <a:prstDash val="solid"/>
+          </a:ln>
+        </p:spPr>
+      </p:sp>
+      <p:sp>
+        <p:nvSpPr>
+          <p:cNvPr id="27" name="mini real 4 1"/>
+          <p:cNvSpPr/>
+          <p:nvPr/>
+        </p:nvSpPr>
+        <p:spPr>
+          <a:xfrm>
+            <a:off x="2109440" y="2472538"/>
+            <a:ext cx="60512" cy="60512"/>
+          </a:xfrm>
+          <a:prstGeom prst="ellipse">
+            <a:avLst/>
+          </a:prstGeom>
+          <a:solidFill>
+            <a:srgbClr val="EB6834"/>
+          </a:solidFill>
+          <a:ln w="5080">
+            <a:solidFill>
+              <a:srgbClr val="FFFFFF"/>
+            </a:solidFill>
+            <a:prstDash val="solid"/>
+          </a:ln>
+        </p:spPr>
+      </p:sp>
+      <p:sp>
+        <p:nvSpPr>
+          <p:cNvPr id="28" name="mini real 4 2"/>
+          <p:cNvSpPr/>
+          <p:nvPr/>
+        </p:nvSpPr>
+        <p:spPr>
+          <a:xfrm>
+            <a:off x="2223740" y="2472538"/>
+            <a:ext cx="60512" cy="60512"/>
+          </a:xfrm>
+          <a:prstGeom prst="ellipse">
+            <a:avLst/>
+          </a:prstGeom>
+          <a:solidFill>
+            <a:srgbClr val="EB6834"/>
+          </a:solidFill>
+          <a:ln w="5080">
+            <a:solidFill>
+              <a:srgbClr val="FFFFFF"/>
+            </a:solidFill>
+            <a:prstDash val="solid"/>
+          </a:ln>
+        </p:spPr>
+      </p:sp>
+      <p:sp>
+        <p:nvSpPr>
+          <p:cNvPr id="29" name="mini slab real 5"/>
+          <p:cNvSpPr/>
+          <p:nvPr/>
+        </p:nvSpPr>
+        <p:spPr>
+          <a:xfrm>
+            <a:off x="2499512" y="2473452"/>
+            <a:ext cx="457200" cy="32004"/>
+          </a:xfrm>
+          <a:prstGeom prst="rect">
+            <a:avLst/>
+          </a:prstGeom>
+          <a:solidFill>
+            <a:srgbClr val="52514E"/>
+          </a:solidFill>
+          <a:ln/>
+        </p:spPr>
+      </p:sp>
+      <p:sp>
+        <p:nvSpPr>
+          <p:cNvPr id="30" name="mini real 5 0"/>
+          <p:cNvSpPr/>
+          <p:nvPr/>
+        </p:nvSpPr>
+        <p:spPr>
+          <a:xfrm>
+            <a:off x="2583557" y="2546604"/>
+            <a:ext cx="60512" cy="60512"/>
+          </a:xfrm>
+          <a:prstGeom prst="ellipse">
+            <a:avLst/>
+          </a:prstGeom>
+          <a:solidFill>
+            <a:srgbClr val="EB6834"/>
+          </a:solidFill>
+          <a:ln w="5080">
+            <a:solidFill>
+              <a:srgbClr val="FFFFFF"/>
+            </a:solidFill>
+            <a:prstDash val="solid"/>
+          </a:ln>
+        </p:spPr>
+      </p:sp>
+      <p:sp>
+        <p:nvSpPr>
+          <p:cNvPr id="31" name="mini real 5 1"/>
+          <p:cNvSpPr/>
+          <p:nvPr/>
+        </p:nvSpPr>
+        <p:spPr>
+          <a:xfrm>
+            <a:off x="2697857" y="2546604"/>
+            <a:ext cx="60512" cy="60512"/>
+          </a:xfrm>
+          <a:prstGeom prst="ellipse">
+            <a:avLst/>
+          </a:prstGeom>
+          <a:solidFill>
+            <a:srgbClr val="EB6834"/>
+          </a:solidFill>
+          <a:ln w="5080">
+            <a:solidFill>
+              <a:srgbClr val="FFFFFF"/>
+            </a:solidFill>
+            <a:prstDash val="solid"/>
+          </a:ln>
+        </p:spPr>
+      </p:sp>
+      <p:sp>
+        <p:nvSpPr>
+          <p:cNvPr id="32" name="mini real 5 2"/>
+          <p:cNvSpPr/>
+          <p:nvPr/>
+        </p:nvSpPr>
+        <p:spPr>
+          <a:xfrm>
+            <a:off x="2812157" y="2546604"/>
+            <a:ext cx="60512" cy="60512"/>
+          </a:xfrm>
+          <a:prstGeom prst="ellipse">
+            <a:avLst/>
+          </a:prstGeom>
+          <a:solidFill>
+            <a:srgbClr val="EB6834"/>
+          </a:solidFill>
+          <a:ln w="5080">
+            <a:solidFill>
+              <a:srgbClr val="FFFFFF"/>
+            </a:solidFill>
+            <a:prstDash val="solid"/>
+          </a:ln>
+        </p:spPr>
+      </p:sp>
+      <p:sp>
+        <p:nvSpPr>
+          <p:cNvPr id="33" name="real cluster ring"/>
+          <p:cNvSpPr/>
+          <p:nvPr/>
+        </p:nvSpPr>
+        <p:spPr>
+          <a:xfrm>
+            <a:off x="987552" y="2279142"/>
+            <a:ext cx="2263140" cy="839419"/>
           </a:xfrm>
           <a:prstGeom prst="ellipse">
             <a:avLst/>
@@ -14887,14 +15154,14 @@
       </p:sp>
       <p:sp>
         <p:nvSpPr>
-          <p:cNvPr id="22" name="real note"/>
+          <p:cNvPr id="34" name="real note"/>
           <p:cNvSpPr txBox="1"/>
           <p:nvPr/>
         </p:nvSpPr>
         <p:spPr>
           <a:xfrm>
-            <a:off x="3023006" y="2377440"/>
-            <a:ext cx="2464308" cy="457200"/>
+            <a:off x="3359506" y="2217420"/>
+            <a:ext cx="2172614" cy="457200"/>
           </a:xfrm>
           <a:prstGeom prst="rect">
             <a:avLst/>
@@ -14915,7 +15182,7 @@
                   <a:srgbClr val="52514E"/>
                 </a:solidFill>
               </a:rPr>
-              <a:t>a method tuned here measures fit to that project</a:t>
+              <a:t>a method tuned here only fits that project</a:t>
             </a:r>
             <a:endParaRPr lang="en-US" sz="1100" dirty="0"/>
           </a:p>
@@ -14923,7 +15190,7 @@
       </p:sp>
       <p:sp>
         <p:nvSpPr>
-          <p:cNvPr id="23" name="space synthetic"/>
+          <p:cNvPr id="35" name="space synthetic"/>
           <p:cNvSpPr/>
           <p:nvPr/>
         </p:nvSpPr>
@@ -14945,14 +15212,14 @@
       </p:sp>
       <p:sp>
         <p:nvSpPr>
-          <p:cNvPr id="24" name="space head synthetic"/>
+          <p:cNvPr id="36" name="space head synthetic"/>
           <p:cNvSpPr txBox="1"/>
           <p:nvPr/>
         </p:nvSpPr>
         <p:spPr>
           <a:xfrm>
-            <a:off x="731520" y="3721608"/>
-            <a:ext cx="4846320" cy="566928"/>
+            <a:off x="731520" y="3703320"/>
+            <a:ext cx="4846320" cy="292608"/>
           </a:xfrm>
           <a:prstGeom prst="rect">
             <a:avLst/>
@@ -14961,7 +15228,7 @@
           <a:ln/>
         </p:spPr>
         <p:txBody>
-          <a:bodyPr wrap="square" lIns="0" tIns="0" rIns="0" bIns="0" rtlCol="0" anchor="t"/>
+          <a:bodyPr wrap="square" lIns="0" tIns="0" rIns="0" bIns="0" rtlCol="0" anchor="ctr"/>
           <a:lstStyle/>
           <a:p>
             <a:pPr indent="0" marL="0">
@@ -14975,9 +15242,6 @@
               </a:rPr>
               <a:t>CrossMEP</a:t>
             </a:r>
-            <a:endParaRPr lang="en-US" sz="1400" dirty="0"/>
-          </a:p>
-          <a:p>
             <a:pPr indent="0" marL="0">
               <a:buNone/>
             </a:pPr>
@@ -14987,7 +15251,7 @@
                   <a:srgbClr val="52514E"/>
                 </a:solidFill>
               </a:rPr>
-              <a:t>the space filled by construction, without limit: a new seed is a new set; uniform over the tiers, or any mix you ask for (generate_custom)</a:t>
+              <a:t>   every tier · kinds and surfaces varied · unlimited</a:t>
             </a:r>
             <a:endParaRPr lang="en-US" sz="1400" dirty="0"/>
           </a:p>
@@ -14995,14 +15259,14 @@
       </p:sp>
       <p:sp>
         <p:nvSpPr>
-          <p:cNvPr id="25" name="x axis synthetic"/>
-          <p:cNvSpPr/>
-          <p:nvPr/>
-        </p:nvSpPr>
-        <p:spPr>
-          <a:xfrm>
-            <a:off x="1051560" y="5303520"/>
-            <a:ext cx="4480560" cy="0"/>
+          <p:cNvPr id="37" name="x axis synthetic"/>
+          <p:cNvSpPr/>
+          <p:nvPr/>
+        </p:nvSpPr>
+        <p:spPr>
+          <a:xfrm>
+            <a:off x="1005840" y="5321808"/>
+            <a:ext cx="4526280" cy="0"/>
           </a:xfrm>
           <a:prstGeom prst="line">
             <a:avLst/>
@@ -15019,14 +15283,14 @@
       </p:sp>
       <p:sp>
         <p:nvSpPr>
-          <p:cNvPr id="26" name="y axis synthetic"/>
-          <p:cNvSpPr/>
-          <p:nvPr/>
-        </p:nvSpPr>
-        <p:spPr>
-          <a:xfrm>
-            <a:off x="1051560" y="4389120"/>
-            <a:ext cx="0" cy="914400"/>
+          <p:cNvPr id="38" name="y axis synthetic"/>
+          <p:cNvSpPr/>
+          <p:nvPr/>
+        </p:nvSpPr>
+        <p:spPr>
+          <a:xfrm>
+            <a:off x="1005840" y="4087368"/>
+            <a:ext cx="0" cy="1234440"/>
           </a:xfrm>
           <a:prstGeom prst="line">
             <a:avLst/>
@@ -15043,14 +15307,14 @@
       </p:sp>
       <p:sp>
         <p:nvSpPr>
-          <p:cNvPr id="27" name="x label synthetic"/>
+          <p:cNvPr id="39" name="x label synthetic"/>
           <p:cNvSpPr txBox="1"/>
           <p:nvPr/>
         </p:nvSpPr>
         <p:spPr>
           <a:xfrm>
-            <a:off x="1051560" y="5330952"/>
-            <a:ext cx="4480560" cy="228600"/>
+            <a:off x="1005840" y="5349240"/>
+            <a:ext cx="4526280" cy="228600"/>
           </a:xfrm>
           <a:prstGeom prst="rect">
             <a:avLst/>
@@ -15079,14 +15343,14 @@
       </p:sp>
       <p:sp>
         <p:nvSpPr>
-          <p:cNvPr id="28" name="y label synthetic"/>
+          <p:cNvPr id="40" name="y label synthetic"/>
           <p:cNvSpPr txBox="1"/>
           <p:nvPr/>
         </p:nvSpPr>
         <p:spPr>
           <a:xfrm rot="16200000">
-            <a:off x="566928" y="4389120"/>
-            <a:ext cx="457200" cy="914400"/>
+            <a:off x="521208" y="4087368"/>
+            <a:ext cx="457200" cy="1234440"/>
           </a:xfrm>
           <a:prstGeom prst="rect">
             <a:avLst/>
@@ -15115,14 +15379,34 @@
       </p:sp>
       <p:sp>
         <p:nvSpPr>
-          <p:cNvPr id="29" name="dot syn 00"/>
-          <p:cNvSpPr/>
-          <p:nvPr/>
-        </p:nvSpPr>
-        <p:spPr>
-          <a:xfrm>
-            <a:off x="1350569" y="5134356"/>
-            <a:ext cx="118872" cy="118872"/>
+          <p:cNvPr id="41" name="mini slab syn 10"/>
+          <p:cNvSpPr/>
+          <p:nvPr/>
+        </p:nvSpPr>
+        <p:spPr>
+          <a:xfrm>
+            <a:off x="1060704" y="4133088"/>
+            <a:ext cx="456057" cy="32004"/>
+          </a:xfrm>
+          <a:prstGeom prst="rect">
+            <a:avLst/>
+          </a:prstGeom>
+          <a:solidFill>
+            <a:srgbClr val="52514E"/>
+          </a:solidFill>
+          <a:ln/>
+        </p:spPr>
+      </p:sp>
+      <p:sp>
+        <p:nvSpPr>
+          <p:cNvPr id="42" name="mini syn 10 0"/>
+          <p:cNvSpPr/>
+          <p:nvPr/>
+        </p:nvSpPr>
+        <p:spPr>
+          <a:xfrm>
+            <a:off x="1247585" y="4206240"/>
+            <a:ext cx="82296" cy="82296"/>
           </a:xfrm>
           <a:prstGeom prst="ellipse">
             <a:avLst/>
@@ -15130,7 +15414,7 @@
           <a:solidFill>
             <a:schemeClr val="accent1"/>
           </a:solidFill>
-          <a:ln w="6350">
+          <a:ln w="5080">
             <a:solidFill>
               <a:srgbClr val="FFFFFF"/>
             </a:solidFill>
@@ -15140,22 +15424,42 @@
       </p:sp>
       <p:sp>
         <p:nvSpPr>
-          <p:cNvPr id="30" name="dot syn 01"/>
-          <p:cNvSpPr/>
-          <p:nvPr/>
-        </p:nvSpPr>
-        <p:spPr>
-          <a:xfrm>
-            <a:off x="1350569" y="4896612"/>
-            <a:ext cx="118872" cy="118872"/>
-          </a:xfrm>
-          <a:prstGeom prst="ellipse">
+          <p:cNvPr id="43" name="mini slab syn 11"/>
+          <p:cNvSpPr/>
+          <p:nvPr/>
+        </p:nvSpPr>
+        <p:spPr>
+          <a:xfrm>
+            <a:off x="1060704" y="4544568"/>
+            <a:ext cx="456057" cy="32004"/>
+          </a:xfrm>
+          <a:prstGeom prst="rect">
+            <a:avLst/>
+          </a:prstGeom>
+          <a:solidFill>
+            <a:srgbClr val="52514E"/>
+          </a:solidFill>
+          <a:ln/>
+        </p:spPr>
+      </p:sp>
+      <p:sp>
+        <p:nvSpPr>
+          <p:cNvPr id="44" name="mini syn 11 0"/>
+          <p:cNvSpPr/>
+          <p:nvPr/>
+        </p:nvSpPr>
+        <p:spPr>
+          <a:xfrm>
+            <a:off x="1220153" y="4608576"/>
+            <a:ext cx="137160" cy="100584"/>
+          </a:xfrm>
+          <a:prstGeom prst="rect">
             <a:avLst/>
           </a:prstGeom>
           <a:solidFill>
             <a:schemeClr val="accent1"/>
           </a:solidFill>
-          <a:ln w="6350">
+          <a:ln w="5080">
             <a:solidFill>
               <a:srgbClr val="FFFFFF"/>
             </a:solidFill>
@@ -15165,14 +15469,34 @@
       </p:sp>
       <p:sp>
         <p:nvSpPr>
-          <p:cNvPr id="31" name="dot syn 02"/>
-          <p:cNvSpPr/>
-          <p:nvPr/>
-        </p:nvSpPr>
-        <p:spPr>
-          <a:xfrm>
-            <a:off x="1350569" y="4658868"/>
-            <a:ext cx="118872" cy="118872"/>
+          <p:cNvPr id="45" name="mini wall syn 12"/>
+          <p:cNvSpPr/>
+          <p:nvPr/>
+        </p:nvSpPr>
+        <p:spPr>
+          <a:xfrm>
+            <a:off x="1060704" y="4956048"/>
+            <a:ext cx="32004" cy="320040"/>
+          </a:xfrm>
+          <a:prstGeom prst="rect">
+            <a:avLst/>
+          </a:prstGeom>
+          <a:solidFill>
+            <a:srgbClr val="52514E"/>
+          </a:solidFill>
+          <a:ln/>
+        </p:spPr>
+      </p:sp>
+      <p:sp>
+        <p:nvSpPr>
+          <p:cNvPr id="46" name="mini syn 12 0"/>
+          <p:cNvSpPr/>
+          <p:nvPr/>
+        </p:nvSpPr>
+        <p:spPr>
+          <a:xfrm>
+            <a:off x="1143000" y="5074920"/>
+            <a:ext cx="82296" cy="82296"/>
           </a:xfrm>
           <a:prstGeom prst="ellipse">
             <a:avLst/>
@@ -15180,7 +15504,7 @@
           <a:solidFill>
             <a:schemeClr val="accent1"/>
           </a:solidFill>
-          <a:ln w="6350">
+          <a:ln w="5080">
             <a:solidFill>
               <a:srgbClr val="FFFFFF"/>
             </a:solidFill>
@@ -15190,14 +15514,34 @@
       </p:sp>
       <p:sp>
         <p:nvSpPr>
-          <p:cNvPr id="32" name="dot syn 03"/>
-          <p:cNvSpPr/>
-          <p:nvPr/>
-        </p:nvSpPr>
-        <p:spPr>
-          <a:xfrm>
-            <a:off x="1350569" y="4421124"/>
-            <a:ext cx="118872" cy="118872"/>
+          <p:cNvPr id="47" name="mini slab syn 20"/>
+          <p:cNvSpPr/>
+          <p:nvPr/>
+        </p:nvSpPr>
+        <p:spPr>
+          <a:xfrm>
+            <a:off x="1626489" y="4133088"/>
+            <a:ext cx="456057" cy="32004"/>
+          </a:xfrm>
+          <a:prstGeom prst="rect">
+            <a:avLst/>
+          </a:prstGeom>
+          <a:solidFill>
+            <a:srgbClr val="52514E"/>
+          </a:solidFill>
+          <a:ln/>
+        </p:spPr>
+      </p:sp>
+      <p:sp>
+        <p:nvSpPr>
+          <p:cNvPr id="48" name="mini syn 20 0"/>
+          <p:cNvSpPr/>
+          <p:nvPr/>
+        </p:nvSpPr>
+        <p:spPr>
+          <a:xfrm>
+            <a:off x="1738268" y="4206240"/>
+            <a:ext cx="80481" cy="80481"/>
           </a:xfrm>
           <a:prstGeom prst="ellipse">
             <a:avLst/>
@@ -15205,7 +15549,7 @@
           <a:solidFill>
             <a:schemeClr val="accent1"/>
           </a:solidFill>
-          <a:ln w="6350">
+          <a:ln w="5080">
             <a:solidFill>
               <a:srgbClr val="FFFFFF"/>
             </a:solidFill>
@@ -15215,14 +15559,14 @@
       </p:sp>
       <p:sp>
         <p:nvSpPr>
-          <p:cNvPr id="33" name="dot syn 10"/>
-          <p:cNvSpPr/>
-          <p:nvPr/>
-        </p:nvSpPr>
-        <p:spPr>
-          <a:xfrm>
-            <a:off x="1910639" y="5134356"/>
-            <a:ext cx="118872" cy="118872"/>
+          <p:cNvPr id="49" name="mini syn 20 1"/>
+          <p:cNvSpPr/>
+          <p:nvPr/>
+        </p:nvSpPr>
+        <p:spPr>
+          <a:xfrm>
+            <a:off x="1890287" y="4206240"/>
+            <a:ext cx="80481" cy="80481"/>
           </a:xfrm>
           <a:prstGeom prst="ellipse">
             <a:avLst/>
@@ -15230,7 +15574,7 @@
           <a:solidFill>
             <a:schemeClr val="accent1"/>
           </a:solidFill>
-          <a:ln w="6350">
+          <a:ln w="5080">
             <a:solidFill>
               <a:srgbClr val="FFFFFF"/>
             </a:solidFill>
@@ -15240,22 +15584,42 @@
       </p:sp>
       <p:sp>
         <p:nvSpPr>
-          <p:cNvPr id="34" name="dot syn 11"/>
-          <p:cNvSpPr/>
-          <p:nvPr/>
-        </p:nvSpPr>
-        <p:spPr>
-          <a:xfrm>
-            <a:off x="1910639" y="4896612"/>
-            <a:ext cx="118872" cy="118872"/>
-          </a:xfrm>
-          <a:prstGeom prst="ellipse">
+          <p:cNvPr id="50" name="mini slab syn 21"/>
+          <p:cNvSpPr/>
+          <p:nvPr/>
+        </p:nvSpPr>
+        <p:spPr>
+          <a:xfrm>
+            <a:off x="1626489" y="4544568"/>
+            <a:ext cx="456057" cy="32004"/>
+          </a:xfrm>
+          <a:prstGeom prst="rect">
+            <a:avLst/>
+          </a:prstGeom>
+          <a:solidFill>
+            <a:srgbClr val="52514E"/>
+          </a:solidFill>
+          <a:ln/>
+        </p:spPr>
+      </p:sp>
+      <p:sp>
+        <p:nvSpPr>
+          <p:cNvPr id="51" name="mini syn 21 0"/>
+          <p:cNvSpPr/>
+          <p:nvPr/>
+        </p:nvSpPr>
+        <p:spPr>
+          <a:xfrm>
+            <a:off x="1711441" y="4608576"/>
+            <a:ext cx="134134" cy="98365"/>
+          </a:xfrm>
+          <a:prstGeom prst="rect">
             <a:avLst/>
           </a:prstGeom>
           <a:solidFill>
             <a:schemeClr val="accent1"/>
           </a:solidFill>
-          <a:ln w="6350">
+          <a:ln w="5080">
             <a:solidFill>
               <a:srgbClr val="FFFFFF"/>
             </a:solidFill>
@@ -15265,14 +15629,14 @@
       </p:sp>
       <p:sp>
         <p:nvSpPr>
-          <p:cNvPr id="35" name="dot syn 12"/>
-          <p:cNvSpPr/>
-          <p:nvPr/>
-        </p:nvSpPr>
-        <p:spPr>
-          <a:xfrm>
-            <a:off x="1910639" y="4658868"/>
-            <a:ext cx="118872" cy="118872"/>
+          <p:cNvPr id="52" name="mini syn 21 1"/>
+          <p:cNvSpPr/>
+          <p:nvPr/>
+        </p:nvSpPr>
+        <p:spPr>
+          <a:xfrm>
+            <a:off x="1890287" y="4617720"/>
+            <a:ext cx="80481" cy="80481"/>
           </a:xfrm>
           <a:prstGeom prst="ellipse">
             <a:avLst/>
@@ -15280,7 +15644,7 @@
           <a:solidFill>
             <a:schemeClr val="accent1"/>
           </a:solidFill>
-          <a:ln w="6350">
+          <a:ln w="5080">
             <a:solidFill>
               <a:srgbClr val="FFFFFF"/>
             </a:solidFill>
@@ -15290,14 +15654,34 @@
       </p:sp>
       <p:sp>
         <p:nvSpPr>
-          <p:cNvPr id="36" name="dot syn 13"/>
-          <p:cNvSpPr/>
-          <p:nvPr/>
-        </p:nvSpPr>
-        <p:spPr>
-          <a:xfrm>
-            <a:off x="1910639" y="4421124"/>
-            <a:ext cx="118872" cy="118872"/>
+          <p:cNvPr id="53" name="mini wall syn 22"/>
+          <p:cNvSpPr/>
+          <p:nvPr/>
+        </p:nvSpPr>
+        <p:spPr>
+          <a:xfrm>
+            <a:off x="1626489" y="4956048"/>
+            <a:ext cx="32004" cy="320040"/>
+          </a:xfrm>
+          <a:prstGeom prst="rect">
+            <a:avLst/>
+          </a:prstGeom>
+          <a:solidFill>
+            <a:srgbClr val="52514E"/>
+          </a:solidFill>
+          <a:ln/>
+        </p:spPr>
+      </p:sp>
+      <p:sp>
+        <p:nvSpPr>
+          <p:cNvPr id="54" name="mini syn 22 0"/>
+          <p:cNvSpPr/>
+          <p:nvPr/>
+        </p:nvSpPr>
+        <p:spPr>
+          <a:xfrm>
+            <a:off x="1708785" y="5025800"/>
+            <a:ext cx="73855" cy="73855"/>
           </a:xfrm>
           <a:prstGeom prst="ellipse">
             <a:avLst/>
@@ -15305,7 +15689,7 @@
           <a:solidFill>
             <a:schemeClr val="accent1"/>
           </a:solidFill>
-          <a:ln w="6350">
+          <a:ln w="5080">
             <a:solidFill>
               <a:srgbClr val="FFFFFF"/>
             </a:solidFill>
@@ -15315,22 +15699,22 @@
       </p:sp>
       <p:sp>
         <p:nvSpPr>
-          <p:cNvPr id="37" name="dot syn 20"/>
-          <p:cNvSpPr/>
-          <p:nvPr/>
-        </p:nvSpPr>
-        <p:spPr>
-          <a:xfrm>
-            <a:off x="2470709" y="5134356"/>
-            <a:ext cx="118872" cy="118872"/>
-          </a:xfrm>
-          <a:prstGeom prst="ellipse">
+          <p:cNvPr id="55" name="mini syn 22 1"/>
+          <p:cNvSpPr/>
+          <p:nvPr/>
+        </p:nvSpPr>
+        <p:spPr>
+          <a:xfrm>
+            <a:off x="1699641" y="5148893"/>
+            <a:ext cx="98474" cy="41031"/>
+          </a:xfrm>
+          <a:prstGeom prst="rect">
             <a:avLst/>
           </a:prstGeom>
           <a:solidFill>
             <a:schemeClr val="accent1"/>
           </a:solidFill>
-          <a:ln w="6350">
+          <a:ln w="5080">
             <a:solidFill>
               <a:srgbClr val="FFFFFF"/>
             </a:solidFill>
@@ -15340,14 +15724,34 @@
       </p:sp>
       <p:sp>
         <p:nvSpPr>
-          <p:cNvPr id="38" name="dot syn 21"/>
-          <p:cNvSpPr/>
-          <p:nvPr/>
-        </p:nvSpPr>
-        <p:spPr>
-          <a:xfrm>
-            <a:off x="2470709" y="4896612"/>
-            <a:ext cx="118872" cy="118872"/>
+          <p:cNvPr id="56" name="mini slab syn 30"/>
+          <p:cNvSpPr/>
+          <p:nvPr/>
+        </p:nvSpPr>
+        <p:spPr>
+          <a:xfrm>
+            <a:off x="2192274" y="4133088"/>
+            <a:ext cx="456057" cy="32004"/>
+          </a:xfrm>
+          <a:prstGeom prst="rect">
+            <a:avLst/>
+          </a:prstGeom>
+          <a:solidFill>
+            <a:srgbClr val="52514E"/>
+          </a:solidFill>
+          <a:ln/>
+        </p:spPr>
+      </p:sp>
+      <p:sp>
+        <p:nvSpPr>
+          <p:cNvPr id="57" name="mini syn 30 0"/>
+          <p:cNvSpPr/>
+          <p:nvPr/>
+        </p:nvSpPr>
+        <p:spPr>
+          <a:xfrm>
+            <a:off x="2276108" y="4206240"/>
+            <a:ext cx="60360" cy="60360"/>
           </a:xfrm>
           <a:prstGeom prst="ellipse">
             <a:avLst/>
@@ -15355,7 +15759,7 @@
           <a:solidFill>
             <a:schemeClr val="accent1"/>
           </a:solidFill>
-          <a:ln w="6350">
+          <a:ln w="5080">
             <a:solidFill>
               <a:srgbClr val="FFFFFF"/>
             </a:solidFill>
@@ -15365,14 +15769,14 @@
       </p:sp>
       <p:sp>
         <p:nvSpPr>
-          <p:cNvPr id="39" name="dot syn 22"/>
-          <p:cNvSpPr/>
-          <p:nvPr/>
-        </p:nvSpPr>
-        <p:spPr>
-          <a:xfrm>
-            <a:off x="2470709" y="4658868"/>
-            <a:ext cx="118872" cy="118872"/>
+          <p:cNvPr id="58" name="mini syn 30 1"/>
+          <p:cNvSpPr/>
+          <p:nvPr/>
+        </p:nvSpPr>
+        <p:spPr>
+          <a:xfrm>
+            <a:off x="2390122" y="4206240"/>
+            <a:ext cx="60360" cy="60360"/>
           </a:xfrm>
           <a:prstGeom prst="ellipse">
             <a:avLst/>
@@ -15380,7 +15784,7 @@
           <a:solidFill>
             <a:schemeClr val="accent1"/>
           </a:solidFill>
-          <a:ln w="6350">
+          <a:ln w="5080">
             <a:solidFill>
               <a:srgbClr val="FFFFFF"/>
             </a:solidFill>
@@ -15390,14 +15794,14 @@
       </p:sp>
       <p:sp>
         <p:nvSpPr>
-          <p:cNvPr id="40" name="dot syn 23"/>
-          <p:cNvSpPr/>
-          <p:nvPr/>
-        </p:nvSpPr>
-        <p:spPr>
-          <a:xfrm>
-            <a:off x="2470709" y="4421124"/>
-            <a:ext cx="118872" cy="118872"/>
+          <p:cNvPr id="59" name="mini syn 30 2"/>
+          <p:cNvSpPr/>
+          <p:nvPr/>
+        </p:nvSpPr>
+        <p:spPr>
+          <a:xfrm>
+            <a:off x="2504137" y="4206240"/>
+            <a:ext cx="60360" cy="60360"/>
           </a:xfrm>
           <a:prstGeom prst="ellipse">
             <a:avLst/>
@@ -15405,7 +15809,7 @@
           <a:solidFill>
             <a:schemeClr val="accent1"/>
           </a:solidFill>
-          <a:ln w="6350">
+          <a:ln w="5080">
             <a:solidFill>
               <a:srgbClr val="FFFFFF"/>
             </a:solidFill>
@@ -15415,22 +15819,42 @@
       </p:sp>
       <p:sp>
         <p:nvSpPr>
-          <p:cNvPr id="41" name="dot syn 30"/>
-          <p:cNvSpPr/>
-          <p:nvPr/>
-        </p:nvSpPr>
-        <p:spPr>
-          <a:xfrm>
-            <a:off x="3030779" y="5134356"/>
-            <a:ext cx="118872" cy="118872"/>
-          </a:xfrm>
-          <a:prstGeom prst="ellipse">
+          <p:cNvPr id="60" name="mini slab syn 31"/>
+          <p:cNvSpPr/>
+          <p:nvPr/>
+        </p:nvSpPr>
+        <p:spPr>
+          <a:xfrm>
+            <a:off x="2192274" y="4544568"/>
+            <a:ext cx="456057" cy="32004"/>
+          </a:xfrm>
+          <a:prstGeom prst="rect">
+            <a:avLst/>
+          </a:prstGeom>
+          <a:solidFill>
+            <a:srgbClr val="52514E"/>
+          </a:solidFill>
+          <a:ln/>
+        </p:spPr>
+      </p:sp>
+      <p:sp>
+        <p:nvSpPr>
+          <p:cNvPr id="61" name="mini syn 31 0"/>
+          <p:cNvSpPr/>
+          <p:nvPr/>
+        </p:nvSpPr>
+        <p:spPr>
+          <a:xfrm>
+            <a:off x="2255988" y="4608576"/>
+            <a:ext cx="100601" cy="73774"/>
+          </a:xfrm>
+          <a:prstGeom prst="rect">
             <a:avLst/>
           </a:prstGeom>
           <a:solidFill>
             <a:schemeClr val="accent1"/>
           </a:solidFill>
-          <a:ln w="6350">
+          <a:ln w="5080">
             <a:solidFill>
               <a:srgbClr val="FFFFFF"/>
             </a:solidFill>
@@ -15440,14 +15864,14 @@
       </p:sp>
       <p:sp>
         <p:nvSpPr>
-          <p:cNvPr id="42" name="dot syn 31"/>
-          <p:cNvSpPr/>
-          <p:nvPr/>
-        </p:nvSpPr>
-        <p:spPr>
-          <a:xfrm>
-            <a:off x="3030779" y="4896612"/>
-            <a:ext cx="118872" cy="118872"/>
+          <p:cNvPr id="62" name="mini syn 31 1"/>
+          <p:cNvSpPr/>
+          <p:nvPr/>
+        </p:nvSpPr>
+        <p:spPr>
+          <a:xfrm>
+            <a:off x="2390122" y="4617720"/>
+            <a:ext cx="60360" cy="60360"/>
           </a:xfrm>
           <a:prstGeom prst="ellipse">
             <a:avLst/>
@@ -15455,7 +15879,7 @@
           <a:solidFill>
             <a:schemeClr val="accent1"/>
           </a:solidFill>
-          <a:ln w="6350">
+          <a:ln w="5080">
             <a:solidFill>
               <a:srgbClr val="FFFFFF"/>
             </a:solidFill>
@@ -15465,22 +15889,22 @@
       </p:sp>
       <p:sp>
         <p:nvSpPr>
-          <p:cNvPr id="43" name="dot syn 32"/>
-          <p:cNvSpPr/>
-          <p:nvPr/>
-        </p:nvSpPr>
-        <p:spPr>
-          <a:xfrm>
-            <a:off x="3030779" y="4658868"/>
-            <a:ext cx="118872" cy="118872"/>
-          </a:xfrm>
-          <a:prstGeom prst="ellipse">
+          <p:cNvPr id="63" name="mini syn 31 2"/>
+          <p:cNvSpPr/>
+          <p:nvPr/>
+        </p:nvSpPr>
+        <p:spPr>
+          <a:xfrm>
+            <a:off x="2494076" y="4636008"/>
+            <a:ext cx="80481" cy="33534"/>
+          </a:xfrm>
+          <a:prstGeom prst="rect">
             <a:avLst/>
           </a:prstGeom>
           <a:solidFill>
             <a:schemeClr val="accent1"/>
           </a:solidFill>
-          <a:ln w="6350">
+          <a:ln w="5080">
             <a:solidFill>
               <a:srgbClr val="FFFFFF"/>
             </a:solidFill>
@@ -15490,14 +15914,34 @@
       </p:sp>
       <p:sp>
         <p:nvSpPr>
-          <p:cNvPr id="44" name="dot syn 33"/>
-          <p:cNvSpPr/>
-          <p:nvPr/>
-        </p:nvSpPr>
-        <p:spPr>
-          <a:xfrm>
-            <a:off x="3030779" y="4421124"/>
-            <a:ext cx="118872" cy="118872"/>
+          <p:cNvPr id="64" name="mini wall syn 32"/>
+          <p:cNvSpPr/>
+          <p:nvPr/>
+        </p:nvSpPr>
+        <p:spPr>
+          <a:xfrm>
+            <a:off x="2192274" y="4956048"/>
+            <a:ext cx="32004" cy="320040"/>
+          </a:xfrm>
+          <a:prstGeom prst="rect">
+            <a:avLst/>
+          </a:prstGeom>
+          <a:solidFill>
+            <a:srgbClr val="52514E"/>
+          </a:solidFill>
+          <a:ln/>
+        </p:spPr>
+      </p:sp>
+      <p:sp>
+        <p:nvSpPr>
+          <p:cNvPr id="65" name="mini syn 32 0"/>
+          <p:cNvSpPr/>
+          <p:nvPr/>
+        </p:nvSpPr>
+        <p:spPr>
+          <a:xfrm>
+            <a:off x="2274570" y="5008362"/>
+            <a:ext cx="55392" cy="55392"/>
           </a:xfrm>
           <a:prstGeom prst="ellipse">
             <a:avLst/>
@@ -15505,7 +15949,7 @@
           <a:solidFill>
             <a:schemeClr val="accent1"/>
           </a:solidFill>
-          <a:ln w="6350">
+          <a:ln w="5080">
             <a:solidFill>
               <a:srgbClr val="FFFFFF"/>
             </a:solidFill>
@@ -15515,22 +15959,22 @@
       </p:sp>
       <p:sp>
         <p:nvSpPr>
-          <p:cNvPr id="45" name="dot syn 40"/>
-          <p:cNvSpPr/>
-          <p:nvPr/>
-        </p:nvSpPr>
-        <p:spPr>
-          <a:xfrm>
-            <a:off x="3590849" y="5134356"/>
-            <a:ext cx="118872" cy="118872"/>
-          </a:xfrm>
-          <a:prstGeom prst="ellipse">
+          <p:cNvPr id="66" name="mini syn 32 1"/>
+          <p:cNvSpPr/>
+          <p:nvPr/>
+        </p:nvSpPr>
+        <p:spPr>
+          <a:xfrm>
+            <a:off x="2265426" y="5100681"/>
+            <a:ext cx="73855" cy="30773"/>
+          </a:xfrm>
+          <a:prstGeom prst="rect">
             <a:avLst/>
           </a:prstGeom>
           <a:solidFill>
             <a:schemeClr val="accent1"/>
           </a:solidFill>
-          <a:ln w="6350">
+          <a:ln w="5080">
             <a:solidFill>
               <a:srgbClr val="FFFFFF"/>
             </a:solidFill>
@@ -15540,14 +15984,14 @@
       </p:sp>
       <p:sp>
         <p:nvSpPr>
-          <p:cNvPr id="46" name="dot syn 41"/>
-          <p:cNvSpPr/>
-          <p:nvPr/>
-        </p:nvSpPr>
-        <p:spPr>
-          <a:xfrm>
-            <a:off x="3590849" y="4896612"/>
-            <a:ext cx="118872" cy="118872"/>
+          <p:cNvPr id="67" name="mini syn 32 2"/>
+          <p:cNvSpPr/>
+          <p:nvPr/>
+        </p:nvSpPr>
+        <p:spPr>
+          <a:xfrm>
+            <a:off x="2274570" y="5168382"/>
+            <a:ext cx="55392" cy="55392"/>
           </a:xfrm>
           <a:prstGeom prst="ellipse">
             <a:avLst/>
@@ -15555,7 +15999,7 @@
           <a:solidFill>
             <a:schemeClr val="accent1"/>
           </a:solidFill>
-          <a:ln w="6350">
+          <a:ln w="5080">
             <a:solidFill>
               <a:srgbClr val="FFFFFF"/>
             </a:solidFill>
@@ -15565,14 +16009,34 @@
       </p:sp>
       <p:sp>
         <p:nvSpPr>
-          <p:cNvPr id="47" name="dot syn 42"/>
-          <p:cNvSpPr/>
-          <p:nvPr/>
-        </p:nvSpPr>
-        <p:spPr>
-          <a:xfrm>
-            <a:off x="3590849" y="4658868"/>
-            <a:ext cx="118872" cy="118872"/>
+          <p:cNvPr id="68" name="mini slab syn 40"/>
+          <p:cNvSpPr/>
+          <p:nvPr/>
+        </p:nvSpPr>
+        <p:spPr>
+          <a:xfrm>
+            <a:off x="2758059" y="4133088"/>
+            <a:ext cx="456057" cy="32004"/>
+          </a:xfrm>
+          <a:prstGeom prst="rect">
+            <a:avLst/>
+          </a:prstGeom>
+          <a:solidFill>
+            <a:srgbClr val="52514E"/>
+          </a:solidFill>
+          <a:ln/>
+        </p:spPr>
+      </p:sp>
+      <p:sp>
+        <p:nvSpPr>
+          <p:cNvPr id="69" name="mini syn 40 0"/>
+          <p:cNvSpPr/>
+          <p:nvPr/>
+        </p:nvSpPr>
+        <p:spPr>
+          <a:xfrm>
+            <a:off x="2825126" y="4206240"/>
+            <a:ext cx="48288" cy="48288"/>
           </a:xfrm>
           <a:prstGeom prst="ellipse">
             <a:avLst/>
@@ -15580,7 +16044,7 @@
           <a:solidFill>
             <a:schemeClr val="accent1"/>
           </a:solidFill>
-          <a:ln w="6350">
+          <a:ln w="5080">
             <a:solidFill>
               <a:srgbClr val="FFFFFF"/>
             </a:solidFill>
@@ -15590,14 +16054,14 @@
       </p:sp>
       <p:sp>
         <p:nvSpPr>
-          <p:cNvPr id="48" name="dot syn 43"/>
-          <p:cNvSpPr/>
-          <p:nvPr/>
-        </p:nvSpPr>
-        <p:spPr>
-          <a:xfrm>
-            <a:off x="3590849" y="4421124"/>
-            <a:ext cx="118872" cy="118872"/>
+          <p:cNvPr id="70" name="mini syn 40 1"/>
+          <p:cNvSpPr/>
+          <p:nvPr/>
+        </p:nvSpPr>
+        <p:spPr>
+          <a:xfrm>
+            <a:off x="2916338" y="4206240"/>
+            <a:ext cx="48288" cy="48288"/>
           </a:xfrm>
           <a:prstGeom prst="ellipse">
             <a:avLst/>
@@ -15605,7 +16069,7 @@
           <a:solidFill>
             <a:schemeClr val="accent1"/>
           </a:solidFill>
-          <a:ln w="6350">
+          <a:ln w="5080">
             <a:solidFill>
               <a:srgbClr val="FFFFFF"/>
             </a:solidFill>
@@ -15615,14 +16079,14 @@
       </p:sp>
       <p:sp>
         <p:nvSpPr>
-          <p:cNvPr id="49" name="dot syn 50"/>
-          <p:cNvSpPr/>
-          <p:nvPr/>
-        </p:nvSpPr>
-        <p:spPr>
-          <a:xfrm>
-            <a:off x="4150919" y="5134356"/>
-            <a:ext cx="118872" cy="118872"/>
+          <p:cNvPr id="71" name="mini syn 40 2"/>
+          <p:cNvSpPr/>
+          <p:nvPr/>
+        </p:nvSpPr>
+        <p:spPr>
+          <a:xfrm>
+            <a:off x="3007549" y="4206240"/>
+            <a:ext cx="48288" cy="48288"/>
           </a:xfrm>
           <a:prstGeom prst="ellipse">
             <a:avLst/>
@@ -15630,7 +16094,7 @@
           <a:solidFill>
             <a:schemeClr val="accent1"/>
           </a:solidFill>
-          <a:ln w="6350">
+          <a:ln w="5080">
             <a:solidFill>
               <a:srgbClr val="FFFFFF"/>
             </a:solidFill>
@@ -15640,14 +16104,14 @@
       </p:sp>
       <p:sp>
         <p:nvSpPr>
-          <p:cNvPr id="50" name="dot syn 51"/>
-          <p:cNvSpPr/>
-          <p:nvPr/>
-        </p:nvSpPr>
-        <p:spPr>
-          <a:xfrm>
-            <a:off x="4150919" y="4896612"/>
-            <a:ext cx="118872" cy="118872"/>
+          <p:cNvPr id="72" name="mini syn 40 3"/>
+          <p:cNvSpPr/>
+          <p:nvPr/>
+        </p:nvSpPr>
+        <p:spPr>
+          <a:xfrm>
+            <a:off x="3098760" y="4206240"/>
+            <a:ext cx="48288" cy="48288"/>
           </a:xfrm>
           <a:prstGeom prst="ellipse">
             <a:avLst/>
@@ -15655,7 +16119,7 @@
           <a:solidFill>
             <a:schemeClr val="accent1"/>
           </a:solidFill>
-          <a:ln w="6350">
+          <a:ln w="5080">
             <a:solidFill>
               <a:srgbClr val="FFFFFF"/>
             </a:solidFill>
@@ -15665,22 +16129,42 @@
       </p:sp>
       <p:sp>
         <p:nvSpPr>
-          <p:cNvPr id="51" name="dot syn 52"/>
-          <p:cNvSpPr/>
-          <p:nvPr/>
-        </p:nvSpPr>
-        <p:spPr>
-          <a:xfrm>
-            <a:off x="4150919" y="4658868"/>
-            <a:ext cx="118872" cy="118872"/>
-          </a:xfrm>
-          <a:prstGeom prst="ellipse">
+          <p:cNvPr id="73" name="mini slab syn 41"/>
+          <p:cNvSpPr/>
+          <p:nvPr/>
+        </p:nvSpPr>
+        <p:spPr>
+          <a:xfrm>
+            <a:off x="2758059" y="4544568"/>
+            <a:ext cx="456057" cy="32004"/>
+          </a:xfrm>
+          <a:prstGeom prst="rect">
+            <a:avLst/>
+          </a:prstGeom>
+          <a:solidFill>
+            <a:srgbClr val="52514E"/>
+          </a:solidFill>
+          <a:ln/>
+        </p:spPr>
+      </p:sp>
+      <p:sp>
+        <p:nvSpPr>
+          <p:cNvPr id="74" name="mini syn 41 0"/>
+          <p:cNvSpPr/>
+          <p:nvPr/>
+        </p:nvSpPr>
+        <p:spPr>
+          <a:xfrm>
+            <a:off x="2809030" y="4608576"/>
+            <a:ext cx="80481" cy="59019"/>
+          </a:xfrm>
+          <a:prstGeom prst="rect">
             <a:avLst/>
           </a:prstGeom>
           <a:solidFill>
             <a:schemeClr val="accent1"/>
           </a:solidFill>
-          <a:ln w="6350">
+          <a:ln w="5080">
             <a:solidFill>
               <a:srgbClr val="FFFFFF"/>
             </a:solidFill>
@@ -15690,14 +16174,14 @@
       </p:sp>
       <p:sp>
         <p:nvSpPr>
-          <p:cNvPr id="52" name="dot syn 53"/>
-          <p:cNvSpPr/>
-          <p:nvPr/>
-        </p:nvSpPr>
-        <p:spPr>
-          <a:xfrm>
-            <a:off x="4150919" y="4421124"/>
-            <a:ext cx="118872" cy="118872"/>
+          <p:cNvPr id="75" name="mini syn 41 1"/>
+          <p:cNvSpPr/>
+          <p:nvPr/>
+        </p:nvSpPr>
+        <p:spPr>
+          <a:xfrm>
+            <a:off x="2916338" y="4617720"/>
+            <a:ext cx="48288" cy="48288"/>
           </a:xfrm>
           <a:prstGeom prst="ellipse">
             <a:avLst/>
@@ -15705,7 +16189,7 @@
           <a:solidFill>
             <a:schemeClr val="accent1"/>
           </a:solidFill>
-          <a:ln w="6350">
+          <a:ln w="5080">
             <a:solidFill>
               <a:srgbClr val="FFFFFF"/>
             </a:solidFill>
@@ -15715,22 +16199,22 @@
       </p:sp>
       <p:sp>
         <p:nvSpPr>
-          <p:cNvPr id="53" name="dot syn 60"/>
-          <p:cNvSpPr/>
-          <p:nvPr/>
-        </p:nvSpPr>
-        <p:spPr>
-          <a:xfrm>
-            <a:off x="4710989" y="5134356"/>
-            <a:ext cx="118872" cy="118872"/>
-          </a:xfrm>
-          <a:prstGeom prst="ellipse">
+          <p:cNvPr id="76" name="mini syn 41 2"/>
+          <p:cNvSpPr/>
+          <p:nvPr/>
+        </p:nvSpPr>
+        <p:spPr>
+          <a:xfrm>
+            <a:off x="2999501" y="4636008"/>
+            <a:ext cx="64385" cy="26827"/>
+          </a:xfrm>
+          <a:prstGeom prst="rect">
             <a:avLst/>
           </a:prstGeom>
           <a:solidFill>
             <a:schemeClr val="accent1"/>
           </a:solidFill>
-          <a:ln w="6350">
+          <a:ln w="5080">
             <a:solidFill>
               <a:srgbClr val="FFFFFF"/>
             </a:solidFill>
@@ -15740,14 +16224,14 @@
       </p:sp>
       <p:sp>
         <p:nvSpPr>
-          <p:cNvPr id="54" name="dot syn 61"/>
-          <p:cNvSpPr/>
-          <p:nvPr/>
-        </p:nvSpPr>
-        <p:spPr>
-          <a:xfrm>
-            <a:off x="4710989" y="4896612"/>
-            <a:ext cx="118872" cy="118872"/>
+          <p:cNvPr id="77" name="mini syn 41 3"/>
+          <p:cNvSpPr/>
+          <p:nvPr/>
+        </p:nvSpPr>
+        <p:spPr>
+          <a:xfrm>
+            <a:off x="3098760" y="4617720"/>
+            <a:ext cx="48288" cy="48288"/>
           </a:xfrm>
           <a:prstGeom prst="ellipse">
             <a:avLst/>
@@ -15755,7 +16239,7 @@
           <a:solidFill>
             <a:schemeClr val="accent1"/>
           </a:solidFill>
-          <a:ln w="6350">
+          <a:ln w="5080">
             <a:solidFill>
               <a:srgbClr val="FFFFFF"/>
             </a:solidFill>
@@ -15765,14 +16249,34 @@
       </p:sp>
       <p:sp>
         <p:nvSpPr>
-          <p:cNvPr id="55" name="dot syn 62"/>
-          <p:cNvSpPr/>
-          <p:nvPr/>
-        </p:nvSpPr>
-        <p:spPr>
-          <a:xfrm>
-            <a:off x="4710989" y="4658868"/>
-            <a:ext cx="118872" cy="118872"/>
+          <p:cNvPr id="78" name="mini wall syn 42"/>
+          <p:cNvSpPr/>
+          <p:nvPr/>
+        </p:nvSpPr>
+        <p:spPr>
+          <a:xfrm>
+            <a:off x="2758059" y="4956048"/>
+            <a:ext cx="32004" cy="320040"/>
+          </a:xfrm>
+          <a:prstGeom prst="rect">
+            <a:avLst/>
+          </a:prstGeom>
+          <a:solidFill>
+            <a:srgbClr val="52514E"/>
+          </a:solidFill>
+          <a:ln/>
+        </p:spPr>
+      </p:sp>
+      <p:sp>
+        <p:nvSpPr>
+          <p:cNvPr id="79" name="mini syn 42 0"/>
+          <p:cNvSpPr/>
+          <p:nvPr/>
+        </p:nvSpPr>
+        <p:spPr>
+          <a:xfrm>
+            <a:off x="2840355" y="4997899"/>
+            <a:ext cx="44313" cy="44313"/>
           </a:xfrm>
           <a:prstGeom prst="ellipse">
             <a:avLst/>
@@ -15780,7 +16284,7 @@
           <a:solidFill>
             <a:schemeClr val="accent1"/>
           </a:solidFill>
-          <a:ln w="6350">
+          <a:ln w="5080">
             <a:solidFill>
               <a:srgbClr val="FFFFFF"/>
             </a:solidFill>
@@ -15790,22 +16294,22 @@
       </p:sp>
       <p:sp>
         <p:nvSpPr>
-          <p:cNvPr id="56" name="dot syn 63"/>
-          <p:cNvSpPr/>
-          <p:nvPr/>
-        </p:nvSpPr>
-        <p:spPr>
-          <a:xfrm>
-            <a:off x="4710989" y="4421124"/>
-            <a:ext cx="118872" cy="118872"/>
-          </a:xfrm>
-          <a:prstGeom prst="ellipse">
+          <p:cNvPr id="80" name="mini syn 42 1"/>
+          <p:cNvSpPr/>
+          <p:nvPr/>
+        </p:nvSpPr>
+        <p:spPr>
+          <a:xfrm>
+            <a:off x="2831211" y="5071755"/>
+            <a:ext cx="59084" cy="24618"/>
+          </a:xfrm>
+          <a:prstGeom prst="rect">
             <a:avLst/>
           </a:prstGeom>
           <a:solidFill>
             <a:schemeClr val="accent1"/>
           </a:solidFill>
-          <a:ln w="6350">
+          <a:ln w="5080">
             <a:solidFill>
               <a:srgbClr val="FFFFFF"/>
             </a:solidFill>
@@ -15815,14 +16319,14 @@
       </p:sp>
       <p:sp>
         <p:nvSpPr>
-          <p:cNvPr id="57" name="dot syn 70"/>
-          <p:cNvSpPr/>
-          <p:nvPr/>
-        </p:nvSpPr>
-        <p:spPr>
-          <a:xfrm>
-            <a:off x="5271059" y="5134356"/>
-            <a:ext cx="118872" cy="118872"/>
+          <p:cNvPr id="81" name="mini syn 42 2"/>
+          <p:cNvSpPr/>
+          <p:nvPr/>
+        </p:nvSpPr>
+        <p:spPr>
+          <a:xfrm>
+            <a:off x="2840355" y="5125915"/>
+            <a:ext cx="44313" cy="44313"/>
           </a:xfrm>
           <a:prstGeom prst="ellipse">
             <a:avLst/>
@@ -15830,7 +16334,7 @@
           <a:solidFill>
             <a:schemeClr val="accent1"/>
           </a:solidFill>
-          <a:ln w="6350">
+          <a:ln w="5080">
             <a:solidFill>
               <a:srgbClr val="FFFFFF"/>
             </a:solidFill>
@@ -15840,14 +16344,14 @@
       </p:sp>
       <p:sp>
         <p:nvSpPr>
-          <p:cNvPr id="58" name="dot syn 71"/>
-          <p:cNvSpPr/>
-          <p:nvPr/>
-        </p:nvSpPr>
-        <p:spPr>
-          <a:xfrm>
-            <a:off x="5271059" y="4896612"/>
-            <a:ext cx="118872" cy="118872"/>
+          <p:cNvPr id="82" name="mini syn 42 3"/>
+          <p:cNvSpPr/>
+          <p:nvPr/>
+        </p:nvSpPr>
+        <p:spPr>
+          <a:xfrm>
+            <a:off x="2840355" y="5189923"/>
+            <a:ext cx="44313" cy="44313"/>
           </a:xfrm>
           <a:prstGeom prst="ellipse">
             <a:avLst/>
@@ -15855,7 +16359,7 @@
           <a:solidFill>
             <a:schemeClr val="accent1"/>
           </a:solidFill>
-          <a:ln w="6350">
+          <a:ln w="5080">
             <a:solidFill>
               <a:srgbClr val="FFFFFF"/>
             </a:solidFill>
@@ -15865,14 +16369,34 @@
       </p:sp>
       <p:sp>
         <p:nvSpPr>
-          <p:cNvPr id="59" name="dot syn 72"/>
-          <p:cNvSpPr/>
-          <p:nvPr/>
-        </p:nvSpPr>
-        <p:spPr>
-          <a:xfrm>
-            <a:off x="5271059" y="4658868"/>
-            <a:ext cx="118872" cy="118872"/>
+          <p:cNvPr id="83" name="mini slab syn 50"/>
+          <p:cNvSpPr/>
+          <p:nvPr/>
+        </p:nvSpPr>
+        <p:spPr>
+          <a:xfrm>
+            <a:off x="3323844" y="4133088"/>
+            <a:ext cx="456057" cy="32004"/>
+          </a:xfrm>
+          <a:prstGeom prst="rect">
+            <a:avLst/>
+          </a:prstGeom>
+          <a:solidFill>
+            <a:srgbClr val="52514E"/>
+          </a:solidFill>
+          <a:ln/>
+        </p:spPr>
+      </p:sp>
+      <p:sp>
+        <p:nvSpPr>
+          <p:cNvPr id="84" name="mini syn 50 0"/>
+          <p:cNvSpPr/>
+          <p:nvPr/>
+        </p:nvSpPr>
+        <p:spPr>
+          <a:xfrm>
+            <a:off x="3379733" y="4206240"/>
+            <a:ext cx="40240" cy="40240"/>
           </a:xfrm>
           <a:prstGeom prst="ellipse">
             <a:avLst/>
@@ -15880,7 +16404,7 @@
           <a:solidFill>
             <a:schemeClr val="accent1"/>
           </a:solidFill>
-          <a:ln w="6350">
+          <a:ln w="5080">
             <a:solidFill>
               <a:srgbClr val="FFFFFF"/>
             </a:solidFill>
@@ -15890,14 +16414,14 @@
       </p:sp>
       <p:sp>
         <p:nvSpPr>
-          <p:cNvPr id="60" name="dot syn 73"/>
-          <p:cNvSpPr/>
-          <p:nvPr/>
-        </p:nvSpPr>
-        <p:spPr>
-          <a:xfrm>
-            <a:off x="5271059" y="4421124"/>
-            <a:ext cx="118872" cy="118872"/>
+          <p:cNvPr id="85" name="mini syn 50 1"/>
+          <p:cNvSpPr/>
+          <p:nvPr/>
+        </p:nvSpPr>
+        <p:spPr>
+          <a:xfrm>
+            <a:off x="3455743" y="4206240"/>
+            <a:ext cx="40240" cy="40240"/>
           </a:xfrm>
           <a:prstGeom prst="ellipse">
             <a:avLst/>
@@ -15905,7 +16429,7 @@
           <a:solidFill>
             <a:schemeClr val="accent1"/>
           </a:solidFill>
-          <a:ln w="6350">
+          <a:ln w="5080">
             <a:solidFill>
               <a:srgbClr val="FFFFFF"/>
             </a:solidFill>
@@ -15915,7 +16439,2127 @@
       </p:sp>
       <p:sp>
         <p:nvSpPr>
-          <p:cNvPr id="61" name="glance heading"/>
+          <p:cNvPr id="86" name="mini syn 50 2"/>
+          <p:cNvSpPr/>
+          <p:nvPr/>
+        </p:nvSpPr>
+        <p:spPr>
+          <a:xfrm>
+            <a:off x="3531752" y="4206240"/>
+            <a:ext cx="40240" cy="40240"/>
+          </a:xfrm>
+          <a:prstGeom prst="ellipse">
+            <a:avLst/>
+          </a:prstGeom>
+          <a:solidFill>
+            <a:schemeClr val="accent1"/>
+          </a:solidFill>
+          <a:ln w="5080">
+            <a:solidFill>
+              <a:srgbClr val="FFFFFF"/>
+            </a:solidFill>
+            <a:prstDash val="solid"/>
+          </a:ln>
+        </p:spPr>
+      </p:sp>
+      <p:sp>
+        <p:nvSpPr>
+          <p:cNvPr id="87" name="mini syn 50 3"/>
+          <p:cNvSpPr/>
+          <p:nvPr/>
+        </p:nvSpPr>
+        <p:spPr>
+          <a:xfrm>
+            <a:off x="3607762" y="4206240"/>
+            <a:ext cx="40240" cy="40240"/>
+          </a:xfrm>
+          <a:prstGeom prst="ellipse">
+            <a:avLst/>
+          </a:prstGeom>
+          <a:solidFill>
+            <a:schemeClr val="accent1"/>
+          </a:solidFill>
+          <a:ln w="5080">
+            <a:solidFill>
+              <a:srgbClr val="FFFFFF"/>
+            </a:solidFill>
+            <a:prstDash val="solid"/>
+          </a:ln>
+        </p:spPr>
+      </p:sp>
+      <p:sp>
+        <p:nvSpPr>
+          <p:cNvPr id="88" name="mini syn 50 4"/>
+          <p:cNvSpPr/>
+          <p:nvPr/>
+        </p:nvSpPr>
+        <p:spPr>
+          <a:xfrm>
+            <a:off x="3683771" y="4206240"/>
+            <a:ext cx="40240" cy="40240"/>
+          </a:xfrm>
+          <a:prstGeom prst="ellipse">
+            <a:avLst/>
+          </a:prstGeom>
+          <a:solidFill>
+            <a:schemeClr val="accent1"/>
+          </a:solidFill>
+          <a:ln w="5080">
+            <a:solidFill>
+              <a:srgbClr val="FFFFFF"/>
+            </a:solidFill>
+            <a:prstDash val="solid"/>
+          </a:ln>
+        </p:spPr>
+      </p:sp>
+      <p:sp>
+        <p:nvSpPr>
+          <p:cNvPr id="89" name="mini slab syn 51"/>
+          <p:cNvSpPr/>
+          <p:nvPr/>
+        </p:nvSpPr>
+        <p:spPr>
+          <a:xfrm>
+            <a:off x="3323844" y="4544568"/>
+            <a:ext cx="456057" cy="32004"/>
+          </a:xfrm>
+          <a:prstGeom prst="rect">
+            <a:avLst/>
+          </a:prstGeom>
+          <a:solidFill>
+            <a:srgbClr val="52514E"/>
+          </a:solidFill>
+          <a:ln/>
+        </p:spPr>
+      </p:sp>
+      <p:sp>
+        <p:nvSpPr>
+          <p:cNvPr id="90" name="mini syn 51 0"/>
+          <p:cNvSpPr/>
+          <p:nvPr/>
+        </p:nvSpPr>
+        <p:spPr>
+          <a:xfrm>
+            <a:off x="3366320" y="4608576"/>
+            <a:ext cx="67067" cy="49183"/>
+          </a:xfrm>
+          <a:prstGeom prst="rect">
+            <a:avLst/>
+          </a:prstGeom>
+          <a:solidFill>
+            <a:schemeClr val="accent1"/>
+          </a:solidFill>
+          <a:ln w="5080">
+            <a:solidFill>
+              <a:srgbClr val="FFFFFF"/>
+            </a:solidFill>
+            <a:prstDash val="solid"/>
+          </a:ln>
+        </p:spPr>
+      </p:sp>
+      <p:sp>
+        <p:nvSpPr>
+          <p:cNvPr id="91" name="mini syn 51 1"/>
+          <p:cNvSpPr/>
+          <p:nvPr/>
+        </p:nvSpPr>
+        <p:spPr>
+          <a:xfrm>
+            <a:off x="3455743" y="4617720"/>
+            <a:ext cx="40240" cy="40240"/>
+          </a:xfrm>
+          <a:prstGeom prst="ellipse">
+            <a:avLst/>
+          </a:prstGeom>
+          <a:solidFill>
+            <a:schemeClr val="accent1"/>
+          </a:solidFill>
+          <a:ln w="5080">
+            <a:solidFill>
+              <a:srgbClr val="FFFFFF"/>
+            </a:solidFill>
+            <a:prstDash val="solid"/>
+          </a:ln>
+        </p:spPr>
+      </p:sp>
+      <p:sp>
+        <p:nvSpPr>
+          <p:cNvPr id="92" name="mini syn 51 2"/>
+          <p:cNvSpPr/>
+          <p:nvPr/>
+        </p:nvSpPr>
+        <p:spPr>
+          <a:xfrm>
+            <a:off x="3525046" y="4636008"/>
+            <a:ext cx="53654" cy="22356"/>
+          </a:xfrm>
+          <a:prstGeom prst="rect">
+            <a:avLst/>
+          </a:prstGeom>
+          <a:solidFill>
+            <a:schemeClr val="accent1"/>
+          </a:solidFill>
+          <a:ln w="5080">
+            <a:solidFill>
+              <a:srgbClr val="FFFFFF"/>
+            </a:solidFill>
+            <a:prstDash val="solid"/>
+          </a:ln>
+        </p:spPr>
+      </p:sp>
+      <p:sp>
+        <p:nvSpPr>
+          <p:cNvPr id="93" name="mini syn 51 3"/>
+          <p:cNvSpPr/>
+          <p:nvPr/>
+        </p:nvSpPr>
+        <p:spPr>
+          <a:xfrm>
+            <a:off x="3607762" y="4617720"/>
+            <a:ext cx="40240" cy="40240"/>
+          </a:xfrm>
+          <a:prstGeom prst="ellipse">
+            <a:avLst/>
+          </a:prstGeom>
+          <a:solidFill>
+            <a:schemeClr val="accent1"/>
+          </a:solidFill>
+          <a:ln w="5080">
+            <a:solidFill>
+              <a:srgbClr val="FFFFFF"/>
+            </a:solidFill>
+            <a:prstDash val="solid"/>
+          </a:ln>
+        </p:spPr>
+      </p:sp>
+      <p:sp>
+        <p:nvSpPr>
+          <p:cNvPr id="94" name="mini syn 51 4"/>
+          <p:cNvSpPr/>
+          <p:nvPr/>
+        </p:nvSpPr>
+        <p:spPr>
+          <a:xfrm>
+            <a:off x="3670358" y="4608576"/>
+            <a:ext cx="67067" cy="49183"/>
+          </a:xfrm>
+          <a:prstGeom prst="rect">
+            <a:avLst/>
+          </a:prstGeom>
+          <a:solidFill>
+            <a:schemeClr val="accent1"/>
+          </a:solidFill>
+          <a:ln w="5080">
+            <a:solidFill>
+              <a:srgbClr val="FFFFFF"/>
+            </a:solidFill>
+            <a:prstDash val="solid"/>
+          </a:ln>
+        </p:spPr>
+      </p:sp>
+      <p:sp>
+        <p:nvSpPr>
+          <p:cNvPr id="95" name="mini wall syn 52"/>
+          <p:cNvSpPr/>
+          <p:nvPr/>
+        </p:nvSpPr>
+        <p:spPr>
+          <a:xfrm>
+            <a:off x="3323844" y="4956048"/>
+            <a:ext cx="32004" cy="320040"/>
+          </a:xfrm>
+          <a:prstGeom prst="rect">
+            <a:avLst/>
+          </a:prstGeom>
+          <a:solidFill>
+            <a:srgbClr val="52514E"/>
+          </a:solidFill>
+          <a:ln/>
+        </p:spPr>
+      </p:sp>
+      <p:sp>
+        <p:nvSpPr>
+          <p:cNvPr id="96" name="mini syn 52 0"/>
+          <p:cNvSpPr/>
+          <p:nvPr/>
+        </p:nvSpPr>
+        <p:spPr>
+          <a:xfrm>
+            <a:off x="3406140" y="4990924"/>
+            <a:ext cx="36928" cy="36928"/>
+          </a:xfrm>
+          <a:prstGeom prst="ellipse">
+            <a:avLst/>
+          </a:prstGeom>
+          <a:solidFill>
+            <a:schemeClr val="accent1"/>
+          </a:solidFill>
+          <a:ln w="5080">
+            <a:solidFill>
+              <a:srgbClr val="FFFFFF"/>
+            </a:solidFill>
+            <a:prstDash val="solid"/>
+          </a:ln>
+        </p:spPr>
+      </p:sp>
+      <p:sp>
+        <p:nvSpPr>
+          <p:cNvPr id="97" name="mini syn 52 1"/>
+          <p:cNvSpPr/>
+          <p:nvPr/>
+        </p:nvSpPr>
+        <p:spPr>
+          <a:xfrm>
+            <a:off x="3396996" y="5052470"/>
+            <a:ext cx="49237" cy="20515"/>
+          </a:xfrm>
+          <a:prstGeom prst="rect">
+            <a:avLst/>
+          </a:prstGeom>
+          <a:solidFill>
+            <a:schemeClr val="accent1"/>
+          </a:solidFill>
+          <a:ln w="5080">
+            <a:solidFill>
+              <a:srgbClr val="FFFFFF"/>
+            </a:solidFill>
+            <a:prstDash val="solid"/>
+          </a:ln>
+        </p:spPr>
+      </p:sp>
+      <p:sp>
+        <p:nvSpPr>
+          <p:cNvPr id="98" name="mini syn 52 2"/>
+          <p:cNvSpPr/>
+          <p:nvPr/>
+        </p:nvSpPr>
+        <p:spPr>
+          <a:xfrm>
+            <a:off x="3406140" y="5097604"/>
+            <a:ext cx="36928" cy="36928"/>
+          </a:xfrm>
+          <a:prstGeom prst="ellipse">
+            <a:avLst/>
+          </a:prstGeom>
+          <a:solidFill>
+            <a:schemeClr val="accent1"/>
+          </a:solidFill>
+          <a:ln w="5080">
+            <a:solidFill>
+              <a:srgbClr val="FFFFFF"/>
+            </a:solidFill>
+            <a:prstDash val="solid"/>
+          </a:ln>
+        </p:spPr>
+      </p:sp>
+      <p:sp>
+        <p:nvSpPr>
+          <p:cNvPr id="99" name="mini syn 52 3"/>
+          <p:cNvSpPr/>
+          <p:nvPr/>
+        </p:nvSpPr>
+        <p:spPr>
+          <a:xfrm>
+            <a:off x="3406140" y="5150944"/>
+            <a:ext cx="36928" cy="36928"/>
+          </a:xfrm>
+          <a:prstGeom prst="ellipse">
+            <a:avLst/>
+          </a:prstGeom>
+          <a:solidFill>
+            <a:schemeClr val="accent1"/>
+          </a:solidFill>
+          <a:ln w="5080">
+            <a:solidFill>
+              <a:srgbClr val="FFFFFF"/>
+            </a:solidFill>
+            <a:prstDash val="solid"/>
+          </a:ln>
+        </p:spPr>
+      </p:sp>
+      <p:sp>
+        <p:nvSpPr>
+          <p:cNvPr id="100" name="mini syn 52 4"/>
+          <p:cNvSpPr/>
+          <p:nvPr/>
+        </p:nvSpPr>
+        <p:spPr>
+          <a:xfrm>
+            <a:off x="3396996" y="5212490"/>
+            <a:ext cx="49237" cy="20515"/>
+          </a:xfrm>
+          <a:prstGeom prst="rect">
+            <a:avLst/>
+          </a:prstGeom>
+          <a:solidFill>
+            <a:schemeClr val="accent1"/>
+          </a:solidFill>
+          <a:ln w="5080">
+            <a:solidFill>
+              <a:srgbClr val="FFFFFF"/>
+            </a:solidFill>
+            <a:prstDash val="solid"/>
+          </a:ln>
+        </p:spPr>
+      </p:sp>
+      <p:sp>
+        <p:nvSpPr>
+          <p:cNvPr id="101" name="mini slab syn 60"/>
+          <p:cNvSpPr/>
+          <p:nvPr/>
+        </p:nvSpPr>
+        <p:spPr>
+          <a:xfrm>
+            <a:off x="3889629" y="4133088"/>
+            <a:ext cx="456057" cy="32004"/>
+          </a:xfrm>
+          <a:prstGeom prst="rect">
+            <a:avLst/>
+          </a:prstGeom>
+          <a:solidFill>
+            <a:srgbClr val="52514E"/>
+          </a:solidFill>
+          <a:ln/>
+        </p:spPr>
+      </p:sp>
+      <p:sp>
+        <p:nvSpPr>
+          <p:cNvPr id="102" name="mini syn 60 0"/>
+          <p:cNvSpPr/>
+          <p:nvPr/>
+        </p:nvSpPr>
+        <p:spPr>
+          <a:xfrm>
+            <a:off x="3937534" y="4206240"/>
+            <a:ext cx="34492" cy="34492"/>
+          </a:xfrm>
+          <a:prstGeom prst="ellipse">
+            <a:avLst/>
+          </a:prstGeom>
+          <a:solidFill>
+            <a:schemeClr val="accent1"/>
+          </a:solidFill>
+          <a:ln w="5080">
+            <a:solidFill>
+              <a:srgbClr val="FFFFFF"/>
+            </a:solidFill>
+            <a:prstDash val="solid"/>
+          </a:ln>
+        </p:spPr>
+      </p:sp>
+      <p:sp>
+        <p:nvSpPr>
+          <p:cNvPr id="103" name="mini syn 60 1"/>
+          <p:cNvSpPr/>
+          <p:nvPr/>
+        </p:nvSpPr>
+        <p:spPr>
+          <a:xfrm>
+            <a:off x="4002685" y="4206240"/>
+            <a:ext cx="34492" cy="34492"/>
+          </a:xfrm>
+          <a:prstGeom prst="ellipse">
+            <a:avLst/>
+          </a:prstGeom>
+          <a:solidFill>
+            <a:schemeClr val="accent1"/>
+          </a:solidFill>
+          <a:ln w="5080">
+            <a:solidFill>
+              <a:srgbClr val="FFFFFF"/>
+            </a:solidFill>
+            <a:prstDash val="solid"/>
+          </a:ln>
+        </p:spPr>
+      </p:sp>
+      <p:sp>
+        <p:nvSpPr>
+          <p:cNvPr id="104" name="mini syn 60 2"/>
+          <p:cNvSpPr/>
+          <p:nvPr/>
+        </p:nvSpPr>
+        <p:spPr>
+          <a:xfrm>
+            <a:off x="4067836" y="4206240"/>
+            <a:ext cx="34492" cy="34492"/>
+          </a:xfrm>
+          <a:prstGeom prst="ellipse">
+            <a:avLst/>
+          </a:prstGeom>
+          <a:solidFill>
+            <a:schemeClr val="accent1"/>
+          </a:solidFill>
+          <a:ln w="5080">
+            <a:solidFill>
+              <a:srgbClr val="FFFFFF"/>
+            </a:solidFill>
+            <a:prstDash val="solid"/>
+          </a:ln>
+        </p:spPr>
+      </p:sp>
+      <p:sp>
+        <p:nvSpPr>
+          <p:cNvPr id="105" name="mini syn 60 3"/>
+          <p:cNvSpPr/>
+          <p:nvPr/>
+        </p:nvSpPr>
+        <p:spPr>
+          <a:xfrm>
+            <a:off x="4132987" y="4206240"/>
+            <a:ext cx="34492" cy="34492"/>
+          </a:xfrm>
+          <a:prstGeom prst="ellipse">
+            <a:avLst/>
+          </a:prstGeom>
+          <a:solidFill>
+            <a:schemeClr val="accent1"/>
+          </a:solidFill>
+          <a:ln w="5080">
+            <a:solidFill>
+              <a:srgbClr val="FFFFFF"/>
+            </a:solidFill>
+            <a:prstDash val="solid"/>
+          </a:ln>
+        </p:spPr>
+      </p:sp>
+      <p:sp>
+        <p:nvSpPr>
+          <p:cNvPr id="106" name="mini syn 60 4"/>
+          <p:cNvSpPr/>
+          <p:nvPr/>
+        </p:nvSpPr>
+        <p:spPr>
+          <a:xfrm>
+            <a:off x="4198138" y="4206240"/>
+            <a:ext cx="34492" cy="34492"/>
+          </a:xfrm>
+          <a:prstGeom prst="ellipse">
+            <a:avLst/>
+          </a:prstGeom>
+          <a:solidFill>
+            <a:schemeClr val="accent1"/>
+          </a:solidFill>
+          <a:ln w="5080">
+            <a:solidFill>
+              <a:srgbClr val="FFFFFF"/>
+            </a:solidFill>
+            <a:prstDash val="solid"/>
+          </a:ln>
+        </p:spPr>
+      </p:sp>
+      <p:sp>
+        <p:nvSpPr>
+          <p:cNvPr id="107" name="mini syn 60 5"/>
+          <p:cNvSpPr/>
+          <p:nvPr/>
+        </p:nvSpPr>
+        <p:spPr>
+          <a:xfrm>
+            <a:off x="4263289" y="4206240"/>
+            <a:ext cx="34492" cy="34492"/>
+          </a:xfrm>
+          <a:prstGeom prst="ellipse">
+            <a:avLst/>
+          </a:prstGeom>
+          <a:solidFill>
+            <a:schemeClr val="accent1"/>
+          </a:solidFill>
+          <a:ln w="5080">
+            <a:solidFill>
+              <a:srgbClr val="FFFFFF"/>
+            </a:solidFill>
+            <a:prstDash val="solid"/>
+          </a:ln>
+        </p:spPr>
+      </p:sp>
+      <p:sp>
+        <p:nvSpPr>
+          <p:cNvPr id="108" name="mini slab syn 61"/>
+          <p:cNvSpPr/>
+          <p:nvPr/>
+        </p:nvSpPr>
+        <p:spPr>
+          <a:xfrm>
+            <a:off x="3889629" y="4544568"/>
+            <a:ext cx="456057" cy="32004"/>
+          </a:xfrm>
+          <a:prstGeom prst="rect">
+            <a:avLst/>
+          </a:prstGeom>
+          <a:solidFill>
+            <a:srgbClr val="52514E"/>
+          </a:solidFill>
+          <a:ln/>
+        </p:spPr>
+      </p:sp>
+      <p:sp>
+        <p:nvSpPr>
+          <p:cNvPr id="109" name="mini syn 61 0"/>
+          <p:cNvSpPr/>
+          <p:nvPr/>
+        </p:nvSpPr>
+        <p:spPr>
+          <a:xfrm>
+            <a:off x="3926037" y="4608576"/>
+            <a:ext cx="57486" cy="42157"/>
+          </a:xfrm>
+          <a:prstGeom prst="rect">
+            <a:avLst/>
+          </a:prstGeom>
+          <a:solidFill>
+            <a:schemeClr val="accent1"/>
+          </a:solidFill>
+          <a:ln w="5080">
+            <a:solidFill>
+              <a:srgbClr val="FFFFFF"/>
+            </a:solidFill>
+            <a:prstDash val="solid"/>
+          </a:ln>
+        </p:spPr>
+      </p:sp>
+      <p:sp>
+        <p:nvSpPr>
+          <p:cNvPr id="110" name="mini syn 61 1"/>
+          <p:cNvSpPr/>
+          <p:nvPr/>
+        </p:nvSpPr>
+        <p:spPr>
+          <a:xfrm>
+            <a:off x="4002685" y="4617720"/>
+            <a:ext cx="34492" cy="34492"/>
+          </a:xfrm>
+          <a:prstGeom prst="ellipse">
+            <a:avLst/>
+          </a:prstGeom>
+          <a:solidFill>
+            <a:schemeClr val="accent1"/>
+          </a:solidFill>
+          <a:ln w="5080">
+            <a:solidFill>
+              <a:srgbClr val="FFFFFF"/>
+            </a:solidFill>
+            <a:prstDash val="solid"/>
+          </a:ln>
+        </p:spPr>
+      </p:sp>
+      <p:sp>
+        <p:nvSpPr>
+          <p:cNvPr id="111" name="mini syn 61 2"/>
+          <p:cNvSpPr/>
+          <p:nvPr/>
+        </p:nvSpPr>
+        <p:spPr>
+          <a:xfrm>
+            <a:off x="4062088" y="4636008"/>
+            <a:ext cx="45989" cy="19162"/>
+          </a:xfrm>
+          <a:prstGeom prst="rect">
+            <a:avLst/>
+          </a:prstGeom>
+          <a:solidFill>
+            <a:schemeClr val="accent1"/>
+          </a:solidFill>
+          <a:ln w="5080">
+            <a:solidFill>
+              <a:srgbClr val="FFFFFF"/>
+            </a:solidFill>
+            <a:prstDash val="solid"/>
+          </a:ln>
+        </p:spPr>
+      </p:sp>
+      <p:sp>
+        <p:nvSpPr>
+          <p:cNvPr id="112" name="mini syn 61 3"/>
+          <p:cNvSpPr/>
+          <p:nvPr/>
+        </p:nvSpPr>
+        <p:spPr>
+          <a:xfrm>
+            <a:off x="4132987" y="4617720"/>
+            <a:ext cx="34492" cy="34492"/>
+          </a:xfrm>
+          <a:prstGeom prst="ellipse">
+            <a:avLst/>
+          </a:prstGeom>
+          <a:solidFill>
+            <a:schemeClr val="accent1"/>
+          </a:solidFill>
+          <a:ln w="5080">
+            <a:solidFill>
+              <a:srgbClr val="FFFFFF"/>
+            </a:solidFill>
+            <a:prstDash val="solid"/>
+          </a:ln>
+        </p:spPr>
+      </p:sp>
+      <p:sp>
+        <p:nvSpPr>
+          <p:cNvPr id="113" name="mini syn 61 4"/>
+          <p:cNvSpPr/>
+          <p:nvPr/>
+        </p:nvSpPr>
+        <p:spPr>
+          <a:xfrm>
+            <a:off x="4186641" y="4608576"/>
+            <a:ext cx="57486" cy="42157"/>
+          </a:xfrm>
+          <a:prstGeom prst="rect">
+            <a:avLst/>
+          </a:prstGeom>
+          <a:solidFill>
+            <a:schemeClr val="accent1"/>
+          </a:solidFill>
+          <a:ln w="5080">
+            <a:solidFill>
+              <a:srgbClr val="FFFFFF"/>
+            </a:solidFill>
+            <a:prstDash val="solid"/>
+          </a:ln>
+        </p:spPr>
+      </p:sp>
+      <p:sp>
+        <p:nvSpPr>
+          <p:cNvPr id="114" name="mini syn 61 5"/>
+          <p:cNvSpPr/>
+          <p:nvPr/>
+        </p:nvSpPr>
+        <p:spPr>
+          <a:xfrm>
+            <a:off x="4263289" y="4617720"/>
+            <a:ext cx="34492" cy="34492"/>
+          </a:xfrm>
+          <a:prstGeom prst="ellipse">
+            <a:avLst/>
+          </a:prstGeom>
+          <a:solidFill>
+            <a:schemeClr val="accent1"/>
+          </a:solidFill>
+          <a:ln w="5080">
+            <a:solidFill>
+              <a:srgbClr val="FFFFFF"/>
+            </a:solidFill>
+            <a:prstDash val="solid"/>
+          </a:ln>
+        </p:spPr>
+      </p:sp>
+      <p:sp>
+        <p:nvSpPr>
+          <p:cNvPr id="115" name="mini wall syn 62"/>
+          <p:cNvSpPr/>
+          <p:nvPr/>
+        </p:nvSpPr>
+        <p:spPr>
+          <a:xfrm>
+            <a:off x="3889629" y="4956048"/>
+            <a:ext cx="32004" cy="320040"/>
+          </a:xfrm>
+          <a:prstGeom prst="rect">
+            <a:avLst/>
+          </a:prstGeom>
+          <a:solidFill>
+            <a:srgbClr val="52514E"/>
+          </a:solidFill>
+          <a:ln/>
+        </p:spPr>
+      </p:sp>
+      <p:sp>
+        <p:nvSpPr>
+          <p:cNvPr id="116" name="mini syn 62 0"/>
+          <p:cNvSpPr/>
+          <p:nvPr/>
+        </p:nvSpPr>
+        <p:spPr>
+          <a:xfrm>
+            <a:off x="3971925" y="4985942"/>
+            <a:ext cx="31652" cy="31652"/>
+          </a:xfrm>
+          <a:prstGeom prst="ellipse">
+            <a:avLst/>
+          </a:prstGeom>
+          <a:solidFill>
+            <a:schemeClr val="accent1"/>
+          </a:solidFill>
+          <a:ln w="5080">
+            <a:solidFill>
+              <a:srgbClr val="FFFFFF"/>
+            </a:solidFill>
+            <a:prstDash val="solid"/>
+          </a:ln>
+        </p:spPr>
+      </p:sp>
+      <p:sp>
+        <p:nvSpPr>
+          <p:cNvPr id="117" name="mini syn 62 1"/>
+          <p:cNvSpPr/>
+          <p:nvPr/>
+        </p:nvSpPr>
+        <p:spPr>
+          <a:xfrm>
+            <a:off x="3962781" y="5038696"/>
+            <a:ext cx="42203" cy="17585"/>
+          </a:xfrm>
+          <a:prstGeom prst="rect">
+            <a:avLst/>
+          </a:prstGeom>
+          <a:solidFill>
+            <a:schemeClr val="accent1"/>
+          </a:solidFill>
+          <a:ln w="5080">
+            <a:solidFill>
+              <a:srgbClr val="FFFFFF"/>
+            </a:solidFill>
+            <a:prstDash val="solid"/>
+          </a:ln>
+        </p:spPr>
+      </p:sp>
+      <p:sp>
+        <p:nvSpPr>
+          <p:cNvPr id="118" name="mini syn 62 2"/>
+          <p:cNvSpPr/>
+          <p:nvPr/>
+        </p:nvSpPr>
+        <p:spPr>
+          <a:xfrm>
+            <a:off x="3971925" y="5077382"/>
+            <a:ext cx="31652" cy="31652"/>
+          </a:xfrm>
+          <a:prstGeom prst="ellipse">
+            <a:avLst/>
+          </a:prstGeom>
+          <a:solidFill>
+            <a:schemeClr val="accent1"/>
+          </a:solidFill>
+          <a:ln w="5080">
+            <a:solidFill>
+              <a:srgbClr val="FFFFFF"/>
+            </a:solidFill>
+            <a:prstDash val="solid"/>
+          </a:ln>
+        </p:spPr>
+      </p:sp>
+      <p:sp>
+        <p:nvSpPr>
+          <p:cNvPr id="119" name="mini syn 62 3"/>
+          <p:cNvSpPr/>
+          <p:nvPr/>
+        </p:nvSpPr>
+        <p:spPr>
+          <a:xfrm>
+            <a:off x="3971925" y="5123102"/>
+            <a:ext cx="31652" cy="31652"/>
+          </a:xfrm>
+          <a:prstGeom prst="ellipse">
+            <a:avLst/>
+          </a:prstGeom>
+          <a:solidFill>
+            <a:schemeClr val="accent1"/>
+          </a:solidFill>
+          <a:ln w="5080">
+            <a:solidFill>
+              <a:srgbClr val="FFFFFF"/>
+            </a:solidFill>
+            <a:prstDash val="solid"/>
+          </a:ln>
+        </p:spPr>
+      </p:sp>
+      <p:sp>
+        <p:nvSpPr>
+          <p:cNvPr id="120" name="mini syn 62 4"/>
+          <p:cNvSpPr/>
+          <p:nvPr/>
+        </p:nvSpPr>
+        <p:spPr>
+          <a:xfrm>
+            <a:off x="3962781" y="5175856"/>
+            <a:ext cx="42203" cy="17585"/>
+          </a:xfrm>
+          <a:prstGeom prst="rect">
+            <a:avLst/>
+          </a:prstGeom>
+          <a:solidFill>
+            <a:schemeClr val="accent1"/>
+          </a:solidFill>
+          <a:ln w="5080">
+            <a:solidFill>
+              <a:srgbClr val="FFFFFF"/>
+            </a:solidFill>
+            <a:prstDash val="solid"/>
+          </a:ln>
+        </p:spPr>
+      </p:sp>
+      <p:sp>
+        <p:nvSpPr>
+          <p:cNvPr id="121" name="mini syn 62 5"/>
+          <p:cNvSpPr/>
+          <p:nvPr/>
+        </p:nvSpPr>
+        <p:spPr>
+          <a:xfrm>
+            <a:off x="3971925" y="5214542"/>
+            <a:ext cx="31652" cy="31652"/>
+          </a:xfrm>
+          <a:prstGeom prst="ellipse">
+            <a:avLst/>
+          </a:prstGeom>
+          <a:solidFill>
+            <a:schemeClr val="accent1"/>
+          </a:solidFill>
+          <a:ln w="5080">
+            <a:solidFill>
+              <a:srgbClr val="FFFFFF"/>
+            </a:solidFill>
+            <a:prstDash val="solid"/>
+          </a:ln>
+        </p:spPr>
+      </p:sp>
+      <p:sp>
+        <p:nvSpPr>
+          <p:cNvPr id="122" name="mini slab syn 70"/>
+          <p:cNvSpPr/>
+          <p:nvPr/>
+        </p:nvSpPr>
+        <p:spPr>
+          <a:xfrm>
+            <a:off x="4455414" y="4133088"/>
+            <a:ext cx="456057" cy="32004"/>
+          </a:xfrm>
+          <a:prstGeom prst="rect">
+            <a:avLst/>
+          </a:prstGeom>
+          <a:solidFill>
+            <a:srgbClr val="52514E"/>
+          </a:solidFill>
+          <a:ln/>
+        </p:spPr>
+      </p:sp>
+      <p:sp>
+        <p:nvSpPr>
+          <p:cNvPr id="123" name="mini syn 70 0"/>
+          <p:cNvSpPr/>
+          <p:nvPr/>
+        </p:nvSpPr>
+        <p:spPr>
+          <a:xfrm>
+            <a:off x="4497331" y="4206240"/>
+            <a:ext cx="30180" cy="30180"/>
+          </a:xfrm>
+          <a:prstGeom prst="ellipse">
+            <a:avLst/>
+          </a:prstGeom>
+          <a:solidFill>
+            <a:schemeClr val="accent1"/>
+          </a:solidFill>
+          <a:ln w="5080">
+            <a:solidFill>
+              <a:srgbClr val="FFFFFF"/>
+            </a:solidFill>
+            <a:prstDash val="solid"/>
+          </a:ln>
+        </p:spPr>
+      </p:sp>
+      <p:sp>
+        <p:nvSpPr>
+          <p:cNvPr id="124" name="mini syn 70 1"/>
+          <p:cNvSpPr/>
+          <p:nvPr/>
+        </p:nvSpPr>
+        <p:spPr>
+          <a:xfrm>
+            <a:off x="4554338" y="4206240"/>
+            <a:ext cx="30180" cy="30180"/>
+          </a:xfrm>
+          <a:prstGeom prst="ellipse">
+            <a:avLst/>
+          </a:prstGeom>
+          <a:solidFill>
+            <a:schemeClr val="accent1"/>
+          </a:solidFill>
+          <a:ln w="5080">
+            <a:solidFill>
+              <a:srgbClr val="FFFFFF"/>
+            </a:solidFill>
+            <a:prstDash val="solid"/>
+          </a:ln>
+        </p:spPr>
+      </p:sp>
+      <p:sp>
+        <p:nvSpPr>
+          <p:cNvPr id="125" name="mini syn 70 2"/>
+          <p:cNvSpPr/>
+          <p:nvPr/>
+        </p:nvSpPr>
+        <p:spPr>
+          <a:xfrm>
+            <a:off x="4611345" y="4206240"/>
+            <a:ext cx="30180" cy="30180"/>
+          </a:xfrm>
+          <a:prstGeom prst="ellipse">
+            <a:avLst/>
+          </a:prstGeom>
+          <a:solidFill>
+            <a:schemeClr val="accent1"/>
+          </a:solidFill>
+          <a:ln w="5080">
+            <a:solidFill>
+              <a:srgbClr val="FFFFFF"/>
+            </a:solidFill>
+            <a:prstDash val="solid"/>
+          </a:ln>
+        </p:spPr>
+      </p:sp>
+      <p:sp>
+        <p:nvSpPr>
+          <p:cNvPr id="126" name="mini syn 70 3"/>
+          <p:cNvSpPr/>
+          <p:nvPr/>
+        </p:nvSpPr>
+        <p:spPr>
+          <a:xfrm>
+            <a:off x="4668352" y="4206240"/>
+            <a:ext cx="30180" cy="30180"/>
+          </a:xfrm>
+          <a:prstGeom prst="ellipse">
+            <a:avLst/>
+          </a:prstGeom>
+          <a:solidFill>
+            <a:schemeClr val="accent1"/>
+          </a:solidFill>
+          <a:ln w="5080">
+            <a:solidFill>
+              <a:srgbClr val="FFFFFF"/>
+            </a:solidFill>
+            <a:prstDash val="solid"/>
+          </a:ln>
+        </p:spPr>
+      </p:sp>
+      <p:sp>
+        <p:nvSpPr>
+          <p:cNvPr id="127" name="mini syn 70 4"/>
+          <p:cNvSpPr/>
+          <p:nvPr/>
+        </p:nvSpPr>
+        <p:spPr>
+          <a:xfrm>
+            <a:off x="4725360" y="4206240"/>
+            <a:ext cx="30180" cy="30180"/>
+          </a:xfrm>
+          <a:prstGeom prst="ellipse">
+            <a:avLst/>
+          </a:prstGeom>
+          <a:solidFill>
+            <a:schemeClr val="accent1"/>
+          </a:solidFill>
+          <a:ln w="5080">
+            <a:solidFill>
+              <a:srgbClr val="FFFFFF"/>
+            </a:solidFill>
+            <a:prstDash val="solid"/>
+          </a:ln>
+        </p:spPr>
+      </p:sp>
+      <p:sp>
+        <p:nvSpPr>
+          <p:cNvPr id="128" name="mini syn 70 5"/>
+          <p:cNvSpPr/>
+          <p:nvPr/>
+        </p:nvSpPr>
+        <p:spPr>
+          <a:xfrm>
+            <a:off x="4782367" y="4206240"/>
+            <a:ext cx="30180" cy="30180"/>
+          </a:xfrm>
+          <a:prstGeom prst="ellipse">
+            <a:avLst/>
+          </a:prstGeom>
+          <a:solidFill>
+            <a:schemeClr val="accent1"/>
+          </a:solidFill>
+          <a:ln w="5080">
+            <a:solidFill>
+              <a:srgbClr val="FFFFFF"/>
+            </a:solidFill>
+            <a:prstDash val="solid"/>
+          </a:ln>
+        </p:spPr>
+      </p:sp>
+      <p:sp>
+        <p:nvSpPr>
+          <p:cNvPr id="129" name="mini syn 70 6"/>
+          <p:cNvSpPr/>
+          <p:nvPr/>
+        </p:nvSpPr>
+        <p:spPr>
+          <a:xfrm>
+            <a:off x="4839374" y="4206240"/>
+            <a:ext cx="30180" cy="30180"/>
+          </a:xfrm>
+          <a:prstGeom prst="ellipse">
+            <a:avLst/>
+          </a:prstGeom>
+          <a:solidFill>
+            <a:schemeClr val="accent1"/>
+          </a:solidFill>
+          <a:ln w="5080">
+            <a:solidFill>
+              <a:srgbClr val="FFFFFF"/>
+            </a:solidFill>
+            <a:prstDash val="solid"/>
+          </a:ln>
+        </p:spPr>
+      </p:sp>
+      <p:sp>
+        <p:nvSpPr>
+          <p:cNvPr id="130" name="mini slab syn 71"/>
+          <p:cNvSpPr/>
+          <p:nvPr/>
+        </p:nvSpPr>
+        <p:spPr>
+          <a:xfrm>
+            <a:off x="4455414" y="4544568"/>
+            <a:ext cx="456057" cy="32004"/>
+          </a:xfrm>
+          <a:prstGeom prst="rect">
+            <a:avLst/>
+          </a:prstGeom>
+          <a:solidFill>
+            <a:srgbClr val="52514E"/>
+          </a:solidFill>
+          <a:ln/>
+        </p:spPr>
+      </p:sp>
+      <p:sp>
+        <p:nvSpPr>
+          <p:cNvPr id="131" name="mini syn 71 0"/>
+          <p:cNvSpPr/>
+          <p:nvPr/>
+        </p:nvSpPr>
+        <p:spPr>
+          <a:xfrm>
+            <a:off x="4487271" y="4608576"/>
+            <a:ext cx="50300" cy="36887"/>
+          </a:xfrm>
+          <a:prstGeom prst="rect">
+            <a:avLst/>
+          </a:prstGeom>
+          <a:solidFill>
+            <a:schemeClr val="accent1"/>
+          </a:solidFill>
+          <a:ln w="5080">
+            <a:solidFill>
+              <a:srgbClr val="FFFFFF"/>
+            </a:solidFill>
+            <a:prstDash val="solid"/>
+          </a:ln>
+        </p:spPr>
+      </p:sp>
+      <p:sp>
+        <p:nvSpPr>
+          <p:cNvPr id="132" name="mini syn 71 1"/>
+          <p:cNvSpPr/>
+          <p:nvPr/>
+        </p:nvSpPr>
+        <p:spPr>
+          <a:xfrm>
+            <a:off x="4554338" y="4617720"/>
+            <a:ext cx="30180" cy="30180"/>
+          </a:xfrm>
+          <a:prstGeom prst="ellipse">
+            <a:avLst/>
+          </a:prstGeom>
+          <a:solidFill>
+            <a:schemeClr val="accent1"/>
+          </a:solidFill>
+          <a:ln w="5080">
+            <a:solidFill>
+              <a:srgbClr val="FFFFFF"/>
+            </a:solidFill>
+            <a:prstDash val="solid"/>
+          </a:ln>
+        </p:spPr>
+      </p:sp>
+      <p:sp>
+        <p:nvSpPr>
+          <p:cNvPr id="133" name="mini syn 71 2"/>
+          <p:cNvSpPr/>
+          <p:nvPr/>
+        </p:nvSpPr>
+        <p:spPr>
+          <a:xfrm>
+            <a:off x="4606315" y="4636008"/>
+            <a:ext cx="40240" cy="16767"/>
+          </a:xfrm>
+          <a:prstGeom prst="rect">
+            <a:avLst/>
+          </a:prstGeom>
+          <a:solidFill>
+            <a:schemeClr val="accent1"/>
+          </a:solidFill>
+          <a:ln w="5080">
+            <a:solidFill>
+              <a:srgbClr val="FFFFFF"/>
+            </a:solidFill>
+            <a:prstDash val="solid"/>
+          </a:ln>
+        </p:spPr>
+      </p:sp>
+      <p:sp>
+        <p:nvSpPr>
+          <p:cNvPr id="134" name="mini syn 71 3"/>
+          <p:cNvSpPr/>
+          <p:nvPr/>
+        </p:nvSpPr>
+        <p:spPr>
+          <a:xfrm>
+            <a:off x="4668352" y="4617720"/>
+            <a:ext cx="30180" cy="30180"/>
+          </a:xfrm>
+          <a:prstGeom prst="ellipse">
+            <a:avLst/>
+          </a:prstGeom>
+          <a:solidFill>
+            <a:schemeClr val="accent1"/>
+          </a:solidFill>
+          <a:ln w="5080">
+            <a:solidFill>
+              <a:srgbClr val="FFFFFF"/>
+            </a:solidFill>
+            <a:prstDash val="solid"/>
+          </a:ln>
+        </p:spPr>
+      </p:sp>
+      <p:sp>
+        <p:nvSpPr>
+          <p:cNvPr id="135" name="mini syn 71 4"/>
+          <p:cNvSpPr/>
+          <p:nvPr/>
+        </p:nvSpPr>
+        <p:spPr>
+          <a:xfrm>
+            <a:off x="4715299" y="4608576"/>
+            <a:ext cx="50300" cy="36887"/>
+          </a:xfrm>
+          <a:prstGeom prst="rect">
+            <a:avLst/>
+          </a:prstGeom>
+          <a:solidFill>
+            <a:schemeClr val="accent1"/>
+          </a:solidFill>
+          <a:ln w="5080">
+            <a:solidFill>
+              <a:srgbClr val="FFFFFF"/>
+            </a:solidFill>
+            <a:prstDash val="solid"/>
+          </a:ln>
+        </p:spPr>
+      </p:sp>
+      <p:sp>
+        <p:nvSpPr>
+          <p:cNvPr id="136" name="mini syn 71 5"/>
+          <p:cNvSpPr/>
+          <p:nvPr/>
+        </p:nvSpPr>
+        <p:spPr>
+          <a:xfrm>
+            <a:off x="4782367" y="4617720"/>
+            <a:ext cx="30180" cy="30180"/>
+          </a:xfrm>
+          <a:prstGeom prst="ellipse">
+            <a:avLst/>
+          </a:prstGeom>
+          <a:solidFill>
+            <a:schemeClr val="accent1"/>
+          </a:solidFill>
+          <a:ln w="5080">
+            <a:solidFill>
+              <a:srgbClr val="FFFFFF"/>
+            </a:solidFill>
+            <a:prstDash val="solid"/>
+          </a:ln>
+        </p:spPr>
+      </p:sp>
+      <p:sp>
+        <p:nvSpPr>
+          <p:cNvPr id="137" name="mini syn 71 6"/>
+          <p:cNvSpPr/>
+          <p:nvPr/>
+        </p:nvSpPr>
+        <p:spPr>
+          <a:xfrm>
+            <a:off x="4834344" y="4636008"/>
+            <a:ext cx="40240" cy="16767"/>
+          </a:xfrm>
+          <a:prstGeom prst="rect">
+            <a:avLst/>
+          </a:prstGeom>
+          <a:solidFill>
+            <a:schemeClr val="accent1"/>
+          </a:solidFill>
+          <a:ln w="5080">
+            <a:solidFill>
+              <a:srgbClr val="FFFFFF"/>
+            </a:solidFill>
+            <a:prstDash val="solid"/>
+          </a:ln>
+        </p:spPr>
+      </p:sp>
+      <p:sp>
+        <p:nvSpPr>
+          <p:cNvPr id="138" name="mini wall syn 72"/>
+          <p:cNvSpPr/>
+          <p:nvPr/>
+        </p:nvSpPr>
+        <p:spPr>
+          <a:xfrm>
+            <a:off x="4455414" y="4956048"/>
+            <a:ext cx="32004" cy="320040"/>
+          </a:xfrm>
+          <a:prstGeom prst="rect">
+            <a:avLst/>
+          </a:prstGeom>
+          <a:solidFill>
+            <a:srgbClr val="52514E"/>
+          </a:solidFill>
+          <a:ln/>
+        </p:spPr>
+      </p:sp>
+      <p:sp>
+        <p:nvSpPr>
+          <p:cNvPr id="139" name="mini syn 72 0"/>
+          <p:cNvSpPr/>
+          <p:nvPr/>
+        </p:nvSpPr>
+        <p:spPr>
+          <a:xfrm>
+            <a:off x="4537710" y="4982205"/>
+            <a:ext cx="27696" cy="27696"/>
+          </a:xfrm>
+          <a:prstGeom prst="ellipse">
+            <a:avLst/>
+          </a:prstGeom>
+          <a:solidFill>
+            <a:schemeClr val="accent1"/>
+          </a:solidFill>
+          <a:ln w="5080">
+            <a:solidFill>
+              <a:srgbClr val="FFFFFF"/>
+            </a:solidFill>
+            <a:prstDash val="solid"/>
+          </a:ln>
+        </p:spPr>
+      </p:sp>
+      <p:sp>
+        <p:nvSpPr>
+          <p:cNvPr id="140" name="mini syn 72 1"/>
+          <p:cNvSpPr/>
+          <p:nvPr/>
+        </p:nvSpPr>
+        <p:spPr>
+          <a:xfrm>
+            <a:off x="4528566" y="5028365"/>
+            <a:ext cx="36928" cy="15387"/>
+          </a:xfrm>
+          <a:prstGeom prst="rect">
+            <a:avLst/>
+          </a:prstGeom>
+          <a:solidFill>
+            <a:schemeClr val="accent1"/>
+          </a:solidFill>
+          <a:ln w="5080">
+            <a:solidFill>
+              <a:srgbClr val="FFFFFF"/>
+            </a:solidFill>
+            <a:prstDash val="solid"/>
+          </a:ln>
+        </p:spPr>
+      </p:sp>
+      <p:sp>
+        <p:nvSpPr>
+          <p:cNvPr id="141" name="mini syn 72 2"/>
+          <p:cNvSpPr/>
+          <p:nvPr/>
+        </p:nvSpPr>
+        <p:spPr>
+          <a:xfrm>
+            <a:off x="4537710" y="5062215"/>
+            <a:ext cx="27696" cy="27696"/>
+          </a:xfrm>
+          <a:prstGeom prst="ellipse">
+            <a:avLst/>
+          </a:prstGeom>
+          <a:solidFill>
+            <a:schemeClr val="accent1"/>
+          </a:solidFill>
+          <a:ln w="5080">
+            <a:solidFill>
+              <a:srgbClr val="FFFFFF"/>
+            </a:solidFill>
+            <a:prstDash val="solid"/>
+          </a:ln>
+        </p:spPr>
+      </p:sp>
+      <p:sp>
+        <p:nvSpPr>
+          <p:cNvPr id="142" name="mini syn 72 3"/>
+          <p:cNvSpPr/>
+          <p:nvPr/>
+        </p:nvSpPr>
+        <p:spPr>
+          <a:xfrm>
+            <a:off x="4537710" y="5102220"/>
+            <a:ext cx="27696" cy="27696"/>
+          </a:xfrm>
+          <a:prstGeom prst="ellipse">
+            <a:avLst/>
+          </a:prstGeom>
+          <a:solidFill>
+            <a:schemeClr val="accent1"/>
+          </a:solidFill>
+          <a:ln w="5080">
+            <a:solidFill>
+              <a:srgbClr val="FFFFFF"/>
+            </a:solidFill>
+            <a:prstDash val="solid"/>
+          </a:ln>
+        </p:spPr>
+      </p:sp>
+      <p:sp>
+        <p:nvSpPr>
+          <p:cNvPr id="143" name="mini syn 72 4"/>
+          <p:cNvSpPr/>
+          <p:nvPr/>
+        </p:nvSpPr>
+        <p:spPr>
+          <a:xfrm>
+            <a:off x="4528566" y="5148380"/>
+            <a:ext cx="36928" cy="15387"/>
+          </a:xfrm>
+          <a:prstGeom prst="rect">
+            <a:avLst/>
+          </a:prstGeom>
+          <a:solidFill>
+            <a:schemeClr val="accent1"/>
+          </a:solidFill>
+          <a:ln w="5080">
+            <a:solidFill>
+              <a:srgbClr val="FFFFFF"/>
+            </a:solidFill>
+            <a:prstDash val="solid"/>
+          </a:ln>
+        </p:spPr>
+      </p:sp>
+      <p:sp>
+        <p:nvSpPr>
+          <p:cNvPr id="144" name="mini syn 72 5"/>
+          <p:cNvSpPr/>
+          <p:nvPr/>
+        </p:nvSpPr>
+        <p:spPr>
+          <a:xfrm>
+            <a:off x="4537710" y="5182230"/>
+            <a:ext cx="27696" cy="27696"/>
+          </a:xfrm>
+          <a:prstGeom prst="ellipse">
+            <a:avLst/>
+          </a:prstGeom>
+          <a:solidFill>
+            <a:schemeClr val="accent1"/>
+          </a:solidFill>
+          <a:ln w="5080">
+            <a:solidFill>
+              <a:srgbClr val="FFFFFF"/>
+            </a:solidFill>
+            <a:prstDash val="solid"/>
+          </a:ln>
+        </p:spPr>
+      </p:sp>
+      <p:sp>
+        <p:nvSpPr>
+          <p:cNvPr id="145" name="mini syn 72 6"/>
+          <p:cNvSpPr/>
+          <p:nvPr/>
+        </p:nvSpPr>
+        <p:spPr>
+          <a:xfrm>
+            <a:off x="4537710" y="5222235"/>
+            <a:ext cx="27696" cy="27696"/>
+          </a:xfrm>
+          <a:prstGeom prst="ellipse">
+            <a:avLst/>
+          </a:prstGeom>
+          <a:solidFill>
+            <a:schemeClr val="accent1"/>
+          </a:solidFill>
+          <a:ln w="5080">
+            <a:solidFill>
+              <a:srgbClr val="FFFFFF"/>
+            </a:solidFill>
+            <a:prstDash val="solid"/>
+          </a:ln>
+        </p:spPr>
+      </p:sp>
+      <p:sp>
+        <p:nvSpPr>
+          <p:cNvPr id="146" name="mini slab syn 80"/>
+          <p:cNvSpPr/>
+          <p:nvPr/>
+        </p:nvSpPr>
+        <p:spPr>
+          <a:xfrm>
+            <a:off x="5021199" y="4133088"/>
+            <a:ext cx="456057" cy="32004"/>
+          </a:xfrm>
+          <a:prstGeom prst="rect">
+            <a:avLst/>
+          </a:prstGeom>
+          <a:solidFill>
+            <a:srgbClr val="52514E"/>
+          </a:solidFill>
+          <a:ln/>
+        </p:spPr>
+      </p:sp>
+      <p:sp>
+        <p:nvSpPr>
+          <p:cNvPr id="147" name="mini syn 80 0"/>
+          <p:cNvSpPr/>
+          <p:nvPr/>
+        </p:nvSpPr>
+        <p:spPr>
+          <a:xfrm>
+            <a:off x="5058459" y="4206240"/>
+            <a:ext cx="26827" cy="26827"/>
+          </a:xfrm>
+          <a:prstGeom prst="ellipse">
+            <a:avLst/>
+          </a:prstGeom>
+          <a:solidFill>
+            <a:schemeClr val="accent1"/>
+          </a:solidFill>
+          <a:ln w="5080">
+            <a:solidFill>
+              <a:srgbClr val="FFFFFF"/>
+            </a:solidFill>
+            <a:prstDash val="solid"/>
+          </a:ln>
+        </p:spPr>
+      </p:sp>
+      <p:sp>
+        <p:nvSpPr>
+          <p:cNvPr id="148" name="mini syn 80 1"/>
+          <p:cNvSpPr/>
+          <p:nvPr/>
+        </p:nvSpPr>
+        <p:spPr>
+          <a:xfrm>
+            <a:off x="5109132" y="4206240"/>
+            <a:ext cx="26827" cy="26827"/>
+          </a:xfrm>
+          <a:prstGeom prst="ellipse">
+            <a:avLst/>
+          </a:prstGeom>
+          <a:solidFill>
+            <a:schemeClr val="accent1"/>
+          </a:solidFill>
+          <a:ln w="5080">
+            <a:solidFill>
+              <a:srgbClr val="FFFFFF"/>
+            </a:solidFill>
+            <a:prstDash val="solid"/>
+          </a:ln>
+        </p:spPr>
+      </p:sp>
+      <p:sp>
+        <p:nvSpPr>
+          <p:cNvPr id="149" name="mini syn 80 2"/>
+          <p:cNvSpPr/>
+          <p:nvPr/>
+        </p:nvSpPr>
+        <p:spPr>
+          <a:xfrm>
+            <a:off x="5159805" y="4206240"/>
+            <a:ext cx="26827" cy="26827"/>
+          </a:xfrm>
+          <a:prstGeom prst="ellipse">
+            <a:avLst/>
+          </a:prstGeom>
+          <a:solidFill>
+            <a:schemeClr val="accent1"/>
+          </a:solidFill>
+          <a:ln w="5080">
+            <a:solidFill>
+              <a:srgbClr val="FFFFFF"/>
+            </a:solidFill>
+            <a:prstDash val="solid"/>
+          </a:ln>
+        </p:spPr>
+      </p:sp>
+      <p:sp>
+        <p:nvSpPr>
+          <p:cNvPr id="150" name="mini syn 80 3"/>
+          <p:cNvSpPr/>
+          <p:nvPr/>
+        </p:nvSpPr>
+        <p:spPr>
+          <a:xfrm>
+            <a:off x="5210478" y="4206240"/>
+            <a:ext cx="26827" cy="26827"/>
+          </a:xfrm>
+          <a:prstGeom prst="ellipse">
+            <a:avLst/>
+          </a:prstGeom>
+          <a:solidFill>
+            <a:schemeClr val="accent1"/>
+          </a:solidFill>
+          <a:ln w="5080">
+            <a:solidFill>
+              <a:srgbClr val="FFFFFF"/>
+            </a:solidFill>
+            <a:prstDash val="solid"/>
+          </a:ln>
+        </p:spPr>
+      </p:sp>
+      <p:sp>
+        <p:nvSpPr>
+          <p:cNvPr id="151" name="mini syn 80 4"/>
+          <p:cNvSpPr/>
+          <p:nvPr/>
+        </p:nvSpPr>
+        <p:spPr>
+          <a:xfrm>
+            <a:off x="5261151" y="4206240"/>
+            <a:ext cx="26827" cy="26827"/>
+          </a:xfrm>
+          <a:prstGeom prst="ellipse">
+            <a:avLst/>
+          </a:prstGeom>
+          <a:solidFill>
+            <a:schemeClr val="accent1"/>
+          </a:solidFill>
+          <a:ln w="5080">
+            <a:solidFill>
+              <a:srgbClr val="FFFFFF"/>
+            </a:solidFill>
+            <a:prstDash val="solid"/>
+          </a:ln>
+        </p:spPr>
+      </p:sp>
+      <p:sp>
+        <p:nvSpPr>
+          <p:cNvPr id="152" name="mini syn 80 5"/>
+          <p:cNvSpPr/>
+          <p:nvPr/>
+        </p:nvSpPr>
+        <p:spPr>
+          <a:xfrm>
+            <a:off x="5311824" y="4206240"/>
+            <a:ext cx="26827" cy="26827"/>
+          </a:xfrm>
+          <a:prstGeom prst="ellipse">
+            <a:avLst/>
+          </a:prstGeom>
+          <a:solidFill>
+            <a:schemeClr val="accent1"/>
+          </a:solidFill>
+          <a:ln w="5080">
+            <a:solidFill>
+              <a:srgbClr val="FFFFFF"/>
+            </a:solidFill>
+            <a:prstDash val="solid"/>
+          </a:ln>
+        </p:spPr>
+      </p:sp>
+      <p:sp>
+        <p:nvSpPr>
+          <p:cNvPr id="153" name="mini syn 80 6"/>
+          <p:cNvSpPr/>
+          <p:nvPr/>
+        </p:nvSpPr>
+        <p:spPr>
+          <a:xfrm>
+            <a:off x="5362497" y="4206240"/>
+            <a:ext cx="26827" cy="26827"/>
+          </a:xfrm>
+          <a:prstGeom prst="ellipse">
+            <a:avLst/>
+          </a:prstGeom>
+          <a:solidFill>
+            <a:schemeClr val="accent1"/>
+          </a:solidFill>
+          <a:ln w="5080">
+            <a:solidFill>
+              <a:srgbClr val="FFFFFF"/>
+            </a:solidFill>
+            <a:prstDash val="solid"/>
+          </a:ln>
+        </p:spPr>
+      </p:sp>
+      <p:sp>
+        <p:nvSpPr>
+          <p:cNvPr id="154" name="mini syn 80 7"/>
+          <p:cNvSpPr/>
+          <p:nvPr/>
+        </p:nvSpPr>
+        <p:spPr>
+          <a:xfrm>
+            <a:off x="5413170" y="4206240"/>
+            <a:ext cx="26827" cy="26827"/>
+          </a:xfrm>
+          <a:prstGeom prst="ellipse">
+            <a:avLst/>
+          </a:prstGeom>
+          <a:solidFill>
+            <a:schemeClr val="accent1"/>
+          </a:solidFill>
+          <a:ln w="5080">
+            <a:solidFill>
+              <a:srgbClr val="FFFFFF"/>
+            </a:solidFill>
+            <a:prstDash val="solid"/>
+          </a:ln>
+        </p:spPr>
+      </p:sp>
+      <p:sp>
+        <p:nvSpPr>
+          <p:cNvPr id="155" name="mini slab syn 81"/>
+          <p:cNvSpPr/>
+          <p:nvPr/>
+        </p:nvSpPr>
+        <p:spPr>
+          <a:xfrm>
+            <a:off x="5021199" y="4544568"/>
+            <a:ext cx="456057" cy="32004"/>
+          </a:xfrm>
+          <a:prstGeom prst="rect">
+            <a:avLst/>
+          </a:prstGeom>
+          <a:solidFill>
+            <a:srgbClr val="52514E"/>
+          </a:solidFill>
+          <a:ln/>
+        </p:spPr>
+      </p:sp>
+      <p:sp>
+        <p:nvSpPr>
+          <p:cNvPr id="156" name="mini syn 81 0"/>
+          <p:cNvSpPr/>
+          <p:nvPr/>
+        </p:nvSpPr>
+        <p:spPr>
+          <a:xfrm>
+            <a:off x="5049516" y="4608576"/>
+            <a:ext cx="44711" cy="32788"/>
+          </a:xfrm>
+          <a:prstGeom prst="rect">
+            <a:avLst/>
+          </a:prstGeom>
+          <a:solidFill>
+            <a:schemeClr val="accent1"/>
+          </a:solidFill>
+          <a:ln w="5080">
+            <a:solidFill>
+              <a:srgbClr val="FFFFFF"/>
+            </a:solidFill>
+            <a:prstDash val="solid"/>
+          </a:ln>
+        </p:spPr>
+      </p:sp>
+      <p:sp>
+        <p:nvSpPr>
+          <p:cNvPr id="157" name="mini syn 81 1"/>
+          <p:cNvSpPr/>
+          <p:nvPr/>
+        </p:nvSpPr>
+        <p:spPr>
+          <a:xfrm>
+            <a:off x="5109132" y="4617720"/>
+            <a:ext cx="26827" cy="26827"/>
+          </a:xfrm>
+          <a:prstGeom prst="ellipse">
+            <a:avLst/>
+          </a:prstGeom>
+          <a:solidFill>
+            <a:schemeClr val="accent1"/>
+          </a:solidFill>
+          <a:ln w="5080">
+            <a:solidFill>
+              <a:srgbClr val="FFFFFF"/>
+            </a:solidFill>
+            <a:prstDash val="solid"/>
+          </a:ln>
+        </p:spPr>
+      </p:sp>
+      <p:sp>
+        <p:nvSpPr>
+          <p:cNvPr id="158" name="mini syn 81 2"/>
+          <p:cNvSpPr/>
+          <p:nvPr/>
+        </p:nvSpPr>
+        <p:spPr>
+          <a:xfrm>
+            <a:off x="5155333" y="4636008"/>
+            <a:ext cx="35769" cy="14904"/>
+          </a:xfrm>
+          <a:prstGeom prst="rect">
+            <a:avLst/>
+          </a:prstGeom>
+          <a:solidFill>
+            <a:schemeClr val="accent1"/>
+          </a:solidFill>
+          <a:ln w="5080">
+            <a:solidFill>
+              <a:srgbClr val="FFFFFF"/>
+            </a:solidFill>
+            <a:prstDash val="solid"/>
+          </a:ln>
+        </p:spPr>
+      </p:sp>
+      <p:sp>
+        <p:nvSpPr>
+          <p:cNvPr id="159" name="mini syn 81 3"/>
+          <p:cNvSpPr/>
+          <p:nvPr/>
+        </p:nvSpPr>
+        <p:spPr>
+          <a:xfrm>
+            <a:off x="5210478" y="4617720"/>
+            <a:ext cx="26827" cy="26827"/>
+          </a:xfrm>
+          <a:prstGeom prst="ellipse">
+            <a:avLst/>
+          </a:prstGeom>
+          <a:solidFill>
+            <a:schemeClr val="accent1"/>
+          </a:solidFill>
+          <a:ln w="5080">
+            <a:solidFill>
+              <a:srgbClr val="FFFFFF"/>
+            </a:solidFill>
+            <a:prstDash val="solid"/>
+          </a:ln>
+        </p:spPr>
+      </p:sp>
+      <p:sp>
+        <p:nvSpPr>
+          <p:cNvPr id="160" name="mini syn 81 4"/>
+          <p:cNvSpPr/>
+          <p:nvPr/>
+        </p:nvSpPr>
+        <p:spPr>
+          <a:xfrm>
+            <a:off x="5252208" y="4608576"/>
+            <a:ext cx="44711" cy="32788"/>
+          </a:xfrm>
+          <a:prstGeom prst="rect">
+            <a:avLst/>
+          </a:prstGeom>
+          <a:solidFill>
+            <a:schemeClr val="accent1"/>
+          </a:solidFill>
+          <a:ln w="5080">
+            <a:solidFill>
+              <a:srgbClr val="FFFFFF"/>
+            </a:solidFill>
+            <a:prstDash val="solid"/>
+          </a:ln>
+        </p:spPr>
+      </p:sp>
+      <p:sp>
+        <p:nvSpPr>
+          <p:cNvPr id="161" name="mini syn 81 5"/>
+          <p:cNvSpPr/>
+          <p:nvPr/>
+        </p:nvSpPr>
+        <p:spPr>
+          <a:xfrm>
+            <a:off x="5311824" y="4617720"/>
+            <a:ext cx="26827" cy="26827"/>
+          </a:xfrm>
+          <a:prstGeom prst="ellipse">
+            <a:avLst/>
+          </a:prstGeom>
+          <a:solidFill>
+            <a:schemeClr val="accent1"/>
+          </a:solidFill>
+          <a:ln w="5080">
+            <a:solidFill>
+              <a:srgbClr val="FFFFFF"/>
+            </a:solidFill>
+            <a:prstDash val="solid"/>
+          </a:ln>
+        </p:spPr>
+      </p:sp>
+      <p:sp>
+        <p:nvSpPr>
+          <p:cNvPr id="162" name="mini syn 81 6"/>
+          <p:cNvSpPr/>
+          <p:nvPr/>
+        </p:nvSpPr>
+        <p:spPr>
+          <a:xfrm>
+            <a:off x="5358025" y="4636008"/>
+            <a:ext cx="35769" cy="14904"/>
+          </a:xfrm>
+          <a:prstGeom prst="rect">
+            <a:avLst/>
+          </a:prstGeom>
+          <a:solidFill>
+            <a:schemeClr val="accent1"/>
+          </a:solidFill>
+          <a:ln w="5080">
+            <a:solidFill>
+              <a:srgbClr val="FFFFFF"/>
+            </a:solidFill>
+            <a:prstDash val="solid"/>
+          </a:ln>
+        </p:spPr>
+      </p:sp>
+      <p:sp>
+        <p:nvSpPr>
+          <p:cNvPr id="163" name="mini syn 81 7"/>
+          <p:cNvSpPr/>
+          <p:nvPr/>
+        </p:nvSpPr>
+        <p:spPr>
+          <a:xfrm>
+            <a:off x="5413170" y="4617720"/>
+            <a:ext cx="26827" cy="26827"/>
+          </a:xfrm>
+          <a:prstGeom prst="ellipse">
+            <a:avLst/>
+          </a:prstGeom>
+          <a:solidFill>
+            <a:schemeClr val="accent1"/>
+          </a:solidFill>
+          <a:ln w="5080">
+            <a:solidFill>
+              <a:srgbClr val="FFFFFF"/>
+            </a:solidFill>
+            <a:prstDash val="solid"/>
+          </a:ln>
+        </p:spPr>
+      </p:sp>
+      <p:sp>
+        <p:nvSpPr>
+          <p:cNvPr id="164" name="mini wall syn 82"/>
+          <p:cNvSpPr/>
+          <p:nvPr/>
+        </p:nvSpPr>
+        <p:spPr>
+          <a:xfrm>
+            <a:off x="5021199" y="4956048"/>
+            <a:ext cx="32004" cy="320040"/>
+          </a:xfrm>
+          <a:prstGeom prst="rect">
+            <a:avLst/>
+          </a:prstGeom>
+          <a:solidFill>
+            <a:srgbClr val="52514E"/>
+          </a:solidFill>
+          <a:ln/>
+        </p:spPr>
+      </p:sp>
+      <p:sp>
+        <p:nvSpPr>
+          <p:cNvPr id="165" name="mini syn 82 0"/>
+          <p:cNvSpPr/>
+          <p:nvPr/>
+        </p:nvSpPr>
+        <p:spPr>
+          <a:xfrm>
+            <a:off x="5103495" y="4979299"/>
+            <a:ext cx="24618" cy="24618"/>
+          </a:xfrm>
+          <a:prstGeom prst="ellipse">
+            <a:avLst/>
+          </a:prstGeom>
+          <a:solidFill>
+            <a:schemeClr val="accent1"/>
+          </a:solidFill>
+          <a:ln w="5080">
+            <a:solidFill>
+              <a:srgbClr val="FFFFFF"/>
+            </a:solidFill>
+            <a:prstDash val="solid"/>
+          </a:ln>
+        </p:spPr>
+      </p:sp>
+      <p:sp>
+        <p:nvSpPr>
+          <p:cNvPr id="166" name="mini syn 82 1"/>
+          <p:cNvSpPr/>
+          <p:nvPr/>
+        </p:nvSpPr>
+        <p:spPr>
+          <a:xfrm>
+            <a:off x="5094351" y="5020330"/>
+            <a:ext cx="32825" cy="13677"/>
+          </a:xfrm>
+          <a:prstGeom prst="rect">
+            <a:avLst/>
+          </a:prstGeom>
+          <a:solidFill>
+            <a:schemeClr val="accent1"/>
+          </a:solidFill>
+          <a:ln w="5080">
+            <a:solidFill>
+              <a:srgbClr val="FFFFFF"/>
+            </a:solidFill>
+            <a:prstDash val="solid"/>
+          </a:ln>
+        </p:spPr>
+      </p:sp>
+      <p:sp>
+        <p:nvSpPr>
+          <p:cNvPr id="167" name="mini syn 82 2"/>
+          <p:cNvSpPr/>
+          <p:nvPr/>
+        </p:nvSpPr>
+        <p:spPr>
+          <a:xfrm>
+            <a:off x="5103495" y="5050419"/>
+            <a:ext cx="24618" cy="24618"/>
+          </a:xfrm>
+          <a:prstGeom prst="ellipse">
+            <a:avLst/>
+          </a:prstGeom>
+          <a:solidFill>
+            <a:schemeClr val="accent1"/>
+          </a:solidFill>
+          <a:ln w="5080">
+            <a:solidFill>
+              <a:srgbClr val="FFFFFF"/>
+            </a:solidFill>
+            <a:prstDash val="solid"/>
+          </a:ln>
+        </p:spPr>
+      </p:sp>
+      <p:sp>
+        <p:nvSpPr>
+          <p:cNvPr id="168" name="mini syn 82 3"/>
+          <p:cNvSpPr/>
+          <p:nvPr/>
+        </p:nvSpPr>
+        <p:spPr>
+          <a:xfrm>
+            <a:off x="5103495" y="5085979"/>
+            <a:ext cx="24618" cy="24618"/>
+          </a:xfrm>
+          <a:prstGeom prst="ellipse">
+            <a:avLst/>
+          </a:prstGeom>
+          <a:solidFill>
+            <a:schemeClr val="accent1"/>
+          </a:solidFill>
+          <a:ln w="5080">
+            <a:solidFill>
+              <a:srgbClr val="FFFFFF"/>
+            </a:solidFill>
+            <a:prstDash val="solid"/>
+          </a:ln>
+        </p:spPr>
+      </p:sp>
+      <p:sp>
+        <p:nvSpPr>
+          <p:cNvPr id="169" name="mini syn 82 4"/>
+          <p:cNvSpPr/>
+          <p:nvPr/>
+        </p:nvSpPr>
+        <p:spPr>
+          <a:xfrm>
+            <a:off x="5094351" y="5127010"/>
+            <a:ext cx="32825" cy="13677"/>
+          </a:xfrm>
+          <a:prstGeom prst="rect">
+            <a:avLst/>
+          </a:prstGeom>
+          <a:solidFill>
+            <a:schemeClr val="accent1"/>
+          </a:solidFill>
+          <a:ln w="5080">
+            <a:solidFill>
+              <a:srgbClr val="FFFFFF"/>
+            </a:solidFill>
+            <a:prstDash val="solid"/>
+          </a:ln>
+        </p:spPr>
+      </p:sp>
+      <p:sp>
+        <p:nvSpPr>
+          <p:cNvPr id="170" name="mini syn 82 5"/>
+          <p:cNvSpPr/>
+          <p:nvPr/>
+        </p:nvSpPr>
+        <p:spPr>
+          <a:xfrm>
+            <a:off x="5103495" y="5157099"/>
+            <a:ext cx="24618" cy="24618"/>
+          </a:xfrm>
+          <a:prstGeom prst="ellipse">
+            <a:avLst/>
+          </a:prstGeom>
+          <a:solidFill>
+            <a:schemeClr val="accent1"/>
+          </a:solidFill>
+          <a:ln w="5080">
+            <a:solidFill>
+              <a:srgbClr val="FFFFFF"/>
+            </a:solidFill>
+            <a:prstDash val="solid"/>
+          </a:ln>
+        </p:spPr>
+      </p:sp>
+      <p:sp>
+        <p:nvSpPr>
+          <p:cNvPr id="171" name="mini syn 82 6"/>
+          <p:cNvSpPr/>
+          <p:nvPr/>
+        </p:nvSpPr>
+        <p:spPr>
+          <a:xfrm>
+            <a:off x="5103495" y="5192659"/>
+            <a:ext cx="24618" cy="24618"/>
+          </a:xfrm>
+          <a:prstGeom prst="ellipse">
+            <a:avLst/>
+          </a:prstGeom>
+          <a:solidFill>
+            <a:schemeClr val="accent1"/>
+          </a:solidFill>
+          <a:ln w="5080">
+            <a:solidFill>
+              <a:srgbClr val="FFFFFF"/>
+            </a:solidFill>
+            <a:prstDash val="solid"/>
+          </a:ln>
+        </p:spPr>
+      </p:sp>
+      <p:sp>
+        <p:nvSpPr>
+          <p:cNvPr id="172" name="mini syn 82 7"/>
+          <p:cNvSpPr/>
+          <p:nvPr/>
+        </p:nvSpPr>
+        <p:spPr>
+          <a:xfrm>
+            <a:off x="5094351" y="5233690"/>
+            <a:ext cx="32825" cy="13677"/>
+          </a:xfrm>
+          <a:prstGeom prst="rect">
+            <a:avLst/>
+          </a:prstGeom>
+          <a:solidFill>
+            <a:schemeClr val="accent1"/>
+          </a:solidFill>
+          <a:ln w="5080">
+            <a:solidFill>
+              <a:srgbClr val="FFFFFF"/>
+            </a:solidFill>
+            <a:prstDash val="solid"/>
+          </a:ln>
+        </p:spPr>
+      </p:sp>
+      <p:sp>
+        <p:nvSpPr>
+          <p:cNvPr id="173" name="glance heading"/>
           <p:cNvSpPr txBox="1"/>
           <p:nvPr/>
         </p:nvSpPr>
@@ -15951,7 +18595,7 @@
       </p:sp>
       <p:sp>
         <p:nvSpPr>
-          <p:cNvPr id="62" name="tile contexts in four splits on disjoint seeds"/>
+          <p:cNvPr id="174" name="tile contexts, four splits, disjoint seeds"/>
           <p:cNvSpPr/>
           <p:nvPr/>
         </p:nvSpPr>
@@ -15973,7 +18617,7 @@
       </p:sp>
       <p:sp>
         <p:nvSpPr>
-          <p:cNvPr id="63" name="value contexts in four splits on disjoint seeds"/>
+          <p:cNvPr id="175" name="value contexts, four splits, disjoint seeds"/>
           <p:cNvSpPr txBox="1"/>
           <p:nvPr/>
         </p:nvSpPr>
@@ -16009,7 +18653,7 @@
       </p:sp>
       <p:sp>
         <p:nvSpPr>
-          <p:cNvPr id="64" name="label contexts in four splits on disjoint seeds"/>
+          <p:cNvPr id="176" name="label contexts, four splits, disjoint seeds"/>
           <p:cNvSpPr txBox="1"/>
           <p:nvPr/>
         </p:nvSpPr>
@@ -16037,7 +18681,7 @@
                   <a:srgbClr val="52514E"/>
                 </a:solidFill>
               </a:rPr>
-              <a:t>contexts in four splits on disjoint seeds</a:t>
+              <a:t>contexts, four splits, disjoint seeds</a:t>
             </a:r>
             <a:endParaRPr lang="en-US" sz="1150" dirty="0"/>
           </a:p>
@@ -16045,7 +18689,7 @@
       </p:sp>
       <p:sp>
         <p:nvSpPr>
-          <p:cNvPr id="65" name="tile elements: pipes, cable trays, ducts and conduits; six trades"/>
+          <p:cNvPr id="177" name="tile elements, four kinds, six trades"/>
           <p:cNvSpPr/>
           <p:nvPr/>
         </p:nvSpPr>
@@ -16067,7 +18711,7 @@
       </p:sp>
       <p:sp>
         <p:nvSpPr>
-          <p:cNvPr id="66" name="value elements: pipes, cable trays, ducts and conduits; six trades"/>
+          <p:cNvPr id="178" name="value elements, four kinds, six trades"/>
           <p:cNvSpPr txBox="1"/>
           <p:nvPr/>
         </p:nvSpPr>
@@ -16103,7 +18747,7 @@
       </p:sp>
       <p:sp>
         <p:nvSpPr>
-          <p:cNvPr id="67" name="label elements: pipes, cable trays, ducts and conduits; six trades"/>
+          <p:cNvPr id="179" name="label elements, four kinds, six trades"/>
           <p:cNvSpPr txBox="1"/>
           <p:nvPr/>
         </p:nvSpPr>
@@ -16131,7 +18775,7 @@
                   <a:srgbClr val="52514E"/>
                 </a:solidFill>
               </a:rPr>
-              <a:t>elements: pipes, cable trays, ducts and conduits; six trades</a:t>
+              <a:t>elements, four kinds, six trades</a:t>
             </a:r>
             <a:endParaRPr lang="en-US" sz="1150" dirty="0"/>
           </a:p>
@@ -16139,7 +18783,7 @@
       </p:sp>
       <p:sp>
         <p:nvSpPr>
-          <p:cNvPr id="68" name="tile eight difficulty tiers by exact element count"/>
+          <p:cNvPr id="180" name="tile tiers by exact element count"/>
           <p:cNvSpPr/>
           <p:nvPr/>
         </p:nvSpPr>
@@ -16161,7 +18805,7 @@
       </p:sp>
       <p:sp>
         <p:nvSpPr>
-          <p:cNvPr id="69" name="value eight difficulty tiers by exact element count"/>
+          <p:cNvPr id="181" name="value tiers by exact element count"/>
           <p:cNvSpPr txBox="1"/>
           <p:nvPr/>
         </p:nvSpPr>
@@ -16197,7 +18841,7 @@
       </p:sp>
       <p:sp>
         <p:nvSpPr>
-          <p:cNvPr id="70" name="label eight difficulty tiers by exact element count"/>
+          <p:cNvPr id="182" name="label tiers by exact element count"/>
           <p:cNvSpPr txBox="1"/>
           <p:nvPr/>
         </p:nvSpPr>
@@ -16225,7 +18869,7 @@
                   <a:srgbClr val="52514E"/>
                 </a:solidFill>
               </a:rPr>
-              <a:t>eight difficulty tiers by exact element count</a:t>
+              <a:t>tiers by exact element count</a:t>
             </a:r>
             <a:endParaRPr lang="en-US" sz="1150" dirty="0"/>
           </a:p>
@@ -16233,7 +18877,7 @@
       </p:sp>
       <p:sp>
         <p:nvSpPr>
-          <p:cNvPr id="71" name="tile the brief, not the answer: no support-assembly information"/>
+          <p:cNvPr id="183" name="tile the brief, not the answer"/>
           <p:cNvSpPr/>
           <p:nvPr/>
         </p:nvSpPr>
@@ -16255,7 +18899,7 @@
       </p:sp>
       <p:sp>
         <p:nvSpPr>
-          <p:cNvPr id="72" name="value the brief, not the answer: no support-assembly information"/>
+          <p:cNvPr id="184" name="value the brief, not the answer"/>
           <p:cNvSpPr txBox="1"/>
           <p:nvPr/>
         </p:nvSpPr>
@@ -16291,7 +18935,7 @@
       </p:sp>
       <p:sp>
         <p:nvSpPr>
-          <p:cNvPr id="73" name="label the brief, not the answer: no support-assembly information"/>
+          <p:cNvPr id="185" name="label the brief, not the answer"/>
           <p:cNvSpPr txBox="1"/>
           <p:nvPr/>
         </p:nvSpPr>
@@ -16319,7 +18963,7 @@
                   <a:srgbClr val="52514E"/>
                 </a:solidFill>
               </a:rPr>
-              <a:t>the brief, not the answer: no support-assembly information</a:t>
+              <a:t>the brief, not the answer</a:t>
             </a:r>
             <a:endParaRPr lang="en-US" sz="1150" dirty="0"/>
           </a:p>
@@ -16327,7 +18971,7 @@
       </p:sp>
       <p:sp>
         <p:nvSpPr>
-          <p:cNvPr id="74" name="tile every constant with its source, or declared a design choice"/>
+          <p:cNvPr id="186" name="tile every constant sourced or declared"/>
           <p:cNvSpPr/>
           <p:nvPr/>
         </p:nvSpPr>
@@ -16349,7 +18993,7 @@
       </p:sp>
       <p:sp>
         <p:nvSpPr>
-          <p:cNvPr id="75" name="value every constant with its source, or declared a design choice"/>
+          <p:cNvPr id="187" name="value every constant sourced or declared"/>
           <p:cNvSpPr txBox="1"/>
           <p:nvPr/>
         </p:nvSpPr>
@@ -16385,7 +19029,7 @@
       </p:sp>
       <p:sp>
         <p:nvSpPr>
-          <p:cNvPr id="76" name="label every constant with its source, or declared a design choice"/>
+          <p:cNvPr id="188" name="label every constant sourced or declared"/>
           <p:cNvSpPr txBox="1"/>
           <p:nvPr/>
         </p:nvSpPr>
@@ -16413,7 +19057,7 @@
                   <a:srgbClr val="52514E"/>
                 </a:solidFill>
               </a:rPr>
-              <a:t>every constant with its source, or declared a design choice</a:t>
+              <a:t>every constant sourced or declared</a:t>
             </a:r>
             <a:endParaRPr lang="en-US" sz="1150" dirty="0"/>
           </a:p>
@@ -16421,7 +19065,7 @@
       </p:sp>
       <p:sp>
         <p:nvSpPr>
-          <p:cNvPr id="77" name="tile data CC BY 4.0, code MIT; a seeded, deterministic generator"/>
+          <p:cNvPr id="189" name="tile data CC BY 4.0, code MIT"/>
           <p:cNvSpPr/>
           <p:nvPr/>
         </p:nvSpPr>
@@ -16443,7 +19087,7 @@
       </p:sp>
       <p:sp>
         <p:nvSpPr>
-          <p:cNvPr id="78" name="value data CC BY 4.0, code MIT; a seeded, deterministic generator"/>
+          <p:cNvPr id="190" name="value data CC BY 4.0, code MIT"/>
           <p:cNvSpPr txBox="1"/>
           <p:nvPr/>
         </p:nvSpPr>
@@ -16479,7 +19123,7 @@
       </p:sp>
       <p:sp>
         <p:nvSpPr>
-          <p:cNvPr id="79" name="label data CC BY 4.0, code MIT; a seeded, deterministic generator"/>
+          <p:cNvPr id="191" name="label data CC BY 4.0, code MIT"/>
           <p:cNvSpPr txBox="1"/>
           <p:nvPr/>
         </p:nvSpPr>
@@ -16507,7 +19151,7 @@
                   <a:srgbClr val="52514E"/>
                 </a:solidFill>
               </a:rPr>
-              <a:t>data CC BY 4.0, code MIT; a seeded, deterministic generator</a:t>
+              <a:t>data CC BY 4.0, code MIT</a:t>
             </a:r>
             <a:endParaRPr lang="en-US" sz="1150" dirty="0"/>
           </a:p>

</xml_diff>

<commit_message>
Talk: slide 6 thumbnails on white cards, one per datapoint; at-a-glance as icon tiles
</commit_message>
<xml_diff>
--- a/docs/CrossMEP_CIBW78_talk.pptx
+++ b/docs/CrossMEP_CIBW78_talk.pptx
@@ -124,12 +124,12 @@
   <p:extLst>
     <p:ext uri="{521415D9-36F7-43E2-AB2F-B90AF26B5E84}">
       <p14:sectionLst xmlns:p14="http://schemas.microsoft.com/office/powerpoint/2010/main">
-        <p14:section name="Opening" id="{521c0017-bd6d-fe2d-035d-e867eea9b7b9}">
+        <p14:section name="Opening" id="{fac17887-2821-2f7a-9895-4bfe5f9a0156}">
           <p14:sldIdLst>
             <p14:sldId id="256"/>
           </p14:sldIdLst>
         </p14:section>
-        <p14:section name="Motivation" id="{e18b5bb8-1f13-f976-aee9-2a98f360947f}">
+        <p14:section name="Motivation" id="{83e74715-7f66-b7e2-28fe-09d164261fb6}">
           <p14:sldIdLst>
             <p14:sldId id="257"/>
             <p14:sldId id="258"/>
@@ -138,7 +138,7 @@
             <p14:sldId id="261"/>
           </p14:sldIdLst>
         </p14:section>
-        <p14:section name="The dataset" id="{22c66ab9-fb38-fae5-623f-5b49cd9e0105}">
+        <p14:section name="The dataset" id="{709f30f9-bf3b-a126-bc38-f0618633a07f}">
           <p14:sldIdLst>
             <p14:sldId id="262"/>
             <p14:sldId id="263"/>
@@ -147,14 +147,14 @@
             <p14:sldId id="266"/>
           </p14:sldIdLst>
         </p14:section>
-        <p14:section name="Experiments" id="{4cf845ca-fd69-5860-5c24-a5e696147190}">
+        <p14:section name="Experiments" id="{8928fe26-e890-1ec0-1c45-95abe83039e0}">
           <p14:sldIdLst>
             <p14:sldId id="267"/>
             <p14:sldId id="268"/>
             <p14:sldId id="269"/>
           </p14:sldIdLst>
         </p14:section>
-        <p14:section name="Use" id="{b294b918-0363-943f-9613-27707e0547d9}">
+        <p14:section name="Use" id="{d4c47090-b65e-a9c6-4417-192b65f62e43}">
           <p14:sldIdLst>
             <p14:sldId id="270"/>
             <p14:sldId id="271"/>
@@ -14562,7 +14562,32 @@
       </p:sp>
       <p:sp>
         <p:nvSpPr>
-          <p:cNvPr id="9" name="mini slab real 0"/>
+          <p:cNvPr id="9" name="mini card real 0"/>
+          <p:cNvSpPr/>
+          <p:nvPr/>
+        </p:nvSpPr>
+        <p:spPr>
+          <a:xfrm>
+            <a:off x="1095908" y="2736342"/>
+            <a:ext cx="548640" cy="329184"/>
+          </a:xfrm>
+          <a:prstGeom prst="rect">
+            <a:avLst/>
+          </a:prstGeom>
+          <a:solidFill>
+            <a:srgbClr val="FFFFFF"/>
+          </a:solidFill>
+          <a:ln w="6350">
+            <a:solidFill>
+              <a:srgbClr val="898781"/>
+            </a:solidFill>
+            <a:prstDash val="solid"/>
+          </a:ln>
+        </p:spPr>
+      </p:sp>
+      <p:sp>
+        <p:nvSpPr>
+          <p:cNvPr id="10" name="mini slab real 0"/>
           <p:cNvSpPr/>
           <p:nvPr/>
         </p:nvSpPr>
@@ -14582,7 +14607,7 @@
       </p:sp>
       <p:sp>
         <p:nvSpPr>
-          <p:cNvPr id="10" name="mini real 0 0"/>
+          <p:cNvPr id="11" name="mini real 0 0"/>
           <p:cNvSpPr/>
           <p:nvPr/>
         </p:nvSpPr>
@@ -14607,7 +14632,7 @@
       </p:sp>
       <p:sp>
         <p:nvSpPr>
-          <p:cNvPr id="11" name="mini real 0 1"/>
+          <p:cNvPr id="12" name="mini real 0 1"/>
           <p:cNvSpPr/>
           <p:nvPr/>
         </p:nvSpPr>
@@ -14632,7 +14657,7 @@
       </p:sp>
       <p:sp>
         <p:nvSpPr>
-          <p:cNvPr id="12" name="mini real 0 2"/>
+          <p:cNvPr id="13" name="mini real 0 2"/>
           <p:cNvSpPr/>
           <p:nvPr/>
         </p:nvSpPr>
@@ -14657,7 +14682,32 @@
       </p:sp>
       <p:sp>
         <p:nvSpPr>
-          <p:cNvPr id="13" name="mini slab real 1"/>
+          <p:cNvPr id="14" name="mini card real 1"/>
+          <p:cNvSpPr/>
+          <p:nvPr/>
+        </p:nvSpPr>
+        <p:spPr>
+          <a:xfrm>
+            <a:off x="1593799" y="2649931"/>
+            <a:ext cx="548640" cy="329184"/>
+          </a:xfrm>
+          <a:prstGeom prst="rect">
+            <a:avLst/>
+          </a:prstGeom>
+          <a:solidFill>
+            <a:srgbClr val="FFFFFF"/>
+          </a:solidFill>
+          <a:ln w="6350">
+            <a:solidFill>
+              <a:srgbClr val="898781"/>
+            </a:solidFill>
+            <a:prstDash val="solid"/>
+          </a:ln>
+        </p:spPr>
+      </p:sp>
+      <p:sp>
+        <p:nvSpPr>
+          <p:cNvPr id="15" name="mini slab real 1"/>
           <p:cNvSpPr/>
           <p:nvPr/>
         </p:nvSpPr>
@@ -14677,7 +14727,7 @@
       </p:sp>
       <p:sp>
         <p:nvSpPr>
-          <p:cNvPr id="14" name="mini real 1 0"/>
+          <p:cNvPr id="16" name="mini real 1 0"/>
           <p:cNvSpPr/>
           <p:nvPr/>
         </p:nvSpPr>
@@ -14702,7 +14752,7 @@
       </p:sp>
       <p:sp>
         <p:nvSpPr>
-          <p:cNvPr id="15" name="mini real 1 1"/>
+          <p:cNvPr id="17" name="mini real 1 1"/>
           <p:cNvSpPr/>
           <p:nvPr/>
         </p:nvSpPr>
@@ -14727,7 +14777,7 @@
       </p:sp>
       <p:sp>
         <p:nvSpPr>
-          <p:cNvPr id="16" name="mini real 1 2"/>
+          <p:cNvPr id="18" name="mini real 1 2"/>
           <p:cNvSpPr/>
           <p:nvPr/>
         </p:nvSpPr>
@@ -14752,7 +14802,32 @@
       </p:sp>
       <p:sp>
         <p:nvSpPr>
-          <p:cNvPr id="17" name="mini slab real 2"/>
+          <p:cNvPr id="19" name="mini card real 2"/>
+          <p:cNvSpPr/>
+          <p:nvPr/>
+        </p:nvSpPr>
+        <p:spPr>
+          <a:xfrm>
+            <a:off x="2091690" y="2748686"/>
+            <a:ext cx="548640" cy="329184"/>
+          </a:xfrm>
+          <a:prstGeom prst="rect">
+            <a:avLst/>
+          </a:prstGeom>
+          <a:solidFill>
+            <a:srgbClr val="FFFFFF"/>
+          </a:solidFill>
+          <a:ln w="6350">
+            <a:solidFill>
+              <a:srgbClr val="898781"/>
+            </a:solidFill>
+            <a:prstDash val="solid"/>
+          </a:ln>
+        </p:spPr>
+      </p:sp>
+      <p:sp>
+        <p:nvSpPr>
+          <p:cNvPr id="20" name="mini slab real 2"/>
           <p:cNvSpPr/>
           <p:nvPr/>
         </p:nvSpPr>
@@ -14772,7 +14847,7 @@
       </p:sp>
       <p:sp>
         <p:nvSpPr>
-          <p:cNvPr id="18" name="mini real 2 0"/>
+          <p:cNvPr id="21" name="mini real 2 0"/>
           <p:cNvSpPr/>
           <p:nvPr/>
         </p:nvSpPr>
@@ -14797,7 +14872,7 @@
       </p:sp>
       <p:sp>
         <p:nvSpPr>
-          <p:cNvPr id="19" name="mini real 2 1"/>
+          <p:cNvPr id="22" name="mini real 2 1"/>
           <p:cNvSpPr/>
           <p:nvPr/>
         </p:nvSpPr>
@@ -14822,7 +14897,7 @@
       </p:sp>
       <p:sp>
         <p:nvSpPr>
-          <p:cNvPr id="20" name="mini real 2 2"/>
+          <p:cNvPr id="23" name="mini real 2 2"/>
           <p:cNvSpPr/>
           <p:nvPr/>
         </p:nvSpPr>
@@ -14847,7 +14922,32 @@
       </p:sp>
       <p:sp>
         <p:nvSpPr>
-          <p:cNvPr id="21" name="mini slab real 3"/>
+          <p:cNvPr id="24" name="mini card real 3"/>
+          <p:cNvSpPr/>
+          <p:nvPr/>
+        </p:nvSpPr>
+        <p:spPr>
+          <a:xfrm>
+            <a:off x="1231697" y="2304288"/>
+            <a:ext cx="548640" cy="329184"/>
+          </a:xfrm>
+          <a:prstGeom prst="rect">
+            <a:avLst/>
+          </a:prstGeom>
+          <a:solidFill>
+            <a:srgbClr val="FFFFFF"/>
+          </a:solidFill>
+          <a:ln w="6350">
+            <a:solidFill>
+              <a:srgbClr val="898781"/>
+            </a:solidFill>
+            <a:prstDash val="solid"/>
+          </a:ln>
+        </p:spPr>
+      </p:sp>
+      <p:sp>
+        <p:nvSpPr>
+          <p:cNvPr id="25" name="mini slab real 3"/>
           <p:cNvSpPr/>
           <p:nvPr/>
         </p:nvSpPr>
@@ -14867,7 +14967,7 @@
       </p:sp>
       <p:sp>
         <p:nvSpPr>
-          <p:cNvPr id="22" name="mini real 3 0"/>
+          <p:cNvPr id="26" name="mini real 3 0"/>
           <p:cNvSpPr/>
           <p:nvPr/>
         </p:nvSpPr>
@@ -14892,7 +14992,7 @@
       </p:sp>
       <p:sp>
         <p:nvSpPr>
-          <p:cNvPr id="23" name="mini real 3 1"/>
+          <p:cNvPr id="27" name="mini real 3 1"/>
           <p:cNvSpPr/>
           <p:nvPr/>
         </p:nvSpPr>
@@ -14917,7 +15017,7 @@
       </p:sp>
       <p:sp>
         <p:nvSpPr>
-          <p:cNvPr id="24" name="mini real 3 2"/>
+          <p:cNvPr id="28" name="mini real 3 2"/>
           <p:cNvSpPr/>
           <p:nvPr/>
         </p:nvSpPr>
@@ -14942,7 +15042,32 @@
       </p:sp>
       <p:sp>
         <p:nvSpPr>
-          <p:cNvPr id="25" name="mini slab real 4"/>
+          <p:cNvPr id="29" name="mini card real 4"/>
+          <p:cNvSpPr/>
+          <p:nvPr/>
+        </p:nvSpPr>
+        <p:spPr>
+          <a:xfrm>
+            <a:off x="1865376" y="2353666"/>
+            <a:ext cx="548640" cy="329184"/>
+          </a:xfrm>
+          <a:prstGeom prst="rect">
+            <a:avLst/>
+          </a:prstGeom>
+          <a:solidFill>
+            <a:srgbClr val="FFFFFF"/>
+          </a:solidFill>
+          <a:ln w="6350">
+            <a:solidFill>
+              <a:srgbClr val="898781"/>
+            </a:solidFill>
+            <a:prstDash val="solid"/>
+          </a:ln>
+        </p:spPr>
+      </p:sp>
+      <p:sp>
+        <p:nvSpPr>
+          <p:cNvPr id="30" name="mini slab real 4"/>
           <p:cNvSpPr/>
           <p:nvPr/>
         </p:nvSpPr>
@@ -14962,7 +15087,7 @@
       </p:sp>
       <p:sp>
         <p:nvSpPr>
-          <p:cNvPr id="26" name="mini real 4 0"/>
+          <p:cNvPr id="31" name="mini real 4 0"/>
           <p:cNvSpPr/>
           <p:nvPr/>
         </p:nvSpPr>
@@ -14987,7 +15112,7 @@
       </p:sp>
       <p:sp>
         <p:nvSpPr>
-          <p:cNvPr id="27" name="mini real 4 1"/>
+          <p:cNvPr id="32" name="mini real 4 1"/>
           <p:cNvSpPr/>
           <p:nvPr/>
         </p:nvSpPr>
@@ -15012,7 +15137,7 @@
       </p:sp>
       <p:sp>
         <p:nvSpPr>
-          <p:cNvPr id="28" name="mini real 4 2"/>
+          <p:cNvPr id="33" name="mini real 4 2"/>
           <p:cNvSpPr/>
           <p:nvPr/>
         </p:nvSpPr>
@@ -15037,7 +15162,32 @@
       </p:sp>
       <p:sp>
         <p:nvSpPr>
-          <p:cNvPr id="29" name="mini slab real 5"/>
+          <p:cNvPr id="34" name="mini card real 5"/>
+          <p:cNvSpPr/>
+          <p:nvPr/>
+        </p:nvSpPr>
+        <p:spPr>
+          <a:xfrm>
+            <a:off x="2453792" y="2427732"/>
+            <a:ext cx="548640" cy="329184"/>
+          </a:xfrm>
+          <a:prstGeom prst="rect">
+            <a:avLst/>
+          </a:prstGeom>
+          <a:solidFill>
+            <a:srgbClr val="FFFFFF"/>
+          </a:solidFill>
+          <a:ln w="6350">
+            <a:solidFill>
+              <a:srgbClr val="898781"/>
+            </a:solidFill>
+            <a:prstDash val="solid"/>
+          </a:ln>
+        </p:spPr>
+      </p:sp>
+      <p:sp>
+        <p:nvSpPr>
+          <p:cNvPr id="35" name="mini slab real 5"/>
           <p:cNvSpPr/>
           <p:nvPr/>
         </p:nvSpPr>
@@ -15057,7 +15207,7 @@
       </p:sp>
       <p:sp>
         <p:nvSpPr>
-          <p:cNvPr id="30" name="mini real 5 0"/>
+          <p:cNvPr id="36" name="mini real 5 0"/>
           <p:cNvSpPr/>
           <p:nvPr/>
         </p:nvSpPr>
@@ -15082,7 +15232,7 @@
       </p:sp>
       <p:sp>
         <p:nvSpPr>
-          <p:cNvPr id="31" name="mini real 5 1"/>
+          <p:cNvPr id="37" name="mini real 5 1"/>
           <p:cNvSpPr/>
           <p:nvPr/>
         </p:nvSpPr>
@@ -15107,7 +15257,7 @@
       </p:sp>
       <p:sp>
         <p:nvSpPr>
-          <p:cNvPr id="32" name="mini real 5 2"/>
+          <p:cNvPr id="38" name="mini real 5 2"/>
           <p:cNvSpPr/>
           <p:nvPr/>
         </p:nvSpPr>
@@ -15132,7 +15282,7 @@
       </p:sp>
       <p:sp>
         <p:nvSpPr>
-          <p:cNvPr id="33" name="real cluster ring"/>
+          <p:cNvPr id="39" name="real cluster ring"/>
           <p:cNvSpPr/>
           <p:nvPr/>
         </p:nvSpPr>
@@ -15154,7 +15304,7 @@
       </p:sp>
       <p:sp>
         <p:nvSpPr>
-          <p:cNvPr id="34" name="real note"/>
+          <p:cNvPr id="40" name="real note"/>
           <p:cNvSpPr txBox="1"/>
           <p:nvPr/>
         </p:nvSpPr>
@@ -15190,7 +15340,7 @@
       </p:sp>
       <p:sp>
         <p:nvSpPr>
-          <p:cNvPr id="35" name="space synthetic"/>
+          <p:cNvPr id="41" name="space synthetic"/>
           <p:cNvSpPr/>
           <p:nvPr/>
         </p:nvSpPr>
@@ -15212,7 +15362,7 @@
       </p:sp>
       <p:sp>
         <p:nvSpPr>
-          <p:cNvPr id="36" name="space head synthetic"/>
+          <p:cNvPr id="42" name="space head synthetic"/>
           <p:cNvSpPr txBox="1"/>
           <p:nvPr/>
         </p:nvSpPr>
@@ -15259,7 +15409,7 @@
       </p:sp>
       <p:sp>
         <p:nvSpPr>
-          <p:cNvPr id="37" name="x axis synthetic"/>
+          <p:cNvPr id="43" name="x axis synthetic"/>
           <p:cNvSpPr/>
           <p:nvPr/>
         </p:nvSpPr>
@@ -15283,7 +15433,7 @@
       </p:sp>
       <p:sp>
         <p:nvSpPr>
-          <p:cNvPr id="38" name="y axis synthetic"/>
+          <p:cNvPr id="44" name="y axis synthetic"/>
           <p:cNvSpPr/>
           <p:nvPr/>
         </p:nvSpPr>
@@ -15307,7 +15457,7 @@
       </p:sp>
       <p:sp>
         <p:nvSpPr>
-          <p:cNvPr id="39" name="x label synthetic"/>
+          <p:cNvPr id="45" name="x label synthetic"/>
           <p:cNvSpPr txBox="1"/>
           <p:nvPr/>
         </p:nvSpPr>
@@ -15343,7 +15493,7 @@
       </p:sp>
       <p:sp>
         <p:nvSpPr>
-          <p:cNvPr id="40" name="y label synthetic"/>
+          <p:cNvPr id="46" name="y label synthetic"/>
           <p:cNvSpPr txBox="1"/>
           <p:nvPr/>
         </p:nvSpPr>
@@ -15379,14 +15529,39 @@
       </p:sp>
       <p:sp>
         <p:nvSpPr>
-          <p:cNvPr id="41" name="mini slab syn 10"/>
-          <p:cNvSpPr/>
-          <p:nvPr/>
-        </p:nvSpPr>
-        <p:spPr>
-          <a:xfrm>
-            <a:off x="1060704" y="4133088"/>
-            <a:ext cx="456057" cy="32004"/>
+          <p:cNvPr id="47" name="mini card syn 10"/>
+          <p:cNvSpPr/>
+          <p:nvPr/>
+        </p:nvSpPr>
+        <p:spPr>
+          <a:xfrm>
+            <a:off x="1042416" y="4114800"/>
+            <a:ext cx="492633" cy="356616"/>
+          </a:xfrm>
+          <a:prstGeom prst="rect">
+            <a:avLst/>
+          </a:prstGeom>
+          <a:solidFill>
+            <a:srgbClr val="FFFFFF"/>
+          </a:solidFill>
+          <a:ln w="6350">
+            <a:solidFill>
+              <a:srgbClr val="898781"/>
+            </a:solidFill>
+            <a:prstDash val="solid"/>
+          </a:ln>
+        </p:spPr>
+      </p:sp>
+      <p:sp>
+        <p:nvSpPr>
+          <p:cNvPr id="48" name="mini slab syn 10"/>
+          <p:cNvSpPr/>
+          <p:nvPr/>
+        </p:nvSpPr>
+        <p:spPr>
+          <a:xfrm>
+            <a:off x="1088136" y="4160520"/>
+            <a:ext cx="401193" cy="32004"/>
           </a:xfrm>
           <a:prstGeom prst="rect">
             <a:avLst/>
@@ -15399,13 +15574,13 @@
       </p:sp>
       <p:sp>
         <p:nvSpPr>
-          <p:cNvPr id="42" name="mini syn 10 0"/>
-          <p:cNvSpPr/>
-          <p:nvPr/>
-        </p:nvSpPr>
-        <p:spPr>
-          <a:xfrm>
-            <a:off x="1247585" y="4206240"/>
+          <p:cNvPr id="49" name="mini syn 10 0"/>
+          <p:cNvSpPr/>
+          <p:nvPr/>
+        </p:nvSpPr>
+        <p:spPr>
+          <a:xfrm>
+            <a:off x="1247585" y="4233672"/>
             <a:ext cx="82296" cy="82296"/>
           </a:xfrm>
           <a:prstGeom prst="ellipse">
@@ -15424,14 +15599,39 @@
       </p:sp>
       <p:sp>
         <p:nvSpPr>
-          <p:cNvPr id="43" name="mini slab syn 11"/>
-          <p:cNvSpPr/>
-          <p:nvPr/>
-        </p:nvSpPr>
-        <p:spPr>
-          <a:xfrm>
-            <a:off x="1060704" y="4544568"/>
-            <a:ext cx="456057" cy="32004"/>
+          <p:cNvPr id="50" name="mini card syn 11"/>
+          <p:cNvSpPr/>
+          <p:nvPr/>
+        </p:nvSpPr>
+        <p:spPr>
+          <a:xfrm>
+            <a:off x="1042416" y="4526280"/>
+            <a:ext cx="492633" cy="356616"/>
+          </a:xfrm>
+          <a:prstGeom prst="rect">
+            <a:avLst/>
+          </a:prstGeom>
+          <a:solidFill>
+            <a:srgbClr val="FFFFFF"/>
+          </a:solidFill>
+          <a:ln w="6350">
+            <a:solidFill>
+              <a:srgbClr val="898781"/>
+            </a:solidFill>
+            <a:prstDash val="solid"/>
+          </a:ln>
+        </p:spPr>
+      </p:sp>
+      <p:sp>
+        <p:nvSpPr>
+          <p:cNvPr id="51" name="mini slab syn 11"/>
+          <p:cNvSpPr/>
+          <p:nvPr/>
+        </p:nvSpPr>
+        <p:spPr>
+          <a:xfrm>
+            <a:off x="1088136" y="4572000"/>
+            <a:ext cx="401193" cy="32004"/>
           </a:xfrm>
           <a:prstGeom prst="rect">
             <a:avLst/>
@@ -15444,13 +15644,13 @@
       </p:sp>
       <p:sp>
         <p:nvSpPr>
-          <p:cNvPr id="44" name="mini syn 11 0"/>
-          <p:cNvSpPr/>
-          <p:nvPr/>
-        </p:nvSpPr>
-        <p:spPr>
-          <a:xfrm>
-            <a:off x="1220153" y="4608576"/>
+          <p:cNvPr id="52" name="mini syn 11 0"/>
+          <p:cNvSpPr/>
+          <p:nvPr/>
+        </p:nvSpPr>
+        <p:spPr>
+          <a:xfrm>
+            <a:off x="1220153" y="4636008"/>
             <a:ext cx="137160" cy="100584"/>
           </a:xfrm>
           <a:prstGeom prst="rect">
@@ -15469,14 +15669,39 @@
       </p:sp>
       <p:sp>
         <p:nvSpPr>
-          <p:cNvPr id="45" name="mini wall syn 12"/>
-          <p:cNvSpPr/>
-          <p:nvPr/>
-        </p:nvSpPr>
-        <p:spPr>
-          <a:xfrm>
-            <a:off x="1060704" y="4956048"/>
-            <a:ext cx="32004" cy="320040"/>
+          <p:cNvPr id="53" name="mini card syn 12"/>
+          <p:cNvSpPr/>
+          <p:nvPr/>
+        </p:nvSpPr>
+        <p:spPr>
+          <a:xfrm>
+            <a:off x="1042416" y="4937760"/>
+            <a:ext cx="492633" cy="356616"/>
+          </a:xfrm>
+          <a:prstGeom prst="rect">
+            <a:avLst/>
+          </a:prstGeom>
+          <a:solidFill>
+            <a:srgbClr val="FFFFFF"/>
+          </a:solidFill>
+          <a:ln w="6350">
+            <a:solidFill>
+              <a:srgbClr val="898781"/>
+            </a:solidFill>
+            <a:prstDash val="solid"/>
+          </a:ln>
+        </p:spPr>
+      </p:sp>
+      <p:sp>
+        <p:nvSpPr>
+          <p:cNvPr id="54" name="mini wall syn 12"/>
+          <p:cNvSpPr/>
+          <p:nvPr/>
+        </p:nvSpPr>
+        <p:spPr>
+          <a:xfrm>
+            <a:off x="1088136" y="4983480"/>
+            <a:ext cx="32004" cy="265176"/>
           </a:xfrm>
           <a:prstGeom prst="rect">
             <a:avLst/>
@@ -15489,13 +15714,13 @@
       </p:sp>
       <p:sp>
         <p:nvSpPr>
-          <p:cNvPr id="46" name="mini syn 12 0"/>
-          <p:cNvSpPr/>
-          <p:nvPr/>
-        </p:nvSpPr>
-        <p:spPr>
-          <a:xfrm>
-            <a:off x="1143000" y="5074920"/>
+          <p:cNvPr id="55" name="mini syn 12 0"/>
+          <p:cNvSpPr/>
+          <p:nvPr/>
+        </p:nvSpPr>
+        <p:spPr>
+          <a:xfrm>
+            <a:off x="1170432" y="5074920"/>
             <a:ext cx="82296" cy="82296"/>
           </a:xfrm>
           <a:prstGeom prst="ellipse">
@@ -15514,14 +15739,39 @@
       </p:sp>
       <p:sp>
         <p:nvSpPr>
-          <p:cNvPr id="47" name="mini slab syn 20"/>
-          <p:cNvSpPr/>
-          <p:nvPr/>
-        </p:nvSpPr>
-        <p:spPr>
-          <a:xfrm>
-            <a:off x="1626489" y="4133088"/>
-            <a:ext cx="456057" cy="32004"/>
+          <p:cNvPr id="56" name="mini card syn 20"/>
+          <p:cNvSpPr/>
+          <p:nvPr/>
+        </p:nvSpPr>
+        <p:spPr>
+          <a:xfrm>
+            <a:off x="1608201" y="4114800"/>
+            <a:ext cx="492633" cy="356616"/>
+          </a:xfrm>
+          <a:prstGeom prst="rect">
+            <a:avLst/>
+          </a:prstGeom>
+          <a:solidFill>
+            <a:srgbClr val="FFFFFF"/>
+          </a:solidFill>
+          <a:ln w="6350">
+            <a:solidFill>
+              <a:srgbClr val="898781"/>
+            </a:solidFill>
+            <a:prstDash val="solid"/>
+          </a:ln>
+        </p:spPr>
+      </p:sp>
+      <p:sp>
+        <p:nvSpPr>
+          <p:cNvPr id="57" name="mini slab syn 20"/>
+          <p:cNvSpPr/>
+          <p:nvPr/>
+        </p:nvSpPr>
+        <p:spPr>
+          <a:xfrm>
+            <a:off x="1653921" y="4160520"/>
+            <a:ext cx="401193" cy="32004"/>
           </a:xfrm>
           <a:prstGeom prst="rect">
             <a:avLst/>
@@ -15534,14 +15784,14 @@
       </p:sp>
       <p:sp>
         <p:nvSpPr>
-          <p:cNvPr id="48" name="mini syn 20 0"/>
-          <p:cNvSpPr/>
-          <p:nvPr/>
-        </p:nvSpPr>
-        <p:spPr>
-          <a:xfrm>
-            <a:off x="1738268" y="4206240"/>
-            <a:ext cx="80481" cy="80481"/>
+          <p:cNvPr id="58" name="mini syn 20 0"/>
+          <p:cNvSpPr/>
+          <p:nvPr/>
+        </p:nvSpPr>
+        <p:spPr>
+          <a:xfrm>
+            <a:off x="1752253" y="4233672"/>
+            <a:ext cx="70799" cy="70799"/>
           </a:xfrm>
           <a:prstGeom prst="ellipse">
             <a:avLst/>
@@ -15559,14 +15809,14 @@
       </p:sp>
       <p:sp>
         <p:nvSpPr>
-          <p:cNvPr id="49" name="mini syn 20 1"/>
-          <p:cNvSpPr/>
-          <p:nvPr/>
-        </p:nvSpPr>
-        <p:spPr>
-          <a:xfrm>
-            <a:off x="1890287" y="4206240"/>
-            <a:ext cx="80481" cy="80481"/>
+          <p:cNvPr id="59" name="mini syn 20 1"/>
+          <p:cNvSpPr/>
+          <p:nvPr/>
+        </p:nvSpPr>
+        <p:spPr>
+          <a:xfrm>
+            <a:off x="1885984" y="4233672"/>
+            <a:ext cx="70799" cy="70799"/>
           </a:xfrm>
           <a:prstGeom prst="ellipse">
             <a:avLst/>
@@ -15584,14 +15834,39 @@
       </p:sp>
       <p:sp>
         <p:nvSpPr>
-          <p:cNvPr id="50" name="mini slab syn 21"/>
-          <p:cNvSpPr/>
-          <p:nvPr/>
-        </p:nvSpPr>
-        <p:spPr>
-          <a:xfrm>
-            <a:off x="1626489" y="4544568"/>
-            <a:ext cx="456057" cy="32004"/>
+          <p:cNvPr id="60" name="mini card syn 21"/>
+          <p:cNvSpPr/>
+          <p:nvPr/>
+        </p:nvSpPr>
+        <p:spPr>
+          <a:xfrm>
+            <a:off x="1608201" y="4526280"/>
+            <a:ext cx="492633" cy="356616"/>
+          </a:xfrm>
+          <a:prstGeom prst="rect">
+            <a:avLst/>
+          </a:prstGeom>
+          <a:solidFill>
+            <a:srgbClr val="FFFFFF"/>
+          </a:solidFill>
+          <a:ln w="6350">
+            <a:solidFill>
+              <a:srgbClr val="898781"/>
+            </a:solidFill>
+            <a:prstDash val="solid"/>
+          </a:ln>
+        </p:spPr>
+      </p:sp>
+      <p:sp>
+        <p:nvSpPr>
+          <p:cNvPr id="61" name="mini slab syn 21"/>
+          <p:cNvSpPr/>
+          <p:nvPr/>
+        </p:nvSpPr>
+        <p:spPr>
+          <a:xfrm>
+            <a:off x="1653921" y="4572000"/>
+            <a:ext cx="401193" cy="32004"/>
           </a:xfrm>
           <a:prstGeom prst="rect">
             <a:avLst/>
@@ -15604,14 +15879,14 @@
       </p:sp>
       <p:sp>
         <p:nvSpPr>
-          <p:cNvPr id="51" name="mini syn 21 0"/>
-          <p:cNvSpPr/>
-          <p:nvPr/>
-        </p:nvSpPr>
-        <p:spPr>
-          <a:xfrm>
-            <a:off x="1711441" y="4608576"/>
-            <a:ext cx="134134" cy="98365"/>
+          <p:cNvPr id="62" name="mini syn 21 0"/>
+          <p:cNvSpPr/>
+          <p:nvPr/>
+        </p:nvSpPr>
+        <p:spPr>
+          <a:xfrm>
+            <a:off x="1728653" y="4636008"/>
+            <a:ext cx="117998" cy="86532"/>
           </a:xfrm>
           <a:prstGeom prst="rect">
             <a:avLst/>
@@ -15629,14 +15904,14 @@
       </p:sp>
       <p:sp>
         <p:nvSpPr>
-          <p:cNvPr id="52" name="mini syn 21 1"/>
-          <p:cNvSpPr/>
-          <p:nvPr/>
-        </p:nvSpPr>
-        <p:spPr>
-          <a:xfrm>
-            <a:off x="1890287" y="4617720"/>
-            <a:ext cx="80481" cy="80481"/>
+          <p:cNvPr id="63" name="mini syn 21 1"/>
+          <p:cNvSpPr/>
+          <p:nvPr/>
+        </p:nvSpPr>
+        <p:spPr>
+          <a:xfrm>
+            <a:off x="1885984" y="4645152"/>
+            <a:ext cx="70799" cy="70799"/>
           </a:xfrm>
           <a:prstGeom prst="ellipse">
             <a:avLst/>
@@ -15654,14 +15929,39 @@
       </p:sp>
       <p:sp>
         <p:nvSpPr>
-          <p:cNvPr id="53" name="mini wall syn 22"/>
-          <p:cNvSpPr/>
-          <p:nvPr/>
-        </p:nvSpPr>
-        <p:spPr>
-          <a:xfrm>
-            <a:off x="1626489" y="4956048"/>
-            <a:ext cx="32004" cy="320040"/>
+          <p:cNvPr id="64" name="mini card syn 22"/>
+          <p:cNvSpPr/>
+          <p:nvPr/>
+        </p:nvSpPr>
+        <p:spPr>
+          <a:xfrm>
+            <a:off x="1608201" y="4937760"/>
+            <a:ext cx="492633" cy="356616"/>
+          </a:xfrm>
+          <a:prstGeom prst="rect">
+            <a:avLst/>
+          </a:prstGeom>
+          <a:solidFill>
+            <a:srgbClr val="FFFFFF"/>
+          </a:solidFill>
+          <a:ln w="6350">
+            <a:solidFill>
+              <a:srgbClr val="898781"/>
+            </a:solidFill>
+            <a:prstDash val="solid"/>
+          </a:ln>
+        </p:spPr>
+      </p:sp>
+      <p:sp>
+        <p:nvSpPr>
+          <p:cNvPr id="65" name="mini wall syn 22"/>
+          <p:cNvSpPr/>
+          <p:nvPr/>
+        </p:nvSpPr>
+        <p:spPr>
+          <a:xfrm>
+            <a:off x="1653921" y="4983480"/>
+            <a:ext cx="32004" cy="265176"/>
           </a:xfrm>
           <a:prstGeom prst="rect">
             <a:avLst/>
@@ -15674,14 +15974,14 @@
       </p:sp>
       <p:sp>
         <p:nvSpPr>
-          <p:cNvPr id="54" name="mini syn 22 0"/>
-          <p:cNvSpPr/>
-          <p:nvPr/>
-        </p:nvSpPr>
-        <p:spPr>
-          <a:xfrm>
-            <a:off x="1708785" y="5025800"/>
-            <a:ext cx="73855" cy="73855"/>
+          <p:cNvPr id="66" name="mini syn 22 0"/>
+          <p:cNvSpPr/>
+          <p:nvPr/>
+        </p:nvSpPr>
+        <p:spPr>
+          <a:xfrm>
+            <a:off x="1736217" y="5041275"/>
+            <a:ext cx="61194" cy="61194"/>
           </a:xfrm>
           <a:prstGeom prst="ellipse">
             <a:avLst/>
@@ -15699,14 +15999,14 @@
       </p:sp>
       <p:sp>
         <p:nvSpPr>
-          <p:cNvPr id="55" name="mini syn 22 1"/>
-          <p:cNvSpPr/>
-          <p:nvPr/>
-        </p:nvSpPr>
-        <p:spPr>
-          <a:xfrm>
-            <a:off x="1699641" y="5148893"/>
-            <a:ext cx="98474" cy="41031"/>
+          <p:cNvPr id="67" name="mini syn 22 1"/>
+          <p:cNvSpPr/>
+          <p:nvPr/>
+        </p:nvSpPr>
+        <p:spPr>
+          <a:xfrm>
+            <a:off x="1727073" y="5143266"/>
+            <a:ext cx="81593" cy="33997"/>
           </a:xfrm>
           <a:prstGeom prst="rect">
             <a:avLst/>
@@ -15724,14 +16024,39 @@
       </p:sp>
       <p:sp>
         <p:nvSpPr>
-          <p:cNvPr id="56" name="mini slab syn 30"/>
-          <p:cNvSpPr/>
-          <p:nvPr/>
-        </p:nvSpPr>
-        <p:spPr>
-          <a:xfrm>
-            <a:off x="2192274" y="4133088"/>
-            <a:ext cx="456057" cy="32004"/>
+          <p:cNvPr id="68" name="mini card syn 30"/>
+          <p:cNvSpPr/>
+          <p:nvPr/>
+        </p:nvSpPr>
+        <p:spPr>
+          <a:xfrm>
+            <a:off x="2173986" y="4114800"/>
+            <a:ext cx="492633" cy="356616"/>
+          </a:xfrm>
+          <a:prstGeom prst="rect">
+            <a:avLst/>
+          </a:prstGeom>
+          <a:solidFill>
+            <a:srgbClr val="FFFFFF"/>
+          </a:solidFill>
+          <a:ln w="6350">
+            <a:solidFill>
+              <a:srgbClr val="898781"/>
+            </a:solidFill>
+            <a:prstDash val="solid"/>
+          </a:ln>
+        </p:spPr>
+      </p:sp>
+      <p:sp>
+        <p:nvSpPr>
+          <p:cNvPr id="69" name="mini slab syn 30"/>
+          <p:cNvSpPr/>
+          <p:nvPr/>
+        </p:nvSpPr>
+        <p:spPr>
+          <a:xfrm>
+            <a:off x="2219706" y="4160520"/>
+            <a:ext cx="401193" cy="32004"/>
           </a:xfrm>
           <a:prstGeom prst="rect">
             <a:avLst/>
@@ -15744,14 +16069,14 @@
       </p:sp>
       <p:sp>
         <p:nvSpPr>
-          <p:cNvPr id="57" name="mini syn 30 0"/>
-          <p:cNvSpPr/>
-          <p:nvPr/>
-        </p:nvSpPr>
-        <p:spPr>
-          <a:xfrm>
-            <a:off x="2276108" y="4206240"/>
-            <a:ext cx="60360" cy="60360"/>
+          <p:cNvPr id="70" name="mini syn 30 0"/>
+          <p:cNvSpPr/>
+          <p:nvPr/>
+        </p:nvSpPr>
+        <p:spPr>
+          <a:xfrm>
+            <a:off x="2293455" y="4233672"/>
+            <a:ext cx="53099" cy="53099"/>
           </a:xfrm>
           <a:prstGeom prst="ellipse">
             <a:avLst/>
@@ -15769,14 +16094,14 @@
       </p:sp>
       <p:sp>
         <p:nvSpPr>
-          <p:cNvPr id="58" name="mini syn 30 1"/>
-          <p:cNvSpPr/>
-          <p:nvPr/>
-        </p:nvSpPr>
-        <p:spPr>
-          <a:xfrm>
-            <a:off x="2390122" y="4206240"/>
-            <a:ext cx="60360" cy="60360"/>
+          <p:cNvPr id="71" name="mini syn 30 1"/>
+          <p:cNvSpPr/>
+          <p:nvPr/>
+        </p:nvSpPr>
+        <p:spPr>
+          <a:xfrm>
+            <a:off x="2393753" y="4233672"/>
+            <a:ext cx="53099" cy="53099"/>
           </a:xfrm>
           <a:prstGeom prst="ellipse">
             <a:avLst/>
@@ -15794,14 +16119,14 @@
       </p:sp>
       <p:sp>
         <p:nvSpPr>
-          <p:cNvPr id="59" name="mini syn 30 2"/>
-          <p:cNvSpPr/>
-          <p:nvPr/>
-        </p:nvSpPr>
-        <p:spPr>
-          <a:xfrm>
-            <a:off x="2504137" y="4206240"/>
-            <a:ext cx="60360" cy="60360"/>
+          <p:cNvPr id="72" name="mini syn 30 2"/>
+          <p:cNvSpPr/>
+          <p:nvPr/>
+        </p:nvSpPr>
+        <p:spPr>
+          <a:xfrm>
+            <a:off x="2494051" y="4233672"/>
+            <a:ext cx="53099" cy="53099"/>
           </a:xfrm>
           <a:prstGeom prst="ellipse">
             <a:avLst/>
@@ -15819,14 +16144,39 @@
       </p:sp>
       <p:sp>
         <p:nvSpPr>
-          <p:cNvPr id="60" name="mini slab syn 31"/>
-          <p:cNvSpPr/>
-          <p:nvPr/>
-        </p:nvSpPr>
-        <p:spPr>
-          <a:xfrm>
-            <a:off x="2192274" y="4544568"/>
-            <a:ext cx="456057" cy="32004"/>
+          <p:cNvPr id="73" name="mini card syn 31"/>
+          <p:cNvSpPr/>
+          <p:nvPr/>
+        </p:nvSpPr>
+        <p:spPr>
+          <a:xfrm>
+            <a:off x="2173986" y="4526280"/>
+            <a:ext cx="492633" cy="356616"/>
+          </a:xfrm>
+          <a:prstGeom prst="rect">
+            <a:avLst/>
+          </a:prstGeom>
+          <a:solidFill>
+            <a:srgbClr val="FFFFFF"/>
+          </a:solidFill>
+          <a:ln w="6350">
+            <a:solidFill>
+              <a:srgbClr val="898781"/>
+            </a:solidFill>
+            <a:prstDash val="solid"/>
+          </a:ln>
+        </p:spPr>
+      </p:sp>
+      <p:sp>
+        <p:nvSpPr>
+          <p:cNvPr id="74" name="mini slab syn 31"/>
+          <p:cNvSpPr/>
+          <p:nvPr/>
+        </p:nvSpPr>
+        <p:spPr>
+          <a:xfrm>
+            <a:off x="2219706" y="4572000"/>
+            <a:ext cx="401193" cy="32004"/>
           </a:xfrm>
           <a:prstGeom prst="rect">
             <a:avLst/>
@@ -15839,14 +16189,14 @@
       </p:sp>
       <p:sp>
         <p:nvSpPr>
-          <p:cNvPr id="61" name="mini syn 31 0"/>
-          <p:cNvSpPr/>
-          <p:nvPr/>
-        </p:nvSpPr>
-        <p:spPr>
-          <a:xfrm>
-            <a:off x="2255988" y="4608576"/>
-            <a:ext cx="100601" cy="73774"/>
+          <p:cNvPr id="75" name="mini syn 31 0"/>
+          <p:cNvSpPr/>
+          <p:nvPr/>
+        </p:nvSpPr>
+        <p:spPr>
+          <a:xfrm>
+            <a:off x="2275755" y="4636008"/>
+            <a:ext cx="88498" cy="64899"/>
           </a:xfrm>
           <a:prstGeom prst="rect">
             <a:avLst/>
@@ -15864,14 +16214,14 @@
       </p:sp>
       <p:sp>
         <p:nvSpPr>
-          <p:cNvPr id="62" name="mini syn 31 1"/>
-          <p:cNvSpPr/>
-          <p:nvPr/>
-        </p:nvSpPr>
-        <p:spPr>
-          <a:xfrm>
-            <a:off x="2390122" y="4617720"/>
-            <a:ext cx="60360" cy="60360"/>
+          <p:cNvPr id="76" name="mini syn 31 1"/>
+          <p:cNvSpPr/>
+          <p:nvPr/>
+        </p:nvSpPr>
+        <p:spPr>
+          <a:xfrm>
+            <a:off x="2393753" y="4645152"/>
+            <a:ext cx="53099" cy="53099"/>
           </a:xfrm>
           <a:prstGeom prst="ellipse">
             <a:avLst/>
@@ -15889,14 +16239,14 @@
       </p:sp>
       <p:sp>
         <p:nvSpPr>
-          <p:cNvPr id="63" name="mini syn 31 2"/>
-          <p:cNvSpPr/>
-          <p:nvPr/>
-        </p:nvSpPr>
-        <p:spPr>
-          <a:xfrm>
-            <a:off x="2494076" y="4636008"/>
-            <a:ext cx="80481" cy="33534"/>
+          <p:cNvPr id="77" name="mini syn 31 2"/>
+          <p:cNvSpPr/>
+          <p:nvPr/>
+        </p:nvSpPr>
+        <p:spPr>
+          <a:xfrm>
+            <a:off x="2485201" y="4663440"/>
+            <a:ext cx="70799" cy="29499"/>
           </a:xfrm>
           <a:prstGeom prst="rect">
             <a:avLst/>
@@ -15914,14 +16264,39 @@
       </p:sp>
       <p:sp>
         <p:nvSpPr>
-          <p:cNvPr id="64" name="mini wall syn 32"/>
-          <p:cNvSpPr/>
-          <p:nvPr/>
-        </p:nvSpPr>
-        <p:spPr>
-          <a:xfrm>
-            <a:off x="2192274" y="4956048"/>
-            <a:ext cx="32004" cy="320040"/>
+          <p:cNvPr id="78" name="mini card syn 32"/>
+          <p:cNvSpPr/>
+          <p:nvPr/>
+        </p:nvSpPr>
+        <p:spPr>
+          <a:xfrm>
+            <a:off x="2173986" y="4937760"/>
+            <a:ext cx="492633" cy="356616"/>
+          </a:xfrm>
+          <a:prstGeom prst="rect">
+            <a:avLst/>
+          </a:prstGeom>
+          <a:solidFill>
+            <a:srgbClr val="FFFFFF"/>
+          </a:solidFill>
+          <a:ln w="6350">
+            <a:solidFill>
+              <a:srgbClr val="898781"/>
+            </a:solidFill>
+            <a:prstDash val="solid"/>
+          </a:ln>
+        </p:spPr>
+      </p:sp>
+      <p:sp>
+        <p:nvSpPr>
+          <p:cNvPr id="79" name="mini wall syn 32"/>
+          <p:cNvSpPr/>
+          <p:nvPr/>
+        </p:nvSpPr>
+        <p:spPr>
+          <a:xfrm>
+            <a:off x="2219706" y="4983480"/>
+            <a:ext cx="32004" cy="265176"/>
           </a:xfrm>
           <a:prstGeom prst="rect">
             <a:avLst/>
@@ -15934,14 +16309,14 @@
       </p:sp>
       <p:sp>
         <p:nvSpPr>
-          <p:cNvPr id="65" name="mini syn 32 0"/>
-          <p:cNvSpPr/>
-          <p:nvPr/>
-        </p:nvSpPr>
-        <p:spPr>
-          <a:xfrm>
-            <a:off x="2274570" y="5008362"/>
-            <a:ext cx="55392" cy="55392"/>
+          <p:cNvPr id="80" name="mini syn 32 0"/>
+          <p:cNvSpPr/>
+          <p:nvPr/>
+        </p:nvSpPr>
+        <p:spPr>
+          <a:xfrm>
+            <a:off x="2302002" y="5026826"/>
+            <a:ext cx="45896" cy="45896"/>
           </a:xfrm>
           <a:prstGeom prst="ellipse">
             <a:avLst/>
@@ -15959,14 +16334,14 @@
       </p:sp>
       <p:sp>
         <p:nvSpPr>
-          <p:cNvPr id="66" name="mini syn 32 1"/>
-          <p:cNvSpPr/>
-          <p:nvPr/>
-        </p:nvSpPr>
-        <p:spPr>
-          <a:xfrm>
-            <a:off x="2265426" y="5100681"/>
-            <a:ext cx="73855" cy="30773"/>
+          <p:cNvPr id="81" name="mini syn 32 1"/>
+          <p:cNvSpPr/>
+          <p:nvPr/>
+        </p:nvSpPr>
+        <p:spPr>
+          <a:xfrm>
+            <a:off x="2292858" y="5103319"/>
+            <a:ext cx="61194" cy="25498"/>
           </a:xfrm>
           <a:prstGeom prst="rect">
             <a:avLst/>
@@ -15984,14 +16359,14 @@
       </p:sp>
       <p:sp>
         <p:nvSpPr>
-          <p:cNvPr id="67" name="mini syn 32 2"/>
-          <p:cNvSpPr/>
-          <p:nvPr/>
-        </p:nvSpPr>
-        <p:spPr>
-          <a:xfrm>
-            <a:off x="2274570" y="5168382"/>
-            <a:ext cx="55392" cy="55392"/>
+          <p:cNvPr id="82" name="mini syn 32 2"/>
+          <p:cNvSpPr/>
+          <p:nvPr/>
+        </p:nvSpPr>
+        <p:spPr>
+          <a:xfrm>
+            <a:off x="2302002" y="5159414"/>
+            <a:ext cx="45896" cy="45896"/>
           </a:xfrm>
           <a:prstGeom prst="ellipse">
             <a:avLst/>
@@ -16009,14 +16384,39 @@
       </p:sp>
       <p:sp>
         <p:nvSpPr>
-          <p:cNvPr id="68" name="mini slab syn 40"/>
-          <p:cNvSpPr/>
-          <p:nvPr/>
-        </p:nvSpPr>
-        <p:spPr>
-          <a:xfrm>
-            <a:off x="2758059" y="4133088"/>
-            <a:ext cx="456057" cy="32004"/>
+          <p:cNvPr id="83" name="mini card syn 40"/>
+          <p:cNvSpPr/>
+          <p:nvPr/>
+        </p:nvSpPr>
+        <p:spPr>
+          <a:xfrm>
+            <a:off x="2739771" y="4114800"/>
+            <a:ext cx="492633" cy="356616"/>
+          </a:xfrm>
+          <a:prstGeom prst="rect">
+            <a:avLst/>
+          </a:prstGeom>
+          <a:solidFill>
+            <a:srgbClr val="FFFFFF"/>
+          </a:solidFill>
+          <a:ln w="6350">
+            <a:solidFill>
+              <a:srgbClr val="898781"/>
+            </a:solidFill>
+            <a:prstDash val="solid"/>
+          </a:ln>
+        </p:spPr>
+      </p:sp>
+      <p:sp>
+        <p:nvSpPr>
+          <p:cNvPr id="84" name="mini slab syn 40"/>
+          <p:cNvSpPr/>
+          <p:nvPr/>
+        </p:nvSpPr>
+        <p:spPr>
+          <a:xfrm>
+            <a:off x="2785491" y="4160520"/>
+            <a:ext cx="401193" cy="32004"/>
           </a:xfrm>
           <a:prstGeom prst="rect">
             <a:avLst/>
@@ -16029,14 +16429,14 @@
       </p:sp>
       <p:sp>
         <p:nvSpPr>
-          <p:cNvPr id="69" name="mini syn 40 0"/>
-          <p:cNvSpPr/>
-          <p:nvPr/>
-        </p:nvSpPr>
-        <p:spPr>
-          <a:xfrm>
-            <a:off x="2825126" y="4206240"/>
-            <a:ext cx="48288" cy="48288"/>
+          <p:cNvPr id="85" name="mini syn 40 0"/>
+          <p:cNvSpPr/>
+          <p:nvPr/>
+        </p:nvSpPr>
+        <p:spPr>
+          <a:xfrm>
+            <a:off x="2844490" y="4233672"/>
+            <a:ext cx="42479" cy="42479"/>
           </a:xfrm>
           <a:prstGeom prst="ellipse">
             <a:avLst/>
@@ -16054,14 +16454,14 @@
       </p:sp>
       <p:sp>
         <p:nvSpPr>
-          <p:cNvPr id="70" name="mini syn 40 1"/>
-          <p:cNvSpPr/>
-          <p:nvPr/>
-        </p:nvSpPr>
-        <p:spPr>
-          <a:xfrm>
-            <a:off x="2916338" y="4206240"/>
-            <a:ext cx="48288" cy="48288"/>
+          <p:cNvPr id="86" name="mini syn 40 1"/>
+          <p:cNvSpPr/>
+          <p:nvPr/>
+        </p:nvSpPr>
+        <p:spPr>
+          <a:xfrm>
+            <a:off x="2924729" y="4233672"/>
+            <a:ext cx="42479" cy="42479"/>
           </a:xfrm>
           <a:prstGeom prst="ellipse">
             <a:avLst/>
@@ -16079,14 +16479,14 @@
       </p:sp>
       <p:sp>
         <p:nvSpPr>
-          <p:cNvPr id="71" name="mini syn 40 2"/>
-          <p:cNvSpPr/>
-          <p:nvPr/>
-        </p:nvSpPr>
-        <p:spPr>
-          <a:xfrm>
-            <a:off x="3007549" y="4206240"/>
-            <a:ext cx="48288" cy="48288"/>
+          <p:cNvPr id="87" name="mini syn 40 2"/>
+          <p:cNvSpPr/>
+          <p:nvPr/>
+        </p:nvSpPr>
+        <p:spPr>
+          <a:xfrm>
+            <a:off x="3004967" y="4233672"/>
+            <a:ext cx="42479" cy="42479"/>
           </a:xfrm>
           <a:prstGeom prst="ellipse">
             <a:avLst/>
@@ -16104,14 +16504,14 @@
       </p:sp>
       <p:sp>
         <p:nvSpPr>
-          <p:cNvPr id="72" name="mini syn 40 3"/>
-          <p:cNvSpPr/>
-          <p:nvPr/>
-        </p:nvSpPr>
-        <p:spPr>
-          <a:xfrm>
-            <a:off x="3098760" y="4206240"/>
-            <a:ext cx="48288" cy="48288"/>
+          <p:cNvPr id="88" name="mini syn 40 3"/>
+          <p:cNvSpPr/>
+          <p:nvPr/>
+        </p:nvSpPr>
+        <p:spPr>
+          <a:xfrm>
+            <a:off x="3085206" y="4233672"/>
+            <a:ext cx="42479" cy="42479"/>
           </a:xfrm>
           <a:prstGeom prst="ellipse">
             <a:avLst/>
@@ -16129,14 +16529,39 @@
       </p:sp>
       <p:sp>
         <p:nvSpPr>
-          <p:cNvPr id="73" name="mini slab syn 41"/>
-          <p:cNvSpPr/>
-          <p:nvPr/>
-        </p:nvSpPr>
-        <p:spPr>
-          <a:xfrm>
-            <a:off x="2758059" y="4544568"/>
-            <a:ext cx="456057" cy="32004"/>
+          <p:cNvPr id="89" name="mini card syn 41"/>
+          <p:cNvSpPr/>
+          <p:nvPr/>
+        </p:nvSpPr>
+        <p:spPr>
+          <a:xfrm>
+            <a:off x="2739771" y="4526280"/>
+            <a:ext cx="492633" cy="356616"/>
+          </a:xfrm>
+          <a:prstGeom prst="rect">
+            <a:avLst/>
+          </a:prstGeom>
+          <a:solidFill>
+            <a:srgbClr val="FFFFFF"/>
+          </a:solidFill>
+          <a:ln w="6350">
+            <a:solidFill>
+              <a:srgbClr val="898781"/>
+            </a:solidFill>
+            <a:prstDash val="solid"/>
+          </a:ln>
+        </p:spPr>
+      </p:sp>
+      <p:sp>
+        <p:nvSpPr>
+          <p:cNvPr id="90" name="mini slab syn 41"/>
+          <p:cNvSpPr/>
+          <p:nvPr/>
+        </p:nvSpPr>
+        <p:spPr>
+          <a:xfrm>
+            <a:off x="2785491" y="4572000"/>
+            <a:ext cx="401193" cy="32004"/>
           </a:xfrm>
           <a:prstGeom prst="rect">
             <a:avLst/>
@@ -16149,14 +16574,14 @@
       </p:sp>
       <p:sp>
         <p:nvSpPr>
-          <p:cNvPr id="74" name="mini syn 41 0"/>
-          <p:cNvSpPr/>
-          <p:nvPr/>
-        </p:nvSpPr>
-        <p:spPr>
-          <a:xfrm>
-            <a:off x="2809030" y="4608576"/>
-            <a:ext cx="80481" cy="59019"/>
+          <p:cNvPr id="91" name="mini syn 41 0"/>
+          <p:cNvSpPr/>
+          <p:nvPr/>
+        </p:nvSpPr>
+        <p:spPr>
+          <a:xfrm>
+            <a:off x="2830330" y="4636008"/>
+            <a:ext cx="70799" cy="51919"/>
           </a:xfrm>
           <a:prstGeom prst="rect">
             <a:avLst/>
@@ -16174,14 +16599,14 @@
       </p:sp>
       <p:sp>
         <p:nvSpPr>
-          <p:cNvPr id="75" name="mini syn 41 1"/>
-          <p:cNvSpPr/>
-          <p:nvPr/>
-        </p:nvSpPr>
-        <p:spPr>
-          <a:xfrm>
-            <a:off x="2916338" y="4617720"/>
-            <a:ext cx="48288" cy="48288"/>
+          <p:cNvPr id="92" name="mini syn 41 1"/>
+          <p:cNvSpPr/>
+          <p:nvPr/>
+        </p:nvSpPr>
+        <p:spPr>
+          <a:xfrm>
+            <a:off x="2924729" y="4645152"/>
+            <a:ext cx="42479" cy="42479"/>
           </a:xfrm>
           <a:prstGeom prst="ellipse">
             <a:avLst/>
@@ -16199,14 +16624,14 @@
       </p:sp>
       <p:sp>
         <p:nvSpPr>
-          <p:cNvPr id="76" name="mini syn 41 2"/>
-          <p:cNvSpPr/>
-          <p:nvPr/>
-        </p:nvSpPr>
-        <p:spPr>
-          <a:xfrm>
-            <a:off x="2999501" y="4636008"/>
-            <a:ext cx="64385" cy="26827"/>
+          <p:cNvPr id="93" name="mini syn 41 2"/>
+          <p:cNvSpPr/>
+          <p:nvPr/>
+        </p:nvSpPr>
+        <p:spPr>
+          <a:xfrm>
+            <a:off x="2997887" y="4663440"/>
+            <a:ext cx="56639" cy="23600"/>
           </a:xfrm>
           <a:prstGeom prst="rect">
             <a:avLst/>
@@ -16224,14 +16649,14 @@
       </p:sp>
       <p:sp>
         <p:nvSpPr>
-          <p:cNvPr id="77" name="mini syn 41 3"/>
-          <p:cNvSpPr/>
-          <p:nvPr/>
-        </p:nvSpPr>
-        <p:spPr>
-          <a:xfrm>
-            <a:off x="3098760" y="4617720"/>
-            <a:ext cx="48288" cy="48288"/>
+          <p:cNvPr id="94" name="mini syn 41 3"/>
+          <p:cNvSpPr/>
+          <p:nvPr/>
+        </p:nvSpPr>
+        <p:spPr>
+          <a:xfrm>
+            <a:off x="3085206" y="4645152"/>
+            <a:ext cx="42479" cy="42479"/>
           </a:xfrm>
           <a:prstGeom prst="ellipse">
             <a:avLst/>
@@ -16249,14 +16674,39 @@
       </p:sp>
       <p:sp>
         <p:nvSpPr>
-          <p:cNvPr id="78" name="mini wall syn 42"/>
-          <p:cNvSpPr/>
-          <p:nvPr/>
-        </p:nvSpPr>
-        <p:spPr>
-          <a:xfrm>
-            <a:off x="2758059" y="4956048"/>
-            <a:ext cx="32004" cy="320040"/>
+          <p:cNvPr id="95" name="mini card syn 42"/>
+          <p:cNvSpPr/>
+          <p:nvPr/>
+        </p:nvSpPr>
+        <p:spPr>
+          <a:xfrm>
+            <a:off x="2739771" y="4937760"/>
+            <a:ext cx="492633" cy="356616"/>
+          </a:xfrm>
+          <a:prstGeom prst="rect">
+            <a:avLst/>
+          </a:prstGeom>
+          <a:solidFill>
+            <a:srgbClr val="FFFFFF"/>
+          </a:solidFill>
+          <a:ln w="6350">
+            <a:solidFill>
+              <a:srgbClr val="898781"/>
+            </a:solidFill>
+            <a:prstDash val="solid"/>
+          </a:ln>
+        </p:spPr>
+      </p:sp>
+      <p:sp>
+        <p:nvSpPr>
+          <p:cNvPr id="96" name="mini wall syn 42"/>
+          <p:cNvSpPr/>
+          <p:nvPr/>
+        </p:nvSpPr>
+        <p:spPr>
+          <a:xfrm>
+            <a:off x="2785491" y="4983480"/>
+            <a:ext cx="32004" cy="265176"/>
           </a:xfrm>
           <a:prstGeom prst="rect">
             <a:avLst/>
@@ -16269,14 +16719,14 @@
       </p:sp>
       <p:sp>
         <p:nvSpPr>
-          <p:cNvPr id="79" name="mini syn 42 0"/>
-          <p:cNvSpPr/>
-          <p:nvPr/>
-        </p:nvSpPr>
-        <p:spPr>
-          <a:xfrm>
-            <a:off x="2840355" y="4997899"/>
-            <a:ext cx="44313" cy="44313"/>
+          <p:cNvPr id="97" name="mini syn 42 0"/>
+          <p:cNvSpPr/>
+          <p:nvPr/>
+        </p:nvSpPr>
+        <p:spPr>
+          <a:xfrm>
+            <a:off x="2867787" y="5018157"/>
+            <a:ext cx="36717" cy="36717"/>
           </a:xfrm>
           <a:prstGeom prst="ellipse">
             <a:avLst/>
@@ -16294,14 +16744,14 @@
       </p:sp>
       <p:sp>
         <p:nvSpPr>
-          <p:cNvPr id="80" name="mini syn 42 1"/>
-          <p:cNvSpPr/>
-          <p:nvPr/>
-        </p:nvSpPr>
-        <p:spPr>
-          <a:xfrm>
-            <a:off x="2831211" y="5071755"/>
-            <a:ext cx="59084" cy="24618"/>
+          <p:cNvPr id="98" name="mini syn 42 1"/>
+          <p:cNvSpPr/>
+          <p:nvPr/>
+        </p:nvSpPr>
+        <p:spPr>
+          <a:xfrm>
+            <a:off x="2858643" y="5079351"/>
+            <a:ext cx="48956" cy="20398"/>
           </a:xfrm>
           <a:prstGeom prst="rect">
             <a:avLst/>
@@ -16319,14 +16769,14 @@
       </p:sp>
       <p:sp>
         <p:nvSpPr>
-          <p:cNvPr id="81" name="mini syn 42 2"/>
-          <p:cNvSpPr/>
-          <p:nvPr/>
-        </p:nvSpPr>
-        <p:spPr>
-          <a:xfrm>
-            <a:off x="2840355" y="5125915"/>
-            <a:ext cx="44313" cy="44313"/>
+          <p:cNvPr id="99" name="mini syn 42 2"/>
+          <p:cNvSpPr/>
+          <p:nvPr/>
+        </p:nvSpPr>
+        <p:spPr>
+          <a:xfrm>
+            <a:off x="2867787" y="5124227"/>
+            <a:ext cx="36717" cy="36717"/>
           </a:xfrm>
           <a:prstGeom prst="ellipse">
             <a:avLst/>
@@ -16344,14 +16794,14 @@
       </p:sp>
       <p:sp>
         <p:nvSpPr>
-          <p:cNvPr id="82" name="mini syn 42 3"/>
-          <p:cNvSpPr/>
-          <p:nvPr/>
-        </p:nvSpPr>
-        <p:spPr>
-          <a:xfrm>
-            <a:off x="2840355" y="5189923"/>
-            <a:ext cx="44313" cy="44313"/>
+          <p:cNvPr id="100" name="mini syn 42 3"/>
+          <p:cNvSpPr/>
+          <p:nvPr/>
+        </p:nvSpPr>
+        <p:spPr>
+          <a:xfrm>
+            <a:off x="2867787" y="5177262"/>
+            <a:ext cx="36717" cy="36717"/>
           </a:xfrm>
           <a:prstGeom prst="ellipse">
             <a:avLst/>
@@ -16369,14 +16819,39 @@
       </p:sp>
       <p:sp>
         <p:nvSpPr>
-          <p:cNvPr id="83" name="mini slab syn 50"/>
-          <p:cNvSpPr/>
-          <p:nvPr/>
-        </p:nvSpPr>
-        <p:spPr>
-          <a:xfrm>
-            <a:off x="3323844" y="4133088"/>
-            <a:ext cx="456057" cy="32004"/>
+          <p:cNvPr id="101" name="mini card syn 50"/>
+          <p:cNvSpPr/>
+          <p:nvPr/>
+        </p:nvSpPr>
+        <p:spPr>
+          <a:xfrm>
+            <a:off x="3305556" y="4114800"/>
+            <a:ext cx="492633" cy="356616"/>
+          </a:xfrm>
+          <a:prstGeom prst="rect">
+            <a:avLst/>
+          </a:prstGeom>
+          <a:solidFill>
+            <a:srgbClr val="FFFFFF"/>
+          </a:solidFill>
+          <a:ln w="6350">
+            <a:solidFill>
+              <a:srgbClr val="898781"/>
+            </a:solidFill>
+            <a:prstDash val="solid"/>
+          </a:ln>
+        </p:spPr>
+      </p:sp>
+      <p:sp>
+        <p:nvSpPr>
+          <p:cNvPr id="102" name="mini slab syn 50"/>
+          <p:cNvSpPr/>
+          <p:nvPr/>
+        </p:nvSpPr>
+        <p:spPr>
+          <a:xfrm>
+            <a:off x="3351276" y="4160520"/>
+            <a:ext cx="401193" cy="32004"/>
           </a:xfrm>
           <a:prstGeom prst="rect">
             <a:avLst/>
@@ -16389,14 +16864,14 @@
       </p:sp>
       <p:sp>
         <p:nvSpPr>
-          <p:cNvPr id="84" name="mini syn 50 0"/>
-          <p:cNvSpPr/>
-          <p:nvPr/>
-        </p:nvSpPr>
-        <p:spPr>
-          <a:xfrm>
-            <a:off x="3379733" y="4206240"/>
-            <a:ext cx="40240" cy="40240"/>
+          <p:cNvPr id="103" name="mini syn 50 0"/>
+          <p:cNvSpPr/>
+          <p:nvPr/>
+        </p:nvSpPr>
+        <p:spPr>
+          <a:xfrm>
+            <a:off x="3400442" y="4233672"/>
+            <a:ext cx="35399" cy="35399"/>
           </a:xfrm>
           <a:prstGeom prst="ellipse">
             <a:avLst/>
@@ -16414,14 +16889,14 @@
       </p:sp>
       <p:sp>
         <p:nvSpPr>
-          <p:cNvPr id="85" name="mini syn 50 1"/>
-          <p:cNvSpPr/>
-          <p:nvPr/>
-        </p:nvSpPr>
-        <p:spPr>
-          <a:xfrm>
-            <a:off x="3455743" y="4206240"/>
-            <a:ext cx="40240" cy="40240"/>
+          <p:cNvPr id="104" name="mini syn 50 1"/>
+          <p:cNvSpPr/>
+          <p:nvPr/>
+        </p:nvSpPr>
+        <p:spPr>
+          <a:xfrm>
+            <a:off x="3467307" y="4233672"/>
+            <a:ext cx="35399" cy="35399"/>
           </a:xfrm>
           <a:prstGeom prst="ellipse">
             <a:avLst/>
@@ -16439,14 +16914,14 @@
       </p:sp>
       <p:sp>
         <p:nvSpPr>
-          <p:cNvPr id="86" name="mini syn 50 2"/>
-          <p:cNvSpPr/>
-          <p:nvPr/>
-        </p:nvSpPr>
-        <p:spPr>
-          <a:xfrm>
-            <a:off x="3531752" y="4206240"/>
-            <a:ext cx="40240" cy="40240"/>
+          <p:cNvPr id="105" name="mini syn 50 2"/>
+          <p:cNvSpPr/>
+          <p:nvPr/>
+        </p:nvSpPr>
+        <p:spPr>
+          <a:xfrm>
+            <a:off x="3534173" y="4233672"/>
+            <a:ext cx="35399" cy="35399"/>
           </a:xfrm>
           <a:prstGeom prst="ellipse">
             <a:avLst/>
@@ -16464,14 +16939,14 @@
       </p:sp>
       <p:sp>
         <p:nvSpPr>
-          <p:cNvPr id="87" name="mini syn 50 3"/>
-          <p:cNvSpPr/>
-          <p:nvPr/>
-        </p:nvSpPr>
-        <p:spPr>
-          <a:xfrm>
-            <a:off x="3607762" y="4206240"/>
-            <a:ext cx="40240" cy="40240"/>
+          <p:cNvPr id="106" name="mini syn 50 3"/>
+          <p:cNvSpPr/>
+          <p:nvPr/>
+        </p:nvSpPr>
+        <p:spPr>
+          <a:xfrm>
+            <a:off x="3601038" y="4233672"/>
+            <a:ext cx="35399" cy="35399"/>
           </a:xfrm>
           <a:prstGeom prst="ellipse">
             <a:avLst/>
@@ -16489,14 +16964,14 @@
       </p:sp>
       <p:sp>
         <p:nvSpPr>
-          <p:cNvPr id="88" name="mini syn 50 4"/>
-          <p:cNvSpPr/>
-          <p:nvPr/>
-        </p:nvSpPr>
-        <p:spPr>
-          <a:xfrm>
-            <a:off x="3683771" y="4206240"/>
-            <a:ext cx="40240" cy="40240"/>
+          <p:cNvPr id="107" name="mini syn 50 4"/>
+          <p:cNvSpPr/>
+          <p:nvPr/>
+        </p:nvSpPr>
+        <p:spPr>
+          <a:xfrm>
+            <a:off x="3667904" y="4233672"/>
+            <a:ext cx="35399" cy="35399"/>
           </a:xfrm>
           <a:prstGeom prst="ellipse">
             <a:avLst/>
@@ -16514,14 +16989,39 @@
       </p:sp>
       <p:sp>
         <p:nvSpPr>
-          <p:cNvPr id="89" name="mini slab syn 51"/>
-          <p:cNvSpPr/>
-          <p:nvPr/>
-        </p:nvSpPr>
-        <p:spPr>
-          <a:xfrm>
-            <a:off x="3323844" y="4544568"/>
-            <a:ext cx="456057" cy="32004"/>
+          <p:cNvPr id="108" name="mini card syn 51"/>
+          <p:cNvSpPr/>
+          <p:nvPr/>
+        </p:nvSpPr>
+        <p:spPr>
+          <a:xfrm>
+            <a:off x="3305556" y="4526280"/>
+            <a:ext cx="492633" cy="356616"/>
+          </a:xfrm>
+          <a:prstGeom prst="rect">
+            <a:avLst/>
+          </a:prstGeom>
+          <a:solidFill>
+            <a:srgbClr val="FFFFFF"/>
+          </a:solidFill>
+          <a:ln w="6350">
+            <a:solidFill>
+              <a:srgbClr val="898781"/>
+            </a:solidFill>
+            <a:prstDash val="solid"/>
+          </a:ln>
+        </p:spPr>
+      </p:sp>
+      <p:sp>
+        <p:nvSpPr>
+          <p:cNvPr id="109" name="mini slab syn 51"/>
+          <p:cNvSpPr/>
+          <p:nvPr/>
+        </p:nvSpPr>
+        <p:spPr>
+          <a:xfrm>
+            <a:off x="3351276" y="4572000"/>
+            <a:ext cx="401193" cy="32004"/>
           </a:xfrm>
           <a:prstGeom prst="rect">
             <a:avLst/>
@@ -16534,14 +17034,14 @@
       </p:sp>
       <p:sp>
         <p:nvSpPr>
-          <p:cNvPr id="90" name="mini syn 51 0"/>
-          <p:cNvSpPr/>
-          <p:nvPr/>
-        </p:nvSpPr>
-        <p:spPr>
-          <a:xfrm>
-            <a:off x="3366320" y="4608576"/>
-            <a:ext cx="67067" cy="49183"/>
+          <p:cNvPr id="110" name="mini syn 51 0"/>
+          <p:cNvSpPr/>
+          <p:nvPr/>
+        </p:nvSpPr>
+        <p:spPr>
+          <a:xfrm>
+            <a:off x="3388642" y="4636008"/>
+            <a:ext cx="58999" cy="43266"/>
           </a:xfrm>
           <a:prstGeom prst="rect">
             <a:avLst/>
@@ -16559,14 +17059,14 @@
       </p:sp>
       <p:sp>
         <p:nvSpPr>
-          <p:cNvPr id="91" name="mini syn 51 1"/>
-          <p:cNvSpPr/>
-          <p:nvPr/>
-        </p:nvSpPr>
-        <p:spPr>
-          <a:xfrm>
-            <a:off x="3455743" y="4617720"/>
-            <a:ext cx="40240" cy="40240"/>
+          <p:cNvPr id="111" name="mini syn 51 1"/>
+          <p:cNvSpPr/>
+          <p:nvPr/>
+        </p:nvSpPr>
+        <p:spPr>
+          <a:xfrm>
+            <a:off x="3467307" y="4645152"/>
+            <a:ext cx="35399" cy="35399"/>
           </a:xfrm>
           <a:prstGeom prst="ellipse">
             <a:avLst/>
@@ -16584,14 +17084,14 @@
       </p:sp>
       <p:sp>
         <p:nvSpPr>
-          <p:cNvPr id="92" name="mini syn 51 2"/>
-          <p:cNvSpPr/>
-          <p:nvPr/>
-        </p:nvSpPr>
-        <p:spPr>
-          <a:xfrm>
-            <a:off x="3525046" y="4636008"/>
-            <a:ext cx="53654" cy="22356"/>
+          <p:cNvPr id="112" name="mini syn 51 2"/>
+          <p:cNvSpPr/>
+          <p:nvPr/>
+        </p:nvSpPr>
+        <p:spPr>
+          <a:xfrm>
+            <a:off x="3528273" y="4663440"/>
+            <a:ext cx="47199" cy="19666"/>
           </a:xfrm>
           <a:prstGeom prst="rect">
             <a:avLst/>
@@ -16609,14 +17109,14 @@
       </p:sp>
       <p:sp>
         <p:nvSpPr>
-          <p:cNvPr id="93" name="mini syn 51 3"/>
-          <p:cNvSpPr/>
-          <p:nvPr/>
-        </p:nvSpPr>
-        <p:spPr>
-          <a:xfrm>
-            <a:off x="3607762" y="4617720"/>
-            <a:ext cx="40240" cy="40240"/>
+          <p:cNvPr id="113" name="mini syn 51 3"/>
+          <p:cNvSpPr/>
+          <p:nvPr/>
+        </p:nvSpPr>
+        <p:spPr>
+          <a:xfrm>
+            <a:off x="3601038" y="4645152"/>
+            <a:ext cx="35399" cy="35399"/>
           </a:xfrm>
           <a:prstGeom prst="ellipse">
             <a:avLst/>
@@ -16634,14 +17134,14 @@
       </p:sp>
       <p:sp>
         <p:nvSpPr>
-          <p:cNvPr id="94" name="mini syn 51 4"/>
-          <p:cNvSpPr/>
-          <p:nvPr/>
-        </p:nvSpPr>
-        <p:spPr>
-          <a:xfrm>
-            <a:off x="3670358" y="4608576"/>
-            <a:ext cx="67067" cy="49183"/>
+          <p:cNvPr id="114" name="mini syn 51 4"/>
+          <p:cNvSpPr/>
+          <p:nvPr/>
+        </p:nvSpPr>
+        <p:spPr>
+          <a:xfrm>
+            <a:off x="3656104" y="4636008"/>
+            <a:ext cx="58999" cy="43266"/>
           </a:xfrm>
           <a:prstGeom prst="rect">
             <a:avLst/>
@@ -16659,14 +17159,39 @@
       </p:sp>
       <p:sp>
         <p:nvSpPr>
-          <p:cNvPr id="95" name="mini wall syn 52"/>
-          <p:cNvSpPr/>
-          <p:nvPr/>
-        </p:nvSpPr>
-        <p:spPr>
-          <a:xfrm>
-            <a:off x="3323844" y="4956048"/>
-            <a:ext cx="32004" cy="320040"/>
+          <p:cNvPr id="115" name="mini card syn 52"/>
+          <p:cNvSpPr/>
+          <p:nvPr/>
+        </p:nvSpPr>
+        <p:spPr>
+          <a:xfrm>
+            <a:off x="3305556" y="4937760"/>
+            <a:ext cx="492633" cy="356616"/>
+          </a:xfrm>
+          <a:prstGeom prst="rect">
+            <a:avLst/>
+          </a:prstGeom>
+          <a:solidFill>
+            <a:srgbClr val="FFFFFF"/>
+          </a:solidFill>
+          <a:ln w="6350">
+            <a:solidFill>
+              <a:srgbClr val="898781"/>
+            </a:solidFill>
+            <a:prstDash val="solid"/>
+          </a:ln>
+        </p:spPr>
+      </p:sp>
+      <p:sp>
+        <p:nvSpPr>
+          <p:cNvPr id="116" name="mini wall syn 52"/>
+          <p:cNvSpPr/>
+          <p:nvPr/>
+        </p:nvSpPr>
+        <p:spPr>
+          <a:xfrm>
+            <a:off x="3351276" y="4983480"/>
+            <a:ext cx="32004" cy="265176"/>
           </a:xfrm>
           <a:prstGeom prst="rect">
             <a:avLst/>
@@ -16679,14 +17204,14 @@
       </p:sp>
       <p:sp>
         <p:nvSpPr>
-          <p:cNvPr id="96" name="mini syn 52 0"/>
-          <p:cNvSpPr/>
-          <p:nvPr/>
-        </p:nvSpPr>
-        <p:spPr>
-          <a:xfrm>
-            <a:off x="3406140" y="4990924"/>
-            <a:ext cx="36928" cy="36928"/>
+          <p:cNvPr id="117" name="mini syn 52 0"/>
+          <p:cNvSpPr/>
+          <p:nvPr/>
+        </p:nvSpPr>
+        <p:spPr>
+          <a:xfrm>
+            <a:off x="3433572" y="5012377"/>
+            <a:ext cx="30597" cy="30597"/>
           </a:xfrm>
           <a:prstGeom prst="ellipse">
             <a:avLst/>
@@ -16704,14 +17229,14 @@
       </p:sp>
       <p:sp>
         <p:nvSpPr>
-          <p:cNvPr id="97" name="mini syn 52 1"/>
-          <p:cNvSpPr/>
-          <p:nvPr/>
-        </p:nvSpPr>
-        <p:spPr>
-          <a:xfrm>
-            <a:off x="3396996" y="5052470"/>
-            <a:ext cx="49237" cy="20515"/>
+          <p:cNvPr id="118" name="mini syn 52 1"/>
+          <p:cNvSpPr/>
+          <p:nvPr/>
+        </p:nvSpPr>
+        <p:spPr>
+          <a:xfrm>
+            <a:off x="3424428" y="5063373"/>
+            <a:ext cx="40796" cy="16998"/>
           </a:xfrm>
           <a:prstGeom prst="rect">
             <a:avLst/>
@@ -16729,14 +17254,14 @@
       </p:sp>
       <p:sp>
         <p:nvSpPr>
-          <p:cNvPr id="98" name="mini syn 52 2"/>
-          <p:cNvSpPr/>
-          <p:nvPr/>
-        </p:nvSpPr>
-        <p:spPr>
-          <a:xfrm>
-            <a:off x="3406140" y="5097604"/>
-            <a:ext cx="36928" cy="36928"/>
+          <p:cNvPr id="119" name="mini syn 52 2"/>
+          <p:cNvSpPr/>
+          <p:nvPr/>
+        </p:nvSpPr>
+        <p:spPr>
+          <a:xfrm>
+            <a:off x="3433572" y="5100769"/>
+            <a:ext cx="30597" cy="30597"/>
           </a:xfrm>
           <a:prstGeom prst="ellipse">
             <a:avLst/>
@@ -16754,14 +17279,14 @@
       </p:sp>
       <p:sp>
         <p:nvSpPr>
-          <p:cNvPr id="99" name="mini syn 52 3"/>
-          <p:cNvSpPr/>
-          <p:nvPr/>
-        </p:nvSpPr>
-        <p:spPr>
-          <a:xfrm>
-            <a:off x="3406140" y="5150944"/>
-            <a:ext cx="36928" cy="36928"/>
+          <p:cNvPr id="120" name="mini syn 52 3"/>
+          <p:cNvSpPr/>
+          <p:nvPr/>
+        </p:nvSpPr>
+        <p:spPr>
+          <a:xfrm>
+            <a:off x="3433572" y="5144965"/>
+            <a:ext cx="30597" cy="30597"/>
           </a:xfrm>
           <a:prstGeom prst="ellipse">
             <a:avLst/>
@@ -16779,14 +17304,14 @@
       </p:sp>
       <p:sp>
         <p:nvSpPr>
-          <p:cNvPr id="100" name="mini syn 52 4"/>
-          <p:cNvSpPr/>
-          <p:nvPr/>
-        </p:nvSpPr>
-        <p:spPr>
-          <a:xfrm>
-            <a:off x="3396996" y="5212490"/>
-            <a:ext cx="49237" cy="20515"/>
+          <p:cNvPr id="121" name="mini syn 52 4"/>
+          <p:cNvSpPr/>
+          <p:nvPr/>
+        </p:nvSpPr>
+        <p:spPr>
+          <a:xfrm>
+            <a:off x="3424428" y="5195961"/>
+            <a:ext cx="40796" cy="16998"/>
           </a:xfrm>
           <a:prstGeom prst="rect">
             <a:avLst/>
@@ -16804,14 +17329,39 @@
       </p:sp>
       <p:sp>
         <p:nvSpPr>
-          <p:cNvPr id="101" name="mini slab syn 60"/>
-          <p:cNvSpPr/>
-          <p:nvPr/>
-        </p:nvSpPr>
-        <p:spPr>
-          <a:xfrm>
-            <a:off x="3889629" y="4133088"/>
-            <a:ext cx="456057" cy="32004"/>
+          <p:cNvPr id="122" name="mini card syn 60"/>
+          <p:cNvSpPr/>
+          <p:nvPr/>
+        </p:nvSpPr>
+        <p:spPr>
+          <a:xfrm>
+            <a:off x="3871341" y="4114800"/>
+            <a:ext cx="492633" cy="356616"/>
+          </a:xfrm>
+          <a:prstGeom prst="rect">
+            <a:avLst/>
+          </a:prstGeom>
+          <a:solidFill>
+            <a:srgbClr val="FFFFFF"/>
+          </a:solidFill>
+          <a:ln w="6350">
+            <a:solidFill>
+              <a:srgbClr val="898781"/>
+            </a:solidFill>
+            <a:prstDash val="solid"/>
+          </a:ln>
+        </p:spPr>
+      </p:sp>
+      <p:sp>
+        <p:nvSpPr>
+          <p:cNvPr id="123" name="mini slab syn 60"/>
+          <p:cNvSpPr/>
+          <p:nvPr/>
+        </p:nvSpPr>
+        <p:spPr>
+          <a:xfrm>
+            <a:off x="3917061" y="4160520"/>
+            <a:ext cx="401193" cy="32004"/>
           </a:xfrm>
           <a:prstGeom prst="rect">
             <a:avLst/>
@@ -16824,14 +17374,14 @@
       </p:sp>
       <p:sp>
         <p:nvSpPr>
-          <p:cNvPr id="102" name="mini syn 60 0"/>
-          <p:cNvSpPr/>
-          <p:nvPr/>
-        </p:nvSpPr>
-        <p:spPr>
-          <a:xfrm>
-            <a:off x="3937534" y="4206240"/>
-            <a:ext cx="34492" cy="34492"/>
+          <p:cNvPr id="124" name="mini syn 60 0"/>
+          <p:cNvSpPr/>
+          <p:nvPr/>
+        </p:nvSpPr>
+        <p:spPr>
+          <a:xfrm>
+            <a:off x="3959203" y="4233672"/>
+            <a:ext cx="30342" cy="30342"/>
           </a:xfrm>
           <a:prstGeom prst="ellipse">
             <a:avLst/>
@@ -16849,14 +17399,14 @@
       </p:sp>
       <p:sp>
         <p:nvSpPr>
-          <p:cNvPr id="103" name="mini syn 60 1"/>
-          <p:cNvSpPr/>
-          <p:nvPr/>
-        </p:nvSpPr>
-        <p:spPr>
-          <a:xfrm>
-            <a:off x="4002685" y="4206240"/>
-            <a:ext cx="34492" cy="34492"/>
+          <p:cNvPr id="125" name="mini syn 60 1"/>
+          <p:cNvSpPr/>
+          <p:nvPr/>
+        </p:nvSpPr>
+        <p:spPr>
+          <a:xfrm>
+            <a:off x="4016516" y="4233672"/>
+            <a:ext cx="30342" cy="30342"/>
           </a:xfrm>
           <a:prstGeom prst="ellipse">
             <a:avLst/>
@@ -16874,14 +17424,14 @@
       </p:sp>
       <p:sp>
         <p:nvSpPr>
-          <p:cNvPr id="104" name="mini syn 60 2"/>
-          <p:cNvSpPr/>
-          <p:nvPr/>
-        </p:nvSpPr>
-        <p:spPr>
-          <a:xfrm>
-            <a:off x="4067836" y="4206240"/>
-            <a:ext cx="34492" cy="34492"/>
+          <p:cNvPr id="126" name="mini syn 60 2"/>
+          <p:cNvSpPr/>
+          <p:nvPr/>
+        </p:nvSpPr>
+        <p:spPr>
+          <a:xfrm>
+            <a:off x="4073830" y="4233672"/>
+            <a:ext cx="30342" cy="30342"/>
           </a:xfrm>
           <a:prstGeom prst="ellipse">
             <a:avLst/>
@@ -16899,14 +17449,14 @@
       </p:sp>
       <p:sp>
         <p:nvSpPr>
-          <p:cNvPr id="105" name="mini syn 60 3"/>
-          <p:cNvSpPr/>
-          <p:nvPr/>
-        </p:nvSpPr>
-        <p:spPr>
-          <a:xfrm>
-            <a:off x="4132987" y="4206240"/>
-            <a:ext cx="34492" cy="34492"/>
+          <p:cNvPr id="127" name="mini syn 60 3"/>
+          <p:cNvSpPr/>
+          <p:nvPr/>
+        </p:nvSpPr>
+        <p:spPr>
+          <a:xfrm>
+            <a:off x="4131143" y="4233672"/>
+            <a:ext cx="30342" cy="30342"/>
           </a:xfrm>
           <a:prstGeom prst="ellipse">
             <a:avLst/>
@@ -16924,14 +17474,14 @@
       </p:sp>
       <p:sp>
         <p:nvSpPr>
-          <p:cNvPr id="106" name="mini syn 60 4"/>
-          <p:cNvSpPr/>
-          <p:nvPr/>
-        </p:nvSpPr>
-        <p:spPr>
-          <a:xfrm>
-            <a:off x="4198138" y="4206240"/>
-            <a:ext cx="34492" cy="34492"/>
+          <p:cNvPr id="128" name="mini syn 60 4"/>
+          <p:cNvSpPr/>
+          <p:nvPr/>
+        </p:nvSpPr>
+        <p:spPr>
+          <a:xfrm>
+            <a:off x="4188456" y="4233672"/>
+            <a:ext cx="30342" cy="30342"/>
           </a:xfrm>
           <a:prstGeom prst="ellipse">
             <a:avLst/>
@@ -16949,14 +17499,14 @@
       </p:sp>
       <p:sp>
         <p:nvSpPr>
-          <p:cNvPr id="107" name="mini syn 60 5"/>
-          <p:cNvSpPr/>
-          <p:nvPr/>
-        </p:nvSpPr>
-        <p:spPr>
-          <a:xfrm>
-            <a:off x="4263289" y="4206240"/>
-            <a:ext cx="34492" cy="34492"/>
+          <p:cNvPr id="129" name="mini syn 60 5"/>
+          <p:cNvSpPr/>
+          <p:nvPr/>
+        </p:nvSpPr>
+        <p:spPr>
+          <a:xfrm>
+            <a:off x="4245770" y="4233672"/>
+            <a:ext cx="30342" cy="30342"/>
           </a:xfrm>
           <a:prstGeom prst="ellipse">
             <a:avLst/>
@@ -16974,14 +17524,39 @@
       </p:sp>
       <p:sp>
         <p:nvSpPr>
-          <p:cNvPr id="108" name="mini slab syn 61"/>
-          <p:cNvSpPr/>
-          <p:nvPr/>
-        </p:nvSpPr>
-        <p:spPr>
-          <a:xfrm>
-            <a:off x="3889629" y="4544568"/>
-            <a:ext cx="456057" cy="32004"/>
+          <p:cNvPr id="130" name="mini card syn 61"/>
+          <p:cNvSpPr/>
+          <p:nvPr/>
+        </p:nvSpPr>
+        <p:spPr>
+          <a:xfrm>
+            <a:off x="3871341" y="4526280"/>
+            <a:ext cx="492633" cy="356616"/>
+          </a:xfrm>
+          <a:prstGeom prst="rect">
+            <a:avLst/>
+          </a:prstGeom>
+          <a:solidFill>
+            <a:srgbClr val="FFFFFF"/>
+          </a:solidFill>
+          <a:ln w="6350">
+            <a:solidFill>
+              <a:srgbClr val="898781"/>
+            </a:solidFill>
+            <a:prstDash val="solid"/>
+          </a:ln>
+        </p:spPr>
+      </p:sp>
+      <p:sp>
+        <p:nvSpPr>
+          <p:cNvPr id="131" name="mini slab syn 61"/>
+          <p:cNvSpPr/>
+          <p:nvPr/>
+        </p:nvSpPr>
+        <p:spPr>
+          <a:xfrm>
+            <a:off x="3917061" y="4572000"/>
+            <a:ext cx="401193" cy="32004"/>
           </a:xfrm>
           <a:prstGeom prst="rect">
             <a:avLst/>
@@ -16994,14 +17569,14 @@
       </p:sp>
       <p:sp>
         <p:nvSpPr>
-          <p:cNvPr id="109" name="mini syn 61 0"/>
-          <p:cNvSpPr/>
-          <p:nvPr/>
-        </p:nvSpPr>
-        <p:spPr>
-          <a:xfrm>
-            <a:off x="3926037" y="4608576"/>
-            <a:ext cx="57486" cy="42157"/>
+          <p:cNvPr id="132" name="mini syn 61 0"/>
+          <p:cNvSpPr/>
+          <p:nvPr/>
+        </p:nvSpPr>
+        <p:spPr>
+          <a:xfrm>
+            <a:off x="3949089" y="4636008"/>
+            <a:ext cx="50571" cy="37085"/>
           </a:xfrm>
           <a:prstGeom prst="rect">
             <a:avLst/>
@@ -17019,14 +17594,14 @@
       </p:sp>
       <p:sp>
         <p:nvSpPr>
-          <p:cNvPr id="110" name="mini syn 61 1"/>
-          <p:cNvSpPr/>
-          <p:nvPr/>
-        </p:nvSpPr>
-        <p:spPr>
-          <a:xfrm>
-            <a:off x="4002685" y="4617720"/>
-            <a:ext cx="34492" cy="34492"/>
+          <p:cNvPr id="133" name="mini syn 61 1"/>
+          <p:cNvSpPr/>
+          <p:nvPr/>
+        </p:nvSpPr>
+        <p:spPr>
+          <a:xfrm>
+            <a:off x="4016516" y="4645152"/>
+            <a:ext cx="30342" cy="30342"/>
           </a:xfrm>
           <a:prstGeom prst="ellipse">
             <a:avLst/>
@@ -17044,14 +17619,14 @@
       </p:sp>
       <p:sp>
         <p:nvSpPr>
-          <p:cNvPr id="111" name="mini syn 61 2"/>
-          <p:cNvSpPr/>
-          <p:nvPr/>
-        </p:nvSpPr>
-        <p:spPr>
-          <a:xfrm>
-            <a:off x="4062088" y="4636008"/>
-            <a:ext cx="45989" cy="19162"/>
+          <p:cNvPr id="134" name="mini syn 61 2"/>
+          <p:cNvSpPr/>
+          <p:nvPr/>
+        </p:nvSpPr>
+        <p:spPr>
+          <a:xfrm>
+            <a:off x="4068773" y="4663440"/>
+            <a:ext cx="40456" cy="16857"/>
           </a:xfrm>
           <a:prstGeom prst="rect">
             <a:avLst/>
@@ -17069,14 +17644,14 @@
       </p:sp>
       <p:sp>
         <p:nvSpPr>
-          <p:cNvPr id="112" name="mini syn 61 3"/>
-          <p:cNvSpPr/>
-          <p:nvPr/>
-        </p:nvSpPr>
-        <p:spPr>
-          <a:xfrm>
-            <a:off x="4132987" y="4617720"/>
-            <a:ext cx="34492" cy="34492"/>
+          <p:cNvPr id="135" name="mini syn 61 3"/>
+          <p:cNvSpPr/>
+          <p:nvPr/>
+        </p:nvSpPr>
+        <p:spPr>
+          <a:xfrm>
+            <a:off x="4131143" y="4645152"/>
+            <a:ext cx="30342" cy="30342"/>
           </a:xfrm>
           <a:prstGeom prst="ellipse">
             <a:avLst/>
@@ -17094,14 +17669,14 @@
       </p:sp>
       <p:sp>
         <p:nvSpPr>
-          <p:cNvPr id="113" name="mini syn 61 4"/>
-          <p:cNvSpPr/>
-          <p:nvPr/>
-        </p:nvSpPr>
-        <p:spPr>
-          <a:xfrm>
-            <a:off x="4186641" y="4608576"/>
-            <a:ext cx="57486" cy="42157"/>
+          <p:cNvPr id="136" name="mini syn 61 4"/>
+          <p:cNvSpPr/>
+          <p:nvPr/>
+        </p:nvSpPr>
+        <p:spPr>
+          <a:xfrm>
+            <a:off x="4178342" y="4636008"/>
+            <a:ext cx="50571" cy="37085"/>
           </a:xfrm>
           <a:prstGeom prst="rect">
             <a:avLst/>
@@ -17119,14 +17694,14 @@
       </p:sp>
       <p:sp>
         <p:nvSpPr>
-          <p:cNvPr id="114" name="mini syn 61 5"/>
-          <p:cNvSpPr/>
-          <p:nvPr/>
-        </p:nvSpPr>
-        <p:spPr>
-          <a:xfrm>
-            <a:off x="4263289" y="4617720"/>
-            <a:ext cx="34492" cy="34492"/>
+          <p:cNvPr id="137" name="mini syn 61 5"/>
+          <p:cNvSpPr/>
+          <p:nvPr/>
+        </p:nvSpPr>
+        <p:spPr>
+          <a:xfrm>
+            <a:off x="4245770" y="4645152"/>
+            <a:ext cx="30342" cy="30342"/>
           </a:xfrm>
           <a:prstGeom prst="ellipse">
             <a:avLst/>
@@ -17144,14 +17719,39 @@
       </p:sp>
       <p:sp>
         <p:nvSpPr>
-          <p:cNvPr id="115" name="mini wall syn 62"/>
-          <p:cNvSpPr/>
-          <p:nvPr/>
-        </p:nvSpPr>
-        <p:spPr>
-          <a:xfrm>
-            <a:off x="3889629" y="4956048"/>
-            <a:ext cx="32004" cy="320040"/>
+          <p:cNvPr id="138" name="mini card syn 62"/>
+          <p:cNvSpPr/>
+          <p:nvPr/>
+        </p:nvSpPr>
+        <p:spPr>
+          <a:xfrm>
+            <a:off x="3871341" y="4937760"/>
+            <a:ext cx="492633" cy="356616"/>
+          </a:xfrm>
+          <a:prstGeom prst="rect">
+            <a:avLst/>
+          </a:prstGeom>
+          <a:solidFill>
+            <a:srgbClr val="FFFFFF"/>
+          </a:solidFill>
+          <a:ln w="6350">
+            <a:solidFill>
+              <a:srgbClr val="898781"/>
+            </a:solidFill>
+            <a:prstDash val="solid"/>
+          </a:ln>
+        </p:spPr>
+      </p:sp>
+      <p:sp>
+        <p:nvSpPr>
+          <p:cNvPr id="139" name="mini wall syn 62"/>
+          <p:cNvSpPr/>
+          <p:nvPr/>
+        </p:nvSpPr>
+        <p:spPr>
+          <a:xfrm>
+            <a:off x="3917061" y="4983480"/>
+            <a:ext cx="32004" cy="265176"/>
           </a:xfrm>
           <a:prstGeom prst="rect">
             <a:avLst/>
@@ -17164,14 +17764,14 @@
       </p:sp>
       <p:sp>
         <p:nvSpPr>
-          <p:cNvPr id="116" name="mini syn 62 0"/>
-          <p:cNvSpPr/>
-          <p:nvPr/>
-        </p:nvSpPr>
-        <p:spPr>
-          <a:xfrm>
-            <a:off x="3971925" y="4985942"/>
-            <a:ext cx="31652" cy="31652"/>
+          <p:cNvPr id="140" name="mini syn 62 0"/>
+          <p:cNvSpPr/>
+          <p:nvPr/>
+        </p:nvSpPr>
+        <p:spPr>
+          <a:xfrm>
+            <a:off x="3999357" y="5008249"/>
+            <a:ext cx="26226" cy="26226"/>
           </a:xfrm>
           <a:prstGeom prst="ellipse">
             <a:avLst/>
@@ -17189,14 +17789,14 @@
       </p:sp>
       <p:sp>
         <p:nvSpPr>
-          <p:cNvPr id="117" name="mini syn 62 1"/>
-          <p:cNvSpPr/>
-          <p:nvPr/>
-        </p:nvSpPr>
-        <p:spPr>
-          <a:xfrm>
-            <a:off x="3962781" y="5038696"/>
-            <a:ext cx="42203" cy="17585"/>
+          <p:cNvPr id="141" name="mini syn 62 1"/>
+          <p:cNvSpPr/>
+          <p:nvPr/>
+        </p:nvSpPr>
+        <p:spPr>
+          <a:xfrm>
+            <a:off x="3990213" y="5051960"/>
+            <a:ext cx="34968" cy="14570"/>
           </a:xfrm>
           <a:prstGeom prst="rect">
             <a:avLst/>
@@ -17214,14 +17814,14 @@
       </p:sp>
       <p:sp>
         <p:nvSpPr>
-          <p:cNvPr id="118" name="mini syn 62 2"/>
-          <p:cNvSpPr/>
-          <p:nvPr/>
-        </p:nvSpPr>
-        <p:spPr>
-          <a:xfrm>
-            <a:off x="3971925" y="5077382"/>
-            <a:ext cx="31652" cy="31652"/>
+          <p:cNvPr id="142" name="mini syn 62 2"/>
+          <p:cNvSpPr/>
+          <p:nvPr/>
+        </p:nvSpPr>
+        <p:spPr>
+          <a:xfrm>
+            <a:off x="3999357" y="5084014"/>
+            <a:ext cx="26226" cy="26226"/>
           </a:xfrm>
           <a:prstGeom prst="ellipse">
             <a:avLst/>
@@ -17239,14 +17839,14 @@
       </p:sp>
       <p:sp>
         <p:nvSpPr>
-          <p:cNvPr id="119" name="mini syn 62 3"/>
-          <p:cNvSpPr/>
-          <p:nvPr/>
-        </p:nvSpPr>
-        <p:spPr>
-          <a:xfrm>
-            <a:off x="3971925" y="5123102"/>
-            <a:ext cx="31652" cy="31652"/>
+          <p:cNvPr id="143" name="mini syn 62 3"/>
+          <p:cNvSpPr/>
+          <p:nvPr/>
+        </p:nvSpPr>
+        <p:spPr>
+          <a:xfrm>
+            <a:off x="3999357" y="5121896"/>
+            <a:ext cx="26226" cy="26226"/>
           </a:xfrm>
           <a:prstGeom prst="ellipse">
             <a:avLst/>
@@ -17264,14 +17864,14 @@
       </p:sp>
       <p:sp>
         <p:nvSpPr>
-          <p:cNvPr id="120" name="mini syn 62 4"/>
-          <p:cNvSpPr/>
-          <p:nvPr/>
-        </p:nvSpPr>
-        <p:spPr>
-          <a:xfrm>
-            <a:off x="3962781" y="5175856"/>
-            <a:ext cx="42203" cy="17585"/>
+          <p:cNvPr id="144" name="mini syn 62 4"/>
+          <p:cNvSpPr/>
+          <p:nvPr/>
+        </p:nvSpPr>
+        <p:spPr>
+          <a:xfrm>
+            <a:off x="3990213" y="5165606"/>
+            <a:ext cx="34968" cy="14570"/>
           </a:xfrm>
           <a:prstGeom prst="rect">
             <a:avLst/>
@@ -17289,14 +17889,14 @@
       </p:sp>
       <p:sp>
         <p:nvSpPr>
-          <p:cNvPr id="121" name="mini syn 62 5"/>
-          <p:cNvSpPr/>
-          <p:nvPr/>
-        </p:nvSpPr>
-        <p:spPr>
-          <a:xfrm>
-            <a:off x="3971925" y="5214542"/>
-            <a:ext cx="31652" cy="31652"/>
+          <p:cNvPr id="145" name="mini syn 62 5"/>
+          <p:cNvSpPr/>
+          <p:nvPr/>
+        </p:nvSpPr>
+        <p:spPr>
+          <a:xfrm>
+            <a:off x="3999357" y="5197661"/>
+            <a:ext cx="26226" cy="26226"/>
           </a:xfrm>
           <a:prstGeom prst="ellipse">
             <a:avLst/>
@@ -17314,14 +17914,39 @@
       </p:sp>
       <p:sp>
         <p:nvSpPr>
-          <p:cNvPr id="122" name="mini slab syn 70"/>
-          <p:cNvSpPr/>
-          <p:nvPr/>
-        </p:nvSpPr>
-        <p:spPr>
-          <a:xfrm>
-            <a:off x="4455414" y="4133088"/>
-            <a:ext cx="456057" cy="32004"/>
+          <p:cNvPr id="146" name="mini card syn 70"/>
+          <p:cNvSpPr/>
+          <p:nvPr/>
+        </p:nvSpPr>
+        <p:spPr>
+          <a:xfrm>
+            <a:off x="4437126" y="4114800"/>
+            <a:ext cx="492633" cy="356616"/>
+          </a:xfrm>
+          <a:prstGeom prst="rect">
+            <a:avLst/>
+          </a:prstGeom>
+          <a:solidFill>
+            <a:srgbClr val="FFFFFF"/>
+          </a:solidFill>
+          <a:ln w="6350">
+            <a:solidFill>
+              <a:srgbClr val="898781"/>
+            </a:solidFill>
+            <a:prstDash val="solid"/>
+          </a:ln>
+        </p:spPr>
+      </p:sp>
+      <p:sp>
+        <p:nvSpPr>
+          <p:cNvPr id="147" name="mini slab syn 70"/>
+          <p:cNvSpPr/>
+          <p:nvPr/>
+        </p:nvSpPr>
+        <p:spPr>
+          <a:xfrm>
+            <a:off x="4482846" y="4160520"/>
+            <a:ext cx="401193" cy="32004"/>
           </a:xfrm>
           <a:prstGeom prst="rect">
             <a:avLst/>
@@ -17334,14 +17959,14 @@
       </p:sp>
       <p:sp>
         <p:nvSpPr>
-          <p:cNvPr id="123" name="mini syn 70 0"/>
-          <p:cNvSpPr/>
-          <p:nvPr/>
-        </p:nvSpPr>
-        <p:spPr>
-          <a:xfrm>
-            <a:off x="4497331" y="4206240"/>
-            <a:ext cx="30180" cy="30180"/>
+          <p:cNvPr id="148" name="mini syn 70 0"/>
+          <p:cNvSpPr/>
+          <p:nvPr/>
+        </p:nvSpPr>
+        <p:spPr>
+          <a:xfrm>
+            <a:off x="4519720" y="4233672"/>
+            <a:ext cx="26550" cy="26550"/>
           </a:xfrm>
           <a:prstGeom prst="ellipse">
             <a:avLst/>
@@ -17359,14 +17984,14 @@
       </p:sp>
       <p:sp>
         <p:nvSpPr>
-          <p:cNvPr id="124" name="mini syn 70 1"/>
-          <p:cNvSpPr/>
-          <p:nvPr/>
-        </p:nvSpPr>
-        <p:spPr>
-          <a:xfrm>
-            <a:off x="4554338" y="4206240"/>
-            <a:ext cx="30180" cy="30180"/>
+          <p:cNvPr id="149" name="mini syn 70 1"/>
+          <p:cNvSpPr/>
+          <p:nvPr/>
+        </p:nvSpPr>
+        <p:spPr>
+          <a:xfrm>
+            <a:off x="4569869" y="4233672"/>
+            <a:ext cx="26550" cy="26550"/>
           </a:xfrm>
           <a:prstGeom prst="ellipse">
             <a:avLst/>
@@ -17384,14 +18009,14 @@
       </p:sp>
       <p:sp>
         <p:nvSpPr>
-          <p:cNvPr id="125" name="mini syn 70 2"/>
-          <p:cNvSpPr/>
-          <p:nvPr/>
-        </p:nvSpPr>
-        <p:spPr>
-          <a:xfrm>
-            <a:off x="4611345" y="4206240"/>
-            <a:ext cx="30180" cy="30180"/>
+          <p:cNvPr id="150" name="mini syn 70 2"/>
+          <p:cNvSpPr/>
+          <p:nvPr/>
+        </p:nvSpPr>
+        <p:spPr>
+          <a:xfrm>
+            <a:off x="4620019" y="4233672"/>
+            <a:ext cx="26550" cy="26550"/>
           </a:xfrm>
           <a:prstGeom prst="ellipse">
             <a:avLst/>
@@ -17409,14 +18034,14 @@
       </p:sp>
       <p:sp>
         <p:nvSpPr>
-          <p:cNvPr id="126" name="mini syn 70 3"/>
-          <p:cNvSpPr/>
-          <p:nvPr/>
-        </p:nvSpPr>
-        <p:spPr>
-          <a:xfrm>
-            <a:off x="4668352" y="4206240"/>
-            <a:ext cx="30180" cy="30180"/>
+          <p:cNvPr id="151" name="mini syn 70 3"/>
+          <p:cNvSpPr/>
+          <p:nvPr/>
+        </p:nvSpPr>
+        <p:spPr>
+          <a:xfrm>
+            <a:off x="4670168" y="4233672"/>
+            <a:ext cx="26550" cy="26550"/>
           </a:xfrm>
           <a:prstGeom prst="ellipse">
             <a:avLst/>
@@ -17434,14 +18059,14 @@
       </p:sp>
       <p:sp>
         <p:nvSpPr>
-          <p:cNvPr id="127" name="mini syn 70 4"/>
-          <p:cNvSpPr/>
-          <p:nvPr/>
-        </p:nvSpPr>
-        <p:spPr>
-          <a:xfrm>
-            <a:off x="4725360" y="4206240"/>
-            <a:ext cx="30180" cy="30180"/>
+          <p:cNvPr id="152" name="mini syn 70 4"/>
+          <p:cNvSpPr/>
+          <p:nvPr/>
+        </p:nvSpPr>
+        <p:spPr>
+          <a:xfrm>
+            <a:off x="4720317" y="4233672"/>
+            <a:ext cx="26550" cy="26550"/>
           </a:xfrm>
           <a:prstGeom prst="ellipse">
             <a:avLst/>
@@ -17459,14 +18084,14 @@
       </p:sp>
       <p:sp>
         <p:nvSpPr>
-          <p:cNvPr id="128" name="mini syn 70 5"/>
-          <p:cNvSpPr/>
-          <p:nvPr/>
-        </p:nvSpPr>
-        <p:spPr>
-          <a:xfrm>
-            <a:off x="4782367" y="4206240"/>
-            <a:ext cx="30180" cy="30180"/>
+          <p:cNvPr id="153" name="mini syn 70 5"/>
+          <p:cNvSpPr/>
+          <p:nvPr/>
+        </p:nvSpPr>
+        <p:spPr>
+          <a:xfrm>
+            <a:off x="4770466" y="4233672"/>
+            <a:ext cx="26550" cy="26550"/>
           </a:xfrm>
           <a:prstGeom prst="ellipse">
             <a:avLst/>
@@ -17484,14 +18109,14 @@
       </p:sp>
       <p:sp>
         <p:nvSpPr>
-          <p:cNvPr id="129" name="mini syn 70 6"/>
-          <p:cNvSpPr/>
-          <p:nvPr/>
-        </p:nvSpPr>
-        <p:spPr>
-          <a:xfrm>
-            <a:off x="4839374" y="4206240"/>
-            <a:ext cx="30180" cy="30180"/>
+          <p:cNvPr id="154" name="mini syn 70 6"/>
+          <p:cNvSpPr/>
+          <p:nvPr/>
+        </p:nvSpPr>
+        <p:spPr>
+          <a:xfrm>
+            <a:off x="4820615" y="4233672"/>
+            <a:ext cx="26550" cy="26550"/>
           </a:xfrm>
           <a:prstGeom prst="ellipse">
             <a:avLst/>
@@ -17509,14 +18134,39 @@
       </p:sp>
       <p:sp>
         <p:nvSpPr>
-          <p:cNvPr id="130" name="mini slab syn 71"/>
-          <p:cNvSpPr/>
-          <p:nvPr/>
-        </p:nvSpPr>
-        <p:spPr>
-          <a:xfrm>
-            <a:off x="4455414" y="4544568"/>
-            <a:ext cx="456057" cy="32004"/>
+          <p:cNvPr id="155" name="mini card syn 71"/>
+          <p:cNvSpPr/>
+          <p:nvPr/>
+        </p:nvSpPr>
+        <p:spPr>
+          <a:xfrm>
+            <a:off x="4437126" y="4526280"/>
+            <a:ext cx="492633" cy="356616"/>
+          </a:xfrm>
+          <a:prstGeom prst="rect">
+            <a:avLst/>
+          </a:prstGeom>
+          <a:solidFill>
+            <a:srgbClr val="FFFFFF"/>
+          </a:solidFill>
+          <a:ln w="6350">
+            <a:solidFill>
+              <a:srgbClr val="898781"/>
+            </a:solidFill>
+            <a:prstDash val="solid"/>
+          </a:ln>
+        </p:spPr>
+      </p:sp>
+      <p:sp>
+        <p:nvSpPr>
+          <p:cNvPr id="156" name="mini slab syn 71"/>
+          <p:cNvSpPr/>
+          <p:nvPr/>
+        </p:nvSpPr>
+        <p:spPr>
+          <a:xfrm>
+            <a:off x="4482846" y="4572000"/>
+            <a:ext cx="401193" cy="32004"/>
           </a:xfrm>
           <a:prstGeom prst="rect">
             <a:avLst/>
@@ -17529,14 +18179,14 @@
       </p:sp>
       <p:sp>
         <p:nvSpPr>
-          <p:cNvPr id="131" name="mini syn 71 0"/>
-          <p:cNvSpPr/>
-          <p:nvPr/>
-        </p:nvSpPr>
-        <p:spPr>
-          <a:xfrm>
-            <a:off x="4487271" y="4608576"/>
-            <a:ext cx="50300" cy="36887"/>
+          <p:cNvPr id="157" name="mini syn 71 0"/>
+          <p:cNvSpPr/>
+          <p:nvPr/>
+        </p:nvSpPr>
+        <p:spPr>
+          <a:xfrm>
+            <a:off x="4510871" y="4636008"/>
+            <a:ext cx="44249" cy="32449"/>
           </a:xfrm>
           <a:prstGeom prst="rect">
             <a:avLst/>
@@ -17554,14 +18204,14 @@
       </p:sp>
       <p:sp>
         <p:nvSpPr>
-          <p:cNvPr id="132" name="mini syn 71 1"/>
-          <p:cNvSpPr/>
-          <p:nvPr/>
-        </p:nvSpPr>
-        <p:spPr>
-          <a:xfrm>
-            <a:off x="4554338" y="4617720"/>
-            <a:ext cx="30180" cy="30180"/>
+          <p:cNvPr id="158" name="mini syn 71 1"/>
+          <p:cNvSpPr/>
+          <p:nvPr/>
+        </p:nvSpPr>
+        <p:spPr>
+          <a:xfrm>
+            <a:off x="4569869" y="4645152"/>
+            <a:ext cx="26550" cy="26550"/>
           </a:xfrm>
           <a:prstGeom prst="ellipse">
             <a:avLst/>
@@ -17579,14 +18229,14 @@
       </p:sp>
       <p:sp>
         <p:nvSpPr>
-          <p:cNvPr id="133" name="mini syn 71 2"/>
-          <p:cNvSpPr/>
-          <p:nvPr/>
-        </p:nvSpPr>
-        <p:spPr>
-          <a:xfrm>
-            <a:off x="4606315" y="4636008"/>
-            <a:ext cx="40240" cy="16767"/>
+          <p:cNvPr id="159" name="mini syn 71 2"/>
+          <p:cNvSpPr/>
+          <p:nvPr/>
+        </p:nvSpPr>
+        <p:spPr>
+          <a:xfrm>
+            <a:off x="4615594" y="4663440"/>
+            <a:ext cx="35399" cy="14750"/>
           </a:xfrm>
           <a:prstGeom prst="rect">
             <a:avLst/>
@@ -17604,14 +18254,14 @@
       </p:sp>
       <p:sp>
         <p:nvSpPr>
-          <p:cNvPr id="134" name="mini syn 71 3"/>
-          <p:cNvSpPr/>
-          <p:nvPr/>
-        </p:nvSpPr>
-        <p:spPr>
-          <a:xfrm>
-            <a:off x="4668352" y="4617720"/>
-            <a:ext cx="30180" cy="30180"/>
+          <p:cNvPr id="160" name="mini syn 71 3"/>
+          <p:cNvSpPr/>
+          <p:nvPr/>
+        </p:nvSpPr>
+        <p:spPr>
+          <a:xfrm>
+            <a:off x="4670168" y="4645152"/>
+            <a:ext cx="26550" cy="26550"/>
           </a:xfrm>
           <a:prstGeom prst="ellipse">
             <a:avLst/>
@@ -17629,14 +18279,14 @@
       </p:sp>
       <p:sp>
         <p:nvSpPr>
-          <p:cNvPr id="135" name="mini syn 71 4"/>
-          <p:cNvSpPr/>
-          <p:nvPr/>
-        </p:nvSpPr>
-        <p:spPr>
-          <a:xfrm>
-            <a:off x="4715299" y="4608576"/>
-            <a:ext cx="50300" cy="36887"/>
+          <p:cNvPr id="161" name="mini syn 71 4"/>
+          <p:cNvSpPr/>
+          <p:nvPr/>
+        </p:nvSpPr>
+        <p:spPr>
+          <a:xfrm>
+            <a:off x="4711467" y="4636008"/>
+            <a:ext cx="44249" cy="32449"/>
           </a:xfrm>
           <a:prstGeom prst="rect">
             <a:avLst/>
@@ -17654,14 +18304,14 @@
       </p:sp>
       <p:sp>
         <p:nvSpPr>
-          <p:cNvPr id="136" name="mini syn 71 5"/>
-          <p:cNvSpPr/>
-          <p:nvPr/>
-        </p:nvSpPr>
-        <p:spPr>
-          <a:xfrm>
-            <a:off x="4782367" y="4617720"/>
-            <a:ext cx="30180" cy="30180"/>
+          <p:cNvPr id="162" name="mini syn 71 5"/>
+          <p:cNvSpPr/>
+          <p:nvPr/>
+        </p:nvSpPr>
+        <p:spPr>
+          <a:xfrm>
+            <a:off x="4770466" y="4645152"/>
+            <a:ext cx="26550" cy="26550"/>
           </a:xfrm>
           <a:prstGeom prst="ellipse">
             <a:avLst/>
@@ -17679,14 +18329,14 @@
       </p:sp>
       <p:sp>
         <p:nvSpPr>
-          <p:cNvPr id="137" name="mini syn 71 6"/>
-          <p:cNvSpPr/>
-          <p:nvPr/>
-        </p:nvSpPr>
-        <p:spPr>
-          <a:xfrm>
-            <a:off x="4834344" y="4636008"/>
-            <a:ext cx="40240" cy="16767"/>
+          <p:cNvPr id="163" name="mini syn 71 6"/>
+          <p:cNvSpPr/>
+          <p:nvPr/>
+        </p:nvSpPr>
+        <p:spPr>
+          <a:xfrm>
+            <a:off x="4816190" y="4663440"/>
+            <a:ext cx="35399" cy="14750"/>
           </a:xfrm>
           <a:prstGeom prst="rect">
             <a:avLst/>
@@ -17704,14 +18354,39 @@
       </p:sp>
       <p:sp>
         <p:nvSpPr>
-          <p:cNvPr id="138" name="mini wall syn 72"/>
-          <p:cNvSpPr/>
-          <p:nvPr/>
-        </p:nvSpPr>
-        <p:spPr>
-          <a:xfrm>
-            <a:off x="4455414" y="4956048"/>
-            <a:ext cx="32004" cy="320040"/>
+          <p:cNvPr id="164" name="mini card syn 72"/>
+          <p:cNvSpPr/>
+          <p:nvPr/>
+        </p:nvSpPr>
+        <p:spPr>
+          <a:xfrm>
+            <a:off x="4437126" y="4937760"/>
+            <a:ext cx="492633" cy="356616"/>
+          </a:xfrm>
+          <a:prstGeom prst="rect">
+            <a:avLst/>
+          </a:prstGeom>
+          <a:solidFill>
+            <a:srgbClr val="FFFFFF"/>
+          </a:solidFill>
+          <a:ln w="6350">
+            <a:solidFill>
+              <a:srgbClr val="898781"/>
+            </a:solidFill>
+            <a:prstDash val="solid"/>
+          </a:ln>
+        </p:spPr>
+      </p:sp>
+      <p:sp>
+        <p:nvSpPr>
+          <p:cNvPr id="165" name="mini wall syn 72"/>
+          <p:cNvSpPr/>
+          <p:nvPr/>
+        </p:nvSpPr>
+        <p:spPr>
+          <a:xfrm>
+            <a:off x="4482846" y="4983480"/>
+            <a:ext cx="32004" cy="265176"/>
           </a:xfrm>
           <a:prstGeom prst="rect">
             <a:avLst/>
@@ -17724,14 +18399,14 @@
       </p:sp>
       <p:sp>
         <p:nvSpPr>
-          <p:cNvPr id="139" name="mini syn 72 0"/>
-          <p:cNvSpPr/>
-          <p:nvPr/>
-        </p:nvSpPr>
-        <p:spPr>
-          <a:xfrm>
-            <a:off x="4537710" y="4982205"/>
-            <a:ext cx="27696" cy="27696"/>
+          <p:cNvPr id="166" name="mini syn 72 0"/>
+          <p:cNvSpPr/>
+          <p:nvPr/>
+        </p:nvSpPr>
+        <p:spPr>
+          <a:xfrm>
+            <a:off x="4565142" y="5005153"/>
+            <a:ext cx="22948" cy="22948"/>
           </a:xfrm>
           <a:prstGeom prst="ellipse">
             <a:avLst/>
@@ -17749,14 +18424,14 @@
       </p:sp>
       <p:sp>
         <p:nvSpPr>
-          <p:cNvPr id="140" name="mini syn 72 1"/>
-          <p:cNvSpPr/>
-          <p:nvPr/>
-        </p:nvSpPr>
-        <p:spPr>
-          <a:xfrm>
-            <a:off x="4528566" y="5028365"/>
-            <a:ext cx="36928" cy="15387"/>
+          <p:cNvPr id="167" name="mini syn 72 1"/>
+          <p:cNvSpPr/>
+          <p:nvPr/>
+        </p:nvSpPr>
+        <p:spPr>
+          <a:xfrm>
+            <a:off x="4555998" y="5043400"/>
+            <a:ext cx="30597" cy="12749"/>
           </a:xfrm>
           <a:prstGeom prst="rect">
             <a:avLst/>
@@ -17774,14 +18449,14 @@
       </p:sp>
       <p:sp>
         <p:nvSpPr>
-          <p:cNvPr id="141" name="mini syn 72 2"/>
-          <p:cNvSpPr/>
-          <p:nvPr/>
-        </p:nvSpPr>
-        <p:spPr>
-          <a:xfrm>
-            <a:off x="4537710" y="5062215"/>
-            <a:ext cx="27696" cy="27696"/>
+          <p:cNvPr id="168" name="mini syn 72 2"/>
+          <p:cNvSpPr/>
+          <p:nvPr/>
+        </p:nvSpPr>
+        <p:spPr>
+          <a:xfrm>
+            <a:off x="4565142" y="5071447"/>
+            <a:ext cx="22948" cy="22948"/>
           </a:xfrm>
           <a:prstGeom prst="ellipse">
             <a:avLst/>
@@ -17799,14 +18474,14 @@
       </p:sp>
       <p:sp>
         <p:nvSpPr>
-          <p:cNvPr id="142" name="mini syn 72 3"/>
-          <p:cNvSpPr/>
-          <p:nvPr/>
-        </p:nvSpPr>
-        <p:spPr>
-          <a:xfrm>
-            <a:off x="4537710" y="5102220"/>
-            <a:ext cx="27696" cy="27696"/>
+          <p:cNvPr id="169" name="mini syn 72 3"/>
+          <p:cNvSpPr/>
+          <p:nvPr/>
+        </p:nvSpPr>
+        <p:spPr>
+          <a:xfrm>
+            <a:off x="4565142" y="5104594"/>
+            <a:ext cx="22948" cy="22948"/>
           </a:xfrm>
           <a:prstGeom prst="ellipse">
             <a:avLst/>
@@ -17824,14 +18499,14 @@
       </p:sp>
       <p:sp>
         <p:nvSpPr>
-          <p:cNvPr id="143" name="mini syn 72 4"/>
-          <p:cNvSpPr/>
-          <p:nvPr/>
-        </p:nvSpPr>
-        <p:spPr>
-          <a:xfrm>
-            <a:off x="4528566" y="5148380"/>
-            <a:ext cx="36928" cy="15387"/>
+          <p:cNvPr id="170" name="mini syn 72 4"/>
+          <p:cNvSpPr/>
+          <p:nvPr/>
+        </p:nvSpPr>
+        <p:spPr>
+          <a:xfrm>
+            <a:off x="4555998" y="5142841"/>
+            <a:ext cx="30597" cy="12749"/>
           </a:xfrm>
           <a:prstGeom prst="rect">
             <a:avLst/>
@@ -17849,14 +18524,14 @@
       </p:sp>
       <p:sp>
         <p:nvSpPr>
-          <p:cNvPr id="144" name="mini syn 72 5"/>
-          <p:cNvSpPr/>
-          <p:nvPr/>
-        </p:nvSpPr>
-        <p:spPr>
-          <a:xfrm>
-            <a:off x="4537710" y="5182230"/>
-            <a:ext cx="27696" cy="27696"/>
+          <p:cNvPr id="171" name="mini syn 72 5"/>
+          <p:cNvSpPr/>
+          <p:nvPr/>
+        </p:nvSpPr>
+        <p:spPr>
+          <a:xfrm>
+            <a:off x="4565142" y="5170888"/>
+            <a:ext cx="22948" cy="22948"/>
           </a:xfrm>
           <a:prstGeom prst="ellipse">
             <a:avLst/>
@@ -17874,14 +18549,14 @@
       </p:sp>
       <p:sp>
         <p:nvSpPr>
-          <p:cNvPr id="145" name="mini syn 72 6"/>
-          <p:cNvSpPr/>
-          <p:nvPr/>
-        </p:nvSpPr>
-        <p:spPr>
-          <a:xfrm>
-            <a:off x="4537710" y="5222235"/>
-            <a:ext cx="27696" cy="27696"/>
+          <p:cNvPr id="172" name="mini syn 72 6"/>
+          <p:cNvSpPr/>
+          <p:nvPr/>
+        </p:nvSpPr>
+        <p:spPr>
+          <a:xfrm>
+            <a:off x="4565142" y="5204035"/>
+            <a:ext cx="22948" cy="22948"/>
           </a:xfrm>
           <a:prstGeom prst="ellipse">
             <a:avLst/>
@@ -17899,14 +18574,39 @@
       </p:sp>
       <p:sp>
         <p:nvSpPr>
-          <p:cNvPr id="146" name="mini slab syn 80"/>
-          <p:cNvSpPr/>
-          <p:nvPr/>
-        </p:nvSpPr>
-        <p:spPr>
-          <a:xfrm>
-            <a:off x="5021199" y="4133088"/>
-            <a:ext cx="456057" cy="32004"/>
+          <p:cNvPr id="173" name="mini card syn 80"/>
+          <p:cNvSpPr/>
+          <p:nvPr/>
+        </p:nvSpPr>
+        <p:spPr>
+          <a:xfrm>
+            <a:off x="5002911" y="4114800"/>
+            <a:ext cx="492633" cy="356616"/>
+          </a:xfrm>
+          <a:prstGeom prst="rect">
+            <a:avLst/>
+          </a:prstGeom>
+          <a:solidFill>
+            <a:srgbClr val="FFFFFF"/>
+          </a:solidFill>
+          <a:ln w="6350">
+            <a:solidFill>
+              <a:srgbClr val="898781"/>
+            </a:solidFill>
+            <a:prstDash val="solid"/>
+          </a:ln>
+        </p:spPr>
+      </p:sp>
+      <p:sp>
+        <p:nvSpPr>
+          <p:cNvPr id="174" name="mini slab syn 80"/>
+          <p:cNvSpPr/>
+          <p:nvPr/>
+        </p:nvSpPr>
+        <p:spPr>
+          <a:xfrm>
+            <a:off x="5048631" y="4160520"/>
+            <a:ext cx="401193" cy="32004"/>
           </a:xfrm>
           <a:prstGeom prst="rect">
             <a:avLst/>
@@ -17919,14 +18619,14 @@
       </p:sp>
       <p:sp>
         <p:nvSpPr>
-          <p:cNvPr id="147" name="mini syn 80 0"/>
-          <p:cNvSpPr/>
-          <p:nvPr/>
-        </p:nvSpPr>
-        <p:spPr>
-          <a:xfrm>
-            <a:off x="5058459" y="4206240"/>
-            <a:ext cx="26827" cy="26827"/>
+          <p:cNvPr id="175" name="mini syn 80 0"/>
+          <p:cNvSpPr/>
+          <p:nvPr/>
+        </p:nvSpPr>
+        <p:spPr>
+          <a:xfrm>
+            <a:off x="5081408" y="4233672"/>
+            <a:ext cx="23600" cy="23600"/>
           </a:xfrm>
           <a:prstGeom prst="ellipse">
             <a:avLst/>
@@ -17944,14 +18644,14 @@
       </p:sp>
       <p:sp>
         <p:nvSpPr>
-          <p:cNvPr id="148" name="mini syn 80 1"/>
-          <p:cNvSpPr/>
-          <p:nvPr/>
-        </p:nvSpPr>
-        <p:spPr>
-          <a:xfrm>
-            <a:off x="5109132" y="4206240"/>
-            <a:ext cx="26827" cy="26827"/>
+          <p:cNvPr id="176" name="mini syn 80 1"/>
+          <p:cNvSpPr/>
+          <p:nvPr/>
+        </p:nvSpPr>
+        <p:spPr>
+          <a:xfrm>
+            <a:off x="5125985" y="4233672"/>
+            <a:ext cx="23600" cy="23600"/>
           </a:xfrm>
           <a:prstGeom prst="ellipse">
             <a:avLst/>
@@ -17969,14 +18669,14 @@
       </p:sp>
       <p:sp>
         <p:nvSpPr>
-          <p:cNvPr id="149" name="mini syn 80 2"/>
-          <p:cNvSpPr/>
-          <p:nvPr/>
-        </p:nvSpPr>
-        <p:spPr>
-          <a:xfrm>
-            <a:off x="5159805" y="4206240"/>
-            <a:ext cx="26827" cy="26827"/>
+          <p:cNvPr id="177" name="mini syn 80 2"/>
+          <p:cNvSpPr/>
+          <p:nvPr/>
+        </p:nvSpPr>
+        <p:spPr>
+          <a:xfrm>
+            <a:off x="5170562" y="4233672"/>
+            <a:ext cx="23600" cy="23600"/>
           </a:xfrm>
           <a:prstGeom prst="ellipse">
             <a:avLst/>
@@ -17994,14 +18694,14 @@
       </p:sp>
       <p:sp>
         <p:nvSpPr>
-          <p:cNvPr id="150" name="mini syn 80 3"/>
-          <p:cNvSpPr/>
-          <p:nvPr/>
-        </p:nvSpPr>
-        <p:spPr>
-          <a:xfrm>
-            <a:off x="5210478" y="4206240"/>
-            <a:ext cx="26827" cy="26827"/>
+          <p:cNvPr id="178" name="mini syn 80 3"/>
+          <p:cNvSpPr/>
+          <p:nvPr/>
+        </p:nvSpPr>
+        <p:spPr>
+          <a:xfrm>
+            <a:off x="5215139" y="4233672"/>
+            <a:ext cx="23600" cy="23600"/>
           </a:xfrm>
           <a:prstGeom prst="ellipse">
             <a:avLst/>
@@ -18019,14 +18719,14 @@
       </p:sp>
       <p:sp>
         <p:nvSpPr>
-          <p:cNvPr id="151" name="mini syn 80 4"/>
-          <p:cNvSpPr/>
-          <p:nvPr/>
-        </p:nvSpPr>
-        <p:spPr>
-          <a:xfrm>
-            <a:off x="5261151" y="4206240"/>
-            <a:ext cx="26827" cy="26827"/>
+          <p:cNvPr id="179" name="mini syn 80 4"/>
+          <p:cNvSpPr/>
+          <p:nvPr/>
+        </p:nvSpPr>
+        <p:spPr>
+          <a:xfrm>
+            <a:off x="5259716" y="4233672"/>
+            <a:ext cx="23600" cy="23600"/>
           </a:xfrm>
           <a:prstGeom prst="ellipse">
             <a:avLst/>
@@ -18044,14 +18744,14 @@
       </p:sp>
       <p:sp>
         <p:nvSpPr>
-          <p:cNvPr id="152" name="mini syn 80 5"/>
-          <p:cNvSpPr/>
-          <p:nvPr/>
-        </p:nvSpPr>
-        <p:spPr>
-          <a:xfrm>
-            <a:off x="5311824" y="4206240"/>
-            <a:ext cx="26827" cy="26827"/>
+          <p:cNvPr id="180" name="mini syn 80 5"/>
+          <p:cNvSpPr/>
+          <p:nvPr/>
+        </p:nvSpPr>
+        <p:spPr>
+          <a:xfrm>
+            <a:off x="5304293" y="4233672"/>
+            <a:ext cx="23600" cy="23600"/>
           </a:xfrm>
           <a:prstGeom prst="ellipse">
             <a:avLst/>
@@ -18069,14 +18769,14 @@
       </p:sp>
       <p:sp>
         <p:nvSpPr>
-          <p:cNvPr id="153" name="mini syn 80 6"/>
-          <p:cNvSpPr/>
-          <p:nvPr/>
-        </p:nvSpPr>
-        <p:spPr>
-          <a:xfrm>
-            <a:off x="5362497" y="4206240"/>
-            <a:ext cx="26827" cy="26827"/>
+          <p:cNvPr id="181" name="mini syn 80 6"/>
+          <p:cNvSpPr/>
+          <p:nvPr/>
+        </p:nvSpPr>
+        <p:spPr>
+          <a:xfrm>
+            <a:off x="5348870" y="4233672"/>
+            <a:ext cx="23600" cy="23600"/>
           </a:xfrm>
           <a:prstGeom prst="ellipse">
             <a:avLst/>
@@ -18094,14 +18794,14 @@
       </p:sp>
       <p:sp>
         <p:nvSpPr>
-          <p:cNvPr id="154" name="mini syn 80 7"/>
-          <p:cNvSpPr/>
-          <p:nvPr/>
-        </p:nvSpPr>
-        <p:spPr>
-          <a:xfrm>
-            <a:off x="5413170" y="4206240"/>
-            <a:ext cx="26827" cy="26827"/>
+          <p:cNvPr id="182" name="mini syn 80 7"/>
+          <p:cNvSpPr/>
+          <p:nvPr/>
+        </p:nvSpPr>
+        <p:spPr>
+          <a:xfrm>
+            <a:off x="5393447" y="4233672"/>
+            <a:ext cx="23600" cy="23600"/>
           </a:xfrm>
           <a:prstGeom prst="ellipse">
             <a:avLst/>
@@ -18119,14 +18819,39 @@
       </p:sp>
       <p:sp>
         <p:nvSpPr>
-          <p:cNvPr id="155" name="mini slab syn 81"/>
-          <p:cNvSpPr/>
-          <p:nvPr/>
-        </p:nvSpPr>
-        <p:spPr>
-          <a:xfrm>
-            <a:off x="5021199" y="4544568"/>
-            <a:ext cx="456057" cy="32004"/>
+          <p:cNvPr id="183" name="mini card syn 81"/>
+          <p:cNvSpPr/>
+          <p:nvPr/>
+        </p:nvSpPr>
+        <p:spPr>
+          <a:xfrm>
+            <a:off x="5002911" y="4526280"/>
+            <a:ext cx="492633" cy="356616"/>
+          </a:xfrm>
+          <a:prstGeom prst="rect">
+            <a:avLst/>
+          </a:prstGeom>
+          <a:solidFill>
+            <a:srgbClr val="FFFFFF"/>
+          </a:solidFill>
+          <a:ln w="6350">
+            <a:solidFill>
+              <a:srgbClr val="898781"/>
+            </a:solidFill>
+            <a:prstDash val="solid"/>
+          </a:ln>
+        </p:spPr>
+      </p:sp>
+      <p:sp>
+        <p:nvSpPr>
+          <p:cNvPr id="184" name="mini slab syn 81"/>
+          <p:cNvSpPr/>
+          <p:nvPr/>
+        </p:nvSpPr>
+        <p:spPr>
+          <a:xfrm>
+            <a:off x="5048631" y="4572000"/>
+            <a:ext cx="401193" cy="32004"/>
           </a:xfrm>
           <a:prstGeom prst="rect">
             <a:avLst/>
@@ -18139,14 +18864,14 @@
       </p:sp>
       <p:sp>
         <p:nvSpPr>
-          <p:cNvPr id="156" name="mini syn 81 0"/>
-          <p:cNvSpPr/>
-          <p:nvPr/>
-        </p:nvSpPr>
-        <p:spPr>
-          <a:xfrm>
-            <a:off x="5049516" y="4608576"/>
-            <a:ext cx="44711" cy="32788"/>
+          <p:cNvPr id="185" name="mini syn 81 0"/>
+          <p:cNvSpPr/>
+          <p:nvPr/>
+        </p:nvSpPr>
+        <p:spPr>
+          <a:xfrm>
+            <a:off x="5073542" y="4636008"/>
+            <a:ext cx="39333" cy="28844"/>
           </a:xfrm>
           <a:prstGeom prst="rect">
             <a:avLst/>
@@ -18164,14 +18889,14 @@
       </p:sp>
       <p:sp>
         <p:nvSpPr>
-          <p:cNvPr id="157" name="mini syn 81 1"/>
-          <p:cNvSpPr/>
-          <p:nvPr/>
-        </p:nvSpPr>
-        <p:spPr>
-          <a:xfrm>
-            <a:off x="5109132" y="4617720"/>
-            <a:ext cx="26827" cy="26827"/>
+          <p:cNvPr id="186" name="mini syn 81 1"/>
+          <p:cNvSpPr/>
+          <p:nvPr/>
+        </p:nvSpPr>
+        <p:spPr>
+          <a:xfrm>
+            <a:off x="5125985" y="4645152"/>
+            <a:ext cx="23600" cy="23600"/>
           </a:xfrm>
           <a:prstGeom prst="ellipse">
             <a:avLst/>
@@ -18189,14 +18914,14 @@
       </p:sp>
       <p:sp>
         <p:nvSpPr>
-          <p:cNvPr id="158" name="mini syn 81 2"/>
-          <p:cNvSpPr/>
-          <p:nvPr/>
-        </p:nvSpPr>
-        <p:spPr>
-          <a:xfrm>
-            <a:off x="5155333" y="4636008"/>
-            <a:ext cx="35769" cy="14904"/>
+          <p:cNvPr id="187" name="mini syn 81 2"/>
+          <p:cNvSpPr/>
+          <p:nvPr/>
+        </p:nvSpPr>
+        <p:spPr>
+          <a:xfrm>
+            <a:off x="5166629" y="4663440"/>
+            <a:ext cx="31466" cy="13111"/>
           </a:xfrm>
           <a:prstGeom prst="rect">
             <a:avLst/>
@@ -18214,14 +18939,14 @@
       </p:sp>
       <p:sp>
         <p:nvSpPr>
-          <p:cNvPr id="159" name="mini syn 81 3"/>
-          <p:cNvSpPr/>
-          <p:nvPr/>
-        </p:nvSpPr>
-        <p:spPr>
-          <a:xfrm>
-            <a:off x="5210478" y="4617720"/>
-            <a:ext cx="26827" cy="26827"/>
+          <p:cNvPr id="188" name="mini syn 81 3"/>
+          <p:cNvSpPr/>
+          <p:nvPr/>
+        </p:nvSpPr>
+        <p:spPr>
+          <a:xfrm>
+            <a:off x="5215139" y="4645152"/>
+            <a:ext cx="23600" cy="23600"/>
           </a:xfrm>
           <a:prstGeom prst="ellipse">
             <a:avLst/>
@@ -18239,14 +18964,14 @@
       </p:sp>
       <p:sp>
         <p:nvSpPr>
-          <p:cNvPr id="160" name="mini syn 81 4"/>
-          <p:cNvSpPr/>
-          <p:nvPr/>
-        </p:nvSpPr>
-        <p:spPr>
-          <a:xfrm>
-            <a:off x="5252208" y="4608576"/>
-            <a:ext cx="44711" cy="32788"/>
+          <p:cNvPr id="189" name="mini syn 81 4"/>
+          <p:cNvSpPr/>
+          <p:nvPr/>
+        </p:nvSpPr>
+        <p:spPr>
+          <a:xfrm>
+            <a:off x="5251850" y="4636008"/>
+            <a:ext cx="39333" cy="28844"/>
           </a:xfrm>
           <a:prstGeom prst="rect">
             <a:avLst/>
@@ -18264,14 +18989,14 @@
       </p:sp>
       <p:sp>
         <p:nvSpPr>
-          <p:cNvPr id="161" name="mini syn 81 5"/>
-          <p:cNvSpPr/>
-          <p:nvPr/>
-        </p:nvSpPr>
-        <p:spPr>
-          <a:xfrm>
-            <a:off x="5311824" y="4617720"/>
-            <a:ext cx="26827" cy="26827"/>
+          <p:cNvPr id="190" name="mini syn 81 5"/>
+          <p:cNvSpPr/>
+          <p:nvPr/>
+        </p:nvSpPr>
+        <p:spPr>
+          <a:xfrm>
+            <a:off x="5304293" y="4645152"/>
+            <a:ext cx="23600" cy="23600"/>
           </a:xfrm>
           <a:prstGeom prst="ellipse">
             <a:avLst/>
@@ -18289,14 +19014,14 @@
       </p:sp>
       <p:sp>
         <p:nvSpPr>
-          <p:cNvPr id="162" name="mini syn 81 6"/>
-          <p:cNvSpPr/>
-          <p:nvPr/>
-        </p:nvSpPr>
-        <p:spPr>
-          <a:xfrm>
-            <a:off x="5358025" y="4636008"/>
-            <a:ext cx="35769" cy="14904"/>
+          <p:cNvPr id="191" name="mini syn 81 6"/>
+          <p:cNvSpPr/>
+          <p:nvPr/>
+        </p:nvSpPr>
+        <p:spPr>
+          <a:xfrm>
+            <a:off x="5344937" y="4663440"/>
+            <a:ext cx="31466" cy="13111"/>
           </a:xfrm>
           <a:prstGeom prst="rect">
             <a:avLst/>
@@ -18314,14 +19039,14 @@
       </p:sp>
       <p:sp>
         <p:nvSpPr>
-          <p:cNvPr id="163" name="mini syn 81 7"/>
-          <p:cNvSpPr/>
-          <p:nvPr/>
-        </p:nvSpPr>
-        <p:spPr>
-          <a:xfrm>
-            <a:off x="5413170" y="4617720"/>
-            <a:ext cx="26827" cy="26827"/>
+          <p:cNvPr id="192" name="mini syn 81 7"/>
+          <p:cNvSpPr/>
+          <p:nvPr/>
+        </p:nvSpPr>
+        <p:spPr>
+          <a:xfrm>
+            <a:off x="5393447" y="4645152"/>
+            <a:ext cx="23600" cy="23600"/>
           </a:xfrm>
           <a:prstGeom prst="ellipse">
             <a:avLst/>
@@ -18339,14 +19064,39 @@
       </p:sp>
       <p:sp>
         <p:nvSpPr>
-          <p:cNvPr id="164" name="mini wall syn 82"/>
-          <p:cNvSpPr/>
-          <p:nvPr/>
-        </p:nvSpPr>
-        <p:spPr>
-          <a:xfrm>
-            <a:off x="5021199" y="4956048"/>
-            <a:ext cx="32004" cy="320040"/>
+          <p:cNvPr id="193" name="mini card syn 82"/>
+          <p:cNvSpPr/>
+          <p:nvPr/>
+        </p:nvSpPr>
+        <p:spPr>
+          <a:xfrm>
+            <a:off x="5002911" y="4937760"/>
+            <a:ext cx="492633" cy="356616"/>
+          </a:xfrm>
+          <a:prstGeom prst="rect">
+            <a:avLst/>
+          </a:prstGeom>
+          <a:solidFill>
+            <a:srgbClr val="FFFFFF"/>
+          </a:solidFill>
+          <a:ln w="6350">
+            <a:solidFill>
+              <a:srgbClr val="898781"/>
+            </a:solidFill>
+            <a:prstDash val="solid"/>
+          </a:ln>
+        </p:spPr>
+      </p:sp>
+      <p:sp>
+        <p:nvSpPr>
+          <p:cNvPr id="194" name="mini wall syn 82"/>
+          <p:cNvSpPr/>
+          <p:nvPr/>
+        </p:nvSpPr>
+        <p:spPr>
+          <a:xfrm>
+            <a:off x="5048631" y="4983480"/>
+            <a:ext cx="32004" cy="265176"/>
           </a:xfrm>
           <a:prstGeom prst="rect">
             <a:avLst/>
@@ -18359,14 +19109,14 @@
       </p:sp>
       <p:sp>
         <p:nvSpPr>
-          <p:cNvPr id="165" name="mini syn 82 0"/>
-          <p:cNvSpPr/>
-          <p:nvPr/>
-        </p:nvSpPr>
-        <p:spPr>
-          <a:xfrm>
-            <a:off x="5103495" y="4979299"/>
-            <a:ext cx="24618" cy="24618"/>
+          <p:cNvPr id="195" name="mini syn 82 0"/>
+          <p:cNvSpPr/>
+          <p:nvPr/>
+        </p:nvSpPr>
+        <p:spPr>
+          <a:xfrm>
+            <a:off x="5130927" y="5002745"/>
+            <a:ext cx="20398" cy="20398"/>
           </a:xfrm>
           <a:prstGeom prst="ellipse">
             <a:avLst/>
@@ -18384,14 +19134,14 @@
       </p:sp>
       <p:sp>
         <p:nvSpPr>
-          <p:cNvPr id="166" name="mini syn 82 1"/>
-          <p:cNvSpPr/>
-          <p:nvPr/>
-        </p:nvSpPr>
-        <p:spPr>
-          <a:xfrm>
-            <a:off x="5094351" y="5020330"/>
-            <a:ext cx="32825" cy="13677"/>
+          <p:cNvPr id="196" name="mini syn 82 1"/>
+          <p:cNvSpPr/>
+          <p:nvPr/>
+        </p:nvSpPr>
+        <p:spPr>
+          <a:xfrm>
+            <a:off x="5121783" y="5036742"/>
+            <a:ext cx="27198" cy="11332"/>
           </a:xfrm>
           <a:prstGeom prst="rect">
             <a:avLst/>
@@ -18409,14 +19159,14 @@
       </p:sp>
       <p:sp>
         <p:nvSpPr>
-          <p:cNvPr id="167" name="mini syn 82 2"/>
-          <p:cNvSpPr/>
-          <p:nvPr/>
-        </p:nvSpPr>
-        <p:spPr>
-          <a:xfrm>
-            <a:off x="5103495" y="5050419"/>
-            <a:ext cx="24618" cy="24618"/>
+          <p:cNvPr id="197" name="mini syn 82 2"/>
+          <p:cNvSpPr/>
+          <p:nvPr/>
+        </p:nvSpPr>
+        <p:spPr>
+          <a:xfrm>
+            <a:off x="5130927" y="5061673"/>
+            <a:ext cx="20398" cy="20398"/>
           </a:xfrm>
           <a:prstGeom prst="ellipse">
             <a:avLst/>
@@ -18434,14 +19184,14 @@
       </p:sp>
       <p:sp>
         <p:nvSpPr>
-          <p:cNvPr id="168" name="mini syn 82 3"/>
-          <p:cNvSpPr/>
-          <p:nvPr/>
-        </p:nvSpPr>
-        <p:spPr>
-          <a:xfrm>
-            <a:off x="5103495" y="5085979"/>
-            <a:ext cx="24618" cy="24618"/>
+          <p:cNvPr id="198" name="mini syn 82 3"/>
+          <p:cNvSpPr/>
+          <p:nvPr/>
+        </p:nvSpPr>
+        <p:spPr>
+          <a:xfrm>
+            <a:off x="5130927" y="5091137"/>
+            <a:ext cx="20398" cy="20398"/>
           </a:xfrm>
           <a:prstGeom prst="ellipse">
             <a:avLst/>
@@ -18459,14 +19209,14 @@
       </p:sp>
       <p:sp>
         <p:nvSpPr>
-          <p:cNvPr id="169" name="mini syn 82 4"/>
-          <p:cNvSpPr/>
-          <p:nvPr/>
-        </p:nvSpPr>
-        <p:spPr>
-          <a:xfrm>
-            <a:off x="5094351" y="5127010"/>
-            <a:ext cx="32825" cy="13677"/>
+          <p:cNvPr id="199" name="mini syn 82 4"/>
+          <p:cNvSpPr/>
+          <p:nvPr/>
+        </p:nvSpPr>
+        <p:spPr>
+          <a:xfrm>
+            <a:off x="5121783" y="5125134"/>
+            <a:ext cx="27198" cy="11332"/>
           </a:xfrm>
           <a:prstGeom prst="rect">
             <a:avLst/>
@@ -18484,14 +19234,14 @@
       </p:sp>
       <p:sp>
         <p:nvSpPr>
-          <p:cNvPr id="170" name="mini syn 82 5"/>
-          <p:cNvSpPr/>
-          <p:nvPr/>
-        </p:nvSpPr>
-        <p:spPr>
-          <a:xfrm>
-            <a:off x="5103495" y="5157099"/>
-            <a:ext cx="24618" cy="24618"/>
+          <p:cNvPr id="200" name="mini syn 82 5"/>
+          <p:cNvSpPr/>
+          <p:nvPr/>
+        </p:nvSpPr>
+        <p:spPr>
+          <a:xfrm>
+            <a:off x="5130927" y="5150065"/>
+            <a:ext cx="20398" cy="20398"/>
           </a:xfrm>
           <a:prstGeom prst="ellipse">
             <a:avLst/>
@@ -18509,14 +19259,14 @@
       </p:sp>
       <p:sp>
         <p:nvSpPr>
-          <p:cNvPr id="171" name="mini syn 82 6"/>
-          <p:cNvSpPr/>
-          <p:nvPr/>
-        </p:nvSpPr>
-        <p:spPr>
-          <a:xfrm>
-            <a:off x="5103495" y="5192659"/>
-            <a:ext cx="24618" cy="24618"/>
+          <p:cNvPr id="201" name="mini syn 82 6"/>
+          <p:cNvSpPr/>
+          <p:nvPr/>
+        </p:nvSpPr>
+        <p:spPr>
+          <a:xfrm>
+            <a:off x="5130927" y="5179529"/>
+            <a:ext cx="20398" cy="20398"/>
           </a:xfrm>
           <a:prstGeom prst="ellipse">
             <a:avLst/>
@@ -18534,14 +19284,14 @@
       </p:sp>
       <p:sp>
         <p:nvSpPr>
-          <p:cNvPr id="172" name="mini syn 82 7"/>
-          <p:cNvSpPr/>
-          <p:nvPr/>
-        </p:nvSpPr>
-        <p:spPr>
-          <a:xfrm>
-            <a:off x="5094351" y="5233690"/>
-            <a:ext cx="32825" cy="13677"/>
+          <p:cNvPr id="202" name="mini syn 82 7"/>
+          <p:cNvSpPr/>
+          <p:nvPr/>
+        </p:nvSpPr>
+        <p:spPr>
+          <a:xfrm>
+            <a:off x="5121783" y="5213526"/>
+            <a:ext cx="27198" cy="11332"/>
           </a:xfrm>
           <a:prstGeom prst="rect">
             <a:avLst/>
@@ -18559,7 +19309,7 @@
       </p:sp>
       <p:sp>
         <p:nvSpPr>
-          <p:cNvPr id="173" name="glance heading"/>
+          <p:cNvPr id="203" name="glance heading"/>
           <p:cNvSpPr txBox="1"/>
           <p:nvPr/>
         </p:nvSpPr>
@@ -18595,18 +19345,18 @@
       </p:sp>
       <p:sp>
         <p:nvSpPr>
-          <p:cNvPr id="174" name="tile contexts, four splits, disjoint seeds"/>
-          <p:cNvSpPr/>
-          <p:nvPr/>
-        </p:nvSpPr>
-        <p:spPr>
-          <a:xfrm>
-            <a:off x="5806440" y="1874520"/>
-            <a:ext cx="1822704" cy="1965960"/>
+          <p:cNvPr id="204" name="glance 7,000"/>
+          <p:cNvSpPr/>
+          <p:nvPr/>
+        </p:nvSpPr>
+        <p:spPr>
+          <a:xfrm>
+            <a:off x="5806440" y="1828800"/>
+            <a:ext cx="2825496" cy="1188720"/>
           </a:xfrm>
           <a:prstGeom prst="roundRect">
             <a:avLst>
-              <a:gd name="adj" fmla="val 3512"/>
+              <a:gd name="adj" fmla="val 5385"/>
             </a:avLst>
           </a:prstGeom>
           <a:solidFill>
@@ -18617,14 +19367,58 @@
       </p:sp>
       <p:sp>
         <p:nvSpPr>
-          <p:cNvPr id="175" name="value contexts, four splits, disjoint seeds"/>
+          <p:cNvPr id="205" name="icon ring glance 7,000"/>
+          <p:cNvSpPr/>
+          <p:nvPr/>
+        </p:nvSpPr>
+        <p:spPr>
+          <a:xfrm>
+            <a:off x="6007608" y="2130552"/>
+            <a:ext cx="585216" cy="585216"/>
+          </a:xfrm>
+          <a:prstGeom prst="ellipse">
+            <a:avLst/>
+          </a:prstGeom>
+          <a:solidFill>
+            <a:schemeClr val="accent1"/>
+          </a:solidFill>
+          <a:ln/>
+        </p:spPr>
+      </p:sp>
+      <p:pic>
+        <p:nvPicPr>
+          <p:cNvPr id="206" name="icon glance 7,000" descr="preencoded.png">    </p:cNvPr>
+          <p:cNvPicPr>
+            <a:picLocks noChangeAspect="1"/>
+          </p:cNvPicPr>
+          <p:nvPr/>
+        </p:nvPicPr>
+        <p:blipFill>
+          <a:blip r:embed="rId1"/>
+          <a:stretch>
+            <a:fillRect/>
+          </a:stretch>
+        </p:blipFill>
+        <p:spPr>
+          <a:xfrm>
+            <a:off x="6130503" y="2253447"/>
+            <a:ext cx="339425" cy="339425"/>
+          </a:xfrm>
+          <a:prstGeom prst="rect">
+            <a:avLst/>
+          </a:prstGeom>
+        </p:spPr>
+      </p:pic>
+      <p:sp>
+        <p:nvSpPr>
+          <p:cNvPr id="207" name="glance value 7,000"/>
           <p:cNvSpPr txBox="1"/>
           <p:nvPr/>
         </p:nvSpPr>
         <p:spPr>
           <a:xfrm>
-            <a:off x="6007608" y="1965960"/>
-            <a:ext cx="1420368" cy="982980"/>
+            <a:off x="6766560" y="1938528"/>
+            <a:ext cx="1728216" cy="502920"/>
           </a:xfrm>
           <a:prstGeom prst="rect">
             <a:avLst/>
@@ -18640,27 +19434,27 @@
               <a:buNone/>
             </a:pPr>
             <a:r>
-              <a:rPr lang="en-US" sz="2600" b="1" dirty="0">
+              <a:rPr lang="en-US" sz="2400" b="1" dirty="0">
                 <a:solidFill>
                   <a:schemeClr val="accent1"/>
                 </a:solidFill>
               </a:rPr>
               <a:t>7,000</a:t>
             </a:r>
-            <a:endParaRPr lang="en-US" sz="2600" dirty="0"/>
+            <a:endParaRPr lang="en-US" sz="2400" dirty="0"/>
           </a:p>
         </p:txBody>
       </p:sp>
       <p:sp>
         <p:nvSpPr>
-          <p:cNvPr id="176" name="label contexts, four splits, disjoint seeds"/>
+          <p:cNvPr id="208" name="glance label 7,000"/>
           <p:cNvSpPr txBox="1"/>
           <p:nvPr/>
         </p:nvSpPr>
         <p:spPr>
           <a:xfrm>
-            <a:off x="6007608" y="3014777"/>
-            <a:ext cx="1420368" cy="747065"/>
+            <a:off x="6766560" y="2450592"/>
+            <a:ext cx="1728216" cy="502920"/>
           </a:xfrm>
           <a:prstGeom prst="rect">
             <a:avLst/>
@@ -18681,7 +19475,7 @@
                   <a:srgbClr val="52514E"/>
                 </a:solidFill>
               </a:rPr>
-              <a:t>contexts, four splits, disjoint seeds</a:t>
+              <a:t>contexts in four splits, on disjoint seeds</a:t>
             </a:r>
             <a:endParaRPr lang="en-US" sz="1150" dirty="0"/>
           </a:p>
@@ -18689,18 +19483,18 @@
       </p:sp>
       <p:sp>
         <p:nvSpPr>
-          <p:cNvPr id="177" name="tile elements, four kinds, six trades"/>
-          <p:cNvSpPr/>
-          <p:nvPr/>
-        </p:nvSpPr>
-        <p:spPr>
-          <a:xfrm>
-            <a:off x="7812024" y="1874520"/>
-            <a:ext cx="1822704" cy="1965960"/>
+          <p:cNvPr id="209" name="glance 31,484"/>
+          <p:cNvSpPr/>
+          <p:nvPr/>
+        </p:nvSpPr>
+        <p:spPr>
+          <a:xfrm>
+            <a:off x="8814816" y="1828800"/>
+            <a:ext cx="2825496" cy="1188720"/>
           </a:xfrm>
           <a:prstGeom prst="roundRect">
             <a:avLst>
-              <a:gd name="adj" fmla="val 3512"/>
+              <a:gd name="adj" fmla="val 5385"/>
             </a:avLst>
           </a:prstGeom>
           <a:solidFill>
@@ -18711,14 +19505,58 @@
       </p:sp>
       <p:sp>
         <p:nvSpPr>
-          <p:cNvPr id="178" name="value elements, four kinds, six trades"/>
+          <p:cNvPr id="210" name="icon ring glance 31,484"/>
+          <p:cNvSpPr/>
+          <p:nvPr/>
+        </p:nvSpPr>
+        <p:spPr>
+          <a:xfrm>
+            <a:off x="9015984" y="2130552"/>
+            <a:ext cx="585216" cy="585216"/>
+          </a:xfrm>
+          <a:prstGeom prst="ellipse">
+            <a:avLst/>
+          </a:prstGeom>
+          <a:solidFill>
+            <a:schemeClr val="accent1"/>
+          </a:solidFill>
+          <a:ln/>
+        </p:spPr>
+      </p:sp>
+      <p:pic>
+        <p:nvPicPr>
+          <p:cNvPr id="211" name="icon glance 31,484" descr="preencoded.png">    </p:cNvPr>
+          <p:cNvPicPr>
+            <a:picLocks noChangeAspect="1"/>
+          </p:cNvPicPr>
+          <p:nvPr/>
+        </p:nvPicPr>
+        <p:blipFill>
+          <a:blip r:embed="rId2"/>
+          <a:stretch>
+            <a:fillRect/>
+          </a:stretch>
+        </p:blipFill>
+        <p:spPr>
+          <a:xfrm>
+            <a:off x="9138879" y="2253447"/>
+            <a:ext cx="339425" cy="339425"/>
+          </a:xfrm>
+          <a:prstGeom prst="rect">
+            <a:avLst/>
+          </a:prstGeom>
+        </p:spPr>
+      </p:pic>
+      <p:sp>
+        <p:nvSpPr>
+          <p:cNvPr id="212" name="glance value 31,484"/>
           <p:cNvSpPr txBox="1"/>
           <p:nvPr/>
         </p:nvSpPr>
         <p:spPr>
           <a:xfrm>
-            <a:off x="8013192" y="1965960"/>
-            <a:ext cx="1420368" cy="982980"/>
+            <a:off x="9774936" y="1938528"/>
+            <a:ext cx="1728216" cy="502920"/>
           </a:xfrm>
           <a:prstGeom prst="rect">
             <a:avLst/>
@@ -18734,27 +19572,27 @@
               <a:buNone/>
             </a:pPr>
             <a:r>
-              <a:rPr lang="en-US" sz="2600" b="1" dirty="0">
+              <a:rPr lang="en-US" sz="2400" b="1" dirty="0">
                 <a:solidFill>
                   <a:schemeClr val="accent1"/>
                 </a:solidFill>
               </a:rPr>
               <a:t>31,484</a:t>
             </a:r>
-            <a:endParaRPr lang="en-US" sz="2600" dirty="0"/>
+            <a:endParaRPr lang="en-US" sz="2400" dirty="0"/>
           </a:p>
         </p:txBody>
       </p:sp>
       <p:sp>
         <p:nvSpPr>
-          <p:cNvPr id="179" name="label elements, four kinds, six trades"/>
+          <p:cNvPr id="213" name="glance label 31,484"/>
           <p:cNvSpPr txBox="1"/>
           <p:nvPr/>
         </p:nvSpPr>
         <p:spPr>
           <a:xfrm>
-            <a:off x="8013192" y="3014777"/>
-            <a:ext cx="1420368" cy="747065"/>
+            <a:off x="9774936" y="2450592"/>
+            <a:ext cx="1728216" cy="502920"/>
           </a:xfrm>
           <a:prstGeom prst="rect">
             <a:avLst/>
@@ -18775,7 +19613,7 @@
                   <a:srgbClr val="52514E"/>
                 </a:solidFill>
               </a:rPr>
-              <a:t>elements, four kinds, six trades</a:t>
+              <a:t>elements: pipes, trays, ducts, conduits; six trades</a:t>
             </a:r>
             <a:endParaRPr lang="en-US" sz="1150" dirty="0"/>
           </a:p>
@@ -18783,18 +19621,18 @@
       </p:sp>
       <p:sp>
         <p:nvSpPr>
-          <p:cNvPr id="180" name="tile tiers by exact element count"/>
-          <p:cNvSpPr/>
-          <p:nvPr/>
-        </p:nvSpPr>
-        <p:spPr>
-          <a:xfrm>
-            <a:off x="9817608" y="1874520"/>
-            <a:ext cx="1822704" cy="1965960"/>
+          <p:cNvPr id="214" name="glance C1–C8"/>
+          <p:cNvSpPr/>
+          <p:nvPr/>
+        </p:nvSpPr>
+        <p:spPr>
+          <a:xfrm>
+            <a:off x="5806440" y="3172968"/>
+            <a:ext cx="2825496" cy="1188720"/>
           </a:xfrm>
           <a:prstGeom prst="roundRect">
             <a:avLst>
-              <a:gd name="adj" fmla="val 3512"/>
+              <a:gd name="adj" fmla="val 5385"/>
             </a:avLst>
           </a:prstGeom>
           <a:solidFill>
@@ -18805,14 +19643,58 @@
       </p:sp>
       <p:sp>
         <p:nvSpPr>
-          <p:cNvPr id="181" name="value tiers by exact element count"/>
+          <p:cNvPr id="215" name="icon ring glance C1–C8"/>
+          <p:cNvSpPr/>
+          <p:nvPr/>
+        </p:nvSpPr>
+        <p:spPr>
+          <a:xfrm>
+            <a:off x="6007608" y="3474720"/>
+            <a:ext cx="585216" cy="585216"/>
+          </a:xfrm>
+          <a:prstGeom prst="ellipse">
+            <a:avLst/>
+          </a:prstGeom>
+          <a:solidFill>
+            <a:schemeClr val="accent1"/>
+          </a:solidFill>
+          <a:ln/>
+        </p:spPr>
+      </p:sp>
+      <p:pic>
+        <p:nvPicPr>
+          <p:cNvPr id="216" name="icon glance C1–C8" descr="preencoded.png">    </p:cNvPr>
+          <p:cNvPicPr>
+            <a:picLocks noChangeAspect="1"/>
+          </p:cNvPicPr>
+          <p:nvPr/>
+        </p:nvPicPr>
+        <p:blipFill>
+          <a:blip r:embed="rId3"/>
+          <a:stretch>
+            <a:fillRect/>
+          </a:stretch>
+        </p:blipFill>
+        <p:spPr>
+          <a:xfrm>
+            <a:off x="6130503" y="3597615"/>
+            <a:ext cx="339425" cy="339425"/>
+          </a:xfrm>
+          <a:prstGeom prst="rect">
+            <a:avLst/>
+          </a:prstGeom>
+        </p:spPr>
+      </p:pic>
+      <p:sp>
+        <p:nvSpPr>
+          <p:cNvPr id="217" name="glance value C1–C8"/>
           <p:cNvSpPr txBox="1"/>
           <p:nvPr/>
         </p:nvSpPr>
         <p:spPr>
           <a:xfrm>
-            <a:off x="10018776" y="1965960"/>
-            <a:ext cx="1420368" cy="982980"/>
+            <a:off x="6766560" y="3282696"/>
+            <a:ext cx="1728216" cy="502920"/>
           </a:xfrm>
           <a:prstGeom prst="rect">
             <a:avLst/>
@@ -18828,27 +19710,27 @@
               <a:buNone/>
             </a:pPr>
             <a:r>
-              <a:rPr lang="en-US" sz="2600" b="1" dirty="0">
+              <a:rPr lang="en-US" sz="2400" b="1" dirty="0">
                 <a:solidFill>
                   <a:schemeClr val="accent1"/>
                 </a:solidFill>
               </a:rPr>
               <a:t>C1–C8</a:t>
             </a:r>
-            <a:endParaRPr lang="en-US" sz="2600" dirty="0"/>
+            <a:endParaRPr lang="en-US" sz="2400" dirty="0"/>
           </a:p>
         </p:txBody>
       </p:sp>
       <p:sp>
         <p:nvSpPr>
-          <p:cNvPr id="182" name="label tiers by exact element count"/>
+          <p:cNvPr id="218" name="glance label C1–C8"/>
           <p:cNvSpPr txBox="1"/>
           <p:nvPr/>
         </p:nvSpPr>
         <p:spPr>
           <a:xfrm>
-            <a:off x="10018776" y="3014777"/>
-            <a:ext cx="1420368" cy="747065"/>
+            <a:off x="6766560" y="3794760"/>
+            <a:ext cx="1728216" cy="502920"/>
           </a:xfrm>
           <a:prstGeom prst="rect">
             <a:avLst/>
@@ -18869,7 +19751,7 @@
                   <a:srgbClr val="52514E"/>
                 </a:solidFill>
               </a:rPr>
-              <a:t>tiers by exact element count</a:t>
+              <a:t>eight tiers by exact element count</a:t>
             </a:r>
             <a:endParaRPr lang="en-US" sz="1150" dirty="0"/>
           </a:p>
@@ -18877,18 +19759,18 @@
       </p:sp>
       <p:sp>
         <p:nvSpPr>
-          <p:cNvPr id="183" name="tile the brief, not the answer"/>
-          <p:cNvSpPr/>
-          <p:nvPr/>
-        </p:nvSpPr>
-        <p:spPr>
-          <a:xfrm>
-            <a:off x="5806440" y="4023360"/>
-            <a:ext cx="1822704" cy="1965960"/>
+          <p:cNvPr id="219" name="glance 0 labels"/>
+          <p:cNvSpPr/>
+          <p:nvPr/>
+        </p:nvSpPr>
+        <p:spPr>
+          <a:xfrm>
+            <a:off x="8814816" y="3172968"/>
+            <a:ext cx="2825496" cy="1188720"/>
           </a:xfrm>
           <a:prstGeom prst="roundRect">
             <a:avLst>
-              <a:gd name="adj" fmla="val 3512"/>
+              <a:gd name="adj" fmla="val 5385"/>
             </a:avLst>
           </a:prstGeom>
           <a:solidFill>
@@ -18899,14 +19781,58 @@
       </p:sp>
       <p:sp>
         <p:nvSpPr>
-          <p:cNvPr id="184" name="value the brief, not the answer"/>
+          <p:cNvPr id="220" name="icon ring glance 0 labels"/>
+          <p:cNvSpPr/>
+          <p:nvPr/>
+        </p:nvSpPr>
+        <p:spPr>
+          <a:xfrm>
+            <a:off x="9015984" y="3474720"/>
+            <a:ext cx="585216" cy="585216"/>
+          </a:xfrm>
+          <a:prstGeom prst="ellipse">
+            <a:avLst/>
+          </a:prstGeom>
+          <a:solidFill>
+            <a:schemeClr val="accent1"/>
+          </a:solidFill>
+          <a:ln/>
+        </p:spPr>
+      </p:sp>
+      <p:pic>
+        <p:nvPicPr>
+          <p:cNvPr id="221" name="icon glance 0 labels" descr="preencoded.png">    </p:cNvPr>
+          <p:cNvPicPr>
+            <a:picLocks noChangeAspect="1"/>
+          </p:cNvPicPr>
+          <p:nvPr/>
+        </p:nvPicPr>
+        <p:blipFill>
+          <a:blip r:embed="rId4"/>
+          <a:stretch>
+            <a:fillRect/>
+          </a:stretch>
+        </p:blipFill>
+        <p:spPr>
+          <a:xfrm>
+            <a:off x="9138879" y="3597615"/>
+            <a:ext cx="339425" cy="339425"/>
+          </a:xfrm>
+          <a:prstGeom prst="rect">
+            <a:avLst/>
+          </a:prstGeom>
+        </p:spPr>
+      </p:pic>
+      <p:sp>
+        <p:nvSpPr>
+          <p:cNvPr id="222" name="glance value 0 labels"/>
           <p:cNvSpPr txBox="1"/>
           <p:nvPr/>
         </p:nvSpPr>
         <p:spPr>
           <a:xfrm>
-            <a:off x="6007608" y="4114800"/>
-            <a:ext cx="1420368" cy="982980"/>
+            <a:off x="9774936" y="3282696"/>
+            <a:ext cx="1728216" cy="502920"/>
           </a:xfrm>
           <a:prstGeom prst="rect">
             <a:avLst/>
@@ -18922,27 +19848,27 @@
               <a:buNone/>
             </a:pPr>
             <a:r>
-              <a:rPr lang="en-US" sz="2600" b="1" dirty="0">
+              <a:rPr lang="en-US" sz="2400" b="1" dirty="0">
                 <a:solidFill>
                   <a:schemeClr val="accent1"/>
                 </a:solidFill>
               </a:rPr>
               <a:t>0 labels</a:t>
             </a:r>
-            <a:endParaRPr lang="en-US" sz="2600" dirty="0"/>
+            <a:endParaRPr lang="en-US" sz="2400" dirty="0"/>
           </a:p>
         </p:txBody>
       </p:sp>
       <p:sp>
         <p:nvSpPr>
-          <p:cNvPr id="185" name="label the brief, not the answer"/>
+          <p:cNvPr id="223" name="glance label 0 labels"/>
           <p:cNvSpPr txBox="1"/>
           <p:nvPr/>
         </p:nvSpPr>
         <p:spPr>
           <a:xfrm>
-            <a:off x="6007608" y="5163617"/>
-            <a:ext cx="1420368" cy="747065"/>
+            <a:off x="9774936" y="3794760"/>
+            <a:ext cx="1728216" cy="502920"/>
           </a:xfrm>
           <a:prstGeom prst="rect">
             <a:avLst/>
@@ -18971,18 +19897,18 @@
       </p:sp>
       <p:sp>
         <p:nvSpPr>
-          <p:cNvPr id="186" name="tile every constant sourced or declared"/>
-          <p:cNvSpPr/>
-          <p:nvPr/>
-        </p:nvSpPr>
-        <p:spPr>
-          <a:xfrm>
-            <a:off x="7812024" y="4023360"/>
-            <a:ext cx="1822704" cy="1965960"/>
+          <p:cNvPr id="224" name="glance Traced"/>
+          <p:cNvSpPr/>
+          <p:nvPr/>
+        </p:nvSpPr>
+        <p:spPr>
+          <a:xfrm>
+            <a:off x="5806440" y="4517136"/>
+            <a:ext cx="2825496" cy="1188720"/>
           </a:xfrm>
           <a:prstGeom prst="roundRect">
             <a:avLst>
-              <a:gd name="adj" fmla="val 3512"/>
+              <a:gd name="adj" fmla="val 5385"/>
             </a:avLst>
           </a:prstGeom>
           <a:solidFill>
@@ -18993,14 +19919,58 @@
       </p:sp>
       <p:sp>
         <p:nvSpPr>
-          <p:cNvPr id="187" name="value every constant sourced or declared"/>
+          <p:cNvPr id="225" name="icon ring glance Traced"/>
+          <p:cNvSpPr/>
+          <p:nvPr/>
+        </p:nvSpPr>
+        <p:spPr>
+          <a:xfrm>
+            <a:off x="6007608" y="4818888"/>
+            <a:ext cx="585216" cy="585216"/>
+          </a:xfrm>
+          <a:prstGeom prst="ellipse">
+            <a:avLst/>
+          </a:prstGeom>
+          <a:solidFill>
+            <a:schemeClr val="accent1"/>
+          </a:solidFill>
+          <a:ln/>
+        </p:spPr>
+      </p:sp>
+      <p:pic>
+        <p:nvPicPr>
+          <p:cNvPr id="226" name="icon glance Traced" descr="preencoded.png">    </p:cNvPr>
+          <p:cNvPicPr>
+            <a:picLocks noChangeAspect="1"/>
+          </p:cNvPicPr>
+          <p:nvPr/>
+        </p:nvPicPr>
+        <p:blipFill>
+          <a:blip r:embed="rId5"/>
+          <a:stretch>
+            <a:fillRect/>
+          </a:stretch>
+        </p:blipFill>
+        <p:spPr>
+          <a:xfrm>
+            <a:off x="6130503" y="4941783"/>
+            <a:ext cx="339425" cy="339425"/>
+          </a:xfrm>
+          <a:prstGeom prst="rect">
+            <a:avLst/>
+          </a:prstGeom>
+        </p:spPr>
+      </p:pic>
+      <p:sp>
+        <p:nvSpPr>
+          <p:cNvPr id="227" name="glance value Traced"/>
           <p:cNvSpPr txBox="1"/>
           <p:nvPr/>
         </p:nvSpPr>
         <p:spPr>
           <a:xfrm>
-            <a:off x="8013192" y="4114800"/>
-            <a:ext cx="1420368" cy="982980"/>
+            <a:off x="6766560" y="4626864"/>
+            <a:ext cx="1728216" cy="502920"/>
           </a:xfrm>
           <a:prstGeom prst="rect">
             <a:avLst/>
@@ -19016,27 +19986,27 @@
               <a:buNone/>
             </a:pPr>
             <a:r>
-              <a:rPr lang="en-US" sz="2600" b="1" dirty="0">
+              <a:rPr lang="en-US" sz="2400" b="1" dirty="0">
                 <a:solidFill>
                   <a:schemeClr val="accent1"/>
                 </a:solidFill>
               </a:rPr>
               <a:t>Traced</a:t>
             </a:r>
-            <a:endParaRPr lang="en-US" sz="2600" dirty="0"/>
+            <a:endParaRPr lang="en-US" sz="2400" dirty="0"/>
           </a:p>
         </p:txBody>
       </p:sp>
       <p:sp>
         <p:nvSpPr>
-          <p:cNvPr id="188" name="label every constant sourced or declared"/>
+          <p:cNvPr id="228" name="glance label Traced"/>
           <p:cNvSpPr txBox="1"/>
           <p:nvPr/>
         </p:nvSpPr>
         <p:spPr>
           <a:xfrm>
-            <a:off x="8013192" y="5163617"/>
-            <a:ext cx="1420368" cy="747065"/>
+            <a:off x="6766560" y="5138928"/>
+            <a:ext cx="1728216" cy="502920"/>
           </a:xfrm>
           <a:prstGeom prst="rect">
             <a:avLst/>
@@ -19065,18 +20035,18 @@
       </p:sp>
       <p:sp>
         <p:nvSpPr>
-          <p:cNvPr id="189" name="tile data CC BY 4.0, code MIT"/>
-          <p:cNvSpPr/>
-          <p:nvPr/>
-        </p:nvSpPr>
-        <p:spPr>
-          <a:xfrm>
-            <a:off x="9817608" y="4023360"/>
-            <a:ext cx="1822704" cy="1965960"/>
+          <p:cNvPr id="229" name="glance Open"/>
+          <p:cNvSpPr/>
+          <p:nvPr/>
+        </p:nvSpPr>
+        <p:spPr>
+          <a:xfrm>
+            <a:off x="8814816" y="4517136"/>
+            <a:ext cx="2825496" cy="1188720"/>
           </a:xfrm>
           <a:prstGeom prst="roundRect">
             <a:avLst>
-              <a:gd name="adj" fmla="val 3512"/>
+              <a:gd name="adj" fmla="val 5385"/>
             </a:avLst>
           </a:prstGeom>
           <a:solidFill>
@@ -19087,14 +20057,58 @@
       </p:sp>
       <p:sp>
         <p:nvSpPr>
-          <p:cNvPr id="190" name="value data CC BY 4.0, code MIT"/>
+          <p:cNvPr id="230" name="icon ring glance Open"/>
+          <p:cNvSpPr/>
+          <p:nvPr/>
+        </p:nvSpPr>
+        <p:spPr>
+          <a:xfrm>
+            <a:off x="9015984" y="4818888"/>
+            <a:ext cx="585216" cy="585216"/>
+          </a:xfrm>
+          <a:prstGeom prst="ellipse">
+            <a:avLst/>
+          </a:prstGeom>
+          <a:solidFill>
+            <a:schemeClr val="accent1"/>
+          </a:solidFill>
+          <a:ln/>
+        </p:spPr>
+      </p:sp>
+      <p:pic>
+        <p:nvPicPr>
+          <p:cNvPr id="231" name="icon glance Open" descr="preencoded.png">    </p:cNvPr>
+          <p:cNvPicPr>
+            <a:picLocks noChangeAspect="1"/>
+          </p:cNvPicPr>
+          <p:nvPr/>
+        </p:nvPicPr>
+        <p:blipFill>
+          <a:blip r:embed="rId6"/>
+          <a:stretch>
+            <a:fillRect/>
+          </a:stretch>
+        </p:blipFill>
+        <p:spPr>
+          <a:xfrm>
+            <a:off x="9138879" y="4941783"/>
+            <a:ext cx="339425" cy="339425"/>
+          </a:xfrm>
+          <a:prstGeom prst="rect">
+            <a:avLst/>
+          </a:prstGeom>
+        </p:spPr>
+      </p:pic>
+      <p:sp>
+        <p:nvSpPr>
+          <p:cNvPr id="232" name="glance value Open"/>
           <p:cNvSpPr txBox="1"/>
           <p:nvPr/>
         </p:nvSpPr>
         <p:spPr>
           <a:xfrm>
-            <a:off x="10018776" y="4114800"/>
-            <a:ext cx="1420368" cy="982980"/>
+            <a:off x="9774936" y="4626864"/>
+            <a:ext cx="1728216" cy="502920"/>
           </a:xfrm>
           <a:prstGeom prst="rect">
             <a:avLst/>
@@ -19110,27 +20124,27 @@
               <a:buNone/>
             </a:pPr>
             <a:r>
-              <a:rPr lang="en-US" sz="2600" b="1" dirty="0">
+              <a:rPr lang="en-US" sz="2400" b="1" dirty="0">
                 <a:solidFill>
                   <a:schemeClr val="accent1"/>
                 </a:solidFill>
               </a:rPr>
               <a:t>Open</a:t>
             </a:r>
-            <a:endParaRPr lang="en-US" sz="2600" dirty="0"/>
+            <a:endParaRPr lang="en-US" sz="2400" dirty="0"/>
           </a:p>
         </p:txBody>
       </p:sp>
       <p:sp>
         <p:nvSpPr>
-          <p:cNvPr id="191" name="label data CC BY 4.0, code MIT"/>
+          <p:cNvPr id="233" name="glance label Open"/>
           <p:cNvSpPr txBox="1"/>
           <p:nvPr/>
         </p:nvSpPr>
         <p:spPr>
           <a:xfrm>
-            <a:off x="10018776" y="5163617"/>
-            <a:ext cx="1420368" cy="747065"/>
+            <a:off x="9774936" y="5138928"/>
+            <a:ext cx="1728216" cy="502920"/>
           </a:xfrm>
           <a:prstGeom prst="rect">
             <a:avLst/>
@@ -19151,7 +20165,7 @@
                   <a:srgbClr val="52514E"/>
                 </a:solidFill>
               </a:rPr>
-              <a:t>data CC BY 4.0, code MIT</a:t>
+              <a:t>data CC BY 4.0, code MIT, seeded generator</a:t>
             </a:r>
             <a:endParaRPr lang="en-US" sz="1150" dirty="0"/>
           </a:p>

</xml_diff>

<commit_message>
Talk: slide 7 rebuilt as the section, the record as a table, three facts and the absent band
Co-Authored-By: Claude Fable 5.1 <noreply@anthropic.com>
Claude-Session: https://claude.ai/code/session_01R1ft1rokeRJHR95rzLxNEC
</commit_message>
<xml_diff>
--- a/docs/CrossMEP_CIBW78_talk.pptx
+++ b/docs/CrossMEP_CIBW78_talk.pptx
@@ -124,12 +124,12 @@
   <p:extLst>
     <p:ext uri="{521415D9-36F7-43E2-AB2F-B90AF26B5E84}">
       <p14:sectionLst xmlns:p14="http://schemas.microsoft.com/office/powerpoint/2010/main">
-        <p14:section name="Opening" id="{fac17887-2821-2f7a-9895-4bfe5f9a0156}">
+        <p14:section name="Opening" id="{e27ff116-1ccd-9c27-6b2f-0734f46ab4cc}">
           <p14:sldIdLst>
             <p14:sldId id="256"/>
           </p14:sldIdLst>
         </p14:section>
-        <p14:section name="Motivation" id="{83e74715-7f66-b7e2-28fe-09d164261fb6}">
+        <p14:section name="Motivation" id="{6ce3a230-53d8-e1d1-70df-03d2e53c4c32}">
           <p14:sldIdLst>
             <p14:sldId id="257"/>
             <p14:sldId id="258"/>
@@ -138,7 +138,7 @@
             <p14:sldId id="261"/>
           </p14:sldIdLst>
         </p14:section>
-        <p14:section name="The dataset" id="{709f30f9-bf3b-a126-bc38-f0618633a07f}">
+        <p14:section name="The dataset" id="{788fc9c9-fc18-ac66-06ca-4923dcc6a267}">
           <p14:sldIdLst>
             <p14:sldId id="262"/>
             <p14:sldId id="263"/>
@@ -147,14 +147,14 @@
             <p14:sldId id="266"/>
           </p14:sldIdLst>
         </p14:section>
-        <p14:section name="Experiments" id="{8928fe26-e890-1ec0-1c45-95abe83039e0}">
+        <p14:section name="Experiments" id="{045e68fa-2344-700d-f405-f6d802a982d6}">
           <p14:sldIdLst>
             <p14:sldId id="267"/>
             <p14:sldId id="268"/>
             <p14:sldId id="269"/>
           </p14:sldIdLst>
         </p14:section>
-        <p14:section name="Use" id="{d4c47090-b65e-a9c6-4417-192b65f62e43}">
+        <p14:section name="Use" id="{20cd651a-bf81-13f0-70e6-91c7531796f7}">
           <p14:sldIdLst>
             <p14:sldId id="270"/>
             <p14:sldId id="271"/>
@@ -20281,7 +20281,7 @@
       </p:sp>
       <p:pic>
         <p:nvPicPr>
-          <p:cNvPr id="3" name="context figure" descr="/home/user/crossmep_dataset/docs/figures/01_what_a_context_is.png">    </p:cNvPr>
+          <p:cNvPr id="3" name="context section" descr="preencoded.png">    </p:cNvPr>
           <p:cNvPicPr>
             <a:picLocks noChangeAspect="1"/>
           </p:cNvPicPr>
@@ -20295,8 +20295,8 @@
         </p:blipFill>
         <p:spPr>
           <a:xfrm>
-            <a:off x="1174606" y="1325880"/>
-            <a:ext cx="9839739" cy="4526280"/>
+            <a:off x="548640" y="1325880"/>
+            <a:ext cx="5760720" cy="3532517"/>
           </a:xfrm>
           <a:prstGeom prst="rect">
             <a:avLst/>
@@ -20305,14 +20305,14 @@
       </p:pic>
       <p:sp>
         <p:nvSpPr>
-          <p:cNvPr id="4" name="context caption"/>
+          <p:cNvPr id="4" name="fields heading"/>
           <p:cNvSpPr txBox="1"/>
           <p:nvPr/>
         </p:nvSpPr>
         <p:spPr>
           <a:xfrm>
-            <a:off x="548640" y="5943600"/>
-            <a:ext cx="11091672" cy="502920"/>
+            <a:off x="548640" y="5440680"/>
+            <a:ext cx="5760720" cy="274320"/>
           </a:xfrm>
           <a:prstGeom prst="rect">
             <a:avLst/>
@@ -20321,21 +20321,3350 @@
           <a:ln/>
         </p:spPr>
         <p:txBody>
-          <a:bodyPr wrap="square" lIns="0" tIns="0" rIns="0" bIns="0" rtlCol="0" anchor="t"/>
+          <a:bodyPr wrap="square" lIns="0" tIns="0" rIns="0" bIns="0" rtlCol="0" anchor="ctr"/>
           <a:lstStyle/>
           <a:p>
             <a:pPr indent="0" marL="0">
               <a:buNone/>
             </a:pPr>
             <a:r>
-              <a:rPr lang="en-US" sz="1100" dirty="0">
+              <a:rPr lang="en-US" sz="1200" b="1" dirty="0">
+                <a:solidFill>
+                  <a:schemeClr val="tx1"/>
+                </a:solidFill>
+              </a:rPr>
+              <a:t>What every element carries</a:t>
+            </a:r>
+            <a:endParaRPr lang="en-US" sz="1200" dirty="0"/>
+          </a:p>
+        </p:txBody>
+      </p:sp>
+      <p:sp>
+        <p:nvSpPr>
+          <p:cNvPr id="5" name="chip kind"/>
+          <p:cNvSpPr/>
+          <p:nvPr/>
+        </p:nvSpPr>
+        <p:spPr>
+          <a:xfrm>
+            <a:off x="548640" y="5760720"/>
+            <a:ext cx="453542" cy="310896"/>
+          </a:xfrm>
+          <a:prstGeom prst="roundRect">
+            <a:avLst>
+              <a:gd name="adj" fmla="val 50000"/>
+            </a:avLst>
+          </a:prstGeom>
+          <a:solidFill>
+            <a:srgbClr val="EEF1F4"/>
+          </a:solidFill>
+          <a:ln w="9525">
+            <a:solidFill>
+              <a:srgbClr val="E1E0D9"/>
+            </a:solidFill>
+            <a:prstDash val="solid"/>
+          </a:ln>
+        </p:spPr>
+      </p:sp>
+      <p:sp>
+        <p:nvSpPr>
+          <p:cNvPr id="6" name="chip text kind"/>
+          <p:cNvSpPr txBox="1"/>
+          <p:nvPr/>
+        </p:nvSpPr>
+        <p:spPr>
+          <a:xfrm>
+            <a:off x="548640" y="5760720"/>
+            <a:ext cx="453542" cy="310896"/>
+          </a:xfrm>
+          <a:prstGeom prst="rect">
+            <a:avLst/>
+          </a:prstGeom>
+          <a:noFill/>
+          <a:ln/>
+        </p:spPr>
+        <p:txBody>
+          <a:bodyPr wrap="square" lIns="0" tIns="0" rIns="0" bIns="0" rtlCol="0" anchor="ctr"/>
+          <a:lstStyle/>
+          <a:p>
+            <a:pPr algn="ctr" indent="0" marL="0">
+              <a:buNone/>
+            </a:pPr>
+            <a:r>
+              <a:rPr lang="en-US" sz="1000" dirty="0">
+                <a:solidFill>
+                  <a:schemeClr val="tx1"/>
+                </a:solidFill>
+              </a:rPr>
+              <a:t>kind</a:t>
+            </a:r>
+            <a:endParaRPr lang="en-US" sz="1000" dirty="0"/>
+          </a:p>
+        </p:txBody>
+      </p:sp>
+      <p:sp>
+        <p:nvSpPr>
+          <p:cNvPr id="7" name="chip service, trade"/>
+          <p:cNvSpPr/>
+          <p:nvPr/>
+        </p:nvSpPr>
+        <p:spPr>
+          <a:xfrm>
+            <a:off x="1111910" y="5760720"/>
+            <a:ext cx="1038758" cy="310896"/>
+          </a:xfrm>
+          <a:prstGeom prst="roundRect">
+            <a:avLst>
+              <a:gd name="adj" fmla="val 50000"/>
+            </a:avLst>
+          </a:prstGeom>
+          <a:solidFill>
+            <a:srgbClr val="EEF1F4"/>
+          </a:solidFill>
+          <a:ln w="9525">
+            <a:solidFill>
+              <a:srgbClr val="E1E0D9"/>
+            </a:solidFill>
+            <a:prstDash val="solid"/>
+          </a:ln>
+        </p:spPr>
+      </p:sp>
+      <p:sp>
+        <p:nvSpPr>
+          <p:cNvPr id="8" name="chip text service, trade"/>
+          <p:cNvSpPr txBox="1"/>
+          <p:nvPr/>
+        </p:nvSpPr>
+        <p:spPr>
+          <a:xfrm>
+            <a:off x="1111910" y="5760720"/>
+            <a:ext cx="1038758" cy="310896"/>
+          </a:xfrm>
+          <a:prstGeom prst="rect">
+            <a:avLst/>
+          </a:prstGeom>
+          <a:noFill/>
+          <a:ln/>
+        </p:spPr>
+        <p:txBody>
+          <a:bodyPr wrap="square" lIns="0" tIns="0" rIns="0" bIns="0" rtlCol="0" anchor="ctr"/>
+          <a:lstStyle/>
+          <a:p>
+            <a:pPr algn="ctr" indent="0" marL="0">
+              <a:buNone/>
+            </a:pPr>
+            <a:r>
+              <a:rPr lang="en-US" sz="1000" dirty="0">
+                <a:solidFill>
+                  <a:schemeClr val="tx1"/>
+                </a:solidFill>
+              </a:rPr>
+              <a:t>service, trade</a:t>
+            </a:r>
+            <a:endParaRPr lang="en-US" sz="1000" dirty="0"/>
+          </a:p>
+        </p:txBody>
+      </p:sp>
+      <p:sp>
+        <p:nvSpPr>
+          <p:cNvPr id="9" name="chip size"/>
+          <p:cNvSpPr/>
+          <p:nvPr/>
+        </p:nvSpPr>
+        <p:spPr>
+          <a:xfrm>
+            <a:off x="2260397" y="5760720"/>
+            <a:ext cx="453542" cy="310896"/>
+          </a:xfrm>
+          <a:prstGeom prst="roundRect">
+            <a:avLst>
+              <a:gd name="adj" fmla="val 50000"/>
+            </a:avLst>
+          </a:prstGeom>
+          <a:solidFill>
+            <a:srgbClr val="EEF1F4"/>
+          </a:solidFill>
+          <a:ln w="9525">
+            <a:solidFill>
+              <a:srgbClr val="E1E0D9"/>
+            </a:solidFill>
+            <a:prstDash val="solid"/>
+          </a:ln>
+        </p:spPr>
+      </p:sp>
+      <p:sp>
+        <p:nvSpPr>
+          <p:cNvPr id="10" name="chip text size"/>
+          <p:cNvSpPr txBox="1"/>
+          <p:nvPr/>
+        </p:nvSpPr>
+        <p:spPr>
+          <a:xfrm>
+            <a:off x="2260397" y="5760720"/>
+            <a:ext cx="453542" cy="310896"/>
+          </a:xfrm>
+          <a:prstGeom prst="rect">
+            <a:avLst/>
+          </a:prstGeom>
+          <a:noFill/>
+          <a:ln/>
+        </p:spPr>
+        <p:txBody>
+          <a:bodyPr wrap="square" lIns="0" tIns="0" rIns="0" bIns="0" rtlCol="0" anchor="ctr"/>
+          <a:lstStyle/>
+          <a:p>
+            <a:pPr algn="ctr" indent="0" marL="0">
+              <a:buNone/>
+            </a:pPr>
+            <a:r>
+              <a:rPr lang="en-US" sz="1000" dirty="0">
+                <a:solidFill>
+                  <a:schemeClr val="tx1"/>
+                </a:solidFill>
+              </a:rPr>
+              <a:t>size</a:t>
+            </a:r>
+            <a:endParaRPr lang="en-US" sz="1000" dirty="0"/>
+          </a:p>
+        </p:txBody>
+      </p:sp>
+      <p:sp>
+        <p:nvSpPr>
+          <p:cNvPr id="11" name="chip insulation"/>
+          <p:cNvSpPr/>
+          <p:nvPr/>
+        </p:nvSpPr>
+        <p:spPr>
+          <a:xfrm>
+            <a:off x="2823667" y="5760720"/>
+            <a:ext cx="804672" cy="310896"/>
+          </a:xfrm>
+          <a:prstGeom prst="roundRect">
+            <a:avLst>
+              <a:gd name="adj" fmla="val 50000"/>
+            </a:avLst>
+          </a:prstGeom>
+          <a:solidFill>
+            <a:srgbClr val="EEF1F4"/>
+          </a:solidFill>
+          <a:ln w="9525">
+            <a:solidFill>
+              <a:srgbClr val="E1E0D9"/>
+            </a:solidFill>
+            <a:prstDash val="solid"/>
+          </a:ln>
+        </p:spPr>
+      </p:sp>
+      <p:sp>
+        <p:nvSpPr>
+          <p:cNvPr id="12" name="chip text insulation"/>
+          <p:cNvSpPr txBox="1"/>
+          <p:nvPr/>
+        </p:nvSpPr>
+        <p:spPr>
+          <a:xfrm>
+            <a:off x="2823667" y="5760720"/>
+            <a:ext cx="804672" cy="310896"/>
+          </a:xfrm>
+          <a:prstGeom prst="rect">
+            <a:avLst/>
+          </a:prstGeom>
+          <a:noFill/>
+          <a:ln/>
+        </p:spPr>
+        <p:txBody>
+          <a:bodyPr wrap="square" lIns="0" tIns="0" rIns="0" bIns="0" rtlCol="0" anchor="ctr"/>
+          <a:lstStyle/>
+          <a:p>
+            <a:pPr algn="ctr" indent="0" marL="0">
+              <a:buNone/>
+            </a:pPr>
+            <a:r>
+              <a:rPr lang="en-US" sz="1000" dirty="0">
+                <a:solidFill>
+                  <a:schemeClr val="tx1"/>
+                </a:solidFill>
+              </a:rPr>
+              <a:t>insulation</a:t>
+            </a:r>
+            <a:endParaRPr lang="en-US" sz="1000" dirty="0"/>
+          </a:p>
+        </p:txBody>
+      </p:sp>
+      <p:sp>
+        <p:nvSpPr>
+          <p:cNvPr id="13" name="chip position"/>
+          <p:cNvSpPr/>
+          <p:nvPr/>
+        </p:nvSpPr>
+        <p:spPr>
+          <a:xfrm>
+            <a:off x="3738067" y="5760720"/>
+            <a:ext cx="687629" cy="310896"/>
+          </a:xfrm>
+          <a:prstGeom prst="roundRect">
+            <a:avLst>
+              <a:gd name="adj" fmla="val 50000"/>
+            </a:avLst>
+          </a:prstGeom>
+          <a:solidFill>
+            <a:srgbClr val="EEF1F4"/>
+          </a:solidFill>
+          <a:ln w="9525">
+            <a:solidFill>
+              <a:srgbClr val="E1E0D9"/>
+            </a:solidFill>
+            <a:prstDash val="solid"/>
+          </a:ln>
+        </p:spPr>
+      </p:sp>
+      <p:sp>
+        <p:nvSpPr>
+          <p:cNvPr id="14" name="chip text position"/>
+          <p:cNvSpPr txBox="1"/>
+          <p:nvPr/>
+        </p:nvSpPr>
+        <p:spPr>
+          <a:xfrm>
+            <a:off x="3738067" y="5760720"/>
+            <a:ext cx="687629" cy="310896"/>
+          </a:xfrm>
+          <a:prstGeom prst="rect">
+            <a:avLst/>
+          </a:prstGeom>
+          <a:noFill/>
+          <a:ln/>
+        </p:spPr>
+        <p:txBody>
+          <a:bodyPr wrap="square" lIns="0" tIns="0" rIns="0" bIns="0" rtlCol="0" anchor="ctr"/>
+          <a:lstStyle/>
+          <a:p>
+            <a:pPr algn="ctr" indent="0" marL="0">
+              <a:buNone/>
+            </a:pPr>
+            <a:r>
+              <a:rPr lang="en-US" sz="1000" dirty="0">
+                <a:solidFill>
+                  <a:schemeClr val="tx1"/>
+                </a:solidFill>
+              </a:rPr>
+              <a:t>position</a:t>
+            </a:r>
+            <a:endParaRPr lang="en-US" sz="1000" dirty="0"/>
+          </a:p>
+        </p:txBody>
+      </p:sp>
+      <p:sp>
+        <p:nvSpPr>
+          <p:cNvPr id="15" name="chip load = kN/m × span"/>
+          <p:cNvSpPr/>
+          <p:nvPr/>
+        </p:nvSpPr>
+        <p:spPr>
+          <a:xfrm>
+            <a:off x="4535424" y="5760720"/>
+            <a:ext cx="1272845" cy="310896"/>
+          </a:xfrm>
+          <a:prstGeom prst="roundRect">
+            <a:avLst>
+              <a:gd name="adj" fmla="val 50000"/>
+            </a:avLst>
+          </a:prstGeom>
+          <a:solidFill>
+            <a:srgbClr val="EEF1F4"/>
+          </a:solidFill>
+          <a:ln w="9525">
+            <a:solidFill>
+              <a:srgbClr val="E1E0D9"/>
+            </a:solidFill>
+            <a:prstDash val="solid"/>
+          </a:ln>
+        </p:spPr>
+      </p:sp>
+      <p:sp>
+        <p:nvSpPr>
+          <p:cNvPr id="16" name="chip text load = kN/m × span"/>
+          <p:cNvSpPr txBox="1"/>
+          <p:nvPr/>
+        </p:nvSpPr>
+        <p:spPr>
+          <a:xfrm>
+            <a:off x="4535424" y="5760720"/>
+            <a:ext cx="1272845" cy="310896"/>
+          </a:xfrm>
+          <a:prstGeom prst="rect">
+            <a:avLst/>
+          </a:prstGeom>
+          <a:noFill/>
+          <a:ln/>
+        </p:spPr>
+        <p:txBody>
+          <a:bodyPr wrap="square" lIns="0" tIns="0" rIns="0" bIns="0" rtlCol="0" anchor="ctr"/>
+          <a:lstStyle/>
+          <a:p>
+            <a:pPr algn="ctr" indent="0" marL="0">
+              <a:buNone/>
+            </a:pPr>
+            <a:r>
+              <a:rPr lang="en-US" sz="1000" dirty="0">
+                <a:solidFill>
+                  <a:schemeClr val="tx1"/>
+                </a:solidFill>
+              </a:rPr>
+              <a:t>load = kN/m × span</a:t>
+            </a:r>
+            <a:endParaRPr lang="en-US" sz="1000" dirty="0"/>
+          </a:p>
+        </p:txBody>
+      </p:sp>
+      <p:sp>
+        <p:nvSpPr>
+          <p:cNvPr id="17" name="given heading"/>
+          <p:cNvSpPr txBox="1"/>
+          <p:nvPr/>
+        </p:nvSpPr>
+        <p:spPr>
+          <a:xfrm>
+            <a:off x="6537960" y="1325880"/>
+            <a:ext cx="5102352" cy="320040"/>
+          </a:xfrm>
+          <a:prstGeom prst="rect">
+            <a:avLst/>
+          </a:prstGeom>
+          <a:noFill/>
+          <a:ln/>
+        </p:spPr>
+        <p:txBody>
+          <a:bodyPr wrap="square" lIns="0" tIns="0" rIns="0" bIns="0" rtlCol="0" anchor="ctr"/>
+          <a:lstStyle/>
+          <a:p>
+            <a:pPr indent="0" marL="0">
+              <a:buNone/>
+            </a:pPr>
+            <a:r>
+              <a:rPr lang="en-US" sz="1400" b="1" dirty="0">
+                <a:solidFill>
+                  <a:schemeClr val="tx1"/>
+                </a:solidFill>
+              </a:rPr>
+              <a:t>What the support designer is given</a:t>
+            </a:r>
+            <a:endParaRPr lang="en-US" sz="1400" dirty="0"/>
+          </a:p>
+        </p:txBody>
+      </p:sp>
+      <p:graphicFrame>
+        <p:nvGraphicFramePr>
+          <p:cNvPr id="8" name="record table"/>
+          <p:cNvGraphicFramePr>
+            <a:graphicFrameLocks noGrp="1"/>
+          </p:cNvGraphicFramePr>
+          <p:nvPr>
+            <p:extLst>
+              <p:ext uri="{D42A27DB-BD31-4B8C-83A1-F6EECF244321}">
+                <p14:modId xmlns:p14="http://schemas.microsoft.com/office/powerpoint/2010/main" val="1579011935"/>
+              </p:ext>
+            </p:extLst>
+          </p:nvPr>
+        </p:nvGraphicFramePr>
+        <p:xfrm>
+          <a:off x="6537960" y="1691640"/>
+          <a:ext cx="5102352" cy="914400"/>
+        </p:xfrm>
+        <a:graphic>
+          <a:graphicData uri="http://schemas.openxmlformats.org/drawingml/2006/table">
+            <a:tbl>
+              <a:tblPr/>
+              <a:tblGrid>
+                <a:gridCol w="914400"/>
+                <a:gridCol w="1371600"/>
+                <a:gridCol w="640080"/>
+                <a:gridCol w="685800"/>
+                <a:gridCol w="621792"/>
+                <a:gridCol w="868680"/>
+              </a:tblGrid>
+              <a:tr h="310896">
+                <a:tc>
+                  <a:txBody>
+                    <a:bodyPr/>
+                    <a:lstStyle/>
+                    <a:p>
+                      <a:pPr algn="l" indent="0" marL="0">
+                        <a:buNone/>
+                      </a:pPr>
+                      <a:r>
+                        <a:rPr lang="en-US" sz="1100" b="1" dirty="0">
+                          <a:solidFill>
+                            <a:srgbClr val="FFFFFF"/>
+                          </a:solidFill>
+                          <a:latin typeface="Aptos" pitchFamily="34" charset="0"/>
+                          <a:ea typeface="Aptos" pitchFamily="34" charset="-122"/>
+                          <a:cs typeface="Aptos" pitchFamily="34" charset="-120"/>
+                        </a:rPr>
+                        <a:t>Element</a:t>
+                      </a:r>
+                      <a:endParaRPr lang="en-US" sz="1100" dirty="0">
+                        <a:latin typeface="Aptos" charset="0"/>
+                        <a:ea typeface="Aptos" charset="0"/>
+                        <a:cs typeface="Aptos" charset="0"/>
+                      </a:endParaRPr>
+                    </a:p>
+                  </a:txBody>
+                  <a:tcPr marL="54864" marR="54864" marT="54864" marB="54864" anchor="ctr">
+                    <a:lnL w="9525" cap="flat" cmpd="sng" algn="ctr">
+                      <a:solidFill>
+                        <a:srgbClr val="E1E0D9"/>
+                      </a:solidFill>
+                      <a:prstDash val="solid"/>
+                      <a:round/>
+                      <a:headEnd type="none" w="med" len="med"/>
+                      <a:tailEnd type="none" w="med" len="med"/>
+                    </a:lnL>
+                    <a:lnR w="9525" cap="flat" cmpd="sng" algn="ctr">
+                      <a:solidFill>
+                        <a:srgbClr val="E1E0D9"/>
+                      </a:solidFill>
+                      <a:prstDash val="solid"/>
+                      <a:round/>
+                      <a:headEnd type="none" w="med" len="med"/>
+                      <a:tailEnd type="none" w="med" len="med"/>
+                    </a:lnR>
+                    <a:lnT w="9525" cap="flat" cmpd="sng" algn="ctr">
+                      <a:solidFill>
+                        <a:srgbClr val="E1E0D9"/>
+                      </a:solidFill>
+                      <a:prstDash val="solid"/>
+                      <a:round/>
+                      <a:headEnd type="none" w="med" len="med"/>
+                      <a:tailEnd type="none" w="med" len="med"/>
+                    </a:lnT>
+                    <a:lnB w="9525" cap="flat" cmpd="sng" algn="ctr">
+                      <a:solidFill>
+                        <a:srgbClr val="E1E0D9"/>
+                      </a:solidFill>
+                      <a:prstDash val="solid"/>
+                      <a:round/>
+                      <a:headEnd type="none" w="med" len="med"/>
+                      <a:tailEnd type="none" w="med" len="med"/>
+                    </a:lnB>
+                    <a:solidFill>
+                      <a:srgbClr val="1F2933"/>
+                    </a:solidFill>
+                  </a:tcPr>
+                </a:tc>
+                <a:tc>
+                  <a:txBody>
+                    <a:bodyPr/>
+                    <a:lstStyle/>
+                    <a:p>
+                      <a:pPr algn="l" indent="0" marL="0">
+                        <a:buNone/>
+                      </a:pPr>
+                      <a:r>
+                        <a:rPr lang="en-US" sz="1100" b="1" dirty="0">
+                          <a:solidFill>
+                            <a:srgbClr val="FFFFFF"/>
+                          </a:solidFill>
+                          <a:latin typeface="Aptos" pitchFamily="34" charset="0"/>
+                          <a:ea typeface="Aptos" pitchFamily="34" charset="-122"/>
+                          <a:cs typeface="Aptos" pitchFamily="34" charset="-120"/>
+                        </a:rPr>
+                        <a:t>Trade</a:t>
+                      </a:r>
+                      <a:endParaRPr lang="en-US" sz="1100" dirty="0">
+                        <a:latin typeface="Aptos" charset="0"/>
+                        <a:ea typeface="Aptos" charset="0"/>
+                        <a:cs typeface="Aptos" charset="0"/>
+                      </a:endParaRPr>
+                    </a:p>
+                  </a:txBody>
+                  <a:tcPr marL="54864" marR="54864" marT="54864" marB="54864" anchor="ctr">
+                    <a:lnL w="9525" cap="flat" cmpd="sng" algn="ctr">
+                      <a:solidFill>
+                        <a:srgbClr val="E1E0D9"/>
+                      </a:solidFill>
+                      <a:prstDash val="solid"/>
+                      <a:round/>
+                      <a:headEnd type="none" w="med" len="med"/>
+                      <a:tailEnd type="none" w="med" len="med"/>
+                    </a:lnL>
+                    <a:lnR w="9525" cap="flat" cmpd="sng" algn="ctr">
+                      <a:solidFill>
+                        <a:srgbClr val="E1E0D9"/>
+                      </a:solidFill>
+                      <a:prstDash val="solid"/>
+                      <a:round/>
+                      <a:headEnd type="none" w="med" len="med"/>
+                      <a:tailEnd type="none" w="med" len="med"/>
+                    </a:lnR>
+                    <a:lnT w="9525" cap="flat" cmpd="sng" algn="ctr">
+                      <a:solidFill>
+                        <a:srgbClr val="E1E0D9"/>
+                      </a:solidFill>
+                      <a:prstDash val="solid"/>
+                      <a:round/>
+                      <a:headEnd type="none" w="med" len="med"/>
+                      <a:tailEnd type="none" w="med" len="med"/>
+                    </a:lnT>
+                    <a:lnB w="9525" cap="flat" cmpd="sng" algn="ctr">
+                      <a:solidFill>
+                        <a:srgbClr val="E1E0D9"/>
+                      </a:solidFill>
+                      <a:prstDash val="solid"/>
+                      <a:round/>
+                      <a:headEnd type="none" w="med" len="med"/>
+                      <a:tailEnd type="none" w="med" len="med"/>
+                    </a:lnB>
+                    <a:solidFill>
+                      <a:srgbClr val="1F2933"/>
+                    </a:solidFill>
+                  </a:tcPr>
+                </a:tc>
+                <a:tc>
+                  <a:txBody>
+                    <a:bodyPr/>
+                    <a:lstStyle/>
+                    <a:p>
+                      <a:pPr algn="r" indent="0" marL="0">
+                        <a:buNone/>
+                      </a:pPr>
+                      <a:r>
+                        <a:rPr lang="en-US" sz="1100" b="1" dirty="0">
+                          <a:solidFill>
+                            <a:srgbClr val="FFFFFF"/>
+                          </a:solidFill>
+                          <a:latin typeface="Aptos" pitchFamily="34" charset="0"/>
+                          <a:ea typeface="Aptos" pitchFamily="34" charset="-122"/>
+                          <a:cs typeface="Aptos" pitchFamily="34" charset="-120"/>
+                        </a:rPr>
+                        <a:t>Ins. mm</a:t>
+                      </a:r>
+                      <a:endParaRPr lang="en-US" sz="1100" dirty="0">
+                        <a:latin typeface="Aptos" charset="0"/>
+                        <a:ea typeface="Aptos" charset="0"/>
+                        <a:cs typeface="Aptos" charset="0"/>
+                      </a:endParaRPr>
+                    </a:p>
+                  </a:txBody>
+                  <a:tcPr marL="54864" marR="54864" marT="54864" marB="54864" anchor="ctr">
+                    <a:lnL w="9525" cap="flat" cmpd="sng" algn="ctr">
+                      <a:solidFill>
+                        <a:srgbClr val="E1E0D9"/>
+                      </a:solidFill>
+                      <a:prstDash val="solid"/>
+                      <a:round/>
+                      <a:headEnd type="none" w="med" len="med"/>
+                      <a:tailEnd type="none" w="med" len="med"/>
+                    </a:lnL>
+                    <a:lnR w="9525" cap="flat" cmpd="sng" algn="ctr">
+                      <a:solidFill>
+                        <a:srgbClr val="E1E0D9"/>
+                      </a:solidFill>
+                      <a:prstDash val="solid"/>
+                      <a:round/>
+                      <a:headEnd type="none" w="med" len="med"/>
+                      <a:tailEnd type="none" w="med" len="med"/>
+                    </a:lnR>
+                    <a:lnT w="9525" cap="flat" cmpd="sng" algn="ctr">
+                      <a:solidFill>
+                        <a:srgbClr val="E1E0D9"/>
+                      </a:solidFill>
+                      <a:prstDash val="solid"/>
+                      <a:round/>
+                      <a:headEnd type="none" w="med" len="med"/>
+                      <a:tailEnd type="none" w="med" len="med"/>
+                    </a:lnT>
+                    <a:lnB w="9525" cap="flat" cmpd="sng" algn="ctr">
+                      <a:solidFill>
+                        <a:srgbClr val="E1E0D9"/>
+                      </a:solidFill>
+                      <a:prstDash val="solid"/>
+                      <a:round/>
+                      <a:headEnd type="none" w="med" len="med"/>
+                      <a:tailEnd type="none" w="med" len="med"/>
+                    </a:lnB>
+                    <a:solidFill>
+                      <a:srgbClr val="1F2933"/>
+                    </a:solidFill>
+                  </a:tcPr>
+                </a:tc>
+                <a:tc>
+                  <a:txBody>
+                    <a:bodyPr/>
+                    <a:lstStyle/>
+                    <a:p>
+                      <a:pPr algn="r" indent="0" marL="0">
+                        <a:buNone/>
+                      </a:pPr>
+                      <a:r>
+                        <a:rPr lang="en-US" sz="1100" b="1" dirty="0">
+                          <a:solidFill>
+                            <a:srgbClr val="FFFFFF"/>
+                          </a:solidFill>
+                          <a:latin typeface="Aptos" pitchFamily="34" charset="0"/>
+                          <a:ea typeface="Aptos" pitchFamily="34" charset="-122"/>
+                          <a:cs typeface="Aptos" pitchFamily="34" charset="-120"/>
+                        </a:rPr>
+                        <a:t>kN/m</a:t>
+                      </a:r>
+                      <a:endParaRPr lang="en-US" sz="1100" dirty="0">
+                        <a:latin typeface="Aptos" charset="0"/>
+                        <a:ea typeface="Aptos" charset="0"/>
+                        <a:cs typeface="Aptos" charset="0"/>
+                      </a:endParaRPr>
+                    </a:p>
+                  </a:txBody>
+                  <a:tcPr marL="54864" marR="54864" marT="54864" marB="54864" anchor="ctr">
+                    <a:lnL w="9525" cap="flat" cmpd="sng" algn="ctr">
+                      <a:solidFill>
+                        <a:srgbClr val="E1E0D9"/>
+                      </a:solidFill>
+                      <a:prstDash val="solid"/>
+                      <a:round/>
+                      <a:headEnd type="none" w="med" len="med"/>
+                      <a:tailEnd type="none" w="med" len="med"/>
+                    </a:lnL>
+                    <a:lnR w="9525" cap="flat" cmpd="sng" algn="ctr">
+                      <a:solidFill>
+                        <a:srgbClr val="E1E0D9"/>
+                      </a:solidFill>
+                      <a:prstDash val="solid"/>
+                      <a:round/>
+                      <a:headEnd type="none" w="med" len="med"/>
+                      <a:tailEnd type="none" w="med" len="med"/>
+                    </a:lnR>
+                    <a:lnT w="9525" cap="flat" cmpd="sng" algn="ctr">
+                      <a:solidFill>
+                        <a:srgbClr val="E1E0D9"/>
+                      </a:solidFill>
+                      <a:prstDash val="solid"/>
+                      <a:round/>
+                      <a:headEnd type="none" w="med" len="med"/>
+                      <a:tailEnd type="none" w="med" len="med"/>
+                    </a:lnT>
+                    <a:lnB w="9525" cap="flat" cmpd="sng" algn="ctr">
+                      <a:solidFill>
+                        <a:srgbClr val="E1E0D9"/>
+                      </a:solidFill>
+                      <a:prstDash val="solid"/>
+                      <a:round/>
+                      <a:headEnd type="none" w="med" len="med"/>
+                      <a:tailEnd type="none" w="med" len="med"/>
+                    </a:lnB>
+                    <a:solidFill>
+                      <a:srgbClr val="1F2933"/>
+                    </a:solidFill>
+                  </a:tcPr>
+                </a:tc>
+                <a:tc>
+                  <a:txBody>
+                    <a:bodyPr/>
+                    <a:lstStyle/>
+                    <a:p>
+                      <a:pPr algn="r" indent="0" marL="0">
+                        <a:buNone/>
+                      </a:pPr>
+                      <a:r>
+                        <a:rPr lang="en-US" sz="1100" b="1" dirty="0">
+                          <a:solidFill>
+                            <a:srgbClr val="FFFFFF"/>
+                          </a:solidFill>
+                          <a:latin typeface="Aptos" pitchFamily="34" charset="0"/>
+                          <a:ea typeface="Aptos" pitchFamily="34" charset="-122"/>
+                          <a:cs typeface="Aptos" pitchFamily="34" charset="-120"/>
+                        </a:rPr>
+                        <a:t>Span</a:t>
+                      </a:r>
+                      <a:endParaRPr lang="en-US" sz="1100" dirty="0">
+                        <a:latin typeface="Aptos" charset="0"/>
+                        <a:ea typeface="Aptos" charset="0"/>
+                        <a:cs typeface="Aptos" charset="0"/>
+                      </a:endParaRPr>
+                    </a:p>
+                  </a:txBody>
+                  <a:tcPr marL="54864" marR="54864" marT="54864" marB="54864" anchor="ctr">
+                    <a:lnL w="9525" cap="flat" cmpd="sng" algn="ctr">
+                      <a:solidFill>
+                        <a:srgbClr val="E1E0D9"/>
+                      </a:solidFill>
+                      <a:prstDash val="solid"/>
+                      <a:round/>
+                      <a:headEnd type="none" w="med" len="med"/>
+                      <a:tailEnd type="none" w="med" len="med"/>
+                    </a:lnL>
+                    <a:lnR w="9525" cap="flat" cmpd="sng" algn="ctr">
+                      <a:solidFill>
+                        <a:srgbClr val="E1E0D9"/>
+                      </a:solidFill>
+                      <a:prstDash val="solid"/>
+                      <a:round/>
+                      <a:headEnd type="none" w="med" len="med"/>
+                      <a:tailEnd type="none" w="med" len="med"/>
+                    </a:lnR>
+                    <a:lnT w="9525" cap="flat" cmpd="sng" algn="ctr">
+                      <a:solidFill>
+                        <a:srgbClr val="E1E0D9"/>
+                      </a:solidFill>
+                      <a:prstDash val="solid"/>
+                      <a:round/>
+                      <a:headEnd type="none" w="med" len="med"/>
+                      <a:tailEnd type="none" w="med" len="med"/>
+                    </a:lnT>
+                    <a:lnB w="9525" cap="flat" cmpd="sng" algn="ctr">
+                      <a:solidFill>
+                        <a:srgbClr val="E1E0D9"/>
+                      </a:solidFill>
+                      <a:prstDash val="solid"/>
+                      <a:round/>
+                      <a:headEnd type="none" w="med" len="med"/>
+                      <a:tailEnd type="none" w="med" len="med"/>
+                    </a:lnB>
+                    <a:solidFill>
+                      <a:srgbClr val="1F2933"/>
+                    </a:solidFill>
+                  </a:tcPr>
+                </a:tc>
+                <a:tc>
+                  <a:txBody>
+                    <a:bodyPr/>
+                    <a:lstStyle/>
+                    <a:p>
+                      <a:pPr algn="r" indent="0" marL="0">
+                        <a:buNone/>
+                      </a:pPr>
+                      <a:r>
+                        <a:rPr lang="en-US" sz="1100" b="1" dirty="0">
+                          <a:solidFill>
+                            <a:srgbClr val="FFFFFF"/>
+                          </a:solidFill>
+                          <a:latin typeface="Aptos" pitchFamily="34" charset="0"/>
+                          <a:ea typeface="Aptos" pitchFamily="34" charset="-122"/>
+                          <a:cs typeface="Aptos" pitchFamily="34" charset="-120"/>
+                        </a:rPr>
+                        <a:t>kN at support</a:t>
+                      </a:r>
+                      <a:endParaRPr lang="en-US" sz="1100" dirty="0">
+                        <a:latin typeface="Aptos" charset="0"/>
+                        <a:ea typeface="Aptos" charset="0"/>
+                        <a:cs typeface="Aptos" charset="0"/>
+                      </a:endParaRPr>
+                    </a:p>
+                  </a:txBody>
+                  <a:tcPr marL="54864" marR="54864" marT="54864" marB="54864" anchor="ctr">
+                    <a:lnL w="9525" cap="flat" cmpd="sng" algn="ctr">
+                      <a:solidFill>
+                        <a:srgbClr val="E1E0D9"/>
+                      </a:solidFill>
+                      <a:prstDash val="solid"/>
+                      <a:round/>
+                      <a:headEnd type="none" w="med" len="med"/>
+                      <a:tailEnd type="none" w="med" len="med"/>
+                    </a:lnL>
+                    <a:lnR w="9525" cap="flat" cmpd="sng" algn="ctr">
+                      <a:solidFill>
+                        <a:srgbClr val="E1E0D9"/>
+                      </a:solidFill>
+                      <a:prstDash val="solid"/>
+                      <a:round/>
+                      <a:headEnd type="none" w="med" len="med"/>
+                      <a:tailEnd type="none" w="med" len="med"/>
+                    </a:lnR>
+                    <a:lnT w="9525" cap="flat" cmpd="sng" algn="ctr">
+                      <a:solidFill>
+                        <a:srgbClr val="E1E0D9"/>
+                      </a:solidFill>
+                      <a:prstDash val="solid"/>
+                      <a:round/>
+                      <a:headEnd type="none" w="med" len="med"/>
+                      <a:tailEnd type="none" w="med" len="med"/>
+                    </a:lnT>
+                    <a:lnB w="9525" cap="flat" cmpd="sng" algn="ctr">
+                      <a:solidFill>
+                        <a:srgbClr val="E1E0D9"/>
+                      </a:solidFill>
+                      <a:prstDash val="solid"/>
+                      <a:round/>
+                      <a:headEnd type="none" w="med" len="med"/>
+                      <a:tailEnd type="none" w="med" len="med"/>
+                    </a:lnB>
+                    <a:solidFill>
+                      <a:srgbClr val="1F2933"/>
+                    </a:solidFill>
+                  </a:tcPr>
+                </a:tc>
+              </a:tr>
+              <a:tr h="310896">
+                <a:tc>
+                  <a:txBody>
+                    <a:bodyPr/>
+                    <a:lstStyle/>
+                    <a:p>
+                      <a:pPr algn="l" indent="0" marL="0">
+                        <a:buNone/>
+                      </a:pPr>
+                      <a:r>
+                        <a:rPr lang="en-US" sz="1150" b="1" dirty="0">
+                          <a:solidFill>
+                            <a:srgbClr val="0B0B0B"/>
+                          </a:solidFill>
+                          <a:latin typeface="Aptos" pitchFamily="34" charset="0"/>
+                          <a:ea typeface="Aptos" pitchFamily="34" charset="-122"/>
+                          <a:cs typeface="Aptos" pitchFamily="34" charset="-120"/>
+                        </a:rPr>
+                        <a:t>600 tray</a:t>
+                      </a:r>
+                      <a:endParaRPr lang="en-US" sz="1150" dirty="0">
+                        <a:latin typeface="Aptos" charset="0"/>
+                        <a:ea typeface="Aptos" charset="0"/>
+                        <a:cs typeface="Aptos" charset="0"/>
+                      </a:endParaRPr>
+                    </a:p>
+                  </a:txBody>
+                  <a:tcPr marL="54864" marR="54864" marT="54864" marB="54864" anchor="ctr">
+                    <a:lnL w="9525" cap="flat" cmpd="sng" algn="ctr">
+                      <a:solidFill>
+                        <a:srgbClr val="E1E0D9"/>
+                      </a:solidFill>
+                      <a:prstDash val="solid"/>
+                      <a:round/>
+                      <a:headEnd type="none" w="med" len="med"/>
+                      <a:tailEnd type="none" w="med" len="med"/>
+                    </a:lnL>
+                    <a:lnR w="9525" cap="flat" cmpd="sng" algn="ctr">
+                      <a:solidFill>
+                        <a:srgbClr val="E1E0D9"/>
+                      </a:solidFill>
+                      <a:prstDash val="solid"/>
+                      <a:round/>
+                      <a:headEnd type="none" w="med" len="med"/>
+                      <a:tailEnd type="none" w="med" len="med"/>
+                    </a:lnR>
+                    <a:lnT w="9525" cap="flat" cmpd="sng" algn="ctr">
+                      <a:solidFill>
+                        <a:srgbClr val="E1E0D9"/>
+                      </a:solidFill>
+                      <a:prstDash val="solid"/>
+                      <a:round/>
+                      <a:headEnd type="none" w="med" len="med"/>
+                      <a:tailEnd type="none" w="med" len="med"/>
+                    </a:lnT>
+                    <a:lnB w="9525" cap="flat" cmpd="sng" algn="ctr">
+                      <a:solidFill>
+                        <a:srgbClr val="E1E0D9"/>
+                      </a:solidFill>
+                      <a:prstDash val="solid"/>
+                      <a:round/>
+                      <a:headEnd type="none" w="med" len="med"/>
+                      <a:tailEnd type="none" w="med" len="med"/>
+                    </a:lnB>
+                  </a:tcPr>
+                </a:tc>
+                <a:tc>
+                  <a:txBody>
+                    <a:bodyPr/>
+                    <a:lstStyle/>
+                    <a:p>
+                      <a:pPr algn="l" indent="0" marL="0">
+                        <a:buNone/>
+                      </a:pPr>
+                      <a:r>
+                        <a:rPr lang="en-US" sz="1150" dirty="0">
+                          <a:solidFill>
+                            <a:srgbClr val="4A3AA7"/>
+                          </a:solidFill>
+                          <a:latin typeface="Aptos" pitchFamily="34" charset="0"/>
+                          <a:ea typeface="Aptos" pitchFamily="34" charset="-122"/>
+                          <a:cs typeface="Aptos" pitchFamily="34" charset="-120"/>
+                        </a:rPr>
+                        <a:t>● </a:t>
+                      </a:r>
+                      <a:pPr algn="l" indent="0" marL="0">
+                        <a:buNone/>
+                      </a:pPr>
+                      <a:r>
+                        <a:rPr lang="en-US" sz="1150" dirty="0">
+                          <a:solidFill>
+                            <a:srgbClr val="0B0B0B"/>
+                          </a:solidFill>
+                          <a:latin typeface="Aptos" pitchFamily="34" charset="0"/>
+                          <a:ea typeface="Aptos" pitchFamily="34" charset="-122"/>
+                          <a:cs typeface="Aptos" pitchFamily="34" charset="-120"/>
+                        </a:rPr>
+                        <a:t>electrical</a:t>
+                      </a:r>
+                      <a:endParaRPr lang="en-US" sz="1150" dirty="0">
+                        <a:latin typeface="Aptos" charset="0"/>
+                        <a:ea typeface="Aptos" charset="0"/>
+                        <a:cs typeface="Aptos" charset="0"/>
+                      </a:endParaRPr>
+                    </a:p>
+                  </a:txBody>
+                  <a:tcPr marL="54864" marR="54864" marT="54864" marB="54864" anchor="ctr">
+                    <a:lnL w="9525" cap="flat" cmpd="sng" algn="ctr">
+                      <a:solidFill>
+                        <a:srgbClr val="E1E0D9"/>
+                      </a:solidFill>
+                      <a:prstDash val="solid"/>
+                      <a:round/>
+                      <a:headEnd type="none" w="med" len="med"/>
+                      <a:tailEnd type="none" w="med" len="med"/>
+                    </a:lnL>
+                    <a:lnR w="9525" cap="flat" cmpd="sng" algn="ctr">
+                      <a:solidFill>
+                        <a:srgbClr val="E1E0D9"/>
+                      </a:solidFill>
+                      <a:prstDash val="solid"/>
+                      <a:round/>
+                      <a:headEnd type="none" w="med" len="med"/>
+                      <a:tailEnd type="none" w="med" len="med"/>
+                    </a:lnR>
+                    <a:lnT w="9525" cap="flat" cmpd="sng" algn="ctr">
+                      <a:solidFill>
+                        <a:srgbClr val="E1E0D9"/>
+                      </a:solidFill>
+                      <a:prstDash val="solid"/>
+                      <a:round/>
+                      <a:headEnd type="none" w="med" len="med"/>
+                      <a:tailEnd type="none" w="med" len="med"/>
+                    </a:lnT>
+                    <a:lnB w="9525" cap="flat" cmpd="sng" algn="ctr">
+                      <a:solidFill>
+                        <a:srgbClr val="E1E0D9"/>
+                      </a:solidFill>
+                      <a:prstDash val="solid"/>
+                      <a:round/>
+                      <a:headEnd type="none" w="med" len="med"/>
+                      <a:tailEnd type="none" w="med" len="med"/>
+                    </a:lnB>
+                  </a:tcPr>
+                </a:tc>
+                <a:tc>
+                  <a:txBody>
+                    <a:bodyPr/>
+                    <a:lstStyle/>
+                    <a:p>
+                      <a:pPr algn="r" indent="0" marL="0">
+                        <a:buNone/>
+                      </a:pPr>
+                      <a:r>
+                        <a:rPr lang="en-US" sz="1150" dirty="0">
+                          <a:solidFill>
+                            <a:srgbClr val="0B0B0B"/>
+                          </a:solidFill>
+                          <a:latin typeface="Aptos" pitchFamily="34" charset="0"/>
+                          <a:ea typeface="Aptos" pitchFamily="34" charset="-122"/>
+                          <a:cs typeface="Aptos" pitchFamily="34" charset="-120"/>
+                        </a:rPr>
+                        <a:t>0</a:t>
+                      </a:r>
+                      <a:endParaRPr lang="en-US" sz="1150" dirty="0">
+                        <a:latin typeface="Aptos" charset="0"/>
+                        <a:ea typeface="Aptos" charset="0"/>
+                        <a:cs typeface="Aptos" charset="0"/>
+                      </a:endParaRPr>
+                    </a:p>
+                  </a:txBody>
+                  <a:tcPr marL="54864" marR="54864" marT="54864" marB="54864" anchor="ctr">
+                    <a:lnL w="9525" cap="flat" cmpd="sng" algn="ctr">
+                      <a:solidFill>
+                        <a:srgbClr val="E1E0D9"/>
+                      </a:solidFill>
+                      <a:prstDash val="solid"/>
+                      <a:round/>
+                      <a:headEnd type="none" w="med" len="med"/>
+                      <a:tailEnd type="none" w="med" len="med"/>
+                    </a:lnL>
+                    <a:lnR w="9525" cap="flat" cmpd="sng" algn="ctr">
+                      <a:solidFill>
+                        <a:srgbClr val="E1E0D9"/>
+                      </a:solidFill>
+                      <a:prstDash val="solid"/>
+                      <a:round/>
+                      <a:headEnd type="none" w="med" len="med"/>
+                      <a:tailEnd type="none" w="med" len="med"/>
+                    </a:lnR>
+                    <a:lnT w="9525" cap="flat" cmpd="sng" algn="ctr">
+                      <a:solidFill>
+                        <a:srgbClr val="E1E0D9"/>
+                      </a:solidFill>
+                      <a:prstDash val="solid"/>
+                      <a:round/>
+                      <a:headEnd type="none" w="med" len="med"/>
+                      <a:tailEnd type="none" w="med" len="med"/>
+                    </a:lnT>
+                    <a:lnB w="9525" cap="flat" cmpd="sng" algn="ctr">
+                      <a:solidFill>
+                        <a:srgbClr val="E1E0D9"/>
+                      </a:solidFill>
+                      <a:prstDash val="solid"/>
+                      <a:round/>
+                      <a:headEnd type="none" w="med" len="med"/>
+                      <a:tailEnd type="none" w="med" len="med"/>
+                    </a:lnB>
+                  </a:tcPr>
+                </a:tc>
+                <a:tc>
+                  <a:txBody>
+                    <a:bodyPr/>
+                    <a:lstStyle/>
+                    <a:p>
+                      <a:pPr algn="r" indent="0" marL="0">
+                        <a:buNone/>
+                      </a:pPr>
+                      <a:r>
+                        <a:rPr lang="en-US" sz="1150" dirty="0">
+                          <a:solidFill>
+                            <a:srgbClr val="0B0B0B"/>
+                          </a:solidFill>
+                          <a:latin typeface="Aptos" pitchFamily="34" charset="0"/>
+                          <a:ea typeface="Aptos" pitchFamily="34" charset="-122"/>
+                          <a:cs typeface="Aptos" pitchFamily="34" charset="-120"/>
+                        </a:rPr>
+                        <a:t>1.079</a:t>
+                      </a:r>
+                      <a:endParaRPr lang="en-US" sz="1150" dirty="0">
+                        <a:latin typeface="Aptos" charset="0"/>
+                        <a:ea typeface="Aptos" charset="0"/>
+                        <a:cs typeface="Aptos" charset="0"/>
+                      </a:endParaRPr>
+                    </a:p>
+                  </a:txBody>
+                  <a:tcPr marL="54864" marR="54864" marT="54864" marB="54864" anchor="ctr">
+                    <a:lnL w="9525" cap="flat" cmpd="sng" algn="ctr">
+                      <a:solidFill>
+                        <a:srgbClr val="E1E0D9"/>
+                      </a:solidFill>
+                      <a:prstDash val="solid"/>
+                      <a:round/>
+                      <a:headEnd type="none" w="med" len="med"/>
+                      <a:tailEnd type="none" w="med" len="med"/>
+                    </a:lnL>
+                    <a:lnR w="9525" cap="flat" cmpd="sng" algn="ctr">
+                      <a:solidFill>
+                        <a:srgbClr val="E1E0D9"/>
+                      </a:solidFill>
+                      <a:prstDash val="solid"/>
+                      <a:round/>
+                      <a:headEnd type="none" w="med" len="med"/>
+                      <a:tailEnd type="none" w="med" len="med"/>
+                    </a:lnR>
+                    <a:lnT w="9525" cap="flat" cmpd="sng" algn="ctr">
+                      <a:solidFill>
+                        <a:srgbClr val="E1E0D9"/>
+                      </a:solidFill>
+                      <a:prstDash val="solid"/>
+                      <a:round/>
+                      <a:headEnd type="none" w="med" len="med"/>
+                      <a:tailEnd type="none" w="med" len="med"/>
+                    </a:lnT>
+                    <a:lnB w="9525" cap="flat" cmpd="sng" algn="ctr">
+                      <a:solidFill>
+                        <a:srgbClr val="E1E0D9"/>
+                      </a:solidFill>
+                      <a:prstDash val="solid"/>
+                      <a:round/>
+                      <a:headEnd type="none" w="med" len="med"/>
+                      <a:tailEnd type="none" w="med" len="med"/>
+                    </a:lnB>
+                  </a:tcPr>
+                </a:tc>
+                <a:tc>
+                  <a:txBody>
+                    <a:bodyPr/>
+                    <a:lstStyle/>
+                    <a:p>
+                      <a:pPr algn="r" indent="0" marL="0">
+                        <a:buNone/>
+                      </a:pPr>
+                      <a:r>
+                        <a:rPr lang="en-US" sz="1150" dirty="0">
+                          <a:solidFill>
+                            <a:srgbClr val="0B0B0B"/>
+                          </a:solidFill>
+                          <a:latin typeface="Aptos" pitchFamily="34" charset="0"/>
+                          <a:ea typeface="Aptos" pitchFamily="34" charset="-122"/>
+                          <a:cs typeface="Aptos" pitchFamily="34" charset="-120"/>
+                        </a:rPr>
+                        <a:t>2.0 m</a:t>
+                      </a:r>
+                      <a:endParaRPr lang="en-US" sz="1150" dirty="0">
+                        <a:latin typeface="Aptos" charset="0"/>
+                        <a:ea typeface="Aptos" charset="0"/>
+                        <a:cs typeface="Aptos" charset="0"/>
+                      </a:endParaRPr>
+                    </a:p>
+                  </a:txBody>
+                  <a:tcPr marL="54864" marR="54864" marT="54864" marB="54864" anchor="ctr">
+                    <a:lnL w="9525" cap="flat" cmpd="sng" algn="ctr">
+                      <a:solidFill>
+                        <a:srgbClr val="E1E0D9"/>
+                      </a:solidFill>
+                      <a:prstDash val="solid"/>
+                      <a:round/>
+                      <a:headEnd type="none" w="med" len="med"/>
+                      <a:tailEnd type="none" w="med" len="med"/>
+                    </a:lnL>
+                    <a:lnR w="9525" cap="flat" cmpd="sng" algn="ctr">
+                      <a:solidFill>
+                        <a:srgbClr val="E1E0D9"/>
+                      </a:solidFill>
+                      <a:prstDash val="solid"/>
+                      <a:round/>
+                      <a:headEnd type="none" w="med" len="med"/>
+                      <a:tailEnd type="none" w="med" len="med"/>
+                    </a:lnR>
+                    <a:lnT w="9525" cap="flat" cmpd="sng" algn="ctr">
+                      <a:solidFill>
+                        <a:srgbClr val="E1E0D9"/>
+                      </a:solidFill>
+                      <a:prstDash val="solid"/>
+                      <a:round/>
+                      <a:headEnd type="none" w="med" len="med"/>
+                      <a:tailEnd type="none" w="med" len="med"/>
+                    </a:lnT>
+                    <a:lnB w="9525" cap="flat" cmpd="sng" algn="ctr">
+                      <a:solidFill>
+                        <a:srgbClr val="E1E0D9"/>
+                      </a:solidFill>
+                      <a:prstDash val="solid"/>
+                      <a:round/>
+                      <a:headEnd type="none" w="med" len="med"/>
+                      <a:tailEnd type="none" w="med" len="med"/>
+                    </a:lnB>
+                  </a:tcPr>
+                </a:tc>
+                <a:tc>
+                  <a:txBody>
+                    <a:bodyPr/>
+                    <a:lstStyle/>
+                    <a:p>
+                      <a:pPr algn="r" indent="0" marL="0">
+                        <a:buNone/>
+                      </a:pPr>
+                      <a:r>
+                        <a:rPr lang="en-US" sz="1150" b="1" dirty="0">
+                          <a:solidFill>
+                            <a:srgbClr val="0B0B0B"/>
+                          </a:solidFill>
+                          <a:latin typeface="Aptos" pitchFamily="34" charset="0"/>
+                          <a:ea typeface="Aptos" pitchFamily="34" charset="-122"/>
+                          <a:cs typeface="Aptos" pitchFamily="34" charset="-120"/>
+                        </a:rPr>
+                        <a:t>2.16</a:t>
+                      </a:r>
+                      <a:endParaRPr lang="en-US" sz="1150" dirty="0">
+                        <a:latin typeface="Aptos" charset="0"/>
+                        <a:ea typeface="Aptos" charset="0"/>
+                        <a:cs typeface="Aptos" charset="0"/>
+                      </a:endParaRPr>
+                    </a:p>
+                  </a:txBody>
+                  <a:tcPr marL="54864" marR="54864" marT="54864" marB="54864" anchor="ctr">
+                    <a:lnL w="9525" cap="flat" cmpd="sng" algn="ctr">
+                      <a:solidFill>
+                        <a:srgbClr val="E1E0D9"/>
+                      </a:solidFill>
+                      <a:prstDash val="solid"/>
+                      <a:round/>
+                      <a:headEnd type="none" w="med" len="med"/>
+                      <a:tailEnd type="none" w="med" len="med"/>
+                    </a:lnL>
+                    <a:lnR w="9525" cap="flat" cmpd="sng" algn="ctr">
+                      <a:solidFill>
+                        <a:srgbClr val="E1E0D9"/>
+                      </a:solidFill>
+                      <a:prstDash val="solid"/>
+                      <a:round/>
+                      <a:headEnd type="none" w="med" len="med"/>
+                      <a:tailEnd type="none" w="med" len="med"/>
+                    </a:lnR>
+                    <a:lnT w="9525" cap="flat" cmpd="sng" algn="ctr">
+                      <a:solidFill>
+                        <a:srgbClr val="E1E0D9"/>
+                      </a:solidFill>
+                      <a:prstDash val="solid"/>
+                      <a:round/>
+                      <a:headEnd type="none" w="med" len="med"/>
+                      <a:tailEnd type="none" w="med" len="med"/>
+                    </a:lnT>
+                    <a:lnB w="9525" cap="flat" cmpd="sng" algn="ctr">
+                      <a:solidFill>
+                        <a:srgbClr val="E1E0D9"/>
+                      </a:solidFill>
+                      <a:prstDash val="solid"/>
+                      <a:round/>
+                      <a:headEnd type="none" w="med" len="med"/>
+                      <a:tailEnd type="none" w="med" len="med"/>
+                    </a:lnB>
+                  </a:tcPr>
+                </a:tc>
+              </a:tr>
+              <a:tr h="310896">
+                <a:tc>
+                  <a:txBody>
+                    <a:bodyPr/>
+                    <a:lstStyle/>
+                    <a:p>
+                      <a:pPr algn="l" indent="0" marL="0">
+                        <a:buNone/>
+                      </a:pPr>
+                      <a:r>
+                        <a:rPr lang="en-US" sz="1150" b="1" dirty="0">
+                          <a:solidFill>
+                            <a:srgbClr val="0B0B0B"/>
+                          </a:solidFill>
+                          <a:latin typeface="Aptos" pitchFamily="34" charset="0"/>
+                          <a:ea typeface="Aptos" pitchFamily="34" charset="-122"/>
+                          <a:cs typeface="Aptos" pitchFamily="34" charset="-120"/>
+                        </a:rPr>
+                        <a:t>150 tray</a:t>
+                      </a:r>
+                      <a:endParaRPr lang="en-US" sz="1150" dirty="0">
+                        <a:latin typeface="Aptos" charset="0"/>
+                        <a:ea typeface="Aptos" charset="0"/>
+                        <a:cs typeface="Aptos" charset="0"/>
+                      </a:endParaRPr>
+                    </a:p>
+                  </a:txBody>
+                  <a:tcPr marL="54864" marR="54864" marT="54864" marB="54864" anchor="ctr">
+                    <a:lnL w="9525" cap="flat" cmpd="sng" algn="ctr">
+                      <a:solidFill>
+                        <a:srgbClr val="E1E0D9"/>
+                      </a:solidFill>
+                      <a:prstDash val="solid"/>
+                      <a:round/>
+                      <a:headEnd type="none" w="med" len="med"/>
+                      <a:tailEnd type="none" w="med" len="med"/>
+                    </a:lnL>
+                    <a:lnR w="9525" cap="flat" cmpd="sng" algn="ctr">
+                      <a:solidFill>
+                        <a:srgbClr val="E1E0D9"/>
+                      </a:solidFill>
+                      <a:prstDash val="solid"/>
+                      <a:round/>
+                      <a:headEnd type="none" w="med" len="med"/>
+                      <a:tailEnd type="none" w="med" len="med"/>
+                    </a:lnR>
+                    <a:lnT w="9525" cap="flat" cmpd="sng" algn="ctr">
+                      <a:solidFill>
+                        <a:srgbClr val="E1E0D9"/>
+                      </a:solidFill>
+                      <a:prstDash val="solid"/>
+                      <a:round/>
+                      <a:headEnd type="none" w="med" len="med"/>
+                      <a:tailEnd type="none" w="med" len="med"/>
+                    </a:lnT>
+                    <a:lnB w="9525" cap="flat" cmpd="sng" algn="ctr">
+                      <a:solidFill>
+                        <a:srgbClr val="E1E0D9"/>
+                      </a:solidFill>
+                      <a:prstDash val="solid"/>
+                      <a:round/>
+                      <a:headEnd type="none" w="med" len="med"/>
+                      <a:tailEnd type="none" w="med" len="med"/>
+                    </a:lnB>
+                  </a:tcPr>
+                </a:tc>
+                <a:tc>
+                  <a:txBody>
+                    <a:bodyPr/>
+                    <a:lstStyle/>
+                    <a:p>
+                      <a:pPr algn="l" indent="0" marL="0">
+                        <a:buNone/>
+                      </a:pPr>
+                      <a:r>
+                        <a:rPr lang="en-US" sz="1150" dirty="0">
+                          <a:solidFill>
+                            <a:srgbClr val="4A3AA7"/>
+                          </a:solidFill>
+                          <a:latin typeface="Aptos" pitchFamily="34" charset="0"/>
+                          <a:ea typeface="Aptos" pitchFamily="34" charset="-122"/>
+                          <a:cs typeface="Aptos" pitchFamily="34" charset="-120"/>
+                        </a:rPr>
+                        <a:t>● </a:t>
+                      </a:r>
+                      <a:pPr algn="l" indent="0" marL="0">
+                        <a:buNone/>
+                      </a:pPr>
+                      <a:r>
+                        <a:rPr lang="en-US" sz="1150" dirty="0">
+                          <a:solidFill>
+                            <a:srgbClr val="0B0B0B"/>
+                          </a:solidFill>
+                          <a:latin typeface="Aptos" pitchFamily="34" charset="0"/>
+                          <a:ea typeface="Aptos" pitchFamily="34" charset="-122"/>
+                          <a:cs typeface="Aptos" pitchFamily="34" charset="-120"/>
+                        </a:rPr>
+                        <a:t>electrical</a:t>
+                      </a:r>
+                      <a:endParaRPr lang="en-US" sz="1150" dirty="0">
+                        <a:latin typeface="Aptos" charset="0"/>
+                        <a:ea typeface="Aptos" charset="0"/>
+                        <a:cs typeface="Aptos" charset="0"/>
+                      </a:endParaRPr>
+                    </a:p>
+                  </a:txBody>
+                  <a:tcPr marL="54864" marR="54864" marT="54864" marB="54864" anchor="ctr">
+                    <a:lnL w="9525" cap="flat" cmpd="sng" algn="ctr">
+                      <a:solidFill>
+                        <a:srgbClr val="E1E0D9"/>
+                      </a:solidFill>
+                      <a:prstDash val="solid"/>
+                      <a:round/>
+                      <a:headEnd type="none" w="med" len="med"/>
+                      <a:tailEnd type="none" w="med" len="med"/>
+                    </a:lnL>
+                    <a:lnR w="9525" cap="flat" cmpd="sng" algn="ctr">
+                      <a:solidFill>
+                        <a:srgbClr val="E1E0D9"/>
+                      </a:solidFill>
+                      <a:prstDash val="solid"/>
+                      <a:round/>
+                      <a:headEnd type="none" w="med" len="med"/>
+                      <a:tailEnd type="none" w="med" len="med"/>
+                    </a:lnR>
+                    <a:lnT w="9525" cap="flat" cmpd="sng" algn="ctr">
+                      <a:solidFill>
+                        <a:srgbClr val="E1E0D9"/>
+                      </a:solidFill>
+                      <a:prstDash val="solid"/>
+                      <a:round/>
+                      <a:headEnd type="none" w="med" len="med"/>
+                      <a:tailEnd type="none" w="med" len="med"/>
+                    </a:lnT>
+                    <a:lnB w="9525" cap="flat" cmpd="sng" algn="ctr">
+                      <a:solidFill>
+                        <a:srgbClr val="E1E0D9"/>
+                      </a:solidFill>
+                      <a:prstDash val="solid"/>
+                      <a:round/>
+                      <a:headEnd type="none" w="med" len="med"/>
+                      <a:tailEnd type="none" w="med" len="med"/>
+                    </a:lnB>
+                  </a:tcPr>
+                </a:tc>
+                <a:tc>
+                  <a:txBody>
+                    <a:bodyPr/>
+                    <a:lstStyle/>
+                    <a:p>
+                      <a:pPr algn="r" indent="0" marL="0">
+                        <a:buNone/>
+                      </a:pPr>
+                      <a:r>
+                        <a:rPr lang="en-US" sz="1150" dirty="0">
+                          <a:solidFill>
+                            <a:srgbClr val="0B0B0B"/>
+                          </a:solidFill>
+                          <a:latin typeface="Aptos" pitchFamily="34" charset="0"/>
+                          <a:ea typeface="Aptos" pitchFamily="34" charset="-122"/>
+                          <a:cs typeface="Aptos" pitchFamily="34" charset="-120"/>
+                        </a:rPr>
+                        <a:t>0</a:t>
+                      </a:r>
+                      <a:endParaRPr lang="en-US" sz="1150" dirty="0">
+                        <a:latin typeface="Aptos" charset="0"/>
+                        <a:ea typeface="Aptos" charset="0"/>
+                        <a:cs typeface="Aptos" charset="0"/>
+                      </a:endParaRPr>
+                    </a:p>
+                  </a:txBody>
+                  <a:tcPr marL="54864" marR="54864" marT="54864" marB="54864" anchor="ctr">
+                    <a:lnL w="9525" cap="flat" cmpd="sng" algn="ctr">
+                      <a:solidFill>
+                        <a:srgbClr val="E1E0D9"/>
+                      </a:solidFill>
+                      <a:prstDash val="solid"/>
+                      <a:round/>
+                      <a:headEnd type="none" w="med" len="med"/>
+                      <a:tailEnd type="none" w="med" len="med"/>
+                    </a:lnL>
+                    <a:lnR w="9525" cap="flat" cmpd="sng" algn="ctr">
+                      <a:solidFill>
+                        <a:srgbClr val="E1E0D9"/>
+                      </a:solidFill>
+                      <a:prstDash val="solid"/>
+                      <a:round/>
+                      <a:headEnd type="none" w="med" len="med"/>
+                      <a:tailEnd type="none" w="med" len="med"/>
+                    </a:lnR>
+                    <a:lnT w="9525" cap="flat" cmpd="sng" algn="ctr">
+                      <a:solidFill>
+                        <a:srgbClr val="E1E0D9"/>
+                      </a:solidFill>
+                      <a:prstDash val="solid"/>
+                      <a:round/>
+                      <a:headEnd type="none" w="med" len="med"/>
+                      <a:tailEnd type="none" w="med" len="med"/>
+                    </a:lnT>
+                    <a:lnB w="9525" cap="flat" cmpd="sng" algn="ctr">
+                      <a:solidFill>
+                        <a:srgbClr val="E1E0D9"/>
+                      </a:solidFill>
+                      <a:prstDash val="solid"/>
+                      <a:round/>
+                      <a:headEnd type="none" w="med" len="med"/>
+                      <a:tailEnd type="none" w="med" len="med"/>
+                    </a:lnB>
+                  </a:tcPr>
+                </a:tc>
+                <a:tc>
+                  <a:txBody>
+                    <a:bodyPr/>
+                    <a:lstStyle/>
+                    <a:p>
+                      <a:pPr algn="r" indent="0" marL="0">
+                        <a:buNone/>
+                      </a:pPr>
+                      <a:r>
+                        <a:rPr lang="en-US" sz="1150" dirty="0">
+                          <a:solidFill>
+                            <a:srgbClr val="0B0B0B"/>
+                          </a:solidFill>
+                          <a:latin typeface="Aptos" pitchFamily="34" charset="0"/>
+                          <a:ea typeface="Aptos" pitchFamily="34" charset="-122"/>
+                          <a:cs typeface="Aptos" pitchFamily="34" charset="-120"/>
+                        </a:rPr>
+                        <a:t>0.270</a:t>
+                      </a:r>
+                      <a:endParaRPr lang="en-US" sz="1150" dirty="0">
+                        <a:latin typeface="Aptos" charset="0"/>
+                        <a:ea typeface="Aptos" charset="0"/>
+                        <a:cs typeface="Aptos" charset="0"/>
+                      </a:endParaRPr>
+                    </a:p>
+                  </a:txBody>
+                  <a:tcPr marL="54864" marR="54864" marT="54864" marB="54864" anchor="ctr">
+                    <a:lnL w="9525" cap="flat" cmpd="sng" algn="ctr">
+                      <a:solidFill>
+                        <a:srgbClr val="E1E0D9"/>
+                      </a:solidFill>
+                      <a:prstDash val="solid"/>
+                      <a:round/>
+                      <a:headEnd type="none" w="med" len="med"/>
+                      <a:tailEnd type="none" w="med" len="med"/>
+                    </a:lnL>
+                    <a:lnR w="9525" cap="flat" cmpd="sng" algn="ctr">
+                      <a:solidFill>
+                        <a:srgbClr val="E1E0D9"/>
+                      </a:solidFill>
+                      <a:prstDash val="solid"/>
+                      <a:round/>
+                      <a:headEnd type="none" w="med" len="med"/>
+                      <a:tailEnd type="none" w="med" len="med"/>
+                    </a:lnR>
+                    <a:lnT w="9525" cap="flat" cmpd="sng" algn="ctr">
+                      <a:solidFill>
+                        <a:srgbClr val="E1E0D9"/>
+                      </a:solidFill>
+                      <a:prstDash val="solid"/>
+                      <a:round/>
+                      <a:headEnd type="none" w="med" len="med"/>
+                      <a:tailEnd type="none" w="med" len="med"/>
+                    </a:lnT>
+                    <a:lnB w="9525" cap="flat" cmpd="sng" algn="ctr">
+                      <a:solidFill>
+                        <a:srgbClr val="E1E0D9"/>
+                      </a:solidFill>
+                      <a:prstDash val="solid"/>
+                      <a:round/>
+                      <a:headEnd type="none" w="med" len="med"/>
+                      <a:tailEnd type="none" w="med" len="med"/>
+                    </a:lnB>
+                  </a:tcPr>
+                </a:tc>
+                <a:tc>
+                  <a:txBody>
+                    <a:bodyPr/>
+                    <a:lstStyle/>
+                    <a:p>
+                      <a:pPr algn="r" indent="0" marL="0">
+                        <a:buNone/>
+                      </a:pPr>
+                      <a:r>
+                        <a:rPr lang="en-US" sz="1150" dirty="0">
+                          <a:solidFill>
+                            <a:srgbClr val="0B0B0B"/>
+                          </a:solidFill>
+                          <a:latin typeface="Aptos" pitchFamily="34" charset="0"/>
+                          <a:ea typeface="Aptos" pitchFamily="34" charset="-122"/>
+                          <a:cs typeface="Aptos" pitchFamily="34" charset="-120"/>
+                        </a:rPr>
+                        <a:t>2.0 m</a:t>
+                      </a:r>
+                      <a:endParaRPr lang="en-US" sz="1150" dirty="0">
+                        <a:latin typeface="Aptos" charset="0"/>
+                        <a:ea typeface="Aptos" charset="0"/>
+                        <a:cs typeface="Aptos" charset="0"/>
+                      </a:endParaRPr>
+                    </a:p>
+                  </a:txBody>
+                  <a:tcPr marL="54864" marR="54864" marT="54864" marB="54864" anchor="ctr">
+                    <a:lnL w="9525" cap="flat" cmpd="sng" algn="ctr">
+                      <a:solidFill>
+                        <a:srgbClr val="E1E0D9"/>
+                      </a:solidFill>
+                      <a:prstDash val="solid"/>
+                      <a:round/>
+                      <a:headEnd type="none" w="med" len="med"/>
+                      <a:tailEnd type="none" w="med" len="med"/>
+                    </a:lnL>
+                    <a:lnR w="9525" cap="flat" cmpd="sng" algn="ctr">
+                      <a:solidFill>
+                        <a:srgbClr val="E1E0D9"/>
+                      </a:solidFill>
+                      <a:prstDash val="solid"/>
+                      <a:round/>
+                      <a:headEnd type="none" w="med" len="med"/>
+                      <a:tailEnd type="none" w="med" len="med"/>
+                    </a:lnR>
+                    <a:lnT w="9525" cap="flat" cmpd="sng" algn="ctr">
+                      <a:solidFill>
+                        <a:srgbClr val="E1E0D9"/>
+                      </a:solidFill>
+                      <a:prstDash val="solid"/>
+                      <a:round/>
+                      <a:headEnd type="none" w="med" len="med"/>
+                      <a:tailEnd type="none" w="med" len="med"/>
+                    </a:lnT>
+                    <a:lnB w="9525" cap="flat" cmpd="sng" algn="ctr">
+                      <a:solidFill>
+                        <a:srgbClr val="E1E0D9"/>
+                      </a:solidFill>
+                      <a:prstDash val="solid"/>
+                      <a:round/>
+                      <a:headEnd type="none" w="med" len="med"/>
+                      <a:tailEnd type="none" w="med" len="med"/>
+                    </a:lnB>
+                  </a:tcPr>
+                </a:tc>
+                <a:tc>
+                  <a:txBody>
+                    <a:bodyPr/>
+                    <a:lstStyle/>
+                    <a:p>
+                      <a:pPr algn="r" indent="0" marL="0">
+                        <a:buNone/>
+                      </a:pPr>
+                      <a:r>
+                        <a:rPr lang="en-US" sz="1150" b="1" dirty="0">
+                          <a:solidFill>
+                            <a:srgbClr val="0B0B0B"/>
+                          </a:solidFill>
+                          <a:latin typeface="Aptos" pitchFamily="34" charset="0"/>
+                          <a:ea typeface="Aptos" pitchFamily="34" charset="-122"/>
+                          <a:cs typeface="Aptos" pitchFamily="34" charset="-120"/>
+                        </a:rPr>
+                        <a:t>0.54</a:t>
+                      </a:r>
+                      <a:endParaRPr lang="en-US" sz="1150" dirty="0">
+                        <a:latin typeface="Aptos" charset="0"/>
+                        <a:ea typeface="Aptos" charset="0"/>
+                        <a:cs typeface="Aptos" charset="0"/>
+                      </a:endParaRPr>
+                    </a:p>
+                  </a:txBody>
+                  <a:tcPr marL="54864" marR="54864" marT="54864" marB="54864" anchor="ctr">
+                    <a:lnL w="9525" cap="flat" cmpd="sng" algn="ctr">
+                      <a:solidFill>
+                        <a:srgbClr val="E1E0D9"/>
+                      </a:solidFill>
+                      <a:prstDash val="solid"/>
+                      <a:round/>
+                      <a:headEnd type="none" w="med" len="med"/>
+                      <a:tailEnd type="none" w="med" len="med"/>
+                    </a:lnL>
+                    <a:lnR w="9525" cap="flat" cmpd="sng" algn="ctr">
+                      <a:solidFill>
+                        <a:srgbClr val="E1E0D9"/>
+                      </a:solidFill>
+                      <a:prstDash val="solid"/>
+                      <a:round/>
+                      <a:headEnd type="none" w="med" len="med"/>
+                      <a:tailEnd type="none" w="med" len="med"/>
+                    </a:lnR>
+                    <a:lnT w="9525" cap="flat" cmpd="sng" algn="ctr">
+                      <a:solidFill>
+                        <a:srgbClr val="E1E0D9"/>
+                      </a:solidFill>
+                      <a:prstDash val="solid"/>
+                      <a:round/>
+                      <a:headEnd type="none" w="med" len="med"/>
+                      <a:tailEnd type="none" w="med" len="med"/>
+                    </a:lnT>
+                    <a:lnB w="9525" cap="flat" cmpd="sng" algn="ctr">
+                      <a:solidFill>
+                        <a:srgbClr val="E1E0D9"/>
+                      </a:solidFill>
+                      <a:prstDash val="solid"/>
+                      <a:round/>
+                      <a:headEnd type="none" w="med" len="med"/>
+                      <a:tailEnd type="none" w="med" len="med"/>
+                    </a:lnB>
+                  </a:tcPr>
+                </a:tc>
+              </a:tr>
+              <a:tr h="310896">
+                <a:tc>
+                  <a:txBody>
+                    <a:bodyPr/>
+                    <a:lstStyle/>
+                    <a:p>
+                      <a:pPr algn="l" indent="0" marL="0">
+                        <a:buNone/>
+                      </a:pPr>
+                      <a:r>
+                        <a:rPr lang="en-US" sz="1150" b="1" dirty="0">
+                          <a:solidFill>
+                            <a:srgbClr val="0B0B0B"/>
+                          </a:solidFill>
+                          <a:latin typeface="Aptos" pitchFamily="34" charset="0"/>
+                          <a:ea typeface="Aptos" pitchFamily="34" charset="-122"/>
+                          <a:cs typeface="Aptos" pitchFamily="34" charset="-120"/>
+                        </a:rPr>
+                        <a:t>DN32</a:t>
+                      </a:r>
+                      <a:endParaRPr lang="en-US" sz="1150" dirty="0">
+                        <a:latin typeface="Aptos" charset="0"/>
+                        <a:ea typeface="Aptos" charset="0"/>
+                        <a:cs typeface="Aptos" charset="0"/>
+                      </a:endParaRPr>
+                    </a:p>
+                  </a:txBody>
+                  <a:tcPr marL="54864" marR="54864" marT="54864" marB="54864" anchor="ctr">
+                    <a:lnL w="9525" cap="flat" cmpd="sng" algn="ctr">
+                      <a:solidFill>
+                        <a:srgbClr val="E1E0D9"/>
+                      </a:solidFill>
+                      <a:prstDash val="solid"/>
+                      <a:round/>
+                      <a:headEnd type="none" w="med" len="med"/>
+                      <a:tailEnd type="none" w="med" len="med"/>
+                    </a:lnL>
+                    <a:lnR w="9525" cap="flat" cmpd="sng" algn="ctr">
+                      <a:solidFill>
+                        <a:srgbClr val="E1E0D9"/>
+                      </a:solidFill>
+                      <a:prstDash val="solid"/>
+                      <a:round/>
+                      <a:headEnd type="none" w="med" len="med"/>
+                      <a:tailEnd type="none" w="med" len="med"/>
+                    </a:lnR>
+                    <a:lnT w="9525" cap="flat" cmpd="sng" algn="ctr">
+                      <a:solidFill>
+                        <a:srgbClr val="E1E0D9"/>
+                      </a:solidFill>
+                      <a:prstDash val="solid"/>
+                      <a:round/>
+                      <a:headEnd type="none" w="med" len="med"/>
+                      <a:tailEnd type="none" w="med" len="med"/>
+                    </a:lnT>
+                    <a:lnB w="9525" cap="flat" cmpd="sng" algn="ctr">
+                      <a:solidFill>
+                        <a:srgbClr val="E1E0D9"/>
+                      </a:solidFill>
+                      <a:prstDash val="solid"/>
+                      <a:round/>
+                      <a:headEnd type="none" w="med" len="med"/>
+                      <a:tailEnd type="none" w="med" len="med"/>
+                    </a:lnB>
+                  </a:tcPr>
+                </a:tc>
+                <a:tc>
+                  <a:txBody>
+                    <a:bodyPr/>
+                    <a:lstStyle/>
+                    <a:p>
+                      <a:pPr algn="l" indent="0" marL="0">
+                        <a:buNone/>
+                      </a:pPr>
+                      <a:r>
+                        <a:rPr lang="en-US" sz="1150" dirty="0">
+                          <a:solidFill>
+                            <a:srgbClr val="E34948"/>
+                          </a:solidFill>
+                          <a:latin typeface="Aptos" pitchFamily="34" charset="0"/>
+                          <a:ea typeface="Aptos" pitchFamily="34" charset="-122"/>
+                          <a:cs typeface="Aptos" pitchFamily="34" charset="-120"/>
+                        </a:rPr>
+                        <a:t>● </a:t>
+                      </a:r>
+                      <a:pPr algn="l" indent="0" marL="0">
+                        <a:buNone/>
+                      </a:pPr>
+                      <a:r>
+                        <a:rPr lang="en-US" sz="1150" dirty="0">
+                          <a:solidFill>
+                            <a:srgbClr val="0B0B0B"/>
+                          </a:solidFill>
+                          <a:latin typeface="Aptos" pitchFamily="34" charset="0"/>
+                          <a:ea typeface="Aptos" pitchFamily="34" charset="-122"/>
+                          <a:cs typeface="Aptos" pitchFamily="34" charset="-120"/>
+                        </a:rPr>
+                        <a:t>sprinkler</a:t>
+                      </a:r>
+                      <a:endParaRPr lang="en-US" sz="1150" dirty="0">
+                        <a:latin typeface="Aptos" charset="0"/>
+                        <a:ea typeface="Aptos" charset="0"/>
+                        <a:cs typeface="Aptos" charset="0"/>
+                      </a:endParaRPr>
+                    </a:p>
+                  </a:txBody>
+                  <a:tcPr marL="54864" marR="54864" marT="54864" marB="54864" anchor="ctr">
+                    <a:lnL w="9525" cap="flat" cmpd="sng" algn="ctr">
+                      <a:solidFill>
+                        <a:srgbClr val="E1E0D9"/>
+                      </a:solidFill>
+                      <a:prstDash val="solid"/>
+                      <a:round/>
+                      <a:headEnd type="none" w="med" len="med"/>
+                      <a:tailEnd type="none" w="med" len="med"/>
+                    </a:lnL>
+                    <a:lnR w="9525" cap="flat" cmpd="sng" algn="ctr">
+                      <a:solidFill>
+                        <a:srgbClr val="E1E0D9"/>
+                      </a:solidFill>
+                      <a:prstDash val="solid"/>
+                      <a:round/>
+                      <a:headEnd type="none" w="med" len="med"/>
+                      <a:tailEnd type="none" w="med" len="med"/>
+                    </a:lnR>
+                    <a:lnT w="9525" cap="flat" cmpd="sng" algn="ctr">
+                      <a:solidFill>
+                        <a:srgbClr val="E1E0D9"/>
+                      </a:solidFill>
+                      <a:prstDash val="solid"/>
+                      <a:round/>
+                      <a:headEnd type="none" w="med" len="med"/>
+                      <a:tailEnd type="none" w="med" len="med"/>
+                    </a:lnT>
+                    <a:lnB w="9525" cap="flat" cmpd="sng" algn="ctr">
+                      <a:solidFill>
+                        <a:srgbClr val="E1E0D9"/>
+                      </a:solidFill>
+                      <a:prstDash val="solid"/>
+                      <a:round/>
+                      <a:headEnd type="none" w="med" len="med"/>
+                      <a:tailEnd type="none" w="med" len="med"/>
+                    </a:lnB>
+                  </a:tcPr>
+                </a:tc>
+                <a:tc>
+                  <a:txBody>
+                    <a:bodyPr/>
+                    <a:lstStyle/>
+                    <a:p>
+                      <a:pPr algn="r" indent="0" marL="0">
+                        <a:buNone/>
+                      </a:pPr>
+                      <a:r>
+                        <a:rPr lang="en-US" sz="1150" dirty="0">
+                          <a:solidFill>
+                            <a:srgbClr val="0B0B0B"/>
+                          </a:solidFill>
+                          <a:latin typeface="Aptos" pitchFamily="34" charset="0"/>
+                          <a:ea typeface="Aptos" pitchFamily="34" charset="-122"/>
+                          <a:cs typeface="Aptos" pitchFamily="34" charset="-120"/>
+                        </a:rPr>
+                        <a:t>0</a:t>
+                      </a:r>
+                      <a:endParaRPr lang="en-US" sz="1150" dirty="0">
+                        <a:latin typeface="Aptos" charset="0"/>
+                        <a:ea typeface="Aptos" charset="0"/>
+                        <a:cs typeface="Aptos" charset="0"/>
+                      </a:endParaRPr>
+                    </a:p>
+                  </a:txBody>
+                  <a:tcPr marL="54864" marR="54864" marT="54864" marB="54864" anchor="ctr">
+                    <a:lnL w="9525" cap="flat" cmpd="sng" algn="ctr">
+                      <a:solidFill>
+                        <a:srgbClr val="E1E0D9"/>
+                      </a:solidFill>
+                      <a:prstDash val="solid"/>
+                      <a:round/>
+                      <a:headEnd type="none" w="med" len="med"/>
+                      <a:tailEnd type="none" w="med" len="med"/>
+                    </a:lnL>
+                    <a:lnR w="9525" cap="flat" cmpd="sng" algn="ctr">
+                      <a:solidFill>
+                        <a:srgbClr val="E1E0D9"/>
+                      </a:solidFill>
+                      <a:prstDash val="solid"/>
+                      <a:round/>
+                      <a:headEnd type="none" w="med" len="med"/>
+                      <a:tailEnd type="none" w="med" len="med"/>
+                    </a:lnR>
+                    <a:lnT w="9525" cap="flat" cmpd="sng" algn="ctr">
+                      <a:solidFill>
+                        <a:srgbClr val="E1E0D9"/>
+                      </a:solidFill>
+                      <a:prstDash val="solid"/>
+                      <a:round/>
+                      <a:headEnd type="none" w="med" len="med"/>
+                      <a:tailEnd type="none" w="med" len="med"/>
+                    </a:lnT>
+                    <a:lnB w="9525" cap="flat" cmpd="sng" algn="ctr">
+                      <a:solidFill>
+                        <a:srgbClr val="E1E0D9"/>
+                      </a:solidFill>
+                      <a:prstDash val="solid"/>
+                      <a:round/>
+                      <a:headEnd type="none" w="med" len="med"/>
+                      <a:tailEnd type="none" w="med" len="med"/>
+                    </a:lnB>
+                  </a:tcPr>
+                </a:tc>
+                <a:tc>
+                  <a:txBody>
+                    <a:bodyPr/>
+                    <a:lstStyle/>
+                    <a:p>
+                      <a:pPr algn="r" indent="0" marL="0">
+                        <a:buNone/>
+                      </a:pPr>
+                      <a:r>
+                        <a:rPr lang="en-US" sz="1150" dirty="0">
+                          <a:solidFill>
+                            <a:srgbClr val="0B0B0B"/>
+                          </a:solidFill>
+                          <a:latin typeface="Aptos" pitchFamily="34" charset="0"/>
+                          <a:ea typeface="Aptos" pitchFamily="34" charset="-122"/>
+                          <a:cs typeface="Aptos" pitchFamily="34" charset="-120"/>
+                        </a:rPr>
+                        <a:t>0.040</a:t>
+                      </a:r>
+                      <a:endParaRPr lang="en-US" sz="1150" dirty="0">
+                        <a:latin typeface="Aptos" charset="0"/>
+                        <a:ea typeface="Aptos" charset="0"/>
+                        <a:cs typeface="Aptos" charset="0"/>
+                      </a:endParaRPr>
+                    </a:p>
+                  </a:txBody>
+                  <a:tcPr marL="54864" marR="54864" marT="54864" marB="54864" anchor="ctr">
+                    <a:lnL w="9525" cap="flat" cmpd="sng" algn="ctr">
+                      <a:solidFill>
+                        <a:srgbClr val="E1E0D9"/>
+                      </a:solidFill>
+                      <a:prstDash val="solid"/>
+                      <a:round/>
+                      <a:headEnd type="none" w="med" len="med"/>
+                      <a:tailEnd type="none" w="med" len="med"/>
+                    </a:lnL>
+                    <a:lnR w="9525" cap="flat" cmpd="sng" algn="ctr">
+                      <a:solidFill>
+                        <a:srgbClr val="E1E0D9"/>
+                      </a:solidFill>
+                      <a:prstDash val="solid"/>
+                      <a:round/>
+                      <a:headEnd type="none" w="med" len="med"/>
+                      <a:tailEnd type="none" w="med" len="med"/>
+                    </a:lnR>
+                    <a:lnT w="9525" cap="flat" cmpd="sng" algn="ctr">
+                      <a:solidFill>
+                        <a:srgbClr val="E1E0D9"/>
+                      </a:solidFill>
+                      <a:prstDash val="solid"/>
+                      <a:round/>
+                      <a:headEnd type="none" w="med" len="med"/>
+                      <a:tailEnd type="none" w="med" len="med"/>
+                    </a:lnT>
+                    <a:lnB w="9525" cap="flat" cmpd="sng" algn="ctr">
+                      <a:solidFill>
+                        <a:srgbClr val="E1E0D9"/>
+                      </a:solidFill>
+                      <a:prstDash val="solid"/>
+                      <a:round/>
+                      <a:headEnd type="none" w="med" len="med"/>
+                      <a:tailEnd type="none" w="med" len="med"/>
+                    </a:lnB>
+                  </a:tcPr>
+                </a:tc>
+                <a:tc>
+                  <a:txBody>
+                    <a:bodyPr/>
+                    <a:lstStyle/>
+                    <a:p>
+                      <a:pPr algn="r" indent="0" marL="0">
+                        <a:buNone/>
+                      </a:pPr>
+                      <a:r>
+                        <a:rPr lang="en-US" sz="1150" dirty="0">
+                          <a:solidFill>
+                            <a:srgbClr val="0B0B0B"/>
+                          </a:solidFill>
+                          <a:latin typeface="Aptos" pitchFamily="34" charset="0"/>
+                          <a:ea typeface="Aptos" pitchFamily="34" charset="-122"/>
+                          <a:cs typeface="Aptos" pitchFamily="34" charset="-120"/>
+                        </a:rPr>
+                        <a:t>2.1 m</a:t>
+                      </a:r>
+                      <a:endParaRPr lang="en-US" sz="1150" dirty="0">
+                        <a:latin typeface="Aptos" charset="0"/>
+                        <a:ea typeface="Aptos" charset="0"/>
+                        <a:cs typeface="Aptos" charset="0"/>
+                      </a:endParaRPr>
+                    </a:p>
+                  </a:txBody>
+                  <a:tcPr marL="54864" marR="54864" marT="54864" marB="54864" anchor="ctr">
+                    <a:lnL w="9525" cap="flat" cmpd="sng" algn="ctr">
+                      <a:solidFill>
+                        <a:srgbClr val="E1E0D9"/>
+                      </a:solidFill>
+                      <a:prstDash val="solid"/>
+                      <a:round/>
+                      <a:headEnd type="none" w="med" len="med"/>
+                      <a:tailEnd type="none" w="med" len="med"/>
+                    </a:lnL>
+                    <a:lnR w="9525" cap="flat" cmpd="sng" algn="ctr">
+                      <a:solidFill>
+                        <a:srgbClr val="E1E0D9"/>
+                      </a:solidFill>
+                      <a:prstDash val="solid"/>
+                      <a:round/>
+                      <a:headEnd type="none" w="med" len="med"/>
+                      <a:tailEnd type="none" w="med" len="med"/>
+                    </a:lnR>
+                    <a:lnT w="9525" cap="flat" cmpd="sng" algn="ctr">
+                      <a:solidFill>
+                        <a:srgbClr val="E1E0D9"/>
+                      </a:solidFill>
+                      <a:prstDash val="solid"/>
+                      <a:round/>
+                      <a:headEnd type="none" w="med" len="med"/>
+                      <a:tailEnd type="none" w="med" len="med"/>
+                    </a:lnT>
+                    <a:lnB w="9525" cap="flat" cmpd="sng" algn="ctr">
+                      <a:solidFill>
+                        <a:srgbClr val="E1E0D9"/>
+                      </a:solidFill>
+                      <a:prstDash val="solid"/>
+                      <a:round/>
+                      <a:headEnd type="none" w="med" len="med"/>
+                      <a:tailEnd type="none" w="med" len="med"/>
+                    </a:lnB>
+                  </a:tcPr>
+                </a:tc>
+                <a:tc>
+                  <a:txBody>
+                    <a:bodyPr/>
+                    <a:lstStyle/>
+                    <a:p>
+                      <a:pPr algn="r" indent="0" marL="0">
+                        <a:buNone/>
+                      </a:pPr>
+                      <a:r>
+                        <a:rPr lang="en-US" sz="1150" b="1" dirty="0">
+                          <a:solidFill>
+                            <a:srgbClr val="0B0B0B"/>
+                          </a:solidFill>
+                          <a:latin typeface="Aptos" pitchFamily="34" charset="0"/>
+                          <a:ea typeface="Aptos" pitchFamily="34" charset="-122"/>
+                          <a:cs typeface="Aptos" pitchFamily="34" charset="-120"/>
+                        </a:rPr>
+                        <a:t>0.08</a:t>
+                      </a:r>
+                      <a:endParaRPr lang="en-US" sz="1150" dirty="0">
+                        <a:latin typeface="Aptos" charset="0"/>
+                        <a:ea typeface="Aptos" charset="0"/>
+                        <a:cs typeface="Aptos" charset="0"/>
+                      </a:endParaRPr>
+                    </a:p>
+                  </a:txBody>
+                  <a:tcPr marL="54864" marR="54864" marT="54864" marB="54864" anchor="ctr">
+                    <a:lnL w="9525" cap="flat" cmpd="sng" algn="ctr">
+                      <a:solidFill>
+                        <a:srgbClr val="E1E0D9"/>
+                      </a:solidFill>
+                      <a:prstDash val="solid"/>
+                      <a:round/>
+                      <a:headEnd type="none" w="med" len="med"/>
+                      <a:tailEnd type="none" w="med" len="med"/>
+                    </a:lnL>
+                    <a:lnR w="9525" cap="flat" cmpd="sng" algn="ctr">
+                      <a:solidFill>
+                        <a:srgbClr val="E1E0D9"/>
+                      </a:solidFill>
+                      <a:prstDash val="solid"/>
+                      <a:round/>
+                      <a:headEnd type="none" w="med" len="med"/>
+                      <a:tailEnd type="none" w="med" len="med"/>
+                    </a:lnR>
+                    <a:lnT w="9525" cap="flat" cmpd="sng" algn="ctr">
+                      <a:solidFill>
+                        <a:srgbClr val="E1E0D9"/>
+                      </a:solidFill>
+                      <a:prstDash val="solid"/>
+                      <a:round/>
+                      <a:headEnd type="none" w="med" len="med"/>
+                      <a:tailEnd type="none" w="med" len="med"/>
+                    </a:lnT>
+                    <a:lnB w="9525" cap="flat" cmpd="sng" algn="ctr">
+                      <a:solidFill>
+                        <a:srgbClr val="E1E0D9"/>
+                      </a:solidFill>
+                      <a:prstDash val="solid"/>
+                      <a:round/>
+                      <a:headEnd type="none" w="med" len="med"/>
+                      <a:tailEnd type="none" w="med" len="med"/>
+                    </a:lnB>
+                  </a:tcPr>
+                </a:tc>
+              </a:tr>
+              <a:tr h="310896">
+                <a:tc>
+                  <a:txBody>
+                    <a:bodyPr/>
+                    <a:lstStyle/>
+                    <a:p>
+                      <a:pPr algn="l" indent="0" marL="0">
+                        <a:buNone/>
+                      </a:pPr>
+                      <a:r>
+                        <a:rPr lang="en-US" sz="1150" b="1" dirty="0">
+                          <a:solidFill>
+                            <a:srgbClr val="0B0B0B"/>
+                          </a:solidFill>
+                          <a:latin typeface="Aptos" pitchFamily="34" charset="0"/>
+                          <a:ea typeface="Aptos" pitchFamily="34" charset="-122"/>
+                          <a:cs typeface="Aptos" pitchFamily="34" charset="-120"/>
+                        </a:rPr>
+                        <a:t>DN20</a:t>
+                      </a:r>
+                      <a:endParaRPr lang="en-US" sz="1150" dirty="0">
+                        <a:latin typeface="Aptos" charset="0"/>
+                        <a:ea typeface="Aptos" charset="0"/>
+                        <a:cs typeface="Aptos" charset="0"/>
+                      </a:endParaRPr>
+                    </a:p>
+                  </a:txBody>
+                  <a:tcPr marL="54864" marR="54864" marT="54864" marB="54864" anchor="ctr">
+                    <a:lnL w="9525" cap="flat" cmpd="sng" algn="ctr">
+                      <a:solidFill>
+                        <a:srgbClr val="E1E0D9"/>
+                      </a:solidFill>
+                      <a:prstDash val="solid"/>
+                      <a:round/>
+                      <a:headEnd type="none" w="med" len="med"/>
+                      <a:tailEnd type="none" w="med" len="med"/>
+                    </a:lnL>
+                    <a:lnR w="9525" cap="flat" cmpd="sng" algn="ctr">
+                      <a:solidFill>
+                        <a:srgbClr val="E1E0D9"/>
+                      </a:solidFill>
+                      <a:prstDash val="solid"/>
+                      <a:round/>
+                      <a:headEnd type="none" w="med" len="med"/>
+                      <a:tailEnd type="none" w="med" len="med"/>
+                    </a:lnR>
+                    <a:lnT w="9525" cap="flat" cmpd="sng" algn="ctr">
+                      <a:solidFill>
+                        <a:srgbClr val="E1E0D9"/>
+                      </a:solidFill>
+                      <a:prstDash val="solid"/>
+                      <a:round/>
+                      <a:headEnd type="none" w="med" len="med"/>
+                      <a:tailEnd type="none" w="med" len="med"/>
+                    </a:lnT>
+                    <a:lnB w="9525" cap="flat" cmpd="sng" algn="ctr">
+                      <a:solidFill>
+                        <a:srgbClr val="E1E0D9"/>
+                      </a:solidFill>
+                      <a:prstDash val="solid"/>
+                      <a:round/>
+                      <a:headEnd type="none" w="med" len="med"/>
+                      <a:tailEnd type="none" w="med" len="med"/>
+                    </a:lnB>
+                  </a:tcPr>
+                </a:tc>
+                <a:tc>
+                  <a:txBody>
+                    <a:bodyPr/>
+                    <a:lstStyle/>
+                    <a:p>
+                      <a:pPr algn="l" indent="0" marL="0">
+                        <a:buNone/>
+                      </a:pPr>
+                      <a:r>
+                        <a:rPr lang="en-US" sz="1150" dirty="0">
+                          <a:solidFill>
+                            <a:srgbClr val="2A78D6"/>
+                          </a:solidFill>
+                          <a:latin typeface="Aptos" pitchFamily="34" charset="0"/>
+                          <a:ea typeface="Aptos" pitchFamily="34" charset="-122"/>
+                          <a:cs typeface="Aptos" pitchFamily="34" charset="-120"/>
+                        </a:rPr>
+                        <a:t>● </a:t>
+                      </a:r>
+                      <a:pPr algn="l" indent="0" marL="0">
+                        <a:buNone/>
+                      </a:pPr>
+                      <a:r>
+                        <a:rPr lang="en-US" sz="1150" dirty="0">
+                          <a:solidFill>
+                            <a:srgbClr val="0B0B0B"/>
+                          </a:solidFill>
+                          <a:latin typeface="Aptos" pitchFamily="34" charset="0"/>
+                          <a:ea typeface="Aptos" pitchFamily="34" charset="-122"/>
+                          <a:cs typeface="Aptos" pitchFamily="34" charset="-120"/>
+                        </a:rPr>
+                        <a:t>domestic water</a:t>
+                      </a:r>
+                      <a:endParaRPr lang="en-US" sz="1150" dirty="0">
+                        <a:latin typeface="Aptos" charset="0"/>
+                        <a:ea typeface="Aptos" charset="0"/>
+                        <a:cs typeface="Aptos" charset="0"/>
+                      </a:endParaRPr>
+                    </a:p>
+                  </a:txBody>
+                  <a:tcPr marL="54864" marR="54864" marT="54864" marB="54864" anchor="ctr">
+                    <a:lnL w="9525" cap="flat" cmpd="sng" algn="ctr">
+                      <a:solidFill>
+                        <a:srgbClr val="E1E0D9"/>
+                      </a:solidFill>
+                      <a:prstDash val="solid"/>
+                      <a:round/>
+                      <a:headEnd type="none" w="med" len="med"/>
+                      <a:tailEnd type="none" w="med" len="med"/>
+                    </a:lnL>
+                    <a:lnR w="9525" cap="flat" cmpd="sng" algn="ctr">
+                      <a:solidFill>
+                        <a:srgbClr val="E1E0D9"/>
+                      </a:solidFill>
+                      <a:prstDash val="solid"/>
+                      <a:round/>
+                      <a:headEnd type="none" w="med" len="med"/>
+                      <a:tailEnd type="none" w="med" len="med"/>
+                    </a:lnR>
+                    <a:lnT w="9525" cap="flat" cmpd="sng" algn="ctr">
+                      <a:solidFill>
+                        <a:srgbClr val="E1E0D9"/>
+                      </a:solidFill>
+                      <a:prstDash val="solid"/>
+                      <a:round/>
+                      <a:headEnd type="none" w="med" len="med"/>
+                      <a:tailEnd type="none" w="med" len="med"/>
+                    </a:lnT>
+                    <a:lnB w="9525" cap="flat" cmpd="sng" algn="ctr">
+                      <a:solidFill>
+                        <a:srgbClr val="E1E0D9"/>
+                      </a:solidFill>
+                      <a:prstDash val="solid"/>
+                      <a:round/>
+                      <a:headEnd type="none" w="med" len="med"/>
+                      <a:tailEnd type="none" w="med" len="med"/>
+                    </a:lnB>
+                  </a:tcPr>
+                </a:tc>
+                <a:tc>
+                  <a:txBody>
+                    <a:bodyPr/>
+                    <a:lstStyle/>
+                    <a:p>
+                      <a:pPr algn="r" indent="0" marL="0">
+                        <a:buNone/>
+                      </a:pPr>
+                      <a:r>
+                        <a:rPr lang="en-US" sz="1150" dirty="0">
+                          <a:solidFill>
+                            <a:srgbClr val="0B0B0B"/>
+                          </a:solidFill>
+                          <a:latin typeface="Aptos" pitchFamily="34" charset="0"/>
+                          <a:ea typeface="Aptos" pitchFamily="34" charset="-122"/>
+                          <a:cs typeface="Aptos" pitchFamily="34" charset="-120"/>
+                        </a:rPr>
+                        <a:t>20</a:t>
+                      </a:r>
+                      <a:endParaRPr lang="en-US" sz="1150" dirty="0">
+                        <a:latin typeface="Aptos" charset="0"/>
+                        <a:ea typeface="Aptos" charset="0"/>
+                        <a:cs typeface="Aptos" charset="0"/>
+                      </a:endParaRPr>
+                    </a:p>
+                  </a:txBody>
+                  <a:tcPr marL="54864" marR="54864" marT="54864" marB="54864" anchor="ctr">
+                    <a:lnL w="9525" cap="flat" cmpd="sng" algn="ctr">
+                      <a:solidFill>
+                        <a:srgbClr val="E1E0D9"/>
+                      </a:solidFill>
+                      <a:prstDash val="solid"/>
+                      <a:round/>
+                      <a:headEnd type="none" w="med" len="med"/>
+                      <a:tailEnd type="none" w="med" len="med"/>
+                    </a:lnL>
+                    <a:lnR w="9525" cap="flat" cmpd="sng" algn="ctr">
+                      <a:solidFill>
+                        <a:srgbClr val="E1E0D9"/>
+                      </a:solidFill>
+                      <a:prstDash val="solid"/>
+                      <a:round/>
+                      <a:headEnd type="none" w="med" len="med"/>
+                      <a:tailEnd type="none" w="med" len="med"/>
+                    </a:lnR>
+                    <a:lnT w="9525" cap="flat" cmpd="sng" algn="ctr">
+                      <a:solidFill>
+                        <a:srgbClr val="E1E0D9"/>
+                      </a:solidFill>
+                      <a:prstDash val="solid"/>
+                      <a:round/>
+                      <a:headEnd type="none" w="med" len="med"/>
+                      <a:tailEnd type="none" w="med" len="med"/>
+                    </a:lnT>
+                    <a:lnB w="9525" cap="flat" cmpd="sng" algn="ctr">
+                      <a:solidFill>
+                        <a:srgbClr val="E1E0D9"/>
+                      </a:solidFill>
+                      <a:prstDash val="solid"/>
+                      <a:round/>
+                      <a:headEnd type="none" w="med" len="med"/>
+                      <a:tailEnd type="none" w="med" len="med"/>
+                    </a:lnB>
+                  </a:tcPr>
+                </a:tc>
+                <a:tc>
+                  <a:txBody>
+                    <a:bodyPr/>
+                    <a:lstStyle/>
+                    <a:p>
+                      <a:pPr algn="r" indent="0" marL="0">
+                        <a:buNone/>
+                      </a:pPr>
+                      <a:r>
+                        <a:rPr lang="en-US" sz="1150" dirty="0">
+                          <a:solidFill>
+                            <a:srgbClr val="0B0B0B"/>
+                          </a:solidFill>
+                          <a:latin typeface="Aptos" pitchFamily="34" charset="0"/>
+                          <a:ea typeface="Aptos" pitchFamily="34" charset="-122"/>
+                          <a:cs typeface="Aptos" pitchFamily="34" charset="-120"/>
+                        </a:rPr>
+                        <a:t>0.019</a:t>
+                      </a:r>
+                      <a:endParaRPr lang="en-US" sz="1150" dirty="0">
+                        <a:latin typeface="Aptos" charset="0"/>
+                        <a:ea typeface="Aptos" charset="0"/>
+                        <a:cs typeface="Aptos" charset="0"/>
+                      </a:endParaRPr>
+                    </a:p>
+                  </a:txBody>
+                  <a:tcPr marL="54864" marR="54864" marT="54864" marB="54864" anchor="ctr">
+                    <a:lnL w="9525" cap="flat" cmpd="sng" algn="ctr">
+                      <a:solidFill>
+                        <a:srgbClr val="E1E0D9"/>
+                      </a:solidFill>
+                      <a:prstDash val="solid"/>
+                      <a:round/>
+                      <a:headEnd type="none" w="med" len="med"/>
+                      <a:tailEnd type="none" w="med" len="med"/>
+                    </a:lnL>
+                    <a:lnR w="9525" cap="flat" cmpd="sng" algn="ctr">
+                      <a:solidFill>
+                        <a:srgbClr val="E1E0D9"/>
+                      </a:solidFill>
+                      <a:prstDash val="solid"/>
+                      <a:round/>
+                      <a:headEnd type="none" w="med" len="med"/>
+                      <a:tailEnd type="none" w="med" len="med"/>
+                    </a:lnR>
+                    <a:lnT w="9525" cap="flat" cmpd="sng" algn="ctr">
+                      <a:solidFill>
+                        <a:srgbClr val="E1E0D9"/>
+                      </a:solidFill>
+                      <a:prstDash val="solid"/>
+                      <a:round/>
+                      <a:headEnd type="none" w="med" len="med"/>
+                      <a:tailEnd type="none" w="med" len="med"/>
+                    </a:lnT>
+                    <a:lnB w="9525" cap="flat" cmpd="sng" algn="ctr">
+                      <a:solidFill>
+                        <a:srgbClr val="E1E0D9"/>
+                      </a:solidFill>
+                      <a:prstDash val="solid"/>
+                      <a:round/>
+                      <a:headEnd type="none" w="med" len="med"/>
+                      <a:tailEnd type="none" w="med" len="med"/>
+                    </a:lnB>
+                  </a:tcPr>
+                </a:tc>
+                <a:tc>
+                  <a:txBody>
+                    <a:bodyPr/>
+                    <a:lstStyle/>
+                    <a:p>
+                      <a:pPr algn="r" indent="0" marL="0">
+                        <a:buNone/>
+                      </a:pPr>
+                      <a:r>
+                        <a:rPr lang="en-US" sz="1150" dirty="0">
+                          <a:solidFill>
+                            <a:srgbClr val="0B0B0B"/>
+                          </a:solidFill>
+                          <a:latin typeface="Aptos" pitchFamily="34" charset="0"/>
+                          <a:ea typeface="Aptos" pitchFamily="34" charset="-122"/>
+                          <a:cs typeface="Aptos" pitchFamily="34" charset="-120"/>
+                        </a:rPr>
+                        <a:t>2.1 m</a:t>
+                      </a:r>
+                      <a:endParaRPr lang="en-US" sz="1150" dirty="0">
+                        <a:latin typeface="Aptos" charset="0"/>
+                        <a:ea typeface="Aptos" charset="0"/>
+                        <a:cs typeface="Aptos" charset="0"/>
+                      </a:endParaRPr>
+                    </a:p>
+                  </a:txBody>
+                  <a:tcPr marL="54864" marR="54864" marT="54864" marB="54864" anchor="ctr">
+                    <a:lnL w="9525" cap="flat" cmpd="sng" algn="ctr">
+                      <a:solidFill>
+                        <a:srgbClr val="E1E0D9"/>
+                      </a:solidFill>
+                      <a:prstDash val="solid"/>
+                      <a:round/>
+                      <a:headEnd type="none" w="med" len="med"/>
+                      <a:tailEnd type="none" w="med" len="med"/>
+                    </a:lnL>
+                    <a:lnR w="9525" cap="flat" cmpd="sng" algn="ctr">
+                      <a:solidFill>
+                        <a:srgbClr val="E1E0D9"/>
+                      </a:solidFill>
+                      <a:prstDash val="solid"/>
+                      <a:round/>
+                      <a:headEnd type="none" w="med" len="med"/>
+                      <a:tailEnd type="none" w="med" len="med"/>
+                    </a:lnR>
+                    <a:lnT w="9525" cap="flat" cmpd="sng" algn="ctr">
+                      <a:solidFill>
+                        <a:srgbClr val="E1E0D9"/>
+                      </a:solidFill>
+                      <a:prstDash val="solid"/>
+                      <a:round/>
+                      <a:headEnd type="none" w="med" len="med"/>
+                      <a:tailEnd type="none" w="med" len="med"/>
+                    </a:lnT>
+                    <a:lnB w="9525" cap="flat" cmpd="sng" algn="ctr">
+                      <a:solidFill>
+                        <a:srgbClr val="E1E0D9"/>
+                      </a:solidFill>
+                      <a:prstDash val="solid"/>
+                      <a:round/>
+                      <a:headEnd type="none" w="med" len="med"/>
+                      <a:tailEnd type="none" w="med" len="med"/>
+                    </a:lnB>
+                  </a:tcPr>
+                </a:tc>
+                <a:tc>
+                  <a:txBody>
+                    <a:bodyPr/>
+                    <a:lstStyle/>
+                    <a:p>
+                      <a:pPr algn="r" indent="0" marL="0">
+                        <a:buNone/>
+                      </a:pPr>
+                      <a:r>
+                        <a:rPr lang="en-US" sz="1150" b="1" dirty="0">
+                          <a:solidFill>
+                            <a:srgbClr val="0B0B0B"/>
+                          </a:solidFill>
+                          <a:latin typeface="Aptos" pitchFamily="34" charset="0"/>
+                          <a:ea typeface="Aptos" pitchFamily="34" charset="-122"/>
+                          <a:cs typeface="Aptos" pitchFamily="34" charset="-120"/>
+                        </a:rPr>
+                        <a:t>0.04</a:t>
+                      </a:r>
+                      <a:endParaRPr lang="en-US" sz="1150" dirty="0">
+                        <a:latin typeface="Aptos" charset="0"/>
+                        <a:ea typeface="Aptos" charset="0"/>
+                        <a:cs typeface="Aptos" charset="0"/>
+                      </a:endParaRPr>
+                    </a:p>
+                  </a:txBody>
+                  <a:tcPr marL="54864" marR="54864" marT="54864" marB="54864" anchor="ctr">
+                    <a:lnL w="9525" cap="flat" cmpd="sng" algn="ctr">
+                      <a:solidFill>
+                        <a:srgbClr val="E1E0D9"/>
+                      </a:solidFill>
+                      <a:prstDash val="solid"/>
+                      <a:round/>
+                      <a:headEnd type="none" w="med" len="med"/>
+                      <a:tailEnd type="none" w="med" len="med"/>
+                    </a:lnL>
+                    <a:lnR w="9525" cap="flat" cmpd="sng" algn="ctr">
+                      <a:solidFill>
+                        <a:srgbClr val="E1E0D9"/>
+                      </a:solidFill>
+                      <a:prstDash val="solid"/>
+                      <a:round/>
+                      <a:headEnd type="none" w="med" len="med"/>
+                      <a:tailEnd type="none" w="med" len="med"/>
+                    </a:lnR>
+                    <a:lnT w="9525" cap="flat" cmpd="sng" algn="ctr">
+                      <a:solidFill>
+                        <a:srgbClr val="E1E0D9"/>
+                      </a:solidFill>
+                      <a:prstDash val="solid"/>
+                      <a:round/>
+                      <a:headEnd type="none" w="med" len="med"/>
+                      <a:tailEnd type="none" w="med" len="med"/>
+                    </a:lnT>
+                    <a:lnB w="9525" cap="flat" cmpd="sng" algn="ctr">
+                      <a:solidFill>
+                        <a:srgbClr val="E1E0D9"/>
+                      </a:solidFill>
+                      <a:prstDash val="solid"/>
+                      <a:round/>
+                      <a:headEnd type="none" w="med" len="med"/>
+                      <a:tailEnd type="none" w="med" len="med"/>
+                    </a:lnB>
+                  </a:tcPr>
+                </a:tc>
+              </a:tr>
+              <a:tr h="310896">
+                <a:tc>
+                  <a:txBody>
+                    <a:bodyPr/>
+                    <a:lstStyle/>
+                    <a:p>
+                      <a:pPr algn="l" indent="0" marL="0">
+                        <a:buNone/>
+                      </a:pPr>
+                      <a:r>
+                        <a:rPr lang="en-US" sz="1150" b="1" dirty="0">
+                          <a:solidFill>
+                            <a:srgbClr val="0B0B0B"/>
+                          </a:solidFill>
+                          <a:latin typeface="Aptos" pitchFamily="34" charset="0"/>
+                          <a:ea typeface="Aptos" pitchFamily="34" charset="-122"/>
+                          <a:cs typeface="Aptos" pitchFamily="34" charset="-120"/>
+                        </a:rPr>
+                        <a:t>DN20</a:t>
+                      </a:r>
+                      <a:endParaRPr lang="en-US" sz="1150" dirty="0">
+                        <a:latin typeface="Aptos" charset="0"/>
+                        <a:ea typeface="Aptos" charset="0"/>
+                        <a:cs typeface="Aptos" charset="0"/>
+                      </a:endParaRPr>
+                    </a:p>
+                  </a:txBody>
+                  <a:tcPr marL="54864" marR="54864" marT="54864" marB="54864" anchor="ctr">
+                    <a:lnL w="9525" cap="flat" cmpd="sng" algn="ctr">
+                      <a:solidFill>
+                        <a:srgbClr val="E1E0D9"/>
+                      </a:solidFill>
+                      <a:prstDash val="solid"/>
+                      <a:round/>
+                      <a:headEnd type="none" w="med" len="med"/>
+                      <a:tailEnd type="none" w="med" len="med"/>
+                    </a:lnL>
+                    <a:lnR w="9525" cap="flat" cmpd="sng" algn="ctr">
+                      <a:solidFill>
+                        <a:srgbClr val="E1E0D9"/>
+                      </a:solidFill>
+                      <a:prstDash val="solid"/>
+                      <a:round/>
+                      <a:headEnd type="none" w="med" len="med"/>
+                      <a:tailEnd type="none" w="med" len="med"/>
+                    </a:lnR>
+                    <a:lnT w="9525" cap="flat" cmpd="sng" algn="ctr">
+                      <a:solidFill>
+                        <a:srgbClr val="E1E0D9"/>
+                      </a:solidFill>
+                      <a:prstDash val="solid"/>
+                      <a:round/>
+                      <a:headEnd type="none" w="med" len="med"/>
+                      <a:tailEnd type="none" w="med" len="med"/>
+                    </a:lnT>
+                    <a:lnB w="9525" cap="flat" cmpd="sng" algn="ctr">
+                      <a:solidFill>
+                        <a:srgbClr val="E1E0D9"/>
+                      </a:solidFill>
+                      <a:prstDash val="solid"/>
+                      <a:round/>
+                      <a:headEnd type="none" w="med" len="med"/>
+                      <a:tailEnd type="none" w="med" len="med"/>
+                    </a:lnB>
+                  </a:tcPr>
+                </a:tc>
+                <a:tc>
+                  <a:txBody>
+                    <a:bodyPr/>
+                    <a:lstStyle/>
+                    <a:p>
+                      <a:pPr algn="l" indent="0" marL="0">
+                        <a:buNone/>
+                      </a:pPr>
+                      <a:r>
+                        <a:rPr lang="en-US" sz="1150" dirty="0">
+                          <a:solidFill>
+                            <a:srgbClr val="2A78D6"/>
+                          </a:solidFill>
+                          <a:latin typeface="Aptos" pitchFamily="34" charset="0"/>
+                          <a:ea typeface="Aptos" pitchFamily="34" charset="-122"/>
+                          <a:cs typeface="Aptos" pitchFamily="34" charset="-120"/>
+                        </a:rPr>
+                        <a:t>● </a:t>
+                      </a:r>
+                      <a:pPr algn="l" indent="0" marL="0">
+                        <a:buNone/>
+                      </a:pPr>
+                      <a:r>
+                        <a:rPr lang="en-US" sz="1150" dirty="0">
+                          <a:solidFill>
+                            <a:srgbClr val="0B0B0B"/>
+                          </a:solidFill>
+                          <a:latin typeface="Aptos" pitchFamily="34" charset="0"/>
+                          <a:ea typeface="Aptos" pitchFamily="34" charset="-122"/>
+                          <a:cs typeface="Aptos" pitchFamily="34" charset="-120"/>
+                        </a:rPr>
+                        <a:t>domestic water</a:t>
+                      </a:r>
+                      <a:endParaRPr lang="en-US" sz="1150" dirty="0">
+                        <a:latin typeface="Aptos" charset="0"/>
+                        <a:ea typeface="Aptos" charset="0"/>
+                        <a:cs typeface="Aptos" charset="0"/>
+                      </a:endParaRPr>
+                    </a:p>
+                  </a:txBody>
+                  <a:tcPr marL="54864" marR="54864" marT="54864" marB="54864" anchor="ctr">
+                    <a:lnL w="9525" cap="flat" cmpd="sng" algn="ctr">
+                      <a:solidFill>
+                        <a:srgbClr val="E1E0D9"/>
+                      </a:solidFill>
+                      <a:prstDash val="solid"/>
+                      <a:round/>
+                      <a:headEnd type="none" w="med" len="med"/>
+                      <a:tailEnd type="none" w="med" len="med"/>
+                    </a:lnL>
+                    <a:lnR w="9525" cap="flat" cmpd="sng" algn="ctr">
+                      <a:solidFill>
+                        <a:srgbClr val="E1E0D9"/>
+                      </a:solidFill>
+                      <a:prstDash val="solid"/>
+                      <a:round/>
+                      <a:headEnd type="none" w="med" len="med"/>
+                      <a:tailEnd type="none" w="med" len="med"/>
+                    </a:lnR>
+                    <a:lnT w="9525" cap="flat" cmpd="sng" algn="ctr">
+                      <a:solidFill>
+                        <a:srgbClr val="E1E0D9"/>
+                      </a:solidFill>
+                      <a:prstDash val="solid"/>
+                      <a:round/>
+                      <a:headEnd type="none" w="med" len="med"/>
+                      <a:tailEnd type="none" w="med" len="med"/>
+                    </a:lnT>
+                    <a:lnB w="9525" cap="flat" cmpd="sng" algn="ctr">
+                      <a:solidFill>
+                        <a:srgbClr val="E1E0D9"/>
+                      </a:solidFill>
+                      <a:prstDash val="solid"/>
+                      <a:round/>
+                      <a:headEnd type="none" w="med" len="med"/>
+                      <a:tailEnd type="none" w="med" len="med"/>
+                    </a:lnB>
+                  </a:tcPr>
+                </a:tc>
+                <a:tc>
+                  <a:txBody>
+                    <a:bodyPr/>
+                    <a:lstStyle/>
+                    <a:p>
+                      <a:pPr algn="r" indent="0" marL="0">
+                        <a:buNone/>
+                      </a:pPr>
+                      <a:r>
+                        <a:rPr lang="en-US" sz="1150" dirty="0">
+                          <a:solidFill>
+                            <a:srgbClr val="0B0B0B"/>
+                          </a:solidFill>
+                          <a:latin typeface="Aptos" pitchFamily="34" charset="0"/>
+                          <a:ea typeface="Aptos" pitchFamily="34" charset="-122"/>
+                          <a:cs typeface="Aptos" pitchFamily="34" charset="-120"/>
+                        </a:rPr>
+                        <a:t>0</a:t>
+                      </a:r>
+                      <a:endParaRPr lang="en-US" sz="1150" dirty="0">
+                        <a:latin typeface="Aptos" charset="0"/>
+                        <a:ea typeface="Aptos" charset="0"/>
+                        <a:cs typeface="Aptos" charset="0"/>
+                      </a:endParaRPr>
+                    </a:p>
+                  </a:txBody>
+                  <a:tcPr marL="54864" marR="54864" marT="54864" marB="54864" anchor="ctr">
+                    <a:lnL w="9525" cap="flat" cmpd="sng" algn="ctr">
+                      <a:solidFill>
+                        <a:srgbClr val="E1E0D9"/>
+                      </a:solidFill>
+                      <a:prstDash val="solid"/>
+                      <a:round/>
+                      <a:headEnd type="none" w="med" len="med"/>
+                      <a:tailEnd type="none" w="med" len="med"/>
+                    </a:lnL>
+                    <a:lnR w="9525" cap="flat" cmpd="sng" algn="ctr">
+                      <a:solidFill>
+                        <a:srgbClr val="E1E0D9"/>
+                      </a:solidFill>
+                      <a:prstDash val="solid"/>
+                      <a:round/>
+                      <a:headEnd type="none" w="med" len="med"/>
+                      <a:tailEnd type="none" w="med" len="med"/>
+                    </a:lnR>
+                    <a:lnT w="9525" cap="flat" cmpd="sng" algn="ctr">
+                      <a:solidFill>
+                        <a:srgbClr val="E1E0D9"/>
+                      </a:solidFill>
+                      <a:prstDash val="solid"/>
+                      <a:round/>
+                      <a:headEnd type="none" w="med" len="med"/>
+                      <a:tailEnd type="none" w="med" len="med"/>
+                    </a:lnT>
+                    <a:lnB w="9525" cap="flat" cmpd="sng" algn="ctr">
+                      <a:solidFill>
+                        <a:srgbClr val="E1E0D9"/>
+                      </a:solidFill>
+                      <a:prstDash val="solid"/>
+                      <a:round/>
+                      <a:headEnd type="none" w="med" len="med"/>
+                      <a:tailEnd type="none" w="med" len="med"/>
+                    </a:lnB>
+                  </a:tcPr>
+                </a:tc>
+                <a:tc>
+                  <a:txBody>
+                    <a:bodyPr/>
+                    <a:lstStyle/>
+                    <a:p>
+                      <a:pPr algn="r" indent="0" marL="0">
+                        <a:buNone/>
+                      </a:pPr>
+                      <a:r>
+                        <a:rPr lang="en-US" sz="1150" dirty="0">
+                          <a:solidFill>
+                            <a:srgbClr val="0B0B0B"/>
+                          </a:solidFill>
+                          <a:latin typeface="Aptos" pitchFamily="34" charset="0"/>
+                          <a:ea typeface="Aptos" pitchFamily="34" charset="-122"/>
+                          <a:cs typeface="Aptos" pitchFamily="34" charset="-120"/>
+                        </a:rPr>
+                        <a:t>0.019</a:t>
+                      </a:r>
+                      <a:endParaRPr lang="en-US" sz="1150" dirty="0">
+                        <a:latin typeface="Aptos" charset="0"/>
+                        <a:ea typeface="Aptos" charset="0"/>
+                        <a:cs typeface="Aptos" charset="0"/>
+                      </a:endParaRPr>
+                    </a:p>
+                  </a:txBody>
+                  <a:tcPr marL="54864" marR="54864" marT="54864" marB="54864" anchor="ctr">
+                    <a:lnL w="9525" cap="flat" cmpd="sng" algn="ctr">
+                      <a:solidFill>
+                        <a:srgbClr val="E1E0D9"/>
+                      </a:solidFill>
+                      <a:prstDash val="solid"/>
+                      <a:round/>
+                      <a:headEnd type="none" w="med" len="med"/>
+                      <a:tailEnd type="none" w="med" len="med"/>
+                    </a:lnL>
+                    <a:lnR w="9525" cap="flat" cmpd="sng" algn="ctr">
+                      <a:solidFill>
+                        <a:srgbClr val="E1E0D9"/>
+                      </a:solidFill>
+                      <a:prstDash val="solid"/>
+                      <a:round/>
+                      <a:headEnd type="none" w="med" len="med"/>
+                      <a:tailEnd type="none" w="med" len="med"/>
+                    </a:lnR>
+                    <a:lnT w="9525" cap="flat" cmpd="sng" algn="ctr">
+                      <a:solidFill>
+                        <a:srgbClr val="E1E0D9"/>
+                      </a:solidFill>
+                      <a:prstDash val="solid"/>
+                      <a:round/>
+                      <a:headEnd type="none" w="med" len="med"/>
+                      <a:tailEnd type="none" w="med" len="med"/>
+                    </a:lnT>
+                    <a:lnB w="9525" cap="flat" cmpd="sng" algn="ctr">
+                      <a:solidFill>
+                        <a:srgbClr val="E1E0D9"/>
+                      </a:solidFill>
+                      <a:prstDash val="solid"/>
+                      <a:round/>
+                      <a:headEnd type="none" w="med" len="med"/>
+                      <a:tailEnd type="none" w="med" len="med"/>
+                    </a:lnB>
+                  </a:tcPr>
+                </a:tc>
+                <a:tc>
+                  <a:txBody>
+                    <a:bodyPr/>
+                    <a:lstStyle/>
+                    <a:p>
+                      <a:pPr algn="r" indent="0" marL="0">
+                        <a:buNone/>
+                      </a:pPr>
+                      <a:r>
+                        <a:rPr lang="en-US" sz="1150" dirty="0">
+                          <a:solidFill>
+                            <a:srgbClr val="0B0B0B"/>
+                          </a:solidFill>
+                          <a:latin typeface="Aptos" pitchFamily="34" charset="0"/>
+                          <a:ea typeface="Aptos" pitchFamily="34" charset="-122"/>
+                          <a:cs typeface="Aptos" pitchFamily="34" charset="-120"/>
+                        </a:rPr>
+                        <a:t>2.1 m</a:t>
+                      </a:r>
+                      <a:endParaRPr lang="en-US" sz="1150" dirty="0">
+                        <a:latin typeface="Aptos" charset="0"/>
+                        <a:ea typeface="Aptos" charset="0"/>
+                        <a:cs typeface="Aptos" charset="0"/>
+                      </a:endParaRPr>
+                    </a:p>
+                  </a:txBody>
+                  <a:tcPr marL="54864" marR="54864" marT="54864" marB="54864" anchor="ctr">
+                    <a:lnL w="9525" cap="flat" cmpd="sng" algn="ctr">
+                      <a:solidFill>
+                        <a:srgbClr val="E1E0D9"/>
+                      </a:solidFill>
+                      <a:prstDash val="solid"/>
+                      <a:round/>
+                      <a:headEnd type="none" w="med" len="med"/>
+                      <a:tailEnd type="none" w="med" len="med"/>
+                    </a:lnL>
+                    <a:lnR w="9525" cap="flat" cmpd="sng" algn="ctr">
+                      <a:solidFill>
+                        <a:srgbClr val="E1E0D9"/>
+                      </a:solidFill>
+                      <a:prstDash val="solid"/>
+                      <a:round/>
+                      <a:headEnd type="none" w="med" len="med"/>
+                      <a:tailEnd type="none" w="med" len="med"/>
+                    </a:lnR>
+                    <a:lnT w="9525" cap="flat" cmpd="sng" algn="ctr">
+                      <a:solidFill>
+                        <a:srgbClr val="E1E0D9"/>
+                      </a:solidFill>
+                      <a:prstDash val="solid"/>
+                      <a:round/>
+                      <a:headEnd type="none" w="med" len="med"/>
+                      <a:tailEnd type="none" w="med" len="med"/>
+                    </a:lnT>
+                    <a:lnB w="9525" cap="flat" cmpd="sng" algn="ctr">
+                      <a:solidFill>
+                        <a:srgbClr val="E1E0D9"/>
+                      </a:solidFill>
+                      <a:prstDash val="solid"/>
+                      <a:round/>
+                      <a:headEnd type="none" w="med" len="med"/>
+                      <a:tailEnd type="none" w="med" len="med"/>
+                    </a:lnB>
+                  </a:tcPr>
+                </a:tc>
+                <a:tc>
+                  <a:txBody>
+                    <a:bodyPr/>
+                    <a:lstStyle/>
+                    <a:p>
+                      <a:pPr algn="r" indent="0" marL="0">
+                        <a:buNone/>
+                      </a:pPr>
+                      <a:r>
+                        <a:rPr lang="en-US" sz="1150" b="1" dirty="0">
+                          <a:solidFill>
+                            <a:srgbClr val="0B0B0B"/>
+                          </a:solidFill>
+                          <a:latin typeface="Aptos" pitchFamily="34" charset="0"/>
+                          <a:ea typeface="Aptos" pitchFamily="34" charset="-122"/>
+                          <a:cs typeface="Aptos" pitchFamily="34" charset="-120"/>
+                        </a:rPr>
+                        <a:t>0.04</a:t>
+                      </a:r>
+                      <a:endParaRPr lang="en-US" sz="1150" dirty="0">
+                        <a:latin typeface="Aptos" charset="0"/>
+                        <a:ea typeface="Aptos" charset="0"/>
+                        <a:cs typeface="Aptos" charset="0"/>
+                      </a:endParaRPr>
+                    </a:p>
+                  </a:txBody>
+                  <a:tcPr marL="54864" marR="54864" marT="54864" marB="54864" anchor="ctr">
+                    <a:lnL w="9525" cap="flat" cmpd="sng" algn="ctr">
+                      <a:solidFill>
+                        <a:srgbClr val="E1E0D9"/>
+                      </a:solidFill>
+                      <a:prstDash val="solid"/>
+                      <a:round/>
+                      <a:headEnd type="none" w="med" len="med"/>
+                      <a:tailEnd type="none" w="med" len="med"/>
+                    </a:lnL>
+                    <a:lnR w="9525" cap="flat" cmpd="sng" algn="ctr">
+                      <a:solidFill>
+                        <a:srgbClr val="E1E0D9"/>
+                      </a:solidFill>
+                      <a:prstDash val="solid"/>
+                      <a:round/>
+                      <a:headEnd type="none" w="med" len="med"/>
+                      <a:tailEnd type="none" w="med" len="med"/>
+                    </a:lnR>
+                    <a:lnT w="9525" cap="flat" cmpd="sng" algn="ctr">
+                      <a:solidFill>
+                        <a:srgbClr val="E1E0D9"/>
+                      </a:solidFill>
+                      <a:prstDash val="solid"/>
+                      <a:round/>
+                      <a:headEnd type="none" w="med" len="med"/>
+                      <a:tailEnd type="none" w="med" len="med"/>
+                    </a:lnT>
+                    <a:lnB w="9525" cap="flat" cmpd="sng" algn="ctr">
+                      <a:solidFill>
+                        <a:srgbClr val="E1E0D9"/>
+                      </a:solidFill>
+                      <a:prstDash val="solid"/>
+                      <a:round/>
+                      <a:headEnd type="none" w="med" len="med"/>
+                      <a:tailEnd type="none" w="med" len="med"/>
+                    </a:lnB>
+                  </a:tcPr>
+                </a:tc>
+              </a:tr>
+            </a:tbl>
+          </a:graphicData>
+        </a:graphic>
+      </p:graphicFrame>
+      <p:sp>
+        <p:nvSpPr>
+          <p:cNvPr id="19" name="fact ceiling slab, concrete C30"/>
+          <p:cNvSpPr/>
+          <p:nvPr/>
+        </p:nvSpPr>
+        <p:spPr>
+          <a:xfrm>
+            <a:off x="6537960" y="3785616"/>
+            <a:ext cx="1609344" cy="914400"/>
+          </a:xfrm>
+          <a:prstGeom prst="roundRect">
+            <a:avLst>
+              <a:gd name="adj" fmla="val 7000"/>
+            </a:avLst>
+          </a:prstGeom>
+          <a:solidFill>
+            <a:schemeClr val="bg2"/>
+          </a:solidFill>
+          <a:ln/>
+        </p:spPr>
+      </p:sp>
+      <p:sp>
+        <p:nvSpPr>
+          <p:cNvPr id="20" name="icon ring fact ceiling slab, concrete C30"/>
+          <p:cNvSpPr/>
+          <p:nvPr/>
+        </p:nvSpPr>
+        <p:spPr>
+          <a:xfrm>
+            <a:off x="6675120" y="4014216"/>
+            <a:ext cx="457200" cy="457200"/>
+          </a:xfrm>
+          <a:prstGeom prst="ellipse">
+            <a:avLst/>
+          </a:prstGeom>
+          <a:solidFill>
+            <a:schemeClr val="accent1"/>
+          </a:solidFill>
+          <a:ln/>
+        </p:spPr>
+      </p:sp>
+      <p:pic>
+        <p:nvPicPr>
+          <p:cNvPr id="21" name="icon fact ceiling slab, concrete C30" descr="preencoded.png">    </p:cNvPr>
+          <p:cNvPicPr>
+            <a:picLocks noChangeAspect="1"/>
+          </p:cNvPicPr>
+          <p:nvPr/>
+        </p:nvPicPr>
+        <p:blipFill>
+          <a:blip r:embed="rId2"/>
+          <a:stretch>
+            <a:fillRect/>
+          </a:stretch>
+        </p:blipFill>
+        <p:spPr>
+          <a:xfrm>
+            <a:off x="6771132" y="4110228"/>
+            <a:ext cx="265176" cy="265176"/>
+          </a:xfrm>
+          <a:prstGeom prst="rect">
+            <a:avLst/>
+          </a:prstGeom>
+        </p:spPr>
+      </p:pic>
+      <p:sp>
+        <p:nvSpPr>
+          <p:cNvPr id="22" name="fact text ceiling slab, concrete C30"/>
+          <p:cNvSpPr txBox="1"/>
+          <p:nvPr/>
+        </p:nvSpPr>
+        <p:spPr>
+          <a:xfrm>
+            <a:off x="7223760" y="3858768"/>
+            <a:ext cx="832104" cy="768096"/>
+          </a:xfrm>
+          <a:prstGeom prst="rect">
+            <a:avLst/>
+          </a:prstGeom>
+          <a:noFill/>
+          <a:ln/>
+        </p:spPr>
+        <p:txBody>
+          <a:bodyPr wrap="square" lIns="0" tIns="0" rIns="0" bIns="0" rtlCol="0" anchor="ctr"/>
+          <a:lstStyle/>
+          <a:p>
+            <a:pPr indent="0" marL="0">
+              <a:buNone/>
+            </a:pPr>
+            <a:r>
+              <a:rPr lang="en-US" sz="1250" b="1" dirty="0">
+                <a:solidFill>
+                  <a:schemeClr val="tx1"/>
+                </a:solidFill>
+              </a:rPr>
+              <a:t>150 mm</a:t>
+            </a:r>
+            <a:endParaRPr lang="en-US" sz="1250" dirty="0"/>
+          </a:p>
+          <a:p>
+            <a:pPr indent="0" marL="0">
+              <a:buNone/>
+            </a:pPr>
+            <a:r>
+              <a:rPr lang="en-US" sz="950" dirty="0">
                 <a:solidFill>
                   <a:srgbClr val="52514E"/>
                 </a:solidFill>
               </a:rPr>
-              <a:t>Per element: kind, service and trade · bare size · insulation per side · load per metre × the span it was sized at = load at the support · position along and out from the surface. Per context: slab or wall, substrate, thickness. Absent by design: channel, rods, clamps, anchors — and any “correct” answer, since a feasible support depends on the catalog you build from.</a:t>
+              <a:t>ceiling slab, concrete C30</a:t>
             </a:r>
-            <a:endParaRPr lang="en-US" sz="1100" dirty="0"/>
+            <a:endParaRPr lang="en-US" sz="1250" dirty="0"/>
+          </a:p>
+        </p:txBody>
+      </p:sp>
+      <p:sp>
+        <p:nvSpPr>
+          <p:cNvPr id="23" name="fact total load at this support"/>
+          <p:cNvSpPr/>
+          <p:nvPr/>
+        </p:nvSpPr>
+        <p:spPr>
+          <a:xfrm>
+            <a:off x="8284464" y="3785616"/>
+            <a:ext cx="1609344" cy="914400"/>
+          </a:xfrm>
+          <a:prstGeom prst="roundRect">
+            <a:avLst>
+              <a:gd name="adj" fmla="val 7000"/>
+            </a:avLst>
+          </a:prstGeom>
+          <a:solidFill>
+            <a:schemeClr val="bg2"/>
+          </a:solidFill>
+          <a:ln/>
+        </p:spPr>
+      </p:sp>
+      <p:sp>
+        <p:nvSpPr>
+          <p:cNvPr id="24" name="icon ring fact total load at this support"/>
+          <p:cNvSpPr/>
+          <p:nvPr/>
+        </p:nvSpPr>
+        <p:spPr>
+          <a:xfrm>
+            <a:off x="8421624" y="4014216"/>
+            <a:ext cx="457200" cy="457200"/>
+          </a:xfrm>
+          <a:prstGeom prst="ellipse">
+            <a:avLst/>
+          </a:prstGeom>
+          <a:solidFill>
+            <a:schemeClr val="accent1"/>
+          </a:solidFill>
+          <a:ln/>
+        </p:spPr>
+      </p:sp>
+      <p:pic>
+        <p:nvPicPr>
+          <p:cNvPr id="25" name="icon fact total load at this support" descr="preencoded.png">    </p:cNvPr>
+          <p:cNvPicPr>
+            <a:picLocks noChangeAspect="1"/>
+          </p:cNvPicPr>
+          <p:nvPr/>
+        </p:nvPicPr>
+        <p:blipFill>
+          <a:blip r:embed="rId3"/>
+          <a:stretch>
+            <a:fillRect/>
+          </a:stretch>
+        </p:blipFill>
+        <p:spPr>
+          <a:xfrm>
+            <a:off x="8517636" y="4110228"/>
+            <a:ext cx="265176" cy="265176"/>
+          </a:xfrm>
+          <a:prstGeom prst="rect">
+            <a:avLst/>
+          </a:prstGeom>
+        </p:spPr>
+      </p:pic>
+      <p:sp>
+        <p:nvSpPr>
+          <p:cNvPr id="26" name="fact text total load at this support"/>
+          <p:cNvSpPr txBox="1"/>
+          <p:nvPr/>
+        </p:nvSpPr>
+        <p:spPr>
+          <a:xfrm>
+            <a:off x="8970264" y="3858768"/>
+            <a:ext cx="832104" cy="768096"/>
+          </a:xfrm>
+          <a:prstGeom prst="rect">
+            <a:avLst/>
+          </a:prstGeom>
+          <a:noFill/>
+          <a:ln/>
+        </p:spPr>
+        <p:txBody>
+          <a:bodyPr wrap="square" lIns="0" tIns="0" rIns="0" bIns="0" rtlCol="0" anchor="ctr"/>
+          <a:lstStyle/>
+          <a:p>
+            <a:pPr indent="0" marL="0">
+              <a:buNone/>
+            </a:pPr>
+            <a:r>
+              <a:rPr lang="en-US" sz="1250" b="1" dirty="0">
+                <a:solidFill>
+                  <a:schemeClr val="tx1"/>
+                </a:solidFill>
+              </a:rPr>
+              <a:t>2.86 kN</a:t>
+            </a:r>
+            <a:endParaRPr lang="en-US" sz="1250" dirty="0"/>
+          </a:p>
+          <a:p>
+            <a:pPr indent="0" marL="0">
+              <a:buNone/>
+            </a:pPr>
+            <a:r>
+              <a:rPr lang="en-US" sz="950" dirty="0">
+                <a:solidFill>
+                  <a:srgbClr val="52514E"/>
+                </a:solidFill>
+              </a:rPr>
+              <a:t>total load at this support</a:t>
+            </a:r>
+            <a:endParaRPr lang="en-US" sz="1250" dirty="0"/>
+          </a:p>
+        </p:txBody>
+      </p:sp>
+      <p:sp>
+        <p:nvSpPr>
+          <p:cNvPr id="27" name="fact closest clear gap, 2 rows"/>
+          <p:cNvSpPr/>
+          <p:nvPr/>
+        </p:nvSpPr>
+        <p:spPr>
+          <a:xfrm>
+            <a:off x="10030968" y="3785616"/>
+            <a:ext cx="1609344" cy="914400"/>
+          </a:xfrm>
+          <a:prstGeom prst="roundRect">
+            <a:avLst>
+              <a:gd name="adj" fmla="val 7000"/>
+            </a:avLst>
+          </a:prstGeom>
+          <a:solidFill>
+            <a:schemeClr val="bg2"/>
+          </a:solidFill>
+          <a:ln/>
+        </p:spPr>
+      </p:sp>
+      <p:sp>
+        <p:nvSpPr>
+          <p:cNvPr id="28" name="icon ring fact closest clear gap, 2 rows"/>
+          <p:cNvSpPr/>
+          <p:nvPr/>
+        </p:nvSpPr>
+        <p:spPr>
+          <a:xfrm>
+            <a:off x="10168128" y="4014216"/>
+            <a:ext cx="457200" cy="457200"/>
+          </a:xfrm>
+          <a:prstGeom prst="ellipse">
+            <a:avLst/>
+          </a:prstGeom>
+          <a:solidFill>
+            <a:schemeClr val="accent1"/>
+          </a:solidFill>
+          <a:ln/>
+        </p:spPr>
+      </p:sp>
+      <p:pic>
+        <p:nvPicPr>
+          <p:cNvPr id="29" name="icon fact closest clear gap, 2 rows" descr="preencoded.png">    </p:cNvPr>
+          <p:cNvPicPr>
+            <a:picLocks noChangeAspect="1"/>
+          </p:cNvPicPr>
+          <p:nvPr/>
+        </p:nvPicPr>
+        <p:blipFill>
+          <a:blip r:embed="rId4"/>
+          <a:stretch>
+            <a:fillRect/>
+          </a:stretch>
+        </p:blipFill>
+        <p:spPr>
+          <a:xfrm>
+            <a:off x="10264140" y="4110228"/>
+            <a:ext cx="265176" cy="265176"/>
+          </a:xfrm>
+          <a:prstGeom prst="rect">
+            <a:avLst/>
+          </a:prstGeom>
+        </p:spPr>
+      </p:pic>
+      <p:sp>
+        <p:nvSpPr>
+          <p:cNvPr id="30" name="fact text closest clear gap, 2 rows"/>
+          <p:cNvSpPr txBox="1"/>
+          <p:nvPr/>
+        </p:nvSpPr>
+        <p:spPr>
+          <a:xfrm>
+            <a:off x="10716768" y="3858768"/>
+            <a:ext cx="832104" cy="768096"/>
+          </a:xfrm>
+          <a:prstGeom prst="rect">
+            <a:avLst/>
+          </a:prstGeom>
+          <a:noFill/>
+          <a:ln/>
+        </p:spPr>
+        <p:txBody>
+          <a:bodyPr wrap="square" lIns="0" tIns="0" rIns="0" bIns="0" rtlCol="0" anchor="ctr"/>
+          <a:lstStyle/>
+          <a:p>
+            <a:pPr indent="0" marL="0">
+              <a:buNone/>
+            </a:pPr>
+            <a:r>
+              <a:rPr lang="en-US" sz="1250" b="1" dirty="0">
+                <a:solidFill>
+                  <a:schemeClr val="tx1"/>
+                </a:solidFill>
+              </a:rPr>
+              <a:t>72 mm</a:t>
+            </a:r>
+            <a:endParaRPr lang="en-US" sz="1250" dirty="0"/>
+          </a:p>
+          <a:p>
+            <a:pPr indent="0" marL="0">
+              <a:buNone/>
+            </a:pPr>
+            <a:r>
+              <a:rPr lang="en-US" sz="950" dirty="0">
+                <a:solidFill>
+                  <a:srgbClr val="52514E"/>
+                </a:solidFill>
+              </a:rPr>
+              <a:t>closest clear gap, 2 rows</a:t>
+            </a:r>
+            <a:endParaRPr lang="en-US" sz="1250" dirty="0"/>
+          </a:p>
+        </p:txBody>
+      </p:sp>
+      <p:sp>
+        <p:nvSpPr>
+          <p:cNvPr id="31" name="absent band"/>
+          <p:cNvSpPr/>
+          <p:nvPr/>
+        </p:nvSpPr>
+        <p:spPr>
+          <a:xfrm>
+            <a:off x="6537960" y="4882896"/>
+            <a:ext cx="5102352" cy="1188720"/>
+          </a:xfrm>
+          <a:prstGeom prst="roundRect">
+            <a:avLst>
+              <a:gd name="adj" fmla="val 5385"/>
+            </a:avLst>
+          </a:prstGeom>
+          <a:solidFill>
+            <a:srgbClr val="1F2933"/>
+          </a:solidFill>
+          <a:ln/>
+        </p:spPr>
+      </p:sp>
+      <p:pic>
+        <p:nvPicPr>
+          <p:cNvPr id="32" name="icon absent" descr="preencoded.png">    </p:cNvPr>
+          <p:cNvPicPr>
+            <a:picLocks noChangeAspect="1"/>
+          </p:cNvPicPr>
+          <p:nvPr/>
+        </p:nvPicPr>
+        <p:blipFill>
+          <a:blip r:embed="rId5"/>
+          <a:stretch>
+            <a:fillRect/>
+          </a:stretch>
+        </p:blipFill>
+        <p:spPr>
+          <a:xfrm>
+            <a:off x="6766560" y="5248656"/>
+            <a:ext cx="457200" cy="457200"/>
+          </a:xfrm>
+          <a:prstGeom prst="rect">
+            <a:avLst/>
+          </a:prstGeom>
+        </p:spPr>
+      </p:pic>
+      <p:sp>
+        <p:nvSpPr>
+          <p:cNvPr id="33" name="absent text"/>
+          <p:cNvSpPr txBox="1"/>
+          <p:nvPr/>
+        </p:nvSpPr>
+        <p:spPr>
+          <a:xfrm>
+            <a:off x="7406640" y="4882896"/>
+            <a:ext cx="4050792" cy="1188720"/>
+          </a:xfrm>
+          <a:prstGeom prst="rect">
+            <a:avLst/>
+          </a:prstGeom>
+          <a:noFill/>
+          <a:ln/>
+        </p:spPr>
+        <p:txBody>
+          <a:bodyPr wrap="square" lIns="0" tIns="0" rIns="0" bIns="0" rtlCol="0" anchor="ctr"/>
+          <a:lstStyle/>
+          <a:p>
+            <a:pPr indent="0" marL="0">
+              <a:buNone/>
+            </a:pPr>
+            <a:r>
+              <a:rPr lang="en-US" sz="1200" b="1" dirty="0">
+                <a:solidFill>
+                  <a:srgbClr val="FFFFFF"/>
+                </a:solidFill>
+              </a:rPr>
+              <a:t>Not given, by design: </a:t>
+            </a:r>
+            <a:pPr indent="0" marL="0">
+              <a:buNone/>
+            </a:pPr>
+            <a:r>
+              <a:rPr lang="en-US" sz="1200" dirty="0">
+                <a:solidFill>
+                  <a:srgbClr val="CADCFC"/>
+                </a:solidFill>
+              </a:rPr>
+              <a:t>channel, rods, clamps, anchors. No correct answer either: a feasible support depends on the catalog you build from.</a:t>
+            </a:r>
+            <a:endParaRPr lang="en-US" sz="1200" dirty="0"/>
           </a:p>
         </p:txBody>
       </p:sp>

</xml_diff>

<commit_message>
Talk: slide 8 steps as icon cards on a spine, shorter text, framed example
</commit_message>
<xml_diff>
--- a/docs/CrossMEP_CIBW78_talk.pptx
+++ b/docs/CrossMEP_CIBW78_talk.pptx
@@ -124,12 +124,12 @@
   <p:extLst>
     <p:ext uri="{521415D9-36F7-43E2-AB2F-B90AF26B5E84}">
       <p14:sectionLst xmlns:p14="http://schemas.microsoft.com/office/powerpoint/2010/main">
-        <p14:section name="Opening" id="{e27ff116-1ccd-9c27-6b2f-0734f46ab4cc}">
+        <p14:section name="Opening" id="{93bf4125-47cd-a3b7-1fc8-cfbc99c26387}">
           <p14:sldIdLst>
             <p14:sldId id="256"/>
           </p14:sldIdLst>
         </p14:section>
-        <p14:section name="Motivation" id="{6ce3a230-53d8-e1d1-70df-03d2e53c4c32}">
+        <p14:section name="Motivation" id="{06eb4631-d4aa-1a71-3433-9649db765e20}">
           <p14:sldIdLst>
             <p14:sldId id="257"/>
             <p14:sldId id="258"/>
@@ -138,7 +138,7 @@
             <p14:sldId id="261"/>
           </p14:sldIdLst>
         </p14:section>
-        <p14:section name="The dataset" id="{788fc9c9-fc18-ac66-06ca-4923dcc6a267}">
+        <p14:section name="The dataset" id="{914f84d8-c58c-8289-593b-42b33f4bb92a}">
           <p14:sldIdLst>
             <p14:sldId id="262"/>
             <p14:sldId id="263"/>
@@ -147,14 +147,14 @@
             <p14:sldId id="266"/>
           </p14:sldIdLst>
         </p14:section>
-        <p14:section name="Experiments" id="{045e68fa-2344-700d-f405-f6d802a982d6}">
+        <p14:section name="Experiments" id="{c0835315-0dc9-8c11-fd2f-eeec54b0c20f}">
           <p14:sldIdLst>
             <p14:sldId id="267"/>
             <p14:sldId id="268"/>
             <p14:sldId id="269"/>
           </p14:sldIdLst>
         </p14:section>
-        <p14:section name="Use" id="{20cd651a-bf81-13f0-70e6-91c7531796f7}">
+        <p14:section name="Use" id="{18268bb2-37e1-7df1-bbe0-94950d977d4e}">
           <p14:sldIdLst>
             <p14:sldId id="270"/>
             <p14:sldId id="271"/>
@@ -23778,13 +23778,58 @@
       </p:sp>
       <p:sp>
         <p:nvSpPr>
-          <p:cNvPr id="3" name="step circle 1"/>
-          <p:cNvSpPr/>
-          <p:nvPr/>
-        </p:nvSpPr>
-        <p:spPr>
-          <a:xfrm>
-            <a:off x="548640" y="1453896"/>
+          <p:cNvPr id="3" name="step spine"/>
+          <p:cNvSpPr/>
+          <p:nvPr/>
+        </p:nvSpPr>
+        <p:spPr>
+          <a:xfrm>
+            <a:off x="749808" y="1618488"/>
+            <a:ext cx="0" cy="3931920"/>
+          </a:xfrm>
+          <a:prstGeom prst="line">
+            <a:avLst/>
+          </a:prstGeom>
+          <a:noFill/>
+          <a:ln w="25400">
+            <a:solidFill>
+              <a:srgbClr val="E1E0D9"/>
+            </a:solidFill>
+            <a:prstDash val="solid"/>
+          </a:ln>
+        </p:spPr>
+      </p:sp>
+      <p:sp>
+        <p:nvSpPr>
+          <p:cNvPr id="4" name="step card 1"/>
+          <p:cNvSpPr/>
+          <p:nvPr/>
+        </p:nvSpPr>
+        <p:spPr>
+          <a:xfrm>
+            <a:off x="1097280" y="1417320"/>
+            <a:ext cx="5029200" cy="658368"/>
+          </a:xfrm>
+          <a:prstGeom prst="roundRect">
+            <a:avLst>
+              <a:gd name="adj" fmla="val 9722"/>
+            </a:avLst>
+          </a:prstGeom>
+          <a:solidFill>
+            <a:schemeClr val="bg2"/>
+          </a:solidFill>
+          <a:ln/>
+        </p:spPr>
+      </p:sp>
+      <p:sp>
+        <p:nvSpPr>
+          <p:cNvPr id="5" name="step circle 1"/>
+          <p:cNvSpPr/>
+          <p:nvPr/>
+        </p:nvSpPr>
+        <p:spPr>
+          <a:xfrm>
+            <a:off x="548640" y="1545336"/>
             <a:ext cx="402336" cy="402336"/>
           </a:xfrm>
           <a:prstGeom prst="ellipse">
@@ -23793,18 +23838,23 @@
           <a:solidFill>
             <a:schemeClr val="accent1"/>
           </a:solidFill>
-          <a:ln/>
-        </p:spPr>
-      </p:sp>
-      <p:sp>
-        <p:nvSpPr>
-          <p:cNvPr id="4" name="step number 1"/>
+          <a:ln w="19050">
+            <a:solidFill>
+              <a:srgbClr val="FFFFFF"/>
+            </a:solidFill>
+            <a:prstDash val="solid"/>
+          </a:ln>
+        </p:spPr>
+      </p:sp>
+      <p:sp>
+        <p:nvSpPr>
+          <p:cNvPr id="6" name="step number 1"/>
           <p:cNvSpPr txBox="1"/>
           <p:nvPr/>
         </p:nvSpPr>
         <p:spPr>
           <a:xfrm>
-            <a:off x="548640" y="1453896"/>
+            <a:off x="548640" y="1545336"/>
             <a:ext cx="402336" cy="402336"/>
           </a:xfrm>
           <a:prstGeom prst="rect">
@@ -23821,27 +23871,51 @@
               <a:buNone/>
             </a:pPr>
             <a:r>
-              <a:rPr lang="en-US" sz="1400" b="1" dirty="0">
+              <a:rPr lang="en-US" sz="1300" b="1" dirty="0">
                 <a:solidFill>
                   <a:schemeClr val="bg1"/>
                 </a:solidFill>
               </a:rPr>
               <a:t>1</a:t>
             </a:r>
-            <a:endParaRPr lang="en-US" sz="1400" dirty="0"/>
+            <a:endParaRPr lang="en-US" sz="1300" dirty="0"/>
           </a:p>
         </p:txBody>
       </p:sp>
-      <p:sp>
-        <p:nvSpPr>
-          <p:cNvPr id="5" name="step 1"/>
+      <p:pic>
+        <p:nvPicPr>
+          <p:cNvPr id="7" name="step icon Tier" descr="preencoded.png">    </p:cNvPr>
+          <p:cNvPicPr>
+            <a:picLocks noChangeAspect="1"/>
+          </p:cNvPicPr>
+          <p:nvPr/>
+        </p:nvPicPr>
+        <p:blipFill>
+          <a:blip r:embed="rId1"/>
+          <a:stretch>
+            <a:fillRect/>
+          </a:stretch>
+        </p:blipFill>
+        <p:spPr>
+          <a:xfrm>
+            <a:off x="1261872" y="1591056"/>
+            <a:ext cx="310896" cy="310896"/>
+          </a:xfrm>
+          <a:prstGeom prst="rect">
+            <a:avLst/>
+          </a:prstGeom>
+        </p:spPr>
+      </p:pic>
+      <p:sp>
+        <p:nvSpPr>
+          <p:cNvPr id="8" name="step 1"/>
           <p:cNvSpPr txBox="1"/>
           <p:nvPr/>
         </p:nvSpPr>
         <p:spPr>
           <a:xfrm>
-            <a:off x="1143000" y="1325880"/>
-            <a:ext cx="4983480" cy="658368"/>
+            <a:off x="1737360" y="1417320"/>
+            <a:ext cx="4251960" cy="658368"/>
           </a:xfrm>
           <a:prstGeom prst="rect">
             <a:avLst/>
@@ -23862,18 +23936,21 @@
                   <a:schemeClr val="tx1"/>
                 </a:solidFill>
               </a:rPr>
-              <a:t>Tier. </a:t>
+              <a:t>Tier</a:t>
             </a:r>
+            <a:endParaRPr lang="en-US" sz="1300" dirty="0"/>
+          </a:p>
+          <a:p>
             <a:pPr indent="0" marL="0">
               <a:buNone/>
             </a:pPr>
             <a:r>
-              <a:rPr lang="en-US" sz="1300" dirty="0">
+              <a:rPr lang="en-US" sz="1150" dirty="0">
                 <a:solidFill>
-                  <a:schemeClr val="tx1"/>
+                  <a:srgbClr val="52514E"/>
                 </a:solidFill>
               </a:rPr>
-              <a:t>Cn fixes the exact element count, n = 1 … 8.</a:t>
+              <a:t>Cn fixes the exact element count, n = 1 … 8</a:t>
             </a:r>
             <a:endParaRPr lang="en-US" sz="1300" dirty="0"/>
           </a:p>
@@ -23881,13 +23958,35 @@
       </p:sp>
       <p:sp>
         <p:nvSpPr>
-          <p:cNvPr id="6" name="step circle 2"/>
-          <p:cNvSpPr/>
-          <p:nvPr/>
-        </p:nvSpPr>
-        <p:spPr>
-          <a:xfrm>
-            <a:off x="548640" y="2240280"/>
+          <p:cNvPr id="9" name="step card 2"/>
+          <p:cNvSpPr/>
+          <p:nvPr/>
+        </p:nvSpPr>
+        <p:spPr>
+          <a:xfrm>
+            <a:off x="1097280" y="2203704"/>
+            <a:ext cx="5029200" cy="658368"/>
+          </a:xfrm>
+          <a:prstGeom prst="roundRect">
+            <a:avLst>
+              <a:gd name="adj" fmla="val 9722"/>
+            </a:avLst>
+          </a:prstGeom>
+          <a:solidFill>
+            <a:schemeClr val="bg2"/>
+          </a:solidFill>
+          <a:ln/>
+        </p:spPr>
+      </p:sp>
+      <p:sp>
+        <p:nvSpPr>
+          <p:cNvPr id="10" name="step circle 2"/>
+          <p:cNvSpPr/>
+          <p:nvPr/>
+        </p:nvSpPr>
+        <p:spPr>
+          <a:xfrm>
+            <a:off x="548640" y="2331720"/>
             <a:ext cx="402336" cy="402336"/>
           </a:xfrm>
           <a:prstGeom prst="ellipse">
@@ -23896,18 +23995,23 @@
           <a:solidFill>
             <a:schemeClr val="accent1"/>
           </a:solidFill>
-          <a:ln/>
-        </p:spPr>
-      </p:sp>
-      <p:sp>
-        <p:nvSpPr>
-          <p:cNvPr id="7" name="step number 2"/>
+          <a:ln w="19050">
+            <a:solidFill>
+              <a:srgbClr val="FFFFFF"/>
+            </a:solidFill>
+            <a:prstDash val="solid"/>
+          </a:ln>
+        </p:spPr>
+      </p:sp>
+      <p:sp>
+        <p:nvSpPr>
+          <p:cNvPr id="11" name="step number 2"/>
           <p:cNvSpPr txBox="1"/>
           <p:nvPr/>
         </p:nvSpPr>
         <p:spPr>
           <a:xfrm>
-            <a:off x="548640" y="2240280"/>
+            <a:off x="548640" y="2331720"/>
             <a:ext cx="402336" cy="402336"/>
           </a:xfrm>
           <a:prstGeom prst="rect">
@@ -23924,27 +24028,51 @@
               <a:buNone/>
             </a:pPr>
             <a:r>
-              <a:rPr lang="en-US" sz="1400" b="1" dirty="0">
+              <a:rPr lang="en-US" sz="1300" b="1" dirty="0">
                 <a:solidFill>
                   <a:schemeClr val="bg1"/>
                 </a:solidFill>
               </a:rPr>
               <a:t>2</a:t>
             </a:r>
-            <a:endParaRPr lang="en-US" sz="1400" dirty="0"/>
+            <a:endParaRPr lang="en-US" sz="1300" dirty="0"/>
           </a:p>
         </p:txBody>
       </p:sp>
-      <p:sp>
-        <p:nvSpPr>
-          <p:cNvPr id="8" name="step 2"/>
+      <p:pic>
+        <p:nvPicPr>
+          <p:cNvPr id="12" name="step icon Surface" descr="preencoded.png">    </p:cNvPr>
+          <p:cNvPicPr>
+            <a:picLocks noChangeAspect="1"/>
+          </p:cNvPicPr>
+          <p:nvPr/>
+        </p:nvPicPr>
+        <p:blipFill>
+          <a:blip r:embed="rId2"/>
+          <a:stretch>
+            <a:fillRect/>
+          </a:stretch>
+        </p:blipFill>
+        <p:spPr>
+          <a:xfrm>
+            <a:off x="1261872" y="2377440"/>
+            <a:ext cx="310896" cy="310896"/>
+          </a:xfrm>
+          <a:prstGeom prst="rect">
+            <a:avLst/>
+          </a:prstGeom>
+        </p:spPr>
+      </p:pic>
+      <p:sp>
+        <p:nvSpPr>
+          <p:cNvPr id="13" name="step 2"/>
           <p:cNvSpPr txBox="1"/>
           <p:nvPr/>
         </p:nvSpPr>
         <p:spPr>
           <a:xfrm>
-            <a:off x="1143000" y="2112264"/>
-            <a:ext cx="4983480" cy="658368"/>
+            <a:off x="1737360" y="2203704"/>
+            <a:ext cx="4251960" cy="658368"/>
           </a:xfrm>
           <a:prstGeom prst="rect">
             <a:avLst/>
@@ -23965,18 +24093,21 @@
                   <a:schemeClr val="tx1"/>
                 </a:solidFill>
               </a:rPr>
-              <a:t>Surface. </a:t>
+              <a:t>Surface</a:t>
             </a:r>
+            <a:endParaRPr lang="en-US" sz="1300" dirty="0"/>
+          </a:p>
+          <a:p>
             <a:pPr indent="0" marL="0">
               <a:buNone/>
             </a:pPr>
             <a:r>
-              <a:rPr lang="en-US" sz="1300" dirty="0">
+              <a:rPr lang="en-US" sz="1150" dirty="0">
                 <a:solidFill>
-                  <a:schemeClr val="tx1"/>
+                  <a:srgbClr val="52514E"/>
                 </a:solidFill>
               </a:rPr>
-              <a:t>Ceiling or wall (78 / 22 %); concrete slab or wall, 150–300 mm thick.</a:t>
+              <a:t>ceiling or wall (78 / 22 %); concrete, 150–300 mm thick</a:t>
             </a:r>
             <a:endParaRPr lang="en-US" sz="1300" dirty="0"/>
           </a:p>
@@ -23984,13 +24115,35 @@
       </p:sp>
       <p:sp>
         <p:nvSpPr>
-          <p:cNvPr id="9" name="step circle 3"/>
-          <p:cNvSpPr/>
-          <p:nvPr/>
-        </p:nvSpPr>
-        <p:spPr>
-          <a:xfrm>
-            <a:off x="548640" y="3026664"/>
+          <p:cNvPr id="14" name="step card 3"/>
+          <p:cNvSpPr/>
+          <p:nvPr/>
+        </p:nvSpPr>
+        <p:spPr>
+          <a:xfrm>
+            <a:off x="1097280" y="2990088"/>
+            <a:ext cx="5029200" cy="658368"/>
+          </a:xfrm>
+          <a:prstGeom prst="roundRect">
+            <a:avLst>
+              <a:gd name="adj" fmla="val 9722"/>
+            </a:avLst>
+          </a:prstGeom>
+          <a:solidFill>
+            <a:schemeClr val="bg2"/>
+          </a:solidFill>
+          <a:ln/>
+        </p:spPr>
+      </p:sp>
+      <p:sp>
+        <p:nvSpPr>
+          <p:cNvPr id="15" name="step circle 3"/>
+          <p:cNvSpPr/>
+          <p:nvPr/>
+        </p:nvSpPr>
+        <p:spPr>
+          <a:xfrm>
+            <a:off x="548640" y="3118104"/>
             <a:ext cx="402336" cy="402336"/>
           </a:xfrm>
           <a:prstGeom prst="ellipse">
@@ -23999,18 +24152,23 @@
           <a:solidFill>
             <a:schemeClr val="accent1"/>
           </a:solidFill>
-          <a:ln/>
-        </p:spPr>
-      </p:sp>
-      <p:sp>
-        <p:nvSpPr>
-          <p:cNvPr id="10" name="step number 3"/>
+          <a:ln w="19050">
+            <a:solidFill>
+              <a:srgbClr val="FFFFFF"/>
+            </a:solidFill>
+            <a:prstDash val="solid"/>
+          </a:ln>
+        </p:spPr>
+      </p:sp>
+      <p:sp>
+        <p:nvSpPr>
+          <p:cNvPr id="16" name="step number 3"/>
           <p:cNvSpPr txBox="1"/>
           <p:nvPr/>
         </p:nvSpPr>
         <p:spPr>
           <a:xfrm>
-            <a:off x="548640" y="3026664"/>
+            <a:off x="548640" y="3118104"/>
             <a:ext cx="402336" cy="402336"/>
           </a:xfrm>
           <a:prstGeom prst="rect">
@@ -24027,27 +24185,51 @@
               <a:buNone/>
             </a:pPr>
             <a:r>
-              <a:rPr lang="en-US" sz="1400" b="1" dirty="0">
+              <a:rPr lang="en-US" sz="1300" b="1" dirty="0">
                 <a:solidFill>
                   <a:schemeClr val="bg1"/>
                 </a:solidFill>
               </a:rPr>
               <a:t>3</a:t>
             </a:r>
-            <a:endParaRPr lang="en-US" sz="1400" dirty="0"/>
+            <a:endParaRPr lang="en-US" sz="1300" dirty="0"/>
           </a:p>
         </p:txBody>
       </p:sp>
-      <p:sp>
-        <p:nvSpPr>
-          <p:cNvPr id="11" name="step 3"/>
+      <p:pic>
+        <p:nvPicPr>
+          <p:cNvPr id="17" name="step icon Services" descr="preencoded.png">    </p:cNvPr>
+          <p:cNvPicPr>
+            <a:picLocks noChangeAspect="1"/>
+          </p:cNvPicPr>
+          <p:nvPr/>
+        </p:nvPicPr>
+        <p:blipFill>
+          <a:blip r:embed="rId3"/>
+          <a:stretch>
+            <a:fillRect/>
+          </a:stretch>
+        </p:blipFill>
+        <p:spPr>
+          <a:xfrm>
+            <a:off x="1261872" y="3163824"/>
+            <a:ext cx="310896" cy="310896"/>
+          </a:xfrm>
+          <a:prstGeom prst="rect">
+            <a:avLst/>
+          </a:prstGeom>
+        </p:spPr>
+      </p:pic>
+      <p:sp>
+        <p:nvSpPr>
+          <p:cNvPr id="18" name="step 3"/>
           <p:cNvSpPr txBox="1"/>
           <p:nvPr/>
         </p:nvSpPr>
         <p:spPr>
           <a:xfrm>
-            <a:off x="1143000" y="2898648"/>
-            <a:ext cx="4983480" cy="658368"/>
+            <a:off x="1737360" y="2990088"/>
+            <a:ext cx="4251960" cy="658368"/>
           </a:xfrm>
           <a:prstGeom prst="rect">
             <a:avLst/>
@@ -24068,18 +24250,21 @@
                   <a:schemeClr val="tx1"/>
                 </a:solidFill>
               </a:rPr>
-              <a:t>Services. </a:t>
+              <a:t>Services</a:t>
             </a:r>
+            <a:endParaRPr lang="en-US" sz="1300" dirty="0"/>
+          </a:p>
+          <a:p>
             <a:pPr indent="0" marL="0">
               <a:buNone/>
             </a:pPr>
             <a:r>
-              <a:rPr lang="en-US" sz="1300" dirty="0">
+              <a:rPr lang="en-US" sz="1150" dirty="0">
                 <a:solidFill>
-                  <a:schemeClr val="tx1"/>
+                  <a:srgbClr val="52514E"/>
                 </a:solidFill>
               </a:rPr>
-              <a:t>Grouped as trades run [3]: hot + cold pairs, flow + return, chilled banks, sprinkler mains, 1–2 trays, ducts, conduit groups of 2–6.</a:t>
+              <a:t>grouped as trades run [3]: hot + cold, flow + return, conduit groups, 1–2 trays, ducts</a:t>
             </a:r>
             <a:endParaRPr lang="en-US" sz="1300" dirty="0"/>
           </a:p>
@@ -24087,13 +24272,35 @@
       </p:sp>
       <p:sp>
         <p:nvSpPr>
-          <p:cNvPr id="12" name="step circle 4"/>
-          <p:cNvSpPr/>
-          <p:nvPr/>
-        </p:nvSpPr>
-        <p:spPr>
-          <a:xfrm>
-            <a:off x="548640" y="3813048"/>
+          <p:cNvPr id="19" name="step card 4"/>
+          <p:cNvSpPr/>
+          <p:nvPr/>
+        </p:nvSpPr>
+        <p:spPr>
+          <a:xfrm>
+            <a:off x="1097280" y="3776472"/>
+            <a:ext cx="5029200" cy="658368"/>
+          </a:xfrm>
+          <a:prstGeom prst="roundRect">
+            <a:avLst>
+              <a:gd name="adj" fmla="val 9722"/>
+            </a:avLst>
+          </a:prstGeom>
+          <a:solidFill>
+            <a:schemeClr val="bg2"/>
+          </a:solidFill>
+          <a:ln/>
+        </p:spPr>
+      </p:sp>
+      <p:sp>
+        <p:nvSpPr>
+          <p:cNvPr id="20" name="step circle 4"/>
+          <p:cNvSpPr/>
+          <p:nvPr/>
+        </p:nvSpPr>
+        <p:spPr>
+          <a:xfrm>
+            <a:off x="548640" y="3904488"/>
             <a:ext cx="402336" cy="402336"/>
           </a:xfrm>
           <a:prstGeom prst="ellipse">
@@ -24102,18 +24309,23 @@
           <a:solidFill>
             <a:schemeClr val="accent1"/>
           </a:solidFill>
-          <a:ln/>
-        </p:spPr>
-      </p:sp>
-      <p:sp>
-        <p:nvSpPr>
-          <p:cNvPr id="13" name="step number 4"/>
+          <a:ln w="19050">
+            <a:solidFill>
+              <a:srgbClr val="FFFFFF"/>
+            </a:solidFill>
+            <a:prstDash val="solid"/>
+          </a:ln>
+        </p:spPr>
+      </p:sp>
+      <p:sp>
+        <p:nvSpPr>
+          <p:cNvPr id="21" name="step number 4"/>
           <p:cNvSpPr txBox="1"/>
           <p:nvPr/>
         </p:nvSpPr>
         <p:spPr>
           <a:xfrm>
-            <a:off x="548640" y="3813048"/>
+            <a:off x="548640" y="3904488"/>
             <a:ext cx="402336" cy="402336"/>
           </a:xfrm>
           <a:prstGeom prst="rect">
@@ -24130,27 +24342,51 @@
               <a:buNone/>
             </a:pPr>
             <a:r>
-              <a:rPr lang="en-US" sz="1400" b="1" dirty="0">
+              <a:rPr lang="en-US" sz="1300" b="1" dirty="0">
                 <a:solidFill>
                   <a:schemeClr val="bg1"/>
                 </a:solidFill>
               </a:rPr>
               <a:t>4</a:t>
             </a:r>
-            <a:endParaRPr lang="en-US" sz="1400" dirty="0"/>
+            <a:endParaRPr lang="en-US" sz="1300" dirty="0"/>
           </a:p>
         </p:txBody>
       </p:sp>
-      <p:sp>
-        <p:nvSpPr>
-          <p:cNvPr id="14" name="step 4"/>
+      <p:pic>
+        <p:nvPicPr>
+          <p:cNvPr id="22" name="step icon Rows" descr="preencoded.png">    </p:cNvPr>
+          <p:cNvPicPr>
+            <a:picLocks noChangeAspect="1"/>
+          </p:cNvPicPr>
+          <p:nvPr/>
+        </p:nvPicPr>
+        <p:blipFill>
+          <a:blip r:embed="rId4"/>
+          <a:stretch>
+            <a:fillRect/>
+          </a:stretch>
+        </p:blipFill>
+        <p:spPr>
+          <a:xfrm>
+            <a:off x="1261872" y="3950208"/>
+            <a:ext cx="310896" cy="310896"/>
+          </a:xfrm>
+          <a:prstGeom prst="rect">
+            <a:avLst/>
+          </a:prstGeom>
+        </p:spPr>
+      </p:pic>
+      <p:sp>
+        <p:nvSpPr>
+          <p:cNvPr id="23" name="step 4"/>
           <p:cNvSpPr txBox="1"/>
           <p:nvPr/>
         </p:nvSpPr>
         <p:spPr>
           <a:xfrm>
-            <a:off x="1143000" y="3685032"/>
-            <a:ext cx="4983480" cy="658368"/>
+            <a:off x="1737360" y="3776472"/>
+            <a:ext cx="4251960" cy="658368"/>
           </a:xfrm>
           <a:prstGeom prst="rect">
             <a:avLst/>
@@ -24171,18 +24407,21 @@
                   <a:schemeClr val="tx1"/>
                 </a:solidFill>
               </a:rPr>
-              <a:t>Rows. </a:t>
+              <a:t>Rows</a:t>
             </a:r>
+            <a:endParaRPr lang="en-US" sz="1300" dirty="0"/>
+          </a:p>
+          <a:p>
             <a:pPr indent="0" marL="0">
               <a:buNone/>
             </a:pPr>
             <a:r>
-              <a:rPr lang="en-US" sz="1300" dirty="0">
+              <a:rPr lang="en-US" sz="1150" dirty="0">
                 <a:solidFill>
-                  <a:schemeClr val="tx1"/>
+                  <a:srgbClr val="52514E"/>
                 </a:solidFill>
               </a:rPr>
-              <a:t>Bulky first: ducts nearest the surface, then trays and conduits, then pipes.</a:t>
+              <a:t>bulky first: ducts nearest the slab, then trays and conduits, then pipes</a:t>
             </a:r>
             <a:endParaRPr lang="en-US" sz="1300" dirty="0"/>
           </a:p>
@@ -24190,13 +24429,35 @@
       </p:sp>
       <p:sp>
         <p:nvSpPr>
-          <p:cNvPr id="15" name="step circle 5"/>
-          <p:cNvSpPr/>
-          <p:nvPr/>
-        </p:nvSpPr>
-        <p:spPr>
-          <a:xfrm>
-            <a:off x="548640" y="4599432"/>
+          <p:cNvPr id="24" name="step card 5"/>
+          <p:cNvSpPr/>
+          <p:nvPr/>
+        </p:nvSpPr>
+        <p:spPr>
+          <a:xfrm>
+            <a:off x="1097280" y="4562856"/>
+            <a:ext cx="5029200" cy="658368"/>
+          </a:xfrm>
+          <a:prstGeom prst="roundRect">
+            <a:avLst>
+              <a:gd name="adj" fmla="val 9722"/>
+            </a:avLst>
+          </a:prstGeom>
+          <a:solidFill>
+            <a:schemeClr val="bg2"/>
+          </a:solidFill>
+          <a:ln/>
+        </p:spPr>
+      </p:sp>
+      <p:sp>
+        <p:nvSpPr>
+          <p:cNvPr id="25" name="step circle 5"/>
+          <p:cNvSpPr/>
+          <p:nvPr/>
+        </p:nvSpPr>
+        <p:spPr>
+          <a:xfrm>
+            <a:off x="548640" y="4690872"/>
             <a:ext cx="402336" cy="402336"/>
           </a:xfrm>
           <a:prstGeom prst="ellipse">
@@ -24205,18 +24466,23 @@
           <a:solidFill>
             <a:schemeClr val="accent1"/>
           </a:solidFill>
-          <a:ln/>
-        </p:spPr>
-      </p:sp>
-      <p:sp>
-        <p:nvSpPr>
-          <p:cNvPr id="16" name="step number 5"/>
+          <a:ln w="19050">
+            <a:solidFill>
+              <a:srgbClr val="FFFFFF"/>
+            </a:solidFill>
+            <a:prstDash val="solid"/>
+          </a:ln>
+        </p:spPr>
+      </p:sp>
+      <p:sp>
+        <p:nvSpPr>
+          <p:cNvPr id="26" name="step number 5"/>
           <p:cNvSpPr txBox="1"/>
           <p:nvPr/>
         </p:nvSpPr>
         <p:spPr>
           <a:xfrm>
-            <a:off x="548640" y="4599432"/>
+            <a:off x="548640" y="4690872"/>
             <a:ext cx="402336" cy="402336"/>
           </a:xfrm>
           <a:prstGeom prst="rect">
@@ -24233,27 +24499,51 @@
               <a:buNone/>
             </a:pPr>
             <a:r>
-              <a:rPr lang="en-US" sz="1400" b="1" dirty="0">
+              <a:rPr lang="en-US" sz="1300" b="1" dirty="0">
                 <a:solidFill>
                   <a:schemeClr val="bg1"/>
                 </a:solidFill>
               </a:rPr>
               <a:t>5</a:t>
             </a:r>
-            <a:endParaRPr lang="en-US" sz="1400" dirty="0"/>
+            <a:endParaRPr lang="en-US" sz="1300" dirty="0"/>
           </a:p>
         </p:txBody>
       </p:sp>
-      <p:sp>
-        <p:nvSpPr>
-          <p:cNvPr id="17" name="step 5"/>
+      <p:pic>
+        <p:nvPicPr>
+          <p:cNvPr id="27" name="step icon Spacing" descr="preencoded.png">    </p:cNvPr>
+          <p:cNvPicPr>
+            <a:picLocks noChangeAspect="1"/>
+          </p:cNvPicPr>
+          <p:nvPr/>
+        </p:nvPicPr>
+        <p:blipFill>
+          <a:blip r:embed="rId5"/>
+          <a:stretch>
+            <a:fillRect/>
+          </a:stretch>
+        </p:blipFill>
+        <p:spPr>
+          <a:xfrm>
+            <a:off x="1261872" y="4736592"/>
+            <a:ext cx="310896" cy="310896"/>
+          </a:xfrm>
+          <a:prstGeom prst="rect">
+            <a:avLst/>
+          </a:prstGeom>
+        </p:spPr>
+      </p:pic>
+      <p:sp>
+        <p:nvSpPr>
+          <p:cNvPr id="28" name="step 5"/>
           <p:cNvSpPr txBox="1"/>
           <p:nvPr/>
         </p:nvSpPr>
         <p:spPr>
           <a:xfrm>
-            <a:off x="1143000" y="4471416"/>
-            <a:ext cx="4983480" cy="658368"/>
+            <a:off x="1737360" y="4562856"/>
+            <a:ext cx="4251960" cy="658368"/>
           </a:xfrm>
           <a:prstGeom prst="rect">
             <a:avLst/>
@@ -24274,18 +24564,21 @@
                   <a:schemeClr val="tx1"/>
                 </a:solidFill>
               </a:rPr>
-              <a:t>Spacing. </a:t>
+              <a:t>Spacing</a:t>
             </a:r>
+            <a:endParaRPr lang="en-US" sz="1300" dirty="0"/>
+          </a:p>
+          <a:p>
             <a:pPr indent="0" marL="0">
               <a:buNone/>
             </a:pPr>
             <a:r>
-              <a:rPr lang="en-US" sz="1300" dirty="0">
+              <a:rPr lang="en-US" sz="1150" dirty="0">
                 <a:solidFill>
-                  <a:schemeClr val="tx1"/>
+                  <a:srgbClr val="52514E"/>
                 </a:solidFill>
               </a:rPr>
-              <a:t>Gaps drawn from gaps measured on a built project [12] (at least 25 mm); stagger within rows; electrical above wet on walls [10].</a:t>
+              <a:t>gaps drawn from a built project [12], at least 25 mm; electrical above wet on walls [10]</a:t>
             </a:r>
             <a:endParaRPr lang="en-US" sz="1300" dirty="0"/>
           </a:p>
@@ -24293,13 +24586,35 @@
       </p:sp>
       <p:sp>
         <p:nvSpPr>
-          <p:cNvPr id="18" name="step circle 6"/>
-          <p:cNvSpPr/>
-          <p:nvPr/>
-        </p:nvSpPr>
-        <p:spPr>
-          <a:xfrm>
-            <a:off x="548640" y="5385816"/>
+          <p:cNvPr id="29" name="step card 6"/>
+          <p:cNvSpPr/>
+          <p:nvPr/>
+        </p:nvSpPr>
+        <p:spPr>
+          <a:xfrm>
+            <a:off x="1097280" y="5349240"/>
+            <a:ext cx="5029200" cy="658368"/>
+          </a:xfrm>
+          <a:prstGeom prst="roundRect">
+            <a:avLst>
+              <a:gd name="adj" fmla="val 9722"/>
+            </a:avLst>
+          </a:prstGeom>
+          <a:solidFill>
+            <a:schemeClr val="bg2"/>
+          </a:solidFill>
+          <a:ln/>
+        </p:spPr>
+      </p:sp>
+      <p:sp>
+        <p:nvSpPr>
+          <p:cNvPr id="30" name="step circle 6"/>
+          <p:cNvSpPr/>
+          <p:nvPr/>
+        </p:nvSpPr>
+        <p:spPr>
+          <a:xfrm>
+            <a:off x="548640" y="5477256"/>
             <a:ext cx="402336" cy="402336"/>
           </a:xfrm>
           <a:prstGeom prst="ellipse">
@@ -24308,18 +24623,23 @@
           <a:solidFill>
             <a:schemeClr val="accent1"/>
           </a:solidFill>
-          <a:ln/>
-        </p:spPr>
-      </p:sp>
-      <p:sp>
-        <p:nvSpPr>
-          <p:cNvPr id="19" name="step number 6"/>
+          <a:ln w="19050">
+            <a:solidFill>
+              <a:srgbClr val="FFFFFF"/>
+            </a:solidFill>
+            <a:prstDash val="solid"/>
+          </a:ln>
+        </p:spPr>
+      </p:sp>
+      <p:sp>
+        <p:nvSpPr>
+          <p:cNvPr id="31" name="step number 6"/>
           <p:cNvSpPr txBox="1"/>
           <p:nvPr/>
         </p:nvSpPr>
         <p:spPr>
           <a:xfrm>
-            <a:off x="548640" y="5385816"/>
+            <a:off x="548640" y="5477256"/>
             <a:ext cx="402336" cy="402336"/>
           </a:xfrm>
           <a:prstGeom prst="rect">
@@ -24336,27 +24656,51 @@
               <a:buNone/>
             </a:pPr>
             <a:r>
-              <a:rPr lang="en-US" sz="1400" b="1" dirty="0">
+              <a:rPr lang="en-US" sz="1300" b="1" dirty="0">
                 <a:solidFill>
                   <a:schemeClr val="bg1"/>
                 </a:solidFill>
               </a:rPr>
               <a:t>6</a:t>
             </a:r>
-            <a:endParaRPr lang="en-US" sz="1400" dirty="0"/>
+            <a:endParaRPr lang="en-US" sz="1300" dirty="0"/>
           </a:p>
         </p:txBody>
       </p:sp>
-      <p:sp>
-        <p:nvSpPr>
-          <p:cNvPr id="20" name="step 6"/>
+      <p:pic>
+        <p:nvPicPr>
+          <p:cNvPr id="32" name="step icon Check" descr="preencoded.png">    </p:cNvPr>
+          <p:cNvPicPr>
+            <a:picLocks noChangeAspect="1"/>
+          </p:cNvPicPr>
+          <p:nvPr/>
+        </p:nvPicPr>
+        <p:blipFill>
+          <a:blip r:embed="rId6"/>
+          <a:stretch>
+            <a:fillRect/>
+          </a:stretch>
+        </p:blipFill>
+        <p:spPr>
+          <a:xfrm>
+            <a:off x="1261872" y="5522976"/>
+            <a:ext cx="310896" cy="310896"/>
+          </a:xfrm>
+          <a:prstGeom prst="rect">
+            <a:avLst/>
+          </a:prstGeom>
+        </p:spPr>
+      </p:pic>
+      <p:sp>
+        <p:nvSpPr>
+          <p:cNvPr id="33" name="step 6"/>
           <p:cNvSpPr txBox="1"/>
           <p:nvPr/>
         </p:nvSpPr>
         <p:spPr>
           <a:xfrm>
-            <a:off x="1143000" y="5257800"/>
-            <a:ext cx="4983480" cy="658368"/>
+            <a:off x="1737360" y="5349240"/>
+            <a:ext cx="4251960" cy="658368"/>
           </a:xfrm>
           <a:prstGeom prst="rect">
             <a:avLst/>
@@ -24377,18 +24721,21 @@
                   <a:schemeClr val="tx1"/>
                 </a:solidFill>
               </a:rPr>
-              <a:t>Check. </a:t>
+              <a:t>Check</a:t>
             </a:r>
+            <a:endParaRPr lang="en-US" sz="1300" dirty="0"/>
+          </a:p>
+          <a:p>
             <a:pPr indent="0" marL="0">
               <a:buNone/>
             </a:pPr>
             <a:r>
-              <a:rPr lang="en-US" sz="1300" dirty="0">
+              <a:rPr lang="en-US" sz="1150" dirty="0">
                 <a:solidFill>
-                  <a:schemeClr val="tx1"/>
+                  <a:srgbClr val="52514E"/>
                 </a:solidFill>
               </a:rPr>
-              <a:t>Every pair at least 25 mm clear; rows centred; sizes, insulation, loads and positions recorded.</a:t>
+              <a:t>every pair 25 mm clear, rows centred, everything recorded; same seed, same file</a:t>
             </a:r>
             <a:endParaRPr lang="en-US" sz="1300" dirty="0"/>
           </a:p>
@@ -24396,22 +24743,22 @@
       </p:sp>
       <p:pic>
         <p:nvPicPr>
-          <p:cNvPr id="21" name="generation example" descr="/home/user/crossmep_dataset/docs/figures/05_generation_example.png">    </p:cNvPr>
+          <p:cNvPr id="34" name="generation example" descr="/home/user/crossmep_dataset/docs/figures/05_generation_example.png">    </p:cNvPr>
           <p:cNvPicPr>
             <a:picLocks noChangeAspect="1"/>
           </p:cNvPicPr>
           <p:nvPr/>
         </p:nvPicPr>
         <p:blipFill>
-          <a:blip r:embed="rId1"/>
+          <a:blip r:embed="rId7"/>
           <a:stretch>
             <a:fillRect/>
           </a:stretch>
         </p:blipFill>
         <p:spPr>
           <a:xfrm>
-            <a:off x="6309360" y="1708403"/>
-            <a:ext cx="5330952" cy="3258315"/>
+            <a:off x="6355080" y="1630935"/>
+            <a:ext cx="5285232" cy="3230370"/>
           </a:xfrm>
           <a:prstGeom prst="rect">
             <a:avLst/>
@@ -24420,14 +24767,36 @@
       </p:pic>
       <p:sp>
         <p:nvSpPr>
-          <p:cNvPr id="22" name="generation caption"/>
+          <p:cNvPr id="35" name="example frame"/>
+          <p:cNvSpPr/>
+          <p:nvPr/>
+        </p:nvSpPr>
+        <p:spPr>
+          <a:xfrm>
+            <a:off x="6355080" y="1630935"/>
+            <a:ext cx="5285232" cy="3230370"/>
+          </a:xfrm>
+          <a:prstGeom prst="rect">
+            <a:avLst/>
+          </a:prstGeom>
+          <a:ln w="9525">
+            <a:solidFill>
+              <a:srgbClr val="E1E0D9"/>
+            </a:solidFill>
+            <a:prstDash val="solid"/>
+          </a:ln>
+        </p:spPr>
+      </p:sp>
+      <p:sp>
+        <p:nvSpPr>
+          <p:cNvPr id="36" name="generation caption"/>
           <p:cNvSpPr txBox="1"/>
           <p:nvPr/>
         </p:nvSpPr>
         <p:spPr>
           <a:xfrm>
-            <a:off x="6309360" y="5076445"/>
-            <a:ext cx="5330952" cy="685800"/>
+            <a:off x="6355080" y="4952745"/>
+            <a:ext cx="5285232" cy="411480"/>
           </a:xfrm>
           <a:prstGeom prst="rect">
             <a:avLst/>
@@ -24443,20 +24812,20 @@
               <a:buNone/>
             </a:pPr>
             <a:r>
-              <a:rPr lang="en-US" sz="1100" dirty="0">
+              <a:rPr lang="en-US" sz="1150" dirty="0">
                 <a:solidFill>
                   <a:srgbClr val="52514E"/>
                 </a:solidFill>
               </a:rPr>
-              <a:t>One generated benchmark context, three rows by priority; the gap marked is one draw from the measured distribution. Every context is seeded: the same seed gives the same file, byte for byte.</a:t>
+              <a:t>One generated benchmark context, three rows by priority; the gap marked is one draw from the measured distribution.</a:t>
             </a:r>
-            <a:endParaRPr lang="en-US" sz="1100" dirty="0"/>
+            <a:endParaRPr lang="en-US" sz="1150" dirty="0"/>
           </a:p>
         </p:txBody>
       </p:sp>
       <p:sp>
         <p:nvSpPr>
-          <p:cNvPr id="23" name="references"/>
+          <p:cNvPr id="37" name="references"/>
           <p:cNvSpPr txBox="1"/>
           <p:nvPr/>
         </p:nvSpPr>

</xml_diff>

<commit_message>
Talk and studio: slides 7 and 8 show studio sections (sheet and 3D); the 3D view is grey, cut at the plane, with the section face in the trade colour
Co-Authored-By: Claude Fable 5.1 <noreply@anthropic.com>
Claude-Session: https://claude.ai/code/session_01R1ft1rokeRJHR95rzLxNEC
</commit_message>
<xml_diff>
--- a/docs/CrossMEP_CIBW78_talk.pptx
+++ b/docs/CrossMEP_CIBW78_talk.pptx
@@ -124,12 +124,12 @@
   <p:extLst>
     <p:ext uri="{521415D9-36F7-43E2-AB2F-B90AF26B5E84}">
       <p14:sectionLst xmlns:p14="http://schemas.microsoft.com/office/powerpoint/2010/main">
-        <p14:section name="Opening" id="{93bf4125-47cd-a3b7-1fc8-cfbc99c26387}">
+        <p14:section name="Opening" id="{1a9b7c69-941a-d664-a0a6-e9462303d2d3}">
           <p14:sldIdLst>
             <p14:sldId id="256"/>
           </p14:sldIdLst>
         </p14:section>
-        <p14:section name="Motivation" id="{06eb4631-d4aa-1a71-3433-9649db765e20}">
+        <p14:section name="Motivation" id="{3b8f83d0-925f-fbdb-d0ae-7a3651068010}">
           <p14:sldIdLst>
             <p14:sldId id="257"/>
             <p14:sldId id="258"/>
@@ -138,7 +138,7 @@
             <p14:sldId id="261"/>
           </p14:sldIdLst>
         </p14:section>
-        <p14:section name="The dataset" id="{914f84d8-c58c-8289-593b-42b33f4bb92a}">
+        <p14:section name="The dataset" id="{94cba26a-e6fc-2d4c-de00-a2ba8e0c147c}">
           <p14:sldIdLst>
             <p14:sldId id="262"/>
             <p14:sldId id="263"/>
@@ -147,14 +147,14 @@
             <p14:sldId id="266"/>
           </p14:sldIdLst>
         </p14:section>
-        <p14:section name="Experiments" id="{c0835315-0dc9-8c11-fd2f-eeec54b0c20f}">
+        <p14:section name="Experiments" id="{ee5575c6-37cd-73dc-d847-3106d5153710}">
           <p14:sldIdLst>
             <p14:sldId id="267"/>
             <p14:sldId id="268"/>
             <p14:sldId id="269"/>
           </p14:sldIdLst>
         </p14:section>
-        <p14:section name="Use" id="{18268bb2-37e1-7df1-bbe0-94950d977d4e}">
+        <p14:section name="Use" id="{7c59a61a-3ecb-9aae-5c8c-dc8d48bc658c}">
           <p14:sldIdLst>
             <p14:sldId id="270"/>
             <p14:sldId id="271"/>
@@ -20281,7 +20281,7 @@
       </p:sp>
       <p:pic>
         <p:nvPicPr>
-          <p:cNvPr id="3" name="context section" descr="preencoded.png">    </p:cNvPr>
+          <p:cNvPr id="3" name="section sheet" descr="preencoded.png">    </p:cNvPr>
           <p:cNvPicPr>
             <a:picLocks noChangeAspect="1"/>
           </p:cNvPicPr>
@@ -20295,8 +20295,8 @@
         </p:blipFill>
         <p:spPr>
           <a:xfrm>
-            <a:off x="548640" y="1325880"/>
-            <a:ext cx="5760720" cy="3532517"/>
+            <a:off x="700592" y="1325880"/>
+            <a:ext cx="5456816" cy="2788920"/>
           </a:xfrm>
           <a:prstGeom prst="rect">
             <a:avLst/>
@@ -20305,14 +20305,151 @@
       </p:pic>
       <p:sp>
         <p:nvSpPr>
-          <p:cNvPr id="4" name="fields heading"/>
+          <p:cNvPr id="4" name="sheet frame"/>
+          <p:cNvSpPr/>
+          <p:nvPr/>
+        </p:nvSpPr>
+        <p:spPr>
+          <a:xfrm>
+            <a:off x="645728" y="1271016"/>
+            <a:ext cx="5566544" cy="2898648"/>
+          </a:xfrm>
+          <a:prstGeom prst="rect">
+            <a:avLst/>
+          </a:prstGeom>
+          <a:ln w="9525">
+            <a:solidFill>
+              <a:srgbClr val="E1E0D9"/>
+            </a:solidFill>
+            <a:prstDash val="solid"/>
+          </a:ln>
+        </p:spPr>
+      </p:sp>
+      <p:pic>
+        <p:nvPicPr>
+          <p:cNvPr id="5" name="section 3d" descr="preencoded.png">    </p:cNvPr>
+          <p:cNvPicPr>
+            <a:picLocks noChangeAspect="1"/>
+          </p:cNvPicPr>
+          <p:nvPr/>
+        </p:nvPicPr>
+        <p:blipFill>
+          <a:blip r:embed="rId2"/>
+          <a:stretch>
+            <a:fillRect/>
+          </a:stretch>
+        </p:blipFill>
+        <p:spPr>
+          <a:xfrm>
+            <a:off x="548640" y="4297680"/>
+            <a:ext cx="2468880" cy="1601016"/>
+          </a:xfrm>
+          <a:prstGeom prst="rect">
+            <a:avLst/>
+          </a:prstGeom>
+        </p:spPr>
+      </p:pic>
+      <p:sp>
+        <p:nvSpPr>
+          <p:cNvPr id="6" name="3d legend"/>
           <p:cNvSpPr txBox="1"/>
           <p:nvPr/>
         </p:nvSpPr>
         <p:spPr>
           <a:xfrm>
-            <a:off x="548640" y="5440680"/>
-            <a:ext cx="5760720" cy="274320"/>
+            <a:off x="548640" y="6108192"/>
+            <a:ext cx="2926080" cy="201168"/>
+          </a:xfrm>
+          <a:prstGeom prst="rect">
+            <a:avLst/>
+          </a:prstGeom>
+          <a:noFill/>
+          <a:ln/>
+        </p:spPr>
+        <p:txBody>
+          <a:bodyPr wrap="square" lIns="0" tIns="0" rIns="0" bIns="0" rtlCol="0" anchor="ctr"/>
+          <a:lstStyle/>
+          <a:p>
+            <a:pPr indent="0" marL="0">
+              <a:buNone/>
+            </a:pPr>
+            <a:r>
+              <a:rPr lang="en-US" sz="900" dirty="0">
+                <a:solidFill>
+                  <a:srgbClr val="008300"/>
+                </a:solidFill>
+              </a:rPr>
+              <a:t>● </a:t>
+            </a:r>
+            <a:pPr indent="0" marL="0">
+              <a:buNone/>
+            </a:pPr>
+            <a:r>
+              <a:rPr lang="en-US" sz="900" dirty="0">
+                <a:solidFill>
+                  <a:srgbClr val="52514E"/>
+                </a:solidFill>
+              </a:rPr>
+              <a:t>ventilation   </a:t>
+            </a:r>
+            <a:pPr indent="0" marL="0">
+              <a:buNone/>
+            </a:pPr>
+            <a:r>
+              <a:rPr lang="en-US" sz="900" dirty="0">
+                <a:solidFill>
+                  <a:srgbClr val="4A3AA7"/>
+                </a:solidFill>
+              </a:rPr>
+              <a:t>● </a:t>
+            </a:r>
+            <a:pPr indent="0" marL="0">
+              <a:buNone/>
+            </a:pPr>
+            <a:r>
+              <a:rPr lang="en-US" sz="900" dirty="0">
+                <a:solidFill>
+                  <a:srgbClr val="52514E"/>
+                </a:solidFill>
+              </a:rPr>
+              <a:t>electrical   </a:t>
+            </a:r>
+            <a:pPr indent="0" marL="0">
+              <a:buNone/>
+            </a:pPr>
+            <a:r>
+              <a:rPr lang="en-US" sz="900" dirty="0">
+                <a:solidFill>
+                  <a:srgbClr val="EB6834"/>
+                </a:solidFill>
+              </a:rPr>
+              <a:t>● </a:t>
+            </a:r>
+            <a:pPr indent="0" marL="0">
+              <a:buNone/>
+            </a:pPr>
+            <a:r>
+              <a:rPr lang="en-US" sz="900" dirty="0">
+                <a:solidFill>
+                  <a:srgbClr val="52514E"/>
+                </a:solidFill>
+              </a:rPr>
+              <a:t>heating   </a:t>
+            </a:r>
+            <a:endParaRPr lang="en-US" sz="900" dirty="0"/>
+          </a:p>
+        </p:txBody>
+      </p:sp>
+      <p:sp>
+        <p:nvSpPr>
+          <p:cNvPr id="7" name="fields heading"/>
+          <p:cNvSpPr txBox="1"/>
+          <p:nvPr/>
+        </p:nvSpPr>
+        <p:spPr>
+          <a:xfrm>
+            <a:off x="3246120" y="4297680"/>
+            <a:ext cx="3063240" cy="274320"/>
           </a:xfrm>
           <a:prstGeom prst="rect">
             <a:avLst/>
@@ -20341,13 +20478,13 @@
       </p:sp>
       <p:sp>
         <p:nvSpPr>
-          <p:cNvPr id="5" name="chip kind"/>
-          <p:cNvSpPr/>
-          <p:nvPr/>
-        </p:nvSpPr>
-        <p:spPr>
-          <a:xfrm>
-            <a:off x="548640" y="5760720"/>
+          <p:cNvPr id="8" name="chip kind"/>
+          <p:cNvSpPr/>
+          <p:nvPr/>
+        </p:nvSpPr>
+        <p:spPr>
+          <a:xfrm>
+            <a:off x="3246120" y="4663440"/>
             <a:ext cx="453542" cy="310896"/>
           </a:xfrm>
           <a:prstGeom prst="roundRect">
@@ -20368,13 +20505,13 @@
       </p:sp>
       <p:sp>
         <p:nvSpPr>
-          <p:cNvPr id="6" name="chip text kind"/>
+          <p:cNvPr id="9" name="chip text kind"/>
           <p:cNvSpPr txBox="1"/>
           <p:nvPr/>
         </p:nvSpPr>
         <p:spPr>
           <a:xfrm>
-            <a:off x="548640" y="5760720"/>
+            <a:off x="3246120" y="4663440"/>
             <a:ext cx="453542" cy="310896"/>
           </a:xfrm>
           <a:prstGeom prst="rect">
@@ -20404,13 +20541,13 @@
       </p:sp>
       <p:sp>
         <p:nvSpPr>
-          <p:cNvPr id="7" name="chip service, trade"/>
-          <p:cNvSpPr/>
-          <p:nvPr/>
-        </p:nvSpPr>
-        <p:spPr>
-          <a:xfrm>
-            <a:off x="1111910" y="5760720"/>
+          <p:cNvPr id="10" name="chip service, trade"/>
+          <p:cNvSpPr/>
+          <p:nvPr/>
+        </p:nvSpPr>
+        <p:spPr>
+          <a:xfrm>
+            <a:off x="3809390" y="4663440"/>
             <a:ext cx="1038758" cy="310896"/>
           </a:xfrm>
           <a:prstGeom prst="roundRect">
@@ -20431,13 +20568,13 @@
       </p:sp>
       <p:sp>
         <p:nvSpPr>
-          <p:cNvPr id="8" name="chip text service, trade"/>
+          <p:cNvPr id="11" name="chip text service, trade"/>
           <p:cNvSpPr txBox="1"/>
           <p:nvPr/>
         </p:nvSpPr>
         <p:spPr>
           <a:xfrm>
-            <a:off x="1111910" y="5760720"/>
+            <a:off x="3809390" y="4663440"/>
             <a:ext cx="1038758" cy="310896"/>
           </a:xfrm>
           <a:prstGeom prst="rect">
@@ -20467,13 +20604,13 @@
       </p:sp>
       <p:sp>
         <p:nvSpPr>
-          <p:cNvPr id="9" name="chip size"/>
-          <p:cNvSpPr/>
-          <p:nvPr/>
-        </p:nvSpPr>
-        <p:spPr>
-          <a:xfrm>
-            <a:off x="2260397" y="5760720"/>
+          <p:cNvPr id="12" name="chip size"/>
+          <p:cNvSpPr/>
+          <p:nvPr/>
+        </p:nvSpPr>
+        <p:spPr>
+          <a:xfrm>
+            <a:off x="4957877" y="4663440"/>
             <a:ext cx="453542" cy="310896"/>
           </a:xfrm>
           <a:prstGeom prst="roundRect">
@@ -20494,13 +20631,13 @@
       </p:sp>
       <p:sp>
         <p:nvSpPr>
-          <p:cNvPr id="10" name="chip text size"/>
+          <p:cNvPr id="13" name="chip text size"/>
           <p:cNvSpPr txBox="1"/>
           <p:nvPr/>
         </p:nvSpPr>
         <p:spPr>
           <a:xfrm>
-            <a:off x="2260397" y="5760720"/>
+            <a:off x="4957877" y="4663440"/>
             <a:ext cx="453542" cy="310896"/>
           </a:xfrm>
           <a:prstGeom prst="rect">
@@ -20530,13 +20667,13 @@
       </p:sp>
       <p:sp>
         <p:nvSpPr>
-          <p:cNvPr id="11" name="chip insulation"/>
-          <p:cNvSpPr/>
-          <p:nvPr/>
-        </p:nvSpPr>
-        <p:spPr>
-          <a:xfrm>
-            <a:off x="2823667" y="5760720"/>
+          <p:cNvPr id="14" name="chip insulation"/>
+          <p:cNvSpPr/>
+          <p:nvPr/>
+        </p:nvSpPr>
+        <p:spPr>
+          <a:xfrm>
+            <a:off x="3246120" y="5084064"/>
             <a:ext cx="804672" cy="310896"/>
           </a:xfrm>
           <a:prstGeom prst="roundRect">
@@ -20557,13 +20694,13 @@
       </p:sp>
       <p:sp>
         <p:nvSpPr>
-          <p:cNvPr id="12" name="chip text insulation"/>
+          <p:cNvPr id="15" name="chip text insulation"/>
           <p:cNvSpPr txBox="1"/>
           <p:nvPr/>
         </p:nvSpPr>
         <p:spPr>
           <a:xfrm>
-            <a:off x="2823667" y="5760720"/>
+            <a:off x="3246120" y="5084064"/>
             <a:ext cx="804672" cy="310896"/>
           </a:xfrm>
           <a:prstGeom prst="rect">
@@ -20593,13 +20730,13 @@
       </p:sp>
       <p:sp>
         <p:nvSpPr>
-          <p:cNvPr id="13" name="chip position"/>
-          <p:cNvSpPr/>
-          <p:nvPr/>
-        </p:nvSpPr>
-        <p:spPr>
-          <a:xfrm>
-            <a:off x="3738067" y="5760720"/>
+          <p:cNvPr id="16" name="chip position"/>
+          <p:cNvSpPr/>
+          <p:nvPr/>
+        </p:nvSpPr>
+        <p:spPr>
+          <a:xfrm>
+            <a:off x="4160520" y="5084064"/>
             <a:ext cx="687629" cy="310896"/>
           </a:xfrm>
           <a:prstGeom prst="roundRect">
@@ -20620,13 +20757,13 @@
       </p:sp>
       <p:sp>
         <p:nvSpPr>
-          <p:cNvPr id="14" name="chip text position"/>
+          <p:cNvPr id="17" name="chip text position"/>
           <p:cNvSpPr txBox="1"/>
           <p:nvPr/>
         </p:nvSpPr>
         <p:spPr>
           <a:xfrm>
-            <a:off x="3738067" y="5760720"/>
+            <a:off x="4160520" y="5084064"/>
             <a:ext cx="687629" cy="310896"/>
           </a:xfrm>
           <a:prstGeom prst="rect">
@@ -20656,13 +20793,13 @@
       </p:sp>
       <p:sp>
         <p:nvSpPr>
-          <p:cNvPr id="15" name="chip load = kN/m × span"/>
-          <p:cNvSpPr/>
-          <p:nvPr/>
-        </p:nvSpPr>
-        <p:spPr>
-          <a:xfrm>
-            <a:off x="4535424" y="5760720"/>
+          <p:cNvPr id="18" name="chip load = kN/m × span"/>
+          <p:cNvSpPr/>
+          <p:nvPr/>
+        </p:nvSpPr>
+        <p:spPr>
+          <a:xfrm>
+            <a:off x="4957877" y="5084064"/>
             <a:ext cx="1272845" cy="310896"/>
           </a:xfrm>
           <a:prstGeom prst="roundRect">
@@ -20683,13 +20820,13 @@
       </p:sp>
       <p:sp>
         <p:nvSpPr>
-          <p:cNvPr id="16" name="chip text load = kN/m × span"/>
+          <p:cNvPr id="19" name="chip text load = kN/m × span"/>
           <p:cNvSpPr txBox="1"/>
           <p:nvPr/>
         </p:nvSpPr>
         <p:spPr>
           <a:xfrm>
-            <a:off x="4535424" y="5760720"/>
+            <a:off x="4957877" y="5084064"/>
             <a:ext cx="1272845" cy="310896"/>
           </a:xfrm>
           <a:prstGeom prst="rect">
@@ -20719,7 +20856,7 @@
       </p:sp>
       <p:sp>
         <p:nvSpPr>
-          <p:cNvPr id="17" name="given heading"/>
+          <p:cNvPr id="20" name="given heading"/>
           <p:cNvSpPr txBox="1"/>
           <p:nvPr/>
         </p:nvSpPr>
@@ -20776,12 +20913,12 @@
             <a:tbl>
               <a:tblPr/>
               <a:tblGrid>
-                <a:gridCol w="914400"/>
-                <a:gridCol w="1371600"/>
+                <a:gridCol w="1234440"/>
+                <a:gridCol w="1188720"/>
                 <a:gridCol w="640080"/>
-                <a:gridCol w="685800"/>
-                <a:gridCol w="621792"/>
-                <a:gridCol w="868680"/>
+                <a:gridCol w="640080"/>
+                <a:gridCol w="594360"/>
+                <a:gridCol w="804672"/>
               </a:tblGrid>
               <a:tr h="310896">
                 <a:tc>
@@ -21203,7 +21340,7 @@
                         <a:buNone/>
                       </a:pPr>
                       <a:r>
-                        <a:rPr lang="en-US" sz="1150" b="1" dirty="0">
+                        <a:rPr lang="en-US" sz="1100" b="1" dirty="0">
                           <a:solidFill>
                             <a:srgbClr val="0B0B0B"/>
                           </a:solidFill>
@@ -21211,9 +21348,9 @@
                           <a:ea typeface="Aptos" pitchFamily="34" charset="-122"/>
                           <a:cs typeface="Aptos" pitchFamily="34" charset="-120"/>
                         </a:rPr>
-                        <a:t>600 tray</a:t>
+                        <a:t>400×250 duct</a:t>
                       </a:r>
-                      <a:endParaRPr lang="en-US" sz="1150" dirty="0">
+                      <a:endParaRPr lang="en-US" sz="1100" dirty="0">
                         <a:latin typeface="Aptos" charset="0"/>
                         <a:ea typeface="Aptos" charset="0"/>
                         <a:cs typeface="Aptos" charset="0"/>
@@ -21268,9 +21405,9 @@
                         <a:buNone/>
                       </a:pPr>
                       <a:r>
-                        <a:rPr lang="en-US" sz="1150" dirty="0">
+                        <a:rPr lang="en-US" sz="1100" dirty="0">
                           <a:solidFill>
-                            <a:srgbClr val="4A3AA7"/>
+                            <a:srgbClr val="008300"/>
                           </a:solidFill>
                           <a:latin typeface="Aptos" pitchFamily="34" charset="0"/>
                           <a:ea typeface="Aptos" pitchFamily="34" charset="-122"/>
@@ -21282,7 +21419,7 @@
                         <a:buNone/>
                       </a:pPr>
                       <a:r>
-                        <a:rPr lang="en-US" sz="1150" dirty="0">
+                        <a:rPr lang="en-US" sz="1100" dirty="0">
                           <a:solidFill>
                             <a:srgbClr val="0B0B0B"/>
                           </a:solidFill>
@@ -21290,9 +21427,9 @@
                           <a:ea typeface="Aptos" pitchFamily="34" charset="-122"/>
                           <a:cs typeface="Aptos" pitchFamily="34" charset="-120"/>
                         </a:rPr>
-                        <a:t>electrical</a:t>
+                        <a:t>ventilation</a:t>
                       </a:r>
-                      <a:endParaRPr lang="en-US" sz="1150" dirty="0">
+                      <a:endParaRPr lang="en-US" sz="1100" dirty="0">
                         <a:latin typeface="Aptos" charset="0"/>
                         <a:ea typeface="Aptos" charset="0"/>
                         <a:cs typeface="Aptos" charset="0"/>
@@ -21347,7 +21484,7 @@
                         <a:buNone/>
                       </a:pPr>
                       <a:r>
-                        <a:rPr lang="en-US" sz="1150" dirty="0">
+                        <a:rPr lang="en-US" sz="1100" dirty="0">
                           <a:solidFill>
                             <a:srgbClr val="0B0B0B"/>
                           </a:solidFill>
@@ -21357,7 +21494,7 @@
                         </a:rPr>
                         <a:t>0</a:t>
                       </a:r>
-                      <a:endParaRPr lang="en-US" sz="1150" dirty="0">
+                      <a:endParaRPr lang="en-US" sz="1100" dirty="0">
                         <a:latin typeface="Aptos" charset="0"/>
                         <a:ea typeface="Aptos" charset="0"/>
                         <a:cs typeface="Aptos" charset="0"/>
@@ -21412,7 +21549,7 @@
                         <a:buNone/>
                       </a:pPr>
                       <a:r>
-                        <a:rPr lang="en-US" sz="1150" dirty="0">
+                        <a:rPr lang="en-US" sz="1100" dirty="0">
                           <a:solidFill>
                             <a:srgbClr val="0B0B0B"/>
                           </a:solidFill>
@@ -21420,9 +21557,9 @@
                           <a:ea typeface="Aptos" pitchFamily="34" charset="-122"/>
                           <a:cs typeface="Aptos" pitchFamily="34" charset="-120"/>
                         </a:rPr>
-                        <a:t>1.079</a:t>
+                        <a:t>0.115</a:t>
                       </a:r>
-                      <a:endParaRPr lang="en-US" sz="1150" dirty="0">
+                      <a:endParaRPr lang="en-US" sz="1100" dirty="0">
                         <a:latin typeface="Aptos" charset="0"/>
                         <a:ea typeface="Aptos" charset="0"/>
                         <a:cs typeface="Aptos" charset="0"/>
@@ -21477,7 +21614,7 @@
                         <a:buNone/>
                       </a:pPr>
                       <a:r>
-                        <a:rPr lang="en-US" sz="1150" dirty="0">
+                        <a:rPr lang="en-US" sz="1100" dirty="0">
                           <a:solidFill>
                             <a:srgbClr val="0B0B0B"/>
                           </a:solidFill>
@@ -21485,9 +21622,9 @@
                           <a:ea typeface="Aptos" pitchFamily="34" charset="-122"/>
                           <a:cs typeface="Aptos" pitchFamily="34" charset="-120"/>
                         </a:rPr>
-                        <a:t>2.0 m</a:t>
+                        <a:t>2.4 m</a:t>
                       </a:r>
-                      <a:endParaRPr lang="en-US" sz="1150" dirty="0">
+                      <a:endParaRPr lang="en-US" sz="1100" dirty="0">
                         <a:latin typeface="Aptos" charset="0"/>
                         <a:ea typeface="Aptos" charset="0"/>
                         <a:cs typeface="Aptos" charset="0"/>
@@ -21542,7 +21679,7 @@
                         <a:buNone/>
                       </a:pPr>
                       <a:r>
-                        <a:rPr lang="en-US" sz="1150" b="1" dirty="0">
+                        <a:rPr lang="en-US" sz="1100" b="1" dirty="0">
                           <a:solidFill>
                             <a:srgbClr val="0B0B0B"/>
                           </a:solidFill>
@@ -21550,9 +21687,9 @@
                           <a:ea typeface="Aptos" pitchFamily="34" charset="-122"/>
                           <a:cs typeface="Aptos" pitchFamily="34" charset="-120"/>
                         </a:rPr>
-                        <a:t>2.16</a:t>
+                        <a:t>0.28</a:t>
                       </a:r>
-                      <a:endParaRPr lang="en-US" sz="1150" dirty="0">
+                      <a:endParaRPr lang="en-US" sz="1100" dirty="0">
                         <a:latin typeface="Aptos" charset="0"/>
                         <a:ea typeface="Aptos" charset="0"/>
                         <a:cs typeface="Aptos" charset="0"/>
@@ -21609,7 +21746,7 @@
                         <a:buNone/>
                       </a:pPr>
                       <a:r>
-                        <a:rPr lang="en-US" sz="1150" b="1" dirty="0">
+                        <a:rPr lang="en-US" sz="1100" b="1" dirty="0">
                           <a:solidFill>
                             <a:srgbClr val="0B0B0B"/>
                           </a:solidFill>
@@ -21617,9 +21754,9 @@
                           <a:ea typeface="Aptos" pitchFamily="34" charset="-122"/>
                           <a:cs typeface="Aptos" pitchFamily="34" charset="-120"/>
                         </a:rPr>
-                        <a:t>150 tray</a:t>
+                        <a:t>400×250 duct</a:t>
                       </a:r>
-                      <a:endParaRPr lang="en-US" sz="1150" dirty="0">
+                      <a:endParaRPr lang="en-US" sz="1100" dirty="0">
                         <a:latin typeface="Aptos" charset="0"/>
                         <a:ea typeface="Aptos" charset="0"/>
                         <a:cs typeface="Aptos" charset="0"/>
@@ -21674,9 +21811,9 @@
                         <a:buNone/>
                       </a:pPr>
                       <a:r>
-                        <a:rPr lang="en-US" sz="1150" dirty="0">
+                        <a:rPr lang="en-US" sz="1100" dirty="0">
                           <a:solidFill>
-                            <a:srgbClr val="4A3AA7"/>
+                            <a:srgbClr val="008300"/>
                           </a:solidFill>
                           <a:latin typeface="Aptos" pitchFamily="34" charset="0"/>
                           <a:ea typeface="Aptos" pitchFamily="34" charset="-122"/>
@@ -21688,7 +21825,7 @@
                         <a:buNone/>
                       </a:pPr>
                       <a:r>
-                        <a:rPr lang="en-US" sz="1150" dirty="0">
+                        <a:rPr lang="en-US" sz="1100" dirty="0">
                           <a:solidFill>
                             <a:srgbClr val="0B0B0B"/>
                           </a:solidFill>
@@ -21696,9 +21833,9 @@
                           <a:ea typeface="Aptos" pitchFamily="34" charset="-122"/>
                           <a:cs typeface="Aptos" pitchFamily="34" charset="-120"/>
                         </a:rPr>
-                        <a:t>electrical</a:t>
+                        <a:t>ventilation</a:t>
                       </a:r>
-                      <a:endParaRPr lang="en-US" sz="1150" dirty="0">
+                      <a:endParaRPr lang="en-US" sz="1100" dirty="0">
                         <a:latin typeface="Aptos" charset="0"/>
                         <a:ea typeface="Aptos" charset="0"/>
                         <a:cs typeface="Aptos" charset="0"/>
@@ -21753,7 +21890,7 @@
                         <a:buNone/>
                       </a:pPr>
                       <a:r>
-                        <a:rPr lang="en-US" sz="1150" dirty="0">
+                        <a:rPr lang="en-US" sz="1100" dirty="0">
                           <a:solidFill>
                             <a:srgbClr val="0B0B0B"/>
                           </a:solidFill>
@@ -21763,7 +21900,7 @@
                         </a:rPr>
                         <a:t>0</a:t>
                       </a:r>
-                      <a:endParaRPr lang="en-US" sz="1150" dirty="0">
+                      <a:endParaRPr lang="en-US" sz="1100" dirty="0">
                         <a:latin typeface="Aptos" charset="0"/>
                         <a:ea typeface="Aptos" charset="0"/>
                         <a:cs typeface="Aptos" charset="0"/>
@@ -21818,7 +21955,7 @@
                         <a:buNone/>
                       </a:pPr>
                       <a:r>
-                        <a:rPr lang="en-US" sz="1150" dirty="0">
+                        <a:rPr lang="en-US" sz="1100" dirty="0">
                           <a:solidFill>
                             <a:srgbClr val="0B0B0B"/>
                           </a:solidFill>
@@ -21826,9 +21963,9 @@
                           <a:ea typeface="Aptos" pitchFamily="34" charset="-122"/>
                           <a:cs typeface="Aptos" pitchFamily="34" charset="-120"/>
                         </a:rPr>
-                        <a:t>0.270</a:t>
+                        <a:t>0.115</a:t>
                       </a:r>
-                      <a:endParaRPr lang="en-US" sz="1150" dirty="0">
+                      <a:endParaRPr lang="en-US" sz="1100" dirty="0">
                         <a:latin typeface="Aptos" charset="0"/>
                         <a:ea typeface="Aptos" charset="0"/>
                         <a:cs typeface="Aptos" charset="0"/>
@@ -21883,7 +22020,7 @@
                         <a:buNone/>
                       </a:pPr>
                       <a:r>
-                        <a:rPr lang="en-US" sz="1150" dirty="0">
+                        <a:rPr lang="en-US" sz="1100" dirty="0">
                           <a:solidFill>
                             <a:srgbClr val="0B0B0B"/>
                           </a:solidFill>
@@ -21891,9 +22028,9 @@
                           <a:ea typeface="Aptos" pitchFamily="34" charset="-122"/>
                           <a:cs typeface="Aptos" pitchFamily="34" charset="-120"/>
                         </a:rPr>
-                        <a:t>2.0 m</a:t>
+                        <a:t>2.4 m</a:t>
                       </a:r>
-                      <a:endParaRPr lang="en-US" sz="1150" dirty="0">
+                      <a:endParaRPr lang="en-US" sz="1100" dirty="0">
                         <a:latin typeface="Aptos" charset="0"/>
                         <a:ea typeface="Aptos" charset="0"/>
                         <a:cs typeface="Aptos" charset="0"/>
@@ -21948,7 +22085,7 @@
                         <a:buNone/>
                       </a:pPr>
                       <a:r>
-                        <a:rPr lang="en-US" sz="1150" b="1" dirty="0">
+                        <a:rPr lang="en-US" sz="1100" b="1" dirty="0">
                           <a:solidFill>
                             <a:srgbClr val="0B0B0B"/>
                           </a:solidFill>
@@ -21956,9 +22093,9 @@
                           <a:ea typeface="Aptos" pitchFamily="34" charset="-122"/>
                           <a:cs typeface="Aptos" pitchFamily="34" charset="-120"/>
                         </a:rPr>
-                        <a:t>0.54</a:t>
+                        <a:t>0.28</a:t>
                       </a:r>
-                      <a:endParaRPr lang="en-US" sz="1150" dirty="0">
+                      <a:endParaRPr lang="en-US" sz="1100" dirty="0">
                         <a:latin typeface="Aptos" charset="0"/>
                         <a:ea typeface="Aptos" charset="0"/>
                         <a:cs typeface="Aptos" charset="0"/>
@@ -22015,7 +22152,7 @@
                         <a:buNone/>
                       </a:pPr>
                       <a:r>
-                        <a:rPr lang="en-US" sz="1150" b="1" dirty="0">
+                        <a:rPr lang="en-US" sz="1100" b="1" dirty="0">
                           <a:solidFill>
                             <a:srgbClr val="0B0B0B"/>
                           </a:solidFill>
@@ -22023,9 +22160,9 @@
                           <a:ea typeface="Aptos" pitchFamily="34" charset="-122"/>
                           <a:cs typeface="Aptos" pitchFamily="34" charset="-120"/>
                         </a:rPr>
-                        <a:t>DN32</a:t>
+                        <a:t>450 tray</a:t>
                       </a:r>
-                      <a:endParaRPr lang="en-US" sz="1150" dirty="0">
+                      <a:endParaRPr lang="en-US" sz="1100" dirty="0">
                         <a:latin typeface="Aptos" charset="0"/>
                         <a:ea typeface="Aptos" charset="0"/>
                         <a:cs typeface="Aptos" charset="0"/>
@@ -22080,9 +22217,9 @@
                         <a:buNone/>
                       </a:pPr>
                       <a:r>
-                        <a:rPr lang="en-US" sz="1150" dirty="0">
+                        <a:rPr lang="en-US" sz="1100" dirty="0">
                           <a:solidFill>
-                            <a:srgbClr val="E34948"/>
+                            <a:srgbClr val="4A3AA7"/>
                           </a:solidFill>
                           <a:latin typeface="Aptos" pitchFamily="34" charset="0"/>
                           <a:ea typeface="Aptos" pitchFamily="34" charset="-122"/>
@@ -22094,7 +22231,7 @@
                         <a:buNone/>
                       </a:pPr>
                       <a:r>
-                        <a:rPr lang="en-US" sz="1150" dirty="0">
+                        <a:rPr lang="en-US" sz="1100" dirty="0">
                           <a:solidFill>
                             <a:srgbClr val="0B0B0B"/>
                           </a:solidFill>
@@ -22102,9 +22239,9 @@
                           <a:ea typeface="Aptos" pitchFamily="34" charset="-122"/>
                           <a:cs typeface="Aptos" pitchFamily="34" charset="-120"/>
                         </a:rPr>
-                        <a:t>sprinkler</a:t>
+                        <a:t>electrical</a:t>
                       </a:r>
-                      <a:endParaRPr lang="en-US" sz="1150" dirty="0">
+                      <a:endParaRPr lang="en-US" sz="1100" dirty="0">
                         <a:latin typeface="Aptos" charset="0"/>
                         <a:ea typeface="Aptos" charset="0"/>
                         <a:cs typeface="Aptos" charset="0"/>
@@ -22159,7 +22296,7 @@
                         <a:buNone/>
                       </a:pPr>
                       <a:r>
-                        <a:rPr lang="en-US" sz="1150" dirty="0">
+                        <a:rPr lang="en-US" sz="1100" dirty="0">
                           <a:solidFill>
                             <a:srgbClr val="0B0B0B"/>
                           </a:solidFill>
@@ -22169,7 +22306,7 @@
                         </a:rPr>
                         <a:t>0</a:t>
                       </a:r>
-                      <a:endParaRPr lang="en-US" sz="1150" dirty="0">
+                      <a:endParaRPr lang="en-US" sz="1100" dirty="0">
                         <a:latin typeface="Aptos" charset="0"/>
                         <a:ea typeface="Aptos" charset="0"/>
                         <a:cs typeface="Aptos" charset="0"/>
@@ -22224,7 +22361,7 @@
                         <a:buNone/>
                       </a:pPr>
                       <a:r>
-                        <a:rPr lang="en-US" sz="1150" dirty="0">
+                        <a:rPr lang="en-US" sz="1100" dirty="0">
                           <a:solidFill>
                             <a:srgbClr val="0B0B0B"/>
                           </a:solidFill>
@@ -22232,9 +22369,9 @@
                           <a:ea typeface="Aptos" pitchFamily="34" charset="-122"/>
                           <a:cs typeface="Aptos" pitchFamily="34" charset="-120"/>
                         </a:rPr>
-                        <a:t>0.040</a:t>
+                        <a:t>0.809</a:t>
                       </a:r>
-                      <a:endParaRPr lang="en-US" sz="1150" dirty="0">
+                      <a:endParaRPr lang="en-US" sz="1100" dirty="0">
                         <a:latin typeface="Aptos" charset="0"/>
                         <a:ea typeface="Aptos" charset="0"/>
                         <a:cs typeface="Aptos" charset="0"/>
@@ -22289,7 +22426,7 @@
                         <a:buNone/>
                       </a:pPr>
                       <a:r>
-                        <a:rPr lang="en-US" sz="1150" dirty="0">
+                        <a:rPr lang="en-US" sz="1100" dirty="0">
                           <a:solidFill>
                             <a:srgbClr val="0B0B0B"/>
                           </a:solidFill>
@@ -22297,9 +22434,9 @@
                           <a:ea typeface="Aptos" pitchFamily="34" charset="-122"/>
                           <a:cs typeface="Aptos" pitchFamily="34" charset="-120"/>
                         </a:rPr>
-                        <a:t>2.1 m</a:t>
+                        <a:t>2.0 m</a:t>
                       </a:r>
-                      <a:endParaRPr lang="en-US" sz="1150" dirty="0">
+                      <a:endParaRPr lang="en-US" sz="1100" dirty="0">
                         <a:latin typeface="Aptos" charset="0"/>
                         <a:ea typeface="Aptos" charset="0"/>
                         <a:cs typeface="Aptos" charset="0"/>
@@ -22354,7 +22491,7 @@
                         <a:buNone/>
                       </a:pPr>
                       <a:r>
-                        <a:rPr lang="en-US" sz="1150" b="1" dirty="0">
+                        <a:rPr lang="en-US" sz="1100" b="1" dirty="0">
                           <a:solidFill>
                             <a:srgbClr val="0B0B0B"/>
                           </a:solidFill>
@@ -22362,9 +22499,9 @@
                           <a:ea typeface="Aptos" pitchFamily="34" charset="-122"/>
                           <a:cs typeface="Aptos" pitchFamily="34" charset="-120"/>
                         </a:rPr>
-                        <a:t>0.08</a:t>
+                        <a:t>1.62</a:t>
                       </a:r>
-                      <a:endParaRPr lang="en-US" sz="1150" dirty="0">
+                      <a:endParaRPr lang="en-US" sz="1100" dirty="0">
                         <a:latin typeface="Aptos" charset="0"/>
                         <a:ea typeface="Aptos" charset="0"/>
                         <a:cs typeface="Aptos" charset="0"/>
@@ -22421,7 +22558,7 @@
                         <a:buNone/>
                       </a:pPr>
                       <a:r>
-                        <a:rPr lang="en-US" sz="1150" b="1" dirty="0">
+                        <a:rPr lang="en-US" sz="1100" b="1" dirty="0">
                           <a:solidFill>
                             <a:srgbClr val="0B0B0B"/>
                           </a:solidFill>
@@ -22429,9 +22566,9 @@
                           <a:ea typeface="Aptos" pitchFamily="34" charset="-122"/>
                           <a:cs typeface="Aptos" pitchFamily="34" charset="-120"/>
                         </a:rPr>
-                        <a:t>DN20</a:t>
+                        <a:t>300 tray</a:t>
                       </a:r>
-                      <a:endParaRPr lang="en-US" sz="1150" dirty="0">
+                      <a:endParaRPr lang="en-US" sz="1100" dirty="0">
                         <a:latin typeface="Aptos" charset="0"/>
                         <a:ea typeface="Aptos" charset="0"/>
                         <a:cs typeface="Aptos" charset="0"/>
@@ -22486,9 +22623,9 @@
                         <a:buNone/>
                       </a:pPr>
                       <a:r>
-                        <a:rPr lang="en-US" sz="1150" dirty="0">
+                        <a:rPr lang="en-US" sz="1100" dirty="0">
                           <a:solidFill>
-                            <a:srgbClr val="2A78D6"/>
+                            <a:srgbClr val="4A3AA7"/>
                           </a:solidFill>
                           <a:latin typeface="Aptos" pitchFamily="34" charset="0"/>
                           <a:ea typeface="Aptos" pitchFamily="34" charset="-122"/>
@@ -22500,7 +22637,7 @@
                         <a:buNone/>
                       </a:pPr>
                       <a:r>
-                        <a:rPr lang="en-US" sz="1150" dirty="0">
+                        <a:rPr lang="en-US" sz="1100" dirty="0">
                           <a:solidFill>
                             <a:srgbClr val="0B0B0B"/>
                           </a:solidFill>
@@ -22508,9 +22645,9 @@
                           <a:ea typeface="Aptos" pitchFamily="34" charset="-122"/>
                           <a:cs typeface="Aptos" pitchFamily="34" charset="-120"/>
                         </a:rPr>
-                        <a:t>domestic water</a:t>
+                        <a:t>electrical</a:t>
                       </a:r>
-                      <a:endParaRPr lang="en-US" sz="1150" dirty="0">
+                      <a:endParaRPr lang="en-US" sz="1100" dirty="0">
                         <a:latin typeface="Aptos" charset="0"/>
                         <a:ea typeface="Aptos" charset="0"/>
                         <a:cs typeface="Aptos" charset="0"/>
@@ -22565,7 +22702,7 @@
                         <a:buNone/>
                       </a:pPr>
                       <a:r>
-                        <a:rPr lang="en-US" sz="1150" dirty="0">
+                        <a:rPr lang="en-US" sz="1100" dirty="0">
                           <a:solidFill>
                             <a:srgbClr val="0B0B0B"/>
                           </a:solidFill>
@@ -22573,9 +22710,9 @@
                           <a:ea typeface="Aptos" pitchFamily="34" charset="-122"/>
                           <a:cs typeface="Aptos" pitchFamily="34" charset="-120"/>
                         </a:rPr>
-                        <a:t>20</a:t>
+                        <a:t>0</a:t>
                       </a:r>
-                      <a:endParaRPr lang="en-US" sz="1150" dirty="0">
+                      <a:endParaRPr lang="en-US" sz="1100" dirty="0">
                         <a:latin typeface="Aptos" charset="0"/>
                         <a:ea typeface="Aptos" charset="0"/>
                         <a:cs typeface="Aptos" charset="0"/>
@@ -22630,7 +22767,7 @@
                         <a:buNone/>
                       </a:pPr>
                       <a:r>
-                        <a:rPr lang="en-US" sz="1150" dirty="0">
+                        <a:rPr lang="en-US" sz="1100" dirty="0">
                           <a:solidFill>
                             <a:srgbClr val="0B0B0B"/>
                           </a:solidFill>
@@ -22638,9 +22775,9 @@
                           <a:ea typeface="Aptos" pitchFamily="34" charset="-122"/>
                           <a:cs typeface="Aptos" pitchFamily="34" charset="-120"/>
                         </a:rPr>
-                        <a:t>0.019</a:t>
+                        <a:t>0.540</a:t>
                       </a:r>
-                      <a:endParaRPr lang="en-US" sz="1150" dirty="0">
+                      <a:endParaRPr lang="en-US" sz="1100" dirty="0">
                         <a:latin typeface="Aptos" charset="0"/>
                         <a:ea typeface="Aptos" charset="0"/>
                         <a:cs typeface="Aptos" charset="0"/>
@@ -22695,7 +22832,7 @@
                         <a:buNone/>
                       </a:pPr>
                       <a:r>
-                        <a:rPr lang="en-US" sz="1150" dirty="0">
+                        <a:rPr lang="en-US" sz="1100" dirty="0">
                           <a:solidFill>
                             <a:srgbClr val="0B0B0B"/>
                           </a:solidFill>
@@ -22703,9 +22840,9 @@
                           <a:ea typeface="Aptos" pitchFamily="34" charset="-122"/>
                           <a:cs typeface="Aptos" pitchFamily="34" charset="-120"/>
                         </a:rPr>
-                        <a:t>2.1 m</a:t>
+                        <a:t>2.0 m</a:t>
                       </a:r>
-                      <a:endParaRPr lang="en-US" sz="1150" dirty="0">
+                      <a:endParaRPr lang="en-US" sz="1100" dirty="0">
                         <a:latin typeface="Aptos" charset="0"/>
                         <a:ea typeface="Aptos" charset="0"/>
                         <a:cs typeface="Aptos" charset="0"/>
@@ -22760,7 +22897,7 @@
                         <a:buNone/>
                       </a:pPr>
                       <a:r>
-                        <a:rPr lang="en-US" sz="1150" b="1" dirty="0">
+                        <a:rPr lang="en-US" sz="1100" b="1" dirty="0">
                           <a:solidFill>
                             <a:srgbClr val="0B0B0B"/>
                           </a:solidFill>
@@ -22768,9 +22905,9 @@
                           <a:ea typeface="Aptos" pitchFamily="34" charset="-122"/>
                           <a:cs typeface="Aptos" pitchFamily="34" charset="-120"/>
                         </a:rPr>
-                        <a:t>0.04</a:t>
+                        <a:t>1.08</a:t>
                       </a:r>
-                      <a:endParaRPr lang="en-US" sz="1150" dirty="0">
+                      <a:endParaRPr lang="en-US" sz="1100" dirty="0">
                         <a:latin typeface="Aptos" charset="0"/>
                         <a:ea typeface="Aptos" charset="0"/>
                         <a:cs typeface="Aptos" charset="0"/>
@@ -22827,7 +22964,7 @@
                         <a:buNone/>
                       </a:pPr>
                       <a:r>
-                        <a:rPr lang="en-US" sz="1150" b="1" dirty="0">
+                        <a:rPr lang="en-US" sz="1100" b="1" dirty="0">
                           <a:solidFill>
                             <a:srgbClr val="0B0B0B"/>
                           </a:solidFill>
@@ -22837,7 +22974,7 @@
                         </a:rPr>
                         <a:t>DN20</a:t>
                       </a:r>
-                      <a:endParaRPr lang="en-US" sz="1150" dirty="0">
+                      <a:endParaRPr lang="en-US" sz="1100" dirty="0">
                         <a:latin typeface="Aptos" charset="0"/>
                         <a:ea typeface="Aptos" charset="0"/>
                         <a:cs typeface="Aptos" charset="0"/>
@@ -22892,9 +23029,9 @@
                         <a:buNone/>
                       </a:pPr>
                       <a:r>
-                        <a:rPr lang="en-US" sz="1150" dirty="0">
+                        <a:rPr lang="en-US" sz="1100" dirty="0">
                           <a:solidFill>
-                            <a:srgbClr val="2A78D6"/>
+                            <a:srgbClr val="EB6834"/>
                           </a:solidFill>
                           <a:latin typeface="Aptos" pitchFamily="34" charset="0"/>
                           <a:ea typeface="Aptos" pitchFamily="34" charset="-122"/>
@@ -22906,7 +23043,7 @@
                         <a:buNone/>
                       </a:pPr>
                       <a:r>
-                        <a:rPr lang="en-US" sz="1150" dirty="0">
+                        <a:rPr lang="en-US" sz="1100" dirty="0">
                           <a:solidFill>
                             <a:srgbClr val="0B0B0B"/>
                           </a:solidFill>
@@ -22914,9 +23051,9 @@
                           <a:ea typeface="Aptos" pitchFamily="34" charset="-122"/>
                           <a:cs typeface="Aptos" pitchFamily="34" charset="-120"/>
                         </a:rPr>
-                        <a:t>domestic water</a:t>
+                        <a:t>heating</a:t>
                       </a:r>
-                      <a:endParaRPr lang="en-US" sz="1150" dirty="0">
+                      <a:endParaRPr lang="en-US" sz="1100" dirty="0">
                         <a:latin typeface="Aptos" charset="0"/>
                         <a:ea typeface="Aptos" charset="0"/>
                         <a:cs typeface="Aptos" charset="0"/>
@@ -22971,7 +23108,7 @@
                         <a:buNone/>
                       </a:pPr>
                       <a:r>
-                        <a:rPr lang="en-US" sz="1150" dirty="0">
+                        <a:rPr lang="en-US" sz="1100" dirty="0">
                           <a:solidFill>
                             <a:srgbClr val="0B0B0B"/>
                           </a:solidFill>
@@ -22979,9 +23116,9 @@
                           <a:ea typeface="Aptos" pitchFamily="34" charset="-122"/>
                           <a:cs typeface="Aptos" pitchFamily="34" charset="-120"/>
                         </a:rPr>
-                        <a:t>0</a:t>
+                        <a:t>20</a:t>
                       </a:r>
-                      <a:endParaRPr lang="en-US" sz="1150" dirty="0">
+                      <a:endParaRPr lang="en-US" sz="1100" dirty="0">
                         <a:latin typeface="Aptos" charset="0"/>
                         <a:ea typeface="Aptos" charset="0"/>
                         <a:cs typeface="Aptos" charset="0"/>
@@ -23036,7 +23173,7 @@
                         <a:buNone/>
                       </a:pPr>
                       <a:r>
-                        <a:rPr lang="en-US" sz="1150" dirty="0">
+                        <a:rPr lang="en-US" sz="1100" dirty="0">
                           <a:solidFill>
                             <a:srgbClr val="0B0B0B"/>
                           </a:solidFill>
@@ -23046,7 +23183,7 @@
                         </a:rPr>
                         <a:t>0.019</a:t>
                       </a:r>
-                      <a:endParaRPr lang="en-US" sz="1150" dirty="0">
+                      <a:endParaRPr lang="en-US" sz="1100" dirty="0">
                         <a:latin typeface="Aptos" charset="0"/>
                         <a:ea typeface="Aptos" charset="0"/>
                         <a:cs typeface="Aptos" charset="0"/>
@@ -23101,7 +23238,7 @@
                         <a:buNone/>
                       </a:pPr>
                       <a:r>
-                        <a:rPr lang="en-US" sz="1150" dirty="0">
+                        <a:rPr lang="en-US" sz="1100" dirty="0">
                           <a:solidFill>
                             <a:srgbClr val="0B0B0B"/>
                           </a:solidFill>
@@ -23111,7 +23248,7 @@
                         </a:rPr>
                         <a:t>2.1 m</a:t>
                       </a:r>
-                      <a:endParaRPr lang="en-US" sz="1150" dirty="0">
+                      <a:endParaRPr lang="en-US" sz="1100" dirty="0">
                         <a:latin typeface="Aptos" charset="0"/>
                         <a:ea typeface="Aptos" charset="0"/>
                         <a:cs typeface="Aptos" charset="0"/>
@@ -23166,7 +23303,7 @@
                         <a:buNone/>
                       </a:pPr>
                       <a:r>
-                        <a:rPr lang="en-US" sz="1150" b="1" dirty="0">
+                        <a:rPr lang="en-US" sz="1100" b="1" dirty="0">
                           <a:solidFill>
                             <a:srgbClr val="0B0B0B"/>
                           </a:solidFill>
@@ -23176,7 +23313,7 @@
                         </a:rPr>
                         <a:t>0.04</a:t>
                       </a:r>
-                      <a:endParaRPr lang="en-US" sz="1150" dirty="0">
+                      <a:endParaRPr lang="en-US" sz="1100" dirty="0">
                         <a:latin typeface="Aptos" charset="0"/>
                         <a:ea typeface="Aptos" charset="0"/>
                         <a:cs typeface="Aptos" charset="0"/>
@@ -23229,7 +23366,7 @@
       </p:graphicFrame>
       <p:sp>
         <p:nvSpPr>
-          <p:cNvPr id="19" name="fact ceiling slab, concrete C30"/>
+          <p:cNvPr id="22" name="fact ceiling slab, concrete C30"/>
           <p:cNvSpPr/>
           <p:nvPr/>
         </p:nvSpPr>
@@ -23251,7 +23388,7 @@
       </p:sp>
       <p:sp>
         <p:nvSpPr>
-          <p:cNvPr id="20" name="icon ring fact ceiling slab, concrete C30"/>
+          <p:cNvPr id="23" name="icon ring fact ceiling slab, concrete C30"/>
           <p:cNvSpPr/>
           <p:nvPr/>
         </p:nvSpPr>
@@ -23271,14 +23408,14 @@
       </p:sp>
       <p:pic>
         <p:nvPicPr>
-          <p:cNvPr id="21" name="icon fact ceiling slab, concrete C30" descr="preencoded.png">    </p:cNvPr>
+          <p:cNvPr id="24" name="icon fact ceiling slab, concrete C30" descr="preencoded.png">    </p:cNvPr>
           <p:cNvPicPr>
             <a:picLocks noChangeAspect="1"/>
           </p:cNvPicPr>
           <p:nvPr/>
         </p:nvPicPr>
         <p:blipFill>
-          <a:blip r:embed="rId2"/>
+          <a:blip r:embed="rId3"/>
           <a:stretch>
             <a:fillRect/>
           </a:stretch>
@@ -23295,7 +23432,7 @@
       </p:pic>
       <p:sp>
         <p:nvSpPr>
-          <p:cNvPr id="22" name="fact text ceiling slab, concrete C30"/>
+          <p:cNvPr id="25" name="fact text ceiling slab, concrete C30"/>
           <p:cNvSpPr txBox="1"/>
           <p:nvPr/>
         </p:nvSpPr>
@@ -23323,7 +23460,7 @@
                   <a:schemeClr val="tx1"/>
                 </a:solidFill>
               </a:rPr>
-              <a:t>150 mm</a:t>
+              <a:t>200 mm</a:t>
             </a:r>
             <a:endParaRPr lang="en-US" sz="1250" dirty="0"/>
           </a:p>
@@ -23345,7 +23482,7 @@
       </p:sp>
       <p:sp>
         <p:nvSpPr>
-          <p:cNvPr id="23" name="fact total load at this support"/>
+          <p:cNvPr id="26" name="fact total load at this support"/>
           <p:cNvSpPr/>
           <p:nvPr/>
         </p:nvSpPr>
@@ -23367,7 +23504,7 @@
       </p:sp>
       <p:sp>
         <p:nvSpPr>
-          <p:cNvPr id="24" name="icon ring fact total load at this support"/>
+          <p:cNvPr id="27" name="icon ring fact total load at this support"/>
           <p:cNvSpPr/>
           <p:nvPr/>
         </p:nvSpPr>
@@ -23387,14 +23524,14 @@
       </p:sp>
       <p:pic>
         <p:nvPicPr>
-          <p:cNvPr id="25" name="icon fact total load at this support" descr="preencoded.png">    </p:cNvPr>
+          <p:cNvPr id="28" name="icon fact total load at this support" descr="preencoded.png">    </p:cNvPr>
           <p:cNvPicPr>
             <a:picLocks noChangeAspect="1"/>
           </p:cNvPicPr>
           <p:nvPr/>
         </p:nvPicPr>
         <p:blipFill>
-          <a:blip r:embed="rId3"/>
+          <a:blip r:embed="rId4"/>
           <a:stretch>
             <a:fillRect/>
           </a:stretch>
@@ -23411,7 +23548,7 @@
       </p:pic>
       <p:sp>
         <p:nvSpPr>
-          <p:cNvPr id="26" name="fact text total load at this support"/>
+          <p:cNvPr id="29" name="fact text total load at this support"/>
           <p:cNvSpPr txBox="1"/>
           <p:nvPr/>
         </p:nvSpPr>
@@ -23439,7 +23576,7 @@
                   <a:schemeClr val="tx1"/>
                 </a:solidFill>
               </a:rPr>
-              <a:t>2.86 kN</a:t>
+              <a:t>3.30 kN</a:t>
             </a:r>
             <a:endParaRPr lang="en-US" sz="1250" dirty="0"/>
           </a:p>
@@ -23461,7 +23598,7 @@
       </p:sp>
       <p:sp>
         <p:nvSpPr>
-          <p:cNvPr id="27" name="fact closest clear gap, 2 rows"/>
+          <p:cNvPr id="30" name="fact closest clear gap, 2 rows"/>
           <p:cNvSpPr/>
           <p:nvPr/>
         </p:nvSpPr>
@@ -23483,7 +23620,7 @@
       </p:sp>
       <p:sp>
         <p:nvSpPr>
-          <p:cNvPr id="28" name="icon ring fact closest clear gap, 2 rows"/>
+          <p:cNvPr id="31" name="icon ring fact closest clear gap, 2 rows"/>
           <p:cNvSpPr/>
           <p:nvPr/>
         </p:nvSpPr>
@@ -23503,14 +23640,14 @@
       </p:sp>
       <p:pic>
         <p:nvPicPr>
-          <p:cNvPr id="29" name="icon fact closest clear gap, 2 rows" descr="preencoded.png">    </p:cNvPr>
+          <p:cNvPr id="32" name="icon fact closest clear gap, 2 rows" descr="preencoded.png">    </p:cNvPr>
           <p:cNvPicPr>
             <a:picLocks noChangeAspect="1"/>
           </p:cNvPicPr>
           <p:nvPr/>
         </p:nvPicPr>
         <p:blipFill>
-          <a:blip r:embed="rId4"/>
+          <a:blip r:embed="rId5"/>
           <a:stretch>
             <a:fillRect/>
           </a:stretch>
@@ -23527,7 +23664,7 @@
       </p:pic>
       <p:sp>
         <p:nvSpPr>
-          <p:cNvPr id="30" name="fact text closest clear gap, 2 rows"/>
+          <p:cNvPr id="33" name="fact text closest clear gap, 2 rows"/>
           <p:cNvSpPr txBox="1"/>
           <p:nvPr/>
         </p:nvSpPr>
@@ -23555,7 +23692,7 @@
                   <a:schemeClr val="tx1"/>
                 </a:solidFill>
               </a:rPr>
-              <a:t>72 mm</a:t>
+              <a:t>44 mm</a:t>
             </a:r>
             <a:endParaRPr lang="en-US" sz="1250" dirty="0"/>
           </a:p>
@@ -23577,7 +23714,7 @@
       </p:sp>
       <p:sp>
         <p:nvSpPr>
-          <p:cNvPr id="31" name="absent band"/>
+          <p:cNvPr id="34" name="absent band"/>
           <p:cNvSpPr/>
           <p:nvPr/>
         </p:nvSpPr>
@@ -23599,14 +23736,14 @@
       </p:sp>
       <p:pic>
         <p:nvPicPr>
-          <p:cNvPr id="32" name="icon absent" descr="preencoded.png">    </p:cNvPr>
+          <p:cNvPr id="35" name="icon absent" descr="preencoded.png">    </p:cNvPr>
           <p:cNvPicPr>
             <a:picLocks noChangeAspect="1"/>
           </p:cNvPicPr>
           <p:nvPr/>
         </p:nvPicPr>
         <p:blipFill>
-          <a:blip r:embed="rId5"/>
+          <a:blip r:embed="rId6"/>
           <a:stretch>
             <a:fillRect/>
           </a:stretch>
@@ -23623,7 +23760,7 @@
       </p:pic>
       <p:sp>
         <p:nvSpPr>
-          <p:cNvPr id="33" name="absent text"/>
+          <p:cNvPr id="36" name="absent text"/>
           <p:cNvSpPr txBox="1"/>
           <p:nvPr/>
         </p:nvSpPr>
@@ -24743,7 +24880,7 @@
       </p:sp>
       <p:pic>
         <p:nvPicPr>
-          <p:cNvPr id="34" name="generation example" descr="/home/user/crossmep_dataset/docs/figures/05_generation_example.png">    </p:cNvPr>
+          <p:cNvPr id="34" name="generated sheet" descr="preencoded.png">    </p:cNvPr>
           <p:cNvPicPr>
             <a:picLocks noChangeAspect="1"/>
           </p:cNvPicPr>
@@ -24757,8 +24894,8 @@
         </p:blipFill>
         <p:spPr>
           <a:xfrm>
-            <a:off x="6355080" y="1630935"/>
-            <a:ext cx="5285232" cy="3230370"/>
+            <a:off x="6757067" y="1371600"/>
+            <a:ext cx="4481258" cy="2697480"/>
           </a:xfrm>
           <a:prstGeom prst="rect">
             <a:avLst/>
@@ -24767,14 +24904,14 @@
       </p:pic>
       <p:sp>
         <p:nvSpPr>
-          <p:cNvPr id="35" name="example frame"/>
-          <p:cNvSpPr/>
-          <p:nvPr/>
-        </p:nvSpPr>
-        <p:spPr>
-          <a:xfrm>
-            <a:off x="6355080" y="1630935"/>
-            <a:ext cx="5285232" cy="3230370"/>
+          <p:cNvPr id="35" name="generated sheet frame"/>
+          <p:cNvSpPr/>
+          <p:nvPr/>
+        </p:nvSpPr>
+        <p:spPr>
+          <a:xfrm>
+            <a:off x="6702203" y="1316736"/>
+            <a:ext cx="4590986" cy="2807208"/>
           </a:xfrm>
           <a:prstGeom prst="rect">
             <a:avLst/>
@@ -24787,16 +24924,40 @@
           </a:ln>
         </p:spPr>
       </p:sp>
-      <p:sp>
-        <p:nvSpPr>
-          <p:cNvPr id="36" name="generation caption"/>
+      <p:pic>
+        <p:nvPicPr>
+          <p:cNvPr id="36" name="generated 3d" descr="preencoded.png">    </p:cNvPr>
+          <p:cNvPicPr>
+            <a:picLocks noChangeAspect="1"/>
+          </p:cNvPicPr>
+          <p:nvPr/>
+        </p:nvPicPr>
+        <p:blipFill>
+          <a:blip r:embed="rId8"/>
+          <a:stretch>
+            <a:fillRect/>
+          </a:stretch>
+        </p:blipFill>
+        <p:spPr>
+          <a:xfrm>
+            <a:off x="6598516" y="4206240"/>
+            <a:ext cx="2027727" cy="1691640"/>
+          </a:xfrm>
+          <a:prstGeom prst="rect">
+            <a:avLst/>
+          </a:prstGeom>
+        </p:spPr>
+      </p:pic>
+      <p:sp>
+        <p:nvSpPr>
+          <p:cNvPr id="37" name="generated 3d legend"/>
           <p:cNvSpPr txBox="1"/>
           <p:nvPr/>
         </p:nvSpPr>
         <p:spPr>
           <a:xfrm>
-            <a:off x="6355080" y="4952745"/>
-            <a:ext cx="5285232" cy="411480"/>
+            <a:off x="6355080" y="5925312"/>
+            <a:ext cx="2743200" cy="201168"/>
           </a:xfrm>
           <a:prstGeom prst="rect">
             <a:avLst/>
@@ -24805,27 +24966,118 @@
           <a:ln/>
         </p:spPr>
         <p:txBody>
-          <a:bodyPr wrap="square" lIns="0" tIns="0" rIns="0" bIns="0" rtlCol="0" anchor="t"/>
+          <a:bodyPr wrap="square" lIns="0" tIns="0" rIns="0" bIns="0" rtlCol="0" anchor="ctr"/>
           <a:lstStyle/>
           <a:p>
             <a:pPr indent="0" marL="0">
               <a:buNone/>
             </a:pPr>
             <a:r>
-              <a:rPr lang="en-US" sz="1150" dirty="0">
+              <a:rPr lang="en-US" sz="900" dirty="0">
+                <a:solidFill>
+                  <a:srgbClr val="008300"/>
+                </a:solidFill>
+              </a:rPr>
+              <a:t>● </a:t>
+            </a:r>
+            <a:pPr indent="0" marL="0">
+              <a:buNone/>
+            </a:pPr>
+            <a:r>
+              <a:rPr lang="en-US" sz="900" dirty="0">
                 <a:solidFill>
                   <a:srgbClr val="52514E"/>
                 </a:solidFill>
               </a:rPr>
-              <a:t>One generated benchmark context, three rows by priority; the gap marked is one draw from the measured distribution.</a:t>
+              <a:t>ventilation   </a:t>
             </a:r>
-            <a:endParaRPr lang="en-US" sz="1150" dirty="0"/>
+            <a:pPr indent="0" marL="0">
+              <a:buNone/>
+            </a:pPr>
+            <a:r>
+              <a:rPr lang="en-US" sz="900" dirty="0">
+                <a:solidFill>
+                  <a:srgbClr val="4A3AA7"/>
+                </a:solidFill>
+              </a:rPr>
+              <a:t>● </a:t>
+            </a:r>
+            <a:pPr indent="0" marL="0">
+              <a:buNone/>
+            </a:pPr>
+            <a:r>
+              <a:rPr lang="en-US" sz="900" dirty="0">
+                <a:solidFill>
+                  <a:srgbClr val="52514E"/>
+                </a:solidFill>
+              </a:rPr>
+              <a:t>electrical   </a:t>
+            </a:r>
+            <a:pPr indent="0" marL="0">
+              <a:buNone/>
+            </a:pPr>
+            <a:r>
+              <a:rPr lang="en-US" sz="900" dirty="0">
+                <a:solidFill>
+                  <a:srgbClr val="EB6834"/>
+                </a:solidFill>
+              </a:rPr>
+              <a:t>● </a:t>
+            </a:r>
+            <a:pPr indent="0" marL="0">
+              <a:buNone/>
+            </a:pPr>
+            <a:r>
+              <a:rPr lang="en-US" sz="900" dirty="0">
+                <a:solidFill>
+                  <a:srgbClr val="52514E"/>
+                </a:solidFill>
+              </a:rPr>
+              <a:t>heating   </a:t>
+            </a:r>
+            <a:endParaRPr lang="en-US" sz="900" dirty="0"/>
           </a:p>
         </p:txBody>
       </p:sp>
       <p:sp>
         <p:nvSpPr>
-          <p:cNvPr id="37" name="references"/>
+          <p:cNvPr id="38" name="generation caption"/>
+          <p:cNvSpPr txBox="1"/>
+          <p:nvPr/>
+        </p:nvSpPr>
+        <p:spPr>
+          <a:xfrm>
+            <a:off x="9098280" y="4206240"/>
+            <a:ext cx="2542032" cy="1737360"/>
+          </a:xfrm>
+          <a:prstGeom prst="rect">
+            <a:avLst/>
+          </a:prstGeom>
+          <a:noFill/>
+          <a:ln/>
+        </p:spPr>
+        <p:txBody>
+          <a:bodyPr wrap="square" lIns="0" tIns="0" rIns="0" bIns="0" rtlCol="0" anchor="t"/>
+          <a:lstStyle/>
+          <a:p>
+            <a:pPr indent="0" marL="0">
+              <a:buNone/>
+            </a:pPr>
+            <a:r>
+              <a:rPr lang="en-US" sz="1100" dirty="0">
+                <a:solidFill>
+                  <a:srgbClr val="52514E"/>
+                </a:solidFill>
+              </a:rPr>
+              <a:t>One generated context, tier C8: 8 services on 3 rows, ducts nearest the slab, then the tray and conduits, then the pipe. The gap marked on the sheet is one draw from the measured distribution; the same seed gives the same section.</a:t>
+            </a:r>
+            <a:endParaRPr lang="en-US" sz="1100" dirty="0"/>
+          </a:p>
+        </p:txBody>
+      </p:sp>
+      <p:sp>
+        <p:nvSpPr>
+          <p:cNvPr id="39" name="references"/>
           <p:cNvSpPr txBox="1"/>
           <p:nvPr/>
         </p:nvSpPr>

</xml_diff>

<commit_message>
Talk: slide 9 as element rows with glyphs and three colour-coded kinds of ground
</commit_message>
<xml_diff>
--- a/docs/CrossMEP_CIBW78_talk.pptx
+++ b/docs/CrossMEP_CIBW78_talk.pptx
@@ -124,12 +124,12 @@
   <p:extLst>
     <p:ext uri="{521415D9-36F7-43E2-AB2F-B90AF26B5E84}">
       <p14:sectionLst xmlns:p14="http://schemas.microsoft.com/office/powerpoint/2010/main">
-        <p14:section name="Opening" id="{1a9b7c69-941a-d664-a0a6-e9462303d2d3}">
+        <p14:section name="Opening" id="{5c79d808-11f0-2668-9aed-729bbacd6406}">
           <p14:sldIdLst>
             <p14:sldId id="256"/>
           </p14:sldIdLst>
         </p14:section>
-        <p14:section name="Motivation" id="{3b8f83d0-925f-fbdb-d0ae-7a3651068010}">
+        <p14:section name="Motivation" id="{90d26091-19ad-6fd6-5550-e900b6a36823}">
           <p14:sldIdLst>
             <p14:sldId id="257"/>
             <p14:sldId id="258"/>
@@ -138,7 +138,7 @@
             <p14:sldId id="261"/>
           </p14:sldIdLst>
         </p14:section>
-        <p14:section name="The dataset" id="{94cba26a-e6fc-2d4c-de00-a2ba8e0c147c}">
+        <p14:section name="The dataset" id="{f207685c-c963-9ac3-5085-326decf1b7d9}">
           <p14:sldIdLst>
             <p14:sldId id="262"/>
             <p14:sldId id="263"/>
@@ -147,14 +147,14 @@
             <p14:sldId id="266"/>
           </p14:sldIdLst>
         </p14:section>
-        <p14:section name="Experiments" id="{ee5575c6-37cd-73dc-d847-3106d5153710}">
+        <p14:section name="Experiments" id="{aa9faf52-2dff-2c87-b130-3be1888aeb20}">
           <p14:sldIdLst>
             <p14:sldId id="267"/>
             <p14:sldId id="268"/>
             <p14:sldId id="269"/>
           </p14:sldIdLst>
         </p14:section>
-        <p14:section name="Use" id="{7c59a61a-3ecb-9aae-5c8c-dc8d48bc658c}">
+        <p14:section name="Use" id="{05e7e428-cac6-6942-1850-55c6b2821882}">
           <p14:sldIdLst>
             <p14:sldId id="270"/>
             <p14:sldId id="271"/>
@@ -25219,1238 +25219,90 @@
           </a:p>
         </p:txBody>
       </p:sp>
-      <p:graphicFrame>
-        <p:nvGraphicFramePr>
-          <p:cNvPr id="10" name="sources table"/>
-          <p:cNvGraphicFramePr>
-            <a:graphicFrameLocks noGrp="1"/>
-          </p:cNvGraphicFramePr>
-          <p:nvPr>
-            <p:extLst>
-              <p:ext uri="{D42A27DB-BD31-4B8C-83A1-F6EECF244321}">
-                <p14:modId xmlns:p14="http://schemas.microsoft.com/office/powerpoint/2010/main" val="1579011935"/>
-              </p:ext>
-            </p:extLst>
-          </p:nvPr>
-        </p:nvGraphicFramePr>
-        <p:xfrm>
-          <a:off x="548640" y="1417320"/>
-          <a:ext cx="7223760" cy="914400"/>
-        </p:xfrm>
-        <a:graphic>
-          <a:graphicData uri="http://schemas.openxmlformats.org/drawingml/2006/table">
-            <a:tbl>
-              <a:tblPr/>
-              <a:tblGrid>
-                <a:gridCol w="1737360"/>
-                <a:gridCol w="2560320"/>
-                <a:gridCol w="2926080"/>
-              </a:tblGrid>
-              <a:tr h="384048">
-                <a:tc>
-                  <a:txBody>
-                    <a:bodyPr/>
-                    <a:lstStyle/>
-                    <a:p>
-                      <a:pPr indent="0" marL="0">
-                        <a:buNone/>
-                      </a:pPr>
-                      <a:r>
-                        <a:rPr lang="en-US" sz="1200" b="1" dirty="0">
-                          <a:solidFill>
-                            <a:srgbClr val="FFFFFF"/>
-                          </a:solidFill>
-                          <a:latin typeface="Aptos" pitchFamily="34" charset="0"/>
-                          <a:ea typeface="Aptos" pitchFamily="34" charset="-122"/>
-                          <a:cs typeface="Aptos" pitchFamily="34" charset="-120"/>
-                        </a:rPr>
-                        <a:t>Element</a:t>
-                      </a:r>
-                      <a:endParaRPr lang="en-US" sz="1200" dirty="0">
-                        <a:latin typeface="Aptos" charset="0"/>
-                        <a:ea typeface="Aptos" charset="0"/>
-                        <a:cs typeface="Aptos" charset="0"/>
-                      </a:endParaRPr>
-                    </a:p>
-                  </a:txBody>
-                  <a:tcPr marL="64008" marR="64008" marT="64008" marB="64008" anchor="ctr">
-                    <a:lnL w="9525" cap="flat" cmpd="sng" algn="ctr">
-                      <a:solidFill>
-                        <a:srgbClr val="E1E0D9"/>
-                      </a:solidFill>
-                      <a:prstDash val="solid"/>
-                      <a:round/>
-                      <a:headEnd type="none" w="med" len="med"/>
-                      <a:tailEnd type="none" w="med" len="med"/>
-                    </a:lnL>
-                    <a:lnR w="9525" cap="flat" cmpd="sng" algn="ctr">
-                      <a:solidFill>
-                        <a:srgbClr val="E1E0D9"/>
-                      </a:solidFill>
-                      <a:prstDash val="solid"/>
-                      <a:round/>
-                      <a:headEnd type="none" w="med" len="med"/>
-                      <a:tailEnd type="none" w="med" len="med"/>
-                    </a:lnR>
-                    <a:lnT w="9525" cap="flat" cmpd="sng" algn="ctr">
-                      <a:solidFill>
-                        <a:srgbClr val="E1E0D9"/>
-                      </a:solidFill>
-                      <a:prstDash val="solid"/>
-                      <a:round/>
-                      <a:headEnd type="none" w="med" len="med"/>
-                      <a:tailEnd type="none" w="med" len="med"/>
-                    </a:lnT>
-                    <a:lnB w="9525" cap="flat" cmpd="sng" algn="ctr">
-                      <a:solidFill>
-                        <a:srgbClr val="E1E0D9"/>
-                      </a:solidFill>
-                      <a:prstDash val="solid"/>
-                      <a:round/>
-                      <a:headEnd type="none" w="med" len="med"/>
-                      <a:tailEnd type="none" w="med" len="med"/>
-                    </a:lnB>
-                    <a:solidFill>
-                      <a:srgbClr val="1F2933"/>
-                    </a:solidFill>
-                  </a:tcPr>
-                </a:tc>
-                <a:tc>
-                  <a:txBody>
-                    <a:bodyPr/>
-                    <a:lstStyle/>
-                    <a:p>
-                      <a:pPr indent="0" marL="0">
-                        <a:buNone/>
-                      </a:pPr>
-                      <a:r>
-                        <a:rPr lang="en-US" sz="1200" b="1" dirty="0">
-                          <a:solidFill>
-                            <a:srgbClr val="FFFFFF"/>
-                          </a:solidFill>
-                          <a:latin typeface="Aptos" pitchFamily="34" charset="0"/>
-                          <a:ea typeface="Aptos" pitchFamily="34" charset="-122"/>
-                          <a:cs typeface="Aptos" pitchFamily="34" charset="-120"/>
-                        </a:rPr>
-                        <a:t>Sizes</a:t>
-                      </a:r>
-                      <a:endParaRPr lang="en-US" sz="1200" dirty="0">
-                        <a:latin typeface="Aptos" charset="0"/>
-                        <a:ea typeface="Aptos" charset="0"/>
-                        <a:cs typeface="Aptos" charset="0"/>
-                      </a:endParaRPr>
-                    </a:p>
-                  </a:txBody>
-                  <a:tcPr marL="64008" marR="64008" marT="64008" marB="64008" anchor="ctr">
-                    <a:lnL w="9525" cap="flat" cmpd="sng" algn="ctr">
-                      <a:solidFill>
-                        <a:srgbClr val="E1E0D9"/>
-                      </a:solidFill>
-                      <a:prstDash val="solid"/>
-                      <a:round/>
-                      <a:headEnd type="none" w="med" len="med"/>
-                      <a:tailEnd type="none" w="med" len="med"/>
-                    </a:lnL>
-                    <a:lnR w="9525" cap="flat" cmpd="sng" algn="ctr">
-                      <a:solidFill>
-                        <a:srgbClr val="E1E0D9"/>
-                      </a:solidFill>
-                      <a:prstDash val="solid"/>
-                      <a:round/>
-                      <a:headEnd type="none" w="med" len="med"/>
-                      <a:tailEnd type="none" w="med" len="med"/>
-                    </a:lnR>
-                    <a:lnT w="9525" cap="flat" cmpd="sng" algn="ctr">
-                      <a:solidFill>
-                        <a:srgbClr val="E1E0D9"/>
-                      </a:solidFill>
-                      <a:prstDash val="solid"/>
-                      <a:round/>
-                      <a:headEnd type="none" w="med" len="med"/>
-                      <a:tailEnd type="none" w="med" len="med"/>
-                    </a:lnT>
-                    <a:lnB w="9525" cap="flat" cmpd="sng" algn="ctr">
-                      <a:solidFill>
-                        <a:srgbClr val="E1E0D9"/>
-                      </a:solidFill>
-                      <a:prstDash val="solid"/>
-                      <a:round/>
-                      <a:headEnd type="none" w="med" len="med"/>
-                      <a:tailEnd type="none" w="med" len="med"/>
-                    </a:lnB>
-                    <a:solidFill>
-                      <a:srgbClr val="1F2933"/>
-                    </a:solidFill>
-                  </a:tcPr>
-                </a:tc>
-                <a:tc>
-                  <a:txBody>
-                    <a:bodyPr/>
-                    <a:lstStyle/>
-                    <a:p>
-                      <a:pPr indent="0" marL="0">
-                        <a:buNone/>
-                      </a:pPr>
-                      <a:r>
-                        <a:rPr lang="en-US" sz="1200" b="1" dirty="0">
-                          <a:solidFill>
-                            <a:srgbClr val="FFFFFF"/>
-                          </a:solidFill>
-                          <a:latin typeface="Aptos" pitchFamily="34" charset="0"/>
-                          <a:ea typeface="Aptos" pitchFamily="34" charset="-122"/>
-                          <a:cs typeface="Aptos" pitchFamily="34" charset="-120"/>
-                        </a:rPr>
-                        <a:t>Load basis</a:t>
-                      </a:r>
-                      <a:endParaRPr lang="en-US" sz="1200" dirty="0">
-                        <a:latin typeface="Aptos" charset="0"/>
-                        <a:ea typeface="Aptos" charset="0"/>
-                        <a:cs typeface="Aptos" charset="0"/>
-                      </a:endParaRPr>
-                    </a:p>
-                  </a:txBody>
-                  <a:tcPr marL="64008" marR="64008" marT="64008" marB="64008" anchor="ctr">
-                    <a:lnL w="9525" cap="flat" cmpd="sng" algn="ctr">
-                      <a:solidFill>
-                        <a:srgbClr val="E1E0D9"/>
-                      </a:solidFill>
-                      <a:prstDash val="solid"/>
-                      <a:round/>
-                      <a:headEnd type="none" w="med" len="med"/>
-                      <a:tailEnd type="none" w="med" len="med"/>
-                    </a:lnL>
-                    <a:lnR w="9525" cap="flat" cmpd="sng" algn="ctr">
-                      <a:solidFill>
-                        <a:srgbClr val="E1E0D9"/>
-                      </a:solidFill>
-                      <a:prstDash val="solid"/>
-                      <a:round/>
-                      <a:headEnd type="none" w="med" len="med"/>
-                      <a:tailEnd type="none" w="med" len="med"/>
-                    </a:lnR>
-                    <a:lnT w="9525" cap="flat" cmpd="sng" algn="ctr">
-                      <a:solidFill>
-                        <a:srgbClr val="E1E0D9"/>
-                      </a:solidFill>
-                      <a:prstDash val="solid"/>
-                      <a:round/>
-                      <a:headEnd type="none" w="med" len="med"/>
-                      <a:tailEnd type="none" w="med" len="med"/>
-                    </a:lnT>
-                    <a:lnB w="9525" cap="flat" cmpd="sng" algn="ctr">
-                      <a:solidFill>
-                        <a:srgbClr val="E1E0D9"/>
-                      </a:solidFill>
-                      <a:prstDash val="solid"/>
-                      <a:round/>
-                      <a:headEnd type="none" w="med" len="med"/>
-                      <a:tailEnd type="none" w="med" len="med"/>
-                    </a:lnB>
-                    <a:solidFill>
-                      <a:srgbClr val="1F2933"/>
-                    </a:solidFill>
-                  </a:tcPr>
-                </a:tc>
-              </a:tr>
-              <a:tr h="713232">
-                <a:tc>
-                  <a:txBody>
-                    <a:bodyPr/>
-                    <a:lstStyle/>
-                    <a:p>
-                      <a:pPr indent="0" marL="0">
-                        <a:buNone/>
-                      </a:pPr>
-                      <a:r>
-                        <a:rPr lang="en-US" sz="1200" b="1" dirty="0">
-                          <a:solidFill>
-                            <a:srgbClr val="0B0B0B"/>
-                          </a:solidFill>
-                          <a:latin typeface="Aptos" pitchFamily="34" charset="0"/>
-                          <a:ea typeface="Aptos" pitchFamily="34" charset="-122"/>
-                          <a:cs typeface="Aptos" pitchFamily="34" charset="-120"/>
-                        </a:rPr>
-                        <a:t>Pipes DN15–100</a:t>
-                      </a:r>
-                      <a:endParaRPr lang="en-US" sz="1200" dirty="0">
-                        <a:latin typeface="Aptos" charset="0"/>
-                        <a:ea typeface="Aptos" charset="0"/>
-                        <a:cs typeface="Aptos" charset="0"/>
-                      </a:endParaRPr>
-                    </a:p>
-                  </a:txBody>
-                  <a:tcPr marL="64008" marR="64008" marT="64008" marB="64008" anchor="ctr">
-                    <a:lnL w="9525" cap="flat" cmpd="sng" algn="ctr">
-                      <a:solidFill>
-                        <a:srgbClr val="E1E0D9"/>
-                      </a:solidFill>
-                      <a:prstDash val="solid"/>
-                      <a:round/>
-                      <a:headEnd type="none" w="med" len="med"/>
-                      <a:tailEnd type="none" w="med" len="med"/>
-                    </a:lnL>
-                    <a:lnR w="9525" cap="flat" cmpd="sng" algn="ctr">
-                      <a:solidFill>
-                        <a:srgbClr val="E1E0D9"/>
-                      </a:solidFill>
-                      <a:prstDash val="solid"/>
-                      <a:round/>
-                      <a:headEnd type="none" w="med" len="med"/>
-                      <a:tailEnd type="none" w="med" len="med"/>
-                    </a:lnR>
-                    <a:lnT w="9525" cap="flat" cmpd="sng" algn="ctr">
-                      <a:solidFill>
-                        <a:srgbClr val="E1E0D9"/>
-                      </a:solidFill>
-                      <a:prstDash val="solid"/>
-                      <a:round/>
-                      <a:headEnd type="none" w="med" len="med"/>
-                      <a:tailEnd type="none" w="med" len="med"/>
-                    </a:lnT>
-                    <a:lnB w="9525" cap="flat" cmpd="sng" algn="ctr">
-                      <a:solidFill>
-                        <a:srgbClr val="E1E0D9"/>
-                      </a:solidFill>
-                      <a:prstDash val="solid"/>
-                      <a:round/>
-                      <a:headEnd type="none" w="med" len="med"/>
-                      <a:tailEnd type="none" w="med" len="med"/>
-                    </a:lnB>
-                  </a:tcPr>
-                </a:tc>
-                <a:tc>
-                  <a:txBody>
-                    <a:bodyPr/>
-                    <a:lstStyle/>
-                    <a:p>
-                      <a:pPr indent="0" marL="0">
-                        <a:buNone/>
-                      </a:pPr>
-                      <a:r>
-                        <a:rPr lang="en-US" sz="1200" dirty="0">
-                          <a:solidFill>
-                            <a:srgbClr val="0B0B0B"/>
-                          </a:solidFill>
-                          <a:latin typeface="Aptos" pitchFamily="34" charset="0"/>
-                          <a:ea typeface="Aptos" pitchFamily="34" charset="-122"/>
-                          <a:cs typeface="Aptos" pitchFamily="34" charset="-120"/>
-                        </a:rPr>
-                        <a:t>EN 10220 / EN 10255 medium series [4]</a:t>
-                      </a:r>
-                      <a:endParaRPr lang="en-US" sz="1200" dirty="0">
-                        <a:latin typeface="Aptos" charset="0"/>
-                        <a:ea typeface="Aptos" charset="0"/>
-                        <a:cs typeface="Aptos" charset="0"/>
-                      </a:endParaRPr>
-                    </a:p>
-                  </a:txBody>
-                  <a:tcPr marL="64008" marR="64008" marT="64008" marB="64008" anchor="ctr">
-                    <a:lnL w="9525" cap="flat" cmpd="sng" algn="ctr">
-                      <a:solidFill>
-                        <a:srgbClr val="E1E0D9"/>
-                      </a:solidFill>
-                      <a:prstDash val="solid"/>
-                      <a:round/>
-                      <a:headEnd type="none" w="med" len="med"/>
-                      <a:tailEnd type="none" w="med" len="med"/>
-                    </a:lnL>
-                    <a:lnR w="9525" cap="flat" cmpd="sng" algn="ctr">
-                      <a:solidFill>
-                        <a:srgbClr val="E1E0D9"/>
-                      </a:solidFill>
-                      <a:prstDash val="solid"/>
-                      <a:round/>
-                      <a:headEnd type="none" w="med" len="med"/>
-                      <a:tailEnd type="none" w="med" len="med"/>
-                    </a:lnR>
-                    <a:lnT w="9525" cap="flat" cmpd="sng" algn="ctr">
-                      <a:solidFill>
-                        <a:srgbClr val="E1E0D9"/>
-                      </a:solidFill>
-                      <a:prstDash val="solid"/>
-                      <a:round/>
-                      <a:headEnd type="none" w="med" len="med"/>
-                      <a:tailEnd type="none" w="med" len="med"/>
-                    </a:lnT>
-                    <a:lnB w="9525" cap="flat" cmpd="sng" algn="ctr">
-                      <a:solidFill>
-                        <a:srgbClr val="E1E0D9"/>
-                      </a:solidFill>
-                      <a:prstDash val="solid"/>
-                      <a:round/>
-                      <a:headEnd type="none" w="med" len="med"/>
-                      <a:tailEnd type="none" w="med" len="med"/>
-                    </a:lnB>
-                  </a:tcPr>
-                </a:tc>
-                <a:tc>
-                  <a:txBody>
-                    <a:bodyPr/>
-                    <a:lstStyle/>
-                    <a:p>
-                      <a:pPr indent="0" marL="0">
-                        <a:buNone/>
-                      </a:pPr>
-                      <a:r>
-                        <a:rPr lang="en-US" sz="1200" dirty="0">
-                          <a:solidFill>
-                            <a:srgbClr val="0B0B0B"/>
-                          </a:solidFill>
-                          <a:latin typeface="Aptos" pitchFamily="34" charset="0"/>
-                          <a:ea typeface="Aptos" pitchFamily="34" charset="-122"/>
-                          <a:cs typeface="Aptos" pitchFamily="34" charset="-120"/>
-                        </a:rPr>
-                        <a:t>steel + water × ASME B31.1 water-service span (published points only) [8]</a:t>
-                      </a:r>
-                      <a:endParaRPr lang="en-US" sz="1200" dirty="0">
-                        <a:latin typeface="Aptos" charset="0"/>
-                        <a:ea typeface="Aptos" charset="0"/>
-                        <a:cs typeface="Aptos" charset="0"/>
-                      </a:endParaRPr>
-                    </a:p>
-                  </a:txBody>
-                  <a:tcPr marL="64008" marR="64008" marT="64008" marB="64008" anchor="ctr">
-                    <a:lnL w="9525" cap="flat" cmpd="sng" algn="ctr">
-                      <a:solidFill>
-                        <a:srgbClr val="E1E0D9"/>
-                      </a:solidFill>
-                      <a:prstDash val="solid"/>
-                      <a:round/>
-                      <a:headEnd type="none" w="med" len="med"/>
-                      <a:tailEnd type="none" w="med" len="med"/>
-                    </a:lnL>
-                    <a:lnR w="9525" cap="flat" cmpd="sng" algn="ctr">
-                      <a:solidFill>
-                        <a:srgbClr val="E1E0D9"/>
-                      </a:solidFill>
-                      <a:prstDash val="solid"/>
-                      <a:round/>
-                      <a:headEnd type="none" w="med" len="med"/>
-                      <a:tailEnd type="none" w="med" len="med"/>
-                    </a:lnR>
-                    <a:lnT w="9525" cap="flat" cmpd="sng" algn="ctr">
-                      <a:solidFill>
-                        <a:srgbClr val="E1E0D9"/>
-                      </a:solidFill>
-                      <a:prstDash val="solid"/>
-                      <a:round/>
-                      <a:headEnd type="none" w="med" len="med"/>
-                      <a:tailEnd type="none" w="med" len="med"/>
-                    </a:lnT>
-                    <a:lnB w="9525" cap="flat" cmpd="sng" algn="ctr">
-                      <a:solidFill>
-                        <a:srgbClr val="E1E0D9"/>
-                      </a:solidFill>
-                      <a:prstDash val="solid"/>
-                      <a:round/>
-                      <a:headEnd type="none" w="med" len="med"/>
-                      <a:tailEnd type="none" w="med" len="med"/>
-                    </a:lnB>
-                  </a:tcPr>
-                </a:tc>
-              </a:tr>
-              <a:tr h="713232">
-                <a:tc>
-                  <a:txBody>
-                    <a:bodyPr/>
-                    <a:lstStyle/>
-                    <a:p>
-                      <a:pPr indent="0" marL="0">
-                        <a:buNone/>
-                      </a:pPr>
-                      <a:r>
-                        <a:rPr lang="en-US" sz="1200" b="1" dirty="0">
-                          <a:solidFill>
-                            <a:srgbClr val="0B0B0B"/>
-                          </a:solidFill>
-                          <a:latin typeface="Aptos" pitchFamily="34" charset="0"/>
-                          <a:ea typeface="Aptos" pitchFamily="34" charset="-122"/>
-                          <a:cs typeface="Aptos" pitchFamily="34" charset="-120"/>
-                        </a:rPr>
-                        <a:t>Insulation</a:t>
-                      </a:r>
-                      <a:endParaRPr lang="en-US" sz="1200" dirty="0">
-                        <a:latin typeface="Aptos" charset="0"/>
-                        <a:ea typeface="Aptos" charset="0"/>
-                        <a:cs typeface="Aptos" charset="0"/>
-                      </a:endParaRPr>
-                    </a:p>
-                  </a:txBody>
-                  <a:tcPr marL="64008" marR="64008" marT="64008" marB="64008" anchor="ctr">
-                    <a:lnL w="9525" cap="flat" cmpd="sng" algn="ctr">
-                      <a:solidFill>
-                        <a:srgbClr val="E1E0D9"/>
-                      </a:solidFill>
-                      <a:prstDash val="solid"/>
-                      <a:round/>
-                      <a:headEnd type="none" w="med" len="med"/>
-                      <a:tailEnd type="none" w="med" len="med"/>
-                    </a:lnL>
-                    <a:lnR w="9525" cap="flat" cmpd="sng" algn="ctr">
-                      <a:solidFill>
-                        <a:srgbClr val="E1E0D9"/>
-                      </a:solidFill>
-                      <a:prstDash val="solid"/>
-                      <a:round/>
-                      <a:headEnd type="none" w="med" len="med"/>
-                      <a:tailEnd type="none" w="med" len="med"/>
-                    </a:lnR>
-                    <a:lnT w="9525" cap="flat" cmpd="sng" algn="ctr">
-                      <a:solidFill>
-                        <a:srgbClr val="E1E0D9"/>
-                      </a:solidFill>
-                      <a:prstDash val="solid"/>
-                      <a:round/>
-                      <a:headEnd type="none" w="med" len="med"/>
-                      <a:tailEnd type="none" w="med" len="med"/>
-                    </a:lnT>
-                    <a:lnB w="9525" cap="flat" cmpd="sng" algn="ctr">
-                      <a:solidFill>
-                        <a:srgbClr val="E1E0D9"/>
-                      </a:solidFill>
-                      <a:prstDash val="solid"/>
-                      <a:round/>
-                      <a:headEnd type="none" w="med" len="med"/>
-                      <a:tailEnd type="none" w="med" len="med"/>
-                    </a:lnB>
-                  </a:tcPr>
-                </a:tc>
-                <a:tc>
-                  <a:txBody>
-                    <a:bodyPr/>
-                    <a:lstStyle/>
-                    <a:p>
-                      <a:pPr indent="0" marL="0">
-                        <a:buNone/>
-                      </a:pPr>
-                      <a:r>
-                        <a:rPr lang="en-US" sz="1200" dirty="0">
-                          <a:solidFill>
-                            <a:srgbClr val="0B0B0B"/>
-                          </a:solidFill>
-                          <a:latin typeface="Aptos" pitchFamily="34" charset="0"/>
-                          <a:ea typeface="Aptos" pitchFamily="34" charset="-122"/>
-                          <a:cs typeface="Aptos" pitchFamily="34" charset="-120"/>
-                        </a:rPr>
-                        <a:t>GEG Anlage 8 (heated) [11]; 30/50 mm condensation control (chilled)</a:t>
-                      </a:r>
-                      <a:endParaRPr lang="en-US" sz="1200" dirty="0">
-                        <a:latin typeface="Aptos" charset="0"/>
-                        <a:ea typeface="Aptos" charset="0"/>
-                        <a:cs typeface="Aptos" charset="0"/>
-                      </a:endParaRPr>
-                    </a:p>
-                  </a:txBody>
-                  <a:tcPr marL="64008" marR="64008" marT="64008" marB="64008" anchor="ctr">
-                    <a:lnL w="9525" cap="flat" cmpd="sng" algn="ctr">
-                      <a:solidFill>
-                        <a:srgbClr val="E1E0D9"/>
-                      </a:solidFill>
-                      <a:prstDash val="solid"/>
-                      <a:round/>
-                      <a:headEnd type="none" w="med" len="med"/>
-                      <a:tailEnd type="none" w="med" len="med"/>
-                    </a:lnL>
-                    <a:lnR w="9525" cap="flat" cmpd="sng" algn="ctr">
-                      <a:solidFill>
-                        <a:srgbClr val="E1E0D9"/>
-                      </a:solidFill>
-                      <a:prstDash val="solid"/>
-                      <a:round/>
-                      <a:headEnd type="none" w="med" len="med"/>
-                      <a:tailEnd type="none" w="med" len="med"/>
-                    </a:lnR>
-                    <a:lnT w="9525" cap="flat" cmpd="sng" algn="ctr">
-                      <a:solidFill>
-                        <a:srgbClr val="E1E0D9"/>
-                      </a:solidFill>
-                      <a:prstDash val="solid"/>
-                      <a:round/>
-                      <a:headEnd type="none" w="med" len="med"/>
-                      <a:tailEnd type="none" w="med" len="med"/>
-                    </a:lnT>
-                    <a:lnB w="9525" cap="flat" cmpd="sng" algn="ctr">
-                      <a:solidFill>
-                        <a:srgbClr val="E1E0D9"/>
-                      </a:solidFill>
-                      <a:prstDash val="solid"/>
-                      <a:round/>
-                      <a:headEnd type="none" w="med" len="med"/>
-                      <a:tailEnd type="none" w="med" len="med"/>
-                    </a:lnB>
-                  </a:tcPr>
-                </a:tc>
-                <a:tc>
-                  <a:txBody>
-                    <a:bodyPr/>
-                    <a:lstStyle/>
-                    <a:p>
-                      <a:pPr indent="0" marL="0">
-                        <a:buNone/>
-                      </a:pPr>
-                      <a:r>
-                        <a:rPr lang="en-US" sz="1200" dirty="0">
-                          <a:solidFill>
-                            <a:srgbClr val="0B0B0B"/>
-                          </a:solidFill>
-                          <a:latin typeface="Aptos" pitchFamily="34" charset="0"/>
-                          <a:ea typeface="Aptos" pitchFamily="34" charset="-122"/>
-                          <a:cs typeface="Aptos" pitchFamily="34" charset="-120"/>
-                        </a:rPr>
-                        <a:t>—</a:t>
-                      </a:r>
-                      <a:endParaRPr lang="en-US" sz="1200" dirty="0">
-                        <a:latin typeface="Aptos" charset="0"/>
-                        <a:ea typeface="Aptos" charset="0"/>
-                        <a:cs typeface="Aptos" charset="0"/>
-                      </a:endParaRPr>
-                    </a:p>
-                  </a:txBody>
-                  <a:tcPr marL="64008" marR="64008" marT="64008" marB="64008" anchor="ctr">
-                    <a:lnL w="9525" cap="flat" cmpd="sng" algn="ctr">
-                      <a:solidFill>
-                        <a:srgbClr val="E1E0D9"/>
-                      </a:solidFill>
-                      <a:prstDash val="solid"/>
-                      <a:round/>
-                      <a:headEnd type="none" w="med" len="med"/>
-                      <a:tailEnd type="none" w="med" len="med"/>
-                    </a:lnL>
-                    <a:lnR w="9525" cap="flat" cmpd="sng" algn="ctr">
-                      <a:solidFill>
-                        <a:srgbClr val="E1E0D9"/>
-                      </a:solidFill>
-                      <a:prstDash val="solid"/>
-                      <a:round/>
-                      <a:headEnd type="none" w="med" len="med"/>
-                      <a:tailEnd type="none" w="med" len="med"/>
-                    </a:lnR>
-                    <a:lnT w="9525" cap="flat" cmpd="sng" algn="ctr">
-                      <a:solidFill>
-                        <a:srgbClr val="E1E0D9"/>
-                      </a:solidFill>
-                      <a:prstDash val="solid"/>
-                      <a:round/>
-                      <a:headEnd type="none" w="med" len="med"/>
-                      <a:tailEnd type="none" w="med" len="med"/>
-                    </a:lnT>
-                    <a:lnB w="9525" cap="flat" cmpd="sng" algn="ctr">
-                      <a:solidFill>
-                        <a:srgbClr val="E1E0D9"/>
-                      </a:solidFill>
-                      <a:prstDash val="solid"/>
-                      <a:round/>
-                      <a:headEnd type="none" w="med" len="med"/>
-                      <a:tailEnd type="none" w="med" len="med"/>
-                    </a:lnB>
-                  </a:tcPr>
-                </a:tc>
-              </a:tr>
-              <a:tr h="548640">
-                <a:tc>
-                  <a:txBody>
-                    <a:bodyPr/>
-                    <a:lstStyle/>
-                    <a:p>
-                      <a:pPr indent="0" marL="0">
-                        <a:buNone/>
-                      </a:pPr>
-                      <a:r>
-                        <a:rPr lang="en-US" sz="1200" b="1" dirty="0">
-                          <a:solidFill>
-                            <a:srgbClr val="0B0B0B"/>
-                          </a:solidFill>
-                          <a:latin typeface="Aptos" pitchFamily="34" charset="0"/>
-                          <a:ea typeface="Aptos" pitchFamily="34" charset="-122"/>
-                          <a:cs typeface="Aptos" pitchFamily="34" charset="-120"/>
-                        </a:rPr>
-                        <a:t>Cable trays 150–600</a:t>
-                      </a:r>
-                      <a:endParaRPr lang="en-US" sz="1200" dirty="0">
-                        <a:latin typeface="Aptos" charset="0"/>
-                        <a:ea typeface="Aptos" charset="0"/>
-                        <a:cs typeface="Aptos" charset="0"/>
-                      </a:endParaRPr>
-                    </a:p>
-                  </a:txBody>
-                  <a:tcPr marL="64008" marR="64008" marT="64008" marB="64008" anchor="ctr">
-                    <a:lnL w="9525" cap="flat" cmpd="sng" algn="ctr">
-                      <a:solidFill>
-                        <a:srgbClr val="E1E0D9"/>
-                      </a:solidFill>
-                      <a:prstDash val="solid"/>
-                      <a:round/>
-                      <a:headEnd type="none" w="med" len="med"/>
-                      <a:tailEnd type="none" w="med" len="med"/>
-                    </a:lnL>
-                    <a:lnR w="9525" cap="flat" cmpd="sng" algn="ctr">
-                      <a:solidFill>
-                        <a:srgbClr val="E1E0D9"/>
-                      </a:solidFill>
-                      <a:prstDash val="solid"/>
-                      <a:round/>
-                      <a:headEnd type="none" w="med" len="med"/>
-                      <a:tailEnd type="none" w="med" len="med"/>
-                    </a:lnR>
-                    <a:lnT w="9525" cap="flat" cmpd="sng" algn="ctr">
-                      <a:solidFill>
-                        <a:srgbClr val="E1E0D9"/>
-                      </a:solidFill>
-                      <a:prstDash val="solid"/>
-                      <a:round/>
-                      <a:headEnd type="none" w="med" len="med"/>
-                      <a:tailEnd type="none" w="med" len="med"/>
-                    </a:lnT>
-                    <a:lnB w="9525" cap="flat" cmpd="sng" algn="ctr">
-                      <a:solidFill>
-                        <a:srgbClr val="E1E0D9"/>
-                      </a:solidFill>
-                      <a:prstDash val="solid"/>
-                      <a:round/>
-                      <a:headEnd type="none" w="med" len="med"/>
-                      <a:tailEnd type="none" w="med" len="med"/>
-                    </a:lnB>
-                  </a:tcPr>
-                </a:tc>
-                <a:tc>
-                  <a:txBody>
-                    <a:bodyPr/>
-                    <a:lstStyle/>
-                    <a:p>
-                      <a:pPr indent="0" marL="0">
-                        <a:buNone/>
-                      </a:pPr>
-                      <a:r>
-                        <a:rPr lang="en-US" sz="1200" dirty="0">
-                          <a:solidFill>
-                            <a:srgbClr val="0B0B0B"/>
-                          </a:solidFill>
-                          <a:latin typeface="Aptos" pitchFamily="34" charset="0"/>
-                          <a:ea typeface="Aptos" pitchFamily="34" charset="-122"/>
-                          <a:cs typeface="Aptos" pitchFamily="34" charset="-120"/>
-                        </a:rPr>
-                        <a:t>IEC 61537 systems [6], NEMA VE 1 widths [7]</a:t>
-                      </a:r>
-                      <a:endParaRPr lang="en-US" sz="1200" dirty="0">
-                        <a:latin typeface="Aptos" charset="0"/>
-                        <a:ea typeface="Aptos" charset="0"/>
-                        <a:cs typeface="Aptos" charset="0"/>
-                      </a:endParaRPr>
-                    </a:p>
-                  </a:txBody>
-                  <a:tcPr marL="64008" marR="64008" marT="64008" marB="64008" anchor="ctr">
-                    <a:lnL w="9525" cap="flat" cmpd="sng" algn="ctr">
-                      <a:solidFill>
-                        <a:srgbClr val="E1E0D9"/>
-                      </a:solidFill>
-                      <a:prstDash val="solid"/>
-                      <a:round/>
-                      <a:headEnd type="none" w="med" len="med"/>
-                      <a:tailEnd type="none" w="med" len="med"/>
-                    </a:lnL>
-                    <a:lnR w="9525" cap="flat" cmpd="sng" algn="ctr">
-                      <a:solidFill>
-                        <a:srgbClr val="E1E0D9"/>
-                      </a:solidFill>
-                      <a:prstDash val="solid"/>
-                      <a:round/>
-                      <a:headEnd type="none" w="med" len="med"/>
-                      <a:tailEnd type="none" w="med" len="med"/>
-                    </a:lnR>
-                    <a:lnT w="9525" cap="flat" cmpd="sng" algn="ctr">
-                      <a:solidFill>
-                        <a:srgbClr val="E1E0D9"/>
-                      </a:solidFill>
-                      <a:prstDash val="solid"/>
-                      <a:round/>
-                      <a:headEnd type="none" w="med" len="med"/>
-                      <a:tailEnd type="none" w="med" len="med"/>
-                    </a:lnT>
-                    <a:lnB w="9525" cap="flat" cmpd="sng" algn="ctr">
-                      <a:solidFill>
-                        <a:srgbClr val="E1E0D9"/>
-                      </a:solidFill>
-                      <a:prstDash val="solid"/>
-                      <a:round/>
-                      <a:headEnd type="none" w="med" len="med"/>
-                      <a:tailEnd type="none" w="med" len="med"/>
-                    </a:lnB>
-                  </a:tcPr>
-                </a:tc>
-                <a:tc>
-                  <a:txBody>
-                    <a:bodyPr/>
-                    <a:lstStyle/>
-                    <a:p>
-                      <a:pPr indent="0" marL="0">
-                        <a:buNone/>
-                      </a:pPr>
-                      <a:r>
-                        <a:rPr lang="en-US" sz="1200" dirty="0">
-                          <a:solidFill>
-                            <a:srgbClr val="0B0B0B"/>
-                          </a:solidFill>
-                          <a:latin typeface="Aptos" pitchFamily="34" charset="0"/>
-                          <a:ea typeface="Aptos" pitchFamily="34" charset="-122"/>
-                          <a:cs typeface="Aptos" pitchFamily="34" charset="-120"/>
-                        </a:rPr>
-                        <a:t>full tray: 50 kg/m at 300 mm datum, × 2.0 m (NEMA VE 1 class span) [7]</a:t>
-                      </a:r>
-                      <a:endParaRPr lang="en-US" sz="1200" dirty="0">
-                        <a:latin typeface="Aptos" charset="0"/>
-                        <a:ea typeface="Aptos" charset="0"/>
-                        <a:cs typeface="Aptos" charset="0"/>
-                      </a:endParaRPr>
-                    </a:p>
-                  </a:txBody>
-                  <a:tcPr marL="64008" marR="64008" marT="64008" marB="64008" anchor="ctr">
-                    <a:lnL w="9525" cap="flat" cmpd="sng" algn="ctr">
-                      <a:solidFill>
-                        <a:srgbClr val="E1E0D9"/>
-                      </a:solidFill>
-                      <a:prstDash val="solid"/>
-                      <a:round/>
-                      <a:headEnd type="none" w="med" len="med"/>
-                      <a:tailEnd type="none" w="med" len="med"/>
-                    </a:lnL>
-                    <a:lnR w="9525" cap="flat" cmpd="sng" algn="ctr">
-                      <a:solidFill>
-                        <a:srgbClr val="E1E0D9"/>
-                      </a:solidFill>
-                      <a:prstDash val="solid"/>
-                      <a:round/>
-                      <a:headEnd type="none" w="med" len="med"/>
-                      <a:tailEnd type="none" w="med" len="med"/>
-                    </a:lnR>
-                    <a:lnT w="9525" cap="flat" cmpd="sng" algn="ctr">
-                      <a:solidFill>
-                        <a:srgbClr val="E1E0D9"/>
-                      </a:solidFill>
-                      <a:prstDash val="solid"/>
-                      <a:round/>
-                      <a:headEnd type="none" w="med" len="med"/>
-                      <a:tailEnd type="none" w="med" len="med"/>
-                    </a:lnT>
-                    <a:lnB w="9525" cap="flat" cmpd="sng" algn="ctr">
-                      <a:solidFill>
-                        <a:srgbClr val="E1E0D9"/>
-                      </a:solidFill>
-                      <a:prstDash val="solid"/>
-                      <a:round/>
-                      <a:headEnd type="none" w="med" len="med"/>
-                      <a:tailEnd type="none" w="med" len="med"/>
-                    </a:lnB>
-                  </a:tcPr>
-                </a:tc>
-              </a:tr>
-              <a:tr h="548640">
-                <a:tc>
-                  <a:txBody>
-                    <a:bodyPr/>
-                    <a:lstStyle/>
-                    <a:p>
-                      <a:pPr indent="0" marL="0">
-                        <a:buNone/>
-                      </a:pPr>
-                      <a:r>
-                        <a:rPr lang="en-US" sz="1200" b="1" dirty="0">
-                          <a:solidFill>
-                            <a:srgbClr val="0B0B0B"/>
-                          </a:solidFill>
-                          <a:latin typeface="Aptos" pitchFamily="34" charset="0"/>
-                          <a:ea typeface="Aptos" pitchFamily="34" charset="-122"/>
-                          <a:cs typeface="Aptos" pitchFamily="34" charset="-120"/>
-                        </a:rPr>
-                        <a:t>Ducts</a:t>
-                      </a:r>
-                      <a:endParaRPr lang="en-US" sz="1200" dirty="0">
-                        <a:latin typeface="Aptos" charset="0"/>
-                        <a:ea typeface="Aptos" charset="0"/>
-                        <a:cs typeface="Aptos" charset="0"/>
-                      </a:endParaRPr>
-                    </a:p>
-                  </a:txBody>
-                  <a:tcPr marL="64008" marR="64008" marT="64008" marB="64008" anchor="ctr">
-                    <a:lnL w="9525" cap="flat" cmpd="sng" algn="ctr">
-                      <a:solidFill>
-                        <a:srgbClr val="E1E0D9"/>
-                      </a:solidFill>
-                      <a:prstDash val="solid"/>
-                      <a:round/>
-                      <a:headEnd type="none" w="med" len="med"/>
-                      <a:tailEnd type="none" w="med" len="med"/>
-                    </a:lnL>
-                    <a:lnR w="9525" cap="flat" cmpd="sng" algn="ctr">
-                      <a:solidFill>
-                        <a:srgbClr val="E1E0D9"/>
-                      </a:solidFill>
-                      <a:prstDash val="solid"/>
-                      <a:round/>
-                      <a:headEnd type="none" w="med" len="med"/>
-                      <a:tailEnd type="none" w="med" len="med"/>
-                    </a:lnR>
-                    <a:lnT w="9525" cap="flat" cmpd="sng" algn="ctr">
-                      <a:solidFill>
-                        <a:srgbClr val="E1E0D9"/>
-                      </a:solidFill>
-                      <a:prstDash val="solid"/>
-                      <a:round/>
-                      <a:headEnd type="none" w="med" len="med"/>
-                      <a:tailEnd type="none" w="med" len="med"/>
-                    </a:lnT>
-                    <a:lnB w="9525" cap="flat" cmpd="sng" algn="ctr">
-                      <a:solidFill>
-                        <a:srgbClr val="E1E0D9"/>
-                      </a:solidFill>
-                      <a:prstDash val="solid"/>
-                      <a:round/>
-                      <a:headEnd type="none" w="med" len="med"/>
-                      <a:tailEnd type="none" w="med" len="med"/>
-                    </a:lnB>
-                  </a:tcPr>
-                </a:tc>
-                <a:tc>
-                  <a:txBody>
-                    <a:bodyPr/>
-                    <a:lstStyle/>
-                    <a:p>
-                      <a:pPr indent="0" marL="0">
-                        <a:buNone/>
-                      </a:pPr>
-                      <a:r>
-                        <a:rPr lang="en-US" sz="1200" dirty="0">
-                          <a:solidFill>
-                            <a:srgbClr val="0B0B0B"/>
-                          </a:solidFill>
-                          <a:latin typeface="Aptos" pitchFamily="34" charset="0"/>
-                          <a:ea typeface="Aptos" pitchFamily="34" charset="-122"/>
-                          <a:cs typeface="Aptos" pitchFamily="34" charset="-120"/>
-                        </a:rPr>
-                        <a:t>EN 1505 rectangular; EN 1506 round [5]</a:t>
-                      </a:r>
-                      <a:endParaRPr lang="en-US" sz="1200" dirty="0">
-                        <a:latin typeface="Aptos" charset="0"/>
-                        <a:ea typeface="Aptos" charset="0"/>
-                        <a:cs typeface="Aptos" charset="0"/>
-                      </a:endParaRPr>
-                    </a:p>
-                  </a:txBody>
-                  <a:tcPr marL="64008" marR="64008" marT="64008" marB="64008" anchor="ctr">
-                    <a:lnL w="9525" cap="flat" cmpd="sng" algn="ctr">
-                      <a:solidFill>
-                        <a:srgbClr val="E1E0D9"/>
-                      </a:solidFill>
-                      <a:prstDash val="solid"/>
-                      <a:round/>
-                      <a:headEnd type="none" w="med" len="med"/>
-                      <a:tailEnd type="none" w="med" len="med"/>
-                    </a:lnL>
-                    <a:lnR w="9525" cap="flat" cmpd="sng" algn="ctr">
-                      <a:solidFill>
-                        <a:srgbClr val="E1E0D9"/>
-                      </a:solidFill>
-                      <a:prstDash val="solid"/>
-                      <a:round/>
-                      <a:headEnd type="none" w="med" len="med"/>
-                      <a:tailEnd type="none" w="med" len="med"/>
-                    </a:lnR>
-                    <a:lnT w="9525" cap="flat" cmpd="sng" algn="ctr">
-                      <a:solidFill>
-                        <a:srgbClr val="E1E0D9"/>
-                      </a:solidFill>
-                      <a:prstDash val="solid"/>
-                      <a:round/>
-                      <a:headEnd type="none" w="med" len="med"/>
-                      <a:tailEnd type="none" w="med" len="med"/>
-                    </a:lnT>
-                    <a:lnB w="9525" cap="flat" cmpd="sng" algn="ctr">
-                      <a:solidFill>
-                        <a:srgbClr val="E1E0D9"/>
-                      </a:solidFill>
-                      <a:prstDash val="solid"/>
-                      <a:round/>
-                      <a:headEnd type="none" w="med" len="med"/>
-                      <a:tailEnd type="none" w="med" len="med"/>
-                    </a:lnB>
-                  </a:tcPr>
-                </a:tc>
-                <a:tc>
-                  <a:txBody>
-                    <a:bodyPr/>
-                    <a:lstStyle/>
-                    <a:p>
-                      <a:pPr indent="0" marL="0">
-                        <a:buNone/>
-                      </a:pPr>
-                      <a:r>
-                        <a:rPr lang="en-US" sz="1200" dirty="0">
-                          <a:solidFill>
-                            <a:srgbClr val="0B0B0B"/>
-                          </a:solidFill>
-                          <a:latin typeface="Aptos" pitchFamily="34" charset="0"/>
-                          <a:ea typeface="Aptos" pitchFamily="34" charset="-122"/>
-                          <a:cs typeface="Aptos" pitchFamily="34" charset="-120"/>
-                        </a:rPr>
-                        <a:t>manufacturer duct-weight table incl. flanges, × 2.4 m (SMACNA) [9]</a:t>
-                      </a:r>
-                      <a:endParaRPr lang="en-US" sz="1200" dirty="0">
-                        <a:latin typeface="Aptos" charset="0"/>
-                        <a:ea typeface="Aptos" charset="0"/>
-                        <a:cs typeface="Aptos" charset="0"/>
-                      </a:endParaRPr>
-                    </a:p>
-                  </a:txBody>
-                  <a:tcPr marL="64008" marR="64008" marT="64008" marB="64008" anchor="ctr">
-                    <a:lnL w="9525" cap="flat" cmpd="sng" algn="ctr">
-                      <a:solidFill>
-                        <a:srgbClr val="E1E0D9"/>
-                      </a:solidFill>
-                      <a:prstDash val="solid"/>
-                      <a:round/>
-                      <a:headEnd type="none" w="med" len="med"/>
-                      <a:tailEnd type="none" w="med" len="med"/>
-                    </a:lnL>
-                    <a:lnR w="9525" cap="flat" cmpd="sng" algn="ctr">
-                      <a:solidFill>
-                        <a:srgbClr val="E1E0D9"/>
-                      </a:solidFill>
-                      <a:prstDash val="solid"/>
-                      <a:round/>
-                      <a:headEnd type="none" w="med" len="med"/>
-                      <a:tailEnd type="none" w="med" len="med"/>
-                    </a:lnR>
-                    <a:lnT w="9525" cap="flat" cmpd="sng" algn="ctr">
-                      <a:solidFill>
-                        <a:srgbClr val="E1E0D9"/>
-                      </a:solidFill>
-                      <a:prstDash val="solid"/>
-                      <a:round/>
-                      <a:headEnd type="none" w="med" len="med"/>
-                      <a:tailEnd type="none" w="med" len="med"/>
-                    </a:lnT>
-                    <a:lnB w="9525" cap="flat" cmpd="sng" algn="ctr">
-                      <a:solidFill>
-                        <a:srgbClr val="E1E0D9"/>
-                      </a:solidFill>
-                      <a:prstDash val="solid"/>
-                      <a:round/>
-                      <a:headEnd type="none" w="med" len="med"/>
-                      <a:tailEnd type="none" w="med" len="med"/>
-                    </a:lnB>
-                  </a:tcPr>
-                </a:tc>
-              </a:tr>
-              <a:tr h="548640">
-                <a:tc>
-                  <a:txBody>
-                    <a:bodyPr/>
-                    <a:lstStyle/>
-                    <a:p>
-                      <a:pPr indent="0" marL="0">
-                        <a:buNone/>
-                      </a:pPr>
-                      <a:r>
-                        <a:rPr lang="en-US" sz="1200" b="1" dirty="0">
-                          <a:solidFill>
-                            <a:srgbClr val="0B0B0B"/>
-                          </a:solidFill>
-                          <a:latin typeface="Aptos" pitchFamily="34" charset="0"/>
-                          <a:ea typeface="Aptos" pitchFamily="34" charset="-122"/>
-                          <a:cs typeface="Aptos" pitchFamily="34" charset="-120"/>
-                        </a:rPr>
-                        <a:t>Conduits Ø20–50</a:t>
-                      </a:r>
-                      <a:endParaRPr lang="en-US" sz="1200" dirty="0">
-                        <a:latin typeface="Aptos" charset="0"/>
-                        <a:ea typeface="Aptos" charset="0"/>
-                        <a:cs typeface="Aptos" charset="0"/>
-                      </a:endParaRPr>
-                    </a:p>
-                  </a:txBody>
-                  <a:tcPr marL="64008" marR="64008" marT="64008" marB="64008" anchor="ctr">
-                    <a:lnL w="9525" cap="flat" cmpd="sng" algn="ctr">
-                      <a:solidFill>
-                        <a:srgbClr val="E1E0D9"/>
-                      </a:solidFill>
-                      <a:prstDash val="solid"/>
-                      <a:round/>
-                      <a:headEnd type="none" w="med" len="med"/>
-                      <a:tailEnd type="none" w="med" len="med"/>
-                    </a:lnL>
-                    <a:lnR w="9525" cap="flat" cmpd="sng" algn="ctr">
-                      <a:solidFill>
-                        <a:srgbClr val="E1E0D9"/>
-                      </a:solidFill>
-                      <a:prstDash val="solid"/>
-                      <a:round/>
-                      <a:headEnd type="none" w="med" len="med"/>
-                      <a:tailEnd type="none" w="med" len="med"/>
-                    </a:lnR>
-                    <a:lnT w="9525" cap="flat" cmpd="sng" algn="ctr">
-                      <a:solidFill>
-                        <a:srgbClr val="E1E0D9"/>
-                      </a:solidFill>
-                      <a:prstDash val="solid"/>
-                      <a:round/>
-                      <a:headEnd type="none" w="med" len="med"/>
-                      <a:tailEnd type="none" w="med" len="med"/>
-                    </a:lnT>
-                    <a:lnB w="9525" cap="flat" cmpd="sng" algn="ctr">
-                      <a:solidFill>
-                        <a:srgbClr val="E1E0D9"/>
-                      </a:solidFill>
-                      <a:prstDash val="solid"/>
-                      <a:round/>
-                      <a:headEnd type="none" w="med" len="med"/>
-                      <a:tailEnd type="none" w="med" len="med"/>
-                    </a:lnB>
-                  </a:tcPr>
-                </a:tc>
-                <a:tc>
-                  <a:txBody>
-                    <a:bodyPr/>
-                    <a:lstStyle/>
-                    <a:p>
-                      <a:pPr indent="0" marL="0">
-                        <a:buNone/>
-                      </a:pPr>
-                      <a:r>
-                        <a:rPr lang="en-US" sz="1200" dirty="0">
-                          <a:solidFill>
-                            <a:srgbClr val="0B0B0B"/>
-                          </a:solidFill>
-                          <a:latin typeface="Aptos" pitchFamily="34" charset="0"/>
-                          <a:ea typeface="Aptos" pitchFamily="34" charset="-122"/>
-                          <a:cs typeface="Aptos" pitchFamily="34" charset="-120"/>
-                        </a:rPr>
-                        <a:t>IEC 61386-1 [6], parallel groups of 2–6</a:t>
-                      </a:r>
-                      <a:endParaRPr lang="en-US" sz="1200" dirty="0">
-                        <a:latin typeface="Aptos" charset="0"/>
-                        <a:ea typeface="Aptos" charset="0"/>
-                        <a:cs typeface="Aptos" charset="0"/>
-                      </a:endParaRPr>
-                    </a:p>
-                  </a:txBody>
-                  <a:tcPr marL="64008" marR="64008" marT="64008" marB="64008" anchor="ctr">
-                    <a:lnL w="9525" cap="flat" cmpd="sng" algn="ctr">
-                      <a:solidFill>
-                        <a:srgbClr val="E1E0D9"/>
-                      </a:solidFill>
-                      <a:prstDash val="solid"/>
-                      <a:round/>
-                      <a:headEnd type="none" w="med" len="med"/>
-                      <a:tailEnd type="none" w="med" len="med"/>
-                    </a:lnL>
-                    <a:lnR w="9525" cap="flat" cmpd="sng" algn="ctr">
-                      <a:solidFill>
-                        <a:srgbClr val="E1E0D9"/>
-                      </a:solidFill>
-                      <a:prstDash val="solid"/>
-                      <a:round/>
-                      <a:headEnd type="none" w="med" len="med"/>
-                      <a:tailEnd type="none" w="med" len="med"/>
-                    </a:lnR>
-                    <a:lnT w="9525" cap="flat" cmpd="sng" algn="ctr">
-                      <a:solidFill>
-                        <a:srgbClr val="E1E0D9"/>
-                      </a:solidFill>
-                      <a:prstDash val="solid"/>
-                      <a:round/>
-                      <a:headEnd type="none" w="med" len="med"/>
-                      <a:tailEnd type="none" w="med" len="med"/>
-                    </a:lnT>
-                    <a:lnB w="9525" cap="flat" cmpd="sng" algn="ctr">
-                      <a:solidFill>
-                        <a:srgbClr val="E1E0D9"/>
-                      </a:solidFill>
-                      <a:prstDash val="solid"/>
-                      <a:round/>
-                      <a:headEnd type="none" w="med" len="med"/>
-                      <a:tailEnd type="none" w="med" len="med"/>
-                    </a:lnB>
-                  </a:tcPr>
-                </a:tc>
-                <a:tc>
-                  <a:txBody>
-                    <a:bodyPr/>
-                    <a:lstStyle/>
-                    <a:p>
-                      <a:pPr indent="0" marL="0">
-                        <a:buNone/>
-                      </a:pPr>
-                      <a:r>
-                        <a:rPr lang="en-US" sz="1200" dirty="0">
-                          <a:solidFill>
-                            <a:srgbClr val="0B0B0B"/>
-                          </a:solidFill>
-                          <a:latin typeface="Aptos" pitchFamily="34" charset="0"/>
-                          <a:ea typeface="Aptos" pitchFamily="34" charset="-122"/>
-                          <a:cs typeface="Aptos" pitchFamily="34" charset="-120"/>
-                        </a:rPr>
-                        <a:t>steel tube + 40 %-of-bore cable fill, × 2.0 m (IET / BS 7671) [10]</a:t>
-                      </a:r>
-                      <a:endParaRPr lang="en-US" sz="1200" dirty="0">
-                        <a:latin typeface="Aptos" charset="0"/>
-                        <a:ea typeface="Aptos" charset="0"/>
-                        <a:cs typeface="Aptos" charset="0"/>
-                      </a:endParaRPr>
-                    </a:p>
-                  </a:txBody>
-                  <a:tcPr marL="64008" marR="64008" marT="64008" marB="64008" anchor="ctr">
-                    <a:lnL w="9525" cap="flat" cmpd="sng" algn="ctr">
-                      <a:solidFill>
-                        <a:srgbClr val="E1E0D9"/>
-                      </a:solidFill>
-                      <a:prstDash val="solid"/>
-                      <a:round/>
-                      <a:headEnd type="none" w="med" len="med"/>
-                      <a:tailEnd type="none" w="med" len="med"/>
-                    </a:lnL>
-                    <a:lnR w="9525" cap="flat" cmpd="sng" algn="ctr">
-                      <a:solidFill>
-                        <a:srgbClr val="E1E0D9"/>
-                      </a:solidFill>
-                      <a:prstDash val="solid"/>
-                      <a:round/>
-                      <a:headEnd type="none" w="med" len="med"/>
-                      <a:tailEnd type="none" w="med" len="med"/>
-                    </a:lnR>
-                    <a:lnT w="9525" cap="flat" cmpd="sng" algn="ctr">
-                      <a:solidFill>
-                        <a:srgbClr val="E1E0D9"/>
-                      </a:solidFill>
-                      <a:prstDash val="solid"/>
-                      <a:round/>
-                      <a:headEnd type="none" w="med" len="med"/>
-                      <a:tailEnd type="none" w="med" len="med"/>
-                    </a:lnT>
-                    <a:lnB w="9525" cap="flat" cmpd="sng" algn="ctr">
-                      <a:solidFill>
-                        <a:srgbClr val="E1E0D9"/>
-                      </a:solidFill>
-                      <a:prstDash val="solid"/>
-                      <a:round/>
-                      <a:headEnd type="none" w="med" len="med"/>
-                      <a:tailEnd type="none" w="med" len="med"/>
-                    </a:lnB>
-                  </a:tcPr>
-                </a:tc>
-              </a:tr>
-            </a:tbl>
-          </a:graphicData>
-        </a:graphic>
-      </p:graphicFrame>
-      <p:sp>
-        <p:nvSpPr>
-          <p:cNvPr id="4" name="conventions heading"/>
+      <p:sp>
+        <p:nvSpPr>
+          <p:cNvPr id="3" name="kind Pipes DN15–150"/>
+          <p:cNvSpPr/>
+          <p:nvPr/>
+        </p:nvSpPr>
+        <p:spPr>
+          <a:xfrm>
+            <a:off x="548640" y="1371600"/>
+            <a:ext cx="6812280" cy="713232"/>
+          </a:xfrm>
+          <a:prstGeom prst="roundRect">
+            <a:avLst>
+              <a:gd name="adj" fmla="val 8974"/>
+            </a:avLst>
+          </a:prstGeom>
+          <a:solidFill>
+            <a:schemeClr val="bg2"/>
+          </a:solidFill>
+          <a:ln/>
+        </p:spPr>
+      </p:sp>
+      <p:sp>
+        <p:nvSpPr>
+          <p:cNvPr id="4" name="glyph card Pipes DN15–150"/>
+          <p:cNvSpPr/>
+          <p:nvPr/>
+        </p:nvSpPr>
+        <p:spPr>
+          <a:xfrm>
+            <a:off x="658368" y="1472184"/>
+            <a:ext cx="512064" cy="512064"/>
+          </a:xfrm>
+          <a:prstGeom prst="roundRect">
+            <a:avLst>
+              <a:gd name="adj" fmla="val 10714"/>
+            </a:avLst>
+          </a:prstGeom>
+          <a:solidFill>
+            <a:srgbClr val="FFFFFF"/>
+          </a:solidFill>
+          <a:ln w="9525">
+            <a:solidFill>
+              <a:srgbClr val="E1E0D9"/>
+            </a:solidFill>
+            <a:prstDash val="solid"/>
+          </a:ln>
+        </p:spPr>
+      </p:sp>
+      <p:sp>
+        <p:nvSpPr>
+          <p:cNvPr id="5" name="glyph pipe"/>
+          <p:cNvSpPr/>
+          <p:nvPr/>
+        </p:nvSpPr>
+        <p:spPr>
+          <a:xfrm>
+            <a:off x="749808" y="1563624"/>
+            <a:ext cx="329184" cy="329184"/>
+          </a:xfrm>
+          <a:prstGeom prst="ellipse">
+            <a:avLst/>
+          </a:prstGeom>
+          <a:solidFill>
+            <a:srgbClr val="EEF1F4"/>
+          </a:solidFill>
+          <a:ln w="12700">
+            <a:solidFill>
+              <a:srgbClr val="1F2933"/>
+            </a:solidFill>
+            <a:prstDash val="solid"/>
+          </a:ln>
+        </p:spPr>
+      </p:sp>
+      <p:sp>
+        <p:nvSpPr>
+          <p:cNvPr id="6" name="kind name Pipes DN15–150"/>
           <p:cNvSpPr txBox="1"/>
           <p:nvPr/>
         </p:nvSpPr>
         <p:spPr>
           <a:xfrm>
-            <a:off x="8092440" y="1417320"/>
-            <a:ext cx="3566160" cy="411480"/>
+            <a:off x="1325880" y="1417320"/>
+            <a:ext cx="1600200" cy="621792"/>
           </a:xfrm>
           <a:prstGeom prst="rect">
             <a:avLst/>
@@ -26466,27 +25318,1348 @@
               <a:buNone/>
             </a:pPr>
             <a:r>
-              <a:rPr lang="en-US" sz="1800" b="1" dirty="0">
+              <a:rPr lang="en-US" sz="1300" b="1" dirty="0">
                 <a:solidFill>
                   <a:schemeClr val="tx1"/>
                 </a:solidFill>
               </a:rPr>
-              <a:t>Layout conventions</a:t>
-            </a:r>
-            <a:endParaRPr lang="en-US" sz="1800" dirty="0"/>
+              <a:t>Pipes DN15–150</a:t>
+            </a:r>
+            <a:endParaRPr lang="en-US" sz="1300" dirty="0"/>
           </a:p>
         </p:txBody>
       </p:sp>
       <p:sp>
         <p:nvSpPr>
-          <p:cNvPr id="5" name="conventions"/>
+          <p:cNvPr id="7" name="kind text Pipes DN15–150"/>
           <p:cNvSpPr txBox="1"/>
           <p:nvPr/>
         </p:nvSpPr>
         <p:spPr>
           <a:xfrm>
-            <a:off x="8092440" y="1920240"/>
-            <a:ext cx="3566160" cy="3291840"/>
+            <a:off x="2971800" y="1417320"/>
+            <a:ext cx="4206240" cy="621792"/>
+          </a:xfrm>
+          <a:prstGeom prst="rect">
+            <a:avLst/>
+          </a:prstGeom>
+          <a:noFill/>
+          <a:ln/>
+        </p:spPr>
+        <p:txBody>
+          <a:bodyPr wrap="square" lIns="0" tIns="0" rIns="0" bIns="0" rtlCol="0" anchor="ctr"/>
+          <a:lstStyle/>
+          <a:p>
+            <a:pPr indent="0" marL="0">
+              <a:buNone/>
+            </a:pPr>
+            <a:r>
+              <a:rPr lang="en-US" sz="1050" b="1" dirty="0">
+                <a:solidFill>
+                  <a:schemeClr val="accent1"/>
+                </a:solidFill>
+              </a:rPr>
+              <a:t>Sizes  </a:t>
+            </a:r>
+            <a:pPr indent="0" marL="0">
+              <a:buNone/>
+            </a:pPr>
+            <a:r>
+              <a:rPr lang="en-US" sz="1050" dirty="0">
+                <a:solidFill>
+                  <a:schemeClr val="tx1"/>
+                </a:solidFill>
+              </a:rPr>
+              <a:t>EN 10220 / EN 10255 medium series [4]</a:t>
+            </a:r>
+            <a:endParaRPr lang="en-US" sz="1050" dirty="0"/>
+          </a:p>
+          <a:p>
+            <a:pPr indent="0" marL="0">
+              <a:buNone/>
+            </a:pPr>
+            <a:r>
+              <a:rPr lang="en-US" sz="1050" b="1" dirty="0">
+                <a:solidFill>
+                  <a:schemeClr val="accent1"/>
+                </a:solidFill>
+              </a:rPr>
+              <a:t>Load  </a:t>
+            </a:r>
+            <a:pPr indent="0" marL="0">
+              <a:buNone/>
+            </a:pPr>
+            <a:r>
+              <a:rPr lang="en-US" sz="1050" dirty="0">
+                <a:solidFill>
+                  <a:schemeClr val="tx1"/>
+                </a:solidFill>
+              </a:rPr>
+              <a:t>steel + water × ASME B31.1 water-service span [8]</a:t>
+            </a:r>
+            <a:endParaRPr lang="en-US" sz="1050" dirty="0"/>
+          </a:p>
+        </p:txBody>
+      </p:sp>
+      <p:sp>
+        <p:nvSpPr>
+          <p:cNvPr id="8" name="kind Insulation"/>
+          <p:cNvSpPr/>
+          <p:nvPr/>
+        </p:nvSpPr>
+        <p:spPr>
+          <a:xfrm>
+            <a:off x="548640" y="2176272"/>
+            <a:ext cx="6812280" cy="713232"/>
+          </a:xfrm>
+          <a:prstGeom prst="roundRect">
+            <a:avLst>
+              <a:gd name="adj" fmla="val 8974"/>
+            </a:avLst>
+          </a:prstGeom>
+          <a:solidFill>
+            <a:schemeClr val="bg2"/>
+          </a:solidFill>
+          <a:ln/>
+        </p:spPr>
+      </p:sp>
+      <p:sp>
+        <p:nvSpPr>
+          <p:cNvPr id="9" name="glyph card Insulation"/>
+          <p:cNvSpPr/>
+          <p:nvPr/>
+        </p:nvSpPr>
+        <p:spPr>
+          <a:xfrm>
+            <a:off x="658368" y="2276856"/>
+            <a:ext cx="512064" cy="512064"/>
+          </a:xfrm>
+          <a:prstGeom prst="roundRect">
+            <a:avLst>
+              <a:gd name="adj" fmla="val 10714"/>
+            </a:avLst>
+          </a:prstGeom>
+          <a:solidFill>
+            <a:srgbClr val="FFFFFF"/>
+          </a:solidFill>
+          <a:ln w="9525">
+            <a:solidFill>
+              <a:srgbClr val="E1E0D9"/>
+            </a:solidFill>
+            <a:prstDash val="solid"/>
+          </a:ln>
+        </p:spPr>
+      </p:sp>
+      <p:sp>
+        <p:nvSpPr>
+          <p:cNvPr id="10" name="glyph insulation ring"/>
+          <p:cNvSpPr/>
+          <p:nvPr/>
+        </p:nvSpPr>
+        <p:spPr>
+          <a:xfrm>
+            <a:off x="694944" y="2313432"/>
+            <a:ext cx="438912" cy="438912"/>
+          </a:xfrm>
+          <a:prstGeom prst="ellipse">
+            <a:avLst/>
+          </a:prstGeom>
+          <a:ln w="12700">
+            <a:solidFill>
+              <a:srgbClr val="1F2933"/>
+            </a:solidFill>
+            <a:prstDash val="dash"/>
+          </a:ln>
+        </p:spPr>
+      </p:sp>
+      <p:sp>
+        <p:nvSpPr>
+          <p:cNvPr id="11" name="glyph insulation pipe"/>
+          <p:cNvSpPr/>
+          <p:nvPr/>
+        </p:nvSpPr>
+        <p:spPr>
+          <a:xfrm>
+            <a:off x="804672" y="2423160"/>
+            <a:ext cx="219456" cy="219456"/>
+          </a:xfrm>
+          <a:prstGeom prst="ellipse">
+            <a:avLst/>
+          </a:prstGeom>
+          <a:solidFill>
+            <a:srgbClr val="EEF1F4"/>
+          </a:solidFill>
+          <a:ln w="12700">
+            <a:solidFill>
+              <a:srgbClr val="1F2933"/>
+            </a:solidFill>
+            <a:prstDash val="solid"/>
+          </a:ln>
+        </p:spPr>
+      </p:sp>
+      <p:sp>
+        <p:nvSpPr>
+          <p:cNvPr id="12" name="kind name Insulation"/>
+          <p:cNvSpPr txBox="1"/>
+          <p:nvPr/>
+        </p:nvSpPr>
+        <p:spPr>
+          <a:xfrm>
+            <a:off x="1325880" y="2221992"/>
+            <a:ext cx="1600200" cy="621792"/>
+          </a:xfrm>
+          <a:prstGeom prst="rect">
+            <a:avLst/>
+          </a:prstGeom>
+          <a:noFill/>
+          <a:ln/>
+        </p:spPr>
+        <p:txBody>
+          <a:bodyPr wrap="square" lIns="0" tIns="0" rIns="0" bIns="0" rtlCol="0" anchor="ctr"/>
+          <a:lstStyle/>
+          <a:p>
+            <a:pPr indent="0" marL="0">
+              <a:buNone/>
+            </a:pPr>
+            <a:r>
+              <a:rPr lang="en-US" sz="1300" b="1" dirty="0">
+                <a:solidFill>
+                  <a:schemeClr val="tx1"/>
+                </a:solidFill>
+              </a:rPr>
+              <a:t>Insulation</a:t>
+            </a:r>
+            <a:endParaRPr lang="en-US" sz="1300" dirty="0"/>
+          </a:p>
+        </p:txBody>
+      </p:sp>
+      <p:sp>
+        <p:nvSpPr>
+          <p:cNvPr id="13" name="kind text Insulation"/>
+          <p:cNvSpPr txBox="1"/>
+          <p:nvPr/>
+        </p:nvSpPr>
+        <p:spPr>
+          <a:xfrm>
+            <a:off x="2971800" y="2221992"/>
+            <a:ext cx="4206240" cy="621792"/>
+          </a:xfrm>
+          <a:prstGeom prst="rect">
+            <a:avLst/>
+          </a:prstGeom>
+          <a:noFill/>
+          <a:ln/>
+        </p:spPr>
+        <p:txBody>
+          <a:bodyPr wrap="square" lIns="0" tIns="0" rIns="0" bIns="0" rtlCol="0" anchor="ctr"/>
+          <a:lstStyle/>
+          <a:p>
+            <a:pPr indent="0" marL="0">
+              <a:buNone/>
+            </a:pPr>
+            <a:r>
+              <a:rPr lang="en-US" sz="1050" b="1" dirty="0">
+                <a:solidFill>
+                  <a:schemeClr val="accent1"/>
+                </a:solidFill>
+              </a:rPr>
+              <a:t>Sizes  </a:t>
+            </a:r>
+            <a:pPr indent="0" marL="0">
+              <a:buNone/>
+            </a:pPr>
+            <a:r>
+              <a:rPr lang="en-US" sz="1050" dirty="0">
+                <a:solidFill>
+                  <a:schemeClr val="tx1"/>
+                </a:solidFill>
+              </a:rPr>
+              <a:t>GEG Anlage 8, heated lines [11]; 30 / 50 mm condensation control, chilled</a:t>
+            </a:r>
+            <a:endParaRPr lang="en-US" sz="1050" dirty="0"/>
+          </a:p>
+          <a:p>
+            <a:pPr indent="0" marL="0">
+              <a:buNone/>
+            </a:pPr>
+            <a:r>
+              <a:rPr lang="en-US" sz="1050" b="1" dirty="0">
+                <a:solidFill>
+                  <a:schemeClr val="accent1"/>
+                </a:solidFill>
+              </a:rPr>
+              <a:t>Load  </a:t>
+            </a:r>
+            <a:pPr indent="0" marL="0">
+              <a:buNone/>
+            </a:pPr>
+            <a:r>
+              <a:rPr lang="en-US" sz="1050" dirty="0">
+                <a:solidFill>
+                  <a:schemeClr val="tx1"/>
+                </a:solidFill>
+              </a:rPr>
+              <a:t>adds to the size, not the load</a:t>
+            </a:r>
+            <a:endParaRPr lang="en-US" sz="1050" dirty="0"/>
+          </a:p>
+        </p:txBody>
+      </p:sp>
+      <p:sp>
+        <p:nvSpPr>
+          <p:cNvPr id="14" name="kind Cable trays 150–600"/>
+          <p:cNvSpPr/>
+          <p:nvPr/>
+        </p:nvSpPr>
+        <p:spPr>
+          <a:xfrm>
+            <a:off x="548640" y="2980944"/>
+            <a:ext cx="6812280" cy="713232"/>
+          </a:xfrm>
+          <a:prstGeom prst="roundRect">
+            <a:avLst>
+              <a:gd name="adj" fmla="val 8974"/>
+            </a:avLst>
+          </a:prstGeom>
+          <a:solidFill>
+            <a:schemeClr val="bg2"/>
+          </a:solidFill>
+          <a:ln/>
+        </p:spPr>
+      </p:sp>
+      <p:sp>
+        <p:nvSpPr>
+          <p:cNvPr id="15" name="glyph card Cable trays 150–600"/>
+          <p:cNvSpPr/>
+          <p:nvPr/>
+        </p:nvSpPr>
+        <p:spPr>
+          <a:xfrm>
+            <a:off x="658368" y="3081528"/>
+            <a:ext cx="512064" cy="512064"/>
+          </a:xfrm>
+          <a:prstGeom prst="roundRect">
+            <a:avLst>
+              <a:gd name="adj" fmla="val 10714"/>
+            </a:avLst>
+          </a:prstGeom>
+          <a:solidFill>
+            <a:srgbClr val="FFFFFF"/>
+          </a:solidFill>
+          <a:ln w="9525">
+            <a:solidFill>
+              <a:srgbClr val="E1E0D9"/>
+            </a:solidFill>
+            <a:prstDash val="solid"/>
+          </a:ln>
+        </p:spPr>
+      </p:sp>
+      <p:sp>
+        <p:nvSpPr>
+          <p:cNvPr id="16" name="glyph tray base"/>
+          <p:cNvSpPr/>
+          <p:nvPr/>
+        </p:nvSpPr>
+        <p:spPr>
+          <a:xfrm>
+            <a:off x="694944" y="3355848"/>
+            <a:ext cx="438912" cy="45720"/>
+          </a:xfrm>
+          <a:prstGeom prst="rect">
+            <a:avLst/>
+          </a:prstGeom>
+          <a:solidFill>
+            <a:srgbClr val="1F2933"/>
+          </a:solidFill>
+          <a:ln/>
+        </p:spPr>
+      </p:sp>
+      <p:sp>
+        <p:nvSpPr>
+          <p:cNvPr id="17" name="glyph tray side 0"/>
+          <p:cNvSpPr/>
+          <p:nvPr/>
+        </p:nvSpPr>
+        <p:spPr>
+          <a:xfrm>
+            <a:off x="694944" y="3246120"/>
+            <a:ext cx="45720" cy="155448"/>
+          </a:xfrm>
+          <a:prstGeom prst="rect">
+            <a:avLst/>
+          </a:prstGeom>
+          <a:solidFill>
+            <a:srgbClr val="1F2933"/>
+          </a:solidFill>
+          <a:ln/>
+        </p:spPr>
+      </p:sp>
+      <p:sp>
+        <p:nvSpPr>
+          <p:cNvPr id="18" name="glyph tray side 1"/>
+          <p:cNvSpPr/>
+          <p:nvPr/>
+        </p:nvSpPr>
+        <p:spPr>
+          <a:xfrm>
+            <a:off x="1088136" y="3246120"/>
+            <a:ext cx="45720" cy="155448"/>
+          </a:xfrm>
+          <a:prstGeom prst="rect">
+            <a:avLst/>
+          </a:prstGeom>
+          <a:solidFill>
+            <a:srgbClr val="1F2933"/>
+          </a:solidFill>
+          <a:ln/>
+        </p:spPr>
+      </p:sp>
+      <p:sp>
+        <p:nvSpPr>
+          <p:cNvPr id="19" name="kind name Cable trays 150–600"/>
+          <p:cNvSpPr txBox="1"/>
+          <p:nvPr/>
+        </p:nvSpPr>
+        <p:spPr>
+          <a:xfrm>
+            <a:off x="1325880" y="3026664"/>
+            <a:ext cx="1600200" cy="621792"/>
+          </a:xfrm>
+          <a:prstGeom prst="rect">
+            <a:avLst/>
+          </a:prstGeom>
+          <a:noFill/>
+          <a:ln/>
+        </p:spPr>
+        <p:txBody>
+          <a:bodyPr wrap="square" lIns="0" tIns="0" rIns="0" bIns="0" rtlCol="0" anchor="ctr"/>
+          <a:lstStyle/>
+          <a:p>
+            <a:pPr indent="0" marL="0">
+              <a:buNone/>
+            </a:pPr>
+            <a:r>
+              <a:rPr lang="en-US" sz="1300" b="1" dirty="0">
+                <a:solidFill>
+                  <a:schemeClr val="tx1"/>
+                </a:solidFill>
+              </a:rPr>
+              <a:t>Cable trays 150–600</a:t>
+            </a:r>
+            <a:endParaRPr lang="en-US" sz="1300" dirty="0"/>
+          </a:p>
+        </p:txBody>
+      </p:sp>
+      <p:sp>
+        <p:nvSpPr>
+          <p:cNvPr id="20" name="kind text Cable trays 150–600"/>
+          <p:cNvSpPr txBox="1"/>
+          <p:nvPr/>
+        </p:nvSpPr>
+        <p:spPr>
+          <a:xfrm>
+            <a:off x="2971800" y="3026664"/>
+            <a:ext cx="4206240" cy="621792"/>
+          </a:xfrm>
+          <a:prstGeom prst="rect">
+            <a:avLst/>
+          </a:prstGeom>
+          <a:noFill/>
+          <a:ln/>
+        </p:spPr>
+        <p:txBody>
+          <a:bodyPr wrap="square" lIns="0" tIns="0" rIns="0" bIns="0" rtlCol="0" anchor="ctr"/>
+          <a:lstStyle/>
+          <a:p>
+            <a:pPr indent="0" marL="0">
+              <a:buNone/>
+            </a:pPr>
+            <a:r>
+              <a:rPr lang="en-US" sz="1050" b="1" dirty="0">
+                <a:solidFill>
+                  <a:schemeClr val="accent1"/>
+                </a:solidFill>
+              </a:rPr>
+              <a:t>Sizes  </a:t>
+            </a:r>
+            <a:pPr indent="0" marL="0">
+              <a:buNone/>
+            </a:pPr>
+            <a:r>
+              <a:rPr lang="en-US" sz="1050" dirty="0">
+                <a:solidFill>
+                  <a:schemeClr val="tx1"/>
+                </a:solidFill>
+              </a:rPr>
+              <a:t>IEC 61537 systems [6] in NEMA VE 1 widths [7]</a:t>
+            </a:r>
+            <a:endParaRPr lang="en-US" sz="1050" dirty="0"/>
+          </a:p>
+          <a:p>
+            <a:pPr indent="0" marL="0">
+              <a:buNone/>
+            </a:pPr>
+            <a:r>
+              <a:rPr lang="en-US" sz="1050" b="1" dirty="0">
+                <a:solidFill>
+                  <a:schemeClr val="accent1"/>
+                </a:solidFill>
+              </a:rPr>
+              <a:t>Load  </a:t>
+            </a:r>
+            <a:pPr indent="0" marL="0">
+              <a:buNone/>
+            </a:pPr>
+            <a:r>
+              <a:rPr lang="en-US" sz="1050" dirty="0">
+                <a:solidFill>
+                  <a:schemeClr val="tx1"/>
+                </a:solidFill>
+              </a:rPr>
+              <a:t>50 kg/m full at 300 mm × 2.0 m, below the shortest NEMA class span [7]</a:t>
+            </a:r>
+            <a:endParaRPr lang="en-US" sz="1050" dirty="0"/>
+          </a:p>
+        </p:txBody>
+      </p:sp>
+      <p:sp>
+        <p:nvSpPr>
+          <p:cNvPr id="21" name="kind Ducts"/>
+          <p:cNvSpPr/>
+          <p:nvPr/>
+        </p:nvSpPr>
+        <p:spPr>
+          <a:xfrm>
+            <a:off x="548640" y="3785616"/>
+            <a:ext cx="6812280" cy="713232"/>
+          </a:xfrm>
+          <a:prstGeom prst="roundRect">
+            <a:avLst>
+              <a:gd name="adj" fmla="val 8974"/>
+            </a:avLst>
+          </a:prstGeom>
+          <a:solidFill>
+            <a:schemeClr val="bg2"/>
+          </a:solidFill>
+          <a:ln/>
+        </p:spPr>
+      </p:sp>
+      <p:sp>
+        <p:nvSpPr>
+          <p:cNvPr id="22" name="glyph card Ducts"/>
+          <p:cNvSpPr/>
+          <p:nvPr/>
+        </p:nvSpPr>
+        <p:spPr>
+          <a:xfrm>
+            <a:off x="658368" y="3886200"/>
+            <a:ext cx="512064" cy="512064"/>
+          </a:xfrm>
+          <a:prstGeom prst="roundRect">
+            <a:avLst>
+              <a:gd name="adj" fmla="val 10714"/>
+            </a:avLst>
+          </a:prstGeom>
+          <a:solidFill>
+            <a:srgbClr val="FFFFFF"/>
+          </a:solidFill>
+          <a:ln w="9525">
+            <a:solidFill>
+              <a:srgbClr val="E1E0D9"/>
+            </a:solidFill>
+            <a:prstDash val="solid"/>
+          </a:ln>
+        </p:spPr>
+      </p:sp>
+      <p:sp>
+        <p:nvSpPr>
+          <p:cNvPr id="23" name="glyph duct"/>
+          <p:cNvSpPr/>
+          <p:nvPr/>
+        </p:nvSpPr>
+        <p:spPr>
+          <a:xfrm>
+            <a:off x="694944" y="3995928"/>
+            <a:ext cx="438912" cy="292608"/>
+          </a:xfrm>
+          <a:prstGeom prst="rect">
+            <a:avLst/>
+          </a:prstGeom>
+          <a:solidFill>
+            <a:srgbClr val="EEF1F4"/>
+          </a:solidFill>
+          <a:ln w="12700">
+            <a:solidFill>
+              <a:srgbClr val="1F2933"/>
+            </a:solidFill>
+            <a:prstDash val="solid"/>
+          </a:ln>
+        </p:spPr>
+      </p:sp>
+      <p:sp>
+        <p:nvSpPr>
+          <p:cNvPr id="24" name="kind name Ducts"/>
+          <p:cNvSpPr txBox="1"/>
+          <p:nvPr/>
+        </p:nvSpPr>
+        <p:spPr>
+          <a:xfrm>
+            <a:off x="1325880" y="3831336"/>
+            <a:ext cx="1600200" cy="621792"/>
+          </a:xfrm>
+          <a:prstGeom prst="rect">
+            <a:avLst/>
+          </a:prstGeom>
+          <a:noFill/>
+          <a:ln/>
+        </p:spPr>
+        <p:txBody>
+          <a:bodyPr wrap="square" lIns="0" tIns="0" rIns="0" bIns="0" rtlCol="0" anchor="ctr"/>
+          <a:lstStyle/>
+          <a:p>
+            <a:pPr indent="0" marL="0">
+              <a:buNone/>
+            </a:pPr>
+            <a:r>
+              <a:rPr lang="en-US" sz="1300" b="1" dirty="0">
+                <a:solidFill>
+                  <a:schemeClr val="tx1"/>
+                </a:solidFill>
+              </a:rPr>
+              <a:t>Ducts</a:t>
+            </a:r>
+            <a:endParaRPr lang="en-US" sz="1300" dirty="0"/>
+          </a:p>
+        </p:txBody>
+      </p:sp>
+      <p:sp>
+        <p:nvSpPr>
+          <p:cNvPr id="25" name="kind text Ducts"/>
+          <p:cNvSpPr txBox="1"/>
+          <p:nvPr/>
+        </p:nvSpPr>
+        <p:spPr>
+          <a:xfrm>
+            <a:off x="2971800" y="3831336"/>
+            <a:ext cx="4206240" cy="621792"/>
+          </a:xfrm>
+          <a:prstGeom prst="rect">
+            <a:avLst/>
+          </a:prstGeom>
+          <a:noFill/>
+          <a:ln/>
+        </p:spPr>
+        <p:txBody>
+          <a:bodyPr wrap="square" lIns="0" tIns="0" rIns="0" bIns="0" rtlCol="0" anchor="ctr"/>
+          <a:lstStyle/>
+          <a:p>
+            <a:pPr indent="0" marL="0">
+              <a:buNone/>
+            </a:pPr>
+            <a:r>
+              <a:rPr lang="en-US" sz="1050" b="1" dirty="0">
+                <a:solidFill>
+                  <a:schemeClr val="accent1"/>
+                </a:solidFill>
+              </a:rPr>
+              <a:t>Sizes  </a:t>
+            </a:r>
+            <a:pPr indent="0" marL="0">
+              <a:buNone/>
+            </a:pPr>
+            <a:r>
+              <a:rPr lang="en-US" sz="1050" dirty="0">
+                <a:solidFill>
+                  <a:schemeClr val="tx1"/>
+                </a:solidFill>
+              </a:rPr>
+              <a:t>EN 1505 rectangular, EN 1506 round [5]</a:t>
+            </a:r>
+            <a:endParaRPr lang="en-US" sz="1050" dirty="0"/>
+          </a:p>
+          <a:p>
+            <a:pPr indent="0" marL="0">
+              <a:buNone/>
+            </a:pPr>
+            <a:r>
+              <a:rPr lang="en-US" sz="1050" b="1" dirty="0">
+                <a:solidFill>
+                  <a:schemeClr val="accent1"/>
+                </a:solidFill>
+              </a:rPr>
+              <a:t>Load  </a:t>
+            </a:r>
+            <a:pPr indent="0" marL="0">
+              <a:buNone/>
+            </a:pPr>
+            <a:r>
+              <a:rPr lang="en-US" sz="1050" dirty="0">
+                <a:solidFill>
+                  <a:schemeClr val="tx1"/>
+                </a:solidFill>
+              </a:rPr>
+              <a:t>manufacturer weight table with flanges × 2.4 m (SMACNA) [9]</a:t>
+            </a:r>
+            <a:endParaRPr lang="en-US" sz="1050" dirty="0"/>
+          </a:p>
+        </p:txBody>
+      </p:sp>
+      <p:sp>
+        <p:nvSpPr>
+          <p:cNvPr id="26" name="kind Conduits Ø20–50"/>
+          <p:cNvSpPr/>
+          <p:nvPr/>
+        </p:nvSpPr>
+        <p:spPr>
+          <a:xfrm>
+            <a:off x="548640" y="4590288"/>
+            <a:ext cx="6812280" cy="713232"/>
+          </a:xfrm>
+          <a:prstGeom prst="roundRect">
+            <a:avLst>
+              <a:gd name="adj" fmla="val 8974"/>
+            </a:avLst>
+          </a:prstGeom>
+          <a:solidFill>
+            <a:schemeClr val="bg2"/>
+          </a:solidFill>
+          <a:ln/>
+        </p:spPr>
+      </p:sp>
+      <p:sp>
+        <p:nvSpPr>
+          <p:cNvPr id="27" name="glyph card Conduits Ø20–50"/>
+          <p:cNvSpPr/>
+          <p:nvPr/>
+        </p:nvSpPr>
+        <p:spPr>
+          <a:xfrm>
+            <a:off x="658368" y="4690872"/>
+            <a:ext cx="512064" cy="512064"/>
+          </a:xfrm>
+          <a:prstGeom prst="roundRect">
+            <a:avLst>
+              <a:gd name="adj" fmla="val 10714"/>
+            </a:avLst>
+          </a:prstGeom>
+          <a:solidFill>
+            <a:srgbClr val="FFFFFF"/>
+          </a:solidFill>
+          <a:ln w="9525">
+            <a:solidFill>
+              <a:srgbClr val="E1E0D9"/>
+            </a:solidFill>
+            <a:prstDash val="solid"/>
+          </a:ln>
+        </p:spPr>
+      </p:sp>
+      <p:sp>
+        <p:nvSpPr>
+          <p:cNvPr id="28" name="glyph conduit 0"/>
+          <p:cNvSpPr/>
+          <p:nvPr/>
+        </p:nvSpPr>
+        <p:spPr>
+          <a:xfrm>
+            <a:off x="704088" y="4873752"/>
+            <a:ext cx="128016" cy="128016"/>
+          </a:xfrm>
+          <a:prstGeom prst="ellipse">
+            <a:avLst/>
+          </a:prstGeom>
+          <a:solidFill>
+            <a:srgbClr val="EEF1F4"/>
+          </a:solidFill>
+          <a:ln w="12700">
+            <a:solidFill>
+              <a:srgbClr val="1F2933"/>
+            </a:solidFill>
+            <a:prstDash val="solid"/>
+          </a:ln>
+        </p:spPr>
+      </p:sp>
+      <p:sp>
+        <p:nvSpPr>
+          <p:cNvPr id="29" name="glyph conduit 1"/>
+          <p:cNvSpPr/>
+          <p:nvPr/>
+        </p:nvSpPr>
+        <p:spPr>
+          <a:xfrm>
+            <a:off x="859536" y="4873752"/>
+            <a:ext cx="128016" cy="128016"/>
+          </a:xfrm>
+          <a:prstGeom prst="ellipse">
+            <a:avLst/>
+          </a:prstGeom>
+          <a:solidFill>
+            <a:srgbClr val="EEF1F4"/>
+          </a:solidFill>
+          <a:ln w="12700">
+            <a:solidFill>
+              <a:srgbClr val="1F2933"/>
+            </a:solidFill>
+            <a:prstDash val="solid"/>
+          </a:ln>
+        </p:spPr>
+      </p:sp>
+      <p:sp>
+        <p:nvSpPr>
+          <p:cNvPr id="30" name="glyph conduit 2"/>
+          <p:cNvSpPr/>
+          <p:nvPr/>
+        </p:nvSpPr>
+        <p:spPr>
+          <a:xfrm>
+            <a:off x="1014984" y="4873752"/>
+            <a:ext cx="128016" cy="128016"/>
+          </a:xfrm>
+          <a:prstGeom prst="ellipse">
+            <a:avLst/>
+          </a:prstGeom>
+          <a:solidFill>
+            <a:srgbClr val="EEF1F4"/>
+          </a:solidFill>
+          <a:ln w="12700">
+            <a:solidFill>
+              <a:srgbClr val="1F2933"/>
+            </a:solidFill>
+            <a:prstDash val="solid"/>
+          </a:ln>
+        </p:spPr>
+      </p:sp>
+      <p:sp>
+        <p:nvSpPr>
+          <p:cNvPr id="31" name="kind name Conduits Ø20–50"/>
+          <p:cNvSpPr txBox="1"/>
+          <p:nvPr/>
+        </p:nvSpPr>
+        <p:spPr>
+          <a:xfrm>
+            <a:off x="1325880" y="4636008"/>
+            <a:ext cx="1600200" cy="621792"/>
+          </a:xfrm>
+          <a:prstGeom prst="rect">
+            <a:avLst/>
+          </a:prstGeom>
+          <a:noFill/>
+          <a:ln/>
+        </p:spPr>
+        <p:txBody>
+          <a:bodyPr wrap="square" lIns="0" tIns="0" rIns="0" bIns="0" rtlCol="0" anchor="ctr"/>
+          <a:lstStyle/>
+          <a:p>
+            <a:pPr indent="0" marL="0">
+              <a:buNone/>
+            </a:pPr>
+            <a:r>
+              <a:rPr lang="en-US" sz="1300" b="1" dirty="0">
+                <a:solidFill>
+                  <a:schemeClr val="tx1"/>
+                </a:solidFill>
+              </a:rPr>
+              <a:t>Conduits Ø20–50</a:t>
+            </a:r>
+            <a:endParaRPr lang="en-US" sz="1300" dirty="0"/>
+          </a:p>
+        </p:txBody>
+      </p:sp>
+      <p:sp>
+        <p:nvSpPr>
+          <p:cNvPr id="32" name="kind text Conduits Ø20–50"/>
+          <p:cNvSpPr txBox="1"/>
+          <p:nvPr/>
+        </p:nvSpPr>
+        <p:spPr>
+          <a:xfrm>
+            <a:off x="2971800" y="4636008"/>
+            <a:ext cx="4206240" cy="621792"/>
+          </a:xfrm>
+          <a:prstGeom prst="rect">
+            <a:avLst/>
+          </a:prstGeom>
+          <a:noFill/>
+          <a:ln/>
+        </p:spPr>
+        <p:txBody>
+          <a:bodyPr wrap="square" lIns="0" tIns="0" rIns="0" bIns="0" rtlCol="0" anchor="ctr"/>
+          <a:lstStyle/>
+          <a:p>
+            <a:pPr indent="0" marL="0">
+              <a:buNone/>
+            </a:pPr>
+            <a:r>
+              <a:rPr lang="en-US" sz="1050" b="1" dirty="0">
+                <a:solidFill>
+                  <a:schemeClr val="accent1"/>
+                </a:solidFill>
+              </a:rPr>
+              <a:t>Sizes  </a:t>
+            </a:r>
+            <a:pPr indent="0" marL="0">
+              <a:buNone/>
+            </a:pPr>
+            <a:r>
+              <a:rPr lang="en-US" sz="1050" dirty="0">
+                <a:solidFill>
+                  <a:schemeClr val="tx1"/>
+                </a:solidFill>
+              </a:rPr>
+              <a:t>IEC 61386-1 [6], parallel groups of 2–6</a:t>
+            </a:r>
+            <a:endParaRPr lang="en-US" sz="1050" dirty="0"/>
+          </a:p>
+          <a:p>
+            <a:pPr indent="0" marL="0">
+              <a:buNone/>
+            </a:pPr>
+            <a:r>
+              <a:rPr lang="en-US" sz="1050" b="1" dirty="0">
+                <a:solidFill>
+                  <a:schemeClr val="accent1"/>
+                </a:solidFill>
+              </a:rPr>
+              <a:t>Load  </a:t>
+            </a:r>
+            <a:pPr indent="0" marL="0">
+              <a:buNone/>
+            </a:pPr>
+            <a:r>
+              <a:rPr lang="en-US" sz="1050" dirty="0">
+                <a:solidFill>
+                  <a:schemeClr val="tx1"/>
+                </a:solidFill>
+              </a:rPr>
+              <a:t>steel tube + 40 % cable fill × 2.0 m (IET / BS 7671) [10]</a:t>
+            </a:r>
+            <a:endParaRPr lang="en-US" sz="1050" dirty="0"/>
+          </a:p>
+        </p:txBody>
+      </p:sp>
+      <p:sp>
+        <p:nvSpPr>
+          <p:cNvPr id="33" name="ground Standards"/>
+          <p:cNvSpPr/>
+          <p:nvPr/>
+        </p:nvSpPr>
+        <p:spPr>
+          <a:xfrm>
+            <a:off x="7589520" y="1371600"/>
+            <a:ext cx="4050792" cy="1219200"/>
+          </a:xfrm>
+          <a:prstGeom prst="roundRect">
+            <a:avLst>
+              <a:gd name="adj" fmla="val 5250"/>
+            </a:avLst>
+          </a:prstGeom>
+          <a:solidFill>
+            <a:schemeClr val="bg2"/>
+          </a:solidFill>
+          <a:ln/>
+        </p:spPr>
+      </p:sp>
+      <p:sp>
+        <p:nvSpPr>
+          <p:cNvPr id="34" name="ground bar Standards"/>
+          <p:cNvSpPr/>
+          <p:nvPr/>
+        </p:nvSpPr>
+        <p:spPr>
+          <a:xfrm>
+            <a:off x="7662672" y="1499616"/>
+            <a:ext cx="73152" cy="963168"/>
+          </a:xfrm>
+          <a:prstGeom prst="roundRect">
+            <a:avLst>
+              <a:gd name="adj" fmla="val 50000"/>
+            </a:avLst>
+          </a:prstGeom>
+          <a:solidFill>
+            <a:schemeClr val="accent1"/>
+          </a:solidFill>
+          <a:ln/>
+        </p:spPr>
+      </p:sp>
+      <p:sp>
+        <p:nvSpPr>
+          <p:cNvPr id="35" name="ground ring Standards"/>
+          <p:cNvSpPr/>
+          <p:nvPr/>
+        </p:nvSpPr>
+        <p:spPr>
+          <a:xfrm>
+            <a:off x="7863840" y="1716024"/>
+            <a:ext cx="530352" cy="530352"/>
+          </a:xfrm>
+          <a:prstGeom prst="ellipse">
+            <a:avLst/>
+          </a:prstGeom>
+          <a:solidFill>
+            <a:schemeClr val="accent1"/>
+          </a:solidFill>
+          <a:ln/>
+        </p:spPr>
+      </p:sp>
+      <p:pic>
+        <p:nvPicPr>
+          <p:cNvPr id="36" name="ground icon Standards" descr="preencoded.png">    </p:cNvPr>
+          <p:cNvPicPr>
+            <a:picLocks noChangeAspect="1"/>
+          </p:cNvPicPr>
+          <p:nvPr/>
+        </p:nvPicPr>
+        <p:blipFill>
+          <a:blip r:embed="rId1"/>
+          <a:stretch>
+            <a:fillRect/>
+          </a:stretch>
+        </p:blipFill>
+        <p:spPr>
+          <a:xfrm>
+            <a:off x="7982712" y="1834896"/>
+            <a:ext cx="292608" cy="292608"/>
+          </a:xfrm>
+          <a:prstGeom prst="rect">
+            <a:avLst/>
+          </a:prstGeom>
+        </p:spPr>
+      </p:pic>
+      <p:sp>
+        <p:nvSpPr>
+          <p:cNvPr id="37" name="ground text Standards"/>
+          <p:cNvSpPr txBox="1"/>
+          <p:nvPr/>
+        </p:nvSpPr>
+        <p:spPr>
+          <a:xfrm>
+            <a:off x="8549640" y="1371600"/>
+            <a:ext cx="2907792" cy="1219200"/>
+          </a:xfrm>
+          <a:prstGeom prst="rect">
+            <a:avLst/>
+          </a:prstGeom>
+          <a:noFill/>
+          <a:ln/>
+        </p:spPr>
+        <p:txBody>
+          <a:bodyPr wrap="square" lIns="0" tIns="0" rIns="0" bIns="0" rtlCol="0" anchor="ctr"/>
+          <a:lstStyle/>
+          <a:p>
+            <a:pPr indent="0" marL="0">
+              <a:buNone/>
+            </a:pPr>
+            <a:r>
+              <a:rPr lang="en-US" sz="1400" b="1" dirty="0">
+                <a:solidFill>
+                  <a:schemeClr val="tx1"/>
+                </a:solidFill>
+              </a:rPr>
+              <a:t>Standards</a:t>
+            </a:r>
+            <a:endParaRPr lang="en-US" sz="1400" dirty="0"/>
+          </a:p>
+          <a:p>
+            <a:pPr indent="0" marL="0">
+              <a:buNone/>
+            </a:pPr>
+            <a:r>
+              <a:rPr lang="en-US" sz="1100" dirty="0">
+                <a:solidFill>
+                  <a:srgbClr val="52514E"/>
+                </a:solidFill>
+              </a:rPr>
+              <a:t>what each element is and weighs: sizes, walls, spans, insulation [4]–[11]</a:t>
+            </a:r>
+            <a:endParaRPr lang="en-US" sz="1400" dirty="0"/>
+          </a:p>
+        </p:txBody>
+      </p:sp>
+      <p:sp>
+        <p:nvSpPr>
+          <p:cNvPr id="38" name="ground Measured"/>
+          <p:cNvSpPr/>
+          <p:nvPr/>
+        </p:nvSpPr>
+        <p:spPr>
+          <a:xfrm>
+            <a:off x="7589520" y="2727960"/>
+            <a:ext cx="4050792" cy="1219200"/>
+          </a:xfrm>
+          <a:prstGeom prst="roundRect">
+            <a:avLst>
+              <a:gd name="adj" fmla="val 5250"/>
+            </a:avLst>
+          </a:prstGeom>
+          <a:solidFill>
+            <a:schemeClr val="bg2"/>
+          </a:solidFill>
+          <a:ln/>
+        </p:spPr>
+      </p:sp>
+      <p:sp>
+        <p:nvSpPr>
+          <p:cNvPr id="39" name="ground bar Measured"/>
+          <p:cNvSpPr/>
+          <p:nvPr/>
+        </p:nvSpPr>
+        <p:spPr>
+          <a:xfrm>
+            <a:off x="7662672" y="2855976"/>
+            <a:ext cx="73152" cy="963168"/>
+          </a:xfrm>
+          <a:prstGeom prst="roundRect">
+            <a:avLst>
+              <a:gd name="adj" fmla="val 50000"/>
+            </a:avLst>
+          </a:prstGeom>
+          <a:solidFill>
+            <a:srgbClr val="1BAF7A"/>
+          </a:solidFill>
+          <a:ln/>
+        </p:spPr>
+      </p:sp>
+      <p:sp>
+        <p:nvSpPr>
+          <p:cNvPr id="40" name="ground ring Measured"/>
+          <p:cNvSpPr/>
+          <p:nvPr/>
+        </p:nvSpPr>
+        <p:spPr>
+          <a:xfrm>
+            <a:off x="7863840" y="3072384"/>
+            <a:ext cx="530352" cy="530352"/>
+          </a:xfrm>
+          <a:prstGeom prst="ellipse">
+            <a:avLst/>
+          </a:prstGeom>
+          <a:solidFill>
+            <a:srgbClr val="1BAF7A"/>
+          </a:solidFill>
+          <a:ln/>
+        </p:spPr>
+      </p:sp>
+      <p:pic>
+        <p:nvPicPr>
+          <p:cNvPr id="41" name="ground icon Measured" descr="preencoded.png">    </p:cNvPr>
+          <p:cNvPicPr>
+            <a:picLocks noChangeAspect="1"/>
+          </p:cNvPicPr>
+          <p:nvPr/>
+        </p:nvPicPr>
+        <p:blipFill>
+          <a:blip r:embed="rId2"/>
+          <a:stretch>
+            <a:fillRect/>
+          </a:stretch>
+        </p:blipFill>
+        <p:spPr>
+          <a:xfrm>
+            <a:off x="7982712" y="3191256"/>
+            <a:ext cx="292608" cy="292608"/>
+          </a:xfrm>
+          <a:prstGeom prst="rect">
+            <a:avLst/>
+          </a:prstGeom>
+        </p:spPr>
+      </p:pic>
+      <p:sp>
+        <p:nvSpPr>
+          <p:cNvPr id="42" name="ground text Measured"/>
+          <p:cNvSpPr txBox="1"/>
+          <p:nvPr/>
+        </p:nvSpPr>
+        <p:spPr>
+          <a:xfrm>
+            <a:off x="8549640" y="2727960"/>
+            <a:ext cx="2907792" cy="1219200"/>
+          </a:xfrm>
+          <a:prstGeom prst="rect">
+            <a:avLst/>
+          </a:prstGeom>
+          <a:noFill/>
+          <a:ln/>
+        </p:spPr>
+        <p:txBody>
+          <a:bodyPr wrap="square" lIns="0" tIns="0" rIns="0" bIns="0" rtlCol="0" anchor="ctr"/>
+          <a:lstStyle/>
+          <a:p>
+            <a:pPr indent="0" marL="0">
+              <a:buNone/>
+            </a:pPr>
+            <a:r>
+              <a:rPr lang="en-US" sz="1400" b="1" dirty="0">
+                <a:solidFill>
+                  <a:schemeClr val="tx1"/>
+                </a:solidFill>
+              </a:rPr>
+              <a:t>Measured</a:t>
+            </a:r>
+            <a:endParaRPr lang="en-US" sz="1400" dirty="0"/>
+          </a:p>
+          <a:p>
+            <a:pPr indent="0" marL="0">
+              <a:buNone/>
+            </a:pPr>
+            <a:r>
+              <a:rPr lang="en-US" sz="1100" dirty="0">
+                <a:solidFill>
+                  <a:srgbClr val="52514E"/>
+                </a:solidFill>
+              </a:rPr>
+              <a:t>how close neighbours sit: clear gaps and row stagger from two open buildings [12]</a:t>
+            </a:r>
+            <a:endParaRPr lang="en-US" sz="1400" dirty="0"/>
+          </a:p>
+        </p:txBody>
+      </p:sp>
+      <p:sp>
+        <p:nvSpPr>
+          <p:cNvPr id="43" name="ground Declared"/>
+          <p:cNvSpPr/>
+          <p:nvPr/>
+        </p:nvSpPr>
+        <p:spPr>
+          <a:xfrm>
+            <a:off x="7589520" y="4084320"/>
+            <a:ext cx="4050792" cy="1219200"/>
+          </a:xfrm>
+          <a:prstGeom prst="roundRect">
+            <a:avLst>
+              <a:gd name="adj" fmla="val 5250"/>
+            </a:avLst>
+          </a:prstGeom>
+          <a:solidFill>
+            <a:schemeClr val="bg2"/>
+          </a:solidFill>
+          <a:ln/>
+        </p:spPr>
+      </p:sp>
+      <p:sp>
+        <p:nvSpPr>
+          <p:cNvPr id="44" name="ground bar Declared"/>
+          <p:cNvSpPr/>
+          <p:nvPr/>
+        </p:nvSpPr>
+        <p:spPr>
+          <a:xfrm>
+            <a:off x="7662672" y="4212336"/>
+            <a:ext cx="73152" cy="963168"/>
+          </a:xfrm>
+          <a:prstGeom prst="roundRect">
+            <a:avLst>
+              <a:gd name="adj" fmla="val 50000"/>
+            </a:avLst>
+          </a:prstGeom>
+          <a:solidFill>
+            <a:srgbClr val="EB6834"/>
+          </a:solidFill>
+          <a:ln/>
+        </p:spPr>
+      </p:sp>
+      <p:sp>
+        <p:nvSpPr>
+          <p:cNvPr id="45" name="ground ring Declared"/>
+          <p:cNvSpPr/>
+          <p:nvPr/>
+        </p:nvSpPr>
+        <p:spPr>
+          <a:xfrm>
+            <a:off x="7863840" y="4428744"/>
+            <a:ext cx="530352" cy="530352"/>
+          </a:xfrm>
+          <a:prstGeom prst="ellipse">
+            <a:avLst/>
+          </a:prstGeom>
+          <a:solidFill>
+            <a:srgbClr val="EB6834"/>
+          </a:solidFill>
+          <a:ln/>
+        </p:spPr>
+      </p:sp>
+      <p:pic>
+        <p:nvPicPr>
+          <p:cNvPr id="46" name="ground icon Declared" descr="preencoded.png">    </p:cNvPr>
+          <p:cNvPicPr>
+            <a:picLocks noChangeAspect="1"/>
+          </p:cNvPicPr>
+          <p:nvPr/>
+        </p:nvPicPr>
+        <p:blipFill>
+          <a:blip r:embed="rId3"/>
+          <a:stretch>
+            <a:fillRect/>
+          </a:stretch>
+        </p:blipFill>
+        <p:spPr>
+          <a:xfrm>
+            <a:off x="7982712" y="4547616"/>
+            <a:ext cx="292608" cy="292608"/>
+          </a:xfrm>
+          <a:prstGeom prst="rect">
+            <a:avLst/>
+          </a:prstGeom>
+        </p:spPr>
+      </p:pic>
+      <p:sp>
+        <p:nvSpPr>
+          <p:cNvPr id="47" name="ground text Declared"/>
+          <p:cNvSpPr txBox="1"/>
+          <p:nvPr/>
+        </p:nvSpPr>
+        <p:spPr>
+          <a:xfrm>
+            <a:off x="8549640" y="4084320"/>
+            <a:ext cx="2907792" cy="1219200"/>
+          </a:xfrm>
+          <a:prstGeom prst="rect">
+            <a:avLst/>
+          </a:prstGeom>
+          <a:noFill/>
+          <a:ln/>
+        </p:spPr>
+        <p:txBody>
+          <a:bodyPr wrap="square" lIns="0" tIns="0" rIns="0" bIns="0" rtlCol="0" anchor="ctr"/>
+          <a:lstStyle/>
+          <a:p>
+            <a:pPr indent="0" marL="0">
+              <a:buNone/>
+            </a:pPr>
+            <a:r>
+              <a:rPr lang="en-US" sz="1400" b="1" dirty="0">
+                <a:solidFill>
+                  <a:schemeClr val="tx1"/>
+                </a:solidFill>
+              </a:rPr>
+              <a:t>Declared</a:t>
+            </a:r>
+            <a:endParaRPr lang="en-US" sz="1400" dirty="0"/>
+          </a:p>
+          <a:p>
+            <a:pPr indent="0" marL="0">
+              <a:buNone/>
+            </a:pPr>
+            <a:r>
+              <a:rPr lang="en-US" sz="1100" dirty="0">
+                <a:solidFill>
+                  <a:srgbClr val="52514E"/>
+                </a:solidFill>
+              </a:rPr>
+              <a:t>our choices, labelled as such: trade mix, ceiling / wall 78 / 22 %, number of rows</a:t>
+            </a:r>
+            <a:endParaRPr lang="en-US" sz="1400" dirty="0"/>
+          </a:p>
+        </p:txBody>
+      </p:sp>
+      <p:sp>
+        <p:nvSpPr>
+          <p:cNvPr id="48" name="sources note"/>
+          <p:cNvSpPr txBox="1"/>
+          <p:nvPr/>
+        </p:nvSpPr>
+        <p:spPr>
+          <a:xfrm>
+            <a:off x="548640" y="5440680"/>
+            <a:ext cx="11091672" cy="274320"/>
           </a:xfrm>
           <a:prstGeom prst="rect">
             <a:avLst/>
@@ -26498,158 +26671,24 @@
           <a:bodyPr wrap="square" lIns="0" tIns="0" rIns="0" bIns="0" rtlCol="0" anchor="t"/>
           <a:lstStyle/>
           <a:p>
-            <a:pPr marL="342900" indent="-342900">
-              <a:spcAft>
-                <a:spcPts val="600"/>
-              </a:spcAft>
-              <a:buSzPct val="100000"/>
-              <a:buChar char="•"/>
-            </a:pPr>
-            <a:r>
-              <a:rPr lang="en-US" sz="1300" dirty="0">
-                <a:solidFill>
-                  <a:schemeClr val="tx1"/>
-                </a:solidFill>
-              </a:rPr>
-              <a:t>Bulky services nearest the slab: ducts, then containment, then pipes</a:t>
-            </a:r>
-            <a:endParaRPr lang="en-US" sz="1300" dirty="0"/>
-          </a:p>
-          <a:p>
-            <a:pPr marL="342900" indent="-342900">
-              <a:spcAft>
-                <a:spcPts val="600"/>
-              </a:spcAft>
-              <a:buSzPct val="100000"/>
-              <a:buChar char="•"/>
-            </a:pPr>
-            <a:r>
-              <a:rPr lang="en-US" sz="1300" dirty="0">
-                <a:solidFill>
-                  <a:schemeClr val="tx1"/>
-                </a:solidFill>
-              </a:rPr>
-              <a:t>Trades run in banks: hot + cold pairs, flow + return, conduit groups</a:t>
-            </a:r>
-            <a:endParaRPr lang="en-US" sz="1300" dirty="0"/>
-          </a:p>
-          <a:p>
-            <a:pPr marL="342900" indent="-342900">
-              <a:spcAft>
-                <a:spcPts val="600"/>
-              </a:spcAft>
-              <a:buSzPct val="100000"/>
-              <a:buChar char="•"/>
-            </a:pPr>
-            <a:r>
-              <a:rPr lang="en-US" sz="1300" dirty="0">
-                <a:solidFill>
-                  <a:schemeClr val="tx1"/>
-                </a:solidFill>
-              </a:rPr>
-              <a:t>Electrical kept above wet services on walls (drip; BS 7671 528.3.2) [10]</a:t>
-            </a:r>
-            <a:endParaRPr lang="en-US" sz="1300" dirty="0"/>
-          </a:p>
-          <a:p>
-            <a:pPr marL="342900" indent="-342900">
-              <a:spcAft>
-                <a:spcPts val="600"/>
-              </a:spcAft>
-              <a:buSzPct val="100000"/>
-              <a:buChar char="•"/>
-            </a:pPr>
-            <a:r>
-              <a:rPr lang="en-US" sz="1300" dirty="0">
-                <a:solidFill>
-                  <a:schemeClr val="tx1"/>
-                </a:solidFill>
-              </a:rPr>
-              <a:t>Clear gaps drawn from a distribution measured on a built project [12]; 25 mm minimum</a:t>
-            </a:r>
-            <a:endParaRPr lang="en-US" sz="1300" dirty="0"/>
-          </a:p>
-          <a:p>
-            <a:pPr marL="342900" indent="-342900">
-              <a:spcAft>
-                <a:spcPts val="600"/>
-              </a:spcAft>
-              <a:buSzPct val="100000"/>
-              <a:buChar char="•"/>
-            </a:pPr>
-            <a:r>
-              <a:rPr lang="en-US" sz="1300" dirty="0">
-                <a:solidFill>
-                  <a:schemeClr val="tx1"/>
-                </a:solidFill>
-              </a:rPr>
-              <a:t>Within-row stagger calibrated to measured elevation spread</a:t>
-            </a:r>
-            <a:endParaRPr lang="en-US" sz="1300" dirty="0"/>
-          </a:p>
-        </p:txBody>
-      </p:sp>
-      <p:sp>
-        <p:nvSpPr>
-          <p:cNvPr id="6" name="sources note card"/>
-          <p:cNvSpPr/>
-          <p:nvPr/>
-        </p:nvSpPr>
-        <p:spPr>
-          <a:xfrm>
-            <a:off x="548640" y="4983480"/>
-            <a:ext cx="11091672" cy="685800"/>
-          </a:xfrm>
-          <a:prstGeom prst="roundRect">
-            <a:avLst>
-              <a:gd name="adj" fmla="val 9333"/>
-            </a:avLst>
-          </a:prstGeom>
-          <a:solidFill>
-            <a:schemeClr val="bg2"/>
-          </a:solidFill>
-          <a:ln/>
-        </p:spPr>
-      </p:sp>
-      <p:sp>
-        <p:nvSpPr>
-          <p:cNvPr id="7" name="sources note"/>
-          <p:cNvSpPr txBox="1"/>
-          <p:nvPr/>
-        </p:nvSpPr>
-        <p:spPr>
-          <a:xfrm>
-            <a:off x="822960" y="4983480"/>
-            <a:ext cx="10515600" cy="685800"/>
-          </a:xfrm>
-          <a:prstGeom prst="rect">
-            <a:avLst/>
-          </a:prstGeom>
-          <a:noFill/>
-          <a:ln/>
-        </p:spPr>
-        <p:txBody>
-          <a:bodyPr wrap="square" lIns="0" tIns="0" rIns="0" bIns="0" rtlCol="0" anchor="ctr"/>
-          <a:lstStyle/>
-          <a:p>
             <a:pPr indent="0" marL="0">
               <a:buNone/>
             </a:pPr>
             <a:r>
-              <a:rPr lang="en-US" sz="1250" dirty="0">
-                <a:solidFill>
-                  <a:schemeClr val="tx1"/>
+              <a:rPr lang="en-US" sz="1100" dirty="0">
+                <a:solidFill>
+                  <a:srgbClr val="52514E"/>
                 </a:solidFill>
               </a:rPr>
-              <a:t>Three kinds of ground: standards (what each element is and weighs), measured open buildings (how close neighbours sit) and declared design choices (trade mix, surface mix, number of rows). Every constant carries its source and status in the repository, and the log says why each standard was chosen over its alternatives.</a:t>
-            </a:r>
-            <a:endParaRPr lang="en-US" sz="1250" dirty="0"/>
+              <a:t>Every constant carries its source and status in the repository; the verification log says why each standard was chosen over its alternatives.</a:t>
+            </a:r>
+            <a:endParaRPr lang="en-US" sz="1100" dirty="0"/>
           </a:p>
         </p:txBody>
       </p:sp>
       <p:sp>
         <p:nvSpPr>
-          <p:cNvPr id="8" name="references"/>
+          <p:cNvPr id="49" name="references"/>
           <p:cNvSpPr txBox="1"/>
           <p:nvPr/>
         </p:nvSpPr>

</xml_diff>

<commit_message>
Talk: slide 10 is the two design-check charts alone
</commit_message>
<xml_diff>
--- a/docs/CrossMEP_CIBW78_talk.pptx
+++ b/docs/CrossMEP_CIBW78_talk.pptx
@@ -122,12 +122,12 @@
   <p:extLst>
     <p:ext uri="{521415D9-36F7-43E2-AB2F-B90AF26B5E84}">
       <p14:sectionLst xmlns:p14="http://schemas.microsoft.com/office/powerpoint/2010/main">
-        <p14:section name="Opening" id="{7d8f386a-a5a7-1eb1-d356-c29706b55b18}">
+        <p14:section name="Opening" id="{0e1fd639-608e-b47d-3c59-0ef9051af9c2}">
           <p14:sldIdLst>
             <p14:sldId id="256"/>
           </p14:sldIdLst>
         </p14:section>
-        <p14:section name="Motivation" id="{dcd781e8-0da3-c1d0-9002-c0d31392fb04}">
+        <p14:section name="Motivation" id="{c8eacdc9-d847-1290-5fbf-eb5a9e94c352}">
           <p14:sldIdLst>
             <p14:sldId id="257"/>
             <p14:sldId id="258"/>
@@ -136,21 +136,21 @@
             <p14:sldId id="261"/>
           </p14:sldIdLst>
         </p14:section>
-        <p14:section name="The dataset" id="{3bc824a8-df9a-3b94-e66e-2e27a58b27af}">
+        <p14:section name="The dataset" id="{8ed27c14-aae0-2cf3-0d0f-c06f4a3a7e1d}">
           <p14:sldIdLst>
             <p14:sldId id="262"/>
             <p14:sldId id="263"/>
             <p14:sldId id="264"/>
           </p14:sldIdLst>
         </p14:section>
-        <p14:section name="Experiments" id="{6c47af42-8dfa-5970-6d8e-3882c69630df}">
+        <p14:section name="Experiments" id="{42857e33-927d-9857-20e8-743db16664af}">
           <p14:sldIdLst>
             <p14:sldId id="265"/>
             <p14:sldId id="266"/>
             <p14:sldId id="267"/>
           </p14:sldIdLst>
         </p14:section>
-        <p14:section name="Use" id="{326d3821-53b3-6427-34d9-01dc1b7609f0}">
+        <p14:section name="Use" id="{0600379d-c32d-4930-f42c-77df7370adb1}">
           <p14:sldIdLst>
             <p14:sldId id="268"/>
             <p14:sldId id="269"/>
@@ -179,7 +179,7 @@
           <a:lstStyle/>
           <a:p>
             <a:pPr>
-              <a:defRPr sz="1200" b="0" i="0" u="none" strike="noStrike">
+              <a:defRPr sz="1400" b="0" i="0" u="none" strike="noStrike">
                 <a:solidFill>
                   <a:srgbClr val="0B0B0B"/>
                 </a:solidFill>
@@ -187,7 +187,7 @@
               </a:defRPr>
             </a:pPr>
             <a:r>
-              <a:rPr sz="1200" b="0" i="0" u="none" strike="noStrike">
+              <a:rPr sz="1400" b="0" i="0" u="none" strike="noStrike">
                 <a:solidFill>
                   <a:srgbClr val="0B0B0B"/>
                 </a:solidFill>
@@ -236,7 +236,7 @@
               <a:lstStyle/>
               <a:p>
                 <a:pPr>
-                  <a:defRPr b="0" i="0" strike="noStrike" sz="850" u="none">
+                  <a:defRPr b="0" i="0" strike="noStrike" sz="1000" u="none">
                     <a:solidFill>
                       <a:srgbClr val="0B0B0B"/>
                     </a:solidFill>
@@ -349,7 +349,7 @@
               <a:lstStyle/>
               <a:p>
                 <a:pPr>
-                  <a:defRPr b="0" i="0" strike="noStrike" sz="850" u="none">
+                  <a:defRPr b="0" i="0" strike="noStrike" sz="1000" u="none">
                     <a:solidFill>
                       <a:srgbClr val="0B0B0B"/>
                     </a:solidFill>
@@ -441,7 +441,7 @@
             <a:lstStyle/>
             <a:p>
               <a:pPr>
-                <a:defRPr b="0" i="0" strike="noStrike" sz="850" u="none">
+                <a:defRPr b="0" i="0" strike="noStrike" sz="1000" u="none">
                   <a:solidFill>
                     <a:srgbClr val="0B0B0B"/>
                   </a:solidFill>
@@ -489,7 +489,7 @@
           <a:lstStyle/>
           <a:p>
             <a:pPr>
-              <a:defRPr sz="1100" b="0" i="0" u="none" strike="noStrike">
+              <a:defRPr sz="1200" b="0" i="0" u="none" strike="noStrike">
                 <a:solidFill>
                   <a:srgbClr val="52514E"/>
                 </a:solidFill>
@@ -542,7 +542,7 @@
           <a:lstStyle/>
           <a:p>
             <a:pPr>
-              <a:defRPr sz="1000" b="0" i="0" u="none" strike="noStrike">
+              <a:defRPr sz="1100" b="0" i="0" u="none" strike="noStrike">
                 <a:solidFill>
                   <a:srgbClr val="52514E"/>
                 </a:solidFill>
@@ -572,7 +572,7 @@
         <a:lstStyle/>
         <a:p>
           <a:pPr>
-            <a:defRPr sz="900">
+            <a:defRPr sz="1000">
               <a:latin typeface="+mn-lt"/>
               <a:cs typeface="+mn-lt"/>
             </a:defRPr>
@@ -609,7 +609,7 @@
           <a:lstStyle/>
           <a:p>
             <a:pPr>
-              <a:defRPr sz="1200" b="0" i="0" u="none" strike="noStrike">
+              <a:defRPr sz="1400" b="0" i="0" u="none" strike="noStrike">
                 <a:solidFill>
                   <a:srgbClr val="0B0B0B"/>
                 </a:solidFill>
@@ -617,7 +617,7 @@
               </a:defRPr>
             </a:pPr>
             <a:r>
-              <a:rPr sz="1200" b="0" i="0" u="none" strike="noStrike">
+              <a:rPr sz="1400" b="0" i="0" u="none" strike="noStrike">
                 <a:solidFill>
                   <a:srgbClr val="0B0B0B"/>
                 </a:solidFill>
@@ -666,7 +666,7 @@
               <a:lstStyle/>
               <a:p>
                 <a:pPr>
-                  <a:defRPr b="0" i="0" strike="noStrike" sz="850" u="none">
+                  <a:defRPr b="0" i="0" strike="noStrike" sz="1000" u="none">
                     <a:solidFill>
                       <a:srgbClr val="0B0B0B"/>
                     </a:solidFill>
@@ -773,7 +773,7 @@
               <a:lstStyle/>
               <a:p>
                 <a:pPr>
-                  <a:defRPr b="0" i="0" strike="noStrike" sz="850" u="none">
+                  <a:defRPr b="0" i="0" strike="noStrike" sz="1000" u="none">
                     <a:solidFill>
                       <a:srgbClr val="0B0B0B"/>
                     </a:solidFill>
@@ -859,7 +859,7 @@
             <a:lstStyle/>
             <a:p>
               <a:pPr>
-                <a:defRPr b="0" i="0" strike="noStrike" sz="850" u="none">
+                <a:defRPr b="0" i="0" strike="noStrike" sz="1000" u="none">
                   <a:solidFill>
                     <a:srgbClr val="0B0B0B"/>
                   </a:solidFill>
@@ -907,7 +907,7 @@
           <a:lstStyle/>
           <a:p>
             <a:pPr>
-              <a:defRPr sz="1100" b="0" i="0" u="none" strike="noStrike">
+              <a:defRPr sz="1200" b="0" i="0" u="none" strike="noStrike">
                 <a:solidFill>
                   <a:srgbClr val="52514E"/>
                 </a:solidFill>
@@ -960,7 +960,7 @@
           <a:lstStyle/>
           <a:p>
             <a:pPr>
-              <a:defRPr sz="1000" b="0" i="0" u="none" strike="noStrike">
+              <a:defRPr sz="1100" b="0" i="0" u="none" strike="noStrike">
                 <a:solidFill>
                   <a:srgbClr val="52514E"/>
                 </a:solidFill>
@@ -990,7 +990,7 @@
         <a:lstStyle/>
         <a:p>
           <a:pPr>
-            <a:defRPr sz="900">
+            <a:defRPr sz="1000">
               <a:latin typeface="+mn-lt"/>
               <a:cs typeface="+mn-lt"/>
             </a:defRPr>
@@ -5407,132 +5407,48 @@
           </a:p>
         </p:txBody>
       </p:sp>
-      <p:pic>
-        <p:nvPicPr>
-          <p:cNvPr id="3" name="tiers C1 to C4" descr="preencoded.png">    </p:cNvPr>
-          <p:cNvPicPr>
-            <a:picLocks noChangeAspect="1"/>
-          </p:cNvPicPr>
-          <p:nvPr/>
-        </p:nvPicPr>
-        <p:blipFill>
-          <a:blip r:embed="rId1"/>
-          <a:stretch>
-            <a:fillRect/>
-          </a:stretch>
-        </p:blipFill>
-        <p:spPr>
-          <a:xfrm>
-            <a:off x="548640" y="1325880"/>
-            <a:ext cx="5477256" cy="1278026"/>
-          </a:xfrm>
-          <a:prstGeom prst="rect">
-            <a:avLst/>
-          </a:prstGeom>
-        </p:spPr>
-      </p:pic>
-      <p:pic>
-        <p:nvPicPr>
-          <p:cNvPr id="4" name="tiers C5 to C8" descr="preencoded.png">    </p:cNvPr>
-          <p:cNvPicPr>
-            <a:picLocks noChangeAspect="1"/>
-          </p:cNvPicPr>
-          <p:nvPr/>
-        </p:nvPicPr>
-        <p:blipFill>
-          <a:blip r:embed="rId2"/>
-          <a:stretch>
-            <a:fillRect/>
-          </a:stretch>
-        </p:blipFill>
-        <p:spPr>
-          <a:xfrm>
-            <a:off x="6163056" y="1325880"/>
-            <a:ext cx="5477256" cy="1278026"/>
-          </a:xfrm>
-          <a:prstGeom prst="rect">
-            <a:avLst/>
-          </a:prstGeom>
-        </p:spPr>
-      </p:pic>
-      <p:sp>
-        <p:nvSpPr>
-          <p:cNvPr id="5" name="gallery caption"/>
-          <p:cNvSpPr txBox="1"/>
-          <p:nvPr/>
-        </p:nvSpPr>
-        <p:spPr>
-          <a:xfrm>
-            <a:off x="548640" y="2633472"/>
-            <a:ext cx="11091672" cy="365760"/>
-          </a:xfrm>
-          <a:prstGeom prst="rect">
-            <a:avLst/>
-          </a:prstGeom>
-          <a:noFill/>
-          <a:ln/>
-        </p:spPr>
-        <p:txBody>
-          <a:bodyPr wrap="square" lIns="0" tIns="0" rIns="0" bIns="0" rtlCol="0" anchor="t"/>
-          <a:lstStyle/>
-          <a:p>
-            <a:pPr indent="0" marL="0">
-              <a:buNone/>
-            </a:pPr>
-            <a:r>
-              <a:rPr lang="en-US" sz="1100" dirty="0">
-                <a:solidFill>
-                  <a:srgbClr val="52514E"/>
-                </a:solidFill>
-              </a:rPr>
-              <a:t>One benchmark context per tier, C1 to C8; dashed rings are insulation. Within a tier, kinds, trades, surfaces and stacking all vary: the element count is the one controlled axis of difficulty.</a:t>
-            </a:r>
-            <a:endParaRPr lang="en-US" sz="1100" dirty="0"/>
-          </a:p>
-        </p:txBody>
-      </p:sp>
       <p:graphicFrame>
         <p:nvGraphicFramePr>
-          <p:cNvPr id="6" name="load chart" descr=""/>
+          <p:cNvPr id="3" name="load chart" descr=""/>
           <p:cNvGraphicFramePr/>
           <p:nvPr/>
         </p:nvGraphicFramePr>
         <p:xfrm>
-          <a:off x="548640" y="3063240"/>
-          <a:ext cx="5440680" cy="2697480"/>
+          <a:off x="548640" y="1325880"/>
+          <a:ext cx="5440680" cy="4343400"/>
         </p:xfrm>
         <a:graphic xmlns:a="http://schemas.openxmlformats.org/drawingml/2006/main">
           <a:graphicData uri="http://schemas.openxmlformats.org/drawingml/2006/chart">
-            <c:chart xmlns:c="http://schemas.openxmlformats.org/drawingml/2006/chart" r:id="rId3"/>
+            <c:chart xmlns:c="http://schemas.openxmlformats.org/drawingml/2006/chart" r:id="rId1"/>
           </a:graphicData>
         </a:graphic>
       </p:graphicFrame>
       <p:graphicFrame>
         <p:nvGraphicFramePr>
-          <p:cNvPr id="7" name="gap chart" descr=""/>
+          <p:cNvPr id="4" name="gap chart" descr=""/>
           <p:cNvGraphicFramePr/>
           <p:nvPr/>
         </p:nvGraphicFramePr>
         <p:xfrm>
-          <a:off x="6199632" y="3063240"/>
-          <a:ext cx="5440680" cy="2697480"/>
+          <a:off x="6199632" y="1325880"/>
+          <a:ext cx="5440680" cy="4343400"/>
         </p:xfrm>
         <a:graphic xmlns:a="http://schemas.openxmlformats.org/drawingml/2006/main">
           <a:graphicData uri="http://schemas.openxmlformats.org/drawingml/2006/chart">
-            <c:chart xmlns:c="http://schemas.openxmlformats.org/drawingml/2006/chart" r:id="rId4"/>
+            <c:chart xmlns:c="http://schemas.openxmlformats.org/drawingml/2006/chart" r:id="rId2"/>
           </a:graphicData>
         </a:graphic>
       </p:graphicFrame>
       <p:sp>
         <p:nvSpPr>
-          <p:cNvPr id="8" name="experiment 1 caption"/>
+          <p:cNvPr id="5" name="experiment 1 caption"/>
           <p:cNvSpPr txBox="1"/>
           <p:nvPr/>
         </p:nvSpPr>
         <p:spPr>
           <a:xfrm>
-            <a:off x="548640" y="5833872"/>
-            <a:ext cx="11091672" cy="457200"/>
+            <a:off x="548640" y="5760720"/>
+            <a:ext cx="11091672" cy="502920"/>
           </a:xfrm>
           <a:prstGeom prst="rect">
             <a:avLst/>
@@ -5548,14 +5464,14 @@
               <a:buNone/>
             </a:pPr>
             <a:r>
-              <a:rPr lang="en-US" sz="1050" dirty="0">
+              <a:rPr lang="en-US" sz="1100" dirty="0">
                 <a:solidFill>
                   <a:srgbClr val="52514E"/>
                 </a:solidFill>
               </a:rPr>
-              <a:t>A check that the dataset behaves as designed, not a discovery: the tier fixes the count; load and congestion follow from the rules. Load rises with the tier (rank correlation +0.46 on the benchmark; the population medians rise at every step) and the closest gap narrows at every step (−0.38). Bootstrap intervals in RESULTS.md.</a:t>
-            </a:r>
-            <a:endParaRPr lang="en-US" sz="1050" dirty="0"/>
+              <a:t>A check that the dataset behaves as designed, not a discovery: the tier fixes the element count; load and congestion follow from the rules. Within a tier, kinds, trades, surfaces and stacking all vary. Load rises with the tier (rank correlation +0.46 on the benchmark, 125 contexts per tier; the population medians rise at every step) and the closest gap narrows at every step (−0.38). Bootstrap intervals in RESULTS.md.</a:t>
+            </a:r>
+            <a:endParaRPr lang="en-US" sz="1100" dirty="0"/>
           </a:p>
         </p:txBody>
       </p:sp>

</xml_diff>

<commit_message>
Talk: Stanford and Hilti logos on the title and closing slides; slide text free of repository file names
</commit_message>
<xml_diff>
--- a/docs/CrossMEP_CIBW78_talk.pptx
+++ b/docs/CrossMEP_CIBW78_talk.pptx
@@ -122,12 +122,12 @@
   <p:extLst>
     <p:ext uri="{521415D9-36F7-43E2-AB2F-B90AF26B5E84}">
       <p14:sectionLst xmlns:p14="http://schemas.microsoft.com/office/powerpoint/2010/main">
-        <p14:section name="Opening" id="{0e1fd639-608e-b47d-3c59-0ef9051af9c2}">
+        <p14:section name="Opening" id="{faaf9419-616a-3718-a827-0243eac98725}">
           <p14:sldIdLst>
             <p14:sldId id="256"/>
           </p14:sldIdLst>
         </p14:section>
-        <p14:section name="Motivation" id="{c8eacdc9-d847-1290-5fbf-eb5a9e94c352}">
+        <p14:section name="Motivation" id="{03ea0c07-2e4e-674c-abb3-d1bc742d9927}">
           <p14:sldIdLst>
             <p14:sldId id="257"/>
             <p14:sldId id="258"/>
@@ -136,21 +136,21 @@
             <p14:sldId id="261"/>
           </p14:sldIdLst>
         </p14:section>
-        <p14:section name="The dataset" id="{8ed27c14-aae0-2cf3-0d0f-c06f4a3a7e1d}">
+        <p14:section name="The dataset" id="{2502ba28-70a2-cd3f-3037-bd3e1e2e64a6}">
           <p14:sldIdLst>
             <p14:sldId id="262"/>
             <p14:sldId id="263"/>
             <p14:sldId id="264"/>
           </p14:sldIdLst>
         </p14:section>
-        <p14:section name="Experiments" id="{42857e33-927d-9857-20e8-743db16664af}">
+        <p14:section name="Experiments" id="{44dda875-1ac8-626b-3595-89bb4f858c0d}">
           <p14:sldIdLst>
             <p14:sldId id="265"/>
             <p14:sldId id="266"/>
             <p14:sldId id="267"/>
           </p14:sldIdLst>
         </p14:section>
-        <p14:section name="Use" id="{0600379d-c32d-4930-f42c-77df7370adb1}">
+        <p14:section name="Use" id="{30794afb-42eb-ef0e-4d73-825858ec76b8}">
           <p14:sldIdLst>
             <p14:sldId id="268"/>
             <p14:sldId id="269"/>
@@ -3043,7 +3043,7 @@
           <a:p>
             <a:r>
               <a:rPr lang="en-US" dirty="0"/>
-              <a:t>Three analyses. The first is a design check. One benchmark context per tier: C1 is a single element, the most common support in any building; C8 has eight services on three rows. Within a tier everything else varies, so the element count is the one controlled axis. Load at the support rises with the tier, from about 0.3 to 2.0 kilonewtons, and the closest gap narrows at every step, from 130 to about 51 millimetres. The dataset behaves as designed. (4:00)</a:t>
+              <a:t>Three analyses. The first is a design check. Each tier adds one element: C1 is a single service, the most common support in any building; C8 has eight. Within a tier everything else varies, so the element count is the one controlled axis. Load at the support rises with the tier, from about 0.3 to 2.0 kilonewtons, and the closest gap narrows at every step, from 130 to about 51 millimetres. The dataset behaves as designed. (4:00)</a:t>
             </a:r>
             <a:endParaRPr lang="en-US" dirty="0"/>
           </a:p>
@@ -5344,6 +5344,76 @@
           </a:p>
         </p:txBody>
       </p:sp>
+      <p:sp>
+        <p:nvSpPr>
+          <p:cNvPr id="7" name="logo chip"/>
+          <p:cNvSpPr/>
+          <p:nvPr/>
+        </p:nvSpPr>
+        <p:spPr>
+          <a:xfrm>
+            <a:off x="8229600" y="4892040"/>
+            <a:ext cx="3566160" cy="1188720"/>
+          </a:xfrm>
+          <a:prstGeom prst="roundRect">
+            <a:avLst>
+              <a:gd name="adj" fmla="val 6154"/>
+            </a:avLst>
+          </a:prstGeom>
+          <a:solidFill>
+            <a:srgbClr val="FFFFFF"/>
+          </a:solidFill>
+          <a:ln/>
+        </p:spPr>
+      </p:sp>
+      <p:pic>
+        <p:nvPicPr>
+          <p:cNvPr id="8" name="logo stanford" descr="preencoded.png">    </p:cNvPr>
+          <p:cNvPicPr>
+            <a:picLocks noChangeAspect="1"/>
+          </p:cNvPicPr>
+          <p:nvPr/>
+        </p:nvPicPr>
+        <p:blipFill>
+          <a:blip r:embed="rId2"/>
+          <a:stretch>
+            <a:fillRect/>
+          </a:stretch>
+        </p:blipFill>
+        <p:spPr>
+          <a:xfrm>
+            <a:off x="8412480" y="5078476"/>
+            <a:ext cx="2011680" cy="815848"/>
+          </a:xfrm>
+          <a:prstGeom prst="rect">
+            <a:avLst/>
+          </a:prstGeom>
+        </p:spPr>
+      </p:pic>
+      <p:pic>
+        <p:nvPicPr>
+          <p:cNvPr id="9" name="logo hilti" descr="preencoded.png">    </p:cNvPr>
+          <p:cNvPicPr>
+            <a:picLocks noChangeAspect="1"/>
+          </p:cNvPicPr>
+          <p:nvPr/>
+        </p:nvPicPr>
+        <p:blipFill>
+          <a:blip r:embed="rId3"/>
+          <a:stretch>
+            <a:fillRect/>
+          </a:stretch>
+        </p:blipFill>
+        <p:spPr>
+          <a:xfrm>
+            <a:off x="10607040" y="5364189"/>
+            <a:ext cx="1005840" cy="244423"/>
+          </a:xfrm>
+          <a:prstGeom prst="rect">
+            <a:avLst/>
+          </a:prstGeom>
+        </p:spPr>
+      </p:pic>
     </p:spTree>
   </p:cSld>
   <p:clrMapOvr>
@@ -5469,7 +5539,7 @@
                   <a:srgbClr val="52514E"/>
                 </a:solidFill>
               </a:rPr>
-              <a:t>A check that the dataset behaves as designed, not a discovery: the tier fixes the element count; load and congestion follow from the rules. Within a tier, kinds, trades, surfaces and stacking all vary. Load rises with the tier (rank correlation +0.46 on the benchmark, 125 contexts per tier; the population medians rise at every step) and the closest gap narrows at every step (−0.38). Bootstrap intervals in RESULTS.md.</a:t>
+              <a:t>A check that the dataset behaves as designed, not a discovery: the tier fixes the element count; load and congestion follow from the rules. Within a tier, kinds, trades, surfaces and stacking all vary. Load rises with the tier (rank correlation +0.46 on the benchmark, 125 contexts per tier; the population medians rise at every step) and the closest gap narrows at every step (−0.38); intervals are bootstrapped over contexts.</a:t>
             </a:r>
             <a:endParaRPr lang="en-US" sz="1100" dirty="0"/>
           </a:p>
@@ -8216,7 +8286,7 @@
                   <a:srgbClr val="52514E"/>
                 </a:solidFill>
               </a:rPr>
-              <a:t>Loading, metrics and scoring need only the Python standard library; the generator needs NumPy. Command line: python -m crossmep generate | validate | evaluate.</a:t>
+              <a:t>Loading, metrics and scoring need only the Python standard library; the generator needs NumPy.</a:t>
             </a:r>
             <a:endParaRPr lang="en-US" sz="1100" dirty="0"/>
           </a:p>
@@ -8720,7 +8790,7 @@
                   <a:srgbClr val="52514E"/>
                 </a:solidFill>
               </a:rPr>
-              <a:t>7,000 contexts, 31,484 elements; tiers assigned round-robin. Plain JSON with a JSON Schema, Croissant metadata and a datasheet.</a:t>
+              <a:t>7,000 contexts, 31,484 elements; tiers assigned round-robin. Plain JSON files with a schema and a datasheet.</a:t>
             </a:r>
             <a:endParaRPr lang="en-US" sz="1100" dirty="0"/>
           </a:p>
@@ -9465,7 +9535,7 @@
                   <a:schemeClr val="bg1"/>
                 </a:solidFill>
               </a:rPr>
-              <a:t>open the gallery, filter for the scenes you know, and tell us what looks wrong. Every rule is one documented constant away from being changed.</a:t>
+              <a:t>open the studio, generate the sections you know from your projects, and tell us what looks wrong. Every rule is one documented constant away from being changed.</a:t>
             </a:r>
             <a:endParaRPr lang="en-US" sz="1500" dirty="0"/>
           </a:p>
@@ -9709,7 +9779,77 @@
       </p:pic>
       <p:sp>
         <p:nvSpPr>
-          <p:cNvPr id="5" name="closing link"/>
+          <p:cNvPr id="5" name="logo chip"/>
+          <p:cNvSpPr/>
+          <p:nvPr/>
+        </p:nvSpPr>
+        <p:spPr>
+          <a:xfrm>
+            <a:off x="8229600" y="4892040"/>
+            <a:ext cx="3566160" cy="1188720"/>
+          </a:xfrm>
+          <a:prstGeom prst="roundRect">
+            <a:avLst>
+              <a:gd name="adj" fmla="val 6154"/>
+            </a:avLst>
+          </a:prstGeom>
+          <a:solidFill>
+            <a:srgbClr val="FFFFFF"/>
+          </a:solidFill>
+          <a:ln/>
+        </p:spPr>
+      </p:sp>
+      <p:pic>
+        <p:nvPicPr>
+          <p:cNvPr id="6" name="logo stanford" descr="preencoded.png">    </p:cNvPr>
+          <p:cNvPicPr>
+            <a:picLocks noChangeAspect="1"/>
+          </p:cNvPicPr>
+          <p:nvPr/>
+        </p:nvPicPr>
+        <p:blipFill>
+          <a:blip r:embed="rId2"/>
+          <a:stretch>
+            <a:fillRect/>
+          </a:stretch>
+        </p:blipFill>
+        <p:spPr>
+          <a:xfrm>
+            <a:off x="8412480" y="5078476"/>
+            <a:ext cx="2011680" cy="815848"/>
+          </a:xfrm>
+          <a:prstGeom prst="rect">
+            <a:avLst/>
+          </a:prstGeom>
+        </p:spPr>
+      </p:pic>
+      <p:pic>
+        <p:nvPicPr>
+          <p:cNvPr id="7" name="logo hilti" descr="preencoded.png">    </p:cNvPr>
+          <p:cNvPicPr>
+            <a:picLocks noChangeAspect="1"/>
+          </p:cNvPicPr>
+          <p:nvPr/>
+        </p:nvPicPr>
+        <p:blipFill>
+          <a:blip r:embed="rId3"/>
+          <a:stretch>
+            <a:fillRect/>
+          </a:stretch>
+        </p:blipFill>
+        <p:spPr>
+          <a:xfrm>
+            <a:off x="10607040" y="5364189"/>
+            <a:ext cx="1005840" cy="244423"/>
+          </a:xfrm>
+          <a:prstGeom prst="rect">
+            <a:avLst/>
+          </a:prstGeom>
+        </p:spPr>
+      </p:pic>
+      <p:sp>
+        <p:nvSpPr>
+          <p:cNvPr id="8" name="closing link"/>
           <p:cNvSpPr txBox="1"/>
           <p:nvPr/>
         </p:nvSpPr>
@@ -27349,7 +27489,7 @@
                   <a:srgbClr val="52514E"/>
                 </a:solidFill>
               </a:rPr>
-              <a:t>Every constant carries its source and status in the repository; the verification log says why each standard was chosen over its alternatives.</a:t>
+              <a:t>Every constant carries its source and its status, and why each standard was chosen over its alternatives is written down with it.</a:t>
             </a:r>
             <a:endParaRPr lang="en-US" sz="1100" dirty="0"/>
           </a:p>

</xml_diff>

<commit_message>
Talk: slide 14 as the evaluation protocol flow; slide 15 scope and next as icon rows
Co-Authored-By: Claude Fable 5.1 <noreply@anthropic.com>
Claude-Session: https://claude.ai/code/session_01R1ft1rokeRJHR95rzLxNEC
</commit_message>
<xml_diff>
--- a/docs/CrossMEP_CIBW78_talk.pptx
+++ b/docs/CrossMEP_CIBW78_talk.pptx
@@ -122,12 +122,12 @@
   <p:extLst>
     <p:ext uri="{521415D9-36F7-43E2-AB2F-B90AF26B5E84}">
       <p14:sectionLst xmlns:p14="http://schemas.microsoft.com/office/powerpoint/2010/main">
-        <p14:section name="Opening" id="{faaf9419-616a-3718-a827-0243eac98725}">
+        <p14:section name="Opening" id="{4a2f424f-0723-c449-6e2b-aa9637e6fde2}">
           <p14:sldIdLst>
             <p14:sldId id="256"/>
           </p14:sldIdLst>
         </p14:section>
-        <p14:section name="Motivation" id="{03ea0c07-2e4e-674c-abb3-d1bc742d9927}">
+        <p14:section name="Motivation" id="{cfe50742-5deb-0cd2-b9cf-f86289aa5705}">
           <p14:sldIdLst>
             <p14:sldId id="257"/>
             <p14:sldId id="258"/>
@@ -136,21 +136,21 @@
             <p14:sldId id="261"/>
           </p14:sldIdLst>
         </p14:section>
-        <p14:section name="The dataset" id="{2502ba28-70a2-cd3f-3037-bd3e1e2e64a6}">
+        <p14:section name="The dataset" id="{fb6af2f3-a69a-ad52-76cd-dfd3d4d21a36}">
           <p14:sldIdLst>
             <p14:sldId id="262"/>
             <p14:sldId id="263"/>
             <p14:sldId id="264"/>
           </p14:sldIdLst>
         </p14:section>
-        <p14:section name="Experiments" id="{44dda875-1ac8-626b-3595-89bb4f858c0d}">
+        <p14:section name="Experiments" id="{66b94019-a4a9-e554-3753-0dd9b3dc3202}">
           <p14:sldIdLst>
             <p14:sldId id="265"/>
             <p14:sldId id="266"/>
             <p14:sldId id="267"/>
           </p14:sldIdLst>
         </p14:section>
-        <p14:section name="Use" id="{30794afb-42eb-ef0e-4d73-825858ec76b8}">
+        <p14:section name="Use" id="{4efdd699-8dac-8f94-a5ee-8735819e960b}">
           <p14:sldIdLst>
             <p14:sldId id="268"/>
             <p14:sldId id="269"/>
@@ -8053,21 +8053,753 @@
       </p:sp>
       <p:sp>
         <p:nvSpPr>
-          <p:cNvPr id="3" name="code card"/>
-          <p:cNvSpPr/>
-          <p:nvPr/>
-        </p:nvSpPr>
-        <p:spPr>
-          <a:xfrm>
-            <a:off x="548640" y="1417320"/>
-            <a:ext cx="5486400" cy="1874520"/>
+          <p:cNvPr id="3" name="flow Generator"/>
+          <p:cNvSpPr/>
+          <p:nvPr/>
+        </p:nvSpPr>
+        <p:spPr>
+          <a:xfrm>
+            <a:off x="548640" y="1371600"/>
+            <a:ext cx="2286000" cy="2057400"/>
           </a:xfrm>
           <a:prstGeom prst="roundRect">
             <a:avLst>
-              <a:gd name="adj" fmla="val 3415"/>
+              <a:gd name="adj" fmla="val 3111"/>
             </a:avLst>
           </a:prstGeom>
           <a:solidFill>
+            <a:schemeClr val="bg2"/>
+          </a:solidFill>
+          <a:ln/>
+        </p:spPr>
+      </p:sp>
+      <p:sp>
+        <p:nvSpPr>
+          <p:cNvPr id="4" name="icon ring flow Generator"/>
+          <p:cNvSpPr/>
+          <p:nvPr/>
+        </p:nvSpPr>
+        <p:spPr>
+          <a:xfrm>
+            <a:off x="777240" y="1600200"/>
+            <a:ext cx="548640" cy="548640"/>
+          </a:xfrm>
+          <a:prstGeom prst="ellipse">
+            <a:avLst/>
+          </a:prstGeom>
+          <a:solidFill>
+            <a:schemeClr val="accent1"/>
+          </a:solidFill>
+          <a:ln/>
+        </p:spPr>
+      </p:sp>
+      <p:pic>
+        <p:nvPicPr>
+          <p:cNvPr id="5" name="icon flow Generator" descr="preencoded.png">    </p:cNvPr>
+          <p:cNvPicPr>
+            <a:picLocks noChangeAspect="1"/>
+          </p:cNvPicPr>
+          <p:nvPr/>
+        </p:nvPicPr>
+        <p:blipFill>
+          <a:blip r:embed="rId1"/>
+          <a:stretch>
+            <a:fillRect/>
+          </a:stretch>
+        </p:blipFill>
+        <p:spPr>
+          <a:xfrm>
+            <a:off x="892454" y="1715414"/>
+            <a:ext cx="318211" cy="318211"/>
+          </a:xfrm>
+          <a:prstGeom prst="rect">
+            <a:avLst/>
+          </a:prstGeom>
+        </p:spPr>
+      </p:pic>
+      <p:sp>
+        <p:nvSpPr>
+          <p:cNvPr id="6" name="flow head Generator"/>
+          <p:cNvSpPr txBox="1"/>
+          <p:nvPr/>
+        </p:nvSpPr>
+        <p:spPr>
+          <a:xfrm>
+            <a:off x="1463040" y="1600200"/>
+            <a:ext cx="1188720" cy="548640"/>
+          </a:xfrm>
+          <a:prstGeom prst="rect">
+            <a:avLst/>
+          </a:prstGeom>
+          <a:noFill/>
+          <a:ln/>
+        </p:spPr>
+        <p:txBody>
+          <a:bodyPr wrap="square" lIns="0" tIns="0" rIns="0" bIns="0" rtlCol="0" anchor="ctr"/>
+          <a:lstStyle/>
+          <a:p>
+            <a:pPr indent="0" marL="0">
+              <a:buNone/>
+            </a:pPr>
+            <a:r>
+              <a:rPr lang="en-US" sz="1600" b="1" dirty="0">
+                <a:solidFill>
+                  <a:schemeClr val="tx1"/>
+                </a:solidFill>
+              </a:rPr>
+              <a:t>Generator</a:t>
+            </a:r>
+            <a:endParaRPr lang="en-US" sz="1600" dirty="0"/>
+          </a:p>
+        </p:txBody>
+      </p:sp>
+      <p:sp>
+        <p:nvSpPr>
+          <p:cNvPr id="7" name="flow text Generator"/>
+          <p:cNvSpPr txBox="1"/>
+          <p:nvPr/>
+        </p:nvSpPr>
+        <p:spPr>
+          <a:xfrm>
+            <a:off x="777240" y="2286000"/>
+            <a:ext cx="1828800" cy="1005840"/>
+          </a:xfrm>
+          <a:prstGeom prst="rect">
+            <a:avLst/>
+          </a:prstGeom>
+          <a:noFill/>
+          <a:ln/>
+        </p:spPr>
+        <p:txBody>
+          <a:bodyPr wrap="square" lIns="0" tIns="0" rIns="0" bIns="0" rtlCol="0" anchor="t"/>
+          <a:lstStyle/>
+          <a:p>
+            <a:pPr indent="0" marL="0">
+              <a:buNone/>
+            </a:pPr>
+            <a:r>
+              <a:rPr lang="en-US" sz="1200" dirty="0">
+                <a:solidFill>
+                  <a:schemeClr val="tx1"/>
+                </a:solidFill>
+              </a:rPr>
+              <a:t>unlimited problems: a new seed is a new set; a curriculum from C1 up to C8</a:t>
+            </a:r>
+            <a:endParaRPr lang="en-US" sz="1200" dirty="0"/>
+          </a:p>
+        </p:txBody>
+      </p:sp>
+      <p:sp>
+        <p:nvSpPr>
+          <p:cNvPr id="8" name="flow arrow 0"/>
+          <p:cNvSpPr/>
+          <p:nvPr/>
+        </p:nvSpPr>
+        <p:spPr>
+          <a:xfrm>
+            <a:off x="2880360" y="1874520"/>
+            <a:ext cx="557784" cy="0"/>
+          </a:xfrm>
+          <a:prstGeom prst="line">
+            <a:avLst/>
+          </a:prstGeom>
+          <a:noFill/>
+          <a:ln w="19050">
+            <a:solidFill>
+              <a:srgbClr val="52514E"/>
+            </a:solidFill>
+            <a:prstDash val="solid"/>
+            <a:tailEnd type="triangle"/>
+          </a:ln>
+        </p:spPr>
+      </p:sp>
+      <p:sp>
+        <p:nvSpPr>
+          <p:cNvPr id="9" name="flow link 0"/>
+          <p:cNvSpPr txBox="1"/>
+          <p:nvPr/>
+        </p:nvSpPr>
+        <p:spPr>
+          <a:xfrm>
+            <a:off x="2606040" y="1920240"/>
+            <a:ext cx="1106424" cy="228600"/>
+          </a:xfrm>
+          <a:prstGeom prst="rect">
+            <a:avLst/>
+          </a:prstGeom>
+          <a:noFill/>
+          <a:ln/>
+        </p:spPr>
+        <p:txBody>
+          <a:bodyPr wrap="square" lIns="0" tIns="0" rIns="0" bIns="0" rtlCol="0" anchor="ctr"/>
+          <a:lstStyle/>
+          <a:p>
+            <a:pPr algn="ctr" indent="0" marL="0">
+              <a:buNone/>
+            </a:pPr>
+            <a:r>
+              <a:rPr lang="en-US" sz="950" dirty="0">
+                <a:solidFill>
+                  <a:srgbClr val="52514E"/>
+                </a:solidFill>
+              </a:rPr>
+              <a:t>train on</a:t>
+            </a:r>
+            <a:endParaRPr lang="en-US" sz="950" dirty="0"/>
+          </a:p>
+        </p:txBody>
+      </p:sp>
+      <p:sp>
+        <p:nvSpPr>
+          <p:cNvPr id="10" name="flow Train"/>
+          <p:cNvSpPr/>
+          <p:nvPr/>
+        </p:nvSpPr>
+        <p:spPr>
+          <a:xfrm>
+            <a:off x="3483864" y="1371600"/>
+            <a:ext cx="2286000" cy="2057400"/>
+          </a:xfrm>
+          <a:prstGeom prst="roundRect">
+            <a:avLst>
+              <a:gd name="adj" fmla="val 3111"/>
+            </a:avLst>
+          </a:prstGeom>
+          <a:solidFill>
+            <a:schemeClr val="bg2"/>
+          </a:solidFill>
+          <a:ln/>
+        </p:spPr>
+      </p:sp>
+      <p:sp>
+        <p:nvSpPr>
+          <p:cNvPr id="11" name="icon ring flow Train"/>
+          <p:cNvSpPr/>
+          <p:nvPr/>
+        </p:nvSpPr>
+        <p:spPr>
+          <a:xfrm>
+            <a:off x="3712464" y="1600200"/>
+            <a:ext cx="548640" cy="548640"/>
+          </a:xfrm>
+          <a:prstGeom prst="ellipse">
+            <a:avLst/>
+          </a:prstGeom>
+          <a:solidFill>
+            <a:schemeClr val="accent1"/>
+          </a:solidFill>
+          <a:ln/>
+        </p:spPr>
+      </p:sp>
+      <p:pic>
+        <p:nvPicPr>
+          <p:cNvPr id="12" name="icon flow Train" descr="preencoded.png">    </p:cNvPr>
+          <p:cNvPicPr>
+            <a:picLocks noChangeAspect="1"/>
+          </p:cNvPicPr>
+          <p:nvPr/>
+        </p:nvPicPr>
+        <p:blipFill>
+          <a:blip r:embed="rId2"/>
+          <a:stretch>
+            <a:fillRect/>
+          </a:stretch>
+        </p:blipFill>
+        <p:spPr>
+          <a:xfrm>
+            <a:off x="3827678" y="1715414"/>
+            <a:ext cx="318211" cy="318211"/>
+          </a:xfrm>
+          <a:prstGeom prst="rect">
+            <a:avLst/>
+          </a:prstGeom>
+        </p:spPr>
+      </p:pic>
+      <p:sp>
+        <p:nvSpPr>
+          <p:cNvPr id="13" name="flow head Train"/>
+          <p:cNvSpPr txBox="1"/>
+          <p:nvPr/>
+        </p:nvSpPr>
+        <p:spPr>
+          <a:xfrm>
+            <a:off x="4398264" y="1600200"/>
+            <a:ext cx="1188720" cy="548640"/>
+          </a:xfrm>
+          <a:prstGeom prst="rect">
+            <a:avLst/>
+          </a:prstGeom>
+          <a:noFill/>
+          <a:ln/>
+        </p:spPr>
+        <p:txBody>
+          <a:bodyPr wrap="square" lIns="0" tIns="0" rIns="0" bIns="0" rtlCol="0" anchor="ctr"/>
+          <a:lstStyle/>
+          <a:p>
+            <a:pPr indent="0" marL="0">
+              <a:buNone/>
+            </a:pPr>
+            <a:r>
+              <a:rPr lang="en-US" sz="1600" b="1" dirty="0">
+                <a:solidFill>
+                  <a:schemeClr val="tx1"/>
+                </a:solidFill>
+              </a:rPr>
+              <a:t>Train</a:t>
+            </a:r>
+            <a:endParaRPr lang="en-US" sz="1600" dirty="0"/>
+          </a:p>
+        </p:txBody>
+      </p:sp>
+      <p:sp>
+        <p:nvSpPr>
+          <p:cNvPr id="14" name="flow text Train"/>
+          <p:cNvSpPr txBox="1"/>
+          <p:nvPr/>
+        </p:nvSpPr>
+        <p:spPr>
+          <a:xfrm>
+            <a:off x="3712464" y="2286000"/>
+            <a:ext cx="1828800" cy="1005840"/>
+          </a:xfrm>
+          <a:prstGeom prst="rect">
+            <a:avLst/>
+          </a:prstGeom>
+          <a:noFill/>
+          <a:ln/>
+        </p:spPr>
+        <p:txBody>
+          <a:bodyPr wrap="square" lIns="0" tIns="0" rIns="0" bIns="0" rtlCol="0" anchor="t"/>
+          <a:lstStyle/>
+          <a:p>
+            <a:pPr indent="0" marL="0">
+              <a:buNone/>
+            </a:pPr>
+            <a:r>
+              <a:rPr lang="en-US" sz="1200" dirty="0">
+                <a:solidFill>
+                  <a:schemeClr val="tx1"/>
+                </a:solidFill>
+              </a:rPr>
+              <a:t>5,000 contexts (seed 1000); validation 500, test 500, on their own seeds</a:t>
+            </a:r>
+            <a:endParaRPr lang="en-US" sz="1200" dirty="0"/>
+          </a:p>
+        </p:txBody>
+      </p:sp>
+      <p:sp>
+        <p:nvSpPr>
+          <p:cNvPr id="15" name="flow arrow 1"/>
+          <p:cNvSpPr/>
+          <p:nvPr/>
+        </p:nvSpPr>
+        <p:spPr>
+          <a:xfrm>
+            <a:off x="5815584" y="1874520"/>
+            <a:ext cx="557784" cy="0"/>
+          </a:xfrm>
+          <a:prstGeom prst="line">
+            <a:avLst/>
+          </a:prstGeom>
+          <a:noFill/>
+          <a:ln w="19050">
+            <a:solidFill>
+              <a:srgbClr val="52514E"/>
+            </a:solidFill>
+            <a:prstDash val="solid"/>
+            <a:tailEnd type="triangle"/>
+          </a:ln>
+        </p:spPr>
+      </p:sp>
+      <p:sp>
+        <p:nvSpPr>
+          <p:cNvPr id="16" name="flow link 1"/>
+          <p:cNvSpPr txBox="1"/>
+          <p:nvPr/>
+        </p:nvSpPr>
+        <p:spPr>
+          <a:xfrm>
+            <a:off x="5541264" y="1920240"/>
+            <a:ext cx="1106424" cy="228600"/>
+          </a:xfrm>
+          <a:prstGeom prst="rect">
+            <a:avLst/>
+          </a:prstGeom>
+          <a:noFill/>
+          <a:ln/>
+        </p:spPr>
+        <p:txBody>
+          <a:bodyPr wrap="square" lIns="0" tIns="0" rIns="0" bIns="0" rtlCol="0" anchor="ctr"/>
+          <a:lstStyle/>
+          <a:p>
+            <a:pPr algn="ctr" indent="0" marL="0">
+              <a:buNone/>
+            </a:pPr>
+            <a:r>
+              <a:rPr lang="en-US" sz="950" dirty="0">
+                <a:solidFill>
+                  <a:srgbClr val="52514E"/>
+                </a:solidFill>
+              </a:rPr>
+              <a:t>evaluate on</a:t>
+            </a:r>
+            <a:endParaRPr lang="en-US" sz="950" dirty="0"/>
+          </a:p>
+        </p:txBody>
+      </p:sp>
+      <p:sp>
+        <p:nvSpPr>
+          <p:cNvPr id="17" name="flow Benchmark"/>
+          <p:cNvSpPr/>
+          <p:nvPr/>
+        </p:nvSpPr>
+        <p:spPr>
+          <a:xfrm>
+            <a:off x="6419088" y="1371600"/>
+            <a:ext cx="2286000" cy="2057400"/>
+          </a:xfrm>
+          <a:prstGeom prst="roundRect">
+            <a:avLst>
+              <a:gd name="adj" fmla="val 3111"/>
+            </a:avLst>
+          </a:prstGeom>
+          <a:solidFill>
+            <a:schemeClr val="bg2"/>
+          </a:solidFill>
+          <a:ln/>
+        </p:spPr>
+      </p:sp>
+      <p:sp>
+        <p:nvSpPr>
+          <p:cNvPr id="18" name="icon ring flow Benchmark"/>
+          <p:cNvSpPr/>
+          <p:nvPr/>
+        </p:nvSpPr>
+        <p:spPr>
+          <a:xfrm>
+            <a:off x="6647688" y="1600200"/>
+            <a:ext cx="548640" cy="548640"/>
+          </a:xfrm>
+          <a:prstGeom prst="ellipse">
+            <a:avLst/>
+          </a:prstGeom>
+          <a:solidFill>
+            <a:schemeClr val="accent1"/>
+          </a:solidFill>
+          <a:ln/>
+        </p:spPr>
+      </p:sp>
+      <p:pic>
+        <p:nvPicPr>
+          <p:cNvPr id="19" name="icon flow Benchmark" descr="preencoded.png">    </p:cNvPr>
+          <p:cNvPicPr>
+            <a:picLocks noChangeAspect="1"/>
+          </p:cNvPicPr>
+          <p:nvPr/>
+        </p:nvPicPr>
+        <p:blipFill>
+          <a:blip r:embed="rId3"/>
+          <a:stretch>
+            <a:fillRect/>
+          </a:stretch>
+        </p:blipFill>
+        <p:spPr>
+          <a:xfrm>
+            <a:off x="6762902" y="1715414"/>
+            <a:ext cx="318211" cy="318211"/>
+          </a:xfrm>
+          <a:prstGeom prst="rect">
+            <a:avLst/>
+          </a:prstGeom>
+        </p:spPr>
+      </p:pic>
+      <p:sp>
+        <p:nvSpPr>
+          <p:cNvPr id="20" name="flow head Benchmark"/>
+          <p:cNvSpPr txBox="1"/>
+          <p:nvPr/>
+        </p:nvSpPr>
+        <p:spPr>
+          <a:xfrm>
+            <a:off x="7333488" y="1600200"/>
+            <a:ext cx="1188720" cy="548640"/>
+          </a:xfrm>
+          <a:prstGeom prst="rect">
+            <a:avLst/>
+          </a:prstGeom>
+          <a:noFill/>
+          <a:ln/>
+        </p:spPr>
+        <p:txBody>
+          <a:bodyPr wrap="square" lIns="0" tIns="0" rIns="0" bIns="0" rtlCol="0" anchor="ctr"/>
+          <a:lstStyle/>
+          <a:p>
+            <a:pPr indent="0" marL="0">
+              <a:buNone/>
+            </a:pPr>
+            <a:r>
+              <a:rPr lang="en-US" sz="1600" b="1" dirty="0">
+                <a:solidFill>
+                  <a:schemeClr val="tx1"/>
+                </a:solidFill>
+              </a:rPr>
+              <a:t>Benchmark</a:t>
+            </a:r>
+            <a:endParaRPr lang="en-US" sz="1600" dirty="0"/>
+          </a:p>
+        </p:txBody>
+      </p:sp>
+      <p:sp>
+        <p:nvSpPr>
+          <p:cNvPr id="21" name="flow text Benchmark"/>
+          <p:cNvSpPr txBox="1"/>
+          <p:nvPr/>
+        </p:nvSpPr>
+        <p:spPr>
+          <a:xfrm>
+            <a:off x="6647688" y="2286000"/>
+            <a:ext cx="1828800" cy="1005840"/>
+          </a:xfrm>
+          <a:prstGeom prst="rect">
+            <a:avLst/>
+          </a:prstGeom>
+          <a:noFill/>
+          <a:ln/>
+        </p:spPr>
+        <p:txBody>
+          <a:bodyPr wrap="square" lIns="0" tIns="0" rIns="0" bIns="0" rtlCol="0" anchor="t"/>
+          <a:lstStyle/>
+          <a:p>
+            <a:pPr indent="0" marL="0">
+              <a:buNone/>
+            </a:pPr>
+            <a:r>
+              <a:rPr lang="en-US" sz="1200" dirty="0">
+                <a:solidFill>
+                  <a:schemeClr val="tx1"/>
+                </a:solidFill>
+              </a:rPr>
+              <a:t>1,000 contexts, 125 per tier, seed 42: never trained on, the same for every method</a:t>
+            </a:r>
+            <a:endParaRPr lang="en-US" sz="1200" dirty="0"/>
+          </a:p>
+        </p:txBody>
+      </p:sp>
+      <p:sp>
+        <p:nvSpPr>
+          <p:cNvPr id="22" name="flow arrow 2"/>
+          <p:cNvSpPr/>
+          <p:nvPr/>
+        </p:nvSpPr>
+        <p:spPr>
+          <a:xfrm>
+            <a:off x="8750808" y="1874520"/>
+            <a:ext cx="557784" cy="0"/>
+          </a:xfrm>
+          <a:prstGeom prst="line">
+            <a:avLst/>
+          </a:prstGeom>
+          <a:noFill/>
+          <a:ln w="19050">
+            <a:solidFill>
+              <a:srgbClr val="52514E"/>
+            </a:solidFill>
+            <a:prstDash val="solid"/>
+            <a:tailEnd type="triangle"/>
+          </a:ln>
+        </p:spPr>
+      </p:sp>
+      <p:sp>
+        <p:nvSpPr>
+          <p:cNvPr id="23" name="flow link 2"/>
+          <p:cNvSpPr txBox="1"/>
+          <p:nvPr/>
+        </p:nvSpPr>
+        <p:spPr>
+          <a:xfrm>
+            <a:off x="8476488" y="1920240"/>
+            <a:ext cx="1106424" cy="228600"/>
+          </a:xfrm>
+          <a:prstGeom prst="rect">
+            <a:avLst/>
+          </a:prstGeom>
+          <a:noFill/>
+          <a:ln/>
+        </p:spPr>
+        <p:txBody>
+          <a:bodyPr wrap="square" lIns="0" tIns="0" rIns="0" bIns="0" rtlCol="0" anchor="ctr"/>
+          <a:lstStyle/>
+          <a:p>
+            <a:pPr algn="ctr" indent="0" marL="0">
+              <a:buNone/>
+            </a:pPr>
+            <a:r>
+              <a:rPr lang="en-US" sz="950" dirty="0">
+                <a:solidFill>
+                  <a:srgbClr val="52514E"/>
+                </a:solidFill>
+              </a:rPr>
+              <a:t>then</a:t>
+            </a:r>
+            <a:endParaRPr lang="en-US" sz="950" dirty="0"/>
+          </a:p>
+        </p:txBody>
+      </p:sp>
+      <p:sp>
+        <p:nvSpPr>
+          <p:cNvPr id="24" name="flow Report"/>
+          <p:cNvSpPr/>
+          <p:nvPr/>
+        </p:nvSpPr>
+        <p:spPr>
+          <a:xfrm>
+            <a:off x="9354312" y="1371600"/>
+            <a:ext cx="2286000" cy="2057400"/>
+          </a:xfrm>
+          <a:prstGeom prst="roundRect">
+            <a:avLst>
+              <a:gd name="adj" fmla="val 3111"/>
+            </a:avLst>
+          </a:prstGeom>
+          <a:solidFill>
+            <a:schemeClr val="bg2"/>
+          </a:solidFill>
+          <a:ln/>
+        </p:spPr>
+      </p:sp>
+      <p:sp>
+        <p:nvSpPr>
+          <p:cNvPr id="25" name="icon ring flow Report"/>
+          <p:cNvSpPr/>
+          <p:nvPr/>
+        </p:nvSpPr>
+        <p:spPr>
+          <a:xfrm>
+            <a:off x="9582912" y="1600200"/>
+            <a:ext cx="548640" cy="548640"/>
+          </a:xfrm>
+          <a:prstGeom prst="ellipse">
+            <a:avLst/>
+          </a:prstGeom>
+          <a:solidFill>
+            <a:schemeClr val="accent1"/>
+          </a:solidFill>
+          <a:ln/>
+        </p:spPr>
+      </p:sp>
+      <p:pic>
+        <p:nvPicPr>
+          <p:cNvPr id="26" name="icon flow Report" descr="preencoded.png">    </p:cNvPr>
+          <p:cNvPicPr>
+            <a:picLocks noChangeAspect="1"/>
+          </p:cNvPicPr>
+          <p:nvPr/>
+        </p:nvPicPr>
+        <p:blipFill>
+          <a:blip r:embed="rId4"/>
+          <a:stretch>
+            <a:fillRect/>
+          </a:stretch>
+        </p:blipFill>
+        <p:spPr>
+          <a:xfrm>
+            <a:off x="9698126" y="1715414"/>
+            <a:ext cx="318211" cy="318211"/>
+          </a:xfrm>
+          <a:prstGeom prst="rect">
+            <a:avLst/>
+          </a:prstGeom>
+        </p:spPr>
+      </p:pic>
+      <p:sp>
+        <p:nvSpPr>
+          <p:cNvPr id="27" name="flow head Report"/>
+          <p:cNvSpPr txBox="1"/>
+          <p:nvPr/>
+        </p:nvSpPr>
+        <p:spPr>
+          <a:xfrm>
+            <a:off x="10268712" y="1600200"/>
+            <a:ext cx="1188720" cy="548640"/>
+          </a:xfrm>
+          <a:prstGeom prst="rect">
+            <a:avLst/>
+          </a:prstGeom>
+          <a:noFill/>
+          <a:ln/>
+        </p:spPr>
+        <p:txBody>
+          <a:bodyPr wrap="square" lIns="0" tIns="0" rIns="0" bIns="0" rtlCol="0" anchor="ctr"/>
+          <a:lstStyle/>
+          <a:p>
+            <a:pPr indent="0" marL="0">
+              <a:buNone/>
+            </a:pPr>
+            <a:r>
+              <a:rPr lang="en-US" sz="1600" b="1" dirty="0">
+                <a:solidFill>
+                  <a:schemeClr val="tx1"/>
+                </a:solidFill>
+              </a:rPr>
+              <a:t>Report</a:t>
+            </a:r>
+            <a:endParaRPr lang="en-US" sz="1600" dirty="0"/>
+          </a:p>
+        </p:txBody>
+      </p:sp>
+      <p:sp>
+        <p:nvSpPr>
+          <p:cNvPr id="28" name="flow text Report"/>
+          <p:cNvSpPr txBox="1"/>
+          <p:nvPr/>
+        </p:nvSpPr>
+        <p:spPr>
+          <a:xfrm>
+            <a:off x="9582912" y="2286000"/>
+            <a:ext cx="1828800" cy="1005840"/>
+          </a:xfrm>
+          <a:prstGeom prst="rect">
+            <a:avLst/>
+          </a:prstGeom>
+          <a:noFill/>
+          <a:ln/>
+        </p:spPr>
+        <p:txBody>
+          <a:bodyPr wrap="square" lIns="0" tIns="0" rIns="0" bIns="0" rtlCol="0" anchor="t"/>
+          <a:lstStyle/>
+          <a:p>
+            <a:pPr indent="0" marL="0">
+              <a:buNone/>
+            </a:pPr>
+            <a:r>
+              <a:rPr lang="en-US" sz="1200" dirty="0">
+                <a:solidFill>
+                  <a:schemeClr val="tx1"/>
+                </a:solidFill>
+              </a:rPr>
+              <a:t>per tier, with 95 % intervals and paired tests between methods</a:t>
+            </a:r>
+            <a:endParaRPr lang="en-US" sz="1200" dirty="0"/>
+          </a:p>
+        </p:txBody>
+      </p:sp>
+      <p:sp>
+        <p:nvSpPr>
+          <p:cNvPr id="29" name="code card"/>
+          <p:cNvSpPr/>
+          <p:nvPr/>
+        </p:nvSpPr>
+        <p:spPr>
+          <a:xfrm>
+            <a:off x="548640" y="3749040"/>
+            <a:ext cx="11091672" cy="1325880"/>
+          </a:xfrm>
+          <a:prstGeom prst="roundRect">
+            <a:avLst>
+              <a:gd name="adj" fmla="val 4828"/>
+            </a:avLst>
+          </a:prstGeom>
+          <a:solidFill>
             <a:schemeClr val="tx2"/>
           </a:solidFill>
           <a:ln/>
@@ -8075,14 +8807,14 @@
       </p:sp>
       <p:sp>
         <p:nvSpPr>
-          <p:cNvPr id="4" name="code"/>
+          <p:cNvPr id="30" name="code"/>
           <p:cNvSpPr txBox="1"/>
           <p:nvPr/>
         </p:nvSpPr>
         <p:spPr>
           <a:xfrm>
-            <a:off x="777240" y="1600200"/>
-            <a:ext cx="5029200" cy="1508760"/>
+            <a:off x="777240" y="3931920"/>
+            <a:ext cx="10634472" cy="960120"/>
           </a:xfrm>
           <a:prstGeom prst="rect">
             <a:avLst/>
@@ -8137,41 +8869,7 @@
                 <a:ea typeface="Courier New" pitchFamily="34" charset="-122"/>
                 <a:cs typeface="Courier New" pitchFamily="34" charset="-120"/>
               </a:rPr>
-              <a:t>  # 1,000 contexts</a:t>
-            </a:r>
-            <a:endParaRPr lang="en-US" sz="1300" dirty="0"/>
-          </a:p>
-          <a:p>
-            <a:pPr indent="0" marL="0">
-              <a:buNone/>
-            </a:pPr>
-            <a:r>
-              <a:rPr lang="en-US" sz="1300" dirty="0">
-                <a:solidFill>
-                  <a:srgbClr val="FFFFFF"/>
-                </a:solidFill>
-                <a:latin typeface="Courier New" pitchFamily="34" charset="0"/>
-                <a:ea typeface="Courier New" pitchFamily="34" charset="-122"/>
-                <a:cs typeface="Courier New" pitchFamily="34" charset="-120"/>
-              </a:rPr>
-              <a:t>cm.filter_contexts(data, pipes=2, trays=1)</a:t>
-            </a:r>
-            <a:endParaRPr lang="en-US" sz="1300" dirty="0"/>
-          </a:p>
-          <a:p>
-            <a:pPr indent="0" marL="0">
-              <a:buNone/>
-            </a:pPr>
-            <a:r>
-              <a:rPr lang="en-US" sz="1300" dirty="0">
-                <a:solidFill>
-                  <a:srgbClr val="FFFFFF"/>
-                </a:solidFill>
-                <a:latin typeface="Courier New" pitchFamily="34" charset="0"/>
-                <a:ea typeface="Courier New" pitchFamily="34" charset="-122"/>
-                <a:cs typeface="Courier New" pitchFamily="34" charset="-120"/>
-              </a:rPr>
-              <a:t> </a:t>
+              <a:t>  # 1,000 contexts, or generate your own mix</a:t>
             </a:r>
             <a:endParaRPr lang="en-US" sz="1300" dirty="0"/>
           </a:p>
@@ -8219,53 +8917,22 @@
                 <a:ea typeface="Courier New" pitchFamily="34" charset="-122"/>
                 <a:cs typeface="Courier New" pitchFamily="34" charset="-120"/>
               </a:rPr>
-              <a:t>  # per tier, 95 % CI</a:t>
+              <a:t>  # per tier, 95 % CI    compare(mine, baseline, data)  # paired test</a:t>
             </a:r>
             <a:endParaRPr lang="en-US" sz="1300" dirty="0"/>
           </a:p>
-          <a:p>
-            <a:pPr indent="0" marL="0">
-              <a:buNone/>
-            </a:pPr>
-            <a:r>
-              <a:rPr lang="en-US" sz="1300" dirty="0">
-                <a:solidFill>
-                  <a:srgbClr val="FFFFFF"/>
-                </a:solidFill>
-                <a:latin typeface="Courier New" pitchFamily="34" charset="0"/>
-                <a:ea typeface="Courier New" pitchFamily="34" charset="-122"/>
-                <a:cs typeface="Courier New" pitchFamily="34" charset="-120"/>
-              </a:rPr>
-              <a:t>compare(mine, baseline, data)</a:t>
-            </a:r>
-            <a:pPr indent="0" marL="0">
-              <a:buNone/>
-            </a:pPr>
-            <a:r>
-              <a:rPr lang="en-US" sz="1300" dirty="0">
-                <a:solidFill>
-                  <a:srgbClr val="CADCFC"/>
-                </a:solidFill>
-                <a:latin typeface="Courier New" pitchFamily="34" charset="0"/>
-                <a:ea typeface="Courier New" pitchFamily="34" charset="-122"/>
-                <a:cs typeface="Courier New" pitchFamily="34" charset="-120"/>
-              </a:rPr>
-              <a:t>  # paired test</a:t>
-            </a:r>
-            <a:endParaRPr lang="en-US" sz="1300" dirty="0"/>
-          </a:p>
         </p:txBody>
       </p:sp>
       <p:sp>
         <p:nvSpPr>
-          <p:cNvPr id="5" name="code caption"/>
+          <p:cNvPr id="31" name="code caption"/>
           <p:cNvSpPr txBox="1"/>
           <p:nvPr/>
         </p:nvSpPr>
         <p:spPr>
           <a:xfrm>
-            <a:off x="548640" y="3429000"/>
-            <a:ext cx="5486400" cy="548640"/>
+            <a:off x="548640" y="5212080"/>
+            <a:ext cx="11091672" cy="502920"/>
           </a:xfrm>
           <a:prstGeom prst="rect">
             <a:avLst/>
@@ -8281,800 +8948,14 @@
               <a:buNone/>
             </a:pPr>
             <a:r>
-              <a:rPr lang="en-US" sz="1100" dirty="0">
+              <a:rPr lang="en-US" sz="1150" dirty="0">
                 <a:solidFill>
                   <a:srgbClr val="52514E"/>
                 </a:solidFill>
               </a:rPr>
-              <a:t>Loading, metrics and scoring need only the Python standard library; the generator needs NumPy.</a:t>
-            </a:r>
-            <a:endParaRPr lang="en-US" sz="1100" dirty="0"/>
-          </a:p>
-        </p:txBody>
-      </p:sp>
-      <p:sp>
-        <p:nvSpPr>
-          <p:cNvPr id="6" name="splits heading"/>
-          <p:cNvSpPr txBox="1"/>
-          <p:nvPr/>
-        </p:nvSpPr>
-        <p:spPr>
-          <a:xfrm>
-            <a:off x="6355080" y="1417320"/>
-            <a:ext cx="5285232" cy="274320"/>
-          </a:xfrm>
-          <a:prstGeom prst="rect">
-            <a:avLst/>
-          </a:prstGeom>
-          <a:noFill/>
-          <a:ln/>
-        </p:spPr>
-        <p:txBody>
-          <a:bodyPr wrap="square" lIns="0" tIns="0" rIns="0" bIns="0" rtlCol="0" anchor="ctr"/>
-          <a:lstStyle/>
-          <a:p>
-            <a:pPr indent="0" marL="0">
-              <a:buNone/>
-            </a:pPr>
-            <a:r>
-              <a:rPr lang="en-US" sz="1250" b="1" dirty="0">
-                <a:solidFill>
-                  <a:schemeClr val="tx1"/>
-                </a:solidFill>
-              </a:rPr>
-              <a:t>Four splits on disjoint seeds; the test seeds are never trained on</a:t>
-            </a:r>
-            <a:endParaRPr lang="en-US" sz="1250" dirty="0"/>
-          </a:p>
-        </p:txBody>
-      </p:sp>
-      <p:sp>
-        <p:nvSpPr>
-          <p:cNvPr id="7" name="split train"/>
-          <p:cNvSpPr/>
-          <p:nvPr/>
-        </p:nvSpPr>
-        <p:spPr>
-          <a:xfrm>
-            <a:off x="6355080" y="1783080"/>
-            <a:ext cx="1239012" cy="1371600"/>
-          </a:xfrm>
-          <a:prstGeom prst="roundRect">
-            <a:avLst>
-              <a:gd name="adj" fmla="val 5166"/>
-            </a:avLst>
-          </a:prstGeom>
-          <a:solidFill>
-            <a:schemeClr val="bg2"/>
-          </a:solidFill>
-          <a:ln/>
-        </p:spPr>
-      </p:sp>
-      <p:sp>
-        <p:nvSpPr>
-          <p:cNvPr id="8" name="split count train"/>
-          <p:cNvSpPr txBox="1"/>
-          <p:nvPr/>
-        </p:nvSpPr>
-        <p:spPr>
-          <a:xfrm>
-            <a:off x="6464808" y="1847088"/>
-            <a:ext cx="1019556" cy="457200"/>
-          </a:xfrm>
-          <a:prstGeom prst="rect">
-            <a:avLst/>
-          </a:prstGeom>
-          <a:noFill/>
-          <a:ln/>
-        </p:spPr>
-        <p:txBody>
-          <a:bodyPr wrap="square" lIns="0" tIns="0" rIns="0" bIns="0" rtlCol="0" anchor="ctr"/>
-          <a:lstStyle/>
-          <a:p>
-            <a:pPr indent="0" marL="0">
-              <a:buNone/>
-            </a:pPr>
-            <a:r>
-              <a:rPr lang="en-US" sz="2200" b="1" dirty="0">
-                <a:solidFill>
-                  <a:schemeClr val="accent1"/>
-                </a:solidFill>
-              </a:rPr>
-              <a:t>5,000</a:t>
-            </a:r>
-            <a:endParaRPr lang="en-US" sz="2200" dirty="0"/>
-          </a:p>
-        </p:txBody>
-      </p:sp>
-      <p:sp>
-        <p:nvSpPr>
-          <p:cNvPr id="9" name="split label train"/>
-          <p:cNvSpPr txBox="1"/>
-          <p:nvPr/>
-        </p:nvSpPr>
-        <p:spPr>
-          <a:xfrm>
-            <a:off x="6464808" y="2331720"/>
-            <a:ext cx="1019556" cy="731520"/>
-          </a:xfrm>
-          <a:prstGeom prst="rect">
-            <a:avLst/>
-          </a:prstGeom>
-          <a:noFill/>
-          <a:ln/>
-        </p:spPr>
-        <p:txBody>
-          <a:bodyPr wrap="square" lIns="0" tIns="0" rIns="0" bIns="0" rtlCol="0" anchor="t"/>
-          <a:lstStyle/>
-          <a:p>
-            <a:pPr indent="0" marL="0">
-              <a:buNone/>
-            </a:pPr>
-            <a:r>
-              <a:rPr lang="en-US" sz="1050" b="1" dirty="0">
-                <a:solidFill>
-                  <a:schemeClr val="tx1"/>
-                </a:solidFill>
-              </a:rPr>
-              <a:t>train</a:t>
-            </a:r>
-            <a:endParaRPr lang="en-US" sz="1050" dirty="0"/>
-          </a:p>
-          <a:p>
-            <a:pPr indent="0" marL="0">
-              <a:buNone/>
-            </a:pPr>
-            <a:r>
-              <a:rPr lang="en-US" sz="1050" dirty="0">
-                <a:solidFill>
-                  <a:srgbClr val="52514E"/>
-                </a:solidFill>
-              </a:rPr>
-              <a:t>seed 1000</a:t>
-            </a:r>
-            <a:endParaRPr lang="en-US" sz="1050" dirty="0"/>
-          </a:p>
-        </p:txBody>
-      </p:sp>
-      <p:sp>
-        <p:nvSpPr>
-          <p:cNvPr id="10" name="split val"/>
-          <p:cNvSpPr/>
-          <p:nvPr/>
-        </p:nvSpPr>
-        <p:spPr>
-          <a:xfrm>
-            <a:off x="7703820" y="1783080"/>
-            <a:ext cx="1239012" cy="1371600"/>
-          </a:xfrm>
-          <a:prstGeom prst="roundRect">
-            <a:avLst>
-              <a:gd name="adj" fmla="val 5166"/>
-            </a:avLst>
-          </a:prstGeom>
-          <a:solidFill>
-            <a:schemeClr val="bg2"/>
-          </a:solidFill>
-          <a:ln/>
-        </p:spPr>
-      </p:sp>
-      <p:sp>
-        <p:nvSpPr>
-          <p:cNvPr id="11" name="split count val"/>
-          <p:cNvSpPr txBox="1"/>
-          <p:nvPr/>
-        </p:nvSpPr>
-        <p:spPr>
-          <a:xfrm>
-            <a:off x="7813548" y="1847088"/>
-            <a:ext cx="1019556" cy="457200"/>
-          </a:xfrm>
-          <a:prstGeom prst="rect">
-            <a:avLst/>
-          </a:prstGeom>
-          <a:noFill/>
-          <a:ln/>
-        </p:spPr>
-        <p:txBody>
-          <a:bodyPr wrap="square" lIns="0" tIns="0" rIns="0" bIns="0" rtlCol="0" anchor="ctr"/>
-          <a:lstStyle/>
-          <a:p>
-            <a:pPr indent="0" marL="0">
-              <a:buNone/>
-            </a:pPr>
-            <a:r>
-              <a:rPr lang="en-US" sz="2200" b="1" dirty="0">
-                <a:solidFill>
-                  <a:schemeClr val="accent1"/>
-                </a:solidFill>
-              </a:rPr>
-              <a:t>500</a:t>
-            </a:r>
-            <a:endParaRPr lang="en-US" sz="2200" dirty="0"/>
-          </a:p>
-        </p:txBody>
-      </p:sp>
-      <p:sp>
-        <p:nvSpPr>
-          <p:cNvPr id="12" name="split label val"/>
-          <p:cNvSpPr txBox="1"/>
-          <p:nvPr/>
-        </p:nvSpPr>
-        <p:spPr>
-          <a:xfrm>
-            <a:off x="7813548" y="2331720"/>
-            <a:ext cx="1019556" cy="731520"/>
-          </a:xfrm>
-          <a:prstGeom prst="rect">
-            <a:avLst/>
-          </a:prstGeom>
-          <a:noFill/>
-          <a:ln/>
-        </p:spPr>
-        <p:txBody>
-          <a:bodyPr wrap="square" lIns="0" tIns="0" rIns="0" bIns="0" rtlCol="0" anchor="t"/>
-          <a:lstStyle/>
-          <a:p>
-            <a:pPr indent="0" marL="0">
-              <a:buNone/>
-            </a:pPr>
-            <a:r>
-              <a:rPr lang="en-US" sz="1050" b="1" dirty="0">
-                <a:solidFill>
-                  <a:schemeClr val="tx1"/>
-                </a:solidFill>
-              </a:rPr>
-              <a:t>validation</a:t>
-            </a:r>
-            <a:endParaRPr lang="en-US" sz="1050" dirty="0"/>
-          </a:p>
-          <a:p>
-            <a:pPr indent="0" marL="0">
-              <a:buNone/>
-            </a:pPr>
-            <a:r>
-              <a:rPr lang="en-US" sz="1050" dirty="0">
-                <a:solidFill>
-                  <a:srgbClr val="52514E"/>
-                </a:solidFill>
-              </a:rPr>
-              <a:t>seed 2000</a:t>
-            </a:r>
-            <a:endParaRPr lang="en-US" sz="1050" dirty="0"/>
-          </a:p>
-        </p:txBody>
-      </p:sp>
-      <p:sp>
-        <p:nvSpPr>
-          <p:cNvPr id="13" name="split test"/>
-          <p:cNvSpPr/>
-          <p:nvPr/>
-        </p:nvSpPr>
-        <p:spPr>
-          <a:xfrm>
-            <a:off x="9052560" y="1783080"/>
-            <a:ext cx="1239012" cy="1371600"/>
-          </a:xfrm>
-          <a:prstGeom prst="roundRect">
-            <a:avLst>
-              <a:gd name="adj" fmla="val 5166"/>
-            </a:avLst>
-          </a:prstGeom>
-          <a:solidFill>
-            <a:schemeClr val="bg2"/>
-          </a:solidFill>
-          <a:ln/>
-        </p:spPr>
-      </p:sp>
-      <p:sp>
-        <p:nvSpPr>
-          <p:cNvPr id="14" name="split count test"/>
-          <p:cNvSpPr txBox="1"/>
-          <p:nvPr/>
-        </p:nvSpPr>
-        <p:spPr>
-          <a:xfrm>
-            <a:off x="9162288" y="1847088"/>
-            <a:ext cx="1019556" cy="457200"/>
-          </a:xfrm>
-          <a:prstGeom prst="rect">
-            <a:avLst/>
-          </a:prstGeom>
-          <a:noFill/>
-          <a:ln/>
-        </p:spPr>
-        <p:txBody>
-          <a:bodyPr wrap="square" lIns="0" tIns="0" rIns="0" bIns="0" rtlCol="0" anchor="ctr"/>
-          <a:lstStyle/>
-          <a:p>
-            <a:pPr indent="0" marL="0">
-              <a:buNone/>
-            </a:pPr>
-            <a:r>
-              <a:rPr lang="en-US" sz="2200" b="1" dirty="0">
-                <a:solidFill>
-                  <a:schemeClr val="accent1"/>
-                </a:solidFill>
-              </a:rPr>
-              <a:t>500</a:t>
-            </a:r>
-            <a:endParaRPr lang="en-US" sz="2200" dirty="0"/>
-          </a:p>
-        </p:txBody>
-      </p:sp>
-      <p:sp>
-        <p:nvSpPr>
-          <p:cNvPr id="15" name="split label test"/>
-          <p:cNvSpPr txBox="1"/>
-          <p:nvPr/>
-        </p:nvSpPr>
-        <p:spPr>
-          <a:xfrm>
-            <a:off x="9162288" y="2331720"/>
-            <a:ext cx="1019556" cy="731520"/>
-          </a:xfrm>
-          <a:prstGeom prst="rect">
-            <a:avLst/>
-          </a:prstGeom>
-          <a:noFill/>
-          <a:ln/>
-        </p:spPr>
-        <p:txBody>
-          <a:bodyPr wrap="square" lIns="0" tIns="0" rIns="0" bIns="0" rtlCol="0" anchor="t"/>
-          <a:lstStyle/>
-          <a:p>
-            <a:pPr indent="0" marL="0">
-              <a:buNone/>
-            </a:pPr>
-            <a:r>
-              <a:rPr lang="en-US" sz="1050" b="1" dirty="0">
-                <a:solidFill>
-                  <a:schemeClr val="tx1"/>
-                </a:solidFill>
-              </a:rPr>
-              <a:t>test</a:t>
-            </a:r>
-            <a:endParaRPr lang="en-US" sz="1050" dirty="0"/>
-          </a:p>
-          <a:p>
-            <a:pPr indent="0" marL="0">
-              <a:buNone/>
-            </a:pPr>
-            <a:r>
-              <a:rPr lang="en-US" sz="1050" dirty="0">
-                <a:solidFill>
-                  <a:srgbClr val="52514E"/>
-                </a:solidFill>
-              </a:rPr>
-              <a:t>seed 3000</a:t>
-            </a:r>
-            <a:endParaRPr lang="en-US" sz="1050" dirty="0"/>
-          </a:p>
-        </p:txBody>
-      </p:sp>
-      <p:sp>
-        <p:nvSpPr>
-          <p:cNvPr id="16" name="split benchmark"/>
-          <p:cNvSpPr/>
-          <p:nvPr/>
-        </p:nvSpPr>
-        <p:spPr>
-          <a:xfrm>
-            <a:off x="10401300" y="1783080"/>
-            <a:ext cx="1239012" cy="1371600"/>
-          </a:xfrm>
-          <a:prstGeom prst="roundRect">
-            <a:avLst>
-              <a:gd name="adj" fmla="val 5166"/>
-            </a:avLst>
-          </a:prstGeom>
-          <a:solidFill>
-            <a:schemeClr val="bg2"/>
-          </a:solidFill>
-          <a:ln/>
-        </p:spPr>
-      </p:sp>
-      <p:sp>
-        <p:nvSpPr>
-          <p:cNvPr id="17" name="split count benchmark"/>
-          <p:cNvSpPr txBox="1"/>
-          <p:nvPr/>
-        </p:nvSpPr>
-        <p:spPr>
-          <a:xfrm>
-            <a:off x="10511028" y="1847088"/>
-            <a:ext cx="1019556" cy="457200"/>
-          </a:xfrm>
-          <a:prstGeom prst="rect">
-            <a:avLst/>
-          </a:prstGeom>
-          <a:noFill/>
-          <a:ln/>
-        </p:spPr>
-        <p:txBody>
-          <a:bodyPr wrap="square" lIns="0" tIns="0" rIns="0" bIns="0" rtlCol="0" anchor="ctr"/>
-          <a:lstStyle/>
-          <a:p>
-            <a:pPr indent="0" marL="0">
-              <a:buNone/>
-            </a:pPr>
-            <a:r>
-              <a:rPr lang="en-US" sz="2200" b="1" dirty="0">
-                <a:solidFill>
-                  <a:schemeClr val="accent1"/>
-                </a:solidFill>
-              </a:rPr>
-              <a:t>1,000</a:t>
-            </a:r>
-            <a:endParaRPr lang="en-US" sz="2200" dirty="0"/>
-          </a:p>
-        </p:txBody>
-      </p:sp>
-      <p:sp>
-        <p:nvSpPr>
-          <p:cNvPr id="18" name="split label benchmark"/>
-          <p:cNvSpPr txBox="1"/>
-          <p:nvPr/>
-        </p:nvSpPr>
-        <p:spPr>
-          <a:xfrm>
-            <a:off x="10511028" y="2331720"/>
-            <a:ext cx="1019556" cy="731520"/>
-          </a:xfrm>
-          <a:prstGeom prst="rect">
-            <a:avLst/>
-          </a:prstGeom>
-          <a:noFill/>
-          <a:ln/>
-        </p:spPr>
-        <p:txBody>
-          <a:bodyPr wrap="square" lIns="0" tIns="0" rIns="0" bIns="0" rtlCol="0" anchor="t"/>
-          <a:lstStyle/>
-          <a:p>
-            <a:pPr indent="0" marL="0">
-              <a:buNone/>
-            </a:pPr>
-            <a:r>
-              <a:rPr lang="en-US" sz="1050" b="1" dirty="0">
-                <a:solidFill>
-                  <a:schemeClr val="tx1"/>
-                </a:solidFill>
-              </a:rPr>
-              <a:t>benchmark</a:t>
-            </a:r>
-            <a:endParaRPr lang="en-US" sz="1050" dirty="0"/>
-          </a:p>
-          <a:p>
-            <a:pPr indent="0" marL="0">
-              <a:buNone/>
-            </a:pPr>
-            <a:r>
-              <a:rPr lang="en-US" sz="1050" dirty="0">
-                <a:solidFill>
-                  <a:srgbClr val="52514E"/>
-                </a:solidFill>
-              </a:rPr>
-              <a:t>seed 42 · 125 per tier</a:t>
-            </a:r>
-            <a:endParaRPr lang="en-US" sz="1050" dirty="0"/>
-          </a:p>
-        </p:txBody>
-      </p:sp>
-      <p:sp>
-        <p:nvSpPr>
-          <p:cNvPr id="19" name="splits caption"/>
-          <p:cNvSpPr txBox="1"/>
-          <p:nvPr/>
-        </p:nvSpPr>
-        <p:spPr>
-          <a:xfrm>
-            <a:off x="6355080" y="3246120"/>
-            <a:ext cx="5285232" cy="502920"/>
-          </a:xfrm>
-          <a:prstGeom prst="rect">
-            <a:avLst/>
-          </a:prstGeom>
-          <a:noFill/>
-          <a:ln/>
-        </p:spPr>
-        <p:txBody>
-          <a:bodyPr wrap="square" lIns="0" tIns="0" rIns="0" bIns="0" rtlCol="0" anchor="t"/>
-          <a:lstStyle/>
-          <a:p>
-            <a:pPr indent="0" marL="0">
-              <a:buNone/>
-            </a:pPr>
-            <a:r>
-              <a:rPr lang="en-US" sz="1100" dirty="0">
-                <a:solidFill>
-                  <a:srgbClr val="52514E"/>
-                </a:solidFill>
-              </a:rPr>
-              <a:t>7,000 contexts, 31,484 elements; tiers assigned round-robin. Plain JSON files with a schema and a datasheet.</a:t>
-            </a:r>
-            <a:endParaRPr lang="en-US" sz="1100" dirty="0"/>
-          </a:p>
-        </p:txBody>
-      </p:sp>
-      <p:sp>
-        <p:nvSpPr>
-          <p:cNvPr id="20" name="use Train"/>
-          <p:cNvSpPr/>
-          <p:nvPr/>
-        </p:nvSpPr>
-        <p:spPr>
-          <a:xfrm>
-            <a:off x="548640" y="4343400"/>
-            <a:ext cx="3575304" cy="1280160"/>
-          </a:xfrm>
-          <a:prstGeom prst="roundRect">
-            <a:avLst>
-              <a:gd name="adj" fmla="val 5000"/>
-            </a:avLst>
-          </a:prstGeom>
-          <a:solidFill>
-            <a:schemeClr val="bg2"/>
-          </a:solidFill>
-          <a:ln/>
-        </p:spPr>
-      </p:sp>
-      <p:sp>
-        <p:nvSpPr>
-          <p:cNvPr id="21" name="use head Train"/>
-          <p:cNvSpPr txBox="1"/>
-          <p:nvPr/>
-        </p:nvSpPr>
-        <p:spPr>
-          <a:xfrm>
-            <a:off x="777240" y="4453128"/>
-            <a:ext cx="3118104" cy="365760"/>
-          </a:xfrm>
-          <a:prstGeom prst="rect">
-            <a:avLst/>
-          </a:prstGeom>
-          <a:noFill/>
-          <a:ln/>
-        </p:spPr>
-        <p:txBody>
-          <a:bodyPr wrap="square" lIns="0" tIns="0" rIns="0" bIns="0" rtlCol="0" anchor="ctr"/>
-          <a:lstStyle/>
-          <a:p>
-            <a:pPr indent="0" marL="0">
-              <a:buNone/>
-            </a:pPr>
-            <a:r>
-              <a:rPr lang="en-US" sz="1500" b="1" dirty="0">
-                <a:solidFill>
-                  <a:schemeClr val="tx1"/>
-                </a:solidFill>
-              </a:rPr>
-              <a:t>Train</a:t>
-            </a:r>
-            <a:endParaRPr lang="en-US" sz="1500" dirty="0"/>
-          </a:p>
-        </p:txBody>
-      </p:sp>
-      <p:sp>
-        <p:nvSpPr>
-          <p:cNvPr id="22" name="use text Train"/>
-          <p:cNvSpPr txBox="1"/>
-          <p:nvPr/>
-        </p:nvSpPr>
-        <p:spPr>
-          <a:xfrm>
-            <a:off x="777240" y="4846320"/>
-            <a:ext cx="3118104" cy="640080"/>
-          </a:xfrm>
-          <a:prstGeom prst="rect">
-            <a:avLst/>
-          </a:prstGeom>
-          <a:noFill/>
-          <a:ln/>
-        </p:spPr>
-        <p:txBody>
-          <a:bodyPr wrap="square" lIns="0" tIns="0" rIns="0" bIns="0" rtlCol="0" anchor="t"/>
-          <a:lstStyle/>
-          <a:p>
-            <a:pPr indent="0" marL="0">
-              <a:buNone/>
-            </a:pPr>
-            <a:r>
-              <a:rPr lang="en-US" sz="1250" dirty="0">
-                <a:solidFill>
-                  <a:schemeClr val="tx1"/>
-                </a:solidFill>
-              </a:rPr>
-              <a:t>on the generator: unlimited seeds, a curriculum from C1 up to C8</a:t>
-            </a:r>
-            <a:endParaRPr lang="en-US" sz="1250" dirty="0"/>
-          </a:p>
-        </p:txBody>
-      </p:sp>
-      <p:sp>
-        <p:nvSpPr>
-          <p:cNvPr id="23" name="use Evaluate"/>
-          <p:cNvSpPr/>
-          <p:nvPr/>
-        </p:nvSpPr>
-        <p:spPr>
-          <a:xfrm>
-            <a:off x="4306824" y="4343400"/>
-            <a:ext cx="3575304" cy="1280160"/>
-          </a:xfrm>
-          <a:prstGeom prst="roundRect">
-            <a:avLst>
-              <a:gd name="adj" fmla="val 5000"/>
-            </a:avLst>
-          </a:prstGeom>
-          <a:solidFill>
-            <a:schemeClr val="bg2"/>
-          </a:solidFill>
-          <a:ln/>
-        </p:spPr>
-      </p:sp>
-      <p:sp>
-        <p:nvSpPr>
-          <p:cNvPr id="24" name="use head Evaluate"/>
-          <p:cNvSpPr txBox="1"/>
-          <p:nvPr/>
-        </p:nvSpPr>
-        <p:spPr>
-          <a:xfrm>
-            <a:off x="4535424" y="4453128"/>
-            <a:ext cx="3118104" cy="365760"/>
-          </a:xfrm>
-          <a:prstGeom prst="rect">
-            <a:avLst/>
-          </a:prstGeom>
-          <a:noFill/>
-          <a:ln/>
-        </p:spPr>
-        <p:txBody>
-          <a:bodyPr wrap="square" lIns="0" tIns="0" rIns="0" bIns="0" rtlCol="0" anchor="ctr"/>
-          <a:lstStyle/>
-          <a:p>
-            <a:pPr indent="0" marL="0">
-              <a:buNone/>
-            </a:pPr>
-            <a:r>
-              <a:rPr lang="en-US" sz="1500" b="1" dirty="0">
-                <a:solidFill>
-                  <a:schemeClr val="tx1"/>
-                </a:solidFill>
-              </a:rPr>
-              <a:t>Evaluate</a:t>
-            </a:r>
-            <a:endParaRPr lang="en-US" sz="1500" dirty="0"/>
-          </a:p>
-        </p:txBody>
-      </p:sp>
-      <p:sp>
-        <p:nvSpPr>
-          <p:cNvPr id="25" name="use text Evaluate"/>
-          <p:cNvSpPr txBox="1"/>
-          <p:nvPr/>
-        </p:nvSpPr>
-        <p:spPr>
-          <a:xfrm>
-            <a:off x="4535424" y="4846320"/>
-            <a:ext cx="3118104" cy="640080"/>
-          </a:xfrm>
-          <a:prstGeom prst="rect">
-            <a:avLst/>
-          </a:prstGeom>
-          <a:noFill/>
-          <a:ln/>
-        </p:spPr>
-        <p:txBody>
-          <a:bodyPr wrap="square" lIns="0" tIns="0" rIns="0" bIns="0" rtlCol="0" anchor="t"/>
-          <a:lstStyle/>
-          <a:p>
-            <a:pPr indent="0" marL="0">
-              <a:buNone/>
-            </a:pPr>
-            <a:r>
-              <a:rPr lang="en-US" sz="1250" dirty="0">
-                <a:solidFill>
-                  <a:schemeClr val="tx1"/>
-                </a:solidFill>
-              </a:rPr>
-              <a:t>on the benchmark: 125 held-out contexts per tier, the same for every method</a:t>
-            </a:r>
-            <a:endParaRPr lang="en-US" sz="1250" dirty="0"/>
-          </a:p>
-        </p:txBody>
-      </p:sp>
-      <p:sp>
-        <p:nvSpPr>
-          <p:cNvPr id="26" name="use Report"/>
-          <p:cNvSpPr/>
-          <p:nvPr/>
-        </p:nvSpPr>
-        <p:spPr>
-          <a:xfrm>
-            <a:off x="8065008" y="4343400"/>
-            <a:ext cx="3575304" cy="1280160"/>
-          </a:xfrm>
-          <a:prstGeom prst="roundRect">
-            <a:avLst>
-              <a:gd name="adj" fmla="val 5000"/>
-            </a:avLst>
-          </a:prstGeom>
-          <a:solidFill>
-            <a:schemeClr val="bg2"/>
-          </a:solidFill>
-          <a:ln/>
-        </p:spPr>
-      </p:sp>
-      <p:sp>
-        <p:nvSpPr>
-          <p:cNvPr id="27" name="use head Report"/>
-          <p:cNvSpPr txBox="1"/>
-          <p:nvPr/>
-        </p:nvSpPr>
-        <p:spPr>
-          <a:xfrm>
-            <a:off x="8293608" y="4453128"/>
-            <a:ext cx="3118104" cy="365760"/>
-          </a:xfrm>
-          <a:prstGeom prst="rect">
-            <a:avLst/>
-          </a:prstGeom>
-          <a:noFill/>
-          <a:ln/>
-        </p:spPr>
-        <p:txBody>
-          <a:bodyPr wrap="square" lIns="0" tIns="0" rIns="0" bIns="0" rtlCol="0" anchor="ctr"/>
-          <a:lstStyle/>
-          <a:p>
-            <a:pPr indent="0" marL="0">
-              <a:buNone/>
-            </a:pPr>
-            <a:r>
-              <a:rPr lang="en-US" sz="1500" b="1" dirty="0">
-                <a:solidFill>
-                  <a:schemeClr val="tx1"/>
-                </a:solidFill>
-              </a:rPr>
-              <a:t>Report</a:t>
-            </a:r>
-            <a:endParaRPr lang="en-US" sz="1500" dirty="0"/>
-          </a:p>
-        </p:txBody>
-      </p:sp>
-      <p:sp>
-        <p:nvSpPr>
-          <p:cNvPr id="28" name="use text Report"/>
-          <p:cNvSpPr txBox="1"/>
-          <p:nvPr/>
-        </p:nvSpPr>
-        <p:spPr>
-          <a:xfrm>
-            <a:off x="8293608" y="4846320"/>
-            <a:ext cx="3118104" cy="640080"/>
-          </a:xfrm>
-          <a:prstGeom prst="rect">
-            <a:avLst/>
-          </a:prstGeom>
-          <a:noFill/>
-          <a:ln/>
-        </p:spPr>
-        <p:txBody>
-          <a:bodyPr wrap="square" lIns="0" tIns="0" rIns="0" bIns="0" rtlCol="0" anchor="t"/>
-          <a:lstStyle/>
-          <a:p>
-            <a:pPr indent="0" marL="0">
-              <a:buNone/>
-            </a:pPr>
-            <a:r>
-              <a:rPr lang="en-US" sz="1250" dirty="0">
-                <a:solidFill>
-                  <a:schemeClr val="tx1"/>
-                </a:solidFill>
-              </a:rPr>
-              <a:t>per tier with 95 % intervals, paired tests between methods</a:t>
-            </a:r>
-            <a:endParaRPr lang="en-US" sz="1250" dirty="0"/>
+              <a:t>Four lines to load, score and compare; loading, metrics and scoring need only the Python standard library, the generator needs NumPy. The same files serve reinforcement learning, constraint programming and benchmarking: there are no labels to fit a method to.</a:t>
+            </a:r>
+            <a:endParaRPr lang="en-US" sz="1150" dirty="0"/>
           </a:p>
         </p:txBody>
       </p:sp>
@@ -9216,8 +9097,8 @@
         </p:nvSpPr>
         <p:spPr>
           <a:xfrm>
-            <a:off x="822960" y="1508760"/>
-            <a:ext cx="4882896" cy="411480"/>
+            <a:off x="822960" y="1463040"/>
+            <a:ext cx="4882896" cy="365760"/>
           </a:xfrm>
           <a:prstGeom prst="rect">
             <a:avLst/>
@@ -9246,14 +9127,58 @@
       </p:sp>
       <p:sp>
         <p:nvSpPr>
-          <p:cNvPr id="5" name="scope bullets"/>
+          <p:cNvPr id="5" name="icon ring scope 0"/>
+          <p:cNvSpPr/>
+          <p:nvPr/>
+        </p:nvSpPr>
+        <p:spPr>
+          <a:xfrm>
+            <a:off x="822960" y="2050542"/>
+            <a:ext cx="402336" cy="402336"/>
+          </a:xfrm>
+          <a:prstGeom prst="ellipse">
+            <a:avLst/>
+          </a:prstGeom>
+          <a:solidFill>
+            <a:schemeClr val="accent1"/>
+          </a:solidFill>
+          <a:ln/>
+        </p:spPr>
+      </p:sp>
+      <p:pic>
+        <p:nvPicPr>
+          <p:cNvPr id="6" name="icon scope 0" descr="preencoded.png">    </p:cNvPr>
+          <p:cNvPicPr>
+            <a:picLocks noChangeAspect="1"/>
+          </p:cNvPicPr>
+          <p:nvPr/>
+        </p:nvPicPr>
+        <p:blipFill>
+          <a:blip r:embed="rId1"/>
+          <a:stretch>
+            <a:fillRect/>
+          </a:stretch>
+        </p:blipFill>
+        <p:spPr>
+          <a:xfrm>
+            <a:off x="907451" y="2135033"/>
+            <a:ext cx="233355" cy="233355"/>
+          </a:xfrm>
+          <a:prstGeom prst="rect">
+            <a:avLst/>
+          </a:prstGeom>
+        </p:spPr>
+      </p:pic>
+      <p:sp>
+        <p:nvSpPr>
+          <p:cNvPr id="7" name="scope text 0"/>
           <p:cNvSpPr txBox="1"/>
           <p:nvPr/>
         </p:nvSpPr>
         <p:spPr>
           <a:xfrm>
-            <a:off x="822960" y="2011680"/>
-            <a:ext cx="4882896" cy="2514600"/>
+            <a:off x="1417320" y="1920240"/>
+            <a:ext cx="4334256" cy="662940"/>
           </a:xfrm>
           <a:prstGeom prst="rect">
             <a:avLst/>
@@ -9262,85 +9187,267 @@
           <a:ln/>
         </p:spPr>
         <p:txBody>
-          <a:bodyPr wrap="square" lIns="0" tIns="0" rIns="0" bIns="0" rtlCol="0" anchor="t"/>
+          <a:bodyPr wrap="square" lIns="0" tIns="0" rIns="0" bIns="0" rtlCol="0" anchor="ctr"/>
           <a:lstStyle/>
           <a:p>
-            <a:pPr marL="342900" indent="-342900">
-              <a:spcAft>
-                <a:spcPts val="600"/>
-              </a:spcAft>
-              <a:buSzPct val="100000"/>
-              <a:buChar char="•"/>
-            </a:pPr>
-            <a:r>
-              <a:rPr lang="en-US" sz="1400" dirty="0">
+            <a:pPr indent="0" marL="0">
+              <a:buNone/>
+            </a:pPr>
+            <a:r>
+              <a:rPr lang="en-US" sz="1250" dirty="0">
                 <a:solidFill>
                   <a:schemeClr val="tx1"/>
                 </a:solidFill>
               </a:rPr>
-              <a:t>One cross-section at one support: routing, branches and elevation changes are outside it; so is support spacing — the span is recorded per element, so a method can vary it</a:t>
-            </a:r>
-            <a:endParaRPr lang="en-US" sz="1400" dirty="0"/>
-          </a:p>
-          <a:p>
-            <a:pPr marL="342900" indent="-342900">
-              <a:spcAft>
-                <a:spcPts val="600"/>
-              </a:spcAft>
-              <a:buSzPct val="100000"/>
-              <a:buChar char="•"/>
-            </a:pPr>
-            <a:r>
-              <a:rPr lang="en-US" sz="1400" dirty="0">
+              <a:t>One cross-section at one support: routing, branches and support spacing are outside it; the span is recorded, so a method can vary it</a:t>
+            </a:r>
+            <a:endParaRPr lang="en-US" sz="1250" dirty="0"/>
+          </a:p>
+        </p:txBody>
+      </p:sp>
+      <p:sp>
+        <p:nvSpPr>
+          <p:cNvPr id="8" name="icon ring scope 1"/>
+          <p:cNvSpPr/>
+          <p:nvPr/>
+        </p:nvSpPr>
+        <p:spPr>
+          <a:xfrm>
+            <a:off x="822960" y="2713482"/>
+            <a:ext cx="402336" cy="402336"/>
+          </a:xfrm>
+          <a:prstGeom prst="ellipse">
+            <a:avLst/>
+          </a:prstGeom>
+          <a:solidFill>
+            <a:schemeClr val="accent1"/>
+          </a:solidFill>
+          <a:ln/>
+        </p:spPr>
+      </p:sp>
+      <p:pic>
+        <p:nvPicPr>
+          <p:cNvPr id="9" name="icon scope 1" descr="preencoded.png">    </p:cNvPr>
+          <p:cNvPicPr>
+            <a:picLocks noChangeAspect="1"/>
+          </p:cNvPicPr>
+          <p:nvPr/>
+        </p:nvPicPr>
+        <p:blipFill>
+          <a:blip r:embed="rId2"/>
+          <a:stretch>
+            <a:fillRect/>
+          </a:stretch>
+        </p:blipFill>
+        <p:spPr>
+          <a:xfrm>
+            <a:off x="907451" y="2797973"/>
+            <a:ext cx="233355" cy="233355"/>
+          </a:xfrm>
+          <a:prstGeom prst="rect">
+            <a:avLst/>
+          </a:prstGeom>
+        </p:spPr>
+      </p:pic>
+      <p:sp>
+        <p:nvSpPr>
+          <p:cNvPr id="10" name="scope text 1"/>
+          <p:cNvSpPr txBox="1"/>
+          <p:nvPr/>
+        </p:nvSpPr>
+        <p:spPr>
+          <a:xfrm>
+            <a:off x="1417320" y="2583180"/>
+            <a:ext cx="4334256" cy="662940"/>
+          </a:xfrm>
+          <a:prstGeom prst="rect">
+            <a:avLst/>
+          </a:prstGeom>
+          <a:noFill/>
+          <a:ln/>
+        </p:spPr>
+        <p:txBody>
+          <a:bodyPr wrap="square" lIns="0" tIns="0" rIns="0" bIns="0" rtlCol="0" anchor="ctr"/>
+          <a:lstStyle/>
+          <a:p>
+            <a:pPr indent="0" marL="0">
+              <a:buNone/>
+            </a:pPr>
+            <a:r>
+              <a:rPr lang="en-US" sz="1250" dirty="0">
                 <a:solidFill>
                   <a:schemeClr val="tx1"/>
                 </a:solidFill>
               </a:rPr>
-              <a:t>Realism checked on sections of two open buildings, a residential duplex and a medical clinic; congested racks rest on coordination practice and standards</a:t>
-            </a:r>
-            <a:endParaRPr lang="en-US" sz="1400" dirty="0"/>
-          </a:p>
-          <a:p>
-            <a:pPr marL="342900" indent="-342900">
-              <a:spcAft>
-                <a:spcPts val="600"/>
-              </a:spcAft>
-              <a:buSzPct val="100000"/>
-              <a:buChar char="•"/>
-            </a:pPr>
-            <a:r>
-              <a:rPr lang="en-US" sz="1400" dirty="0">
+              <a:t>Realism checked on two open buildings, a residential duplex and a medical clinic; congested racks rest on practice and standards</a:t>
+            </a:r>
+            <a:endParaRPr lang="en-US" sz="1250" dirty="0"/>
+          </a:p>
+        </p:txBody>
+      </p:sp>
+      <p:sp>
+        <p:nvSpPr>
+          <p:cNvPr id="11" name="icon ring scope 2"/>
+          <p:cNvSpPr/>
+          <p:nvPr/>
+        </p:nvSpPr>
+        <p:spPr>
+          <a:xfrm>
+            <a:off x="822960" y="3376422"/>
+            <a:ext cx="402336" cy="402336"/>
+          </a:xfrm>
+          <a:prstGeom prst="ellipse">
+            <a:avLst/>
+          </a:prstGeom>
+          <a:solidFill>
+            <a:schemeClr val="accent1"/>
+          </a:solidFill>
+          <a:ln/>
+        </p:spPr>
+      </p:sp>
+      <p:pic>
+        <p:nvPicPr>
+          <p:cNvPr id="12" name="icon scope 2" descr="preencoded.png">    </p:cNvPr>
+          <p:cNvPicPr>
+            <a:picLocks noChangeAspect="1"/>
+          </p:cNvPicPr>
+          <p:nvPr/>
+        </p:nvPicPr>
+        <p:blipFill>
+          <a:blip r:embed="rId3"/>
+          <a:stretch>
+            <a:fillRect/>
+          </a:stretch>
+        </p:blipFill>
+        <p:spPr>
+          <a:xfrm>
+            <a:off x="907451" y="3460913"/>
+            <a:ext cx="233355" cy="233355"/>
+          </a:xfrm>
+          <a:prstGeom prst="rect">
+            <a:avLst/>
+          </a:prstGeom>
+        </p:spPr>
+      </p:pic>
+      <p:sp>
+        <p:nvSpPr>
+          <p:cNvPr id="13" name="scope text 2"/>
+          <p:cNvSpPr txBox="1"/>
+          <p:nvPr/>
+        </p:nvSpPr>
+        <p:spPr>
+          <a:xfrm>
+            <a:off x="1417320" y="3246120"/>
+            <a:ext cx="4334256" cy="662940"/>
+          </a:xfrm>
+          <a:prstGeom prst="rect">
+            <a:avLst/>
+          </a:prstGeom>
+          <a:noFill/>
+          <a:ln/>
+        </p:spPr>
+        <p:txBody>
+          <a:bodyPr wrap="square" lIns="0" tIns="0" rIns="0" bIns="0" rtlCol="0" anchor="ctr"/>
+          <a:lstStyle/>
+          <a:p>
+            <a:pPr indent="0" marL="0">
+              <a:buNone/>
+            </a:pPr>
+            <a:r>
+              <a:rPr lang="en-US" sz="1250" dirty="0">
                 <a:solidFill>
                   <a:schemeClr val="tx1"/>
                 </a:solidFill>
               </a:rPr>
               <a:t>Trade mix and tier composition are design choices, not survey results</a:t>
             </a:r>
-            <a:endParaRPr lang="en-US" sz="1400" dirty="0"/>
-          </a:p>
-          <a:p>
-            <a:pPr marL="342900" indent="-342900">
-              <a:spcAft>
-                <a:spcPts val="600"/>
-              </a:spcAft>
-              <a:buSzPct val="100000"/>
-              <a:buChar char="•"/>
-            </a:pPr>
-            <a:r>
-              <a:rPr lang="en-US" sz="1400" dirty="0">
+            <a:endParaRPr lang="en-US" sz="1250" dirty="0"/>
+          </a:p>
+        </p:txBody>
+      </p:sp>
+      <p:sp>
+        <p:nvSpPr>
+          <p:cNvPr id="14" name="icon ring scope 3"/>
+          <p:cNvSpPr/>
+          <p:nvPr/>
+        </p:nvSpPr>
+        <p:spPr>
+          <a:xfrm>
+            <a:off x="822960" y="4039362"/>
+            <a:ext cx="402336" cy="402336"/>
+          </a:xfrm>
+          <a:prstGeom prst="ellipse">
+            <a:avLst/>
+          </a:prstGeom>
+          <a:solidFill>
+            <a:schemeClr val="accent1"/>
+          </a:solidFill>
+          <a:ln/>
+        </p:spPr>
+      </p:sp>
+      <p:pic>
+        <p:nvPicPr>
+          <p:cNvPr id="15" name="icon scope 3" descr="preencoded.png">    </p:cNvPr>
+          <p:cNvPicPr>
+            <a:picLocks noChangeAspect="1"/>
+          </p:cNvPicPr>
+          <p:nvPr/>
+        </p:nvPicPr>
+        <p:blipFill>
+          <a:blip r:embed="rId4"/>
+          <a:stretch>
+            <a:fillRect/>
+          </a:stretch>
+        </p:blipFill>
+        <p:spPr>
+          <a:xfrm>
+            <a:off x="907451" y="4123853"/>
+            <a:ext cx="233355" cy="233355"/>
+          </a:xfrm>
+          <a:prstGeom prst="rect">
+            <a:avLst/>
+          </a:prstGeom>
+        </p:spPr>
+      </p:pic>
+      <p:sp>
+        <p:nvSpPr>
+          <p:cNvPr id="16" name="scope text 3"/>
+          <p:cNvSpPr txBox="1"/>
+          <p:nvPr/>
+        </p:nvSpPr>
+        <p:spPr>
+          <a:xfrm>
+            <a:off x="1417320" y="3909060"/>
+            <a:ext cx="4334256" cy="662940"/>
+          </a:xfrm>
+          <a:prstGeom prst="rect">
+            <a:avLst/>
+          </a:prstGeom>
+          <a:noFill/>
+          <a:ln/>
+        </p:spPr>
+        <p:txBody>
+          <a:bodyPr wrap="square" lIns="0" tIns="0" rIns="0" bIns="0" rtlCol="0" anchor="ctr"/>
+          <a:lstStyle/>
+          <a:p>
+            <a:pPr indent="0" marL="0">
+              <a:buNone/>
+            </a:pPr>
+            <a:r>
+              <a:rPr lang="en-US" sz="1250" dirty="0">
                 <a:solidFill>
                   <a:schemeClr val="tx1"/>
                 </a:solidFill>
               </a:rPr>
               <a:t>Synthetic: not for the structural design of real installations</a:t>
             </a:r>
-            <a:endParaRPr lang="en-US" sz="1400" dirty="0"/>
+            <a:endParaRPr lang="en-US" sz="1250" dirty="0"/>
           </a:p>
         </p:txBody>
       </p:sp>
       <p:sp>
         <p:nvSpPr>
-          <p:cNvPr id="6" name="next card"/>
+          <p:cNvPr id="17" name="next card"/>
           <p:cNvSpPr/>
           <p:nvPr/>
         </p:nvSpPr>
@@ -9362,14 +9469,14 @@
       </p:sp>
       <p:sp>
         <p:nvSpPr>
-          <p:cNvPr id="7" name="next heading"/>
+          <p:cNvPr id="18" name="next heading"/>
           <p:cNvSpPr txBox="1"/>
           <p:nvPr/>
         </p:nvSpPr>
         <p:spPr>
           <a:xfrm>
-            <a:off x="6483096" y="1508760"/>
-            <a:ext cx="4882896" cy="411480"/>
+            <a:off x="6483096" y="1463040"/>
+            <a:ext cx="4882896" cy="365760"/>
           </a:xfrm>
           <a:prstGeom prst="rect">
             <a:avLst/>
@@ -9398,14 +9505,34 @@
       </p:sp>
       <p:sp>
         <p:nvSpPr>
-          <p:cNvPr id="8" name="next bullets"/>
+          <p:cNvPr id="19" name="icon ring next 0"/>
+          <p:cNvSpPr/>
+          <p:nvPr/>
+        </p:nvSpPr>
+        <p:spPr>
+          <a:xfrm>
+            <a:off x="6483096" y="2161032"/>
+            <a:ext cx="402336" cy="402336"/>
+          </a:xfrm>
+          <a:prstGeom prst="ellipse">
+            <a:avLst/>
+          </a:prstGeom>
+          <a:solidFill>
+            <a:schemeClr val="accent1"/>
+          </a:solidFill>
+          <a:ln/>
+        </p:spPr>
+      </p:sp>
+      <p:sp>
+        <p:nvSpPr>
+          <p:cNvPr id="20" name="Text 14"/>
           <p:cNvSpPr txBox="1"/>
           <p:nvPr/>
         </p:nvSpPr>
         <p:spPr>
           <a:xfrm>
-            <a:off x="6483096" y="2011680"/>
-            <a:ext cx="4882896" cy="2514600"/>
+            <a:off x="6483096" y="2161032"/>
+            <a:ext cx="402336" cy="402336"/>
           </a:xfrm>
           <a:prstGeom prst="rect">
             <a:avLst/>
@@ -9414,67 +9541,247 @@
           <a:ln/>
         </p:spPr>
         <p:txBody>
-          <a:bodyPr wrap="square" lIns="0" tIns="0" rIns="0" bIns="0" rtlCol="0" anchor="t"/>
+          <a:bodyPr wrap="square" lIns="0" tIns="0" rIns="0" bIns="0" rtlCol="0" anchor="ctr"/>
           <a:lstStyle/>
           <a:p>
-            <a:pPr marL="342900" indent="-342900">
-              <a:spcAft>
-                <a:spcPts val="600"/>
-              </a:spcAft>
-              <a:buSzPct val="100000"/>
-              <a:buChar char="•"/>
-            </a:pPr>
-            <a:r>
-              <a:rPr lang="en-US" sz="1400" dirty="0">
+            <a:pPr algn="ctr" indent="0" marL="0">
+              <a:buNone/>
+            </a:pPr>
+            <a:r>
+              <a:rPr lang="en-US" sz="1500" b="1" dirty="0">
+                <a:solidFill>
+                  <a:schemeClr val="bg1"/>
+                </a:solidFill>
+              </a:rPr>
+              <a:t>1</a:t>
+            </a:r>
+            <a:endParaRPr lang="en-US" sz="1500" dirty="0"/>
+          </a:p>
+        </p:txBody>
+      </p:sp>
+      <p:sp>
+        <p:nvSpPr>
+          <p:cNvPr id="21" name="next text 0"/>
+          <p:cNvSpPr txBox="1"/>
+          <p:nvPr/>
+        </p:nvSpPr>
+        <p:spPr>
+          <a:xfrm>
+            <a:off x="7077456" y="1920240"/>
+            <a:ext cx="4334256" cy="883920"/>
+          </a:xfrm>
+          <a:prstGeom prst="rect">
+            <a:avLst/>
+          </a:prstGeom>
+          <a:noFill/>
+          <a:ln/>
+        </p:spPr>
+        <p:txBody>
+          <a:bodyPr wrap="square" lIns="0" tIns="0" rIns="0" bIns="0" rtlCol="0" anchor="ctr"/>
+          <a:lstStyle/>
+          <a:p>
+            <a:pPr indent="0" marL="0">
+              <a:buNone/>
+            </a:pPr>
+            <a:r>
+              <a:rPr lang="en-US" sz="1250" dirty="0">
                 <a:solidFill>
                   <a:schemeClr val="tx1"/>
                 </a:solidFill>
               </a:rPr>
               <a:t>A public checker for support designs, with best-known costs from an exact solver on the small tiers</a:t>
             </a:r>
-            <a:endParaRPr lang="en-US" sz="1400" dirty="0"/>
-          </a:p>
-          <a:p>
-            <a:pPr marL="342900" indent="-342900">
-              <a:spcAft>
-                <a:spcPts val="600"/>
-              </a:spcAft>
-              <a:buSzPct val="100000"/>
-              <a:buChar char="•"/>
-            </a:pPr>
-            <a:r>
-              <a:rPr lang="en-US" sz="1400" dirty="0">
+            <a:endParaRPr lang="en-US" sz="1250" dirty="0"/>
+          </a:p>
+        </p:txBody>
+      </p:sp>
+      <p:sp>
+        <p:nvSpPr>
+          <p:cNvPr id="22" name="icon ring next 1"/>
+          <p:cNvSpPr/>
+          <p:nvPr/>
+        </p:nvSpPr>
+        <p:spPr>
+          <a:xfrm>
+            <a:off x="6483096" y="3044952"/>
+            <a:ext cx="402336" cy="402336"/>
+          </a:xfrm>
+          <a:prstGeom prst="ellipse">
+            <a:avLst/>
+          </a:prstGeom>
+          <a:solidFill>
+            <a:schemeClr val="accent1"/>
+          </a:solidFill>
+          <a:ln/>
+        </p:spPr>
+      </p:sp>
+      <p:sp>
+        <p:nvSpPr>
+          <p:cNvPr id="23" name="Text 17"/>
+          <p:cNvSpPr txBox="1"/>
+          <p:nvPr/>
+        </p:nvSpPr>
+        <p:spPr>
+          <a:xfrm>
+            <a:off x="6483096" y="3044952"/>
+            <a:ext cx="402336" cy="402336"/>
+          </a:xfrm>
+          <a:prstGeom prst="rect">
+            <a:avLst/>
+          </a:prstGeom>
+          <a:noFill/>
+          <a:ln/>
+        </p:spPr>
+        <p:txBody>
+          <a:bodyPr wrap="square" lIns="0" tIns="0" rIns="0" bIns="0" rtlCol="0" anchor="ctr"/>
+          <a:lstStyle/>
+          <a:p>
+            <a:pPr algn="ctr" indent="0" marL="0">
+              <a:buNone/>
+            </a:pPr>
+            <a:r>
+              <a:rPr lang="en-US" sz="1500" b="1" dirty="0">
+                <a:solidFill>
+                  <a:schemeClr val="bg1"/>
+                </a:solidFill>
+              </a:rPr>
+              <a:t>2</a:t>
+            </a:r>
+            <a:endParaRPr lang="en-US" sz="1500" dirty="0"/>
+          </a:p>
+        </p:txBody>
+      </p:sp>
+      <p:sp>
+        <p:nvSpPr>
+          <p:cNvPr id="24" name="next text 1"/>
+          <p:cNvSpPr txBox="1"/>
+          <p:nvPr/>
+        </p:nvSpPr>
+        <p:spPr>
+          <a:xfrm>
+            <a:off x="7077456" y="2804160"/>
+            <a:ext cx="4334256" cy="883920"/>
+          </a:xfrm>
+          <a:prstGeom prst="rect">
+            <a:avLst/>
+          </a:prstGeom>
+          <a:noFill/>
+          <a:ln/>
+        </p:spPr>
+        <p:txBody>
+          <a:bodyPr wrap="square" lIns="0" tIns="0" rIns="0" bIns="0" rtlCol="0" anchor="ctr"/>
+          <a:lstStyle/>
+          <a:p>
+            <a:pPr indent="0" marL="0">
+              <a:buNone/>
+            </a:pPr>
+            <a:r>
+              <a:rPr lang="en-US" sz="1250" dirty="0">
                 <a:solidFill>
                   <a:schemeClr val="tx1"/>
                 </a:solidFill>
               </a:rPr>
-              <a:t>The catalog as an input: generated catalogs, and tests on catalogs a method has never seen</a:t>
-            </a:r>
-            <a:endParaRPr lang="en-US" sz="1400" dirty="0"/>
-          </a:p>
-          <a:p>
-            <a:pPr marL="342900" indent="-342900">
-              <a:spcAft>
-                <a:spcPts val="600"/>
-              </a:spcAft>
-              <a:buSzPct val="100000"/>
-              <a:buChar char="•"/>
-            </a:pPr>
-            <a:r>
-              <a:rPr lang="en-US" sz="1400" dirty="0">
+              <a:t>The catalog as an input: generated catalogs, and catalogs a method has never seen</a:t>
+            </a:r>
+            <a:endParaRPr lang="en-US" sz="1250" dirty="0"/>
+          </a:p>
+        </p:txBody>
+      </p:sp>
+      <p:sp>
+        <p:nvSpPr>
+          <p:cNvPr id="25" name="icon ring next 2"/>
+          <p:cNvSpPr/>
+          <p:nvPr/>
+        </p:nvSpPr>
+        <p:spPr>
+          <a:xfrm>
+            <a:off x="6483096" y="3928872"/>
+            <a:ext cx="402336" cy="402336"/>
+          </a:xfrm>
+          <a:prstGeom prst="ellipse">
+            <a:avLst/>
+          </a:prstGeom>
+          <a:solidFill>
+            <a:schemeClr val="accent1"/>
+          </a:solidFill>
+          <a:ln/>
+        </p:spPr>
+      </p:sp>
+      <p:sp>
+        <p:nvSpPr>
+          <p:cNvPr id="26" name="Text 20"/>
+          <p:cNvSpPr txBox="1"/>
+          <p:nvPr/>
+        </p:nvSpPr>
+        <p:spPr>
+          <a:xfrm>
+            <a:off x="6483096" y="3928872"/>
+            <a:ext cx="402336" cy="402336"/>
+          </a:xfrm>
+          <a:prstGeom prst="rect">
+            <a:avLst/>
+          </a:prstGeom>
+          <a:noFill/>
+          <a:ln/>
+        </p:spPr>
+        <p:txBody>
+          <a:bodyPr wrap="square" lIns="0" tIns="0" rIns="0" bIns="0" rtlCol="0" anchor="ctr"/>
+          <a:lstStyle/>
+          <a:p>
+            <a:pPr algn="ctr" indent="0" marL="0">
+              <a:buNone/>
+            </a:pPr>
+            <a:r>
+              <a:rPr lang="en-US" sz="1500" b="1" dirty="0">
+                <a:solidFill>
+                  <a:schemeClr val="bg1"/>
+                </a:solidFill>
+              </a:rPr>
+              <a:t>3</a:t>
+            </a:r>
+            <a:endParaRPr lang="en-US" sz="1500" dirty="0"/>
+          </a:p>
+        </p:txBody>
+      </p:sp>
+      <p:sp>
+        <p:nvSpPr>
+          <p:cNvPr id="27" name="next text 2"/>
+          <p:cNvSpPr txBox="1"/>
+          <p:nvPr/>
+        </p:nvSpPr>
+        <p:spPr>
+          <a:xfrm>
+            <a:off x="7077456" y="3688080"/>
+            <a:ext cx="4334256" cy="883920"/>
+          </a:xfrm>
+          <a:prstGeom prst="rect">
+            <a:avLst/>
+          </a:prstGeom>
+          <a:noFill/>
+          <a:ln/>
+        </p:spPr>
+        <p:txBody>
+          <a:bodyPr wrap="square" lIns="0" tIns="0" rIns="0" bIns="0" rtlCol="0" anchor="ctr"/>
+          <a:lstStyle/>
+          <a:p>
+            <a:pPr indent="0" marL="0">
+              <a:buNone/>
+            </a:pPr>
+            <a:r>
+              <a:rPr lang="en-US" sz="1250" dirty="0">
                 <a:solidFill>
                   <a:schemeClr val="tx1"/>
                 </a:solidFill>
               </a:rPr>
               <a:t>A real test set: sections from commercial projects with supports designed by engineers</a:t>
             </a:r>
-            <a:endParaRPr lang="en-US" sz="1400" dirty="0"/>
+            <a:endParaRPr lang="en-US" sz="1250" dirty="0"/>
           </a:p>
         </p:txBody>
       </p:sp>
       <p:sp>
         <p:nvSpPr>
-          <p:cNvPr id="9" name="ask band"/>
+          <p:cNvPr id="28" name="ask band"/>
           <p:cNvSpPr/>
           <p:nvPr/>
         </p:nvSpPr>
@@ -9496,7 +9803,7 @@
       </p:sp>
       <p:sp>
         <p:nvSpPr>
-          <p:cNvPr id="10" name="ask"/>
+          <p:cNvPr id="29" name="ask"/>
           <p:cNvSpPr txBox="1"/>
           <p:nvPr/>
         </p:nvSpPr>
@@ -9543,14 +9850,14 @@
       </p:sp>
       <p:pic>
         <p:nvPicPr>
-          <p:cNvPr id="11" name="qr ask" descr="/home/user/crossmep_dataset/docs/figures/qr_repo.png">    </p:cNvPr>
+          <p:cNvPr id="30" name="qr ask" descr="/home/user/crossmep_dataset/docs/figures/qr_repo.png">    </p:cNvPr>
           <p:cNvPicPr>
             <a:picLocks noChangeAspect="1"/>
           </p:cNvPicPr>
           <p:nvPr/>
         </p:nvPicPr>
         <p:blipFill>
-          <a:blip r:embed="rId1"/>
+          <a:blip r:embed="rId5"/>
           <a:stretch>
             <a:fillRect/>
           </a:stretch>

</xml_diff>

<commit_message>
Talk: demo slide as in and out panels with the facts line; every title a sentence
Co-Authored-By: Claude Fable 5.1 <noreply@anthropic.com>
Claude-Session: https://claude.ai/code/session_01R1ft1rokeRJHR95rzLxNEC
</commit_message>
<xml_diff>
--- a/docs/CrossMEP_CIBW78_talk.pptx
+++ b/docs/CrossMEP_CIBW78_talk.pptx
@@ -122,12 +122,12 @@
   <p:extLst>
     <p:ext uri="{521415D9-36F7-43E2-AB2F-B90AF26B5E84}">
       <p14:sectionLst xmlns:p14="http://schemas.microsoft.com/office/powerpoint/2010/main">
-        <p14:section name="Opening" id="{4a2f424f-0723-c449-6e2b-aa9637e6fde2}">
+        <p14:section name="Opening" id="{a10a00d9-f52c-a06d-bec7-7c15829e526f}">
           <p14:sldIdLst>
             <p14:sldId id="256"/>
           </p14:sldIdLst>
         </p14:section>
-        <p14:section name="Motivation" id="{cfe50742-5deb-0cd2-b9cf-f86289aa5705}">
+        <p14:section name="Motivation" id="{470bcb2e-d11f-ffb5-8373-db20879570b2}">
           <p14:sldIdLst>
             <p14:sldId id="257"/>
             <p14:sldId id="258"/>
@@ -136,21 +136,21 @@
             <p14:sldId id="261"/>
           </p14:sldIdLst>
         </p14:section>
-        <p14:section name="The dataset" id="{fb6af2f3-a69a-ad52-76cd-dfd3d4d21a36}">
+        <p14:section name="The dataset" id="{ac643583-f124-4dd2-1e22-715ce0408d7c}">
           <p14:sldIdLst>
             <p14:sldId id="262"/>
             <p14:sldId id="263"/>
             <p14:sldId id="264"/>
           </p14:sldIdLst>
         </p14:section>
-        <p14:section name="Experiments" id="{66b94019-a4a9-e554-3753-0dd9b3dc3202}">
+        <p14:section name="Experiments" id="{de0a8344-a63f-ce1c-537d-7981297762dd}">
           <p14:sldIdLst>
             <p14:sldId id="265"/>
             <p14:sldId id="266"/>
             <p14:sldId id="267"/>
           </p14:sldIdLst>
         </p14:section>
-        <p14:section name="Use" id="{4efdd699-8dac-8f94-a5ee-8735819e960b}">
+        <p14:section name="Use" id="{00a8c7fd-79cc-c1fa-d5b7-14e8d0c72b45}">
           <p14:sldIdLst>
             <p14:sldId id="268"/>
             <p14:sldId id="269"/>
@@ -7769,15 +7769,51 @@
                   <a:schemeClr val="tx1"/>
                 </a:solidFill>
               </a:rPr>
-              <a:t>Set the parameters and the generator returns the designer’s brief</a:t>
+              <a:t>The Generator Studio turns a few parameters into the designer’s brief</a:t>
             </a:r>
             <a:endParaRPr lang="en-US" sz="2600" dirty="0"/>
+          </a:p>
+        </p:txBody>
+      </p:sp>
+      <p:sp>
+        <p:nvSpPr>
+          <p:cNvPr id="3" name="in label"/>
+          <p:cNvSpPr txBox="1"/>
+          <p:nvPr/>
+        </p:nvSpPr>
+        <p:spPr>
+          <a:xfrm>
+            <a:off x="548640" y="1280160"/>
+            <a:ext cx="5486400" cy="228600"/>
+          </a:xfrm>
+          <a:prstGeom prst="rect">
+            <a:avLst/>
+          </a:prstGeom>
+          <a:noFill/>
+          <a:ln/>
+        </p:spPr>
+        <p:txBody>
+          <a:bodyPr wrap="square" lIns="0" tIns="0" rIns="0" bIns="0" rtlCol="0" anchor="ctr"/>
+          <a:lstStyle/>
+          <a:p>
+            <a:pPr indent="0" marL="0">
+              <a:buNone/>
+            </a:pPr>
+            <a:r>
+              <a:rPr lang="en-US" sz="1000" b="1" dirty="0">
+                <a:solidFill>
+                  <a:srgbClr val="52514E"/>
+                </a:solidFill>
+              </a:rPr>
+              <a:t>In: the parameters</a:t>
+            </a:r>
+            <a:endParaRPr lang="en-US" sz="1000" dirty="0"/>
           </a:p>
         </p:txBody>
       </p:sp>
       <p:pic>
         <p:nvPicPr>
-          <p:cNvPr id="3" name="studio parameters" descr="preencoded.png">    </p:cNvPr>
+          <p:cNvPr id="4" name="studio parameters" descr="preencoded.png">    </p:cNvPr>
           <p:cNvPicPr>
             <a:picLocks noChangeAspect="1"/>
           </p:cNvPicPr>
@@ -7791,17 +7827,39 @@
         </p:blipFill>
         <p:spPr>
           <a:xfrm>
-            <a:off x="548640" y="1280160"/>
-            <a:ext cx="11091672" cy="733885"/>
+            <a:off x="912010" y="1554480"/>
+            <a:ext cx="10364932" cy="685800"/>
           </a:xfrm>
           <a:prstGeom prst="rect">
             <a:avLst/>
           </a:prstGeom>
         </p:spPr>
       </p:pic>
+      <p:sp>
+        <p:nvSpPr>
+          <p:cNvPr id="5" name="parameters frame"/>
+          <p:cNvSpPr/>
+          <p:nvPr/>
+        </p:nvSpPr>
+        <p:spPr>
+          <a:xfrm>
+            <a:off x="866290" y="1508760"/>
+            <a:ext cx="10456372" cy="777240"/>
+          </a:xfrm>
+          <a:prstGeom prst="rect">
+            <a:avLst/>
+          </a:prstGeom>
+          <a:ln w="9525">
+            <a:solidFill>
+              <a:srgbClr val="E1E0D9"/>
+            </a:solidFill>
+            <a:prstDash val="solid"/>
+          </a:ln>
+        </p:spPr>
+      </p:sp>
       <p:pic>
         <p:nvPicPr>
-          <p:cNvPr id="4" name="studio section" descr="preencoded.png">    </p:cNvPr>
+          <p:cNvPr id="6" name="studio section" descr="preencoded.png">    </p:cNvPr>
           <p:cNvPicPr>
             <a:picLocks noChangeAspect="1"/>
           </p:cNvPicPr>
@@ -7815,8 +7873,8 @@
         </p:blipFill>
         <p:spPr>
           <a:xfrm>
-            <a:off x="548640" y="2196925"/>
-            <a:ext cx="7726680" cy="3000652"/>
+            <a:off x="1061689" y="2697480"/>
+            <a:ext cx="5877622" cy="2514600"/>
           </a:xfrm>
           <a:prstGeom prst="rect">
             <a:avLst/>
@@ -7825,43 +7883,29 @@
       </p:pic>
       <p:sp>
         <p:nvSpPr>
-          <p:cNvPr id="5" name="studio caption"/>
-          <p:cNvSpPr txBox="1"/>
-          <p:nvPr/>
-        </p:nvSpPr>
-        <p:spPr>
-          <a:xfrm>
-            <a:off x="548640" y="5334737"/>
-            <a:ext cx="7726680" cy="731520"/>
-          </a:xfrm>
-          <a:prstGeom prst="rect">
-            <a:avLst/>
-          </a:prstGeom>
-          <a:noFill/>
-          <a:ln/>
-        </p:spPr>
-        <p:txBody>
-          <a:bodyPr wrap="square" lIns="0" tIns="0" rIns="0" bIns="0" rtlCol="0" anchor="t"/>
-          <a:lstStyle/>
-          <a:p>
-            <a:pPr indent="0" marL="0">
-              <a:buNone/>
-            </a:pPr>
-            <a:r>
-              <a:rPr lang="en-US" sz="1250" dirty="0">
-                <a:solidFill>
-                  <a:srgbClr val="52514E"/>
-                </a:solidFill>
-              </a:rPr>
-              <a:t>In: the parameters (tier C7, seed 0). Out: section A–A at the support, as the support designer receives it (scale 1:20), and the same run in 3D. Every section is a stored output of the released generator, with the Python call that reproduces it.</a:t>
-            </a:r>
-            <a:endParaRPr lang="en-US" sz="1250" dirty="0"/>
-          </a:p>
-        </p:txBody>
+          <p:cNvPr id="7" name="section frame"/>
+          <p:cNvSpPr/>
+          <p:nvPr/>
+        </p:nvSpPr>
+        <p:spPr>
+          <a:xfrm>
+            <a:off x="1015969" y="2651760"/>
+            <a:ext cx="5969062" cy="2606040"/>
+          </a:xfrm>
+          <a:prstGeom prst="rect">
+            <a:avLst/>
+          </a:prstGeom>
+          <a:ln w="9525">
+            <a:solidFill>
+              <a:srgbClr val="E1E0D9"/>
+            </a:solidFill>
+            <a:prstDash val="solid"/>
+          </a:ln>
+        </p:spPr>
       </p:sp>
       <p:pic>
         <p:nvPicPr>
-          <p:cNvPr id="6" name="studio 3D" descr="preencoded.png">    </p:cNvPr>
+          <p:cNvPr id="8" name="studio facts" descr="preencoded.png">    </p:cNvPr>
           <p:cNvPicPr>
             <a:picLocks noChangeAspect="1"/>
           </p:cNvPicPr>
@@ -7875,17 +7919,53 @@
         </p:blipFill>
         <p:spPr>
           <a:xfrm>
-            <a:off x="8503920" y="2196925"/>
-            <a:ext cx="3136392" cy="2240280"/>
+            <a:off x="800100" y="5367528"/>
+            <a:ext cx="6400800" cy="329184"/>
           </a:xfrm>
           <a:prstGeom prst="rect">
             <a:avLst/>
           </a:prstGeom>
         </p:spPr>
       </p:pic>
+      <p:sp>
+        <p:nvSpPr>
+          <p:cNvPr id="9" name="out label"/>
+          <p:cNvSpPr txBox="1"/>
+          <p:nvPr/>
+        </p:nvSpPr>
+        <p:spPr>
+          <a:xfrm>
+            <a:off x="548640" y="2423160"/>
+            <a:ext cx="6903720" cy="228600"/>
+          </a:xfrm>
+          <a:prstGeom prst="rect">
+            <a:avLst/>
+          </a:prstGeom>
+          <a:noFill/>
+          <a:ln/>
+        </p:spPr>
+        <p:txBody>
+          <a:bodyPr wrap="square" lIns="0" tIns="0" rIns="0" bIns="0" rtlCol="0" anchor="ctr"/>
+          <a:lstStyle/>
+          <a:p>
+            <a:pPr indent="0" marL="0">
+              <a:buNone/>
+            </a:pPr>
+            <a:r>
+              <a:rPr lang="en-US" sz="1000" b="1" dirty="0">
+                <a:solidFill>
+                  <a:srgbClr val="52514E"/>
+                </a:solidFill>
+              </a:rPr>
+              <a:t>Out: section A–A as the designer receives it, and what it carries</a:t>
+            </a:r>
+            <a:endParaRPr lang="en-US" sz="1000" dirty="0"/>
+          </a:p>
+        </p:txBody>
+      </p:sp>
       <p:pic>
         <p:nvPicPr>
-          <p:cNvPr id="7" name="qr studio" descr="/home/user/crossmep_dataset/docs/figures/qr_studio.png">    </p:cNvPr>
+          <p:cNvPr id="10" name="studio 3D" descr="preencoded.png">    </p:cNvPr>
           <p:cNvPicPr>
             <a:picLocks noChangeAspect="1"/>
           </p:cNvPicPr>
@@ -7899,8 +7979,8 @@
         </p:blipFill>
         <p:spPr>
           <a:xfrm>
-            <a:off x="9454896" y="4665805"/>
-            <a:ext cx="1234440" cy="1234440"/>
+            <a:off x="8137084" y="2697480"/>
+            <a:ext cx="3092824" cy="2103120"/>
           </a:xfrm>
           <a:prstGeom prst="rect">
             <a:avLst/>
@@ -7909,14 +7989,36 @@
       </p:pic>
       <p:sp>
         <p:nvSpPr>
-          <p:cNvPr id="8" name="studio link"/>
+          <p:cNvPr id="11" name="3d frame"/>
+          <p:cNvSpPr/>
+          <p:nvPr/>
+        </p:nvSpPr>
+        <p:spPr>
+          <a:xfrm>
+            <a:off x="8091364" y="2651760"/>
+            <a:ext cx="3184264" cy="2194560"/>
+          </a:xfrm>
+          <a:prstGeom prst="rect">
+            <a:avLst/>
+          </a:prstGeom>
+          <a:ln w="9525">
+            <a:solidFill>
+              <a:srgbClr val="E1E0D9"/>
+            </a:solidFill>
+            <a:prstDash val="solid"/>
+          </a:ln>
+        </p:spPr>
+      </p:sp>
+      <p:sp>
+        <p:nvSpPr>
+          <p:cNvPr id="12" name="out 3d label"/>
           <p:cNvSpPr txBox="1"/>
           <p:nvPr/>
         </p:nvSpPr>
         <p:spPr>
           <a:xfrm>
-            <a:off x="8503920" y="5945965"/>
-            <a:ext cx="3136392" cy="274320"/>
+            <a:off x="7726680" y="2423160"/>
+            <a:ext cx="3913632" cy="228600"/>
           </a:xfrm>
           <a:prstGeom prst="rect">
             <a:avLst/>
@@ -7925,21 +8027,117 @@
           <a:ln/>
         </p:spPr>
         <p:txBody>
-          <a:bodyPr wrap="square" lIns="0" tIns="0" rIns="0" bIns="0" rtlCol="0" anchor="t"/>
+          <a:bodyPr wrap="square" lIns="0" tIns="0" rIns="0" bIns="0" rtlCol="0" anchor="ctr"/>
           <a:lstStyle/>
           <a:p>
-            <a:pPr algn="ctr" indent="0" marL="0">
-              <a:buNone/>
-            </a:pPr>
-            <a:r>
-              <a:rPr lang="en-US" sz="1200" dirty="0">
+            <a:pPr indent="0" marL="0">
+              <a:buNone/>
+            </a:pPr>
+            <a:r>
+              <a:rPr lang="en-US" sz="1000" b="1" dirty="0">
                 <a:solidFill>
                   <a:srgbClr val="52514E"/>
+                </a:solidFill>
+              </a:rPr>
+              <a:t>Out: the same run in 3D, cut at the section</a:t>
+            </a:r>
+            <a:endParaRPr lang="en-US" sz="1000" dirty="0"/>
+          </a:p>
+        </p:txBody>
+      </p:sp>
+      <p:sp>
+        <p:nvSpPr>
+          <p:cNvPr id="13" name="studio link card"/>
+          <p:cNvSpPr/>
+          <p:nvPr/>
+        </p:nvSpPr>
+        <p:spPr>
+          <a:xfrm>
+            <a:off x="7726680" y="4937760"/>
+            <a:ext cx="3913632" cy="1143000"/>
+          </a:xfrm>
+          <a:prstGeom prst="roundRect">
+            <a:avLst>
+              <a:gd name="adj" fmla="val 5600"/>
+            </a:avLst>
+          </a:prstGeom>
+          <a:solidFill>
+            <a:schemeClr val="bg2"/>
+          </a:solidFill>
+          <a:ln/>
+        </p:spPr>
+      </p:sp>
+      <p:pic>
+        <p:nvPicPr>
+          <p:cNvPr id="14" name="qr studio" descr="/home/user/crossmep_dataset/docs/figures/qr_studio.png">    </p:cNvPr>
+          <p:cNvPicPr>
+            <a:picLocks noChangeAspect="1"/>
+          </p:cNvPicPr>
+          <p:nvPr/>
+        </p:nvPicPr>
+        <p:blipFill>
+          <a:blip r:embed="rId5"/>
+          <a:stretch>
+            <a:fillRect/>
+          </a:stretch>
+        </p:blipFill>
+        <p:spPr>
+          <a:xfrm>
+            <a:off x="7836408" y="4992624"/>
+            <a:ext cx="1033272" cy="1033272"/>
+          </a:xfrm>
+          <a:prstGeom prst="rect">
+            <a:avLst/>
+          </a:prstGeom>
+        </p:spPr>
+      </p:pic>
+      <p:sp>
+        <p:nvSpPr>
+          <p:cNvPr id="15" name="studio link"/>
+          <p:cNvSpPr txBox="1"/>
+          <p:nvPr/>
+        </p:nvSpPr>
+        <p:spPr>
+          <a:xfrm>
+            <a:off x="8961120" y="4937760"/>
+            <a:ext cx="2542032" cy="1143000"/>
+          </a:xfrm>
+          <a:prstGeom prst="rect">
+            <a:avLst/>
+          </a:prstGeom>
+          <a:noFill/>
+          <a:ln/>
+        </p:spPr>
+        <p:txBody>
+          <a:bodyPr wrap="square" lIns="0" tIns="0" rIns="0" bIns="0" rtlCol="0" anchor="ctr"/>
+          <a:lstStyle/>
+          <a:p>
+            <a:pPr indent="0" marL="0">
+              <a:buNone/>
+            </a:pPr>
+            <a:r>
+              <a:rPr lang="en-US" sz="1250" b="1" dirty="0">
+                <a:solidFill>
+                  <a:schemeClr val="tx1"/>
                 </a:solidFill>
               </a:rPr>
               <a:t>Scan to open the studio</a:t>
             </a:r>
-            <a:endParaRPr lang="en-US" sz="1200" dirty="0"/>
+            <a:endParaRPr lang="en-US" sz="1250" dirty="0"/>
+          </a:p>
+          <a:p>
+            <a:pPr indent="0" marL="0">
+              <a:buNone/>
+            </a:pPr>
+            <a:r>
+              <a:rPr lang="en-US" sz="1050" dirty="0">
+                <a:solidFill>
+                  <a:srgbClr val="52514E"/>
+                </a:solidFill>
+              </a:rPr>
+              <a:t>every section is a stored output of the released generator, with the call that reproduces it</a:t>
+            </a:r>
+            <a:endParaRPr lang="en-US" sz="1250" dirty="0"/>
           </a:p>
         </p:txBody>
       </p:sp>
@@ -8045,7 +8243,7 @@
                   <a:schemeClr val="tx1"/>
                 </a:solidFill>
               </a:rPr>
-              <a:t>Train on the generator, evaluate on the benchmark, report per tier</a:t>
+              <a:t>A method trains on the generator, is scored on the benchmark and reports per tier</a:t>
             </a:r>
             <a:endParaRPr lang="en-US" sz="2600" dirty="0"/>
           </a:p>
@@ -9061,7 +9259,7 @@
                   <a:schemeClr val="tx1"/>
                 </a:solidFill>
               </a:rPr>
-              <a:t>One section at one support today; a checker and real data come next</a:t>
+              <a:t>CrossMEP covers one section at one support today; a checker and real data come next</a:t>
             </a:r>
             <a:endParaRPr lang="en-US" sz="2600" dirty="0"/>
           </a:p>

</xml_diff>

<commit_message>
Talk: titles without semicolons, closing slide with takeaway tiles, Aptos Mono for code, 9 pt reference lines
</commit_message>
<xml_diff>
--- a/docs/CrossMEP_CIBW78_talk.pptx
+++ b/docs/CrossMEP_CIBW78_talk.pptx
@@ -122,12 +122,12 @@
   <p:extLst>
     <p:ext uri="{521415D9-36F7-43E2-AB2F-B90AF26B5E84}">
       <p14:sectionLst xmlns:p14="http://schemas.microsoft.com/office/powerpoint/2010/main">
-        <p14:section name="Opening" id="{a10a00d9-f52c-a06d-bec7-7c15829e526f}">
+        <p14:section name="Opening" id="{b4466766-735a-cf2e-8aa9-b2112eaf6a3c}">
           <p14:sldIdLst>
             <p14:sldId id="256"/>
           </p14:sldIdLst>
         </p14:section>
-        <p14:section name="Motivation" id="{470bcb2e-d11f-ffb5-8373-db20879570b2}">
+        <p14:section name="Motivation" id="{0cfeaa64-8bf8-6ebf-024f-ea4ec869b525}">
           <p14:sldIdLst>
             <p14:sldId id="257"/>
             <p14:sldId id="258"/>
@@ -136,21 +136,21 @@
             <p14:sldId id="261"/>
           </p14:sldIdLst>
         </p14:section>
-        <p14:section name="The dataset" id="{ac643583-f124-4dd2-1e22-715ce0408d7c}">
+        <p14:section name="The dataset" id="{91d86600-df96-af2b-bb18-af608c2128d8}">
           <p14:sldIdLst>
             <p14:sldId id="262"/>
             <p14:sldId id="263"/>
             <p14:sldId id="264"/>
           </p14:sldIdLst>
         </p14:section>
-        <p14:section name="Experiments" id="{de0a8344-a63f-ce1c-537d-7981297762dd}">
+        <p14:section name="Experiments" id="{2017d6df-31b4-f22c-5a86-cb834ef606bc}">
           <p14:sldIdLst>
             <p14:sldId id="265"/>
             <p14:sldId id="266"/>
             <p14:sldId id="267"/>
           </p14:sldIdLst>
         </p14:section>
-        <p14:section name="Use" id="{00a8c7fd-79cc-c1fa-d5b7-14e8d0c72b45}">
+        <p14:section name="Use" id="{cc50ea19-d016-8cf8-dcbe-11df15abef9f}">
           <p14:sldIdLst>
             <p14:sldId id="268"/>
             <p14:sldId id="269"/>
@@ -5471,7 +5471,7 @@
                   <a:schemeClr val="tx1"/>
                 </a:solidFill>
               </a:rPr>
-              <a:t>Tier Cn holds exactly n elements; higher tiers are heavier and tighter, as designed</a:t>
+              <a:t>Tier Cn holds exactly n elements, and higher tiers are heavier and tighter as designed</a:t>
             </a:r>
             <a:endParaRPr lang="en-US" sz="2600" dirty="0"/>
           </a:p>
@@ -7198,14 +7198,14 @@
               <a:buNone/>
             </a:pPr>
             <a:r>
-              <a:rPr lang="en-US" sz="800" dirty="0">
+              <a:rPr lang="en-US" sz="900" dirty="0">
                 <a:solidFill>
                   <a:srgbClr val="52514E"/>
                 </a:solidFill>
               </a:rPr>
               <a:t>Sections every 250 mm, clinic pipe pairs weighted by shared length; models: buildingSMART Duplex Apartment and Medical-Dental Clinic [12].   [12] buildingSMART International (2020), Duplex Apartment and Medical-Dental Clinic sample IFC files, CC BY 4.0</a:t>
             </a:r>
-            <a:endParaRPr lang="en-US" sz="800" dirty="0"/>
+            <a:endParaRPr lang="en-US" sz="900" dirty="0"/>
           </a:p>
         </p:txBody>
       </p:sp>
@@ -7311,7 +7311,7 @@
                   <a:schemeClr val="tx1"/>
                 </a:solidFill>
               </a:rPr>
-              <a:t>A two-size catalog attaches 1 pipe in 7; the dataset shows what to cover</a:t>
+              <a:t>A two-size catalog attaches one pipe in seven, and the dataset shows what to cover</a:t>
             </a:r>
             <a:endParaRPr lang="en-US" sz="2600" dirty="0"/>
           </a:p>
@@ -7656,14 +7656,14 @@
               <a:buNone/>
             </a:pPr>
             <a:r>
-              <a:rPr lang="en-US" sz="800" dirty="0">
+              <a:rPr lang="en-US" sz="900" dirty="0">
                 <a:solidFill>
                   <a:srgbClr val="52514E"/>
                 </a:solidFill>
               </a:rPr>
               <a:t>[2] Pedrollo, Gvadzabia, Graeber &amp; Fischer (2026), CrossMEP, CIB W78 2026 (this paper)</a:t>
             </a:r>
-            <a:endParaRPr lang="en-US" sz="800" dirty="0"/>
+            <a:endParaRPr lang="en-US" sz="900" dirty="0"/>
           </a:p>
         </p:txBody>
       </p:sp>
@@ -9032,9 +9032,9 @@
                 <a:solidFill>
                   <a:srgbClr val="FFFFFF"/>
                 </a:solidFill>
-                <a:latin typeface="Courier New" pitchFamily="34" charset="0"/>
-                <a:ea typeface="Courier New" pitchFamily="34" charset="-122"/>
-                <a:cs typeface="Courier New" pitchFamily="34" charset="-120"/>
+                <a:latin typeface="Aptos Mono" pitchFamily="34" charset="0"/>
+                <a:ea typeface="Aptos Mono" pitchFamily="34" charset="-122"/>
+                <a:cs typeface="Aptos Mono" pitchFamily="34" charset="-120"/>
               </a:rPr>
               <a:t>import crossmep.tasks as cm</a:t>
             </a:r>
@@ -9049,9 +9049,9 @@
                 <a:solidFill>
                   <a:srgbClr val="FFFFFF"/>
                 </a:solidFill>
-                <a:latin typeface="Courier New" pitchFamily="34" charset="0"/>
-                <a:ea typeface="Courier New" pitchFamily="34" charset="-122"/>
-                <a:cs typeface="Courier New" pitchFamily="34" charset="-120"/>
+                <a:latin typeface="Aptos Mono" pitchFamily="34" charset="0"/>
+                <a:ea typeface="Aptos Mono" pitchFamily="34" charset="-122"/>
+                <a:cs typeface="Aptos Mono" pitchFamily="34" charset="-120"/>
               </a:rPr>
               <a:t>data = cm.load("benchmark")</a:t>
             </a:r>
@@ -9063,9 +9063,9 @@
                 <a:solidFill>
                   <a:srgbClr val="CADCFC"/>
                 </a:solidFill>
-                <a:latin typeface="Courier New" pitchFamily="34" charset="0"/>
-                <a:ea typeface="Courier New" pitchFamily="34" charset="-122"/>
-                <a:cs typeface="Courier New" pitchFamily="34" charset="-120"/>
+                <a:latin typeface="Aptos Mono" pitchFamily="34" charset="0"/>
+                <a:ea typeface="Aptos Mono" pitchFamily="34" charset="-122"/>
+                <a:cs typeface="Aptos Mono" pitchFamily="34" charset="-120"/>
               </a:rPr>
               <a:t>  # 1,000 contexts, or generate your own mix</a:t>
             </a:r>
@@ -9080,9 +9080,9 @@
                 <a:solidFill>
                   <a:srgbClr val="FFFFFF"/>
                 </a:solidFill>
-                <a:latin typeface="Courier New" pitchFamily="34" charset="0"/>
-                <a:ea typeface="Courier New" pitchFamily="34" charset="-122"/>
-                <a:cs typeface="Courier New" pitchFamily="34" charset="-120"/>
+                <a:latin typeface="Aptos Mono" pitchFamily="34" charset="0"/>
+                <a:ea typeface="Aptos Mono" pitchFamily="34" charset="-122"/>
+                <a:cs typeface="Aptos Mono" pitchFamily="34" charset="-120"/>
               </a:rPr>
               <a:t>from crossmep.evaluate import score, compare</a:t>
             </a:r>
@@ -9097,9 +9097,9 @@
                 <a:solidFill>
                   <a:srgbClr val="FFFFFF"/>
                 </a:solidFill>
-                <a:latin typeface="Courier New" pitchFamily="34" charset="0"/>
-                <a:ea typeface="Courier New" pitchFamily="34" charset="-122"/>
-                <a:cs typeface="Courier New" pitchFamily="34" charset="-120"/>
+                <a:latin typeface="Aptos Mono" pitchFamily="34" charset="0"/>
+                <a:ea typeface="Aptos Mono" pitchFamily="34" charset="-122"/>
+                <a:cs typeface="Aptos Mono" pitchFamily="34" charset="-120"/>
               </a:rPr>
               <a:t>score(my_results, data)</a:t>
             </a:r>
@@ -9111,9 +9111,9 @@
                 <a:solidFill>
                   <a:srgbClr val="CADCFC"/>
                 </a:solidFill>
-                <a:latin typeface="Courier New" pitchFamily="34" charset="0"/>
-                <a:ea typeface="Courier New" pitchFamily="34" charset="-122"/>
-                <a:cs typeface="Courier New" pitchFamily="34" charset="-120"/>
+                <a:latin typeface="Aptos Mono" pitchFamily="34" charset="0"/>
+                <a:ea typeface="Aptos Mono" pitchFamily="34" charset="-122"/>
+                <a:cs typeface="Aptos Mono" pitchFamily="34" charset="-120"/>
               </a:rPr>
               <a:t>  # per tier, 95 % CI    compare(mine, baseline, data)  # paired test</a:t>
             </a:r>
@@ -9259,7 +9259,7 @@
                   <a:schemeClr val="tx1"/>
                 </a:solidFill>
               </a:rPr>
-              <a:t>CrossMEP covers one section at one support today; a checker and real data come next</a:t>
+              <a:t>CrossMEP covers one section at one support today, and a checker and real data come next</a:t>
             </a:r>
             <a:endParaRPr lang="en-US" sz="2600" dirty="0"/>
           </a:p>
@@ -10210,7 +10210,7 @@
                   <a:srgbClr val="CADCFC"/>
                 </a:solidFill>
               </a:rPr>
-              <a:t>7,000 support-design problems  ·  every constant sourced or declared</a:t>
+              <a:t>CrossMEP is the brief, not the answer: seven thousand support-design problems, open to anyone who wants to teach a machine to design supports.</a:t>
             </a:r>
             <a:endParaRPr lang="en-US" sz="1600" dirty="0"/>
           </a:p>
@@ -10219,12 +10219,12 @@
               <a:buNone/>
             </a:pPr>
             <a:r>
-              <a:rPr lang="en-US" sz="1600" dirty="0">
+              <a:rPr lang="en-US" sz="600" dirty="0">
                 <a:solidFill>
                   <a:srgbClr val="CADCFC"/>
                 </a:solidFill>
               </a:rPr>
-              <a:t>pipe gaps checked on two open buildings  ·  open data and code</a:t>
+              <a:t> </a:t>
             </a:r>
             <a:endParaRPr lang="en-US" sz="1600" dirty="0"/>
           </a:p>
@@ -10233,34 +10233,42 @@
               <a:buNone/>
             </a:pPr>
             <a:r>
-              <a:rPr lang="en-US" sz="800" dirty="0">
+              <a:rPr lang="en-US" sz="1200" dirty="0">
                 <a:solidFill>
                   <a:srgbClr val="CADCFC"/>
                 </a:solidFill>
               </a:rPr>
-              <a:t> </a:t>
+              <a:t>Data CC BY 4.0, code MIT.  Not for the structural design of real installations.</a:t>
             </a:r>
             <a:endParaRPr lang="en-US" sz="1600" dirty="0"/>
           </a:p>
-          <a:p>
-            <a:pPr indent="0" marL="0">
-              <a:buNone/>
-            </a:pPr>
-            <a:r>
-              <a:rPr lang="en-US" sz="1300" dirty="0">
-                <a:solidFill>
-                  <a:srgbClr val="CADCFC"/>
-                </a:solidFill>
-              </a:rPr>
-              <a:t>Data CC BY 4.0, code MIT.  Not for the structural design of real installations.</a:t>
-            </a:r>
-            <a:endParaRPr lang="en-US" sz="1600" dirty="0"/>
-          </a:p>
         </p:txBody>
+      </p:sp>
+      <p:sp>
+        <p:nvSpPr>
+          <p:cNvPr id="4" name="takeaway 7,000"/>
+          <p:cNvSpPr/>
+          <p:nvPr/>
+        </p:nvSpPr>
+        <p:spPr>
+          <a:xfrm>
+            <a:off x="640080" y="4800600"/>
+            <a:ext cx="1771650" cy="1325880"/>
+          </a:xfrm>
+          <a:prstGeom prst="roundRect">
+            <a:avLst>
+              <a:gd name="adj" fmla="val 4828"/>
+            </a:avLst>
+          </a:prstGeom>
+          <a:solidFill>
+            <a:srgbClr val="2B3946"/>
+          </a:solidFill>
+          <a:ln/>
+        </p:spPr>
       </p:sp>
       <p:pic>
         <p:nvPicPr>
-          <p:cNvPr id="4" name="qr closing" descr="/home/user/crossmep_dataset/docs/figures/qr_repo.png">    </p:cNvPr>
+          <p:cNvPr id="5" name="takeaway icon 7,000" descr="preencoded.png">    </p:cNvPr>
           <p:cNvPicPr>
             <a:picLocks noChangeAspect="1"/>
           </p:cNvPicPr>
@@ -10274,8 +10282,8 @@
         </p:blipFill>
         <p:spPr>
           <a:xfrm>
-            <a:off x="8778240" y="2286000"/>
-            <a:ext cx="2103120" cy="2103120"/>
+            <a:off x="804672" y="4965192"/>
+            <a:ext cx="310896" cy="310896"/>
           </a:xfrm>
           <a:prstGeom prst="rect">
             <a:avLst/>
@@ -10284,29 +10292,101 @@
       </p:pic>
       <p:sp>
         <p:nvSpPr>
-          <p:cNvPr id="5" name="logo chip"/>
-          <p:cNvSpPr/>
-          <p:nvPr/>
-        </p:nvSpPr>
-        <p:spPr>
-          <a:xfrm>
-            <a:off x="8229600" y="4892040"/>
-            <a:ext cx="3566160" cy="1188720"/>
+          <p:cNvPr id="6" name="takeaway value 7,000"/>
+          <p:cNvSpPr txBox="1"/>
+          <p:nvPr/>
+        </p:nvSpPr>
+        <p:spPr>
+          <a:xfrm>
+            <a:off x="1207008" y="4910328"/>
+            <a:ext cx="1085850" cy="411480"/>
+          </a:xfrm>
+          <a:prstGeom prst="rect">
+            <a:avLst/>
+          </a:prstGeom>
+          <a:noFill/>
+          <a:ln/>
+        </p:spPr>
+        <p:txBody>
+          <a:bodyPr wrap="square" lIns="0" tIns="0" rIns="0" bIns="0" rtlCol="0" anchor="ctr"/>
+          <a:lstStyle/>
+          <a:p>
+            <a:pPr indent="0" marL="0">
+              <a:buNone/>
+            </a:pPr>
+            <a:r>
+              <a:rPr lang="en-US" sz="1700" b="1" dirty="0">
+                <a:solidFill>
+                  <a:srgbClr val="FFFFFF"/>
+                </a:solidFill>
+              </a:rPr>
+              <a:t>7,000</a:t>
+            </a:r>
+            <a:endParaRPr lang="en-US" sz="1700" dirty="0"/>
+          </a:p>
+        </p:txBody>
+      </p:sp>
+      <p:sp>
+        <p:nvSpPr>
+          <p:cNvPr id="7" name="takeaway label 7,000"/>
+          <p:cNvSpPr txBox="1"/>
+          <p:nvPr/>
+        </p:nvSpPr>
+        <p:spPr>
+          <a:xfrm>
+            <a:off x="804672" y="5394960"/>
+            <a:ext cx="1442466" cy="658368"/>
+          </a:xfrm>
+          <a:prstGeom prst="rect">
+            <a:avLst/>
+          </a:prstGeom>
+          <a:noFill/>
+          <a:ln/>
+        </p:spPr>
+        <p:txBody>
+          <a:bodyPr wrap="square" lIns="0" tIns="0" rIns="0" bIns="0" rtlCol="0" anchor="t"/>
+          <a:lstStyle/>
+          <a:p>
+            <a:pPr indent="0" marL="0">
+              <a:buNone/>
+            </a:pPr>
+            <a:r>
+              <a:rPr lang="en-US" sz="1050" dirty="0">
+                <a:solidFill>
+                  <a:srgbClr val="CADCFC"/>
+                </a:solidFill>
+              </a:rPr>
+              <a:t>support-design problems in eight tiers</a:t>
+            </a:r>
+            <a:endParaRPr lang="en-US" sz="1050" dirty="0"/>
+          </a:p>
+        </p:txBody>
+      </p:sp>
+      <p:sp>
+        <p:nvSpPr>
+          <p:cNvPr id="8" name="takeaway Sourced"/>
+          <p:cNvSpPr/>
+          <p:nvPr/>
+        </p:nvSpPr>
+        <p:spPr>
+          <a:xfrm>
+            <a:off x="2548890" y="4800600"/>
+            <a:ext cx="1771650" cy="1325880"/>
           </a:xfrm>
           <a:prstGeom prst="roundRect">
             <a:avLst>
-              <a:gd name="adj" fmla="val 6154"/>
+              <a:gd name="adj" fmla="val 4828"/>
             </a:avLst>
           </a:prstGeom>
           <a:solidFill>
-            <a:srgbClr val="FFFFFF"/>
+            <a:srgbClr val="2B3946"/>
           </a:solidFill>
           <a:ln/>
         </p:spPr>
       </p:sp>
       <p:pic>
         <p:nvPicPr>
-          <p:cNvPr id="6" name="logo stanford" descr="preencoded.png">    </p:cNvPr>
+          <p:cNvPr id="9" name="takeaway icon Sourced" descr="preencoded.png">    </p:cNvPr>
           <p:cNvPicPr>
             <a:picLocks noChangeAspect="1"/>
           </p:cNvPicPr>
@@ -10320,17 +10400,111 @@
         </p:blipFill>
         <p:spPr>
           <a:xfrm>
-            <a:off x="8412480" y="5078476"/>
-            <a:ext cx="2011680" cy="815848"/>
+            <a:off x="2713482" y="4965192"/>
+            <a:ext cx="310896" cy="310896"/>
           </a:xfrm>
           <a:prstGeom prst="rect">
             <a:avLst/>
           </a:prstGeom>
         </p:spPr>
       </p:pic>
+      <p:sp>
+        <p:nvSpPr>
+          <p:cNvPr id="10" name="takeaway value Sourced"/>
+          <p:cNvSpPr txBox="1"/>
+          <p:nvPr/>
+        </p:nvSpPr>
+        <p:spPr>
+          <a:xfrm>
+            <a:off x="3115818" y="4910328"/>
+            <a:ext cx="1085850" cy="411480"/>
+          </a:xfrm>
+          <a:prstGeom prst="rect">
+            <a:avLst/>
+          </a:prstGeom>
+          <a:noFill/>
+          <a:ln/>
+        </p:spPr>
+        <p:txBody>
+          <a:bodyPr wrap="square" lIns="0" tIns="0" rIns="0" bIns="0" rtlCol="0" anchor="ctr"/>
+          <a:lstStyle/>
+          <a:p>
+            <a:pPr indent="0" marL="0">
+              <a:buNone/>
+            </a:pPr>
+            <a:r>
+              <a:rPr lang="en-US" sz="1700" b="1" dirty="0">
+                <a:solidFill>
+                  <a:srgbClr val="FFFFFF"/>
+                </a:solidFill>
+              </a:rPr>
+              <a:t>Sourced</a:t>
+            </a:r>
+            <a:endParaRPr lang="en-US" sz="1700" dirty="0"/>
+          </a:p>
+        </p:txBody>
+      </p:sp>
+      <p:sp>
+        <p:nvSpPr>
+          <p:cNvPr id="11" name="takeaway label Sourced"/>
+          <p:cNvSpPr txBox="1"/>
+          <p:nvPr/>
+        </p:nvSpPr>
+        <p:spPr>
+          <a:xfrm>
+            <a:off x="2713482" y="5394960"/>
+            <a:ext cx="1442466" cy="658368"/>
+          </a:xfrm>
+          <a:prstGeom prst="rect">
+            <a:avLst/>
+          </a:prstGeom>
+          <a:noFill/>
+          <a:ln/>
+        </p:spPr>
+        <p:txBody>
+          <a:bodyPr wrap="square" lIns="0" tIns="0" rIns="0" bIns="0" rtlCol="0" anchor="t"/>
+          <a:lstStyle/>
+          <a:p>
+            <a:pPr indent="0" marL="0">
+              <a:buNone/>
+            </a:pPr>
+            <a:r>
+              <a:rPr lang="en-US" sz="1050" dirty="0">
+                <a:solidFill>
+                  <a:srgbClr val="CADCFC"/>
+                </a:solidFill>
+              </a:rPr>
+              <a:t>every constant sourced or declared</a:t>
+            </a:r>
+            <a:endParaRPr lang="en-US" sz="1050" dirty="0"/>
+          </a:p>
+        </p:txBody>
+      </p:sp>
+      <p:sp>
+        <p:nvSpPr>
+          <p:cNvPr id="12" name="takeaway Checked"/>
+          <p:cNvSpPr/>
+          <p:nvPr/>
+        </p:nvSpPr>
+        <p:spPr>
+          <a:xfrm>
+            <a:off x="4457700" y="4800600"/>
+            <a:ext cx="1771650" cy="1325880"/>
+          </a:xfrm>
+          <a:prstGeom prst="roundRect">
+            <a:avLst>
+              <a:gd name="adj" fmla="val 4828"/>
+            </a:avLst>
+          </a:prstGeom>
+          <a:solidFill>
+            <a:srgbClr val="2B3946"/>
+          </a:solidFill>
+          <a:ln/>
+        </p:spPr>
+      </p:sp>
       <p:pic>
         <p:nvPicPr>
-          <p:cNvPr id="7" name="logo hilti" descr="preencoded.png">    </p:cNvPr>
+          <p:cNvPr id="13" name="takeaway icon Checked" descr="preencoded.png">    </p:cNvPr>
           <p:cNvPicPr>
             <a:picLocks noChangeAspect="1"/>
           </p:cNvPicPr>
@@ -10344,8 +10518,8 @@
         </p:blipFill>
         <p:spPr>
           <a:xfrm>
-            <a:off x="10607040" y="5364189"/>
-            <a:ext cx="1005840" cy="244423"/>
+            <a:off x="4622292" y="4965192"/>
+            <a:ext cx="310896" cy="310896"/>
           </a:xfrm>
           <a:prstGeom prst="rect">
             <a:avLst/>
@@ -10354,14 +10528,50 @@
       </p:pic>
       <p:sp>
         <p:nvSpPr>
-          <p:cNvPr id="8" name="closing link"/>
+          <p:cNvPr id="14" name="takeaway value Checked"/>
           <p:cNvSpPr txBox="1"/>
           <p:nvPr/>
         </p:nvSpPr>
         <p:spPr>
           <a:xfrm>
-            <a:off x="8503920" y="4480560"/>
-            <a:ext cx="3108960" cy="731520"/>
+            <a:off x="5024628" y="4910328"/>
+            <a:ext cx="1085850" cy="411480"/>
+          </a:xfrm>
+          <a:prstGeom prst="rect">
+            <a:avLst/>
+          </a:prstGeom>
+          <a:noFill/>
+          <a:ln/>
+        </p:spPr>
+        <p:txBody>
+          <a:bodyPr wrap="square" lIns="0" tIns="0" rIns="0" bIns="0" rtlCol="0" anchor="ctr"/>
+          <a:lstStyle/>
+          <a:p>
+            <a:pPr indent="0" marL="0">
+              <a:buNone/>
+            </a:pPr>
+            <a:r>
+              <a:rPr lang="en-US" sz="1700" b="1" dirty="0">
+                <a:solidFill>
+                  <a:srgbClr val="FFFFFF"/>
+                </a:solidFill>
+              </a:rPr>
+              <a:t>Checked</a:t>
+            </a:r>
+            <a:endParaRPr lang="en-US" sz="1700" dirty="0"/>
+          </a:p>
+        </p:txBody>
+      </p:sp>
+      <p:sp>
+        <p:nvSpPr>
+          <p:cNvPr id="15" name="takeaway label Checked"/>
+          <p:cNvSpPr txBox="1"/>
+          <p:nvPr/>
+        </p:nvSpPr>
+        <p:spPr>
+          <a:xfrm>
+            <a:off x="4622292" y="5394960"/>
+            <a:ext cx="1442466" cy="658368"/>
           </a:xfrm>
           <a:prstGeom prst="rect">
             <a:avLst/>
@@ -10373,6 +10583,184 @@
           <a:bodyPr wrap="square" lIns="0" tIns="0" rIns="0" bIns="0" rtlCol="0" anchor="t"/>
           <a:lstStyle/>
           <a:p>
+            <a:pPr indent="0" marL="0">
+              <a:buNone/>
+            </a:pPr>
+            <a:r>
+              <a:rPr lang="en-US" sz="1050" dirty="0">
+                <a:solidFill>
+                  <a:srgbClr val="CADCFC"/>
+                </a:solidFill>
+              </a:rPr>
+              <a:t>pipe gaps tested on two open buildings</a:t>
+            </a:r>
+            <a:endParaRPr lang="en-US" sz="1050" dirty="0"/>
+          </a:p>
+        </p:txBody>
+      </p:sp>
+      <p:sp>
+        <p:nvSpPr>
+          <p:cNvPr id="16" name="takeaway Open"/>
+          <p:cNvSpPr/>
+          <p:nvPr/>
+        </p:nvSpPr>
+        <p:spPr>
+          <a:xfrm>
+            <a:off x="6366510" y="4800600"/>
+            <a:ext cx="1771650" cy="1325880"/>
+          </a:xfrm>
+          <a:prstGeom prst="roundRect">
+            <a:avLst>
+              <a:gd name="adj" fmla="val 4828"/>
+            </a:avLst>
+          </a:prstGeom>
+          <a:solidFill>
+            <a:srgbClr val="2B3946"/>
+          </a:solidFill>
+          <a:ln/>
+        </p:spPr>
+      </p:sp>
+      <p:pic>
+        <p:nvPicPr>
+          <p:cNvPr id="17" name="takeaway icon Open" descr="preencoded.png">    </p:cNvPr>
+          <p:cNvPicPr>
+            <a:picLocks noChangeAspect="1"/>
+          </p:cNvPicPr>
+          <p:nvPr/>
+        </p:nvPicPr>
+        <p:blipFill>
+          <a:blip r:embed="rId4"/>
+          <a:stretch>
+            <a:fillRect/>
+          </a:stretch>
+        </p:blipFill>
+        <p:spPr>
+          <a:xfrm>
+            <a:off x="6531102" y="4965192"/>
+            <a:ext cx="310896" cy="310896"/>
+          </a:xfrm>
+          <a:prstGeom prst="rect">
+            <a:avLst/>
+          </a:prstGeom>
+        </p:spPr>
+      </p:pic>
+      <p:sp>
+        <p:nvSpPr>
+          <p:cNvPr id="18" name="takeaway value Open"/>
+          <p:cNvSpPr txBox="1"/>
+          <p:nvPr/>
+        </p:nvSpPr>
+        <p:spPr>
+          <a:xfrm>
+            <a:off x="6933438" y="4910328"/>
+            <a:ext cx="1085850" cy="411480"/>
+          </a:xfrm>
+          <a:prstGeom prst="rect">
+            <a:avLst/>
+          </a:prstGeom>
+          <a:noFill/>
+          <a:ln/>
+        </p:spPr>
+        <p:txBody>
+          <a:bodyPr wrap="square" lIns="0" tIns="0" rIns="0" bIns="0" rtlCol="0" anchor="ctr"/>
+          <a:lstStyle/>
+          <a:p>
+            <a:pPr indent="0" marL="0">
+              <a:buNone/>
+            </a:pPr>
+            <a:r>
+              <a:rPr lang="en-US" sz="1700" b="1" dirty="0">
+                <a:solidFill>
+                  <a:srgbClr val="FFFFFF"/>
+                </a:solidFill>
+              </a:rPr>
+              <a:t>Open</a:t>
+            </a:r>
+            <a:endParaRPr lang="en-US" sz="1700" dirty="0"/>
+          </a:p>
+        </p:txBody>
+      </p:sp>
+      <p:sp>
+        <p:nvSpPr>
+          <p:cNvPr id="19" name="takeaway label Open"/>
+          <p:cNvSpPr txBox="1"/>
+          <p:nvPr/>
+        </p:nvSpPr>
+        <p:spPr>
+          <a:xfrm>
+            <a:off x="6531102" y="5394960"/>
+            <a:ext cx="1442466" cy="658368"/>
+          </a:xfrm>
+          <a:prstGeom prst="rect">
+            <a:avLst/>
+          </a:prstGeom>
+          <a:noFill/>
+          <a:ln/>
+        </p:spPr>
+        <p:txBody>
+          <a:bodyPr wrap="square" lIns="0" tIns="0" rIns="0" bIns="0" rtlCol="0" anchor="t"/>
+          <a:lstStyle/>
+          <a:p>
+            <a:pPr indent="0" marL="0">
+              <a:buNone/>
+            </a:pPr>
+            <a:r>
+              <a:rPr lang="en-US" sz="1050" dirty="0">
+                <a:solidFill>
+                  <a:srgbClr val="CADCFC"/>
+                </a:solidFill>
+              </a:rPr>
+              <a:t>data, code and generator</a:t>
+            </a:r>
+            <a:endParaRPr lang="en-US" sz="1050" dirty="0"/>
+          </a:p>
+        </p:txBody>
+      </p:sp>
+      <p:pic>
+        <p:nvPicPr>
+          <p:cNvPr id="20" name="qr closing" descr="/home/user/crossmep_dataset/docs/figures/qr_repo.png">    </p:cNvPr>
+          <p:cNvPicPr>
+            <a:picLocks noChangeAspect="1"/>
+          </p:cNvPicPr>
+          <p:nvPr/>
+        </p:nvPicPr>
+        <p:blipFill>
+          <a:blip r:embed="rId5"/>
+          <a:stretch>
+            <a:fillRect/>
+          </a:stretch>
+        </p:blipFill>
+        <p:spPr>
+          <a:xfrm>
+            <a:off x="9006840" y="1600200"/>
+            <a:ext cx="2011680" cy="2011680"/>
+          </a:xfrm>
+          <a:prstGeom prst="rect">
+            <a:avLst/>
+          </a:prstGeom>
+        </p:spPr>
+      </p:pic>
+      <p:sp>
+        <p:nvSpPr>
+          <p:cNvPr id="21" name="closing link"/>
+          <p:cNvSpPr txBox="1"/>
+          <p:nvPr/>
+        </p:nvSpPr>
+        <p:spPr>
+          <a:xfrm>
+            <a:off x="8229600" y="3703320"/>
+            <a:ext cx="3566160" cy="685800"/>
+          </a:xfrm>
+          <a:prstGeom prst="rect">
+            <a:avLst/>
+          </a:prstGeom>
+          <a:noFill/>
+          <a:ln/>
+        </p:spPr>
+        <p:txBody>
+          <a:bodyPr wrap="square" lIns="0" tIns="0" rIns="0" bIns="0" rtlCol="0" anchor="t"/>
+          <a:lstStyle/>
+          <a:p>
             <a:pPr algn="ctr" indent="0" marL="0">
               <a:buNone/>
             </a:pPr>
@@ -10402,6 +10790,76 @@
           </a:p>
         </p:txBody>
       </p:sp>
+      <p:sp>
+        <p:nvSpPr>
+          <p:cNvPr id="22" name="logo chip"/>
+          <p:cNvSpPr/>
+          <p:nvPr/>
+        </p:nvSpPr>
+        <p:spPr>
+          <a:xfrm>
+            <a:off x="8229600" y="4892040"/>
+            <a:ext cx="3566160" cy="1188720"/>
+          </a:xfrm>
+          <a:prstGeom prst="roundRect">
+            <a:avLst>
+              <a:gd name="adj" fmla="val 6154"/>
+            </a:avLst>
+          </a:prstGeom>
+          <a:solidFill>
+            <a:srgbClr val="FFFFFF"/>
+          </a:solidFill>
+          <a:ln/>
+        </p:spPr>
+      </p:sp>
+      <p:pic>
+        <p:nvPicPr>
+          <p:cNvPr id="23" name="logo stanford" descr="preencoded.png">    </p:cNvPr>
+          <p:cNvPicPr>
+            <a:picLocks noChangeAspect="1"/>
+          </p:cNvPicPr>
+          <p:nvPr/>
+        </p:nvPicPr>
+        <p:blipFill>
+          <a:blip r:embed="rId6"/>
+          <a:stretch>
+            <a:fillRect/>
+          </a:stretch>
+        </p:blipFill>
+        <p:spPr>
+          <a:xfrm>
+            <a:off x="8412480" y="5078476"/>
+            <a:ext cx="2011680" cy="815848"/>
+          </a:xfrm>
+          <a:prstGeom prst="rect">
+            <a:avLst/>
+          </a:prstGeom>
+        </p:spPr>
+      </p:pic>
+      <p:pic>
+        <p:nvPicPr>
+          <p:cNvPr id="24" name="logo hilti" descr="preencoded.png">    </p:cNvPr>
+          <p:cNvPicPr>
+            <a:picLocks noChangeAspect="1"/>
+          </p:cNvPicPr>
+          <p:nvPr/>
+        </p:nvPicPr>
+        <p:blipFill>
+          <a:blip r:embed="rId7"/>
+          <a:stretch>
+            <a:fillRect/>
+          </a:stretch>
+        </p:blipFill>
+        <p:spPr>
+          <a:xfrm>
+            <a:off x="10607040" y="5364189"/>
+            <a:ext cx="1005840" cy="244423"/>
+          </a:xfrm>
+          <a:prstGeom prst="rect">
+            <a:avLst/>
+          </a:prstGeom>
+        </p:spPr>
+      </p:pic>
     </p:spTree>
   </p:cSld>
   <p:clrMapOvr>
@@ -11078,14 +11536,14 @@
               <a:buNone/>
             </a:pPr>
             <a:r>
-              <a:rPr lang="en-US" sz="800" dirty="0">
+              <a:rPr lang="en-US" sz="900" dirty="0">
                 <a:solidFill>
                   <a:srgbClr val="52514E"/>
                 </a:solidFill>
               </a:rPr>
               <a:t>Approximate practitioner estimates [1].   [1] Pedrollo, Graeber &amp; Fischer (2026), Feasibility-aware sequential synthesis of structural support assemblies, ISARC 2026</a:t>
             </a:r>
-            <a:endParaRPr lang="en-US" sz="800" dirty="0"/>
+            <a:endParaRPr lang="en-US" sz="900" dirty="0"/>
           </a:p>
         </p:txBody>
       </p:sp>
@@ -13078,14 +13536,14 @@
               <a:buNone/>
             </a:pPr>
             <a:r>
-              <a:rPr lang="en-US" sz="800" dirty="0">
+              <a:rPr lang="en-US" sz="900" dirty="0">
                 <a:solidFill>
                   <a:srgbClr val="52514E"/>
                 </a:solidFill>
               </a:rPr>
               <a:t>The synthesis problem as defined at ISARC 2026 [1].   [1] Pedrollo, Graeber &amp; Fischer (2026), Feasibility-aware sequential synthesis of structural support assemblies, ISARC 2026</a:t>
             </a:r>
-            <a:endParaRPr lang="en-US" sz="800" dirty="0"/>
+            <a:endParaRPr lang="en-US" sz="900" dirty="0"/>
           </a:p>
         </p:txBody>
       </p:sp>
@@ -13854,14 +14312,14 @@
               <a:buNone/>
             </a:pPr>
             <a:r>
-              <a:rPr lang="en-US" sz="800" dirty="0">
+              <a:rPr lang="en-US" sz="900" dirty="0">
                 <a:solidFill>
                   <a:srgbClr val="52514E"/>
                 </a:solidFill>
               </a:rPr>
               <a:t>[1] Pedrollo, Graeber &amp; Fischer (2026), Feasibility-aware sequential synthesis of structural support assemblies, ISARC 2026   [2] Pedrollo, Gvadzabia, Graeber &amp; Fischer (2026), CrossMEP, CIB W78 2026 (this paper)   [3] Korman, Fischer &amp; Tatum (2003), Knowledge and reasoning for MEP coordination, J. Constr. Eng. Manage. 129(6)</a:t>
             </a:r>
-            <a:endParaRPr lang="en-US" sz="800" dirty="0"/>
+            <a:endParaRPr lang="en-US" sz="900" dirty="0"/>
           </a:p>
         </p:txBody>
       </p:sp>
@@ -15679,7 +16137,7 @@
                   <a:schemeClr val="tx1"/>
                 </a:solidFill>
               </a:rPr>
-              <a:t>Real designs cover one corner of the design space; CrossMEP covers all of it</a:t>
+              <a:t>Real designs cover one corner of the design space and CrossMEP covers all of it</a:t>
             </a:r>
             <a:endParaRPr lang="en-US" sz="2600" dirty="0"/>
           </a:p>
@@ -21587,7 +22045,7 @@
                   <a:schemeClr val="tx1"/>
                 </a:solidFill>
               </a:rPr>
-              <a:t>We generate what a designer receives: the section at one hanger</a:t>
+              <a:t>We generate what a designer receives, the section at one hanger</a:t>
             </a:r>
             <a:endParaRPr lang="en-US" sz="2600" dirty="0"/>
           </a:p>
@@ -26414,14 +26872,14 @@
               <a:buNone/>
             </a:pPr>
             <a:r>
-              <a:rPr lang="en-US" sz="800" dirty="0">
+              <a:rPr lang="en-US" sz="900" dirty="0">
                 <a:solidFill>
                   <a:srgbClr val="52514E"/>
                 </a:solidFill>
               </a:rPr>
               <a:t>[3] Korman, Fischer &amp; Tatum (2003), Knowledge and reasoning for MEP coordination, J. Constr. Eng. Manage. 129(6)   [10] IET On-Site Guide (BS 7671), conduit support spacing; BS 7671 Reg. 528.3.2   [12] buildingSMART International (2020), Duplex Apartment and Medical-Dental Clinic sample IFC files, CC BY 4.0</a:t>
             </a:r>
-            <a:endParaRPr lang="en-US" sz="800" dirty="0"/>
+            <a:endParaRPr lang="en-US" sz="900" dirty="0"/>
           </a:p>
         </p:txBody>
       </p:sp>
@@ -26527,7 +26985,7 @@
                   <a:schemeClr val="tx1"/>
                 </a:solidFill>
               </a:rPr>
-              <a:t>Sizes, spans and loads come from standards; the choices are declared</a:t>
+              <a:t>Sizes, spans and loads come from standards, and the choices are declared</a:t>
             </a:r>
             <a:endParaRPr lang="en-US" sz="2600" dirty="0"/>
           </a:p>
@@ -27972,7 +28430,7 @@
         </p:nvSpPr>
         <p:spPr>
           <a:xfrm>
-            <a:off x="548640" y="5440680"/>
+            <a:off x="548640" y="5376672"/>
             <a:ext cx="11091672" cy="274320"/>
           </a:xfrm>
           <a:prstGeom prst="rect">
@@ -28008,8 +28466,8 @@
         </p:nvSpPr>
         <p:spPr>
           <a:xfrm>
-            <a:off x="548640" y="5715000"/>
-            <a:ext cx="11091672" cy="658368"/>
+            <a:off x="548640" y="5687568"/>
+            <a:ext cx="11091672" cy="694944"/>
           </a:xfrm>
           <a:prstGeom prst="rect">
             <a:avLst/>
@@ -28025,14 +28483,14 @@
               <a:buNone/>
             </a:pPr>
             <a:r>
-              <a:rPr lang="en-US" sz="800" dirty="0">
+              <a:rPr lang="en-US" sz="900" dirty="0">
                 <a:solidFill>
                   <a:srgbClr val="52514E"/>
                 </a:solidFill>
               </a:rPr>
               <a:t>[4] EN 10220:2002, EN 10255:2004 (steel tubes: dimensions, medium series)   [5] EN 1505:1997, EN 1506:2007 (sheet-metal air ducts: rectangular and circular dimensions)   [6] IEC 61386-1 (conduit systems), IEC 61537 (cable tray and ladder systems)   [7] NEMA VE 1 (metal cable tray systems: widths, load-class spans)   [8] ASME B31.1 Table 121.5 (hanger spacing), as republished in the ASHRAE Handbook, HVAC Systems and Equipment   [9] SMACNA, HVAC Duct Construction Standards, Metal and Flexible, Table 5-1   [10] IET On-Site Guide (BS 7671), conduit support spacing; BS 7671 Reg. 528.3.2   [11] GEG (Gebäudeenergiegesetz), Anlage 8 (pipe insulation thickness)   [12] buildingSMART International (2020), Duplex Apartment and Medical-Dental Clinic sample IFC files, CC BY 4.0</a:t>
             </a:r>
-            <a:endParaRPr lang="en-US" sz="800" dirty="0"/>
+            <a:endParaRPr lang="en-US" sz="900" dirty="0"/>
           </a:p>
         </p:txBody>
       </p:sp>

</xml_diff>

<commit_message>
Talk: fuller sentence titles on every slide
Co-Authored-By: Claude Fable 5.1 <noreply@anthropic.com>
Claude-Session: https://claude.ai/code/session_01R1ft1rokeRJHR95rzLxNEC
</commit_message>
<xml_diff>
--- a/docs/CrossMEP_CIBW78_talk.pptx
+++ b/docs/CrossMEP_CIBW78_talk.pptx
@@ -122,12 +122,12 @@
   <p:extLst>
     <p:ext uri="{521415D9-36F7-43E2-AB2F-B90AF26B5E84}">
       <p14:sectionLst xmlns:p14="http://schemas.microsoft.com/office/powerpoint/2010/main">
-        <p14:section name="Opening" id="{b4466766-735a-cf2e-8aa9-b2112eaf6a3c}">
+        <p14:section name="Opening" id="{e0ec0d28-b7e9-2b30-cab7-cb88ce53d1b0}">
           <p14:sldIdLst>
             <p14:sldId id="256"/>
           </p14:sldIdLst>
         </p14:section>
-        <p14:section name="Motivation" id="{0cfeaa64-8bf8-6ebf-024f-ea4ec869b525}">
+        <p14:section name="Motivation" id="{2e37f96a-1a60-990c-54a8-de63b802a8ef}">
           <p14:sldIdLst>
             <p14:sldId id="257"/>
             <p14:sldId id="258"/>
@@ -136,21 +136,21 @@
             <p14:sldId id="261"/>
           </p14:sldIdLst>
         </p14:section>
-        <p14:section name="The dataset" id="{91d86600-df96-af2b-bb18-af608c2128d8}">
+        <p14:section name="The dataset" id="{95c42947-36be-93d6-eb32-b1c88fe3083f}">
           <p14:sldIdLst>
             <p14:sldId id="262"/>
             <p14:sldId id="263"/>
             <p14:sldId id="264"/>
           </p14:sldIdLst>
         </p14:section>
-        <p14:section name="Experiments" id="{2017d6df-31b4-f22c-5a86-cb834ef606bc}">
+        <p14:section name="Experiments" id="{78cd0d0c-a576-613c-4741-5d54200ac191}">
           <p14:sldIdLst>
             <p14:sldId id="265"/>
             <p14:sldId id="266"/>
             <p14:sldId id="267"/>
           </p14:sldIdLst>
         </p14:section>
-        <p14:section name="Use" id="{cc50ea19-d016-8cf8-dcbe-11df15abef9f}">
+        <p14:section name="Use" id="{a404a41f-798e-5b16-676e-ceb1eb26102d}">
           <p14:sldIdLst>
             <p14:sldId id="268"/>
             <p14:sldId id="269"/>
@@ -5471,7 +5471,7 @@
                   <a:schemeClr val="tx1"/>
                 </a:solidFill>
               </a:rPr>
-              <a:t>Tier Cn holds exactly n elements, and higher tiers are heavier and tighter as designed</a:t>
+              <a:t>The tier fixes the element count, and load and congestion grow with it as the rules intend</a:t>
             </a:r>
             <a:endParaRPr lang="en-US" sz="2600" dirty="0"/>
           </a:p>
@@ -5647,7 +5647,7 @@
                   <a:schemeClr val="tx1"/>
                 </a:solidFill>
               </a:rPr>
-              <a:t>Spacing holds up on a clinic the generator never saw</a:t>
+              <a:t>Generated spacing matches a clinic the generator never saw to within 32 millimetres</a:t>
             </a:r>
             <a:endParaRPr lang="en-US" sz="2600" dirty="0"/>
           </a:p>
@@ -7311,7 +7311,7 @@
                   <a:schemeClr val="tx1"/>
                 </a:solidFill>
               </a:rPr>
-              <a:t>A two-size catalog attaches one pipe in seven, and the dataset shows what to cover</a:t>
+              <a:t>The paper’s two clamp sizes reach one pipe in seven, and the dataset says which sizes to add</a:t>
             </a:r>
             <a:endParaRPr lang="en-US" sz="2600" dirty="0"/>
           </a:p>
@@ -7769,7 +7769,7 @@
                   <a:schemeClr val="tx1"/>
                 </a:solidFill>
               </a:rPr>
-              <a:t>The Generator Studio turns a few parameters into the designer’s brief</a:t>
+              <a:t>Pick a tier or an exact mix and a seed, and the Generator Studio returns the designer’s brief</a:t>
             </a:r>
             <a:endParaRPr lang="en-US" sz="2600" dirty="0"/>
           </a:p>
@@ -8243,7 +8243,7 @@
                   <a:schemeClr val="tx1"/>
                 </a:solidFill>
               </a:rPr>
-              <a:t>A method trains on the generator, is scored on the benchmark and reports per tier</a:t>
+              <a:t>Methods train on the generator and are compared on one fixed benchmark, tier by tier</a:t>
             </a:r>
             <a:endParaRPr lang="en-US" sz="2600" dirty="0"/>
           </a:p>
@@ -9259,7 +9259,7 @@
                   <a:schemeClr val="tx1"/>
                 </a:solidFill>
               </a:rPr>
-              <a:t>CrossMEP covers one section at one support today, and a checker and real data come next</a:t>
+              <a:t>Today CrossMEP is one section at one support, and next come a checker and real projects</a:t>
             </a:r>
             <a:endParaRPr lang="en-US" sz="2600" dirty="0"/>
           </a:p>
@@ -10172,7 +10172,7 @@
                   <a:schemeClr val="bg1"/>
                 </a:solidFill>
               </a:rPr>
-              <a:t>Support design now has open problems to learn from</a:t>
+              <a:t>Support design finally has open problems to learn from</a:t>
             </a:r>
             <a:endParaRPr lang="en-US" sz="3600" dirty="0"/>
           </a:p>
@@ -10917,7 +10917,7 @@
                   <a:schemeClr val="tx1"/>
                 </a:solidFill>
               </a:rPr>
-              <a:t>A hospital needs about 10,000 support assemblies, each designed by hand</a:t>
+              <a:t>One hospital needs about ten thousand support assemblies, and every one of them is designed by hand</a:t>
             </a:r>
             <a:endParaRPr lang="en-US" sz="2600" dirty="0"/>
           </a:p>
@@ -11649,7 +11649,7 @@
                   <a:schemeClr val="tx1"/>
                 </a:solidFill>
               </a:rPr>
-              <a:t>A designer turns one cross-section into verified support assemblies</a:t>
+              <a:t>A support designer turns one cross-section into a set of verified support assemblies</a:t>
             </a:r>
             <a:endParaRPr lang="en-US" sz="2600" dirty="0"/>
           </a:p>
@@ -13649,7 +13649,7 @@
                   <a:schemeClr val="tx1"/>
                 </a:solidFill>
               </a:rPr>
-              <a:t>Synthesizing the assembly from a catalog and a context has resisted automation</a:t>
+              <a:t>Choosing the assembly from a catalog is still done by hand, one section at a time</a:t>
             </a:r>
             <a:endParaRPr lang="en-US" sz="2600" dirty="0"/>
           </a:p>
@@ -14425,7 +14425,7 @@
                   <a:schemeClr val="tx1"/>
                 </a:solidFill>
               </a:rPr>
-              <a:t>Whatever the method, it needs problems to learn from and a fixed set to compare on</a:t>
+              <a:t>Any method, learned or not, needs problems to learn from and a fixed benchmark to be judged on</a:t>
             </a:r>
             <a:endParaRPr lang="en-US" sz="2600" dirty="0"/>
           </a:p>
@@ -16137,7 +16137,7 @@
                   <a:schemeClr val="tx1"/>
                 </a:solidFill>
               </a:rPr>
-              <a:t>Real designs cover one corner of the design space and CrossMEP covers all of it</a:t>
+              <a:t>The real designs we had sat in one corner of the design space, so we generate the whole of it</a:t>
             </a:r>
             <a:endParaRPr lang="en-US" sz="2600" dirty="0"/>
           </a:p>
@@ -22045,7 +22045,7 @@
                   <a:schemeClr val="tx1"/>
                 </a:solidFill>
               </a:rPr>
-              <a:t>We generate what a designer receives, the section at one hanger</a:t>
+              <a:t>One context is exactly what a support designer receives at one hanger, without the answer</a:t>
             </a:r>
             <a:endParaRPr lang="en-US" sz="2600" dirty="0"/>
           </a:p>
@@ -25679,7 +25679,7 @@
                   <a:schemeClr val="tx1"/>
                 </a:solidFill>
               </a:rPr>
-              <a:t>Sections follow trade practice and measured spacing, not random shapes</a:t>
+              <a:t>Every section is built the way trades run services, with gaps measured on a real building</a:t>
             </a:r>
             <a:endParaRPr lang="en-US" sz="2600" dirty="0"/>
           </a:p>
@@ -26985,7 +26985,7 @@
                   <a:schemeClr val="tx1"/>
                 </a:solidFill>
               </a:rPr>
-              <a:t>Sizes, spans and loads come from standards, and the choices are declared</a:t>
+              <a:t>Every number is traced to a standard, to a measurement, or to a choice we declare as ours</a:t>
             </a:r>
             <a:endParaRPr lang="en-US" sz="2600" dirty="0"/>
           </a:p>

</xml_diff>

<commit_message>
Talk: slide 2 title names the hospital example and the quarter of MEP effort
Co-Authored-By: Claude Fable 5.1 <noreply@anthropic.com>
Claude-Session: https://claude.ai/code/session_01R1ft1rokeRJHR95rzLxNEC
</commit_message>
<xml_diff>
--- a/docs/CrossMEP_CIBW78_talk.pptx
+++ b/docs/CrossMEP_CIBW78_talk.pptx
@@ -122,12 +122,12 @@
   <p:extLst>
     <p:ext uri="{521415D9-36F7-43E2-AB2F-B90AF26B5E84}">
       <p14:sectionLst xmlns:p14="http://schemas.microsoft.com/office/powerpoint/2010/main">
-        <p14:section name="Opening" id="{e0ec0d28-b7e9-2b30-cab7-cb88ce53d1b0}">
+        <p14:section name="Opening" id="{73692e7e-ce23-ca71-b733-83d8f5f26d18}">
           <p14:sldIdLst>
             <p14:sldId id="256"/>
           </p14:sldIdLst>
         </p14:section>
-        <p14:section name="Motivation" id="{2e37f96a-1a60-990c-54a8-de63b802a8ef}">
+        <p14:section name="Motivation" id="{33d0a286-bc4d-b3be-fda6-de7ef45a5f8b}">
           <p14:sldIdLst>
             <p14:sldId id="257"/>
             <p14:sldId id="258"/>
@@ -136,21 +136,21 @@
             <p14:sldId id="261"/>
           </p14:sldIdLst>
         </p14:section>
-        <p14:section name="The dataset" id="{95c42947-36be-93d6-eb32-b1c88fe3083f}">
+        <p14:section name="The dataset" id="{0896a343-bdaa-af9c-70f6-d54d61a1a580}">
           <p14:sldIdLst>
             <p14:sldId id="262"/>
             <p14:sldId id="263"/>
             <p14:sldId id="264"/>
           </p14:sldIdLst>
         </p14:section>
-        <p14:section name="Experiments" id="{78cd0d0c-a576-613c-4741-5d54200ac191}">
+        <p14:section name="Experiments" id="{640c7115-02ba-9e67-b81a-b7d8e78a89d0}">
           <p14:sldIdLst>
             <p14:sldId id="265"/>
             <p14:sldId id="266"/>
             <p14:sldId id="267"/>
           </p14:sldIdLst>
         </p14:section>
-        <p14:section name="Use" id="{a404a41f-798e-5b16-676e-ceb1eb26102d}">
+        <p14:section name="Use" id="{831a1a4c-d691-8ae9-5554-5537b32c4e40}">
           <p14:sldIdLst>
             <p14:sldId id="268"/>
             <p14:sldId id="269"/>
@@ -10917,7 +10917,7 @@
                   <a:schemeClr val="tx1"/>
                 </a:solidFill>
               </a:rPr>
-              <a:t>One hospital needs about ten thousand support assemblies, and every one of them is designed by hand</a:t>
+              <a:t>In a hospital like this one, ten thousand structural support assemblies are each designed individually, which is why they take about a quarter of the MEP design effort</a:t>
             </a:r>
             <a:endParaRPr lang="en-US" sz="2600" dirty="0"/>
           </a:p>

</xml_diff>

<commit_message>
Talk: slide 2 title at 22 pt so it fits two lines
</commit_message>
<xml_diff>
--- a/docs/CrossMEP_CIBW78_talk.pptx
+++ b/docs/CrossMEP_CIBW78_talk.pptx
@@ -122,12 +122,12 @@
   <p:extLst>
     <p:ext uri="{521415D9-36F7-43E2-AB2F-B90AF26B5E84}">
       <p14:sectionLst xmlns:p14="http://schemas.microsoft.com/office/powerpoint/2010/main">
-        <p14:section name="Opening" id="{73692e7e-ce23-ca71-b733-83d8f5f26d18}">
+        <p14:section name="Opening" id="{2878eae6-b55f-17b7-d6eb-13f6f45b3ac7}">
           <p14:sldIdLst>
             <p14:sldId id="256"/>
           </p14:sldIdLst>
         </p14:section>
-        <p14:section name="Motivation" id="{33d0a286-bc4d-b3be-fda6-de7ef45a5f8b}">
+        <p14:section name="Motivation" id="{c71938c8-614f-ed62-242e-b53bfd996a8b}">
           <p14:sldIdLst>
             <p14:sldId id="257"/>
             <p14:sldId id="258"/>
@@ -136,21 +136,21 @@
             <p14:sldId id="261"/>
           </p14:sldIdLst>
         </p14:section>
-        <p14:section name="The dataset" id="{0896a343-bdaa-af9c-70f6-d54d61a1a580}">
+        <p14:section name="The dataset" id="{bd0de552-6164-9aa3-f80d-503fc014c6e1}">
           <p14:sldIdLst>
             <p14:sldId id="262"/>
             <p14:sldId id="263"/>
             <p14:sldId id="264"/>
           </p14:sldIdLst>
         </p14:section>
-        <p14:section name="Experiments" id="{640c7115-02ba-9e67-b81a-b7d8e78a89d0}">
+        <p14:section name="Experiments" id="{94ec47d0-46cf-e07c-8a88-cf3b6157eada}">
           <p14:sldIdLst>
             <p14:sldId id="265"/>
             <p14:sldId id="266"/>
             <p14:sldId id="267"/>
           </p14:sldIdLst>
         </p14:section>
-        <p14:section name="Use" id="{831a1a4c-d691-8ae9-5554-5537b32c4e40}">
+        <p14:section name="Use" id="{a447d00c-367e-a1f9-66cd-a5010be199ce}">
           <p14:sldIdLst>
             <p14:sldId id="268"/>
             <p14:sldId id="269"/>
@@ -10912,7 +10912,7 @@
               <a:buNone/>
             </a:pPr>
             <a:r>
-              <a:rPr lang="en-US" sz="2600" b="1" dirty="0">
+              <a:rPr lang="en-US" sz="2200" b="1" dirty="0">
                 <a:solidFill>
                   <a:schemeClr val="tx1"/>
                 </a:solidFill>

</xml_diff>

<commit_message>
Talk: slide 5 as a learning loop fed by generated contexts
The old flow diagram (inputs, rules, black box, verifier) is replaced by
the point it was making: a learning method proposes, is checked, and
improves round after round, and each round needs a new context. Below,
where contexts come from: a handful of real sections versus unlimited
generated ones, with an arrow into the loop. Speech and TALK.md updated;
the thumbnail helper is shared between slides 5 and 6.

Co-Authored-By: Claude Fable 5.1 <noreply@anthropic.com>
Claude-Session: https://claude.ai/code/session_01R1ft1rokeRJHR95rzLxNEC
</commit_message>
<xml_diff>
--- a/docs/CrossMEP_CIBW78_talk.pptx
+++ b/docs/CrossMEP_CIBW78_talk.pptx
@@ -122,12 +122,12 @@
   <p:extLst>
     <p:ext uri="{521415D9-36F7-43E2-AB2F-B90AF26B5E84}">
       <p14:sectionLst xmlns:p14="http://schemas.microsoft.com/office/powerpoint/2010/main">
-        <p14:section name="Opening" id="{2878eae6-b55f-17b7-d6eb-13f6f45b3ac7}">
+        <p14:section name="Opening" id="{f9e57f61-23ea-e421-605e-9c668a2b1fe9}">
           <p14:sldIdLst>
             <p14:sldId id="256"/>
           </p14:sldIdLst>
         </p14:section>
-        <p14:section name="Motivation" id="{c71938c8-614f-ed62-242e-b53bfd996a8b}">
+        <p14:section name="Motivation" id="{5f1f5531-bf01-66f7-fcea-f990a7d8a53c}">
           <p14:sldIdLst>
             <p14:sldId id="257"/>
             <p14:sldId id="258"/>
@@ -136,21 +136,21 @@
             <p14:sldId id="261"/>
           </p14:sldIdLst>
         </p14:section>
-        <p14:section name="The dataset" id="{bd0de552-6164-9aa3-f80d-503fc014c6e1}">
+        <p14:section name="The dataset" id="{a006b527-4799-ff66-2ac1-d3d2b47581c4}">
           <p14:sldIdLst>
             <p14:sldId id="262"/>
             <p14:sldId id="263"/>
             <p14:sldId id="264"/>
           </p14:sldIdLst>
         </p14:section>
-        <p14:section name="Experiments" id="{94ec47d0-46cf-e07c-8a88-cf3b6157eada}">
+        <p14:section name="Experiments" id="{ef7f460e-ed43-1b5f-c369-411e192d1c23}">
           <p14:sldIdLst>
             <p14:sldId id="265"/>
             <p14:sldId id="266"/>
             <p14:sldId id="267"/>
           </p14:sldIdLst>
         </p14:section>
-        <p14:section name="Use" id="{a447d00c-367e-a1f9-66cd-a5010be199ce}">
+        <p14:section name="Use" id="{2ced0474-f5f8-b029-9828-8f58023a8c18}">
           <p14:sldIdLst>
             <p14:sldId id="268"/>
             <p14:sldId id="269"/>
@@ -3043,7 +3043,7 @@
           <a:p>
             <a:r>
               <a:rPr lang="en-US" dirty="0"/>
-              <a:t>Three analyses. The first is a design check. Each tier adds one element: C1 is a single service, the most common support in any building; C8 has eight. Within a tier everything else varies, so the element count is the one controlled axis. Load at the support rises with the tier, from about 0.3 to 2.0 kilonewtons, and the closest gap narrows at every step, from 130 to about 51 millimetres. The dataset behaves as designed. (4:00)</a:t>
+              <a:t>Three analyses. The first is a design check. Each tier adds one element: C1 is a single service, the most common support in any building; C8 has eight. Within a tier everything else varies, so the element count is the one controlled axis. Load at the support rises with the tier, from about 0.3 to 2.0 kilonewtons, and the closest gap narrows at every step, from 130 to about 51 millimetres. The dataset behaves as designed. (4:05)</a:t>
             </a:r>
             <a:endParaRPr lang="en-US" dirty="0"/>
           </a:p>
@@ -3923,7 +3923,7 @@
           <a:p>
             <a:r>
               <a:rPr lang="en-US" dirty="0"/>
-              <a:t>What would a method look like? The context and a catalog go in. Rules say which actions are legal; each action adds parts. In the middle, a black box chooses the next action: a rule table, a search, or a learned policy. A verifier checks every finished design and feeds pass or fail back. Whatever sits in the black box, it needs problems to learn from, a fixed set to compare on, and problems that look like practice. (1:45)</a:t>
+              <a:t>How would a machine learn this? Give it a context, let it propose a design, check the design, and feed pass or fail back. Round after round, the method improves. Each round needs a new context. Real projects give a handful, from one project, under NDA: too few to practise on, and a method tuned on them only fits that project. So we generate the contexts, as many as a method needs, and fix one benchmark to judge every method on. (1:45)</a:t>
             </a:r>
             <a:endParaRPr lang="en-US" dirty="0"/>
           </a:p>
@@ -4099,7 +4099,7 @@
           <a:p>
             <a:r>
               <a:rPr lang="en-US" dirty="0"/>
-              <a:t>Here is one context: a two-dimensional section at one support. Each element has its kind, service and trade, its size, insulation and position, and its load: weight per metre times the span it was sized at. Add the surface, slab or wall, and that is all. No channel, no rods, no anchors, no correct answer, because a feasible support depends on the catalog you build from. (2:45)</a:t>
+              <a:t>Here is one context: a two-dimensional section at one support. Each element has its kind, service and trade, its size, insulation and position, and its load: weight per metre times the span it was sized at. Add the surface, slab or wall, and that is all. No channel, no rods, no anchors, no correct answer, because a feasible support depends on the catalog you build from. (2:50)</a:t>
             </a:r>
             <a:endParaRPr lang="en-US" dirty="0"/>
           </a:p>
@@ -14425,7 +14425,7 @@
                   <a:schemeClr val="tx1"/>
                 </a:solidFill>
               </a:rPr>
-              <a:t>Any method, learned or not, needs problems to learn from and a fixed benchmark to be judged on</a:t>
+              <a:t>A learning method needs thousands of contexts to practise on, and real projects give too few, so we generate them</a:t>
             </a:r>
             <a:endParaRPr lang="en-US" sz="2600" dirty="0"/>
           </a:p>
@@ -14433,166 +14433,222 @@
       </p:sp>
       <p:sp>
         <p:nvSpPr>
-          <p:cNvPr id="3" name="box context"/>
-          <p:cNvSpPr/>
-          <p:nvPr/>
-        </p:nvSpPr>
-        <p:spPr>
-          <a:xfrm>
-            <a:off x="548640" y="1554480"/>
-            <a:ext cx="1737360" cy="1097280"/>
+          <p:cNvPr id="3" name="loop heading"/>
+          <p:cNvSpPr txBox="1"/>
+          <p:nvPr/>
+        </p:nvSpPr>
+        <p:spPr>
+          <a:xfrm>
+            <a:off x="548640" y="1325880"/>
+            <a:ext cx="4572000" cy="274320"/>
+          </a:xfrm>
+          <a:prstGeom prst="rect">
+            <a:avLst/>
+          </a:prstGeom>
+          <a:noFill/>
+          <a:ln/>
+        </p:spPr>
+        <p:txBody>
+          <a:bodyPr wrap="square" lIns="0" tIns="0" rIns="0" bIns="0" rtlCol="0" anchor="ctr"/>
+          <a:lstStyle/>
+          <a:p>
+            <a:pPr indent="0" marL="0">
+              <a:buNone/>
+            </a:pPr>
+            <a:r>
+              <a:rPr lang="en-US" sz="1200" b="1" dirty="0">
+                <a:solidFill>
+                  <a:srgbClr val="52514E"/>
+                </a:solidFill>
+              </a:rPr>
+              <a:t>How a learning method learns, round after round</a:t>
+            </a:r>
+            <a:endParaRPr lang="en-US" sz="1200" dirty="0"/>
+          </a:p>
+        </p:txBody>
+      </p:sp>
+      <p:sp>
+        <p:nvSpPr>
+          <p:cNvPr id="4" name="box context"/>
+          <p:cNvSpPr/>
+          <p:nvPr/>
+        </p:nvSpPr>
+        <p:spPr>
+          <a:xfrm>
+            <a:off x="548640" y="1783080"/>
+            <a:ext cx="2103120" cy="1371600"/>
           </a:xfrm>
           <a:prstGeom prst="roundRect">
             <a:avLst>
-              <a:gd name="adj" fmla="val 5000"/>
+              <a:gd name="adj" fmla="val 4000"/>
             </a:avLst>
           </a:prstGeom>
           <a:solidFill>
             <a:schemeClr val="bg2"/>
           </a:solidFill>
-          <a:ln w="12700">
-            <a:solidFill>
-              <a:srgbClr val="52514E"/>
-            </a:solidFill>
-            <a:prstDash val="solid"/>
-          </a:ln>
-        </p:spPr>
-      </p:sp>
-      <p:sp>
-        <p:nvSpPr>
-          <p:cNvPr id="4" name="mini slab"/>
-          <p:cNvSpPr/>
-          <p:nvPr/>
-        </p:nvSpPr>
-        <p:spPr>
-          <a:xfrm>
-            <a:off x="777240" y="1664208"/>
-            <a:ext cx="1280160" cy="91440"/>
-          </a:xfrm>
-          <a:prstGeom prst="rect">
-            <a:avLst/>
-          </a:prstGeom>
-          <a:solidFill>
-            <a:srgbClr val="EEF1F4"/>
+          <a:ln w="19050">
+            <a:solidFill>
+              <a:schemeClr val="accent1"/>
+            </a:solidFill>
+            <a:prstDash val="solid"/>
+          </a:ln>
+        </p:spPr>
+      </p:sp>
+      <p:sp>
+        <p:nvSpPr>
+          <p:cNvPr id="5" name="mini card loop context"/>
+          <p:cNvSpPr/>
+          <p:nvPr/>
+        </p:nvSpPr>
+        <p:spPr>
+          <a:xfrm>
+            <a:off x="1005840" y="1892808"/>
+            <a:ext cx="1188720" cy="475488"/>
+          </a:xfrm>
+          <a:prstGeom prst="rect">
+            <a:avLst/>
+          </a:prstGeom>
+          <a:solidFill>
+            <a:srgbClr val="FFFFFF"/>
           </a:solidFill>
           <a:ln w="6350">
             <a:solidFill>
-              <a:srgbClr val="52514E"/>
-            </a:solidFill>
-            <a:prstDash val="solid"/>
-          </a:ln>
-        </p:spPr>
-      </p:sp>
-      <p:sp>
-        <p:nvSpPr>
-          <p:cNvPr id="5" name="mini duct"/>
-          <p:cNvSpPr/>
-          <p:nvPr/>
-        </p:nvSpPr>
-        <p:spPr>
-          <a:xfrm>
-            <a:off x="868680" y="1828800"/>
-            <a:ext cx="384048" cy="219456"/>
-          </a:xfrm>
-          <a:prstGeom prst="rect">
-            <a:avLst/>
-          </a:prstGeom>
-          <a:solidFill>
-            <a:srgbClr val="FFFFFF"/>
-          </a:solidFill>
-          <a:ln w="9525">
-            <a:solidFill>
-              <a:srgbClr val="52514E"/>
-            </a:solidFill>
-            <a:prstDash val="solid"/>
-          </a:ln>
-        </p:spPr>
-      </p:sp>
-      <p:sp>
-        <p:nvSpPr>
-          <p:cNvPr id="6" name="mini pipe a"/>
-          <p:cNvSpPr/>
-          <p:nvPr/>
-        </p:nvSpPr>
-        <p:spPr>
-          <a:xfrm>
-            <a:off x="1371600" y="1856232"/>
-            <a:ext cx="192024" cy="192024"/>
+              <a:srgbClr val="898781"/>
+            </a:solidFill>
+            <a:prstDash val="solid"/>
+          </a:ln>
+        </p:spPr>
+      </p:sp>
+      <p:sp>
+        <p:nvSpPr>
+          <p:cNvPr id="6" name="mini slab loop context"/>
+          <p:cNvSpPr/>
+          <p:nvPr/>
+        </p:nvSpPr>
+        <p:spPr>
+          <a:xfrm>
+            <a:off x="1051560" y="1938528"/>
+            <a:ext cx="1097280" cy="32004"/>
+          </a:xfrm>
+          <a:prstGeom prst="rect">
+            <a:avLst/>
+          </a:prstGeom>
+          <a:solidFill>
+            <a:srgbClr val="52514E"/>
+          </a:solidFill>
+          <a:ln/>
+        </p:spPr>
+      </p:sp>
+      <p:sp>
+        <p:nvSpPr>
+          <p:cNvPr id="7" name="mini loop context 0"/>
+          <p:cNvSpPr/>
+          <p:nvPr/>
+        </p:nvSpPr>
+        <p:spPr>
+          <a:xfrm>
+            <a:off x="1202436" y="2002536"/>
+            <a:ext cx="137160" cy="100584"/>
+          </a:xfrm>
+          <a:prstGeom prst="rect">
+            <a:avLst/>
+          </a:prstGeom>
+          <a:solidFill>
+            <a:schemeClr val="accent1"/>
+          </a:solidFill>
+          <a:ln w="5080">
+            <a:solidFill>
+              <a:srgbClr val="FFFFFF"/>
+            </a:solidFill>
+            <a:prstDash val="solid"/>
+          </a:ln>
+        </p:spPr>
+      </p:sp>
+      <p:sp>
+        <p:nvSpPr>
+          <p:cNvPr id="8" name="mini loop context 1"/>
+          <p:cNvSpPr/>
+          <p:nvPr/>
+        </p:nvSpPr>
+        <p:spPr>
+          <a:xfrm>
+            <a:off x="1449324" y="2011680"/>
+            <a:ext cx="82296" cy="82296"/>
           </a:xfrm>
           <a:prstGeom prst="ellipse">
             <a:avLst/>
           </a:prstGeom>
           <a:solidFill>
-            <a:srgbClr val="FFFFFF"/>
-          </a:solidFill>
-          <a:ln w="9525">
-            <a:solidFill>
-              <a:srgbClr val="52514E"/>
-            </a:solidFill>
-            <a:prstDash val="solid"/>
-          </a:ln>
-        </p:spPr>
-      </p:sp>
-      <p:sp>
-        <p:nvSpPr>
-          <p:cNvPr id="7" name="mini pipe b"/>
-          <p:cNvSpPr/>
-          <p:nvPr/>
-        </p:nvSpPr>
-        <p:spPr>
-          <a:xfrm>
-            <a:off x="1618488" y="1911096"/>
-            <a:ext cx="137160" cy="137160"/>
+            <a:schemeClr val="accent1"/>
+          </a:solidFill>
+          <a:ln w="5080">
+            <a:solidFill>
+              <a:srgbClr val="FFFFFF"/>
+            </a:solidFill>
+            <a:prstDash val="solid"/>
+          </a:ln>
+        </p:spPr>
+      </p:sp>
+      <p:sp>
+        <p:nvSpPr>
+          <p:cNvPr id="9" name="mini loop context 2"/>
+          <p:cNvSpPr/>
+          <p:nvPr/>
+        </p:nvSpPr>
+        <p:spPr>
+          <a:xfrm>
+            <a:off x="1668780" y="2011680"/>
+            <a:ext cx="82296" cy="82296"/>
           </a:xfrm>
           <a:prstGeom prst="ellipse">
             <a:avLst/>
           </a:prstGeom>
           <a:solidFill>
-            <a:srgbClr val="FFFFFF"/>
-          </a:solidFill>
-          <a:ln w="9525">
-            <a:solidFill>
-              <a:srgbClr val="52514E"/>
-            </a:solidFill>
-            <a:prstDash val="solid"/>
-          </a:ln>
-        </p:spPr>
-      </p:sp>
-      <p:sp>
-        <p:nvSpPr>
-          <p:cNvPr id="8" name="mini tray"/>
-          <p:cNvSpPr/>
-          <p:nvPr/>
-        </p:nvSpPr>
-        <p:spPr>
-          <a:xfrm>
-            <a:off x="1828800" y="1965960"/>
-            <a:ext cx="237744" cy="82296"/>
-          </a:xfrm>
-          <a:prstGeom prst="rect">
-            <a:avLst/>
-          </a:prstGeom>
-          <a:solidFill>
-            <a:srgbClr val="FFFFFF"/>
-          </a:solidFill>
-          <a:ln w="9525">
-            <a:solidFill>
-              <a:srgbClr val="52514E"/>
-            </a:solidFill>
-            <a:prstDash val="solid"/>
-          </a:ln>
-        </p:spPr>
-      </p:sp>
-      <p:sp>
-        <p:nvSpPr>
-          <p:cNvPr id="9" name="text context"/>
+            <a:schemeClr val="accent1"/>
+          </a:solidFill>
+          <a:ln w="5080">
+            <a:solidFill>
+              <a:srgbClr val="FFFFFF"/>
+            </a:solidFill>
+            <a:prstDash val="solid"/>
+          </a:ln>
+        </p:spPr>
+      </p:sp>
+      <p:sp>
+        <p:nvSpPr>
+          <p:cNvPr id="10" name="mini loop context 3"/>
+          <p:cNvSpPr/>
+          <p:nvPr/>
+        </p:nvSpPr>
+        <p:spPr>
+          <a:xfrm>
+            <a:off x="1874520" y="2029968"/>
+            <a:ext cx="109728" cy="45720"/>
+          </a:xfrm>
+          <a:prstGeom prst="rect">
+            <a:avLst/>
+          </a:prstGeom>
+          <a:solidFill>
+            <a:schemeClr val="accent1"/>
+          </a:solidFill>
+          <a:ln w="5080">
+            <a:solidFill>
+              <a:srgbClr val="FFFFFF"/>
+            </a:solidFill>
+            <a:prstDash val="solid"/>
+          </a:ln>
+        </p:spPr>
+      </p:sp>
+      <p:sp>
+        <p:nvSpPr>
+          <p:cNvPr id="11" name="text context"/>
           <p:cNvSpPr txBox="1"/>
           <p:nvPr/>
         </p:nvSpPr>
         <p:spPr>
           <a:xfrm>
-            <a:off x="548640" y="2084832"/>
-            <a:ext cx="1737360" cy="548640"/>
+            <a:off x="548640" y="2404872"/>
+            <a:ext cx="2103120" cy="731520"/>
           </a:xfrm>
           <a:prstGeom prst="rect">
             <a:avLst/>
@@ -14601,7 +14657,7 @@
           <a:ln/>
         </p:spPr>
         <p:txBody>
-          <a:bodyPr wrap="square" lIns="1016" tIns="1016" rIns="1016" bIns="1016" rtlCol="0" anchor="ctr"/>
+          <a:bodyPr wrap="square" lIns="762" tIns="762" rIns="762" bIns="762" rtlCol="0" anchor="t"/>
           <a:lstStyle/>
           <a:p>
             <a:pPr algn="ctr" indent="0" marL="0">
@@ -14622,12 +14678,12 @@
               <a:buNone/>
             </a:pPr>
             <a:r>
-              <a:rPr lang="en-US" sz="1150" dirty="0">
+              <a:rPr lang="en-US" sz="1100" dirty="0">
                 <a:solidFill>
                   <a:srgbClr val="52514E"/>
                 </a:solidFill>
               </a:rPr>
-              <a:t>structure, services, loads</a:t>
+              <a:t>one section at a hanger, without the answer</a:t>
             </a:r>
             <a:endParaRPr lang="en-US" sz="1400" dirty="0"/>
           </a:p>
@@ -14635,109 +14691,29 @@
       </p:sp>
       <p:sp>
         <p:nvSpPr>
-          <p:cNvPr id="10" name="box catalog"/>
-          <p:cNvSpPr/>
-          <p:nvPr/>
-        </p:nvSpPr>
-        <p:spPr>
-          <a:xfrm>
-            <a:off x="640080" y="2743200"/>
-            <a:ext cx="1554480" cy="1051560"/>
-          </a:xfrm>
-          <a:prstGeom prst="can">
-            <a:avLst/>
-          </a:prstGeom>
-          <a:solidFill>
-            <a:schemeClr val="bg2"/>
-          </a:solidFill>
-          <a:ln w="12700">
-            <a:solidFill>
-              <a:srgbClr val="52514E"/>
-            </a:solidFill>
-            <a:prstDash val="solid"/>
-          </a:ln>
-        </p:spPr>
-      </p:sp>
-      <p:sp>
-        <p:nvSpPr>
-          <p:cNvPr id="11" name="text catalog"/>
-          <p:cNvSpPr txBox="1"/>
-          <p:nvPr/>
-        </p:nvSpPr>
-        <p:spPr>
-          <a:xfrm>
-            <a:off x="548640" y="2834640"/>
-            <a:ext cx="1737360" cy="914400"/>
-          </a:xfrm>
-          <a:prstGeom prst="rect">
-            <a:avLst/>
-          </a:prstGeom>
-          <a:noFill/>
-          <a:ln/>
-        </p:spPr>
-        <p:txBody>
-          <a:bodyPr wrap="square" lIns="1016" tIns="1016" rIns="1016" bIns="1016" rtlCol="0" anchor="ctr"/>
-          <a:lstStyle/>
-          <a:p>
-            <a:pPr algn="ctr" indent="0" marL="0">
-              <a:buNone/>
-            </a:pPr>
-            <a:r>
-              <a:rPr lang="en-US" sz="1400" b="1" dirty="0">
-                <a:solidFill>
-                  <a:schemeClr val="tx1"/>
-                </a:solidFill>
-              </a:rPr>
-              <a:t>Catalog</a:t>
-            </a:r>
-            <a:endParaRPr lang="en-US" sz="1400" dirty="0"/>
-          </a:p>
-          <a:p>
-            <a:pPr algn="ctr" indent="0" marL="0">
-              <a:buNone/>
-            </a:pPr>
-            <a:r>
-              <a:rPr lang="en-US" sz="1150" dirty="0">
-                <a:solidFill>
-                  <a:srgbClr val="52514E"/>
-                </a:solidFill>
-              </a:rPr>
-              <a:t>parts, sizes, unit costs</a:t>
-            </a:r>
-            <a:endParaRPr lang="en-US" sz="1400" dirty="0"/>
-          </a:p>
-        </p:txBody>
-      </p:sp>
-      <p:sp>
-        <p:nvSpPr>
-          <p:cNvPr id="12" name="box rules"/>
-          <p:cNvSpPr/>
-          <p:nvPr/>
-        </p:nvSpPr>
-        <p:spPr>
-          <a:xfrm>
-            <a:off x="2743200" y="1554480"/>
-            <a:ext cx="1828800" cy="2240280"/>
+          <p:cNvPr id="12" name="black box method"/>
+          <p:cNvSpPr/>
+          <p:nvPr/>
+        </p:nvSpPr>
+        <p:spPr>
+          <a:xfrm>
+            <a:off x="3246120" y="1783080"/>
+            <a:ext cx="2468880" cy="1371600"/>
           </a:xfrm>
           <a:prstGeom prst="roundRect">
             <a:avLst>
-              <a:gd name="adj" fmla="val 3000"/>
+              <a:gd name="adj" fmla="val 4000"/>
             </a:avLst>
           </a:prstGeom>
           <a:solidFill>
-            <a:schemeClr val="bg2"/>
-          </a:solidFill>
-          <a:ln w="15875">
-            <a:solidFill>
-              <a:srgbClr val="1F2933"/>
-            </a:solidFill>
-            <a:prstDash val="solid"/>
-          </a:ln>
+            <a:srgbClr val="0B0B0B"/>
+          </a:solidFill>
+          <a:ln/>
         </p:spPr>
       </p:sp>
       <p:pic>
         <p:nvPicPr>
-          <p:cNvPr id="13" name="icon rules" descr="preencoded.png">    </p:cNvPr>
+          <p:cNvPr id="13" name="icon method" descr="preencoded.png">    </p:cNvPr>
           <p:cNvPicPr>
             <a:picLocks noChangeAspect="1"/>
           </p:cNvPicPr>
@@ -14751,7 +14727,7 @@
         </p:blipFill>
         <p:spPr>
           <a:xfrm>
-            <a:off x="3429000" y="1828800"/>
+            <a:off x="4251960" y="1911096"/>
             <a:ext cx="457200" cy="457200"/>
           </a:xfrm>
           <a:prstGeom prst="rect">
@@ -14761,14 +14737,14 @@
       </p:pic>
       <p:sp>
         <p:nvSpPr>
-          <p:cNvPr id="14" name="text rules"/>
+          <p:cNvPr id="14" name="text method"/>
           <p:cNvSpPr txBox="1"/>
           <p:nvPr/>
         </p:nvSpPr>
         <p:spPr>
           <a:xfrm>
-            <a:off x="2743200" y="2331720"/>
-            <a:ext cx="1828800" cy="1371600"/>
+            <a:off x="3246120" y="2404872"/>
+            <a:ext cx="2468880" cy="731520"/>
           </a:xfrm>
           <a:prstGeom prst="rect">
             <a:avLst/>
@@ -14777,7 +14753,7 @@
           <a:ln/>
         </p:spPr>
         <p:txBody>
-          <a:bodyPr wrap="square" lIns="1016" tIns="1016" rIns="1016" bIns="1016" rtlCol="0" anchor="ctr"/>
+          <a:bodyPr wrap="square" lIns="762" tIns="762" rIns="762" bIns="762" rtlCol="0" anchor="t"/>
           <a:lstStyle/>
           <a:p>
             <a:pPr algn="ctr" indent="0" marL="0">
@@ -14786,10 +14762,10 @@
             <a:r>
               <a:rPr lang="en-US" sz="1400" b="1" dirty="0">
                 <a:solidFill>
-                  <a:schemeClr val="tx1"/>
+                  <a:srgbClr val="FFFFFF"/>
                 </a:solidFill>
               </a:rPr>
-              <a:t>Rules</a:t>
+              <a:t>Learning method</a:t>
             </a:r>
             <a:endParaRPr lang="en-US" sz="1400" dirty="0"/>
           </a:p>
@@ -14798,12 +14774,12 @@
               <a:buNone/>
             </a:pPr>
             <a:r>
-              <a:rPr lang="en-US" sz="1150" dirty="0">
-                <a:solidFill>
-                  <a:srgbClr val="52514E"/>
+              <a:rPr lang="en-US" sz="1100" dirty="0">
+                <a:solidFill>
+                  <a:srgbClr val="CADCFC"/>
                 </a:solidFill>
               </a:rPr>
-              <a:t>which actions are legal in a state; each action adds parts</a:t>
+              <a:t>a black box that proposes a design</a:t>
             </a:r>
             <a:endParaRPr lang="en-US" sz="1400" dirty="0"/>
           </a:p>
@@ -14811,20 +14787,20 @@
       </p:sp>
       <p:sp>
         <p:nvSpPr>
-          <p:cNvPr id="15" name="arrow context to rules"/>
-          <p:cNvSpPr/>
-          <p:nvPr/>
-        </p:nvSpPr>
-        <p:spPr>
-          <a:xfrm>
-            <a:off x="2286000" y="2103120"/>
-            <a:ext cx="457200" cy="0"/>
+          <p:cNvPr id="15" name="arrow context to method"/>
+          <p:cNvSpPr/>
+          <p:nvPr/>
+        </p:nvSpPr>
+        <p:spPr>
+          <a:xfrm>
+            <a:off x="2651760" y="2468880"/>
+            <a:ext cx="594360" cy="0"/>
           </a:xfrm>
           <a:prstGeom prst="line">
             <a:avLst/>
           </a:prstGeom>
           <a:noFill/>
-          <a:ln w="15875">
+          <a:ln w="19050">
             <a:solidFill>
               <a:srgbClr val="52514E"/>
             </a:solidFill>
@@ -14835,53 +14811,270 @@
       </p:sp>
       <p:sp>
         <p:nvSpPr>
-          <p:cNvPr id="16" name="arrow catalog to rules"/>
-          <p:cNvSpPr/>
-          <p:nvPr/>
-        </p:nvSpPr>
-        <p:spPr>
-          <a:xfrm>
-            <a:off x="2194560" y="3291840"/>
-            <a:ext cx="548640" cy="0"/>
-          </a:xfrm>
-          <a:prstGeom prst="line">
-            <a:avLst/>
-          </a:prstGeom>
-          <a:noFill/>
-          <a:ln w="15875">
-            <a:solidFill>
-              <a:srgbClr val="52514E"/>
-            </a:solidFill>
-            <a:prstDash val="solid"/>
-            <a:tailEnd type="triangle"/>
-          </a:ln>
-        </p:spPr>
-      </p:sp>
-      <p:sp>
-        <p:nvSpPr>
-          <p:cNvPr id="17" name="black box approach"/>
-          <p:cNvSpPr/>
-          <p:nvPr/>
-        </p:nvSpPr>
-        <p:spPr>
-          <a:xfrm>
-            <a:off x="5120640" y="1554480"/>
-            <a:ext cx="2194560" cy="2240280"/>
+          <p:cNvPr id="16" name="box design"/>
+          <p:cNvSpPr/>
+          <p:nvPr/>
+        </p:nvSpPr>
+        <p:spPr>
+          <a:xfrm>
+            <a:off x="6309360" y="1783080"/>
+            <a:ext cx="2103120" cy="1371600"/>
           </a:xfrm>
           <a:prstGeom prst="roundRect">
             <a:avLst>
-              <a:gd name="adj" fmla="val 2500"/>
+              <a:gd name="adj" fmla="val 4000"/>
             </a:avLst>
           </a:prstGeom>
           <a:solidFill>
-            <a:srgbClr val="0B0B0B"/>
-          </a:solidFill>
-          <a:ln/>
+            <a:schemeClr val="bg2"/>
+          </a:solidFill>
+          <a:ln w="12700">
+            <a:solidFill>
+              <a:srgbClr val="52514E"/>
+            </a:solidFill>
+            <a:prstDash val="solid"/>
+          </a:ln>
+        </p:spPr>
+      </p:sp>
+      <p:sp>
+        <p:nvSpPr>
+          <p:cNvPr id="17" name="mini out slab"/>
+          <p:cNvSpPr/>
+          <p:nvPr/>
+        </p:nvSpPr>
+        <p:spPr>
+          <a:xfrm>
+            <a:off x="6903720" y="1911096"/>
+            <a:ext cx="914400" cy="73152"/>
+          </a:xfrm>
+          <a:prstGeom prst="rect">
+            <a:avLst/>
+          </a:prstGeom>
+          <a:solidFill>
+            <a:srgbClr val="EEF1F4"/>
+          </a:solidFill>
+          <a:ln w="6350">
+            <a:solidFill>
+              <a:srgbClr val="52514E"/>
+            </a:solidFill>
+            <a:prstDash val="solid"/>
+          </a:ln>
+        </p:spPr>
+      </p:sp>
+      <p:sp>
+        <p:nvSpPr>
+          <p:cNvPr id="18" name="mini rod 0"/>
+          <p:cNvSpPr/>
+          <p:nvPr/>
+        </p:nvSpPr>
+        <p:spPr>
+          <a:xfrm>
+            <a:off x="6976872" y="1984248"/>
+            <a:ext cx="27432" cy="347472"/>
+          </a:xfrm>
+          <a:prstGeom prst="rect">
+            <a:avLst/>
+          </a:prstGeom>
+          <a:solidFill>
+            <a:srgbClr val="1F2933"/>
+          </a:solidFill>
+          <a:ln/>
+        </p:spPr>
+      </p:sp>
+      <p:sp>
+        <p:nvSpPr>
+          <p:cNvPr id="19" name="mini rod 1"/>
+          <p:cNvSpPr/>
+          <p:nvPr/>
+        </p:nvSpPr>
+        <p:spPr>
+          <a:xfrm>
+            <a:off x="7717536" y="1984248"/>
+            <a:ext cx="27432" cy="347472"/>
+          </a:xfrm>
+          <a:prstGeom prst="rect">
+            <a:avLst/>
+          </a:prstGeom>
+          <a:solidFill>
+            <a:srgbClr val="1F2933"/>
+          </a:solidFill>
+          <a:ln/>
+        </p:spPr>
+      </p:sp>
+      <p:sp>
+        <p:nvSpPr>
+          <p:cNvPr id="20" name="mini bar"/>
+          <p:cNvSpPr/>
+          <p:nvPr/>
+        </p:nvSpPr>
+        <p:spPr>
+          <a:xfrm>
+            <a:off x="6903720" y="2313432"/>
+            <a:ext cx="914400" cy="36576"/>
+          </a:xfrm>
+          <a:prstGeom prst="rect">
+            <a:avLst/>
+          </a:prstGeom>
+          <a:solidFill>
+            <a:srgbClr val="1F2933"/>
+          </a:solidFill>
+          <a:ln/>
+        </p:spPr>
+      </p:sp>
+      <p:sp>
+        <p:nvSpPr>
+          <p:cNvPr id="21" name="mini out pipe a"/>
+          <p:cNvSpPr/>
+          <p:nvPr/>
+        </p:nvSpPr>
+        <p:spPr>
+          <a:xfrm>
+            <a:off x="7132320" y="2130552"/>
+            <a:ext cx="182880" cy="182880"/>
+          </a:xfrm>
+          <a:prstGeom prst="ellipse">
+            <a:avLst/>
+          </a:prstGeom>
+          <a:solidFill>
+            <a:srgbClr val="FFFFFF"/>
+          </a:solidFill>
+          <a:ln w="9525">
+            <a:solidFill>
+              <a:srgbClr val="52514E"/>
+            </a:solidFill>
+            <a:prstDash val="solid"/>
+          </a:ln>
+        </p:spPr>
+      </p:sp>
+      <p:sp>
+        <p:nvSpPr>
+          <p:cNvPr id="22" name="mini out pipe b"/>
+          <p:cNvSpPr/>
+          <p:nvPr/>
+        </p:nvSpPr>
+        <p:spPr>
+          <a:xfrm>
+            <a:off x="7406640" y="2176272"/>
+            <a:ext cx="137160" cy="137160"/>
+          </a:xfrm>
+          <a:prstGeom prst="ellipse">
+            <a:avLst/>
+          </a:prstGeom>
+          <a:solidFill>
+            <a:srgbClr val="FFFFFF"/>
+          </a:solidFill>
+          <a:ln w="9525">
+            <a:solidFill>
+              <a:srgbClr val="52514E"/>
+            </a:solidFill>
+            <a:prstDash val="solid"/>
+          </a:ln>
+        </p:spPr>
+      </p:sp>
+      <p:sp>
+        <p:nvSpPr>
+          <p:cNvPr id="23" name="text design"/>
+          <p:cNvSpPr txBox="1"/>
+          <p:nvPr/>
+        </p:nvSpPr>
+        <p:spPr>
+          <a:xfrm>
+            <a:off x="6309360" y="2404872"/>
+            <a:ext cx="2103120" cy="731520"/>
+          </a:xfrm>
+          <a:prstGeom prst="rect">
+            <a:avLst/>
+          </a:prstGeom>
+          <a:noFill/>
+          <a:ln/>
+        </p:spPr>
+        <p:txBody>
+          <a:bodyPr wrap="square" lIns="762" tIns="762" rIns="762" bIns="762" rtlCol="0" anchor="t"/>
+          <a:lstStyle/>
+          <a:p>
+            <a:pPr algn="ctr" indent="0" marL="0">
+              <a:buNone/>
+            </a:pPr>
+            <a:r>
+              <a:rPr lang="en-US" sz="1400" b="1" dirty="0">
+                <a:solidFill>
+                  <a:schemeClr val="tx1"/>
+                </a:solidFill>
+              </a:rPr>
+              <a:t>Proposed design</a:t>
+            </a:r>
+            <a:endParaRPr lang="en-US" sz="1400" dirty="0"/>
+          </a:p>
+          <a:p>
+            <a:pPr algn="ctr" indent="0" marL="0">
+              <a:buNone/>
+            </a:pPr>
+            <a:r>
+              <a:rPr lang="en-US" sz="1100" dirty="0">
+                <a:solidFill>
+                  <a:srgbClr val="52514E"/>
+                </a:solidFill>
+              </a:rPr>
+              <a:t>an assembly: channel, rods, clamps, anchors</a:t>
+            </a:r>
+            <a:endParaRPr lang="en-US" sz="1400" dirty="0"/>
+          </a:p>
+        </p:txBody>
+      </p:sp>
+      <p:sp>
+        <p:nvSpPr>
+          <p:cNvPr id="24" name="arrow method to design"/>
+          <p:cNvSpPr/>
+          <p:nvPr/>
+        </p:nvSpPr>
+        <p:spPr>
+          <a:xfrm>
+            <a:off x="5715000" y="2468880"/>
+            <a:ext cx="594360" cy="0"/>
+          </a:xfrm>
+          <a:prstGeom prst="line">
+            <a:avLst/>
+          </a:prstGeom>
+          <a:noFill/>
+          <a:ln w="19050">
+            <a:solidFill>
+              <a:srgbClr val="52514E"/>
+            </a:solidFill>
+            <a:prstDash val="solid"/>
+            <a:tailEnd type="triangle"/>
+          </a:ln>
+        </p:spPr>
+      </p:sp>
+      <p:sp>
+        <p:nvSpPr>
+          <p:cNvPr id="25" name="box check"/>
+          <p:cNvSpPr/>
+          <p:nvPr/>
+        </p:nvSpPr>
+        <p:spPr>
+          <a:xfrm>
+            <a:off x="9006840" y="1783080"/>
+            <a:ext cx="2633472" cy="1371600"/>
+          </a:xfrm>
+          <a:prstGeom prst="roundRect">
+            <a:avLst>
+              <a:gd name="adj" fmla="val 4000"/>
+            </a:avLst>
+          </a:prstGeom>
+          <a:solidFill>
+            <a:srgbClr val="EAF5EE"/>
+          </a:solidFill>
+          <a:ln w="19050">
+            <a:solidFill>
+              <a:srgbClr val="008300"/>
+            </a:solidFill>
+            <a:prstDash val="solid"/>
+          </a:ln>
         </p:spPr>
       </p:sp>
       <p:pic>
         <p:nvPicPr>
-          <p:cNvPr id="18" name="icon approach" descr="preencoded.png">    </p:cNvPr>
+          <p:cNvPr id="26" name="icon check" descr="preencoded.png">    </p:cNvPr>
           <p:cNvPicPr>
             <a:picLocks noChangeAspect="1"/>
           </p:cNvPicPr>
@@ -14895,7 +15088,7 @@
         </p:blipFill>
         <p:spPr>
           <a:xfrm>
-            <a:off x="5989320" y="1828800"/>
+            <a:off x="10094976" y="1911096"/>
             <a:ext cx="457200" cy="457200"/>
           </a:xfrm>
           <a:prstGeom prst="rect">
@@ -14905,14 +15098,14 @@
       </p:pic>
       <p:sp>
         <p:nvSpPr>
-          <p:cNvPr id="19" name="text approach"/>
+          <p:cNvPr id="27" name="text check"/>
           <p:cNvSpPr txBox="1"/>
           <p:nvPr/>
         </p:nvSpPr>
         <p:spPr>
           <a:xfrm>
-            <a:off x="5120640" y="2331720"/>
-            <a:ext cx="2194560" cy="1371600"/>
+            <a:off x="9006840" y="2404872"/>
+            <a:ext cx="2633472" cy="731520"/>
           </a:xfrm>
           <a:prstGeom prst="rect">
             <a:avLst/>
@@ -14921,248 +15114,7 @@
           <a:ln/>
         </p:spPr>
         <p:txBody>
-          <a:bodyPr wrap="square" lIns="1016" tIns="1016" rIns="1016" bIns="1016" rtlCol="0" anchor="ctr"/>
-          <a:lstStyle/>
-          <a:p>
-            <a:pPr algn="ctr" indent="0" marL="0">
-              <a:buNone/>
-            </a:pPr>
-            <a:r>
-              <a:rPr lang="en-US" sz="1600" b="1" dirty="0">
-                <a:solidFill>
-                  <a:srgbClr val="FFFFFF"/>
-                </a:solidFill>
-              </a:rPr>
-              <a:t>Approach</a:t>
-            </a:r>
-            <a:endParaRPr lang="en-US" sz="1600" dirty="0"/>
-          </a:p>
-          <a:p>
-            <a:pPr algn="ctr" indent="0" marL="0">
-              <a:buNone/>
-            </a:pPr>
-            <a:r>
-              <a:rPr lang="en-US" sz="1150" dirty="0">
-                <a:solidFill>
-                  <a:srgbClr val="CADCFC"/>
-                </a:solidFill>
-              </a:rPr>
-              <a:t>a black box that chooses the next action</a:t>
-            </a:r>
-            <a:endParaRPr lang="en-US" sz="1600" dirty="0"/>
-          </a:p>
-          <a:p>
-            <a:pPr algn="ctr" indent="0" marL="0">
-              <a:buNone/>
-            </a:pPr>
-            <a:endParaRPr lang="en-US" sz="1600" dirty="0"/>
-          </a:p>
-          <a:p>
-            <a:pPr algn="ctr" indent="0" marL="0">
-              <a:buNone/>
-            </a:pPr>
-            <a:r>
-              <a:rPr lang="en-US" sz="1150" dirty="0">
-                <a:solidFill>
-                  <a:srgbClr val="CADCFC"/>
-                </a:solidFill>
-              </a:rPr>
-              <a:t>rule table · search · learned policy</a:t>
-            </a:r>
-            <a:endParaRPr lang="en-US" sz="1600" dirty="0"/>
-          </a:p>
-        </p:txBody>
-      </p:sp>
-      <p:sp>
-        <p:nvSpPr>
-          <p:cNvPr id="20" name="arrow legal actions"/>
-          <p:cNvSpPr/>
-          <p:nvPr/>
-        </p:nvSpPr>
-        <p:spPr>
-          <a:xfrm>
-            <a:off x="4572000" y="2354580"/>
-            <a:ext cx="548640" cy="0"/>
-          </a:xfrm>
-          <a:prstGeom prst="line">
-            <a:avLst/>
-          </a:prstGeom>
-          <a:noFill/>
-          <a:ln w="15875">
-            <a:solidFill>
-              <a:srgbClr val="52514E"/>
-            </a:solidFill>
-            <a:prstDash val="solid"/>
-            <a:tailEnd type="triangle"/>
-          </a:ln>
-        </p:spPr>
-      </p:sp>
-      <p:sp>
-        <p:nvSpPr>
-          <p:cNvPr id="21" name="label legal actions"/>
-          <p:cNvSpPr txBox="1"/>
-          <p:nvPr/>
-        </p:nvSpPr>
-        <p:spPr>
-          <a:xfrm>
-            <a:off x="4572000" y="2071116"/>
-            <a:ext cx="548640" cy="237744"/>
-          </a:xfrm>
-          <a:prstGeom prst="rect">
-            <a:avLst/>
-          </a:prstGeom>
-          <a:noFill/>
-          <a:ln/>
-        </p:spPr>
-        <p:txBody>
-          <a:bodyPr wrap="square" lIns="0" tIns="0" rIns="0" bIns="0" rtlCol="0" anchor="ctr"/>
-          <a:lstStyle/>
-          <a:p>
-            <a:pPr algn="ctr" indent="0" marL="0">
-              <a:buNone/>
-            </a:pPr>
-            <a:r>
-              <a:rPr lang="en-US" sz="1050" dirty="0">
-                <a:solidFill>
-                  <a:srgbClr val="52514E"/>
-                </a:solidFill>
-              </a:rPr>
-              <a:t>legal actions</a:t>
-            </a:r>
-            <a:endParaRPr lang="en-US" sz="1050" dirty="0"/>
-          </a:p>
-        </p:txBody>
-      </p:sp>
-      <p:sp>
-        <p:nvSpPr>
-          <p:cNvPr id="22" name="arrow chosen action"/>
-          <p:cNvSpPr/>
-          <p:nvPr/>
-        </p:nvSpPr>
-        <p:spPr>
-          <a:xfrm>
-            <a:off x="4572000" y="2994660"/>
-            <a:ext cx="548640" cy="0"/>
-          </a:xfrm>
-          <a:prstGeom prst="line">
-            <a:avLst/>
-          </a:prstGeom>
-          <a:noFill/>
-          <a:ln w="15875">
-            <a:solidFill>
-              <a:srgbClr val="52514E"/>
-            </a:solidFill>
-            <a:prstDash val="solid"/>
-            <a:headEnd type="triangle"/>
-          </a:ln>
-        </p:spPr>
-      </p:sp>
-      <p:sp>
-        <p:nvSpPr>
-          <p:cNvPr id="23" name="label chosen action"/>
-          <p:cNvSpPr txBox="1"/>
-          <p:nvPr/>
-        </p:nvSpPr>
-        <p:spPr>
-          <a:xfrm>
-            <a:off x="4572000" y="3040380"/>
-            <a:ext cx="548640" cy="237744"/>
-          </a:xfrm>
-          <a:prstGeom prst="rect">
-            <a:avLst/>
-          </a:prstGeom>
-          <a:noFill/>
-          <a:ln/>
-        </p:spPr>
-        <p:txBody>
-          <a:bodyPr wrap="square" lIns="0" tIns="0" rIns="0" bIns="0" rtlCol="0" anchor="ctr"/>
-          <a:lstStyle/>
-          <a:p>
-            <a:pPr algn="ctr" indent="0" marL="0">
-              <a:buNone/>
-            </a:pPr>
-            <a:r>
-              <a:rPr lang="en-US" sz="1050" dirty="0">
-                <a:solidFill>
-                  <a:srgbClr val="52514E"/>
-                </a:solidFill>
-              </a:rPr>
-              <a:t>chosen action</a:t>
-            </a:r>
-            <a:endParaRPr lang="en-US" sz="1050" dirty="0"/>
-          </a:p>
-        </p:txBody>
-      </p:sp>
-      <p:sp>
-        <p:nvSpPr>
-          <p:cNvPr id="24" name="box verifier"/>
-          <p:cNvSpPr/>
-          <p:nvPr/>
-        </p:nvSpPr>
-        <p:spPr>
-          <a:xfrm>
-            <a:off x="7863840" y="1554480"/>
-            <a:ext cx="1828800" cy="2240280"/>
-          </a:xfrm>
-          <a:prstGeom prst="roundRect">
-            <a:avLst>
-              <a:gd name="adj" fmla="val 3000"/>
-            </a:avLst>
-          </a:prstGeom>
-          <a:solidFill>
-            <a:srgbClr val="EAF5EE"/>
-          </a:solidFill>
-          <a:ln w="19050">
-            <a:solidFill>
-              <a:srgbClr val="008300"/>
-            </a:solidFill>
-            <a:prstDash val="solid"/>
-          </a:ln>
-        </p:spPr>
-      </p:sp>
-      <p:pic>
-        <p:nvPicPr>
-          <p:cNvPr id="25" name="icon verifier" descr="preencoded.png">    </p:cNvPr>
-          <p:cNvPicPr>
-            <a:picLocks noChangeAspect="1"/>
-          </p:cNvPicPr>
-          <p:nvPr/>
-        </p:nvPicPr>
-        <p:blipFill>
-          <a:blip r:embed="rId3"/>
-          <a:stretch>
-            <a:fillRect/>
-          </a:stretch>
-        </p:blipFill>
-        <p:spPr>
-          <a:xfrm>
-            <a:off x="8549640" y="1828800"/>
-            <a:ext cx="457200" cy="457200"/>
-          </a:xfrm>
-          <a:prstGeom prst="rect">
-            <a:avLst/>
-          </a:prstGeom>
-        </p:spPr>
-      </p:pic>
-      <p:sp>
-        <p:nvSpPr>
-          <p:cNvPr id="26" name="text verifier"/>
-          <p:cNvSpPr txBox="1"/>
-          <p:nvPr/>
-        </p:nvSpPr>
-        <p:spPr>
-          <a:xfrm>
-            <a:off x="7863840" y="2331720"/>
-            <a:ext cx="1828800" cy="1371600"/>
-          </a:xfrm>
-          <a:prstGeom prst="rect">
-            <a:avLst/>
-          </a:prstGeom>
-          <a:noFill/>
-          <a:ln/>
-        </p:spPr>
-        <p:txBody>
-          <a:bodyPr wrap="square" lIns="1016" tIns="1016" rIns="1016" bIns="1016" rtlCol="0" anchor="ctr"/>
+          <a:bodyPr wrap="square" lIns="762" tIns="762" rIns="762" bIns="762" rtlCol="0" anchor="t"/>
           <a:lstStyle/>
           <a:p>
             <a:pPr algn="ctr" indent="0" marL="0">
@@ -15174,7 +15126,7 @@
                   <a:schemeClr val="tx1"/>
                 </a:solidFill>
               </a:rPr>
-              <a:t>Verifier</a:t>
+              <a:t>Check</a:t>
             </a:r>
             <a:endParaRPr lang="en-US" sz="1400" dirty="0"/>
           </a:p>
@@ -15183,12 +15135,12 @@
               <a:buNone/>
             </a:pPr>
             <a:r>
-              <a:rPr lang="en-US" sz="1150" dirty="0">
+              <a:rPr lang="en-US" sz="1100" dirty="0">
                 <a:solidFill>
                   <a:srgbClr val="52514E"/>
                 </a:solidFill>
               </a:rPr>
-              <a:t>judges every finished design: statics, anchors, connectors, buildability</a:t>
+              <a:t>statics, anchors, connectors, buildability, cost</a:t>
             </a:r>
             <a:endParaRPr lang="en-US" sz="1400" dirty="0"/>
           </a:p>
@@ -15196,20 +15148,20 @@
       </p:sp>
       <p:sp>
         <p:nvSpPr>
-          <p:cNvPr id="27" name="arrow finished design"/>
-          <p:cNvSpPr/>
-          <p:nvPr/>
-        </p:nvSpPr>
-        <p:spPr>
-          <a:xfrm>
-            <a:off x="7315200" y="2674620"/>
-            <a:ext cx="548640" cy="0"/>
+          <p:cNvPr id="28" name="arrow design to check"/>
+          <p:cNvSpPr/>
+          <p:nvPr/>
+        </p:nvSpPr>
+        <p:spPr>
+          <a:xfrm>
+            <a:off x="8412480" y="2468880"/>
+            <a:ext cx="594360" cy="0"/>
           </a:xfrm>
           <a:prstGeom prst="line">
             <a:avLst/>
           </a:prstGeom>
           <a:noFill/>
-          <a:ln w="15875">
+          <a:ln w="19050">
             <a:solidFill>
               <a:srgbClr val="52514E"/>
             </a:solidFill>
@@ -15220,14 +15172,84 @@
       </p:sp>
       <p:sp>
         <p:nvSpPr>
-          <p:cNvPr id="28" name="label finished design"/>
+          <p:cNvPr id="29" name="feedback up"/>
+          <p:cNvSpPr/>
+          <p:nvPr/>
+        </p:nvSpPr>
+        <p:spPr>
+          <a:xfrm>
+            <a:off x="10323576" y="1600200"/>
+            <a:ext cx="0" cy="182880"/>
+          </a:xfrm>
+          <a:prstGeom prst="line">
+            <a:avLst/>
+          </a:prstGeom>
+          <a:noFill/>
+          <a:ln w="19050">
+            <a:solidFill>
+              <a:srgbClr val="008300"/>
+            </a:solidFill>
+            <a:prstDash val="dash"/>
+          </a:ln>
+        </p:spPr>
+      </p:sp>
+      <p:sp>
+        <p:nvSpPr>
+          <p:cNvPr id="30" name="feedback across"/>
+          <p:cNvSpPr/>
+          <p:nvPr/>
+        </p:nvSpPr>
+        <p:spPr>
+          <a:xfrm>
+            <a:off x="4480560" y="1600200"/>
+            <a:ext cx="5843016" cy="0"/>
+          </a:xfrm>
+          <a:prstGeom prst="line">
+            <a:avLst/>
+          </a:prstGeom>
+          <a:noFill/>
+          <a:ln w="19050">
+            <a:solidFill>
+              <a:srgbClr val="008300"/>
+            </a:solidFill>
+            <a:prstDash val="dash"/>
+          </a:ln>
+        </p:spPr>
+      </p:sp>
+      <p:sp>
+        <p:nvSpPr>
+          <p:cNvPr id="31" name="feedback down"/>
+          <p:cNvSpPr/>
+          <p:nvPr/>
+        </p:nvSpPr>
+        <p:spPr>
+          <a:xfrm>
+            <a:off x="4480560" y="1600200"/>
+            <a:ext cx="0" cy="182880"/>
+          </a:xfrm>
+          <a:prstGeom prst="line">
+            <a:avLst/>
+          </a:prstGeom>
+          <a:noFill/>
+          <a:ln w="19050">
+            <a:solidFill>
+              <a:srgbClr val="008300"/>
+            </a:solidFill>
+            <a:prstDash val="dash"/>
+            <a:tailEnd type="triangle"/>
+          </a:ln>
+        </p:spPr>
+      </p:sp>
+      <p:sp>
+        <p:nvSpPr>
+          <p:cNvPr id="32" name="label feedback"/>
           <p:cNvSpPr txBox="1"/>
           <p:nvPr/>
         </p:nvSpPr>
         <p:spPr>
           <a:xfrm>
-            <a:off x="7315200" y="2391156"/>
-            <a:ext cx="548640" cy="237744"/>
+            <a:off x="4754880" y="1325880"/>
+            <a:ext cx="5294376" cy="237744"/>
           </a:xfrm>
           <a:prstGeom prst="rect">
             <a:avLst/>
@@ -15243,189 +15265,97 @@
               <a:buNone/>
             </a:pPr>
             <a:r>
-              <a:rPr lang="en-US" sz="1050" dirty="0">
-                <a:solidFill>
-                  <a:srgbClr val="52514E"/>
+              <a:rPr lang="en-US" sz="1100" dirty="0">
+                <a:solidFill>
+                  <a:srgbClr val="008300"/>
                 </a:solidFill>
               </a:rPr>
-              <a:t>finished design</a:t>
+              <a:t>pass or fail is fed back, and the method improves</a:t>
             </a:r>
-            <a:endParaRPr lang="en-US" sz="1050" dirty="0"/>
+            <a:endParaRPr lang="en-US" sz="1100" dirty="0"/>
           </a:p>
         </p:txBody>
       </p:sp>
       <p:sp>
         <p:nvSpPr>
-          <p:cNvPr id="29" name="box output"/>
-          <p:cNvSpPr/>
-          <p:nvPr/>
-        </p:nvSpPr>
-        <p:spPr>
-          <a:xfrm>
-            <a:off x="10104120" y="1554480"/>
-            <a:ext cx="1536192" cy="2240280"/>
-          </a:xfrm>
-          <a:prstGeom prst="roundRect">
-            <a:avLst>
-              <a:gd name="adj" fmla="val 3571"/>
-            </a:avLst>
-          </a:prstGeom>
-          <a:solidFill>
-            <a:schemeClr val="bg2"/>
-          </a:solidFill>
+          <p:cNvPr id="33" name="feed up"/>
+          <p:cNvSpPr/>
+          <p:nvPr/>
+        </p:nvSpPr>
+        <p:spPr>
+          <a:xfrm>
+            <a:off x="7251192" y="3566160"/>
+            <a:ext cx="0" cy="502920"/>
+          </a:xfrm>
+          <a:prstGeom prst="line">
+            <a:avLst/>
+          </a:prstGeom>
+          <a:noFill/>
           <a:ln w="19050">
             <a:solidFill>
-              <a:srgbClr val="0B0B0B"/>
-            </a:solidFill>
-            <a:prstDash val="solid"/>
-          </a:ln>
-        </p:spPr>
-      </p:sp>
-      <p:sp>
-        <p:nvSpPr>
-          <p:cNvPr id="30" name="mini out slab"/>
-          <p:cNvSpPr/>
-          <p:nvPr/>
-        </p:nvSpPr>
-        <p:spPr>
-          <a:xfrm>
-            <a:off x="10287000" y="1719072"/>
-            <a:ext cx="1170432" cy="91440"/>
-          </a:xfrm>
-          <a:prstGeom prst="rect">
-            <a:avLst/>
-          </a:prstGeom>
-          <a:solidFill>
-            <a:srgbClr val="EEF1F4"/>
-          </a:solidFill>
-          <a:ln w="6350">
-            <a:solidFill>
-              <a:srgbClr val="52514E"/>
-            </a:solidFill>
-            <a:prstDash val="solid"/>
-          </a:ln>
-        </p:spPr>
-      </p:sp>
-      <p:sp>
-        <p:nvSpPr>
-          <p:cNvPr id="31" name="mini rod 0"/>
-          <p:cNvSpPr/>
-          <p:nvPr/>
-        </p:nvSpPr>
-        <p:spPr>
-          <a:xfrm>
-            <a:off x="10378440" y="1810512"/>
-            <a:ext cx="27432" cy="429768"/>
-          </a:xfrm>
-          <a:prstGeom prst="rect">
-            <a:avLst/>
-          </a:prstGeom>
-          <a:solidFill>
-            <a:srgbClr val="1F2933"/>
-          </a:solidFill>
-          <a:ln/>
-        </p:spPr>
-      </p:sp>
-      <p:sp>
-        <p:nvSpPr>
-          <p:cNvPr id="32" name="mini rod 1"/>
-          <p:cNvSpPr/>
-          <p:nvPr/>
-        </p:nvSpPr>
-        <p:spPr>
-          <a:xfrm>
-            <a:off x="11338560" y="1810512"/>
-            <a:ext cx="27432" cy="429768"/>
-          </a:xfrm>
-          <a:prstGeom prst="rect">
-            <a:avLst/>
-          </a:prstGeom>
-          <a:solidFill>
-            <a:srgbClr val="1F2933"/>
-          </a:solidFill>
-          <a:ln/>
-        </p:spPr>
-      </p:sp>
-      <p:sp>
-        <p:nvSpPr>
-          <p:cNvPr id="33" name="mini bar"/>
-          <p:cNvSpPr/>
-          <p:nvPr/>
-        </p:nvSpPr>
-        <p:spPr>
-          <a:xfrm>
-            <a:off x="10305288" y="2240280"/>
-            <a:ext cx="1133856" cy="36576"/>
-          </a:xfrm>
-          <a:prstGeom prst="rect">
-            <a:avLst/>
-          </a:prstGeom>
-          <a:solidFill>
-            <a:srgbClr val="1F2933"/>
-          </a:solidFill>
-          <a:ln/>
-        </p:spPr>
-      </p:sp>
-      <p:sp>
-        <p:nvSpPr>
-          <p:cNvPr id="34" name="mini out pipe a"/>
-          <p:cNvSpPr/>
-          <p:nvPr/>
-        </p:nvSpPr>
-        <p:spPr>
-          <a:xfrm>
-            <a:off x="10543032" y="2029968"/>
-            <a:ext cx="210312" cy="210312"/>
-          </a:xfrm>
-          <a:prstGeom prst="ellipse">
-            <a:avLst/>
-          </a:prstGeom>
-          <a:solidFill>
-            <a:srgbClr val="FFFFFF"/>
-          </a:solidFill>
-          <a:ln w="9525">
-            <a:solidFill>
-              <a:srgbClr val="52514E"/>
-            </a:solidFill>
-            <a:prstDash val="solid"/>
-          </a:ln>
-        </p:spPr>
-      </p:sp>
-      <p:sp>
-        <p:nvSpPr>
-          <p:cNvPr id="35" name="mini out pipe b"/>
-          <p:cNvSpPr/>
-          <p:nvPr/>
-        </p:nvSpPr>
-        <p:spPr>
-          <a:xfrm>
-            <a:off x="10890504" y="2084832"/>
-            <a:ext cx="155448" cy="155448"/>
-          </a:xfrm>
-          <a:prstGeom prst="ellipse">
-            <a:avLst/>
-          </a:prstGeom>
-          <a:solidFill>
-            <a:srgbClr val="FFFFFF"/>
-          </a:solidFill>
-          <a:ln w="9525">
-            <a:solidFill>
-              <a:srgbClr val="52514E"/>
-            </a:solidFill>
-            <a:prstDash val="solid"/>
-          </a:ln>
-        </p:spPr>
-      </p:sp>
-      <p:sp>
-        <p:nvSpPr>
-          <p:cNvPr id="36" name="text output"/>
+              <a:schemeClr val="accent1"/>
+            </a:solidFill>
+            <a:prstDash val="solid"/>
+          </a:ln>
+        </p:spPr>
+      </p:sp>
+      <p:sp>
+        <p:nvSpPr>
+          <p:cNvPr id="34" name="feed across"/>
+          <p:cNvSpPr/>
+          <p:nvPr/>
+        </p:nvSpPr>
+        <p:spPr>
+          <a:xfrm>
+            <a:off x="1600200" y="3566160"/>
+            <a:ext cx="5650992" cy="0"/>
+          </a:xfrm>
+          <a:prstGeom prst="line">
+            <a:avLst/>
+          </a:prstGeom>
+          <a:noFill/>
+          <a:ln w="19050">
+            <a:solidFill>
+              <a:schemeClr val="accent1"/>
+            </a:solidFill>
+            <a:prstDash val="solid"/>
+          </a:ln>
+        </p:spPr>
+      </p:sp>
+      <p:sp>
+        <p:nvSpPr>
+          <p:cNvPr id="35" name="feed into context"/>
+          <p:cNvSpPr/>
+          <p:nvPr/>
+        </p:nvSpPr>
+        <p:spPr>
+          <a:xfrm>
+            <a:off x="1600200" y="3154680"/>
+            <a:ext cx="0" cy="411480"/>
+          </a:xfrm>
+          <a:prstGeom prst="line">
+            <a:avLst/>
+          </a:prstGeom>
+          <a:noFill/>
+          <a:ln w="19050">
+            <a:solidFill>
+              <a:schemeClr val="accent1"/>
+            </a:solidFill>
+            <a:prstDash val="solid"/>
+            <a:headEnd type="triangle"/>
+          </a:ln>
+        </p:spPr>
+      </p:sp>
+      <p:sp>
+        <p:nvSpPr>
+          <p:cNvPr id="36" name="label feed"/>
           <p:cNvSpPr txBox="1"/>
           <p:nvPr/>
         </p:nvSpPr>
         <p:spPr>
           <a:xfrm>
-            <a:off x="10104120" y="2331720"/>
-            <a:ext cx="1536192" cy="1371600"/>
+            <a:off x="1874520" y="3291840"/>
+            <a:ext cx="5102352" cy="237744"/>
           </a:xfrm>
           <a:prstGeom prst="rect">
             <a:avLst/>
@@ -15434,163 +15364,140 @@
           <a:ln/>
         </p:spPr>
         <p:txBody>
-          <a:bodyPr wrap="square" lIns="1016" tIns="1016" rIns="1016" bIns="1016" rtlCol="0" anchor="ctr"/>
+          <a:bodyPr wrap="square" lIns="0" tIns="0" rIns="0" bIns="0" rtlCol="0" anchor="ctr"/>
           <a:lstStyle/>
           <a:p>
             <a:pPr algn="ctr" indent="0" marL="0">
               <a:buNone/>
             </a:pPr>
             <a:r>
-              <a:rPr lang="en-US" sz="1400" b="1" dirty="0">
+              <a:rPr lang="en-US" sz="1100" dirty="0">
+                <a:solidFill>
+                  <a:schemeClr val="accent1"/>
+                </a:solidFill>
+              </a:rPr>
+              <a:t>a new context every round: thousands of them, each with the brief and no answer</a:t>
+            </a:r>
+            <a:endParaRPr lang="en-US" sz="1100" dirty="0"/>
+          </a:p>
+        </p:txBody>
+      </p:sp>
+      <p:sp>
+        <p:nvSpPr>
+          <p:cNvPr id="37" name="card real"/>
+          <p:cNvSpPr/>
+          <p:nvPr/>
+        </p:nvSpPr>
+        <p:spPr>
+          <a:xfrm>
+            <a:off x="548640" y="4069080"/>
+            <a:ext cx="5394960" cy="1920240"/>
+          </a:xfrm>
+          <a:prstGeom prst="roundRect">
+            <a:avLst>
+              <a:gd name="adj" fmla="val 3333"/>
+            </a:avLst>
+          </a:prstGeom>
+          <a:solidFill>
+            <a:schemeClr val="bg2"/>
+          </a:solidFill>
+          <a:ln w="19050">
+            <a:solidFill>
+              <a:srgbClr val="EB6834"/>
+            </a:solidFill>
+            <a:prstDash val="solid"/>
+          </a:ln>
+        </p:spPr>
+      </p:sp>
+      <p:sp>
+        <p:nvSpPr>
+          <p:cNvPr id="38" name="card head real"/>
+          <p:cNvSpPr txBox="1"/>
+          <p:nvPr/>
+        </p:nvSpPr>
+        <p:spPr>
+          <a:xfrm>
+            <a:off x="777240" y="4178808"/>
+            <a:ext cx="2926080" cy="329184"/>
+          </a:xfrm>
+          <a:prstGeom prst="rect">
+            <a:avLst/>
+          </a:prstGeom>
+          <a:noFill/>
+          <a:ln/>
+        </p:spPr>
+        <p:txBody>
+          <a:bodyPr wrap="square" lIns="0" tIns="0" rIns="0" bIns="0" rtlCol="0" anchor="ctr"/>
+          <a:lstStyle/>
+          <a:p>
+            <a:pPr indent="0" marL="0">
+              <a:buNone/>
+            </a:pPr>
+            <a:r>
+              <a:rPr lang="en-US" sz="1500" b="1" dirty="0">
                 <a:solidFill>
                   <a:schemeClr val="tx1"/>
                 </a:solidFill>
               </a:rPr>
-              <a:t>Verified designs</a:t>
+              <a:t>Real projects</a:t>
             </a:r>
-            <a:endParaRPr lang="en-US" sz="1400" dirty="0"/>
-          </a:p>
+            <a:endParaRPr lang="en-US" sz="1500" dirty="0"/>
+          </a:p>
+        </p:txBody>
+      </p:sp>
+      <p:sp>
+        <p:nvSpPr>
+          <p:cNvPr id="39" name="card tag real"/>
+          <p:cNvSpPr/>
+          <p:nvPr/>
+        </p:nvSpPr>
+        <p:spPr>
+          <a:xfrm>
+            <a:off x="4251960" y="4206240"/>
+            <a:ext cx="1463040" cy="274320"/>
+          </a:xfrm>
+          <a:prstGeom prst="roundRect">
+            <a:avLst>
+              <a:gd name="adj" fmla="val 50000"/>
+            </a:avLst>
+          </a:prstGeom>
+          <a:solidFill>
+            <a:srgbClr val="EB6834"/>
+          </a:solidFill>
+          <a:ln/>
+        </p:spPr>
+      </p:sp>
+      <p:sp>
+        <p:nvSpPr>
+          <p:cNvPr id="40" name="card tag text real"/>
+          <p:cNvSpPr txBox="1"/>
+          <p:nvPr/>
+        </p:nvSpPr>
+        <p:spPr>
+          <a:xfrm>
+            <a:off x="4251960" y="4206240"/>
+            <a:ext cx="1463040" cy="274320"/>
+          </a:xfrm>
+          <a:prstGeom prst="rect">
+            <a:avLst/>
+          </a:prstGeom>
+          <a:noFill/>
+          <a:ln/>
+        </p:spPr>
+        <p:txBody>
+          <a:bodyPr wrap="square" lIns="0" tIns="0" rIns="0" bIns="0" rtlCol="0" anchor="ctr"/>
+          <a:lstStyle/>
           <a:p>
             <a:pPr algn="ctr" indent="0" marL="0">
               <a:buNone/>
             </a:pPr>
             <a:r>
-              <a:rPr lang="en-US" sz="1150" dirty="0">
-                <a:solidFill>
-                  <a:srgbClr val="52514E"/>
+              <a:rPr lang="en-US" sz="1050" b="1" dirty="0">
+                <a:solidFill>
+                  <a:srgbClr val="FFFFFF"/>
                 </a:solidFill>
               </a:rPr>
-              <a:t>up to ten, ranked by installed cost</a:t>
-            </a:r>
-            <a:endParaRPr lang="en-US" sz="1400" dirty="0"/>
-          </a:p>
-        </p:txBody>
-      </p:sp>
-      <p:sp>
-        <p:nvSpPr>
-          <p:cNvPr id="37" name="arrow to output"/>
-          <p:cNvSpPr/>
-          <p:nvPr/>
-        </p:nvSpPr>
-        <p:spPr>
-          <a:xfrm>
-            <a:off x="9692640" y="2674620"/>
-            <a:ext cx="411480" cy="0"/>
-          </a:xfrm>
-          <a:prstGeom prst="line">
-            <a:avLst/>
-          </a:prstGeom>
-          <a:noFill/>
-          <a:ln w="15875">
-            <a:solidFill>
-              <a:srgbClr val="52514E"/>
-            </a:solidFill>
-            <a:prstDash val="solid"/>
-            <a:tailEnd type="triangle"/>
-          </a:ln>
-        </p:spPr>
-      </p:sp>
-      <p:sp>
-        <p:nvSpPr>
-          <p:cNvPr id="38" name="feedback down"/>
-          <p:cNvSpPr/>
-          <p:nvPr/>
-        </p:nvSpPr>
-        <p:spPr>
-          <a:xfrm>
-            <a:off x="8778240" y="3794760"/>
-            <a:ext cx="0" cy="274320"/>
-          </a:xfrm>
-          <a:prstGeom prst="line">
-            <a:avLst/>
-          </a:prstGeom>
-          <a:noFill/>
-          <a:ln w="15875">
-            <a:solidFill>
-              <a:srgbClr val="008300"/>
-            </a:solidFill>
-            <a:prstDash val="dash"/>
-          </a:ln>
-        </p:spPr>
-      </p:sp>
-      <p:sp>
-        <p:nvSpPr>
-          <p:cNvPr id="39" name="feedback across"/>
-          <p:cNvSpPr/>
-          <p:nvPr/>
-        </p:nvSpPr>
-        <p:spPr>
-          <a:xfrm>
-            <a:off x="6217920" y="4069080"/>
-            <a:ext cx="2560320" cy="0"/>
-          </a:xfrm>
-          <a:prstGeom prst="line">
-            <a:avLst/>
-          </a:prstGeom>
-          <a:noFill/>
-          <a:ln w="15875">
-            <a:solidFill>
-              <a:srgbClr val="008300"/>
-            </a:solidFill>
-            <a:prstDash val="dash"/>
-          </a:ln>
-        </p:spPr>
-      </p:sp>
-      <p:sp>
-        <p:nvSpPr>
-          <p:cNvPr id="40" name="feedback up"/>
-          <p:cNvSpPr/>
-          <p:nvPr/>
-        </p:nvSpPr>
-        <p:spPr>
-          <a:xfrm>
-            <a:off x="6217920" y="3794760"/>
-            <a:ext cx="0" cy="274320"/>
-          </a:xfrm>
-          <a:prstGeom prst="line">
-            <a:avLst/>
-          </a:prstGeom>
-          <a:noFill/>
-          <a:ln w="15875">
-            <a:solidFill>
-              <a:srgbClr val="008300"/>
-            </a:solidFill>
-            <a:prstDash val="dash"/>
-            <a:headEnd type="triangle"/>
-          </a:ln>
-        </p:spPr>
-      </p:sp>
-      <p:sp>
-        <p:nvSpPr>
-          <p:cNvPr id="41" name="label feedback"/>
-          <p:cNvSpPr txBox="1"/>
-          <p:nvPr/>
-        </p:nvSpPr>
-        <p:spPr>
-          <a:xfrm>
-            <a:off x="6400800" y="4096512"/>
-            <a:ext cx="2194560" cy="237744"/>
-          </a:xfrm>
-          <a:prstGeom prst="rect">
-            <a:avLst/>
-          </a:prstGeom>
-          <a:noFill/>
-          <a:ln/>
-        </p:spPr>
-        <p:txBody>
-          <a:bodyPr wrap="square" lIns="0" tIns="0" rIns="0" bIns="0" rtlCol="0" anchor="ctr"/>
-          <a:lstStyle/>
-          <a:p>
-            <a:pPr algn="ctr" indent="0" marL="0">
-              <a:buNone/>
-            </a:pPr>
-            <a:r>
-              <a:rPr lang="en-US" sz="1050" dirty="0">
-                <a:solidFill>
-                  <a:srgbClr val="008300"/>
-                </a:solidFill>
-              </a:rPr>
-              <a:t>pass or fail, fed back</a:t>
+              <a:t>too few</a:t>
             </a:r>
             <a:endParaRPr lang="en-US" sz="1050" dirty="0"/>
           </a:p>
@@ -15598,41 +15505,14 @@
       </p:sp>
       <p:sp>
         <p:nvSpPr>
-          <p:cNvPr id="42" name="legend swatch Input"/>
-          <p:cNvSpPr/>
-          <p:nvPr/>
-        </p:nvSpPr>
-        <p:spPr>
-          <a:xfrm>
-            <a:off x="548640" y="4654296"/>
-            <a:ext cx="274320" cy="182880"/>
-          </a:xfrm>
-          <a:prstGeom prst="roundRect">
-            <a:avLst>
-              <a:gd name="adj" fmla="val 20000"/>
-            </a:avLst>
-          </a:prstGeom>
-          <a:solidFill>
-            <a:schemeClr val="bg2"/>
-          </a:solidFill>
-          <a:ln w="12700">
-            <a:solidFill>
-              <a:srgbClr val="52514E"/>
-            </a:solidFill>
-            <a:prstDash val="solid"/>
-          </a:ln>
-        </p:spPr>
-      </p:sp>
-      <p:sp>
-        <p:nvSpPr>
-          <p:cNvPr id="43" name="legend Input"/>
+          <p:cNvPr id="41" name="card body real"/>
           <p:cNvSpPr txBox="1"/>
           <p:nvPr/>
         </p:nvSpPr>
         <p:spPr>
           <a:xfrm>
-            <a:off x="896112" y="4617720"/>
-            <a:ext cx="2011680" cy="256032"/>
+            <a:off x="777240" y="5257800"/>
+            <a:ext cx="4937760" cy="640080"/>
           </a:xfrm>
           <a:prstGeom prst="rect">
             <a:avLst/>
@@ -15641,7 +15521,7 @@
           <a:ln/>
         </p:spPr>
         <p:txBody>
-          <a:bodyPr wrap="square" lIns="0" tIns="0" rIns="0" bIns="0" rtlCol="0" anchor="ctr"/>
+          <a:bodyPr wrap="square" lIns="0" tIns="0" rIns="0" bIns="0" rtlCol="0" anchor="t"/>
           <a:lstStyle/>
           <a:p>
             <a:pPr indent="0" marL="0">
@@ -15653,7 +15533,7 @@
                   <a:schemeClr val="tx1"/>
                 </a:solidFill>
               </a:rPr>
-              <a:t>Input</a:t>
+              <a:t>A handful of sections, from one project with one trade mix, and confidential. Not enough to practise on, and a method tuned on them only fits that project.</a:t>
             </a:r>
             <a:endParaRPr lang="en-US" sz="1150" dirty="0"/>
           </a:p>
@@ -15661,41 +15541,827 @@
       </p:sp>
       <p:sp>
         <p:nvSpPr>
-          <p:cNvPr id="44" name="legend swatch Rules"/>
-          <p:cNvSpPr/>
-          <p:nvPr/>
-        </p:nvSpPr>
-        <p:spPr>
-          <a:xfrm>
-            <a:off x="1787652" y="4654296"/>
-            <a:ext cx="274320" cy="182880"/>
+          <p:cNvPr id="42" name="mini card real 0"/>
+          <p:cNvSpPr/>
+          <p:nvPr/>
+        </p:nvSpPr>
+        <p:spPr>
+          <a:xfrm>
+            <a:off x="777240" y="4590288"/>
+            <a:ext cx="548640" cy="475488"/>
+          </a:xfrm>
+          <a:prstGeom prst="rect">
+            <a:avLst/>
+          </a:prstGeom>
+          <a:solidFill>
+            <a:srgbClr val="FFFFFF"/>
+          </a:solidFill>
+          <a:ln w="6350">
+            <a:solidFill>
+              <a:srgbClr val="898781"/>
+            </a:solidFill>
+            <a:prstDash val="solid"/>
+          </a:ln>
+        </p:spPr>
+      </p:sp>
+      <p:sp>
+        <p:nvSpPr>
+          <p:cNvPr id="43" name="mini slab real 0"/>
+          <p:cNvSpPr/>
+          <p:nvPr/>
+        </p:nvSpPr>
+        <p:spPr>
+          <a:xfrm>
+            <a:off x="822960" y="4636008"/>
+            <a:ext cx="457200" cy="32004"/>
+          </a:xfrm>
+          <a:prstGeom prst="rect">
+            <a:avLst/>
+          </a:prstGeom>
+          <a:solidFill>
+            <a:srgbClr val="52514E"/>
+          </a:solidFill>
+          <a:ln/>
+        </p:spPr>
+      </p:sp>
+      <p:sp>
+        <p:nvSpPr>
+          <p:cNvPr id="44" name="mini real 0 0"/>
+          <p:cNvSpPr/>
+          <p:nvPr/>
+        </p:nvSpPr>
+        <p:spPr>
+          <a:xfrm>
+            <a:off x="907004" y="4709160"/>
+            <a:ext cx="60512" cy="60512"/>
+          </a:xfrm>
+          <a:prstGeom prst="ellipse">
+            <a:avLst/>
+          </a:prstGeom>
+          <a:solidFill>
+            <a:srgbClr val="EB6834"/>
+          </a:solidFill>
+          <a:ln w="5080">
+            <a:solidFill>
+              <a:srgbClr val="FFFFFF"/>
+            </a:solidFill>
+            <a:prstDash val="solid"/>
+          </a:ln>
+        </p:spPr>
+      </p:sp>
+      <p:sp>
+        <p:nvSpPr>
+          <p:cNvPr id="45" name="mini real 0 1"/>
+          <p:cNvSpPr/>
+          <p:nvPr/>
+        </p:nvSpPr>
+        <p:spPr>
+          <a:xfrm>
+            <a:off x="1021304" y="4709160"/>
+            <a:ext cx="60512" cy="60512"/>
+          </a:xfrm>
+          <a:prstGeom prst="ellipse">
+            <a:avLst/>
+          </a:prstGeom>
+          <a:solidFill>
+            <a:srgbClr val="EB6834"/>
+          </a:solidFill>
+          <a:ln w="5080">
+            <a:solidFill>
+              <a:srgbClr val="FFFFFF"/>
+            </a:solidFill>
+            <a:prstDash val="solid"/>
+          </a:ln>
+        </p:spPr>
+      </p:sp>
+      <p:sp>
+        <p:nvSpPr>
+          <p:cNvPr id="46" name="mini real 0 2"/>
+          <p:cNvSpPr/>
+          <p:nvPr/>
+        </p:nvSpPr>
+        <p:spPr>
+          <a:xfrm>
+            <a:off x="1135604" y="4709160"/>
+            <a:ext cx="60512" cy="60512"/>
+          </a:xfrm>
+          <a:prstGeom prst="ellipse">
+            <a:avLst/>
+          </a:prstGeom>
+          <a:solidFill>
+            <a:srgbClr val="EB6834"/>
+          </a:solidFill>
+          <a:ln w="5080">
+            <a:solidFill>
+              <a:srgbClr val="FFFFFF"/>
+            </a:solidFill>
+            <a:prstDash val="solid"/>
+          </a:ln>
+        </p:spPr>
+      </p:sp>
+      <p:sp>
+        <p:nvSpPr>
+          <p:cNvPr id="47" name="mini card real 1"/>
+          <p:cNvSpPr/>
+          <p:nvPr/>
+        </p:nvSpPr>
+        <p:spPr>
+          <a:xfrm>
+            <a:off x="1344168" y="4590288"/>
+            <a:ext cx="548640" cy="475488"/>
+          </a:xfrm>
+          <a:prstGeom prst="rect">
+            <a:avLst/>
+          </a:prstGeom>
+          <a:solidFill>
+            <a:srgbClr val="FFFFFF"/>
+          </a:solidFill>
+          <a:ln w="6350">
+            <a:solidFill>
+              <a:srgbClr val="898781"/>
+            </a:solidFill>
+            <a:prstDash val="solid"/>
+          </a:ln>
+        </p:spPr>
+      </p:sp>
+      <p:sp>
+        <p:nvSpPr>
+          <p:cNvPr id="48" name="mini slab real 1"/>
+          <p:cNvSpPr/>
+          <p:nvPr/>
+        </p:nvSpPr>
+        <p:spPr>
+          <a:xfrm>
+            <a:off x="1389888" y="4636008"/>
+            <a:ext cx="457200" cy="32004"/>
+          </a:xfrm>
+          <a:prstGeom prst="rect">
+            <a:avLst/>
+          </a:prstGeom>
+          <a:solidFill>
+            <a:srgbClr val="52514E"/>
+          </a:solidFill>
+          <a:ln/>
+        </p:spPr>
+      </p:sp>
+      <p:sp>
+        <p:nvSpPr>
+          <p:cNvPr id="49" name="mini real 1 0"/>
+          <p:cNvSpPr/>
+          <p:nvPr/>
+        </p:nvSpPr>
+        <p:spPr>
+          <a:xfrm>
+            <a:off x="1473932" y="4709160"/>
+            <a:ext cx="60512" cy="60512"/>
+          </a:xfrm>
+          <a:prstGeom prst="ellipse">
+            <a:avLst/>
+          </a:prstGeom>
+          <a:solidFill>
+            <a:srgbClr val="EB6834"/>
+          </a:solidFill>
+          <a:ln w="5080">
+            <a:solidFill>
+              <a:srgbClr val="FFFFFF"/>
+            </a:solidFill>
+            <a:prstDash val="solid"/>
+          </a:ln>
+        </p:spPr>
+      </p:sp>
+      <p:sp>
+        <p:nvSpPr>
+          <p:cNvPr id="50" name="mini real 1 1"/>
+          <p:cNvSpPr/>
+          <p:nvPr/>
+        </p:nvSpPr>
+        <p:spPr>
+          <a:xfrm>
+            <a:off x="1588232" y="4709160"/>
+            <a:ext cx="60512" cy="60512"/>
+          </a:xfrm>
+          <a:prstGeom prst="ellipse">
+            <a:avLst/>
+          </a:prstGeom>
+          <a:solidFill>
+            <a:srgbClr val="EB6834"/>
+          </a:solidFill>
+          <a:ln w="5080">
+            <a:solidFill>
+              <a:srgbClr val="FFFFFF"/>
+            </a:solidFill>
+            <a:prstDash val="solid"/>
+          </a:ln>
+        </p:spPr>
+      </p:sp>
+      <p:sp>
+        <p:nvSpPr>
+          <p:cNvPr id="51" name="mini real 1 2"/>
+          <p:cNvSpPr/>
+          <p:nvPr/>
+        </p:nvSpPr>
+        <p:spPr>
+          <a:xfrm>
+            <a:off x="1702532" y="4709160"/>
+            <a:ext cx="60512" cy="60512"/>
+          </a:xfrm>
+          <a:prstGeom prst="ellipse">
+            <a:avLst/>
+          </a:prstGeom>
+          <a:solidFill>
+            <a:srgbClr val="EB6834"/>
+          </a:solidFill>
+          <a:ln w="5080">
+            <a:solidFill>
+              <a:srgbClr val="FFFFFF"/>
+            </a:solidFill>
+            <a:prstDash val="solid"/>
+          </a:ln>
+        </p:spPr>
+      </p:sp>
+      <p:sp>
+        <p:nvSpPr>
+          <p:cNvPr id="52" name="mini card real 2"/>
+          <p:cNvSpPr/>
+          <p:nvPr/>
+        </p:nvSpPr>
+        <p:spPr>
+          <a:xfrm>
+            <a:off x="1911096" y="4590288"/>
+            <a:ext cx="548640" cy="475488"/>
+          </a:xfrm>
+          <a:prstGeom prst="rect">
+            <a:avLst/>
+          </a:prstGeom>
+          <a:solidFill>
+            <a:srgbClr val="FFFFFF"/>
+          </a:solidFill>
+          <a:ln w="6350">
+            <a:solidFill>
+              <a:srgbClr val="898781"/>
+            </a:solidFill>
+            <a:prstDash val="solid"/>
+          </a:ln>
+        </p:spPr>
+      </p:sp>
+      <p:sp>
+        <p:nvSpPr>
+          <p:cNvPr id="53" name="mini slab real 2"/>
+          <p:cNvSpPr/>
+          <p:nvPr/>
+        </p:nvSpPr>
+        <p:spPr>
+          <a:xfrm>
+            <a:off x="1956816" y="4636008"/>
+            <a:ext cx="457200" cy="32004"/>
+          </a:xfrm>
+          <a:prstGeom prst="rect">
+            <a:avLst/>
+          </a:prstGeom>
+          <a:solidFill>
+            <a:srgbClr val="52514E"/>
+          </a:solidFill>
+          <a:ln/>
+        </p:spPr>
+      </p:sp>
+      <p:sp>
+        <p:nvSpPr>
+          <p:cNvPr id="54" name="mini real 2 0"/>
+          <p:cNvSpPr/>
+          <p:nvPr/>
+        </p:nvSpPr>
+        <p:spPr>
+          <a:xfrm>
+            <a:off x="2040860" y="4709160"/>
+            <a:ext cx="60512" cy="60512"/>
+          </a:xfrm>
+          <a:prstGeom prst="ellipse">
+            <a:avLst/>
+          </a:prstGeom>
+          <a:solidFill>
+            <a:srgbClr val="EB6834"/>
+          </a:solidFill>
+          <a:ln w="5080">
+            <a:solidFill>
+              <a:srgbClr val="FFFFFF"/>
+            </a:solidFill>
+            <a:prstDash val="solid"/>
+          </a:ln>
+        </p:spPr>
+      </p:sp>
+      <p:sp>
+        <p:nvSpPr>
+          <p:cNvPr id="55" name="mini real 2 1"/>
+          <p:cNvSpPr/>
+          <p:nvPr/>
+        </p:nvSpPr>
+        <p:spPr>
+          <a:xfrm>
+            <a:off x="2155160" y="4709160"/>
+            <a:ext cx="60512" cy="60512"/>
+          </a:xfrm>
+          <a:prstGeom prst="ellipse">
+            <a:avLst/>
+          </a:prstGeom>
+          <a:solidFill>
+            <a:srgbClr val="EB6834"/>
+          </a:solidFill>
+          <a:ln w="5080">
+            <a:solidFill>
+              <a:srgbClr val="FFFFFF"/>
+            </a:solidFill>
+            <a:prstDash val="solid"/>
+          </a:ln>
+        </p:spPr>
+      </p:sp>
+      <p:sp>
+        <p:nvSpPr>
+          <p:cNvPr id="56" name="mini real 2 2"/>
+          <p:cNvSpPr/>
+          <p:nvPr/>
+        </p:nvSpPr>
+        <p:spPr>
+          <a:xfrm>
+            <a:off x="2269460" y="4709160"/>
+            <a:ext cx="60512" cy="60512"/>
+          </a:xfrm>
+          <a:prstGeom prst="ellipse">
+            <a:avLst/>
+          </a:prstGeom>
+          <a:solidFill>
+            <a:srgbClr val="EB6834"/>
+          </a:solidFill>
+          <a:ln w="5080">
+            <a:solidFill>
+              <a:srgbClr val="FFFFFF"/>
+            </a:solidFill>
+            <a:prstDash val="solid"/>
+          </a:ln>
+        </p:spPr>
+      </p:sp>
+      <p:sp>
+        <p:nvSpPr>
+          <p:cNvPr id="57" name="mini card real 3"/>
+          <p:cNvSpPr/>
+          <p:nvPr/>
+        </p:nvSpPr>
+        <p:spPr>
+          <a:xfrm>
+            <a:off x="2478024" y="4590288"/>
+            <a:ext cx="548640" cy="475488"/>
+          </a:xfrm>
+          <a:prstGeom prst="rect">
+            <a:avLst/>
+          </a:prstGeom>
+          <a:solidFill>
+            <a:srgbClr val="FFFFFF"/>
+          </a:solidFill>
+          <a:ln w="6350">
+            <a:solidFill>
+              <a:srgbClr val="898781"/>
+            </a:solidFill>
+            <a:prstDash val="solid"/>
+          </a:ln>
+        </p:spPr>
+      </p:sp>
+      <p:sp>
+        <p:nvSpPr>
+          <p:cNvPr id="58" name="mini slab real 3"/>
+          <p:cNvSpPr/>
+          <p:nvPr/>
+        </p:nvSpPr>
+        <p:spPr>
+          <a:xfrm>
+            <a:off x="2523744" y="4636008"/>
+            <a:ext cx="457200" cy="32004"/>
+          </a:xfrm>
+          <a:prstGeom prst="rect">
+            <a:avLst/>
+          </a:prstGeom>
+          <a:solidFill>
+            <a:srgbClr val="52514E"/>
+          </a:solidFill>
+          <a:ln/>
+        </p:spPr>
+      </p:sp>
+      <p:sp>
+        <p:nvSpPr>
+          <p:cNvPr id="59" name="mini real 3 0"/>
+          <p:cNvSpPr/>
+          <p:nvPr/>
+        </p:nvSpPr>
+        <p:spPr>
+          <a:xfrm>
+            <a:off x="2607788" y="4709160"/>
+            <a:ext cx="60512" cy="60512"/>
+          </a:xfrm>
+          <a:prstGeom prst="ellipse">
+            <a:avLst/>
+          </a:prstGeom>
+          <a:solidFill>
+            <a:srgbClr val="EB6834"/>
+          </a:solidFill>
+          <a:ln w="5080">
+            <a:solidFill>
+              <a:srgbClr val="FFFFFF"/>
+            </a:solidFill>
+            <a:prstDash val="solid"/>
+          </a:ln>
+        </p:spPr>
+      </p:sp>
+      <p:sp>
+        <p:nvSpPr>
+          <p:cNvPr id="60" name="mini real 3 1"/>
+          <p:cNvSpPr/>
+          <p:nvPr/>
+        </p:nvSpPr>
+        <p:spPr>
+          <a:xfrm>
+            <a:off x="2722088" y="4709160"/>
+            <a:ext cx="60512" cy="60512"/>
+          </a:xfrm>
+          <a:prstGeom prst="ellipse">
+            <a:avLst/>
+          </a:prstGeom>
+          <a:solidFill>
+            <a:srgbClr val="EB6834"/>
+          </a:solidFill>
+          <a:ln w="5080">
+            <a:solidFill>
+              <a:srgbClr val="FFFFFF"/>
+            </a:solidFill>
+            <a:prstDash val="solid"/>
+          </a:ln>
+        </p:spPr>
+      </p:sp>
+      <p:sp>
+        <p:nvSpPr>
+          <p:cNvPr id="61" name="mini real 3 2"/>
+          <p:cNvSpPr/>
+          <p:nvPr/>
+        </p:nvSpPr>
+        <p:spPr>
+          <a:xfrm>
+            <a:off x="2836388" y="4709160"/>
+            <a:ext cx="60512" cy="60512"/>
+          </a:xfrm>
+          <a:prstGeom prst="ellipse">
+            <a:avLst/>
+          </a:prstGeom>
+          <a:solidFill>
+            <a:srgbClr val="EB6834"/>
+          </a:solidFill>
+          <a:ln w="5080">
+            <a:solidFill>
+              <a:srgbClr val="FFFFFF"/>
+            </a:solidFill>
+            <a:prstDash val="solid"/>
+          </a:ln>
+        </p:spPr>
+      </p:sp>
+      <p:sp>
+        <p:nvSpPr>
+          <p:cNvPr id="62" name="mini card real 4"/>
+          <p:cNvSpPr/>
+          <p:nvPr/>
+        </p:nvSpPr>
+        <p:spPr>
+          <a:xfrm>
+            <a:off x="3044952" y="4590288"/>
+            <a:ext cx="548640" cy="475488"/>
+          </a:xfrm>
+          <a:prstGeom prst="rect">
+            <a:avLst/>
+          </a:prstGeom>
+          <a:solidFill>
+            <a:srgbClr val="FFFFFF"/>
+          </a:solidFill>
+          <a:ln w="6350">
+            <a:solidFill>
+              <a:srgbClr val="898781"/>
+            </a:solidFill>
+            <a:prstDash val="solid"/>
+          </a:ln>
+        </p:spPr>
+      </p:sp>
+      <p:sp>
+        <p:nvSpPr>
+          <p:cNvPr id="63" name="mini slab real 4"/>
+          <p:cNvSpPr/>
+          <p:nvPr/>
+        </p:nvSpPr>
+        <p:spPr>
+          <a:xfrm>
+            <a:off x="3090672" y="4636008"/>
+            <a:ext cx="457200" cy="32004"/>
+          </a:xfrm>
+          <a:prstGeom prst="rect">
+            <a:avLst/>
+          </a:prstGeom>
+          <a:solidFill>
+            <a:srgbClr val="52514E"/>
+          </a:solidFill>
+          <a:ln/>
+        </p:spPr>
+      </p:sp>
+      <p:sp>
+        <p:nvSpPr>
+          <p:cNvPr id="64" name="mini real 4 0"/>
+          <p:cNvSpPr/>
+          <p:nvPr/>
+        </p:nvSpPr>
+        <p:spPr>
+          <a:xfrm>
+            <a:off x="3174716" y="4709160"/>
+            <a:ext cx="60512" cy="60512"/>
+          </a:xfrm>
+          <a:prstGeom prst="ellipse">
+            <a:avLst/>
+          </a:prstGeom>
+          <a:solidFill>
+            <a:srgbClr val="EB6834"/>
+          </a:solidFill>
+          <a:ln w="5080">
+            <a:solidFill>
+              <a:srgbClr val="FFFFFF"/>
+            </a:solidFill>
+            <a:prstDash val="solid"/>
+          </a:ln>
+        </p:spPr>
+      </p:sp>
+      <p:sp>
+        <p:nvSpPr>
+          <p:cNvPr id="65" name="mini real 4 1"/>
+          <p:cNvSpPr/>
+          <p:nvPr/>
+        </p:nvSpPr>
+        <p:spPr>
+          <a:xfrm>
+            <a:off x="3289016" y="4709160"/>
+            <a:ext cx="60512" cy="60512"/>
+          </a:xfrm>
+          <a:prstGeom prst="ellipse">
+            <a:avLst/>
+          </a:prstGeom>
+          <a:solidFill>
+            <a:srgbClr val="EB6834"/>
+          </a:solidFill>
+          <a:ln w="5080">
+            <a:solidFill>
+              <a:srgbClr val="FFFFFF"/>
+            </a:solidFill>
+            <a:prstDash val="solid"/>
+          </a:ln>
+        </p:spPr>
+      </p:sp>
+      <p:sp>
+        <p:nvSpPr>
+          <p:cNvPr id="66" name="mini real 4 2"/>
+          <p:cNvSpPr/>
+          <p:nvPr/>
+        </p:nvSpPr>
+        <p:spPr>
+          <a:xfrm>
+            <a:off x="3403316" y="4709160"/>
+            <a:ext cx="60512" cy="60512"/>
+          </a:xfrm>
+          <a:prstGeom prst="ellipse">
+            <a:avLst/>
+          </a:prstGeom>
+          <a:solidFill>
+            <a:srgbClr val="EB6834"/>
+          </a:solidFill>
+          <a:ln w="5080">
+            <a:solidFill>
+              <a:srgbClr val="FFFFFF"/>
+            </a:solidFill>
+            <a:prstDash val="solid"/>
+          </a:ln>
+        </p:spPr>
+      </p:sp>
+      <p:sp>
+        <p:nvSpPr>
+          <p:cNvPr id="67" name="mini card real 5"/>
+          <p:cNvSpPr/>
+          <p:nvPr/>
+        </p:nvSpPr>
+        <p:spPr>
+          <a:xfrm>
+            <a:off x="3611880" y="4590288"/>
+            <a:ext cx="548640" cy="475488"/>
+          </a:xfrm>
+          <a:prstGeom prst="rect">
+            <a:avLst/>
+          </a:prstGeom>
+          <a:solidFill>
+            <a:srgbClr val="FFFFFF"/>
+          </a:solidFill>
+          <a:ln w="6350">
+            <a:solidFill>
+              <a:srgbClr val="898781"/>
+            </a:solidFill>
+            <a:prstDash val="solid"/>
+          </a:ln>
+        </p:spPr>
+      </p:sp>
+      <p:sp>
+        <p:nvSpPr>
+          <p:cNvPr id="68" name="mini slab real 5"/>
+          <p:cNvSpPr/>
+          <p:nvPr/>
+        </p:nvSpPr>
+        <p:spPr>
+          <a:xfrm>
+            <a:off x="3657600" y="4636008"/>
+            <a:ext cx="457200" cy="32004"/>
+          </a:xfrm>
+          <a:prstGeom prst="rect">
+            <a:avLst/>
+          </a:prstGeom>
+          <a:solidFill>
+            <a:srgbClr val="52514E"/>
+          </a:solidFill>
+          <a:ln/>
+        </p:spPr>
+      </p:sp>
+      <p:sp>
+        <p:nvSpPr>
+          <p:cNvPr id="69" name="mini real 5 0"/>
+          <p:cNvSpPr/>
+          <p:nvPr/>
+        </p:nvSpPr>
+        <p:spPr>
+          <a:xfrm>
+            <a:off x="3741644" y="4709160"/>
+            <a:ext cx="60512" cy="60512"/>
+          </a:xfrm>
+          <a:prstGeom prst="ellipse">
+            <a:avLst/>
+          </a:prstGeom>
+          <a:solidFill>
+            <a:srgbClr val="EB6834"/>
+          </a:solidFill>
+          <a:ln w="5080">
+            <a:solidFill>
+              <a:srgbClr val="FFFFFF"/>
+            </a:solidFill>
+            <a:prstDash val="solid"/>
+          </a:ln>
+        </p:spPr>
+      </p:sp>
+      <p:sp>
+        <p:nvSpPr>
+          <p:cNvPr id="70" name="mini real 5 1"/>
+          <p:cNvSpPr/>
+          <p:nvPr/>
+        </p:nvSpPr>
+        <p:spPr>
+          <a:xfrm>
+            <a:off x="3855944" y="4709160"/>
+            <a:ext cx="60512" cy="60512"/>
+          </a:xfrm>
+          <a:prstGeom prst="ellipse">
+            <a:avLst/>
+          </a:prstGeom>
+          <a:solidFill>
+            <a:srgbClr val="EB6834"/>
+          </a:solidFill>
+          <a:ln w="5080">
+            <a:solidFill>
+              <a:srgbClr val="FFFFFF"/>
+            </a:solidFill>
+            <a:prstDash val="solid"/>
+          </a:ln>
+        </p:spPr>
+      </p:sp>
+      <p:sp>
+        <p:nvSpPr>
+          <p:cNvPr id="71" name="mini real 5 2"/>
+          <p:cNvSpPr/>
+          <p:nvPr/>
+        </p:nvSpPr>
+        <p:spPr>
+          <a:xfrm>
+            <a:off x="3970244" y="4709160"/>
+            <a:ext cx="60512" cy="60512"/>
+          </a:xfrm>
+          <a:prstGeom prst="ellipse">
+            <a:avLst/>
+          </a:prstGeom>
+          <a:solidFill>
+            <a:srgbClr val="EB6834"/>
+          </a:solidFill>
+          <a:ln w="5080">
+            <a:solidFill>
+              <a:srgbClr val="FFFFFF"/>
+            </a:solidFill>
+            <a:prstDash val="solid"/>
+          </a:ln>
+        </p:spPr>
+      </p:sp>
+      <p:sp>
+        <p:nvSpPr>
+          <p:cNvPr id="72" name="empty slot 6"/>
+          <p:cNvSpPr/>
+          <p:nvPr/>
+        </p:nvSpPr>
+        <p:spPr>
+          <a:xfrm>
+            <a:off x="4178808" y="4590288"/>
+            <a:ext cx="548640" cy="475488"/>
+          </a:xfrm>
+          <a:prstGeom prst="rect">
+            <a:avLst/>
+          </a:prstGeom>
+          <a:ln w="6350">
+            <a:solidFill>
+              <a:srgbClr val="898781"/>
+            </a:solidFill>
+            <a:prstDash val="dash"/>
+          </a:ln>
+        </p:spPr>
+      </p:sp>
+      <p:sp>
+        <p:nvSpPr>
+          <p:cNvPr id="73" name="empty slot 7"/>
+          <p:cNvSpPr/>
+          <p:nvPr/>
+        </p:nvSpPr>
+        <p:spPr>
+          <a:xfrm>
+            <a:off x="4745736" y="4590288"/>
+            <a:ext cx="548640" cy="475488"/>
+          </a:xfrm>
+          <a:prstGeom prst="rect">
+            <a:avLst/>
+          </a:prstGeom>
+          <a:ln w="6350">
+            <a:solidFill>
+              <a:srgbClr val="898781"/>
+            </a:solidFill>
+            <a:prstDash val="dash"/>
+          </a:ln>
+        </p:spPr>
+      </p:sp>
+      <p:sp>
+        <p:nvSpPr>
+          <p:cNvPr id="74" name="empty slot 8"/>
+          <p:cNvSpPr/>
+          <p:nvPr/>
+        </p:nvSpPr>
+        <p:spPr>
+          <a:xfrm>
+            <a:off x="5312664" y="4590288"/>
+            <a:ext cx="548640" cy="475488"/>
+          </a:xfrm>
+          <a:prstGeom prst="rect">
+            <a:avLst/>
+          </a:prstGeom>
+          <a:ln w="6350">
+            <a:solidFill>
+              <a:srgbClr val="898781"/>
+            </a:solidFill>
+            <a:prstDash val="dash"/>
+          </a:ln>
+        </p:spPr>
+      </p:sp>
+      <p:sp>
+        <p:nvSpPr>
+          <p:cNvPr id="75" name="card generated"/>
+          <p:cNvSpPr/>
+          <p:nvPr/>
+        </p:nvSpPr>
+        <p:spPr>
+          <a:xfrm>
+            <a:off x="6245352" y="4069080"/>
+            <a:ext cx="5394960" cy="1920240"/>
           </a:xfrm>
           <a:prstGeom prst="roundRect">
             <a:avLst>
-              <a:gd name="adj" fmla="val 20000"/>
+              <a:gd name="adj" fmla="val 3333"/>
             </a:avLst>
           </a:prstGeom>
           <a:solidFill>
             <a:schemeClr val="bg2"/>
           </a:solidFill>
-          <a:ln w="12700">
-            <a:solidFill>
-              <a:srgbClr val="1F2933"/>
-            </a:solidFill>
-            <a:prstDash val="solid"/>
-          </a:ln>
-        </p:spPr>
-      </p:sp>
-      <p:sp>
-        <p:nvSpPr>
-          <p:cNvPr id="45" name="legend Rules"/>
+          <a:ln w="19050">
+            <a:solidFill>
+              <a:schemeClr val="accent1"/>
+            </a:solidFill>
+            <a:prstDash val="solid"/>
+          </a:ln>
+        </p:spPr>
+      </p:sp>
+      <p:sp>
+        <p:nvSpPr>
+          <p:cNvPr id="76" name="card head generated"/>
           <p:cNvSpPr txBox="1"/>
           <p:nvPr/>
         </p:nvSpPr>
         <p:spPr>
           <a:xfrm>
-            <a:off x="2135124" y="4617720"/>
-            <a:ext cx="2011680" cy="256032"/>
+            <a:off x="6473952" y="4178808"/>
+            <a:ext cx="2926080" cy="329184"/>
           </a:xfrm>
           <a:prstGeom prst="rect">
             <a:avLst/>
@@ -15705,6 +16371,100 @@
         </p:spPr>
         <p:txBody>
           <a:bodyPr wrap="square" lIns="0" tIns="0" rIns="0" bIns="0" rtlCol="0" anchor="ctr"/>
+          <a:lstStyle/>
+          <a:p>
+            <a:pPr indent="0" marL="0">
+              <a:buNone/>
+            </a:pPr>
+            <a:r>
+              <a:rPr lang="en-US" sz="1500" b="1" dirty="0">
+                <a:solidFill>
+                  <a:schemeClr val="tx1"/>
+                </a:solidFill>
+              </a:rPr>
+              <a:t>CrossMEP generates them</a:t>
+            </a:r>
+            <a:endParaRPr lang="en-US" sz="1500" dirty="0"/>
+          </a:p>
+        </p:txBody>
+      </p:sp>
+      <p:sp>
+        <p:nvSpPr>
+          <p:cNvPr id="77" name="card tag generated"/>
+          <p:cNvSpPr/>
+          <p:nvPr/>
+        </p:nvSpPr>
+        <p:spPr>
+          <a:xfrm>
+            <a:off x="9948672" y="4206240"/>
+            <a:ext cx="1463040" cy="274320"/>
+          </a:xfrm>
+          <a:prstGeom prst="roundRect">
+            <a:avLst>
+              <a:gd name="adj" fmla="val 50000"/>
+            </a:avLst>
+          </a:prstGeom>
+          <a:solidFill>
+            <a:schemeClr val="accent1"/>
+          </a:solidFill>
+          <a:ln/>
+        </p:spPr>
+      </p:sp>
+      <p:sp>
+        <p:nvSpPr>
+          <p:cNvPr id="78" name="card tag text generated"/>
+          <p:cNvSpPr txBox="1"/>
+          <p:nvPr/>
+        </p:nvSpPr>
+        <p:spPr>
+          <a:xfrm>
+            <a:off x="9948672" y="4206240"/>
+            <a:ext cx="1463040" cy="274320"/>
+          </a:xfrm>
+          <a:prstGeom prst="rect">
+            <a:avLst/>
+          </a:prstGeom>
+          <a:noFill/>
+          <a:ln/>
+        </p:spPr>
+        <p:txBody>
+          <a:bodyPr wrap="square" lIns="0" tIns="0" rIns="0" bIns="0" rtlCol="0" anchor="ctr"/>
+          <a:lstStyle/>
+          <a:p>
+            <a:pPr algn="ctr" indent="0" marL="0">
+              <a:buNone/>
+            </a:pPr>
+            <a:r>
+              <a:rPr lang="en-US" sz="1050" b="1" dirty="0">
+                <a:solidFill>
+                  <a:srgbClr val="FFFFFF"/>
+                </a:solidFill>
+              </a:rPr>
+              <a:t>unlimited</a:t>
+            </a:r>
+            <a:endParaRPr lang="en-US" sz="1050" dirty="0"/>
+          </a:p>
+        </p:txBody>
+      </p:sp>
+      <p:sp>
+        <p:nvSpPr>
+          <p:cNvPr id="79" name="card body generated"/>
+          <p:cNvSpPr txBox="1"/>
+          <p:nvPr/>
+        </p:nvSpPr>
+        <p:spPr>
+          <a:xfrm>
+            <a:off x="6473952" y="5257800"/>
+            <a:ext cx="4937760" cy="640080"/>
+          </a:xfrm>
+          <a:prstGeom prst="rect">
+            <a:avLst/>
+          </a:prstGeom>
+          <a:noFill/>
+          <a:ln/>
+        </p:spPr>
+        <p:txBody>
+          <a:bodyPr wrap="square" lIns="0" tIns="0" rIns="0" bIns="0" rtlCol="0" anchor="t"/>
           <a:lstStyle/>
           <a:p>
             <a:pPr indent="0" marL="0">
@@ -15716,7 +16476,7 @@
                   <a:schemeClr val="tx1"/>
                 </a:solidFill>
               </a:rPr>
-              <a:t>Rules</a:t>
+              <a:t>As many contexts as a method needs: every tier from one to eight elements, kinds and surfaces varied, a new seed a new set. And one fixed benchmark, never trained on, to judge every method on.</a:t>
             </a:r>
             <a:endParaRPr lang="en-US" sz="1150" dirty="0"/>
           </a:p>
@@ -15724,316 +16484,1263 @@
       </p:sp>
       <p:sp>
         <p:nvSpPr>
-          <p:cNvPr id="46" name="legend swatch Approach (black box)"/>
-          <p:cNvSpPr/>
-          <p:nvPr/>
-        </p:nvSpPr>
-        <p:spPr>
-          <a:xfrm>
-            <a:off x="3026664" y="4654296"/>
-            <a:ext cx="274320" cy="182880"/>
-          </a:xfrm>
-          <a:prstGeom prst="roundRect">
-            <a:avLst>
-              <a:gd name="adj" fmla="val 20000"/>
-            </a:avLst>
-          </a:prstGeom>
-          <a:solidFill>
-            <a:srgbClr val="0B0B0B"/>
-          </a:solidFill>
-          <a:ln w="12700">
-            <a:solidFill>
-              <a:srgbClr val="0B0B0B"/>
-            </a:solidFill>
-            <a:prstDash val="solid"/>
-          </a:ln>
-        </p:spPr>
-      </p:sp>
-      <p:sp>
-        <p:nvSpPr>
-          <p:cNvPr id="47" name="legend Approach (black box)"/>
-          <p:cNvSpPr txBox="1"/>
-          <p:nvPr/>
-        </p:nvSpPr>
-        <p:spPr>
-          <a:xfrm>
-            <a:off x="3374136" y="4617720"/>
-            <a:ext cx="2011680" cy="256032"/>
-          </a:xfrm>
-          <a:prstGeom prst="rect">
-            <a:avLst/>
-          </a:prstGeom>
-          <a:noFill/>
-          <a:ln/>
-        </p:spPr>
-        <p:txBody>
-          <a:bodyPr wrap="square" lIns="0" tIns="0" rIns="0" bIns="0" rtlCol="0" anchor="ctr"/>
-          <a:lstStyle/>
-          <a:p>
-            <a:pPr indent="0" marL="0">
-              <a:buNone/>
-            </a:pPr>
-            <a:r>
-              <a:rPr lang="en-US" sz="1150" dirty="0">
-                <a:solidFill>
-                  <a:schemeClr val="tx1"/>
-                </a:solidFill>
-              </a:rPr>
-              <a:t>Approach (black box)</a:t>
-            </a:r>
-            <a:endParaRPr lang="en-US" sz="1150" dirty="0"/>
-          </a:p>
-        </p:txBody>
-      </p:sp>
-      <p:sp>
-        <p:nvSpPr>
-          <p:cNvPr id="48" name="legend swatch Verifier"/>
-          <p:cNvSpPr/>
-          <p:nvPr/>
-        </p:nvSpPr>
-        <p:spPr>
-          <a:xfrm>
-            <a:off x="5431536" y="4654296"/>
-            <a:ext cx="274320" cy="182880"/>
-          </a:xfrm>
-          <a:prstGeom prst="roundRect">
-            <a:avLst>
-              <a:gd name="adj" fmla="val 20000"/>
-            </a:avLst>
-          </a:prstGeom>
-          <a:solidFill>
-            <a:srgbClr val="EAF5EE"/>
-          </a:solidFill>
-          <a:ln w="12700">
-            <a:solidFill>
-              <a:srgbClr val="008300"/>
-            </a:solidFill>
-            <a:prstDash val="solid"/>
-          </a:ln>
-        </p:spPr>
-      </p:sp>
-      <p:sp>
-        <p:nvSpPr>
-          <p:cNvPr id="49" name="legend Verifier"/>
-          <p:cNvSpPr txBox="1"/>
-          <p:nvPr/>
-        </p:nvSpPr>
-        <p:spPr>
-          <a:xfrm>
-            <a:off x="5779008" y="4617720"/>
-            <a:ext cx="2011680" cy="256032"/>
-          </a:xfrm>
-          <a:prstGeom prst="rect">
-            <a:avLst/>
-          </a:prstGeom>
-          <a:noFill/>
-          <a:ln/>
-        </p:spPr>
-        <p:txBody>
-          <a:bodyPr wrap="square" lIns="0" tIns="0" rIns="0" bIns="0" rtlCol="0" anchor="ctr"/>
-          <a:lstStyle/>
-          <a:p>
-            <a:pPr indent="0" marL="0">
-              <a:buNone/>
-            </a:pPr>
-            <a:r>
-              <a:rPr lang="en-US" sz="1150" dirty="0">
-                <a:solidFill>
-                  <a:schemeClr val="tx1"/>
-                </a:solidFill>
-              </a:rPr>
-              <a:t>Verifier</a:t>
-            </a:r>
-            <a:endParaRPr lang="en-US" sz="1150" dirty="0"/>
-          </a:p>
-        </p:txBody>
-      </p:sp>
-      <p:sp>
-        <p:nvSpPr>
-          <p:cNvPr id="50" name="legend swatch Output"/>
-          <p:cNvSpPr/>
-          <p:nvPr/>
-        </p:nvSpPr>
-        <p:spPr>
-          <a:xfrm>
-            <a:off x="6903720" y="4654296"/>
-            <a:ext cx="274320" cy="182880"/>
-          </a:xfrm>
-          <a:prstGeom prst="roundRect">
-            <a:avLst>
-              <a:gd name="adj" fmla="val 20000"/>
-            </a:avLst>
-          </a:prstGeom>
-          <a:solidFill>
-            <a:schemeClr val="bg2"/>
-          </a:solidFill>
-          <a:ln w="12700">
-            <a:solidFill>
-              <a:srgbClr val="0B0B0B"/>
-            </a:solidFill>
-            <a:prstDash val="solid"/>
-          </a:ln>
-        </p:spPr>
-      </p:sp>
-      <p:sp>
-        <p:nvSpPr>
-          <p:cNvPr id="51" name="legend Output"/>
-          <p:cNvSpPr txBox="1"/>
-          <p:nvPr/>
-        </p:nvSpPr>
-        <p:spPr>
-          <a:xfrm>
-            <a:off x="7251192" y="4617720"/>
-            <a:ext cx="2011680" cy="256032"/>
-          </a:xfrm>
-          <a:prstGeom prst="rect">
-            <a:avLst/>
-          </a:prstGeom>
-          <a:noFill/>
-          <a:ln/>
-        </p:spPr>
-        <p:txBody>
-          <a:bodyPr wrap="square" lIns="0" tIns="0" rIns="0" bIns="0" rtlCol="0" anchor="ctr"/>
-          <a:lstStyle/>
-          <a:p>
-            <a:pPr indent="0" marL="0">
-              <a:buNone/>
-            </a:pPr>
-            <a:r>
-              <a:rPr lang="en-US" sz="1150" dirty="0">
-                <a:solidFill>
-                  <a:schemeClr val="tx1"/>
-                </a:solidFill>
-              </a:rPr>
-              <a:t>Output</a:t>
-            </a:r>
-            <a:endParaRPr lang="en-US" sz="1150" dirty="0"/>
-          </a:p>
-        </p:txBody>
-      </p:sp>
-      <p:sp>
-        <p:nvSpPr>
-          <p:cNvPr id="52" name="needs band"/>
-          <p:cNvSpPr/>
-          <p:nvPr/>
-        </p:nvSpPr>
-        <p:spPr>
-          <a:xfrm>
-            <a:off x="548640" y="5074920"/>
-            <a:ext cx="11091672" cy="914400"/>
-          </a:xfrm>
-          <a:prstGeom prst="roundRect">
-            <a:avLst>
-              <a:gd name="adj" fmla="val 7000"/>
-            </a:avLst>
-          </a:prstGeom>
-          <a:solidFill>
-            <a:schemeClr val="tx2"/>
-          </a:solidFill>
-          <a:ln/>
-        </p:spPr>
-      </p:sp>
-      <p:sp>
-        <p:nvSpPr>
-          <p:cNvPr id="53" name="needs text"/>
-          <p:cNvSpPr txBox="1"/>
-          <p:nvPr/>
-        </p:nvSpPr>
-        <p:spPr>
-          <a:xfrm>
-            <a:off x="822960" y="5074920"/>
-            <a:ext cx="10515600" cy="914400"/>
-          </a:xfrm>
-          <a:prstGeom prst="rect">
-            <a:avLst/>
-          </a:prstGeom>
-          <a:noFill/>
-          <a:ln/>
-        </p:spPr>
-        <p:txBody>
-          <a:bodyPr wrap="square" lIns="0" tIns="0" rIns="0" bIns="0" rtlCol="0" anchor="ctr"/>
-          <a:lstStyle/>
-          <a:p>
-            <a:pPr indent="0" marL="0">
-              <a:buNone/>
-            </a:pPr>
-            <a:r>
-              <a:rPr lang="en-US" sz="1600" dirty="0">
-                <a:solidFill>
-                  <a:srgbClr val="FFFFFF"/>
-                </a:solidFill>
-              </a:rPr>
-              <a:t>Whatever sits in the black box, it needs </a:t>
-            </a:r>
-            <a:pPr indent="0" marL="0">
-              <a:buNone/>
-            </a:pPr>
-            <a:r>
-              <a:rPr lang="en-US" sz="1600" b="1" dirty="0">
-                <a:solidFill>
-                  <a:srgbClr val="FFFFFF"/>
-                </a:solidFill>
-              </a:rPr>
-              <a:t>problems to learn from</a:t>
-            </a:r>
-            <a:pPr indent="0" marL="0">
-              <a:buNone/>
-            </a:pPr>
-            <a:r>
-              <a:rPr lang="en-US" sz="1600" dirty="0">
-                <a:solidFill>
-                  <a:srgbClr val="FFFFFF"/>
-                </a:solidFill>
-              </a:rPr>
-              <a:t>, </a:t>
-            </a:r>
-            <a:pPr indent="0" marL="0">
-              <a:buNone/>
-            </a:pPr>
-            <a:r>
-              <a:rPr lang="en-US" sz="1600" b="1" dirty="0">
-                <a:solidFill>
-                  <a:srgbClr val="FFFFFF"/>
-                </a:solidFill>
-              </a:rPr>
-              <a:t>a fixed set to compare on</a:t>
-            </a:r>
-            <a:pPr indent="0" marL="0">
-              <a:buNone/>
-            </a:pPr>
-            <a:r>
-              <a:rPr lang="en-US" sz="1600" dirty="0">
-                <a:solidFill>
-                  <a:srgbClr val="FFFFFF"/>
-                </a:solidFill>
-              </a:rPr>
-              <a:t> and </a:t>
-            </a:r>
-            <a:pPr indent="0" marL="0">
-              <a:buNone/>
-            </a:pPr>
-            <a:r>
-              <a:rPr lang="en-US" sz="1600" b="1" dirty="0">
-                <a:solidFill>
-                  <a:srgbClr val="FFFFFF"/>
-                </a:solidFill>
-              </a:rPr>
-              <a:t>problems that look like practice</a:t>
-            </a:r>
-            <a:pPr indent="0" marL="0">
-              <a:buNone/>
-            </a:pPr>
-            <a:r>
-              <a:rPr lang="en-US" sz="1600" dirty="0">
-                <a:solidFill>
-                  <a:srgbClr val="FFFFFF"/>
-                </a:solidFill>
-              </a:rPr>
-              <a:t>.</a:t>
-            </a:r>
-            <a:endParaRPr lang="en-US" sz="1600" dirty="0"/>
-          </a:p>
-        </p:txBody>
+          <p:cNvPr id="80" name="mini card gen 1"/>
+          <p:cNvSpPr/>
+          <p:nvPr/>
+        </p:nvSpPr>
+        <p:spPr>
+          <a:xfrm>
+            <a:off x="6473952" y="4590288"/>
+            <a:ext cx="603504" cy="475488"/>
+          </a:xfrm>
+          <a:prstGeom prst="rect">
+            <a:avLst/>
+          </a:prstGeom>
+          <a:solidFill>
+            <a:srgbClr val="FFFFFF"/>
+          </a:solidFill>
+          <a:ln w="6350">
+            <a:solidFill>
+              <a:srgbClr val="898781"/>
+            </a:solidFill>
+            <a:prstDash val="solid"/>
+          </a:ln>
+        </p:spPr>
+      </p:sp>
+      <p:sp>
+        <p:nvSpPr>
+          <p:cNvPr id="81" name="mini slab gen 1"/>
+          <p:cNvSpPr/>
+          <p:nvPr/>
+        </p:nvSpPr>
+        <p:spPr>
+          <a:xfrm>
+            <a:off x="6519672" y="4636008"/>
+            <a:ext cx="512064" cy="32004"/>
+          </a:xfrm>
+          <a:prstGeom prst="rect">
+            <a:avLst/>
+          </a:prstGeom>
+          <a:solidFill>
+            <a:srgbClr val="52514E"/>
+          </a:solidFill>
+          <a:ln/>
+        </p:spPr>
+      </p:sp>
+      <p:sp>
+        <p:nvSpPr>
+          <p:cNvPr id="82" name="mini gen 1 0"/>
+          <p:cNvSpPr/>
+          <p:nvPr/>
+        </p:nvSpPr>
+        <p:spPr>
+          <a:xfrm>
+            <a:off x="6707124" y="4700016"/>
+            <a:ext cx="137160" cy="100584"/>
+          </a:xfrm>
+          <a:prstGeom prst="rect">
+            <a:avLst/>
+          </a:prstGeom>
+          <a:solidFill>
+            <a:schemeClr val="accent1"/>
+          </a:solidFill>
+          <a:ln w="5080">
+            <a:solidFill>
+              <a:srgbClr val="FFFFFF"/>
+            </a:solidFill>
+            <a:prstDash val="solid"/>
+          </a:ln>
+        </p:spPr>
+      </p:sp>
+      <p:sp>
+        <p:nvSpPr>
+          <p:cNvPr id="83" name="mini card gen 2"/>
+          <p:cNvSpPr/>
+          <p:nvPr/>
+        </p:nvSpPr>
+        <p:spPr>
+          <a:xfrm>
+            <a:off x="7095744" y="4590288"/>
+            <a:ext cx="603504" cy="475488"/>
+          </a:xfrm>
+          <a:prstGeom prst="rect">
+            <a:avLst/>
+          </a:prstGeom>
+          <a:solidFill>
+            <a:srgbClr val="FFFFFF"/>
+          </a:solidFill>
+          <a:ln w="6350">
+            <a:solidFill>
+              <a:srgbClr val="898781"/>
+            </a:solidFill>
+            <a:prstDash val="solid"/>
+          </a:ln>
+        </p:spPr>
+      </p:sp>
+      <p:sp>
+        <p:nvSpPr>
+          <p:cNvPr id="84" name="mini slab gen 2"/>
+          <p:cNvSpPr/>
+          <p:nvPr/>
+        </p:nvSpPr>
+        <p:spPr>
+          <a:xfrm>
+            <a:off x="7141464" y="4636008"/>
+            <a:ext cx="512064" cy="32004"/>
+          </a:xfrm>
+          <a:prstGeom prst="rect">
+            <a:avLst/>
+          </a:prstGeom>
+          <a:solidFill>
+            <a:srgbClr val="52514E"/>
+          </a:solidFill>
+          <a:ln/>
+        </p:spPr>
+      </p:sp>
+      <p:sp>
+        <p:nvSpPr>
+          <p:cNvPr id="85" name="mini gen 2 0"/>
+          <p:cNvSpPr/>
+          <p:nvPr/>
+        </p:nvSpPr>
+        <p:spPr>
+          <a:xfrm>
+            <a:off x="7271004" y="4709160"/>
+            <a:ext cx="82296" cy="82296"/>
+          </a:xfrm>
+          <a:prstGeom prst="ellipse">
+            <a:avLst/>
+          </a:prstGeom>
+          <a:solidFill>
+            <a:schemeClr val="accent1"/>
+          </a:solidFill>
+          <a:ln w="5080">
+            <a:solidFill>
+              <a:srgbClr val="FFFFFF"/>
+            </a:solidFill>
+            <a:prstDash val="solid"/>
+          </a:ln>
+        </p:spPr>
+      </p:sp>
+      <p:sp>
+        <p:nvSpPr>
+          <p:cNvPr id="86" name="mini gen 2 1"/>
+          <p:cNvSpPr/>
+          <p:nvPr/>
+        </p:nvSpPr>
+        <p:spPr>
+          <a:xfrm>
+            <a:off x="7427976" y="4727448"/>
+            <a:ext cx="109728" cy="45720"/>
+          </a:xfrm>
+          <a:prstGeom prst="rect">
+            <a:avLst/>
+          </a:prstGeom>
+          <a:solidFill>
+            <a:schemeClr val="accent1"/>
+          </a:solidFill>
+          <a:ln w="5080">
+            <a:solidFill>
+              <a:srgbClr val="FFFFFF"/>
+            </a:solidFill>
+            <a:prstDash val="solid"/>
+          </a:ln>
+        </p:spPr>
+      </p:sp>
+      <p:sp>
+        <p:nvSpPr>
+          <p:cNvPr id="87" name="mini card gen 3"/>
+          <p:cNvSpPr/>
+          <p:nvPr/>
+        </p:nvSpPr>
+        <p:spPr>
+          <a:xfrm>
+            <a:off x="7717536" y="4590288"/>
+            <a:ext cx="603504" cy="475488"/>
+          </a:xfrm>
+          <a:prstGeom prst="rect">
+            <a:avLst/>
+          </a:prstGeom>
+          <a:solidFill>
+            <a:srgbClr val="FFFFFF"/>
+          </a:solidFill>
+          <a:ln w="6350">
+            <a:solidFill>
+              <a:srgbClr val="898781"/>
+            </a:solidFill>
+            <a:prstDash val="solid"/>
+          </a:ln>
+        </p:spPr>
+      </p:sp>
+      <p:sp>
+        <p:nvSpPr>
+          <p:cNvPr id="88" name="mini wall gen 3"/>
+          <p:cNvSpPr/>
+          <p:nvPr/>
+        </p:nvSpPr>
+        <p:spPr>
+          <a:xfrm>
+            <a:off x="7763256" y="4636008"/>
+            <a:ext cx="32004" cy="384048"/>
+          </a:xfrm>
+          <a:prstGeom prst="rect">
+            <a:avLst/>
+          </a:prstGeom>
+          <a:solidFill>
+            <a:srgbClr val="52514E"/>
+          </a:solidFill>
+          <a:ln/>
+        </p:spPr>
+      </p:sp>
+      <p:sp>
+        <p:nvSpPr>
+          <p:cNvPr id="89" name="mini gen 3 0"/>
+          <p:cNvSpPr/>
+          <p:nvPr/>
+        </p:nvSpPr>
+        <p:spPr>
+          <a:xfrm>
+            <a:off x="7845552" y="4698785"/>
+            <a:ext cx="66470" cy="66470"/>
+          </a:xfrm>
+          <a:prstGeom prst="ellipse">
+            <a:avLst/>
+          </a:prstGeom>
+          <a:solidFill>
+            <a:schemeClr val="accent1"/>
+          </a:solidFill>
+          <a:ln w="5080">
+            <a:solidFill>
+              <a:srgbClr val="FFFFFF"/>
+            </a:solidFill>
+            <a:prstDash val="solid"/>
+          </a:ln>
+        </p:spPr>
+      </p:sp>
+      <p:sp>
+        <p:nvSpPr>
+          <p:cNvPr id="90" name="mini gen 3 1"/>
+          <p:cNvSpPr/>
+          <p:nvPr/>
+        </p:nvSpPr>
+        <p:spPr>
+          <a:xfrm>
+            <a:off x="7845552" y="4794797"/>
+            <a:ext cx="66470" cy="66470"/>
+          </a:xfrm>
+          <a:prstGeom prst="ellipse">
+            <a:avLst/>
+          </a:prstGeom>
+          <a:solidFill>
+            <a:schemeClr val="accent1"/>
+          </a:solidFill>
+          <a:ln w="5080">
+            <a:solidFill>
+              <a:srgbClr val="FFFFFF"/>
+            </a:solidFill>
+            <a:prstDash val="solid"/>
+          </a:ln>
+        </p:spPr>
+      </p:sp>
+      <p:sp>
+        <p:nvSpPr>
+          <p:cNvPr id="91" name="mini gen 3 2"/>
+          <p:cNvSpPr/>
+          <p:nvPr/>
+        </p:nvSpPr>
+        <p:spPr>
+          <a:xfrm>
+            <a:off x="7845552" y="4890809"/>
+            <a:ext cx="66470" cy="66470"/>
+          </a:xfrm>
+          <a:prstGeom prst="ellipse">
+            <a:avLst/>
+          </a:prstGeom>
+          <a:solidFill>
+            <a:schemeClr val="accent1"/>
+          </a:solidFill>
+          <a:ln w="5080">
+            <a:solidFill>
+              <a:srgbClr val="FFFFFF"/>
+            </a:solidFill>
+            <a:prstDash val="solid"/>
+          </a:ln>
+        </p:spPr>
+      </p:sp>
+      <p:sp>
+        <p:nvSpPr>
+          <p:cNvPr id="92" name="mini card gen 4"/>
+          <p:cNvSpPr/>
+          <p:nvPr/>
+        </p:nvSpPr>
+        <p:spPr>
+          <a:xfrm>
+            <a:off x="8339328" y="4590288"/>
+            <a:ext cx="603504" cy="475488"/>
+          </a:xfrm>
+          <a:prstGeom prst="rect">
+            <a:avLst/>
+          </a:prstGeom>
+          <a:solidFill>
+            <a:srgbClr val="FFFFFF"/>
+          </a:solidFill>
+          <a:ln w="6350">
+            <a:solidFill>
+              <a:srgbClr val="898781"/>
+            </a:solidFill>
+            <a:prstDash val="solid"/>
+          </a:ln>
+        </p:spPr>
+      </p:sp>
+      <p:sp>
+        <p:nvSpPr>
+          <p:cNvPr id="93" name="mini slab gen 4"/>
+          <p:cNvSpPr/>
+          <p:nvPr/>
+        </p:nvSpPr>
+        <p:spPr>
+          <a:xfrm>
+            <a:off x="8385048" y="4636008"/>
+            <a:ext cx="512064" cy="32004"/>
+          </a:xfrm>
+          <a:prstGeom prst="rect">
+            <a:avLst/>
+          </a:prstGeom>
+          <a:solidFill>
+            <a:srgbClr val="52514E"/>
+          </a:solidFill>
+          <a:ln/>
+        </p:spPr>
+      </p:sp>
+      <p:sp>
+        <p:nvSpPr>
+          <p:cNvPr id="94" name="mini gen 4 0"/>
+          <p:cNvSpPr/>
+          <p:nvPr/>
+        </p:nvSpPr>
+        <p:spPr>
+          <a:xfrm>
+            <a:off x="8442279" y="4700016"/>
+            <a:ext cx="90364" cy="66267"/>
+          </a:xfrm>
+          <a:prstGeom prst="rect">
+            <a:avLst/>
+          </a:prstGeom>
+          <a:solidFill>
+            <a:schemeClr val="accent1"/>
+          </a:solidFill>
+          <a:ln w="5080">
+            <a:solidFill>
+              <a:srgbClr val="FFFFFF"/>
+            </a:solidFill>
+            <a:prstDash val="solid"/>
+          </a:ln>
+        </p:spPr>
+      </p:sp>
+      <p:sp>
+        <p:nvSpPr>
+          <p:cNvPr id="95" name="mini gen 4 1"/>
+          <p:cNvSpPr/>
+          <p:nvPr/>
+        </p:nvSpPr>
+        <p:spPr>
+          <a:xfrm>
+            <a:off x="8562764" y="4709160"/>
+            <a:ext cx="54219" cy="54219"/>
+          </a:xfrm>
+          <a:prstGeom prst="ellipse">
+            <a:avLst/>
+          </a:prstGeom>
+          <a:solidFill>
+            <a:schemeClr val="accent1"/>
+          </a:solidFill>
+          <a:ln w="5080">
+            <a:solidFill>
+              <a:srgbClr val="FFFFFF"/>
+            </a:solidFill>
+            <a:prstDash val="solid"/>
+          </a:ln>
+        </p:spPr>
+      </p:sp>
+      <p:sp>
+        <p:nvSpPr>
+          <p:cNvPr id="96" name="mini gen 4 2"/>
+          <p:cNvSpPr/>
+          <p:nvPr/>
+        </p:nvSpPr>
+        <p:spPr>
+          <a:xfrm>
+            <a:off x="8656141" y="4727448"/>
+            <a:ext cx="72291" cy="30121"/>
+          </a:xfrm>
+          <a:prstGeom prst="rect">
+            <a:avLst/>
+          </a:prstGeom>
+          <a:solidFill>
+            <a:schemeClr val="accent1"/>
+          </a:solidFill>
+          <a:ln w="5080">
+            <a:solidFill>
+              <a:srgbClr val="FFFFFF"/>
+            </a:solidFill>
+            <a:prstDash val="solid"/>
+          </a:ln>
+        </p:spPr>
+      </p:sp>
+      <p:sp>
+        <p:nvSpPr>
+          <p:cNvPr id="97" name="mini gen 4 3"/>
+          <p:cNvSpPr/>
+          <p:nvPr/>
+        </p:nvSpPr>
+        <p:spPr>
+          <a:xfrm>
+            <a:off x="8767590" y="4709160"/>
+            <a:ext cx="54219" cy="54219"/>
+          </a:xfrm>
+          <a:prstGeom prst="ellipse">
+            <a:avLst/>
+          </a:prstGeom>
+          <a:solidFill>
+            <a:schemeClr val="accent1"/>
+          </a:solidFill>
+          <a:ln w="5080">
+            <a:solidFill>
+              <a:srgbClr val="FFFFFF"/>
+            </a:solidFill>
+            <a:prstDash val="solid"/>
+          </a:ln>
+        </p:spPr>
+      </p:sp>
+      <p:sp>
+        <p:nvSpPr>
+          <p:cNvPr id="98" name="mini card gen 5"/>
+          <p:cNvSpPr/>
+          <p:nvPr/>
+        </p:nvSpPr>
+        <p:spPr>
+          <a:xfrm>
+            <a:off x="8961120" y="4590288"/>
+            <a:ext cx="603504" cy="475488"/>
+          </a:xfrm>
+          <a:prstGeom prst="rect">
+            <a:avLst/>
+          </a:prstGeom>
+          <a:solidFill>
+            <a:srgbClr val="FFFFFF"/>
+          </a:solidFill>
+          <a:ln w="6350">
+            <a:solidFill>
+              <a:srgbClr val="898781"/>
+            </a:solidFill>
+            <a:prstDash val="solid"/>
+          </a:ln>
+        </p:spPr>
+      </p:sp>
+      <p:sp>
+        <p:nvSpPr>
+          <p:cNvPr id="99" name="mini slab gen 5"/>
+          <p:cNvSpPr/>
+          <p:nvPr/>
+        </p:nvSpPr>
+        <p:spPr>
+          <a:xfrm>
+            <a:off x="9006840" y="4636008"/>
+            <a:ext cx="512064" cy="32004"/>
+          </a:xfrm>
+          <a:prstGeom prst="rect">
+            <a:avLst/>
+          </a:prstGeom>
+          <a:solidFill>
+            <a:srgbClr val="52514E"/>
+          </a:solidFill>
+          <a:ln/>
+        </p:spPr>
+      </p:sp>
+      <p:sp>
+        <p:nvSpPr>
+          <p:cNvPr id="100" name="mini gen 5 0"/>
+          <p:cNvSpPr/>
+          <p:nvPr/>
+        </p:nvSpPr>
+        <p:spPr>
+          <a:xfrm>
+            <a:off x="9069593" y="4709160"/>
+            <a:ext cx="45182" cy="45182"/>
+          </a:xfrm>
+          <a:prstGeom prst="ellipse">
+            <a:avLst/>
+          </a:prstGeom>
+          <a:solidFill>
+            <a:schemeClr val="accent1"/>
+          </a:solidFill>
+          <a:ln w="5080">
+            <a:solidFill>
+              <a:srgbClr val="FFFFFF"/>
+            </a:solidFill>
+            <a:prstDash val="solid"/>
+          </a:ln>
+        </p:spPr>
+      </p:sp>
+      <p:sp>
+        <p:nvSpPr>
+          <p:cNvPr id="101" name="mini gen 5 1"/>
+          <p:cNvSpPr/>
+          <p:nvPr/>
+        </p:nvSpPr>
+        <p:spPr>
+          <a:xfrm>
+            <a:off x="9147407" y="4727448"/>
+            <a:ext cx="60243" cy="25101"/>
+          </a:xfrm>
+          <a:prstGeom prst="rect">
+            <a:avLst/>
+          </a:prstGeom>
+          <a:solidFill>
+            <a:schemeClr val="accent1"/>
+          </a:solidFill>
+          <a:ln w="5080">
+            <a:solidFill>
+              <a:srgbClr val="FFFFFF"/>
+            </a:solidFill>
+            <a:prstDash val="solid"/>
+          </a:ln>
+        </p:spPr>
+      </p:sp>
+      <p:sp>
+        <p:nvSpPr>
+          <p:cNvPr id="102" name="mini gen 5 2"/>
+          <p:cNvSpPr/>
+          <p:nvPr/>
+        </p:nvSpPr>
+        <p:spPr>
+          <a:xfrm>
+            <a:off x="9240281" y="4709160"/>
+            <a:ext cx="45182" cy="45182"/>
+          </a:xfrm>
+          <a:prstGeom prst="ellipse">
+            <a:avLst/>
+          </a:prstGeom>
+          <a:solidFill>
+            <a:schemeClr val="accent1"/>
+          </a:solidFill>
+          <a:ln w="5080">
+            <a:solidFill>
+              <a:srgbClr val="FFFFFF"/>
+            </a:solidFill>
+            <a:prstDash val="solid"/>
+          </a:ln>
+        </p:spPr>
+      </p:sp>
+      <p:sp>
+        <p:nvSpPr>
+          <p:cNvPr id="103" name="mini gen 5 3"/>
+          <p:cNvSpPr/>
+          <p:nvPr/>
+        </p:nvSpPr>
+        <p:spPr>
+          <a:xfrm>
+            <a:off x="9325625" y="4709160"/>
+            <a:ext cx="45182" cy="45182"/>
+          </a:xfrm>
+          <a:prstGeom prst="ellipse">
+            <a:avLst/>
+          </a:prstGeom>
+          <a:solidFill>
+            <a:schemeClr val="accent1"/>
+          </a:solidFill>
+          <a:ln w="5080">
+            <a:solidFill>
+              <a:srgbClr val="FFFFFF"/>
+            </a:solidFill>
+            <a:prstDash val="solid"/>
+          </a:ln>
+        </p:spPr>
+      </p:sp>
+      <p:sp>
+        <p:nvSpPr>
+          <p:cNvPr id="104" name="mini gen 5 4"/>
+          <p:cNvSpPr/>
+          <p:nvPr/>
+        </p:nvSpPr>
+        <p:spPr>
+          <a:xfrm>
+            <a:off x="9403439" y="4727448"/>
+            <a:ext cx="60243" cy="25101"/>
+          </a:xfrm>
+          <a:prstGeom prst="rect">
+            <a:avLst/>
+          </a:prstGeom>
+          <a:solidFill>
+            <a:schemeClr val="accent1"/>
+          </a:solidFill>
+          <a:ln w="5080">
+            <a:solidFill>
+              <a:srgbClr val="FFFFFF"/>
+            </a:solidFill>
+            <a:prstDash val="solid"/>
+          </a:ln>
+        </p:spPr>
+      </p:sp>
+      <p:sp>
+        <p:nvSpPr>
+          <p:cNvPr id="105" name="mini card gen 6"/>
+          <p:cNvSpPr/>
+          <p:nvPr/>
+        </p:nvSpPr>
+        <p:spPr>
+          <a:xfrm>
+            <a:off x="9582912" y="4590288"/>
+            <a:ext cx="603504" cy="475488"/>
+          </a:xfrm>
+          <a:prstGeom prst="rect">
+            <a:avLst/>
+          </a:prstGeom>
+          <a:solidFill>
+            <a:srgbClr val="FFFFFF"/>
+          </a:solidFill>
+          <a:ln w="6350">
+            <a:solidFill>
+              <a:srgbClr val="898781"/>
+            </a:solidFill>
+            <a:prstDash val="solid"/>
+          </a:ln>
+        </p:spPr>
+      </p:sp>
+      <p:sp>
+        <p:nvSpPr>
+          <p:cNvPr id="106" name="mini slab gen 6"/>
+          <p:cNvSpPr/>
+          <p:nvPr/>
+        </p:nvSpPr>
+        <p:spPr>
+          <a:xfrm>
+            <a:off x="9628632" y="4636008"/>
+            <a:ext cx="512064" cy="32004"/>
+          </a:xfrm>
+          <a:prstGeom prst="rect">
+            <a:avLst/>
+          </a:prstGeom>
+          <a:solidFill>
+            <a:srgbClr val="52514E"/>
+          </a:solidFill>
+          <a:ln/>
+        </p:spPr>
+      </p:sp>
+      <p:sp>
+        <p:nvSpPr>
+          <p:cNvPr id="107" name="mini gen 6 0"/>
+          <p:cNvSpPr/>
+          <p:nvPr/>
+        </p:nvSpPr>
+        <p:spPr>
+          <a:xfrm>
+            <a:off x="9682420" y="4709160"/>
+            <a:ext cx="38728" cy="38728"/>
+          </a:xfrm>
+          <a:prstGeom prst="ellipse">
+            <a:avLst/>
+          </a:prstGeom>
+          <a:solidFill>
+            <a:schemeClr val="accent1"/>
+          </a:solidFill>
+          <a:ln w="5080">
+            <a:solidFill>
+              <a:srgbClr val="FFFFFF"/>
+            </a:solidFill>
+            <a:prstDash val="solid"/>
+          </a:ln>
+        </p:spPr>
+      </p:sp>
+      <p:sp>
+        <p:nvSpPr>
+          <p:cNvPr id="108" name="mini gen 6 1"/>
+          <p:cNvSpPr/>
+          <p:nvPr/>
+        </p:nvSpPr>
+        <p:spPr>
+          <a:xfrm>
+            <a:off x="9755572" y="4709160"/>
+            <a:ext cx="38728" cy="38728"/>
+          </a:xfrm>
+          <a:prstGeom prst="ellipse">
+            <a:avLst/>
+          </a:prstGeom>
+          <a:solidFill>
+            <a:schemeClr val="accent1"/>
+          </a:solidFill>
+          <a:ln w="5080">
+            <a:solidFill>
+              <a:srgbClr val="FFFFFF"/>
+            </a:solidFill>
+            <a:prstDash val="solid"/>
+          </a:ln>
+        </p:spPr>
+      </p:sp>
+      <p:sp>
+        <p:nvSpPr>
+          <p:cNvPr id="109" name="mini gen 6 2"/>
+          <p:cNvSpPr/>
+          <p:nvPr/>
+        </p:nvSpPr>
+        <p:spPr>
+          <a:xfrm>
+            <a:off x="9828724" y="4709160"/>
+            <a:ext cx="38728" cy="38728"/>
+          </a:xfrm>
+          <a:prstGeom prst="ellipse">
+            <a:avLst/>
+          </a:prstGeom>
+          <a:solidFill>
+            <a:schemeClr val="accent1"/>
+          </a:solidFill>
+          <a:ln w="5080">
+            <a:solidFill>
+              <a:srgbClr val="FFFFFF"/>
+            </a:solidFill>
+            <a:prstDash val="solid"/>
+          </a:ln>
+        </p:spPr>
+      </p:sp>
+      <p:sp>
+        <p:nvSpPr>
+          <p:cNvPr id="110" name="mini gen 6 3"/>
+          <p:cNvSpPr/>
+          <p:nvPr/>
+        </p:nvSpPr>
+        <p:spPr>
+          <a:xfrm>
+            <a:off x="9901876" y="4709160"/>
+            <a:ext cx="38728" cy="38728"/>
+          </a:xfrm>
+          <a:prstGeom prst="ellipse">
+            <a:avLst/>
+          </a:prstGeom>
+          <a:solidFill>
+            <a:schemeClr val="accent1"/>
+          </a:solidFill>
+          <a:ln w="5080">
+            <a:solidFill>
+              <a:srgbClr val="FFFFFF"/>
+            </a:solidFill>
+            <a:prstDash val="solid"/>
+          </a:ln>
+        </p:spPr>
+      </p:sp>
+      <p:sp>
+        <p:nvSpPr>
+          <p:cNvPr id="111" name="mini gen 6 4"/>
+          <p:cNvSpPr/>
+          <p:nvPr/>
+        </p:nvSpPr>
+        <p:spPr>
+          <a:xfrm>
+            <a:off x="9975028" y="4709160"/>
+            <a:ext cx="38728" cy="38728"/>
+          </a:xfrm>
+          <a:prstGeom prst="ellipse">
+            <a:avLst/>
+          </a:prstGeom>
+          <a:solidFill>
+            <a:schemeClr val="accent1"/>
+          </a:solidFill>
+          <a:ln w="5080">
+            <a:solidFill>
+              <a:srgbClr val="FFFFFF"/>
+            </a:solidFill>
+            <a:prstDash val="solid"/>
+          </a:ln>
+        </p:spPr>
+      </p:sp>
+      <p:sp>
+        <p:nvSpPr>
+          <p:cNvPr id="112" name="mini gen 6 5"/>
+          <p:cNvSpPr/>
+          <p:nvPr/>
+        </p:nvSpPr>
+        <p:spPr>
+          <a:xfrm>
+            <a:off x="10048180" y="4709160"/>
+            <a:ext cx="38728" cy="38728"/>
+          </a:xfrm>
+          <a:prstGeom prst="ellipse">
+            <a:avLst/>
+          </a:prstGeom>
+          <a:solidFill>
+            <a:schemeClr val="accent1"/>
+          </a:solidFill>
+          <a:ln w="5080">
+            <a:solidFill>
+              <a:srgbClr val="FFFFFF"/>
+            </a:solidFill>
+            <a:prstDash val="solid"/>
+          </a:ln>
+        </p:spPr>
+      </p:sp>
+      <p:sp>
+        <p:nvSpPr>
+          <p:cNvPr id="113" name="mini card gen 7"/>
+          <p:cNvSpPr/>
+          <p:nvPr/>
+        </p:nvSpPr>
+        <p:spPr>
+          <a:xfrm>
+            <a:off x="10204704" y="4590288"/>
+            <a:ext cx="603504" cy="475488"/>
+          </a:xfrm>
+          <a:prstGeom prst="rect">
+            <a:avLst/>
+          </a:prstGeom>
+          <a:solidFill>
+            <a:srgbClr val="FFFFFF"/>
+          </a:solidFill>
+          <a:ln w="6350">
+            <a:solidFill>
+              <a:srgbClr val="898781"/>
+            </a:solidFill>
+            <a:prstDash val="solid"/>
+          </a:ln>
+        </p:spPr>
+      </p:sp>
+      <p:sp>
+        <p:nvSpPr>
+          <p:cNvPr id="114" name="mini wall gen 7"/>
+          <p:cNvSpPr/>
+          <p:nvPr/>
+        </p:nvSpPr>
+        <p:spPr>
+          <a:xfrm>
+            <a:off x="10250424" y="4636008"/>
+            <a:ext cx="32004" cy="384048"/>
+          </a:xfrm>
+          <a:prstGeom prst="rect">
+            <a:avLst/>
+          </a:prstGeom>
+          <a:solidFill>
+            <a:srgbClr val="52514E"/>
+          </a:solidFill>
+          <a:ln/>
+        </p:spPr>
+      </p:sp>
+      <p:sp>
+        <p:nvSpPr>
+          <p:cNvPr id="115" name="mini gen 7 0"/>
+          <p:cNvSpPr/>
+          <p:nvPr/>
+        </p:nvSpPr>
+        <p:spPr>
+          <a:xfrm>
+            <a:off x="10323576" y="4665550"/>
+            <a:ext cx="55392" cy="36928"/>
+          </a:xfrm>
+          <a:prstGeom prst="rect">
+            <a:avLst/>
+          </a:prstGeom>
+          <a:solidFill>
+            <a:schemeClr val="accent1"/>
+          </a:solidFill>
+          <a:ln w="5080">
+            <a:solidFill>
+              <a:srgbClr val="FFFFFF"/>
+            </a:solidFill>
+            <a:prstDash val="solid"/>
+          </a:ln>
+        </p:spPr>
+      </p:sp>
+      <p:sp>
+        <p:nvSpPr>
+          <p:cNvPr id="116" name="mini gen 7 1"/>
+          <p:cNvSpPr/>
+          <p:nvPr/>
+        </p:nvSpPr>
+        <p:spPr>
+          <a:xfrm>
+            <a:off x="10332720" y="4715403"/>
+            <a:ext cx="33235" cy="33235"/>
+          </a:xfrm>
+          <a:prstGeom prst="ellipse">
+            <a:avLst/>
+          </a:prstGeom>
+          <a:solidFill>
+            <a:schemeClr val="accent1"/>
+          </a:solidFill>
+          <a:ln w="5080">
+            <a:solidFill>
+              <a:srgbClr val="FFFFFF"/>
+            </a:solidFill>
+            <a:prstDash val="solid"/>
+          </a:ln>
+        </p:spPr>
+      </p:sp>
+      <p:sp>
+        <p:nvSpPr>
+          <p:cNvPr id="117" name="mini gen 7 2"/>
+          <p:cNvSpPr/>
+          <p:nvPr/>
+        </p:nvSpPr>
+        <p:spPr>
+          <a:xfrm>
+            <a:off x="10323576" y="4770794"/>
+            <a:ext cx="44313" cy="18464"/>
+          </a:xfrm>
+          <a:prstGeom prst="rect">
+            <a:avLst/>
+          </a:prstGeom>
+          <a:solidFill>
+            <a:schemeClr val="accent1"/>
+          </a:solidFill>
+          <a:ln w="5080">
+            <a:solidFill>
+              <a:srgbClr val="FFFFFF"/>
+            </a:solidFill>
+            <a:prstDash val="solid"/>
+          </a:ln>
+        </p:spPr>
+      </p:sp>
+      <p:sp>
+        <p:nvSpPr>
+          <p:cNvPr id="118" name="mini gen 7 3"/>
+          <p:cNvSpPr/>
+          <p:nvPr/>
+        </p:nvSpPr>
+        <p:spPr>
+          <a:xfrm>
+            <a:off x="10332720" y="4811415"/>
+            <a:ext cx="33235" cy="33235"/>
+          </a:xfrm>
+          <a:prstGeom prst="ellipse">
+            <a:avLst/>
+          </a:prstGeom>
+          <a:solidFill>
+            <a:schemeClr val="accent1"/>
+          </a:solidFill>
+          <a:ln w="5080">
+            <a:solidFill>
+              <a:srgbClr val="FFFFFF"/>
+            </a:solidFill>
+            <a:prstDash val="solid"/>
+          </a:ln>
+        </p:spPr>
+      </p:sp>
+      <p:sp>
+        <p:nvSpPr>
+          <p:cNvPr id="119" name="mini gen 7 4"/>
+          <p:cNvSpPr/>
+          <p:nvPr/>
+        </p:nvSpPr>
+        <p:spPr>
+          <a:xfrm>
+            <a:off x="10323576" y="4857574"/>
+            <a:ext cx="55392" cy="36928"/>
+          </a:xfrm>
+          <a:prstGeom prst="rect">
+            <a:avLst/>
+          </a:prstGeom>
+          <a:solidFill>
+            <a:schemeClr val="accent1"/>
+          </a:solidFill>
+          <a:ln w="5080">
+            <a:solidFill>
+              <a:srgbClr val="FFFFFF"/>
+            </a:solidFill>
+            <a:prstDash val="solid"/>
+          </a:ln>
+        </p:spPr>
+      </p:sp>
+      <p:sp>
+        <p:nvSpPr>
+          <p:cNvPr id="120" name="mini gen 7 5"/>
+          <p:cNvSpPr/>
+          <p:nvPr/>
+        </p:nvSpPr>
+        <p:spPr>
+          <a:xfrm>
+            <a:off x="10332720" y="4907427"/>
+            <a:ext cx="33235" cy="33235"/>
+          </a:xfrm>
+          <a:prstGeom prst="ellipse">
+            <a:avLst/>
+          </a:prstGeom>
+          <a:solidFill>
+            <a:schemeClr val="accent1"/>
+          </a:solidFill>
+          <a:ln w="5080">
+            <a:solidFill>
+              <a:srgbClr val="FFFFFF"/>
+            </a:solidFill>
+            <a:prstDash val="solid"/>
+          </a:ln>
+        </p:spPr>
+      </p:sp>
+      <p:sp>
+        <p:nvSpPr>
+          <p:cNvPr id="121" name="mini gen 7 6"/>
+          <p:cNvSpPr/>
+          <p:nvPr/>
+        </p:nvSpPr>
+        <p:spPr>
+          <a:xfrm>
+            <a:off x="10323576" y="4962818"/>
+            <a:ext cx="44313" cy="18464"/>
+          </a:xfrm>
+          <a:prstGeom prst="rect">
+            <a:avLst/>
+          </a:prstGeom>
+          <a:solidFill>
+            <a:schemeClr val="accent1"/>
+          </a:solidFill>
+          <a:ln w="5080">
+            <a:solidFill>
+              <a:srgbClr val="FFFFFF"/>
+            </a:solidFill>
+            <a:prstDash val="solid"/>
+          </a:ln>
+        </p:spPr>
+      </p:sp>
+      <p:sp>
+        <p:nvSpPr>
+          <p:cNvPr id="122" name="mini card gen 8"/>
+          <p:cNvSpPr/>
+          <p:nvPr/>
+        </p:nvSpPr>
+        <p:spPr>
+          <a:xfrm>
+            <a:off x="10826496" y="4590288"/>
+            <a:ext cx="603504" cy="475488"/>
+          </a:xfrm>
+          <a:prstGeom prst="rect">
+            <a:avLst/>
+          </a:prstGeom>
+          <a:solidFill>
+            <a:srgbClr val="FFFFFF"/>
+          </a:solidFill>
+          <a:ln w="6350">
+            <a:solidFill>
+              <a:srgbClr val="898781"/>
+            </a:solidFill>
+            <a:prstDash val="solid"/>
+          </a:ln>
+        </p:spPr>
+      </p:sp>
+      <p:sp>
+        <p:nvSpPr>
+          <p:cNvPr id="123" name="mini slab gen 8"/>
+          <p:cNvSpPr/>
+          <p:nvPr/>
+        </p:nvSpPr>
+        <p:spPr>
+          <a:xfrm>
+            <a:off x="10872216" y="4636008"/>
+            <a:ext cx="512064" cy="32004"/>
+          </a:xfrm>
+          <a:prstGeom prst="rect">
+            <a:avLst/>
+          </a:prstGeom>
+          <a:solidFill>
+            <a:srgbClr val="52514E"/>
+          </a:solidFill>
+          <a:ln/>
+        </p:spPr>
+      </p:sp>
+      <p:sp>
+        <p:nvSpPr>
+          <p:cNvPr id="124" name="mini gen 8 0"/>
+          <p:cNvSpPr/>
+          <p:nvPr/>
+        </p:nvSpPr>
+        <p:spPr>
+          <a:xfrm>
+            <a:off x="10914051" y="4709160"/>
+            <a:ext cx="30121" cy="30121"/>
+          </a:xfrm>
+          <a:prstGeom prst="ellipse">
+            <a:avLst/>
+          </a:prstGeom>
+          <a:solidFill>
+            <a:schemeClr val="accent1"/>
+          </a:solidFill>
+          <a:ln w="5080">
+            <a:solidFill>
+              <a:srgbClr val="FFFFFF"/>
+            </a:solidFill>
+            <a:prstDash val="solid"/>
+          </a:ln>
+        </p:spPr>
+      </p:sp>
+      <p:sp>
+        <p:nvSpPr>
+          <p:cNvPr id="125" name="mini gen 8 1"/>
+          <p:cNvSpPr/>
+          <p:nvPr/>
+        </p:nvSpPr>
+        <p:spPr>
+          <a:xfrm>
+            <a:off x="10965927" y="4727448"/>
+            <a:ext cx="40162" cy="16734"/>
+          </a:xfrm>
+          <a:prstGeom prst="rect">
+            <a:avLst/>
+          </a:prstGeom>
+          <a:solidFill>
+            <a:schemeClr val="accent1"/>
+          </a:solidFill>
+          <a:ln w="5080">
+            <a:solidFill>
+              <a:srgbClr val="FFFFFF"/>
+            </a:solidFill>
+            <a:prstDash val="solid"/>
+          </a:ln>
+        </p:spPr>
+      </p:sp>
+      <p:sp>
+        <p:nvSpPr>
+          <p:cNvPr id="126" name="mini gen 8 2"/>
+          <p:cNvSpPr/>
+          <p:nvPr/>
+        </p:nvSpPr>
+        <p:spPr>
+          <a:xfrm>
+            <a:off x="11027843" y="4709160"/>
+            <a:ext cx="30121" cy="30121"/>
+          </a:xfrm>
+          <a:prstGeom prst="ellipse">
+            <a:avLst/>
+          </a:prstGeom>
+          <a:solidFill>
+            <a:schemeClr val="accent1"/>
+          </a:solidFill>
+          <a:ln w="5080">
+            <a:solidFill>
+              <a:srgbClr val="FFFFFF"/>
+            </a:solidFill>
+            <a:prstDash val="solid"/>
+          </a:ln>
+        </p:spPr>
+      </p:sp>
+      <p:sp>
+        <p:nvSpPr>
+          <p:cNvPr id="127" name="mini gen 8 3"/>
+          <p:cNvSpPr/>
+          <p:nvPr/>
+        </p:nvSpPr>
+        <p:spPr>
+          <a:xfrm>
+            <a:off x="11084739" y="4709160"/>
+            <a:ext cx="30121" cy="30121"/>
+          </a:xfrm>
+          <a:prstGeom prst="ellipse">
+            <a:avLst/>
+          </a:prstGeom>
+          <a:solidFill>
+            <a:schemeClr val="accent1"/>
+          </a:solidFill>
+          <a:ln w="5080">
+            <a:solidFill>
+              <a:srgbClr val="FFFFFF"/>
+            </a:solidFill>
+            <a:prstDash val="solid"/>
+          </a:ln>
+        </p:spPr>
+      </p:sp>
+      <p:sp>
+        <p:nvSpPr>
+          <p:cNvPr id="128" name="mini gen 8 4"/>
+          <p:cNvSpPr/>
+          <p:nvPr/>
+        </p:nvSpPr>
+        <p:spPr>
+          <a:xfrm>
+            <a:off x="11136615" y="4727448"/>
+            <a:ext cx="40162" cy="16734"/>
+          </a:xfrm>
+          <a:prstGeom prst="rect">
+            <a:avLst/>
+          </a:prstGeom>
+          <a:solidFill>
+            <a:schemeClr val="accent1"/>
+          </a:solidFill>
+          <a:ln w="5080">
+            <a:solidFill>
+              <a:srgbClr val="FFFFFF"/>
+            </a:solidFill>
+            <a:prstDash val="solid"/>
+          </a:ln>
+        </p:spPr>
+      </p:sp>
+      <p:sp>
+        <p:nvSpPr>
+          <p:cNvPr id="129" name="mini gen 8 5"/>
+          <p:cNvSpPr/>
+          <p:nvPr/>
+        </p:nvSpPr>
+        <p:spPr>
+          <a:xfrm>
+            <a:off x="11198531" y="4709160"/>
+            <a:ext cx="30121" cy="30121"/>
+          </a:xfrm>
+          <a:prstGeom prst="ellipse">
+            <a:avLst/>
+          </a:prstGeom>
+          <a:solidFill>
+            <a:schemeClr val="accent1"/>
+          </a:solidFill>
+          <a:ln w="5080">
+            <a:solidFill>
+              <a:srgbClr val="FFFFFF"/>
+            </a:solidFill>
+            <a:prstDash val="solid"/>
+          </a:ln>
+        </p:spPr>
+      </p:sp>
+      <p:sp>
+        <p:nvSpPr>
+          <p:cNvPr id="130" name="mini gen 8 6"/>
+          <p:cNvSpPr/>
+          <p:nvPr/>
+        </p:nvSpPr>
+        <p:spPr>
+          <a:xfrm>
+            <a:off x="11255427" y="4709160"/>
+            <a:ext cx="30121" cy="30121"/>
+          </a:xfrm>
+          <a:prstGeom prst="ellipse">
+            <a:avLst/>
+          </a:prstGeom>
+          <a:solidFill>
+            <a:schemeClr val="accent1"/>
+          </a:solidFill>
+          <a:ln w="5080">
+            <a:solidFill>
+              <a:srgbClr val="FFFFFF"/>
+            </a:solidFill>
+            <a:prstDash val="solid"/>
+          </a:ln>
+        </p:spPr>
+      </p:sp>
+      <p:sp>
+        <p:nvSpPr>
+          <p:cNvPr id="131" name="mini gen 8 7"/>
+          <p:cNvSpPr/>
+          <p:nvPr/>
+        </p:nvSpPr>
+        <p:spPr>
+          <a:xfrm>
+            <a:off x="11307303" y="4727448"/>
+            <a:ext cx="40162" cy="16734"/>
+          </a:xfrm>
+          <a:prstGeom prst="rect">
+            <a:avLst/>
+          </a:prstGeom>
+          <a:solidFill>
+            <a:schemeClr val="accent1"/>
+          </a:solidFill>
+          <a:ln w="5080">
+            <a:solidFill>
+              <a:srgbClr val="FFFFFF"/>
+            </a:solidFill>
+            <a:prstDash val="solid"/>
+          </a:ln>
+        </p:spPr>
       </p:sp>
       <p:sp>
         <p:nvSpPr>

</xml_diff>

<commit_message>
Talk: tighter speech for slides 1 to 5, hook before the introduction
</commit_message>
<xml_diff>
--- a/docs/CrossMEP_CIBW78_talk.pptx
+++ b/docs/CrossMEP_CIBW78_talk.pptx
@@ -122,12 +122,12 @@
   <p:extLst>
     <p:ext uri="{521415D9-36F7-43E2-AB2F-B90AF26B5E84}">
       <p14:sectionLst xmlns:p14="http://schemas.microsoft.com/office/powerpoint/2010/main">
-        <p14:section name="Opening" id="{f9e57f61-23ea-e421-605e-9c668a2b1fe9}">
+        <p14:section name="Opening" id="{e897c386-cac4-9b32-4772-b95465210eae}">
           <p14:sldIdLst>
             <p14:sldId id="256"/>
           </p14:sldIdLst>
         </p14:section>
-        <p14:section name="Motivation" id="{5f1f5531-bf01-66f7-fcea-f990a7d8a53c}">
+        <p14:section name="Motivation" id="{1f7c0389-a1db-0479-1903-3b3a75219fbc}">
           <p14:sldIdLst>
             <p14:sldId id="257"/>
             <p14:sldId id="258"/>
@@ -136,21 +136,21 @@
             <p14:sldId id="261"/>
           </p14:sldIdLst>
         </p14:section>
-        <p14:section name="The dataset" id="{a006b527-4799-ff66-2ac1-d3d2b47581c4}">
+        <p14:section name="The dataset" id="{84b369d3-87b3-93da-26f5-e36d94706415}">
           <p14:sldIdLst>
             <p14:sldId id="262"/>
             <p14:sldId id="263"/>
             <p14:sldId id="264"/>
           </p14:sldIdLst>
         </p14:section>
-        <p14:section name="Experiments" id="{ef7f460e-ed43-1b5f-c369-411e192d1c23}">
+        <p14:section name="Experiments" id="{8ec7769c-64fd-db8e-9cbe-b27f028f51bf}">
           <p14:sldIdLst>
             <p14:sldId id="265"/>
             <p14:sldId id="266"/>
             <p14:sldId id="267"/>
           </p14:sldIdLst>
         </p14:section>
-        <p14:section name="Use" id="{2ced0474-f5f8-b029-9828-8f58023a8c18}">
+        <p14:section name="Use" id="{534c0141-2b3d-c4a9-7750-b3953b437f9b}">
           <p14:sldIdLst>
             <p14:sldId id="268"/>
             <p14:sldId id="269"/>
@@ -2955,7 +2955,7 @@
           <a:p>
             <a:r>
               <a:rPr lang="en-US" dirty="0"/>
-              <a:t>I'm Lavinia Pedrollo, from Stanford. Every pipe, duct and cable tray in a building hangs from a support that an engineer designs by hand. We want machines to do some of that, and the first thing missing was data: no public set of support-design problems existed. So we built one, CrossMEP, with David Gvadzabia, Torben Graeber and Martin Fischer. (0:00)</a:t>
+              <a:t>Good morning. Every pipe, duct and cable tray in a building hangs from a support, and every one of those supports is designed by hand. We want machines to learn to design them. A learning machine needs problems to practise on, and in public there were none. So we built them. I'm Lavinia Pedrollo, from Stanford, and this is CrossMEP, with David Gvadzabia, Torben Graeber and Martin Fischer. (0:00)</a:t>
             </a:r>
             <a:endParaRPr lang="en-US" dirty="0"/>
           </a:p>
@@ -3043,7 +3043,7 @@
           <a:p>
             <a:r>
               <a:rPr lang="en-US" dirty="0"/>
-              <a:t>Three analyses. The first is a design check. Each tier adds one element: C1 is a single service, the most common support in any building; C8 has eight. Within a tier everything else varies, so the element count is the one controlled axis. Load at the support rises with the tier, from about 0.3 to 2.0 kilonewtons, and the closest gap narrows at every step, from 130 to about 51 millimetres. The dataset behaves as designed. (4:05)</a:t>
+              <a:t>Three analyses. The first is a design check. Each tier adds one element: C1 is a single service, the most common support in any building; C8 has eight. Within a tier everything else varies, so the element count is the one controlled axis. Load at the support rises with the tier, from about 0.3 to 2.0 kilonewtons, and the closest gap narrows at every step, from 130 to about 51 millimetres. The dataset behaves as designed. (4:25)</a:t>
             </a:r>
             <a:endParaRPr lang="en-US" dirty="0"/>
           </a:p>
@@ -3131,7 +3131,7 @@
           <a:p>
             <a:r>
               <a:rPr lang="en-US" dirty="0"/>
-              <a:t>The second is the one the generator could fail: is the spacing realistic in a building it has never seen? The gap distribution was fitted on a residential duplex. We held out a medical clinic, cut it into sections every 250 millimetres, and measured the gaps between pipes side by side. Generator to clinic: 32 millimetres. Above the 8 a perfect generator would show, but about as close as the duplex's own two models are to each other. A fixed 25-millimetre gap would be about 190 off. (4:35)</a:t>
+              <a:t>The second is the one the generator could fail: is the spacing realistic in a building it has never seen? The gap distribution was fitted on a residential duplex. We held out a medical clinic, cut it into sections every 250 millimetres, and measured the gaps between pipes side by side. Generator to clinic: 32 millimetres. Above the 8 a perfect generator would show, but about as close as the duplex's own two models are to each other. A fixed 25-millimetre gap would be about 190 off. (4:55)</a:t>
             </a:r>
             <a:endParaRPr lang="en-US" dirty="0"/>
           </a:p>
@@ -3219,7 +3219,7 @@
           <a:p>
             <a:r>
               <a:rPr lang="en-US" dirty="0"/>
-              <a:t>The third is a use of the dataset: what must a catalog of clamps cover? Our paper's two-size catalog attaches 14.5 percent of the pipes, interval 13 to 16, all one size, DN40. Trays, ducts and conduits are not covered at all. On the right, what the dataset asks of any catalog: two well-placed sizes reach 38 percent, six sizes 76, fifteen every pipe. What the catalog should contain becomes a measurement. (5:10)</a:t>
+              <a:t>The third is a use of the dataset: what must a catalog of clamps cover? Our paper's two-size catalog attaches 14.5 percent of the pipes, interval 13 to 16, all one size, DN40. Trays, ducts and conduits are not covered at all. On the right, what the dataset asks of any catalog: two well-placed sizes reach 38 percent, six sizes 76, fifteen every pipe. What the catalog should contain becomes a measurement. (5:30)</a:t>
             </a:r>
             <a:endParaRPr lang="en-US" dirty="0"/>
           </a:p>
@@ -3307,7 +3307,7 @@
           <a:p>
             <a:r>
               <a:rPr lang="en-US" dirty="0"/>
-              <a:t>Let me show it. This is the Generator Studio. I choose what crosses the hanger, a tier or an exact mix, and a seed. Out comes the section a designer receives, drawn as an engineer would issue it: every service at true size, its level, its load, the closest gap, and the run in 3D. Every section is a stored output of the released generator. Scan the code to try it. [Live: switch to the studio, click C3, then Generate another twice, then Exact mix with a duct. If the demo fails, stay on this slide: its screenshot is the fallback. Before the talk: open the studio once with internet, set its link sharing to public, scan the QR from a phone not logged in.] (5:40)</a:t>
+              <a:t>Let me show it. This is the Generator Studio. I choose what crosses the hanger, a tier or an exact mix, and a seed. Out comes the section a designer receives, drawn as an engineer would issue it: every service at true size, its level, its load, the closest gap, and the run in 3D. Every section is a stored output of the released generator. Scan the code to try it. [Live: switch to the studio, click C3, then Generate another twice, then Exact mix with a duct. If the demo fails, stay on this slide: its screenshot is the fallback. Before the talk: open the studio once with internet, set its link sharing to public, scan the QR from a phone not logged in.] (6:00)</a:t>
             </a:r>
             <a:endParaRPr lang="en-US" dirty="0"/>
           </a:p>
@@ -3395,7 +3395,7 @@
           <a:p>
             <a:r>
               <a:rPr lang="en-US" dirty="0"/>
-              <a:t>Using it takes a few lines: load a split, filter by composition, or generate your own mix. Four splits on disjoint seeds: five thousand to train, five hundred each for validation and test, and a benchmark of a thousand, a hundred and twenty-five per tier. The same files serve reinforcement learning, constraint programming and benchmarking, and we ship the scoring. Train on the generator. Evaluate on the benchmark, the same contexts for every method. Report per tier, with intervals and paired tests. (6:45)</a:t>
+              <a:t>Using it takes a few lines: load a split, filter by composition, or generate your own mix. Four splits on disjoint seeds: five thousand to train, five hundred each for validation and test, and a benchmark of a thousand, a hundred and twenty-five per tier. The same files serve reinforcement learning, constraint programming and benchmarking, and we ship the scoring. Train on the generator. Evaluate on the benchmark, the same contexts for every method. Report per tier, with intervals and paired tests. (7:05)</a:t>
             </a:r>
             <a:endParaRPr lang="en-US" dirty="0"/>
           </a:p>
@@ -3483,7 +3483,7 @@
           <a:p>
             <a:r>
               <a:rPr lang="en-US" dirty="0"/>
-              <a:t>Scope. CrossMEP is one section at one support. Pipe spacing was checked on two open buildings; the rest rests on practice and standards, and the trade mix is a design choice. It is not for the structural design of real installations. Next: a public checker, so methods can be compared on the answer; the catalog as an input; and a real test set from commercial projects, with supports designed by engineers. That is where I would value your eye. (7:20)</a:t>
+              <a:t>Scope. CrossMEP is one section at one support. Pipe spacing was checked on two open buildings; the rest rests on practice and standards, and the trade mix is a design choice. It is not for the structural design of real installations. Next: a public checker, so methods can be compared on the answer; the catalog as an input; and a real test set from commercial projects, with supports designed by engineers. That is where I would value your eye. (7:40)</a:t>
             </a:r>
             <a:endParaRPr lang="en-US" dirty="0"/>
           </a:p>
@@ -3571,7 +3571,7 @@
           <a:p>
             <a:r>
               <a:rPr lang="en-US" dirty="0"/>
-              <a:t>To sum up: CrossMEP is the brief, not the answer. Seven thousand support-design problems, every constant sourced or declared, spacing checked on two open buildings, all of it open. If you coordinate services or design supports, try the studio and tell me what looks wrong. Thank you. (7:50)</a:t>
+              <a:t>To sum up: CrossMEP is the brief, not the answer. Seven thousand support-design problems, every constant sourced or declared, spacing checked on two open buildings, all of it open. If you coordinate services or design supports, try the studio and tell me what looks wrong. Thank you. (8:10)</a:t>
             </a:r>
             <a:endParaRPr lang="en-US" dirty="0"/>
           </a:p>
@@ -3659,7 +3659,7 @@
           <a:p>
             <a:r>
               <a:rPr lang="en-US" dirty="0"/>
-              <a:t>Here is the scale. Every red mark in this hospital is a place where services hang from the structure. A modular support groups several services on one prefabricated frame: a structural support assembly. A hospital this size needs about ten thousand. Each takes twenty minutes to two hours to design, roughly a quarter of the MEP design effort. Practitioner estimates, but these are the numbers people live with. (0:25)</a:t>
+              <a:t>Here is the scale. This is a hospital, and every red mark is a place where services hang from the structure. A modular support groups several services on one prefabricated frame: a structural support assembly. A hospital this size needs about ten thousand of them, each designed individually, twenty minutes to two hours apiece. Add it up and it is about a quarter of the MEP design effort. Practitioner estimates, but these are the numbers people live with. (0:30)</a:t>
             </a:r>
             <a:endParaRPr lang="en-US" dirty="0"/>
           </a:p>
@@ -3747,7 +3747,7 @@
           <a:p>
             <a:r>
               <a:rPr lang="en-US" dirty="0"/>
-              <a:t>What exactly is designed, and from what? In: one cross-section at a hanger. The structure it hangs from, and the services crossing it, each with trade, position, size and weight per metre. That is the context: the brief. Out: assemblies of catalog parts that carry those services to the structure, checked for statics, anchors, connectors and buildability, ranked by cost. That is the answer. Keep the two apart: CrossMEP is contexts. It contains no assemblies. (0:55)</a:t>
+              <a:t>So what exactly is designed, and from what? In: one cross-section at a hanger. The structure it hangs from, and the services crossing it, each with its trade, position, size and weight per metre. We call that the context. It is the brief. Out: assemblies of catalog parts that carry those services to the structure, checked for statics, anchors, connectors and buildability, ranked by cost. That is the answer. Hold on to these two words, because CrossMEP is contexts only. It contains no assemblies. (1:00)</a:t>
             </a:r>
             <a:endParaRPr lang="en-US" dirty="0"/>
           </a:p>
@@ -3835,7 +3835,7 @@
           <a:p>
             <a:r>
               <a:rPr lang="en-US" dirty="0"/>
-              <a:t>Why is this still done by hand? Designers work from one section at each hanger, after coordination. Tools coordinate and check; they do not choose the layout or the parts. Three reasons: the topology comes from experience, the rules interact across thousands of combinations, and catalogs change faster than rule systems can be rewritten. (1:25)</a:t>
+              <a:t>Why is this still done by hand? A designer works from one section at each hanger, after coordination. Tools coordinate the model and check a design, but they do not choose the layout or the parts. Three reasons it has resisted automation: the topology comes from experience, the rules interact across thousands of combinations, and catalogs change faster than rule systems can be rewritten. (1:35)</a:t>
             </a:r>
             <a:endParaRPr lang="en-US" dirty="0"/>
           </a:p>
@@ -3923,7 +3923,7 @@
           <a:p>
             <a:r>
               <a:rPr lang="en-US" dirty="0"/>
-              <a:t>How would a machine learn this? Give it a context, let it propose a design, check the design, and feed pass or fail back. Round after round, the method improves. Each round needs a new context. Real projects give a handful, from one project, under NDA: too few to practise on, and a method tuned on them only fits that project. So we generate the contexts, as many as a method needs, and fix one benchmark to judge every method on. (1:45)</a:t>
+              <a:t>So how would a machine learn it? Give it a context. Let it propose an assembly. Check the assembly, and feed pass or fail back. Round after round, it gets better. But every round needs a new context, and that is where it stops. Real projects give a handful of sections, from one project, under NDA: too few to practise on, and a method tuned on them only fits that project. So we generate the contexts, as many as a method needs, and we fix one benchmark to judge every method on. (2:00)</a:t>
             </a:r>
             <a:endParaRPr lang="en-US" dirty="0"/>
           </a:p>
@@ -4011,7 +4011,7 @@
           <a:p>
             <a:r>
               <a:rPr lang="en-US" dirty="0"/>
-              <a:t>The real designs we had were few, from one kind of project with one trade mix: one corner of the design space. A method tuned on them measures fit to that project. So we generate. CrossMEP fills the space by construction, without limit: a new seed is a new set, uniform over the tiers or any mix you ask for. Seven thousand contexts are the release, not the ceiling. (2:20)</a:t>
+              <a:t>The real designs we had were few, from one kind of project with one trade mix: one corner of the design space. A method tuned on them measures fit to that project. So we generate. CrossMEP fills the space by construction, without limit: a new seed is a new set, uniform over the tiers or any mix you ask for. Seven thousand contexts are the release, not the ceiling. (2:40)</a:t>
             </a:r>
             <a:endParaRPr lang="en-US" dirty="0"/>
           </a:p>
@@ -4099,7 +4099,7 @@
           <a:p>
             <a:r>
               <a:rPr lang="en-US" dirty="0"/>
-              <a:t>Here is one context: a two-dimensional section at one support. Each element has its kind, service and trade, its size, insulation and position, and its load: weight per metre times the span it was sized at. Add the surface, slab or wall, and that is all. No channel, no rods, no anchors, no correct answer, because a feasible support depends on the catalog you build from. (2:50)</a:t>
+              <a:t>Here is one context: a two-dimensional section at one support. Each element has its kind, service and trade, its size, insulation and position, and its load: weight per metre times the span it was sized at. Add the surface, slab or wall, and that is all. No channel, no rods, no anchors, no correct answer, because a feasible support depends on the catalog you build from. (3:10)</a:t>
             </a:r>
             <a:endParaRPr lang="en-US" dirty="0"/>
           </a:p>
@@ -4187,7 +4187,7 @@
           <a:p>
             <a:r>
               <a:rPr lang="en-US" dirty="0"/>
-              <a:t>How is a context made? By rules an engineer would recognize. The tier fixes the element count. We pick the surface and fill it the way trades run services: hot and cold together, flow and return together, conduits in groups, bulky services nearest the slab. Gaps are drawn from gaps measured on a built project, never below twenty-five millimetres. On walls, electrical stays above water. Same seed, same file. (3:15)</a:t>
+              <a:t>How is a context made? By rules an engineer would recognize. The tier fixes the element count. We pick the surface and fill it the way trades run services: hot and cold together, flow and return together, conduits in groups, bulky services nearest the slab. Gaps are drawn from gaps measured on a built project, never below twenty-five millimetres. On walls, electrical stays above water. Same seed, same file. (3:35)</a:t>
             </a:r>
             <a:endParaRPr lang="en-US" dirty="0"/>
           </a:p>
@@ -4275,7 +4275,7 @@
           <a:p>
             <a:r>
               <a:rPr lang="en-US" dirty="0"/>
-              <a:t>Where do the numbers come from? Sizes, weights and spans from standards: EN for pipes and ducts, IEC for conduits and trays, ASME for spans, GEG for insulation. Spacing from measured open buildings. And a few choices of our own, like the trade mix, labelled as choices. (3:45)</a:t>
+              <a:t>Where do the numbers come from? Sizes, weights and spans from standards: EN for pipes and ducts, IEC for conduits and trays, ASME for spans, GEG for insulation. Spacing from measured open buildings. And a few choices of our own, like the trade mix, labelled as choices. (4:05)</a:t>
             </a:r>
             <a:endParaRPr lang="en-US" dirty="0"/>
           </a:p>

</xml_diff>

<commit_message>
Talk: slide 6 shows the ninety real designs in their corner of the design space
Title, cluster and speech now say what the real data was: ninety designs
from one project, a duct with many pipes each, no trays, nothing as simple
as one pipe. Slide 5 stays generic so the number lands once.
</commit_message>
<xml_diff>
--- a/docs/CrossMEP_CIBW78_talk.pptx
+++ b/docs/CrossMEP_CIBW78_talk.pptx
@@ -122,12 +122,12 @@
   <p:extLst>
     <p:ext uri="{521415D9-36F7-43E2-AB2F-B90AF26B5E84}">
       <p14:sectionLst xmlns:p14="http://schemas.microsoft.com/office/powerpoint/2010/main">
-        <p14:section name="Opening" id="{e897c386-cac4-9b32-4772-b95465210eae}">
+        <p14:section name="Opening" id="{3e9ff9de-461c-bf85-b48f-a4e4408db7cf}">
           <p14:sldIdLst>
             <p14:sldId id="256"/>
           </p14:sldIdLst>
         </p14:section>
-        <p14:section name="Motivation" id="{1f7c0389-a1db-0479-1903-3b3a75219fbc}">
+        <p14:section name="Motivation" id="{41e6bc5b-3d06-e545-9b5c-eac3ccfb6da6}">
           <p14:sldIdLst>
             <p14:sldId id="257"/>
             <p14:sldId id="258"/>
@@ -136,21 +136,21 @@
             <p14:sldId id="261"/>
           </p14:sldIdLst>
         </p14:section>
-        <p14:section name="The dataset" id="{84b369d3-87b3-93da-26f5-e36d94706415}">
+        <p14:section name="The dataset" id="{fed08a7a-e08b-375e-149b-80653295e0e5}">
           <p14:sldIdLst>
             <p14:sldId id="262"/>
             <p14:sldId id="263"/>
             <p14:sldId id="264"/>
           </p14:sldIdLst>
         </p14:section>
-        <p14:section name="Experiments" id="{8ec7769c-64fd-db8e-9cbe-b27f028f51bf}">
+        <p14:section name="Experiments" id="{05e19931-68de-e3f4-8d11-bfe4c5ee4683}">
           <p14:sldIdLst>
             <p14:sldId id="265"/>
             <p14:sldId id="266"/>
             <p14:sldId id="267"/>
           </p14:sldIdLst>
         </p14:section>
-        <p14:section name="Use" id="{534c0141-2b3d-c4a9-7750-b3953b437f9b}">
+        <p14:section name="Use" id="{d4d71d4b-2c84-a880-172b-2194da059b4c}">
           <p14:sldIdLst>
             <p14:sldId id="268"/>
             <p14:sldId id="269"/>
@@ -3043,7 +3043,7 @@
           <a:p>
             <a:r>
               <a:rPr lang="en-US" dirty="0"/>
-              <a:t>Three analyses. The first is a design check. Each tier adds one element: C1 is a single service, the most common support in any building; C8 has eight. Within a tier everything else varies, so the element count is the one controlled axis. Load at the support rises with the tier, from about 0.3 to 2.0 kilonewtons, and the closest gap narrows at every step, from 130 to about 51 millimetres. The dataset behaves as designed. (4:25)</a:t>
+              <a:t>Three analyses. The first is a design check. Each tier adds one element: C1 is a single service, the most common support in any building; C8 has eight. Within a tier everything else varies, so the element count is the one controlled axis. Load at the support rises with the tier, from about 0.3 to 2.0 kilonewtons, and the closest gap narrows at every step, from 130 to about 51 millimetres. The dataset behaves as designed. (4:35)</a:t>
             </a:r>
             <a:endParaRPr lang="en-US" dirty="0"/>
           </a:p>
@@ -3131,7 +3131,7 @@
           <a:p>
             <a:r>
               <a:rPr lang="en-US" dirty="0"/>
-              <a:t>The second is the one the generator could fail: is the spacing realistic in a building it has never seen? The gap distribution was fitted on a residential duplex. We held out a medical clinic, cut it into sections every 250 millimetres, and measured the gaps between pipes side by side. Generator to clinic: 32 millimetres. Above the 8 a perfect generator would show, but about as close as the duplex's own two models are to each other. A fixed 25-millimetre gap would be about 190 off. (4:55)</a:t>
+              <a:t>The second is the one the generator could fail: is the spacing realistic in a building it has never seen? The gap distribution was fitted on a residential duplex. We held out a medical clinic, cut it into sections every 250 millimetres, and measured the gaps between pipes side by side. Generator to clinic: 32 millimetres. Above the 8 a perfect generator would show, but about as close as the duplex's own two models are to each other. A fixed 25-millimetre gap would be about 190 off. (5:05)</a:t>
             </a:r>
             <a:endParaRPr lang="en-US" dirty="0"/>
           </a:p>
@@ -3219,7 +3219,7 @@
           <a:p>
             <a:r>
               <a:rPr lang="en-US" dirty="0"/>
-              <a:t>The third is a use of the dataset: what must a catalog of clamps cover? Our paper's two-size catalog attaches 14.5 percent of the pipes, interval 13 to 16, all one size, DN40. Trays, ducts and conduits are not covered at all. On the right, what the dataset asks of any catalog: two well-placed sizes reach 38 percent, six sizes 76, fifteen every pipe. What the catalog should contain becomes a measurement. (5:30)</a:t>
+              <a:t>The third is a use of the dataset: what must a catalog of clamps cover? Our paper's two-size catalog attaches 14.5 percent of the pipes, interval 13 to 16, all one size, DN40. Trays, ducts and conduits are not covered at all. On the right, what the dataset asks of any catalog: two well-placed sizes reach 38 percent, six sizes 76, fifteen every pipe. What the catalog should contain becomes a measurement. (5:40)</a:t>
             </a:r>
             <a:endParaRPr lang="en-US" dirty="0"/>
           </a:p>
@@ -3307,7 +3307,7 @@
           <a:p>
             <a:r>
               <a:rPr lang="en-US" dirty="0"/>
-              <a:t>Let me show it. This is the Generator Studio. I choose what crosses the hanger, a tier or an exact mix, and a seed. Out comes the section a designer receives, drawn as an engineer would issue it: every service at true size, its level, its load, the closest gap, and the run in 3D. Every section is a stored output of the released generator. Scan the code to try it. [Live: switch to the studio, click C3, then Generate another twice, then Exact mix with a duct. If the demo fails, stay on this slide: its screenshot is the fallback. Before the talk: open the studio once with internet, set its link sharing to public, scan the QR from a phone not logged in.] (6:00)</a:t>
+              <a:t>Let me show it. This is the Generator Studio. I choose what crosses the hanger, a tier or an exact mix, and a seed. Out comes the section a designer receives, drawn as an engineer would issue it: every service at true size, its level, its load, the closest gap, and the run in 3D. Every section is a stored output of the released generator. Scan the code to try it. [Live: switch to the studio, click C3, then Generate another twice, then Exact mix with a duct. If the demo fails, stay on this slide: its screenshot is the fallback. Before the talk: open the studio once with internet, set its link sharing to public, scan the QR from a phone not logged in.] (6:10)</a:t>
             </a:r>
             <a:endParaRPr lang="en-US" dirty="0"/>
           </a:p>
@@ -3395,7 +3395,7 @@
           <a:p>
             <a:r>
               <a:rPr lang="en-US" dirty="0"/>
-              <a:t>Using it takes a few lines: load a split, filter by composition, or generate your own mix. Four splits on disjoint seeds: five thousand to train, five hundred each for validation and test, and a benchmark of a thousand, a hundred and twenty-five per tier. The same files serve reinforcement learning, constraint programming and benchmarking, and we ship the scoring. Train on the generator. Evaluate on the benchmark, the same contexts for every method. Report per tier, with intervals and paired tests. (7:05)</a:t>
+              <a:t>Using it takes a few lines: load a split, filter by composition, or generate your own mix. Four splits on disjoint seeds: five thousand to train, five hundred each for validation and test, and a benchmark of a thousand, a hundred and twenty-five per tier. The same files serve reinforcement learning, constraint programming and benchmarking, and we ship the scoring. Train on the generator. Evaluate on the benchmark, the same contexts for every method. Report per tier, with intervals and paired tests. (7:15)</a:t>
             </a:r>
             <a:endParaRPr lang="en-US" dirty="0"/>
           </a:p>
@@ -3483,7 +3483,7 @@
           <a:p>
             <a:r>
               <a:rPr lang="en-US" dirty="0"/>
-              <a:t>Scope. CrossMEP is one section at one support. Pipe spacing was checked on two open buildings; the rest rests on practice and standards, and the trade mix is a design choice. It is not for the structural design of real installations. Next: a public checker, so methods can be compared on the answer; the catalog as an input; and a real test set from commercial projects, with supports designed by engineers. That is where I would value your eye. (7:40)</a:t>
+              <a:t>Scope. CrossMEP is one section at one support. Pipe spacing was checked on two open buildings; the rest rests on practice and standards, and the trade mix is a design choice. It is not for the structural design of real installations. Next: a public checker, so methods can be compared on the answer; the catalog as an input; and a real test set from commercial projects, with supports designed by engineers. That is where I would value your eye. (7:50)</a:t>
             </a:r>
             <a:endParaRPr lang="en-US" dirty="0"/>
           </a:p>
@@ -3571,7 +3571,7 @@
           <a:p>
             <a:r>
               <a:rPr lang="en-US" dirty="0"/>
-              <a:t>To sum up: CrossMEP is the brief, not the answer. Seven thousand support-design problems, every constant sourced or declared, spacing checked on two open buildings, all of it open. If you coordinate services or design supports, try the studio and tell me what looks wrong. Thank you. (8:10)</a:t>
+              <a:t>To sum up: CrossMEP is the brief, not the answer. Seven thousand support-design problems, every constant sourced or declared, spacing checked on two open buildings, all of it open. If you coordinate services or design supports, try the studio and tell me what looks wrong. Thank you. (8:20)</a:t>
             </a:r>
             <a:endParaRPr lang="en-US" dirty="0"/>
           </a:p>
@@ -3923,7 +3923,7 @@
           <a:p>
             <a:r>
               <a:rPr lang="en-US" dirty="0"/>
-              <a:t>So how would a machine learn it? Give it a context. Let it propose an assembly. Check the assembly, and feed pass or fail back. Round after round, it gets better. But every round needs a new context, and that is where it stops. Real projects give a handful of sections, from one project, under NDA: too few to practise on, and a method tuned on them only fits that project. So we generate the contexts, as many as a method needs, and we fix one benchmark to judge every method on. (2:00)</a:t>
+              <a:t>So how would a machine learn it? Give it a context. Let it propose an assembly. Check the assembly, and feed pass or fail back. Round after round, it gets better. But every round needs a new context, and that is where it stops. Real projects give a handful of sections, all from the same kind of job and confidential: too few to practise on, and a method tuned on them only fits that job. So we generate the contexts, as many as a method needs, and we fix one benchmark to judge every method on. (2:00)</a:t>
             </a:r>
             <a:endParaRPr lang="en-US" dirty="0"/>
           </a:p>
@@ -4011,7 +4011,7 @@
           <a:p>
             <a:r>
               <a:rPr lang="en-US" dirty="0"/>
-              <a:t>The real designs we had were few, from one kind of project with one trade mix: one corner of the design space. A method tuned on them measures fit to that project. So we generate. CrossMEP fills the space by construction, without limit: a new seed is a new set, uniform over the tiers or any mix you ask for. Seven thousand contexts are the release, not the ceiling. (2:40)</a:t>
+              <a:t>How scarce? The real designs we could get were ninety, from one project. Nearly every one had a duct and many pipes. Not one had a cable tray, and not one was as simple as a single pipe: one corner of the design space. A method tuned on them measures fit to that project. So CrossMEP fills the space by construction: every tier from one element to eight, kinds and surfaces varied, without limit. A new seed is a new set. Seven thousand contexts are the release, not the ceiling. (2:40)</a:t>
             </a:r>
             <a:endParaRPr lang="en-US" dirty="0"/>
           </a:p>
@@ -4099,7 +4099,7 @@
           <a:p>
             <a:r>
               <a:rPr lang="en-US" dirty="0"/>
-              <a:t>Here is one context: a two-dimensional section at one support. Each element has its kind, service and trade, its size, insulation and position, and its load: weight per metre times the span it was sized at. Add the surface, slab or wall, and that is all. No channel, no rods, no anchors, no correct answer, because a feasible support depends on the catalog you build from. (3:10)</a:t>
+              <a:t>Here is one context: a two-dimensional section at one support. Each element has its kind, service and trade, its size, insulation and position, and its load: weight per metre times the span it was sized at. Add the surface, slab or wall, and that is all. No channel, no rods, no anchors, no correct answer, because a feasible support depends on the catalog you build from. (3:20)</a:t>
             </a:r>
             <a:endParaRPr lang="en-US" dirty="0"/>
           </a:p>
@@ -4187,7 +4187,7 @@
           <a:p>
             <a:r>
               <a:rPr lang="en-US" dirty="0"/>
-              <a:t>How is a context made? By rules an engineer would recognize. The tier fixes the element count. We pick the surface and fill it the way trades run services: hot and cold together, flow and return together, conduits in groups, bulky services nearest the slab. Gaps are drawn from gaps measured on a built project, never below twenty-five millimetres. On walls, electrical stays above water. Same seed, same file. (3:35)</a:t>
+              <a:t>How is a context made? By rules an engineer would recognize. The tier fixes the element count. We pick the surface and fill it the way trades run services: hot and cold together, flow and return together, conduits in groups, bulky services nearest the slab. Gaps are drawn from gaps measured on a built project, never below twenty-five millimetres. On walls, electrical stays above water. Same seed, same file. (3:45)</a:t>
             </a:r>
             <a:endParaRPr lang="en-US" dirty="0"/>
           </a:p>
@@ -4275,7 +4275,7 @@
           <a:p>
             <a:r>
               <a:rPr lang="en-US" dirty="0"/>
-              <a:t>Where do the numbers come from? Sizes, weights and spans from standards: EN for pipes and ducts, IEC for conduits and trays, ASME for spans, GEG for insulation. Spacing from measured open buildings. And a few choices of our own, like the trade mix, labelled as choices. (4:05)</a:t>
+              <a:t>Where do the numbers come from? Sizes, weights and spans from standards: EN for pipes and ducts, IEC for conduits and trays, ASME for spans, GEG for insulation. Spacing from measured open buildings. And a few choices of our own, like the trade mix, labelled as choices. (4:15)</a:t>
             </a:r>
             <a:endParaRPr lang="en-US" dirty="0"/>
           </a:p>
@@ -17844,7 +17844,7 @@
                   <a:schemeClr val="tx1"/>
                 </a:solidFill>
               </a:rPr>
-              <a:t>The real designs we had sat in one corner of the design space, so we generate the whole of it</a:t>
+              <a:t>The ninety real designs we had came from one project and filled one corner of the design space, so CrossMEP covers all of it by construction</a:t>
             </a:r>
             <a:endParaRPr lang="en-US" sz="2600" dirty="0"/>
           </a:p>
@@ -17913,7 +17913,7 @@
                   <a:srgbClr val="52514E"/>
                 </a:solidFill>
               </a:rPr>
-              <a:t>   few · one project · one trade mix</a:t>
+              <a:t>   ninety · one project · confidential</a:t>
             </a:r>
             <a:endParaRPr lang="en-US" sz="1400" dirty="0"/>
           </a:p>
@@ -18047,8 +18047,8 @@
         </p:nvSpPr>
         <p:spPr>
           <a:xfrm>
-            <a:off x="1095908" y="2736342"/>
-            <a:ext cx="548640" cy="329184"/>
+            <a:off x="3223260" y="2032711"/>
+            <a:ext cx="640080" cy="329184"/>
           </a:xfrm>
           <a:prstGeom prst="rect">
             <a:avLst/>
@@ -18072,8 +18072,8 @@
         </p:nvSpPr>
         <p:spPr>
           <a:xfrm>
-            <a:off x="1141628" y="2782062"/>
-            <a:ext cx="457200" cy="32004"/>
+            <a:off x="3268980" y="2078431"/>
+            <a:ext cx="548640" cy="32004"/>
           </a:xfrm>
           <a:prstGeom prst="rect">
             <a:avLst/>
@@ -18092,8 +18092,33 @@
         </p:nvSpPr>
         <p:spPr>
           <a:xfrm>
-            <a:off x="1225673" y="2855214"/>
-            <a:ext cx="60512" cy="60512"/>
+            <a:off x="3312779" y="2142439"/>
+            <a:ext cx="69156" cy="50715"/>
+          </a:xfrm>
+          <a:prstGeom prst="rect">
+            <a:avLst/>
+          </a:prstGeom>
+          <a:solidFill>
+            <a:srgbClr val="EB6834"/>
+          </a:solidFill>
+          <a:ln w="5080">
+            <a:solidFill>
+              <a:srgbClr val="FFFFFF"/>
+            </a:solidFill>
+            <a:prstDash val="solid"/>
+          </a:ln>
+        </p:spPr>
+      </p:sp>
+      <p:sp>
+        <p:nvSpPr>
+          <p:cNvPr id="12" name="mini real 0 1"/>
+          <p:cNvSpPr/>
+          <p:nvPr/>
+        </p:nvSpPr>
+        <p:spPr>
+          <a:xfrm>
+            <a:off x="3404987" y="2151583"/>
+            <a:ext cx="41494" cy="41494"/>
           </a:xfrm>
           <a:prstGeom prst="ellipse">
             <a:avLst/>
@@ -18111,14 +18136,14 @@
       </p:sp>
       <p:sp>
         <p:nvSpPr>
-          <p:cNvPr id="12" name="mini real 0 1"/>
-          <p:cNvSpPr/>
-          <p:nvPr/>
-        </p:nvSpPr>
-        <p:spPr>
-          <a:xfrm>
-            <a:off x="1339973" y="2855214"/>
-            <a:ext cx="60512" cy="60512"/>
+          <p:cNvPr id="13" name="mini real 0 2"/>
+          <p:cNvSpPr/>
+          <p:nvPr/>
+        </p:nvSpPr>
+        <p:spPr>
+          <a:xfrm>
+            <a:off x="3483365" y="2151583"/>
+            <a:ext cx="41494" cy="41494"/>
           </a:xfrm>
           <a:prstGeom prst="ellipse">
             <a:avLst/>
@@ -18136,14 +18161,14 @@
       </p:sp>
       <p:sp>
         <p:nvSpPr>
-          <p:cNvPr id="13" name="mini real 0 2"/>
-          <p:cNvSpPr/>
-          <p:nvPr/>
-        </p:nvSpPr>
-        <p:spPr>
-          <a:xfrm>
-            <a:off x="1454273" y="2855214"/>
-            <a:ext cx="60512" cy="60512"/>
+          <p:cNvPr id="14" name="mini real 0 3"/>
+          <p:cNvSpPr/>
+          <p:nvPr/>
+        </p:nvSpPr>
+        <p:spPr>
+          <a:xfrm>
+            <a:off x="3561742" y="2151583"/>
+            <a:ext cx="41494" cy="41494"/>
           </a:xfrm>
           <a:prstGeom prst="ellipse">
             <a:avLst/>
@@ -18161,14 +18186,64 @@
       </p:sp>
       <p:sp>
         <p:nvSpPr>
-          <p:cNvPr id="14" name="mini card real 1"/>
-          <p:cNvSpPr/>
-          <p:nvPr/>
-        </p:nvSpPr>
-        <p:spPr>
-          <a:xfrm>
-            <a:off x="1593799" y="2649931"/>
-            <a:ext cx="548640" cy="329184"/>
+          <p:cNvPr id="15" name="mini real 0 4"/>
+          <p:cNvSpPr/>
+          <p:nvPr/>
+        </p:nvSpPr>
+        <p:spPr>
+          <a:xfrm>
+            <a:off x="3626288" y="2142439"/>
+            <a:ext cx="69156" cy="50715"/>
+          </a:xfrm>
+          <a:prstGeom prst="rect">
+            <a:avLst/>
+          </a:prstGeom>
+          <a:solidFill>
+            <a:srgbClr val="EB6834"/>
+          </a:solidFill>
+          <a:ln w="5080">
+            <a:solidFill>
+              <a:srgbClr val="FFFFFF"/>
+            </a:solidFill>
+            <a:prstDash val="solid"/>
+          </a:ln>
+        </p:spPr>
+      </p:sp>
+      <p:sp>
+        <p:nvSpPr>
+          <p:cNvPr id="16" name="mini real 0 5"/>
+          <p:cNvSpPr/>
+          <p:nvPr/>
+        </p:nvSpPr>
+        <p:spPr>
+          <a:xfrm>
+            <a:off x="3718496" y="2151583"/>
+            <a:ext cx="41494" cy="41494"/>
+          </a:xfrm>
+          <a:prstGeom prst="ellipse">
+            <a:avLst/>
+          </a:prstGeom>
+          <a:solidFill>
+            <a:srgbClr val="EB6834"/>
+          </a:solidFill>
+          <a:ln w="5080">
+            <a:solidFill>
+              <a:srgbClr val="FFFFFF"/>
+            </a:solidFill>
+            <a:prstDash val="solid"/>
+          </a:ln>
+        </p:spPr>
+      </p:sp>
+      <p:sp>
+        <p:nvSpPr>
+          <p:cNvPr id="17" name="mini card real 1"/>
+          <p:cNvSpPr/>
+          <p:nvPr/>
+        </p:nvSpPr>
+        <p:spPr>
+          <a:xfrm>
+            <a:off x="3856939" y="2032711"/>
+            <a:ext cx="640080" cy="329184"/>
           </a:xfrm>
           <a:prstGeom prst="rect">
             <a:avLst/>
@@ -18186,14 +18261,14 @@
       </p:sp>
       <p:sp>
         <p:nvSpPr>
-          <p:cNvPr id="15" name="mini slab real 1"/>
-          <p:cNvSpPr/>
-          <p:nvPr/>
-        </p:nvSpPr>
-        <p:spPr>
-          <a:xfrm>
-            <a:off x="1639519" y="2695651"/>
-            <a:ext cx="457200" cy="32004"/>
+          <p:cNvPr id="18" name="mini slab real 1"/>
+          <p:cNvSpPr/>
+          <p:nvPr/>
+        </p:nvSpPr>
+        <p:spPr>
+          <a:xfrm>
+            <a:off x="3902659" y="2078431"/>
+            <a:ext cx="548640" cy="32004"/>
           </a:xfrm>
           <a:prstGeom prst="rect">
             <a:avLst/>
@@ -18206,14 +18281,39 @@
       </p:sp>
       <p:sp>
         <p:nvSpPr>
-          <p:cNvPr id="16" name="mini real 1 0"/>
-          <p:cNvSpPr/>
-          <p:nvPr/>
-        </p:nvSpPr>
-        <p:spPr>
-          <a:xfrm>
-            <a:off x="1723563" y="2768803"/>
-            <a:ext cx="60512" cy="60512"/>
+          <p:cNvPr id="19" name="mini real 1 0"/>
+          <p:cNvSpPr/>
+          <p:nvPr/>
+        </p:nvSpPr>
+        <p:spPr>
+          <a:xfrm>
+            <a:off x="3940983" y="2142439"/>
+            <a:ext cx="60512" cy="44375"/>
+          </a:xfrm>
+          <a:prstGeom prst="rect">
+            <a:avLst/>
+          </a:prstGeom>
+          <a:solidFill>
+            <a:srgbClr val="EB6834"/>
+          </a:solidFill>
+          <a:ln w="5080">
+            <a:solidFill>
+              <a:srgbClr val="FFFFFF"/>
+            </a:solidFill>
+            <a:prstDash val="solid"/>
+          </a:ln>
+        </p:spPr>
+      </p:sp>
+      <p:sp>
+        <p:nvSpPr>
+          <p:cNvPr id="20" name="mini real 1 1"/>
+          <p:cNvSpPr/>
+          <p:nvPr/>
+        </p:nvSpPr>
+        <p:spPr>
+          <a:xfrm>
+            <a:off x="4021666" y="2151583"/>
+            <a:ext cx="36307" cy="36307"/>
           </a:xfrm>
           <a:prstGeom prst="ellipse">
             <a:avLst/>
@@ -18231,14 +18331,14 @@
       </p:sp>
       <p:sp>
         <p:nvSpPr>
-          <p:cNvPr id="17" name="mini real 1 1"/>
-          <p:cNvSpPr/>
-          <p:nvPr/>
-        </p:nvSpPr>
-        <p:spPr>
-          <a:xfrm>
-            <a:off x="1837863" y="2768803"/>
-            <a:ext cx="60512" cy="60512"/>
+          <p:cNvPr id="21" name="mini real 1 2"/>
+          <p:cNvSpPr/>
+          <p:nvPr/>
+        </p:nvSpPr>
+        <p:spPr>
+          <a:xfrm>
+            <a:off x="4090246" y="2151583"/>
+            <a:ext cx="36307" cy="36307"/>
           </a:xfrm>
           <a:prstGeom prst="ellipse">
             <a:avLst/>
@@ -18256,14 +18356,14 @@
       </p:sp>
       <p:sp>
         <p:nvSpPr>
-          <p:cNvPr id="18" name="mini real 1 2"/>
-          <p:cNvSpPr/>
-          <p:nvPr/>
-        </p:nvSpPr>
-        <p:spPr>
-          <a:xfrm>
-            <a:off x="1952163" y="2768803"/>
-            <a:ext cx="60512" cy="60512"/>
+          <p:cNvPr id="22" name="mini real 1 3"/>
+          <p:cNvSpPr/>
+          <p:nvPr/>
+        </p:nvSpPr>
+        <p:spPr>
+          <a:xfrm>
+            <a:off x="4158826" y="2151583"/>
+            <a:ext cx="36307" cy="36307"/>
           </a:xfrm>
           <a:prstGeom prst="ellipse">
             <a:avLst/>
@@ -18281,14 +18381,89 @@
       </p:sp>
       <p:sp>
         <p:nvSpPr>
-          <p:cNvPr id="19" name="mini card real 2"/>
-          <p:cNvSpPr/>
-          <p:nvPr/>
-        </p:nvSpPr>
-        <p:spPr>
-          <a:xfrm>
-            <a:off x="2091690" y="2748686"/>
-            <a:ext cx="548640" cy="329184"/>
+          <p:cNvPr id="23" name="mini real 1 4"/>
+          <p:cNvSpPr/>
+          <p:nvPr/>
+        </p:nvSpPr>
+        <p:spPr>
+          <a:xfrm>
+            <a:off x="4215303" y="2142439"/>
+            <a:ext cx="60512" cy="44375"/>
+          </a:xfrm>
+          <a:prstGeom prst="rect">
+            <a:avLst/>
+          </a:prstGeom>
+          <a:solidFill>
+            <a:srgbClr val="EB6834"/>
+          </a:solidFill>
+          <a:ln w="5080">
+            <a:solidFill>
+              <a:srgbClr val="FFFFFF"/>
+            </a:solidFill>
+            <a:prstDash val="solid"/>
+          </a:ln>
+        </p:spPr>
+      </p:sp>
+      <p:sp>
+        <p:nvSpPr>
+          <p:cNvPr id="24" name="mini real 1 5"/>
+          <p:cNvSpPr/>
+          <p:nvPr/>
+        </p:nvSpPr>
+        <p:spPr>
+          <a:xfrm>
+            <a:off x="4295986" y="2151583"/>
+            <a:ext cx="36307" cy="36307"/>
+          </a:xfrm>
+          <a:prstGeom prst="ellipse">
+            <a:avLst/>
+          </a:prstGeom>
+          <a:solidFill>
+            <a:srgbClr val="EB6834"/>
+          </a:solidFill>
+          <a:ln w="5080">
+            <a:solidFill>
+              <a:srgbClr val="FFFFFF"/>
+            </a:solidFill>
+            <a:prstDash val="solid"/>
+          </a:ln>
+        </p:spPr>
+      </p:sp>
+      <p:sp>
+        <p:nvSpPr>
+          <p:cNvPr id="25" name="mini real 1 6"/>
+          <p:cNvSpPr/>
+          <p:nvPr/>
+        </p:nvSpPr>
+        <p:spPr>
+          <a:xfrm>
+            <a:off x="4364566" y="2151583"/>
+            <a:ext cx="36307" cy="36307"/>
+          </a:xfrm>
+          <a:prstGeom prst="ellipse">
+            <a:avLst/>
+          </a:prstGeom>
+          <a:solidFill>
+            <a:srgbClr val="EB6834"/>
+          </a:solidFill>
+          <a:ln w="5080">
+            <a:solidFill>
+              <a:srgbClr val="FFFFFF"/>
+            </a:solidFill>
+            <a:prstDash val="solid"/>
+          </a:ln>
+        </p:spPr>
+      </p:sp>
+      <p:sp>
+        <p:nvSpPr>
+          <p:cNvPr id="26" name="mini card real 2"/>
+          <p:cNvSpPr/>
+          <p:nvPr/>
+        </p:nvSpPr>
+        <p:spPr>
+          <a:xfrm>
+            <a:off x="4490618" y="2032711"/>
+            <a:ext cx="640080" cy="329184"/>
           </a:xfrm>
           <a:prstGeom prst="rect">
             <a:avLst/>
@@ -18306,14 +18481,14 @@
       </p:sp>
       <p:sp>
         <p:nvSpPr>
-          <p:cNvPr id="20" name="mini slab real 2"/>
-          <p:cNvSpPr/>
-          <p:nvPr/>
-        </p:nvSpPr>
-        <p:spPr>
-          <a:xfrm>
-            <a:off x="2137410" y="2794406"/>
-            <a:ext cx="457200" cy="32004"/>
+          <p:cNvPr id="27" name="mini slab real 2"/>
+          <p:cNvSpPr/>
+          <p:nvPr/>
+        </p:nvSpPr>
+        <p:spPr>
+          <a:xfrm>
+            <a:off x="4536338" y="2078431"/>
+            <a:ext cx="548640" cy="32004"/>
           </a:xfrm>
           <a:prstGeom prst="rect">
             <a:avLst/>
@@ -18326,14 +18501,39 @@
       </p:sp>
       <p:sp>
         <p:nvSpPr>
-          <p:cNvPr id="21" name="mini real 2 0"/>
-          <p:cNvSpPr/>
-          <p:nvPr/>
-        </p:nvSpPr>
-        <p:spPr>
-          <a:xfrm>
-            <a:off x="2221454" y="2867558"/>
-            <a:ext cx="60512" cy="60512"/>
+          <p:cNvPr id="28" name="mini real 2 0"/>
+          <p:cNvSpPr/>
+          <p:nvPr/>
+        </p:nvSpPr>
+        <p:spPr>
+          <a:xfrm>
+            <a:off x="4570404" y="2142439"/>
+            <a:ext cx="53788" cy="39445"/>
+          </a:xfrm>
+          <a:prstGeom prst="rect">
+            <a:avLst/>
+          </a:prstGeom>
+          <a:solidFill>
+            <a:srgbClr val="EB6834"/>
+          </a:solidFill>
+          <a:ln w="5080">
+            <a:solidFill>
+              <a:srgbClr val="FFFFFF"/>
+            </a:solidFill>
+            <a:prstDash val="solid"/>
+          </a:ln>
+        </p:spPr>
+      </p:sp>
+      <p:sp>
+        <p:nvSpPr>
+          <p:cNvPr id="29" name="mini real 2 1"/>
+          <p:cNvSpPr/>
+          <p:nvPr/>
+        </p:nvSpPr>
+        <p:spPr>
+          <a:xfrm>
+            <a:off x="4642122" y="2151583"/>
+            <a:ext cx="32273" cy="32273"/>
           </a:xfrm>
           <a:prstGeom prst="ellipse">
             <a:avLst/>
@@ -18351,14 +18551,14 @@
       </p:sp>
       <p:sp>
         <p:nvSpPr>
-          <p:cNvPr id="22" name="mini real 2 1"/>
-          <p:cNvSpPr/>
-          <p:nvPr/>
-        </p:nvSpPr>
-        <p:spPr>
-          <a:xfrm>
-            <a:off x="2335754" y="2867558"/>
-            <a:ext cx="60512" cy="60512"/>
+          <p:cNvPr id="30" name="mini real 2 2"/>
+          <p:cNvSpPr/>
+          <p:nvPr/>
+        </p:nvSpPr>
+        <p:spPr>
+          <a:xfrm>
+            <a:off x="4703082" y="2151583"/>
+            <a:ext cx="32273" cy="32273"/>
           </a:xfrm>
           <a:prstGeom prst="ellipse">
             <a:avLst/>
@@ -18376,14 +18576,14 @@
       </p:sp>
       <p:sp>
         <p:nvSpPr>
-          <p:cNvPr id="23" name="mini real 2 2"/>
-          <p:cNvSpPr/>
-          <p:nvPr/>
-        </p:nvSpPr>
-        <p:spPr>
-          <a:xfrm>
-            <a:off x="2450054" y="2867558"/>
-            <a:ext cx="60512" cy="60512"/>
+          <p:cNvPr id="31" name="mini real 2 3"/>
+          <p:cNvSpPr/>
+          <p:nvPr/>
+        </p:nvSpPr>
+        <p:spPr>
+          <a:xfrm>
+            <a:off x="4764042" y="2151583"/>
+            <a:ext cx="32273" cy="32273"/>
           </a:xfrm>
           <a:prstGeom prst="ellipse">
             <a:avLst/>
@@ -18401,14 +18601,114 @@
       </p:sp>
       <p:sp>
         <p:nvSpPr>
-          <p:cNvPr id="24" name="mini card real 3"/>
-          <p:cNvSpPr/>
-          <p:nvPr/>
-        </p:nvSpPr>
-        <p:spPr>
-          <a:xfrm>
-            <a:off x="1231697" y="2304288"/>
-            <a:ext cx="548640" cy="329184"/>
+          <p:cNvPr id="32" name="mini real 2 4"/>
+          <p:cNvSpPr/>
+          <p:nvPr/>
+        </p:nvSpPr>
+        <p:spPr>
+          <a:xfrm>
+            <a:off x="4814244" y="2142439"/>
+            <a:ext cx="53788" cy="39445"/>
+          </a:xfrm>
+          <a:prstGeom prst="rect">
+            <a:avLst/>
+          </a:prstGeom>
+          <a:solidFill>
+            <a:srgbClr val="EB6834"/>
+          </a:solidFill>
+          <a:ln w="5080">
+            <a:solidFill>
+              <a:srgbClr val="FFFFFF"/>
+            </a:solidFill>
+            <a:prstDash val="solid"/>
+          </a:ln>
+        </p:spPr>
+      </p:sp>
+      <p:sp>
+        <p:nvSpPr>
+          <p:cNvPr id="33" name="mini real 2 5"/>
+          <p:cNvSpPr/>
+          <p:nvPr/>
+        </p:nvSpPr>
+        <p:spPr>
+          <a:xfrm>
+            <a:off x="4885962" y="2151583"/>
+            <a:ext cx="32273" cy="32273"/>
+          </a:xfrm>
+          <a:prstGeom prst="ellipse">
+            <a:avLst/>
+          </a:prstGeom>
+          <a:solidFill>
+            <a:srgbClr val="EB6834"/>
+          </a:solidFill>
+          <a:ln w="5080">
+            <a:solidFill>
+              <a:srgbClr val="FFFFFF"/>
+            </a:solidFill>
+            <a:prstDash val="solid"/>
+          </a:ln>
+        </p:spPr>
+      </p:sp>
+      <p:sp>
+        <p:nvSpPr>
+          <p:cNvPr id="34" name="mini real 2 6"/>
+          <p:cNvSpPr/>
+          <p:nvPr/>
+        </p:nvSpPr>
+        <p:spPr>
+          <a:xfrm>
+            <a:off x="4946922" y="2151583"/>
+            <a:ext cx="32273" cy="32273"/>
+          </a:xfrm>
+          <a:prstGeom prst="ellipse">
+            <a:avLst/>
+          </a:prstGeom>
+          <a:solidFill>
+            <a:srgbClr val="EB6834"/>
+          </a:solidFill>
+          <a:ln w="5080">
+            <a:solidFill>
+              <a:srgbClr val="FFFFFF"/>
+            </a:solidFill>
+            <a:prstDash val="solid"/>
+          </a:ln>
+        </p:spPr>
+      </p:sp>
+      <p:sp>
+        <p:nvSpPr>
+          <p:cNvPr id="35" name="mini real 2 7"/>
+          <p:cNvSpPr/>
+          <p:nvPr/>
+        </p:nvSpPr>
+        <p:spPr>
+          <a:xfrm>
+            <a:off x="5007882" y="2151583"/>
+            <a:ext cx="32273" cy="32273"/>
+          </a:xfrm>
+          <a:prstGeom prst="ellipse">
+            <a:avLst/>
+          </a:prstGeom>
+          <a:solidFill>
+            <a:srgbClr val="EB6834"/>
+          </a:solidFill>
+          <a:ln w="5080">
+            <a:solidFill>
+              <a:srgbClr val="FFFFFF"/>
+            </a:solidFill>
+            <a:prstDash val="solid"/>
+          </a:ln>
+        </p:spPr>
+      </p:sp>
+      <p:sp>
+        <p:nvSpPr>
+          <p:cNvPr id="36" name="mini card real 3"/>
+          <p:cNvSpPr/>
+          <p:nvPr/>
+        </p:nvSpPr>
+        <p:spPr>
+          <a:xfrm>
+            <a:off x="3404311" y="2427732"/>
+            <a:ext cx="640080" cy="329184"/>
           </a:xfrm>
           <a:prstGeom prst="rect">
             <a:avLst/>
@@ -18426,14 +18726,14 @@
       </p:sp>
       <p:sp>
         <p:nvSpPr>
-          <p:cNvPr id="25" name="mini slab real 3"/>
-          <p:cNvSpPr/>
-          <p:nvPr/>
-        </p:nvSpPr>
-        <p:spPr>
-          <a:xfrm>
-            <a:off x="1277417" y="2350008"/>
-            <a:ext cx="457200" cy="32004"/>
+          <p:cNvPr id="37" name="mini slab real 3"/>
+          <p:cNvSpPr/>
+          <p:nvPr/>
+        </p:nvSpPr>
+        <p:spPr>
+          <a:xfrm>
+            <a:off x="3450031" y="2473452"/>
+            <a:ext cx="548640" cy="32004"/>
           </a:xfrm>
           <a:prstGeom prst="rect">
             <a:avLst/>
@@ -18446,14 +18746,39 @@
       </p:sp>
       <p:sp>
         <p:nvSpPr>
-          <p:cNvPr id="26" name="mini real 3 0"/>
-          <p:cNvSpPr/>
-          <p:nvPr/>
-        </p:nvSpPr>
-        <p:spPr>
-          <a:xfrm>
-            <a:off x="1361461" y="2423160"/>
-            <a:ext cx="60512" cy="60512"/>
+          <p:cNvPr id="38" name="mini real 3 0"/>
+          <p:cNvSpPr/>
+          <p:nvPr/>
+        </p:nvSpPr>
+        <p:spPr>
+          <a:xfrm>
+            <a:off x="3493830" y="2537460"/>
+            <a:ext cx="69156" cy="50715"/>
+          </a:xfrm>
+          <a:prstGeom prst="rect">
+            <a:avLst/>
+          </a:prstGeom>
+          <a:solidFill>
+            <a:srgbClr val="EB6834"/>
+          </a:solidFill>
+          <a:ln w="5080">
+            <a:solidFill>
+              <a:srgbClr val="FFFFFF"/>
+            </a:solidFill>
+            <a:prstDash val="solid"/>
+          </a:ln>
+        </p:spPr>
+      </p:sp>
+      <p:sp>
+        <p:nvSpPr>
+          <p:cNvPr id="39" name="mini real 3 1"/>
+          <p:cNvSpPr/>
+          <p:nvPr/>
+        </p:nvSpPr>
+        <p:spPr>
+          <a:xfrm>
+            <a:off x="3586039" y="2546604"/>
+            <a:ext cx="41494" cy="41494"/>
           </a:xfrm>
           <a:prstGeom prst="ellipse">
             <a:avLst/>
@@ -18471,14 +18796,14 @@
       </p:sp>
       <p:sp>
         <p:nvSpPr>
-          <p:cNvPr id="27" name="mini real 3 1"/>
-          <p:cNvSpPr/>
-          <p:nvPr/>
-        </p:nvSpPr>
-        <p:spPr>
-          <a:xfrm>
-            <a:off x="1475761" y="2423160"/>
-            <a:ext cx="60512" cy="60512"/>
+          <p:cNvPr id="40" name="mini real 3 2"/>
+          <p:cNvSpPr/>
+          <p:nvPr/>
+        </p:nvSpPr>
+        <p:spPr>
+          <a:xfrm>
+            <a:off x="3664416" y="2546604"/>
+            <a:ext cx="41494" cy="41494"/>
           </a:xfrm>
           <a:prstGeom prst="ellipse">
             <a:avLst/>
@@ -18496,14 +18821,14 @@
       </p:sp>
       <p:sp>
         <p:nvSpPr>
-          <p:cNvPr id="28" name="mini real 3 2"/>
-          <p:cNvSpPr/>
-          <p:nvPr/>
-        </p:nvSpPr>
-        <p:spPr>
-          <a:xfrm>
-            <a:off x="1590061" y="2423160"/>
-            <a:ext cx="60512" cy="60512"/>
+          <p:cNvPr id="41" name="mini real 3 3"/>
+          <p:cNvSpPr/>
+          <p:nvPr/>
+        </p:nvSpPr>
+        <p:spPr>
+          <a:xfrm>
+            <a:off x="3742793" y="2546604"/>
+            <a:ext cx="41494" cy="41494"/>
           </a:xfrm>
           <a:prstGeom prst="ellipse">
             <a:avLst/>
@@ -18521,14 +18846,64 @@
       </p:sp>
       <p:sp>
         <p:nvSpPr>
-          <p:cNvPr id="29" name="mini card real 4"/>
-          <p:cNvSpPr/>
-          <p:nvPr/>
-        </p:nvSpPr>
-        <p:spPr>
-          <a:xfrm>
-            <a:off x="1865376" y="2353666"/>
-            <a:ext cx="548640" cy="329184"/>
+          <p:cNvPr id="42" name="mini real 3 4"/>
+          <p:cNvSpPr/>
+          <p:nvPr/>
+        </p:nvSpPr>
+        <p:spPr>
+          <a:xfrm>
+            <a:off x="3807339" y="2537460"/>
+            <a:ext cx="69156" cy="50715"/>
+          </a:xfrm>
+          <a:prstGeom prst="rect">
+            <a:avLst/>
+          </a:prstGeom>
+          <a:solidFill>
+            <a:srgbClr val="EB6834"/>
+          </a:solidFill>
+          <a:ln w="5080">
+            <a:solidFill>
+              <a:srgbClr val="FFFFFF"/>
+            </a:solidFill>
+            <a:prstDash val="solid"/>
+          </a:ln>
+        </p:spPr>
+      </p:sp>
+      <p:sp>
+        <p:nvSpPr>
+          <p:cNvPr id="43" name="mini real 3 5"/>
+          <p:cNvSpPr/>
+          <p:nvPr/>
+        </p:nvSpPr>
+        <p:spPr>
+          <a:xfrm>
+            <a:off x="3899547" y="2546604"/>
+            <a:ext cx="41494" cy="41494"/>
+          </a:xfrm>
+          <a:prstGeom prst="ellipse">
+            <a:avLst/>
+          </a:prstGeom>
+          <a:solidFill>
+            <a:srgbClr val="EB6834"/>
+          </a:solidFill>
+          <a:ln w="5080">
+            <a:solidFill>
+              <a:srgbClr val="FFFFFF"/>
+            </a:solidFill>
+            <a:prstDash val="solid"/>
+          </a:ln>
+        </p:spPr>
+      </p:sp>
+      <p:sp>
+        <p:nvSpPr>
+          <p:cNvPr id="44" name="mini card real 4"/>
+          <p:cNvSpPr/>
+          <p:nvPr/>
+        </p:nvSpPr>
+        <p:spPr>
+          <a:xfrm>
+            <a:off x="4037990" y="2427732"/>
+            <a:ext cx="640080" cy="329184"/>
           </a:xfrm>
           <a:prstGeom prst="rect">
             <a:avLst/>
@@ -18546,14 +18921,14 @@
       </p:sp>
       <p:sp>
         <p:nvSpPr>
-          <p:cNvPr id="30" name="mini slab real 4"/>
-          <p:cNvSpPr/>
-          <p:nvPr/>
-        </p:nvSpPr>
-        <p:spPr>
-          <a:xfrm>
-            <a:off x="1911096" y="2399386"/>
-            <a:ext cx="457200" cy="32004"/>
+          <p:cNvPr id="45" name="mini slab real 4"/>
+          <p:cNvSpPr/>
+          <p:nvPr/>
+        </p:nvSpPr>
+        <p:spPr>
+          <a:xfrm>
+            <a:off x="4083710" y="2473452"/>
+            <a:ext cx="548640" cy="32004"/>
           </a:xfrm>
           <a:prstGeom prst="rect">
             <a:avLst/>
@@ -18566,14 +18941,39 @@
       </p:sp>
       <p:sp>
         <p:nvSpPr>
-          <p:cNvPr id="31" name="mini real 4 0"/>
-          <p:cNvSpPr/>
-          <p:nvPr/>
-        </p:nvSpPr>
-        <p:spPr>
-          <a:xfrm>
-            <a:off x="1995140" y="2472538"/>
-            <a:ext cx="60512" cy="60512"/>
+          <p:cNvPr id="46" name="mini real 4 0"/>
+          <p:cNvSpPr/>
+          <p:nvPr/>
+        </p:nvSpPr>
+        <p:spPr>
+          <a:xfrm>
+            <a:off x="4122035" y="2537460"/>
+            <a:ext cx="60512" cy="44375"/>
+          </a:xfrm>
+          <a:prstGeom prst="rect">
+            <a:avLst/>
+          </a:prstGeom>
+          <a:solidFill>
+            <a:srgbClr val="EB6834"/>
+          </a:solidFill>
+          <a:ln w="5080">
+            <a:solidFill>
+              <a:srgbClr val="FFFFFF"/>
+            </a:solidFill>
+            <a:prstDash val="solid"/>
+          </a:ln>
+        </p:spPr>
+      </p:sp>
+      <p:sp>
+        <p:nvSpPr>
+          <p:cNvPr id="47" name="mini real 4 1"/>
+          <p:cNvSpPr/>
+          <p:nvPr/>
+        </p:nvSpPr>
+        <p:spPr>
+          <a:xfrm>
+            <a:off x="4202717" y="2546604"/>
+            <a:ext cx="36307" cy="36307"/>
           </a:xfrm>
           <a:prstGeom prst="ellipse">
             <a:avLst/>
@@ -18591,14 +18991,14 @@
       </p:sp>
       <p:sp>
         <p:nvSpPr>
-          <p:cNvPr id="32" name="mini real 4 1"/>
-          <p:cNvSpPr/>
-          <p:nvPr/>
-        </p:nvSpPr>
-        <p:spPr>
-          <a:xfrm>
-            <a:off x="2109440" y="2472538"/>
-            <a:ext cx="60512" cy="60512"/>
+          <p:cNvPr id="48" name="mini real 4 2"/>
+          <p:cNvSpPr/>
+          <p:nvPr/>
+        </p:nvSpPr>
+        <p:spPr>
+          <a:xfrm>
+            <a:off x="4271297" y="2546604"/>
+            <a:ext cx="36307" cy="36307"/>
           </a:xfrm>
           <a:prstGeom prst="ellipse">
             <a:avLst/>
@@ -18616,14 +19016,14 @@
       </p:sp>
       <p:sp>
         <p:nvSpPr>
-          <p:cNvPr id="33" name="mini real 4 2"/>
-          <p:cNvSpPr/>
-          <p:nvPr/>
-        </p:nvSpPr>
-        <p:spPr>
-          <a:xfrm>
-            <a:off x="2223740" y="2472538"/>
-            <a:ext cx="60512" cy="60512"/>
+          <p:cNvPr id="49" name="mini real 4 3"/>
+          <p:cNvSpPr/>
+          <p:nvPr/>
+        </p:nvSpPr>
+        <p:spPr>
+          <a:xfrm>
+            <a:off x="4339877" y="2546604"/>
+            <a:ext cx="36307" cy="36307"/>
           </a:xfrm>
           <a:prstGeom prst="ellipse">
             <a:avLst/>
@@ -18641,14 +19041,89 @@
       </p:sp>
       <p:sp>
         <p:nvSpPr>
-          <p:cNvPr id="34" name="mini card real 5"/>
-          <p:cNvSpPr/>
-          <p:nvPr/>
-        </p:nvSpPr>
-        <p:spPr>
-          <a:xfrm>
-            <a:off x="2453792" y="2427732"/>
-            <a:ext cx="548640" cy="329184"/>
+          <p:cNvPr id="50" name="mini real 4 4"/>
+          <p:cNvSpPr/>
+          <p:nvPr/>
+        </p:nvSpPr>
+        <p:spPr>
+          <a:xfrm>
+            <a:off x="4396355" y="2537460"/>
+            <a:ext cx="60512" cy="44375"/>
+          </a:xfrm>
+          <a:prstGeom prst="rect">
+            <a:avLst/>
+          </a:prstGeom>
+          <a:solidFill>
+            <a:srgbClr val="EB6834"/>
+          </a:solidFill>
+          <a:ln w="5080">
+            <a:solidFill>
+              <a:srgbClr val="FFFFFF"/>
+            </a:solidFill>
+            <a:prstDash val="solid"/>
+          </a:ln>
+        </p:spPr>
+      </p:sp>
+      <p:sp>
+        <p:nvSpPr>
+          <p:cNvPr id="51" name="mini real 4 5"/>
+          <p:cNvSpPr/>
+          <p:nvPr/>
+        </p:nvSpPr>
+        <p:spPr>
+          <a:xfrm>
+            <a:off x="4477037" y="2546604"/>
+            <a:ext cx="36307" cy="36307"/>
+          </a:xfrm>
+          <a:prstGeom prst="ellipse">
+            <a:avLst/>
+          </a:prstGeom>
+          <a:solidFill>
+            <a:srgbClr val="EB6834"/>
+          </a:solidFill>
+          <a:ln w="5080">
+            <a:solidFill>
+              <a:srgbClr val="FFFFFF"/>
+            </a:solidFill>
+            <a:prstDash val="solid"/>
+          </a:ln>
+        </p:spPr>
+      </p:sp>
+      <p:sp>
+        <p:nvSpPr>
+          <p:cNvPr id="52" name="mini real 4 6"/>
+          <p:cNvSpPr/>
+          <p:nvPr/>
+        </p:nvSpPr>
+        <p:spPr>
+          <a:xfrm>
+            <a:off x="4545617" y="2546604"/>
+            <a:ext cx="36307" cy="36307"/>
+          </a:xfrm>
+          <a:prstGeom prst="ellipse">
+            <a:avLst/>
+          </a:prstGeom>
+          <a:solidFill>
+            <a:srgbClr val="EB6834"/>
+          </a:solidFill>
+          <a:ln w="5080">
+            <a:solidFill>
+              <a:srgbClr val="FFFFFF"/>
+            </a:solidFill>
+            <a:prstDash val="solid"/>
+          </a:ln>
+        </p:spPr>
+      </p:sp>
+      <p:sp>
+        <p:nvSpPr>
+          <p:cNvPr id="53" name="mini card real 5"/>
+          <p:cNvSpPr/>
+          <p:nvPr/>
+        </p:nvSpPr>
+        <p:spPr>
+          <a:xfrm>
+            <a:off x="4671670" y="2427732"/>
+            <a:ext cx="640080" cy="329184"/>
           </a:xfrm>
           <a:prstGeom prst="rect">
             <a:avLst/>
@@ -18666,14 +19141,14 @@
       </p:sp>
       <p:sp>
         <p:nvSpPr>
-          <p:cNvPr id="35" name="mini slab real 5"/>
-          <p:cNvSpPr/>
-          <p:nvPr/>
-        </p:nvSpPr>
-        <p:spPr>
-          <a:xfrm>
-            <a:off x="2499512" y="2473452"/>
-            <a:ext cx="457200" cy="32004"/>
+          <p:cNvPr id="54" name="mini slab real 5"/>
+          <p:cNvSpPr/>
+          <p:nvPr/>
+        </p:nvSpPr>
+        <p:spPr>
+          <a:xfrm>
+            <a:off x="4717390" y="2473452"/>
+            <a:ext cx="548640" cy="32004"/>
           </a:xfrm>
           <a:prstGeom prst="rect">
             <a:avLst/>
@@ -18686,14 +19161,39 @@
       </p:sp>
       <p:sp>
         <p:nvSpPr>
-          <p:cNvPr id="36" name="mini real 5 0"/>
-          <p:cNvSpPr/>
-          <p:nvPr/>
-        </p:nvSpPr>
-        <p:spPr>
-          <a:xfrm>
-            <a:off x="2583557" y="2546604"/>
-            <a:ext cx="60512" cy="60512"/>
+          <p:cNvPr id="55" name="mini real 5 0"/>
+          <p:cNvSpPr/>
+          <p:nvPr/>
+        </p:nvSpPr>
+        <p:spPr>
+          <a:xfrm>
+            <a:off x="4751455" y="2537460"/>
+            <a:ext cx="53788" cy="39445"/>
+          </a:xfrm>
+          <a:prstGeom prst="rect">
+            <a:avLst/>
+          </a:prstGeom>
+          <a:solidFill>
+            <a:srgbClr val="EB6834"/>
+          </a:solidFill>
+          <a:ln w="5080">
+            <a:solidFill>
+              <a:srgbClr val="FFFFFF"/>
+            </a:solidFill>
+            <a:prstDash val="solid"/>
+          </a:ln>
+        </p:spPr>
+      </p:sp>
+      <p:sp>
+        <p:nvSpPr>
+          <p:cNvPr id="56" name="mini real 5 1"/>
+          <p:cNvSpPr/>
+          <p:nvPr/>
+        </p:nvSpPr>
+        <p:spPr>
+          <a:xfrm>
+            <a:off x="4823173" y="2546604"/>
+            <a:ext cx="32273" cy="32273"/>
           </a:xfrm>
           <a:prstGeom prst="ellipse">
             <a:avLst/>
@@ -18711,14 +19211,14 @@
       </p:sp>
       <p:sp>
         <p:nvSpPr>
-          <p:cNvPr id="37" name="mini real 5 1"/>
-          <p:cNvSpPr/>
-          <p:nvPr/>
-        </p:nvSpPr>
-        <p:spPr>
-          <a:xfrm>
-            <a:off x="2697857" y="2546604"/>
-            <a:ext cx="60512" cy="60512"/>
+          <p:cNvPr id="57" name="mini real 5 2"/>
+          <p:cNvSpPr/>
+          <p:nvPr/>
+        </p:nvSpPr>
+        <p:spPr>
+          <a:xfrm>
+            <a:off x="4884133" y="2546604"/>
+            <a:ext cx="32273" cy="32273"/>
           </a:xfrm>
           <a:prstGeom prst="ellipse">
             <a:avLst/>
@@ -18736,14 +19236,14 @@
       </p:sp>
       <p:sp>
         <p:nvSpPr>
-          <p:cNvPr id="38" name="mini real 5 2"/>
-          <p:cNvSpPr/>
-          <p:nvPr/>
-        </p:nvSpPr>
-        <p:spPr>
-          <a:xfrm>
-            <a:off x="2812157" y="2546604"/>
-            <a:ext cx="60512" cy="60512"/>
+          <p:cNvPr id="58" name="mini real 5 3"/>
+          <p:cNvSpPr/>
+          <p:nvPr/>
+        </p:nvSpPr>
+        <p:spPr>
+          <a:xfrm>
+            <a:off x="4945093" y="2546604"/>
+            <a:ext cx="32273" cy="32273"/>
           </a:xfrm>
           <a:prstGeom prst="ellipse">
             <a:avLst/>
@@ -18761,18 +19261,118 @@
       </p:sp>
       <p:sp>
         <p:nvSpPr>
-          <p:cNvPr id="39" name="real cluster ring"/>
-          <p:cNvSpPr/>
-          <p:nvPr/>
-        </p:nvSpPr>
-        <p:spPr>
-          <a:xfrm>
-            <a:off x="987552" y="2279142"/>
-            <a:ext cx="2263140" cy="839419"/>
+          <p:cNvPr id="59" name="mini real 5 4"/>
+          <p:cNvSpPr/>
+          <p:nvPr/>
+        </p:nvSpPr>
+        <p:spPr>
+          <a:xfrm>
+            <a:off x="4995295" y="2537460"/>
+            <a:ext cx="53788" cy="39445"/>
+          </a:xfrm>
+          <a:prstGeom prst="rect">
+            <a:avLst/>
+          </a:prstGeom>
+          <a:solidFill>
+            <a:srgbClr val="EB6834"/>
+          </a:solidFill>
+          <a:ln w="5080">
+            <a:solidFill>
+              <a:srgbClr val="FFFFFF"/>
+            </a:solidFill>
+            <a:prstDash val="solid"/>
+          </a:ln>
+        </p:spPr>
+      </p:sp>
+      <p:sp>
+        <p:nvSpPr>
+          <p:cNvPr id="60" name="mini real 5 5"/>
+          <p:cNvSpPr/>
+          <p:nvPr/>
+        </p:nvSpPr>
+        <p:spPr>
+          <a:xfrm>
+            <a:off x="5067013" y="2546604"/>
+            <a:ext cx="32273" cy="32273"/>
           </a:xfrm>
           <a:prstGeom prst="ellipse">
             <a:avLst/>
           </a:prstGeom>
+          <a:solidFill>
+            <a:srgbClr val="EB6834"/>
+          </a:solidFill>
+          <a:ln w="5080">
+            <a:solidFill>
+              <a:srgbClr val="FFFFFF"/>
+            </a:solidFill>
+            <a:prstDash val="solid"/>
+          </a:ln>
+        </p:spPr>
+      </p:sp>
+      <p:sp>
+        <p:nvSpPr>
+          <p:cNvPr id="61" name="mini real 5 6"/>
+          <p:cNvSpPr/>
+          <p:nvPr/>
+        </p:nvSpPr>
+        <p:spPr>
+          <a:xfrm>
+            <a:off x="5127973" y="2546604"/>
+            <a:ext cx="32273" cy="32273"/>
+          </a:xfrm>
+          <a:prstGeom prst="ellipse">
+            <a:avLst/>
+          </a:prstGeom>
+          <a:solidFill>
+            <a:srgbClr val="EB6834"/>
+          </a:solidFill>
+          <a:ln w="5080">
+            <a:solidFill>
+              <a:srgbClr val="FFFFFF"/>
+            </a:solidFill>
+            <a:prstDash val="solid"/>
+          </a:ln>
+        </p:spPr>
+      </p:sp>
+      <p:sp>
+        <p:nvSpPr>
+          <p:cNvPr id="62" name="mini real 5 7"/>
+          <p:cNvSpPr/>
+          <p:nvPr/>
+        </p:nvSpPr>
+        <p:spPr>
+          <a:xfrm>
+            <a:off x="5188933" y="2546604"/>
+            <a:ext cx="32273" cy="32273"/>
+          </a:xfrm>
+          <a:prstGeom prst="ellipse">
+            <a:avLst/>
+          </a:prstGeom>
+          <a:solidFill>
+            <a:srgbClr val="EB6834"/>
+          </a:solidFill>
+          <a:ln w="5080">
+            <a:solidFill>
+              <a:srgbClr val="FFFFFF"/>
+            </a:solidFill>
+            <a:prstDash val="solid"/>
+          </a:ln>
+        </p:spPr>
+      </p:sp>
+      <p:sp>
+        <p:nvSpPr>
+          <p:cNvPr id="63" name="real cluster ring"/>
+          <p:cNvSpPr/>
+          <p:nvPr/>
+        </p:nvSpPr>
+        <p:spPr>
+          <a:xfrm>
+            <a:off x="2997403" y="1970532"/>
+            <a:ext cx="2444191" cy="962863"/>
+          </a:xfrm>
+          <a:prstGeom prst="ellipse">
+            <a:avLst/>
+          </a:prstGeom>
           <a:ln w="12700">
             <a:solidFill>
               <a:srgbClr val="EB6834"/>
@@ -18783,14 +19383,14 @@
       </p:sp>
       <p:sp>
         <p:nvSpPr>
-          <p:cNvPr id="40" name="real note"/>
+          <p:cNvPr id="64" name="real note"/>
           <p:cNvSpPr txBox="1"/>
           <p:nvPr/>
         </p:nvSpPr>
         <p:spPr>
           <a:xfrm>
-            <a:off x="3359506" y="2217420"/>
-            <a:ext cx="2172614" cy="457200"/>
+            <a:off x="1024128" y="1995221"/>
+            <a:ext cx="1810512" cy="925830"/>
           </a:xfrm>
           <a:prstGeom prst="rect">
             <a:avLst/>
@@ -18801,6 +19401,20 @@
         <p:txBody>
           <a:bodyPr wrap="square" lIns="0" tIns="0" rIns="0" bIns="0" rtlCol="0" anchor="ctr"/>
           <a:lstStyle/>
+          <a:p>
+            <a:pPr indent="0" marL="0">
+              <a:buNone/>
+            </a:pPr>
+            <a:r>
+              <a:rPr lang="en-US" sz="1100" dirty="0">
+                <a:solidFill>
+                  <a:srgbClr val="52514E"/>
+                </a:solidFill>
+              </a:rPr>
+              <a:t>ducts and many pipes, no trays, nothing as simple as one pipe</a:t>
+            </a:r>
+            <a:endParaRPr lang="en-US" sz="1100" dirty="0"/>
+          </a:p>
           <a:p>
             <a:pPr indent="0" marL="0">
               <a:buNone/>
@@ -18819,7 +19433,7 @@
       </p:sp>
       <p:sp>
         <p:nvSpPr>
-          <p:cNvPr id="41" name="space synthetic"/>
+          <p:cNvPr id="65" name="space synthetic"/>
           <p:cNvSpPr/>
           <p:nvPr/>
         </p:nvSpPr>
@@ -18841,7 +19455,7 @@
       </p:sp>
       <p:sp>
         <p:nvSpPr>
-          <p:cNvPr id="42" name="space head synthetic"/>
+          <p:cNvPr id="66" name="space head synthetic"/>
           <p:cNvSpPr txBox="1"/>
           <p:nvPr/>
         </p:nvSpPr>
@@ -18888,7 +19502,7 @@
       </p:sp>
       <p:sp>
         <p:nvSpPr>
-          <p:cNvPr id="43" name="x axis synthetic"/>
+          <p:cNvPr id="67" name="x axis synthetic"/>
           <p:cNvSpPr/>
           <p:nvPr/>
         </p:nvSpPr>
@@ -18912,7 +19526,7 @@
       </p:sp>
       <p:sp>
         <p:nvSpPr>
-          <p:cNvPr id="44" name="y axis synthetic"/>
+          <p:cNvPr id="68" name="y axis synthetic"/>
           <p:cNvSpPr/>
           <p:nvPr/>
         </p:nvSpPr>
@@ -18936,7 +19550,7 @@
       </p:sp>
       <p:sp>
         <p:nvSpPr>
-          <p:cNvPr id="45" name="x label synthetic"/>
+          <p:cNvPr id="69" name="x label synthetic"/>
           <p:cNvSpPr txBox="1"/>
           <p:nvPr/>
         </p:nvSpPr>
@@ -18972,7 +19586,7 @@
       </p:sp>
       <p:sp>
         <p:nvSpPr>
-          <p:cNvPr id="46" name="y label synthetic"/>
+          <p:cNvPr id="70" name="y label synthetic"/>
           <p:cNvSpPr txBox="1"/>
           <p:nvPr/>
         </p:nvSpPr>
@@ -19008,7 +19622,7 @@
       </p:sp>
       <p:sp>
         <p:nvSpPr>
-          <p:cNvPr id="47" name="mini card syn 10"/>
+          <p:cNvPr id="71" name="mini card syn 10"/>
           <p:cNvSpPr/>
           <p:nvPr/>
         </p:nvSpPr>
@@ -19033,7 +19647,7 @@
       </p:sp>
       <p:sp>
         <p:nvSpPr>
-          <p:cNvPr id="48" name="mini slab syn 10"/>
+          <p:cNvPr id="72" name="mini slab syn 10"/>
           <p:cNvSpPr/>
           <p:nvPr/>
         </p:nvSpPr>
@@ -19053,7 +19667,7 @@
       </p:sp>
       <p:sp>
         <p:nvSpPr>
-          <p:cNvPr id="49" name="mini syn 10 0"/>
+          <p:cNvPr id="73" name="mini syn 10 0"/>
           <p:cNvSpPr/>
           <p:nvPr/>
         </p:nvSpPr>
@@ -19078,7 +19692,7 @@
       </p:sp>
       <p:sp>
         <p:nvSpPr>
-          <p:cNvPr id="50" name="mini card syn 11"/>
+          <p:cNvPr id="74" name="mini card syn 11"/>
           <p:cNvSpPr/>
           <p:nvPr/>
         </p:nvSpPr>
@@ -19103,7 +19717,7 @@
       </p:sp>
       <p:sp>
         <p:nvSpPr>
-          <p:cNvPr id="51" name="mini slab syn 11"/>
+          <p:cNvPr id="75" name="mini slab syn 11"/>
           <p:cNvSpPr/>
           <p:nvPr/>
         </p:nvSpPr>
@@ -19123,7 +19737,7 @@
       </p:sp>
       <p:sp>
         <p:nvSpPr>
-          <p:cNvPr id="52" name="mini syn 11 0"/>
+          <p:cNvPr id="76" name="mini syn 11 0"/>
           <p:cNvSpPr/>
           <p:nvPr/>
         </p:nvSpPr>
@@ -19148,7 +19762,7 @@
       </p:sp>
       <p:sp>
         <p:nvSpPr>
-          <p:cNvPr id="53" name="mini card syn 12"/>
+          <p:cNvPr id="77" name="mini card syn 12"/>
           <p:cNvSpPr/>
           <p:nvPr/>
         </p:nvSpPr>
@@ -19173,7 +19787,7 @@
       </p:sp>
       <p:sp>
         <p:nvSpPr>
-          <p:cNvPr id="54" name="mini wall syn 12"/>
+          <p:cNvPr id="78" name="mini wall syn 12"/>
           <p:cNvSpPr/>
           <p:nvPr/>
         </p:nvSpPr>
@@ -19193,7 +19807,7 @@
       </p:sp>
       <p:sp>
         <p:nvSpPr>
-          <p:cNvPr id="55" name="mini syn 12 0"/>
+          <p:cNvPr id="79" name="mini syn 12 0"/>
           <p:cNvSpPr/>
           <p:nvPr/>
         </p:nvSpPr>
@@ -19218,7 +19832,7 @@
       </p:sp>
       <p:sp>
         <p:nvSpPr>
-          <p:cNvPr id="56" name="mini card syn 20"/>
+          <p:cNvPr id="80" name="mini card syn 20"/>
           <p:cNvSpPr/>
           <p:nvPr/>
         </p:nvSpPr>
@@ -19243,7 +19857,7 @@
       </p:sp>
       <p:sp>
         <p:nvSpPr>
-          <p:cNvPr id="57" name="mini slab syn 20"/>
+          <p:cNvPr id="81" name="mini slab syn 20"/>
           <p:cNvSpPr/>
           <p:nvPr/>
         </p:nvSpPr>
@@ -19263,7 +19877,7 @@
       </p:sp>
       <p:sp>
         <p:nvSpPr>
-          <p:cNvPr id="58" name="mini syn 20 0"/>
+          <p:cNvPr id="82" name="mini syn 20 0"/>
           <p:cNvSpPr/>
           <p:nvPr/>
         </p:nvSpPr>
@@ -19288,7 +19902,7 @@
       </p:sp>
       <p:sp>
         <p:nvSpPr>
-          <p:cNvPr id="59" name="mini syn 20 1"/>
+          <p:cNvPr id="83" name="mini syn 20 1"/>
           <p:cNvSpPr/>
           <p:nvPr/>
         </p:nvSpPr>
@@ -19313,7 +19927,7 @@
       </p:sp>
       <p:sp>
         <p:nvSpPr>
-          <p:cNvPr id="60" name="mini card syn 21"/>
+          <p:cNvPr id="84" name="mini card syn 21"/>
           <p:cNvSpPr/>
           <p:nvPr/>
         </p:nvSpPr>
@@ -19338,7 +19952,7 @@
       </p:sp>
       <p:sp>
         <p:nvSpPr>
-          <p:cNvPr id="61" name="mini slab syn 21"/>
+          <p:cNvPr id="85" name="mini slab syn 21"/>
           <p:cNvSpPr/>
           <p:nvPr/>
         </p:nvSpPr>
@@ -19358,7 +19972,7 @@
       </p:sp>
       <p:sp>
         <p:nvSpPr>
-          <p:cNvPr id="62" name="mini syn 21 0"/>
+          <p:cNvPr id="86" name="mini syn 21 0"/>
           <p:cNvSpPr/>
           <p:nvPr/>
         </p:nvSpPr>
@@ -19383,7 +19997,7 @@
       </p:sp>
       <p:sp>
         <p:nvSpPr>
-          <p:cNvPr id="63" name="mini syn 21 1"/>
+          <p:cNvPr id="87" name="mini syn 21 1"/>
           <p:cNvSpPr/>
           <p:nvPr/>
         </p:nvSpPr>
@@ -19408,7 +20022,7 @@
       </p:sp>
       <p:sp>
         <p:nvSpPr>
-          <p:cNvPr id="64" name="mini card syn 22"/>
+          <p:cNvPr id="88" name="mini card syn 22"/>
           <p:cNvSpPr/>
           <p:nvPr/>
         </p:nvSpPr>
@@ -19433,7 +20047,7 @@
       </p:sp>
       <p:sp>
         <p:nvSpPr>
-          <p:cNvPr id="65" name="mini wall syn 22"/>
+          <p:cNvPr id="89" name="mini wall syn 22"/>
           <p:cNvSpPr/>
           <p:nvPr/>
         </p:nvSpPr>
@@ -19453,7 +20067,7 @@
       </p:sp>
       <p:sp>
         <p:nvSpPr>
-          <p:cNvPr id="66" name="mini syn 22 0"/>
+          <p:cNvPr id="90" name="mini syn 22 0"/>
           <p:cNvSpPr/>
           <p:nvPr/>
         </p:nvSpPr>
@@ -19478,7 +20092,7 @@
       </p:sp>
       <p:sp>
         <p:nvSpPr>
-          <p:cNvPr id="67" name="mini syn 22 1"/>
+          <p:cNvPr id="91" name="mini syn 22 1"/>
           <p:cNvSpPr/>
           <p:nvPr/>
         </p:nvSpPr>
@@ -19503,7 +20117,7 @@
       </p:sp>
       <p:sp>
         <p:nvSpPr>
-          <p:cNvPr id="68" name="mini card syn 30"/>
+          <p:cNvPr id="92" name="mini card syn 30"/>
           <p:cNvSpPr/>
           <p:nvPr/>
         </p:nvSpPr>
@@ -19528,7 +20142,7 @@
       </p:sp>
       <p:sp>
         <p:nvSpPr>
-          <p:cNvPr id="69" name="mini slab syn 30"/>
+          <p:cNvPr id="93" name="mini slab syn 30"/>
           <p:cNvSpPr/>
           <p:nvPr/>
         </p:nvSpPr>
@@ -19548,7 +20162,7 @@
       </p:sp>
       <p:sp>
         <p:nvSpPr>
-          <p:cNvPr id="70" name="mini syn 30 0"/>
+          <p:cNvPr id="94" name="mini syn 30 0"/>
           <p:cNvSpPr/>
           <p:nvPr/>
         </p:nvSpPr>
@@ -19573,7 +20187,7 @@
       </p:sp>
       <p:sp>
         <p:nvSpPr>
-          <p:cNvPr id="71" name="mini syn 30 1"/>
+          <p:cNvPr id="95" name="mini syn 30 1"/>
           <p:cNvSpPr/>
           <p:nvPr/>
         </p:nvSpPr>
@@ -19598,7 +20212,7 @@
       </p:sp>
       <p:sp>
         <p:nvSpPr>
-          <p:cNvPr id="72" name="mini syn 30 2"/>
+          <p:cNvPr id="96" name="mini syn 30 2"/>
           <p:cNvSpPr/>
           <p:nvPr/>
         </p:nvSpPr>
@@ -19623,7 +20237,7 @@
       </p:sp>
       <p:sp>
         <p:nvSpPr>
-          <p:cNvPr id="73" name="mini card syn 31"/>
+          <p:cNvPr id="97" name="mini card syn 31"/>
           <p:cNvSpPr/>
           <p:nvPr/>
         </p:nvSpPr>
@@ -19648,7 +20262,7 @@
       </p:sp>
       <p:sp>
         <p:nvSpPr>
-          <p:cNvPr id="74" name="mini slab syn 31"/>
+          <p:cNvPr id="98" name="mini slab syn 31"/>
           <p:cNvSpPr/>
           <p:nvPr/>
         </p:nvSpPr>
@@ -19668,7 +20282,7 @@
       </p:sp>
       <p:sp>
         <p:nvSpPr>
-          <p:cNvPr id="75" name="mini syn 31 0"/>
+          <p:cNvPr id="99" name="mini syn 31 0"/>
           <p:cNvSpPr/>
           <p:nvPr/>
         </p:nvSpPr>
@@ -19693,7 +20307,7 @@
       </p:sp>
       <p:sp>
         <p:nvSpPr>
-          <p:cNvPr id="76" name="mini syn 31 1"/>
+          <p:cNvPr id="100" name="mini syn 31 1"/>
           <p:cNvSpPr/>
           <p:nvPr/>
         </p:nvSpPr>
@@ -19718,7 +20332,7 @@
       </p:sp>
       <p:sp>
         <p:nvSpPr>
-          <p:cNvPr id="77" name="mini syn 31 2"/>
+          <p:cNvPr id="101" name="mini syn 31 2"/>
           <p:cNvSpPr/>
           <p:nvPr/>
         </p:nvSpPr>
@@ -19743,7 +20357,7 @@
       </p:sp>
       <p:sp>
         <p:nvSpPr>
-          <p:cNvPr id="78" name="mini card syn 32"/>
+          <p:cNvPr id="102" name="mini card syn 32"/>
           <p:cNvSpPr/>
           <p:nvPr/>
         </p:nvSpPr>
@@ -19768,7 +20382,7 @@
       </p:sp>
       <p:sp>
         <p:nvSpPr>
-          <p:cNvPr id="79" name="mini wall syn 32"/>
+          <p:cNvPr id="103" name="mini wall syn 32"/>
           <p:cNvSpPr/>
           <p:nvPr/>
         </p:nvSpPr>
@@ -19788,7 +20402,7 @@
       </p:sp>
       <p:sp>
         <p:nvSpPr>
-          <p:cNvPr id="80" name="mini syn 32 0"/>
+          <p:cNvPr id="104" name="mini syn 32 0"/>
           <p:cNvSpPr/>
           <p:nvPr/>
         </p:nvSpPr>
@@ -19813,7 +20427,7 @@
       </p:sp>
       <p:sp>
         <p:nvSpPr>
-          <p:cNvPr id="81" name="mini syn 32 1"/>
+          <p:cNvPr id="105" name="mini syn 32 1"/>
           <p:cNvSpPr/>
           <p:nvPr/>
         </p:nvSpPr>
@@ -19838,7 +20452,7 @@
       </p:sp>
       <p:sp>
         <p:nvSpPr>
-          <p:cNvPr id="82" name="mini syn 32 2"/>
+          <p:cNvPr id="106" name="mini syn 32 2"/>
           <p:cNvSpPr/>
           <p:nvPr/>
         </p:nvSpPr>
@@ -19863,7 +20477,7 @@
       </p:sp>
       <p:sp>
         <p:nvSpPr>
-          <p:cNvPr id="83" name="mini card syn 40"/>
+          <p:cNvPr id="107" name="mini card syn 40"/>
           <p:cNvSpPr/>
           <p:nvPr/>
         </p:nvSpPr>
@@ -19888,7 +20502,7 @@
       </p:sp>
       <p:sp>
         <p:nvSpPr>
-          <p:cNvPr id="84" name="mini slab syn 40"/>
+          <p:cNvPr id="108" name="mini slab syn 40"/>
           <p:cNvSpPr/>
           <p:nvPr/>
         </p:nvSpPr>
@@ -19908,7 +20522,7 @@
       </p:sp>
       <p:sp>
         <p:nvSpPr>
-          <p:cNvPr id="85" name="mini syn 40 0"/>
+          <p:cNvPr id="109" name="mini syn 40 0"/>
           <p:cNvSpPr/>
           <p:nvPr/>
         </p:nvSpPr>
@@ -19933,7 +20547,7 @@
       </p:sp>
       <p:sp>
         <p:nvSpPr>
-          <p:cNvPr id="86" name="mini syn 40 1"/>
+          <p:cNvPr id="110" name="mini syn 40 1"/>
           <p:cNvSpPr/>
           <p:nvPr/>
         </p:nvSpPr>
@@ -19958,7 +20572,7 @@
       </p:sp>
       <p:sp>
         <p:nvSpPr>
-          <p:cNvPr id="87" name="mini syn 40 2"/>
+          <p:cNvPr id="111" name="mini syn 40 2"/>
           <p:cNvSpPr/>
           <p:nvPr/>
         </p:nvSpPr>
@@ -19983,7 +20597,7 @@
       </p:sp>
       <p:sp>
         <p:nvSpPr>
-          <p:cNvPr id="88" name="mini syn 40 3"/>
+          <p:cNvPr id="112" name="mini syn 40 3"/>
           <p:cNvSpPr/>
           <p:nvPr/>
         </p:nvSpPr>
@@ -20008,7 +20622,7 @@
       </p:sp>
       <p:sp>
         <p:nvSpPr>
-          <p:cNvPr id="89" name="mini card syn 41"/>
+          <p:cNvPr id="113" name="mini card syn 41"/>
           <p:cNvSpPr/>
           <p:nvPr/>
         </p:nvSpPr>
@@ -20033,7 +20647,7 @@
       </p:sp>
       <p:sp>
         <p:nvSpPr>
-          <p:cNvPr id="90" name="mini slab syn 41"/>
+          <p:cNvPr id="114" name="mini slab syn 41"/>
           <p:cNvSpPr/>
           <p:nvPr/>
         </p:nvSpPr>
@@ -20053,7 +20667,7 @@
       </p:sp>
       <p:sp>
         <p:nvSpPr>
-          <p:cNvPr id="91" name="mini syn 41 0"/>
+          <p:cNvPr id="115" name="mini syn 41 0"/>
           <p:cNvSpPr/>
           <p:nvPr/>
         </p:nvSpPr>
@@ -20078,7 +20692,7 @@
       </p:sp>
       <p:sp>
         <p:nvSpPr>
-          <p:cNvPr id="92" name="mini syn 41 1"/>
+          <p:cNvPr id="116" name="mini syn 41 1"/>
           <p:cNvSpPr/>
           <p:nvPr/>
         </p:nvSpPr>
@@ -20103,7 +20717,7 @@
       </p:sp>
       <p:sp>
         <p:nvSpPr>
-          <p:cNvPr id="93" name="mini syn 41 2"/>
+          <p:cNvPr id="117" name="mini syn 41 2"/>
           <p:cNvSpPr/>
           <p:nvPr/>
         </p:nvSpPr>
@@ -20128,7 +20742,7 @@
       </p:sp>
       <p:sp>
         <p:nvSpPr>
-          <p:cNvPr id="94" name="mini syn 41 3"/>
+          <p:cNvPr id="118" name="mini syn 41 3"/>
           <p:cNvSpPr/>
           <p:nvPr/>
         </p:nvSpPr>
@@ -20153,7 +20767,7 @@
       </p:sp>
       <p:sp>
         <p:nvSpPr>
-          <p:cNvPr id="95" name="mini card syn 42"/>
+          <p:cNvPr id="119" name="mini card syn 42"/>
           <p:cNvSpPr/>
           <p:nvPr/>
         </p:nvSpPr>
@@ -20178,7 +20792,7 @@
       </p:sp>
       <p:sp>
         <p:nvSpPr>
-          <p:cNvPr id="96" name="mini wall syn 42"/>
+          <p:cNvPr id="120" name="mini wall syn 42"/>
           <p:cNvSpPr/>
           <p:nvPr/>
         </p:nvSpPr>
@@ -20198,7 +20812,7 @@
       </p:sp>
       <p:sp>
         <p:nvSpPr>
-          <p:cNvPr id="97" name="mini syn 42 0"/>
+          <p:cNvPr id="121" name="mini syn 42 0"/>
           <p:cNvSpPr/>
           <p:nvPr/>
         </p:nvSpPr>
@@ -20223,7 +20837,7 @@
       </p:sp>
       <p:sp>
         <p:nvSpPr>
-          <p:cNvPr id="98" name="mini syn 42 1"/>
+          <p:cNvPr id="122" name="mini syn 42 1"/>
           <p:cNvSpPr/>
           <p:nvPr/>
         </p:nvSpPr>
@@ -20248,7 +20862,7 @@
       </p:sp>
       <p:sp>
         <p:nvSpPr>
-          <p:cNvPr id="99" name="mini syn 42 2"/>
+          <p:cNvPr id="123" name="mini syn 42 2"/>
           <p:cNvSpPr/>
           <p:nvPr/>
         </p:nvSpPr>
@@ -20273,7 +20887,7 @@
       </p:sp>
       <p:sp>
         <p:nvSpPr>
-          <p:cNvPr id="100" name="mini syn 42 3"/>
+          <p:cNvPr id="124" name="mini syn 42 3"/>
           <p:cNvSpPr/>
           <p:nvPr/>
         </p:nvSpPr>
@@ -20298,7 +20912,7 @@
       </p:sp>
       <p:sp>
         <p:nvSpPr>
-          <p:cNvPr id="101" name="mini card syn 50"/>
+          <p:cNvPr id="125" name="mini card syn 50"/>
           <p:cNvSpPr/>
           <p:nvPr/>
         </p:nvSpPr>
@@ -20323,7 +20937,7 @@
       </p:sp>
       <p:sp>
         <p:nvSpPr>
-          <p:cNvPr id="102" name="mini slab syn 50"/>
+          <p:cNvPr id="126" name="mini slab syn 50"/>
           <p:cNvSpPr/>
           <p:nvPr/>
         </p:nvSpPr>
@@ -20343,7 +20957,7 @@
       </p:sp>
       <p:sp>
         <p:nvSpPr>
-          <p:cNvPr id="103" name="mini syn 50 0"/>
+          <p:cNvPr id="127" name="mini syn 50 0"/>
           <p:cNvSpPr/>
           <p:nvPr/>
         </p:nvSpPr>
@@ -20368,7 +20982,7 @@
       </p:sp>
       <p:sp>
         <p:nvSpPr>
-          <p:cNvPr id="104" name="mini syn 50 1"/>
+          <p:cNvPr id="128" name="mini syn 50 1"/>
           <p:cNvSpPr/>
           <p:nvPr/>
         </p:nvSpPr>
@@ -20393,7 +21007,7 @@
       </p:sp>
       <p:sp>
         <p:nvSpPr>
-          <p:cNvPr id="105" name="mini syn 50 2"/>
+          <p:cNvPr id="129" name="mini syn 50 2"/>
           <p:cNvSpPr/>
           <p:nvPr/>
         </p:nvSpPr>
@@ -20418,7 +21032,7 @@
       </p:sp>
       <p:sp>
         <p:nvSpPr>
-          <p:cNvPr id="106" name="mini syn 50 3"/>
+          <p:cNvPr id="130" name="mini syn 50 3"/>
           <p:cNvSpPr/>
           <p:nvPr/>
         </p:nvSpPr>
@@ -20443,7 +21057,7 @@
       </p:sp>
       <p:sp>
         <p:nvSpPr>
-          <p:cNvPr id="107" name="mini syn 50 4"/>
+          <p:cNvPr id="131" name="mini syn 50 4"/>
           <p:cNvSpPr/>
           <p:nvPr/>
         </p:nvSpPr>
@@ -20468,7 +21082,7 @@
       </p:sp>
       <p:sp>
         <p:nvSpPr>
-          <p:cNvPr id="108" name="mini card syn 51"/>
+          <p:cNvPr id="132" name="mini card syn 51"/>
           <p:cNvSpPr/>
           <p:nvPr/>
         </p:nvSpPr>
@@ -20493,7 +21107,7 @@
       </p:sp>
       <p:sp>
         <p:nvSpPr>
-          <p:cNvPr id="109" name="mini slab syn 51"/>
+          <p:cNvPr id="133" name="mini slab syn 51"/>
           <p:cNvSpPr/>
           <p:nvPr/>
         </p:nvSpPr>
@@ -20513,7 +21127,7 @@
       </p:sp>
       <p:sp>
         <p:nvSpPr>
-          <p:cNvPr id="110" name="mini syn 51 0"/>
+          <p:cNvPr id="134" name="mini syn 51 0"/>
           <p:cNvSpPr/>
           <p:nvPr/>
         </p:nvSpPr>
@@ -20538,7 +21152,7 @@
       </p:sp>
       <p:sp>
         <p:nvSpPr>
-          <p:cNvPr id="111" name="mini syn 51 1"/>
+          <p:cNvPr id="135" name="mini syn 51 1"/>
           <p:cNvSpPr/>
           <p:nvPr/>
         </p:nvSpPr>
@@ -20563,7 +21177,7 @@
       </p:sp>
       <p:sp>
         <p:nvSpPr>
-          <p:cNvPr id="112" name="mini syn 51 2"/>
+          <p:cNvPr id="136" name="mini syn 51 2"/>
           <p:cNvSpPr/>
           <p:nvPr/>
         </p:nvSpPr>
@@ -20588,7 +21202,7 @@
       </p:sp>
       <p:sp>
         <p:nvSpPr>
-          <p:cNvPr id="113" name="mini syn 51 3"/>
+          <p:cNvPr id="137" name="mini syn 51 3"/>
           <p:cNvSpPr/>
           <p:nvPr/>
         </p:nvSpPr>
@@ -20613,7 +21227,7 @@
       </p:sp>
       <p:sp>
         <p:nvSpPr>
-          <p:cNvPr id="114" name="mini syn 51 4"/>
+          <p:cNvPr id="138" name="mini syn 51 4"/>
           <p:cNvSpPr/>
           <p:nvPr/>
         </p:nvSpPr>
@@ -20638,7 +21252,7 @@
       </p:sp>
       <p:sp>
         <p:nvSpPr>
-          <p:cNvPr id="115" name="mini card syn 52"/>
+          <p:cNvPr id="139" name="mini card syn 52"/>
           <p:cNvSpPr/>
           <p:nvPr/>
         </p:nvSpPr>
@@ -20663,7 +21277,7 @@
       </p:sp>
       <p:sp>
         <p:nvSpPr>
-          <p:cNvPr id="116" name="mini wall syn 52"/>
+          <p:cNvPr id="140" name="mini wall syn 52"/>
           <p:cNvSpPr/>
           <p:nvPr/>
         </p:nvSpPr>
@@ -20683,7 +21297,7 @@
       </p:sp>
       <p:sp>
         <p:nvSpPr>
-          <p:cNvPr id="117" name="mini syn 52 0"/>
+          <p:cNvPr id="141" name="mini syn 52 0"/>
           <p:cNvSpPr/>
           <p:nvPr/>
         </p:nvSpPr>
@@ -20708,7 +21322,7 @@
       </p:sp>
       <p:sp>
         <p:nvSpPr>
-          <p:cNvPr id="118" name="mini syn 52 1"/>
+          <p:cNvPr id="142" name="mini syn 52 1"/>
           <p:cNvSpPr/>
           <p:nvPr/>
         </p:nvSpPr>
@@ -20733,7 +21347,7 @@
       </p:sp>
       <p:sp>
         <p:nvSpPr>
-          <p:cNvPr id="119" name="mini syn 52 2"/>
+          <p:cNvPr id="143" name="mini syn 52 2"/>
           <p:cNvSpPr/>
           <p:nvPr/>
         </p:nvSpPr>
@@ -20758,7 +21372,7 @@
       </p:sp>
       <p:sp>
         <p:nvSpPr>
-          <p:cNvPr id="120" name="mini syn 52 3"/>
+          <p:cNvPr id="144" name="mini syn 52 3"/>
           <p:cNvSpPr/>
           <p:nvPr/>
         </p:nvSpPr>
@@ -20783,7 +21397,7 @@
       </p:sp>
       <p:sp>
         <p:nvSpPr>
-          <p:cNvPr id="121" name="mini syn 52 4"/>
+          <p:cNvPr id="145" name="mini syn 52 4"/>
           <p:cNvSpPr/>
           <p:nvPr/>
         </p:nvSpPr>
@@ -20808,7 +21422,7 @@
       </p:sp>
       <p:sp>
         <p:nvSpPr>
-          <p:cNvPr id="122" name="mini card syn 60"/>
+          <p:cNvPr id="146" name="mini card syn 60"/>
           <p:cNvSpPr/>
           <p:nvPr/>
         </p:nvSpPr>
@@ -20833,7 +21447,7 @@
       </p:sp>
       <p:sp>
         <p:nvSpPr>
-          <p:cNvPr id="123" name="mini slab syn 60"/>
+          <p:cNvPr id="147" name="mini slab syn 60"/>
           <p:cNvSpPr/>
           <p:nvPr/>
         </p:nvSpPr>
@@ -20853,7 +21467,7 @@
       </p:sp>
       <p:sp>
         <p:nvSpPr>
-          <p:cNvPr id="124" name="mini syn 60 0"/>
+          <p:cNvPr id="148" name="mini syn 60 0"/>
           <p:cNvSpPr/>
           <p:nvPr/>
         </p:nvSpPr>
@@ -20878,7 +21492,7 @@
       </p:sp>
       <p:sp>
         <p:nvSpPr>
-          <p:cNvPr id="125" name="mini syn 60 1"/>
+          <p:cNvPr id="149" name="mini syn 60 1"/>
           <p:cNvSpPr/>
           <p:nvPr/>
         </p:nvSpPr>
@@ -20903,7 +21517,7 @@
       </p:sp>
       <p:sp>
         <p:nvSpPr>
-          <p:cNvPr id="126" name="mini syn 60 2"/>
+          <p:cNvPr id="150" name="mini syn 60 2"/>
           <p:cNvSpPr/>
           <p:nvPr/>
         </p:nvSpPr>
@@ -20928,7 +21542,7 @@
       </p:sp>
       <p:sp>
         <p:nvSpPr>
-          <p:cNvPr id="127" name="mini syn 60 3"/>
+          <p:cNvPr id="151" name="mini syn 60 3"/>
           <p:cNvSpPr/>
           <p:nvPr/>
         </p:nvSpPr>
@@ -20953,7 +21567,7 @@
       </p:sp>
       <p:sp>
         <p:nvSpPr>
-          <p:cNvPr id="128" name="mini syn 60 4"/>
+          <p:cNvPr id="152" name="mini syn 60 4"/>
           <p:cNvSpPr/>
           <p:nvPr/>
         </p:nvSpPr>
@@ -20978,7 +21592,7 @@
       </p:sp>
       <p:sp>
         <p:nvSpPr>
-          <p:cNvPr id="129" name="mini syn 60 5"/>
+          <p:cNvPr id="153" name="mini syn 60 5"/>
           <p:cNvSpPr/>
           <p:nvPr/>
         </p:nvSpPr>
@@ -21003,7 +21617,7 @@
       </p:sp>
       <p:sp>
         <p:nvSpPr>
-          <p:cNvPr id="130" name="mini card syn 61"/>
+          <p:cNvPr id="154" name="mini card syn 61"/>
           <p:cNvSpPr/>
           <p:nvPr/>
         </p:nvSpPr>
@@ -21028,7 +21642,7 @@
       </p:sp>
       <p:sp>
         <p:nvSpPr>
-          <p:cNvPr id="131" name="mini slab syn 61"/>
+          <p:cNvPr id="155" name="mini slab syn 61"/>
           <p:cNvSpPr/>
           <p:nvPr/>
         </p:nvSpPr>
@@ -21048,7 +21662,7 @@
       </p:sp>
       <p:sp>
         <p:nvSpPr>
-          <p:cNvPr id="132" name="mini syn 61 0"/>
+          <p:cNvPr id="156" name="mini syn 61 0"/>
           <p:cNvSpPr/>
           <p:nvPr/>
         </p:nvSpPr>
@@ -21073,7 +21687,7 @@
       </p:sp>
       <p:sp>
         <p:nvSpPr>
-          <p:cNvPr id="133" name="mini syn 61 1"/>
+          <p:cNvPr id="157" name="mini syn 61 1"/>
           <p:cNvSpPr/>
           <p:nvPr/>
         </p:nvSpPr>
@@ -21098,7 +21712,7 @@
       </p:sp>
       <p:sp>
         <p:nvSpPr>
-          <p:cNvPr id="134" name="mini syn 61 2"/>
+          <p:cNvPr id="158" name="mini syn 61 2"/>
           <p:cNvSpPr/>
           <p:nvPr/>
         </p:nvSpPr>
@@ -21123,7 +21737,7 @@
       </p:sp>
       <p:sp>
         <p:nvSpPr>
-          <p:cNvPr id="135" name="mini syn 61 3"/>
+          <p:cNvPr id="159" name="mini syn 61 3"/>
           <p:cNvSpPr/>
           <p:nvPr/>
         </p:nvSpPr>
@@ -21148,7 +21762,7 @@
       </p:sp>
       <p:sp>
         <p:nvSpPr>
-          <p:cNvPr id="136" name="mini syn 61 4"/>
+          <p:cNvPr id="160" name="mini syn 61 4"/>
           <p:cNvSpPr/>
           <p:nvPr/>
         </p:nvSpPr>
@@ -21173,7 +21787,7 @@
       </p:sp>
       <p:sp>
         <p:nvSpPr>
-          <p:cNvPr id="137" name="mini syn 61 5"/>
+          <p:cNvPr id="161" name="mini syn 61 5"/>
           <p:cNvSpPr/>
           <p:nvPr/>
         </p:nvSpPr>
@@ -21198,7 +21812,7 @@
       </p:sp>
       <p:sp>
         <p:nvSpPr>
-          <p:cNvPr id="138" name="mini card syn 62"/>
+          <p:cNvPr id="162" name="mini card syn 62"/>
           <p:cNvSpPr/>
           <p:nvPr/>
         </p:nvSpPr>
@@ -21223,7 +21837,7 @@
       </p:sp>
       <p:sp>
         <p:nvSpPr>
-          <p:cNvPr id="139" name="mini wall syn 62"/>
+          <p:cNvPr id="163" name="mini wall syn 62"/>
           <p:cNvSpPr/>
           <p:nvPr/>
         </p:nvSpPr>
@@ -21243,7 +21857,7 @@
       </p:sp>
       <p:sp>
         <p:nvSpPr>
-          <p:cNvPr id="140" name="mini syn 62 0"/>
+          <p:cNvPr id="164" name="mini syn 62 0"/>
           <p:cNvSpPr/>
           <p:nvPr/>
         </p:nvSpPr>
@@ -21268,7 +21882,7 @@
       </p:sp>
       <p:sp>
         <p:nvSpPr>
-          <p:cNvPr id="141" name="mini syn 62 1"/>
+          <p:cNvPr id="165" name="mini syn 62 1"/>
           <p:cNvSpPr/>
           <p:nvPr/>
         </p:nvSpPr>
@@ -21293,7 +21907,7 @@
       </p:sp>
       <p:sp>
         <p:nvSpPr>
-          <p:cNvPr id="142" name="mini syn 62 2"/>
+          <p:cNvPr id="166" name="mini syn 62 2"/>
           <p:cNvSpPr/>
           <p:nvPr/>
         </p:nvSpPr>
@@ -21318,7 +21932,7 @@
       </p:sp>
       <p:sp>
         <p:nvSpPr>
-          <p:cNvPr id="143" name="mini syn 62 3"/>
+          <p:cNvPr id="167" name="mini syn 62 3"/>
           <p:cNvSpPr/>
           <p:nvPr/>
         </p:nvSpPr>
@@ -21343,7 +21957,7 @@
       </p:sp>
       <p:sp>
         <p:nvSpPr>
-          <p:cNvPr id="144" name="mini syn 62 4"/>
+          <p:cNvPr id="168" name="mini syn 62 4"/>
           <p:cNvSpPr/>
           <p:nvPr/>
         </p:nvSpPr>
@@ -21368,7 +21982,7 @@
       </p:sp>
       <p:sp>
         <p:nvSpPr>
-          <p:cNvPr id="145" name="mini syn 62 5"/>
+          <p:cNvPr id="169" name="mini syn 62 5"/>
           <p:cNvSpPr/>
           <p:nvPr/>
         </p:nvSpPr>
@@ -21393,7 +22007,7 @@
       </p:sp>
       <p:sp>
         <p:nvSpPr>
-          <p:cNvPr id="146" name="mini card syn 70"/>
+          <p:cNvPr id="170" name="mini card syn 70"/>
           <p:cNvSpPr/>
           <p:nvPr/>
         </p:nvSpPr>
@@ -21418,7 +22032,7 @@
       </p:sp>
       <p:sp>
         <p:nvSpPr>
-          <p:cNvPr id="147" name="mini slab syn 70"/>
+          <p:cNvPr id="171" name="mini slab syn 70"/>
           <p:cNvSpPr/>
           <p:nvPr/>
         </p:nvSpPr>
@@ -21438,7 +22052,7 @@
       </p:sp>
       <p:sp>
         <p:nvSpPr>
-          <p:cNvPr id="148" name="mini syn 70 0"/>
+          <p:cNvPr id="172" name="mini syn 70 0"/>
           <p:cNvSpPr/>
           <p:nvPr/>
         </p:nvSpPr>
@@ -21463,7 +22077,7 @@
       </p:sp>
       <p:sp>
         <p:nvSpPr>
-          <p:cNvPr id="149" name="mini syn 70 1"/>
+          <p:cNvPr id="173" name="mini syn 70 1"/>
           <p:cNvSpPr/>
           <p:nvPr/>
         </p:nvSpPr>
@@ -21488,7 +22102,7 @@
       </p:sp>
       <p:sp>
         <p:nvSpPr>
-          <p:cNvPr id="150" name="mini syn 70 2"/>
+          <p:cNvPr id="174" name="mini syn 70 2"/>
           <p:cNvSpPr/>
           <p:nvPr/>
         </p:nvSpPr>
@@ -21513,7 +22127,7 @@
       </p:sp>
       <p:sp>
         <p:nvSpPr>
-          <p:cNvPr id="151" name="mini syn 70 3"/>
+          <p:cNvPr id="175" name="mini syn 70 3"/>
           <p:cNvSpPr/>
           <p:nvPr/>
         </p:nvSpPr>
@@ -21538,7 +22152,7 @@
       </p:sp>
       <p:sp>
         <p:nvSpPr>
-          <p:cNvPr id="152" name="mini syn 70 4"/>
+          <p:cNvPr id="176" name="mini syn 70 4"/>
           <p:cNvSpPr/>
           <p:nvPr/>
         </p:nvSpPr>
@@ -21563,7 +22177,7 @@
       </p:sp>
       <p:sp>
         <p:nvSpPr>
-          <p:cNvPr id="153" name="mini syn 70 5"/>
+          <p:cNvPr id="177" name="mini syn 70 5"/>
           <p:cNvSpPr/>
           <p:nvPr/>
         </p:nvSpPr>
@@ -21588,7 +22202,7 @@
       </p:sp>
       <p:sp>
         <p:nvSpPr>
-          <p:cNvPr id="154" name="mini syn 70 6"/>
+          <p:cNvPr id="178" name="mini syn 70 6"/>
           <p:cNvSpPr/>
           <p:nvPr/>
         </p:nvSpPr>
@@ -21613,7 +22227,7 @@
       </p:sp>
       <p:sp>
         <p:nvSpPr>
-          <p:cNvPr id="155" name="mini card syn 71"/>
+          <p:cNvPr id="179" name="mini card syn 71"/>
           <p:cNvSpPr/>
           <p:nvPr/>
         </p:nvSpPr>
@@ -21638,7 +22252,7 @@
       </p:sp>
       <p:sp>
         <p:nvSpPr>
-          <p:cNvPr id="156" name="mini slab syn 71"/>
+          <p:cNvPr id="180" name="mini slab syn 71"/>
           <p:cNvSpPr/>
           <p:nvPr/>
         </p:nvSpPr>
@@ -21658,7 +22272,7 @@
       </p:sp>
       <p:sp>
         <p:nvSpPr>
-          <p:cNvPr id="157" name="mini syn 71 0"/>
+          <p:cNvPr id="181" name="mini syn 71 0"/>
           <p:cNvSpPr/>
           <p:nvPr/>
         </p:nvSpPr>
@@ -21683,7 +22297,7 @@
       </p:sp>
       <p:sp>
         <p:nvSpPr>
-          <p:cNvPr id="158" name="mini syn 71 1"/>
+          <p:cNvPr id="182" name="mini syn 71 1"/>
           <p:cNvSpPr/>
           <p:nvPr/>
         </p:nvSpPr>
@@ -21708,7 +22322,7 @@
       </p:sp>
       <p:sp>
         <p:nvSpPr>
-          <p:cNvPr id="159" name="mini syn 71 2"/>
+          <p:cNvPr id="183" name="mini syn 71 2"/>
           <p:cNvSpPr/>
           <p:nvPr/>
         </p:nvSpPr>
@@ -21733,7 +22347,7 @@
       </p:sp>
       <p:sp>
         <p:nvSpPr>
-          <p:cNvPr id="160" name="mini syn 71 3"/>
+          <p:cNvPr id="184" name="mini syn 71 3"/>
           <p:cNvSpPr/>
           <p:nvPr/>
         </p:nvSpPr>
@@ -21758,7 +22372,7 @@
       </p:sp>
       <p:sp>
         <p:nvSpPr>
-          <p:cNvPr id="161" name="mini syn 71 4"/>
+          <p:cNvPr id="185" name="mini syn 71 4"/>
           <p:cNvSpPr/>
           <p:nvPr/>
         </p:nvSpPr>
@@ -21783,7 +22397,7 @@
       </p:sp>
       <p:sp>
         <p:nvSpPr>
-          <p:cNvPr id="162" name="mini syn 71 5"/>
+          <p:cNvPr id="186" name="mini syn 71 5"/>
           <p:cNvSpPr/>
           <p:nvPr/>
         </p:nvSpPr>
@@ -21808,7 +22422,7 @@
       </p:sp>
       <p:sp>
         <p:nvSpPr>
-          <p:cNvPr id="163" name="mini syn 71 6"/>
+          <p:cNvPr id="187" name="mini syn 71 6"/>
           <p:cNvSpPr/>
           <p:nvPr/>
         </p:nvSpPr>
@@ -21833,7 +22447,7 @@
       </p:sp>
       <p:sp>
         <p:nvSpPr>
-          <p:cNvPr id="164" name="mini card syn 72"/>
+          <p:cNvPr id="188" name="mini card syn 72"/>
           <p:cNvSpPr/>
           <p:nvPr/>
         </p:nvSpPr>
@@ -21858,7 +22472,7 @@
       </p:sp>
       <p:sp>
         <p:nvSpPr>
-          <p:cNvPr id="165" name="mini wall syn 72"/>
+          <p:cNvPr id="189" name="mini wall syn 72"/>
           <p:cNvSpPr/>
           <p:nvPr/>
         </p:nvSpPr>
@@ -21878,7 +22492,7 @@
       </p:sp>
       <p:sp>
         <p:nvSpPr>
-          <p:cNvPr id="166" name="mini syn 72 0"/>
+          <p:cNvPr id="190" name="mini syn 72 0"/>
           <p:cNvSpPr/>
           <p:nvPr/>
         </p:nvSpPr>
@@ -21903,7 +22517,7 @@
       </p:sp>
       <p:sp>
         <p:nvSpPr>
-          <p:cNvPr id="167" name="mini syn 72 1"/>
+          <p:cNvPr id="191" name="mini syn 72 1"/>
           <p:cNvSpPr/>
           <p:nvPr/>
         </p:nvSpPr>
@@ -21928,7 +22542,7 @@
       </p:sp>
       <p:sp>
         <p:nvSpPr>
-          <p:cNvPr id="168" name="mini syn 72 2"/>
+          <p:cNvPr id="192" name="mini syn 72 2"/>
           <p:cNvSpPr/>
           <p:nvPr/>
         </p:nvSpPr>
@@ -21953,7 +22567,7 @@
       </p:sp>
       <p:sp>
         <p:nvSpPr>
-          <p:cNvPr id="169" name="mini syn 72 3"/>
+          <p:cNvPr id="193" name="mini syn 72 3"/>
           <p:cNvSpPr/>
           <p:nvPr/>
         </p:nvSpPr>
@@ -21978,7 +22592,7 @@
       </p:sp>
       <p:sp>
         <p:nvSpPr>
-          <p:cNvPr id="170" name="mini syn 72 4"/>
+          <p:cNvPr id="194" name="mini syn 72 4"/>
           <p:cNvSpPr/>
           <p:nvPr/>
         </p:nvSpPr>
@@ -22003,7 +22617,7 @@
       </p:sp>
       <p:sp>
         <p:nvSpPr>
-          <p:cNvPr id="171" name="mini syn 72 5"/>
+          <p:cNvPr id="195" name="mini syn 72 5"/>
           <p:cNvSpPr/>
           <p:nvPr/>
         </p:nvSpPr>
@@ -22028,7 +22642,7 @@
       </p:sp>
       <p:sp>
         <p:nvSpPr>
-          <p:cNvPr id="172" name="mini syn 72 6"/>
+          <p:cNvPr id="196" name="mini syn 72 6"/>
           <p:cNvSpPr/>
           <p:nvPr/>
         </p:nvSpPr>
@@ -22053,7 +22667,7 @@
       </p:sp>
       <p:sp>
         <p:nvSpPr>
-          <p:cNvPr id="173" name="mini card syn 80"/>
+          <p:cNvPr id="197" name="mini card syn 80"/>
           <p:cNvSpPr/>
           <p:nvPr/>
         </p:nvSpPr>
@@ -22078,7 +22692,7 @@
       </p:sp>
       <p:sp>
         <p:nvSpPr>
-          <p:cNvPr id="174" name="mini slab syn 80"/>
+          <p:cNvPr id="198" name="mini slab syn 80"/>
           <p:cNvSpPr/>
           <p:nvPr/>
         </p:nvSpPr>
@@ -22098,7 +22712,7 @@
       </p:sp>
       <p:sp>
         <p:nvSpPr>
-          <p:cNvPr id="175" name="mini syn 80 0"/>
+          <p:cNvPr id="199" name="mini syn 80 0"/>
           <p:cNvSpPr/>
           <p:nvPr/>
         </p:nvSpPr>
@@ -22123,7 +22737,7 @@
       </p:sp>
       <p:sp>
         <p:nvSpPr>
-          <p:cNvPr id="176" name="mini syn 80 1"/>
+          <p:cNvPr id="200" name="mini syn 80 1"/>
           <p:cNvSpPr/>
           <p:nvPr/>
         </p:nvSpPr>
@@ -22148,7 +22762,7 @@
       </p:sp>
       <p:sp>
         <p:nvSpPr>
-          <p:cNvPr id="177" name="mini syn 80 2"/>
+          <p:cNvPr id="201" name="mini syn 80 2"/>
           <p:cNvSpPr/>
           <p:nvPr/>
         </p:nvSpPr>
@@ -22173,7 +22787,7 @@
       </p:sp>
       <p:sp>
         <p:nvSpPr>
-          <p:cNvPr id="178" name="mini syn 80 3"/>
+          <p:cNvPr id="202" name="mini syn 80 3"/>
           <p:cNvSpPr/>
           <p:nvPr/>
         </p:nvSpPr>
@@ -22198,7 +22812,7 @@
       </p:sp>
       <p:sp>
         <p:nvSpPr>
-          <p:cNvPr id="179" name="mini syn 80 4"/>
+          <p:cNvPr id="203" name="mini syn 80 4"/>
           <p:cNvSpPr/>
           <p:nvPr/>
         </p:nvSpPr>
@@ -22223,7 +22837,7 @@
       </p:sp>
       <p:sp>
         <p:nvSpPr>
-          <p:cNvPr id="180" name="mini syn 80 5"/>
+          <p:cNvPr id="204" name="mini syn 80 5"/>
           <p:cNvSpPr/>
           <p:nvPr/>
         </p:nvSpPr>
@@ -22248,7 +22862,7 @@
       </p:sp>
       <p:sp>
         <p:nvSpPr>
-          <p:cNvPr id="181" name="mini syn 80 6"/>
+          <p:cNvPr id="205" name="mini syn 80 6"/>
           <p:cNvSpPr/>
           <p:nvPr/>
         </p:nvSpPr>
@@ -22273,7 +22887,7 @@
       </p:sp>
       <p:sp>
         <p:nvSpPr>
-          <p:cNvPr id="182" name="mini syn 80 7"/>
+          <p:cNvPr id="206" name="mini syn 80 7"/>
           <p:cNvSpPr/>
           <p:nvPr/>
         </p:nvSpPr>
@@ -22298,7 +22912,7 @@
       </p:sp>
       <p:sp>
         <p:nvSpPr>
-          <p:cNvPr id="183" name="mini card syn 81"/>
+          <p:cNvPr id="207" name="mini card syn 81"/>
           <p:cNvSpPr/>
           <p:nvPr/>
         </p:nvSpPr>
@@ -22323,7 +22937,7 @@
       </p:sp>
       <p:sp>
         <p:nvSpPr>
-          <p:cNvPr id="184" name="mini slab syn 81"/>
+          <p:cNvPr id="208" name="mini slab syn 81"/>
           <p:cNvSpPr/>
           <p:nvPr/>
         </p:nvSpPr>
@@ -22343,7 +22957,7 @@
       </p:sp>
       <p:sp>
         <p:nvSpPr>
-          <p:cNvPr id="185" name="mini syn 81 0"/>
+          <p:cNvPr id="209" name="mini syn 81 0"/>
           <p:cNvSpPr/>
           <p:nvPr/>
         </p:nvSpPr>
@@ -22368,7 +22982,7 @@
       </p:sp>
       <p:sp>
         <p:nvSpPr>
-          <p:cNvPr id="186" name="mini syn 81 1"/>
+          <p:cNvPr id="210" name="mini syn 81 1"/>
           <p:cNvSpPr/>
           <p:nvPr/>
         </p:nvSpPr>
@@ -22393,7 +23007,7 @@
       </p:sp>
       <p:sp>
         <p:nvSpPr>
-          <p:cNvPr id="187" name="mini syn 81 2"/>
+          <p:cNvPr id="211" name="mini syn 81 2"/>
           <p:cNvSpPr/>
           <p:nvPr/>
         </p:nvSpPr>
@@ -22418,7 +23032,7 @@
       </p:sp>
       <p:sp>
         <p:nvSpPr>
-          <p:cNvPr id="188" name="mini syn 81 3"/>
+          <p:cNvPr id="212" name="mini syn 81 3"/>
           <p:cNvSpPr/>
           <p:nvPr/>
         </p:nvSpPr>
@@ -22443,7 +23057,7 @@
       </p:sp>
       <p:sp>
         <p:nvSpPr>
-          <p:cNvPr id="189" name="mini syn 81 4"/>
+          <p:cNvPr id="213" name="mini syn 81 4"/>
           <p:cNvSpPr/>
           <p:nvPr/>
         </p:nvSpPr>
@@ -22468,7 +23082,7 @@
       </p:sp>
       <p:sp>
         <p:nvSpPr>
-          <p:cNvPr id="190" name="mini syn 81 5"/>
+          <p:cNvPr id="214" name="mini syn 81 5"/>
           <p:cNvSpPr/>
           <p:nvPr/>
         </p:nvSpPr>
@@ -22493,7 +23107,7 @@
       </p:sp>
       <p:sp>
         <p:nvSpPr>
-          <p:cNvPr id="191" name="mini syn 81 6"/>
+          <p:cNvPr id="215" name="mini syn 81 6"/>
           <p:cNvSpPr/>
           <p:nvPr/>
         </p:nvSpPr>
@@ -22518,7 +23132,7 @@
       </p:sp>
       <p:sp>
         <p:nvSpPr>
-          <p:cNvPr id="192" name="mini syn 81 7"/>
+          <p:cNvPr id="216" name="mini syn 81 7"/>
           <p:cNvSpPr/>
           <p:nvPr/>
         </p:nvSpPr>
@@ -22543,7 +23157,7 @@
       </p:sp>
       <p:sp>
         <p:nvSpPr>
-          <p:cNvPr id="193" name="mini card syn 82"/>
+          <p:cNvPr id="217" name="mini card syn 82"/>
           <p:cNvSpPr/>
           <p:nvPr/>
         </p:nvSpPr>
@@ -22568,7 +23182,7 @@
       </p:sp>
       <p:sp>
         <p:nvSpPr>
-          <p:cNvPr id="194" name="mini wall syn 82"/>
+          <p:cNvPr id="218" name="mini wall syn 82"/>
           <p:cNvSpPr/>
           <p:nvPr/>
         </p:nvSpPr>
@@ -22588,7 +23202,7 @@
       </p:sp>
       <p:sp>
         <p:nvSpPr>
-          <p:cNvPr id="195" name="mini syn 82 0"/>
+          <p:cNvPr id="219" name="mini syn 82 0"/>
           <p:cNvSpPr/>
           <p:nvPr/>
         </p:nvSpPr>
@@ -22613,7 +23227,7 @@
       </p:sp>
       <p:sp>
         <p:nvSpPr>
-          <p:cNvPr id="196" name="mini syn 82 1"/>
+          <p:cNvPr id="220" name="mini syn 82 1"/>
           <p:cNvSpPr/>
           <p:nvPr/>
         </p:nvSpPr>
@@ -22638,7 +23252,7 @@
       </p:sp>
       <p:sp>
         <p:nvSpPr>
-          <p:cNvPr id="197" name="mini syn 82 2"/>
+          <p:cNvPr id="221" name="mini syn 82 2"/>
           <p:cNvSpPr/>
           <p:nvPr/>
         </p:nvSpPr>
@@ -22663,7 +23277,7 @@
       </p:sp>
       <p:sp>
         <p:nvSpPr>
-          <p:cNvPr id="198" name="mini syn 82 3"/>
+          <p:cNvPr id="222" name="mini syn 82 3"/>
           <p:cNvSpPr/>
           <p:nvPr/>
         </p:nvSpPr>
@@ -22688,7 +23302,7 @@
       </p:sp>
       <p:sp>
         <p:nvSpPr>
-          <p:cNvPr id="199" name="mini syn 82 4"/>
+          <p:cNvPr id="223" name="mini syn 82 4"/>
           <p:cNvSpPr/>
           <p:nvPr/>
         </p:nvSpPr>
@@ -22713,7 +23327,7 @@
       </p:sp>
       <p:sp>
         <p:nvSpPr>
-          <p:cNvPr id="200" name="mini syn 82 5"/>
+          <p:cNvPr id="224" name="mini syn 82 5"/>
           <p:cNvSpPr/>
           <p:nvPr/>
         </p:nvSpPr>
@@ -22738,7 +23352,7 @@
       </p:sp>
       <p:sp>
         <p:nvSpPr>
-          <p:cNvPr id="201" name="mini syn 82 6"/>
+          <p:cNvPr id="225" name="mini syn 82 6"/>
           <p:cNvSpPr/>
           <p:nvPr/>
         </p:nvSpPr>
@@ -22763,7 +23377,7 @@
       </p:sp>
       <p:sp>
         <p:nvSpPr>
-          <p:cNvPr id="202" name="mini syn 82 7"/>
+          <p:cNvPr id="226" name="mini syn 82 7"/>
           <p:cNvSpPr/>
           <p:nvPr/>
         </p:nvSpPr>
@@ -22788,7 +23402,7 @@
       </p:sp>
       <p:sp>
         <p:nvSpPr>
-          <p:cNvPr id="203" name="glance heading"/>
+          <p:cNvPr id="227" name="glance heading"/>
           <p:cNvSpPr txBox="1"/>
           <p:nvPr/>
         </p:nvSpPr>
@@ -22824,7 +23438,7 @@
       </p:sp>
       <p:sp>
         <p:nvSpPr>
-          <p:cNvPr id="204" name="glance 7,000"/>
+          <p:cNvPr id="228" name="glance 7,000"/>
           <p:cNvSpPr/>
           <p:nvPr/>
         </p:nvSpPr>
@@ -22846,7 +23460,7 @@
       </p:sp>
       <p:sp>
         <p:nvSpPr>
-          <p:cNvPr id="205" name="icon ring glance 7,000"/>
+          <p:cNvPr id="229" name="icon ring glance 7,000"/>
           <p:cNvSpPr/>
           <p:nvPr/>
         </p:nvSpPr>
@@ -22866,7 +23480,7 @@
       </p:sp>
       <p:pic>
         <p:nvPicPr>
-          <p:cNvPr id="206" name="icon glance 7,000" descr="preencoded.png">    </p:cNvPr>
+          <p:cNvPr id="230" name="icon glance 7,000" descr="preencoded.png">    </p:cNvPr>
           <p:cNvPicPr>
             <a:picLocks noChangeAspect="1"/>
           </p:cNvPicPr>
@@ -22890,7 +23504,7 @@
       </p:pic>
       <p:sp>
         <p:nvSpPr>
-          <p:cNvPr id="207" name="glance value 7,000"/>
+          <p:cNvPr id="231" name="glance value 7,000"/>
           <p:cNvSpPr txBox="1"/>
           <p:nvPr/>
         </p:nvSpPr>
@@ -22926,7 +23540,7 @@
       </p:sp>
       <p:sp>
         <p:nvSpPr>
-          <p:cNvPr id="208" name="glance label 7,000"/>
+          <p:cNvPr id="232" name="glance label 7,000"/>
           <p:cNvSpPr txBox="1"/>
           <p:nvPr/>
         </p:nvSpPr>
@@ -22962,7 +23576,7 @@
       </p:sp>
       <p:sp>
         <p:nvSpPr>
-          <p:cNvPr id="209" name="glance 31,484"/>
+          <p:cNvPr id="233" name="glance 31,484"/>
           <p:cNvSpPr/>
           <p:nvPr/>
         </p:nvSpPr>
@@ -22984,7 +23598,7 @@
       </p:sp>
       <p:sp>
         <p:nvSpPr>
-          <p:cNvPr id="210" name="icon ring glance 31,484"/>
+          <p:cNvPr id="234" name="icon ring glance 31,484"/>
           <p:cNvSpPr/>
           <p:nvPr/>
         </p:nvSpPr>
@@ -23004,7 +23618,7 @@
       </p:sp>
       <p:pic>
         <p:nvPicPr>
-          <p:cNvPr id="211" name="icon glance 31,484" descr="preencoded.png">    </p:cNvPr>
+          <p:cNvPr id="235" name="icon glance 31,484" descr="preencoded.png">    </p:cNvPr>
           <p:cNvPicPr>
             <a:picLocks noChangeAspect="1"/>
           </p:cNvPicPr>
@@ -23028,7 +23642,7 @@
       </p:pic>
       <p:sp>
         <p:nvSpPr>
-          <p:cNvPr id="212" name="glance value 31,484"/>
+          <p:cNvPr id="236" name="glance value 31,484"/>
           <p:cNvSpPr txBox="1"/>
           <p:nvPr/>
         </p:nvSpPr>
@@ -23064,7 +23678,7 @@
       </p:sp>
       <p:sp>
         <p:nvSpPr>
-          <p:cNvPr id="213" name="glance label 31,484"/>
+          <p:cNvPr id="237" name="glance label 31,484"/>
           <p:cNvSpPr txBox="1"/>
           <p:nvPr/>
         </p:nvSpPr>
@@ -23100,7 +23714,7 @@
       </p:sp>
       <p:sp>
         <p:nvSpPr>
-          <p:cNvPr id="214" name="glance C1–C8"/>
+          <p:cNvPr id="238" name="glance C1–C8"/>
           <p:cNvSpPr/>
           <p:nvPr/>
         </p:nvSpPr>
@@ -23122,7 +23736,7 @@
       </p:sp>
       <p:sp>
         <p:nvSpPr>
-          <p:cNvPr id="215" name="icon ring glance C1–C8"/>
+          <p:cNvPr id="239" name="icon ring glance C1–C8"/>
           <p:cNvSpPr/>
           <p:nvPr/>
         </p:nvSpPr>
@@ -23142,7 +23756,7 @@
       </p:sp>
       <p:pic>
         <p:nvPicPr>
-          <p:cNvPr id="216" name="icon glance C1–C8" descr="preencoded.png">    </p:cNvPr>
+          <p:cNvPr id="240" name="icon glance C1–C8" descr="preencoded.png">    </p:cNvPr>
           <p:cNvPicPr>
             <a:picLocks noChangeAspect="1"/>
           </p:cNvPicPr>
@@ -23166,7 +23780,7 @@
       </p:pic>
       <p:sp>
         <p:nvSpPr>
-          <p:cNvPr id="217" name="glance value C1–C8"/>
+          <p:cNvPr id="241" name="glance value C1–C8"/>
           <p:cNvSpPr txBox="1"/>
           <p:nvPr/>
         </p:nvSpPr>
@@ -23202,7 +23816,7 @@
       </p:sp>
       <p:sp>
         <p:nvSpPr>
-          <p:cNvPr id="218" name="glance label C1–C8"/>
+          <p:cNvPr id="242" name="glance label C1–C8"/>
           <p:cNvSpPr txBox="1"/>
           <p:nvPr/>
         </p:nvSpPr>
@@ -23238,7 +23852,7 @@
       </p:sp>
       <p:sp>
         <p:nvSpPr>
-          <p:cNvPr id="219" name="glance 0 labels"/>
+          <p:cNvPr id="243" name="glance 0 labels"/>
           <p:cNvSpPr/>
           <p:nvPr/>
         </p:nvSpPr>
@@ -23260,7 +23874,7 @@
       </p:sp>
       <p:sp>
         <p:nvSpPr>
-          <p:cNvPr id="220" name="icon ring glance 0 labels"/>
+          <p:cNvPr id="244" name="icon ring glance 0 labels"/>
           <p:cNvSpPr/>
           <p:nvPr/>
         </p:nvSpPr>
@@ -23280,7 +23894,7 @@
       </p:sp>
       <p:pic>
         <p:nvPicPr>
-          <p:cNvPr id="221" name="icon glance 0 labels" descr="preencoded.png">    </p:cNvPr>
+          <p:cNvPr id="245" name="icon glance 0 labels" descr="preencoded.png">    </p:cNvPr>
           <p:cNvPicPr>
             <a:picLocks noChangeAspect="1"/>
           </p:cNvPicPr>
@@ -23304,7 +23918,7 @@
       </p:pic>
       <p:sp>
         <p:nvSpPr>
-          <p:cNvPr id="222" name="glance value 0 labels"/>
+          <p:cNvPr id="246" name="glance value 0 labels"/>
           <p:cNvSpPr txBox="1"/>
           <p:nvPr/>
         </p:nvSpPr>
@@ -23340,7 +23954,7 @@
       </p:sp>
       <p:sp>
         <p:nvSpPr>
-          <p:cNvPr id="223" name="glance label 0 labels"/>
+          <p:cNvPr id="247" name="glance label 0 labels"/>
           <p:cNvSpPr txBox="1"/>
           <p:nvPr/>
         </p:nvSpPr>
@@ -23376,7 +23990,7 @@
       </p:sp>
       <p:sp>
         <p:nvSpPr>
-          <p:cNvPr id="224" name="glance Traced"/>
+          <p:cNvPr id="248" name="glance Traced"/>
           <p:cNvSpPr/>
           <p:nvPr/>
         </p:nvSpPr>
@@ -23398,7 +24012,7 @@
       </p:sp>
       <p:sp>
         <p:nvSpPr>
-          <p:cNvPr id="225" name="icon ring glance Traced"/>
+          <p:cNvPr id="249" name="icon ring glance Traced"/>
           <p:cNvSpPr/>
           <p:nvPr/>
         </p:nvSpPr>
@@ -23418,7 +24032,7 @@
       </p:sp>
       <p:pic>
         <p:nvPicPr>
-          <p:cNvPr id="226" name="icon glance Traced" descr="preencoded.png">    </p:cNvPr>
+          <p:cNvPr id="250" name="icon glance Traced" descr="preencoded.png">    </p:cNvPr>
           <p:cNvPicPr>
             <a:picLocks noChangeAspect="1"/>
           </p:cNvPicPr>
@@ -23442,7 +24056,7 @@
       </p:pic>
       <p:sp>
         <p:nvSpPr>
-          <p:cNvPr id="227" name="glance value Traced"/>
+          <p:cNvPr id="251" name="glance value Traced"/>
           <p:cNvSpPr txBox="1"/>
           <p:nvPr/>
         </p:nvSpPr>
@@ -23478,7 +24092,7 @@
       </p:sp>
       <p:sp>
         <p:nvSpPr>
-          <p:cNvPr id="228" name="glance label Traced"/>
+          <p:cNvPr id="252" name="glance label Traced"/>
           <p:cNvSpPr txBox="1"/>
           <p:nvPr/>
         </p:nvSpPr>
@@ -23514,7 +24128,7 @@
       </p:sp>
       <p:sp>
         <p:nvSpPr>
-          <p:cNvPr id="229" name="glance Open"/>
+          <p:cNvPr id="253" name="glance Open"/>
           <p:cNvSpPr/>
           <p:nvPr/>
         </p:nvSpPr>
@@ -23536,7 +24150,7 @@
       </p:sp>
       <p:sp>
         <p:nvSpPr>
-          <p:cNvPr id="230" name="icon ring glance Open"/>
+          <p:cNvPr id="254" name="icon ring glance Open"/>
           <p:cNvSpPr/>
           <p:nvPr/>
         </p:nvSpPr>
@@ -23556,7 +24170,7 @@
       </p:sp>
       <p:pic>
         <p:nvPicPr>
-          <p:cNvPr id="231" name="icon glance Open" descr="preencoded.png">    </p:cNvPr>
+          <p:cNvPr id="255" name="icon glance Open" descr="preencoded.png">    </p:cNvPr>
           <p:cNvPicPr>
             <a:picLocks noChangeAspect="1"/>
           </p:cNvPicPr>
@@ -23580,7 +24194,7 @@
       </p:pic>
       <p:sp>
         <p:nvSpPr>
-          <p:cNvPr id="232" name="glance value Open"/>
+          <p:cNvPr id="256" name="glance value Open"/>
           <p:cNvSpPr txBox="1"/>
           <p:nvPr/>
         </p:nvSpPr>
@@ -23616,7 +24230,7 @@
       </p:sp>
       <p:sp>
         <p:nvSpPr>
-          <p:cNvPr id="233" name="glance label Open"/>
+          <p:cNvPr id="257" name="glance label Open"/>
           <p:cNvSpPr txBox="1"/>
           <p:nvPr/>
         </p:nvSpPr>

</xml_diff>

<commit_message>
Talk: new opening for slide 1
</commit_message>
<xml_diff>
--- a/docs/CrossMEP_CIBW78_talk.pptx
+++ b/docs/CrossMEP_CIBW78_talk.pptx
@@ -122,12 +122,12 @@
   <p:extLst>
     <p:ext uri="{521415D9-36F7-43E2-AB2F-B90AF26B5E84}">
       <p14:sectionLst xmlns:p14="http://schemas.microsoft.com/office/powerpoint/2010/main">
-        <p14:section name="Opening" id="{3e9ff9de-461c-bf85-b48f-a4e4408db7cf}">
+        <p14:section name="Opening" id="{fca4918c-cb23-363e-d9c4-51024700193c}">
           <p14:sldIdLst>
             <p14:sldId id="256"/>
           </p14:sldIdLst>
         </p14:section>
-        <p14:section name="Motivation" id="{41e6bc5b-3d06-e545-9b5c-eac3ccfb6da6}">
+        <p14:section name="Motivation" id="{4b2c31f0-0fed-4a4b-87c7-4d22fdc02120}">
           <p14:sldIdLst>
             <p14:sldId id="257"/>
             <p14:sldId id="258"/>
@@ -136,21 +136,21 @@
             <p14:sldId id="261"/>
           </p14:sldIdLst>
         </p14:section>
-        <p14:section name="The dataset" id="{fed08a7a-e08b-375e-149b-80653295e0e5}">
+        <p14:section name="The dataset" id="{3f67b54c-675f-aa17-adba-a12514784fe8}">
           <p14:sldIdLst>
             <p14:sldId id="262"/>
             <p14:sldId id="263"/>
             <p14:sldId id="264"/>
           </p14:sldIdLst>
         </p14:section>
-        <p14:section name="Experiments" id="{05e19931-68de-e3f4-8d11-bfe4c5ee4683}">
+        <p14:section name="Experiments" id="{bca74537-24f0-16fc-2474-5437f1f5b0d9}">
           <p14:sldIdLst>
             <p14:sldId id="265"/>
             <p14:sldId id="266"/>
             <p14:sldId id="267"/>
           </p14:sldIdLst>
         </p14:section>
-        <p14:section name="Use" id="{d4d71d4b-2c84-a880-172b-2194da059b4c}">
+        <p14:section name="Use" id="{cd8621e5-2eb7-ce59-5b7a-1111131e6441}">
           <p14:sldIdLst>
             <p14:sldId id="268"/>
             <p14:sldId id="269"/>
@@ -2955,7 +2955,7 @@
           <a:p>
             <a:r>
               <a:rPr lang="en-US" dirty="0"/>
-              <a:t>Good morning. Every pipe, duct and cable tray in a building hangs from a support, and every one of those supports is designed by hand. We want machines to learn to design them. A learning machine needs problems to practise on, and in public there were none. So we built them. I'm Lavinia Pedrollo, from Stanford, and this is CrossMEP, with David Gvadzabia, Torben Graeber and Martin Fischer. (0:00)</a:t>
+              <a:t>Hi, I'm Lavinia, a PhD student at Stanford University, and today I am happy to present CrossMEP, which is the dataset we built when we found that the data to learn support design from did not exist. Support design is the one part of MEP that every tool coordinates, every tool checks, and no tool does. A hospital has ten thousand of these supports, each chosen by hand from a catalog. We think a machine can learn to choose them, and what has stopped anyone trying is not the algorithm. It is that nobody had the problems to practise on. So we built the problems. (0:00)</a:t>
             </a:r>
             <a:endParaRPr lang="en-US" dirty="0"/>
           </a:p>
@@ -3043,7 +3043,7 @@
           <a:p>
             <a:r>
               <a:rPr lang="en-US" dirty="0"/>
-              <a:t>Three analyses. The first is a design check. Each tier adds one element: C1 is a single service, the most common support in any building; C8 has eight. Within a tier everything else varies, so the element count is the one controlled axis. Load at the support rises with the tier, from about 0.3 to 2.0 kilonewtons, and the closest gap narrows at every step, from 130 to about 51 millimetres. The dataset behaves as designed. (4:35)</a:t>
+              <a:t>Three analyses. The first is a design check. Each tier adds one element: C1 is a single service, the most common support in any building; C8 has eight. Within a tier everything else varies, so the element count is the one controlled axis. Load at the support rises with the tier, from about 0.3 to 2.0 kilonewtons, and the closest gap narrows at every step, from 130 to about 51 millimetres. The dataset behaves as designed. (4:50)</a:t>
             </a:r>
             <a:endParaRPr lang="en-US" dirty="0"/>
           </a:p>
@@ -3131,7 +3131,7 @@
           <a:p>
             <a:r>
               <a:rPr lang="en-US" dirty="0"/>
-              <a:t>The second is the one the generator could fail: is the spacing realistic in a building it has never seen? The gap distribution was fitted on a residential duplex. We held out a medical clinic, cut it into sections every 250 millimetres, and measured the gaps between pipes side by side. Generator to clinic: 32 millimetres. Above the 8 a perfect generator would show, but about as close as the duplex's own two models are to each other. A fixed 25-millimetre gap would be about 190 off. (5:05)</a:t>
+              <a:t>The second is the one the generator could fail: is the spacing realistic in a building it has never seen? The gap distribution was fitted on a residential duplex. We held out a medical clinic, cut it into sections every 250 millimetres, and measured the gaps between pipes side by side. Generator to clinic: 32 millimetres. Above the 8 a perfect generator would show, but about as close as the duplex's own two models are to each other. A fixed 25-millimetre gap would be about 190 off. (5:20)</a:t>
             </a:r>
             <a:endParaRPr lang="en-US" dirty="0"/>
           </a:p>
@@ -3219,7 +3219,7 @@
           <a:p>
             <a:r>
               <a:rPr lang="en-US" dirty="0"/>
-              <a:t>The third is a use of the dataset: what must a catalog of clamps cover? Our paper's two-size catalog attaches 14.5 percent of the pipes, interval 13 to 16, all one size, DN40. Trays, ducts and conduits are not covered at all. On the right, what the dataset asks of any catalog: two well-placed sizes reach 38 percent, six sizes 76, fifteen every pipe. What the catalog should contain becomes a measurement. (5:40)</a:t>
+              <a:t>The third is a use of the dataset: what must a catalog of clamps cover? Our paper's two-size catalog attaches 14.5 percent of the pipes, interval 13 to 16, all one size, DN40. Trays, ducts and conduits are not covered at all. On the right, what the dataset asks of any catalog: two well-placed sizes reach 38 percent, six sizes 76, fifteen every pipe. What the catalog should contain becomes a measurement. (5:55)</a:t>
             </a:r>
             <a:endParaRPr lang="en-US" dirty="0"/>
           </a:p>
@@ -3307,7 +3307,7 @@
           <a:p>
             <a:r>
               <a:rPr lang="en-US" dirty="0"/>
-              <a:t>Let me show it. This is the Generator Studio. I choose what crosses the hanger, a tier or an exact mix, and a seed. Out comes the section a designer receives, drawn as an engineer would issue it: every service at true size, its level, its load, the closest gap, and the run in 3D. Every section is a stored output of the released generator. Scan the code to try it. [Live: switch to the studio, click C3, then Generate another twice, then Exact mix with a duct. If the demo fails, stay on this slide: its screenshot is the fallback. Before the talk: open the studio once with internet, set its link sharing to public, scan the QR from a phone not logged in.] (6:10)</a:t>
+              <a:t>Let me show it. This is the Generator Studio. I choose what crosses the hanger, a tier or an exact mix, and a seed. Out comes the section a designer receives, drawn as an engineer would issue it: every service at true size, its level, its load, the closest gap, and the run in 3D. Every section is a stored output of the released generator. Scan the code to try it. [Live: switch to the studio, click C3, then Generate another twice, then Exact mix with a duct. If the demo fails, stay on this slide: its screenshot is the fallback. Before the talk: open the studio once with internet, set its link sharing to public, scan the QR from a phone not logged in.] (6:25)</a:t>
             </a:r>
             <a:endParaRPr lang="en-US" dirty="0"/>
           </a:p>
@@ -3395,7 +3395,7 @@
           <a:p>
             <a:r>
               <a:rPr lang="en-US" dirty="0"/>
-              <a:t>Using it takes a few lines: load a split, filter by composition, or generate your own mix. Four splits on disjoint seeds: five thousand to train, five hundred each for validation and test, and a benchmark of a thousand, a hundred and twenty-five per tier. The same files serve reinforcement learning, constraint programming and benchmarking, and we ship the scoring. Train on the generator. Evaluate on the benchmark, the same contexts for every method. Report per tier, with intervals and paired tests. (7:15)</a:t>
+              <a:t>Using it takes a few lines: load a split, filter by composition, or generate your own mix. Four splits on disjoint seeds: five thousand to train, five hundred each for validation and test, and a benchmark of a thousand, a hundred and twenty-five per tier. The same files serve reinforcement learning, constraint programming and benchmarking, and we ship the scoring. Train on the generator. Evaluate on the benchmark, the same contexts for every method. Report per tier, with intervals and paired tests. (7:30)</a:t>
             </a:r>
             <a:endParaRPr lang="en-US" dirty="0"/>
           </a:p>
@@ -3483,7 +3483,7 @@
           <a:p>
             <a:r>
               <a:rPr lang="en-US" dirty="0"/>
-              <a:t>Scope. CrossMEP is one section at one support. Pipe spacing was checked on two open buildings; the rest rests on practice and standards, and the trade mix is a design choice. It is not for the structural design of real installations. Next: a public checker, so methods can be compared on the answer; the catalog as an input; and a real test set from commercial projects, with supports designed by engineers. That is where I would value your eye. (7:50)</a:t>
+              <a:t>Scope. CrossMEP is one section at one support. Pipe spacing was checked on two open buildings; the rest rests on practice and standards, and the trade mix is a design choice. It is not for the structural design of real installations. Next: a public checker, so methods can be compared on the answer; the catalog as an input; and a real test set from commercial projects, with supports designed by engineers. That is where I would value your eye. (8:05)</a:t>
             </a:r>
             <a:endParaRPr lang="en-US" dirty="0"/>
           </a:p>
@@ -3571,7 +3571,7 @@
           <a:p>
             <a:r>
               <a:rPr lang="en-US" dirty="0"/>
-              <a:t>To sum up: CrossMEP is the brief, not the answer. Seven thousand support-design problems, every constant sourced or declared, spacing checked on two open buildings, all of it open. If you coordinate services or design supports, try the studio and tell me what looks wrong. Thank you. (8:20)</a:t>
+              <a:t>To sum up: CrossMEP is the brief, not the answer. Seven thousand support-design problems, every constant sourced or declared, spacing checked on two open buildings, all of it open. If you coordinate services or design supports, try the studio and tell me what looks wrong. Thank you. (8:35)</a:t>
             </a:r>
             <a:endParaRPr lang="en-US" dirty="0"/>
           </a:p>
@@ -3659,7 +3659,7 @@
           <a:p>
             <a:r>
               <a:rPr lang="en-US" dirty="0"/>
-              <a:t>Here is the scale. This is a hospital, and every red mark is a place where services hang from the structure. A modular support groups several services on one prefabricated frame: a structural support assembly. A hospital this size needs about ten thousand of them, each designed individually, twenty minutes to two hours apiece. Add it up and it is about a quarter of the MEP design effort. Practitioner estimates, but these are the numbers people live with. (0:30)</a:t>
+              <a:t>Here is the scale. This is a hospital, and every red mark is a place where services hang from the structure. A modular support groups several services on one prefabricated frame: a structural support assembly. A hospital this size needs about ten thousand of them, each designed individually, twenty minutes to two hours apiece. Add it up and it is about a quarter of the MEP design effort. Practitioner estimates, but these are the numbers people live with. (0:45)</a:t>
             </a:r>
             <a:endParaRPr lang="en-US" dirty="0"/>
           </a:p>
@@ -3747,7 +3747,7 @@
           <a:p>
             <a:r>
               <a:rPr lang="en-US" dirty="0"/>
-              <a:t>So what exactly is designed, and from what? In: one cross-section at a hanger. The structure it hangs from, and the services crossing it, each with its trade, position, size and weight per metre. We call that the context. It is the brief. Out: assemblies of catalog parts that carry those services to the structure, checked for statics, anchors, connectors and buildability, ranked by cost. That is the answer. Hold on to these two words, because CrossMEP is contexts only. It contains no assemblies. (1:00)</a:t>
+              <a:t>So what exactly is designed, and from what? In: one cross-section at a hanger. The structure it hangs from, and the services crossing it, each with its trade, position, size and weight per metre. We call that the context. It is the brief. Out: assemblies of catalog parts that carry those services to the structure, checked for statics, anchors, connectors and buildability, ranked by cost. That is the answer. Hold on to these two words, because CrossMEP is contexts only. It contains no assemblies. (1:15)</a:t>
             </a:r>
             <a:endParaRPr lang="en-US" dirty="0"/>
           </a:p>
@@ -3835,7 +3835,7 @@
           <a:p>
             <a:r>
               <a:rPr lang="en-US" dirty="0"/>
-              <a:t>Why is this still done by hand? A designer works from one section at each hanger, after coordination. Tools coordinate the model and check a design, but they do not choose the layout or the parts. Three reasons it has resisted automation: the topology comes from experience, the rules interact across thousands of combinations, and catalogs change faster than rule systems can be rewritten. (1:35)</a:t>
+              <a:t>Why is this still done by hand? A designer works from one section at each hanger, after coordination. Tools coordinate the model and check a design, but they do not choose the layout or the parts. Three reasons it has resisted automation: the topology comes from experience, the rules interact across thousands of combinations, and catalogs change faster than rule systems can be rewritten. (1:50)</a:t>
             </a:r>
             <a:endParaRPr lang="en-US" dirty="0"/>
           </a:p>
@@ -3923,7 +3923,7 @@
           <a:p>
             <a:r>
               <a:rPr lang="en-US" dirty="0"/>
-              <a:t>So how would a machine learn it? Give it a context. Let it propose an assembly. Check the assembly, and feed pass or fail back. Round after round, it gets better. But every round needs a new context, and that is where it stops. Real projects give a handful of sections, all from the same kind of job and confidential: too few to practise on, and a method tuned on them only fits that job. So we generate the contexts, as many as a method needs, and we fix one benchmark to judge every method on. (2:00)</a:t>
+              <a:t>So how would a machine learn it? Give it a context. Let it propose an assembly. Check the assembly, and feed pass or fail back. Round after round, it gets better. But every round needs a new context, and that is where it stops. Real projects give a handful of sections, all from the same kind of job and confidential: too few to practise on, and a method tuned on them only fits that job. So we generate the contexts, as many as a method needs, and we fix one benchmark to judge every method on. (2:15)</a:t>
             </a:r>
             <a:endParaRPr lang="en-US" dirty="0"/>
           </a:p>
@@ -4011,7 +4011,7 @@
           <a:p>
             <a:r>
               <a:rPr lang="en-US" dirty="0"/>
-              <a:t>How scarce? The real designs we could get were ninety, from one project. Nearly every one had a duct and many pipes. Not one had a cable tray, and not one was as simple as a single pipe: one corner of the design space. A method tuned on them measures fit to that project. So CrossMEP fills the space by construction: every tier from one element to eight, kinds and surfaces varied, without limit. A new seed is a new set. Seven thousand contexts are the release, not the ceiling. (2:40)</a:t>
+              <a:t>How scarce? The real designs we could get were ninety, from one project. Nearly every one had a duct and many pipes. Not one had a cable tray, and not one was as simple as a single pipe: one corner of the design space. A method tuned on them measures fit to that project. So CrossMEP fills the space by construction: every tier from one element to eight, kinds and surfaces varied, without limit. A new seed is a new set. Seven thousand contexts are the release, not the ceiling. (2:55)</a:t>
             </a:r>
             <a:endParaRPr lang="en-US" dirty="0"/>
           </a:p>
@@ -4099,7 +4099,7 @@
           <a:p>
             <a:r>
               <a:rPr lang="en-US" dirty="0"/>
-              <a:t>Here is one context: a two-dimensional section at one support. Each element has its kind, service and trade, its size, insulation and position, and its load: weight per metre times the span it was sized at. Add the surface, slab or wall, and that is all. No channel, no rods, no anchors, no correct answer, because a feasible support depends on the catalog you build from. (3:20)</a:t>
+              <a:t>Here is one context: a two-dimensional section at one support. Each element has its kind, service and trade, its size, insulation and position, and its load: weight per metre times the span it was sized at. Add the surface, slab or wall, and that is all. No channel, no rods, no anchors, no correct answer, because a feasible support depends on the catalog you build from. (3:35)</a:t>
             </a:r>
             <a:endParaRPr lang="en-US" dirty="0"/>
           </a:p>
@@ -4187,7 +4187,7 @@
           <a:p>
             <a:r>
               <a:rPr lang="en-US" dirty="0"/>
-              <a:t>How is a context made? By rules an engineer would recognize. The tier fixes the element count. We pick the surface and fill it the way trades run services: hot and cold together, flow and return together, conduits in groups, bulky services nearest the slab. Gaps are drawn from gaps measured on a built project, never below twenty-five millimetres. On walls, electrical stays above water. Same seed, same file. (3:45)</a:t>
+              <a:t>How is a context made? By rules an engineer would recognize. The tier fixes the element count. We pick the surface and fill it the way trades run services: hot and cold together, flow and return together, conduits in groups, bulky services nearest the slab. Gaps are drawn from gaps measured on a built project, never below twenty-five millimetres. On walls, electrical stays above water. Same seed, same file. (4:00)</a:t>
             </a:r>
             <a:endParaRPr lang="en-US" dirty="0"/>
           </a:p>
@@ -4275,7 +4275,7 @@
           <a:p>
             <a:r>
               <a:rPr lang="en-US" dirty="0"/>
-              <a:t>Where do the numbers come from? Sizes, weights and spans from standards: EN for pipes and ducts, IEC for conduits and trays, ASME for spans, GEG for insulation. Spacing from measured open buildings. And a few choices of our own, like the trade mix, labelled as choices. (4:15)</a:t>
+              <a:t>Where do the numbers come from? Sizes, weights and spans from standards: EN for pipes and ducts, IEC for conduits and trays, ASME for spans, GEG for insulation. Spacing from measured open buildings. And a few choices of our own, like the trade mix, labelled as choices. (4:30)</a:t>
             </a:r>
             <a:endParaRPr lang="en-US" dirty="0"/>
           </a:p>

</xml_diff>

<commit_message>
Talk: slide 3 and 4 titles as written by the author
Co-Authored-By: Claude Fable 5.1 <noreply@anthropic.com>
Claude-Session: https://claude.ai/code/session_01R1ft1rokeRJHR95rzLxNEC
</commit_message>
<xml_diff>
--- a/docs/CrossMEP_CIBW78_talk.pptx
+++ b/docs/CrossMEP_CIBW78_talk.pptx
@@ -122,12 +122,12 @@
   <p:extLst>
     <p:ext uri="{521415D9-36F7-43E2-AB2F-B90AF26B5E84}">
       <p14:sectionLst xmlns:p14="http://schemas.microsoft.com/office/powerpoint/2010/main">
-        <p14:section name="Opening" id="{fca4918c-cb23-363e-d9c4-51024700193c}">
+        <p14:section name="Opening" id="{29e82c75-0c73-e37f-61a9-1c646f26b447}">
           <p14:sldIdLst>
             <p14:sldId id="256"/>
           </p14:sldIdLst>
         </p14:section>
-        <p14:section name="Motivation" id="{4b2c31f0-0fed-4a4b-87c7-4d22fdc02120}">
+        <p14:section name="Motivation" id="{0a051618-b5fc-66e4-6969-0eb3348b205b}">
           <p14:sldIdLst>
             <p14:sldId id="257"/>
             <p14:sldId id="258"/>
@@ -136,21 +136,21 @@
             <p14:sldId id="261"/>
           </p14:sldIdLst>
         </p14:section>
-        <p14:section name="The dataset" id="{3f67b54c-675f-aa17-adba-a12514784fe8}">
+        <p14:section name="The dataset" id="{e2f689c0-196e-b2b6-3062-47a7a2d7adf5}">
           <p14:sldIdLst>
             <p14:sldId id="262"/>
             <p14:sldId id="263"/>
             <p14:sldId id="264"/>
           </p14:sldIdLst>
         </p14:section>
-        <p14:section name="Experiments" id="{bca74537-24f0-16fc-2474-5437f1f5b0d9}">
+        <p14:section name="Experiments" id="{580ed5fc-feae-dd0d-836b-e7ad4ffe8e49}">
           <p14:sldIdLst>
             <p14:sldId id="265"/>
             <p14:sldId id="266"/>
             <p14:sldId id="267"/>
           </p14:sldIdLst>
         </p14:section>
-        <p14:section name="Use" id="{cd8621e5-2eb7-ce59-5b7a-1111131e6441}">
+        <p14:section name="Use" id="{ca471e54-8cd4-a12e-c3c2-822748426bcc}">
           <p14:sldIdLst>
             <p14:sldId id="268"/>
             <p14:sldId id="269"/>
@@ -11649,7 +11649,7 @@
                   <a:schemeClr val="tx1"/>
                 </a:solidFill>
               </a:rPr>
-              <a:t>A support designer turns one cross-section into a set of verified support assemblies</a:t>
+              <a:t>An SSA designer turns one MEP cross-section into a feasible structural support assembly</a:t>
             </a:r>
             <a:endParaRPr lang="en-US" sz="2600" dirty="0"/>
           </a:p>
@@ -13644,12 +13644,12 @@
               <a:buNone/>
             </a:pPr>
             <a:r>
-              <a:rPr lang="en-US" sz="2600" b="1" dirty="0">
+              <a:rPr lang="en-US" sz="2200" b="1" dirty="0">
                 <a:solidFill>
                   <a:schemeClr val="tx1"/>
                 </a:solidFill>
               </a:rPr>
-              <a:t>Choosing the assembly from a catalog is still done by hand, one section at a time</a:t>
+              <a:t>Existing tools coordinate and verify modular support assemblies, but their synthesis remains manual because it relies on tacit engineering expertise and complex catalog-driven rules</a:t>
             </a:r>
             <a:endParaRPr lang="en-US" sz="2600" dirty="0"/>
           </a:p>

</xml_diff>

<commit_message>
Talk: fold in the author's slide 2, 3 and 5 edits; unique shape ids so PowerPoint opens the deck without repair
pptxgenjs gives the slide-number placeholder a fixed id and tables their
own, so slides with many shapes carried duplicate ids and PowerPoint
offered to repair the file, dropping shapes. The post-processing step now
renumbers ids per slide and writes the package without directory entries.
</commit_message>
<xml_diff>
--- a/docs/CrossMEP_CIBW78_talk.pptx
+++ b/docs/CrossMEP_CIBW78_talk.pptx
@@ -122,12 +122,12 @@
   <p:extLst>
     <p:ext uri="{521415D9-36F7-43E2-AB2F-B90AF26B5E84}">
       <p14:sectionLst xmlns:p14="http://schemas.microsoft.com/office/powerpoint/2010/main">
-        <p14:section name="Opening" id="{29e82c75-0c73-e37f-61a9-1c646f26b447}">
+        <p14:section name="Opening" id="{10255f91-07a6-325f-1289-2346353109e2}">
           <p14:sldIdLst>
             <p14:sldId id="256"/>
           </p14:sldIdLst>
         </p14:section>
-        <p14:section name="Motivation" id="{0a051618-b5fc-66e4-6969-0eb3348b205b}">
+        <p14:section name="Motivation" id="{c1531636-c515-da40-e09f-1d275e146f8b}">
           <p14:sldIdLst>
             <p14:sldId id="257"/>
             <p14:sldId id="258"/>
@@ -136,21 +136,21 @@
             <p14:sldId id="261"/>
           </p14:sldIdLst>
         </p14:section>
-        <p14:section name="The dataset" id="{e2f689c0-196e-b2b6-3062-47a7a2d7adf5}">
+        <p14:section name="The dataset" id="{ea4cb01e-c2ee-c8a4-db9e-d839f32913b9}">
           <p14:sldIdLst>
             <p14:sldId id="262"/>
             <p14:sldId id="263"/>
             <p14:sldId id="264"/>
           </p14:sldIdLst>
         </p14:section>
-        <p14:section name="Experiments" id="{580ed5fc-feae-dd0d-836b-e7ad4ffe8e49}">
+        <p14:section name="Experiments" id="{c0cca296-c535-74d2-99c8-3d14ffb30aba}">
           <p14:sldIdLst>
             <p14:sldId id="265"/>
             <p14:sldId id="266"/>
             <p14:sldId id="267"/>
           </p14:sldIdLst>
         </p14:section>
-        <p14:section name="Use" id="{ca471e54-8cd4-a12e-c3c2-822748426bcc}">
+        <p14:section name="Use" id="{bfcc802d-e049-1ece-030d-70b5e44e791a}">
           <p14:sldIdLst>
             <p14:sldId id="268"/>
             <p14:sldId id="269"/>
@@ -5547,7 +5547,7 @@
       </p:sp>
       <p:sp>
         <p:nvSpPr>
-          <p:cNvPr id="25" name="Slide Number Placeholder 0"/>
+          <p:cNvPr id="6" name="Slide Number Placeholder 0"/>
           <p:cNvSpPr>
             <a:spLocks noGrp="1"/>
           </p:cNvSpPr>
@@ -7211,7 +7211,7 @@
       </p:sp>
       <p:sp>
         <p:nvSpPr>
-          <p:cNvPr id="25" name="Slide Number Placeholder 0"/>
+          <p:cNvPr id="54" name="Slide Number Placeholder 0"/>
           <p:cNvSpPr>
             <a:spLocks noGrp="1"/>
           </p:cNvSpPr>
@@ -7669,7 +7669,7 @@
       </p:sp>
       <p:sp>
         <p:nvSpPr>
-          <p:cNvPr id="25" name="Slide Number Placeholder 0"/>
+          <p:cNvPr id="15" name="Slide Number Placeholder 0"/>
           <p:cNvSpPr>
             <a:spLocks noGrp="1"/>
           </p:cNvSpPr>
@@ -8143,7 +8143,7 @@
       </p:sp>
       <p:sp>
         <p:nvSpPr>
-          <p:cNvPr id="25" name="Slide Number Placeholder 0"/>
+          <p:cNvPr id="16" name="Slide Number Placeholder 0"/>
           <p:cNvSpPr>
             <a:spLocks noGrp="1"/>
           </p:cNvSpPr>
@@ -9159,7 +9159,7 @@
       </p:sp>
       <p:sp>
         <p:nvSpPr>
-          <p:cNvPr id="25" name="Slide Number Placeholder 0"/>
+          <p:cNvPr id="32" name="Slide Number Placeholder 0"/>
           <p:cNvSpPr>
             <a:spLocks noGrp="1"/>
           </p:cNvSpPr>
@@ -10072,7 +10072,7 @@
       </p:pic>
       <p:sp>
         <p:nvSpPr>
-          <p:cNvPr id="25" name="Slide Number Placeholder 0"/>
+          <p:cNvPr id="31" name="Slide Number Placeholder 0"/>
           <p:cNvSpPr>
             <a:spLocks noGrp="1"/>
           </p:cNvSpPr>
@@ -10917,7 +10917,7 @@
                   <a:schemeClr val="tx1"/>
                 </a:solidFill>
               </a:rPr>
-              <a:t>In a hospital like this one, ten thousand structural support assemblies are each designed individually, which is why they take about a quarter of the MEP design effort</a:t>
+              <a:t>The synthesis of structural support assemblies (SSAs) takes 25% of MEP design effort because every assembly must be designed individually</a:t>
             </a:r>
             <a:endParaRPr lang="en-US" sz="2600" dirty="0"/>
           </a:p>
@@ -10963,7 +10963,7 @@
           </a:prstGeom>
           <a:ln w="19050">
             <a:solidFill>
-              <a:srgbClr val="EB6834"/>
+              <a:srgbClr val="C00000"/>
             </a:solidFill>
             <a:prstDash val="solid"/>
           </a:ln>
@@ -10986,7 +10986,7 @@
           <a:noFill/>
           <a:ln w="19050">
             <a:solidFill>
-              <a:srgbClr val="EB6834"/>
+              <a:srgbClr val="C00000"/>
             </a:solidFill>
             <a:prstDash val="solid"/>
           </a:ln>
@@ -11009,7 +11009,7 @@
           <a:noFill/>
           <a:ln w="19050">
             <a:solidFill>
-              <a:srgbClr val="EB6834"/>
+              <a:srgbClr val="C00000"/>
             </a:solidFill>
             <a:prstDash val="solid"/>
           </a:ln>
@@ -11055,7 +11055,7 @@
           </a:prstGeom>
           <a:ln w="19050">
             <a:solidFill>
-              <a:srgbClr val="EB6834"/>
+              <a:srgbClr val="C00000"/>
             </a:solidFill>
             <a:prstDash val="solid"/>
           </a:ln>
@@ -11134,7 +11134,7 @@
             <a:avLst/>
           </a:prstGeom>
           <a:solidFill>
-            <a:schemeClr val="accent1"/>
+            <a:srgbClr val="C00000"/>
           </a:solidFill>
           <a:ln/>
         </p:spPr>
@@ -11190,7 +11190,7 @@
             <a:r>
               <a:rPr lang="en-US" sz="2800" b="1" dirty="0">
                 <a:solidFill>
-                  <a:schemeClr val="accent1"/>
+                  <a:srgbClr val="C00000"/>
                 </a:solidFill>
               </a:rPr>
               <a:t>≈ 10,000</a:t>
@@ -11220,6 +11220,17 @@
           <a:bodyPr wrap="square" lIns="0" tIns="0" rIns="0" bIns="0" rtlCol="0" anchor="t"/>
           <a:lstStyle/>
           <a:p>
+            <a:pPr indent="0" marL="0">
+              <a:buNone/>
+            </a:pPr>
+            <a:r>
+              <a:rPr lang="en-US" sz="1200" b="1" dirty="0">
+                <a:solidFill>
+                  <a:srgbClr val="C00000"/>
+                </a:solidFill>
+              </a:rPr>
+              <a:t>support assemblies </a:t>
+            </a:r>
             <a:pPr indent="0" marL="0">
               <a:buNone/>
             </a:pPr>
@@ -11229,7 +11240,7 @@
                   <a:srgbClr val="52514E"/>
                 </a:solidFill>
               </a:rPr>
-              <a:t>support assemblies in one 200,000 sq ft hospital</a:t>
+              <a:t>in one 200,000 sq ft hospital project</a:t>
             </a:r>
             <a:endParaRPr lang="en-US" sz="1200" dirty="0"/>
           </a:p>
@@ -11272,7 +11283,7 @@
             <a:avLst/>
           </a:prstGeom>
           <a:solidFill>
-            <a:schemeClr val="accent1"/>
+            <a:srgbClr val="C00000"/>
           </a:solidFill>
           <a:ln/>
         </p:spPr>
@@ -11328,7 +11339,7 @@
             <a:r>
               <a:rPr lang="en-US" sz="2800" b="1" dirty="0">
                 <a:solidFill>
-                  <a:schemeClr val="accent1"/>
+                  <a:srgbClr val="C00000"/>
                 </a:solidFill>
               </a:rPr>
               <a:t>20 min – 2 h</a:t>
@@ -11358,6 +11369,17 @@
           <a:bodyPr wrap="square" lIns="0" tIns="0" rIns="0" bIns="0" rtlCol="0" anchor="t"/>
           <a:lstStyle/>
           <a:p>
+            <a:pPr indent="0" marL="0">
+              <a:buNone/>
+            </a:pPr>
+            <a:r>
+              <a:rPr lang="en-US" sz="1200" b="1" dirty="0">
+                <a:solidFill>
+                  <a:srgbClr val="C00000"/>
+                </a:solidFill>
+              </a:rPr>
+              <a:t>of engineering time </a:t>
+            </a:r>
             <a:pPr indent="0" marL="0">
               <a:buNone/>
             </a:pPr>
@@ -11367,7 +11389,7 @@
                   <a:srgbClr val="52514E"/>
                 </a:solidFill>
               </a:rPr>
-              <a:t>of engineering for each assembly, designed one by one</a:t>
+              <a:t>for each assembly, designed one by one</a:t>
             </a:r>
             <a:endParaRPr lang="en-US" sz="1200" dirty="0"/>
           </a:p>
@@ -11410,7 +11432,7 @@
             <a:avLst/>
           </a:prstGeom>
           <a:solidFill>
-            <a:schemeClr val="accent1"/>
+            <a:srgbClr val="C00000"/>
           </a:solidFill>
           <a:ln/>
         </p:spPr>
@@ -11466,10 +11488,10 @@
             <a:r>
               <a:rPr lang="en-US" sz="2800" b="1" dirty="0">
                 <a:solidFill>
-                  <a:schemeClr val="accent1"/>
+                  <a:srgbClr val="C00000"/>
                 </a:solidFill>
               </a:rPr>
-              <a:t>≈ ¼</a:t>
+              <a:t>≈ $600k</a:t>
             </a:r>
             <a:endParaRPr lang="en-US" sz="2800" dirty="0"/>
           </a:p>
@@ -11496,6 +11518,17 @@
           <a:bodyPr wrap="square" lIns="0" tIns="0" rIns="0" bIns="0" rtlCol="0" anchor="t"/>
           <a:lstStyle/>
           <a:p>
+            <a:pPr indent="0" marL="0">
+              <a:buNone/>
+            </a:pPr>
+            <a:r>
+              <a:rPr lang="en-US" sz="1200" b="1" dirty="0">
+                <a:solidFill>
+                  <a:srgbClr val="C00000"/>
+                </a:solidFill>
+              </a:rPr>
+              <a:t>of engineering cost </a:t>
+            </a:r>
             <a:pPr indent="0" marL="0">
               <a:buNone/>
             </a:pPr>
@@ -11505,7 +11538,7 @@
                   <a:srgbClr val="52514E"/>
                 </a:solidFill>
               </a:rPr>
-              <a:t>of MEP design effort; on the order of $600K per project</a:t>
+              <a:t>cumulative per hospital project</a:t>
             </a:r>
             <a:endParaRPr lang="en-US" sz="1200" dirty="0"/>
           </a:p>
@@ -11549,7 +11582,7 @@
       </p:sp>
       <p:sp>
         <p:nvSpPr>
-          <p:cNvPr id="25" name="Slide Number Placeholder 0"/>
+          <p:cNvPr id="26" name="Slide Number Placeholder 0"/>
           <p:cNvSpPr>
             <a:spLocks noGrp="1"/>
           </p:cNvSpPr>
@@ -11657,43 +11690,7 @@
       </p:sp>
       <p:sp>
         <p:nvSpPr>
-          <p:cNvPr id="3" name="head in"/>
-          <p:cNvSpPr txBox="1"/>
-          <p:nvPr/>
-        </p:nvSpPr>
-        <p:spPr>
-          <a:xfrm>
-            <a:off x="548640" y="1325880"/>
-            <a:ext cx="4846320" cy="274320"/>
-          </a:xfrm>
-          <a:prstGeom prst="rect">
-            <a:avLst/>
-          </a:prstGeom>
-          <a:noFill/>
-          <a:ln/>
-        </p:spPr>
-        <p:txBody>
-          <a:bodyPr wrap="square" lIns="0" tIns="0" rIns="0" bIns="0" rtlCol="0" anchor="ctr"/>
-          <a:lstStyle/>
-          <a:p>
-            <a:pPr indent="0" marL="0">
-              <a:buNone/>
-            </a:pPr>
-            <a:r>
-              <a:rPr lang="en-US" sz="1600" b="1" dirty="0">
-                <a:solidFill>
-                  <a:schemeClr val="tx1"/>
-                </a:solidFill>
-              </a:rPr>
-              <a:t>In: one cross-section = a context</a:t>
-            </a:r>
-            <a:endParaRPr lang="en-US" sz="1600" dirty="0"/>
-          </a:p>
-        </p:txBody>
-      </p:sp>
-      <p:sp>
-        <p:nvSpPr>
-          <p:cNvPr id="4" name="frame in"/>
+          <p:cNvPr id="3" name="frame in"/>
           <p:cNvSpPr/>
           <p:nvPr/>
         </p:nvSpPr>
@@ -11720,7 +11717,7 @@
       </p:sp>
       <p:sp>
         <p:nvSpPr>
-          <p:cNvPr id="5" name="ceiling in"/>
+          <p:cNvPr id="4" name="ceiling in"/>
           <p:cNvSpPr/>
           <p:nvPr/>
         </p:nvSpPr>
@@ -11745,7 +11742,7 @@
       </p:sp>
       <p:sp>
         <p:nvSpPr>
-          <p:cNvPr id="6" name="hatch in 0.8"/>
+          <p:cNvPr id="5" name="hatch in 0.8"/>
           <p:cNvSpPr/>
           <p:nvPr/>
         </p:nvSpPr>
@@ -11768,7 +11765,7 @@
       </p:sp>
       <p:sp>
         <p:nvSpPr>
-          <p:cNvPr id="7" name="hatch in 1.1"/>
+          <p:cNvPr id="6" name="hatch in 1.1"/>
           <p:cNvSpPr/>
           <p:nvPr/>
         </p:nvSpPr>
@@ -11791,7 +11788,7 @@
       </p:sp>
       <p:sp>
         <p:nvSpPr>
-          <p:cNvPr id="8" name="hatch in 1.4"/>
+          <p:cNvPr id="7" name="hatch in 1.4"/>
           <p:cNvSpPr/>
           <p:nvPr/>
         </p:nvSpPr>
@@ -11814,7 +11811,7 @@
       </p:sp>
       <p:sp>
         <p:nvSpPr>
-          <p:cNvPr id="9" name="hatch in 1.7"/>
+          <p:cNvPr id="8" name="hatch in 1.7"/>
           <p:cNvSpPr/>
           <p:nvPr/>
         </p:nvSpPr>
@@ -11837,7 +11834,7 @@
       </p:sp>
       <p:sp>
         <p:nvSpPr>
-          <p:cNvPr id="10" name="hatch in 2.0"/>
+          <p:cNvPr id="9" name="hatch in 2.0"/>
           <p:cNvSpPr/>
           <p:nvPr/>
         </p:nvSpPr>
@@ -11860,7 +11857,7 @@
       </p:sp>
       <p:sp>
         <p:nvSpPr>
-          <p:cNvPr id="11" name="hatch in 2.3"/>
+          <p:cNvPr id="10" name="hatch in 2.3"/>
           <p:cNvSpPr/>
           <p:nvPr/>
         </p:nvSpPr>
@@ -11883,7 +11880,7 @@
       </p:sp>
       <p:sp>
         <p:nvSpPr>
-          <p:cNvPr id="12" name="hatch in 2.6"/>
+          <p:cNvPr id="11" name="hatch in 2.6"/>
           <p:cNvSpPr/>
           <p:nvPr/>
         </p:nvSpPr>
@@ -11906,7 +11903,7 @@
       </p:sp>
       <p:sp>
         <p:nvSpPr>
-          <p:cNvPr id="13" name="hatch in 2.9"/>
+          <p:cNvPr id="12" name="hatch in 2.9"/>
           <p:cNvSpPr/>
           <p:nvPr/>
         </p:nvSpPr>
@@ -11929,7 +11926,7 @@
       </p:sp>
       <p:sp>
         <p:nvSpPr>
-          <p:cNvPr id="14" name="hatch in 3.2"/>
+          <p:cNvPr id="13" name="hatch in 3.2"/>
           <p:cNvSpPr/>
           <p:nvPr/>
         </p:nvSpPr>
@@ -11952,7 +11949,7 @@
       </p:sp>
       <p:sp>
         <p:nvSpPr>
-          <p:cNvPr id="15" name="hatch in 3.5"/>
+          <p:cNvPr id="14" name="hatch in 3.5"/>
           <p:cNvSpPr/>
           <p:nvPr/>
         </p:nvSpPr>
@@ -11975,7 +11972,7 @@
       </p:sp>
       <p:sp>
         <p:nvSpPr>
-          <p:cNvPr id="16" name="hatch in 3.8"/>
+          <p:cNvPr id="15" name="hatch in 3.8"/>
           <p:cNvSpPr/>
           <p:nvPr/>
         </p:nvSpPr>
@@ -11998,7 +11995,7 @@
       </p:sp>
       <p:sp>
         <p:nvSpPr>
-          <p:cNvPr id="17" name="hatch in 4.1"/>
+          <p:cNvPr id="16" name="hatch in 4.1"/>
           <p:cNvSpPr/>
           <p:nvPr/>
         </p:nvSpPr>
@@ -12021,7 +12018,7 @@
       </p:sp>
       <p:sp>
         <p:nvSpPr>
-          <p:cNvPr id="18" name="hatch in 4.4"/>
+          <p:cNvPr id="17" name="hatch in 4.4"/>
           <p:cNvSpPr/>
           <p:nvPr/>
         </p:nvSpPr>
@@ -12044,7 +12041,7 @@
       </p:sp>
       <p:sp>
         <p:nvSpPr>
-          <p:cNvPr id="19" name="hatch in 4.7"/>
+          <p:cNvPr id="18" name="hatch in 4.7"/>
           <p:cNvSpPr/>
           <p:nvPr/>
         </p:nvSpPr>
@@ -12067,7 +12064,7 @@
       </p:sp>
       <p:sp>
         <p:nvSpPr>
-          <p:cNvPr id="20" name="hatch in 5.0"/>
+          <p:cNvPr id="19" name="hatch in 5.0"/>
           <p:cNvSpPr/>
           <p:nvPr/>
         </p:nvSpPr>
@@ -12090,7 +12087,7 @@
       </p:sp>
       <p:sp>
         <p:nvSpPr>
-          <p:cNvPr id="21" name="hatch in 5.3"/>
+          <p:cNvPr id="20" name="hatch in 5.3"/>
           <p:cNvSpPr/>
           <p:nvPr/>
         </p:nvSpPr>
@@ -12113,7 +12110,7 @@
       </p:sp>
       <p:sp>
         <p:nvSpPr>
-          <p:cNvPr id="22" name="ceiling label in"/>
+          <p:cNvPr id="21" name="ceiling label in"/>
           <p:cNvSpPr txBox="1"/>
           <p:nvPr/>
         </p:nvSpPr>
@@ -12151,7 +12148,7 @@
       </p:sp>
       <p:sp>
         <p:nvSpPr>
-          <p:cNvPr id="23" name="duct in"/>
+          <p:cNvPr id="22" name="duct in"/>
           <p:cNvSpPr/>
           <p:nvPr/>
         </p:nvSpPr>
@@ -12176,7 +12173,7 @@
       </p:sp>
       <p:sp>
         <p:nvSpPr>
-          <p:cNvPr id="24" name="duct label in"/>
+          <p:cNvPr id="23" name="duct label in"/>
           <p:cNvSpPr txBox="1"/>
           <p:nvPr/>
         </p:nvSpPr>
@@ -12212,7 +12209,7 @@
       </p:sp>
       <p:sp>
         <p:nvSpPr>
-          <p:cNvPr id="25" name="pipe a in"/>
+          <p:cNvPr id="24" name="pipe a in"/>
           <p:cNvSpPr/>
           <p:nvPr/>
         </p:nvSpPr>
@@ -12237,7 +12234,7 @@
       </p:sp>
       <p:sp>
         <p:nvSpPr>
-          <p:cNvPr id="26" name="pipe b in"/>
+          <p:cNvPr id="25" name="pipe b in"/>
           <p:cNvSpPr/>
           <p:nvPr/>
         </p:nvSpPr>
@@ -12262,7 +12259,7 @@
       </p:sp>
       <p:sp>
         <p:nvSpPr>
-          <p:cNvPr id="27" name="tray in"/>
+          <p:cNvPr id="26" name="tray in"/>
           <p:cNvSpPr/>
           <p:nvPr/>
         </p:nvSpPr>
@@ -12287,7 +12284,7 @@
       </p:sp>
       <p:sp>
         <p:nvSpPr>
-          <p:cNvPr id="28" name="pipes label"/>
+          <p:cNvPr id="27" name="pipes label"/>
           <p:cNvSpPr txBox="1"/>
           <p:nvPr/>
         </p:nvSpPr>
@@ -12323,7 +12320,7 @@
       </p:sp>
       <p:sp>
         <p:nvSpPr>
-          <p:cNvPr id="29" name="tray label"/>
+          <p:cNvPr id="28" name="tray label"/>
           <p:cNvSpPr txBox="1"/>
           <p:nvPr/>
         </p:nvSpPr>
@@ -12359,57 +12356,7 @@
       </p:sp>
       <p:sp>
         <p:nvSpPr>
-          <p:cNvPr id="30" name="in caption"/>
-          <p:cNvSpPr txBox="1"/>
-          <p:nvPr/>
-        </p:nvSpPr>
-        <p:spPr>
-          <a:xfrm>
-            <a:off x="548640" y="4663440"/>
-            <a:ext cx="4846320" cy="502920"/>
-          </a:xfrm>
-          <a:prstGeom prst="rect">
-            <a:avLst/>
-          </a:prstGeom>
-          <a:noFill/>
-          <a:ln/>
-        </p:spPr>
-        <p:txBody>
-          <a:bodyPr wrap="square" lIns="0" tIns="0" rIns="0" bIns="0" rtlCol="0" anchor="t"/>
-          <a:lstStyle/>
-          <a:p>
-            <a:pPr indent="0" marL="0">
-              <a:buNone/>
-            </a:pPr>
-            <a:r>
-              <a:rPr lang="en-US" sz="1200" dirty="0">
-                <a:solidFill>
-                  <a:srgbClr val="52514E"/>
-                </a:solidFill>
-              </a:rPr>
-              <a:t>Structure: ceiling, floor or wall, with anchor zones</a:t>
-            </a:r>
-            <a:endParaRPr lang="en-US" sz="1200" dirty="0"/>
-          </a:p>
-          <a:p>
-            <a:pPr indent="0" marL="0">
-              <a:buNone/>
-            </a:pPr>
-            <a:r>
-              <a:rPr lang="en-US" sz="1200" dirty="0">
-                <a:solidFill>
-                  <a:srgbClr val="52514E"/>
-                </a:solidFill>
-              </a:rPr>
-              <a:t>Services: trade, position, size and weight per metre</a:t>
-            </a:r>
-            <a:endParaRPr lang="en-US" sz="1200" dirty="0"/>
-          </a:p>
-        </p:txBody>
-      </p:sp>
-      <p:sp>
-        <p:nvSpPr>
-          <p:cNvPr id="31" name="design arrow"/>
+          <p:cNvPr id="29" name="design arrow"/>
           <p:cNvSpPr/>
           <p:nvPr/>
         </p:nvSpPr>
@@ -12433,7 +12380,7 @@
       </p:sp>
       <p:sp>
         <p:nvSpPr>
-          <p:cNvPr id="32" name="design label"/>
+          <p:cNvPr id="30" name="design label"/>
           <p:cNvSpPr txBox="1"/>
           <p:nvPr/>
         </p:nvSpPr>
@@ -12469,49 +12416,13 @@
       </p:sp>
       <p:sp>
         <p:nvSpPr>
-          <p:cNvPr id="33" name="head out"/>
-          <p:cNvSpPr txBox="1"/>
-          <p:nvPr/>
-        </p:nvSpPr>
-        <p:spPr>
-          <a:xfrm>
-            <a:off x="6793992" y="1325880"/>
-            <a:ext cx="4846320" cy="274320"/>
-          </a:xfrm>
-          <a:prstGeom prst="rect">
-            <a:avLst/>
-          </a:prstGeom>
-          <a:noFill/>
-          <a:ln/>
-        </p:spPr>
-        <p:txBody>
-          <a:bodyPr wrap="square" lIns="0" tIns="0" rIns="0" bIns="0" rtlCol="0" anchor="ctr"/>
-          <a:lstStyle/>
-          <a:p>
-            <a:pPr indent="0" marL="0">
-              <a:buNone/>
-            </a:pPr>
-            <a:r>
-              <a:rPr lang="en-US" sz="1600" b="1" dirty="0">
-                <a:solidFill>
-                  <a:schemeClr val="tx1"/>
-                </a:solidFill>
-              </a:rPr>
-              <a:t>Out: verified support designs = assemblies</a:t>
-            </a:r>
-            <a:endParaRPr lang="en-US" sz="1600" dirty="0"/>
-          </a:p>
-        </p:txBody>
-      </p:sp>
-      <p:sp>
-        <p:nvSpPr>
-          <p:cNvPr id="34" name="frame out back 0"/>
-          <p:cNvSpPr/>
-          <p:nvPr/>
-        </p:nvSpPr>
-        <p:spPr>
-          <a:xfrm>
-            <a:off x="6976872" y="1645920"/>
+          <p:cNvPr id="31" name="frame out"/>
+          <p:cNvSpPr/>
+          <p:nvPr/>
+        </p:nvSpPr>
+        <p:spPr>
+          <a:xfrm>
+            <a:off x="6793992" y="1828800"/>
             <a:ext cx="4846320" cy="2743200"/>
           </a:xfrm>
           <a:prstGeom prst="roundRect">
@@ -12522,60 +12433,6 @@
           <a:solidFill>
             <a:srgbClr val="FFFFFF"/>
           </a:solidFill>
-          <a:ln w="12700">
-            <a:solidFill>
-              <a:srgbClr val="E1E0D9"/>
-            </a:solidFill>
-            <a:prstDash val="solid"/>
-          </a:ln>
-        </p:spPr>
-      </p:sp>
-      <p:sp>
-        <p:nvSpPr>
-          <p:cNvPr id="35" name="frame out back 1"/>
-          <p:cNvSpPr/>
-          <p:nvPr/>
-        </p:nvSpPr>
-        <p:spPr>
-          <a:xfrm>
-            <a:off x="6885432" y="1737360"/>
-            <a:ext cx="4846320" cy="2743200"/>
-          </a:xfrm>
-          <a:prstGeom prst="roundRect">
-            <a:avLst>
-              <a:gd name="adj" fmla="val 2000"/>
-            </a:avLst>
-          </a:prstGeom>
-          <a:solidFill>
-            <a:srgbClr val="FFFFFF"/>
-          </a:solidFill>
-          <a:ln w="12700">
-            <a:solidFill>
-              <a:srgbClr val="E1E0D9"/>
-            </a:solidFill>
-            <a:prstDash val="solid"/>
-          </a:ln>
-        </p:spPr>
-      </p:sp>
-      <p:sp>
-        <p:nvSpPr>
-          <p:cNvPr id="36" name="frame out"/>
-          <p:cNvSpPr/>
-          <p:nvPr/>
-        </p:nvSpPr>
-        <p:spPr>
-          <a:xfrm>
-            <a:off x="6793992" y="1828800"/>
-            <a:ext cx="4846320" cy="2743200"/>
-          </a:xfrm>
-          <a:prstGeom prst="roundRect">
-            <a:avLst>
-              <a:gd name="adj" fmla="val 2000"/>
-            </a:avLst>
-          </a:prstGeom>
-          <a:solidFill>
-            <a:srgbClr val="FFFFFF"/>
-          </a:solidFill>
           <a:ln w="9525">
             <a:solidFill>
               <a:srgbClr val="52514E"/>
@@ -12586,7 +12443,7 @@
       </p:sp>
       <p:sp>
         <p:nvSpPr>
-          <p:cNvPr id="37" name="ceiling out"/>
+          <p:cNvPr id="32" name="ceiling out"/>
           <p:cNvSpPr/>
           <p:nvPr/>
         </p:nvSpPr>
@@ -12611,7 +12468,7 @@
       </p:sp>
       <p:sp>
         <p:nvSpPr>
-          <p:cNvPr id="38" name="hatch out 7.6"/>
+          <p:cNvPr id="33" name="hatch out 7.6"/>
           <p:cNvSpPr/>
           <p:nvPr/>
         </p:nvSpPr>
@@ -12634,7 +12491,7 @@
       </p:sp>
       <p:sp>
         <p:nvSpPr>
-          <p:cNvPr id="39" name="hatch out 7.9"/>
+          <p:cNvPr id="34" name="hatch out 7.9"/>
           <p:cNvSpPr/>
           <p:nvPr/>
         </p:nvSpPr>
@@ -12657,7 +12514,7 @@
       </p:sp>
       <p:sp>
         <p:nvSpPr>
-          <p:cNvPr id="40" name="hatch out 8.2"/>
+          <p:cNvPr id="35" name="hatch out 8.2"/>
           <p:cNvSpPr/>
           <p:nvPr/>
         </p:nvSpPr>
@@ -12680,7 +12537,7 @@
       </p:sp>
       <p:sp>
         <p:nvSpPr>
-          <p:cNvPr id="41" name="hatch out 8.5"/>
+          <p:cNvPr id="36" name="hatch out 8.5"/>
           <p:cNvSpPr/>
           <p:nvPr/>
         </p:nvSpPr>
@@ -12703,7 +12560,7 @@
       </p:sp>
       <p:sp>
         <p:nvSpPr>
-          <p:cNvPr id="42" name="hatch out 8.8"/>
+          <p:cNvPr id="37" name="hatch out 8.8"/>
           <p:cNvSpPr/>
           <p:nvPr/>
         </p:nvSpPr>
@@ -12726,7 +12583,7 @@
       </p:sp>
       <p:sp>
         <p:nvSpPr>
-          <p:cNvPr id="43" name="hatch out 9.1"/>
+          <p:cNvPr id="38" name="hatch out 9.1"/>
           <p:cNvSpPr/>
           <p:nvPr/>
         </p:nvSpPr>
@@ -12749,7 +12606,7 @@
       </p:sp>
       <p:sp>
         <p:nvSpPr>
-          <p:cNvPr id="44" name="hatch out 9.4"/>
+          <p:cNvPr id="39" name="hatch out 9.4"/>
           <p:cNvSpPr/>
           <p:nvPr/>
         </p:nvSpPr>
@@ -12772,7 +12629,7 @@
       </p:sp>
       <p:sp>
         <p:nvSpPr>
-          <p:cNvPr id="45" name="hatch out 9.7"/>
+          <p:cNvPr id="40" name="hatch out 9.7"/>
           <p:cNvSpPr/>
           <p:nvPr/>
         </p:nvSpPr>
@@ -12795,7 +12652,7 @@
       </p:sp>
       <p:sp>
         <p:nvSpPr>
-          <p:cNvPr id="46" name="hatch out 10.0"/>
+          <p:cNvPr id="41" name="hatch out 10.0"/>
           <p:cNvSpPr/>
           <p:nvPr/>
         </p:nvSpPr>
@@ -12818,7 +12675,7 @@
       </p:sp>
       <p:sp>
         <p:nvSpPr>
-          <p:cNvPr id="47" name="hatch out 10.3"/>
+          <p:cNvPr id="42" name="hatch out 10.3"/>
           <p:cNvSpPr/>
           <p:nvPr/>
         </p:nvSpPr>
@@ -12841,7 +12698,7 @@
       </p:sp>
       <p:sp>
         <p:nvSpPr>
-          <p:cNvPr id="48" name="hatch out 10.6"/>
+          <p:cNvPr id="43" name="hatch out 10.6"/>
           <p:cNvSpPr/>
           <p:nvPr/>
         </p:nvSpPr>
@@ -12864,7 +12721,7 @@
       </p:sp>
       <p:sp>
         <p:nvSpPr>
-          <p:cNvPr id="49" name="hatch out 10.9"/>
+          <p:cNvPr id="44" name="hatch out 10.9"/>
           <p:cNvSpPr/>
           <p:nvPr/>
         </p:nvSpPr>
@@ -12887,7 +12744,7 @@
       </p:sp>
       <p:sp>
         <p:nvSpPr>
-          <p:cNvPr id="50" name="hatch out 11.2"/>
+          <p:cNvPr id="45" name="hatch out 11.2"/>
           <p:cNvSpPr/>
           <p:nvPr/>
         </p:nvSpPr>
@@ -12910,7 +12767,7 @@
       </p:sp>
       <p:sp>
         <p:nvSpPr>
-          <p:cNvPr id="51" name="hatch out 11.5"/>
+          <p:cNvPr id="46" name="hatch out 11.5"/>
           <p:cNvSpPr/>
           <p:nvPr/>
         </p:nvSpPr>
@@ -12933,7 +12790,7 @@
       </p:sp>
       <p:sp>
         <p:nvSpPr>
-          <p:cNvPr id="52" name="hatch out 11.8"/>
+          <p:cNvPr id="47" name="hatch out 11.8"/>
           <p:cNvSpPr/>
           <p:nvPr/>
         </p:nvSpPr>
@@ -12956,7 +12813,7 @@
       </p:sp>
       <p:sp>
         <p:nvSpPr>
-          <p:cNvPr id="53" name="hatch out 12.1"/>
+          <p:cNvPr id="48" name="hatch out 12.1"/>
           <p:cNvSpPr/>
           <p:nvPr/>
         </p:nvSpPr>
@@ -12979,7 +12836,7 @@
       </p:sp>
       <p:sp>
         <p:nvSpPr>
-          <p:cNvPr id="54" name="ceiling label out"/>
+          <p:cNvPr id="49" name="ceiling label out"/>
           <p:cNvSpPr txBox="1"/>
           <p:nvPr/>
         </p:nvSpPr>
@@ -13017,7 +12874,7 @@
       </p:sp>
       <p:sp>
         <p:nvSpPr>
-          <p:cNvPr id="55" name="duct out"/>
+          <p:cNvPr id="50" name="duct out"/>
           <p:cNvSpPr/>
           <p:nvPr/>
         </p:nvSpPr>
@@ -13042,7 +12899,7 @@
       </p:sp>
       <p:sp>
         <p:nvSpPr>
-          <p:cNvPr id="56" name="duct label out"/>
+          <p:cNvPr id="51" name="duct label out"/>
           <p:cNvSpPr txBox="1"/>
           <p:nvPr/>
         </p:nvSpPr>
@@ -13078,7 +12935,7 @@
       </p:sp>
       <p:sp>
         <p:nvSpPr>
-          <p:cNvPr id="57" name="pipe a out"/>
+          <p:cNvPr id="52" name="pipe a out"/>
           <p:cNvSpPr/>
           <p:nvPr/>
         </p:nvSpPr>
@@ -13103,7 +12960,7 @@
       </p:sp>
       <p:sp>
         <p:nvSpPr>
-          <p:cNvPr id="58" name="pipe b out"/>
+          <p:cNvPr id="53" name="pipe b out"/>
           <p:cNvSpPr/>
           <p:nvPr/>
         </p:nvSpPr>
@@ -13128,7 +12985,7 @@
       </p:sp>
       <p:sp>
         <p:nvSpPr>
-          <p:cNvPr id="59" name="tray out"/>
+          <p:cNvPr id="54" name="tray out"/>
           <p:cNvSpPr/>
           <p:nvPr/>
         </p:nvSpPr>
@@ -13153,7 +13010,7 @@
       </p:sp>
       <p:sp>
         <p:nvSpPr>
-          <p:cNvPr id="60" name="anchor 0"/>
+          <p:cNvPr id="55" name="anchor 0"/>
           <p:cNvSpPr/>
           <p:nvPr/>
         </p:nvSpPr>
@@ -13173,7 +13030,7 @@
       </p:sp>
       <p:sp>
         <p:nvSpPr>
-          <p:cNvPr id="61" name="rod 0"/>
+          <p:cNvPr id="56" name="rod 0"/>
           <p:cNvSpPr/>
           <p:nvPr/>
         </p:nvSpPr>
@@ -13193,7 +13050,7 @@
       </p:sp>
       <p:sp>
         <p:nvSpPr>
-          <p:cNvPr id="62" name="anchor 1"/>
+          <p:cNvPr id="57" name="anchor 1"/>
           <p:cNvSpPr/>
           <p:nvPr/>
         </p:nvSpPr>
@@ -13213,7 +13070,7 @@
       </p:sp>
       <p:sp>
         <p:nvSpPr>
-          <p:cNvPr id="63" name="rod 1"/>
+          <p:cNvPr id="58" name="rod 1"/>
           <p:cNvSpPr/>
           <p:nvPr/>
         </p:nvSpPr>
@@ -13233,7 +13090,7 @@
       </p:sp>
       <p:sp>
         <p:nvSpPr>
-          <p:cNvPr id="64" name="trapeze bar"/>
+          <p:cNvPr id="59" name="trapeze bar"/>
           <p:cNvSpPr/>
           <p:nvPr/>
         </p:nvSpPr>
@@ -13253,7 +13110,7 @@
       </p:sp>
       <p:sp>
         <p:nvSpPr>
-          <p:cNvPr id="65" name="assembly name"/>
+          <p:cNvPr id="60" name="assembly name"/>
           <p:cNvSpPr txBox="1"/>
           <p:nvPr/>
         </p:nvSpPr>
@@ -13289,7 +13146,7 @@
       </p:sp>
       <p:sp>
         <p:nvSpPr>
-          <p:cNvPr id="66" name="verified"/>
+          <p:cNvPr id="61" name="verified"/>
           <p:cNvSpPr txBox="1"/>
           <p:nvPr/>
         </p:nvSpPr>
@@ -13325,231 +13182,7 @@
       </p:sp>
       <p:sp>
         <p:nvSpPr>
-          <p:cNvPr id="67" name="out caption"/>
-          <p:cNvSpPr txBox="1"/>
-          <p:nvPr/>
-        </p:nvSpPr>
-        <p:spPr>
-          <a:xfrm>
-            <a:off x="6793992" y="4663440"/>
-            <a:ext cx="4846320" cy="502920"/>
-          </a:xfrm>
-          <a:prstGeom prst="rect">
-            <a:avLst/>
-          </a:prstGeom>
-          <a:noFill/>
-          <a:ln/>
-        </p:spPr>
-        <p:txBody>
-          <a:bodyPr wrap="square" lIns="0" tIns="0" rIns="0" bIns="0" rtlCol="0" anchor="t"/>
-          <a:lstStyle/>
-          <a:p>
-            <a:pPr indent="0" marL="0">
-              <a:buNone/>
-            </a:pPr>
-            <a:r>
-              <a:rPr lang="en-US" sz="1200" dirty="0">
-                <a:solidFill>
-                  <a:srgbClr val="52514E"/>
-                </a:solidFill>
-              </a:rPr>
-              <a:t>Up to ten designs, ranked by installed cost</a:t>
-            </a:r>
-            <a:endParaRPr lang="en-US" sz="1200" dirty="0"/>
-          </a:p>
-          <a:p>
-            <a:pPr indent="0" marL="0">
-              <a:buNone/>
-            </a:pPr>
-            <a:r>
-              <a:rPr lang="en-US" sz="1200" dirty="0">
-                <a:solidFill>
-                  <a:srgbClr val="52514E"/>
-                </a:solidFill>
-              </a:rPr>
-              <a:t>Each checked: statics, anchors, connectors, buildability</a:t>
-            </a:r>
-            <a:endParaRPr lang="en-US" sz="1200" dirty="0"/>
-          </a:p>
-        </p:txBody>
-      </p:sp>
-      <p:sp>
-        <p:nvSpPr>
-          <p:cNvPr id="68" name="gloss context"/>
-          <p:cNvSpPr/>
-          <p:nvPr/>
-        </p:nvSpPr>
-        <p:spPr>
-          <a:xfrm>
-            <a:off x="548640" y="5257800"/>
-            <a:ext cx="5454396" cy="777240"/>
-          </a:xfrm>
-          <a:prstGeom prst="roundRect">
-            <a:avLst>
-              <a:gd name="adj" fmla="val 8235"/>
-            </a:avLst>
-          </a:prstGeom>
-          <a:solidFill>
-            <a:schemeClr val="bg2"/>
-          </a:solidFill>
-          <a:ln/>
-        </p:spPr>
-      </p:sp>
-      <p:sp>
-        <p:nvSpPr>
-          <p:cNvPr id="69" name="gloss text context"/>
-          <p:cNvSpPr txBox="1"/>
-          <p:nvPr/>
-        </p:nvSpPr>
-        <p:spPr>
-          <a:xfrm>
-            <a:off x="777240" y="5257800"/>
-            <a:ext cx="4997196" cy="777240"/>
-          </a:xfrm>
-          <a:prstGeom prst="rect">
-            <a:avLst/>
-          </a:prstGeom>
-          <a:noFill/>
-          <a:ln/>
-        </p:spPr>
-        <p:txBody>
-          <a:bodyPr wrap="square" lIns="0" tIns="0" rIns="0" bIns="0" rtlCol="0" anchor="ctr"/>
-          <a:lstStyle/>
-          <a:p>
-            <a:pPr indent="0" marL="0">
-              <a:buNone/>
-            </a:pPr>
-            <a:r>
-              <a:rPr lang="en-US" sz="1300" b="1" dirty="0">
-                <a:solidFill>
-                  <a:schemeClr val="accent1"/>
-                </a:solidFill>
-              </a:rPr>
-              <a:t>Context, the brief: </a:t>
-            </a:r>
-            <a:pPr indent="0" marL="0">
-              <a:buNone/>
-            </a:pPr>
-            <a:r>
-              <a:rPr lang="en-US" sz="1300" dirty="0">
-                <a:solidFill>
-                  <a:schemeClr val="tx1"/>
-                </a:solidFill>
-              </a:rPr>
-              <a:t>the section at one hanger, its structure and services. This is what CrossMEP contains.</a:t>
-            </a:r>
-            <a:endParaRPr lang="en-US" sz="1300" dirty="0"/>
-          </a:p>
-        </p:txBody>
-      </p:sp>
-      <p:sp>
-        <p:nvSpPr>
-          <p:cNvPr id="70" name="gloss assembly"/>
-          <p:cNvSpPr/>
-          <p:nvPr/>
-        </p:nvSpPr>
-        <p:spPr>
-          <a:xfrm>
-            <a:off x="6185916" y="5257800"/>
-            <a:ext cx="5454396" cy="777240"/>
-          </a:xfrm>
-          <a:prstGeom prst="roundRect">
-            <a:avLst>
-              <a:gd name="adj" fmla="val 8235"/>
-            </a:avLst>
-          </a:prstGeom>
-          <a:solidFill>
-            <a:schemeClr val="bg2"/>
-          </a:solidFill>
-          <a:ln/>
-        </p:spPr>
-      </p:sp>
-      <p:sp>
-        <p:nvSpPr>
-          <p:cNvPr id="71" name="gloss text assembly"/>
-          <p:cNvSpPr txBox="1"/>
-          <p:nvPr/>
-        </p:nvSpPr>
-        <p:spPr>
-          <a:xfrm>
-            <a:off x="6414516" y="5257800"/>
-            <a:ext cx="4997196" cy="777240"/>
-          </a:xfrm>
-          <a:prstGeom prst="rect">
-            <a:avLst/>
-          </a:prstGeom>
-          <a:noFill/>
-          <a:ln/>
-        </p:spPr>
-        <p:txBody>
-          <a:bodyPr wrap="square" lIns="0" tIns="0" rIns="0" bIns="0" rtlCol="0" anchor="ctr"/>
-          <a:lstStyle/>
-          <a:p>
-            <a:pPr indent="0" marL="0">
-              <a:buNone/>
-            </a:pPr>
-            <a:r>
-              <a:rPr lang="en-US" sz="1300" b="1" dirty="0">
-                <a:solidFill>
-                  <a:schemeClr val="accent1"/>
-                </a:solidFill>
-              </a:rPr>
-              <a:t>Assembly, the answer: </a:t>
-            </a:r>
-            <a:pPr indent="0" marL="0">
-              <a:buNone/>
-            </a:pPr>
-            <a:r>
-              <a:rPr lang="en-US" sz="1300" dirty="0">
-                <a:solidFill>
-                  <a:schemeClr val="tx1"/>
-                </a:solidFill>
-              </a:rPr>
-              <a:t>catalog parts that carry the services to the structure. Not in CrossMEP: a method produces it.</a:t>
-            </a:r>
-            <a:endParaRPr lang="en-US" sz="1300" dirty="0"/>
-          </a:p>
-        </p:txBody>
-      </p:sp>
-      <p:sp>
-        <p:nvSpPr>
-          <p:cNvPr id="72" name="references"/>
-          <p:cNvSpPr txBox="1"/>
-          <p:nvPr/>
-        </p:nvSpPr>
-        <p:spPr>
-          <a:xfrm>
-            <a:off x="548640" y="6163056"/>
-            <a:ext cx="11091672" cy="237744"/>
-          </a:xfrm>
-          <a:prstGeom prst="rect">
-            <a:avLst/>
-          </a:prstGeom>
-          <a:noFill/>
-          <a:ln/>
-        </p:spPr>
-        <p:txBody>
-          <a:bodyPr wrap="square" lIns="0" tIns="0" rIns="0" bIns="0" rtlCol="0" anchor="b"/>
-          <a:lstStyle/>
-          <a:p>
-            <a:pPr indent="0" marL="0">
-              <a:buNone/>
-            </a:pPr>
-            <a:r>
-              <a:rPr lang="en-US" sz="900" dirty="0">
-                <a:solidFill>
-                  <a:srgbClr val="52514E"/>
-                </a:solidFill>
-              </a:rPr>
-              <a:t>The synthesis problem as defined at ISARC 2026 [1].   [1] Pedrollo, Graeber &amp; Fischer (2026), Feasibility-aware sequential synthesis of structural support assemblies, ISARC 2026</a:t>
-            </a:r>
-            <a:endParaRPr lang="en-US" sz="900" dirty="0"/>
-          </a:p>
-        </p:txBody>
-      </p:sp>
-      <p:sp>
-        <p:nvSpPr>
-          <p:cNvPr id="25" name="Slide Number Placeholder 0"/>
+          <p:cNvPr id="62" name="Slide Number Placeholder 0"/>
           <p:cNvSpPr>
             <a:spLocks noGrp="1"/>
           </p:cNvSpPr>
@@ -15278,14 +14911,41 @@
       </p:sp>
       <p:sp>
         <p:nvSpPr>
-          <p:cNvPr id="33" name="feed up"/>
-          <p:cNvSpPr/>
-          <p:nvPr/>
-        </p:nvSpPr>
-        <p:spPr>
-          <a:xfrm>
-            <a:off x="7251192" y="3566160"/>
-            <a:ext cx="0" cy="502920"/>
+          <p:cNvPr id="33" name="sources frame"/>
+          <p:cNvSpPr/>
+          <p:nvPr/>
+        </p:nvSpPr>
+        <p:spPr>
+          <a:xfrm>
+            <a:off x="548640" y="4005072"/>
+            <a:ext cx="11164824" cy="2048256"/>
+          </a:xfrm>
+          <a:prstGeom prst="roundRect">
+            <a:avLst>
+              <a:gd name="adj" fmla="val 3125"/>
+            </a:avLst>
+          </a:prstGeom>
+          <a:solidFill>
+            <a:schemeClr val="bg2"/>
+          </a:solidFill>
+          <a:ln w="19050">
+            <a:solidFill>
+              <a:schemeClr val="accent1"/>
+            </a:solidFill>
+            <a:prstDash val="solid"/>
+          </a:ln>
+        </p:spPr>
+      </p:sp>
+      <p:sp>
+        <p:nvSpPr>
+          <p:cNvPr id="34" name="callout left"/>
+          <p:cNvSpPr/>
+          <p:nvPr/>
+        </p:nvSpPr>
+        <p:spPr>
+          <a:xfrm>
+            <a:off x="548640" y="3154680"/>
+            <a:ext cx="0" cy="850392"/>
           </a:xfrm>
           <a:prstGeom prst="line">
             <a:avLst/>
@@ -15295,20 +14955,20 @@
             <a:solidFill>
               <a:schemeClr val="accent1"/>
             </a:solidFill>
-            <a:prstDash val="solid"/>
-          </a:ln>
-        </p:spPr>
-      </p:sp>
-      <p:sp>
-        <p:nvSpPr>
-          <p:cNvPr id="34" name="feed across"/>
-          <p:cNvSpPr/>
-          <p:nvPr/>
-        </p:nvSpPr>
-        <p:spPr>
-          <a:xfrm>
-            <a:off x="1600200" y="3566160"/>
-            <a:ext cx="5650992" cy="0"/>
+            <a:prstDash val="sysDot"/>
+          </a:ln>
+        </p:spPr>
+      </p:sp>
+      <p:sp>
+        <p:nvSpPr>
+          <p:cNvPr id="35" name="callout right"/>
+          <p:cNvSpPr/>
+          <p:nvPr/>
+        </p:nvSpPr>
+        <p:spPr>
+          <a:xfrm>
+            <a:off x="2651760" y="3154680"/>
+            <a:ext cx="9061704" cy="850392"/>
           </a:xfrm>
           <a:prstGeom prst="line">
             <a:avLst/>
@@ -15318,80 +14978,20 @@
             <a:solidFill>
               <a:schemeClr val="accent1"/>
             </a:solidFill>
-            <a:prstDash val="solid"/>
-          </a:ln>
-        </p:spPr>
-      </p:sp>
-      <p:sp>
-        <p:nvSpPr>
-          <p:cNvPr id="35" name="feed into context"/>
-          <p:cNvSpPr/>
-          <p:nvPr/>
-        </p:nvSpPr>
-        <p:spPr>
-          <a:xfrm>
-            <a:off x="1600200" y="3154680"/>
-            <a:ext cx="0" cy="411480"/>
-          </a:xfrm>
-          <a:prstGeom prst="line">
-            <a:avLst/>
-          </a:prstGeom>
-          <a:noFill/>
-          <a:ln w="19050">
-            <a:solidFill>
-              <a:schemeClr val="accent1"/>
-            </a:solidFill>
-            <a:prstDash val="solid"/>
-            <a:headEnd type="triangle"/>
-          </a:ln>
-        </p:spPr>
-      </p:sp>
-      <p:sp>
-        <p:nvSpPr>
-          <p:cNvPr id="36" name="label feed"/>
-          <p:cNvSpPr txBox="1"/>
-          <p:nvPr/>
-        </p:nvSpPr>
-        <p:spPr>
-          <a:xfrm>
-            <a:off x="1874520" y="3291840"/>
-            <a:ext cx="5102352" cy="237744"/>
-          </a:xfrm>
-          <a:prstGeom prst="rect">
-            <a:avLst/>
-          </a:prstGeom>
-          <a:noFill/>
-          <a:ln/>
-        </p:spPr>
-        <p:txBody>
-          <a:bodyPr wrap="square" lIns="0" tIns="0" rIns="0" bIns="0" rtlCol="0" anchor="ctr"/>
-          <a:lstStyle/>
-          <a:p>
-            <a:pPr algn="ctr" indent="0" marL="0">
-              <a:buNone/>
-            </a:pPr>
-            <a:r>
-              <a:rPr lang="en-US" sz="1100" dirty="0">
-                <a:solidFill>
-                  <a:schemeClr val="accent1"/>
-                </a:solidFill>
-              </a:rPr>
-              <a:t>a new context every round: thousands of them, each with the brief and no answer</a:t>
-            </a:r>
-            <a:endParaRPr lang="en-US" sz="1100" dirty="0"/>
-          </a:p>
-        </p:txBody>
-      </p:sp>
-      <p:sp>
-        <p:nvSpPr>
-          <p:cNvPr id="37" name="card real"/>
-          <p:cNvSpPr/>
-          <p:nvPr/>
-        </p:nvSpPr>
-        <p:spPr>
-          <a:xfrm>
-            <a:off x="548640" y="4069080"/>
-            <a:ext cx="5394960" cy="1920240"/>
+            <a:prstDash val="sysDot"/>
+          </a:ln>
+        </p:spPr>
+      </p:sp>
+      <p:sp>
+        <p:nvSpPr>
+          <p:cNvPr id="36" name="card real"/>
+          <p:cNvSpPr/>
+          <p:nvPr/>
+        </p:nvSpPr>
+        <p:spPr>
+          <a:xfrm>
+            <a:off x="612648" y="4069080"/>
+            <a:ext cx="5330952" cy="1920240"/>
           </a:xfrm>
           <a:prstGeom prst="roundRect">
             <a:avLst>
@@ -15399,7 +14999,7 @@
             </a:avLst>
           </a:prstGeom>
           <a:solidFill>
-            <a:schemeClr val="bg2"/>
+            <a:srgbClr val="FFFFFF"/>
           </a:solidFill>
           <a:ln w="19050">
             <a:solidFill>
@@ -15411,13 +15011,13 @@
       </p:sp>
       <p:sp>
         <p:nvSpPr>
-          <p:cNvPr id="38" name="card head real"/>
+          <p:cNvPr id="37" name="card head real"/>
           <p:cNvSpPr txBox="1"/>
           <p:nvPr/>
         </p:nvSpPr>
         <p:spPr>
           <a:xfrm>
-            <a:off x="777240" y="4178808"/>
+            <a:off x="841248" y="4178808"/>
             <a:ext cx="2926080" cy="329184"/>
           </a:xfrm>
           <a:prstGeom prst="rect">
@@ -15447,14 +15047,14 @@
       </p:sp>
       <p:sp>
         <p:nvSpPr>
-          <p:cNvPr id="39" name="card tag real"/>
-          <p:cNvSpPr/>
-          <p:nvPr/>
-        </p:nvSpPr>
-        <p:spPr>
-          <a:xfrm>
-            <a:off x="4251960" y="4206240"/>
-            <a:ext cx="1463040" cy="274320"/>
+          <p:cNvPr id="38" name="card tag real"/>
+          <p:cNvSpPr/>
+          <p:nvPr/>
+        </p:nvSpPr>
+        <p:spPr>
+          <a:xfrm>
+            <a:off x="3611880" y="4206240"/>
+            <a:ext cx="2103120" cy="274320"/>
           </a:xfrm>
           <a:prstGeom prst="roundRect">
             <a:avLst>
@@ -15469,14 +15069,14 @@
       </p:sp>
       <p:sp>
         <p:nvSpPr>
-          <p:cNvPr id="40" name="card tag text real"/>
+          <p:cNvPr id="39" name="card tag text real"/>
           <p:cNvSpPr txBox="1"/>
           <p:nvPr/>
         </p:nvSpPr>
         <p:spPr>
           <a:xfrm>
-            <a:off x="4251960" y="4206240"/>
-            <a:ext cx="1463040" cy="274320"/>
+            <a:off x="3611880" y="4206240"/>
+            <a:ext cx="2103120" cy="274320"/>
           </a:xfrm>
           <a:prstGeom prst="rect">
             <a:avLst/>
@@ -15497,7 +15097,7 @@
                   <a:srgbClr val="FFFFFF"/>
                 </a:solidFill>
               </a:rPr>
-              <a:t>too few</a:t>
+              <a:t>too few, not diverse enough</a:t>
             </a:r>
             <a:endParaRPr lang="en-US" sz="1050" dirty="0"/>
           </a:p>
@@ -15505,14 +15105,14 @@
       </p:sp>
       <p:sp>
         <p:nvSpPr>
-          <p:cNvPr id="41" name="card body real"/>
+          <p:cNvPr id="40" name="card body real"/>
           <p:cNvSpPr txBox="1"/>
           <p:nvPr/>
         </p:nvSpPr>
         <p:spPr>
           <a:xfrm>
-            <a:off x="777240" y="5257800"/>
-            <a:ext cx="4937760" cy="640080"/>
+            <a:off x="841248" y="5257800"/>
+            <a:ext cx="4873752" cy="640080"/>
           </a:xfrm>
           <a:prstGeom prst="rect">
             <a:avLst/>
@@ -15541,13 +15141,13 @@
       </p:sp>
       <p:sp>
         <p:nvSpPr>
-          <p:cNvPr id="42" name="mini card real 0"/>
-          <p:cNvSpPr/>
-          <p:nvPr/>
-        </p:nvSpPr>
-        <p:spPr>
-          <a:xfrm>
-            <a:off x="777240" y="4590288"/>
+          <p:cNvPr id="41" name="mini card real 0"/>
+          <p:cNvSpPr/>
+          <p:nvPr/>
+        </p:nvSpPr>
+        <p:spPr>
+          <a:xfrm>
+            <a:off x="841248" y="4590288"/>
             <a:ext cx="548640" cy="475488"/>
           </a:xfrm>
           <a:prstGeom prst="rect">
@@ -15566,13 +15166,13 @@
       </p:sp>
       <p:sp>
         <p:nvSpPr>
-          <p:cNvPr id="43" name="mini slab real 0"/>
-          <p:cNvSpPr/>
-          <p:nvPr/>
-        </p:nvSpPr>
-        <p:spPr>
-          <a:xfrm>
-            <a:off x="822960" y="4636008"/>
+          <p:cNvPr id="42" name="mini slab real 0"/>
+          <p:cNvSpPr/>
+          <p:nvPr/>
+        </p:nvSpPr>
+        <p:spPr>
+          <a:xfrm>
+            <a:off x="886968" y="4636008"/>
             <a:ext cx="457200" cy="32004"/>
           </a:xfrm>
           <a:prstGeom prst="rect">
@@ -15586,13 +15186,13 @@
       </p:sp>
       <p:sp>
         <p:nvSpPr>
-          <p:cNvPr id="44" name="mini real 0 0"/>
-          <p:cNvSpPr/>
-          <p:nvPr/>
-        </p:nvSpPr>
-        <p:spPr>
-          <a:xfrm>
-            <a:off x="907004" y="4709160"/>
+          <p:cNvPr id="43" name="mini real 0 0"/>
+          <p:cNvSpPr/>
+          <p:nvPr/>
+        </p:nvSpPr>
+        <p:spPr>
+          <a:xfrm>
+            <a:off x="971012" y="4709160"/>
             <a:ext cx="60512" cy="60512"/>
           </a:xfrm>
           <a:prstGeom prst="ellipse">
@@ -15611,13 +15211,13 @@
       </p:sp>
       <p:sp>
         <p:nvSpPr>
-          <p:cNvPr id="45" name="mini real 0 1"/>
-          <p:cNvSpPr/>
-          <p:nvPr/>
-        </p:nvSpPr>
-        <p:spPr>
-          <a:xfrm>
-            <a:off x="1021304" y="4709160"/>
+          <p:cNvPr id="44" name="mini real 0 1"/>
+          <p:cNvSpPr/>
+          <p:nvPr/>
+        </p:nvSpPr>
+        <p:spPr>
+          <a:xfrm>
+            <a:off x="1085312" y="4709160"/>
             <a:ext cx="60512" cy="60512"/>
           </a:xfrm>
           <a:prstGeom prst="ellipse">
@@ -15636,13 +15236,13 @@
       </p:sp>
       <p:sp>
         <p:nvSpPr>
-          <p:cNvPr id="46" name="mini real 0 2"/>
-          <p:cNvSpPr/>
-          <p:nvPr/>
-        </p:nvSpPr>
-        <p:spPr>
-          <a:xfrm>
-            <a:off x="1135604" y="4709160"/>
+          <p:cNvPr id="45" name="mini real 0 2"/>
+          <p:cNvSpPr/>
+          <p:nvPr/>
+        </p:nvSpPr>
+        <p:spPr>
+          <a:xfrm>
+            <a:off x="1199612" y="4709160"/>
             <a:ext cx="60512" cy="60512"/>
           </a:xfrm>
           <a:prstGeom prst="ellipse">
@@ -15661,13 +15261,13 @@
       </p:sp>
       <p:sp>
         <p:nvSpPr>
-          <p:cNvPr id="47" name="mini card real 1"/>
-          <p:cNvSpPr/>
-          <p:nvPr/>
-        </p:nvSpPr>
-        <p:spPr>
-          <a:xfrm>
-            <a:off x="1344168" y="4590288"/>
+          <p:cNvPr id="46" name="mini card real 1"/>
+          <p:cNvSpPr/>
+          <p:nvPr/>
+        </p:nvSpPr>
+        <p:spPr>
+          <a:xfrm>
+            <a:off x="1408176" y="4590288"/>
             <a:ext cx="548640" cy="475488"/>
           </a:xfrm>
           <a:prstGeom prst="rect">
@@ -15686,13 +15286,13 @@
       </p:sp>
       <p:sp>
         <p:nvSpPr>
-          <p:cNvPr id="48" name="mini slab real 1"/>
-          <p:cNvSpPr/>
-          <p:nvPr/>
-        </p:nvSpPr>
-        <p:spPr>
-          <a:xfrm>
-            <a:off x="1389888" y="4636008"/>
+          <p:cNvPr id="47" name="mini slab real 1"/>
+          <p:cNvSpPr/>
+          <p:nvPr/>
+        </p:nvSpPr>
+        <p:spPr>
+          <a:xfrm>
+            <a:off x="1453896" y="4636008"/>
             <a:ext cx="457200" cy="32004"/>
           </a:xfrm>
           <a:prstGeom prst="rect">
@@ -15706,13 +15306,13 @@
       </p:sp>
       <p:sp>
         <p:nvSpPr>
-          <p:cNvPr id="49" name="mini real 1 0"/>
-          <p:cNvSpPr/>
-          <p:nvPr/>
-        </p:nvSpPr>
-        <p:spPr>
-          <a:xfrm>
-            <a:off x="1473932" y="4709160"/>
+          <p:cNvPr id="48" name="mini real 1 0"/>
+          <p:cNvSpPr/>
+          <p:nvPr/>
+        </p:nvSpPr>
+        <p:spPr>
+          <a:xfrm>
+            <a:off x="1537940" y="4709160"/>
             <a:ext cx="60512" cy="60512"/>
           </a:xfrm>
           <a:prstGeom prst="ellipse">
@@ -15731,13 +15331,13 @@
       </p:sp>
       <p:sp>
         <p:nvSpPr>
-          <p:cNvPr id="50" name="mini real 1 1"/>
-          <p:cNvSpPr/>
-          <p:nvPr/>
-        </p:nvSpPr>
-        <p:spPr>
-          <a:xfrm>
-            <a:off x="1588232" y="4709160"/>
+          <p:cNvPr id="49" name="mini real 1 1"/>
+          <p:cNvSpPr/>
+          <p:nvPr/>
+        </p:nvSpPr>
+        <p:spPr>
+          <a:xfrm>
+            <a:off x="1652240" y="4709160"/>
             <a:ext cx="60512" cy="60512"/>
           </a:xfrm>
           <a:prstGeom prst="ellipse">
@@ -15756,13 +15356,13 @@
       </p:sp>
       <p:sp>
         <p:nvSpPr>
-          <p:cNvPr id="51" name="mini real 1 2"/>
-          <p:cNvSpPr/>
-          <p:nvPr/>
-        </p:nvSpPr>
-        <p:spPr>
-          <a:xfrm>
-            <a:off x="1702532" y="4709160"/>
+          <p:cNvPr id="50" name="mini real 1 2"/>
+          <p:cNvSpPr/>
+          <p:nvPr/>
+        </p:nvSpPr>
+        <p:spPr>
+          <a:xfrm>
+            <a:off x="1766540" y="4709160"/>
             <a:ext cx="60512" cy="60512"/>
           </a:xfrm>
           <a:prstGeom prst="ellipse">
@@ -15781,13 +15381,13 @@
       </p:sp>
       <p:sp>
         <p:nvSpPr>
-          <p:cNvPr id="52" name="mini card real 2"/>
-          <p:cNvSpPr/>
-          <p:nvPr/>
-        </p:nvSpPr>
-        <p:spPr>
-          <a:xfrm>
-            <a:off x="1911096" y="4590288"/>
+          <p:cNvPr id="51" name="mini card real 2"/>
+          <p:cNvSpPr/>
+          <p:nvPr/>
+        </p:nvSpPr>
+        <p:spPr>
+          <a:xfrm>
+            <a:off x="1975104" y="4590288"/>
             <a:ext cx="548640" cy="475488"/>
           </a:xfrm>
           <a:prstGeom prst="rect">
@@ -15806,13 +15406,13 @@
       </p:sp>
       <p:sp>
         <p:nvSpPr>
-          <p:cNvPr id="53" name="mini slab real 2"/>
-          <p:cNvSpPr/>
-          <p:nvPr/>
-        </p:nvSpPr>
-        <p:spPr>
-          <a:xfrm>
-            <a:off x="1956816" y="4636008"/>
+          <p:cNvPr id="52" name="mini slab real 2"/>
+          <p:cNvSpPr/>
+          <p:nvPr/>
+        </p:nvSpPr>
+        <p:spPr>
+          <a:xfrm>
+            <a:off x="2020824" y="4636008"/>
             <a:ext cx="457200" cy="32004"/>
           </a:xfrm>
           <a:prstGeom prst="rect">
@@ -15826,13 +15426,13 @@
       </p:sp>
       <p:sp>
         <p:nvSpPr>
-          <p:cNvPr id="54" name="mini real 2 0"/>
-          <p:cNvSpPr/>
-          <p:nvPr/>
-        </p:nvSpPr>
-        <p:spPr>
-          <a:xfrm>
-            <a:off x="2040860" y="4709160"/>
+          <p:cNvPr id="53" name="mini real 2 0"/>
+          <p:cNvSpPr/>
+          <p:nvPr/>
+        </p:nvSpPr>
+        <p:spPr>
+          <a:xfrm>
+            <a:off x="2104868" y="4709160"/>
             <a:ext cx="60512" cy="60512"/>
           </a:xfrm>
           <a:prstGeom prst="ellipse">
@@ -15851,13 +15451,13 @@
       </p:sp>
       <p:sp>
         <p:nvSpPr>
-          <p:cNvPr id="55" name="mini real 2 1"/>
-          <p:cNvSpPr/>
-          <p:nvPr/>
-        </p:nvSpPr>
-        <p:spPr>
-          <a:xfrm>
-            <a:off x="2155160" y="4709160"/>
+          <p:cNvPr id="54" name="mini real 2 1"/>
+          <p:cNvSpPr/>
+          <p:nvPr/>
+        </p:nvSpPr>
+        <p:spPr>
+          <a:xfrm>
+            <a:off x="2219168" y="4709160"/>
             <a:ext cx="60512" cy="60512"/>
           </a:xfrm>
           <a:prstGeom prst="ellipse">
@@ -15876,13 +15476,13 @@
       </p:sp>
       <p:sp>
         <p:nvSpPr>
-          <p:cNvPr id="56" name="mini real 2 2"/>
-          <p:cNvSpPr/>
-          <p:nvPr/>
-        </p:nvSpPr>
-        <p:spPr>
-          <a:xfrm>
-            <a:off x="2269460" y="4709160"/>
+          <p:cNvPr id="55" name="mini real 2 2"/>
+          <p:cNvSpPr/>
+          <p:nvPr/>
+        </p:nvSpPr>
+        <p:spPr>
+          <a:xfrm>
+            <a:off x="2333468" y="4709160"/>
             <a:ext cx="60512" cy="60512"/>
           </a:xfrm>
           <a:prstGeom prst="ellipse">
@@ -15901,13 +15501,13 @@
       </p:sp>
       <p:sp>
         <p:nvSpPr>
-          <p:cNvPr id="57" name="mini card real 3"/>
-          <p:cNvSpPr/>
-          <p:nvPr/>
-        </p:nvSpPr>
-        <p:spPr>
-          <a:xfrm>
-            <a:off x="2478024" y="4590288"/>
+          <p:cNvPr id="56" name="mini card real 3"/>
+          <p:cNvSpPr/>
+          <p:nvPr/>
+        </p:nvSpPr>
+        <p:spPr>
+          <a:xfrm>
+            <a:off x="2542032" y="4590288"/>
             <a:ext cx="548640" cy="475488"/>
           </a:xfrm>
           <a:prstGeom prst="rect">
@@ -15926,13 +15526,13 @@
       </p:sp>
       <p:sp>
         <p:nvSpPr>
-          <p:cNvPr id="58" name="mini slab real 3"/>
-          <p:cNvSpPr/>
-          <p:nvPr/>
-        </p:nvSpPr>
-        <p:spPr>
-          <a:xfrm>
-            <a:off x="2523744" y="4636008"/>
+          <p:cNvPr id="57" name="mini slab real 3"/>
+          <p:cNvSpPr/>
+          <p:nvPr/>
+        </p:nvSpPr>
+        <p:spPr>
+          <a:xfrm>
+            <a:off x="2587752" y="4636008"/>
             <a:ext cx="457200" cy="32004"/>
           </a:xfrm>
           <a:prstGeom prst="rect">
@@ -15946,13 +15546,13 @@
       </p:sp>
       <p:sp>
         <p:nvSpPr>
-          <p:cNvPr id="59" name="mini real 3 0"/>
-          <p:cNvSpPr/>
-          <p:nvPr/>
-        </p:nvSpPr>
-        <p:spPr>
-          <a:xfrm>
-            <a:off x="2607788" y="4709160"/>
+          <p:cNvPr id="58" name="mini real 3 0"/>
+          <p:cNvSpPr/>
+          <p:nvPr/>
+        </p:nvSpPr>
+        <p:spPr>
+          <a:xfrm>
+            <a:off x="2671796" y="4709160"/>
             <a:ext cx="60512" cy="60512"/>
           </a:xfrm>
           <a:prstGeom prst="ellipse">
@@ -15971,13 +15571,13 @@
       </p:sp>
       <p:sp>
         <p:nvSpPr>
-          <p:cNvPr id="60" name="mini real 3 1"/>
-          <p:cNvSpPr/>
-          <p:nvPr/>
-        </p:nvSpPr>
-        <p:spPr>
-          <a:xfrm>
-            <a:off x="2722088" y="4709160"/>
+          <p:cNvPr id="59" name="mini real 3 1"/>
+          <p:cNvSpPr/>
+          <p:nvPr/>
+        </p:nvSpPr>
+        <p:spPr>
+          <a:xfrm>
+            <a:off x="2786096" y="4709160"/>
             <a:ext cx="60512" cy="60512"/>
           </a:xfrm>
           <a:prstGeom prst="ellipse">
@@ -15996,13 +15596,13 @@
       </p:sp>
       <p:sp>
         <p:nvSpPr>
-          <p:cNvPr id="61" name="mini real 3 2"/>
-          <p:cNvSpPr/>
-          <p:nvPr/>
-        </p:nvSpPr>
-        <p:spPr>
-          <a:xfrm>
-            <a:off x="2836388" y="4709160"/>
+          <p:cNvPr id="60" name="mini real 3 2"/>
+          <p:cNvSpPr/>
+          <p:nvPr/>
+        </p:nvSpPr>
+        <p:spPr>
+          <a:xfrm>
+            <a:off x="2900396" y="4709160"/>
             <a:ext cx="60512" cy="60512"/>
           </a:xfrm>
           <a:prstGeom prst="ellipse">
@@ -16021,13 +15621,13 @@
       </p:sp>
       <p:sp>
         <p:nvSpPr>
-          <p:cNvPr id="62" name="mini card real 4"/>
-          <p:cNvSpPr/>
-          <p:nvPr/>
-        </p:nvSpPr>
-        <p:spPr>
-          <a:xfrm>
-            <a:off x="3044952" y="4590288"/>
+          <p:cNvPr id="61" name="mini card real 4"/>
+          <p:cNvSpPr/>
+          <p:nvPr/>
+        </p:nvSpPr>
+        <p:spPr>
+          <a:xfrm>
+            <a:off x="3108960" y="4590288"/>
             <a:ext cx="548640" cy="475488"/>
           </a:xfrm>
           <a:prstGeom prst="rect">
@@ -16046,13 +15646,13 @@
       </p:sp>
       <p:sp>
         <p:nvSpPr>
-          <p:cNvPr id="63" name="mini slab real 4"/>
-          <p:cNvSpPr/>
-          <p:nvPr/>
-        </p:nvSpPr>
-        <p:spPr>
-          <a:xfrm>
-            <a:off x="3090672" y="4636008"/>
+          <p:cNvPr id="62" name="mini slab real 4"/>
+          <p:cNvSpPr/>
+          <p:nvPr/>
+        </p:nvSpPr>
+        <p:spPr>
+          <a:xfrm>
+            <a:off x="3154680" y="4636008"/>
             <a:ext cx="457200" cy="32004"/>
           </a:xfrm>
           <a:prstGeom prst="rect">
@@ -16066,13 +15666,13 @@
       </p:sp>
       <p:sp>
         <p:nvSpPr>
-          <p:cNvPr id="64" name="mini real 4 0"/>
-          <p:cNvSpPr/>
-          <p:nvPr/>
-        </p:nvSpPr>
-        <p:spPr>
-          <a:xfrm>
-            <a:off x="3174716" y="4709160"/>
+          <p:cNvPr id="63" name="mini real 4 0"/>
+          <p:cNvSpPr/>
+          <p:nvPr/>
+        </p:nvSpPr>
+        <p:spPr>
+          <a:xfrm>
+            <a:off x="3238724" y="4709160"/>
             <a:ext cx="60512" cy="60512"/>
           </a:xfrm>
           <a:prstGeom prst="ellipse">
@@ -16091,13 +15691,13 @@
       </p:sp>
       <p:sp>
         <p:nvSpPr>
-          <p:cNvPr id="65" name="mini real 4 1"/>
-          <p:cNvSpPr/>
-          <p:nvPr/>
-        </p:nvSpPr>
-        <p:spPr>
-          <a:xfrm>
-            <a:off x="3289016" y="4709160"/>
+          <p:cNvPr id="64" name="mini real 4 1"/>
+          <p:cNvSpPr/>
+          <p:nvPr/>
+        </p:nvSpPr>
+        <p:spPr>
+          <a:xfrm>
+            <a:off x="3353024" y="4709160"/>
             <a:ext cx="60512" cy="60512"/>
           </a:xfrm>
           <a:prstGeom prst="ellipse">
@@ -16116,13 +15716,13 @@
       </p:sp>
       <p:sp>
         <p:nvSpPr>
-          <p:cNvPr id="66" name="mini real 4 2"/>
-          <p:cNvSpPr/>
-          <p:nvPr/>
-        </p:nvSpPr>
-        <p:spPr>
-          <a:xfrm>
-            <a:off x="3403316" y="4709160"/>
+          <p:cNvPr id="65" name="mini real 4 2"/>
+          <p:cNvSpPr/>
+          <p:nvPr/>
+        </p:nvSpPr>
+        <p:spPr>
+          <a:xfrm>
+            <a:off x="3467324" y="4709160"/>
             <a:ext cx="60512" cy="60512"/>
           </a:xfrm>
           <a:prstGeom prst="ellipse">
@@ -16141,13 +15741,13 @@
       </p:sp>
       <p:sp>
         <p:nvSpPr>
-          <p:cNvPr id="67" name="mini card real 5"/>
-          <p:cNvSpPr/>
-          <p:nvPr/>
-        </p:nvSpPr>
-        <p:spPr>
-          <a:xfrm>
-            <a:off x="3611880" y="4590288"/>
+          <p:cNvPr id="66" name="mini card real 5"/>
+          <p:cNvSpPr/>
+          <p:nvPr/>
+        </p:nvSpPr>
+        <p:spPr>
+          <a:xfrm>
+            <a:off x="3675888" y="4590288"/>
             <a:ext cx="548640" cy="475488"/>
           </a:xfrm>
           <a:prstGeom prst="rect">
@@ -16166,13 +15766,13 @@
       </p:sp>
       <p:sp>
         <p:nvSpPr>
-          <p:cNvPr id="68" name="mini slab real 5"/>
-          <p:cNvSpPr/>
-          <p:nvPr/>
-        </p:nvSpPr>
-        <p:spPr>
-          <a:xfrm>
-            <a:off x="3657600" y="4636008"/>
+          <p:cNvPr id="67" name="mini slab real 5"/>
+          <p:cNvSpPr/>
+          <p:nvPr/>
+        </p:nvSpPr>
+        <p:spPr>
+          <a:xfrm>
+            <a:off x="3721608" y="4636008"/>
             <a:ext cx="457200" cy="32004"/>
           </a:xfrm>
           <a:prstGeom prst="rect">
@@ -16186,13 +15786,13 @@
       </p:sp>
       <p:sp>
         <p:nvSpPr>
-          <p:cNvPr id="69" name="mini real 5 0"/>
-          <p:cNvSpPr/>
-          <p:nvPr/>
-        </p:nvSpPr>
-        <p:spPr>
-          <a:xfrm>
-            <a:off x="3741644" y="4709160"/>
+          <p:cNvPr id="68" name="mini real 5 0"/>
+          <p:cNvSpPr/>
+          <p:nvPr/>
+        </p:nvSpPr>
+        <p:spPr>
+          <a:xfrm>
+            <a:off x="3805652" y="4709160"/>
             <a:ext cx="60512" cy="60512"/>
           </a:xfrm>
           <a:prstGeom prst="ellipse">
@@ -16211,13 +15811,13 @@
       </p:sp>
       <p:sp>
         <p:nvSpPr>
-          <p:cNvPr id="70" name="mini real 5 1"/>
-          <p:cNvSpPr/>
-          <p:nvPr/>
-        </p:nvSpPr>
-        <p:spPr>
-          <a:xfrm>
-            <a:off x="3855944" y="4709160"/>
+          <p:cNvPr id="69" name="mini real 5 1"/>
+          <p:cNvSpPr/>
+          <p:nvPr/>
+        </p:nvSpPr>
+        <p:spPr>
+          <a:xfrm>
+            <a:off x="3919952" y="4709160"/>
             <a:ext cx="60512" cy="60512"/>
           </a:xfrm>
           <a:prstGeom prst="ellipse">
@@ -16236,13 +15836,13 @@
       </p:sp>
       <p:sp>
         <p:nvSpPr>
-          <p:cNvPr id="71" name="mini real 5 2"/>
-          <p:cNvSpPr/>
-          <p:nvPr/>
-        </p:nvSpPr>
-        <p:spPr>
-          <a:xfrm>
-            <a:off x="3970244" y="4709160"/>
+          <p:cNvPr id="70" name="mini real 5 2"/>
+          <p:cNvSpPr/>
+          <p:nvPr/>
+        </p:nvSpPr>
+        <p:spPr>
+          <a:xfrm>
+            <a:off x="4034252" y="4709160"/>
             <a:ext cx="60512" cy="60512"/>
           </a:xfrm>
           <a:prstGeom prst="ellipse">
@@ -16261,13 +15861,13 @@
       </p:sp>
       <p:sp>
         <p:nvSpPr>
-          <p:cNvPr id="72" name="empty slot 6"/>
-          <p:cNvSpPr/>
-          <p:nvPr/>
-        </p:nvSpPr>
-        <p:spPr>
-          <a:xfrm>
-            <a:off x="4178808" y="4590288"/>
+          <p:cNvPr id="71" name="empty slot 6"/>
+          <p:cNvSpPr/>
+          <p:nvPr/>
+        </p:nvSpPr>
+        <p:spPr>
+          <a:xfrm>
+            <a:off x="4242816" y="4590288"/>
             <a:ext cx="548640" cy="475488"/>
           </a:xfrm>
           <a:prstGeom prst="rect">
@@ -16283,13 +15883,13 @@
       </p:sp>
       <p:sp>
         <p:nvSpPr>
-          <p:cNvPr id="73" name="empty slot 7"/>
-          <p:cNvSpPr/>
-          <p:nvPr/>
-        </p:nvSpPr>
-        <p:spPr>
-          <a:xfrm>
-            <a:off x="4745736" y="4590288"/>
+          <p:cNvPr id="72" name="empty slot 7"/>
+          <p:cNvSpPr/>
+          <p:nvPr/>
+        </p:nvSpPr>
+        <p:spPr>
+          <a:xfrm>
+            <a:off x="4809744" y="4590288"/>
             <a:ext cx="548640" cy="475488"/>
           </a:xfrm>
           <a:prstGeom prst="rect">
@@ -16305,13 +15905,13 @@
       </p:sp>
       <p:sp>
         <p:nvSpPr>
-          <p:cNvPr id="74" name="empty slot 8"/>
-          <p:cNvSpPr/>
-          <p:nvPr/>
-        </p:nvSpPr>
-        <p:spPr>
-          <a:xfrm>
-            <a:off x="5312664" y="4590288"/>
+          <p:cNvPr id="73" name="empty slot 8"/>
+          <p:cNvSpPr/>
+          <p:nvPr/>
+        </p:nvSpPr>
+        <p:spPr>
+          <a:xfrm>
+            <a:off x="5376672" y="4590288"/>
             <a:ext cx="548640" cy="475488"/>
           </a:xfrm>
           <a:prstGeom prst="rect">
@@ -16327,14 +15927,14 @@
       </p:sp>
       <p:sp>
         <p:nvSpPr>
-          <p:cNvPr id="75" name="card generated"/>
+          <p:cNvPr id="74" name="card generated"/>
           <p:cNvSpPr/>
           <p:nvPr/>
         </p:nvSpPr>
         <p:spPr>
           <a:xfrm>
             <a:off x="6245352" y="4069080"/>
-            <a:ext cx="5394960" cy="1920240"/>
+            <a:ext cx="5330952" cy="1920240"/>
           </a:xfrm>
           <a:prstGeom prst="roundRect">
             <a:avLst>
@@ -16342,7 +15942,7 @@
             </a:avLst>
           </a:prstGeom>
           <a:solidFill>
-            <a:schemeClr val="bg2"/>
+            <a:srgbClr val="FFFFFF"/>
           </a:solidFill>
           <a:ln w="19050">
             <a:solidFill>
@@ -16354,7 +15954,7 @@
       </p:sp>
       <p:sp>
         <p:nvSpPr>
-          <p:cNvPr id="76" name="card head generated"/>
+          <p:cNvPr id="75" name="card head generated"/>
           <p:cNvSpPr txBox="1"/>
           <p:nvPr/>
         </p:nvSpPr>
@@ -16390,13 +15990,13 @@
       </p:sp>
       <p:sp>
         <p:nvSpPr>
-          <p:cNvPr id="77" name="card tag generated"/>
-          <p:cNvSpPr/>
-          <p:nvPr/>
-        </p:nvSpPr>
-        <p:spPr>
-          <a:xfrm>
-            <a:off x="9948672" y="4206240"/>
+          <p:cNvPr id="76" name="card tag generated"/>
+          <p:cNvSpPr/>
+          <p:nvPr/>
+        </p:nvSpPr>
+        <p:spPr>
+          <a:xfrm>
+            <a:off x="9884664" y="4206240"/>
             <a:ext cx="1463040" cy="274320"/>
           </a:xfrm>
           <a:prstGeom prst="roundRect">
@@ -16412,13 +16012,13 @@
       </p:sp>
       <p:sp>
         <p:nvSpPr>
-          <p:cNvPr id="78" name="card tag text generated"/>
+          <p:cNvPr id="77" name="card tag text generated"/>
           <p:cNvSpPr txBox="1"/>
           <p:nvPr/>
         </p:nvSpPr>
         <p:spPr>
           <a:xfrm>
-            <a:off x="9948672" y="4206240"/>
+            <a:off x="9884664" y="4206240"/>
             <a:ext cx="1463040" cy="274320"/>
           </a:xfrm>
           <a:prstGeom prst="rect">
@@ -16440,7 +16040,7 @@
                   <a:srgbClr val="FFFFFF"/>
                 </a:solidFill>
               </a:rPr>
-              <a:t>unlimited</a:t>
+              <a:t>unlimited, diverse</a:t>
             </a:r>
             <a:endParaRPr lang="en-US" sz="1050" dirty="0"/>
           </a:p>
@@ -16448,14 +16048,14 @@
       </p:sp>
       <p:sp>
         <p:nvSpPr>
-          <p:cNvPr id="79" name="card body generated"/>
+          <p:cNvPr id="78" name="card body generated"/>
           <p:cNvSpPr txBox="1"/>
           <p:nvPr/>
         </p:nvSpPr>
         <p:spPr>
           <a:xfrm>
             <a:off x="6473952" y="5257800"/>
-            <a:ext cx="4937760" cy="640080"/>
+            <a:ext cx="4873752" cy="640080"/>
           </a:xfrm>
           <a:prstGeom prst="rect">
             <a:avLst/>
@@ -16484,7 +16084,7 @@
       </p:sp>
       <p:sp>
         <p:nvSpPr>
-          <p:cNvPr id="80" name="mini card gen 1"/>
+          <p:cNvPr id="79" name="mini card gen 1"/>
           <p:cNvSpPr/>
           <p:nvPr/>
         </p:nvSpPr>
@@ -16509,7 +16109,7 @@
       </p:sp>
       <p:sp>
         <p:nvSpPr>
-          <p:cNvPr id="81" name="mini slab gen 1"/>
+          <p:cNvPr id="80" name="mini slab gen 1"/>
           <p:cNvSpPr/>
           <p:nvPr/>
         </p:nvSpPr>
@@ -16529,7 +16129,7 @@
       </p:sp>
       <p:sp>
         <p:nvSpPr>
-          <p:cNvPr id="82" name="mini gen 1 0"/>
+          <p:cNvPr id="81" name="mini gen 1 0"/>
           <p:cNvSpPr/>
           <p:nvPr/>
         </p:nvSpPr>
@@ -16554,7 +16154,7 @@
       </p:sp>
       <p:sp>
         <p:nvSpPr>
-          <p:cNvPr id="83" name="mini card gen 2"/>
+          <p:cNvPr id="82" name="mini card gen 2"/>
           <p:cNvSpPr/>
           <p:nvPr/>
         </p:nvSpPr>
@@ -16579,7 +16179,7 @@
       </p:sp>
       <p:sp>
         <p:nvSpPr>
-          <p:cNvPr id="84" name="mini slab gen 2"/>
+          <p:cNvPr id="83" name="mini slab gen 2"/>
           <p:cNvSpPr/>
           <p:nvPr/>
         </p:nvSpPr>
@@ -16599,7 +16199,7 @@
       </p:sp>
       <p:sp>
         <p:nvSpPr>
-          <p:cNvPr id="85" name="mini gen 2 0"/>
+          <p:cNvPr id="84" name="mini gen 2 0"/>
           <p:cNvSpPr/>
           <p:nvPr/>
         </p:nvSpPr>
@@ -16624,7 +16224,7 @@
       </p:sp>
       <p:sp>
         <p:nvSpPr>
-          <p:cNvPr id="86" name="mini gen 2 1"/>
+          <p:cNvPr id="85" name="mini gen 2 1"/>
           <p:cNvSpPr/>
           <p:nvPr/>
         </p:nvSpPr>
@@ -16649,7 +16249,7 @@
       </p:sp>
       <p:sp>
         <p:nvSpPr>
-          <p:cNvPr id="87" name="mini card gen 3"/>
+          <p:cNvPr id="86" name="mini card gen 3"/>
           <p:cNvSpPr/>
           <p:nvPr/>
         </p:nvSpPr>
@@ -16674,7 +16274,7 @@
       </p:sp>
       <p:sp>
         <p:nvSpPr>
-          <p:cNvPr id="88" name="mini wall gen 3"/>
+          <p:cNvPr id="87" name="mini wall gen 3"/>
           <p:cNvSpPr/>
           <p:nvPr/>
         </p:nvSpPr>
@@ -16694,7 +16294,7 @@
       </p:sp>
       <p:sp>
         <p:nvSpPr>
-          <p:cNvPr id="89" name="mini gen 3 0"/>
+          <p:cNvPr id="88" name="mini gen 3 0"/>
           <p:cNvSpPr/>
           <p:nvPr/>
         </p:nvSpPr>
@@ -16719,7 +16319,7 @@
       </p:sp>
       <p:sp>
         <p:nvSpPr>
-          <p:cNvPr id="90" name="mini gen 3 1"/>
+          <p:cNvPr id="89" name="mini gen 3 1"/>
           <p:cNvSpPr/>
           <p:nvPr/>
         </p:nvSpPr>
@@ -16744,7 +16344,7 @@
       </p:sp>
       <p:sp>
         <p:nvSpPr>
-          <p:cNvPr id="91" name="mini gen 3 2"/>
+          <p:cNvPr id="90" name="mini gen 3 2"/>
           <p:cNvSpPr/>
           <p:nvPr/>
         </p:nvSpPr>
@@ -16769,7 +16369,7 @@
       </p:sp>
       <p:sp>
         <p:nvSpPr>
-          <p:cNvPr id="92" name="mini card gen 4"/>
+          <p:cNvPr id="91" name="mini card gen 4"/>
           <p:cNvSpPr/>
           <p:nvPr/>
         </p:nvSpPr>
@@ -16794,7 +16394,7 @@
       </p:sp>
       <p:sp>
         <p:nvSpPr>
-          <p:cNvPr id="93" name="mini slab gen 4"/>
+          <p:cNvPr id="92" name="mini slab gen 4"/>
           <p:cNvSpPr/>
           <p:nvPr/>
         </p:nvSpPr>
@@ -16814,7 +16414,7 @@
       </p:sp>
       <p:sp>
         <p:nvSpPr>
-          <p:cNvPr id="94" name="mini gen 4 0"/>
+          <p:cNvPr id="93" name="mini gen 4 0"/>
           <p:cNvSpPr/>
           <p:nvPr/>
         </p:nvSpPr>
@@ -16839,7 +16439,7 @@
       </p:sp>
       <p:sp>
         <p:nvSpPr>
-          <p:cNvPr id="95" name="mini gen 4 1"/>
+          <p:cNvPr id="94" name="mini gen 4 1"/>
           <p:cNvSpPr/>
           <p:nvPr/>
         </p:nvSpPr>
@@ -16864,7 +16464,7 @@
       </p:sp>
       <p:sp>
         <p:nvSpPr>
-          <p:cNvPr id="96" name="mini gen 4 2"/>
+          <p:cNvPr id="95" name="mini gen 4 2"/>
           <p:cNvSpPr/>
           <p:nvPr/>
         </p:nvSpPr>
@@ -16889,7 +16489,7 @@
       </p:sp>
       <p:sp>
         <p:nvSpPr>
-          <p:cNvPr id="97" name="mini gen 4 3"/>
+          <p:cNvPr id="96" name="mini gen 4 3"/>
           <p:cNvSpPr/>
           <p:nvPr/>
         </p:nvSpPr>
@@ -16914,7 +16514,7 @@
       </p:sp>
       <p:sp>
         <p:nvSpPr>
-          <p:cNvPr id="98" name="mini card gen 5"/>
+          <p:cNvPr id="97" name="mini card gen 5"/>
           <p:cNvSpPr/>
           <p:nvPr/>
         </p:nvSpPr>
@@ -16939,7 +16539,7 @@
       </p:sp>
       <p:sp>
         <p:nvSpPr>
-          <p:cNvPr id="99" name="mini slab gen 5"/>
+          <p:cNvPr id="98" name="mini slab gen 5"/>
           <p:cNvSpPr/>
           <p:nvPr/>
         </p:nvSpPr>
@@ -16959,7 +16559,7 @@
       </p:sp>
       <p:sp>
         <p:nvSpPr>
-          <p:cNvPr id="100" name="mini gen 5 0"/>
+          <p:cNvPr id="99" name="mini gen 5 0"/>
           <p:cNvSpPr/>
           <p:nvPr/>
         </p:nvSpPr>
@@ -16984,7 +16584,7 @@
       </p:sp>
       <p:sp>
         <p:nvSpPr>
-          <p:cNvPr id="101" name="mini gen 5 1"/>
+          <p:cNvPr id="100" name="mini gen 5 1"/>
           <p:cNvSpPr/>
           <p:nvPr/>
         </p:nvSpPr>
@@ -17009,7 +16609,7 @@
       </p:sp>
       <p:sp>
         <p:nvSpPr>
-          <p:cNvPr id="102" name="mini gen 5 2"/>
+          <p:cNvPr id="101" name="mini gen 5 2"/>
           <p:cNvSpPr/>
           <p:nvPr/>
         </p:nvSpPr>
@@ -17034,7 +16634,7 @@
       </p:sp>
       <p:sp>
         <p:nvSpPr>
-          <p:cNvPr id="103" name="mini gen 5 3"/>
+          <p:cNvPr id="102" name="mini gen 5 3"/>
           <p:cNvSpPr/>
           <p:nvPr/>
         </p:nvSpPr>
@@ -17059,7 +16659,7 @@
       </p:sp>
       <p:sp>
         <p:nvSpPr>
-          <p:cNvPr id="104" name="mini gen 5 4"/>
+          <p:cNvPr id="103" name="mini gen 5 4"/>
           <p:cNvSpPr/>
           <p:nvPr/>
         </p:nvSpPr>
@@ -17084,7 +16684,7 @@
       </p:sp>
       <p:sp>
         <p:nvSpPr>
-          <p:cNvPr id="105" name="mini card gen 6"/>
+          <p:cNvPr id="104" name="mini card gen 6"/>
           <p:cNvSpPr/>
           <p:nvPr/>
         </p:nvSpPr>
@@ -17109,7 +16709,7 @@
       </p:sp>
       <p:sp>
         <p:nvSpPr>
-          <p:cNvPr id="106" name="mini slab gen 6"/>
+          <p:cNvPr id="105" name="mini slab gen 6"/>
           <p:cNvSpPr/>
           <p:nvPr/>
         </p:nvSpPr>
@@ -17129,7 +16729,7 @@
       </p:sp>
       <p:sp>
         <p:nvSpPr>
-          <p:cNvPr id="107" name="mini gen 6 0"/>
+          <p:cNvPr id="106" name="mini gen 6 0"/>
           <p:cNvSpPr/>
           <p:nvPr/>
         </p:nvSpPr>
@@ -17154,7 +16754,7 @@
       </p:sp>
       <p:sp>
         <p:nvSpPr>
-          <p:cNvPr id="108" name="mini gen 6 1"/>
+          <p:cNvPr id="107" name="mini gen 6 1"/>
           <p:cNvSpPr/>
           <p:nvPr/>
         </p:nvSpPr>
@@ -17179,7 +16779,7 @@
       </p:sp>
       <p:sp>
         <p:nvSpPr>
-          <p:cNvPr id="109" name="mini gen 6 2"/>
+          <p:cNvPr id="108" name="mini gen 6 2"/>
           <p:cNvSpPr/>
           <p:nvPr/>
         </p:nvSpPr>
@@ -17204,7 +16804,7 @@
       </p:sp>
       <p:sp>
         <p:nvSpPr>
-          <p:cNvPr id="110" name="mini gen 6 3"/>
+          <p:cNvPr id="109" name="mini gen 6 3"/>
           <p:cNvSpPr/>
           <p:nvPr/>
         </p:nvSpPr>
@@ -17229,7 +16829,7 @@
       </p:sp>
       <p:sp>
         <p:nvSpPr>
-          <p:cNvPr id="111" name="mini gen 6 4"/>
+          <p:cNvPr id="110" name="mini gen 6 4"/>
           <p:cNvSpPr/>
           <p:nvPr/>
         </p:nvSpPr>
@@ -17254,7 +16854,7 @@
       </p:sp>
       <p:sp>
         <p:nvSpPr>
-          <p:cNvPr id="112" name="mini gen 6 5"/>
+          <p:cNvPr id="111" name="mini gen 6 5"/>
           <p:cNvSpPr/>
           <p:nvPr/>
         </p:nvSpPr>
@@ -17279,7 +16879,7 @@
       </p:sp>
       <p:sp>
         <p:nvSpPr>
-          <p:cNvPr id="113" name="mini card gen 7"/>
+          <p:cNvPr id="112" name="mini card gen 7"/>
           <p:cNvSpPr/>
           <p:nvPr/>
         </p:nvSpPr>
@@ -17304,7 +16904,7 @@
       </p:sp>
       <p:sp>
         <p:nvSpPr>
-          <p:cNvPr id="114" name="mini wall gen 7"/>
+          <p:cNvPr id="113" name="mini wall gen 7"/>
           <p:cNvSpPr/>
           <p:nvPr/>
         </p:nvSpPr>
@@ -17324,7 +16924,7 @@
       </p:sp>
       <p:sp>
         <p:nvSpPr>
-          <p:cNvPr id="115" name="mini gen 7 0"/>
+          <p:cNvPr id="114" name="mini gen 7 0"/>
           <p:cNvSpPr/>
           <p:nvPr/>
         </p:nvSpPr>
@@ -17349,7 +16949,7 @@
       </p:sp>
       <p:sp>
         <p:nvSpPr>
-          <p:cNvPr id="116" name="mini gen 7 1"/>
+          <p:cNvPr id="115" name="mini gen 7 1"/>
           <p:cNvSpPr/>
           <p:nvPr/>
         </p:nvSpPr>
@@ -17374,7 +16974,7 @@
       </p:sp>
       <p:sp>
         <p:nvSpPr>
-          <p:cNvPr id="117" name="mini gen 7 2"/>
+          <p:cNvPr id="116" name="mini gen 7 2"/>
           <p:cNvSpPr/>
           <p:nvPr/>
         </p:nvSpPr>
@@ -17399,7 +16999,7 @@
       </p:sp>
       <p:sp>
         <p:nvSpPr>
-          <p:cNvPr id="118" name="mini gen 7 3"/>
+          <p:cNvPr id="117" name="mini gen 7 3"/>
           <p:cNvSpPr/>
           <p:nvPr/>
         </p:nvSpPr>
@@ -17424,7 +17024,7 @@
       </p:sp>
       <p:sp>
         <p:nvSpPr>
-          <p:cNvPr id="119" name="mini gen 7 4"/>
+          <p:cNvPr id="118" name="mini gen 7 4"/>
           <p:cNvSpPr/>
           <p:nvPr/>
         </p:nvSpPr>
@@ -17449,7 +17049,7 @@
       </p:sp>
       <p:sp>
         <p:nvSpPr>
-          <p:cNvPr id="120" name="mini gen 7 5"/>
+          <p:cNvPr id="119" name="mini gen 7 5"/>
           <p:cNvSpPr/>
           <p:nvPr/>
         </p:nvSpPr>
@@ -17474,7 +17074,7 @@
       </p:sp>
       <p:sp>
         <p:nvSpPr>
-          <p:cNvPr id="121" name="mini gen 7 6"/>
+          <p:cNvPr id="120" name="mini gen 7 6"/>
           <p:cNvSpPr/>
           <p:nvPr/>
         </p:nvSpPr>
@@ -17499,7 +17099,7 @@
       </p:sp>
       <p:sp>
         <p:nvSpPr>
-          <p:cNvPr id="122" name="mini card gen 8"/>
+          <p:cNvPr id="121" name="mini card gen 8"/>
           <p:cNvSpPr/>
           <p:nvPr/>
         </p:nvSpPr>
@@ -17524,7 +17124,7 @@
       </p:sp>
       <p:sp>
         <p:nvSpPr>
-          <p:cNvPr id="123" name="mini slab gen 8"/>
+          <p:cNvPr id="122" name="mini slab gen 8"/>
           <p:cNvSpPr/>
           <p:nvPr/>
         </p:nvSpPr>
@@ -17544,7 +17144,7 @@
       </p:sp>
       <p:sp>
         <p:nvSpPr>
-          <p:cNvPr id="124" name="mini gen 8 0"/>
+          <p:cNvPr id="123" name="mini gen 8 0"/>
           <p:cNvSpPr/>
           <p:nvPr/>
         </p:nvSpPr>
@@ -17569,7 +17169,7 @@
       </p:sp>
       <p:sp>
         <p:nvSpPr>
-          <p:cNvPr id="125" name="mini gen 8 1"/>
+          <p:cNvPr id="124" name="mini gen 8 1"/>
           <p:cNvSpPr/>
           <p:nvPr/>
         </p:nvSpPr>
@@ -17594,7 +17194,7 @@
       </p:sp>
       <p:sp>
         <p:nvSpPr>
-          <p:cNvPr id="126" name="mini gen 8 2"/>
+          <p:cNvPr id="125" name="mini gen 8 2"/>
           <p:cNvSpPr/>
           <p:nvPr/>
         </p:nvSpPr>
@@ -17619,7 +17219,7 @@
       </p:sp>
       <p:sp>
         <p:nvSpPr>
-          <p:cNvPr id="127" name="mini gen 8 3"/>
+          <p:cNvPr id="126" name="mini gen 8 3"/>
           <p:cNvSpPr/>
           <p:nvPr/>
         </p:nvSpPr>
@@ -17644,7 +17244,7 @@
       </p:sp>
       <p:sp>
         <p:nvSpPr>
-          <p:cNvPr id="128" name="mini gen 8 4"/>
+          <p:cNvPr id="127" name="mini gen 8 4"/>
           <p:cNvSpPr/>
           <p:nvPr/>
         </p:nvSpPr>
@@ -17669,7 +17269,7 @@
       </p:sp>
       <p:sp>
         <p:nvSpPr>
-          <p:cNvPr id="129" name="mini gen 8 5"/>
+          <p:cNvPr id="128" name="mini gen 8 5"/>
           <p:cNvSpPr/>
           <p:nvPr/>
         </p:nvSpPr>
@@ -17694,7 +17294,7 @@
       </p:sp>
       <p:sp>
         <p:nvSpPr>
-          <p:cNvPr id="130" name="mini gen 8 6"/>
+          <p:cNvPr id="129" name="mini gen 8 6"/>
           <p:cNvSpPr/>
           <p:nvPr/>
         </p:nvSpPr>
@@ -17719,7 +17319,7 @@
       </p:sp>
       <p:sp>
         <p:nvSpPr>
-          <p:cNvPr id="131" name="mini gen 8 7"/>
+          <p:cNvPr id="130" name="mini gen 8 7"/>
           <p:cNvSpPr/>
           <p:nvPr/>
         </p:nvSpPr>
@@ -17744,7 +17344,7 @@
       </p:sp>
       <p:sp>
         <p:nvSpPr>
-          <p:cNvPr id="25" name="Slide Number Placeholder 0"/>
+          <p:cNvPr id="131" name="Slide Number Placeholder 0"/>
           <p:cNvSpPr>
             <a:spLocks noGrp="1"/>
           </p:cNvSpPr>
@@ -24266,7 +23866,7 @@
       </p:sp>
       <p:sp>
         <p:nvSpPr>
-          <p:cNvPr id="25" name="Slide Number Placeholder 0"/>
+          <p:cNvPr id="258" name="Slide Number Placeholder 0"/>
           <p:cNvSpPr>
             <a:spLocks noGrp="1"/>
           </p:cNvSpPr>
@@ -24985,7 +24585,7 @@
       </p:sp>
       <p:graphicFrame>
         <p:nvGraphicFramePr>
-          <p:cNvPr id="8" name="record table"/>
+          <p:cNvPr id="21" name="record table"/>
           <p:cNvGraphicFramePr>
             <a:graphicFrameLocks noGrp="1"/>
           </p:cNvGraphicFramePr>
@@ -27900,7 +27500,7 @@
       </p:sp>
       <p:sp>
         <p:nvSpPr>
-          <p:cNvPr id="25" name="Slide Number Placeholder 0"/>
+          <p:cNvPr id="37" name="Slide Number Placeholder 0"/>
           <p:cNvSpPr>
             <a:spLocks noGrp="1"/>
           </p:cNvSpPr>
@@ -29206,7 +28806,7 @@
       </p:sp>
       <p:sp>
         <p:nvSpPr>
-          <p:cNvPr id="25" name="Slide Number Placeholder 0"/>
+          <p:cNvPr id="40" name="Slide Number Placeholder 0"/>
           <p:cNvSpPr>
             <a:spLocks noGrp="1"/>
           </p:cNvSpPr>
@@ -30817,7 +30417,7 @@
       </p:sp>
       <p:sp>
         <p:nvSpPr>
-          <p:cNvPr id="25" name="Slide Number Placeholder 0"/>
+          <p:cNvPr id="50" name="Slide Number Placeholder 0"/>
           <p:cNvSpPr>
             <a:spLocks noGrp="1"/>
           </p:cNvSpPr>

</xml_diff>

<commit_message>
Talk: build a deck PowerPoint opens without repair, with a schema validator to prove it
The pptx failed OOXML schema validation in four ways: a zoom line on
slide 2 with a negative extent, a repeated <a:pPr> between runs of every
two-colour label, the notes-master list after the slide list, and bar
charts with a third axis id and a misplaced tickLblSkip. The first is
fixed at the call; the builder's post-processing repairs the rest and
throws on any negative extent. scripts/validate_pptx runs the schemas
(Apache POI XMLBeans) over every part: zero errors on this build.
</commit_message>
<xml_diff>
--- a/docs/CrossMEP_CIBW78_talk.pptx
+++ b/docs/CrossMEP_CIBW78_talk.pptx
@@ -4,6 +4,9 @@
   <p:sldMasterIdLst>
     <p:sldMasterId id="2147483648" r:id="rId1"/>
   </p:sldMasterIdLst>
+  <p:notesMasterIdLst>
+    <p:notesMasterId r:id="rId18"/>
+  </p:notesMasterIdLst>
   <p:sldIdLst>
     <p:sldId id="256" r:id="rId2"/>
     <p:sldId id="257" r:id="rId3"/>
@@ -22,9 +25,6 @@
     <p:sldId id="270" r:id="rId16"/>
     <p:sldId id="271" r:id="rId17"/>
   </p:sldIdLst>
-  <p:notesMasterIdLst>
-    <p:notesMasterId r:id="rId18"/>
-  </p:notesMasterIdLst>
   <p:sldSz cx="12192000" cy="6858000"/>
   <p:notesSz cx="6858000" cy="12192000"/>
   <p:defaultTextStyle>
@@ -122,12 +122,12 @@
   <p:extLst>
     <p:ext uri="{521415D9-36F7-43E2-AB2F-B90AF26B5E84}">
       <p14:sectionLst xmlns:p14="http://schemas.microsoft.com/office/powerpoint/2010/main">
-        <p14:section name="Opening" id="{10255f91-07a6-325f-1289-2346353109e2}">
+        <p14:section name="Opening" id="{5e01afed-1ce9-0c66-daf9-ce577f0e8d2e}">
           <p14:sldIdLst>
             <p14:sldId id="256"/>
           </p14:sldIdLst>
         </p14:section>
-        <p14:section name="Motivation" id="{c1531636-c515-da40-e09f-1d275e146f8b}">
+        <p14:section name="Motivation" id="{711b2408-8801-25f9-4255-47c90959a7fe}">
           <p14:sldIdLst>
             <p14:sldId id="257"/>
             <p14:sldId id="258"/>
@@ -136,21 +136,21 @@
             <p14:sldId id="261"/>
           </p14:sldIdLst>
         </p14:section>
-        <p14:section name="The dataset" id="{ea4cb01e-c2ee-c8a4-db9e-d839f32913b9}">
+        <p14:section name="The dataset" id="{c051ae77-5f4f-24fa-c57e-8a31faf11252}">
           <p14:sldIdLst>
             <p14:sldId id="262"/>
             <p14:sldId id="263"/>
             <p14:sldId id="264"/>
           </p14:sldIdLst>
         </p14:section>
-        <p14:section name="Experiments" id="{c0cca296-c535-74d2-99c8-3d14ffb30aba}">
+        <p14:section name="Experiments" id="{6afdbb1e-9228-057d-8094-2fad0976ce21}">
           <p14:sldIdLst>
             <p14:sldId id="265"/>
             <p14:sldId id="266"/>
             <p14:sldId id="267"/>
           </p14:sldIdLst>
         </p14:section>
-        <p14:section name="Use" id="{bfcc802d-e049-1ece-030d-70b5e44e791a}">
+        <p14:section name="Use" id="{ad57052c-04ab-c168-4d7e-002b5d37e527}">
           <p14:sldIdLst>
             <p14:sldId id="268"/>
             <p14:sldId id="269"/>
@@ -462,7 +462,6 @@
         <c:overlap val="0"/>
         <c:axId val="2094734554"/>
         <c:axId val="2094734552"/>
-        <c:axId val="2094734556"/>
       </c:barChart>
       <c:catAx>
         <c:axId val="2094734554"/>
@@ -880,7 +879,6 @@
         <c:overlap val="0"/>
         <c:axId val="2094734554"/>
         <c:axId val="2094734552"/>
-        <c:axId val="2094734556"/>
       </c:barChart>
       <c:catAx>
         <c:axId val="2094734554"/>
@@ -1502,7 +1500,6 @@
         <c:overlap val="0"/>
         <c:axId val="2094734554"/>
         <c:axId val="2094734552"/>
-        <c:axId val="2094734556"/>
       </c:barChart>
       <c:catAx>
         <c:axId val="2094734554"/>
@@ -1572,8 +1569,8 @@
         <c:crosses val="autoZero"/>
         <c:auto val="1"/>
         <c:lblAlgn val="ctr"/>
+        <c:tickLblSkip val="4"/>
         <c:noMultiLvlLbl val="1"/>
-        <c:tickLblSkip val="4"/>
       </c:catAx>
       <c:valAx>
         <c:axId val="2094734552"/>
@@ -2039,7 +2036,6 @@
         <c:overlap val="100"/>
         <c:axId val="2094734554"/>
         <c:axId val="2094734552"/>
-        <c:axId val="2094734556"/>
       </c:barChart>
       <c:catAx>
         <c:axId val="2094734554"/>
@@ -2411,7 +2407,6 @@
         <c:overlap val="0"/>
         <c:axId val="2094734554"/>
         <c:axId val="2094734552"/>
-        <c:axId val="2094734556"/>
       </c:barChart>
       <c:catAx>
         <c:axId val="2094734554"/>
@@ -6843,9 +6838,6 @@
               </a:rPr>
               <a:t>● </a:t>
             </a:r>
-            <a:pPr indent="0" marL="0">
-              <a:buNone/>
-            </a:pPr>
             <a:r>
               <a:rPr lang="en-US" sz="900" dirty="0">
                 <a:solidFill>
@@ -6854,9 +6846,6 @@
               </a:rPr>
               <a:t>generated vs a real model     </a:t>
             </a:r>
-            <a:pPr indent="0" marL="0">
-              <a:buNone/>
-            </a:pPr>
             <a:r>
               <a:rPr lang="en-US" sz="900" dirty="0">
                 <a:solidFill>
@@ -6865,9 +6854,6 @@
               </a:rPr>
               <a:t>● </a:t>
             </a:r>
-            <a:pPr indent="0" marL="0">
-              <a:buNone/>
-            </a:pPr>
             <a:r>
               <a:rPr lang="en-US" sz="900" dirty="0">
                 <a:solidFill>
@@ -6876,9 +6862,6 @@
               </a:rPr>
               <a:t>real vs real     </a:t>
             </a:r>
-            <a:pPr indent="0" marL="0">
-              <a:buNone/>
-            </a:pPr>
             <a:r>
               <a:rPr lang="en-US" sz="900" dirty="0">
                 <a:solidFill>
@@ -9055,9 +9038,6 @@
               </a:rPr>
               <a:t>data = cm.load("benchmark")</a:t>
             </a:r>
-            <a:pPr indent="0" marL="0">
-              <a:buNone/>
-            </a:pPr>
             <a:r>
               <a:rPr lang="en-US" sz="1300" dirty="0">
                 <a:solidFill>
@@ -9103,9 +9083,6 @@
               </a:rPr>
               <a:t>score(my_results, data)</a:t>
             </a:r>
-            <a:pPr indent="0" marL="0">
-              <a:buNone/>
-            </a:pPr>
             <a:r>
               <a:rPr lang="en-US" sz="1300" dirty="0">
                 <a:solidFill>
@@ -10031,9 +10008,6 @@
               </a:rPr>
               <a:t>If you coordinate services or design supports, </a:t>
             </a:r>
-            <a:pPr indent="0" marL="0">
-              <a:buNone/>
-            </a:pPr>
             <a:r>
               <a:rPr lang="en-US" sz="1500" dirty="0">
                 <a:solidFill>
@@ -10977,8 +10951,8 @@
         </p:nvSpPr>
         <p:spPr>
           <a:xfrm flipV="1">
-            <a:off x="3897484" y="2791716"/>
-            <a:ext cx="3051956" cy="-1008636"/>
+            <a:off x="3897484" y="1783080"/>
+            <a:ext cx="3051956" cy="1008636"/>
           </a:xfrm>
           <a:prstGeom prst="line">
             <a:avLst/>
@@ -11231,9 +11205,6 @@
               </a:rPr>
               <a:t>support assemblies </a:t>
             </a:r>
-            <a:pPr indent="0" marL="0">
-              <a:buNone/>
-            </a:pPr>
             <a:r>
               <a:rPr lang="en-US" sz="1200" dirty="0">
                 <a:solidFill>
@@ -11380,9 +11351,6 @@
               </a:rPr>
               <a:t>of engineering time </a:t>
             </a:r>
-            <a:pPr indent="0" marL="0">
-              <a:buNone/>
-            </a:pPr>
             <a:r>
               <a:rPr lang="en-US" sz="1200" dirty="0">
                 <a:solidFill>
@@ -11529,9 +11497,6 @@
               </a:rPr>
               <a:t>of engineering cost </a:t>
             </a:r>
-            <a:pPr indent="0" marL="0">
-              <a:buNone/>
-            </a:pPr>
             <a:r>
               <a:rPr lang="en-US" sz="1200" dirty="0">
                 <a:solidFill>
@@ -17504,9 +17469,6 @@
               </a:rPr>
               <a:t>The real designs we had</a:t>
             </a:r>
-            <a:pPr indent="0" marL="0">
-              <a:buNone/>
-            </a:pPr>
             <a:r>
               <a:rPr lang="en-US" sz="1150" dirty="0">
                 <a:solidFill>
@@ -19085,9 +19047,6 @@
               </a:rPr>
               <a:t>CrossMEP</a:t>
             </a:r>
-            <a:pPr indent="0" marL="0">
-              <a:buNone/>
-            </a:pPr>
             <a:r>
               <a:rPr lang="en-US" sz="1150" dirty="0">
                 <a:solidFill>
@@ -24074,9 +24033,6 @@
               </a:rPr>
               <a:t>● </a:t>
             </a:r>
-            <a:pPr indent="0" marL="0">
-              <a:buNone/>
-            </a:pPr>
             <a:r>
               <a:rPr lang="en-US" sz="900" dirty="0">
                 <a:solidFill>
@@ -24085,9 +24041,6 @@
               </a:rPr>
               <a:t>ventilation   </a:t>
             </a:r>
-            <a:pPr indent="0" marL="0">
-              <a:buNone/>
-            </a:pPr>
             <a:r>
               <a:rPr lang="en-US" sz="900" dirty="0">
                 <a:solidFill>
@@ -24096,9 +24049,6 @@
               </a:rPr>
               <a:t>● </a:t>
             </a:r>
-            <a:pPr indent="0" marL="0">
-              <a:buNone/>
-            </a:pPr>
             <a:r>
               <a:rPr lang="en-US" sz="900" dirty="0">
                 <a:solidFill>
@@ -24107,9 +24057,6 @@
               </a:rPr>
               <a:t>electrical   </a:t>
             </a:r>
-            <a:pPr indent="0" marL="0">
-              <a:buNone/>
-            </a:pPr>
             <a:r>
               <a:rPr lang="en-US" sz="900" dirty="0">
                 <a:solidFill>
@@ -24118,9 +24065,6 @@
               </a:rPr>
               <a:t>● </a:t>
             </a:r>
-            <a:pPr indent="0" marL="0">
-              <a:buNone/>
-            </a:pPr>
             <a:r>
               <a:rPr lang="en-US" sz="900" dirty="0">
                 <a:solidFill>
@@ -25108,9 +25052,6 @@
                         </a:rPr>
                         <a:t>● </a:t>
                       </a:r>
-                      <a:pPr algn="l" indent="0" marL="0">
-                        <a:buNone/>
-                      </a:pPr>
                       <a:r>
                         <a:rPr lang="en-US" sz="1100" dirty="0">
                           <a:solidFill>
@@ -25514,9 +25455,6 @@
                         </a:rPr>
                         <a:t>● </a:t>
                       </a:r>
-                      <a:pPr algn="l" indent="0" marL="0">
-                        <a:buNone/>
-                      </a:pPr>
                       <a:r>
                         <a:rPr lang="en-US" sz="1100" dirty="0">
                           <a:solidFill>
@@ -25920,9 +25858,6 @@
                         </a:rPr>
                         <a:t>● </a:t>
                       </a:r>
-                      <a:pPr algn="l" indent="0" marL="0">
-                        <a:buNone/>
-                      </a:pPr>
                       <a:r>
                         <a:rPr lang="en-US" sz="1100" dirty="0">
                           <a:solidFill>
@@ -26326,9 +26261,6 @@
                         </a:rPr>
                         <a:t>● </a:t>
                       </a:r>
-                      <a:pPr algn="l" indent="0" marL="0">
-                        <a:buNone/>
-                      </a:pPr>
                       <a:r>
                         <a:rPr lang="en-US" sz="1100" dirty="0">
                           <a:solidFill>
@@ -26732,9 +26664,6 @@
                         </a:rPr>
                         <a:t>● </a:t>
                       </a:r>
-                      <a:pPr algn="l" indent="0" marL="0">
-                        <a:buNone/>
-                      </a:pPr>
                       <a:r>
                         <a:rPr lang="en-US" sz="1100" dirty="0">
                           <a:solidFill>
@@ -27483,9 +27412,6 @@
               </a:rPr>
               <a:t>Not given, by design: </a:t>
             </a:r>
-            <a:pPr indent="0" marL="0">
-              <a:buNone/>
-            </a:pPr>
             <a:r>
               <a:rPr lang="en-US" sz="1200" dirty="0">
                 <a:solidFill>
@@ -28673,9 +28599,6 @@
               </a:rPr>
               <a:t>● </a:t>
             </a:r>
-            <a:pPr indent="0" marL="0">
-              <a:buNone/>
-            </a:pPr>
             <a:r>
               <a:rPr lang="en-US" sz="900" dirty="0">
                 <a:solidFill>
@@ -28684,9 +28607,6 @@
               </a:rPr>
               <a:t>ventilation   </a:t>
             </a:r>
-            <a:pPr indent="0" marL="0">
-              <a:buNone/>
-            </a:pPr>
             <a:r>
               <a:rPr lang="en-US" sz="900" dirty="0">
                 <a:solidFill>
@@ -28695,9 +28615,6 @@
               </a:rPr>
               <a:t>● </a:t>
             </a:r>
-            <a:pPr indent="0" marL="0">
-              <a:buNone/>
-            </a:pPr>
             <a:r>
               <a:rPr lang="en-US" sz="900" dirty="0">
                 <a:solidFill>
@@ -28706,9 +28623,6 @@
               </a:rPr>
               <a:t>electrical   </a:t>
             </a:r>
-            <a:pPr indent="0" marL="0">
-              <a:buNone/>
-            </a:pPr>
             <a:r>
               <a:rPr lang="en-US" sz="900" dirty="0">
                 <a:solidFill>
@@ -28717,9 +28631,6 @@
               </a:rPr>
               <a:t>● </a:t>
             </a:r>
-            <a:pPr indent="0" marL="0">
-              <a:buNone/>
-            </a:pPr>
             <a:r>
               <a:rPr lang="en-US" sz="900" dirty="0">
                 <a:solidFill>
@@ -29054,9 +28965,6 @@
               </a:rPr>
               <a:t>Sizes  </a:t>
             </a:r>
-            <a:pPr indent="0" marL="0">
-              <a:buNone/>
-            </a:pPr>
             <a:r>
               <a:rPr lang="en-US" sz="1050" dirty="0">
                 <a:solidFill>
@@ -29079,9 +28987,6 @@
               </a:rPr>
               <a:t>Load  </a:t>
             </a:r>
-            <a:pPr indent="0" marL="0">
-              <a:buNone/>
-            </a:pPr>
             <a:r>
               <a:rPr lang="en-US" sz="1050" dirty="0">
                 <a:solidFill>
@@ -29258,9 +29163,6 @@
               </a:rPr>
               <a:t>Sizes  </a:t>
             </a:r>
-            <a:pPr indent="0" marL="0">
-              <a:buNone/>
-            </a:pPr>
             <a:r>
               <a:rPr lang="en-US" sz="1050" dirty="0">
                 <a:solidFill>
@@ -29283,9 +29185,6 @@
               </a:rPr>
               <a:t>Load  </a:t>
             </a:r>
-            <a:pPr indent="0" marL="0">
-              <a:buNone/>
-            </a:pPr>
             <a:r>
               <a:rPr lang="en-US" sz="1050" dirty="0">
                 <a:solidFill>
@@ -29475,9 +29374,6 @@
               </a:rPr>
               <a:t>Sizes  </a:t>
             </a:r>
-            <a:pPr indent="0" marL="0">
-              <a:buNone/>
-            </a:pPr>
             <a:r>
               <a:rPr lang="en-US" sz="1050" dirty="0">
                 <a:solidFill>
@@ -29500,9 +29396,6 @@
               </a:rPr>
               <a:t>Load  </a:t>
             </a:r>
-            <a:pPr indent="0" marL="0">
-              <a:buNone/>
-            </a:pPr>
             <a:r>
               <a:rPr lang="en-US" sz="1050" dirty="0">
                 <a:solidFill>
@@ -29657,9 +29550,6 @@
               </a:rPr>
               <a:t>Sizes  </a:t>
             </a:r>
-            <a:pPr indent="0" marL="0">
-              <a:buNone/>
-            </a:pPr>
             <a:r>
               <a:rPr lang="en-US" sz="1050" dirty="0">
                 <a:solidFill>
@@ -29682,9 +29572,6 @@
               </a:rPr>
               <a:t>Load  </a:t>
             </a:r>
-            <a:pPr indent="0" marL="0">
-              <a:buNone/>
-            </a:pPr>
             <a:r>
               <a:rPr lang="en-US" sz="1050" dirty="0">
                 <a:solidFill>
@@ -29889,9 +29776,6 @@
               </a:rPr>
               <a:t>Sizes  </a:t>
             </a:r>
-            <a:pPr indent="0" marL="0">
-              <a:buNone/>
-            </a:pPr>
             <a:r>
               <a:rPr lang="en-US" sz="1050" dirty="0">
                 <a:solidFill>
@@ -29914,9 +29798,6 @@
               </a:rPr>
               <a:t>Load  </a:t>
             </a:r>
-            <a:pPr indent="0" marL="0">
-              <a:buNone/>
-            </a:pPr>
             <a:r>
               <a:rPr lang="en-US" sz="1050" dirty="0">
                 <a:solidFill>

</xml_diff>

<commit_message>
Talk: the overall-idea schematic on the title slide
</commit_message>
<xml_diff>
--- a/docs/CrossMEP_CIBW78_talk.pptx
+++ b/docs/CrossMEP_CIBW78_talk.pptx
@@ -122,12 +122,12 @@
   <p:extLst>
     <p:ext uri="{521415D9-36F7-43E2-AB2F-B90AF26B5E84}">
       <p14:sectionLst xmlns:p14="http://schemas.microsoft.com/office/powerpoint/2010/main">
-        <p14:section name="Opening" id="{5e01afed-1ce9-0c66-daf9-ce577f0e8d2e}">
+        <p14:section name="Opening" id="{dddf1e6d-ea8c-6661-94c5-db4b96f5a34c}">
           <p14:sldIdLst>
             <p14:sldId id="256"/>
           </p14:sldIdLst>
         </p14:section>
-        <p14:section name="Motivation" id="{711b2408-8801-25f9-4255-47c90959a7fe}">
+        <p14:section name="Motivation" id="{f3ef74da-c763-4f39-47e3-a0717de1917b}">
           <p14:sldIdLst>
             <p14:sldId id="257"/>
             <p14:sldId id="258"/>
@@ -136,21 +136,21 @@
             <p14:sldId id="261"/>
           </p14:sldIdLst>
         </p14:section>
-        <p14:section name="The dataset" id="{c051ae77-5f4f-24fa-c57e-8a31faf11252}">
+        <p14:section name="The dataset" id="{0b8dcb40-c699-4515-a943-694c6c0cfa3c}">
           <p14:sldIdLst>
             <p14:sldId id="262"/>
             <p14:sldId id="263"/>
             <p14:sldId id="264"/>
           </p14:sldIdLst>
         </p14:section>
-        <p14:section name="Experiments" id="{6afdbb1e-9228-057d-8094-2fad0976ce21}">
+        <p14:section name="Experiments" id="{e984147f-382f-80a4-237a-51a3caf573f5}">
           <p14:sldIdLst>
             <p14:sldId id="265"/>
             <p14:sldId id="266"/>
             <p14:sldId id="267"/>
           </p14:sldIdLst>
         </p14:section>
-        <p14:section name="Use" id="{ad57052c-04ab-c168-4d7e-002b5d37e527}">
+        <p14:section name="Use" id="{9d353080-f9e3-97c4-e0e8-87cd0a889f33}">
           <p14:sldIdLst>
             <p14:sldId id="268"/>
             <p14:sldId id="269"/>
@@ -5279,9 +5279,31 @@
           </a:p>
         </p:txBody>
       </p:sp>
+      <p:sp>
+        <p:nvSpPr>
+          <p:cNvPr id="5" name="title art panel"/>
+          <p:cNvSpPr/>
+          <p:nvPr/>
+        </p:nvSpPr>
+        <p:spPr>
+          <a:xfrm>
+            <a:off x="8479705" y="256032"/>
+            <a:ext cx="3407495" cy="6345936"/>
+          </a:xfrm>
+          <a:prstGeom prst="roundRect">
+            <a:avLst>
+              <a:gd name="adj" fmla="val 2683"/>
+            </a:avLst>
+          </a:prstGeom>
+          <a:solidFill>
+            <a:srgbClr val="FFFFFF"/>
+          </a:solidFill>
+          <a:ln/>
+        </p:spPr>
+      </p:sp>
       <p:pic>
         <p:nvPicPr>
-          <p:cNvPr id="5" name="title art" descr="/home/user/crossmep_dataset/docs/figures/title_art.png">    </p:cNvPr>
+          <p:cNvPr id="6" name="title art" descr="/home/user/crossmep_dataset/docs/CrossMEP_title_art_idea_white.png">    </p:cNvPr>
           <p:cNvPicPr>
             <a:picLocks noChangeAspect="1"/>
           </p:cNvPicPr>
@@ -5295,8 +5317,8 @@
         </p:blipFill>
         <p:spPr>
           <a:xfrm>
-            <a:off x="7772400" y="1463040"/>
-            <a:ext cx="4023360" cy="2514600"/>
+            <a:off x="8589433" y="365760"/>
+            <a:ext cx="3188039" cy="6126480"/>
           </a:xfrm>
           <a:prstGeom prst="rect">
             <a:avLst/>
@@ -5305,49 +5327,13 @@
       </p:pic>
       <p:sp>
         <p:nvSpPr>
-          <p:cNvPr id="6" name="art caption"/>
-          <p:cNvSpPr txBox="1"/>
-          <p:nvPr/>
-        </p:nvSpPr>
-        <p:spPr>
-          <a:xfrm>
-            <a:off x="7772400" y="4069080"/>
-            <a:ext cx="4023360" cy="274320"/>
-          </a:xfrm>
-          <a:prstGeom prst="rect">
-            <a:avLst/>
-          </a:prstGeom>
-          <a:noFill/>
-          <a:ln/>
-        </p:spPr>
-        <p:txBody>
-          <a:bodyPr wrap="square" lIns="0" tIns="0" rIns="0" bIns="0" rtlCol="0" anchor="ctr"/>
-          <a:lstStyle/>
-          <a:p>
-            <a:pPr algn="r" indent="0" marL="0">
-              <a:buNone/>
-            </a:pPr>
-            <a:r>
-              <a:rPr lang="en-US" sz="1000" dirty="0">
-                <a:solidFill>
-                  <a:srgbClr val="CADCFC"/>
-                </a:solidFill>
-              </a:rPr>
-              <a:t>a generated C8 context: eight services on three rows</a:t>
-            </a:r>
-            <a:endParaRPr lang="en-US" sz="1000" dirty="0"/>
-          </a:p>
-        </p:txBody>
-      </p:sp>
-      <p:sp>
-        <p:nvSpPr>
           <p:cNvPr id="7" name="logo chip"/>
           <p:cNvSpPr/>
           <p:nvPr/>
         </p:nvSpPr>
         <p:spPr>
           <a:xfrm>
-            <a:off x="8229600" y="4892040"/>
+            <a:off x="640080" y="5532120"/>
             <a:ext cx="3566160" cy="1188720"/>
           </a:xfrm>
           <a:prstGeom prst="roundRect">
@@ -5377,7 +5363,7 @@
         </p:blipFill>
         <p:spPr>
           <a:xfrm>
-            <a:off x="8412480" y="5078476"/>
+            <a:off x="822960" y="5718556"/>
             <a:ext cx="2011680" cy="815848"/>
           </a:xfrm>
           <a:prstGeom prst="rect">
@@ -5401,7 +5387,7 @@
         </p:blipFill>
         <p:spPr>
           <a:xfrm>
-            <a:off x="10607040" y="5364189"/>
+            <a:off x="3017520" y="6004269"/>
             <a:ext cx="1005840" cy="244423"/>
           </a:xfrm>
           <a:prstGeom prst="rect">

</xml_diff>

<commit_message>
Talk: slides 2 and 3 redrawn, count times time equals effort, named parts and checks
</commit_message>
<xml_diff>
--- a/docs/CrossMEP_CIBW78_talk.pptx
+++ b/docs/CrossMEP_CIBW78_talk.pptx
@@ -122,12 +122,12 @@
   <p:extLst>
     <p:ext uri="{521415D9-36F7-43E2-AB2F-B90AF26B5E84}">
       <p14:sectionLst xmlns:p14="http://schemas.microsoft.com/office/powerpoint/2010/main">
-        <p14:section name="Opening" id="{dddf1e6d-ea8c-6661-94c5-db4b96f5a34c}">
+        <p14:section name="Opening" id="{e9446530-2452-98e5-5e6c-27b3f4b4821c}">
           <p14:sldIdLst>
             <p14:sldId id="256"/>
           </p14:sldIdLst>
         </p14:section>
-        <p14:section name="Motivation" id="{f3ef74da-c763-4f39-47e3-a0717de1917b}">
+        <p14:section name="Motivation" id="{fb6506e2-6730-1a37-1cbd-dae2fb478759}">
           <p14:sldIdLst>
             <p14:sldId id="257"/>
             <p14:sldId id="258"/>
@@ -136,21 +136,21 @@
             <p14:sldId id="261"/>
           </p14:sldIdLst>
         </p14:section>
-        <p14:section name="The dataset" id="{0b8dcb40-c699-4515-a943-694c6c0cfa3c}">
+        <p14:section name="The dataset" id="{55dead16-14fe-c812-5d04-afebdcf01b88}">
           <p14:sldIdLst>
             <p14:sldId id="262"/>
             <p14:sldId id="263"/>
             <p14:sldId id="264"/>
           </p14:sldIdLst>
         </p14:section>
-        <p14:section name="Experiments" id="{e984147f-382f-80a4-237a-51a3caf573f5}">
+        <p14:section name="Experiments" id="{27ba7f4d-723a-81de-47d5-bd23908bd1e5}">
           <p14:sldIdLst>
             <p14:sldId id="265"/>
             <p14:sldId id="266"/>
             <p14:sldId id="267"/>
           </p14:sldIdLst>
         </p14:section>
-        <p14:section name="Use" id="{9d353080-f9e3-97c4-e0e8-87cd0a889f33}">
+        <p14:section name="Use" id="{259df7ca-d0ab-fc76-4fbd-141d18091964}">
           <p14:sldIdLst>
             <p14:sldId id="268"/>
             <p14:sldId id="269"/>
@@ -11059,14 +11059,97 @@
       </p:sp>
       <p:sp>
         <p:nvSpPr>
-          <p:cNvPr id="10" name="tile assemblies"/>
+          <p:cNvPr id="10" name="model chip"/>
+          <p:cNvSpPr/>
+          <p:nvPr/>
+        </p:nvSpPr>
+        <p:spPr>
+          <a:xfrm>
+            <a:off x="685800" y="4245102"/>
+            <a:ext cx="3429000" cy="329184"/>
+          </a:xfrm>
+          <a:prstGeom prst="roundRect">
+            <a:avLst>
+              <a:gd name="adj" fmla="val 50000"/>
+            </a:avLst>
+          </a:prstGeom>
+          <a:solidFill>
+            <a:srgbClr val="FFFFFF"/>
+          </a:solidFill>
+          <a:ln w="9525">
+            <a:solidFill>
+              <a:srgbClr val="E1E0D9"/>
+            </a:solidFill>
+            <a:prstDash val="solid"/>
+          </a:ln>
+        </p:spPr>
+      </p:sp>
+      <p:sp>
+        <p:nvSpPr>
+          <p:cNvPr id="11" name="model chip dot"/>
+          <p:cNvSpPr/>
+          <p:nvPr/>
+        </p:nvSpPr>
+        <p:spPr>
+          <a:xfrm>
+            <a:off x="822960" y="4336542"/>
+            <a:ext cx="146304" cy="146304"/>
+          </a:xfrm>
+          <a:prstGeom prst="ellipse">
+            <a:avLst/>
+          </a:prstGeom>
+          <a:solidFill>
+            <a:srgbClr val="C00000"/>
+          </a:solidFill>
+          <a:ln/>
+        </p:spPr>
+      </p:sp>
+      <p:sp>
+        <p:nvSpPr>
+          <p:cNvPr id="12" name="model chip text"/>
+          <p:cNvSpPr txBox="1"/>
+          <p:nvPr/>
+        </p:nvSpPr>
+        <p:spPr>
+          <a:xfrm>
+            <a:off x="1024128" y="4245102"/>
+            <a:ext cx="3063240" cy="329184"/>
+          </a:xfrm>
+          <a:prstGeom prst="rect">
+            <a:avLst/>
+          </a:prstGeom>
+          <a:noFill/>
+          <a:ln/>
+        </p:spPr>
+        <p:txBody>
+          <a:bodyPr wrap="square" lIns="0" tIns="0" rIns="0" bIns="0" rtlCol="0" anchor="ctr"/>
+          <a:lstStyle/>
+          <a:p>
+            <a:pPr indent="0" marL="0">
+              <a:buNone/>
+            </a:pPr>
+            <a:r>
+              <a:rPr lang="en-US" sz="1050" dirty="0">
+                <a:solidFill>
+                  <a:schemeClr val="tx1"/>
+                </a:solidFill>
+              </a:rPr>
+              <a:t>200,000 sq ft hospital · every red mark is one support</a:t>
+            </a:r>
+            <a:endParaRPr lang="en-US" sz="1050" dirty="0"/>
+          </a:p>
+        </p:txBody>
+      </p:sp>
+      <p:sp>
+        <p:nvSpPr>
+          <p:cNvPr id="13" name="tile assemblies"/>
           <p:cNvSpPr/>
           <p:nvPr/>
         </p:nvSpPr>
         <p:spPr>
           <a:xfrm>
             <a:off x="548640" y="4892040"/>
-            <a:ext cx="3575304" cy="1188720"/>
+            <a:ext cx="3258312" cy="1188720"/>
           </a:xfrm>
           <a:prstGeom prst="roundRect">
             <a:avLst>
@@ -11081,7 +11164,7 @@
       </p:sp>
       <p:sp>
         <p:nvSpPr>
-          <p:cNvPr id="11" name="icon ring assemblies"/>
+          <p:cNvPr id="14" name="icon ring assemblies"/>
           <p:cNvSpPr/>
           <p:nvPr/>
         </p:nvSpPr>
@@ -11101,7 +11184,7 @@
       </p:sp>
       <p:pic>
         <p:nvPicPr>
-          <p:cNvPr id="12" name="icon assemblies" descr="preencoded.png">    </p:cNvPr>
+          <p:cNvPr id="15" name="icon assemblies" descr="preencoded.png">    </p:cNvPr>
           <p:cNvPicPr>
             <a:picLocks noChangeAspect="1"/>
           </p:cNvPicPr>
@@ -11125,14 +11208,14 @@
       </p:pic>
       <p:sp>
         <p:nvSpPr>
-          <p:cNvPr id="13" name="value assemblies"/>
+          <p:cNvPr id="16" name="value assemblies"/>
           <p:cNvSpPr txBox="1"/>
           <p:nvPr/>
         </p:nvSpPr>
         <p:spPr>
           <a:xfrm>
             <a:off x="1554480" y="4956048"/>
-            <a:ext cx="2386584" cy="548640"/>
+            <a:ext cx="2115312" cy="548640"/>
           </a:xfrm>
           <a:prstGeom prst="rect">
             <a:avLst/>
@@ -11161,14 +11244,14 @@
       </p:sp>
       <p:sp>
         <p:nvSpPr>
-          <p:cNvPr id="14" name="label assemblies"/>
+          <p:cNvPr id="17" name="label assemblies"/>
           <p:cNvSpPr txBox="1"/>
           <p:nvPr/>
         </p:nvSpPr>
         <p:spPr>
           <a:xfrm>
             <a:off x="1554480" y="5504688"/>
-            <a:ext cx="2386584" cy="530352"/>
+            <a:ext cx="2115312" cy="548640"/>
           </a:xfrm>
           <a:prstGeom prst="rect">
             <a:avLst/>
@@ -11184,7 +11267,7 @@
               <a:buNone/>
             </a:pPr>
             <a:r>
-              <a:rPr lang="en-US" sz="1200" b="1" dirty="0">
+              <a:rPr lang="en-US" sz="1150" b="1" dirty="0">
                 <a:solidFill>
                   <a:srgbClr val="C00000"/>
                 </a:solidFill>
@@ -11192,27 +11275,88 @@
               <a:t>support assemblies </a:t>
             </a:r>
             <a:r>
-              <a:rPr lang="en-US" sz="1200" dirty="0">
+              <a:rPr lang="en-US" sz="1150" dirty="0">
                 <a:solidFill>
                   <a:srgbClr val="52514E"/>
                 </a:solidFill>
               </a:rPr>
-              <a:t>in one 200,000 sq ft hospital project</a:t>
+              <a:t>in one hospital project, each one its own design</a:t>
             </a:r>
-            <a:endParaRPr lang="en-US" sz="1200" dirty="0"/>
+            <a:endParaRPr lang="en-US" sz="1150" dirty="0"/>
           </a:p>
         </p:txBody>
       </p:sp>
       <p:sp>
         <p:nvSpPr>
-          <p:cNvPr id="15" name="tile time"/>
-          <p:cNvSpPr/>
-          <p:nvPr/>
-        </p:nvSpPr>
-        <p:spPr>
-          <a:xfrm>
-            <a:off x="4306824" y="4892040"/>
-            <a:ext cx="3575304" cy="1188720"/>
+          <p:cNvPr id="18" name="op times"/>
+          <p:cNvSpPr/>
+          <p:nvPr/>
+        </p:nvSpPr>
+        <p:spPr>
+          <a:xfrm>
+            <a:off x="3944112" y="5294376"/>
+            <a:ext cx="384048" cy="384048"/>
+          </a:xfrm>
+          <a:prstGeom prst="ellipse">
+            <a:avLst/>
+          </a:prstGeom>
+          <a:solidFill>
+            <a:srgbClr val="FFFFFF"/>
+          </a:solidFill>
+          <a:ln w="19050">
+            <a:solidFill>
+              <a:srgbClr val="C00000"/>
+            </a:solidFill>
+            <a:prstDash val="solid"/>
+          </a:ln>
+        </p:spPr>
+      </p:sp>
+      <p:sp>
+        <p:nvSpPr>
+          <p:cNvPr id="19" name="op text times"/>
+          <p:cNvSpPr txBox="1"/>
+          <p:nvPr/>
+        </p:nvSpPr>
+        <p:spPr>
+          <a:xfrm>
+            <a:off x="3944112" y="5294376"/>
+            <a:ext cx="384048" cy="384048"/>
+          </a:xfrm>
+          <a:prstGeom prst="rect">
+            <a:avLst/>
+          </a:prstGeom>
+          <a:noFill/>
+          <a:ln/>
+        </p:spPr>
+        <p:txBody>
+          <a:bodyPr wrap="square" lIns="0" tIns="0" rIns="0" bIns="0" rtlCol="0" anchor="ctr"/>
+          <a:lstStyle/>
+          <a:p>
+            <a:pPr algn="ctr" indent="0" marL="0">
+              <a:buNone/>
+            </a:pPr>
+            <a:r>
+              <a:rPr lang="en-US" sz="1800" b="1" dirty="0">
+                <a:solidFill>
+                  <a:srgbClr val="C00000"/>
+                </a:solidFill>
+              </a:rPr>
+              <a:t>×</a:t>
+            </a:r>
+            <a:endParaRPr lang="en-US" sz="1800" dirty="0"/>
+          </a:p>
+        </p:txBody>
+      </p:sp>
+      <p:sp>
+        <p:nvSpPr>
+          <p:cNvPr id="20" name="tile time"/>
+          <p:cNvSpPr/>
+          <p:nvPr/>
+        </p:nvSpPr>
+        <p:spPr>
+          <a:xfrm>
+            <a:off x="4465320" y="4892040"/>
+            <a:ext cx="3258312" cy="1188720"/>
           </a:xfrm>
           <a:prstGeom prst="roundRect">
             <a:avLst>
@@ -11227,13 +11371,13 @@
       </p:sp>
       <p:sp>
         <p:nvSpPr>
-          <p:cNvPr id="16" name="icon ring time"/>
-          <p:cNvSpPr/>
-          <p:nvPr/>
-        </p:nvSpPr>
-        <p:spPr>
-          <a:xfrm>
-            <a:off x="4535424" y="5193792"/>
+          <p:cNvPr id="21" name="icon ring time"/>
+          <p:cNvSpPr/>
+          <p:nvPr/>
+        </p:nvSpPr>
+        <p:spPr>
+          <a:xfrm>
+            <a:off x="4693920" y="5193792"/>
             <a:ext cx="585216" cy="585216"/>
           </a:xfrm>
           <a:prstGeom prst="ellipse">
@@ -11247,7 +11391,7 @@
       </p:sp>
       <p:pic>
         <p:nvPicPr>
-          <p:cNvPr id="17" name="icon time" descr="preencoded.png">    </p:cNvPr>
+          <p:cNvPr id="22" name="icon time" descr="preencoded.png">    </p:cNvPr>
           <p:cNvPicPr>
             <a:picLocks noChangeAspect="1"/>
           </p:cNvPicPr>
@@ -11261,7 +11405,7 @@
         </p:blipFill>
         <p:spPr>
           <a:xfrm>
-            <a:off x="4658319" y="5316687"/>
+            <a:off x="4816815" y="5316687"/>
             <a:ext cx="339425" cy="339425"/>
           </a:xfrm>
           <a:prstGeom prst="rect">
@@ -11271,14 +11415,14 @@
       </p:pic>
       <p:sp>
         <p:nvSpPr>
-          <p:cNvPr id="18" name="value time"/>
+          <p:cNvPr id="23" name="value time"/>
           <p:cNvSpPr txBox="1"/>
           <p:nvPr/>
         </p:nvSpPr>
         <p:spPr>
           <a:xfrm>
-            <a:off x="5312664" y="4956048"/>
-            <a:ext cx="2386584" cy="548640"/>
+            <a:off x="5471160" y="4956048"/>
+            <a:ext cx="2115312" cy="548640"/>
           </a:xfrm>
           <a:prstGeom prst="rect">
             <a:avLst/>
@@ -11307,14 +11451,14 @@
       </p:sp>
       <p:sp>
         <p:nvSpPr>
-          <p:cNvPr id="19" name="label time"/>
+          <p:cNvPr id="24" name="label time"/>
           <p:cNvSpPr txBox="1"/>
           <p:nvPr/>
         </p:nvSpPr>
         <p:spPr>
           <a:xfrm>
-            <a:off x="5312664" y="5504688"/>
-            <a:ext cx="2386584" cy="530352"/>
+            <a:off x="5471160" y="5504688"/>
+            <a:ext cx="2115312" cy="548640"/>
           </a:xfrm>
           <a:prstGeom prst="rect">
             <a:avLst/>
@@ -11330,7 +11474,7 @@
               <a:buNone/>
             </a:pPr>
             <a:r>
-              <a:rPr lang="en-US" sz="1200" b="1" dirty="0">
+              <a:rPr lang="en-US" sz="1150" b="1" dirty="0">
                 <a:solidFill>
                   <a:srgbClr val="C00000"/>
                 </a:solidFill>
@@ -11338,27 +11482,88 @@
               <a:t>of engineering time </a:t>
             </a:r>
             <a:r>
-              <a:rPr lang="en-US" sz="1200" dirty="0">
+              <a:rPr lang="en-US" sz="1150" dirty="0">
                 <a:solidFill>
                   <a:srgbClr val="52514E"/>
                 </a:solidFill>
               </a:rPr>
               <a:t>for each assembly, designed one by one</a:t>
             </a:r>
-            <a:endParaRPr lang="en-US" sz="1200" dirty="0"/>
+            <a:endParaRPr lang="en-US" sz="1150" dirty="0"/>
           </a:p>
         </p:txBody>
       </p:sp>
       <p:sp>
         <p:nvSpPr>
-          <p:cNvPr id="20" name="tile effort"/>
-          <p:cNvSpPr/>
-          <p:nvPr/>
-        </p:nvSpPr>
-        <p:spPr>
-          <a:xfrm>
-            <a:off x="8065008" y="4892040"/>
-            <a:ext cx="3575304" cy="1188720"/>
+          <p:cNvPr id="25" name="op equals"/>
+          <p:cNvSpPr/>
+          <p:nvPr/>
+        </p:nvSpPr>
+        <p:spPr>
+          <a:xfrm>
+            <a:off x="7860792" y="5294376"/>
+            <a:ext cx="384048" cy="384048"/>
+          </a:xfrm>
+          <a:prstGeom prst="ellipse">
+            <a:avLst/>
+          </a:prstGeom>
+          <a:solidFill>
+            <a:srgbClr val="FFFFFF"/>
+          </a:solidFill>
+          <a:ln w="19050">
+            <a:solidFill>
+              <a:srgbClr val="C00000"/>
+            </a:solidFill>
+            <a:prstDash val="solid"/>
+          </a:ln>
+        </p:spPr>
+      </p:sp>
+      <p:sp>
+        <p:nvSpPr>
+          <p:cNvPr id="26" name="op text equals"/>
+          <p:cNvSpPr txBox="1"/>
+          <p:nvPr/>
+        </p:nvSpPr>
+        <p:spPr>
+          <a:xfrm>
+            <a:off x="7860792" y="5294376"/>
+            <a:ext cx="384048" cy="384048"/>
+          </a:xfrm>
+          <a:prstGeom prst="rect">
+            <a:avLst/>
+          </a:prstGeom>
+          <a:noFill/>
+          <a:ln/>
+        </p:spPr>
+        <p:txBody>
+          <a:bodyPr wrap="square" lIns="0" tIns="0" rIns="0" bIns="0" rtlCol="0" anchor="ctr"/>
+          <a:lstStyle/>
+          <a:p>
+            <a:pPr algn="ctr" indent="0" marL="0">
+              <a:buNone/>
+            </a:pPr>
+            <a:r>
+              <a:rPr lang="en-US" sz="1800" b="1" dirty="0">
+                <a:solidFill>
+                  <a:srgbClr val="C00000"/>
+                </a:solidFill>
+              </a:rPr>
+              <a:t>=</a:t>
+            </a:r>
+            <a:endParaRPr lang="en-US" sz="1800" dirty="0"/>
+          </a:p>
+        </p:txBody>
+      </p:sp>
+      <p:sp>
+        <p:nvSpPr>
+          <p:cNvPr id="27" name="tile effort"/>
+          <p:cNvSpPr/>
+          <p:nvPr/>
+        </p:nvSpPr>
+        <p:spPr>
+          <a:xfrm>
+            <a:off x="8382000" y="4892040"/>
+            <a:ext cx="3258312" cy="1188720"/>
           </a:xfrm>
           <a:prstGeom prst="roundRect">
             <a:avLst>
@@ -11373,13 +11578,13 @@
       </p:sp>
       <p:sp>
         <p:nvSpPr>
-          <p:cNvPr id="21" name="icon ring effort"/>
-          <p:cNvSpPr/>
-          <p:nvPr/>
-        </p:nvSpPr>
-        <p:spPr>
-          <a:xfrm>
-            <a:off x="8293608" y="5193792"/>
+          <p:cNvPr id="28" name="icon ring effort"/>
+          <p:cNvSpPr/>
+          <p:nvPr/>
+        </p:nvSpPr>
+        <p:spPr>
+          <a:xfrm>
+            <a:off x="8610600" y="5193792"/>
             <a:ext cx="585216" cy="585216"/>
           </a:xfrm>
           <a:prstGeom prst="ellipse">
@@ -11393,7 +11598,7 @@
       </p:sp>
       <p:pic>
         <p:nvPicPr>
-          <p:cNvPr id="22" name="icon effort" descr="preencoded.png">    </p:cNvPr>
+          <p:cNvPr id="29" name="icon effort" descr="preencoded.png">    </p:cNvPr>
           <p:cNvPicPr>
             <a:picLocks noChangeAspect="1"/>
           </p:cNvPicPr>
@@ -11407,7 +11612,7 @@
         </p:blipFill>
         <p:spPr>
           <a:xfrm>
-            <a:off x="8416503" y="5316687"/>
+            <a:off x="8733495" y="5316687"/>
             <a:ext cx="339425" cy="339425"/>
           </a:xfrm>
           <a:prstGeom prst="rect">
@@ -11417,14 +11622,14 @@
       </p:pic>
       <p:sp>
         <p:nvSpPr>
-          <p:cNvPr id="23" name="value effort"/>
+          <p:cNvPr id="30" name="value effort"/>
           <p:cNvSpPr txBox="1"/>
           <p:nvPr/>
         </p:nvSpPr>
         <p:spPr>
           <a:xfrm>
-            <a:off x="9070848" y="4956048"/>
-            <a:ext cx="2386584" cy="548640"/>
+            <a:off x="9387840" y="4956048"/>
+            <a:ext cx="2115312" cy="548640"/>
           </a:xfrm>
           <a:prstGeom prst="rect">
             <a:avLst/>
@@ -11445,7 +11650,7 @@
                   <a:srgbClr val="C00000"/>
                 </a:solidFill>
               </a:rPr>
-              <a:t>≈ $600k</a:t>
+              <a:t>≈ 25 %</a:t>
             </a:r>
             <a:endParaRPr lang="en-US" sz="2800" dirty="0"/>
           </a:p>
@@ -11453,14 +11658,14 @@
       </p:sp>
       <p:sp>
         <p:nvSpPr>
-          <p:cNvPr id="24" name="label effort"/>
+          <p:cNvPr id="31" name="label effort"/>
           <p:cNvSpPr txBox="1"/>
           <p:nvPr/>
         </p:nvSpPr>
         <p:spPr>
           <a:xfrm>
-            <a:off x="9070848" y="5504688"/>
-            <a:ext cx="2386584" cy="530352"/>
+            <a:off x="9387840" y="5504688"/>
+            <a:ext cx="2115312" cy="548640"/>
           </a:xfrm>
           <a:prstGeom prst="rect">
             <a:avLst/>
@@ -11476,28 +11681,28 @@
               <a:buNone/>
             </a:pPr>
             <a:r>
-              <a:rPr lang="en-US" sz="1200" b="1" dirty="0">
+              <a:rPr lang="en-US" sz="1150" b="1" dirty="0">
                 <a:solidFill>
                   <a:srgbClr val="C00000"/>
                 </a:solidFill>
               </a:rPr>
-              <a:t>of engineering cost </a:t>
+              <a:t>of MEP design effort, </a:t>
             </a:r>
             <a:r>
-              <a:rPr lang="en-US" sz="1200" dirty="0">
+              <a:rPr lang="en-US" sz="1150" dirty="0">
                 <a:solidFill>
                   <a:srgbClr val="52514E"/>
                 </a:solidFill>
               </a:rPr>
-              <a:t>cumulative per hospital project</a:t>
+              <a:t>about $600k of engineering cost per project</a:t>
             </a:r>
-            <a:endParaRPr lang="en-US" sz="1200" dirty="0"/>
+            <a:endParaRPr lang="en-US" sz="1150" dirty="0"/>
           </a:p>
         </p:txBody>
       </p:sp>
       <p:sp>
         <p:nvSpPr>
-          <p:cNvPr id="25" name="references"/>
+          <p:cNvPr id="32" name="references"/>
           <p:cNvSpPr txBox="1"/>
           <p:nvPr/>
         </p:nvSpPr>
@@ -11533,7 +11738,7 @@
       </p:sp>
       <p:sp>
         <p:nvSpPr>
-          <p:cNvPr id="26" name="Slide Number Placeholder 0"/>
+          <p:cNvPr id="33" name="Slide Number Placeholder 0"/>
           <p:cNvSpPr>
             <a:spLocks noGrp="1"/>
           </p:cNvSpPr>
@@ -11647,35 +11852,93 @@
         </p:nvSpPr>
         <p:spPr>
           <a:xfrm>
-            <a:off x="548640" y="1828800"/>
-            <a:ext cx="4846320" cy="2743200"/>
+            <a:off x="548640" y="1600200"/>
+            <a:ext cx="5029200" cy="3977640"/>
           </a:xfrm>
           <a:prstGeom prst="roundRect">
             <a:avLst>
-              <a:gd name="adj" fmla="val 2000"/>
+              <a:gd name="adj" fmla="val 1379"/>
             </a:avLst>
           </a:prstGeom>
           <a:solidFill>
             <a:srgbClr val="FFFFFF"/>
           </a:solidFill>
-          <a:ln w="12700">
-            <a:solidFill>
-              <a:srgbClr val="E1E0D9"/>
-            </a:solidFill>
-            <a:prstDash val="solid"/>
-          </a:ln>
-        </p:spPr>
-      </p:sp>
-      <p:sp>
-        <p:nvSpPr>
-          <p:cNvPr id="4" name="ceiling in"/>
-          <p:cNvSpPr/>
-          <p:nvPr/>
-        </p:nvSpPr>
-        <p:spPr>
-          <a:xfrm>
-            <a:off x="731520" y="2011680"/>
-            <a:ext cx="4480560" cy="384048"/>
+          <a:ln w="15875">
+            <a:solidFill>
+              <a:schemeClr val="accent1"/>
+            </a:solidFill>
+            <a:prstDash val="solid"/>
+          </a:ln>
+        </p:spPr>
+      </p:sp>
+      <p:sp>
+        <p:nvSpPr>
+          <p:cNvPr id="4" name="tab context"/>
+          <p:cNvSpPr/>
+          <p:nvPr/>
+        </p:nvSpPr>
+        <p:spPr>
+          <a:xfrm>
+            <a:off x="777240" y="1444752"/>
+            <a:ext cx="2377440" cy="310896"/>
+          </a:xfrm>
+          <a:prstGeom prst="roundRect">
+            <a:avLst>
+              <a:gd name="adj" fmla="val 50000"/>
+            </a:avLst>
+          </a:prstGeom>
+          <a:solidFill>
+            <a:schemeClr val="accent1"/>
+          </a:solidFill>
+          <a:ln/>
+        </p:spPr>
+      </p:sp>
+      <p:sp>
+        <p:nvSpPr>
+          <p:cNvPr id="5" name="tab text context"/>
+          <p:cNvSpPr txBox="1"/>
+          <p:nvPr/>
+        </p:nvSpPr>
+        <p:spPr>
+          <a:xfrm>
+            <a:off x="777240" y="1444752"/>
+            <a:ext cx="2377440" cy="310896"/>
+          </a:xfrm>
+          <a:prstGeom prst="rect">
+            <a:avLst/>
+          </a:prstGeom>
+          <a:noFill/>
+          <a:ln/>
+        </p:spPr>
+        <p:txBody>
+          <a:bodyPr wrap="square" lIns="0" tIns="0" rIns="0" bIns="0" rtlCol="0" anchor="ctr"/>
+          <a:lstStyle/>
+          <a:p>
+            <a:pPr algn="ctr" indent="0" marL="0">
+              <a:buNone/>
+            </a:pPr>
+            <a:r>
+              <a:rPr lang="en-US" sz="1100" b="1" dirty="0">
+                <a:solidFill>
+                  <a:srgbClr val="FFFFFF"/>
+                </a:solidFill>
+              </a:rPr>
+              <a:t>CONTEXT  ·  the brief</a:t>
+            </a:r>
+            <a:endParaRPr lang="en-US" sz="1100" dirty="0"/>
+          </a:p>
+        </p:txBody>
+      </p:sp>
+      <p:sp>
+        <p:nvSpPr>
+          <p:cNvPr id="6" name="ceiling in"/>
+          <p:cNvSpPr/>
+          <p:nvPr/>
+        </p:nvSpPr>
+        <p:spPr>
+          <a:xfrm>
+            <a:off x="777240" y="1965960"/>
+            <a:ext cx="4572000" cy="384048"/>
           </a:xfrm>
           <a:prstGeom prst="rect">
             <a:avLst/>
@@ -11693,13 +11956,13 @@
       </p:sp>
       <p:sp>
         <p:nvSpPr>
-          <p:cNvPr id="5" name="hatch in 0.8"/>
+          <p:cNvPr id="7" name="hatch in 0.8"/>
           <p:cNvSpPr/>
           <p:nvPr/>
         </p:nvSpPr>
         <p:spPr>
           <a:xfrm flipV="1">
-            <a:off x="731520" y="2011680"/>
+            <a:off x="777240" y="1965960"/>
             <a:ext cx="274320" cy="384048"/>
           </a:xfrm>
           <a:prstGeom prst="line">
@@ -11716,13 +11979,13 @@
       </p:sp>
       <p:sp>
         <p:nvSpPr>
-          <p:cNvPr id="6" name="hatch in 1.1"/>
+          <p:cNvPr id="8" name="hatch in 1.1"/>
           <p:cNvSpPr/>
           <p:nvPr/>
         </p:nvSpPr>
         <p:spPr>
           <a:xfrm flipV="1">
-            <a:off x="1005840" y="2011680"/>
+            <a:off x="1051560" y="1965960"/>
             <a:ext cx="274320" cy="384048"/>
           </a:xfrm>
           <a:prstGeom prst="line">
@@ -11739,13 +12002,13 @@
       </p:sp>
       <p:sp>
         <p:nvSpPr>
-          <p:cNvPr id="7" name="hatch in 1.4"/>
+          <p:cNvPr id="9" name="hatch in 1.4"/>
           <p:cNvSpPr/>
           <p:nvPr/>
         </p:nvSpPr>
         <p:spPr>
           <a:xfrm flipV="1">
-            <a:off x="1280160" y="2011680"/>
+            <a:off x="1325880" y="1965960"/>
             <a:ext cx="274320" cy="384048"/>
           </a:xfrm>
           <a:prstGeom prst="line">
@@ -11762,13 +12025,13 @@
       </p:sp>
       <p:sp>
         <p:nvSpPr>
-          <p:cNvPr id="8" name="hatch in 1.7"/>
+          <p:cNvPr id="10" name="hatch in 1.8"/>
           <p:cNvSpPr/>
           <p:nvPr/>
         </p:nvSpPr>
         <p:spPr>
           <a:xfrm flipV="1">
-            <a:off x="1554480" y="2011680"/>
+            <a:off x="1600200" y="1965960"/>
             <a:ext cx="274320" cy="384048"/>
           </a:xfrm>
           <a:prstGeom prst="line">
@@ -11785,13 +12048,13 @@
       </p:sp>
       <p:sp>
         <p:nvSpPr>
-          <p:cNvPr id="9" name="hatch in 2.0"/>
+          <p:cNvPr id="11" name="hatch in 2.0"/>
           <p:cNvSpPr/>
           <p:nvPr/>
         </p:nvSpPr>
         <p:spPr>
           <a:xfrm flipV="1">
-            <a:off x="1828800" y="2011680"/>
+            <a:off x="1874520" y="1965960"/>
             <a:ext cx="274320" cy="384048"/>
           </a:xfrm>
           <a:prstGeom prst="line">
@@ -11808,13 +12071,13 @@
       </p:sp>
       <p:sp>
         <p:nvSpPr>
-          <p:cNvPr id="10" name="hatch in 2.3"/>
+          <p:cNvPr id="12" name="hatch in 2.3"/>
           <p:cNvSpPr/>
           <p:nvPr/>
         </p:nvSpPr>
         <p:spPr>
           <a:xfrm flipV="1">
-            <a:off x="2103120" y="2011680"/>
+            <a:off x="2148840" y="1965960"/>
             <a:ext cx="274320" cy="384048"/>
           </a:xfrm>
           <a:prstGeom prst="line">
@@ -11831,13 +12094,13 @@
       </p:sp>
       <p:sp>
         <p:nvSpPr>
-          <p:cNvPr id="11" name="hatch in 2.6"/>
+          <p:cNvPr id="13" name="hatch in 2.6"/>
           <p:cNvSpPr/>
           <p:nvPr/>
         </p:nvSpPr>
         <p:spPr>
           <a:xfrm flipV="1">
-            <a:off x="2377440" y="2011680"/>
+            <a:off x="2423160" y="1965960"/>
             <a:ext cx="274320" cy="384048"/>
           </a:xfrm>
           <a:prstGeom prst="line">
@@ -11854,13 +12117,13 @@
       </p:sp>
       <p:sp>
         <p:nvSpPr>
-          <p:cNvPr id="12" name="hatch in 2.9"/>
+          <p:cNvPr id="14" name="hatch in 2.9"/>
           <p:cNvSpPr/>
           <p:nvPr/>
         </p:nvSpPr>
         <p:spPr>
           <a:xfrm flipV="1">
-            <a:off x="2651760" y="2011680"/>
+            <a:off x="2697480" y="1965960"/>
             <a:ext cx="274320" cy="384048"/>
           </a:xfrm>
           <a:prstGeom prst="line">
@@ -11877,13 +12140,13 @@
       </p:sp>
       <p:sp>
         <p:nvSpPr>
-          <p:cNvPr id="13" name="hatch in 3.2"/>
+          <p:cNvPr id="15" name="hatch in 3.2"/>
           <p:cNvSpPr/>
           <p:nvPr/>
         </p:nvSpPr>
         <p:spPr>
           <a:xfrm flipV="1">
-            <a:off x="2926080" y="2011680"/>
+            <a:off x="2971800" y="1965960"/>
             <a:ext cx="274320" cy="384048"/>
           </a:xfrm>
           <a:prstGeom prst="line">
@@ -11900,13 +12163,13 @@
       </p:sp>
       <p:sp>
         <p:nvSpPr>
-          <p:cNvPr id="14" name="hatch in 3.5"/>
+          <p:cNvPr id="16" name="hatch in 3.5"/>
           <p:cNvSpPr/>
           <p:nvPr/>
         </p:nvSpPr>
         <p:spPr>
           <a:xfrm flipV="1">
-            <a:off x="3200400" y="2011680"/>
+            <a:off x="3246120" y="1965960"/>
             <a:ext cx="274320" cy="384048"/>
           </a:xfrm>
           <a:prstGeom prst="line">
@@ -11923,13 +12186,13 @@
       </p:sp>
       <p:sp>
         <p:nvSpPr>
-          <p:cNvPr id="15" name="hatch in 3.8"/>
+          <p:cNvPr id="17" name="hatch in 3.8"/>
           <p:cNvSpPr/>
           <p:nvPr/>
         </p:nvSpPr>
         <p:spPr>
           <a:xfrm flipV="1">
-            <a:off x="3474720" y="2011680"/>
+            <a:off x="3520440" y="1965960"/>
             <a:ext cx="274320" cy="384048"/>
           </a:xfrm>
           <a:prstGeom prst="line">
@@ -11946,13 +12209,13 @@
       </p:sp>
       <p:sp>
         <p:nvSpPr>
-          <p:cNvPr id="16" name="hatch in 4.1"/>
+          <p:cNvPr id="18" name="hatch in 4.1"/>
           <p:cNvSpPr/>
           <p:nvPr/>
         </p:nvSpPr>
         <p:spPr>
           <a:xfrm flipV="1">
-            <a:off x="3749040" y="2011680"/>
+            <a:off x="3794760" y="1965960"/>
             <a:ext cx="274320" cy="384048"/>
           </a:xfrm>
           <a:prstGeom prst="line">
@@ -11969,13 +12232,13 @@
       </p:sp>
       <p:sp>
         <p:nvSpPr>
-          <p:cNvPr id="17" name="hatch in 4.4"/>
+          <p:cNvPr id="19" name="hatch in 4.4"/>
           <p:cNvSpPr/>
           <p:nvPr/>
         </p:nvSpPr>
         <p:spPr>
           <a:xfrm flipV="1">
-            <a:off x="4023360" y="2011680"/>
+            <a:off x="4069080" y="1965960"/>
             <a:ext cx="274320" cy="384048"/>
           </a:xfrm>
           <a:prstGeom prst="line">
@@ -11992,13 +12255,13 @@
       </p:sp>
       <p:sp>
         <p:nvSpPr>
-          <p:cNvPr id="18" name="hatch in 4.7"/>
+          <p:cNvPr id="20" name="hatch in 4.7"/>
           <p:cNvSpPr/>
           <p:nvPr/>
         </p:nvSpPr>
         <p:spPr>
           <a:xfrm flipV="1">
-            <a:off x="4297680" y="2011680"/>
+            <a:off x="4343400" y="1965960"/>
             <a:ext cx="274320" cy="384048"/>
           </a:xfrm>
           <a:prstGeom prst="line">
@@ -12015,13 +12278,13 @@
       </p:sp>
       <p:sp>
         <p:nvSpPr>
-          <p:cNvPr id="19" name="hatch in 5.0"/>
+          <p:cNvPr id="21" name="hatch in 5.0"/>
           <p:cNvSpPr/>
           <p:nvPr/>
         </p:nvSpPr>
         <p:spPr>
           <a:xfrm flipV="1">
-            <a:off x="4572000" y="2011680"/>
+            <a:off x="4617720" y="1965960"/>
             <a:ext cx="274320" cy="384048"/>
           </a:xfrm>
           <a:prstGeom prst="line">
@@ -12038,13 +12301,13 @@
       </p:sp>
       <p:sp>
         <p:nvSpPr>
-          <p:cNvPr id="20" name="hatch in 5.3"/>
+          <p:cNvPr id="22" name="hatch in 5.3"/>
           <p:cNvSpPr/>
           <p:nvPr/>
         </p:nvSpPr>
         <p:spPr>
           <a:xfrm flipV="1">
-            <a:off x="4846320" y="2011680"/>
+            <a:off x="4892040" y="1965960"/>
             <a:ext cx="274320" cy="384048"/>
           </a:xfrm>
           <a:prstGeom prst="line">
@@ -12061,14 +12324,14 @@
       </p:sp>
       <p:sp>
         <p:nvSpPr>
-          <p:cNvPr id="21" name="ceiling label in"/>
+          <p:cNvPr id="23" name="ceiling label in"/>
           <p:cNvSpPr txBox="1"/>
           <p:nvPr/>
         </p:nvSpPr>
         <p:spPr>
           <a:xfrm>
-            <a:off x="2194560" y="2075688"/>
-            <a:ext cx="1554480" cy="256032"/>
+            <a:off x="2148840" y="2029968"/>
+            <a:ext cx="1828800" cy="256032"/>
           </a:xfrm>
           <a:prstGeom prst="rect">
             <a:avLst/>
@@ -12091,7 +12354,7 @@
                   <a:schemeClr val="tx1"/>
                 </a:solidFill>
               </a:rPr>
-              <a:t>Concrete ceiling</a:t>
+              <a:t>Concrete slab, 200 mm</a:t>
             </a:r>
             <a:endParaRPr lang="en-US" sz="1100" dirty="0"/>
           </a:p>
@@ -12099,14 +12362,14 @@
       </p:sp>
       <p:sp>
         <p:nvSpPr>
-          <p:cNvPr id="22" name="duct in"/>
-          <p:cNvSpPr/>
-          <p:nvPr/>
-        </p:nvSpPr>
-        <p:spPr>
-          <a:xfrm>
-            <a:off x="960120" y="3017520"/>
-            <a:ext cx="1417320" cy="868680"/>
+          <p:cNvPr id="24" name="duct in"/>
+          <p:cNvSpPr/>
+          <p:nvPr/>
+        </p:nvSpPr>
+        <p:spPr>
+          <a:xfrm>
+            <a:off x="1005840" y="3246120"/>
+            <a:ext cx="1554480" cy="960120"/>
           </a:xfrm>
           <a:prstGeom prst="rect">
             <a:avLst/>
@@ -12124,14 +12387,111 @@
       </p:sp>
       <p:sp>
         <p:nvSpPr>
-          <p:cNvPr id="23" name="duct label in"/>
+          <p:cNvPr id="25" name="insulation in"/>
+          <p:cNvSpPr/>
+          <p:nvPr/>
+        </p:nvSpPr>
+        <p:spPr>
+          <a:xfrm>
+            <a:off x="2752344" y="3392424"/>
+            <a:ext cx="896112" cy="896112"/>
+          </a:xfrm>
+          <a:prstGeom prst="ellipse">
+            <a:avLst/>
+          </a:prstGeom>
+          <a:ln w="9525">
+            <a:solidFill>
+              <a:srgbClr val="52514E"/>
+            </a:solidFill>
+            <a:prstDash val="sysDash"/>
+          </a:ln>
+        </p:spPr>
+      </p:sp>
+      <p:sp>
+        <p:nvSpPr>
+          <p:cNvPr id="26" name="pipe a in"/>
+          <p:cNvSpPr/>
+          <p:nvPr/>
+        </p:nvSpPr>
+        <p:spPr>
+          <a:xfrm>
+            <a:off x="2834640" y="3474720"/>
+            <a:ext cx="731520" cy="731520"/>
+          </a:xfrm>
+          <a:prstGeom prst="ellipse">
+            <a:avLst/>
+          </a:prstGeom>
+          <a:solidFill>
+            <a:srgbClr val="EEF1F4"/>
+          </a:solidFill>
+          <a:ln w="12700">
+            <a:solidFill>
+              <a:srgbClr val="52514E"/>
+            </a:solidFill>
+            <a:prstDash val="solid"/>
+          </a:ln>
+        </p:spPr>
+      </p:sp>
+      <p:sp>
+        <p:nvSpPr>
+          <p:cNvPr id="27" name="pipe b in"/>
+          <p:cNvSpPr/>
+          <p:nvPr/>
+        </p:nvSpPr>
+        <p:spPr>
+          <a:xfrm>
+            <a:off x="3840480" y="3749040"/>
+            <a:ext cx="457200" cy="457200"/>
+          </a:xfrm>
+          <a:prstGeom prst="ellipse">
+            <a:avLst/>
+          </a:prstGeom>
+          <a:solidFill>
+            <a:srgbClr val="EEF1F4"/>
+          </a:solidFill>
+          <a:ln w="12700">
+            <a:solidFill>
+              <a:srgbClr val="52514E"/>
+            </a:solidFill>
+            <a:prstDash val="solid"/>
+          </a:ln>
+        </p:spPr>
+      </p:sp>
+      <p:sp>
+        <p:nvSpPr>
+          <p:cNvPr id="28" name="tray in"/>
+          <p:cNvSpPr/>
+          <p:nvPr/>
+        </p:nvSpPr>
+        <p:spPr>
+          <a:xfrm>
+            <a:off x="4434840" y="3913632"/>
+            <a:ext cx="777240" cy="292608"/>
+          </a:xfrm>
+          <a:prstGeom prst="rect">
+            <a:avLst/>
+          </a:prstGeom>
+          <a:solidFill>
+            <a:srgbClr val="EEF1F4"/>
+          </a:solidFill>
+          <a:ln w="12700">
+            <a:solidFill>
+              <a:srgbClr val="52514E"/>
+            </a:solidFill>
+            <a:prstDash val="solid"/>
+          </a:ln>
+        </p:spPr>
+      </p:sp>
+      <p:sp>
+        <p:nvSpPr>
+          <p:cNvPr id="29" name="label duct"/>
           <p:cNvSpPr txBox="1"/>
           <p:nvPr/>
         </p:nvSpPr>
         <p:spPr>
           <a:xfrm>
-            <a:off x="960120" y="3017520"/>
-            <a:ext cx="1417320" cy="868680"/>
+            <a:off x="1005840" y="4279392"/>
+            <a:ext cx="1554480" cy="237744"/>
           </a:xfrm>
           <a:prstGeom prst="rect">
             <a:avLst/>
@@ -12147,102 +12507,27 @@
               <a:buNone/>
             </a:pPr>
             <a:r>
-              <a:rPr lang="en-US" sz="1200" dirty="0">
-                <a:solidFill>
-                  <a:schemeClr val="tx1"/>
+              <a:rPr lang="en-US" sz="1050" dirty="0">
+                <a:solidFill>
+                  <a:srgbClr val="52514E"/>
                 </a:solidFill>
               </a:rPr>
-              <a:t>Duct</a:t>
+              <a:t>Duct 600 × 400</a:t>
             </a:r>
-            <a:endParaRPr lang="en-US" sz="1200" dirty="0"/>
+            <a:endParaRPr lang="en-US" sz="1050" dirty="0"/>
           </a:p>
         </p:txBody>
       </p:sp>
       <p:sp>
         <p:nvSpPr>
-          <p:cNvPr id="24" name="pipe a in"/>
-          <p:cNvSpPr/>
-          <p:nvPr/>
-        </p:nvSpPr>
-        <p:spPr>
-          <a:xfrm>
-            <a:off x="2697480" y="3246120"/>
-            <a:ext cx="640080" cy="640080"/>
-          </a:xfrm>
-          <a:prstGeom prst="ellipse">
-            <a:avLst/>
-          </a:prstGeom>
-          <a:solidFill>
-            <a:srgbClr val="EEF1F4"/>
-          </a:solidFill>
-          <a:ln w="12700">
-            <a:solidFill>
-              <a:srgbClr val="52514E"/>
-            </a:solidFill>
-            <a:prstDash val="solid"/>
-          </a:ln>
-        </p:spPr>
-      </p:sp>
-      <p:sp>
-        <p:nvSpPr>
-          <p:cNvPr id="25" name="pipe b in"/>
-          <p:cNvSpPr/>
-          <p:nvPr/>
-        </p:nvSpPr>
-        <p:spPr>
-          <a:xfrm>
-            <a:off x="3474720" y="3474720"/>
-            <a:ext cx="411480" cy="411480"/>
-          </a:xfrm>
-          <a:prstGeom prst="ellipse">
-            <a:avLst/>
-          </a:prstGeom>
-          <a:solidFill>
-            <a:srgbClr val="EEF1F4"/>
-          </a:solidFill>
-          <a:ln w="12700">
-            <a:solidFill>
-              <a:srgbClr val="52514E"/>
-            </a:solidFill>
-            <a:prstDash val="solid"/>
-          </a:ln>
-        </p:spPr>
-      </p:sp>
-      <p:sp>
-        <p:nvSpPr>
-          <p:cNvPr id="26" name="tray in"/>
-          <p:cNvSpPr/>
-          <p:nvPr/>
-        </p:nvSpPr>
-        <p:spPr>
-          <a:xfrm>
-            <a:off x="3931920" y="3611880"/>
-            <a:ext cx="914400" cy="274320"/>
-          </a:xfrm>
-          <a:prstGeom prst="rect">
-            <a:avLst/>
-          </a:prstGeom>
-          <a:solidFill>
-            <a:srgbClr val="EEF1F4"/>
-          </a:solidFill>
-          <a:ln w="12700">
-            <a:solidFill>
-              <a:srgbClr val="52514E"/>
-            </a:solidFill>
-            <a:prstDash val="solid"/>
-          </a:ln>
-        </p:spPr>
-      </p:sp>
-      <p:sp>
-        <p:nvSpPr>
-          <p:cNvPr id="27" name="pipes label"/>
+          <p:cNvPr id="30" name="label dn80"/>
           <p:cNvSpPr txBox="1"/>
           <p:nvPr/>
         </p:nvSpPr>
         <p:spPr>
           <a:xfrm>
-            <a:off x="2697480" y="3959352"/>
-            <a:ext cx="1188720" cy="274320"/>
+            <a:off x="2560320" y="4279392"/>
+            <a:ext cx="1371600" cy="237744"/>
           </a:xfrm>
           <a:prstGeom prst="rect">
             <a:avLst/>
@@ -12258,27 +12543,27 @@
               <a:buNone/>
             </a:pPr>
             <a:r>
-              <a:rPr lang="en-US" sz="1200" dirty="0">
-                <a:solidFill>
-                  <a:schemeClr val="tx1"/>
+              <a:rPr lang="en-US" sz="1050" dirty="0">
+                <a:solidFill>
+                  <a:srgbClr val="52514E"/>
                 </a:solidFill>
               </a:rPr>
-              <a:t>Pipes</a:t>
+              <a:t>DN80, insulated</a:t>
             </a:r>
-            <a:endParaRPr lang="en-US" sz="1200" dirty="0"/>
+            <a:endParaRPr lang="en-US" sz="1050" dirty="0"/>
           </a:p>
         </p:txBody>
       </p:sp>
       <p:sp>
         <p:nvSpPr>
-          <p:cNvPr id="28" name="tray label"/>
+          <p:cNvPr id="31" name="label dn40"/>
           <p:cNvSpPr txBox="1"/>
           <p:nvPr/>
         </p:nvSpPr>
         <p:spPr>
           <a:xfrm>
-            <a:off x="3840480" y="3959352"/>
-            <a:ext cx="1097280" cy="274320"/>
+            <a:off x="3749040" y="4279392"/>
+            <a:ext cx="640080" cy="237744"/>
           </a:xfrm>
           <a:prstGeom prst="rect">
             <a:avLst/>
@@ -12294,51 +12579,27 @@
               <a:buNone/>
             </a:pPr>
             <a:r>
-              <a:rPr lang="en-US" sz="1200" dirty="0">
-                <a:solidFill>
-                  <a:schemeClr val="tx1"/>
+              <a:rPr lang="en-US" sz="1050" dirty="0">
+                <a:solidFill>
+                  <a:srgbClr val="52514E"/>
                 </a:solidFill>
               </a:rPr>
-              <a:t>Cable tray</a:t>
+              <a:t>DN40</a:t>
             </a:r>
-            <a:endParaRPr lang="en-US" sz="1200" dirty="0"/>
+            <a:endParaRPr lang="en-US" sz="1050" dirty="0"/>
           </a:p>
         </p:txBody>
       </p:sp>
       <p:sp>
         <p:nvSpPr>
-          <p:cNvPr id="29" name="design arrow"/>
-          <p:cNvSpPr/>
-          <p:nvPr/>
-        </p:nvSpPr>
-        <p:spPr>
-          <a:xfrm>
-            <a:off x="5577840" y="3200400"/>
-            <a:ext cx="1033272" cy="0"/>
-          </a:xfrm>
-          <a:prstGeom prst="line">
-            <a:avLst/>
-          </a:prstGeom>
-          <a:noFill/>
-          <a:ln w="19050">
-            <a:solidFill>
-              <a:srgbClr val="52514E"/>
-            </a:solidFill>
-            <a:prstDash val="solid"/>
-            <a:tailEnd type="triangle"/>
-          </a:ln>
-        </p:spPr>
-      </p:sp>
-      <p:sp>
-        <p:nvSpPr>
-          <p:cNvPr id="30" name="design label"/>
+          <p:cNvPr id="32" name="label tray"/>
           <p:cNvSpPr txBox="1"/>
           <p:nvPr/>
         </p:nvSpPr>
         <p:spPr>
           <a:xfrm>
-            <a:off x="5394960" y="2834640"/>
-            <a:ext cx="1399032" cy="274320"/>
+            <a:off x="4297680" y="4279392"/>
+            <a:ext cx="1051560" cy="237744"/>
           </a:xfrm>
           <a:prstGeom prst="rect">
             <a:avLst/>
@@ -12354,36 +12615,318 @@
               <a:buNone/>
             </a:pPr>
             <a:r>
-              <a:rPr lang="en-US" sz="1150" dirty="0">
+              <a:rPr lang="en-US" sz="1050" dirty="0">
                 <a:solidFill>
                   <a:srgbClr val="52514E"/>
                 </a:solidFill>
               </a:rPr>
-              <a:t>design</a:t>
+              <a:t>Cable tray 300</a:t>
             </a:r>
-            <a:endParaRPr lang="en-US" sz="1150" dirty="0"/>
+            <a:endParaRPr lang="en-US" sz="1050" dirty="0"/>
           </a:p>
         </p:txBody>
       </p:sp>
       <p:sp>
         <p:nvSpPr>
-          <p:cNvPr id="31" name="frame out"/>
-          <p:cNvSpPr/>
-          <p:nvPr/>
-        </p:nvSpPr>
-        <p:spPr>
-          <a:xfrm>
-            <a:off x="6793992" y="1828800"/>
-            <a:ext cx="4846320" cy="2743200"/>
+          <p:cNvPr id="33" name="in note"/>
+          <p:cNvSpPr txBox="1"/>
+          <p:nvPr/>
+        </p:nvSpPr>
+        <p:spPr>
+          <a:xfrm>
+            <a:off x="777240" y="4919472"/>
+            <a:ext cx="4572000" cy="502920"/>
+          </a:xfrm>
+          <a:prstGeom prst="rect">
+            <a:avLst/>
+          </a:prstGeom>
+          <a:noFill/>
+          <a:ln/>
+        </p:spPr>
+        <p:txBody>
+          <a:bodyPr wrap="square" lIns="0" tIns="0" rIns="0" bIns="0" rtlCol="0" anchor="ctr"/>
+          <a:lstStyle/>
+          <a:p>
+            <a:pPr indent="0" marL="0">
+              <a:buNone/>
+            </a:pPr>
+            <a:r>
+              <a:rPr lang="en-US" sz="1100" dirty="0">
+                <a:solidFill>
+                  <a:srgbClr val="52514E"/>
+                </a:solidFill>
+              </a:rPr>
+              <a:t>Every element with its kind, trade, size, insulation, position and load per metre. Nothing else.</a:t>
+            </a:r>
+            <a:endParaRPr lang="en-US" sz="1100" dirty="0"/>
+          </a:p>
+        </p:txBody>
+      </p:sp>
+      <p:sp>
+        <p:nvSpPr>
+          <p:cNvPr id="34" name="arrow in"/>
+          <p:cNvSpPr/>
+          <p:nvPr/>
+        </p:nvSpPr>
+        <p:spPr>
+          <a:xfrm>
+            <a:off x="5650992" y="3589020"/>
+            <a:ext cx="123444" cy="0"/>
+          </a:xfrm>
+          <a:prstGeom prst="line">
+            <a:avLst/>
+          </a:prstGeom>
+          <a:noFill/>
+          <a:ln w="19050">
+            <a:solidFill>
+              <a:srgbClr val="52514E"/>
+            </a:solidFill>
+            <a:prstDash val="solid"/>
+          </a:ln>
+        </p:spPr>
+      </p:sp>
+      <p:sp>
+        <p:nvSpPr>
+          <p:cNvPr id="35" name="arrow out"/>
+          <p:cNvSpPr/>
+          <p:nvPr/>
+        </p:nvSpPr>
+        <p:spPr>
+          <a:xfrm>
+            <a:off x="6414516" y="3589020"/>
+            <a:ext cx="123444" cy="0"/>
+          </a:xfrm>
+          <a:prstGeom prst="line">
+            <a:avLst/>
+          </a:prstGeom>
+          <a:noFill/>
+          <a:ln w="19050">
+            <a:solidFill>
+              <a:srgbClr val="52514E"/>
+            </a:solidFill>
+            <a:prstDash val="solid"/>
+            <a:tailEnd type="triangle"/>
+          </a:ln>
+        </p:spPr>
+      </p:sp>
+      <p:sp>
+        <p:nvSpPr>
+          <p:cNvPr id="36" name="icon ring designer"/>
+          <p:cNvSpPr/>
+          <p:nvPr/>
+        </p:nvSpPr>
+        <p:spPr>
+          <a:xfrm>
+            <a:off x="5774436" y="3268980"/>
+            <a:ext cx="640080" cy="640080"/>
+          </a:xfrm>
+          <a:prstGeom prst="ellipse">
+            <a:avLst/>
+          </a:prstGeom>
+          <a:solidFill>
+            <a:schemeClr val="accent1"/>
+          </a:solidFill>
+          <a:ln/>
+        </p:spPr>
+      </p:sp>
+      <p:pic>
+        <p:nvPicPr>
+          <p:cNvPr id="37" name="icon designer" descr="preencoded.png">    </p:cNvPr>
+          <p:cNvPicPr>
+            <a:picLocks noChangeAspect="1"/>
+          </p:cNvPicPr>
+          <p:nvPr/>
+        </p:nvPicPr>
+        <p:blipFill>
+          <a:blip r:embed="rId1"/>
+          <a:stretch>
+            <a:fillRect/>
+          </a:stretch>
+        </p:blipFill>
+        <p:spPr>
+          <a:xfrm>
+            <a:off x="5908853" y="3403397"/>
+            <a:ext cx="371246" cy="371246"/>
+          </a:xfrm>
+          <a:prstGeom prst="rect">
+            <a:avLst/>
+          </a:prstGeom>
+        </p:spPr>
+      </p:pic>
+      <p:sp>
+        <p:nvSpPr>
+          <p:cNvPr id="38" name="designer label"/>
+          <p:cNvSpPr txBox="1"/>
+          <p:nvPr/>
+        </p:nvSpPr>
+        <p:spPr>
+          <a:xfrm>
+            <a:off x="5545836" y="2958084"/>
+            <a:ext cx="1097280" cy="237744"/>
+          </a:xfrm>
+          <a:prstGeom prst="rect">
+            <a:avLst/>
+          </a:prstGeom>
+          <a:noFill/>
+          <a:ln/>
+        </p:spPr>
+        <p:txBody>
+          <a:bodyPr wrap="square" lIns="0" tIns="0" rIns="0" bIns="0" rtlCol="0" anchor="ctr"/>
+          <a:lstStyle/>
+          <a:p>
+            <a:pPr algn="ctr" indent="0" marL="0">
+              <a:buNone/>
+            </a:pPr>
+            <a:r>
+              <a:rPr lang="en-US" sz="1050" b="1" dirty="0">
+                <a:solidFill>
+                  <a:schemeClr val="tx1"/>
+                </a:solidFill>
+              </a:rPr>
+              <a:t>SSA designer</a:t>
+            </a:r>
+            <a:endParaRPr lang="en-US" sz="1050" dirty="0"/>
+          </a:p>
+        </p:txBody>
+      </p:sp>
+      <p:sp>
+        <p:nvSpPr>
+          <p:cNvPr id="39" name="designer sub"/>
+          <p:cNvSpPr txBox="1"/>
+          <p:nvPr/>
+        </p:nvSpPr>
+        <p:spPr>
+          <a:xfrm>
+            <a:off x="5591556" y="3963924"/>
+            <a:ext cx="1005840" cy="237744"/>
+          </a:xfrm>
+          <a:prstGeom prst="rect">
+            <a:avLst/>
+          </a:prstGeom>
+          <a:noFill/>
+          <a:ln/>
+        </p:spPr>
+        <p:txBody>
+          <a:bodyPr wrap="square" lIns="0" tIns="0" rIns="0" bIns="0" rtlCol="0" anchor="ctr"/>
+          <a:lstStyle/>
+          <a:p>
+            <a:pPr algn="ctr" indent="0" marL="0">
+              <a:buNone/>
+            </a:pPr>
+            <a:r>
+              <a:rPr lang="en-US" sz="1050" dirty="0">
+                <a:solidFill>
+                  <a:srgbClr val="52514E"/>
+                </a:solidFill>
+              </a:rPr>
+              <a:t>from a catalog</a:t>
+            </a:r>
+            <a:endParaRPr lang="en-US" sz="1050" dirty="0"/>
+          </a:p>
+        </p:txBody>
+      </p:sp>
+      <p:sp>
+        <p:nvSpPr>
+          <p:cNvPr id="40" name="frame out"/>
+          <p:cNvSpPr/>
+          <p:nvPr/>
+        </p:nvSpPr>
+        <p:spPr>
+          <a:xfrm>
+            <a:off x="6611112" y="1600200"/>
+            <a:ext cx="5029200" cy="3977640"/>
           </a:xfrm>
           <a:prstGeom prst="roundRect">
             <a:avLst>
-              <a:gd name="adj" fmla="val 2000"/>
+              <a:gd name="adj" fmla="val 1379"/>
             </a:avLst>
           </a:prstGeom>
           <a:solidFill>
             <a:srgbClr val="FFFFFF"/>
           </a:solidFill>
+          <a:ln w="15875">
+            <a:solidFill>
+              <a:srgbClr val="1F2933"/>
+            </a:solidFill>
+            <a:prstDash val="solid"/>
+          </a:ln>
+        </p:spPr>
+      </p:sp>
+      <p:sp>
+        <p:nvSpPr>
+          <p:cNvPr id="41" name="tab assembly"/>
+          <p:cNvSpPr/>
+          <p:nvPr/>
+        </p:nvSpPr>
+        <p:spPr>
+          <a:xfrm>
+            <a:off x="6839712" y="1444752"/>
+            <a:ext cx="2377440" cy="310896"/>
+          </a:xfrm>
+          <a:prstGeom prst="roundRect">
+            <a:avLst>
+              <a:gd name="adj" fmla="val 50000"/>
+            </a:avLst>
+          </a:prstGeom>
+          <a:solidFill>
+            <a:srgbClr val="1F2933"/>
+          </a:solidFill>
+          <a:ln/>
+        </p:spPr>
+      </p:sp>
+      <p:sp>
+        <p:nvSpPr>
+          <p:cNvPr id="42" name="tab text assembly"/>
+          <p:cNvSpPr txBox="1"/>
+          <p:nvPr/>
+        </p:nvSpPr>
+        <p:spPr>
+          <a:xfrm>
+            <a:off x="6839712" y="1444752"/>
+            <a:ext cx="2377440" cy="310896"/>
+          </a:xfrm>
+          <a:prstGeom prst="rect">
+            <a:avLst/>
+          </a:prstGeom>
+          <a:noFill/>
+          <a:ln/>
+        </p:spPr>
+        <p:txBody>
+          <a:bodyPr wrap="square" lIns="0" tIns="0" rIns="0" bIns="0" rtlCol="0" anchor="ctr"/>
+          <a:lstStyle/>
+          <a:p>
+            <a:pPr algn="ctr" indent="0" marL="0">
+              <a:buNone/>
+            </a:pPr>
+            <a:r>
+              <a:rPr lang="en-US" sz="1100" b="1" dirty="0">
+                <a:solidFill>
+                  <a:srgbClr val="FFFFFF"/>
+                </a:solidFill>
+              </a:rPr>
+              <a:t>FEASIBLE SSA  ·  the answer</a:t>
+            </a:r>
+            <a:endParaRPr lang="en-US" sz="1100" dirty="0"/>
+          </a:p>
+        </p:txBody>
+      </p:sp>
+      <p:sp>
+        <p:nvSpPr>
+          <p:cNvPr id="43" name="ceiling out"/>
+          <p:cNvSpPr/>
+          <p:nvPr/>
+        </p:nvSpPr>
+        <p:spPr>
+          <a:xfrm>
+            <a:off x="6839712" y="1965960"/>
+            <a:ext cx="4572000" cy="384048"/>
+          </a:xfrm>
+          <a:prstGeom prst="rect">
+            <a:avLst/>
+          </a:prstGeom>
+          <a:solidFill>
+            <a:srgbClr val="EEF1F4"/>
+          </a:solidFill>
           <a:ln w="9525">
             <a:solidFill>
               <a:srgbClr val="52514E"/>
@@ -12394,38 +12937,13 @@
       </p:sp>
       <p:sp>
         <p:nvSpPr>
-          <p:cNvPr id="32" name="ceiling out"/>
-          <p:cNvSpPr/>
-          <p:nvPr/>
-        </p:nvSpPr>
-        <p:spPr>
-          <a:xfrm>
-            <a:off x="6976872" y="2011680"/>
-            <a:ext cx="4480560" cy="384048"/>
-          </a:xfrm>
-          <a:prstGeom prst="rect">
-            <a:avLst/>
-          </a:prstGeom>
-          <a:solidFill>
-            <a:srgbClr val="EEF1F4"/>
-          </a:solidFill>
-          <a:ln w="9525">
-            <a:solidFill>
-              <a:srgbClr val="52514E"/>
-            </a:solidFill>
-            <a:prstDash val="solid"/>
-          </a:ln>
-        </p:spPr>
-      </p:sp>
-      <p:sp>
-        <p:nvSpPr>
-          <p:cNvPr id="33" name="hatch out 7.6"/>
+          <p:cNvPr id="44" name="hatch out 7.5"/>
           <p:cNvSpPr/>
           <p:nvPr/>
         </p:nvSpPr>
         <p:spPr>
           <a:xfrm flipV="1">
-            <a:off x="6976872" y="2011680"/>
+            <a:off x="6839712" y="1965960"/>
             <a:ext cx="274320" cy="384048"/>
           </a:xfrm>
           <a:prstGeom prst="line">
@@ -12442,13 +12960,13 @@
       </p:sp>
       <p:sp>
         <p:nvSpPr>
-          <p:cNvPr id="34" name="hatch out 7.9"/>
+          <p:cNvPr id="45" name="hatch out 7.8"/>
           <p:cNvSpPr/>
           <p:nvPr/>
         </p:nvSpPr>
         <p:spPr>
           <a:xfrm flipV="1">
-            <a:off x="7251192" y="2011680"/>
+            <a:off x="7114032" y="1965960"/>
             <a:ext cx="274320" cy="384048"/>
           </a:xfrm>
           <a:prstGeom prst="line">
@@ -12465,13 +12983,13 @@
       </p:sp>
       <p:sp>
         <p:nvSpPr>
-          <p:cNvPr id="35" name="hatch out 8.2"/>
+          <p:cNvPr id="46" name="hatch out 8.1"/>
           <p:cNvSpPr/>
           <p:nvPr/>
         </p:nvSpPr>
         <p:spPr>
           <a:xfrm flipV="1">
-            <a:off x="7525512" y="2011680"/>
+            <a:off x="7388352" y="1965960"/>
             <a:ext cx="274320" cy="384048"/>
           </a:xfrm>
           <a:prstGeom prst="line">
@@ -12488,13 +13006,13 @@
       </p:sp>
       <p:sp>
         <p:nvSpPr>
-          <p:cNvPr id="36" name="hatch out 8.5"/>
+          <p:cNvPr id="47" name="hatch out 8.4"/>
           <p:cNvSpPr/>
           <p:nvPr/>
         </p:nvSpPr>
         <p:spPr>
           <a:xfrm flipV="1">
-            <a:off x="7799832" y="2011680"/>
+            <a:off x="7662672" y="1965960"/>
             <a:ext cx="274320" cy="384048"/>
           </a:xfrm>
           <a:prstGeom prst="line">
@@ -12511,13 +13029,13 @@
       </p:sp>
       <p:sp>
         <p:nvSpPr>
-          <p:cNvPr id="37" name="hatch out 8.8"/>
+          <p:cNvPr id="48" name="hatch out 8.7"/>
           <p:cNvSpPr/>
           <p:nvPr/>
         </p:nvSpPr>
         <p:spPr>
           <a:xfrm flipV="1">
-            <a:off x="8074152" y="2011680"/>
+            <a:off x="7936992" y="1965960"/>
             <a:ext cx="274320" cy="384048"/>
           </a:xfrm>
           <a:prstGeom prst="line">
@@ -12534,13 +13052,13 @@
       </p:sp>
       <p:sp>
         <p:nvSpPr>
-          <p:cNvPr id="38" name="hatch out 9.1"/>
+          <p:cNvPr id="49" name="hatch out 9.0"/>
           <p:cNvSpPr/>
           <p:nvPr/>
         </p:nvSpPr>
         <p:spPr>
           <a:xfrm flipV="1">
-            <a:off x="8348472" y="2011680"/>
+            <a:off x="8211312" y="1965960"/>
             <a:ext cx="274320" cy="384048"/>
           </a:xfrm>
           <a:prstGeom prst="line">
@@ -12557,13 +13075,13 @@
       </p:sp>
       <p:sp>
         <p:nvSpPr>
-          <p:cNvPr id="39" name="hatch out 9.4"/>
+          <p:cNvPr id="50" name="hatch out 9.3"/>
           <p:cNvSpPr/>
           <p:nvPr/>
         </p:nvSpPr>
         <p:spPr>
           <a:xfrm flipV="1">
-            <a:off x="8622792" y="2011680"/>
+            <a:off x="8485632" y="1965960"/>
             <a:ext cx="274320" cy="384048"/>
           </a:xfrm>
           <a:prstGeom prst="line">
@@ -12580,13 +13098,13 @@
       </p:sp>
       <p:sp>
         <p:nvSpPr>
-          <p:cNvPr id="40" name="hatch out 9.7"/>
+          <p:cNvPr id="51" name="hatch out 9.6"/>
           <p:cNvSpPr/>
           <p:nvPr/>
         </p:nvSpPr>
         <p:spPr>
           <a:xfrm flipV="1">
-            <a:off x="8897112" y="2011680"/>
+            <a:off x="8759952" y="1965960"/>
             <a:ext cx="274320" cy="384048"/>
           </a:xfrm>
           <a:prstGeom prst="line">
@@ -12603,13 +13121,13 @@
       </p:sp>
       <p:sp>
         <p:nvSpPr>
-          <p:cNvPr id="41" name="hatch out 10.0"/>
+          <p:cNvPr id="52" name="hatch out 9.9"/>
           <p:cNvSpPr/>
           <p:nvPr/>
         </p:nvSpPr>
         <p:spPr>
           <a:xfrm flipV="1">
-            <a:off x="9171432" y="2011680"/>
+            <a:off x="9034272" y="1965960"/>
             <a:ext cx="274320" cy="384048"/>
           </a:xfrm>
           <a:prstGeom prst="line">
@@ -12626,13 +13144,13 @@
       </p:sp>
       <p:sp>
         <p:nvSpPr>
-          <p:cNvPr id="42" name="hatch out 10.3"/>
+          <p:cNvPr id="53" name="hatch out 10.2"/>
           <p:cNvSpPr/>
           <p:nvPr/>
         </p:nvSpPr>
         <p:spPr>
           <a:xfrm flipV="1">
-            <a:off x="9445752" y="2011680"/>
+            <a:off x="9308592" y="1965960"/>
             <a:ext cx="274320" cy="384048"/>
           </a:xfrm>
           <a:prst